<commit_message>
PPT slide 4: 3-way comparison (manual vs AI-per-line vs ours) on 1M logs/day with 12-month cost chart
Co-authored-by: arena-agent <297053741+arena-agent@users.noreply.github.com>
</commit_message>
<xml_diff>
--- a/presentation/SIH2026_Idea_Submission.pptx
+++ b/presentation/SIH2026_Idea_Submission.pptx
@@ -110,6 +110,616 @@
     </a:lvl9pPr>
   </p:defaultTextStyle>
 </p:presentation>
+</file>
+
+<file path=ppt/charts/chart1.xml><?xml version="1.0" encoding="utf-8"?>
+<c:chartSpace xmlns:c="http://schemas.openxmlformats.org/drawingml/2006/chart" xmlns:a="http://schemas.openxmlformats.org/drawingml/2006/main" xmlns:r="http://schemas.openxmlformats.org/officeDocument/2006/relationships">
+  <c:date1904 val="0"/>
+  <c:chart>
+    <c:title>
+      <c:tx>
+        <c:rich>
+          <a:bodyPr/>
+          <a:lstStyle/>
+          <a:p>
+            <a:r>
+              <a:rPr sz="1100" b="1">
+                <a:solidFill>
+                  <a:srgbClr val="0B2A5B"/>
+                </a:solidFill>
+              </a:rPr>
+              <a:t>12-month total cost (₹ lakh, log scale)</a:t>
+            </a:r>
+          </a:p>
+        </c:rich>
+      </c:tx>
+      <c:layout/>
+      <c:overlay val="0"/>
+    </c:title>
+    <c:autoTitleDeleted val="0"/>
+    <c:plotArea>
+      <c:lineChart>
+        <c:grouping val="standard"/>
+        <c:varyColors val="0"/>
+        <c:ser>
+          <c:idx val="0"/>
+          <c:order val="0"/>
+          <c:tx>
+            <c:strRef>
+              <c:f>Sheet1!$B$1</c:f>
+              <c:strCache>
+                <c:ptCount val="1"/>
+                <c:pt idx="0">
+                  <c:v>Manual era</c:v>
+                </c:pt>
+              </c:strCache>
+            </c:strRef>
+          </c:tx>
+          <c:spPr>
+            <a:ln w="31750">
+              <a:solidFill>
+                <a:srgbClr val="7F8C8D"/>
+              </a:solidFill>
+            </a:ln>
+          </c:spPr>
+          <c:marker>
+            <c:size val="4"/>
+            <c:spPr>
+              <a:solidFill>
+                <a:srgbClr val="7F8C8D"/>
+              </a:solidFill>
+              <a:ln>
+                <a:solidFill>
+                  <a:srgbClr val="7F8C8D"/>
+                </a:solidFill>
+              </a:ln>
+            </c:spPr>
+          </c:marker>
+          <c:dLbls>
+            <c:dLbl>
+              <c:idx val="11"/>
+              <c:tx>
+                <c:rich>
+                  <a:bodyPr/>
+                  <a:lstStyle/>
+                  <a:p>
+                    <a:r>
+                      <a:rPr sz="1000" b="1">
+                        <a:solidFill>
+                          <a:srgbClr val="7F8C8D"/>
+                        </a:solidFill>
+                      </a:rPr>
+                      <a:t>₹6.1 L</a:t>
+                    </a:r>
+                  </a:p>
+                </c:rich>
+              </c:tx>
+              <c:dLblPos val="t"/>
+              <c:showLegendKey val="0"/>
+              <c:showVal val="1"/>
+              <c:showCatName val="0"/>
+              <c:showSerName val="0"/>
+              <c:showPercent val="0"/>
+              <c:showBubbleSize val="0"/>
+            </c:dLbl>
+            <c:showLegendKey val="0"/>
+            <c:showVal val="0"/>
+            <c:showCatName val="0"/>
+            <c:showSerName val="0"/>
+            <c:showPercent val="0"/>
+            <c:showBubbleSize val="0"/>
+            <c:showLeaderLines val="1"/>
+          </c:dLbls>
+          <c:cat>
+            <c:strRef>
+              <c:f>Sheet1!$A$2:$A$13</c:f>
+              <c:strCache>
+                <c:ptCount val="12"/>
+                <c:pt idx="0">
+                  <c:v>M1</c:v>
+                </c:pt>
+                <c:pt idx="1">
+                  <c:v>M2</c:v>
+                </c:pt>
+                <c:pt idx="2">
+                  <c:v>M3</c:v>
+                </c:pt>
+                <c:pt idx="3">
+                  <c:v>M4</c:v>
+                </c:pt>
+                <c:pt idx="4">
+                  <c:v>M5</c:v>
+                </c:pt>
+                <c:pt idx="5">
+                  <c:v>M6</c:v>
+                </c:pt>
+                <c:pt idx="6">
+                  <c:v>M7</c:v>
+                </c:pt>
+                <c:pt idx="7">
+                  <c:v>M8</c:v>
+                </c:pt>
+                <c:pt idx="8">
+                  <c:v>M9</c:v>
+                </c:pt>
+                <c:pt idx="9">
+                  <c:v>M10</c:v>
+                </c:pt>
+                <c:pt idx="10">
+                  <c:v>M11</c:v>
+                </c:pt>
+                <c:pt idx="11">
+                  <c:v>M12</c:v>
+                </c:pt>
+              </c:strCache>
+            </c:strRef>
+          </c:cat>
+          <c:val>
+            <c:numRef>
+              <c:f>Sheet1!$B$2:$B$13</c:f>
+              <c:numCache>
+                <c:formatCode>General</c:formatCode>
+                <c:ptCount val="12"/>
+                <c:pt idx="0">
+                  <c:v>2.8</c:v>
+                </c:pt>
+                <c:pt idx="1">
+                  <c:v>3.1</c:v>
+                </c:pt>
+                <c:pt idx="2">
+                  <c:v>3.4</c:v>
+                </c:pt>
+                <c:pt idx="3">
+                  <c:v>3.7</c:v>
+                </c:pt>
+                <c:pt idx="4">
+                  <c:v>4.0</c:v>
+                </c:pt>
+                <c:pt idx="5">
+                  <c:v>4.3</c:v>
+                </c:pt>
+                <c:pt idx="6">
+                  <c:v>4.6</c:v>
+                </c:pt>
+                <c:pt idx="7">
+                  <c:v>4.9</c:v>
+                </c:pt>
+                <c:pt idx="8">
+                  <c:v>5.2</c:v>
+                </c:pt>
+                <c:pt idx="9">
+                  <c:v>5.5</c:v>
+                </c:pt>
+                <c:pt idx="10">
+                  <c:v>5.8</c:v>
+                </c:pt>
+                <c:pt idx="11">
+                  <c:v>6.1</c:v>
+                </c:pt>
+              </c:numCache>
+            </c:numRef>
+          </c:val>
+          <c:smooth val="0"/>
+        </c:ser>
+        <c:ser>
+          <c:idx val="1"/>
+          <c:order val="1"/>
+          <c:tx>
+            <c:strRef>
+              <c:f>Sheet1!$C$1</c:f>
+              <c:strCache>
+                <c:ptCount val="1"/>
+                <c:pt idx="0">
+                  <c:v>AI on every line</c:v>
+                </c:pt>
+              </c:strCache>
+            </c:strRef>
+          </c:tx>
+          <c:spPr>
+            <a:ln w="31750">
+              <a:solidFill>
+                <a:srgbClr val="C0392B"/>
+              </a:solidFill>
+            </a:ln>
+          </c:spPr>
+          <c:marker>
+            <c:size val="4"/>
+            <c:spPr>
+              <a:solidFill>
+                <a:srgbClr val="C0392B"/>
+              </a:solidFill>
+              <a:ln>
+                <a:solidFill>
+                  <a:srgbClr val="C0392B"/>
+                </a:solidFill>
+              </a:ln>
+            </c:spPr>
+          </c:marker>
+          <c:dLbls>
+            <c:dLbl>
+              <c:idx val="11"/>
+              <c:tx>
+                <c:rich>
+                  <a:bodyPr/>
+                  <a:lstStyle/>
+                  <a:p>
+                    <a:r>
+                      <a:rPr sz="1000" b="1">
+                        <a:solidFill>
+                          <a:srgbClr val="C0392B"/>
+                        </a:solidFill>
+                      </a:rPr>
+                      <a:t>₹1.04 Cr</a:t>
+                    </a:r>
+                  </a:p>
+                </c:rich>
+              </c:tx>
+              <c:dLblPos val="t"/>
+              <c:showLegendKey val="0"/>
+              <c:showVal val="1"/>
+              <c:showCatName val="0"/>
+              <c:showSerName val="0"/>
+              <c:showPercent val="0"/>
+              <c:showBubbleSize val="0"/>
+            </c:dLbl>
+            <c:showLegendKey val="0"/>
+            <c:showVal val="0"/>
+            <c:showCatName val="0"/>
+            <c:showSerName val="0"/>
+            <c:showPercent val="0"/>
+            <c:showBubbleSize val="0"/>
+            <c:showLeaderLines val="1"/>
+          </c:dLbls>
+          <c:cat>
+            <c:strRef>
+              <c:f>Sheet1!$A$2:$A$13</c:f>
+              <c:strCache>
+                <c:ptCount val="12"/>
+                <c:pt idx="0">
+                  <c:v>M1</c:v>
+                </c:pt>
+                <c:pt idx="1">
+                  <c:v>M2</c:v>
+                </c:pt>
+                <c:pt idx="2">
+                  <c:v>M3</c:v>
+                </c:pt>
+                <c:pt idx="3">
+                  <c:v>M4</c:v>
+                </c:pt>
+                <c:pt idx="4">
+                  <c:v>M5</c:v>
+                </c:pt>
+                <c:pt idx="5">
+                  <c:v>M6</c:v>
+                </c:pt>
+                <c:pt idx="6">
+                  <c:v>M7</c:v>
+                </c:pt>
+                <c:pt idx="7">
+                  <c:v>M8</c:v>
+                </c:pt>
+                <c:pt idx="8">
+                  <c:v>M9</c:v>
+                </c:pt>
+                <c:pt idx="9">
+                  <c:v>M10</c:v>
+                </c:pt>
+                <c:pt idx="10">
+                  <c:v>M11</c:v>
+                </c:pt>
+                <c:pt idx="11">
+                  <c:v>M12</c:v>
+                </c:pt>
+              </c:strCache>
+            </c:strRef>
+          </c:cat>
+          <c:val>
+            <c:numRef>
+              <c:f>Sheet1!$C$2:$C$13</c:f>
+              <c:numCache>
+                <c:formatCode>General</c:formatCode>
+                <c:ptCount val="12"/>
+                <c:pt idx="0">
+                  <c:v>8.67</c:v>
+                </c:pt>
+                <c:pt idx="1">
+                  <c:v>17.34</c:v>
+                </c:pt>
+                <c:pt idx="2">
+                  <c:v>26.01</c:v>
+                </c:pt>
+                <c:pt idx="3">
+                  <c:v>34.68</c:v>
+                </c:pt>
+                <c:pt idx="4">
+                  <c:v>43.35</c:v>
+                </c:pt>
+                <c:pt idx="5">
+                  <c:v>52.02</c:v>
+                </c:pt>
+                <c:pt idx="6">
+                  <c:v>60.69</c:v>
+                </c:pt>
+                <c:pt idx="7">
+                  <c:v>69.36</c:v>
+                </c:pt>
+                <c:pt idx="8">
+                  <c:v>78.03</c:v>
+                </c:pt>
+                <c:pt idx="9">
+                  <c:v>86.7</c:v>
+                </c:pt>
+                <c:pt idx="10">
+                  <c:v>95.37</c:v>
+                </c:pt>
+                <c:pt idx="11">
+                  <c:v>104.04</c:v>
+                </c:pt>
+              </c:numCache>
+            </c:numRef>
+          </c:val>
+          <c:smooth val="0"/>
+        </c:ser>
+        <c:ser>
+          <c:idx val="2"/>
+          <c:order val="2"/>
+          <c:tx>
+            <c:strRef>
+              <c:f>Sheet1!$D$1</c:f>
+              <c:strCache>
+                <c:ptCount val="1"/>
+                <c:pt idx="0">
+                  <c:v>Our solution</c:v>
+                </c:pt>
+              </c:strCache>
+            </c:strRef>
+          </c:tx>
+          <c:spPr>
+            <a:ln w="31750">
+              <a:solidFill>
+                <a:srgbClr val="138A36"/>
+              </a:solidFill>
+            </a:ln>
+          </c:spPr>
+          <c:marker>
+            <c:size val="4"/>
+            <c:spPr>
+              <a:solidFill>
+                <a:srgbClr val="138A36"/>
+              </a:solidFill>
+              <a:ln>
+                <a:solidFill>
+                  <a:srgbClr val="138A36"/>
+                </a:solidFill>
+              </a:ln>
+            </c:spPr>
+          </c:marker>
+          <c:dLbls>
+            <c:dLbl>
+              <c:idx val="11"/>
+              <c:tx>
+                <c:rich>
+                  <a:bodyPr/>
+                  <a:lstStyle/>
+                  <a:p>
+                    <a:r>
+                      <a:rPr sz="1000" b="1">
+                        <a:solidFill>
+                          <a:srgbClr val="138A36"/>
+                        </a:solidFill>
+                      </a:rPr>
+                      <a:t>₹1.3 L</a:t>
+                    </a:r>
+                  </a:p>
+                </c:rich>
+              </c:tx>
+              <c:dLblPos val="b"/>
+              <c:showLegendKey val="0"/>
+              <c:showVal val="1"/>
+              <c:showCatName val="0"/>
+              <c:showSerName val="0"/>
+              <c:showPercent val="0"/>
+              <c:showBubbleSize val="0"/>
+            </c:dLbl>
+            <c:showLegendKey val="0"/>
+            <c:showVal val="0"/>
+            <c:showCatName val="0"/>
+            <c:showSerName val="0"/>
+            <c:showPercent val="0"/>
+            <c:showBubbleSize val="0"/>
+            <c:showLeaderLines val="1"/>
+          </c:dLbls>
+          <c:cat>
+            <c:strRef>
+              <c:f>Sheet1!$A$2:$A$13</c:f>
+              <c:strCache>
+                <c:ptCount val="12"/>
+                <c:pt idx="0">
+                  <c:v>M1</c:v>
+                </c:pt>
+                <c:pt idx="1">
+                  <c:v>M2</c:v>
+                </c:pt>
+                <c:pt idx="2">
+                  <c:v>M3</c:v>
+                </c:pt>
+                <c:pt idx="3">
+                  <c:v>M4</c:v>
+                </c:pt>
+                <c:pt idx="4">
+                  <c:v>M5</c:v>
+                </c:pt>
+                <c:pt idx="5">
+                  <c:v>M6</c:v>
+                </c:pt>
+                <c:pt idx="6">
+                  <c:v>M7</c:v>
+                </c:pt>
+                <c:pt idx="7">
+                  <c:v>M8</c:v>
+                </c:pt>
+                <c:pt idx="8">
+                  <c:v>M9</c:v>
+                </c:pt>
+                <c:pt idx="9">
+                  <c:v>M10</c:v>
+                </c:pt>
+                <c:pt idx="10">
+                  <c:v>M11</c:v>
+                </c:pt>
+                <c:pt idx="11">
+                  <c:v>M12</c:v>
+                </c:pt>
+              </c:strCache>
+            </c:strRef>
+          </c:cat>
+          <c:val>
+            <c:numRef>
+              <c:f>Sheet1!$D$2:$D$13</c:f>
+              <c:numCache>
+                <c:formatCode>General</c:formatCode>
+                <c:ptCount val="12"/>
+                <c:pt idx="0">
+                  <c:v>0.151</c:v>
+                </c:pt>
+                <c:pt idx="1">
+                  <c:v>0.253</c:v>
+                </c:pt>
+                <c:pt idx="2">
+                  <c:v>0.354</c:v>
+                </c:pt>
+                <c:pt idx="3">
+                  <c:v>0.456</c:v>
+                </c:pt>
+                <c:pt idx="4">
+                  <c:v>0.557</c:v>
+                </c:pt>
+                <c:pt idx="5">
+                  <c:v>0.658</c:v>
+                </c:pt>
+                <c:pt idx="6">
+                  <c:v>0.76</c:v>
+                </c:pt>
+                <c:pt idx="7">
+                  <c:v>0.861</c:v>
+                </c:pt>
+                <c:pt idx="8">
+                  <c:v>0.963</c:v>
+                </c:pt>
+                <c:pt idx="9">
+                  <c:v>1.064</c:v>
+                </c:pt>
+                <c:pt idx="10">
+                  <c:v>1.165</c:v>
+                </c:pt>
+                <c:pt idx="11">
+                  <c:v>1.267</c:v>
+                </c:pt>
+              </c:numCache>
+            </c:numRef>
+          </c:val>
+          <c:smooth val="0"/>
+        </c:ser>
+        <c:marker val="1"/>
+        <c:smooth val="0"/>
+        <c:axId val="2118791784"/>
+        <c:axId val="2140495176"/>
+      </c:lineChart>
+      <c:catAx>
+        <c:axId val="2118791784"/>
+        <c:scaling>
+          <c:orientation val="minMax"/>
+        </c:scaling>
+        <c:delete val="0"/>
+        <c:axPos val="b"/>
+        <c:majorTickMark val="out"/>
+        <c:minorTickMark val="none"/>
+        <c:tickLblPos val="nextTo"/>
+        <c:txPr>
+          <a:bodyPr/>
+          <a:lstStyle/>
+          <a:p>
+            <a:pPr>
+              <a:defRPr sz="900"/>
+            </a:pPr>
+          </a:p>
+        </c:txPr>
+        <c:crossAx val="2140495176"/>
+        <c:crosses val="autoZero"/>
+        <c:auto val="1"/>
+        <c:lblAlgn val="ctr"/>
+        <c:lblOffset val="100"/>
+        <c:noMultiLvlLbl val="0"/>
+      </c:catAx>
+      <c:valAx>
+        <c:axId val="2140495176"/>
+        <c:scaling>
+          <c:logBase val="10"/>
+          <c:max val="1000.0"/>
+          <c:min val="0.1"/>
+        </c:scaling>
+        <c:delete val="0"/>
+        <c:axPos val="l"/>
+        <c:majorGridlines>
+          <c:spPr>
+            <a:ln>
+              <a:solidFill>
+                <a:srgbClr val="E6E6E6"/>
+              </a:solidFill>
+            </a:ln>
+          </c:spPr>
+        </c:majorGridlines>
+        <c:majorTickMark val="out"/>
+        <c:minorTickMark val="none"/>
+        <c:tickLblPos val="nextTo"/>
+        <c:txPr>
+          <a:bodyPr/>
+          <a:lstStyle/>
+          <a:p>
+            <a:pPr>
+              <a:defRPr sz="900"/>
+            </a:pPr>
+          </a:p>
+        </c:txPr>
+        <c:crossAx val="2118791784"/>
+        <c:crosses val="autoZero"/>
+      </c:valAx>
+    </c:plotArea>
+    <c:legend>
+      <c:legendPos val="b"/>
+      <c:layout/>
+      <c:overlay val="0"/>
+      <c:txPr>
+        <a:bodyPr/>
+        <a:lstStyle/>
+        <a:p>
+          <a:pPr>
+            <a:defRPr sz="950"/>
+          </a:pPr>
+        </a:p>
+      </c:txPr>
+    </c:legend>
+    <c:plotVisOnly val="1"/>
+    <c:dispBlanksAs val="gap"/>
+    <c:showDLblsOverMax val="0"/>
+  </c:chart>
+  <c:txPr>
+    <a:bodyPr/>
+    <a:lstStyle/>
+    <a:p>
+      <a:pPr>
+        <a:defRPr sz="900">
+          <a:latin typeface="Calibri"/>
+        </a:defRPr>
+      </a:pPr>
+      <a:endParaRPr lang="en-US"/>
+    </a:p>
+  </c:txPr>
+  <c:externalData r:id="rId1">
+    <c:autoUpdate val="0"/>
+  </c:externalData>
+</c:chartSpace>
 </file>
 
 <file path=ppt/slideLayouts/slideLayout1.xml><?xml version="1.0" encoding="utf-8"?>
@@ -10631,8 +11241,8 @@
         </p:nvSpPr>
         <p:spPr>
           <a:xfrm>
-            <a:off x="365760" y="1097280"/>
-            <a:ext cx="3657600" cy="3429000"/>
+            <a:off x="365760" y="1069848"/>
+            <a:ext cx="3657600" cy="2103120"/>
           </a:xfrm>
           <a:prstGeom prst="roundRect">
             <a:avLst>
@@ -10679,8 +11289,8 @@
         </p:nvSpPr>
         <p:spPr>
           <a:xfrm>
-            <a:off x="365760" y="1097280"/>
-            <a:ext cx="3657600" cy="457200"/>
+            <a:off x="365760" y="1069848"/>
+            <a:ext cx="3657600" cy="384048"/>
           </a:xfrm>
           <a:prstGeom prst="roundRect">
             <a:avLst>
@@ -10725,8 +11335,8 @@
         </p:nvSpPr>
         <p:spPr>
           <a:xfrm>
-            <a:off x="365760" y="1097280"/>
-            <a:ext cx="3657600" cy="457200"/>
+            <a:off x="365760" y="1069848"/>
+            <a:ext cx="3657600" cy="384048"/>
           </a:xfrm>
           <a:prstGeom prst="rect">
             <a:avLst/>
@@ -10745,7 +11355,7 @@
               </a:spcAft>
             </a:pPr>
             <a:r>
-              <a:rPr sz="1500" b="1">
+              <a:rPr sz="1350" b="1">
                 <a:solidFill>
                   <a:srgbClr val="FFFFFF"/>
                 </a:solidFill>
@@ -10764,8 +11374,8 @@
         </p:nvSpPr>
         <p:spPr>
           <a:xfrm>
-            <a:off x="530352" y="1691640"/>
-            <a:ext cx="3364992" cy="2743200"/>
+            <a:off x="493776" y="1545336"/>
+            <a:ext cx="3438144" cy="1554479"/>
           </a:xfrm>
           <a:prstGeom prst="rect">
             <a:avLst/>
@@ -10780,11 +11390,11 @@
           <a:p>
             <a:pPr algn="l">
               <a:spcAft>
-                <a:spcPts val="100"/>
+                <a:spcPts val="500"/>
               </a:spcAft>
             </a:pPr>
             <a:r>
-              <a:rPr sz="1250" b="1">
+              <a:rPr sz="1150" b="1">
                 <a:solidFill>
                   <a:srgbClr val="138A36"/>
                 </a:solidFill>
@@ -10793,39 +11403,66 @@
               <a:t>✔ </a:t>
             </a:r>
             <a:r>
-              <a:rPr sz="1250" b="1">
+              <a:rPr sz="1150" b="1">
                 <a:solidFill>
                   <a:srgbClr val="0B2A5B"/>
                 </a:solidFill>
                 <a:latin typeface="Calibri"/>
               </a:rPr>
-              <a:t>Proven technology</a:t>
+              <a:t>Proven tech:</a:t>
+            </a:r>
+            <a:r>
+              <a:rPr sz="1150" b="0">
+                <a:solidFill>
+                  <a:srgbClr val="1E2530"/>
+                </a:solidFill>
+                <a:latin typeface="Calibri"/>
+              </a:rPr>
+              <a:t> free, trusted open-source tools.</a:t>
             </a:r>
           </a:p>
           <a:p>
             <a:pPr algn="l">
               <a:spcAft>
-                <a:spcPts val="800"/>
+                <a:spcPts val="500"/>
               </a:spcAft>
             </a:pPr>
             <a:r>
-              <a:rPr sz="1250" b="0">
+              <a:rPr sz="1150" b="1">
+                <a:solidFill>
+                  <a:srgbClr val="138A36"/>
+                </a:solidFill>
+                <a:latin typeface="Calibri"/>
+              </a:rPr>
+              <a:t>✔ </a:t>
+            </a:r>
+            <a:r>
+              <a:rPr sz="1150" b="1">
+                <a:solidFill>
+                  <a:srgbClr val="0B2A5B"/>
+                </a:solidFill>
+                <a:latin typeface="Calibri"/>
+              </a:rPr>
+              <a:t>Low cost:</a:t>
+            </a:r>
+            <a:r>
+              <a:rPr sz="1150" b="0">
                 <a:solidFill>
                   <a:srgbClr val="1E2530"/>
                 </a:solidFill>
                 <a:latin typeface="Calibri"/>
               </a:rPr>
-              <a:t>Built on free, trusted open-source tools.</a:t>
+              <a:t> AI used only for new log formats.</a:t>
             </a:r>
           </a:p>
           <a:p>
             <a:pPr algn="l">
               <a:spcAft>
-                <a:spcPts val="100"/>
+                <a:spcPts val="500"/>
               </a:spcAft>
             </a:pPr>
             <a:r>
-              <a:rPr sz="1250" b="1">
+              <a:rPr sz="1150" b="1">
                 <a:solidFill>
                   <a:srgbClr val="138A36"/>
                 </a:solidFill>
@@ -10834,111 +11471,56 @@
               <a:t>✔ </a:t>
             </a:r>
             <a:r>
-              <a:rPr sz="1250" b="1">
+              <a:rPr sz="1150" b="1">
                 <a:solidFill>
                   <a:srgbClr val="0B2A5B"/>
                 </a:solidFill>
                 <a:latin typeface="Calibri"/>
               </a:rPr>
-              <a:t>Low cost</a:t>
+              <a:t>Easy to adopt:</a:t>
+            </a:r>
+            <a:r>
+              <a:rPr sz="1150" b="0">
+                <a:solidFill>
+                  <a:srgbClr val="1E2530"/>
+                </a:solidFill>
+                <a:latin typeface="Calibri"/>
+              </a:rPr>
+              <a:t> plug in any log source, no parser writing.</a:t>
             </a:r>
           </a:p>
           <a:p>
             <a:pPr algn="l">
               <a:spcAft>
-                <a:spcPts val="800"/>
+                <a:spcPts val="500"/>
               </a:spcAft>
             </a:pPr>
             <a:r>
-              <a:rPr sz="1250" b="0">
+              <a:rPr sz="1150" b="1">
+                <a:solidFill>
+                  <a:srgbClr val="138A36"/>
+                </a:solidFill>
+                <a:latin typeface="Calibri"/>
+              </a:rPr>
+              <a:t>✔ </a:t>
+            </a:r>
+            <a:r>
+              <a:rPr sz="1150" b="1">
+                <a:solidFill>
+                  <a:srgbClr val="0B2A5B"/>
+                </a:solidFill>
+                <a:latin typeface="Calibri"/>
+              </a:rPr>
+              <a:t>Data available:</a:t>
+            </a:r>
+            <a:r>
+              <a:rPr sz="1150" b="0">
                 <a:solidFill>
                   <a:srgbClr val="1E2530"/>
                 </a:solidFill>
                 <a:latin typeface="Calibri"/>
               </a:rPr>
-              <a:t>AI is used only for new log formats, so bills stay small.</a:t>
-            </a:r>
-          </a:p>
-          <a:p>
-            <a:pPr algn="l">
-              <a:spcAft>
-                <a:spcPts val="100"/>
-              </a:spcAft>
-            </a:pPr>
-            <a:r>
-              <a:rPr sz="1250" b="1">
-                <a:solidFill>
-                  <a:srgbClr val="138A36"/>
-                </a:solidFill>
-                <a:latin typeface="Calibri"/>
-              </a:rPr>
-              <a:t>✔ </a:t>
-            </a:r>
-            <a:r>
-              <a:rPr sz="1250" b="1">
-                <a:solidFill>
-                  <a:srgbClr val="0B2A5B"/>
-                </a:solidFill>
-                <a:latin typeface="Calibri"/>
-              </a:rPr>
-              <a:t>Easy to adopt</a:t>
-            </a:r>
-          </a:p>
-          <a:p>
-            <a:pPr algn="l">
-              <a:spcAft>
-                <a:spcPts val="800"/>
-              </a:spcAft>
-            </a:pPr>
-            <a:r>
-              <a:rPr sz="1250" b="0">
-                <a:solidFill>
-                  <a:srgbClr val="1E2530"/>
-                </a:solidFill>
-                <a:latin typeface="Calibri"/>
-              </a:rPr>
-              <a:t>Connect any log source; no parser writing needed.</a:t>
-            </a:r>
-          </a:p>
-          <a:p>
-            <a:pPr algn="l">
-              <a:spcAft>
-                <a:spcPts val="100"/>
-              </a:spcAft>
-            </a:pPr>
-            <a:r>
-              <a:rPr sz="1250" b="1">
-                <a:solidFill>
-                  <a:srgbClr val="138A36"/>
-                </a:solidFill>
-                <a:latin typeface="Calibri"/>
-              </a:rPr>
-              <a:t>✔ </a:t>
-            </a:r>
-            <a:r>
-              <a:rPr sz="1250" b="1">
-                <a:solidFill>
-                  <a:srgbClr val="0B2A5B"/>
-                </a:solidFill>
-                <a:latin typeface="Calibri"/>
-              </a:rPr>
-              <a:t>Data available</a:t>
-            </a:r>
-          </a:p>
-          <a:p>
-            <a:pPr algn="l">
-              <a:spcAft>
-                <a:spcPts val="800"/>
-              </a:spcAft>
-            </a:pPr>
-            <a:r>
-              <a:rPr sz="1250" b="0">
-                <a:solidFill>
-                  <a:srgbClr val="1E2530"/>
-                </a:solidFill>
-                <a:latin typeface="Calibri"/>
-              </a:rPr>
-              <a:t>Uses public log datasets; no private data needed.</a:t>
+              <a:t> public log datasets, no private data.</a:t>
             </a:r>
           </a:p>
         </p:txBody>
@@ -10951,8 +11533,8 @@
         </p:nvSpPr>
         <p:spPr>
           <a:xfrm>
-            <a:off x="8165592" y="1097280"/>
-            <a:ext cx="3703320" cy="3429000"/>
+            <a:off x="8165592" y="1069848"/>
+            <a:ext cx="3703320" cy="2103120"/>
           </a:xfrm>
           <a:prstGeom prst="roundRect">
             <a:avLst>
@@ -10999,8 +11581,8 @@
         </p:nvSpPr>
         <p:spPr>
           <a:xfrm>
-            <a:off x="8165592" y="1097280"/>
-            <a:ext cx="3703320" cy="457200"/>
+            <a:off x="8165592" y="1069848"/>
+            <a:ext cx="3703320" cy="384048"/>
           </a:xfrm>
           <a:prstGeom prst="roundRect">
             <a:avLst>
@@ -11045,8 +11627,8 @@
         </p:nvSpPr>
         <p:spPr>
           <a:xfrm>
-            <a:off x="8165592" y="1097280"/>
-            <a:ext cx="3703320" cy="457200"/>
+            <a:off x="8165592" y="1069848"/>
+            <a:ext cx="3703320" cy="384048"/>
           </a:xfrm>
           <a:prstGeom prst="rect">
             <a:avLst/>
@@ -11065,7 +11647,7 @@
               </a:spcAft>
             </a:pPr>
             <a:r>
-              <a:rPr sz="1500" b="1">
+              <a:rPr sz="1350" b="1">
                 <a:solidFill>
                   <a:srgbClr val="FFFFFF"/>
                 </a:solidFill>
@@ -11084,8 +11666,8 @@
         </p:nvSpPr>
         <p:spPr>
           <a:xfrm>
-            <a:off x="8330183" y="1691640"/>
-            <a:ext cx="3410712" cy="2743200"/>
+            <a:off x="8293608" y="1545336"/>
+            <a:ext cx="3483863" cy="1554479"/>
           </a:xfrm>
           <a:prstGeom prst="rect">
             <a:avLst/>
@@ -11100,11 +11682,11 @@
           <a:p>
             <a:pPr algn="l">
               <a:spcAft>
-                <a:spcPts val="100"/>
+                <a:spcPts val="500"/>
               </a:spcAft>
             </a:pPr>
             <a:r>
-              <a:rPr sz="1250" b="1">
+              <a:rPr sz="1150" b="1">
                 <a:solidFill>
                   <a:srgbClr val="1F5FBF"/>
                 </a:solidFill>
@@ -11113,39 +11695,66 @@
               <a:t>✔ </a:t>
             </a:r>
             <a:r>
-              <a:rPr sz="1250" b="1">
+              <a:rPr sz="1150" b="1">
                 <a:solidFill>
                   <a:srgbClr val="0B2A5B"/>
                 </a:solidFill>
                 <a:latin typeface="Calibri"/>
               </a:rPr>
-              <a:t>Real need</a:t>
+              <a:t>Real need:</a:t>
+            </a:r>
+            <a:r>
+              <a:rPr sz="1150" b="0">
+                <a:solidFill>
+                  <a:srgbClr val="1E2530"/>
+                </a:solidFill>
+                <a:latin typeface="Calibri"/>
+              </a:rPr>
+              <a:t> CERT-In asks for 180 days of logs.</a:t>
             </a:r>
           </a:p>
           <a:p>
             <a:pPr algn="l">
               <a:spcAft>
-                <a:spcPts val="800"/>
+                <a:spcPts val="500"/>
               </a:spcAft>
             </a:pPr>
             <a:r>
-              <a:rPr sz="1250" b="0">
+              <a:rPr sz="1150" b="1">
+                <a:solidFill>
+                  <a:srgbClr val="1F5FBF"/>
+                </a:solidFill>
+                <a:latin typeface="Calibri"/>
+              </a:rPr>
+              <a:t>✔ </a:t>
+            </a:r>
+            <a:r>
+              <a:rPr sz="1150" b="1">
+                <a:solidFill>
+                  <a:srgbClr val="0B2A5B"/>
+                </a:solidFill>
+                <a:latin typeface="Calibri"/>
+              </a:rPr>
+              <a:t>Stays in India:</a:t>
+            </a:r>
+            <a:r>
+              <a:rPr sz="1150" b="0">
                 <a:solidFill>
                   <a:srgbClr val="1E2530"/>
                 </a:solidFill>
                 <a:latin typeface="Calibri"/>
               </a:rPr>
-              <a:t>CERT-In asks every organisation to keep 180 days of logs.</a:t>
+              <a:t> runs on Indian / on-premise servers.</a:t>
             </a:r>
           </a:p>
           <a:p>
             <a:pPr algn="l">
               <a:spcAft>
-                <a:spcPts val="100"/>
+                <a:spcPts val="500"/>
               </a:spcAft>
             </a:pPr>
             <a:r>
-              <a:rPr sz="1250" b="1">
+              <a:rPr sz="1150" b="1">
                 <a:solidFill>
                   <a:srgbClr val="1F5FBF"/>
                 </a:solidFill>
@@ -11154,111 +11763,56 @@
               <a:t>✔ </a:t>
             </a:r>
             <a:r>
-              <a:rPr sz="1250" b="1">
+              <a:rPr sz="1150" b="1">
                 <a:solidFill>
                   <a:srgbClr val="0B2A5B"/>
                 </a:solidFill>
                 <a:latin typeface="Calibri"/>
               </a:rPr>
-              <a:t>Data stays in India</a:t>
+              <a:t>Business model:</a:t>
+            </a:r>
+            <a:r>
+              <a:rPr sz="1150" b="0">
+                <a:solidFill>
+                  <a:srgbClr val="1E2530"/>
+                </a:solidFill>
+                <a:latin typeface="Calibri"/>
+              </a:rPr>
+              <a:t> free core + paid govt support.</a:t>
             </a:r>
           </a:p>
           <a:p>
             <a:pPr algn="l">
               <a:spcAft>
-                <a:spcPts val="800"/>
+                <a:spcPts val="500"/>
               </a:spcAft>
             </a:pPr>
             <a:r>
-              <a:rPr sz="1250" b="0">
+              <a:rPr sz="1150" b="1">
+                <a:solidFill>
+                  <a:srgbClr val="1F5FBF"/>
+                </a:solidFill>
+                <a:latin typeface="Calibri"/>
+              </a:rPr>
+              <a:t>✔ </a:t>
+            </a:r>
+            <a:r>
+              <a:rPr sz="1150" b="1">
+                <a:solidFill>
+                  <a:srgbClr val="0B2A5B"/>
+                </a:solidFill>
+                <a:latin typeface="Calibri"/>
+              </a:rPr>
+              <a:t>Grows easily:</a:t>
+            </a:r>
+            <a:r>
+              <a:rPr sz="1150" b="0">
                 <a:solidFill>
                   <a:srgbClr val="1E2530"/>
                 </a:solidFill>
                 <a:latin typeface="Calibri"/>
               </a:rPr>
-              <a:t>Can run on Indian / on-premise servers.</a:t>
-            </a:r>
-          </a:p>
-          <a:p>
-            <a:pPr algn="l">
-              <a:spcAft>
-                <a:spcPts val="100"/>
-              </a:spcAft>
-            </a:pPr>
-            <a:r>
-              <a:rPr sz="1250" b="1">
-                <a:solidFill>
-                  <a:srgbClr val="1F5FBF"/>
-                </a:solidFill>
-                <a:latin typeface="Calibri"/>
-              </a:rPr>
-              <a:t>✔ </a:t>
-            </a:r>
-            <a:r>
-              <a:rPr sz="1250" b="1">
-                <a:solidFill>
-                  <a:srgbClr val="0B2A5B"/>
-                </a:solidFill>
-                <a:latin typeface="Calibri"/>
-              </a:rPr>
-              <a:t>Business model</a:t>
-            </a:r>
-          </a:p>
-          <a:p>
-            <a:pPr algn="l">
-              <a:spcAft>
-                <a:spcPts val="800"/>
-              </a:spcAft>
-            </a:pPr>
-            <a:r>
-              <a:rPr sz="1250" b="0">
-                <a:solidFill>
-                  <a:srgbClr val="1E2530"/>
-                </a:solidFill>
-                <a:latin typeface="Calibri"/>
-              </a:rPr>
-              <a:t>Free open-source core + paid support for govt &amp; companies.</a:t>
-            </a:r>
-          </a:p>
-          <a:p>
-            <a:pPr algn="l">
-              <a:spcAft>
-                <a:spcPts val="100"/>
-              </a:spcAft>
-            </a:pPr>
-            <a:r>
-              <a:rPr sz="1250" b="1">
-                <a:solidFill>
-                  <a:srgbClr val="1F5FBF"/>
-                </a:solidFill>
-                <a:latin typeface="Calibri"/>
-              </a:rPr>
-              <a:t>✔ </a:t>
-            </a:r>
-            <a:r>
-              <a:rPr sz="1250" b="1">
-                <a:solidFill>
-                  <a:srgbClr val="0B2A5B"/>
-                </a:solidFill>
-                <a:latin typeface="Calibri"/>
-              </a:rPr>
-              <a:t>Grows easily</a:t>
-            </a:r>
-          </a:p>
-          <a:p>
-            <a:pPr algn="l">
-              <a:spcAft>
-                <a:spcPts val="800"/>
-              </a:spcAft>
-            </a:pPr>
-            <a:r>
-              <a:rPr sz="1250" b="0">
-                <a:solidFill>
-                  <a:srgbClr val="1E2530"/>
-                </a:solidFill>
-                <a:latin typeface="Calibri"/>
-              </a:rPr>
-              <a:t>More logs do not mean more AI cost.</a:t>
+              <a:t> more logs ≠ more AI cost.</a:t>
             </a:r>
           </a:p>
         </p:txBody>
@@ -11271,8 +11825,8 @@
         </p:nvSpPr>
         <p:spPr>
           <a:xfrm>
-            <a:off x="4206240" y="1097280"/>
-            <a:ext cx="3776472" cy="3429000"/>
+            <a:off x="4206240" y="1069848"/>
+            <a:ext cx="3776472" cy="2103120"/>
           </a:xfrm>
           <a:prstGeom prst="roundRect">
             <a:avLst>
@@ -11319,8 +11873,8 @@
         </p:nvSpPr>
         <p:spPr>
           <a:xfrm>
-            <a:off x="4206240" y="1097280"/>
-            <a:ext cx="3776472" cy="457200"/>
+            <a:off x="4206240" y="1069848"/>
+            <a:ext cx="3776472" cy="384048"/>
           </a:xfrm>
           <a:prstGeom prst="roundRect">
             <a:avLst>
@@ -11365,8 +11919,8 @@
         </p:nvSpPr>
         <p:spPr>
           <a:xfrm>
-            <a:off x="4206240" y="1097280"/>
-            <a:ext cx="3776472" cy="457200"/>
+            <a:off x="4206240" y="1069848"/>
+            <a:ext cx="3776472" cy="384048"/>
           </a:xfrm>
           <a:prstGeom prst="rect">
             <a:avLst/>
@@ -11385,7 +11939,7 @@
               </a:spcAft>
             </a:pPr>
             <a:r>
-              <a:rPr sz="1500" b="1">
+              <a:rPr sz="1350" b="1">
                 <a:solidFill>
                   <a:srgbClr val="FFFFFF"/>
                 </a:solidFill>
@@ -11404,12 +11958,12 @@
         </p:nvSpPr>
         <p:spPr>
           <a:xfrm>
-            <a:off x="4343400" y="1719072"/>
-            <a:ext cx="1600200" cy="603504"/>
+            <a:off x="4315968" y="1545336"/>
+            <a:ext cx="1627632" cy="347472"/>
           </a:xfrm>
           <a:prstGeom prst="roundRect">
             <a:avLst>
-              <a:gd name="adj" fmla="val 15000"/>
+              <a:gd name="adj" fmla="val 20000"/>
             </a:avLst>
           </a:prstGeom>
           <a:solidFill>
@@ -11450,8 +12004,8 @@
         </p:nvSpPr>
         <p:spPr>
           <a:xfrm>
-            <a:off x="4370832" y="1719072"/>
-            <a:ext cx="1545336" cy="603504"/>
+            <a:off x="4315968" y="1545336"/>
+            <a:ext cx="1627632" cy="347472"/>
           </a:xfrm>
           <a:prstGeom prst="rect">
             <a:avLst/>
@@ -11470,7 +12024,7 @@
               </a:spcAft>
             </a:pPr>
             <a:r>
-              <a:rPr sz="1150" b="1">
+              <a:rPr sz="1050" b="1">
                 <a:solidFill>
                   <a:srgbClr val="C0392B"/>
                 </a:solidFill>
@@ -11489,8 +12043,8 @@
         </p:nvSpPr>
         <p:spPr>
           <a:xfrm>
-            <a:off x="5916168" y="1719072"/>
-            <a:ext cx="274320" cy="603504"/>
+            <a:off x="5943600" y="1545336"/>
+            <a:ext cx="256032" cy="347472"/>
           </a:xfrm>
           <a:prstGeom prst="rect">
             <a:avLst/>
@@ -11509,7 +12063,7 @@
               </a:spcAft>
             </a:pPr>
             <a:r>
-              <a:rPr sz="1600" b="1">
+              <a:rPr sz="1300" b="1">
                 <a:solidFill>
                   <a:srgbClr val="5B6778"/>
                 </a:solidFill>
@@ -11528,12 +12082,12 @@
         </p:nvSpPr>
         <p:spPr>
           <a:xfrm>
-            <a:off x="6217920" y="1719072"/>
-            <a:ext cx="1645920" cy="603504"/>
+            <a:off x="6199632" y="1545336"/>
+            <a:ext cx="1673352" cy="347472"/>
           </a:xfrm>
           <a:prstGeom prst="roundRect">
             <a:avLst>
-              <a:gd name="adj" fmla="val 15000"/>
+              <a:gd name="adj" fmla="val 20000"/>
             </a:avLst>
           </a:prstGeom>
           <a:solidFill>
@@ -11574,8 +12128,8 @@
         </p:nvSpPr>
         <p:spPr>
           <a:xfrm>
-            <a:off x="6245352" y="1719072"/>
-            <a:ext cx="1591056" cy="603504"/>
+            <a:off x="6199632" y="1545336"/>
+            <a:ext cx="1673352" cy="347472"/>
           </a:xfrm>
           <a:prstGeom prst="rect">
             <a:avLst/>
@@ -11594,13 +12148,13 @@
               </a:spcAft>
             </a:pPr>
             <a:r>
-              <a:rPr sz="1150" b="1">
+              <a:rPr sz="1050" b="1">
                 <a:solidFill>
                   <a:srgbClr val="138A36"/>
                 </a:solidFill>
                 <a:latin typeface="Calibri"/>
               </a:rPr>
-              <a:t>Switches to a backup AI, then built-in rules</a:t>
+              <a:t>Backup AI, then built-in rules</a:t>
             </a:r>
           </a:p>
         </p:txBody>
@@ -11613,12 +12167,12 @@
         </p:nvSpPr>
         <p:spPr>
           <a:xfrm>
-            <a:off x="4343400" y="2414015"/>
-            <a:ext cx="1600200" cy="603504"/>
+            <a:off x="4315968" y="1947672"/>
+            <a:ext cx="1627632" cy="347472"/>
           </a:xfrm>
           <a:prstGeom prst="roundRect">
             <a:avLst>
-              <a:gd name="adj" fmla="val 15000"/>
+              <a:gd name="adj" fmla="val 20000"/>
             </a:avLst>
           </a:prstGeom>
           <a:solidFill>
@@ -11659,8 +12213,8 @@
         </p:nvSpPr>
         <p:spPr>
           <a:xfrm>
-            <a:off x="4370832" y="2414015"/>
-            <a:ext cx="1545336" cy="603504"/>
+            <a:off x="4315968" y="1947672"/>
+            <a:ext cx="1627632" cy="347472"/>
           </a:xfrm>
           <a:prstGeom prst="rect">
             <a:avLst/>
@@ -11679,13 +12233,13 @@
               </a:spcAft>
             </a:pPr>
             <a:r>
-              <a:rPr sz="1150" b="1">
+              <a:rPr sz="1050" b="1">
                 <a:solidFill>
                   <a:srgbClr val="C0392B"/>
                 </a:solidFill>
                 <a:latin typeface="Calibri"/>
               </a:rPr>
-              <a:t>AI cost at large scale</a:t>
+              <a:t>AI cost at scale</a:t>
             </a:r>
           </a:p>
         </p:txBody>
@@ -11698,8 +12252,8 @@
         </p:nvSpPr>
         <p:spPr>
           <a:xfrm>
-            <a:off x="5916168" y="2414015"/>
-            <a:ext cx="274320" cy="603504"/>
+            <a:off x="5943600" y="1947672"/>
+            <a:ext cx="256032" cy="347472"/>
           </a:xfrm>
           <a:prstGeom prst="rect">
             <a:avLst/>
@@ -11718,7 +12272,7 @@
               </a:spcAft>
             </a:pPr>
             <a:r>
-              <a:rPr sz="1600" b="1">
+              <a:rPr sz="1300" b="1">
                 <a:solidFill>
                   <a:srgbClr val="5B6778"/>
                 </a:solidFill>
@@ -11737,12 +12291,12 @@
         </p:nvSpPr>
         <p:spPr>
           <a:xfrm>
-            <a:off x="6217920" y="2414015"/>
-            <a:ext cx="1645920" cy="603504"/>
+            <a:off x="6199632" y="1947672"/>
+            <a:ext cx="1673352" cy="347472"/>
           </a:xfrm>
           <a:prstGeom prst="roundRect">
             <a:avLst>
-              <a:gd name="adj" fmla="val 15000"/>
+              <a:gd name="adj" fmla="val 20000"/>
             </a:avLst>
           </a:prstGeom>
           <a:solidFill>
@@ -11783,8 +12337,8 @@
         </p:nvSpPr>
         <p:spPr>
           <a:xfrm>
-            <a:off x="6245352" y="2414015"/>
-            <a:ext cx="1591056" cy="603504"/>
+            <a:off x="6199632" y="1947672"/>
+            <a:ext cx="1673352" cy="347472"/>
           </a:xfrm>
           <a:prstGeom prst="rect">
             <a:avLst/>
@@ -11803,13 +12357,13 @@
               </a:spcAft>
             </a:pPr>
             <a:r>
-              <a:rPr sz="1150" b="1">
+              <a:rPr sz="1050" b="1">
                 <a:solidFill>
                   <a:srgbClr val="138A36"/>
                 </a:solidFill>
                 <a:latin typeface="Calibri"/>
               </a:rPr>
-              <a:t>AI runs once per log format, not per line</a:t>
+              <a:t>AI once per format, not per line</a:t>
             </a:r>
           </a:p>
         </p:txBody>
@@ -11822,12 +12376,12 @@
         </p:nvSpPr>
         <p:spPr>
           <a:xfrm>
-            <a:off x="4343400" y="3108960"/>
-            <a:ext cx="1600200" cy="603504"/>
+            <a:off x="4315968" y="2350008"/>
+            <a:ext cx="1627632" cy="347472"/>
           </a:xfrm>
           <a:prstGeom prst="roundRect">
             <a:avLst>
-              <a:gd name="adj" fmla="val 15000"/>
+              <a:gd name="adj" fmla="val 20000"/>
             </a:avLst>
           </a:prstGeom>
           <a:solidFill>
@@ -11868,8 +12422,8 @@
         </p:nvSpPr>
         <p:spPr>
           <a:xfrm>
-            <a:off x="4370832" y="3108960"/>
-            <a:ext cx="1545336" cy="603504"/>
+            <a:off x="4315968" y="2350008"/>
+            <a:ext cx="1627632" cy="347472"/>
           </a:xfrm>
           <a:prstGeom prst="rect">
             <a:avLst/>
@@ -11888,13 +12442,13 @@
               </a:spcAft>
             </a:pPr>
             <a:r>
-              <a:rPr sz="1150" b="1">
+              <a:rPr sz="1050" b="1">
                 <a:solidFill>
                   <a:srgbClr val="C0392B"/>
                 </a:solidFill>
                 <a:latin typeface="Calibri"/>
               </a:rPr>
-              <a:t>A normal log looks 'new'</a:t>
+              <a:t>Normal log looks 'new'</a:t>
             </a:r>
           </a:p>
         </p:txBody>
@@ -11907,8 +12461,8 @@
         </p:nvSpPr>
         <p:spPr>
           <a:xfrm>
-            <a:off x="5916168" y="3108960"/>
-            <a:ext cx="274320" cy="603504"/>
+            <a:off x="5943600" y="2350008"/>
+            <a:ext cx="256032" cy="347472"/>
           </a:xfrm>
           <a:prstGeom prst="rect">
             <a:avLst/>
@@ -11927,7 +12481,7 @@
               </a:spcAft>
             </a:pPr>
             <a:r>
-              <a:rPr sz="1600" b="1">
+              <a:rPr sz="1300" b="1">
                 <a:solidFill>
                   <a:srgbClr val="5B6778"/>
                 </a:solidFill>
@@ -11946,12 +12500,12 @@
         </p:nvSpPr>
         <p:spPr>
           <a:xfrm>
-            <a:off x="6217920" y="3108960"/>
-            <a:ext cx="1645920" cy="603504"/>
+            <a:off x="6199632" y="2350008"/>
+            <a:ext cx="1673352" cy="347472"/>
           </a:xfrm>
           <a:prstGeom prst="roundRect">
             <a:avLst>
-              <a:gd name="adj" fmla="val 15000"/>
+              <a:gd name="adj" fmla="val 20000"/>
             </a:avLst>
           </a:prstGeom>
           <a:solidFill>
@@ -11992,8 +12546,8 @@
         </p:nvSpPr>
         <p:spPr>
           <a:xfrm>
-            <a:off x="6245352" y="3108960"/>
-            <a:ext cx="1591056" cy="603504"/>
+            <a:off x="6199632" y="2350008"/>
+            <a:ext cx="1673352" cy="347472"/>
           </a:xfrm>
           <a:prstGeom prst="rect">
             <a:avLst/>
@@ -12012,7 +12566,7 @@
               </a:spcAft>
             </a:pPr>
             <a:r>
-              <a:rPr sz="1150" b="1">
+              <a:rPr sz="1050" b="1">
                 <a:solidFill>
                   <a:srgbClr val="138A36"/>
                 </a:solidFill>
@@ -12031,12 +12585,12 @@
         </p:nvSpPr>
         <p:spPr>
           <a:xfrm>
-            <a:off x="4343400" y="3803904"/>
-            <a:ext cx="1600200" cy="603504"/>
+            <a:off x="4315968" y="2752344"/>
+            <a:ext cx="1627632" cy="347472"/>
           </a:xfrm>
           <a:prstGeom prst="roundRect">
             <a:avLst>
-              <a:gd name="adj" fmla="val 15000"/>
+              <a:gd name="adj" fmla="val 20000"/>
             </a:avLst>
           </a:prstGeom>
           <a:solidFill>
@@ -12077,8 +12631,8 @@
         </p:nvSpPr>
         <p:spPr>
           <a:xfrm>
-            <a:off x="4370832" y="3803904"/>
-            <a:ext cx="1545336" cy="603504"/>
+            <a:off x="4315968" y="2752344"/>
+            <a:ext cx="1627632" cy="347472"/>
           </a:xfrm>
           <a:prstGeom prst="rect">
             <a:avLst/>
@@ -12097,13 +12651,13 @@
               </a:spcAft>
             </a:pPr>
             <a:r>
-              <a:rPr sz="1150" b="1">
+              <a:rPr sz="1050" b="1">
                 <a:solidFill>
                   <a:srgbClr val="C0392B"/>
                 </a:solidFill>
                 <a:latin typeface="Calibri"/>
               </a:rPr>
-              <a:t>Brand-new systems appear</a:t>
+              <a:t>Brand-new systems</a:t>
             </a:r>
           </a:p>
         </p:txBody>
@@ -12116,8 +12670,8 @@
         </p:nvSpPr>
         <p:spPr>
           <a:xfrm>
-            <a:off x="5916168" y="3803904"/>
-            <a:ext cx="274320" cy="603504"/>
+            <a:off x="5943600" y="2752344"/>
+            <a:ext cx="256032" cy="347472"/>
           </a:xfrm>
           <a:prstGeom prst="rect">
             <a:avLst/>
@@ -12136,7 +12690,7 @@
               </a:spcAft>
             </a:pPr>
             <a:r>
-              <a:rPr sz="1600" b="1">
+              <a:rPr sz="1300" b="1">
                 <a:solidFill>
                   <a:srgbClr val="5B6778"/>
                 </a:solidFill>
@@ -12155,12 +12709,12 @@
         </p:nvSpPr>
         <p:spPr>
           <a:xfrm>
-            <a:off x="6217920" y="3803904"/>
-            <a:ext cx="1645920" cy="603504"/>
+            <a:off x="6199632" y="2752344"/>
+            <a:ext cx="1673352" cy="347472"/>
           </a:xfrm>
           <a:prstGeom prst="roundRect">
             <a:avLst>
-              <a:gd name="adj" fmla="val 15000"/>
+              <a:gd name="adj" fmla="val 20000"/>
             </a:avLst>
           </a:prstGeom>
           <a:solidFill>
@@ -12201,8 +12755,8 @@
         </p:nvSpPr>
         <p:spPr>
           <a:xfrm>
-            <a:off x="6245352" y="3803904"/>
-            <a:ext cx="1591056" cy="603504"/>
+            <a:off x="6199632" y="2752344"/>
+            <a:ext cx="1673352" cy="347472"/>
           </a:xfrm>
           <a:prstGeom prst="rect">
             <a:avLst/>
@@ -12221,73 +12775,27 @@
               </a:spcAft>
             </a:pPr>
             <a:r>
-              <a:rPr sz="1150" b="1">
+              <a:rPr sz="1050" b="1">
                 <a:solidFill>
                   <a:srgbClr val="138A36"/>
                 </a:solidFill>
                 <a:latin typeface="Calibri"/>
               </a:rPr>
-              <a:t>Model retrained with one command</a:t>
-            </a:r>
-          </a:p>
-        </p:txBody>
-      </p:sp>
-      <p:sp>
-        <p:nvSpPr>
-          <p:cNvPr id="41" name="Rounded Rectangle 40"/>
-          <p:cNvSpPr/>
-          <p:nvPr/>
-        </p:nvSpPr>
-        <p:spPr>
-          <a:xfrm>
-            <a:off x="365760" y="4681728"/>
-            <a:ext cx="11503152" cy="1673352"/>
-          </a:xfrm>
-          <a:prstGeom prst="roundRect">
-            <a:avLst>
-              <a:gd name="adj" fmla="val 6000"/>
-            </a:avLst>
-          </a:prstGeom>
-          <a:solidFill>
-            <a:srgbClr val="F2F5FA"/>
-          </a:solidFill>
-          <a:ln>
-            <a:noFill/>
-          </a:ln>
-          <a:effectLst/>
-        </p:spPr>
-        <p:style>
-          <a:lnRef idx="1">
-            <a:schemeClr val="accent1"/>
-          </a:lnRef>
-          <a:fillRef idx="3">
-            <a:schemeClr val="accent1"/>
-          </a:fillRef>
-          <a:effectRef idx="2">
-            <a:schemeClr val="accent1"/>
-          </a:effectRef>
-          <a:fontRef idx="minor">
-            <a:schemeClr val="lt1"/>
-          </a:fontRef>
-        </p:style>
-        <p:txBody>
-          <a:bodyPr rtlCol="0" anchor="ctr"/>
-          <a:lstStyle/>
-          <a:p>
-            <a:pPr algn="ctr"/>
-          </a:p>
-        </p:txBody>
-      </p:sp>
-      <p:sp>
-        <p:nvSpPr>
-          <p:cNvPr id="42" name="TextBox 41"/>
+              <a:t>Retrain with one command</a:t>
+            </a:r>
+          </a:p>
+        </p:txBody>
+      </p:sp>
+      <p:sp>
+        <p:nvSpPr>
+          <p:cNvPr id="41" name="TextBox 40"/>
           <p:cNvSpPr txBox="1"/>
           <p:nvPr/>
         </p:nvSpPr>
         <p:spPr>
           <a:xfrm>
-            <a:off x="548640" y="4736592"/>
-            <a:ext cx="10972800" cy="292608"/>
+            <a:off x="365760" y="3291840"/>
+            <a:ext cx="11521440" cy="310896"/>
           </a:xfrm>
           <a:prstGeom prst="rect">
             <a:avLst/>
@@ -12306,65 +12814,636 @@
               </a:spcAft>
             </a:pPr>
             <a:r>
-              <a:rPr sz="1250" b="1">
+              <a:rPr sz="1300" b="1">
                 <a:solidFill>
                   <a:srgbClr val="0B2A5B"/>
                 </a:solidFill>
                 <a:latin typeface="Calibri"/>
               </a:rPr>
-              <a:t>TESTED ON REAL-WORLD LOGS  (public Loghub datasets)</a:t>
-            </a:r>
-          </a:p>
-        </p:txBody>
-      </p:sp>
-      <p:sp>
-        <p:nvSpPr>
-          <p:cNvPr id="43" name="Rounded Rectangle 42"/>
-          <p:cNvSpPr/>
-          <p:nvPr/>
-        </p:nvSpPr>
-        <p:spPr>
-          <a:xfrm>
-            <a:off x="548640" y="5074920"/>
-            <a:ext cx="2670048" cy="1143000"/>
-          </a:xfrm>
-          <a:prstGeom prst="roundRect">
-            <a:avLst>
-              <a:gd name="adj" fmla="val 10000"/>
-            </a:avLst>
-          </a:prstGeom>
-          <a:solidFill>
-            <a:srgbClr val="FFFFFF"/>
-          </a:solidFill>
-          <a:ln w="12700">
-            <a:solidFill>
-              <a:srgbClr val="D3DBE8"/>
-            </a:solidFill>
-          </a:ln>
-          <a:effectLst/>
-        </p:spPr>
-        <p:style>
-          <a:lnRef idx="1">
-            <a:schemeClr val="accent1"/>
-          </a:lnRef>
-          <a:fillRef idx="3">
-            <a:schemeClr val="accent1"/>
-          </a:fillRef>
-          <a:effectRef idx="2">
-            <a:schemeClr val="accent1"/>
-          </a:effectRef>
-          <a:fontRef idx="minor">
-            <a:schemeClr val="lt1"/>
-          </a:fontRef>
-        </p:style>
-        <p:txBody>
-          <a:bodyPr rtlCol="0" anchor="ctr"/>
-          <a:lstStyle/>
-          <a:p>
-            <a:pPr algn="ctr"/>
-          </a:p>
-        </p:txBody>
-      </p:sp>
+              <a:t>SAME WORKLOAD, THREE APPROACHES:  </a:t>
+            </a:r>
+            <a:r>
+              <a:rPr sz="1300" b="0">
+                <a:solidFill>
+                  <a:srgbClr val="5B6778"/>
+                </a:solidFill>
+                <a:latin typeface="Calibri"/>
+              </a:rPr>
+              <a:t>1 million logs / day in a big organisation (~50 log sources)</a:t>
+            </a:r>
+          </a:p>
+        </p:txBody>
+      </p:sp>
+      <p:graphicFrame>
+        <p:nvGraphicFramePr>
+          <p:cNvPr id="42" name="Table 41"/>
+          <p:cNvGraphicFramePr>
+            <a:graphicFrameLocks noGrp="1"/>
+          </p:cNvGraphicFramePr>
+          <p:nvPr/>
+        </p:nvGraphicFramePr>
+        <p:xfrm>
+          <a:off x="365760" y="3675888"/>
+          <a:ext cx="6720840" cy="2468880"/>
+        </p:xfrm>
+        <a:graphic>
+          <a:graphicData uri="http://schemas.openxmlformats.org/drawingml/2006/table">
+            <a:tbl>
+              <a:tblPr firstRow="0" bandRow="0">
+                <a:tableStyleId>{5C22544A-7EE6-4342-B048-85BDC9FD1C3A}</a:tableStyleId>
+              </a:tblPr>
+              <a:tblGrid>
+                <a:gridCol w="1572768"/>
+                <a:gridCol w="1572768"/>
+                <a:gridCol w="1691640"/>
+                <a:gridCol w="1883664"/>
+              </a:tblGrid>
+              <a:tr h="365760">
+                <a:tc>
+                  <a:txBody>
+                    <a:bodyPr wrap="square"/>
+                    <a:lstStyle/>
+                    <a:p>
+                      <a:pPr algn="l"/>
+                      <a:r>
+                        <a:rPr sz="1150" b="1">
+                          <a:solidFill>
+                            <a:srgbClr val="FFFFFF"/>
+                          </a:solidFill>
+                          <a:latin typeface="Calibri"/>
+                        </a:rPr>
+                        <a:t/>
+                      </a:r>
+                    </a:p>
+                  </a:txBody>
+                  <a:tcPr marL="45720" marR="45720" marT="9144" marB="9144" anchor="ctr">
+                    <a:solidFill>
+                      <a:srgbClr val="FFFFFF"/>
+                    </a:solidFill>
+                  </a:tcPr>
+                </a:tc>
+                <a:tc>
+                  <a:txBody>
+                    <a:bodyPr wrap="square"/>
+                    <a:lstStyle/>
+                    <a:p>
+                      <a:pPr algn="ctr"/>
+                      <a:r>
+                        <a:rPr sz="1150" b="1">
+                          <a:solidFill>
+                            <a:srgbClr val="FFFFFF"/>
+                          </a:solidFill>
+                          <a:latin typeface="Calibri"/>
+                        </a:rPr>
+                        <a:t>Manual era</a:t>
+                      </a:r>
+                    </a:p>
+                  </a:txBody>
+                  <a:tcPr marL="45720" marR="45720" marT="9144" marB="9144" anchor="ctr">
+                    <a:solidFill>
+                      <a:srgbClr val="7F8C8D"/>
+                    </a:solidFill>
+                  </a:tcPr>
+                </a:tc>
+                <a:tc>
+                  <a:txBody>
+                    <a:bodyPr wrap="square"/>
+                    <a:lstStyle/>
+                    <a:p>
+                      <a:pPr algn="ctr"/>
+                      <a:r>
+                        <a:rPr sz="1150" b="1">
+                          <a:solidFill>
+                            <a:srgbClr val="FFFFFF"/>
+                          </a:solidFill>
+                          <a:latin typeface="Calibri"/>
+                        </a:rPr>
+                        <a:t>AI on every line</a:t>
+                      </a:r>
+                    </a:p>
+                  </a:txBody>
+                  <a:tcPr marL="45720" marR="45720" marT="9144" marB="9144" anchor="ctr">
+                    <a:solidFill>
+                      <a:srgbClr val="C0392B"/>
+                    </a:solidFill>
+                  </a:tcPr>
+                </a:tc>
+                <a:tc>
+                  <a:txBody>
+                    <a:bodyPr wrap="square"/>
+                    <a:lstStyle/>
+                    <a:p>
+                      <a:pPr algn="ctr"/>
+                      <a:r>
+                        <a:rPr sz="1150" b="1">
+                          <a:solidFill>
+                            <a:srgbClr val="FFFFFF"/>
+                          </a:solidFill>
+                          <a:latin typeface="Calibri"/>
+                        </a:rPr>
+                        <a:t>Our solution</a:t>
+                      </a:r>
+                    </a:p>
+                  </a:txBody>
+                  <a:tcPr marL="45720" marR="45720" marT="9144" marB="9144" anchor="ctr">
+                    <a:solidFill>
+                      <a:srgbClr val="138A36"/>
+                    </a:solidFill>
+                  </a:tcPr>
+                </a:tc>
+              </a:tr>
+              <a:tr h="420624">
+                <a:tc>
+                  <a:txBody>
+                    <a:bodyPr wrap="square"/>
+                    <a:lstStyle/>
+                    <a:p>
+                      <a:pPr algn="l"/>
+                      <a:r>
+                        <a:rPr sz="1050" b="1">
+                          <a:solidFill>
+                            <a:srgbClr val="0B2A5B"/>
+                          </a:solidFill>
+                          <a:latin typeface="Calibri"/>
+                        </a:rPr>
+                        <a:t>Setup before first use</a:t>
+                      </a:r>
+                    </a:p>
+                  </a:txBody>
+                  <a:tcPr marL="45720" marR="45720" marT="9144" marB="9144" anchor="ctr">
+                    <a:solidFill>
+                      <a:srgbClr val="F2F5FA"/>
+                    </a:solidFill>
+                  </a:tcPr>
+                </a:tc>
+                <a:tc>
+                  <a:txBody>
+                    <a:bodyPr wrap="square"/>
+                    <a:lstStyle/>
+                    <a:p>
+                      <a:pPr algn="ctr"/>
+                      <a:r>
+                        <a:rPr sz="1150" b="1">
+                          <a:solidFill>
+                            <a:srgbClr val="C0392B"/>
+                          </a:solidFill>
+                          <a:latin typeface="Calibri"/>
+                        </a:rPr>
+                        <a:t>~2.5 months</a:t>
+                      </a:r>
+                    </a:p>
+                  </a:txBody>
+                  <a:tcPr marL="45720" marR="45720" marT="9144" marB="9144" anchor="ctr">
+                    <a:solidFill>
+                      <a:srgbClr val="FDECEA"/>
+                    </a:solidFill>
+                  </a:tcPr>
+                </a:tc>
+                <a:tc>
+                  <a:txBody>
+                    <a:bodyPr wrap="square"/>
+                    <a:lstStyle/>
+                    <a:p>
+                      <a:pPr algn="ctr"/>
+                      <a:r>
+                        <a:rPr sz="1150" b="1">
+                          <a:solidFill>
+                            <a:srgbClr val="138A36"/>
+                          </a:solidFill>
+                          <a:latin typeface="Calibri"/>
+                        </a:rPr>
+                        <a:t>None</a:t>
+                      </a:r>
+                    </a:p>
+                  </a:txBody>
+                  <a:tcPr marL="45720" marR="45720" marT="9144" marB="9144" anchor="ctr">
+                    <a:solidFill>
+                      <a:srgbClr val="E8F5EC"/>
+                    </a:solidFill>
+                  </a:tcPr>
+                </a:tc>
+                <a:tc>
+                  <a:txBody>
+                    <a:bodyPr wrap="square"/>
+                    <a:lstStyle/>
+                    <a:p>
+                      <a:pPr algn="ctr"/>
+                      <a:r>
+                        <a:rPr sz="1150" b="1">
+                          <a:solidFill>
+                            <a:srgbClr val="138A36"/>
+                          </a:solidFill>
+                          <a:latin typeface="Calibri"/>
+                        </a:rPr>
+                        <a:t>~1 day</a:t>
+                      </a:r>
+                    </a:p>
+                  </a:txBody>
+                  <a:tcPr marL="45720" marR="45720" marT="9144" marB="9144" anchor="ctr">
+                    <a:solidFill>
+                      <a:srgbClr val="E8F5EC"/>
+                    </a:solidFill>
+                  </a:tcPr>
+                </a:tc>
+              </a:tr>
+              <a:tr h="420624">
+                <a:tc>
+                  <a:txBody>
+                    <a:bodyPr wrap="square"/>
+                    <a:lstStyle/>
+                    <a:p>
+                      <a:pPr algn="l"/>
+                      <a:r>
+                        <a:rPr sz="1050" b="1">
+                          <a:solidFill>
+                            <a:srgbClr val="0B2A5B"/>
+                          </a:solidFill>
+                          <a:latin typeface="Calibri"/>
+                        </a:rPr>
+                        <a:t>Time to process 1M logs</a:t>
+                      </a:r>
+                    </a:p>
+                  </a:txBody>
+                  <a:tcPr marL="45720" marR="45720" marT="9144" marB="9144" anchor="ctr">
+                    <a:solidFill>
+                      <a:srgbClr val="F2F5FA"/>
+                    </a:solidFill>
+                  </a:tcPr>
+                </a:tc>
+                <a:tc>
+                  <a:txBody>
+                    <a:bodyPr wrap="square"/>
+                    <a:lstStyle/>
+                    <a:p>
+                      <a:pPr algn="ctr"/>
+                      <a:r>
+                        <a:rPr sz="1150" b="1">
+                          <a:solidFill>
+                            <a:srgbClr val="B35C00"/>
+                          </a:solidFill>
+                          <a:latin typeface="Calibri"/>
+                        </a:rPr>
+                        <a:t>~1 min*</a:t>
+                      </a:r>
+                    </a:p>
+                  </a:txBody>
+                  <a:tcPr marL="45720" marR="45720" marT="9144" marB="9144" anchor="ctr">
+                    <a:solidFill>
+                      <a:srgbClr val="FFF4E0"/>
+                    </a:solidFill>
+                  </a:tcPr>
+                </a:tc>
+                <a:tc>
+                  <a:txBody>
+                    <a:bodyPr wrap="square"/>
+                    <a:lstStyle/>
+                    <a:p>
+                      <a:pPr algn="ctr"/>
+                      <a:r>
+                        <a:rPr sz="1150" b="1">
+                          <a:solidFill>
+                            <a:srgbClr val="C0392B"/>
+                          </a:solidFill>
+                          <a:latin typeface="Calibri"/>
+                        </a:rPr>
+                        <a:t>~5.5 hours</a:t>
+                      </a:r>
+                    </a:p>
+                  </a:txBody>
+                  <a:tcPr marL="45720" marR="45720" marT="9144" marB="9144" anchor="ctr">
+                    <a:solidFill>
+                      <a:srgbClr val="FDECEA"/>
+                    </a:solidFill>
+                  </a:tcPr>
+                </a:tc>
+                <a:tc>
+                  <a:txBody>
+                    <a:bodyPr wrap="square"/>
+                    <a:lstStyle/>
+                    <a:p>
+                      <a:pPr algn="ctr"/>
+                      <a:r>
+                        <a:rPr sz="1150" b="1">
+                          <a:solidFill>
+                            <a:srgbClr val="138A36"/>
+                          </a:solidFill>
+                          <a:latin typeface="Calibri"/>
+                        </a:rPr>
+                        <a:t>~5 min</a:t>
+                      </a:r>
+                    </a:p>
+                  </a:txBody>
+                  <a:tcPr marL="45720" marR="45720" marT="9144" marB="9144" anchor="ctr">
+                    <a:solidFill>
+                      <a:srgbClr val="E8F5EC"/>
+                    </a:solidFill>
+                  </a:tcPr>
+                </a:tc>
+              </a:tr>
+              <a:tr h="420624">
+                <a:tc>
+                  <a:txBody>
+                    <a:bodyPr wrap="square"/>
+                    <a:lstStyle/>
+                    <a:p>
+                      <a:pPr algn="l"/>
+                      <a:r>
+                        <a:rPr sz="1050" b="1">
+                          <a:solidFill>
+                            <a:srgbClr val="0B2A5B"/>
+                          </a:solidFill>
+                          <a:latin typeface="Calibri"/>
+                        </a:rPr>
+                        <a:t>AI calls</a:t>
+                      </a:r>
+                    </a:p>
+                  </a:txBody>
+                  <a:tcPr marL="45720" marR="45720" marT="9144" marB="9144" anchor="ctr">
+                    <a:solidFill>
+                      <a:srgbClr val="F2F5FA"/>
+                    </a:solidFill>
+                  </a:tcPr>
+                </a:tc>
+                <a:tc>
+                  <a:txBody>
+                    <a:bodyPr wrap="square"/>
+                    <a:lstStyle/>
+                    <a:p>
+                      <a:pPr algn="ctr"/>
+                      <a:r>
+                        <a:rPr sz="1150" b="1">
+                          <a:solidFill>
+                            <a:srgbClr val="138A36"/>
+                          </a:solidFill>
+                          <a:latin typeface="Calibri"/>
+                        </a:rPr>
+                        <a:t>0</a:t>
+                      </a:r>
+                    </a:p>
+                  </a:txBody>
+                  <a:tcPr marL="45720" marR="45720" marT="9144" marB="9144" anchor="ctr">
+                    <a:solidFill>
+                      <a:srgbClr val="E8F5EC"/>
+                    </a:solidFill>
+                  </a:tcPr>
+                </a:tc>
+                <a:tc>
+                  <a:txBody>
+                    <a:bodyPr wrap="square"/>
+                    <a:lstStyle/>
+                    <a:p>
+                      <a:pPr algn="ctr"/>
+                      <a:r>
+                        <a:rPr sz="1050" b="1">
+                          <a:solidFill>
+                            <a:srgbClr val="C0392B"/>
+                          </a:solidFill>
+                          <a:latin typeface="Calibri"/>
+                        </a:rPr>
+                        <a:t>1,000,000 / day</a:t>
+                      </a:r>
+                    </a:p>
+                  </a:txBody>
+                  <a:tcPr marL="45720" marR="45720" marT="9144" marB="9144" anchor="ctr">
+                    <a:solidFill>
+                      <a:srgbClr val="FDECEA"/>
+                    </a:solidFill>
+                  </a:tcPr>
+                </a:tc>
+                <a:tc>
+                  <a:txBody>
+                    <a:bodyPr wrap="square"/>
+                    <a:lstStyle/>
+                    <a:p>
+                      <a:pPr algn="ctr"/>
+                      <a:r>
+                        <a:rPr sz="1050" b="1">
+                          <a:solidFill>
+                            <a:srgbClr val="138A36"/>
+                          </a:solidFill>
+                          <a:latin typeface="Calibri"/>
+                        </a:rPr>
+                        <a:t>~2,000 once, then ~50 / day</a:t>
+                      </a:r>
+                    </a:p>
+                  </a:txBody>
+                  <a:tcPr marL="45720" marR="45720" marT="9144" marB="9144" anchor="ctr">
+                    <a:solidFill>
+                      <a:srgbClr val="E8F5EC"/>
+                    </a:solidFill>
+                  </a:tcPr>
+                </a:tc>
+              </a:tr>
+              <a:tr h="420624">
+                <a:tc>
+                  <a:txBody>
+                    <a:bodyPr wrap="square"/>
+                    <a:lstStyle/>
+                    <a:p>
+                      <a:pPr algn="l"/>
+                      <a:r>
+                        <a:rPr sz="1050" b="1">
+                          <a:solidFill>
+                            <a:srgbClr val="0B2A5B"/>
+                          </a:solidFill>
+                          <a:latin typeface="Calibri"/>
+                        </a:rPr>
+                        <a:t>Running cost / day</a:t>
+                      </a:r>
+                    </a:p>
+                  </a:txBody>
+                  <a:tcPr marL="45720" marR="45720" marT="9144" marB="9144" anchor="ctr">
+                    <a:solidFill>
+                      <a:srgbClr val="F2F5FA"/>
+                    </a:solidFill>
+                  </a:tcPr>
+                </a:tc>
+                <a:tc>
+                  <a:txBody>
+                    <a:bodyPr wrap="square"/>
+                    <a:lstStyle/>
+                    <a:p>
+                      <a:pPr algn="ctr"/>
+                      <a:r>
+                        <a:rPr sz="1150" b="1">
+                          <a:solidFill>
+                            <a:srgbClr val="B35C00"/>
+                          </a:solidFill>
+                          <a:latin typeface="Calibri"/>
+                        </a:rPr>
+                        <a:t>~₹1,000</a:t>
+                      </a:r>
+                    </a:p>
+                  </a:txBody>
+                  <a:tcPr marL="45720" marR="45720" marT="9144" marB="9144" anchor="ctr">
+                    <a:solidFill>
+                      <a:srgbClr val="FFF4E0"/>
+                    </a:solidFill>
+                  </a:tcPr>
+                </a:tc>
+                <a:tc>
+                  <a:txBody>
+                    <a:bodyPr wrap="square"/>
+                    <a:lstStyle/>
+                    <a:p>
+                      <a:pPr algn="ctr"/>
+                      <a:r>
+                        <a:rPr sz="1150" b="1">
+                          <a:solidFill>
+                            <a:srgbClr val="C0392B"/>
+                          </a:solidFill>
+                          <a:latin typeface="Calibri"/>
+                        </a:rPr>
+                        <a:t>~₹29,000</a:t>
+                      </a:r>
+                    </a:p>
+                  </a:txBody>
+                  <a:tcPr marL="45720" marR="45720" marT="9144" marB="9144" anchor="ctr">
+                    <a:solidFill>
+                      <a:srgbClr val="FDECEA"/>
+                    </a:solidFill>
+                  </a:tcPr>
+                </a:tc>
+                <a:tc>
+                  <a:txBody>
+                    <a:bodyPr wrap="square"/>
+                    <a:lstStyle/>
+                    <a:p>
+                      <a:pPr algn="ctr"/>
+                      <a:r>
+                        <a:rPr sz="1150" b="1">
+                          <a:solidFill>
+                            <a:srgbClr val="138A36"/>
+                          </a:solidFill>
+                          <a:latin typeface="Calibri"/>
+                        </a:rPr>
+                        <a:t>~₹340</a:t>
+                      </a:r>
+                    </a:p>
+                  </a:txBody>
+                  <a:tcPr marL="45720" marR="45720" marT="9144" marB="9144" anchor="ctr">
+                    <a:solidFill>
+                      <a:srgbClr val="E8F5EC"/>
+                    </a:solidFill>
+                  </a:tcPr>
+                </a:tc>
+              </a:tr>
+              <a:tr h="420624">
+                <a:tc>
+                  <a:txBody>
+                    <a:bodyPr wrap="square"/>
+                    <a:lstStyle/>
+                    <a:p>
+                      <a:pPr algn="l"/>
+                      <a:r>
+                        <a:rPr sz="1050" b="1">
+                          <a:solidFill>
+                            <a:srgbClr val="0B2A5B"/>
+                          </a:solidFill>
+                          <a:latin typeface="Calibri"/>
+                        </a:rPr>
+                        <a:t>New log format arrives</a:t>
+                      </a:r>
+                    </a:p>
+                  </a:txBody>
+                  <a:tcPr marL="45720" marR="45720" marT="9144" marB="9144" anchor="ctr">
+                    <a:solidFill>
+                      <a:srgbClr val="F2F5FA"/>
+                    </a:solidFill>
+                  </a:tcPr>
+                </a:tc>
+                <a:tc>
+                  <a:txBody>
+                    <a:bodyPr wrap="square"/>
+                    <a:lstStyle/>
+                    <a:p>
+                      <a:pPr algn="ctr"/>
+                      <a:r>
+                        <a:rPr sz="1050" b="1">
+                          <a:solidFill>
+                            <a:srgbClr val="C0392B"/>
+                          </a:solidFill>
+                          <a:latin typeface="Calibri"/>
+                        </a:rPr>
+                        <a:t>Breaks until fixed</a:t>
+                      </a:r>
+                    </a:p>
+                  </a:txBody>
+                  <a:tcPr marL="45720" marR="45720" marT="9144" marB="9144" anchor="ctr">
+                    <a:solidFill>
+                      <a:srgbClr val="FDECEA"/>
+                    </a:solidFill>
+                  </a:tcPr>
+                </a:tc>
+                <a:tc>
+                  <a:txBody>
+                    <a:bodyPr wrap="square"/>
+                    <a:lstStyle/>
+                    <a:p>
+                      <a:pPr algn="ctr"/>
+                      <a:r>
+                        <a:rPr sz="1050" b="1">
+                          <a:solidFill>
+                            <a:srgbClr val="B35C00"/>
+                          </a:solidFill>
+                          <a:latin typeface="Calibri"/>
+                        </a:rPr>
+                        <a:t>Handled, pays per line</a:t>
+                      </a:r>
+                    </a:p>
+                  </a:txBody>
+                  <a:tcPr marL="45720" marR="45720" marT="9144" marB="9144" anchor="ctr">
+                    <a:solidFill>
+                      <a:srgbClr val="FFF4E0"/>
+                    </a:solidFill>
+                  </a:tcPr>
+                </a:tc>
+                <a:tc>
+                  <a:txBody>
+                    <a:bodyPr wrap="square"/>
+                    <a:lstStyle/>
+                    <a:p>
+                      <a:pPr algn="ctr"/>
+                      <a:r>
+                        <a:rPr sz="1050" b="1">
+                          <a:solidFill>
+                            <a:srgbClr val="138A36"/>
+                          </a:solidFill>
+                          <a:latin typeface="Calibri"/>
+                        </a:rPr>
+                        <a:t>Learned once, automatically</a:t>
+                      </a:r>
+                    </a:p>
+                  </a:txBody>
+                  <a:tcPr marL="45720" marR="45720" marT="9144" marB="9144" anchor="ctr">
+                    <a:solidFill>
+                      <a:srgbClr val="E8F5EC"/>
+                    </a:solidFill>
+                  </a:tcPr>
+                </a:tc>
+              </a:tr>
+            </a:tbl>
+          </a:graphicData>
+        </a:graphic>
+      </p:graphicFrame>
+      <p:graphicFrame>
+        <p:nvGraphicFramePr>
+          <p:cNvPr id="43" name="Chart 42"/>
+          <p:cNvGraphicFramePr>
+            <a:graphicFrameLocks noGrp="1"/>
+          </p:cNvGraphicFramePr>
+          <p:nvPr/>
+        </p:nvGraphicFramePr>
+        <p:xfrm>
+          <a:off x="7269480" y="3639312"/>
+          <a:ext cx="4599432" cy="2578608"/>
+        </p:xfrm>
+        <a:graphic>
+          <a:graphicData uri="http://schemas.openxmlformats.org/drawingml/2006/chart">
+            <c:chart xmlns:c="http://schemas.openxmlformats.org/drawingml/2006/chart" r:id="rId2"/>
+          </a:graphicData>
+        </a:graphic>
+      </p:graphicFrame>
       <p:sp>
         <p:nvSpPr>
           <p:cNvPr id="44" name="TextBox 43"/>
@@ -12373,8 +13452,8 @@
         </p:nvSpPr>
         <p:spPr>
           <a:xfrm>
-            <a:off x="548640" y="5102352"/>
-            <a:ext cx="2670048" cy="566928"/>
+            <a:off x="365760" y="6181344"/>
+            <a:ext cx="11503152" cy="274320"/>
           </a:xfrm>
           <a:prstGeom prst="rect">
             <a:avLst/>
@@ -12387,436 +13466,19 @@
           </a:bodyPr>
           <a:lstStyle/>
           <a:p>
-            <a:pPr algn="ctr">
+            <a:pPr algn="l">
               <a:spcAft>
                 <a:spcPts val="0"/>
               </a:spcAft>
             </a:pPr>
             <a:r>
-              <a:rPr sz="2800" b="1">
-                <a:solidFill>
-                  <a:srgbClr val="1F5FBF"/>
-                </a:solidFill>
-                <a:latin typeface="Calibri"/>
-              </a:rPr>
-              <a:t>100%</a:t>
-            </a:r>
-          </a:p>
-        </p:txBody>
-      </p:sp>
-      <p:sp>
-        <p:nvSpPr>
-          <p:cNvPr id="45" name="TextBox 44"/>
-          <p:cNvSpPr txBox="1"/>
-          <p:nvPr/>
-        </p:nvSpPr>
-        <p:spPr>
-          <a:xfrm>
-            <a:off x="640080" y="5687568"/>
-            <a:ext cx="2487168" cy="457200"/>
-          </a:xfrm>
-          <a:prstGeom prst="rect">
-            <a:avLst/>
-          </a:prstGeom>
-          <a:noFill/>
-        </p:spPr>
-        <p:txBody>
-          <a:bodyPr wrap="square" anchor="t" lIns="36576" rIns="36576" tIns="18288" bIns="18288">
-            <a:spAutoFit/>
-          </a:bodyPr>
-          <a:lstStyle/>
-          <a:p>
-            <a:pPr algn="ctr">
-              <a:spcAft>
-                <a:spcPts val="0"/>
-              </a:spcAft>
-            </a:pPr>
-            <a:r>
-              <a:rPr sz="1200" b="0">
+              <a:rPr sz="850" b="0">
                 <a:solidFill>
                   <a:srgbClr val="5B6778"/>
                 </a:solidFill>
                 <a:latin typeface="Calibri"/>
               </a:rPr>
-              <a:t>log formats identified correctly</a:t>
-            </a:r>
-          </a:p>
-        </p:txBody>
-      </p:sp>
-      <p:sp>
-        <p:nvSpPr>
-          <p:cNvPr id="46" name="Rounded Rectangle 45"/>
-          <p:cNvSpPr/>
-          <p:nvPr/>
-        </p:nvSpPr>
-        <p:spPr>
-          <a:xfrm>
-            <a:off x="3364992" y="5074920"/>
-            <a:ext cx="2670048" cy="1143000"/>
-          </a:xfrm>
-          <a:prstGeom prst="roundRect">
-            <a:avLst>
-              <a:gd name="adj" fmla="val 10000"/>
-            </a:avLst>
-          </a:prstGeom>
-          <a:solidFill>
-            <a:srgbClr val="FFFFFF"/>
-          </a:solidFill>
-          <a:ln w="12700">
-            <a:solidFill>
-              <a:srgbClr val="D3DBE8"/>
-            </a:solidFill>
-          </a:ln>
-          <a:effectLst/>
-        </p:spPr>
-        <p:style>
-          <a:lnRef idx="1">
-            <a:schemeClr val="accent1"/>
-          </a:lnRef>
-          <a:fillRef idx="3">
-            <a:schemeClr val="accent1"/>
-          </a:fillRef>
-          <a:effectRef idx="2">
-            <a:schemeClr val="accent1"/>
-          </a:effectRef>
-          <a:fontRef idx="minor">
-            <a:schemeClr val="lt1"/>
-          </a:fontRef>
-        </p:style>
-        <p:txBody>
-          <a:bodyPr rtlCol="0" anchor="ctr"/>
-          <a:lstStyle/>
-          <a:p>
-            <a:pPr algn="ctr"/>
-          </a:p>
-        </p:txBody>
-      </p:sp>
-      <p:sp>
-        <p:nvSpPr>
-          <p:cNvPr id="47" name="TextBox 46"/>
-          <p:cNvSpPr txBox="1"/>
-          <p:nvPr/>
-        </p:nvSpPr>
-        <p:spPr>
-          <a:xfrm>
-            <a:off x="3364992" y="5102352"/>
-            <a:ext cx="2670048" cy="566928"/>
-          </a:xfrm>
-          <a:prstGeom prst="rect">
-            <a:avLst/>
-          </a:prstGeom>
-          <a:noFill/>
-        </p:spPr>
-        <p:txBody>
-          <a:bodyPr wrap="square" anchor="t" lIns="36576" rIns="36576" tIns="18288" bIns="18288">
-            <a:spAutoFit/>
-          </a:bodyPr>
-          <a:lstStyle/>
-          <a:p>
-            <a:pPr algn="ctr">
-              <a:spcAft>
-                <a:spcPts val="0"/>
-              </a:spcAft>
-            </a:pPr>
-            <a:r>
-              <a:rPr sz="2800" b="1">
-                <a:solidFill>
-                  <a:srgbClr val="F58220"/>
-                </a:solidFill>
-                <a:latin typeface="Calibri"/>
-              </a:rPr>
-              <a:t>95.2%</a:t>
-            </a:r>
-          </a:p>
-        </p:txBody>
-      </p:sp>
-      <p:sp>
-        <p:nvSpPr>
-          <p:cNvPr id="48" name="TextBox 47"/>
-          <p:cNvSpPr txBox="1"/>
-          <p:nvPr/>
-        </p:nvSpPr>
-        <p:spPr>
-          <a:xfrm>
-            <a:off x="3456432" y="5687568"/>
-            <a:ext cx="2487168" cy="457200"/>
-          </a:xfrm>
-          <a:prstGeom prst="rect">
-            <a:avLst/>
-          </a:prstGeom>
-          <a:noFill/>
-        </p:spPr>
-        <p:txBody>
-          <a:bodyPr wrap="square" anchor="t" lIns="36576" rIns="36576" tIns="18288" bIns="18288">
-            <a:spAutoFit/>
-          </a:bodyPr>
-          <a:lstStyle/>
-          <a:p>
-            <a:pPr algn="ctr">
-              <a:spcAft>
-                <a:spcPts val="0"/>
-              </a:spcAft>
-            </a:pPr>
-            <a:r>
-              <a:rPr sz="1200" b="0">
-                <a:solidFill>
-                  <a:srgbClr val="5B6778"/>
-                </a:solidFill>
-                <a:latin typeface="Calibri"/>
-              </a:rPr>
-              <a:t>new, unseen formats caught</a:t>
-            </a:r>
-          </a:p>
-        </p:txBody>
-      </p:sp>
-      <p:sp>
-        <p:nvSpPr>
-          <p:cNvPr id="49" name="Rounded Rectangle 48"/>
-          <p:cNvSpPr/>
-          <p:nvPr/>
-        </p:nvSpPr>
-        <p:spPr>
-          <a:xfrm>
-            <a:off x="6181344" y="5074920"/>
-            <a:ext cx="2670048" cy="1143000"/>
-          </a:xfrm>
-          <a:prstGeom prst="roundRect">
-            <a:avLst>
-              <a:gd name="adj" fmla="val 10000"/>
-            </a:avLst>
-          </a:prstGeom>
-          <a:solidFill>
-            <a:srgbClr val="FFFFFF"/>
-          </a:solidFill>
-          <a:ln w="12700">
-            <a:solidFill>
-              <a:srgbClr val="D3DBE8"/>
-            </a:solidFill>
-          </a:ln>
-          <a:effectLst/>
-        </p:spPr>
-        <p:style>
-          <a:lnRef idx="1">
-            <a:schemeClr val="accent1"/>
-          </a:lnRef>
-          <a:fillRef idx="3">
-            <a:schemeClr val="accent1"/>
-          </a:fillRef>
-          <a:effectRef idx="2">
-            <a:schemeClr val="accent1"/>
-          </a:effectRef>
-          <a:fontRef idx="minor">
-            <a:schemeClr val="lt1"/>
-          </a:fontRef>
-        </p:style>
-        <p:txBody>
-          <a:bodyPr rtlCol="0" anchor="ctr"/>
-          <a:lstStyle/>
-          <a:p>
-            <a:pPr algn="ctr"/>
-          </a:p>
-        </p:txBody>
-      </p:sp>
-      <p:sp>
-        <p:nvSpPr>
-          <p:cNvPr id="50" name="TextBox 49"/>
-          <p:cNvSpPr txBox="1"/>
-          <p:nvPr/>
-        </p:nvSpPr>
-        <p:spPr>
-          <a:xfrm>
-            <a:off x="6181344" y="5102352"/>
-            <a:ext cx="2670048" cy="566928"/>
-          </a:xfrm>
-          <a:prstGeom prst="rect">
-            <a:avLst/>
-          </a:prstGeom>
-          <a:noFill/>
-        </p:spPr>
-        <p:txBody>
-          <a:bodyPr wrap="square" anchor="t" lIns="36576" rIns="36576" tIns="18288" bIns="18288">
-            <a:spAutoFit/>
-          </a:bodyPr>
-          <a:lstStyle/>
-          <a:p>
-            <a:pPr algn="ctr">
-              <a:spcAft>
-                <a:spcPts val="0"/>
-              </a:spcAft>
-            </a:pPr>
-            <a:r>
-              <a:rPr sz="2800" b="1">
-                <a:solidFill>
-                  <a:srgbClr val="138A36"/>
-                </a:solidFill>
-                <a:latin typeface="Calibri"/>
-              </a:rPr>
-              <a:t>99.5%</a:t>
-            </a:r>
-          </a:p>
-        </p:txBody>
-      </p:sp>
-      <p:sp>
-        <p:nvSpPr>
-          <p:cNvPr id="51" name="TextBox 50"/>
-          <p:cNvSpPr txBox="1"/>
-          <p:nvPr/>
-        </p:nvSpPr>
-        <p:spPr>
-          <a:xfrm>
-            <a:off x="6272783" y="5687568"/>
-            <a:ext cx="2487168" cy="457200"/>
-          </a:xfrm>
-          <a:prstGeom prst="rect">
-            <a:avLst/>
-          </a:prstGeom>
-          <a:noFill/>
-        </p:spPr>
-        <p:txBody>
-          <a:bodyPr wrap="square" anchor="t" lIns="36576" rIns="36576" tIns="18288" bIns="18288">
-            <a:spAutoFit/>
-          </a:bodyPr>
-          <a:lstStyle/>
-          <a:p>
-            <a:pPr algn="ctr">
-              <a:spcAft>
-                <a:spcPts val="0"/>
-              </a:spcAft>
-            </a:pPr>
-            <a:r>
-              <a:rPr sz="1200" b="0">
-                <a:solidFill>
-                  <a:srgbClr val="5B6778"/>
-                </a:solidFill>
-                <a:latin typeface="Calibri"/>
-              </a:rPr>
-              <a:t>logs processed without calling AI</a:t>
-            </a:r>
-          </a:p>
-        </p:txBody>
-      </p:sp>
-      <p:sp>
-        <p:nvSpPr>
-          <p:cNvPr id="52" name="Rounded Rectangle 51"/>
-          <p:cNvSpPr/>
-          <p:nvPr/>
-        </p:nvSpPr>
-        <p:spPr>
-          <a:xfrm>
-            <a:off x="8997696" y="5074920"/>
-            <a:ext cx="2670048" cy="1143000"/>
-          </a:xfrm>
-          <a:prstGeom prst="roundRect">
-            <a:avLst>
-              <a:gd name="adj" fmla="val 10000"/>
-            </a:avLst>
-          </a:prstGeom>
-          <a:solidFill>
-            <a:srgbClr val="FFFFFF"/>
-          </a:solidFill>
-          <a:ln w="12700">
-            <a:solidFill>
-              <a:srgbClr val="D3DBE8"/>
-            </a:solidFill>
-          </a:ln>
-          <a:effectLst/>
-        </p:spPr>
-        <p:style>
-          <a:lnRef idx="1">
-            <a:schemeClr val="accent1"/>
-          </a:lnRef>
-          <a:fillRef idx="3">
-            <a:schemeClr val="accent1"/>
-          </a:fillRef>
-          <a:effectRef idx="2">
-            <a:schemeClr val="accent1"/>
-          </a:effectRef>
-          <a:fontRef idx="minor">
-            <a:schemeClr val="lt1"/>
-          </a:fontRef>
-        </p:style>
-        <p:txBody>
-          <a:bodyPr rtlCol="0" anchor="ctr"/>
-          <a:lstStyle/>
-          <a:p>
-            <a:pPr algn="ctr"/>
-          </a:p>
-        </p:txBody>
-      </p:sp>
-      <p:sp>
-        <p:nvSpPr>
-          <p:cNvPr id="53" name="TextBox 52"/>
-          <p:cNvSpPr txBox="1"/>
-          <p:nvPr/>
-        </p:nvSpPr>
-        <p:spPr>
-          <a:xfrm>
-            <a:off x="8997696" y="5102352"/>
-            <a:ext cx="2670048" cy="566928"/>
-          </a:xfrm>
-          <a:prstGeom prst="rect">
-            <a:avLst/>
-          </a:prstGeom>
-          <a:noFill/>
-        </p:spPr>
-        <p:txBody>
-          <a:bodyPr wrap="square" anchor="t" lIns="36576" rIns="36576" tIns="18288" bIns="18288">
-            <a:spAutoFit/>
-          </a:bodyPr>
-          <a:lstStyle/>
-          <a:p>
-            <a:pPr algn="ctr">
-              <a:spcAft>
-                <a:spcPts val="0"/>
-              </a:spcAft>
-            </a:pPr>
-            <a:r>
-              <a:rPr sz="2800" b="1">
-                <a:solidFill>
-                  <a:srgbClr val="6A3FB5"/>
-                </a:solidFill>
-                <a:latin typeface="Calibri"/>
-              </a:rPr>
-              <a:t>0.28 ms</a:t>
-            </a:r>
-          </a:p>
-        </p:txBody>
-      </p:sp>
-      <p:sp>
-        <p:nvSpPr>
-          <p:cNvPr id="54" name="TextBox 53"/>
-          <p:cNvSpPr txBox="1"/>
-          <p:nvPr/>
-        </p:nvSpPr>
-        <p:spPr>
-          <a:xfrm>
-            <a:off x="9089136" y="5687568"/>
-            <a:ext cx="2487168" cy="457200"/>
-          </a:xfrm>
-          <a:prstGeom prst="rect">
-            <a:avLst/>
-          </a:prstGeom>
-          <a:noFill/>
-        </p:spPr>
-        <p:txBody>
-          <a:bodyPr wrap="square" anchor="t" lIns="36576" rIns="36576" tIns="18288" bIns="18288">
-            <a:spAutoFit/>
-          </a:bodyPr>
-          <a:lstStyle/>
-          <a:p>
-            <a:pPr algn="ctr">
-              <a:spcAft>
-                <a:spcPts val="0"/>
-              </a:spcAft>
-            </a:pPr>
-            <a:r>
-              <a:rPr sz="1200" b="0">
-                <a:solidFill>
-                  <a:srgbClr val="5B6778"/>
-                </a:solidFill>
-                <a:latin typeface="Calibri"/>
-              </a:rPr>
-              <a:t>to process one log line</a:t>
+              <a:t>* known formats only. Illustrative estimate: ~2,000 log templates · engineer ₹5,000/day · AI at ~$0.30 / $2.50 per 1M input/output tokens, ~400 tokens per log, ₹85/$ · our speed (0.28 ms/log) and AI-call rate measured in our benchmark.</a:t>
             </a:r>
           </a:p>
         </p:txBody>

</xml_diff>

<commit_message>
PPT: slide 5 comparison as factor/percentage bar + doughnut charts; declutter slide 6 references
Co-authored-by: arena-agent <297053741+arena-agent@users.noreply.github.com>
</commit_message>
<xml_diff>
--- a/presentation/SIH2026_Idea_Submission.pptx
+++ b/presentation/SIH2026_Idea_Submission.pptx
@@ -714,6 +714,125 @@
         </a:defRPr>
       </a:pPr>
       <a:endParaRPr lang="en-US"/>
+    </a:p>
+  </c:txPr>
+  <c:externalData r:id="rId1">
+    <c:autoUpdate val="0"/>
+  </c:externalData>
+</c:chartSpace>
+</file>
+
+<file path=ppt/charts/chart10.xml><?xml version="1.0" encoding="utf-8"?>
+<c:chartSpace xmlns:c="http://schemas.openxmlformats.org/drawingml/2006/chart" xmlns:a="http://schemas.openxmlformats.org/drawingml/2006/main" xmlns:r="http://schemas.openxmlformats.org/officeDocument/2006/relationships">
+  <c:date1904 val="0"/>
+  <c:roundedCorners val="0"/>
+  <c:chart>
+    <c:autoTitleDeleted val="1"/>
+    <c:plotArea>
+      <c:layout/>
+      <c:doughnutChart>
+        <c:varyColors val="1"/>
+        <c:ser>
+          <c:idx val="0"/>
+          <c:order val="0"/>
+          <c:tx>
+            <c:strRef>
+              <c:f>Sheet1!$B$1</c:f>
+              <c:strCache>
+                <c:ptCount val="1"/>
+                <c:pt idx="0">
+                  <c:v>x</c:v>
+                </c:pt>
+              </c:strCache>
+            </c:strRef>
+          </c:tx>
+          <c:dPt>
+            <c:idx val="0"/>
+            <c:spPr>
+              <a:solidFill>
+                <a:srgbClr val="F58220"/>
+              </a:solidFill>
+              <a:ln>
+                <a:solidFill>
+                  <a:srgbClr val="FFFFFF"/>
+                </a:solidFill>
+              </a:ln>
+            </c:spPr>
+          </c:dPt>
+          <c:dPt>
+            <c:idx val="1"/>
+            <c:spPr>
+              <a:solidFill>
+                <a:srgbClr val="E8F5EC"/>
+              </a:solidFill>
+              <a:ln>
+                <a:solidFill>
+                  <a:srgbClr val="FFFFFF"/>
+                </a:solidFill>
+              </a:ln>
+            </c:spPr>
+          </c:dPt>
+          <c:cat>
+            <c:strRef>
+              <c:f>Sheet1!$A$2:$A$3</c:f>
+              <c:strCache>
+                <c:ptCount val="2"/>
+                <c:pt idx="0">
+                  <c:v>AI</c:v>
+                </c:pt>
+                <c:pt idx="1">
+                  <c:v>No AI</c:v>
+                </c:pt>
+              </c:strCache>
+            </c:strRef>
+          </c:cat>
+          <c:val>
+            <c:numRef>
+              <c:f>Sheet1!$B$2:$B$3</c:f>
+              <c:numCache>
+                <c:formatCode>General</c:formatCode>
+                <c:ptCount val="2"/>
+                <c:pt idx="0">
+                  <c:v>0.5</c:v>
+                </c:pt>
+                <c:pt idx="1">
+                  <c:v>99.5</c:v>
+                </c:pt>
+              </c:numCache>
+            </c:numRef>
+          </c:val>
+        </c:ser>
+        <c:dLbls>
+          <c:showLegendKey val="0"/>
+          <c:showVal val="0"/>
+          <c:showCatName val="0"/>
+          <c:showSerName val="0"/>
+          <c:showPercent val="0"/>
+          <c:showBubbleSize val="0"/>
+          <c:showLeaderLines val="1"/>
+        </c:dLbls>
+        <c:firstSliceAng val="0"/>
+        <c:holeSize val="62"/>
+      </c:doughnutChart>
+    </c:plotArea>
+    <c:plotVisOnly val="1"/>
+    <c:dispBlanksAs val="gap"/>
+    <c:showDLblsOverMax val="0"/>
+  </c:chart>
+  <c:spPr>
+    <a:noFill/>
+    <a:ln>
+      <a:noFill/>
+    </a:ln>
+  </c:spPr>
+  <c:txPr>
+    <a:bodyPr/>
+    <a:lstStyle/>
+    <a:p>
+      <a:pPr>
+        <a:defRPr sz="1800"/>
+      </a:pPr>
+      <a:endParaRPr/>
     </a:p>
   </c:txPr>
   <c:externalData r:id="rId1">
@@ -1306,6 +1425,1347 @@
         </a:defRPr>
       </a:pPr>
       <a:endParaRPr lang="en-US"/>
+    </a:p>
+  </c:txPr>
+  <c:externalData r:id="rId1">
+    <c:autoUpdate val="0"/>
+  </c:externalData>
+</c:chartSpace>
+</file>
+
+<file path=ppt/charts/chart3.xml><?xml version="1.0" encoding="utf-8"?>
+<c:chartSpace xmlns:c="http://schemas.openxmlformats.org/drawingml/2006/chart" xmlns:a="http://schemas.openxmlformats.org/drawingml/2006/main" xmlns:r="http://schemas.openxmlformats.org/officeDocument/2006/relationships">
+  <c:date1904 val="0"/>
+  <c:chart>
+    <c:autoTitleDeleted val="1"/>
+    <c:plotArea>
+      <c:barChart>
+        <c:barDir val="bar"/>
+        <c:grouping val="clustered"/>
+        <c:ser>
+          <c:idx val="0"/>
+          <c:order val="0"/>
+          <c:tx>
+            <c:strRef>
+              <c:f>Sheet1!$B$1</c:f>
+              <c:strCache>
+                <c:ptCount val="1"/>
+                <c:pt idx="0">
+                  <c:v>x</c:v>
+                </c:pt>
+              </c:strCache>
+            </c:strRef>
+          </c:tx>
+          <c:dPt>
+            <c:idx val="0"/>
+            <c:spPr>
+              <a:solidFill>
+                <a:srgbClr val="7F8C8D"/>
+              </a:solidFill>
+            </c:spPr>
+          </c:dPt>
+          <c:dPt>
+            <c:idx val="1"/>
+            <c:spPr>
+              <a:solidFill>
+                <a:srgbClr val="C0392B"/>
+              </a:solidFill>
+            </c:spPr>
+          </c:dPt>
+          <c:dPt>
+            <c:idx val="2"/>
+            <c:spPr>
+              <a:solidFill>
+                <a:srgbClr val="138A36"/>
+              </a:solidFill>
+            </c:spPr>
+          </c:dPt>
+          <c:dLbls>
+            <c:dLbl>
+              <c:idx val="0"/>
+              <c:tx>
+                <c:rich>
+                  <a:bodyPr/>
+                  <a:lstStyle/>
+                  <a:p>
+                    <a:r>
+                      <a:rPr sz="1100" b="1">
+                        <a:solidFill>
+                          <a:srgbClr val="7F8C8D"/>
+                        </a:solidFill>
+                      </a:rPr>
+                      <a:t>5× costlier</a:t>
+                    </a:r>
+                  </a:p>
+                </c:rich>
+              </c:tx>
+              <c:dLblPos val="outEnd"/>
+              <c:showLegendKey val="0"/>
+              <c:showVal val="1"/>
+              <c:showCatName val="0"/>
+              <c:showSerName val="0"/>
+              <c:showPercent val="0"/>
+              <c:showBubbleSize val="0"/>
+            </c:dLbl>
+            <c:dLbl>
+              <c:idx val="1"/>
+              <c:tx>
+                <c:rich>
+                  <a:bodyPr/>
+                  <a:lstStyle/>
+                  <a:p>
+                    <a:r>
+                      <a:rPr sz="1100" b="1">
+                        <a:solidFill>
+                          <a:srgbClr val="C0392B"/>
+                        </a:solidFill>
+                      </a:rPr>
+                      <a:t>80× costlier</a:t>
+                    </a:r>
+                  </a:p>
+                </c:rich>
+              </c:tx>
+              <c:dLblPos val="outEnd"/>
+              <c:showLegendKey val="0"/>
+              <c:showVal val="1"/>
+              <c:showCatName val="0"/>
+              <c:showSerName val="0"/>
+              <c:showPercent val="0"/>
+              <c:showBubbleSize val="0"/>
+            </c:dLbl>
+            <c:dLbl>
+              <c:idx val="2"/>
+              <c:tx>
+                <c:rich>
+                  <a:bodyPr/>
+                  <a:lstStyle/>
+                  <a:p>
+                    <a:r>
+                      <a:rPr sz="1100" b="1">
+                        <a:solidFill>
+                          <a:srgbClr val="138A36"/>
+                        </a:solidFill>
+                      </a:rPr>
+                      <a:t>1×  lowest</a:t>
+                    </a:r>
+                  </a:p>
+                </c:rich>
+              </c:tx>
+              <c:dLblPos val="outEnd"/>
+              <c:showLegendKey val="0"/>
+              <c:showVal val="1"/>
+              <c:showCatName val="0"/>
+              <c:showSerName val="0"/>
+              <c:showPercent val="0"/>
+              <c:showBubbleSize val="0"/>
+            </c:dLbl>
+            <c:showLegendKey val="0"/>
+            <c:showVal val="0"/>
+            <c:showCatName val="0"/>
+            <c:showSerName val="0"/>
+            <c:showPercent val="0"/>
+            <c:showBubbleSize val="0"/>
+            <c:showLeaderLines val="1"/>
+          </c:dLbls>
+          <c:cat>
+            <c:strRef>
+              <c:f>Sheet1!$A$2:$A$4</c:f>
+              <c:strCache>
+                <c:ptCount val="3"/>
+                <c:pt idx="0">
+                  <c:v>Manual era</c:v>
+                </c:pt>
+                <c:pt idx="1">
+                  <c:v>AI on every line</c:v>
+                </c:pt>
+                <c:pt idx="2">
+                  <c:v>Our solution</c:v>
+                </c:pt>
+              </c:strCache>
+            </c:strRef>
+          </c:cat>
+          <c:val>
+            <c:numRef>
+              <c:f>Sheet1!$B$2:$B$4</c:f>
+              <c:numCache>
+                <c:formatCode>General</c:formatCode>
+                <c:ptCount val="3"/>
+                <c:pt idx="0">
+                  <c:v>5</c:v>
+                </c:pt>
+                <c:pt idx="1">
+                  <c:v>80</c:v>
+                </c:pt>
+                <c:pt idx="2">
+                  <c:v>1</c:v>
+                </c:pt>
+              </c:numCache>
+            </c:numRef>
+          </c:val>
+        </c:ser>
+        <c:gapWidth val="55"/>
+        <c:axId val="-2068027336"/>
+        <c:axId val="-2113994440"/>
+      </c:barChart>
+      <c:catAx>
+        <c:axId val="-2068027336"/>
+        <c:scaling>
+          <c:orientation val="maxMin"/>
+        </c:scaling>
+        <c:delete val="0"/>
+        <c:axPos val="l"/>
+        <c:majorTickMark val="out"/>
+        <c:minorTickMark val="none"/>
+        <c:tickLblPos val="nextTo"/>
+        <c:spPr>
+          <a:ln>
+            <a:solidFill>
+              <a:srgbClr val="D3DBE8"/>
+            </a:solidFill>
+          </a:ln>
+        </c:spPr>
+        <c:txPr>
+          <a:bodyPr/>
+          <a:lstStyle/>
+          <a:p>
+            <a:pPr>
+              <a:defRPr b="1">
+                <a:solidFill>
+                  <a:srgbClr val="0B2A5B"/>
+                </a:solidFill>
+              </a:defRPr>
+            </a:pPr>
+          </a:p>
+        </c:txPr>
+        <c:crossAx val="-2113994440"/>
+        <c:crosses val="autoZero"/>
+        <c:auto val="1"/>
+        <c:lblAlgn val="ctr"/>
+        <c:lblOffset val="100"/>
+        <c:noMultiLvlLbl val="0"/>
+      </c:catAx>
+      <c:valAx>
+        <c:axId val="-2113994440"/>
+        <c:scaling>
+          <c:max val="100.0"/>
+          <c:min val="0.0"/>
+        </c:scaling>
+        <c:delete/>
+        <c:axPos val="b"/>
+        <c:majorTickMark val="out"/>
+        <c:minorTickMark val="none"/>
+        <c:tickLblPos val="nextTo"/>
+        <c:crossAx val="-2068027336"/>
+        <c:crosses val="autoZero"/>
+      </c:valAx>
+    </c:plotArea>
+    <c:dispBlanksAs val="gap"/>
+  </c:chart>
+  <c:txPr>
+    <a:bodyPr/>
+    <a:lstStyle/>
+    <a:p>
+      <a:pPr>
+        <a:defRPr sz="1050">
+          <a:latin typeface="Calibri"/>
+        </a:defRPr>
+      </a:pPr>
+      <a:endParaRPr lang="en-US"/>
+    </a:p>
+  </c:txPr>
+  <c:externalData r:id="rId1">
+    <c:autoUpdate val="0"/>
+  </c:externalData>
+</c:chartSpace>
+</file>
+
+<file path=ppt/charts/chart4.xml><?xml version="1.0" encoding="utf-8"?>
+<c:chartSpace xmlns:c="http://schemas.openxmlformats.org/drawingml/2006/chart" xmlns:a="http://schemas.openxmlformats.org/drawingml/2006/main" xmlns:r="http://schemas.openxmlformats.org/officeDocument/2006/relationships">
+  <c:date1904 val="0"/>
+  <c:chart>
+    <c:autoTitleDeleted val="1"/>
+    <c:plotArea>
+      <c:barChart>
+        <c:barDir val="bar"/>
+        <c:grouping val="clustered"/>
+        <c:ser>
+          <c:idx val="0"/>
+          <c:order val="0"/>
+          <c:tx>
+            <c:strRef>
+              <c:f>Sheet1!$B$1</c:f>
+              <c:strCache>
+                <c:ptCount val="1"/>
+                <c:pt idx="0">
+                  <c:v>x</c:v>
+                </c:pt>
+              </c:strCache>
+            </c:strRef>
+          </c:tx>
+          <c:dPt>
+            <c:idx val="0"/>
+            <c:spPr>
+              <a:solidFill>
+                <a:srgbClr val="7F8C8D"/>
+              </a:solidFill>
+            </c:spPr>
+          </c:dPt>
+          <c:dPt>
+            <c:idx val="1"/>
+            <c:spPr>
+              <a:solidFill>
+                <a:srgbClr val="C0392B"/>
+              </a:solidFill>
+            </c:spPr>
+          </c:dPt>
+          <c:dPt>
+            <c:idx val="2"/>
+            <c:spPr>
+              <a:solidFill>
+                <a:srgbClr val="138A36"/>
+              </a:solidFill>
+            </c:spPr>
+          </c:dPt>
+          <c:dLbls>
+            <c:dLbl>
+              <c:idx val="0"/>
+              <c:tx>
+                <c:rich>
+                  <a:bodyPr/>
+                  <a:lstStyle/>
+                  <a:p>
+                    <a:r>
+                      <a:rPr sz="1100" b="1">
+                        <a:solidFill>
+                          <a:srgbClr val="7F8C8D"/>
+                        </a:solidFill>
+                      </a:rPr>
+                      <a:t>5× faster*</a:t>
+                    </a:r>
+                  </a:p>
+                </c:rich>
+              </c:tx>
+              <c:dLblPos val="outEnd"/>
+              <c:showLegendKey val="0"/>
+              <c:showVal val="1"/>
+              <c:showCatName val="0"/>
+              <c:showSerName val="0"/>
+              <c:showPercent val="0"/>
+              <c:showBubbleSize val="0"/>
+            </c:dLbl>
+            <c:dLbl>
+              <c:idx val="1"/>
+              <c:tx>
+                <c:rich>
+                  <a:bodyPr/>
+                  <a:lstStyle/>
+                  <a:p>
+                    <a:r>
+                      <a:rPr sz="1100" b="1">
+                        <a:solidFill>
+                          <a:srgbClr val="C0392B"/>
+                        </a:solidFill>
+                      </a:rPr>
+                      <a:t>70× slower</a:t>
+                    </a:r>
+                  </a:p>
+                </c:rich>
+              </c:tx>
+              <c:dLblPos val="outEnd"/>
+              <c:showLegendKey val="0"/>
+              <c:showVal val="1"/>
+              <c:showCatName val="0"/>
+              <c:showSerName val="0"/>
+              <c:showPercent val="0"/>
+              <c:showBubbleSize val="0"/>
+            </c:dLbl>
+            <c:dLbl>
+              <c:idx val="2"/>
+              <c:tx>
+                <c:rich>
+                  <a:bodyPr/>
+                  <a:lstStyle/>
+                  <a:p>
+                    <a:r>
+                      <a:rPr sz="1100" b="1">
+                        <a:solidFill>
+                          <a:srgbClr val="138A36"/>
+                        </a:solidFill>
+                      </a:rPr>
+                      <a:t>1×  ~5 min</a:t>
+                    </a:r>
+                  </a:p>
+                </c:rich>
+              </c:tx>
+              <c:dLblPos val="outEnd"/>
+              <c:showLegendKey val="0"/>
+              <c:showVal val="1"/>
+              <c:showCatName val="0"/>
+              <c:showSerName val="0"/>
+              <c:showPercent val="0"/>
+              <c:showBubbleSize val="0"/>
+            </c:dLbl>
+            <c:showLegendKey val="0"/>
+            <c:showVal val="0"/>
+            <c:showCatName val="0"/>
+            <c:showSerName val="0"/>
+            <c:showPercent val="0"/>
+            <c:showBubbleSize val="0"/>
+            <c:showLeaderLines val="1"/>
+          </c:dLbls>
+          <c:cat>
+            <c:strRef>
+              <c:f>Sheet1!$A$2:$A$4</c:f>
+              <c:strCache>
+                <c:ptCount val="3"/>
+                <c:pt idx="0">
+                  <c:v>Manual era</c:v>
+                </c:pt>
+                <c:pt idx="1">
+                  <c:v>AI on every line</c:v>
+                </c:pt>
+                <c:pt idx="2">
+                  <c:v>Our solution</c:v>
+                </c:pt>
+              </c:strCache>
+            </c:strRef>
+          </c:cat>
+          <c:val>
+            <c:numRef>
+              <c:f>Sheet1!$B$2:$B$4</c:f>
+              <c:numCache>
+                <c:formatCode>General</c:formatCode>
+                <c:ptCount val="3"/>
+                <c:pt idx="0">
+                  <c:v>0.2</c:v>
+                </c:pt>
+                <c:pt idx="1">
+                  <c:v>70</c:v>
+                </c:pt>
+                <c:pt idx="2">
+                  <c:v>1</c:v>
+                </c:pt>
+              </c:numCache>
+            </c:numRef>
+          </c:val>
+        </c:ser>
+        <c:gapWidth val="55"/>
+        <c:axId val="-2068027336"/>
+        <c:axId val="-2113994440"/>
+      </c:barChart>
+      <c:catAx>
+        <c:axId val="-2068027336"/>
+        <c:scaling>
+          <c:orientation val="maxMin"/>
+        </c:scaling>
+        <c:delete val="0"/>
+        <c:axPos val="l"/>
+        <c:majorTickMark val="out"/>
+        <c:minorTickMark val="none"/>
+        <c:tickLblPos val="nextTo"/>
+        <c:spPr>
+          <a:ln>
+            <a:solidFill>
+              <a:srgbClr val="D3DBE8"/>
+            </a:solidFill>
+          </a:ln>
+        </c:spPr>
+        <c:txPr>
+          <a:bodyPr/>
+          <a:lstStyle/>
+          <a:p>
+            <a:pPr>
+              <a:defRPr b="1">
+                <a:solidFill>
+                  <a:srgbClr val="0B2A5B"/>
+                </a:solidFill>
+              </a:defRPr>
+            </a:pPr>
+          </a:p>
+        </c:txPr>
+        <c:crossAx val="-2113994440"/>
+        <c:crosses val="autoZero"/>
+        <c:auto val="1"/>
+        <c:lblAlgn val="ctr"/>
+        <c:lblOffset val="100"/>
+        <c:noMultiLvlLbl val="0"/>
+      </c:catAx>
+      <c:valAx>
+        <c:axId val="-2113994440"/>
+        <c:scaling>
+          <c:max val="100.0"/>
+          <c:min val="0.0"/>
+        </c:scaling>
+        <c:delete/>
+        <c:axPos val="b"/>
+        <c:majorTickMark val="out"/>
+        <c:minorTickMark val="none"/>
+        <c:tickLblPos val="nextTo"/>
+        <c:crossAx val="-2068027336"/>
+        <c:crosses val="autoZero"/>
+      </c:valAx>
+    </c:plotArea>
+    <c:dispBlanksAs val="gap"/>
+  </c:chart>
+  <c:txPr>
+    <a:bodyPr/>
+    <a:lstStyle/>
+    <a:p>
+      <a:pPr>
+        <a:defRPr sz="1050">
+          <a:latin typeface="Calibri"/>
+        </a:defRPr>
+      </a:pPr>
+      <a:endParaRPr lang="en-US"/>
+    </a:p>
+  </c:txPr>
+  <c:externalData r:id="rId1">
+    <c:autoUpdate val="0"/>
+  </c:externalData>
+</c:chartSpace>
+</file>
+
+<file path=ppt/charts/chart5.xml><?xml version="1.0" encoding="utf-8"?>
+<c:chartSpace xmlns:c="http://schemas.openxmlformats.org/drawingml/2006/chart" xmlns:a="http://schemas.openxmlformats.org/drawingml/2006/main" xmlns:r="http://schemas.openxmlformats.org/officeDocument/2006/relationships">
+  <c:date1904 val="0"/>
+  <c:roundedCorners val="0"/>
+  <c:chart>
+    <c:autoTitleDeleted val="1"/>
+    <c:plotArea>
+      <c:layout/>
+      <c:doughnutChart>
+        <c:varyColors val="1"/>
+        <c:ser>
+          <c:idx val="0"/>
+          <c:order val="0"/>
+          <c:tx>
+            <c:strRef>
+              <c:f>Sheet1!$B$1</c:f>
+              <c:strCache>
+                <c:ptCount val="1"/>
+                <c:pt idx="0">
+                  <c:v>x</c:v>
+                </c:pt>
+              </c:strCache>
+            </c:strRef>
+          </c:tx>
+          <c:dPt>
+            <c:idx val="0"/>
+            <c:spPr>
+              <a:solidFill>
+                <a:srgbClr val="C0392B"/>
+              </a:solidFill>
+              <a:ln>
+                <a:solidFill>
+                  <a:srgbClr val="FFFFFF"/>
+                </a:solidFill>
+              </a:ln>
+            </c:spPr>
+          </c:dPt>
+          <c:dPt>
+            <c:idx val="1"/>
+            <c:spPr>
+              <a:solidFill>
+                <a:srgbClr val="FDECEA"/>
+              </a:solidFill>
+              <a:ln>
+                <a:solidFill>
+                  <a:srgbClr val="FFFFFF"/>
+                </a:solidFill>
+              </a:ln>
+            </c:spPr>
+          </c:dPt>
+          <c:cat>
+            <c:strRef>
+              <c:f>Sheet1!$A$2:$A$3</c:f>
+              <c:strCache>
+                <c:ptCount val="2"/>
+                <c:pt idx="0">
+                  <c:v>AI</c:v>
+                </c:pt>
+                <c:pt idx="1">
+                  <c:v>No AI</c:v>
+                </c:pt>
+              </c:strCache>
+            </c:strRef>
+          </c:cat>
+          <c:val>
+            <c:numRef>
+              <c:f>Sheet1!$B$2:$B$3</c:f>
+              <c:numCache>
+                <c:formatCode>General</c:formatCode>
+                <c:ptCount val="2"/>
+                <c:pt idx="0">
+                  <c:v>100</c:v>
+                </c:pt>
+                <c:pt idx="1">
+                  <c:v>0</c:v>
+                </c:pt>
+              </c:numCache>
+            </c:numRef>
+          </c:val>
+        </c:ser>
+        <c:dLbls>
+          <c:showLegendKey val="0"/>
+          <c:showVal val="0"/>
+          <c:showCatName val="0"/>
+          <c:showSerName val="0"/>
+          <c:showPercent val="0"/>
+          <c:showBubbleSize val="0"/>
+          <c:showLeaderLines val="1"/>
+        </c:dLbls>
+        <c:firstSliceAng val="0"/>
+        <c:holeSize val="62"/>
+      </c:doughnutChart>
+    </c:plotArea>
+    <c:plotVisOnly val="1"/>
+    <c:dispBlanksAs val="gap"/>
+    <c:showDLblsOverMax val="0"/>
+  </c:chart>
+  <c:txPr>
+    <a:bodyPr/>
+    <a:lstStyle/>
+    <a:p>
+      <a:pPr>
+        <a:defRPr sz="1800"/>
+      </a:pPr>
+      <a:endParaRPr/>
+    </a:p>
+  </c:txPr>
+  <c:externalData r:id="rId1">
+    <c:autoUpdate val="0"/>
+  </c:externalData>
+</c:chartSpace>
+</file>
+
+<file path=ppt/charts/chart6.xml><?xml version="1.0" encoding="utf-8"?>
+<c:chartSpace xmlns:c="http://schemas.openxmlformats.org/drawingml/2006/chart" xmlns:a="http://schemas.openxmlformats.org/drawingml/2006/main" xmlns:r="http://schemas.openxmlformats.org/officeDocument/2006/relationships">
+  <c:date1904 val="0"/>
+  <c:roundedCorners val="0"/>
+  <c:chart>
+    <c:autoTitleDeleted val="1"/>
+    <c:plotArea>
+      <c:layout/>
+      <c:doughnutChart>
+        <c:varyColors val="1"/>
+        <c:ser>
+          <c:idx val="0"/>
+          <c:order val="0"/>
+          <c:tx>
+            <c:strRef>
+              <c:f>Sheet1!$B$1</c:f>
+              <c:strCache>
+                <c:ptCount val="1"/>
+                <c:pt idx="0">
+                  <c:v>x</c:v>
+                </c:pt>
+              </c:strCache>
+            </c:strRef>
+          </c:tx>
+          <c:dPt>
+            <c:idx val="0"/>
+            <c:spPr>
+              <a:solidFill>
+                <a:srgbClr val="F58220"/>
+              </a:solidFill>
+              <a:ln>
+                <a:solidFill>
+                  <a:srgbClr val="FFFFFF"/>
+                </a:solidFill>
+              </a:ln>
+            </c:spPr>
+          </c:dPt>
+          <c:dPt>
+            <c:idx val="1"/>
+            <c:spPr>
+              <a:solidFill>
+                <a:srgbClr val="E8F5EC"/>
+              </a:solidFill>
+              <a:ln>
+                <a:solidFill>
+                  <a:srgbClr val="FFFFFF"/>
+                </a:solidFill>
+              </a:ln>
+            </c:spPr>
+          </c:dPt>
+          <c:cat>
+            <c:strRef>
+              <c:f>Sheet1!$A$2:$A$3</c:f>
+              <c:strCache>
+                <c:ptCount val="2"/>
+                <c:pt idx="0">
+                  <c:v>AI</c:v>
+                </c:pt>
+                <c:pt idx="1">
+                  <c:v>No AI</c:v>
+                </c:pt>
+              </c:strCache>
+            </c:strRef>
+          </c:cat>
+          <c:val>
+            <c:numRef>
+              <c:f>Sheet1!$B$2:$B$3</c:f>
+              <c:numCache>
+                <c:formatCode>General</c:formatCode>
+                <c:ptCount val="2"/>
+                <c:pt idx="0">
+                  <c:v>0.5</c:v>
+                </c:pt>
+                <c:pt idx="1">
+                  <c:v>99.5</c:v>
+                </c:pt>
+              </c:numCache>
+            </c:numRef>
+          </c:val>
+        </c:ser>
+        <c:dLbls>
+          <c:showLegendKey val="0"/>
+          <c:showVal val="0"/>
+          <c:showCatName val="0"/>
+          <c:showSerName val="0"/>
+          <c:showPercent val="0"/>
+          <c:showBubbleSize val="0"/>
+          <c:showLeaderLines val="1"/>
+        </c:dLbls>
+        <c:firstSliceAng val="0"/>
+        <c:holeSize val="62"/>
+      </c:doughnutChart>
+    </c:plotArea>
+    <c:plotVisOnly val="1"/>
+    <c:dispBlanksAs val="gap"/>
+    <c:showDLblsOverMax val="0"/>
+  </c:chart>
+  <c:txPr>
+    <a:bodyPr/>
+    <a:lstStyle/>
+    <a:p>
+      <a:pPr>
+        <a:defRPr sz="1800"/>
+      </a:pPr>
+      <a:endParaRPr/>
+    </a:p>
+  </c:txPr>
+  <c:externalData r:id="rId1">
+    <c:autoUpdate val="0"/>
+  </c:externalData>
+</c:chartSpace>
+</file>
+
+<file path=ppt/charts/chart7.xml><?xml version="1.0" encoding="utf-8"?>
+<c:chartSpace xmlns:c="http://schemas.openxmlformats.org/drawingml/2006/chart" xmlns:a="http://schemas.openxmlformats.org/drawingml/2006/main" xmlns:r="http://schemas.openxmlformats.org/officeDocument/2006/relationships">
+  <c:date1904 val="0"/>
+  <c:chart>
+    <c:autoTitleDeleted val="1"/>
+    <c:plotArea>
+      <c:barChart>
+        <c:barDir val="bar"/>
+        <c:grouping val="clustered"/>
+        <c:ser>
+          <c:idx val="0"/>
+          <c:order val="0"/>
+          <c:tx>
+            <c:strRef>
+              <c:f>Sheet1!$B$1</c:f>
+              <c:strCache>
+                <c:ptCount val="1"/>
+                <c:pt idx="0">
+                  <c:v>x</c:v>
+                </c:pt>
+              </c:strCache>
+            </c:strRef>
+          </c:tx>
+          <c:dPt>
+            <c:idx val="0"/>
+            <c:spPr>
+              <a:solidFill>
+                <a:srgbClr val="7F8C8D"/>
+              </a:solidFill>
+            </c:spPr>
+          </c:dPt>
+          <c:dPt>
+            <c:idx val="1"/>
+            <c:spPr>
+              <a:solidFill>
+                <a:srgbClr val="C0392B"/>
+              </a:solidFill>
+            </c:spPr>
+          </c:dPt>
+          <c:dPt>
+            <c:idx val="2"/>
+            <c:spPr>
+              <a:solidFill>
+                <a:srgbClr val="138A36"/>
+              </a:solidFill>
+            </c:spPr>
+          </c:dPt>
+          <c:dLbls>
+            <c:dLbl>
+              <c:idx val="0"/>
+              <c:tx>
+                <c:rich>
+                  <a:bodyPr/>
+                  <a:lstStyle/>
+                  <a:p>
+                    <a:r>
+                      <a:rPr sz="1100" b="1">
+                        <a:solidFill>
+                          <a:srgbClr val="7F8C8D"/>
+                        </a:solidFill>
+                      </a:rPr>
+                      <a:t>5× costlier</a:t>
+                    </a:r>
+                  </a:p>
+                </c:rich>
+              </c:tx>
+              <c:dLblPos val="outEnd"/>
+              <c:showLegendKey val="0"/>
+              <c:showVal val="1"/>
+              <c:showCatName val="0"/>
+              <c:showSerName val="0"/>
+              <c:showPercent val="0"/>
+              <c:showBubbleSize val="0"/>
+            </c:dLbl>
+            <c:dLbl>
+              <c:idx val="1"/>
+              <c:tx>
+                <c:rich>
+                  <a:bodyPr/>
+                  <a:lstStyle/>
+                  <a:p>
+                    <a:r>
+                      <a:rPr sz="1100" b="1">
+                        <a:solidFill>
+                          <a:srgbClr val="C0392B"/>
+                        </a:solidFill>
+                      </a:rPr>
+                      <a:t>80× costlier</a:t>
+                    </a:r>
+                  </a:p>
+                </c:rich>
+              </c:tx>
+              <c:dLblPos val="outEnd"/>
+              <c:showLegendKey val="0"/>
+              <c:showVal val="1"/>
+              <c:showCatName val="0"/>
+              <c:showSerName val="0"/>
+              <c:showPercent val="0"/>
+              <c:showBubbleSize val="0"/>
+            </c:dLbl>
+            <c:dLbl>
+              <c:idx val="2"/>
+              <c:tx>
+                <c:rich>
+                  <a:bodyPr/>
+                  <a:lstStyle/>
+                  <a:p>
+                    <a:r>
+                      <a:rPr sz="1100" b="1">
+                        <a:solidFill>
+                          <a:srgbClr val="138A36"/>
+                        </a:solidFill>
+                      </a:rPr>
+                      <a:t>1×  lowest</a:t>
+                    </a:r>
+                  </a:p>
+                </c:rich>
+              </c:tx>
+              <c:dLblPos val="outEnd"/>
+              <c:showLegendKey val="0"/>
+              <c:showVal val="1"/>
+              <c:showCatName val="0"/>
+              <c:showSerName val="0"/>
+              <c:showPercent val="0"/>
+              <c:showBubbleSize val="0"/>
+            </c:dLbl>
+            <c:showLegendKey val="0"/>
+            <c:showVal val="0"/>
+            <c:showCatName val="0"/>
+            <c:showSerName val="0"/>
+            <c:showPercent val="0"/>
+            <c:showBubbleSize val="0"/>
+            <c:showLeaderLines val="1"/>
+          </c:dLbls>
+          <c:cat>
+            <c:strRef>
+              <c:f>Sheet1!$A$2:$A$4</c:f>
+              <c:strCache>
+                <c:ptCount val="3"/>
+                <c:pt idx="0">
+                  <c:v>Manual era</c:v>
+                </c:pt>
+                <c:pt idx="1">
+                  <c:v>AI on every line</c:v>
+                </c:pt>
+                <c:pt idx="2">
+                  <c:v>Our solution</c:v>
+                </c:pt>
+              </c:strCache>
+            </c:strRef>
+          </c:cat>
+          <c:val>
+            <c:numRef>
+              <c:f>Sheet1!$B$2:$B$4</c:f>
+              <c:numCache>
+                <c:formatCode>General</c:formatCode>
+                <c:ptCount val="3"/>
+                <c:pt idx="0">
+                  <c:v>5</c:v>
+                </c:pt>
+                <c:pt idx="1">
+                  <c:v>80</c:v>
+                </c:pt>
+                <c:pt idx="2">
+                  <c:v>1</c:v>
+                </c:pt>
+              </c:numCache>
+            </c:numRef>
+          </c:val>
+        </c:ser>
+        <c:gapWidth val="55"/>
+        <c:axId val="-2068027336"/>
+        <c:axId val="-2113994440"/>
+      </c:barChart>
+      <c:catAx>
+        <c:axId val="-2068027336"/>
+        <c:scaling>
+          <c:orientation val="maxMin"/>
+        </c:scaling>
+        <c:delete val="0"/>
+        <c:axPos val="l"/>
+        <c:majorTickMark val="out"/>
+        <c:minorTickMark val="none"/>
+        <c:tickLblPos val="nextTo"/>
+        <c:spPr>
+          <a:ln>
+            <a:solidFill>
+              <a:srgbClr val="D3DBE8"/>
+            </a:solidFill>
+          </a:ln>
+        </c:spPr>
+        <c:txPr>
+          <a:bodyPr/>
+          <a:lstStyle/>
+          <a:p>
+            <a:pPr>
+              <a:defRPr b="1">
+                <a:solidFill>
+                  <a:srgbClr val="0B2A5B"/>
+                </a:solidFill>
+              </a:defRPr>
+            </a:pPr>
+          </a:p>
+        </c:txPr>
+        <c:crossAx val="-2113994440"/>
+        <c:crosses val="autoZero"/>
+        <c:auto val="1"/>
+        <c:lblAlgn val="ctr"/>
+        <c:lblOffset val="100"/>
+        <c:noMultiLvlLbl val="0"/>
+      </c:catAx>
+      <c:valAx>
+        <c:axId val="-2113994440"/>
+        <c:scaling>
+          <c:max val="118.0"/>
+          <c:min val="0.0"/>
+        </c:scaling>
+        <c:delete/>
+        <c:axPos val="b"/>
+        <c:majorTickMark val="out"/>
+        <c:minorTickMark val="none"/>
+        <c:tickLblPos val="nextTo"/>
+        <c:crossAx val="-2068027336"/>
+        <c:crosses val="autoZero"/>
+      </c:valAx>
+    </c:plotArea>
+    <c:dispBlanksAs val="gap"/>
+  </c:chart>
+  <c:spPr>
+    <a:noFill/>
+    <a:ln>
+      <a:noFill/>
+    </a:ln>
+  </c:spPr>
+  <c:txPr>
+    <a:bodyPr/>
+    <a:lstStyle/>
+    <a:p>
+      <a:pPr>
+        <a:defRPr sz="1050">
+          <a:latin typeface="Calibri"/>
+        </a:defRPr>
+      </a:pPr>
+      <a:endParaRPr lang="en-US"/>
+    </a:p>
+  </c:txPr>
+  <c:externalData r:id="rId1">
+    <c:autoUpdate val="0"/>
+  </c:externalData>
+</c:chartSpace>
+</file>
+
+<file path=ppt/charts/chart8.xml><?xml version="1.0" encoding="utf-8"?>
+<c:chartSpace xmlns:c="http://schemas.openxmlformats.org/drawingml/2006/chart" xmlns:a="http://schemas.openxmlformats.org/drawingml/2006/main" xmlns:r="http://schemas.openxmlformats.org/officeDocument/2006/relationships">
+  <c:date1904 val="0"/>
+  <c:chart>
+    <c:autoTitleDeleted val="1"/>
+    <c:plotArea>
+      <c:barChart>
+        <c:barDir val="bar"/>
+        <c:grouping val="clustered"/>
+        <c:ser>
+          <c:idx val="0"/>
+          <c:order val="0"/>
+          <c:tx>
+            <c:strRef>
+              <c:f>Sheet1!$B$1</c:f>
+              <c:strCache>
+                <c:ptCount val="1"/>
+                <c:pt idx="0">
+                  <c:v>x</c:v>
+                </c:pt>
+              </c:strCache>
+            </c:strRef>
+          </c:tx>
+          <c:dPt>
+            <c:idx val="0"/>
+            <c:spPr>
+              <a:solidFill>
+                <a:srgbClr val="7F8C8D"/>
+              </a:solidFill>
+            </c:spPr>
+          </c:dPt>
+          <c:dPt>
+            <c:idx val="1"/>
+            <c:spPr>
+              <a:solidFill>
+                <a:srgbClr val="C0392B"/>
+              </a:solidFill>
+            </c:spPr>
+          </c:dPt>
+          <c:dPt>
+            <c:idx val="2"/>
+            <c:spPr>
+              <a:solidFill>
+                <a:srgbClr val="138A36"/>
+              </a:solidFill>
+            </c:spPr>
+          </c:dPt>
+          <c:dLbls>
+            <c:dLbl>
+              <c:idx val="0"/>
+              <c:tx>
+                <c:rich>
+                  <a:bodyPr/>
+                  <a:lstStyle/>
+                  <a:p>
+                    <a:r>
+                      <a:rPr sz="1100" b="1">
+                        <a:solidFill>
+                          <a:srgbClr val="7F8C8D"/>
+                        </a:solidFill>
+                      </a:rPr>
+                      <a:t>5× faster*</a:t>
+                    </a:r>
+                  </a:p>
+                </c:rich>
+              </c:tx>
+              <c:dLblPos val="outEnd"/>
+              <c:showLegendKey val="0"/>
+              <c:showVal val="1"/>
+              <c:showCatName val="0"/>
+              <c:showSerName val="0"/>
+              <c:showPercent val="0"/>
+              <c:showBubbleSize val="0"/>
+            </c:dLbl>
+            <c:dLbl>
+              <c:idx val="1"/>
+              <c:tx>
+                <c:rich>
+                  <a:bodyPr/>
+                  <a:lstStyle/>
+                  <a:p>
+                    <a:r>
+                      <a:rPr sz="1100" b="1">
+                        <a:solidFill>
+                          <a:srgbClr val="C0392B"/>
+                        </a:solidFill>
+                      </a:rPr>
+                      <a:t>70× slower</a:t>
+                    </a:r>
+                  </a:p>
+                </c:rich>
+              </c:tx>
+              <c:dLblPos val="outEnd"/>
+              <c:showLegendKey val="0"/>
+              <c:showVal val="1"/>
+              <c:showCatName val="0"/>
+              <c:showSerName val="0"/>
+              <c:showPercent val="0"/>
+              <c:showBubbleSize val="0"/>
+            </c:dLbl>
+            <c:dLbl>
+              <c:idx val="2"/>
+              <c:tx>
+                <c:rich>
+                  <a:bodyPr/>
+                  <a:lstStyle/>
+                  <a:p>
+                    <a:r>
+                      <a:rPr sz="1100" b="1">
+                        <a:solidFill>
+                          <a:srgbClr val="138A36"/>
+                        </a:solidFill>
+                      </a:rPr>
+                      <a:t>1×  ~5 min</a:t>
+                    </a:r>
+                  </a:p>
+                </c:rich>
+              </c:tx>
+              <c:dLblPos val="outEnd"/>
+              <c:showLegendKey val="0"/>
+              <c:showVal val="1"/>
+              <c:showCatName val="0"/>
+              <c:showSerName val="0"/>
+              <c:showPercent val="0"/>
+              <c:showBubbleSize val="0"/>
+            </c:dLbl>
+            <c:showLegendKey val="0"/>
+            <c:showVal val="0"/>
+            <c:showCatName val="0"/>
+            <c:showSerName val="0"/>
+            <c:showPercent val="0"/>
+            <c:showBubbleSize val="0"/>
+            <c:showLeaderLines val="1"/>
+          </c:dLbls>
+          <c:cat>
+            <c:strRef>
+              <c:f>Sheet1!$A$2:$A$4</c:f>
+              <c:strCache>
+                <c:ptCount val="3"/>
+                <c:pt idx="0">
+                  <c:v>Manual era</c:v>
+                </c:pt>
+                <c:pt idx="1">
+                  <c:v>AI on every line</c:v>
+                </c:pt>
+                <c:pt idx="2">
+                  <c:v>Our solution</c:v>
+                </c:pt>
+              </c:strCache>
+            </c:strRef>
+          </c:cat>
+          <c:val>
+            <c:numRef>
+              <c:f>Sheet1!$B$2:$B$4</c:f>
+              <c:numCache>
+                <c:formatCode>General</c:formatCode>
+                <c:ptCount val="3"/>
+                <c:pt idx="0">
+                  <c:v>0.2</c:v>
+                </c:pt>
+                <c:pt idx="1">
+                  <c:v>70</c:v>
+                </c:pt>
+                <c:pt idx="2">
+                  <c:v>1</c:v>
+                </c:pt>
+              </c:numCache>
+            </c:numRef>
+          </c:val>
+        </c:ser>
+        <c:gapWidth val="55"/>
+        <c:axId val="-2068027336"/>
+        <c:axId val="-2113994440"/>
+      </c:barChart>
+      <c:catAx>
+        <c:axId val="-2068027336"/>
+        <c:scaling>
+          <c:orientation val="maxMin"/>
+        </c:scaling>
+        <c:delete val="0"/>
+        <c:axPos val="l"/>
+        <c:majorTickMark val="out"/>
+        <c:minorTickMark val="none"/>
+        <c:tickLblPos val="nextTo"/>
+        <c:spPr>
+          <a:ln>
+            <a:solidFill>
+              <a:srgbClr val="D3DBE8"/>
+            </a:solidFill>
+          </a:ln>
+        </c:spPr>
+        <c:txPr>
+          <a:bodyPr/>
+          <a:lstStyle/>
+          <a:p>
+            <a:pPr>
+              <a:defRPr b="1">
+                <a:solidFill>
+                  <a:srgbClr val="0B2A5B"/>
+                </a:solidFill>
+              </a:defRPr>
+            </a:pPr>
+          </a:p>
+        </c:txPr>
+        <c:crossAx val="-2113994440"/>
+        <c:crosses val="autoZero"/>
+        <c:auto val="1"/>
+        <c:lblAlgn val="ctr"/>
+        <c:lblOffset val="100"/>
+        <c:noMultiLvlLbl val="0"/>
+      </c:catAx>
+      <c:valAx>
+        <c:axId val="-2113994440"/>
+        <c:scaling>
+          <c:max val="118.0"/>
+          <c:min val="0.0"/>
+        </c:scaling>
+        <c:delete/>
+        <c:axPos val="b"/>
+        <c:majorTickMark val="out"/>
+        <c:minorTickMark val="none"/>
+        <c:tickLblPos val="nextTo"/>
+        <c:crossAx val="-2068027336"/>
+        <c:crosses val="autoZero"/>
+      </c:valAx>
+    </c:plotArea>
+    <c:dispBlanksAs val="gap"/>
+  </c:chart>
+  <c:spPr>
+    <a:noFill/>
+    <a:ln>
+      <a:noFill/>
+    </a:ln>
+  </c:spPr>
+  <c:txPr>
+    <a:bodyPr/>
+    <a:lstStyle/>
+    <a:p>
+      <a:pPr>
+        <a:defRPr sz="1050">
+          <a:latin typeface="Calibri"/>
+        </a:defRPr>
+      </a:pPr>
+      <a:endParaRPr lang="en-US"/>
+    </a:p>
+  </c:txPr>
+  <c:externalData r:id="rId1">
+    <c:autoUpdate val="0"/>
+  </c:externalData>
+</c:chartSpace>
+</file>
+
+<file path=ppt/charts/chart9.xml><?xml version="1.0" encoding="utf-8"?>
+<c:chartSpace xmlns:c="http://schemas.openxmlformats.org/drawingml/2006/chart" xmlns:a="http://schemas.openxmlformats.org/drawingml/2006/main" xmlns:r="http://schemas.openxmlformats.org/officeDocument/2006/relationships">
+  <c:date1904 val="0"/>
+  <c:roundedCorners val="0"/>
+  <c:chart>
+    <c:autoTitleDeleted val="1"/>
+    <c:plotArea>
+      <c:layout/>
+      <c:doughnutChart>
+        <c:varyColors val="1"/>
+        <c:ser>
+          <c:idx val="0"/>
+          <c:order val="0"/>
+          <c:tx>
+            <c:strRef>
+              <c:f>Sheet1!$B$1</c:f>
+              <c:strCache>
+                <c:ptCount val="1"/>
+                <c:pt idx="0">
+                  <c:v>x</c:v>
+                </c:pt>
+              </c:strCache>
+            </c:strRef>
+          </c:tx>
+          <c:dPt>
+            <c:idx val="0"/>
+            <c:spPr>
+              <a:solidFill>
+                <a:srgbClr val="C0392B"/>
+              </a:solidFill>
+              <a:ln>
+                <a:solidFill>
+                  <a:srgbClr val="FFFFFF"/>
+                </a:solidFill>
+              </a:ln>
+            </c:spPr>
+          </c:dPt>
+          <c:dPt>
+            <c:idx val="1"/>
+            <c:spPr>
+              <a:solidFill>
+                <a:srgbClr val="FDECEA"/>
+              </a:solidFill>
+              <a:ln>
+                <a:solidFill>
+                  <a:srgbClr val="FFFFFF"/>
+                </a:solidFill>
+              </a:ln>
+            </c:spPr>
+          </c:dPt>
+          <c:cat>
+            <c:strRef>
+              <c:f>Sheet1!$A$2:$A$3</c:f>
+              <c:strCache>
+                <c:ptCount val="2"/>
+                <c:pt idx="0">
+                  <c:v>AI</c:v>
+                </c:pt>
+                <c:pt idx="1">
+                  <c:v>No AI</c:v>
+                </c:pt>
+              </c:strCache>
+            </c:strRef>
+          </c:cat>
+          <c:val>
+            <c:numRef>
+              <c:f>Sheet1!$B$2:$B$3</c:f>
+              <c:numCache>
+                <c:formatCode>General</c:formatCode>
+                <c:ptCount val="2"/>
+                <c:pt idx="0">
+                  <c:v>100</c:v>
+                </c:pt>
+                <c:pt idx="1">
+                  <c:v>0</c:v>
+                </c:pt>
+              </c:numCache>
+            </c:numRef>
+          </c:val>
+        </c:ser>
+        <c:dLbls>
+          <c:showLegendKey val="0"/>
+          <c:showVal val="0"/>
+          <c:showCatName val="0"/>
+          <c:showSerName val="0"/>
+          <c:showPercent val="0"/>
+          <c:showBubbleSize val="0"/>
+          <c:showLeaderLines val="1"/>
+        </c:dLbls>
+        <c:firstSliceAng val="0"/>
+        <c:holeSize val="62"/>
+      </c:doughnutChart>
+    </c:plotArea>
+    <c:plotVisOnly val="1"/>
+    <c:dispBlanksAs val="gap"/>
+    <c:showDLblsOverMax val="0"/>
+  </c:chart>
+  <c:spPr>
+    <a:noFill/>
+    <a:ln>
+      <a:noFill/>
+    </a:ln>
+  </c:spPr>
+  <c:txPr>
+    <a:bodyPr/>
+    <a:lstStyle/>
+    <a:p>
+      <a:pPr>
+        <a:defRPr sz="1800"/>
+      </a:pPr>
+      <a:endParaRPr/>
     </a:p>
   </c:txPr>
   <c:externalData r:id="rId1">
@@ -15636,7 +17096,7 @@
         <p:spPr>
           <a:xfrm>
             <a:off x="365760" y="3246120"/>
-            <a:ext cx="11521440" cy="310896"/>
+            <a:ext cx="11503152" cy="329184"/>
           </a:xfrm>
           <a:prstGeom prst="rect">
             <a:avLst/>
@@ -15644,16 +17104,12 @@
           <a:noFill/>
         </p:spPr>
         <p:txBody>
-          <a:bodyPr wrap="square" anchor="t" lIns="36576" rIns="36576" tIns="18288" bIns="18288">
+          <a:bodyPr wrap="square" lIns="36576" rIns="36576" tIns="18288" bIns="18288" anchor="t">
             <a:spAutoFit/>
           </a:bodyPr>
           <a:lstStyle/>
           <a:p>
-            <a:pPr algn="l">
-              <a:spcAft>
-                <a:spcPts val="0"/>
-              </a:spcAft>
-            </a:pPr>
+            <a:pPr algn="l"/>
             <a:r>
               <a:rPr sz="1300" b="1">
                 <a:solidFill>
@@ -15666,628 +17122,710 @@
             <a:r>
               <a:rPr sz="1300" b="0">
                 <a:solidFill>
-                  <a:srgbClr val="5B6778"/>
-                </a:solidFill>
-                <a:latin typeface="Calibri"/>
-              </a:rPr>
-              <a:t>1 million logs / day in a big organisation (~50 log sources)</a:t>
+                  <a:srgbClr val="5F6B7A"/>
+                </a:solidFill>
+                <a:latin typeface="Calibri"/>
+              </a:rPr>
+              <a:t>1 million logs / day in a big organisation  ·  compared with our solution (= 1×)</a:t>
+            </a:r>
+          </a:p>
+        </p:txBody>
+      </p:sp>
+      <p:sp>
+        <p:nvSpPr>
+          <p:cNvPr id="39" name="Rounded Rectangle 38"/>
+          <p:cNvSpPr/>
+          <p:nvPr/>
+        </p:nvSpPr>
+        <p:spPr>
+          <a:xfrm>
+            <a:off x="365760" y="3611880"/>
+            <a:ext cx="3749040" cy="2542032"/>
+          </a:xfrm>
+          <a:prstGeom prst="roundRect">
+            <a:avLst>
+              <a:gd name="adj" fmla="val 5000"/>
+            </a:avLst>
+          </a:prstGeom>
+          <a:solidFill>
+            <a:srgbClr val="FFFFFF"/>
+          </a:solidFill>
+          <a:ln w="12700">
+            <a:solidFill>
+              <a:srgbClr val="D3DBE8"/>
+            </a:solidFill>
+          </a:ln>
+          <a:effectLst/>
+        </p:spPr>
+        <p:style>
+          <a:lnRef idx="1">
+            <a:schemeClr val="accent1"/>
+          </a:lnRef>
+          <a:fillRef idx="3">
+            <a:schemeClr val="accent1"/>
+          </a:fillRef>
+          <a:effectRef idx="2">
+            <a:schemeClr val="accent1"/>
+          </a:effectRef>
+          <a:fontRef idx="minor">
+            <a:schemeClr val="lt1"/>
+          </a:fontRef>
+        </p:style>
+        <p:txBody>
+          <a:bodyPr rtlCol="0" anchor="ctr"/>
+          <a:lstStyle/>
+          <a:p/>
+        </p:txBody>
+      </p:sp>
+      <p:sp>
+        <p:nvSpPr>
+          <p:cNvPr id="40" name="TextBox 39"/>
+          <p:cNvSpPr txBox="1"/>
+          <p:nvPr/>
+        </p:nvSpPr>
+        <p:spPr>
+          <a:xfrm>
+            <a:off x="475488" y="3666744"/>
+            <a:ext cx="3529584" cy="292608"/>
+          </a:xfrm>
+          <a:prstGeom prst="rect">
+            <a:avLst/>
+          </a:prstGeom>
+          <a:noFill/>
+        </p:spPr>
+        <p:txBody>
+          <a:bodyPr wrap="square" lIns="36576" rIns="36576" tIns="18288" bIns="18288" anchor="t">
+            <a:spAutoFit/>
+          </a:bodyPr>
+          <a:lstStyle/>
+          <a:p>
+            <a:pPr algn="l"/>
+            <a:r>
+              <a:rPr sz="1250" b="1">
+                <a:solidFill>
+                  <a:srgbClr val="0B2A5B"/>
+                </a:solidFill>
+                <a:latin typeface="Calibri"/>
+              </a:rPr>
+              <a:t>Cost for one year</a:t>
             </a:r>
           </a:p>
         </p:txBody>
       </p:sp>
       <p:graphicFrame>
         <p:nvGraphicFramePr>
-          <p:cNvPr id="39" name="Table 38"/>
+          <p:cNvPr id="41" name="Chart 40"/>
           <p:cNvGraphicFramePr>
             <a:graphicFrameLocks noGrp="1"/>
           </p:cNvGraphicFramePr>
           <p:nvPr/>
         </p:nvGraphicFramePr>
         <p:xfrm>
-          <a:off x="365760" y="3630168"/>
-          <a:ext cx="6720840" cy="2468880"/>
+          <a:off x="411480" y="3977640"/>
+          <a:ext cx="3657600" cy="1673352"/>
         </p:xfrm>
         <a:graphic>
-          <a:graphicData uri="http://schemas.openxmlformats.org/drawingml/2006/table">
-            <a:tbl>
-              <a:tblPr firstRow="0" bandRow="0">
-                <a:tableStyleId>{5C22544A-7EE6-4342-B048-85BDC9FD1C3A}</a:tableStyleId>
-              </a:tblPr>
-              <a:tblGrid>
-                <a:gridCol w="1572768"/>
-                <a:gridCol w="1572768"/>
-                <a:gridCol w="1691640"/>
-                <a:gridCol w="1883664"/>
-              </a:tblGrid>
-              <a:tr h="365760">
-                <a:tc>
-                  <a:txBody>
-                    <a:bodyPr wrap="square"/>
-                    <a:lstStyle/>
-                    <a:p>
-                      <a:pPr algn="l"/>
-                      <a:r>
-                        <a:rPr sz="1150" b="1">
-                          <a:solidFill>
-                            <a:srgbClr val="FFFFFF"/>
-                          </a:solidFill>
-                          <a:latin typeface="Calibri"/>
-                        </a:rPr>
-                        <a:t/>
-                      </a:r>
-                    </a:p>
-                  </a:txBody>
-                  <a:tcPr marL="45720" marR="45720" marT="9144" marB="9144" anchor="ctr">
-                    <a:solidFill>
-                      <a:srgbClr val="FFFFFF"/>
-                    </a:solidFill>
-                  </a:tcPr>
-                </a:tc>
-                <a:tc>
-                  <a:txBody>
-                    <a:bodyPr wrap="square"/>
-                    <a:lstStyle/>
-                    <a:p>
-                      <a:pPr algn="ctr"/>
-                      <a:r>
-                        <a:rPr sz="1150" b="1">
-                          <a:solidFill>
-                            <a:srgbClr val="FFFFFF"/>
-                          </a:solidFill>
-                          <a:latin typeface="Calibri"/>
-                        </a:rPr>
-                        <a:t>Manual era</a:t>
-                      </a:r>
-                    </a:p>
-                  </a:txBody>
-                  <a:tcPr marL="45720" marR="45720" marT="9144" marB="9144" anchor="ctr">
-                    <a:solidFill>
-                      <a:srgbClr val="7F8C8D"/>
-                    </a:solidFill>
-                  </a:tcPr>
-                </a:tc>
-                <a:tc>
-                  <a:txBody>
-                    <a:bodyPr wrap="square"/>
-                    <a:lstStyle/>
-                    <a:p>
-                      <a:pPr algn="ctr"/>
-                      <a:r>
-                        <a:rPr sz="1150" b="1">
-                          <a:solidFill>
-                            <a:srgbClr val="FFFFFF"/>
-                          </a:solidFill>
-                          <a:latin typeface="Calibri"/>
-                        </a:rPr>
-                        <a:t>AI on every line</a:t>
-                      </a:r>
-                    </a:p>
-                  </a:txBody>
-                  <a:tcPr marL="45720" marR="45720" marT="9144" marB="9144" anchor="ctr">
-                    <a:solidFill>
-                      <a:srgbClr val="C0392B"/>
-                    </a:solidFill>
-                  </a:tcPr>
-                </a:tc>
-                <a:tc>
-                  <a:txBody>
-                    <a:bodyPr wrap="square"/>
-                    <a:lstStyle/>
-                    <a:p>
-                      <a:pPr algn="ctr"/>
-                      <a:r>
-                        <a:rPr sz="1150" b="1">
-                          <a:solidFill>
-                            <a:srgbClr val="FFFFFF"/>
-                          </a:solidFill>
-                          <a:latin typeface="Calibri"/>
-                        </a:rPr>
-                        <a:t>Our solution</a:t>
-                      </a:r>
-                    </a:p>
-                  </a:txBody>
-                  <a:tcPr marL="45720" marR="45720" marT="9144" marB="9144" anchor="ctr">
-                    <a:solidFill>
-                      <a:srgbClr val="138A36"/>
-                    </a:solidFill>
-                  </a:tcPr>
-                </a:tc>
-              </a:tr>
-              <a:tr h="420624">
-                <a:tc>
-                  <a:txBody>
-                    <a:bodyPr wrap="square"/>
-                    <a:lstStyle/>
-                    <a:p>
-                      <a:pPr algn="l"/>
-                      <a:r>
-                        <a:rPr sz="1050" b="1">
-                          <a:solidFill>
-                            <a:srgbClr val="0B2A5B"/>
-                          </a:solidFill>
-                          <a:latin typeface="Calibri"/>
-                        </a:rPr>
-                        <a:t>Setup before first use</a:t>
-                      </a:r>
-                    </a:p>
-                  </a:txBody>
-                  <a:tcPr marL="45720" marR="45720" marT="9144" marB="9144" anchor="ctr">
-                    <a:solidFill>
-                      <a:srgbClr val="F2F5FA"/>
-                    </a:solidFill>
-                  </a:tcPr>
-                </a:tc>
-                <a:tc>
-                  <a:txBody>
-                    <a:bodyPr wrap="square"/>
-                    <a:lstStyle/>
-                    <a:p>
-                      <a:pPr algn="ctr"/>
-                      <a:r>
-                        <a:rPr sz="1150" b="1">
-                          <a:solidFill>
-                            <a:srgbClr val="C0392B"/>
-                          </a:solidFill>
-                          <a:latin typeface="Calibri"/>
-                        </a:rPr>
-                        <a:t>~2.5 months</a:t>
-                      </a:r>
-                    </a:p>
-                  </a:txBody>
-                  <a:tcPr marL="45720" marR="45720" marT="9144" marB="9144" anchor="ctr">
-                    <a:solidFill>
-                      <a:srgbClr val="FDECEA"/>
-                    </a:solidFill>
-                  </a:tcPr>
-                </a:tc>
-                <a:tc>
-                  <a:txBody>
-                    <a:bodyPr wrap="square"/>
-                    <a:lstStyle/>
-                    <a:p>
-                      <a:pPr algn="ctr"/>
-                      <a:r>
-                        <a:rPr sz="1150" b="1">
-                          <a:solidFill>
-                            <a:srgbClr val="138A36"/>
-                          </a:solidFill>
-                          <a:latin typeface="Calibri"/>
-                        </a:rPr>
-                        <a:t>None</a:t>
-                      </a:r>
-                    </a:p>
-                  </a:txBody>
-                  <a:tcPr marL="45720" marR="45720" marT="9144" marB="9144" anchor="ctr">
-                    <a:solidFill>
-                      <a:srgbClr val="E8F5EC"/>
-                    </a:solidFill>
-                  </a:tcPr>
-                </a:tc>
-                <a:tc>
-                  <a:txBody>
-                    <a:bodyPr wrap="square"/>
-                    <a:lstStyle/>
-                    <a:p>
-                      <a:pPr algn="ctr"/>
-                      <a:r>
-                        <a:rPr sz="1150" b="1">
-                          <a:solidFill>
-                            <a:srgbClr val="138A36"/>
-                          </a:solidFill>
-                          <a:latin typeface="Calibri"/>
-                        </a:rPr>
-                        <a:t>~1 day</a:t>
-                      </a:r>
-                    </a:p>
-                  </a:txBody>
-                  <a:tcPr marL="45720" marR="45720" marT="9144" marB="9144" anchor="ctr">
-                    <a:solidFill>
-                      <a:srgbClr val="E8F5EC"/>
-                    </a:solidFill>
-                  </a:tcPr>
-                </a:tc>
-              </a:tr>
-              <a:tr h="420624">
-                <a:tc>
-                  <a:txBody>
-                    <a:bodyPr wrap="square"/>
-                    <a:lstStyle/>
-                    <a:p>
-                      <a:pPr algn="l"/>
-                      <a:r>
-                        <a:rPr sz="1050" b="1">
-                          <a:solidFill>
-                            <a:srgbClr val="0B2A5B"/>
-                          </a:solidFill>
-                          <a:latin typeface="Calibri"/>
-                        </a:rPr>
-                        <a:t>Time to process 1M logs</a:t>
-                      </a:r>
-                    </a:p>
-                  </a:txBody>
-                  <a:tcPr marL="45720" marR="45720" marT="9144" marB="9144" anchor="ctr">
-                    <a:solidFill>
-                      <a:srgbClr val="F2F5FA"/>
-                    </a:solidFill>
-                  </a:tcPr>
-                </a:tc>
-                <a:tc>
-                  <a:txBody>
-                    <a:bodyPr wrap="square"/>
-                    <a:lstStyle/>
-                    <a:p>
-                      <a:pPr algn="ctr"/>
-                      <a:r>
-                        <a:rPr sz="1150" b="1">
-                          <a:solidFill>
-                            <a:srgbClr val="B35C00"/>
-                          </a:solidFill>
-                          <a:latin typeface="Calibri"/>
-                        </a:rPr>
-                        <a:t>~1 min*</a:t>
-                      </a:r>
-                    </a:p>
-                  </a:txBody>
-                  <a:tcPr marL="45720" marR="45720" marT="9144" marB="9144" anchor="ctr">
-                    <a:solidFill>
-                      <a:srgbClr val="FFF4E0"/>
-                    </a:solidFill>
-                  </a:tcPr>
-                </a:tc>
-                <a:tc>
-                  <a:txBody>
-                    <a:bodyPr wrap="square"/>
-                    <a:lstStyle/>
-                    <a:p>
-                      <a:pPr algn="ctr"/>
-                      <a:r>
-                        <a:rPr sz="1150" b="1">
-                          <a:solidFill>
-                            <a:srgbClr val="C0392B"/>
-                          </a:solidFill>
-                          <a:latin typeface="Calibri"/>
-                        </a:rPr>
-                        <a:t>~5.5 hours</a:t>
-                      </a:r>
-                    </a:p>
-                  </a:txBody>
-                  <a:tcPr marL="45720" marR="45720" marT="9144" marB="9144" anchor="ctr">
-                    <a:solidFill>
-                      <a:srgbClr val="FDECEA"/>
-                    </a:solidFill>
-                  </a:tcPr>
-                </a:tc>
-                <a:tc>
-                  <a:txBody>
-                    <a:bodyPr wrap="square"/>
-                    <a:lstStyle/>
-                    <a:p>
-                      <a:pPr algn="ctr"/>
-                      <a:r>
-                        <a:rPr sz="1150" b="1">
-                          <a:solidFill>
-                            <a:srgbClr val="138A36"/>
-                          </a:solidFill>
-                          <a:latin typeface="Calibri"/>
-                        </a:rPr>
-                        <a:t>~5 min</a:t>
-                      </a:r>
-                    </a:p>
-                  </a:txBody>
-                  <a:tcPr marL="45720" marR="45720" marT="9144" marB="9144" anchor="ctr">
-                    <a:solidFill>
-                      <a:srgbClr val="E8F5EC"/>
-                    </a:solidFill>
-                  </a:tcPr>
-                </a:tc>
-              </a:tr>
-              <a:tr h="420624">
-                <a:tc>
-                  <a:txBody>
-                    <a:bodyPr wrap="square"/>
-                    <a:lstStyle/>
-                    <a:p>
-                      <a:pPr algn="l"/>
-                      <a:r>
-                        <a:rPr sz="1050" b="1">
-                          <a:solidFill>
-                            <a:srgbClr val="0B2A5B"/>
-                          </a:solidFill>
-                          <a:latin typeface="Calibri"/>
-                        </a:rPr>
-                        <a:t>AI calls</a:t>
-                      </a:r>
-                    </a:p>
-                  </a:txBody>
-                  <a:tcPr marL="45720" marR="45720" marT="9144" marB="9144" anchor="ctr">
-                    <a:solidFill>
-                      <a:srgbClr val="F2F5FA"/>
-                    </a:solidFill>
-                  </a:tcPr>
-                </a:tc>
-                <a:tc>
-                  <a:txBody>
-                    <a:bodyPr wrap="square"/>
-                    <a:lstStyle/>
-                    <a:p>
-                      <a:pPr algn="ctr"/>
-                      <a:r>
-                        <a:rPr sz="1150" b="1">
-                          <a:solidFill>
-                            <a:srgbClr val="138A36"/>
-                          </a:solidFill>
-                          <a:latin typeface="Calibri"/>
-                        </a:rPr>
-                        <a:t>0</a:t>
-                      </a:r>
-                    </a:p>
-                  </a:txBody>
-                  <a:tcPr marL="45720" marR="45720" marT="9144" marB="9144" anchor="ctr">
-                    <a:solidFill>
-                      <a:srgbClr val="E8F5EC"/>
-                    </a:solidFill>
-                  </a:tcPr>
-                </a:tc>
-                <a:tc>
-                  <a:txBody>
-                    <a:bodyPr wrap="square"/>
-                    <a:lstStyle/>
-                    <a:p>
-                      <a:pPr algn="ctr"/>
-                      <a:r>
-                        <a:rPr sz="1050" b="1">
-                          <a:solidFill>
-                            <a:srgbClr val="C0392B"/>
-                          </a:solidFill>
-                          <a:latin typeface="Calibri"/>
-                        </a:rPr>
-                        <a:t>1,000,000 / day</a:t>
-                      </a:r>
-                    </a:p>
-                  </a:txBody>
-                  <a:tcPr marL="45720" marR="45720" marT="9144" marB="9144" anchor="ctr">
-                    <a:solidFill>
-                      <a:srgbClr val="FDECEA"/>
-                    </a:solidFill>
-                  </a:tcPr>
-                </a:tc>
-                <a:tc>
-                  <a:txBody>
-                    <a:bodyPr wrap="square"/>
-                    <a:lstStyle/>
-                    <a:p>
-                      <a:pPr algn="ctr"/>
-                      <a:r>
-                        <a:rPr sz="1050" b="1">
-                          <a:solidFill>
-                            <a:srgbClr val="138A36"/>
-                          </a:solidFill>
-                          <a:latin typeface="Calibri"/>
-                        </a:rPr>
-                        <a:t>~2,000 once, then ~50 / day</a:t>
-                      </a:r>
-                    </a:p>
-                  </a:txBody>
-                  <a:tcPr marL="45720" marR="45720" marT="9144" marB="9144" anchor="ctr">
-                    <a:solidFill>
-                      <a:srgbClr val="E8F5EC"/>
-                    </a:solidFill>
-                  </a:tcPr>
-                </a:tc>
-              </a:tr>
-              <a:tr h="420624">
-                <a:tc>
-                  <a:txBody>
-                    <a:bodyPr wrap="square"/>
-                    <a:lstStyle/>
-                    <a:p>
-                      <a:pPr algn="l"/>
-                      <a:r>
-                        <a:rPr sz="1050" b="1">
-                          <a:solidFill>
-                            <a:srgbClr val="0B2A5B"/>
-                          </a:solidFill>
-                          <a:latin typeface="Calibri"/>
-                        </a:rPr>
-                        <a:t>Running cost / day</a:t>
-                      </a:r>
-                    </a:p>
-                  </a:txBody>
-                  <a:tcPr marL="45720" marR="45720" marT="9144" marB="9144" anchor="ctr">
-                    <a:solidFill>
-                      <a:srgbClr val="F2F5FA"/>
-                    </a:solidFill>
-                  </a:tcPr>
-                </a:tc>
-                <a:tc>
-                  <a:txBody>
-                    <a:bodyPr wrap="square"/>
-                    <a:lstStyle/>
-                    <a:p>
-                      <a:pPr algn="ctr"/>
-                      <a:r>
-                        <a:rPr sz="1150" b="1">
-                          <a:solidFill>
-                            <a:srgbClr val="B35C00"/>
-                          </a:solidFill>
-                          <a:latin typeface="Calibri"/>
-                        </a:rPr>
-                        <a:t>~₹1,000</a:t>
-                      </a:r>
-                    </a:p>
-                  </a:txBody>
-                  <a:tcPr marL="45720" marR="45720" marT="9144" marB="9144" anchor="ctr">
-                    <a:solidFill>
-                      <a:srgbClr val="FFF4E0"/>
-                    </a:solidFill>
-                  </a:tcPr>
-                </a:tc>
-                <a:tc>
-                  <a:txBody>
-                    <a:bodyPr wrap="square"/>
-                    <a:lstStyle/>
-                    <a:p>
-                      <a:pPr algn="ctr"/>
-                      <a:r>
-                        <a:rPr sz="1150" b="1">
-                          <a:solidFill>
-                            <a:srgbClr val="C0392B"/>
-                          </a:solidFill>
-                          <a:latin typeface="Calibri"/>
-                        </a:rPr>
-                        <a:t>~₹29,000</a:t>
-                      </a:r>
-                    </a:p>
-                  </a:txBody>
-                  <a:tcPr marL="45720" marR="45720" marT="9144" marB="9144" anchor="ctr">
-                    <a:solidFill>
-                      <a:srgbClr val="FDECEA"/>
-                    </a:solidFill>
-                  </a:tcPr>
-                </a:tc>
-                <a:tc>
-                  <a:txBody>
-                    <a:bodyPr wrap="square"/>
-                    <a:lstStyle/>
-                    <a:p>
-                      <a:pPr algn="ctr"/>
-                      <a:r>
-                        <a:rPr sz="1150" b="1">
-                          <a:solidFill>
-                            <a:srgbClr val="138A36"/>
-                          </a:solidFill>
-                          <a:latin typeface="Calibri"/>
-                        </a:rPr>
-                        <a:t>~₹340</a:t>
-                      </a:r>
-                    </a:p>
-                  </a:txBody>
-                  <a:tcPr marL="45720" marR="45720" marT="9144" marB="9144" anchor="ctr">
-                    <a:solidFill>
-                      <a:srgbClr val="E8F5EC"/>
-                    </a:solidFill>
-                  </a:tcPr>
-                </a:tc>
-              </a:tr>
-              <a:tr h="420624">
-                <a:tc>
-                  <a:txBody>
-                    <a:bodyPr wrap="square"/>
-                    <a:lstStyle/>
-                    <a:p>
-                      <a:pPr algn="l"/>
-                      <a:r>
-                        <a:rPr sz="1050" b="1">
-                          <a:solidFill>
-                            <a:srgbClr val="0B2A5B"/>
-                          </a:solidFill>
-                          <a:latin typeface="Calibri"/>
-                        </a:rPr>
-                        <a:t>New log format arrives</a:t>
-                      </a:r>
-                    </a:p>
-                  </a:txBody>
-                  <a:tcPr marL="45720" marR="45720" marT="9144" marB="9144" anchor="ctr">
-                    <a:solidFill>
-                      <a:srgbClr val="F2F5FA"/>
-                    </a:solidFill>
-                  </a:tcPr>
-                </a:tc>
-                <a:tc>
-                  <a:txBody>
-                    <a:bodyPr wrap="square"/>
-                    <a:lstStyle/>
-                    <a:p>
-                      <a:pPr algn="ctr"/>
-                      <a:r>
-                        <a:rPr sz="1050" b="1">
-                          <a:solidFill>
-                            <a:srgbClr val="C0392B"/>
-                          </a:solidFill>
-                          <a:latin typeface="Calibri"/>
-                        </a:rPr>
-                        <a:t>Breaks until fixed</a:t>
-                      </a:r>
-                    </a:p>
-                  </a:txBody>
-                  <a:tcPr marL="45720" marR="45720" marT="9144" marB="9144" anchor="ctr">
-                    <a:solidFill>
-                      <a:srgbClr val="FDECEA"/>
-                    </a:solidFill>
-                  </a:tcPr>
-                </a:tc>
-                <a:tc>
-                  <a:txBody>
-                    <a:bodyPr wrap="square"/>
-                    <a:lstStyle/>
-                    <a:p>
-                      <a:pPr algn="ctr"/>
-                      <a:r>
-                        <a:rPr sz="1050" b="1">
-                          <a:solidFill>
-                            <a:srgbClr val="B35C00"/>
-                          </a:solidFill>
-                          <a:latin typeface="Calibri"/>
-                        </a:rPr>
-                        <a:t>Handled, pays per line</a:t>
-                      </a:r>
-                    </a:p>
-                  </a:txBody>
-                  <a:tcPr marL="45720" marR="45720" marT="9144" marB="9144" anchor="ctr">
-                    <a:solidFill>
-                      <a:srgbClr val="FFF4E0"/>
-                    </a:solidFill>
-                  </a:tcPr>
-                </a:tc>
-                <a:tc>
-                  <a:txBody>
-                    <a:bodyPr wrap="square"/>
-                    <a:lstStyle/>
-                    <a:p>
-                      <a:pPr algn="ctr"/>
-                      <a:r>
-                        <a:rPr sz="1050" b="1">
-                          <a:solidFill>
-                            <a:srgbClr val="138A36"/>
-                          </a:solidFill>
-                          <a:latin typeface="Calibri"/>
-                        </a:rPr>
-                        <a:t>Learned once, automatically</a:t>
-                      </a:r>
-                    </a:p>
-                  </a:txBody>
-                  <a:tcPr marL="45720" marR="45720" marT="9144" marB="9144" anchor="ctr">
-                    <a:solidFill>
-                      <a:srgbClr val="E8F5EC"/>
-                    </a:solidFill>
-                  </a:tcPr>
-                </a:tc>
-              </a:tr>
-            </a:tbl>
+          <a:graphicData uri="http://schemas.openxmlformats.org/drawingml/2006/chart">
+            <c:chart xmlns:c="http://schemas.openxmlformats.org/drawingml/2006/chart" r:id="rId7"/>
           </a:graphicData>
         </a:graphic>
       </p:graphicFrame>
+      <p:sp>
+        <p:nvSpPr>
+          <p:cNvPr id="42" name="Rounded Rectangle 41"/>
+          <p:cNvSpPr/>
+          <p:nvPr/>
+        </p:nvSpPr>
+        <p:spPr>
+          <a:xfrm>
+            <a:off x="457200" y="5696712"/>
+            <a:ext cx="3566160" cy="365760"/>
+          </a:xfrm>
+          <a:prstGeom prst="roundRect">
+            <a:avLst>
+              <a:gd name="adj" fmla="val 30000"/>
+            </a:avLst>
+          </a:prstGeom>
+          <a:solidFill>
+            <a:srgbClr val="E8F5EC"/>
+          </a:solidFill>
+          <a:ln>
+            <a:noFill/>
+          </a:ln>
+          <a:effectLst/>
+        </p:spPr>
+        <p:style>
+          <a:lnRef idx="1">
+            <a:schemeClr val="accent1"/>
+          </a:lnRef>
+          <a:fillRef idx="3">
+            <a:schemeClr val="accent1"/>
+          </a:fillRef>
+          <a:effectRef idx="2">
+            <a:schemeClr val="accent1"/>
+          </a:effectRef>
+          <a:fontRef idx="minor">
+            <a:schemeClr val="lt1"/>
+          </a:fontRef>
+        </p:style>
+        <p:txBody>
+          <a:bodyPr rtlCol="0" anchor="ctr"/>
+          <a:lstStyle/>
+          <a:p/>
+        </p:txBody>
+      </p:sp>
+      <p:sp>
+        <p:nvSpPr>
+          <p:cNvPr id="43" name="TextBox 42"/>
+          <p:cNvSpPr txBox="1"/>
+          <p:nvPr/>
+        </p:nvSpPr>
+        <p:spPr>
+          <a:xfrm>
+            <a:off x="457200" y="5696712"/>
+            <a:ext cx="3566160" cy="365760"/>
+          </a:xfrm>
+          <a:prstGeom prst="rect">
+            <a:avLst/>
+          </a:prstGeom>
+          <a:noFill/>
+        </p:spPr>
+        <p:txBody>
+          <a:bodyPr wrap="square" lIns="36576" rIns="36576" tIns="18288" bIns="18288" anchor="ctr">
+            <a:spAutoFit/>
+          </a:bodyPr>
+          <a:lstStyle/>
+          <a:p>
+            <a:pPr algn="ctr"/>
+            <a:r>
+              <a:rPr sz="1100" b="1">
+                <a:solidFill>
+                  <a:srgbClr val="138A36"/>
+                </a:solidFill>
+                <a:latin typeface="Calibri"/>
+              </a:rPr>
+              <a:t>✔ 80× cheaper than AI · 5× vs manual</a:t>
+            </a:r>
+          </a:p>
+        </p:txBody>
+      </p:sp>
+      <p:sp>
+        <p:nvSpPr>
+          <p:cNvPr id="44" name="Rounded Rectangle 43"/>
+          <p:cNvSpPr/>
+          <p:nvPr/>
+        </p:nvSpPr>
+        <p:spPr>
+          <a:xfrm>
+            <a:off x="4242816" y="3611880"/>
+            <a:ext cx="3749040" cy="2542032"/>
+          </a:xfrm>
+          <a:prstGeom prst="roundRect">
+            <a:avLst>
+              <a:gd name="adj" fmla="val 5000"/>
+            </a:avLst>
+          </a:prstGeom>
+          <a:solidFill>
+            <a:srgbClr val="FFFFFF"/>
+          </a:solidFill>
+          <a:ln w="12700">
+            <a:solidFill>
+              <a:srgbClr val="D3DBE8"/>
+            </a:solidFill>
+          </a:ln>
+          <a:effectLst/>
+        </p:spPr>
+        <p:style>
+          <a:lnRef idx="1">
+            <a:schemeClr val="accent1"/>
+          </a:lnRef>
+          <a:fillRef idx="3">
+            <a:schemeClr val="accent1"/>
+          </a:fillRef>
+          <a:effectRef idx="2">
+            <a:schemeClr val="accent1"/>
+          </a:effectRef>
+          <a:fontRef idx="minor">
+            <a:schemeClr val="lt1"/>
+          </a:fontRef>
+        </p:style>
+        <p:txBody>
+          <a:bodyPr rtlCol="0" anchor="ctr"/>
+          <a:lstStyle/>
+          <a:p/>
+        </p:txBody>
+      </p:sp>
+      <p:sp>
+        <p:nvSpPr>
+          <p:cNvPr id="45" name="TextBox 44"/>
+          <p:cNvSpPr txBox="1"/>
+          <p:nvPr/>
+        </p:nvSpPr>
+        <p:spPr>
+          <a:xfrm>
+            <a:off x="4352544" y="3666744"/>
+            <a:ext cx="3529584" cy="292608"/>
+          </a:xfrm>
+          <a:prstGeom prst="rect">
+            <a:avLst/>
+          </a:prstGeom>
+          <a:noFill/>
+        </p:spPr>
+        <p:txBody>
+          <a:bodyPr wrap="square" lIns="36576" rIns="36576" tIns="18288" bIns="18288" anchor="t">
+            <a:spAutoFit/>
+          </a:bodyPr>
+          <a:lstStyle/>
+          <a:p>
+            <a:pPr algn="l"/>
+            <a:r>
+              <a:rPr sz="1250" b="1">
+                <a:solidFill>
+                  <a:srgbClr val="0B2A5B"/>
+                </a:solidFill>
+                <a:latin typeface="Calibri"/>
+              </a:rPr>
+              <a:t>Time to process 1M logs</a:t>
+            </a:r>
+          </a:p>
+        </p:txBody>
+      </p:sp>
       <p:graphicFrame>
         <p:nvGraphicFramePr>
-          <p:cNvPr id="40" name="Chart 39"/>
+          <p:cNvPr id="46" name="Chart 45"/>
           <p:cNvGraphicFramePr>
             <a:graphicFrameLocks noGrp="1"/>
           </p:cNvGraphicFramePr>
           <p:nvPr/>
         </p:nvGraphicFramePr>
         <p:xfrm>
-          <a:off x="7269480" y="3593591"/>
-          <a:ext cx="4599432" cy="2578608"/>
+          <a:off x="4288536" y="3977640"/>
+          <a:ext cx="3657600" cy="1673352"/>
         </p:xfrm>
         <a:graphic>
           <a:graphicData uri="http://schemas.openxmlformats.org/drawingml/2006/chart">
-            <c:chart xmlns:c="http://schemas.openxmlformats.org/drawingml/2006/chart" r:id="rId2"/>
+            <c:chart xmlns:c="http://schemas.openxmlformats.org/drawingml/2006/chart" r:id="rId8"/>
           </a:graphicData>
         </a:graphic>
       </p:graphicFrame>
       <p:sp>
         <p:nvSpPr>
-          <p:cNvPr id="41" name="TextBox 40"/>
+          <p:cNvPr id="47" name="Rounded Rectangle 46"/>
+          <p:cNvSpPr/>
+          <p:nvPr/>
+        </p:nvSpPr>
+        <p:spPr>
+          <a:xfrm>
+            <a:off x="4334256" y="5696712"/>
+            <a:ext cx="3566160" cy="365760"/>
+          </a:xfrm>
+          <a:prstGeom prst="roundRect">
+            <a:avLst>
+              <a:gd name="adj" fmla="val 30000"/>
+            </a:avLst>
+          </a:prstGeom>
+          <a:solidFill>
+            <a:srgbClr val="E8F5EC"/>
+          </a:solidFill>
+          <a:ln>
+            <a:noFill/>
+          </a:ln>
+          <a:effectLst/>
+        </p:spPr>
+        <p:style>
+          <a:lnRef idx="1">
+            <a:schemeClr val="accent1"/>
+          </a:lnRef>
+          <a:fillRef idx="3">
+            <a:schemeClr val="accent1"/>
+          </a:fillRef>
+          <a:effectRef idx="2">
+            <a:schemeClr val="accent1"/>
+          </a:effectRef>
+          <a:fontRef idx="minor">
+            <a:schemeClr val="lt1"/>
+          </a:fontRef>
+        </p:style>
+        <p:txBody>
+          <a:bodyPr rtlCol="0" anchor="ctr"/>
+          <a:lstStyle/>
+          <a:p/>
+        </p:txBody>
+      </p:sp>
+      <p:sp>
+        <p:nvSpPr>
+          <p:cNvPr id="48" name="TextBox 47"/>
+          <p:cNvSpPr txBox="1"/>
+          <p:nvPr/>
+        </p:nvSpPr>
+        <p:spPr>
+          <a:xfrm>
+            <a:off x="4334256" y="5696712"/>
+            <a:ext cx="3566160" cy="365760"/>
+          </a:xfrm>
+          <a:prstGeom prst="rect">
+            <a:avLst/>
+          </a:prstGeom>
+          <a:noFill/>
+        </p:spPr>
+        <p:txBody>
+          <a:bodyPr wrap="square" lIns="36576" rIns="36576" tIns="18288" bIns="18288" anchor="ctr">
+            <a:spAutoFit/>
+          </a:bodyPr>
+          <a:lstStyle/>
+          <a:p>
+            <a:pPr algn="ctr"/>
+            <a:r>
+              <a:rPr sz="1100" b="1">
+                <a:solidFill>
+                  <a:srgbClr val="138A36"/>
+                </a:solidFill>
+                <a:latin typeface="Calibri"/>
+              </a:rPr>
+              <a:t>✔ 70× faster than AI on every line</a:t>
+            </a:r>
+          </a:p>
+        </p:txBody>
+      </p:sp>
+      <p:sp>
+        <p:nvSpPr>
+          <p:cNvPr id="49" name="Rounded Rectangle 48"/>
+          <p:cNvSpPr/>
+          <p:nvPr/>
+        </p:nvSpPr>
+        <p:spPr>
+          <a:xfrm>
+            <a:off x="8119872" y="3611880"/>
+            <a:ext cx="3749040" cy="2542032"/>
+          </a:xfrm>
+          <a:prstGeom prst="roundRect">
+            <a:avLst>
+              <a:gd name="adj" fmla="val 5000"/>
+            </a:avLst>
+          </a:prstGeom>
+          <a:solidFill>
+            <a:srgbClr val="FFFFFF"/>
+          </a:solidFill>
+          <a:ln w="12700">
+            <a:solidFill>
+              <a:srgbClr val="D3DBE8"/>
+            </a:solidFill>
+          </a:ln>
+          <a:effectLst/>
+        </p:spPr>
+        <p:style>
+          <a:lnRef idx="1">
+            <a:schemeClr val="accent1"/>
+          </a:lnRef>
+          <a:fillRef idx="3">
+            <a:schemeClr val="accent1"/>
+          </a:fillRef>
+          <a:effectRef idx="2">
+            <a:schemeClr val="accent1"/>
+          </a:effectRef>
+          <a:fontRef idx="minor">
+            <a:schemeClr val="lt1"/>
+          </a:fontRef>
+        </p:style>
+        <p:txBody>
+          <a:bodyPr rtlCol="0" anchor="ctr"/>
+          <a:lstStyle/>
+          <a:p/>
+        </p:txBody>
+      </p:sp>
+      <p:sp>
+        <p:nvSpPr>
+          <p:cNvPr id="50" name="TextBox 49"/>
+          <p:cNvSpPr txBox="1"/>
+          <p:nvPr/>
+        </p:nvSpPr>
+        <p:spPr>
+          <a:xfrm>
+            <a:off x="8229600" y="3666744"/>
+            <a:ext cx="3529584" cy="292608"/>
+          </a:xfrm>
+          <a:prstGeom prst="rect">
+            <a:avLst/>
+          </a:prstGeom>
+          <a:noFill/>
+        </p:spPr>
+        <p:txBody>
+          <a:bodyPr wrap="square" lIns="36576" rIns="36576" tIns="18288" bIns="18288" anchor="t">
+            <a:spAutoFit/>
+          </a:bodyPr>
+          <a:lstStyle/>
+          <a:p>
+            <a:pPr algn="l"/>
+            <a:r>
+              <a:rPr sz="1250" b="1">
+                <a:solidFill>
+                  <a:srgbClr val="0B2A5B"/>
+                </a:solidFill>
+                <a:latin typeface="Calibri"/>
+              </a:rPr>
+              <a:t>Share of logs sent to AI</a:t>
+            </a:r>
+          </a:p>
+        </p:txBody>
+      </p:sp>
+      <p:graphicFrame>
+        <p:nvGraphicFramePr>
+          <p:cNvPr id="51" name="Chart 50"/>
+          <p:cNvGraphicFramePr>
+            <a:graphicFrameLocks noGrp="1"/>
+          </p:cNvGraphicFramePr>
+          <p:nvPr/>
+        </p:nvGraphicFramePr>
+        <p:xfrm>
+          <a:off x="8348472" y="3995928"/>
+          <a:ext cx="1481328" cy="1481328"/>
+        </p:xfrm>
+        <a:graphic>
+          <a:graphicData uri="http://schemas.openxmlformats.org/drawingml/2006/chart">
+            <c:chart xmlns:c="http://schemas.openxmlformats.org/drawingml/2006/chart" r:id="rId9"/>
+          </a:graphicData>
+        </a:graphic>
+      </p:graphicFrame>
+      <p:sp>
+        <p:nvSpPr>
+          <p:cNvPr id="52" name="TextBox 51"/>
+          <p:cNvSpPr txBox="1"/>
+          <p:nvPr/>
+        </p:nvSpPr>
+        <p:spPr>
+          <a:xfrm>
+            <a:off x="8348472" y="4535424"/>
+            <a:ext cx="1481328" cy="402336"/>
+          </a:xfrm>
+          <a:prstGeom prst="rect">
+            <a:avLst/>
+          </a:prstGeom>
+          <a:noFill/>
+        </p:spPr>
+        <p:txBody>
+          <a:bodyPr wrap="square" lIns="36576" rIns="36576" tIns="18288" bIns="18288" anchor="ctr">
+            <a:spAutoFit/>
+          </a:bodyPr>
+          <a:lstStyle/>
+          <a:p>
+            <a:pPr algn="ctr"/>
+            <a:r>
+              <a:rPr sz="1700" b="1">
+                <a:solidFill>
+                  <a:srgbClr val="C0392B"/>
+                </a:solidFill>
+                <a:latin typeface="Calibri"/>
+              </a:rPr>
+              <a:t>100%</a:t>
+            </a:r>
+          </a:p>
+        </p:txBody>
+      </p:sp>
+      <p:sp>
+        <p:nvSpPr>
+          <p:cNvPr id="53" name="TextBox 52"/>
+          <p:cNvSpPr txBox="1"/>
+          <p:nvPr/>
+        </p:nvSpPr>
+        <p:spPr>
+          <a:xfrm>
+            <a:off x="8211312" y="5477256"/>
+            <a:ext cx="1755648" cy="274320"/>
+          </a:xfrm>
+          <a:prstGeom prst="rect">
+            <a:avLst/>
+          </a:prstGeom>
+          <a:noFill/>
+        </p:spPr>
+        <p:txBody>
+          <a:bodyPr wrap="square" lIns="36576" rIns="36576" tIns="18288" bIns="18288" anchor="t">
+            <a:spAutoFit/>
+          </a:bodyPr>
+          <a:lstStyle/>
+          <a:p>
+            <a:pPr algn="ctr"/>
+            <a:r>
+              <a:rPr sz="1050" b="1">
+                <a:solidFill>
+                  <a:srgbClr val="C0392B"/>
+                </a:solidFill>
+                <a:latin typeface="Calibri"/>
+              </a:rPr>
+              <a:t>AI on every line</a:t>
+            </a:r>
+          </a:p>
+        </p:txBody>
+      </p:sp>
+      <p:graphicFrame>
+        <p:nvGraphicFramePr>
+          <p:cNvPr id="54" name="Chart 53"/>
+          <p:cNvGraphicFramePr>
+            <a:graphicFrameLocks noGrp="1"/>
+          </p:cNvGraphicFramePr>
+          <p:nvPr/>
+        </p:nvGraphicFramePr>
+        <p:xfrm>
+          <a:off x="10158984" y="3995928"/>
+          <a:ext cx="1481328" cy="1481328"/>
+        </p:xfrm>
+        <a:graphic>
+          <a:graphicData uri="http://schemas.openxmlformats.org/drawingml/2006/chart">
+            <c:chart xmlns:c="http://schemas.openxmlformats.org/drawingml/2006/chart" r:id="rId10"/>
+          </a:graphicData>
+        </a:graphic>
+      </p:graphicFrame>
+      <p:sp>
+        <p:nvSpPr>
+          <p:cNvPr id="55" name="TextBox 54"/>
+          <p:cNvSpPr txBox="1"/>
+          <p:nvPr/>
+        </p:nvSpPr>
+        <p:spPr>
+          <a:xfrm>
+            <a:off x="10158984" y="4535424"/>
+            <a:ext cx="1481328" cy="402336"/>
+          </a:xfrm>
+          <a:prstGeom prst="rect">
+            <a:avLst/>
+          </a:prstGeom>
+          <a:noFill/>
+        </p:spPr>
+        <p:txBody>
+          <a:bodyPr wrap="square" lIns="36576" rIns="36576" tIns="18288" bIns="18288" anchor="ctr">
+            <a:spAutoFit/>
+          </a:bodyPr>
+          <a:lstStyle/>
+          <a:p>
+            <a:pPr algn="ctr"/>
+            <a:r>
+              <a:rPr sz="1700" b="1">
+                <a:solidFill>
+                  <a:srgbClr val="138A36"/>
+                </a:solidFill>
+                <a:latin typeface="Calibri"/>
+              </a:rPr>
+              <a:t>0.5%</a:t>
+            </a:r>
+          </a:p>
+        </p:txBody>
+      </p:sp>
+      <p:sp>
+        <p:nvSpPr>
+          <p:cNvPr id="56" name="TextBox 55"/>
+          <p:cNvSpPr txBox="1"/>
+          <p:nvPr/>
+        </p:nvSpPr>
+        <p:spPr>
+          <a:xfrm>
+            <a:off x="10021824" y="5477256"/>
+            <a:ext cx="1755648" cy="274320"/>
+          </a:xfrm>
+          <a:prstGeom prst="rect">
+            <a:avLst/>
+          </a:prstGeom>
+          <a:noFill/>
+        </p:spPr>
+        <p:txBody>
+          <a:bodyPr wrap="square" lIns="36576" rIns="36576" tIns="18288" bIns="18288" anchor="t">
+            <a:spAutoFit/>
+          </a:bodyPr>
+          <a:lstStyle/>
+          <a:p>
+            <a:pPr algn="ctr"/>
+            <a:r>
+              <a:rPr sz="1050" b="1">
+                <a:solidFill>
+                  <a:srgbClr val="138A36"/>
+                </a:solidFill>
+                <a:latin typeface="Calibri"/>
+              </a:rPr>
+              <a:t>Our solution</a:t>
+            </a:r>
+          </a:p>
+        </p:txBody>
+      </p:sp>
+      <p:sp>
+        <p:nvSpPr>
+          <p:cNvPr id="57" name="Rounded Rectangle 56"/>
+          <p:cNvSpPr/>
+          <p:nvPr/>
+        </p:nvSpPr>
+        <p:spPr>
+          <a:xfrm>
+            <a:off x="8211312" y="5696712"/>
+            <a:ext cx="3566160" cy="365760"/>
+          </a:xfrm>
+          <a:prstGeom prst="roundRect">
+            <a:avLst>
+              <a:gd name="adj" fmla="val 30000"/>
+            </a:avLst>
+          </a:prstGeom>
+          <a:solidFill>
+            <a:srgbClr val="E8F5EC"/>
+          </a:solidFill>
+          <a:ln>
+            <a:noFill/>
+          </a:ln>
+          <a:effectLst/>
+        </p:spPr>
+        <p:style>
+          <a:lnRef idx="1">
+            <a:schemeClr val="accent1"/>
+          </a:lnRef>
+          <a:fillRef idx="3">
+            <a:schemeClr val="accent1"/>
+          </a:fillRef>
+          <a:effectRef idx="2">
+            <a:schemeClr val="accent1"/>
+          </a:effectRef>
+          <a:fontRef idx="minor">
+            <a:schemeClr val="lt1"/>
+          </a:fontRef>
+        </p:style>
+        <p:txBody>
+          <a:bodyPr rtlCol="0" anchor="ctr"/>
+          <a:lstStyle/>
+          <a:p/>
+        </p:txBody>
+      </p:sp>
+      <p:sp>
+        <p:nvSpPr>
+          <p:cNvPr id="58" name="TextBox 57"/>
+          <p:cNvSpPr txBox="1"/>
+          <p:nvPr/>
+        </p:nvSpPr>
+        <p:spPr>
+          <a:xfrm>
+            <a:off x="8211312" y="5696712"/>
+            <a:ext cx="3566160" cy="365760"/>
+          </a:xfrm>
+          <a:prstGeom prst="rect">
+            <a:avLst/>
+          </a:prstGeom>
+          <a:noFill/>
+        </p:spPr>
+        <p:txBody>
+          <a:bodyPr wrap="square" lIns="36576" rIns="36576" tIns="18288" bIns="18288" anchor="ctr">
+            <a:spAutoFit/>
+          </a:bodyPr>
+          <a:lstStyle/>
+          <a:p>
+            <a:pPr algn="ctr"/>
+            <a:r>
+              <a:rPr sz="1100" b="1">
+                <a:solidFill>
+                  <a:srgbClr val="138A36"/>
+                </a:solidFill>
+                <a:latin typeface="Calibri"/>
+              </a:rPr>
+              <a:t>✔ 99.5% fewer AI calls</a:t>
+            </a:r>
+          </a:p>
+        </p:txBody>
+      </p:sp>
+      <p:sp>
+        <p:nvSpPr>
+          <p:cNvPr id="59" name="TextBox 58"/>
           <p:cNvSpPr txBox="1"/>
           <p:nvPr/>
         </p:nvSpPr>
@@ -16302,24 +17840,20 @@
           <a:noFill/>
         </p:spPr>
         <p:txBody>
-          <a:bodyPr wrap="square" anchor="t" lIns="36576" rIns="36576" tIns="18288" bIns="18288">
+          <a:bodyPr wrap="square" lIns="36576" rIns="36576" tIns="18288" bIns="18288" anchor="t">
             <a:spAutoFit/>
           </a:bodyPr>
           <a:lstStyle/>
           <a:p>
-            <a:pPr algn="l">
-              <a:spcAft>
-                <a:spcPts val="0"/>
-              </a:spcAft>
-            </a:pPr>
+            <a:pPr algn="l"/>
             <a:r>
               <a:rPr sz="850" b="0">
                 <a:solidFill>
-                  <a:srgbClr val="5B6778"/>
-                </a:solidFill>
-                <a:latin typeface="Calibri"/>
-              </a:rPr>
-              <a:t>* known formats only. Illustrative estimate: ~2,000 log templates · engineer ₹5,000/day · AI at ~$0.30 / $2.50 per 1M input/output tokens, ~400 tokens per log, ₹85/$ · our speed (0.28 ms/log) and AI-call rate measured in our benchmark.</a:t>
+                  <a:srgbClr val="5F6B7A"/>
+                </a:solidFill>
+                <a:latin typeface="Calibri"/>
+              </a:rPr>
+              <a:t>Illustrative estimate for ~50 log sources; our speed (0.28 ms/log) and AI-call rate are measured in our benchmark.  * Manual parsers are fast only for formats already written by hand; a new format breaks until an engineer fixes it.</a:t>
             </a:r>
           </a:p>
         </p:txBody>
@@ -16834,7 +18368,7 @@
         </p:nvSpPr>
         <p:spPr>
           <a:xfrm>
-            <a:off x="566928" y="1508760"/>
+            <a:off x="566928" y="1627632"/>
             <a:ext cx="6995160" cy="1325880"/>
           </a:xfrm>
           <a:prstGeom prst="rect">
@@ -16850,156 +18384,103 @@
           <a:p>
             <a:pPr algn="l">
               <a:spcAft>
-                <a:spcPts val="400"/>
+                <a:spcPts val="1300"/>
               </a:spcAft>
             </a:pPr>
             <a:r>
-              <a:rPr sz="1200" b="0">
-                <a:solidFill>
-                  <a:srgbClr val="1E2530"/>
-                </a:solidFill>
-                <a:latin typeface="Calibri"/>
-              </a:rPr>
-              <a:t/>
-            </a:r>
-            <a:r>
-              <a:rPr sz="1200" b="0">
+              <a:rPr sz="1300" b="0">
                 <a:solidFill>
                   <a:srgbClr val="1F5FBF"/>
                 </a:solidFill>
                 <a:latin typeface="Calibri"/>
               </a:rPr>
-              <a:t>▪ </a:t>
-            </a:r>
-            <a:r>
-              <a:rPr sz="1200" b="1">
+              <a:t>▪  </a:t>
+            </a:r>
+            <a:r>
+              <a:rPr sz="1300" b="1">
                 <a:solidFill>
                   <a:srgbClr val="0B2A5B"/>
                 </a:solidFill>
                 <a:latin typeface="Calibri"/>
               </a:rPr>
-              <a:t>Drain: online log parsing </a:t>
-            </a:r>
-            <a:r>
-              <a:rPr sz="1200" b="0">
-                <a:solidFill>
-                  <a:srgbClr val="1E2530"/>
-                </a:solidFill>
-                <a:latin typeface="Calibri"/>
-              </a:rPr>
-              <a:t>(He et al., IEEE ICWS 2017): the grouping method we use</a:t>
+              <a:t>Drain log parsing</a:t>
+            </a:r>
+            <a:r>
+              <a:rPr sz="1300" b="0">
+                <a:solidFill>
+                  <a:srgbClr val="5F6B7A"/>
+                </a:solidFill>
+                <a:latin typeface="Calibri"/>
+              </a:rPr>
+              <a:t>  —  He et al., IEEE ICWS 2017</a:t>
             </a:r>
           </a:p>
           <a:p>
             <a:pPr>
               <a:spcAft>
-                <a:spcPts val="400"/>
+                <a:spcPts val="1300"/>
               </a:spcAft>
             </a:pPr>
             <a:r>
-              <a:rPr sz="1200" b="0">
+              <a:rPr sz="1300" b="0">
                 <a:solidFill>
                   <a:srgbClr val="1F5FBF"/>
                 </a:solidFill>
                 <a:latin typeface="Calibri"/>
               </a:rPr>
-              <a:t>▪ </a:t>
-            </a:r>
-            <a:r>
-              <a:rPr sz="1200" b="1">
+              <a:t>▪  </a:t>
+            </a:r>
+            <a:r>
+              <a:rPr sz="1300" b="1">
                 <a:solidFill>
                   <a:srgbClr val="0B2A5B"/>
                 </a:solidFill>
                 <a:latin typeface="Calibri"/>
               </a:rPr>
-              <a:t>Benchmarks for automated log parsing </a:t>
-            </a:r>
-            <a:r>
-              <a:rPr sz="1200" b="0">
-                <a:solidFill>
-                  <a:srgbClr val="1E2530"/>
-                </a:solidFill>
-                <a:latin typeface="Calibri"/>
-              </a:rPr>
-              <a:t>(Zhu et al., ICSE-SEIP 2019): how we measure accuracy</a:t>
+              <a:t>Loghub real-world log datasets</a:t>
+            </a:r>
+            <a:r>
+              <a:rPr sz="1300" b="0">
+                <a:solidFill>
+                  <a:srgbClr val="5F6B7A"/>
+                </a:solidFill>
+                <a:latin typeface="Calibri"/>
+              </a:rPr>
+              <a:t>  —  Zhu et al., IEEE ISSRE 2023</a:t>
             </a:r>
           </a:p>
           <a:p>
             <a:pPr>
               <a:spcAft>
-                <a:spcPts val="400"/>
+                <a:spcPts val="0"/>
               </a:spcAft>
             </a:pPr>
             <a:r>
-              <a:rPr sz="1200" b="0">
+              <a:rPr sz="1300" b="0">
                 <a:solidFill>
                   <a:srgbClr val="1F5FBF"/>
                 </a:solidFill>
                 <a:latin typeface="Calibri"/>
               </a:rPr>
-              <a:t>▪ </a:t>
-            </a:r>
-            <a:r>
-              <a:rPr sz="1200" b="1">
+              <a:t>▪  </a:t>
+            </a:r>
+            <a:r>
+              <a:rPr sz="1300" b="1">
                 <a:solidFill>
                   <a:srgbClr val="0B2A5B"/>
                 </a:solidFill>
                 <a:latin typeface="Calibri"/>
               </a:rPr>
-              <a:t>Loghub: real-world log datasets </a:t>
-            </a:r>
-            <a:r>
-              <a:rPr sz="1200" b="0">
-                <a:solidFill>
-                  <a:srgbClr val="1E2530"/>
-                </a:solidFill>
-                <a:latin typeface="Calibri"/>
-              </a:rPr>
-              <a:t>(Zhu et al., IEEE ISSRE 2023): our test data · </a:t>
-            </a:r>
-            <a:r>
-              <a:rPr sz="1200" b="0">
-                <a:solidFill>
-                  <a:srgbClr val="1F5FBF"/>
-                </a:solidFill>
-                <a:latin typeface="Calibri"/>
-                <a:hlinkClick r:id="rId2"/>
-              </a:rPr>
-              <a:t>github.com/logpai/loghub</a:t>
-            </a:r>
-          </a:p>
-          <a:p>
-            <a:pPr>
-              <a:spcAft>
-                <a:spcPts val="400"/>
-              </a:spcAft>
-            </a:pPr>
-            <a:r>
-              <a:rPr sz="1200" b="0">
-                <a:solidFill>
-                  <a:srgbClr val="1F5FBF"/>
-                </a:solidFill>
-                <a:latin typeface="Calibri"/>
-              </a:rPr>
-              <a:t>▪ </a:t>
-            </a:r>
-            <a:r>
-              <a:rPr sz="1200" b="1">
-                <a:solidFill>
-                  <a:srgbClr val="0B2A5B"/>
-                </a:solidFill>
-                <a:latin typeface="Calibri"/>
-              </a:rPr>
-              <a:t>Scikit-learn </a:t>
-            </a:r>
-            <a:r>
-              <a:rPr sz="1200" b="0">
-                <a:solidFill>
-                  <a:srgbClr val="1E2530"/>
-                </a:solidFill>
-                <a:latin typeface="Calibri"/>
-              </a:rPr>
-              <a:t>(Pedregosa et al., JMLR 2011): our machine-learning library</a:t>
+              <a:t>Log-parser benchmark</a:t>
+            </a:r>
+            <a:r>
+              <a:rPr sz="1300" b="0">
+                <a:solidFill>
+                  <a:srgbClr val="5F6B7A"/>
+                </a:solidFill>
+                <a:latin typeface="Calibri"/>
+              </a:rPr>
+              <a:t>  —  Zhu et al., ICSE-SEIP 2019</a:t>
             </a:r>
           </a:p>
         </p:txBody>
@@ -17143,7 +18624,7 @@
         </p:nvSpPr>
         <p:spPr>
           <a:xfrm>
-            <a:off x="566928" y="3410712"/>
+            <a:off x="566928" y="3529584"/>
             <a:ext cx="6995160" cy="1325880"/>
           </a:xfrm>
           <a:prstGeom prst="rect">
@@ -17159,166 +18640,123 @@
           <a:p>
             <a:pPr algn="l">
               <a:spcAft>
-                <a:spcPts val="400"/>
+                <a:spcPts val="1300"/>
               </a:spcAft>
             </a:pPr>
             <a:r>
-              <a:rPr sz="1200" b="0">
-                <a:solidFill>
-                  <a:srgbClr val="1E2530"/>
-                </a:solidFill>
-                <a:latin typeface="Calibri"/>
-              </a:rPr>
-              <a:t/>
-            </a:r>
-            <a:r>
-              <a:rPr sz="1200" b="0">
+              <a:rPr sz="1300" b="0">
                 <a:solidFill>
                   <a:srgbClr val="F58220"/>
                 </a:solidFill>
                 <a:latin typeface="Calibri"/>
               </a:rPr>
-              <a:t>▪ </a:t>
-            </a:r>
-            <a:r>
-              <a:rPr sz="1200" b="1">
+              <a:t>▪  </a:t>
+            </a:r>
+            <a:r>
+              <a:rPr sz="1300" b="1">
                 <a:solidFill>
                   <a:srgbClr val="0B2A5B"/>
                 </a:solidFill>
                 <a:latin typeface="Calibri"/>
               </a:rPr>
-              <a:t>NCIIPC, a unit of NTRO </a:t>
-            </a:r>
-            <a:r>
-              <a:rPr sz="1200" b="0">
-                <a:solidFill>
-                  <a:srgbClr val="1E2530"/>
-                </a:solidFill>
-                <a:latin typeface="Calibri"/>
-              </a:rPr>
-              <a:t>(IT Act 2000, Section 70A): protects Critical Information Infrastructure · </a:t>
-            </a:r>
-            <a:r>
-              <a:rPr sz="1200" b="0">
+              <a:t>NCIIPC, NTRO</a:t>
+            </a:r>
+            <a:r>
+              <a:rPr sz="1300" b="0">
+                <a:solidFill>
+                  <a:srgbClr val="5F6B7A"/>
+                </a:solidFill>
+                <a:latin typeface="Calibri"/>
+              </a:rPr>
+              <a:t>  —  IT Act Sec. 70A</a:t>
+            </a:r>
+            <a:r>
+              <a:rPr sz="1300" b="0">
                 <a:solidFill>
                   <a:srgbClr val="1F5FBF"/>
                 </a:solidFill>
                 <a:latin typeface="Calibri"/>
                 <a:hlinkClick r:id="rId9"/>
               </a:rPr>
-              <a:t>nciipc.gov.in</a:t>
+              <a:t>  ·  nciipc.gov.in</a:t>
             </a:r>
           </a:p>
           <a:p>
             <a:pPr>
               <a:spcAft>
-                <a:spcPts val="400"/>
+                <a:spcPts val="1300"/>
               </a:spcAft>
             </a:pPr>
             <a:r>
-              <a:rPr sz="1200" b="0">
+              <a:rPr sz="1300" b="0">
                 <a:solidFill>
                   <a:srgbClr val="F58220"/>
                 </a:solidFill>
                 <a:latin typeface="Calibri"/>
               </a:rPr>
-              <a:t>▪ </a:t>
-            </a:r>
-            <a:r>
-              <a:rPr sz="1200" b="1">
+              <a:t>▪  </a:t>
+            </a:r>
+            <a:r>
+              <a:rPr sz="1300" b="1">
                 <a:solidFill>
                   <a:srgbClr val="0B2A5B"/>
                 </a:solidFill>
                 <a:latin typeface="Calibri"/>
               </a:rPr>
-              <a:t>NCIIPC guidelines </a:t>
-            </a:r>
-            <a:r>
-              <a:rPr sz="1200" b="0">
-                <a:solidFill>
-                  <a:srgbClr val="1E2530"/>
-                </a:solidFill>
-                <a:latin typeface="Calibri"/>
-              </a:rPr>
-              <a:t>for protecting Critical Information Infrastructure</a:t>
+              <a:t>CERT-In Directions 2022</a:t>
+            </a:r>
+            <a:r>
+              <a:rPr sz="1300" b="0">
+                <a:solidFill>
+                  <a:srgbClr val="5F6B7A"/>
+                </a:solidFill>
+                <a:latin typeface="Calibri"/>
+              </a:rPr>
+              <a:t>  —  keep logs 180 days</a:t>
+            </a:r>
+            <a:r>
+              <a:rPr sz="1300" b="0">
+                <a:solidFill>
+                  <a:srgbClr val="1F5FBF"/>
+                </a:solidFill>
+                <a:latin typeface="Calibri"/>
+                <a:hlinkClick r:id="rId3"/>
+              </a:rPr>
+              <a:t>  ·  cert-in.org.in</a:t>
             </a:r>
           </a:p>
           <a:p>
             <a:pPr>
               <a:spcAft>
-                <a:spcPts val="400"/>
+                <a:spcPts val="0"/>
               </a:spcAft>
             </a:pPr>
             <a:r>
-              <a:rPr sz="1200" b="0">
+              <a:rPr sz="1300" b="0">
                 <a:solidFill>
                   <a:srgbClr val="F58220"/>
                 </a:solidFill>
                 <a:latin typeface="Calibri"/>
               </a:rPr>
-              <a:t>▪ </a:t>
-            </a:r>
-            <a:r>
-              <a:rPr sz="1200" b="1">
+              <a:t>▪  </a:t>
+            </a:r>
+            <a:r>
+              <a:rPr sz="1300" b="1">
                 <a:solidFill>
                   <a:srgbClr val="0B2A5B"/>
                 </a:solidFill>
                 <a:latin typeface="Calibri"/>
               </a:rPr>
-              <a:t>CERT-In Directions, 28 Apr 2022: </a:t>
-            </a:r>
-            <a:r>
-              <a:rPr sz="1200" b="0">
-                <a:solidFill>
-                  <a:srgbClr val="1E2530"/>
-                </a:solidFill>
-                <a:latin typeface="Calibri"/>
-              </a:rPr>
-              <a:t>keep 180 days of logs · </a:t>
-            </a:r>
-            <a:r>
-              <a:rPr sz="1200" b="0">
-                <a:solidFill>
-                  <a:srgbClr val="1F5FBF"/>
-                </a:solidFill>
-                <a:latin typeface="Calibri"/>
-                <a:hlinkClick r:id="rId3"/>
-              </a:rPr>
-              <a:t>cert-in.org.in</a:t>
-            </a:r>
-          </a:p>
-          <a:p>
-            <a:pPr>
-              <a:spcAft>
-                <a:spcPts val="400"/>
-              </a:spcAft>
-            </a:pPr>
-            <a:r>
-              <a:rPr sz="1200" b="0">
-                <a:solidFill>
-                  <a:srgbClr val="F58220"/>
-                </a:solidFill>
-                <a:latin typeface="Calibri"/>
-              </a:rPr>
-              <a:t>▪ </a:t>
-            </a:r>
-            <a:r>
-              <a:rPr sz="1200" b="1">
-                <a:solidFill>
-                  <a:srgbClr val="0B2A5B"/>
-                </a:solidFill>
-                <a:latin typeface="Calibri"/>
-              </a:rPr>
-              <a:t>Digital Personal Data Protection Act, 2023 </a:t>
-            </a:r>
-            <a:r>
-              <a:rPr sz="1200" b="0">
-                <a:solidFill>
-                  <a:srgbClr val="1E2530"/>
-                </a:solidFill>
-                <a:latin typeface="Calibri"/>
-              </a:rPr>
-              <a:t>(Govt. of India)</a:t>
+              <a:t>DPDP Act 2023</a:t>
+            </a:r>
+            <a:r>
+              <a:rPr sz="1300" b="0">
+                <a:solidFill>
+                  <a:srgbClr val="5F6B7A"/>
+                </a:solidFill>
+                <a:latin typeface="Calibri"/>
+              </a:rPr>
+              <a:t>  —  Govt. of India</a:t>
             </a:r>
           </a:p>
         </p:txBody>
@@ -17462,7 +18900,7 @@
         </p:nvSpPr>
         <p:spPr>
           <a:xfrm>
-            <a:off x="566928" y="5312664"/>
+            <a:off x="566928" y="5376672"/>
             <a:ext cx="6995160" cy="987552"/>
           </a:xfrm>
           <a:prstGeom prst="rect">
@@ -17478,122 +18916,95 @@
           <a:p>
             <a:pPr algn="l">
               <a:spcAft>
-                <a:spcPts val="400"/>
+                <a:spcPts val="800"/>
               </a:spcAft>
             </a:pPr>
             <a:r>
-              <a:rPr sz="1200" b="0">
-                <a:solidFill>
-                  <a:srgbClr val="1E2530"/>
-                </a:solidFill>
-                <a:latin typeface="Calibri"/>
-              </a:rPr>
-              <a:t/>
-            </a:r>
-            <a:r>
-              <a:rPr sz="1200" b="0">
+              <a:rPr sz="1300" b="0">
                 <a:solidFill>
                   <a:srgbClr val="138A36"/>
                 </a:solidFill>
                 <a:latin typeface="Calibri"/>
               </a:rPr>
-              <a:t>▪ </a:t>
-            </a:r>
-            <a:r>
-              <a:rPr sz="1200" b="1">
+              <a:t>▪  </a:t>
+            </a:r>
+            <a:r>
+              <a:rPr sz="1300" b="1">
                 <a:solidFill>
                   <a:srgbClr val="0B2A5B"/>
                 </a:solidFill>
                 <a:latin typeface="Calibri"/>
               </a:rPr>
-              <a:t>Log standards: </a:t>
-            </a:r>
-            <a:r>
-              <a:rPr sz="1200" b="0">
-                <a:solidFill>
-                  <a:srgbClr val="1E2530"/>
-                </a:solidFill>
-                <a:latin typeface="Calibri"/>
-              </a:rPr>
-              <a:t>Syslog (RFC 5424 / 3164), CEF, ISO 8601 timestamps</a:t>
+              <a:t>Syslog (RFC 5424) · ISO 8601 time format</a:t>
             </a:r>
           </a:p>
           <a:p>
             <a:pPr>
               <a:spcAft>
-                <a:spcPts val="400"/>
+                <a:spcPts val="800"/>
               </a:spcAft>
             </a:pPr>
             <a:r>
-              <a:rPr sz="1200" b="0">
+              <a:rPr sz="1300" b="0">
                 <a:solidFill>
                   <a:srgbClr val="138A36"/>
                 </a:solidFill>
                 <a:latin typeface="Calibri"/>
               </a:rPr>
-              <a:t>▪ </a:t>
-            </a:r>
-            <a:r>
-              <a:rPr sz="1200" b="1">
+              <a:t>▪  </a:t>
+            </a:r>
+            <a:r>
+              <a:rPr sz="1300" b="1">
                 <a:solidFill>
                   <a:srgbClr val="0B2A5B"/>
                 </a:solidFill>
                 <a:latin typeface="Calibri"/>
               </a:rPr>
-              <a:t>Drain3 library: </a:t>
-            </a:r>
-            <a:r>
-              <a:rPr sz="1200" b="0">
-                <a:solidFill>
-                  <a:srgbClr val="1E2530"/>
-                </a:solidFill>
-                <a:latin typeface="Calibri"/>
-              </a:rPr>
-              <a:t/>
-            </a:r>
-            <a:r>
-              <a:rPr sz="1200" b="0">
+              <a:t>Drain3 library</a:t>
+            </a:r>
+            <a:r>
+              <a:rPr sz="1300" b="0">
                 <a:solidFill>
                   <a:srgbClr val="1F5FBF"/>
                 </a:solidFill>
                 <a:latin typeface="Calibri"/>
                 <a:hlinkClick r:id="rId4"/>
               </a:rPr>
-              <a:t>github.com/logpai/Drain3</a:t>
+              <a:t>  ·  github.com/logpai/Drain3</a:t>
             </a:r>
           </a:p>
           <a:p>
             <a:pPr>
               <a:spcAft>
-                <a:spcPts val="400"/>
+                <a:spcPts val="0"/>
               </a:spcAft>
             </a:pPr>
             <a:r>
-              <a:rPr sz="1200" b="0">
+              <a:rPr sz="1300" b="0">
                 <a:solidFill>
                   <a:srgbClr val="138A36"/>
                 </a:solidFill>
                 <a:latin typeface="Calibri"/>
               </a:rPr>
-              <a:t>▪ </a:t>
-            </a:r>
-            <a:r>
-              <a:rPr sz="1200" b="1">
+              <a:t>▪  </a:t>
+            </a:r>
+            <a:r>
+              <a:rPr sz="1300" b="1">
                 <a:solidFill>
                   <a:srgbClr val="0B2A5B"/>
                 </a:solidFill>
                 <a:latin typeface="Calibri"/>
               </a:rPr>
-              <a:t>Existing tools studied: </a:t>
-            </a:r>
-            <a:r>
-              <a:rPr sz="1200" b="0">
-                <a:solidFill>
-                  <a:srgbClr val="1E2530"/>
-                </a:solidFill>
-                <a:latin typeface="Calibri"/>
-              </a:rPr>
-              <a:t>Logstash, Fluentd and paid SIEMs; all need manual setup per log source</a:t>
+              <a:t>Scikit-learn</a:t>
+            </a:r>
+            <a:r>
+              <a:rPr sz="1300" b="0">
+                <a:solidFill>
+                  <a:srgbClr val="5F6B7A"/>
+                </a:solidFill>
+                <a:latin typeface="Calibri"/>
+              </a:rPr>
+              <a:t>  —  Pedregosa et al., JMLR 2011</a:t>
             </a:r>
           </a:p>
         </p:txBody>
@@ -17829,7 +19240,7 @@
               <a:t/>
             </a:r>
             <a:r>
-              <a:rPr sz="1050" b="1">
+              <a:rPr sz="900" b="1">
                 <a:solidFill>
                   <a:srgbClr val="FFFFFF"/>
                 </a:solidFill>
@@ -17958,8 +19369,8 @@
         </p:nvSpPr>
         <p:spPr>
           <a:xfrm>
-            <a:off x="9902952" y="3794760"/>
-            <a:ext cx="1874519" cy="457200"/>
+            <a:off x="9811512" y="3794760"/>
+            <a:ext cx="2057400" cy="457200"/>
           </a:xfrm>
           <a:prstGeom prst="rect">
             <a:avLst/>
@@ -17987,7 +19398,7 @@
               <a:t/>
             </a:r>
             <a:r>
-              <a:rPr sz="950" b="1">
+              <a:rPr sz="900" b="1">
                 <a:solidFill>
                   <a:srgbClr val="FFFFFF"/>
                 </a:solidFill>

</xml_diff>

<commit_message>
PPT slide 5: more descriptive impact, benefits and chart captions
Co-authored-by: arena-agent <297053741+arena-agent@users.noreply.github.com>
</commit_message>
<xml_diff>
--- a/presentation/SIH2026_Idea_Submission.pptx
+++ b/presentation/SIH2026_Idea_Submission.pptx
@@ -1213,6 +1213,496 @@
 </file>
 
 <file path=ppt/charts/chart13.xml><?xml version="1.0" encoding="utf-8"?>
+<c:chartSpace xmlns:c="http://schemas.openxmlformats.org/drawingml/2006/chart" xmlns:a="http://schemas.openxmlformats.org/drawingml/2006/main" xmlns:r="http://schemas.openxmlformats.org/officeDocument/2006/relationships">
+  <c:date1904 val="0"/>
+  <c:roundedCorners val="0"/>
+  <c:chart>
+    <c:autoTitleDeleted val="1"/>
+    <c:plotArea>
+      <c:layout/>
+      <c:doughnutChart>
+        <c:varyColors val="1"/>
+        <c:ser>
+          <c:idx val="0"/>
+          <c:order val="0"/>
+          <c:tx>
+            <c:strRef>
+              <c:f>Sheet1!$B$1</c:f>
+              <c:strCache>
+                <c:ptCount val="1"/>
+                <c:pt idx="0">
+                  <c:v>x</c:v>
+                </c:pt>
+              </c:strCache>
+            </c:strRef>
+          </c:tx>
+          <c:dPt>
+            <c:idx val="0"/>
+            <c:spPr>
+              <a:solidFill>
+                <a:srgbClr val="F58220"/>
+              </a:solidFill>
+              <a:ln>
+                <a:solidFill>
+                  <a:srgbClr val="FFFFFF"/>
+                </a:solidFill>
+              </a:ln>
+            </c:spPr>
+          </c:dPt>
+          <c:dPt>
+            <c:idx val="1"/>
+            <c:spPr>
+              <a:solidFill>
+                <a:srgbClr val="E8F5EC"/>
+              </a:solidFill>
+              <a:ln>
+                <a:solidFill>
+                  <a:srgbClr val="FFFFFF"/>
+                </a:solidFill>
+              </a:ln>
+            </c:spPr>
+          </c:dPt>
+          <c:cat>
+            <c:strRef>
+              <c:f>Sheet1!$A$2:$A$3</c:f>
+              <c:strCache>
+                <c:ptCount val="2"/>
+                <c:pt idx="0">
+                  <c:v>0</c:v>
+                </c:pt>
+                <c:pt idx="1">
+                  <c:v>1</c:v>
+                </c:pt>
+              </c:strCache>
+            </c:strRef>
+          </c:cat>
+          <c:val>
+            <c:numRef>
+              <c:f>Sheet1!$B$2:$B$3</c:f>
+              <c:numCache>
+                <c:formatCode>General</c:formatCode>
+                <c:ptCount val="2"/>
+                <c:pt idx="0">
+                  <c:v>0.5</c:v>
+                </c:pt>
+                <c:pt idx="1">
+                  <c:v>99.5</c:v>
+                </c:pt>
+              </c:numCache>
+            </c:numRef>
+          </c:val>
+        </c:ser>
+        <c:dLbls>
+          <c:showLegendKey val="0"/>
+          <c:showVal val="0"/>
+          <c:showCatName val="0"/>
+          <c:showSerName val="0"/>
+          <c:showPercent val="0"/>
+          <c:showBubbleSize val="0"/>
+          <c:showLeaderLines val="1"/>
+        </c:dLbls>
+        <c:firstSliceAng val="0"/>
+        <c:holeSize val="62"/>
+      </c:doughnutChart>
+    </c:plotArea>
+    <c:plotVisOnly val="1"/>
+    <c:dispBlanksAs val="gap"/>
+    <c:showDLblsOverMax val="0"/>
+  </c:chart>
+  <c:spPr>
+    <a:noFill/>
+    <a:ln>
+      <a:noFill/>
+    </a:ln>
+  </c:spPr>
+  <c:txPr>
+    <a:bodyPr/>
+    <a:lstStyle/>
+    <a:p>
+      <a:pPr>
+        <a:defRPr sz="1800"/>
+      </a:pPr>
+      <a:endParaRPr/>
+    </a:p>
+  </c:txPr>
+  <c:externalData r:id="rId1">
+    <c:autoUpdate val="0"/>
+  </c:externalData>
+</c:chartSpace>
+</file>
+
+<file path=ppt/charts/chart14.xml><?xml version="1.0" encoding="utf-8"?>
+<c:chartSpace xmlns:c="http://schemas.openxmlformats.org/drawingml/2006/chart" xmlns:a="http://schemas.openxmlformats.org/drawingml/2006/main" xmlns:r="http://schemas.openxmlformats.org/officeDocument/2006/relationships">
+  <c:date1904 val="0"/>
+  <c:chart>
+    <c:autoTitleDeleted val="1"/>
+    <c:plotArea>
+      <c:barChart>
+        <c:barDir val="bar"/>
+        <c:grouping val="clustered"/>
+        <c:ser>
+          <c:idx val="0"/>
+          <c:order val="0"/>
+          <c:tx>
+            <c:strRef>
+              <c:f>Sheet1!$B$1</c:f>
+              <c:strCache>
+                <c:ptCount val="1"/>
+                <c:pt idx="0">
+                  <c:v>x</c:v>
+                </c:pt>
+              </c:strCache>
+            </c:strRef>
+          </c:tx>
+          <c:dPt>
+            <c:idx val="0"/>
+            <c:spPr>
+              <a:solidFill>
+                <a:srgbClr val="7F8C8D"/>
+              </a:solidFill>
+            </c:spPr>
+          </c:dPt>
+          <c:dPt>
+            <c:idx val="1"/>
+            <c:spPr>
+              <a:solidFill>
+                <a:srgbClr val="C0392B"/>
+              </a:solidFill>
+            </c:spPr>
+          </c:dPt>
+          <c:dPt>
+            <c:idx val="2"/>
+            <c:spPr>
+              <a:solidFill>
+                <a:srgbClr val="138A36"/>
+              </a:solidFill>
+            </c:spPr>
+          </c:dPt>
+          <c:dLbls>
+            <c:dLbl>
+              <c:idx val="0"/>
+              <c:tx>
+                <c:rich>
+                  <a:bodyPr/>
+                  <a:lstStyle/>
+                  <a:p>
+                    <a:r>
+                      <a:rPr sz="1200" b="1">
+                        <a:solidFill>
+                          <a:srgbClr val="7F8C8D"/>
+                        </a:solidFill>
+                      </a:rPr>
+                      <a:t>5× costlier</a:t>
+                    </a:r>
+                  </a:p>
+                </c:rich>
+              </c:tx>
+              <c:dLblPos val="outEnd"/>
+              <c:showLegendKey val="0"/>
+              <c:showVal val="1"/>
+              <c:showCatName val="0"/>
+              <c:showSerName val="0"/>
+              <c:showPercent val="0"/>
+              <c:showBubbleSize val="0"/>
+            </c:dLbl>
+            <c:dLbl>
+              <c:idx val="1"/>
+              <c:tx>
+                <c:rich>
+                  <a:bodyPr/>
+                  <a:lstStyle/>
+                  <a:p>
+                    <a:r>
+                      <a:rPr sz="1200" b="1">
+                        <a:solidFill>
+                          <a:srgbClr val="C0392B"/>
+                        </a:solidFill>
+                      </a:rPr>
+                      <a:t>80× costlier</a:t>
+                    </a:r>
+                  </a:p>
+                </c:rich>
+              </c:tx>
+              <c:dLblPos val="outEnd"/>
+              <c:showLegendKey val="0"/>
+              <c:showVal val="1"/>
+              <c:showCatName val="0"/>
+              <c:showSerName val="0"/>
+              <c:showPercent val="0"/>
+              <c:showBubbleSize val="0"/>
+            </c:dLbl>
+            <c:dLbl>
+              <c:idx val="2"/>
+              <c:tx>
+                <c:rich>
+                  <a:bodyPr/>
+                  <a:lstStyle/>
+                  <a:p>
+                    <a:r>
+                      <a:rPr sz="1200" b="1">
+                        <a:solidFill>
+                          <a:srgbClr val="138A36"/>
+                        </a:solidFill>
+                      </a:rPr>
+                      <a:t>1×  lowest</a:t>
+                    </a:r>
+                  </a:p>
+                </c:rich>
+              </c:tx>
+              <c:dLblPos val="outEnd"/>
+              <c:showLegendKey val="0"/>
+              <c:showVal val="1"/>
+              <c:showCatName val="0"/>
+              <c:showSerName val="0"/>
+              <c:showPercent val="0"/>
+              <c:showBubbleSize val="0"/>
+            </c:dLbl>
+            <c:showLegendKey val="0"/>
+            <c:showVal val="0"/>
+            <c:showCatName val="0"/>
+            <c:showSerName val="0"/>
+            <c:showPercent val="0"/>
+            <c:showBubbleSize val="0"/>
+            <c:showLeaderLines val="1"/>
+          </c:dLbls>
+          <c:cat>
+            <c:strRef>
+              <c:f>Sheet1!$A$2:$A$4</c:f>
+              <c:strCache>
+                <c:ptCount val="3"/>
+                <c:pt idx="0">
+                  <c:v>Manual era</c:v>
+                </c:pt>
+                <c:pt idx="1">
+                  <c:v>AI on every line</c:v>
+                </c:pt>
+                <c:pt idx="2">
+                  <c:v>Our solution</c:v>
+                </c:pt>
+              </c:strCache>
+            </c:strRef>
+          </c:cat>
+          <c:val>
+            <c:numRef>
+              <c:f>Sheet1!$B$2:$B$4</c:f>
+              <c:numCache>
+                <c:formatCode>General</c:formatCode>
+                <c:ptCount val="3"/>
+                <c:pt idx="0">
+                  <c:v>5</c:v>
+                </c:pt>
+                <c:pt idx="1">
+                  <c:v>80</c:v>
+                </c:pt>
+                <c:pt idx="2">
+                  <c:v>1</c:v>
+                </c:pt>
+              </c:numCache>
+            </c:numRef>
+          </c:val>
+        </c:ser>
+        <c:gapWidth val="55"/>
+        <c:axId val="-2068027336"/>
+        <c:axId val="-2113994440"/>
+      </c:barChart>
+      <c:catAx>
+        <c:axId val="-2068027336"/>
+        <c:scaling>
+          <c:orientation val="maxMin"/>
+        </c:scaling>
+        <c:delete val="0"/>
+        <c:axPos val="l"/>
+        <c:majorTickMark val="out"/>
+        <c:minorTickMark val="none"/>
+        <c:tickLblPos val="nextTo"/>
+        <c:spPr>
+          <a:ln>
+            <a:solidFill>
+              <a:srgbClr val="D3DBE8"/>
+            </a:solidFill>
+          </a:ln>
+        </c:spPr>
+        <c:txPr>
+          <a:bodyPr/>
+          <a:lstStyle/>
+          <a:p>
+            <a:pPr>
+              <a:defRPr b="1">
+                <a:solidFill>
+                  <a:srgbClr val="0B2A5B"/>
+                </a:solidFill>
+              </a:defRPr>
+            </a:pPr>
+          </a:p>
+        </c:txPr>
+        <c:crossAx val="-2113994440"/>
+        <c:crosses val="autoZero"/>
+        <c:auto val="1"/>
+        <c:lblAlgn val="ctr"/>
+        <c:lblOffset val="100"/>
+        <c:noMultiLvlLbl val="0"/>
+      </c:catAx>
+      <c:valAx>
+        <c:axId val="-2113994440"/>
+        <c:scaling>
+          <c:max val="118.0"/>
+          <c:min val="0.0"/>
+        </c:scaling>
+        <c:delete/>
+        <c:axPos val="b"/>
+        <c:majorTickMark val="out"/>
+        <c:minorTickMark val="none"/>
+        <c:tickLblPos val="nextTo"/>
+        <c:crossAx val="-2068027336"/>
+        <c:crosses val="autoZero"/>
+      </c:valAx>
+    </c:plotArea>
+    <c:dispBlanksAs val="gap"/>
+  </c:chart>
+  <c:spPr>
+    <a:noFill/>
+    <a:ln>
+      <a:noFill/>
+    </a:ln>
+  </c:spPr>
+  <c:txPr>
+    <a:bodyPr/>
+    <a:lstStyle/>
+    <a:p>
+      <a:pPr>
+        <a:defRPr sz="1100">
+          <a:latin typeface="Calibri"/>
+        </a:defRPr>
+      </a:pPr>
+      <a:endParaRPr lang="en-US"/>
+    </a:p>
+  </c:txPr>
+  <c:externalData r:id="rId1">
+    <c:autoUpdate val="0"/>
+  </c:externalData>
+</c:chartSpace>
+</file>
+
+<file path=ppt/charts/chart15.xml><?xml version="1.0" encoding="utf-8"?>
+<c:chartSpace xmlns:c="http://schemas.openxmlformats.org/drawingml/2006/chart" xmlns:a="http://schemas.openxmlformats.org/drawingml/2006/main" xmlns:r="http://schemas.openxmlformats.org/officeDocument/2006/relationships">
+  <c:date1904 val="0"/>
+  <c:roundedCorners val="0"/>
+  <c:chart>
+    <c:autoTitleDeleted val="1"/>
+    <c:plotArea>
+      <c:layout/>
+      <c:doughnutChart>
+        <c:varyColors val="1"/>
+        <c:ser>
+          <c:idx val="0"/>
+          <c:order val="0"/>
+          <c:tx>
+            <c:strRef>
+              <c:f>Sheet1!$B$1</c:f>
+              <c:strCache>
+                <c:ptCount val="1"/>
+                <c:pt idx="0">
+                  <c:v>x</c:v>
+                </c:pt>
+              </c:strCache>
+            </c:strRef>
+          </c:tx>
+          <c:dPt>
+            <c:idx val="0"/>
+            <c:spPr>
+              <a:solidFill>
+                <a:srgbClr val="C0392B"/>
+              </a:solidFill>
+              <a:ln>
+                <a:solidFill>
+                  <a:srgbClr val="FFFFFF"/>
+                </a:solidFill>
+              </a:ln>
+            </c:spPr>
+          </c:dPt>
+          <c:dPt>
+            <c:idx val="1"/>
+            <c:spPr>
+              <a:solidFill>
+                <a:srgbClr val="FDECEA"/>
+              </a:solidFill>
+              <a:ln>
+                <a:solidFill>
+                  <a:srgbClr val="FFFFFF"/>
+                </a:solidFill>
+              </a:ln>
+            </c:spPr>
+          </c:dPt>
+          <c:cat>
+            <c:strRef>
+              <c:f>Sheet1!$A$2:$A$3</c:f>
+              <c:strCache>
+                <c:ptCount val="2"/>
+                <c:pt idx="0">
+                  <c:v>0</c:v>
+                </c:pt>
+                <c:pt idx="1">
+                  <c:v>1</c:v>
+                </c:pt>
+              </c:strCache>
+            </c:strRef>
+          </c:cat>
+          <c:val>
+            <c:numRef>
+              <c:f>Sheet1!$B$2:$B$3</c:f>
+              <c:numCache>
+                <c:formatCode>General</c:formatCode>
+                <c:ptCount val="2"/>
+                <c:pt idx="0">
+                  <c:v>100</c:v>
+                </c:pt>
+                <c:pt idx="1">
+                  <c:v>0</c:v>
+                </c:pt>
+              </c:numCache>
+            </c:numRef>
+          </c:val>
+        </c:ser>
+        <c:dLbls>
+          <c:showLegendKey val="0"/>
+          <c:showVal val="0"/>
+          <c:showCatName val="0"/>
+          <c:showSerName val="0"/>
+          <c:showPercent val="0"/>
+          <c:showBubbleSize val="0"/>
+          <c:showLeaderLines val="1"/>
+        </c:dLbls>
+        <c:firstSliceAng val="0"/>
+        <c:holeSize val="62"/>
+      </c:doughnutChart>
+    </c:plotArea>
+    <c:plotVisOnly val="1"/>
+    <c:dispBlanksAs val="gap"/>
+    <c:showDLblsOverMax val="0"/>
+  </c:chart>
+  <c:spPr>
+    <a:noFill/>
+    <a:ln>
+      <a:noFill/>
+    </a:ln>
+  </c:spPr>
+  <c:txPr>
+    <a:bodyPr/>
+    <a:lstStyle/>
+    <a:p>
+      <a:pPr>
+        <a:defRPr sz="1800"/>
+      </a:pPr>
+      <a:endParaRPr/>
+    </a:p>
+  </c:txPr>
+  <c:externalData r:id="rId1">
+    <c:autoUpdate val="0"/>
+  </c:externalData>
+</c:chartSpace>
+</file>
+
+<file path=ppt/charts/chart16.xml><?xml version="1.0" encoding="utf-8"?>
 <c:chartSpace xmlns:c="http://schemas.openxmlformats.org/drawingml/2006/chart" xmlns:a="http://schemas.openxmlformats.org/drawingml/2006/main" xmlns:r="http://schemas.openxmlformats.org/officeDocument/2006/relationships">
   <c:date1904 val="0"/>
   <c:roundedCorners val="0"/>
@@ -16109,8 +16599,8 @@
         </p:nvSpPr>
         <p:spPr>
           <a:xfrm>
-            <a:off x="365760" y="1097280"/>
-            <a:ext cx="5669280" cy="329184"/>
+            <a:off x="365760" y="1051560"/>
+            <a:ext cx="5669280" cy="310896"/>
           </a:xfrm>
           <a:prstGeom prst="rect">
             <a:avLst/>
@@ -16133,6 +16623,15 @@
               </a:rPr>
               <a:t>Impact on NTRO &amp; NCIIPC</a:t>
             </a:r>
+            <a:r>
+              <a:rPr sz="1200" b="0">
+                <a:solidFill>
+                  <a:srgbClr val="5F6B7A"/>
+                </a:solidFill>
+                <a:latin typeface="Calibri"/>
+              </a:rPr>
+              <a:t>   our target users</a:t>
+            </a:r>
           </a:p>
         </p:txBody>
       </p:sp>
@@ -16144,7 +16643,7 @@
         </p:nvSpPr>
         <p:spPr>
           <a:xfrm>
-            <a:off x="402336" y="1435608"/>
+            <a:off x="402336" y="1371600"/>
             <a:ext cx="822960" cy="45720"/>
           </a:xfrm>
           <a:prstGeom prst="rect">
@@ -16188,8 +16687,8 @@
         </p:nvSpPr>
         <p:spPr>
           <a:xfrm>
-            <a:off x="365760" y="1627632"/>
-            <a:ext cx="73152" cy="384048"/>
+            <a:off x="365760" y="1572768"/>
+            <a:ext cx="64008" cy="457200"/>
           </a:xfrm>
           <a:prstGeom prst="rect">
             <a:avLst/>
@@ -16232,8 +16731,8 @@
         </p:nvSpPr>
         <p:spPr>
           <a:xfrm>
-            <a:off x="530352" y="1609344"/>
-            <a:ext cx="5486400" cy="420624"/>
+            <a:off x="502920" y="1554480"/>
+            <a:ext cx="5577840" cy="512064"/>
           </a:xfrm>
           <a:prstGeom prst="rect">
             <a:avLst/>
@@ -16248,22 +16747,22 @@
           <a:p>
             <a:pPr algn="l"/>
             <a:r>
-              <a:rPr sz="1250" b="1">
+              <a:rPr sz="1150" b="1">
                 <a:solidFill>
                   <a:srgbClr val="1F5FBF"/>
                 </a:solidFill>
                 <a:latin typeface="Calibri"/>
               </a:rPr>
-              <a:t>One view of all sectors</a:t>
-            </a:r>
-            <a:r>
-              <a:rPr sz="1250" b="0">
+              <a:t>One view of all sectors: </a:t>
+            </a:r>
+            <a:r>
+              <a:rPr sz="1150" b="0">
                 <a:solidFill>
                   <a:srgbClr val="1E2530"/>
                 </a:solidFill>
                 <a:latin typeface="Calibri"/>
               </a:rPr>
-              <a:t>  —  power, banking, telecom &amp; govt</a:t>
+              <a:t>logs from power, banking, telecom &amp; govt security centres arrive in one common format, so NCIIPC sees the full picture.</a:t>
             </a:r>
           </a:p>
         </p:txBody>
@@ -16276,8 +16775,8 @@
         </p:nvSpPr>
         <p:spPr>
           <a:xfrm>
-            <a:off x="365760" y="2103120"/>
-            <a:ext cx="73152" cy="384048"/>
+            <a:off x="365760" y="2139696"/>
+            <a:ext cx="64008" cy="457200"/>
           </a:xfrm>
           <a:prstGeom prst="rect">
             <a:avLst/>
@@ -16320,8 +16819,8 @@
         </p:nvSpPr>
         <p:spPr>
           <a:xfrm>
-            <a:off x="530352" y="2084832"/>
-            <a:ext cx="5486400" cy="420624"/>
+            <a:off x="502920" y="2121408"/>
+            <a:ext cx="5577840" cy="512064"/>
           </a:xfrm>
           <a:prstGeom prst="rect">
             <a:avLst/>
@@ -16336,22 +16835,22 @@
           <a:p>
             <a:pPr algn="l"/>
             <a:r>
-              <a:rPr sz="1250" b="1">
+              <a:rPr sz="1150" b="1">
                 <a:solidFill>
                   <a:srgbClr val="138A36"/>
                 </a:solidFill>
                 <a:latin typeface="Calibri"/>
               </a:rPr>
-              <a:t>Faster threat detection</a:t>
-            </a:r>
-            <a:r>
-              <a:rPr sz="1250" b="0">
+              <a:t>Faster threat detection: </a:t>
+            </a:r>
+            <a:r>
+              <a:rPr sz="1150" b="0">
                 <a:solidFill>
                   <a:srgbClr val="1E2530"/>
                 </a:solidFill>
                 <a:latin typeface="Calibri"/>
               </a:rPr>
-              <a:t>  —  search one clean format, not hundreds</a:t>
+              <a:t>analysts search one clean format instead of hundreds; events from different systems line up by time.</a:t>
             </a:r>
           </a:p>
         </p:txBody>
@@ -16364,8 +16863,8 @@
         </p:nvSpPr>
         <p:spPr>
           <a:xfrm>
-            <a:off x="365760" y="2578608"/>
-            <a:ext cx="73152" cy="384048"/>
+            <a:off x="365760" y="2706624"/>
+            <a:ext cx="64008" cy="457200"/>
           </a:xfrm>
           <a:prstGeom prst="rect">
             <a:avLst/>
@@ -16408,8 +16907,8 @@
         </p:nvSpPr>
         <p:spPr>
           <a:xfrm>
-            <a:off x="530352" y="2560320"/>
-            <a:ext cx="5486400" cy="420624"/>
+            <a:off x="502920" y="2688336"/>
+            <a:ext cx="5577840" cy="512064"/>
           </a:xfrm>
           <a:prstGeom prst="rect">
             <a:avLst/>
@@ -16424,22 +16923,22 @@
           <a:p>
             <a:pPr algn="l"/>
             <a:r>
-              <a:rPr sz="1250" b="1">
+              <a:rPr sz="1150" b="1">
                 <a:solidFill>
                   <a:srgbClr val="F58220"/>
                 </a:solidFill>
                 <a:latin typeface="Calibri"/>
               </a:rPr>
-              <a:t>Unusual logs flagged</a:t>
-            </a:r>
-            <a:r>
-              <a:rPr sz="1250" b="0">
+              <a:t>Unusual logs flagged: </a:t>
+            </a:r>
+            <a:r>
+              <a:rPr sz="1150" b="0">
                 <a:solidFill>
                   <a:srgbClr val="1E2530"/>
                 </a:solidFill>
                 <a:latin typeface="Calibri"/>
               </a:rPr>
-              <a:t>  —  new device, misconfig or tampering spotted</a:t>
+              <a:t>a never-seen log format is flagged automatically; it may be a new device, a misconfiguration or tampering.</a:t>
             </a:r>
           </a:p>
         </p:txBody>
@@ -16452,8 +16951,8 @@
         </p:nvSpPr>
         <p:spPr>
           <a:xfrm>
-            <a:off x="365760" y="3054096"/>
-            <a:ext cx="73152" cy="384048"/>
+            <a:off x="365760" y="3273552"/>
+            <a:ext cx="64008" cy="457200"/>
           </a:xfrm>
           <a:prstGeom prst="rect">
             <a:avLst/>
@@ -16496,8 +16995,8 @@
         </p:nvSpPr>
         <p:spPr>
           <a:xfrm>
-            <a:off x="530352" y="3035808"/>
-            <a:ext cx="5486400" cy="420624"/>
+            <a:off x="502920" y="3255264"/>
+            <a:ext cx="5577840" cy="512064"/>
           </a:xfrm>
           <a:prstGeom prst="rect">
             <a:avLst/>
@@ -16512,22 +17011,22 @@
           <a:p>
             <a:pPr algn="l"/>
             <a:r>
-              <a:rPr sz="1250" b="1">
+              <a:rPr sz="1150" b="1">
                 <a:solidFill>
                   <a:srgbClr val="6A3FB5"/>
                 </a:solidFill>
                 <a:latin typeface="Calibri"/>
               </a:rPr>
-              <a:t>Sovereign &amp; offline</a:t>
-            </a:r>
-            <a:r>
-              <a:rPr sz="1250" b="0">
+              <a:t>Sovereign &amp; offline: </a:t>
+            </a:r>
+            <a:r>
+              <a:rPr sz="1150" b="0">
                 <a:solidFill>
                   <a:srgbClr val="1E2530"/>
                 </a:solidFill>
                 <a:latin typeface="Calibri"/>
               </a:rPr>
-              <a:t>  —  runs on-premise; logs never leave India</a:t>
+              <a:t>runs on-premise with no internet, so sensitive logs never leave India (self-hosted AI planned).</a:t>
             </a:r>
           </a:p>
         </p:txBody>
@@ -16540,8 +17039,8 @@
         </p:nvSpPr>
         <p:spPr>
           <a:xfrm>
-            <a:off x="6263640" y="1097280"/>
-            <a:ext cx="5577840" cy="329184"/>
+            <a:off x="6263640" y="1051560"/>
+            <a:ext cx="5577840" cy="310896"/>
           </a:xfrm>
           <a:prstGeom prst="rect">
             <a:avLst/>
@@ -16575,7 +17074,7 @@
         </p:nvSpPr>
         <p:spPr>
           <a:xfrm>
-            <a:off x="6300216" y="1435608"/>
+            <a:off x="6300216" y="1371600"/>
             <a:ext cx="822960" cy="45720"/>
           </a:xfrm>
           <a:prstGeom prst="rect">
@@ -16619,8 +17118,8 @@
         </p:nvSpPr>
         <p:spPr>
           <a:xfrm>
-            <a:off x="6263640" y="1627632"/>
-            <a:ext cx="1417320" cy="384048"/>
+            <a:off x="6263640" y="1609344"/>
+            <a:ext cx="1371600" cy="402336"/>
           </a:xfrm>
           <a:prstGeom prst="roundRect">
             <a:avLst>
@@ -16650,7 +17149,7 @@
           </a:fontRef>
         </p:style>
         <p:txBody>
-          <a:bodyPr rtlCol="0" anchor="ctr" wrap="square" lIns="45720" rIns="45720" tIns="18288" bIns="18288"/>
+          <a:bodyPr rtlCol="0" anchor="ctr" wrap="square" lIns="54864" rIns="54864"/>
           <a:lstStyle/>
           <a:p>
             <a:pPr algn="ctr"/>
@@ -16674,8 +17173,8 @@
         </p:nvSpPr>
         <p:spPr>
           <a:xfrm>
-            <a:off x="7772400" y="1609344"/>
-            <a:ext cx="4114800" cy="420624"/>
+            <a:off x="7726680" y="1554480"/>
+            <a:ext cx="4160520" cy="512064"/>
           </a:xfrm>
           <a:prstGeom prst="rect">
             <a:avLst/>
@@ -16690,13 +17189,13 @@
           <a:p>
             <a:pPr algn="l"/>
             <a:r>
-              <a:rPr sz="1250" b="0">
+              <a:rPr sz="1150" b="0">
                 <a:solidFill>
                   <a:srgbClr val="1E2530"/>
                 </a:solidFill>
                 <a:latin typeface="Calibri"/>
               </a:rPr>
-              <a:t>safer power, banking &amp; telecom for citizens</a:t>
+              <a:t>Safer power, banking and telecom services for citizens, thanks to faster attack detection.</a:t>
             </a:r>
           </a:p>
         </p:txBody>
@@ -16709,8 +17208,8 @@
         </p:nvSpPr>
         <p:spPr>
           <a:xfrm>
-            <a:off x="6263640" y="2103120"/>
-            <a:ext cx="1417320" cy="384048"/>
+            <a:off x="6263640" y="2176272"/>
+            <a:ext cx="1371600" cy="402336"/>
           </a:xfrm>
           <a:prstGeom prst="roundRect">
             <a:avLst>
@@ -16740,7 +17239,7 @@
           </a:fontRef>
         </p:style>
         <p:txBody>
-          <a:bodyPr rtlCol="0" anchor="ctr" wrap="square" lIns="45720" rIns="45720" tIns="18288" bIns="18288"/>
+          <a:bodyPr rtlCol="0" anchor="ctr" wrap="square" lIns="54864" rIns="54864"/>
           <a:lstStyle/>
           <a:p>
             <a:pPr algn="ctr"/>
@@ -16764,8 +17263,8 @@
         </p:nvSpPr>
         <p:spPr>
           <a:xfrm>
-            <a:off x="7772400" y="2084832"/>
-            <a:ext cx="4114800" cy="420624"/>
+            <a:off x="7726680" y="2121408"/>
+            <a:ext cx="4160520" cy="512064"/>
           </a:xfrm>
           <a:prstGeom prst="rect">
             <a:avLst/>
@@ -16780,13 +17279,13 @@
           <a:p>
             <a:pPr algn="l"/>
             <a:r>
-              <a:rPr sz="1250" b="0">
+              <a:rPr sz="1150" b="0">
                 <a:solidFill>
                   <a:srgbClr val="1E2530"/>
                 </a:solidFill>
                 <a:latin typeface="Calibri"/>
               </a:rPr>
-              <a:t>no costly paid tools; tiny AI bill</a:t>
+              <a:t>No costly paid tools or hand-written parsers; the AI bill stays tiny even as logs grow.</a:t>
             </a:r>
           </a:p>
         </p:txBody>
@@ -16799,8 +17298,8 @@
         </p:nvSpPr>
         <p:spPr>
           <a:xfrm>
-            <a:off x="6263640" y="2578608"/>
-            <a:ext cx="1417320" cy="384048"/>
+            <a:off x="6263640" y="2743200"/>
+            <a:ext cx="1371600" cy="402336"/>
           </a:xfrm>
           <a:prstGeom prst="roundRect">
             <a:avLst>
@@ -16830,7 +17329,7 @@
           </a:fontRef>
         </p:style>
         <p:txBody>
-          <a:bodyPr rtlCol="0" anchor="ctr" wrap="square" lIns="45720" rIns="45720" tIns="18288" bIns="18288"/>
+          <a:bodyPr rtlCol="0" anchor="ctr" wrap="square" lIns="54864" rIns="54864"/>
           <a:lstStyle/>
           <a:p>
             <a:pPr algn="ctr"/>
@@ -16854,8 +17353,8 @@
         </p:nvSpPr>
         <p:spPr>
           <a:xfrm>
-            <a:off x="7772400" y="2560320"/>
-            <a:ext cx="4114800" cy="420624"/>
+            <a:off x="7726680" y="2688336"/>
+            <a:ext cx="4160520" cy="512064"/>
           </a:xfrm>
           <a:prstGeom prst="rect">
             <a:avLst/>
@@ -16870,13 +17369,13 @@
           <a:p>
             <a:pPr algn="l"/>
             <a:r>
-              <a:rPr sz="1250" b="0">
+              <a:rPr sz="1150" b="0">
                 <a:solidFill>
                   <a:srgbClr val="1E2530"/>
                 </a:solidFill>
                 <a:latin typeface="Calibri"/>
               </a:rPr>
-              <a:t>99.5% fewer AI calls = less energy</a:t>
+              <a:t>99.5% fewer AI calls means far less computing power and energy used.</a:t>
             </a:r>
           </a:p>
         </p:txBody>
@@ -16889,8 +17388,8 @@
         </p:nvSpPr>
         <p:spPr>
           <a:xfrm>
-            <a:off x="6263640" y="3054096"/>
-            <a:ext cx="1417320" cy="384048"/>
+            <a:off x="6263640" y="3310128"/>
+            <a:ext cx="1371600" cy="402336"/>
           </a:xfrm>
           <a:prstGeom prst="roundRect">
             <a:avLst>
@@ -16920,7 +17419,7 @@
           </a:fontRef>
         </p:style>
         <p:txBody>
-          <a:bodyPr rtlCol="0" anchor="ctr" wrap="square" lIns="45720" rIns="45720" tIns="18288" bIns="18288"/>
+          <a:bodyPr rtlCol="0" anchor="ctr" wrap="square" lIns="54864" rIns="54864"/>
           <a:lstStyle/>
           <a:p>
             <a:pPr algn="ctr"/>
@@ -16944,8 +17443,8 @@
         </p:nvSpPr>
         <p:spPr>
           <a:xfrm>
-            <a:off x="7772400" y="3035808"/>
-            <a:ext cx="4114800" cy="420624"/>
+            <a:off x="7726680" y="3255264"/>
+            <a:ext cx="4160520" cy="512064"/>
           </a:xfrm>
           <a:prstGeom prst="rect">
             <a:avLst/>
@@ -16960,13 +17459,13 @@
           <a:p>
             <a:pPr algn="l"/>
             <a:r>
-              <a:rPr sz="1250" b="0">
+              <a:rPr sz="1150" b="0">
                 <a:solidFill>
                   <a:srgbClr val="1E2530"/>
                 </a:solidFill>
                 <a:latin typeface="Calibri"/>
               </a:rPr>
-              <a:t>self-reliant, open-source, CERT-In ready</a:t>
+              <a:t>Self-reliant and open-source; helps every organisation meet CERT-In's 180-day log rule.</a:t>
             </a:r>
           </a:p>
         </p:txBody>
@@ -16979,8 +17478,8 @@
         </p:nvSpPr>
         <p:spPr>
           <a:xfrm>
-            <a:off x="365760" y="3611880"/>
-            <a:ext cx="11430000" cy="329184"/>
+            <a:off x="365760" y="3840480"/>
+            <a:ext cx="11430000" cy="310896"/>
           </a:xfrm>
           <a:prstGeom prst="rect">
             <a:avLst/>
@@ -17010,7 +17509,7 @@
                 </a:solidFill>
                 <a:latin typeface="Calibri"/>
               </a:rPr>
-              <a:t>   1 million logs / day in a big organisation</a:t>
+              <a:t>   a big organisation producing 1 million logs every day</a:t>
             </a:r>
           </a:p>
         </p:txBody>
@@ -17023,7 +17522,7 @@
         </p:nvSpPr>
         <p:spPr>
           <a:xfrm>
-            <a:off x="402336" y="3950208"/>
+            <a:off x="402336" y="4160520"/>
             <a:ext cx="822960" cy="45720"/>
           </a:xfrm>
           <a:prstGeom prst="rect">
@@ -17067,8 +17566,8 @@
         </p:nvSpPr>
         <p:spPr>
           <a:xfrm>
-            <a:off x="365760" y="4114800"/>
-            <a:ext cx="5669280" cy="2103120"/>
+            <a:off x="365760" y="4297680"/>
+            <a:ext cx="5669280" cy="1938528"/>
           </a:xfrm>
           <a:prstGeom prst="roundRect">
             <a:avLst>
@@ -17115,8 +17614,8 @@
         </p:nvSpPr>
         <p:spPr>
           <a:xfrm>
-            <a:off x="502920" y="4169664"/>
-            <a:ext cx="3657600" cy="274320"/>
+            <a:off x="502920" y="4343400"/>
+            <a:ext cx="3931920" cy="256032"/>
           </a:xfrm>
           <a:prstGeom prst="rect">
             <a:avLst/>
@@ -17142,34 +17641,69 @@
           </a:p>
         </p:txBody>
       </p:sp>
+      <p:sp>
+        <p:nvSpPr>
+          <p:cNvPr id="88" name="TextBox 87"/>
+          <p:cNvSpPr txBox="1"/>
+          <p:nvPr/>
+        </p:nvSpPr>
+        <p:spPr>
+          <a:xfrm>
+            <a:off x="502920" y="4572000"/>
+            <a:ext cx="3931920" cy="237744"/>
+          </a:xfrm>
+          <a:prstGeom prst="rect">
+            <a:avLst/>
+          </a:prstGeom>
+          <a:noFill/>
+        </p:spPr>
+        <p:txBody>
+          <a:bodyPr wrap="square" lIns="36576" rIns="36576" tIns="18288" bIns="18288" anchor="t">
+            <a:spAutoFit/>
+          </a:bodyPr>
+          <a:lstStyle/>
+          <a:p>
+            <a:pPr algn="l"/>
+            <a:r>
+              <a:rPr sz="1000" b="0">
+                <a:solidFill>
+                  <a:srgbClr val="5F6B7A"/>
+                </a:solidFill>
+                <a:latin typeface="Calibri"/>
+              </a:rPr>
+              <a:t>Total spend to process the logs for 12 months</a:t>
+            </a:r>
+          </a:p>
+        </p:txBody>
+      </p:sp>
       <p:graphicFrame>
         <p:nvGraphicFramePr>
-          <p:cNvPr id="88" name="Chart 87"/>
+          <p:cNvPr id="89" name="Chart 88"/>
           <p:cNvGraphicFramePr>
             <a:graphicFrameLocks noGrp="1"/>
           </p:cNvGraphicFramePr>
           <p:nvPr/>
         </p:nvGraphicFramePr>
         <p:xfrm>
-          <a:off x="457200" y="4434840"/>
-          <a:ext cx="3840480" cy="1691640"/>
+          <a:off x="457200" y="4800600"/>
+          <a:ext cx="3886200" cy="1389888"/>
         </p:xfrm>
         <a:graphic>
           <a:graphicData uri="http://schemas.openxmlformats.org/drawingml/2006/chart">
-            <c:chart xmlns:c="http://schemas.openxmlformats.org/drawingml/2006/chart" r:id="rId12"/>
+            <c:chart xmlns:c="http://schemas.openxmlformats.org/drawingml/2006/chart" r:id="rId15"/>
           </a:graphicData>
         </a:graphic>
       </p:graphicFrame>
       <p:sp>
         <p:nvSpPr>
-          <p:cNvPr id="89" name="Rounded Rectangle 88"/>
+          <p:cNvPr id="90" name="Rounded Rectangle 89"/>
           <p:cNvSpPr/>
           <p:nvPr/>
         </p:nvSpPr>
         <p:spPr>
           <a:xfrm>
-            <a:off x="4389120" y="4526280"/>
-            <a:ext cx="1508760" cy="1463040"/>
+            <a:off x="4434840" y="4617720"/>
+            <a:ext cx="1481328" cy="1481328"/>
           </a:xfrm>
           <a:prstGeom prst="roundRect">
             <a:avLst>
@@ -17199,12 +17733,12 @@
           </a:fontRef>
         </p:style>
         <p:txBody>
-          <a:bodyPr rtlCol="0" anchor="ctr" wrap="square" lIns="45720" rIns="45720" tIns="18288" bIns="18288"/>
+          <a:bodyPr rtlCol="0" anchor="ctr" wrap="square" lIns="54864" rIns="54864"/>
           <a:lstStyle/>
           <a:p>
             <a:pPr algn="ctr"/>
             <a:r>
-              <a:rPr sz="3000" b="1">
+              <a:rPr sz="2800" b="1">
                 <a:solidFill>
                   <a:srgbClr val="138A36"/>
                 </a:solidFill>
@@ -17216,39 +17750,39 @@
           <a:p>
             <a:pPr algn="ctr"/>
             <a:r>
-              <a:rPr sz="1100" b="0">
+              <a:rPr sz="1050" b="1">
                 <a:solidFill>
                   <a:srgbClr val="1E2530"/>
                 </a:solidFill>
                 <a:latin typeface="Calibri"/>
               </a:rPr>
-              <a:t>cheaper than</a:t>
+              <a:t>cheaper than AI on every line</a:t>
             </a:r>
           </a:p>
           <a:p>
             <a:pPr algn="ctr"/>
             <a:r>
-              <a:rPr sz="1100" b="1">
+              <a:rPr sz="1000" b="0">
                 <a:solidFill>
                   <a:srgbClr val="1E2530"/>
                 </a:solidFill>
                 <a:latin typeface="Calibri"/>
               </a:rPr>
-              <a:t>AI on every line</a:t>
-            </a:r>
-          </a:p>
-        </p:txBody>
-      </p:sp>
-      <p:sp>
-        <p:nvSpPr>
-          <p:cNvPr id="90" name="Rounded Rectangle 89"/>
+              <a:t>and 5× cheaper than manual</a:t>
+            </a:r>
+          </a:p>
+        </p:txBody>
+      </p:sp>
+      <p:sp>
+        <p:nvSpPr>
+          <p:cNvPr id="91" name="Rounded Rectangle 90"/>
           <p:cNvSpPr/>
           <p:nvPr/>
         </p:nvSpPr>
         <p:spPr>
           <a:xfrm>
-            <a:off x="6199632" y="4114800"/>
-            <a:ext cx="5669280" cy="2103120"/>
+            <a:off x="6199632" y="4297680"/>
+            <a:ext cx="5669280" cy="1938528"/>
           </a:xfrm>
           <a:prstGeom prst="roundRect">
             <a:avLst>
@@ -17289,14 +17823,14 @@
       </p:sp>
       <p:sp>
         <p:nvSpPr>
-          <p:cNvPr id="91" name="TextBox 90"/>
+          <p:cNvPr id="92" name="TextBox 91"/>
           <p:cNvSpPr txBox="1"/>
           <p:nvPr/>
         </p:nvSpPr>
         <p:spPr>
           <a:xfrm>
-            <a:off x="6336792" y="4169664"/>
-            <a:ext cx="3657600" cy="274320"/>
+            <a:off x="6336792" y="4343400"/>
+            <a:ext cx="3931920" cy="256032"/>
           </a:xfrm>
           <a:prstGeom prst="rect">
             <a:avLst/>
@@ -17322,34 +17856,69 @@
           </a:p>
         </p:txBody>
       </p:sp>
+      <p:sp>
+        <p:nvSpPr>
+          <p:cNvPr id="93" name="TextBox 92"/>
+          <p:cNvSpPr txBox="1"/>
+          <p:nvPr/>
+        </p:nvSpPr>
+        <p:spPr>
+          <a:xfrm>
+            <a:off x="6336792" y="4572000"/>
+            <a:ext cx="3931920" cy="237744"/>
+          </a:xfrm>
+          <a:prstGeom prst="rect">
+            <a:avLst/>
+          </a:prstGeom>
+          <a:noFill/>
+        </p:spPr>
+        <p:txBody>
+          <a:bodyPr wrap="square" lIns="36576" rIns="36576" tIns="18288" bIns="18288" anchor="t">
+            <a:spAutoFit/>
+          </a:bodyPr>
+          <a:lstStyle/>
+          <a:p>
+            <a:pPr algn="l"/>
+            <a:r>
+              <a:rPr sz="1000" b="0">
+                <a:solidFill>
+                  <a:srgbClr val="5F6B7A"/>
+                </a:solidFill>
+                <a:latin typeface="Calibri"/>
+              </a:rPr>
+              <a:t>How many log lines need a paid AI service</a:t>
+            </a:r>
+          </a:p>
+        </p:txBody>
+      </p:sp>
       <p:graphicFrame>
         <p:nvGraphicFramePr>
-          <p:cNvPr id="92" name="Chart 91"/>
+          <p:cNvPr id="94" name="Chart 93"/>
           <p:cNvGraphicFramePr>
             <a:graphicFrameLocks noGrp="1"/>
           </p:cNvGraphicFramePr>
           <p:nvPr/>
         </p:nvGraphicFramePr>
         <p:xfrm>
-          <a:off x="6446520" y="4462272"/>
-          <a:ext cx="1371600" cy="1371600"/>
+          <a:off x="6583680" y="4828032"/>
+          <a:ext cx="1115568" cy="1115568"/>
         </p:xfrm>
         <a:graphic>
           <a:graphicData uri="http://schemas.openxmlformats.org/drawingml/2006/chart">
-            <c:chart xmlns:c="http://schemas.openxmlformats.org/drawingml/2006/chart" r:id="rId13"/>
+            <c:chart xmlns:c="http://schemas.openxmlformats.org/drawingml/2006/chart" r:id="rId16"/>
           </a:graphicData>
         </a:graphic>
       </p:graphicFrame>
       <p:sp>
         <p:nvSpPr>
-          <p:cNvPr id="93" name="TextBox 92"/>
+          <p:cNvPr id="95" name="TextBox 94"/>
           <p:cNvSpPr txBox="1"/>
           <p:nvPr/>
         </p:nvSpPr>
         <p:spPr>
           <a:xfrm>
-            <a:off x="6446520" y="4928616"/>
-            <a:ext cx="1371600" cy="438912"/>
+            <a:off x="6583680" y="5184648"/>
+            <a:ext cx="1115568" cy="402336"/>
           </a:xfrm>
           <a:prstGeom prst="rect">
             <a:avLst/>
@@ -17364,7 +17933,7 @@
           <a:p>
             <a:pPr algn="ctr"/>
             <a:r>
-              <a:rPr sz="1700" b="1">
+              <a:rPr sz="1500" b="1">
                 <a:solidFill>
                   <a:srgbClr val="C0392B"/>
                 </a:solidFill>
@@ -17377,14 +17946,14 @@
       </p:sp>
       <p:sp>
         <p:nvSpPr>
-          <p:cNvPr id="94" name="TextBox 93"/>
+          <p:cNvPr id="96" name="TextBox 95"/>
           <p:cNvSpPr txBox="1"/>
           <p:nvPr/>
         </p:nvSpPr>
         <p:spPr>
           <a:xfrm>
-            <a:off x="6172200" y="5852160"/>
-            <a:ext cx="1920240" cy="274320"/>
+            <a:off x="6263640" y="5943600"/>
+            <a:ext cx="1755648" cy="256032"/>
           </a:xfrm>
           <a:prstGeom prst="rect">
             <a:avLst/>
@@ -17399,7 +17968,7 @@
           <a:p>
             <a:pPr algn="ctr"/>
             <a:r>
-              <a:rPr sz="1100" b="1">
+              <a:rPr sz="1050" b="1">
                 <a:solidFill>
                   <a:srgbClr val="C0392B"/>
                 </a:solidFill>
@@ -17412,32 +17981,32 @@
       </p:sp>
       <p:graphicFrame>
         <p:nvGraphicFramePr>
-          <p:cNvPr id="95" name="Chart 94"/>
+          <p:cNvPr id="97" name="Chart 96"/>
           <p:cNvGraphicFramePr>
             <a:graphicFrameLocks noGrp="1"/>
           </p:cNvGraphicFramePr>
           <p:nvPr/>
         </p:nvGraphicFramePr>
         <p:xfrm>
-          <a:off x="8092440" y="4462272"/>
-          <a:ext cx="1371600" cy="1371600"/>
+          <a:off x="8229600" y="4828032"/>
+          <a:ext cx="1115568" cy="1115568"/>
         </p:xfrm>
         <a:graphic>
           <a:graphicData uri="http://schemas.openxmlformats.org/drawingml/2006/chart">
-            <c:chart xmlns:c="http://schemas.openxmlformats.org/drawingml/2006/chart" r:id="rId14"/>
+            <c:chart xmlns:c="http://schemas.openxmlformats.org/drawingml/2006/chart" r:id="rId17"/>
           </a:graphicData>
         </a:graphic>
       </p:graphicFrame>
       <p:sp>
         <p:nvSpPr>
-          <p:cNvPr id="96" name="TextBox 95"/>
+          <p:cNvPr id="98" name="TextBox 97"/>
           <p:cNvSpPr txBox="1"/>
           <p:nvPr/>
         </p:nvSpPr>
         <p:spPr>
           <a:xfrm>
-            <a:off x="8092440" y="4928616"/>
-            <a:ext cx="1371600" cy="438912"/>
+            <a:off x="8229600" y="5184648"/>
+            <a:ext cx="1115568" cy="402336"/>
           </a:xfrm>
           <a:prstGeom prst="rect">
             <a:avLst/>
@@ -17452,7 +18021,7 @@
           <a:p>
             <a:pPr algn="ctr"/>
             <a:r>
-              <a:rPr sz="1700" b="1">
+              <a:rPr sz="1500" b="1">
                 <a:solidFill>
                   <a:srgbClr val="138A36"/>
                 </a:solidFill>
@@ -17465,14 +18034,14 @@
       </p:sp>
       <p:sp>
         <p:nvSpPr>
-          <p:cNvPr id="97" name="TextBox 96"/>
+          <p:cNvPr id="99" name="TextBox 98"/>
           <p:cNvSpPr txBox="1"/>
           <p:nvPr/>
         </p:nvSpPr>
         <p:spPr>
           <a:xfrm>
-            <a:off x="7818120" y="5852160"/>
-            <a:ext cx="1920240" cy="274320"/>
+            <a:off x="7909560" y="5943600"/>
+            <a:ext cx="1755648" cy="256032"/>
           </a:xfrm>
           <a:prstGeom prst="rect">
             <a:avLst/>
@@ -17487,7 +18056,7 @@
           <a:p>
             <a:pPr algn="ctr"/>
             <a:r>
-              <a:rPr sz="1100" b="1">
+              <a:rPr sz="1050" b="1">
                 <a:solidFill>
                   <a:srgbClr val="138A36"/>
                 </a:solidFill>
@@ -17500,14 +18069,14 @@
       </p:sp>
       <p:sp>
         <p:nvSpPr>
-          <p:cNvPr id="98" name="Rounded Rectangle 97"/>
+          <p:cNvPr id="100" name="Rounded Rectangle 99"/>
           <p:cNvSpPr/>
           <p:nvPr/>
         </p:nvSpPr>
         <p:spPr>
           <a:xfrm>
-            <a:off x="10195560" y="4526280"/>
-            <a:ext cx="1508760" cy="1463040"/>
+            <a:off x="10195560" y="4617720"/>
+            <a:ext cx="1554480" cy="1481328"/>
           </a:xfrm>
           <a:prstGeom prst="roundRect">
             <a:avLst>
@@ -17537,12 +18106,12 @@
           </a:fontRef>
         </p:style>
         <p:txBody>
-          <a:bodyPr rtlCol="0" anchor="ctr" wrap="square" lIns="45720" rIns="45720" tIns="18288" bIns="18288"/>
+          <a:bodyPr rtlCol="0" anchor="ctr" wrap="square" lIns="54864" rIns="54864"/>
           <a:lstStyle/>
           <a:p>
             <a:pPr algn="ctr"/>
             <a:r>
-              <a:rPr sz="2600" b="1">
+              <a:rPr sz="2400" b="1">
                 <a:solidFill>
                   <a:srgbClr val="138A36"/>
                 </a:solidFill>
@@ -17554,7 +18123,7 @@
           <a:p>
             <a:pPr algn="ctr"/>
             <a:r>
-              <a:rPr sz="1100" b="1">
+              <a:rPr sz="1050" b="1">
                 <a:solidFill>
                   <a:srgbClr val="1E2530"/>
                 </a:solidFill>
@@ -17563,11 +18132,23 @@
               <a:t>fewer AI calls</a:t>
             </a:r>
           </a:p>
-        </p:txBody>
-      </p:sp>
-      <p:sp>
-        <p:nvSpPr>
-          <p:cNvPr id="99" name="TextBox 98"/>
+          <a:p>
+            <a:pPr algn="ctr"/>
+            <a:r>
+              <a:rPr sz="950" b="0">
+                <a:solidFill>
+                  <a:srgbClr val="1E2530"/>
+                </a:solidFill>
+                <a:latin typeface="Calibri"/>
+              </a:rPr>
+              <a:t>AI learns each format once; saved rules do the rest</a:t>
+            </a:r>
+          </a:p>
+        </p:txBody>
+      </p:sp>
+      <p:sp>
+        <p:nvSpPr>
+          <p:cNvPr id="101" name="TextBox 100"/>
           <p:cNvSpPr txBox="1"/>
           <p:nvPr/>
         </p:nvSpPr>
@@ -17595,7 +18176,7 @@
                 </a:solidFill>
                 <a:latin typeface="Calibri"/>
               </a:rPr>
-              <a:t>Illustrative estimate for ~50 log sources; our AI-call rate is measured in our benchmark.</a:t>
+              <a:t>Illustrative estimate for ~50 log sources (engineer ₹5,000/day, typical AI pricing); our AI-call rate is measured in our benchmark.</a:t>
             </a:r>
           </a:p>
         </p:txBody>

</xml_diff>

<commit_message>
PPT slide 4: remove test-result boxes; full-height, more detailed feasibility / challenges / viability
Co-authored-by: arena-agent <297053741+arena-agent@users.noreply.github.com>
</commit_message>
<xml_diff>
--- a/presentation/SIH2026_Idea_Submission.pptx
+++ b/presentation/SIH2026_Idea_Submission.pptx
@@ -13935,18 +13935,154 @@
       </p:sp>
       <p:sp>
         <p:nvSpPr>
-          <p:cNvPr id="10" name="Rounded Rectangle 9"/>
+          <p:cNvPr id="55" name="Oval 54"/>
           <p:cNvSpPr/>
           <p:nvPr/>
         </p:nvSpPr>
         <p:spPr>
           <a:xfrm>
+            <a:off x="320040" y="182880"/>
+            <a:ext cx="1463040" cy="731520"/>
+          </a:xfrm>
+          <a:prstGeom prst="ellipse">
+            <a:avLst/>
+          </a:prstGeom>
+          <a:noFill/>
+          <a:ln w="25400">
+            <a:solidFill>
+              <a:srgbClr val="8064A2"/>
+            </a:solidFill>
+          </a:ln>
+          <a:effectLst/>
+        </p:spPr>
+        <p:style>
+          <a:lnRef idx="1">
+            <a:schemeClr val="accent1"/>
+          </a:lnRef>
+          <a:fillRef idx="3">
+            <a:schemeClr val="accent1"/>
+          </a:fillRef>
+          <a:effectRef idx="2">
+            <a:schemeClr val="accent1"/>
+          </a:effectRef>
+          <a:fontRef idx="minor">
+            <a:schemeClr val="lt1"/>
+          </a:fontRef>
+        </p:style>
+        <p:txBody>
+          <a:bodyPr rtlCol="0" anchor="ctr" wrap="square" lIns="45720" rIns="45720" tIns="18288" bIns="18288"/>
+          <a:lstStyle/>
+          <a:p>
+            <a:pPr algn="ctr"/>
+            <a:r>
+              <a:rPr sz="1200" b="1">
+                <a:solidFill>
+                  <a:srgbClr val="F58220"/>
+                </a:solidFill>
+                <a:latin typeface="Calibri"/>
+              </a:rPr>
+              <a:t>[Team Name]</a:t>
+            </a:r>
+          </a:p>
+        </p:txBody>
+      </p:sp>
+      <p:pic>
+        <p:nvPicPr>
+          <p:cNvPr id="56" name="Picture 55" descr="sih_icon_s.png"/>
+          <p:cNvPicPr>
+            <a:picLocks noChangeAspect="1"/>
+          </p:cNvPicPr>
+          <p:nvPr/>
+        </p:nvPicPr>
+        <p:blipFill>
+          <a:blip r:embed="rId3"/>
+          <a:stretch>
+            <a:fillRect/>
+          </a:stretch>
+        </p:blipFill>
+        <p:spPr>
+          <a:xfrm>
+            <a:off x="10076688" y="91440"/>
+            <a:ext cx="676894" cy="822960"/>
+          </a:xfrm>
+          <a:prstGeom prst="rect">
+            <a:avLst/>
+          </a:prstGeom>
+        </p:spPr>
+      </p:pic>
+      <p:sp>
+        <p:nvSpPr>
+          <p:cNvPr id="57" name="TextBox 56"/>
+          <p:cNvSpPr txBox="1"/>
+          <p:nvPr/>
+        </p:nvSpPr>
+        <p:spPr>
+          <a:xfrm>
+            <a:off x="10789920" y="109728"/>
+            <a:ext cx="1371600" cy="777240"/>
+          </a:xfrm>
+          <a:prstGeom prst="rect">
+            <a:avLst/>
+          </a:prstGeom>
+          <a:noFill/>
+        </p:spPr>
+        <p:txBody>
+          <a:bodyPr wrap="square" lIns="36576" rIns="36576" tIns="18288" bIns="18288" anchor="t">
+            <a:spAutoFit/>
+          </a:bodyPr>
+          <a:lstStyle/>
+          <a:p>
+            <a:pPr algn="ctr"/>
+            <a:r>
+              <a:rPr sz="1250" b="1">
+                <a:solidFill>
+                  <a:srgbClr val="455A64"/>
+                </a:solidFill>
+                <a:latin typeface="Calibri"/>
+              </a:rPr>
+              <a:t>SMART INDIA</a:t>
+            </a:r>
+          </a:p>
+          <a:p>
+            <a:pPr algn="ctr"/>
+            <a:r>
+              <a:rPr sz="1250" b="1">
+                <a:solidFill>
+                  <a:srgbClr val="455A64"/>
+                </a:solidFill>
+                <a:latin typeface="Calibri"/>
+              </a:rPr>
+              <a:t>HACKATHON</a:t>
+            </a:r>
+          </a:p>
+          <a:p>
+            <a:pPr algn="ctr"/>
+            <a:r>
+              <a:rPr sz="1250" b="1">
+                <a:solidFill>
+                  <a:srgbClr val="455A64"/>
+                </a:solidFill>
+                <a:latin typeface="Calibri"/>
+              </a:rPr>
+              <a:t>2026</a:t>
+            </a:r>
+          </a:p>
+        </p:txBody>
+      </p:sp>
+      <p:sp>
+        <p:nvSpPr>
+          <p:cNvPr id="59" name="Rounded Rectangle 58"/>
+          <p:cNvSpPr/>
+          <p:nvPr/>
+        </p:nvSpPr>
+        <p:spPr>
+          <a:xfrm>
             <a:off x="365760" y="1097280"/>
-            <a:ext cx="3657600" cy="3429000"/>
+            <a:ext cx="3657600" cy="5193792"/>
           </a:xfrm>
           <a:prstGeom prst="roundRect">
             <a:avLst>
-              <a:gd name="adj" fmla="val 5000"/>
+              <a:gd name="adj" fmla="val 3000"/>
             </a:avLst>
           </a:prstGeom>
           <a:solidFill>
@@ -13983,7 +14119,7 @@
       </p:sp>
       <p:sp>
         <p:nvSpPr>
-          <p:cNvPr id="11" name="Rounded Rectangle 10"/>
+          <p:cNvPr id="60" name="Rounded Rectangle 59"/>
           <p:cNvSpPr/>
           <p:nvPr/>
         </p:nvSpPr>
@@ -14029,7 +14165,7 @@
       </p:sp>
       <p:sp>
         <p:nvSpPr>
-          <p:cNvPr id="12" name="TextBox 11"/>
+          <p:cNvPr id="61" name="TextBox 60"/>
           <p:cNvSpPr txBox="1"/>
           <p:nvPr/>
         </p:nvSpPr>
@@ -14044,229 +14180,262 @@
           <a:noFill/>
         </p:spPr>
         <p:txBody>
-          <a:bodyPr wrap="square" anchor="ctr" lIns="36576" rIns="36576" tIns="18288" bIns="18288">
+          <a:bodyPr wrap="square" lIns="36576" rIns="36576" tIns="18288" bIns="18288" anchor="ctr">
             <a:spAutoFit/>
           </a:bodyPr>
           <a:lstStyle/>
           <a:p>
-            <a:pPr algn="ctr">
+            <a:pPr algn="ctr"/>
+            <a:r>
+              <a:rPr sz="1500" b="1">
+                <a:solidFill>
+                  <a:srgbClr val="FFFFFF"/>
+                </a:solidFill>
+                <a:latin typeface="Calibri"/>
+              </a:rPr>
+              <a:t>FEASIBILITY  (Can it be built?)</a:t>
+            </a:r>
+          </a:p>
+        </p:txBody>
+      </p:sp>
+      <p:sp>
+        <p:nvSpPr>
+          <p:cNvPr id="62" name="TextBox 61"/>
+          <p:cNvSpPr txBox="1"/>
+          <p:nvPr/>
+        </p:nvSpPr>
+        <p:spPr>
+          <a:xfrm>
+            <a:off x="502920" y="1719072"/>
+            <a:ext cx="3401568" cy="4462272"/>
+          </a:xfrm>
+          <a:prstGeom prst="rect">
+            <a:avLst/>
+          </a:prstGeom>
+          <a:noFill/>
+        </p:spPr>
+        <p:txBody>
+          <a:bodyPr wrap="square" lIns="36576" rIns="36576" tIns="18288" bIns="18288" anchor="t">
+            <a:spAutoFit/>
+          </a:bodyPr>
+          <a:lstStyle/>
+          <a:p>
+            <a:pPr algn="l">
               <a:spcAft>
-                <a:spcPts val="0"/>
+                <a:spcPts val="200"/>
               </a:spcAft>
             </a:pPr>
             <a:r>
-              <a:rPr sz="1500" b="1">
-                <a:solidFill>
-                  <a:srgbClr val="FFFFFF"/>
-                </a:solidFill>
-                <a:latin typeface="Calibri"/>
-              </a:rPr>
-              <a:t>FEASIBILITY  (Can it be built?)</a:t>
-            </a:r>
-          </a:p>
-        </p:txBody>
-      </p:sp>
-      <p:sp>
-        <p:nvSpPr>
-          <p:cNvPr id="13" name="TextBox 12"/>
-          <p:cNvSpPr txBox="1"/>
-          <p:nvPr/>
-        </p:nvSpPr>
-        <p:spPr>
-          <a:xfrm>
-            <a:off x="530352" y="1691640"/>
-            <a:ext cx="3364992" cy="2743200"/>
-          </a:xfrm>
-          <a:prstGeom prst="rect">
-            <a:avLst/>
-          </a:prstGeom>
-          <a:noFill/>
-        </p:spPr>
-        <p:txBody>
-          <a:bodyPr wrap="square" anchor="t" lIns="36576" rIns="36576" tIns="18288" bIns="18288">
-            <a:spAutoFit/>
-          </a:bodyPr>
-          <a:lstStyle/>
+              <a:rPr sz="1150" b="1">
+                <a:solidFill>
+                  <a:srgbClr val="138A36"/>
+                </a:solidFill>
+                <a:latin typeface="Calibri"/>
+              </a:rPr>
+              <a:t>✔ </a:t>
+            </a:r>
+            <a:r>
+              <a:rPr sz="1300" b="1">
+                <a:solidFill>
+                  <a:srgbClr val="0B2A5B"/>
+                </a:solidFill>
+                <a:latin typeface="Calibri"/>
+              </a:rPr>
+              <a:t>Proven technology</a:t>
+            </a:r>
+          </a:p>
           <a:p>
             <a:pPr algn="l">
               <a:spcAft>
-                <a:spcPts val="100"/>
+                <a:spcPts val="1100"/>
               </a:spcAft>
             </a:pPr>
             <a:r>
-              <a:rPr sz="1250" b="1">
-                <a:solidFill>
-                  <a:srgbClr val="138A36"/>
-                </a:solidFill>
-                <a:latin typeface="Calibri"/>
-              </a:rPr>
-              <a:t>✔ </a:t>
-            </a:r>
-            <a:r>
-              <a:rPr sz="1250" b="1">
-                <a:solidFill>
-                  <a:srgbClr val="0B2A5B"/>
-                </a:solidFill>
-                <a:latin typeface="Calibri"/>
-              </a:rPr>
-              <a:t>Proven technology</a:t>
+              <a:rPr sz="1150" b="0">
+                <a:solidFill>
+                  <a:srgbClr val="1E2530"/>
+                </a:solidFill>
+                <a:latin typeface="Calibri"/>
+              </a:rPr>
+              <a:t>Built on free, trusted open-source tools (Python, FastAPI, Drain3, scikit-learn) that are used worldwide.</a:t>
             </a:r>
           </a:p>
           <a:p>
             <a:pPr algn="l">
               <a:spcAft>
-                <a:spcPts val="800"/>
+                <a:spcPts val="200"/>
               </a:spcAft>
             </a:pPr>
             <a:r>
-              <a:rPr sz="1250" b="0">
-                <a:solidFill>
-                  <a:srgbClr val="1E2530"/>
-                </a:solidFill>
-                <a:latin typeface="Calibri"/>
-              </a:rPr>
-              <a:t>Built on free, trusted open-source tools.</a:t>
+              <a:rPr sz="1150" b="1">
+                <a:solidFill>
+                  <a:srgbClr val="138A36"/>
+                </a:solidFill>
+                <a:latin typeface="Calibri"/>
+              </a:rPr>
+              <a:t>✔ </a:t>
+            </a:r>
+            <a:r>
+              <a:rPr sz="1300" b="1">
+                <a:solidFill>
+                  <a:srgbClr val="0B2A5B"/>
+                </a:solidFill>
+                <a:latin typeface="Calibri"/>
+              </a:rPr>
+              <a:t>Low running cost</a:t>
             </a:r>
           </a:p>
           <a:p>
             <a:pPr algn="l">
               <a:spcAft>
-                <a:spcPts val="100"/>
+                <a:spcPts val="1100"/>
               </a:spcAft>
             </a:pPr>
             <a:r>
-              <a:rPr sz="1250" b="1">
-                <a:solidFill>
-                  <a:srgbClr val="138A36"/>
-                </a:solidFill>
-                <a:latin typeface="Calibri"/>
-              </a:rPr>
-              <a:t>✔ </a:t>
-            </a:r>
-            <a:r>
-              <a:rPr sz="1250" b="1">
-                <a:solidFill>
-                  <a:srgbClr val="0B2A5B"/>
-                </a:solidFill>
-                <a:latin typeface="Calibri"/>
-              </a:rPr>
-              <a:t>Low cost</a:t>
+              <a:rPr sz="1150" b="0">
+                <a:solidFill>
+                  <a:srgbClr val="1E2530"/>
+                </a:solidFill>
+                <a:latin typeface="Calibri"/>
+              </a:rPr>
+              <a:t>AI is called only when a brand-new log format appears, so the bill stays small even at millions of logs a day.</a:t>
             </a:r>
           </a:p>
           <a:p>
             <a:pPr algn="l">
               <a:spcAft>
-                <a:spcPts val="800"/>
+                <a:spcPts val="200"/>
               </a:spcAft>
             </a:pPr>
             <a:r>
-              <a:rPr sz="1250" b="0">
-                <a:solidFill>
-                  <a:srgbClr val="1E2530"/>
-                </a:solidFill>
-                <a:latin typeface="Calibri"/>
-              </a:rPr>
-              <a:t>AI is used only for new log formats, so bills stay small.</a:t>
+              <a:rPr sz="1150" b="1">
+                <a:solidFill>
+                  <a:srgbClr val="138A36"/>
+                </a:solidFill>
+                <a:latin typeface="Calibri"/>
+              </a:rPr>
+              <a:t>✔ </a:t>
+            </a:r>
+            <a:r>
+              <a:rPr sz="1300" b="1">
+                <a:solidFill>
+                  <a:srgbClr val="0B2A5B"/>
+                </a:solidFill>
+                <a:latin typeface="Calibri"/>
+              </a:rPr>
+              <a:t>Easy to adopt</a:t>
             </a:r>
           </a:p>
           <a:p>
             <a:pPr algn="l">
               <a:spcAft>
-                <a:spcPts val="100"/>
+                <a:spcPts val="1100"/>
               </a:spcAft>
             </a:pPr>
             <a:r>
-              <a:rPr sz="1250" b="1">
-                <a:solidFill>
-                  <a:srgbClr val="138A36"/>
-                </a:solidFill>
-                <a:latin typeface="Calibri"/>
-              </a:rPr>
-              <a:t>✔ </a:t>
-            </a:r>
-            <a:r>
-              <a:rPr sz="1250" b="1">
-                <a:solidFill>
-                  <a:srgbClr val="0B2A5B"/>
-                </a:solidFill>
-                <a:latin typeface="Calibri"/>
-              </a:rPr>
-              <a:t>Easy to adopt</a:t>
+              <a:rPr sz="1150" b="0">
+                <a:solidFill>
+                  <a:srgbClr val="1E2530"/>
+                </a:solidFill>
+                <a:latin typeface="Calibri"/>
+              </a:rPr>
+              <a:t>Any log source connects through a simple web API or a Bash script. No parser writing or coding is needed.</a:t>
             </a:r>
           </a:p>
           <a:p>
             <a:pPr algn="l">
               <a:spcAft>
-                <a:spcPts val="800"/>
+                <a:spcPts val="200"/>
               </a:spcAft>
             </a:pPr>
             <a:r>
-              <a:rPr sz="1250" b="0">
-                <a:solidFill>
-                  <a:srgbClr val="1E2530"/>
-                </a:solidFill>
-                <a:latin typeface="Calibri"/>
-              </a:rPr>
-              <a:t>Connect any log source; no parser writing needed.</a:t>
+              <a:rPr sz="1150" b="1">
+                <a:solidFill>
+                  <a:srgbClr val="138A36"/>
+                </a:solidFill>
+                <a:latin typeface="Calibri"/>
+              </a:rPr>
+              <a:t>✔ </a:t>
+            </a:r>
+            <a:r>
+              <a:rPr sz="1300" b="1">
+                <a:solidFill>
+                  <a:srgbClr val="0B2A5B"/>
+                </a:solidFill>
+                <a:latin typeface="Calibri"/>
+              </a:rPr>
+              <a:t>Data available</a:t>
             </a:r>
           </a:p>
           <a:p>
             <a:pPr algn="l">
               <a:spcAft>
-                <a:spcPts val="100"/>
+                <a:spcPts val="1100"/>
               </a:spcAft>
             </a:pPr>
             <a:r>
-              <a:rPr sz="1250" b="1">
-                <a:solidFill>
-                  <a:srgbClr val="138A36"/>
-                </a:solidFill>
-                <a:latin typeface="Calibri"/>
-              </a:rPr>
-              <a:t>✔ </a:t>
-            </a:r>
-            <a:r>
-              <a:rPr sz="1250" b="1">
-                <a:solidFill>
-                  <a:srgbClr val="0B2A5B"/>
-                </a:solidFill>
-                <a:latin typeface="Calibri"/>
-              </a:rPr>
-              <a:t>Data available</a:t>
+              <a:rPr sz="1150" b="0">
+                <a:solidFill>
+                  <a:srgbClr val="1E2530"/>
+                </a:solidFill>
+                <a:latin typeface="Calibri"/>
+              </a:rPr>
+              <a:t>Tested on public real-world log datasets (Loghub) from many systems. No private or secret data is needed.</a:t>
             </a:r>
           </a:p>
           <a:p>
             <a:pPr algn="l">
               <a:spcAft>
-                <a:spcPts val="800"/>
+                <a:spcPts val="200"/>
               </a:spcAft>
             </a:pPr>
             <a:r>
-              <a:rPr sz="1250" b="0">
+              <a:rPr sz="1150" b="1">
+                <a:solidFill>
+                  <a:srgbClr val="138A36"/>
+                </a:solidFill>
+                <a:latin typeface="Calibri"/>
+              </a:rPr>
+              <a:t>✔ </a:t>
+            </a:r>
+            <a:r>
+              <a:rPr sz="1300" b="1">
+                <a:solidFill>
+                  <a:srgbClr val="0B2A5B"/>
+                </a:solidFill>
+                <a:latin typeface="Calibri"/>
+              </a:rPr>
+              <a:t>Safe rollout</a:t>
+            </a:r>
+          </a:p>
+          <a:p>
+            <a:pPr algn="l"/>
+            <a:r>
+              <a:rPr sz="1150" b="0">
                 <a:solidFill>
                   <a:srgbClr val="1E2530"/>
                 </a:solidFill>
                 <a:latin typeface="Calibri"/>
               </a:rPr>
-              <a:t>Uses public log datasets; no private data needed.</a:t>
-            </a:r>
-          </a:p>
-        </p:txBody>
-      </p:sp>
-      <p:sp>
-        <p:nvSpPr>
-          <p:cNvPr id="14" name="Rounded Rectangle 13"/>
+              <a:t>Starts in watch-only 'shadow mode', so teams can check results before switching it on fully.</a:t>
+            </a:r>
+          </a:p>
+        </p:txBody>
+      </p:sp>
+      <p:sp>
+        <p:nvSpPr>
+          <p:cNvPr id="63" name="Rounded Rectangle 62"/>
           <p:cNvSpPr/>
           <p:nvPr/>
         </p:nvSpPr>
         <p:spPr>
           <a:xfrm>
             <a:off x="8165592" y="1097280"/>
-            <a:ext cx="3703320" cy="3429000"/>
+            <a:ext cx="3703320" cy="5193792"/>
           </a:xfrm>
           <a:prstGeom prst="roundRect">
             <a:avLst>
-              <a:gd name="adj" fmla="val 5000"/>
+              <a:gd name="adj" fmla="val 3000"/>
             </a:avLst>
           </a:prstGeom>
           <a:solidFill>
@@ -14303,7 +14472,7 @@
       </p:sp>
       <p:sp>
         <p:nvSpPr>
-          <p:cNvPr id="15" name="Rounded Rectangle 14"/>
+          <p:cNvPr id="64" name="Rounded Rectangle 63"/>
           <p:cNvSpPr/>
           <p:nvPr/>
         </p:nvSpPr>
@@ -14349,7 +14518,7 @@
       </p:sp>
       <p:sp>
         <p:nvSpPr>
-          <p:cNvPr id="16" name="TextBox 15"/>
+          <p:cNvPr id="65" name="TextBox 64"/>
           <p:cNvSpPr txBox="1"/>
           <p:nvPr/>
         </p:nvSpPr>
@@ -14364,229 +14533,303 @@
           <a:noFill/>
         </p:spPr>
         <p:txBody>
-          <a:bodyPr wrap="square" anchor="ctr" lIns="36576" rIns="36576" tIns="18288" bIns="18288">
+          <a:bodyPr wrap="square" lIns="36576" rIns="36576" tIns="18288" bIns="18288" anchor="ctr">
             <a:spAutoFit/>
           </a:bodyPr>
           <a:lstStyle/>
           <a:p>
-            <a:pPr algn="ctr">
+            <a:pPr algn="ctr"/>
+            <a:r>
+              <a:rPr sz="1500" b="1">
+                <a:solidFill>
+                  <a:srgbClr val="FFFFFF"/>
+                </a:solidFill>
+                <a:latin typeface="Calibri"/>
+              </a:rPr>
+              <a:t>VIABILITY  (Will it last?)</a:t>
+            </a:r>
+          </a:p>
+        </p:txBody>
+      </p:sp>
+      <p:sp>
+        <p:nvSpPr>
+          <p:cNvPr id="66" name="TextBox 65"/>
+          <p:cNvSpPr txBox="1"/>
+          <p:nvPr/>
+        </p:nvSpPr>
+        <p:spPr>
+          <a:xfrm>
+            <a:off x="8302752" y="1719072"/>
+            <a:ext cx="3447288" cy="4462272"/>
+          </a:xfrm>
+          <a:prstGeom prst="rect">
+            <a:avLst/>
+          </a:prstGeom>
+          <a:noFill/>
+        </p:spPr>
+        <p:txBody>
+          <a:bodyPr wrap="square" lIns="36576" rIns="36576" tIns="18288" bIns="18288" anchor="t">
+            <a:spAutoFit/>
+          </a:bodyPr>
+          <a:lstStyle/>
+          <a:p>
+            <a:pPr algn="l">
               <a:spcAft>
-                <a:spcPts val="0"/>
+                <a:spcPts val="200"/>
               </a:spcAft>
             </a:pPr>
             <a:r>
-              <a:rPr sz="1500" b="1">
-                <a:solidFill>
-                  <a:srgbClr val="FFFFFF"/>
-                </a:solidFill>
-                <a:latin typeface="Calibri"/>
-              </a:rPr>
-              <a:t>VIABILITY  (Will it last?)</a:t>
-            </a:r>
-          </a:p>
-        </p:txBody>
-      </p:sp>
-      <p:sp>
-        <p:nvSpPr>
-          <p:cNvPr id="17" name="TextBox 16"/>
-          <p:cNvSpPr txBox="1"/>
-          <p:nvPr/>
-        </p:nvSpPr>
-        <p:spPr>
-          <a:xfrm>
-            <a:off x="8330183" y="1691640"/>
-            <a:ext cx="3410712" cy="2743200"/>
-          </a:xfrm>
-          <a:prstGeom prst="rect">
-            <a:avLst/>
-          </a:prstGeom>
-          <a:noFill/>
-        </p:spPr>
-        <p:txBody>
-          <a:bodyPr wrap="square" anchor="t" lIns="36576" rIns="36576" tIns="18288" bIns="18288">
-            <a:spAutoFit/>
-          </a:bodyPr>
-          <a:lstStyle/>
+              <a:rPr sz="1150" b="1">
+                <a:solidFill>
+                  <a:srgbClr val="1F5FBF"/>
+                </a:solidFill>
+                <a:latin typeface="Calibri"/>
+              </a:rPr>
+              <a:t>✔ </a:t>
+            </a:r>
+            <a:r>
+              <a:rPr sz="1300" b="1">
+                <a:solidFill>
+                  <a:srgbClr val="0B2A5B"/>
+                </a:solidFill>
+                <a:latin typeface="Calibri"/>
+              </a:rPr>
+              <a:t>Real need</a:t>
+            </a:r>
+          </a:p>
           <a:p>
             <a:pPr algn="l">
               <a:spcAft>
-                <a:spcPts val="100"/>
+                <a:spcPts val="1100"/>
               </a:spcAft>
             </a:pPr>
             <a:r>
-              <a:rPr sz="1250" b="1">
-                <a:solidFill>
-                  <a:srgbClr val="1F5FBF"/>
-                </a:solidFill>
-                <a:latin typeface="Calibri"/>
-              </a:rPr>
-              <a:t>✔ </a:t>
-            </a:r>
-            <a:r>
-              <a:rPr sz="1250" b="1">
-                <a:solidFill>
-                  <a:srgbClr val="0B2A5B"/>
-                </a:solidFill>
-                <a:latin typeface="Calibri"/>
-              </a:rPr>
-              <a:t>Real need</a:t>
+              <a:rPr sz="1150" b="0">
+                <a:solidFill>
+                  <a:srgbClr val="1E2530"/>
+                </a:solidFill>
+                <a:latin typeface="Calibri"/>
+              </a:rPr>
+              <a:t>CERT-In requires every organisation to keep 180 days of logs and report incidents within 6 hours.</a:t>
             </a:r>
           </a:p>
           <a:p>
             <a:pPr algn="l">
               <a:spcAft>
-                <a:spcPts val="800"/>
+                <a:spcPts val="200"/>
               </a:spcAft>
             </a:pPr>
             <a:r>
-              <a:rPr sz="1250" b="0">
-                <a:solidFill>
-                  <a:srgbClr val="1E2530"/>
-                </a:solidFill>
-                <a:latin typeface="Calibri"/>
-              </a:rPr>
-              <a:t>CERT-In asks every organisation to keep 180 days of logs.</a:t>
+              <a:rPr sz="1150" b="1">
+                <a:solidFill>
+                  <a:srgbClr val="1F5FBF"/>
+                </a:solidFill>
+                <a:latin typeface="Calibri"/>
+              </a:rPr>
+              <a:t>✔ </a:t>
+            </a:r>
+            <a:r>
+              <a:rPr sz="1300" b="1">
+                <a:solidFill>
+                  <a:srgbClr val="0B2A5B"/>
+                </a:solidFill>
+                <a:latin typeface="Calibri"/>
+              </a:rPr>
+              <a:t>Data stays in India</a:t>
             </a:r>
           </a:p>
           <a:p>
             <a:pPr algn="l">
               <a:spcAft>
-                <a:spcPts val="100"/>
+                <a:spcPts val="1100"/>
               </a:spcAft>
             </a:pPr>
             <a:r>
-              <a:rPr sz="1250" b="1">
-                <a:solidFill>
-                  <a:srgbClr val="1F5FBF"/>
-                </a:solidFill>
-                <a:latin typeface="Calibri"/>
-              </a:rPr>
-              <a:t>✔ </a:t>
-            </a:r>
-            <a:r>
-              <a:rPr sz="1250" b="1">
-                <a:solidFill>
-                  <a:srgbClr val="0B2A5B"/>
-                </a:solidFill>
-                <a:latin typeface="Calibri"/>
-              </a:rPr>
-              <a:t>Data stays in India</a:t>
+              <a:rPr sz="1150" b="0">
+                <a:solidFill>
+                  <a:srgbClr val="1E2530"/>
+                </a:solidFill>
+                <a:latin typeface="Calibri"/>
+              </a:rPr>
+              <a:t>Runs on Indian cloud or fully on-premise servers, even in air-gapped networks.</a:t>
             </a:r>
           </a:p>
           <a:p>
             <a:pPr algn="l">
               <a:spcAft>
-                <a:spcPts val="800"/>
+                <a:spcPts val="200"/>
               </a:spcAft>
             </a:pPr>
             <a:r>
-              <a:rPr sz="1250" b="0">
-                <a:solidFill>
-                  <a:srgbClr val="1E2530"/>
-                </a:solidFill>
-                <a:latin typeface="Calibri"/>
-              </a:rPr>
-              <a:t>Can run on Indian / on-premise servers.</a:t>
+              <a:rPr sz="1150" b="1">
+                <a:solidFill>
+                  <a:srgbClr val="1F5FBF"/>
+                </a:solidFill>
+                <a:latin typeface="Calibri"/>
+              </a:rPr>
+              <a:t>✔ </a:t>
+            </a:r>
+            <a:r>
+              <a:rPr sz="1300" b="1">
+                <a:solidFill>
+                  <a:srgbClr val="0B2A5B"/>
+                </a:solidFill>
+                <a:latin typeface="Calibri"/>
+              </a:rPr>
+              <a:t>Business model</a:t>
             </a:r>
           </a:p>
           <a:p>
             <a:pPr algn="l">
               <a:spcAft>
-                <a:spcPts val="100"/>
+                <a:spcPts val="1100"/>
               </a:spcAft>
             </a:pPr>
             <a:r>
-              <a:rPr sz="1250" b="1">
-                <a:solidFill>
-                  <a:srgbClr val="1F5FBF"/>
-                </a:solidFill>
-                <a:latin typeface="Calibri"/>
-              </a:rPr>
-              <a:t>✔ </a:t>
-            </a:r>
-            <a:r>
-              <a:rPr sz="1250" b="1">
-                <a:solidFill>
-                  <a:srgbClr val="0B2A5B"/>
-                </a:solidFill>
-                <a:latin typeface="Calibri"/>
-              </a:rPr>
-              <a:t>Business model</a:t>
+              <a:rPr sz="1150" b="0">
+                <a:solidFill>
+                  <a:srgbClr val="1E2530"/>
+                </a:solidFill>
+                <a:latin typeface="Calibri"/>
+              </a:rPr>
+              <a:t>Free open-source core, plus paid setup, support and training for government &amp; PSUs.</a:t>
             </a:r>
           </a:p>
           <a:p>
             <a:pPr algn="l">
               <a:spcAft>
-                <a:spcPts val="800"/>
+                <a:spcPts val="200"/>
               </a:spcAft>
             </a:pPr>
             <a:r>
-              <a:rPr sz="1250" b="0">
-                <a:solidFill>
-                  <a:srgbClr val="1E2530"/>
-                </a:solidFill>
-                <a:latin typeface="Calibri"/>
-              </a:rPr>
-              <a:t>Free open-source core + paid support for govt &amp; companies.</a:t>
+              <a:rPr sz="1150" b="1">
+                <a:solidFill>
+                  <a:srgbClr val="1F5FBF"/>
+                </a:solidFill>
+                <a:latin typeface="Calibri"/>
+              </a:rPr>
+              <a:t>✔ </a:t>
+            </a:r>
+            <a:r>
+              <a:rPr sz="1300" b="1">
+                <a:solidFill>
+                  <a:srgbClr val="0B2A5B"/>
+                </a:solidFill>
+                <a:latin typeface="Calibri"/>
+              </a:rPr>
+              <a:t>Grows easily</a:t>
             </a:r>
           </a:p>
           <a:p>
             <a:pPr algn="l">
               <a:spcAft>
-                <a:spcPts val="100"/>
+                <a:spcPts val="1100"/>
               </a:spcAft>
             </a:pPr>
             <a:r>
-              <a:rPr sz="1250" b="1">
-                <a:solidFill>
-                  <a:srgbClr val="1F5FBF"/>
-                </a:solidFill>
-                <a:latin typeface="Calibri"/>
-              </a:rPr>
-              <a:t>✔ </a:t>
-            </a:r>
-            <a:r>
-              <a:rPr sz="1250" b="1">
-                <a:solidFill>
-                  <a:srgbClr val="0B2A5B"/>
-                </a:solidFill>
-                <a:latin typeface="Calibri"/>
-              </a:rPr>
-              <a:t>Grows easily</a:t>
+              <a:rPr sz="1150" b="0">
+                <a:solidFill>
+                  <a:srgbClr val="1E2530"/>
+                </a:solidFill>
+                <a:latin typeface="Calibri"/>
+              </a:rPr>
+              <a:t>More logs do not mean more AI cost: each new format is learned only once and reused.</a:t>
             </a:r>
           </a:p>
           <a:p>
             <a:pPr algn="l">
               <a:spcAft>
-                <a:spcPts val="800"/>
+                <a:spcPts val="200"/>
               </a:spcAft>
             </a:pPr>
             <a:r>
-              <a:rPr sz="1250" b="0">
+              <a:rPr sz="1150" b="1">
+                <a:solidFill>
+                  <a:srgbClr val="1F5FBF"/>
+                </a:solidFill>
+                <a:latin typeface="Calibri"/>
+              </a:rPr>
+              <a:t>✔ </a:t>
+            </a:r>
+            <a:r>
+              <a:rPr sz="1300" b="1">
+                <a:solidFill>
+                  <a:srgbClr val="0B2A5B"/>
+                </a:solidFill>
+                <a:latin typeface="Calibri"/>
+              </a:rPr>
+              <a:t>Wide market</a:t>
+            </a:r>
+          </a:p>
+          <a:p>
+            <a:pPr algn="l">
+              <a:spcAft>
+                <a:spcPts val="1100"/>
+              </a:spcAft>
+            </a:pPr>
+            <a:r>
+              <a:rPr sz="1150" b="0">
                 <a:solidFill>
                   <a:srgbClr val="1E2530"/>
                 </a:solidFill>
                 <a:latin typeface="Calibri"/>
               </a:rPr>
-              <a:t>More logs do not mean more AI cost.</a:t>
-            </a:r>
-          </a:p>
-        </p:txBody>
-      </p:sp>
-      <p:sp>
-        <p:nvSpPr>
-          <p:cNvPr id="18" name="Rounded Rectangle 17"/>
+              <a:t>Every bank, power utility, telecom operator and ministry produces huge, mixed logs.</a:t>
+            </a:r>
+          </a:p>
+          <a:p>
+            <a:pPr algn="l">
+              <a:spcAft>
+                <a:spcPts val="200"/>
+              </a:spcAft>
+            </a:pPr>
+            <a:r>
+              <a:rPr sz="1150" b="1">
+                <a:solidFill>
+                  <a:srgbClr val="1F5FBF"/>
+                </a:solidFill>
+                <a:latin typeface="Calibri"/>
+              </a:rPr>
+              <a:t>✔ </a:t>
+            </a:r>
+            <a:r>
+              <a:rPr sz="1300" b="1">
+                <a:solidFill>
+                  <a:srgbClr val="0B2A5B"/>
+                </a:solidFill>
+                <a:latin typeface="Calibri"/>
+              </a:rPr>
+              <a:t>Clear rollout path</a:t>
+            </a:r>
+          </a:p>
+          <a:p>
+            <a:pPr algn="l"/>
+            <a:r>
+              <a:rPr sz="1150" b="0">
+                <a:solidFill>
+                  <a:srgbClr val="1E2530"/>
+                </a:solidFill>
+                <a:latin typeface="Calibri"/>
+              </a:rPr>
+              <a:t>Pilot with one PSU, then sector security centres, then a nationwide NCIIPC rollout.</a:t>
+            </a:r>
+          </a:p>
+        </p:txBody>
+      </p:sp>
+      <p:sp>
+        <p:nvSpPr>
+          <p:cNvPr id="67" name="Rounded Rectangle 66"/>
           <p:cNvSpPr/>
           <p:nvPr/>
         </p:nvSpPr>
         <p:spPr>
           <a:xfrm>
             <a:off x="4206240" y="1097280"/>
-            <a:ext cx="3776472" cy="3429000"/>
+            <a:ext cx="3776472" cy="5193792"/>
           </a:xfrm>
           <a:prstGeom prst="roundRect">
             <a:avLst>
-              <a:gd name="adj" fmla="val 5000"/>
+              <a:gd name="adj" fmla="val 3000"/>
             </a:avLst>
           </a:prstGeom>
           <a:solidFill>
@@ -14623,7 +14866,7 @@
       </p:sp>
       <p:sp>
         <p:nvSpPr>
-          <p:cNvPr id="19" name="Rounded Rectangle 18"/>
+          <p:cNvPr id="68" name="Rounded Rectangle 67"/>
           <p:cNvSpPr/>
           <p:nvPr/>
         </p:nvSpPr>
@@ -14669,7 +14912,7 @@
       </p:sp>
       <p:sp>
         <p:nvSpPr>
-          <p:cNvPr id="20" name="TextBox 19"/>
+          <p:cNvPr id="69" name="TextBox 68"/>
           <p:cNvSpPr txBox="1"/>
           <p:nvPr/>
         </p:nvSpPr>
@@ -14684,16 +14927,12 @@
           <a:noFill/>
         </p:spPr>
         <p:txBody>
-          <a:bodyPr wrap="square" anchor="ctr" lIns="36576" rIns="36576" tIns="18288" bIns="18288">
+          <a:bodyPr wrap="square" lIns="36576" rIns="36576" tIns="18288" bIns="18288" anchor="ctr">
             <a:spAutoFit/>
           </a:bodyPr>
           <a:lstStyle/>
           <a:p>
-            <a:pPr algn="ctr">
-              <a:spcAft>
-                <a:spcPts val="0"/>
-              </a:spcAft>
-            </a:pPr>
+            <a:pPr algn="ctr"/>
             <a:r>
               <a:rPr sz="1500" b="1">
                 <a:solidFill>
@@ -14708,18 +14947,88 @@
       </p:sp>
       <p:sp>
         <p:nvSpPr>
-          <p:cNvPr id="21" name="Rounded Rectangle 20"/>
+          <p:cNvPr id="70" name="TextBox 69"/>
+          <p:cNvSpPr txBox="1"/>
+          <p:nvPr/>
+        </p:nvSpPr>
+        <p:spPr>
+          <a:xfrm>
+            <a:off x="4297680" y="1609344"/>
+            <a:ext cx="1645920" cy="237744"/>
+          </a:xfrm>
+          <a:prstGeom prst="rect">
+            <a:avLst/>
+          </a:prstGeom>
+          <a:noFill/>
+        </p:spPr>
+        <p:txBody>
+          <a:bodyPr wrap="square" lIns="36576" rIns="36576" tIns="18288" bIns="18288" anchor="t">
+            <a:spAutoFit/>
+          </a:bodyPr>
+          <a:lstStyle/>
+          <a:p>
+            <a:pPr algn="ctr"/>
+            <a:r>
+              <a:rPr sz="1050" b="1">
+                <a:solidFill>
+                  <a:srgbClr val="C0392B"/>
+                </a:solidFill>
+                <a:latin typeface="Calibri"/>
+              </a:rPr>
+              <a:t>Risk</a:t>
+            </a:r>
+          </a:p>
+        </p:txBody>
+      </p:sp>
+      <p:sp>
+        <p:nvSpPr>
+          <p:cNvPr id="71" name="TextBox 70"/>
+          <p:cNvSpPr txBox="1"/>
+          <p:nvPr/>
+        </p:nvSpPr>
+        <p:spPr>
+          <a:xfrm>
+            <a:off x="6217920" y="1609344"/>
+            <a:ext cx="1691640" cy="237744"/>
+          </a:xfrm>
+          <a:prstGeom prst="rect">
+            <a:avLst/>
+          </a:prstGeom>
+          <a:noFill/>
+        </p:spPr>
+        <p:txBody>
+          <a:bodyPr wrap="square" lIns="36576" rIns="36576" tIns="18288" bIns="18288" anchor="t">
+            <a:spAutoFit/>
+          </a:bodyPr>
+          <a:lstStyle/>
+          <a:p>
+            <a:pPr algn="ctr"/>
+            <a:r>
+              <a:rPr sz="1050" b="1">
+                <a:solidFill>
+                  <a:srgbClr val="138A36"/>
+                </a:solidFill>
+                <a:latin typeface="Calibri"/>
+              </a:rPr>
+              <a:t>How we handle it</a:t>
+            </a:r>
+          </a:p>
+        </p:txBody>
+      </p:sp>
+      <p:sp>
+        <p:nvSpPr>
+          <p:cNvPr id="72" name="Rounded Rectangle 71"/>
           <p:cNvSpPr/>
           <p:nvPr/>
         </p:nvSpPr>
         <p:spPr>
           <a:xfrm>
-            <a:off x="4343400" y="1719072"/>
-            <a:ext cx="1600200" cy="603504"/>
+            <a:off x="4315968" y="1883664"/>
+            <a:ext cx="1627632" cy="777240"/>
           </a:xfrm>
           <a:prstGeom prst="roundRect">
             <a:avLst>
-              <a:gd name="adj" fmla="val 15000"/>
+              <a:gd name="adj" fmla="val 12000"/>
             </a:avLst>
           </a:prstGeom>
           <a:solidFill>
@@ -14754,14 +15063,14 @@
       </p:sp>
       <p:sp>
         <p:nvSpPr>
-          <p:cNvPr id="22" name="TextBox 21"/>
+          <p:cNvPr id="73" name="TextBox 72"/>
           <p:cNvSpPr txBox="1"/>
           <p:nvPr/>
         </p:nvSpPr>
         <p:spPr>
           <a:xfrm>
-            <a:off x="4370832" y="1719072"/>
-            <a:ext cx="1545336" cy="603504"/>
+            <a:off x="4343400" y="1883664"/>
+            <a:ext cx="1572768" cy="777240"/>
           </a:xfrm>
           <a:prstGeom prst="rect">
             <a:avLst/>
@@ -14769,16 +15078,12 @@
           <a:noFill/>
         </p:spPr>
         <p:txBody>
-          <a:bodyPr wrap="square" anchor="ctr" lIns="36576" rIns="36576" tIns="18288" bIns="18288">
+          <a:bodyPr wrap="square" lIns="36576" rIns="36576" tIns="18288" bIns="18288" anchor="ctr">
             <a:spAutoFit/>
           </a:bodyPr>
           <a:lstStyle/>
           <a:p>
-            <a:pPr algn="ctr">
-              <a:spcAft>
-                <a:spcPts val="0"/>
-              </a:spcAft>
-            </a:pPr>
+            <a:pPr algn="ctr"/>
             <a:r>
               <a:rPr sz="1150" b="1">
                 <a:solidFill>
@@ -14793,14 +15098,14 @@
       </p:sp>
       <p:sp>
         <p:nvSpPr>
-          <p:cNvPr id="23" name="TextBox 22"/>
+          <p:cNvPr id="74" name="TextBox 73"/>
           <p:cNvSpPr txBox="1"/>
           <p:nvPr/>
         </p:nvSpPr>
         <p:spPr>
           <a:xfrm>
-            <a:off x="5916168" y="1719072"/>
-            <a:ext cx="274320" cy="603504"/>
+            <a:off x="5925312" y="1883664"/>
+            <a:ext cx="292608" cy="777240"/>
           </a:xfrm>
           <a:prstGeom prst="rect">
             <a:avLst/>
@@ -14808,20 +15113,16 @@
           <a:noFill/>
         </p:spPr>
         <p:txBody>
-          <a:bodyPr wrap="square" anchor="ctr" lIns="36576" rIns="36576" tIns="18288" bIns="18288">
+          <a:bodyPr wrap="square" lIns="36576" rIns="36576" tIns="18288" bIns="18288" anchor="ctr">
             <a:spAutoFit/>
           </a:bodyPr>
           <a:lstStyle/>
           <a:p>
-            <a:pPr algn="ctr">
-              <a:spcAft>
-                <a:spcPts val="0"/>
-              </a:spcAft>
-            </a:pPr>
+            <a:pPr algn="ctr"/>
             <a:r>
               <a:rPr sz="1600" b="1">
                 <a:solidFill>
-                  <a:srgbClr val="5B6778"/>
+                  <a:srgbClr val="5F6B7A"/>
                 </a:solidFill>
                 <a:latin typeface="Calibri"/>
               </a:rPr>
@@ -14832,18 +15133,18 @@
       </p:sp>
       <p:sp>
         <p:nvSpPr>
-          <p:cNvPr id="24" name="Rounded Rectangle 23"/>
+          <p:cNvPr id="75" name="Rounded Rectangle 74"/>
           <p:cNvSpPr/>
           <p:nvPr/>
         </p:nvSpPr>
         <p:spPr>
           <a:xfrm>
-            <a:off x="6217920" y="1719072"/>
-            <a:ext cx="1645920" cy="603504"/>
+            <a:off x="6217920" y="1883664"/>
+            <a:ext cx="1664208" cy="777240"/>
           </a:xfrm>
           <a:prstGeom prst="roundRect">
             <a:avLst>
-              <a:gd name="adj" fmla="val 15000"/>
+              <a:gd name="adj" fmla="val 12000"/>
             </a:avLst>
           </a:prstGeom>
           <a:solidFill>
@@ -14878,14 +15179,14 @@
       </p:sp>
       <p:sp>
         <p:nvSpPr>
-          <p:cNvPr id="25" name="TextBox 24"/>
+          <p:cNvPr id="76" name="TextBox 75"/>
           <p:cNvSpPr txBox="1"/>
           <p:nvPr/>
         </p:nvSpPr>
         <p:spPr>
           <a:xfrm>
-            <a:off x="6245352" y="1719072"/>
-            <a:ext cx="1591056" cy="603504"/>
+            <a:off x="6245352" y="1883664"/>
+            <a:ext cx="1609344" cy="777240"/>
           </a:xfrm>
           <a:prstGeom prst="rect">
             <a:avLst/>
@@ -14893,42 +15194,38 @@
           <a:noFill/>
         </p:spPr>
         <p:txBody>
-          <a:bodyPr wrap="square" anchor="ctr" lIns="36576" rIns="36576" tIns="18288" bIns="18288">
+          <a:bodyPr wrap="square" lIns="36576" rIns="36576" tIns="18288" bIns="18288" anchor="ctr">
             <a:spAutoFit/>
           </a:bodyPr>
           <a:lstStyle/>
           <a:p>
-            <a:pPr algn="ctr">
-              <a:spcAft>
-                <a:spcPts val="0"/>
-              </a:spcAft>
-            </a:pPr>
-            <a:r>
-              <a:rPr sz="1150" b="1">
+            <a:pPr algn="ctr"/>
+            <a:r>
+              <a:rPr sz="1050" b="1">
                 <a:solidFill>
                   <a:srgbClr val="138A36"/>
                 </a:solidFill>
                 <a:latin typeface="Calibri"/>
               </a:rPr>
-              <a:t>Switches to a backup AI, then built-in rules</a:t>
-            </a:r>
-          </a:p>
-        </p:txBody>
-      </p:sp>
-      <p:sp>
-        <p:nvSpPr>
-          <p:cNvPr id="26" name="Rounded Rectangle 25"/>
+              <a:t>Switches to a backup AI, then to built-in rules; logs keep flowing</a:t>
+            </a:r>
+          </a:p>
+        </p:txBody>
+      </p:sp>
+      <p:sp>
+        <p:nvSpPr>
+          <p:cNvPr id="77" name="Rounded Rectangle 76"/>
           <p:cNvSpPr/>
           <p:nvPr/>
         </p:nvSpPr>
         <p:spPr>
           <a:xfrm>
-            <a:off x="4343400" y="2414015"/>
-            <a:ext cx="1600200" cy="603504"/>
+            <a:off x="4315968" y="2752344"/>
+            <a:ext cx="1627632" cy="777240"/>
           </a:xfrm>
           <a:prstGeom prst="roundRect">
             <a:avLst>
-              <a:gd name="adj" fmla="val 15000"/>
+              <a:gd name="adj" fmla="val 12000"/>
             </a:avLst>
           </a:prstGeom>
           <a:solidFill>
@@ -14963,14 +15260,14 @@
       </p:sp>
       <p:sp>
         <p:nvSpPr>
-          <p:cNvPr id="27" name="TextBox 26"/>
+          <p:cNvPr id="78" name="TextBox 77"/>
           <p:cNvSpPr txBox="1"/>
           <p:nvPr/>
         </p:nvSpPr>
         <p:spPr>
           <a:xfrm>
-            <a:off x="4370832" y="2414015"/>
-            <a:ext cx="1545336" cy="603504"/>
+            <a:off x="4343400" y="2752344"/>
+            <a:ext cx="1572768" cy="777240"/>
           </a:xfrm>
           <a:prstGeom prst="rect">
             <a:avLst/>
@@ -14978,16 +15275,12 @@
           <a:noFill/>
         </p:spPr>
         <p:txBody>
-          <a:bodyPr wrap="square" anchor="ctr" lIns="36576" rIns="36576" tIns="18288" bIns="18288">
+          <a:bodyPr wrap="square" lIns="36576" rIns="36576" tIns="18288" bIns="18288" anchor="ctr">
             <a:spAutoFit/>
           </a:bodyPr>
           <a:lstStyle/>
           <a:p>
-            <a:pPr algn="ctr">
-              <a:spcAft>
-                <a:spcPts val="0"/>
-              </a:spcAft>
-            </a:pPr>
+            <a:pPr algn="ctr"/>
             <a:r>
               <a:rPr sz="1150" b="1">
                 <a:solidFill>
@@ -15002,14 +15295,14 @@
       </p:sp>
       <p:sp>
         <p:nvSpPr>
-          <p:cNvPr id="28" name="TextBox 27"/>
+          <p:cNvPr id="79" name="TextBox 78"/>
           <p:cNvSpPr txBox="1"/>
           <p:nvPr/>
         </p:nvSpPr>
         <p:spPr>
           <a:xfrm>
-            <a:off x="5916168" y="2414015"/>
-            <a:ext cx="274320" cy="603504"/>
+            <a:off x="5925312" y="2752344"/>
+            <a:ext cx="292608" cy="777240"/>
           </a:xfrm>
           <a:prstGeom prst="rect">
             <a:avLst/>
@@ -15017,20 +15310,16 @@
           <a:noFill/>
         </p:spPr>
         <p:txBody>
-          <a:bodyPr wrap="square" anchor="ctr" lIns="36576" rIns="36576" tIns="18288" bIns="18288">
+          <a:bodyPr wrap="square" lIns="36576" rIns="36576" tIns="18288" bIns="18288" anchor="ctr">
             <a:spAutoFit/>
           </a:bodyPr>
           <a:lstStyle/>
           <a:p>
-            <a:pPr algn="ctr">
-              <a:spcAft>
-                <a:spcPts val="0"/>
-              </a:spcAft>
-            </a:pPr>
+            <a:pPr algn="ctr"/>
             <a:r>
               <a:rPr sz="1600" b="1">
                 <a:solidFill>
-                  <a:srgbClr val="5B6778"/>
+                  <a:srgbClr val="5F6B7A"/>
                 </a:solidFill>
                 <a:latin typeface="Calibri"/>
               </a:rPr>
@@ -15041,18 +15330,18 @@
       </p:sp>
       <p:sp>
         <p:nvSpPr>
-          <p:cNvPr id="29" name="Rounded Rectangle 28"/>
+          <p:cNvPr id="80" name="Rounded Rectangle 79"/>
           <p:cNvSpPr/>
           <p:nvPr/>
         </p:nvSpPr>
         <p:spPr>
           <a:xfrm>
-            <a:off x="6217920" y="2414015"/>
-            <a:ext cx="1645920" cy="603504"/>
+            <a:off x="6217920" y="2752344"/>
+            <a:ext cx="1664208" cy="777240"/>
           </a:xfrm>
           <a:prstGeom prst="roundRect">
             <a:avLst>
-              <a:gd name="adj" fmla="val 15000"/>
+              <a:gd name="adj" fmla="val 12000"/>
             </a:avLst>
           </a:prstGeom>
           <a:solidFill>
@@ -15087,14 +15376,14 @@
       </p:sp>
       <p:sp>
         <p:nvSpPr>
-          <p:cNvPr id="30" name="TextBox 29"/>
+          <p:cNvPr id="81" name="TextBox 80"/>
           <p:cNvSpPr txBox="1"/>
           <p:nvPr/>
         </p:nvSpPr>
         <p:spPr>
           <a:xfrm>
-            <a:off x="6245352" y="2414015"/>
-            <a:ext cx="1591056" cy="603504"/>
+            <a:off x="6245352" y="2752344"/>
+            <a:ext cx="1609344" cy="777240"/>
           </a:xfrm>
           <a:prstGeom prst="rect">
             <a:avLst/>
@@ -15102,42 +15391,38 @@
           <a:noFill/>
         </p:spPr>
         <p:txBody>
-          <a:bodyPr wrap="square" anchor="ctr" lIns="36576" rIns="36576" tIns="18288" bIns="18288">
+          <a:bodyPr wrap="square" lIns="36576" rIns="36576" tIns="18288" bIns="18288" anchor="ctr">
             <a:spAutoFit/>
           </a:bodyPr>
           <a:lstStyle/>
           <a:p>
-            <a:pPr algn="ctr">
-              <a:spcAft>
-                <a:spcPts val="0"/>
-              </a:spcAft>
-            </a:pPr>
-            <a:r>
-              <a:rPr sz="1150" b="1">
+            <a:pPr algn="ctr"/>
+            <a:r>
+              <a:rPr sz="1050" b="1">
                 <a:solidFill>
                   <a:srgbClr val="138A36"/>
                 </a:solidFill>
                 <a:latin typeface="Calibri"/>
               </a:rPr>
-              <a:t>AI runs once per log format, not per line</a:t>
-            </a:r>
-          </a:p>
-        </p:txBody>
-      </p:sp>
-      <p:sp>
-        <p:nvSpPr>
-          <p:cNvPr id="31" name="Rounded Rectangle 30"/>
+              <a:t>AI runs once per log format, not per line; 99.5% of lines skip AI</a:t>
+            </a:r>
+          </a:p>
+        </p:txBody>
+      </p:sp>
+      <p:sp>
+        <p:nvSpPr>
+          <p:cNvPr id="82" name="Rounded Rectangle 81"/>
           <p:cNvSpPr/>
           <p:nvPr/>
         </p:nvSpPr>
         <p:spPr>
           <a:xfrm>
-            <a:off x="4343400" y="3108960"/>
-            <a:ext cx="1600200" cy="603504"/>
+            <a:off x="4315968" y="3621024"/>
+            <a:ext cx="1627632" cy="777240"/>
           </a:xfrm>
           <a:prstGeom prst="roundRect">
             <a:avLst>
-              <a:gd name="adj" fmla="val 15000"/>
+              <a:gd name="adj" fmla="val 12000"/>
             </a:avLst>
           </a:prstGeom>
           <a:solidFill>
@@ -15172,14 +15457,14 @@
       </p:sp>
       <p:sp>
         <p:nvSpPr>
-          <p:cNvPr id="32" name="TextBox 31"/>
+          <p:cNvPr id="83" name="TextBox 82"/>
           <p:cNvSpPr txBox="1"/>
           <p:nvPr/>
         </p:nvSpPr>
         <p:spPr>
           <a:xfrm>
-            <a:off x="4370832" y="3108960"/>
-            <a:ext cx="1545336" cy="603504"/>
+            <a:off x="4343400" y="3621024"/>
+            <a:ext cx="1572768" cy="777240"/>
           </a:xfrm>
           <a:prstGeom prst="rect">
             <a:avLst/>
@@ -15187,16 +15472,12 @@
           <a:noFill/>
         </p:spPr>
         <p:txBody>
-          <a:bodyPr wrap="square" anchor="ctr" lIns="36576" rIns="36576" tIns="18288" bIns="18288">
+          <a:bodyPr wrap="square" lIns="36576" rIns="36576" tIns="18288" bIns="18288" anchor="ctr">
             <a:spAutoFit/>
           </a:bodyPr>
           <a:lstStyle/>
           <a:p>
-            <a:pPr algn="ctr">
-              <a:spcAft>
-                <a:spcPts val="0"/>
-              </a:spcAft>
-            </a:pPr>
+            <a:pPr algn="ctr"/>
             <a:r>
               <a:rPr sz="1150" b="1">
                 <a:solidFill>
@@ -15211,14 +15492,14 @@
       </p:sp>
       <p:sp>
         <p:nvSpPr>
-          <p:cNvPr id="33" name="TextBox 32"/>
+          <p:cNvPr id="84" name="TextBox 83"/>
           <p:cNvSpPr txBox="1"/>
           <p:nvPr/>
         </p:nvSpPr>
         <p:spPr>
           <a:xfrm>
-            <a:off x="5916168" y="3108960"/>
-            <a:ext cx="274320" cy="603504"/>
+            <a:off x="5925312" y="3621024"/>
+            <a:ext cx="292608" cy="777240"/>
           </a:xfrm>
           <a:prstGeom prst="rect">
             <a:avLst/>
@@ -15226,20 +15507,16 @@
           <a:noFill/>
         </p:spPr>
         <p:txBody>
-          <a:bodyPr wrap="square" anchor="ctr" lIns="36576" rIns="36576" tIns="18288" bIns="18288">
+          <a:bodyPr wrap="square" lIns="36576" rIns="36576" tIns="18288" bIns="18288" anchor="ctr">
             <a:spAutoFit/>
           </a:bodyPr>
           <a:lstStyle/>
           <a:p>
-            <a:pPr algn="ctr">
-              <a:spcAft>
-                <a:spcPts val="0"/>
-              </a:spcAft>
-            </a:pPr>
+            <a:pPr algn="ctr"/>
             <a:r>
               <a:rPr sz="1600" b="1">
                 <a:solidFill>
-                  <a:srgbClr val="5B6778"/>
+                  <a:srgbClr val="5F6B7A"/>
                 </a:solidFill>
                 <a:latin typeface="Calibri"/>
               </a:rPr>
@@ -15250,18 +15527,18 @@
       </p:sp>
       <p:sp>
         <p:nvSpPr>
-          <p:cNvPr id="34" name="Rounded Rectangle 33"/>
+          <p:cNvPr id="85" name="Rounded Rectangle 84"/>
           <p:cNvSpPr/>
           <p:nvPr/>
         </p:nvSpPr>
         <p:spPr>
           <a:xfrm>
-            <a:off x="6217920" y="3108960"/>
-            <a:ext cx="1645920" cy="603504"/>
+            <a:off x="6217920" y="3621024"/>
+            <a:ext cx="1664208" cy="777240"/>
           </a:xfrm>
           <a:prstGeom prst="roundRect">
             <a:avLst>
-              <a:gd name="adj" fmla="val 15000"/>
+              <a:gd name="adj" fmla="val 12000"/>
             </a:avLst>
           </a:prstGeom>
           <a:solidFill>
@@ -15296,14 +15573,14 @@
       </p:sp>
       <p:sp>
         <p:nvSpPr>
-          <p:cNvPr id="35" name="TextBox 34"/>
+          <p:cNvPr id="86" name="TextBox 85"/>
           <p:cNvSpPr txBox="1"/>
           <p:nvPr/>
         </p:nvSpPr>
         <p:spPr>
           <a:xfrm>
-            <a:off x="6245352" y="3108960"/>
-            <a:ext cx="1591056" cy="603504"/>
+            <a:off x="6245352" y="3621024"/>
+            <a:ext cx="1609344" cy="777240"/>
           </a:xfrm>
           <a:prstGeom prst="rect">
             <a:avLst/>
@@ -15311,42 +15588,38 @@
           <a:noFill/>
         </p:spPr>
         <p:txBody>
-          <a:bodyPr wrap="square" anchor="ctr" lIns="36576" rIns="36576" tIns="18288" bIns="18288">
+          <a:bodyPr wrap="square" lIns="36576" rIns="36576" tIns="18288" bIns="18288" anchor="ctr">
             <a:spAutoFit/>
           </a:bodyPr>
           <a:lstStyle/>
           <a:p>
-            <a:pPr algn="ctr">
-              <a:spcAft>
-                <a:spcPts val="0"/>
-              </a:spcAft>
-            </a:pPr>
-            <a:r>
-              <a:rPr sz="1150" b="1">
+            <a:pPr algn="ctr"/>
+            <a:r>
+              <a:rPr sz="1050" b="1">
                 <a:solidFill>
                   <a:srgbClr val="138A36"/>
                 </a:solidFill>
                 <a:latin typeface="Calibri"/>
               </a:rPr>
-              <a:t>Held for review, never lost</a:t>
-            </a:r>
-          </a:p>
-        </p:txBody>
-      </p:sp>
-      <p:sp>
-        <p:nvSpPr>
-          <p:cNvPr id="36" name="Rounded Rectangle 35"/>
+              <a:t>Held in a review queue, never dropped; accepted once confirmed</a:t>
+            </a:r>
+          </a:p>
+        </p:txBody>
+      </p:sp>
+      <p:sp>
+        <p:nvSpPr>
+          <p:cNvPr id="87" name="Rounded Rectangle 86"/>
           <p:cNvSpPr/>
           <p:nvPr/>
         </p:nvSpPr>
         <p:spPr>
           <a:xfrm>
-            <a:off x="4343400" y="3803904"/>
-            <a:ext cx="1600200" cy="603504"/>
+            <a:off x="4315968" y="4489704"/>
+            <a:ext cx="1627632" cy="777240"/>
           </a:xfrm>
           <a:prstGeom prst="roundRect">
             <a:avLst>
-              <a:gd name="adj" fmla="val 15000"/>
+              <a:gd name="adj" fmla="val 12000"/>
             </a:avLst>
           </a:prstGeom>
           <a:solidFill>
@@ -15381,14 +15654,14 @@
       </p:sp>
       <p:sp>
         <p:nvSpPr>
-          <p:cNvPr id="37" name="TextBox 36"/>
+          <p:cNvPr id="88" name="TextBox 87"/>
           <p:cNvSpPr txBox="1"/>
           <p:nvPr/>
         </p:nvSpPr>
         <p:spPr>
           <a:xfrm>
-            <a:off x="4370832" y="3803904"/>
-            <a:ext cx="1545336" cy="603504"/>
+            <a:off x="4343400" y="4489704"/>
+            <a:ext cx="1572768" cy="777240"/>
           </a:xfrm>
           <a:prstGeom prst="rect">
             <a:avLst/>
@@ -15396,16 +15669,12 @@
           <a:noFill/>
         </p:spPr>
         <p:txBody>
-          <a:bodyPr wrap="square" anchor="ctr" lIns="36576" rIns="36576" tIns="18288" bIns="18288">
+          <a:bodyPr wrap="square" lIns="36576" rIns="36576" tIns="18288" bIns="18288" anchor="ctr">
             <a:spAutoFit/>
           </a:bodyPr>
           <a:lstStyle/>
           <a:p>
-            <a:pPr algn="ctr">
-              <a:spcAft>
-                <a:spcPts val="0"/>
-              </a:spcAft>
-            </a:pPr>
+            <a:pPr algn="ctr"/>
             <a:r>
               <a:rPr sz="1150" b="1">
                 <a:solidFill>
@@ -15420,14 +15689,14 @@
       </p:sp>
       <p:sp>
         <p:nvSpPr>
-          <p:cNvPr id="38" name="TextBox 37"/>
+          <p:cNvPr id="89" name="TextBox 88"/>
           <p:cNvSpPr txBox="1"/>
           <p:nvPr/>
         </p:nvSpPr>
         <p:spPr>
           <a:xfrm>
-            <a:off x="5916168" y="3803904"/>
-            <a:ext cx="274320" cy="603504"/>
+            <a:off x="5925312" y="4489704"/>
+            <a:ext cx="292608" cy="777240"/>
           </a:xfrm>
           <a:prstGeom prst="rect">
             <a:avLst/>
@@ -15435,20 +15704,16 @@
           <a:noFill/>
         </p:spPr>
         <p:txBody>
-          <a:bodyPr wrap="square" anchor="ctr" lIns="36576" rIns="36576" tIns="18288" bIns="18288">
+          <a:bodyPr wrap="square" lIns="36576" rIns="36576" tIns="18288" bIns="18288" anchor="ctr">
             <a:spAutoFit/>
           </a:bodyPr>
           <a:lstStyle/>
           <a:p>
-            <a:pPr algn="ctr">
-              <a:spcAft>
-                <a:spcPts val="0"/>
-              </a:spcAft>
-            </a:pPr>
+            <a:pPr algn="ctr"/>
             <a:r>
               <a:rPr sz="1600" b="1">
                 <a:solidFill>
-                  <a:srgbClr val="5B6778"/>
+                  <a:srgbClr val="5F6B7A"/>
                 </a:solidFill>
                 <a:latin typeface="Calibri"/>
               </a:rPr>
@@ -15459,18 +15724,18 @@
       </p:sp>
       <p:sp>
         <p:nvSpPr>
-          <p:cNvPr id="39" name="Rounded Rectangle 38"/>
+          <p:cNvPr id="90" name="Rounded Rectangle 89"/>
           <p:cNvSpPr/>
           <p:nvPr/>
         </p:nvSpPr>
         <p:spPr>
           <a:xfrm>
-            <a:off x="6217920" y="3803904"/>
-            <a:ext cx="1645920" cy="603504"/>
+            <a:off x="6217920" y="4489704"/>
+            <a:ext cx="1664208" cy="777240"/>
           </a:xfrm>
           <a:prstGeom prst="roundRect">
             <a:avLst>
-              <a:gd name="adj" fmla="val 15000"/>
+              <a:gd name="adj" fmla="val 12000"/>
             </a:avLst>
           </a:prstGeom>
           <a:solidFill>
@@ -15505,14 +15770,14 @@
       </p:sp>
       <p:sp>
         <p:nvSpPr>
-          <p:cNvPr id="40" name="TextBox 39"/>
+          <p:cNvPr id="91" name="TextBox 90"/>
           <p:cNvSpPr txBox="1"/>
           <p:nvPr/>
         </p:nvSpPr>
         <p:spPr>
           <a:xfrm>
-            <a:off x="6245352" y="3803904"/>
-            <a:ext cx="1591056" cy="603504"/>
+            <a:off x="6245352" y="4489704"/>
+            <a:ext cx="1609344" cy="777240"/>
           </a:xfrm>
           <a:prstGeom prst="rect">
             <a:avLst/>
@@ -15520,46 +15785,42 @@
           <a:noFill/>
         </p:spPr>
         <p:txBody>
-          <a:bodyPr wrap="square" anchor="ctr" lIns="36576" rIns="36576" tIns="18288" bIns="18288">
+          <a:bodyPr wrap="square" lIns="36576" rIns="36576" tIns="18288" bIns="18288" anchor="ctr">
             <a:spAutoFit/>
           </a:bodyPr>
           <a:lstStyle/>
           <a:p>
-            <a:pPr algn="ctr">
-              <a:spcAft>
-                <a:spcPts val="0"/>
-              </a:spcAft>
-            </a:pPr>
-            <a:r>
-              <a:rPr sz="1150" b="1">
+            <a:pPr algn="ctr"/>
+            <a:r>
+              <a:rPr sz="1050" b="1">
                 <a:solidFill>
                   <a:srgbClr val="138A36"/>
                 </a:solidFill>
                 <a:latin typeface="Calibri"/>
               </a:rPr>
-              <a:t>Model retrained with one command</a:t>
-            </a:r>
-          </a:p>
-        </p:txBody>
-      </p:sp>
-      <p:sp>
-        <p:nvSpPr>
-          <p:cNvPr id="41" name="Rounded Rectangle 40"/>
+              <a:t>The format-check model is retrained with one command</a:t>
+            </a:r>
+          </a:p>
+        </p:txBody>
+      </p:sp>
+      <p:sp>
+        <p:nvSpPr>
+          <p:cNvPr id="92" name="Rounded Rectangle 91"/>
           <p:cNvSpPr/>
           <p:nvPr/>
         </p:nvSpPr>
         <p:spPr>
           <a:xfrm>
-            <a:off x="365760" y="4681728"/>
-            <a:ext cx="11503152" cy="1673352"/>
+            <a:off x="4315968" y="5358384"/>
+            <a:ext cx="1627632" cy="777240"/>
           </a:xfrm>
           <a:prstGeom prst="roundRect">
             <a:avLst>
-              <a:gd name="adj" fmla="val 6000"/>
+              <a:gd name="adj" fmla="val 12000"/>
             </a:avLst>
           </a:prstGeom>
           <a:solidFill>
-            <a:srgbClr val="F2F5FA"/>
+            <a:srgbClr val="FDECEA"/>
           </a:solidFill>
           <a:ln>
             <a:noFill/>
@@ -15590,14 +15851,14 @@
       </p:sp>
       <p:sp>
         <p:nvSpPr>
-          <p:cNvPr id="42" name="TextBox 41"/>
+          <p:cNvPr id="93" name="TextBox 92"/>
           <p:cNvSpPr txBox="1"/>
           <p:nvPr/>
         </p:nvSpPr>
         <p:spPr>
           <a:xfrm>
-            <a:off x="548640" y="4736592"/>
-            <a:ext cx="10972800" cy="292608"/>
+            <a:off x="4343400" y="5358384"/>
+            <a:ext cx="1572768" cy="777240"/>
           </a:xfrm>
           <a:prstGeom prst="rect">
             <a:avLst/>
@@ -15605,51 +15866,80 @@
           <a:noFill/>
         </p:spPr>
         <p:txBody>
-          <a:bodyPr wrap="square" anchor="t" lIns="36576" rIns="36576" tIns="18288" bIns="18288">
+          <a:bodyPr wrap="square" lIns="36576" rIns="36576" tIns="18288" bIns="18288" anchor="ctr">
             <a:spAutoFit/>
           </a:bodyPr>
           <a:lstStyle/>
           <a:p>
-            <a:pPr algn="l">
-              <a:spcAft>
-                <a:spcPts val="0"/>
-              </a:spcAft>
-            </a:pPr>
-            <a:r>
-              <a:rPr sz="1250" b="1">
-                <a:solidFill>
-                  <a:srgbClr val="0B2A5B"/>
-                </a:solidFill>
-                <a:latin typeface="Calibri"/>
-              </a:rPr>
-              <a:t>TESTED ON REAL-WORLD LOGS  (public Loghub datasets)</a:t>
-            </a:r>
-          </a:p>
-        </p:txBody>
-      </p:sp>
-      <p:sp>
-        <p:nvSpPr>
-          <p:cNvPr id="43" name="Rounded Rectangle 42"/>
+            <a:pPr algn="ctr"/>
+            <a:r>
+              <a:rPr sz="1150" b="1">
+                <a:solidFill>
+                  <a:srgbClr val="C0392B"/>
+                </a:solidFill>
+                <a:latin typeface="Calibri"/>
+              </a:rPr>
+              <a:t>Sensitive data in logs</a:t>
+            </a:r>
+          </a:p>
+        </p:txBody>
+      </p:sp>
+      <p:sp>
+        <p:nvSpPr>
+          <p:cNvPr id="94" name="TextBox 93"/>
+          <p:cNvSpPr txBox="1"/>
+          <p:nvPr/>
+        </p:nvSpPr>
+        <p:spPr>
+          <a:xfrm>
+            <a:off x="5925312" y="5358384"/>
+            <a:ext cx="292608" cy="777240"/>
+          </a:xfrm>
+          <a:prstGeom prst="rect">
+            <a:avLst/>
+          </a:prstGeom>
+          <a:noFill/>
+        </p:spPr>
+        <p:txBody>
+          <a:bodyPr wrap="square" lIns="36576" rIns="36576" tIns="18288" bIns="18288" anchor="ctr">
+            <a:spAutoFit/>
+          </a:bodyPr>
+          <a:lstStyle/>
+          <a:p>
+            <a:pPr algn="ctr"/>
+            <a:r>
+              <a:rPr sz="1600" b="1">
+                <a:solidFill>
+                  <a:srgbClr val="5F6B7A"/>
+                </a:solidFill>
+                <a:latin typeface="Calibri"/>
+              </a:rPr>
+              <a:t>→</a:t>
+            </a:r>
+          </a:p>
+        </p:txBody>
+      </p:sp>
+      <p:sp>
+        <p:nvSpPr>
+          <p:cNvPr id="95" name="Rounded Rectangle 94"/>
           <p:cNvSpPr/>
           <p:nvPr/>
         </p:nvSpPr>
         <p:spPr>
           <a:xfrm>
-            <a:off x="548640" y="5074920"/>
-            <a:ext cx="2670048" cy="1143000"/>
+            <a:off x="6217920" y="5358384"/>
+            <a:ext cx="1664208" cy="777240"/>
           </a:xfrm>
           <a:prstGeom prst="roundRect">
             <a:avLst>
-              <a:gd name="adj" fmla="val 10000"/>
+              <a:gd name="adj" fmla="val 12000"/>
             </a:avLst>
           </a:prstGeom>
           <a:solidFill>
-            <a:srgbClr val="FFFFFF"/>
+            <a:srgbClr val="E8F5EC"/>
           </a:solidFill>
-          <a:ln w="12700">
-            <a:solidFill>
-              <a:srgbClr val="D3DBE8"/>
-            </a:solidFill>
+          <a:ln>
+            <a:noFill/>
           </a:ln>
           <a:effectLst/>
         </p:spPr>
@@ -15677,14 +15967,14 @@
       </p:sp>
       <p:sp>
         <p:nvSpPr>
-          <p:cNvPr id="44" name="TextBox 43"/>
+          <p:cNvPr id="96" name="TextBox 95"/>
           <p:cNvSpPr txBox="1"/>
           <p:nvPr/>
         </p:nvSpPr>
         <p:spPr>
           <a:xfrm>
-            <a:off x="548640" y="5102352"/>
-            <a:ext cx="2670048" cy="566928"/>
+            <a:off x="6245352" y="5358384"/>
+            <a:ext cx="1609344" cy="777240"/>
           </a:xfrm>
           <a:prstGeom prst="rect">
             <a:avLst/>
@@ -15692,577 +15982,20 @@
           <a:noFill/>
         </p:spPr>
         <p:txBody>
-          <a:bodyPr wrap="square" anchor="t" lIns="36576" rIns="36576" tIns="18288" bIns="18288">
+          <a:bodyPr wrap="square" lIns="36576" rIns="36576" tIns="18288" bIns="18288" anchor="ctr">
             <a:spAutoFit/>
           </a:bodyPr>
           <a:lstStyle/>
           <a:p>
-            <a:pPr algn="ctr">
-              <a:spcAft>
-                <a:spcPts val="0"/>
-              </a:spcAft>
-            </a:pPr>
-            <a:r>
-              <a:rPr sz="2800" b="1">
-                <a:solidFill>
-                  <a:srgbClr val="1F5FBF"/>
-                </a:solidFill>
-                <a:latin typeface="Calibri"/>
-              </a:rPr>
-              <a:t>100%</a:t>
-            </a:r>
-          </a:p>
-        </p:txBody>
-      </p:sp>
-      <p:sp>
-        <p:nvSpPr>
-          <p:cNvPr id="45" name="TextBox 44"/>
-          <p:cNvSpPr txBox="1"/>
-          <p:nvPr/>
-        </p:nvSpPr>
-        <p:spPr>
-          <a:xfrm>
-            <a:off x="640080" y="5687568"/>
-            <a:ext cx="2487168" cy="457200"/>
-          </a:xfrm>
-          <a:prstGeom prst="rect">
-            <a:avLst/>
-          </a:prstGeom>
-          <a:noFill/>
-        </p:spPr>
-        <p:txBody>
-          <a:bodyPr wrap="square" anchor="t" lIns="36576" rIns="36576" tIns="18288" bIns="18288">
-            <a:spAutoFit/>
-          </a:bodyPr>
-          <a:lstStyle/>
-          <a:p>
-            <a:pPr algn="ctr">
-              <a:spcAft>
-                <a:spcPts val="0"/>
-              </a:spcAft>
-            </a:pPr>
-            <a:r>
-              <a:rPr sz="1200" b="0">
-                <a:solidFill>
-                  <a:srgbClr val="5B6778"/>
-                </a:solidFill>
-                <a:latin typeface="Calibri"/>
-              </a:rPr>
-              <a:t>log formats identified correctly</a:t>
-            </a:r>
-          </a:p>
-        </p:txBody>
-      </p:sp>
-      <p:sp>
-        <p:nvSpPr>
-          <p:cNvPr id="46" name="Rounded Rectangle 45"/>
-          <p:cNvSpPr/>
-          <p:nvPr/>
-        </p:nvSpPr>
-        <p:spPr>
-          <a:xfrm>
-            <a:off x="3364992" y="5074920"/>
-            <a:ext cx="2670048" cy="1143000"/>
-          </a:xfrm>
-          <a:prstGeom prst="roundRect">
-            <a:avLst>
-              <a:gd name="adj" fmla="val 10000"/>
-            </a:avLst>
-          </a:prstGeom>
-          <a:solidFill>
-            <a:srgbClr val="FFFFFF"/>
-          </a:solidFill>
-          <a:ln w="12700">
-            <a:solidFill>
-              <a:srgbClr val="D3DBE8"/>
-            </a:solidFill>
-          </a:ln>
-          <a:effectLst/>
-        </p:spPr>
-        <p:style>
-          <a:lnRef idx="1">
-            <a:schemeClr val="accent1"/>
-          </a:lnRef>
-          <a:fillRef idx="3">
-            <a:schemeClr val="accent1"/>
-          </a:fillRef>
-          <a:effectRef idx="2">
-            <a:schemeClr val="accent1"/>
-          </a:effectRef>
-          <a:fontRef idx="minor">
-            <a:schemeClr val="lt1"/>
-          </a:fontRef>
-        </p:style>
-        <p:txBody>
-          <a:bodyPr rtlCol="0" anchor="ctr"/>
-          <a:lstStyle/>
-          <a:p>
             <a:pPr algn="ctr"/>
-          </a:p>
-        </p:txBody>
-      </p:sp>
-      <p:sp>
-        <p:nvSpPr>
-          <p:cNvPr id="47" name="TextBox 46"/>
-          <p:cNvSpPr txBox="1"/>
-          <p:nvPr/>
-        </p:nvSpPr>
-        <p:spPr>
-          <a:xfrm>
-            <a:off x="3364992" y="5102352"/>
-            <a:ext cx="2670048" cy="566928"/>
-          </a:xfrm>
-          <a:prstGeom prst="rect">
-            <a:avLst/>
-          </a:prstGeom>
-          <a:noFill/>
-        </p:spPr>
-        <p:txBody>
-          <a:bodyPr wrap="square" anchor="t" lIns="36576" rIns="36576" tIns="18288" bIns="18288">
-            <a:spAutoFit/>
-          </a:bodyPr>
-          <a:lstStyle/>
-          <a:p>
-            <a:pPr algn="ctr">
-              <a:spcAft>
-                <a:spcPts val="0"/>
-              </a:spcAft>
-            </a:pPr>
-            <a:r>
-              <a:rPr sz="2800" b="1">
-                <a:solidFill>
-                  <a:srgbClr val="F58220"/>
-                </a:solidFill>
-                <a:latin typeface="Calibri"/>
-              </a:rPr>
-              <a:t>95.2%</a:t>
-            </a:r>
-          </a:p>
-        </p:txBody>
-      </p:sp>
-      <p:sp>
-        <p:nvSpPr>
-          <p:cNvPr id="48" name="TextBox 47"/>
-          <p:cNvSpPr txBox="1"/>
-          <p:nvPr/>
-        </p:nvSpPr>
-        <p:spPr>
-          <a:xfrm>
-            <a:off x="3456432" y="5687568"/>
-            <a:ext cx="2487168" cy="457200"/>
-          </a:xfrm>
-          <a:prstGeom prst="rect">
-            <a:avLst/>
-          </a:prstGeom>
-          <a:noFill/>
-        </p:spPr>
-        <p:txBody>
-          <a:bodyPr wrap="square" anchor="t" lIns="36576" rIns="36576" tIns="18288" bIns="18288">
-            <a:spAutoFit/>
-          </a:bodyPr>
-          <a:lstStyle/>
-          <a:p>
-            <a:pPr algn="ctr">
-              <a:spcAft>
-                <a:spcPts val="0"/>
-              </a:spcAft>
-            </a:pPr>
-            <a:r>
-              <a:rPr sz="1200" b="0">
-                <a:solidFill>
-                  <a:srgbClr val="5B6778"/>
-                </a:solidFill>
-                <a:latin typeface="Calibri"/>
-              </a:rPr>
-              <a:t>new, unseen formats caught</a:t>
-            </a:r>
-          </a:p>
-        </p:txBody>
-      </p:sp>
-      <p:sp>
-        <p:nvSpPr>
-          <p:cNvPr id="49" name="Rounded Rectangle 48"/>
-          <p:cNvSpPr/>
-          <p:nvPr/>
-        </p:nvSpPr>
-        <p:spPr>
-          <a:xfrm>
-            <a:off x="6181344" y="5074920"/>
-            <a:ext cx="2670048" cy="1143000"/>
-          </a:xfrm>
-          <a:prstGeom prst="roundRect">
-            <a:avLst>
-              <a:gd name="adj" fmla="val 10000"/>
-            </a:avLst>
-          </a:prstGeom>
-          <a:solidFill>
-            <a:srgbClr val="FFFFFF"/>
-          </a:solidFill>
-          <a:ln w="12700">
-            <a:solidFill>
-              <a:srgbClr val="D3DBE8"/>
-            </a:solidFill>
-          </a:ln>
-          <a:effectLst/>
-        </p:spPr>
-        <p:style>
-          <a:lnRef idx="1">
-            <a:schemeClr val="accent1"/>
-          </a:lnRef>
-          <a:fillRef idx="3">
-            <a:schemeClr val="accent1"/>
-          </a:fillRef>
-          <a:effectRef idx="2">
-            <a:schemeClr val="accent1"/>
-          </a:effectRef>
-          <a:fontRef idx="minor">
-            <a:schemeClr val="lt1"/>
-          </a:fontRef>
-        </p:style>
-        <p:txBody>
-          <a:bodyPr rtlCol="0" anchor="ctr"/>
-          <a:lstStyle/>
-          <a:p>
-            <a:pPr algn="ctr"/>
-          </a:p>
-        </p:txBody>
-      </p:sp>
-      <p:sp>
-        <p:nvSpPr>
-          <p:cNvPr id="50" name="TextBox 49"/>
-          <p:cNvSpPr txBox="1"/>
-          <p:nvPr/>
-        </p:nvSpPr>
-        <p:spPr>
-          <a:xfrm>
-            <a:off x="6181344" y="5102352"/>
-            <a:ext cx="2670048" cy="566928"/>
-          </a:xfrm>
-          <a:prstGeom prst="rect">
-            <a:avLst/>
-          </a:prstGeom>
-          <a:noFill/>
-        </p:spPr>
-        <p:txBody>
-          <a:bodyPr wrap="square" anchor="t" lIns="36576" rIns="36576" tIns="18288" bIns="18288">
-            <a:spAutoFit/>
-          </a:bodyPr>
-          <a:lstStyle/>
-          <a:p>
-            <a:pPr algn="ctr">
-              <a:spcAft>
-                <a:spcPts val="0"/>
-              </a:spcAft>
-            </a:pPr>
-            <a:r>
-              <a:rPr sz="2800" b="1">
+            <a:r>
+              <a:rPr sz="1050" b="1">
                 <a:solidFill>
                   <a:srgbClr val="138A36"/>
                 </a:solidFill>
                 <a:latin typeface="Calibri"/>
               </a:rPr>
-              <a:t>99.5%</a:t>
-            </a:r>
-          </a:p>
-        </p:txBody>
-      </p:sp>
-      <p:sp>
-        <p:nvSpPr>
-          <p:cNvPr id="51" name="TextBox 50"/>
-          <p:cNvSpPr txBox="1"/>
-          <p:nvPr/>
-        </p:nvSpPr>
-        <p:spPr>
-          <a:xfrm>
-            <a:off x="6272783" y="5687568"/>
-            <a:ext cx="2487168" cy="457200"/>
-          </a:xfrm>
-          <a:prstGeom prst="rect">
-            <a:avLst/>
-          </a:prstGeom>
-          <a:noFill/>
-        </p:spPr>
-        <p:txBody>
-          <a:bodyPr wrap="square" anchor="t" lIns="36576" rIns="36576" tIns="18288" bIns="18288">
-            <a:spAutoFit/>
-          </a:bodyPr>
-          <a:lstStyle/>
-          <a:p>
-            <a:pPr algn="ctr">
-              <a:spcAft>
-                <a:spcPts val="0"/>
-              </a:spcAft>
-            </a:pPr>
-            <a:r>
-              <a:rPr sz="1200" b="0">
-                <a:solidFill>
-                  <a:srgbClr val="5B6778"/>
-                </a:solidFill>
-                <a:latin typeface="Calibri"/>
-              </a:rPr>
-              <a:t>logs processed without calling AI</a:t>
-            </a:r>
-          </a:p>
-        </p:txBody>
-      </p:sp>
-      <p:sp>
-        <p:nvSpPr>
-          <p:cNvPr id="52" name="Rounded Rectangle 51"/>
-          <p:cNvSpPr/>
-          <p:nvPr/>
-        </p:nvSpPr>
-        <p:spPr>
-          <a:xfrm>
-            <a:off x="8997696" y="5074920"/>
-            <a:ext cx="2670048" cy="1143000"/>
-          </a:xfrm>
-          <a:prstGeom prst="roundRect">
-            <a:avLst>
-              <a:gd name="adj" fmla="val 10000"/>
-            </a:avLst>
-          </a:prstGeom>
-          <a:solidFill>
-            <a:srgbClr val="FFFFFF"/>
-          </a:solidFill>
-          <a:ln w="12700">
-            <a:solidFill>
-              <a:srgbClr val="D3DBE8"/>
-            </a:solidFill>
-          </a:ln>
-          <a:effectLst/>
-        </p:spPr>
-        <p:style>
-          <a:lnRef idx="1">
-            <a:schemeClr val="accent1"/>
-          </a:lnRef>
-          <a:fillRef idx="3">
-            <a:schemeClr val="accent1"/>
-          </a:fillRef>
-          <a:effectRef idx="2">
-            <a:schemeClr val="accent1"/>
-          </a:effectRef>
-          <a:fontRef idx="minor">
-            <a:schemeClr val="lt1"/>
-          </a:fontRef>
-        </p:style>
-        <p:txBody>
-          <a:bodyPr rtlCol="0" anchor="ctr"/>
-          <a:lstStyle/>
-          <a:p>
-            <a:pPr algn="ctr"/>
-          </a:p>
-        </p:txBody>
-      </p:sp>
-      <p:sp>
-        <p:nvSpPr>
-          <p:cNvPr id="53" name="TextBox 52"/>
-          <p:cNvSpPr txBox="1"/>
-          <p:nvPr/>
-        </p:nvSpPr>
-        <p:spPr>
-          <a:xfrm>
-            <a:off x="8997696" y="5102352"/>
-            <a:ext cx="2670048" cy="566928"/>
-          </a:xfrm>
-          <a:prstGeom prst="rect">
-            <a:avLst/>
-          </a:prstGeom>
-          <a:noFill/>
-        </p:spPr>
-        <p:txBody>
-          <a:bodyPr wrap="square" anchor="t" lIns="36576" rIns="36576" tIns="18288" bIns="18288">
-            <a:spAutoFit/>
-          </a:bodyPr>
-          <a:lstStyle/>
-          <a:p>
-            <a:pPr algn="ctr">
-              <a:spcAft>
-                <a:spcPts val="0"/>
-              </a:spcAft>
-            </a:pPr>
-            <a:r>
-              <a:rPr sz="2800" b="1">
-                <a:solidFill>
-                  <a:srgbClr val="6A3FB5"/>
-                </a:solidFill>
-                <a:latin typeface="Calibri"/>
-              </a:rPr>
-              <a:t>0.28 ms</a:t>
-            </a:r>
-          </a:p>
-        </p:txBody>
-      </p:sp>
-      <p:sp>
-        <p:nvSpPr>
-          <p:cNvPr id="54" name="TextBox 53"/>
-          <p:cNvSpPr txBox="1"/>
-          <p:nvPr/>
-        </p:nvSpPr>
-        <p:spPr>
-          <a:xfrm>
-            <a:off x="9089136" y="5687568"/>
-            <a:ext cx="2487168" cy="457200"/>
-          </a:xfrm>
-          <a:prstGeom prst="rect">
-            <a:avLst/>
-          </a:prstGeom>
-          <a:noFill/>
-        </p:spPr>
-        <p:txBody>
-          <a:bodyPr wrap="square" anchor="t" lIns="36576" rIns="36576" tIns="18288" bIns="18288">
-            <a:spAutoFit/>
-          </a:bodyPr>
-          <a:lstStyle/>
-          <a:p>
-            <a:pPr algn="ctr">
-              <a:spcAft>
-                <a:spcPts val="0"/>
-              </a:spcAft>
-            </a:pPr>
-            <a:r>
-              <a:rPr sz="1200" b="0">
-                <a:solidFill>
-                  <a:srgbClr val="5B6778"/>
-                </a:solidFill>
-                <a:latin typeface="Calibri"/>
-              </a:rPr>
-              <a:t>to process one log line</a:t>
-            </a:r>
-          </a:p>
-        </p:txBody>
-      </p:sp>
-      <p:sp>
-        <p:nvSpPr>
-          <p:cNvPr id="55" name="Oval 54"/>
-          <p:cNvSpPr/>
-          <p:nvPr/>
-        </p:nvSpPr>
-        <p:spPr>
-          <a:xfrm>
-            <a:off x="320040" y="182880"/>
-            <a:ext cx="1463040" cy="731520"/>
-          </a:xfrm>
-          <a:prstGeom prst="ellipse">
-            <a:avLst/>
-          </a:prstGeom>
-          <a:noFill/>
-          <a:ln w="25400">
-            <a:solidFill>
-              <a:srgbClr val="8064A2"/>
-            </a:solidFill>
-          </a:ln>
-          <a:effectLst/>
-        </p:spPr>
-        <p:style>
-          <a:lnRef idx="1">
-            <a:schemeClr val="accent1"/>
-          </a:lnRef>
-          <a:fillRef idx="3">
-            <a:schemeClr val="accent1"/>
-          </a:fillRef>
-          <a:effectRef idx="2">
-            <a:schemeClr val="accent1"/>
-          </a:effectRef>
-          <a:fontRef idx="minor">
-            <a:schemeClr val="lt1"/>
-          </a:fontRef>
-        </p:style>
-        <p:txBody>
-          <a:bodyPr rtlCol="0" anchor="ctr" wrap="square" lIns="45720" rIns="45720" tIns="18288" bIns="18288"/>
-          <a:lstStyle/>
-          <a:p>
-            <a:pPr algn="ctr"/>
-            <a:r>
-              <a:rPr sz="1200" b="1">
-                <a:solidFill>
-                  <a:srgbClr val="F58220"/>
-                </a:solidFill>
-                <a:latin typeface="Calibri"/>
-              </a:rPr>
-              <a:t>[Team Name]</a:t>
-            </a:r>
-          </a:p>
-        </p:txBody>
-      </p:sp>
-      <p:pic>
-        <p:nvPicPr>
-          <p:cNvPr id="56" name="Picture 55" descr="sih_icon_s.png"/>
-          <p:cNvPicPr>
-            <a:picLocks noChangeAspect="1"/>
-          </p:cNvPicPr>
-          <p:nvPr/>
-        </p:nvPicPr>
-        <p:blipFill>
-          <a:blip r:embed="rId3"/>
-          <a:stretch>
-            <a:fillRect/>
-          </a:stretch>
-        </p:blipFill>
-        <p:spPr>
-          <a:xfrm>
-            <a:off x="10076688" y="91440"/>
-            <a:ext cx="676894" cy="822960"/>
-          </a:xfrm>
-          <a:prstGeom prst="rect">
-            <a:avLst/>
-          </a:prstGeom>
-        </p:spPr>
-      </p:pic>
-      <p:sp>
-        <p:nvSpPr>
-          <p:cNvPr id="57" name="TextBox 56"/>
-          <p:cNvSpPr txBox="1"/>
-          <p:nvPr/>
-        </p:nvSpPr>
-        <p:spPr>
-          <a:xfrm>
-            <a:off x="10789920" y="109728"/>
-            <a:ext cx="1371600" cy="777240"/>
-          </a:xfrm>
-          <a:prstGeom prst="rect">
-            <a:avLst/>
-          </a:prstGeom>
-          <a:noFill/>
-        </p:spPr>
-        <p:txBody>
-          <a:bodyPr wrap="square" lIns="36576" rIns="36576" tIns="18288" bIns="18288" anchor="t">
-            <a:spAutoFit/>
-          </a:bodyPr>
-          <a:lstStyle/>
-          <a:p>
-            <a:pPr algn="ctr"/>
-            <a:r>
-              <a:rPr sz="1250" b="1">
-                <a:solidFill>
-                  <a:srgbClr val="455A64"/>
-                </a:solidFill>
-                <a:latin typeface="Calibri"/>
-              </a:rPr>
-              <a:t>SMART INDIA</a:t>
-            </a:r>
-          </a:p>
-          <a:p>
-            <a:pPr algn="ctr"/>
-            <a:r>
-              <a:rPr sz="1250" b="1">
-                <a:solidFill>
-                  <a:srgbClr val="455A64"/>
-                </a:solidFill>
-                <a:latin typeface="Calibri"/>
-              </a:rPr>
-              <a:t>HACKATHON</a:t>
-            </a:r>
-          </a:p>
-          <a:p>
-            <a:pPr algn="ctr"/>
-            <a:r>
-              <a:rPr sz="1250" b="1">
-                <a:solidFill>
-                  <a:srgbClr val="455A64"/>
-                </a:solidFill>
-                <a:latin typeface="Calibri"/>
-              </a:rPr>
-              <a:t>2026</a:t>
+              <a:t>Runs on-premise; self-hosted AI planned so nothing leaves the network</a:t>
             </a:r>
           </a:p>
         </p:txBody>

</xml_diff>

<commit_message>
PPT: rewrite feasibility points; humble wording, remove test/benchmark claims
Co-authored-by: arena-agent <297053741+arena-agent@users.noreply.github.com>
</commit_message>
<xml_diff>
--- a/presentation/SIH2026_Idea_Submission.pptx
+++ b/presentation/SIH2026_Idea_Submission.pptx
@@ -8136,26 +8136,7 @@
                 </a:solidFill>
                 <a:latin typeface="Calibri"/>
               </a:rPr>
-              <a:t>LLM flexibility,</a:t>
-            </a:r>
-          </a:p>
-          <a:p>
-            <a:pPr algn="ctr">
-              <a:lnSpc>
-                <a:spcPct val="90000"/>
-              </a:lnSpc>
-              <a:spcAft>
-                <a:spcPts val="0"/>
-              </a:spcAft>
-            </a:pPr>
-            <a:r>
-              <a:rPr sz="1400" b="1" i="0">
-                <a:solidFill>
-                  <a:srgbClr val="1F5FBF"/>
-                </a:solidFill>
-                <a:latin typeface="Calibri"/>
-              </a:rPr>
-              <a:t>regex speed</a:t>
+              <a:t>Fast and flexible</a:t>
             </a:r>
           </a:p>
         </p:txBody>
@@ -8197,7 +8178,7 @@
                 </a:solidFill>
                 <a:latin typeface="Calibri"/>
               </a:rPr>
-              <a:t>99.5% of lines never touch the AI engine; 0.28 ms/line</a:t>
+              <a:t>Most lines are handled by fast saved rules; AI is used only when truly needed</a:t>
             </a:r>
           </a:p>
         </p:txBody>
@@ -8331,7 +8312,7 @@
                 </a:solidFill>
                 <a:latin typeface="Calibri"/>
               </a:rPr>
-              <a:t>98% fewer</a:t>
+              <a:t>Far fewer</a:t>
             </a:r>
           </a:p>
           <a:p>
@@ -8350,7 +8331,7 @@
                 </a:solidFill>
                 <a:latin typeface="Calibri"/>
               </a:rPr>
-              <a:t>LLM calls</a:t>
+              <a:t>AI calls</a:t>
             </a:r>
           </a:p>
         </p:txBody>
@@ -8392,7 +8373,7 @@
                 </a:solidFill>
                 <a:latin typeface="Calibri"/>
               </a:rPr>
-              <a:t>on a flood of new formats, thanks to quarantine + graduation</a:t>
+              <a:t>A new format is learned once, then reused for every similar line</a:t>
             </a:r>
           </a:p>
         </p:txBody>
@@ -8526,7 +8507,7 @@
                 </a:solidFill>
                 <a:latin typeface="Calibri"/>
               </a:rPr>
-              <a:t>Catches never-</a:t>
+              <a:t>Flags never-</a:t>
             </a:r>
           </a:p>
           <a:p>
@@ -8587,7 +8568,7 @@
                 </a:solidFill>
                 <a:latin typeface="Calibri"/>
               </a:rPr>
-              <a:t>95.2% recall on real systems it was never trained on</a:t>
+              <a:t>Designed to flag log formats it has never seen before, for human review</a:t>
             </a:r>
           </a:p>
         </p:txBody>
@@ -8721,7 +8702,7 @@
                 </a:solidFill>
                 <a:latin typeface="Calibri"/>
               </a:rPr>
-              <a:t>Zero-risk</a:t>
+              <a:t>Low-risk</a:t>
             </a:r>
           </a:p>
           <a:p>
@@ -8782,7 +8763,7 @@
                 </a:solidFill>
                 <a:latin typeface="Calibri"/>
               </a:rPr>
-              <a:t>shadow mode first; works with no API key (heuristic fallback)</a:t>
+              <a:t>Shadow mode first; works with no API key (heuristic fallback)</a:t>
             </a:r>
           </a:p>
         </p:txBody>
@@ -9767,7 +9748,7 @@
                 </a:solidFill>
                 <a:latin typeface="Calibri"/>
               </a:rPr>
-              <a:t>99.5% of lines skip the LLM</a:t>
+              <a:t>most lines skip the AI</a:t>
             </a:r>
           </a:p>
         </p:txBody>
@@ -10837,7 +10818,7 @@
                 </a:solidFill>
                 <a:latin typeface="Calibri"/>
               </a:rPr>
-              <a:t>~0.016 ms / line</a:t>
+              <a:t>groups similar lines</a:t>
             </a:r>
           </a:p>
         </p:txBody>
@@ -12937,7 +12918,7 @@
                 </a:solidFill>
                 <a:latin typeface="Calibri"/>
               </a:rPr>
-              <a:t>Accuracy reports</a:t>
+              <a:t>Data analysis</a:t>
             </a:r>
           </a:p>
         </p:txBody>
@@ -14241,13 +14222,13 @@
                 </a:solidFill>
                 <a:latin typeface="Calibri"/>
               </a:rPr>
-              <a:t>Proven technology</a:t>
-            </a:r>
-          </a:p>
-          <a:p>
-            <a:pPr algn="l">
+              <a:t>Built on mature open-source tools</a:t>
+            </a:r>
+          </a:p>
+          <a:p>
+            <a:pPr>
               <a:spcAft>
-                <a:spcPts val="1100"/>
+                <a:spcPts val="1000"/>
               </a:spcAft>
             </a:pPr>
             <a:r>
@@ -14257,11 +14238,11 @@
                 </a:solidFill>
                 <a:latin typeface="Calibri"/>
               </a:rPr>
-              <a:t>Built on free, trusted open-source tools (Python, FastAPI, Drain3, scikit-learn) that are used worldwide.</a:t>
-            </a:r>
-          </a:p>
-          <a:p>
-            <a:pPr algn="l">
+              <a:t>Python, FastAPI, Drain3 and scikit-learn are free and widely used, so nothing new has to be invented.</a:t>
+            </a:r>
+          </a:p>
+          <a:p>
+            <a:pPr>
               <a:spcAft>
                 <a:spcPts val="200"/>
               </a:spcAft>
@@ -14282,13 +14263,13 @@
                 </a:solidFill>
                 <a:latin typeface="Calibri"/>
               </a:rPr>
-              <a:t>Low running cost</a:t>
-            </a:r>
-          </a:p>
-          <a:p>
-            <a:pPr algn="l">
+              <a:t>Low, predictable cost</a:t>
+            </a:r>
+          </a:p>
+          <a:p>
+            <a:pPr>
               <a:spcAft>
-                <a:spcPts val="1100"/>
+                <a:spcPts val="1000"/>
               </a:spcAft>
             </a:pPr>
             <a:r>
@@ -14298,11 +14279,11 @@
                 </a:solidFill>
                 <a:latin typeface="Calibri"/>
               </a:rPr>
-              <a:t>AI is called only when a brand-new log format appears, so the bill stays small even at millions of logs a day.</a:t>
-            </a:r>
-          </a:p>
-          <a:p>
-            <a:pPr algn="l">
+              <a:t>AI is needed only when a new log format first appears; everyday logs reuse saved rules.</a:t>
+            </a:r>
+          </a:p>
+          <a:p>
+            <a:pPr>
               <a:spcAft>
                 <a:spcPts val="200"/>
               </a:spcAft>
@@ -14323,13 +14304,13 @@
                 </a:solidFill>
                 <a:latin typeface="Calibri"/>
               </a:rPr>
-              <a:t>Easy to adopt</a:t>
-            </a:r>
-          </a:p>
-          <a:p>
-            <a:pPr algn="l">
+              <a:t>Fits into existing setups</a:t>
+            </a:r>
+          </a:p>
+          <a:p>
+            <a:pPr>
               <a:spcAft>
-                <a:spcPts val="1100"/>
+                <a:spcPts val="1000"/>
               </a:spcAft>
             </a:pPr>
             <a:r>
@@ -14339,11 +14320,11 @@
                 </a:solidFill>
                 <a:latin typeface="Calibri"/>
               </a:rPr>
-              <a:t>Any log source connects through a simple web API or a Bash script. No parser writing or coding is needed.</a:t>
-            </a:r>
-          </a:p>
-          <a:p>
-            <a:pPr algn="l">
+              <a:t>Works alongside current tools; logs arrive through a simple web API or a small script.</a:t>
+            </a:r>
+          </a:p>
+          <a:p>
+            <a:pPr>
               <a:spcAft>
                 <a:spcPts val="200"/>
               </a:spcAft>
@@ -14364,13 +14345,13 @@
                 </a:solidFill>
                 <a:latin typeface="Calibri"/>
               </a:rPr>
-              <a:t>Data available</a:t>
-            </a:r>
-          </a:p>
-          <a:p>
-            <a:pPr algn="l">
+              <a:t>Open data to build on</a:t>
+            </a:r>
+          </a:p>
+          <a:p>
+            <a:pPr>
               <a:spcAft>
-                <a:spcPts val="1100"/>
+                <a:spcPts val="1000"/>
               </a:spcAft>
             </a:pPr>
             <a:r>
@@ -14380,11 +14361,11 @@
                 </a:solidFill>
                 <a:latin typeface="Calibri"/>
               </a:rPr>
-              <a:t>Tested on public real-world log datasets (Loghub) from many systems. No private or secret data is needed.</a:t>
-            </a:r>
-          </a:p>
-          <a:p>
-            <a:pPr algn="l">
+              <a:t>Public log datasets from the research community let us develop it without private data.</a:t>
+            </a:r>
+          </a:p>
+          <a:p>
+            <a:pPr>
               <a:spcAft>
                 <a:spcPts val="200"/>
               </a:spcAft>
@@ -14405,11 +14386,15 @@
                 </a:solidFill>
                 <a:latin typeface="Calibri"/>
               </a:rPr>
-              <a:t>Safe rollout</a:t>
-            </a:r>
-          </a:p>
-          <a:p>
-            <a:pPr algn="l"/>
+              <a:t>Gradual, low-risk adoption</a:t>
+            </a:r>
+          </a:p>
+          <a:p>
+            <a:pPr>
+              <a:spcAft>
+                <a:spcPts val="1000"/>
+              </a:spcAft>
+            </a:pPr>
             <a:r>
               <a:rPr sz="1150" b="0">
                 <a:solidFill>
@@ -14417,7 +14402,48 @@
                 </a:solidFill>
                 <a:latin typeface="Calibri"/>
               </a:rPr>
-              <a:t>Starts in watch-only 'shadow mode', so teams can check results before switching it on fully.</a:t>
+              <a:t>Can run in watch-only 'shadow mode' next to current tools before teams rely on it.</a:t>
+            </a:r>
+          </a:p>
+          <a:p>
+            <a:pPr>
+              <a:spcAft>
+                <a:spcPts val="200"/>
+              </a:spcAft>
+            </a:pPr>
+            <a:r>
+              <a:rPr sz="1150" b="1">
+                <a:solidFill>
+                  <a:srgbClr val="138A36"/>
+                </a:solidFill>
+                <a:latin typeface="Calibri"/>
+              </a:rPr>
+              <a:t>✔ </a:t>
+            </a:r>
+            <a:r>
+              <a:rPr sz="1300" b="1">
+                <a:solidFill>
+                  <a:srgbClr val="0B2A5B"/>
+                </a:solidFill>
+                <a:latin typeface="Calibri"/>
+              </a:rPr>
+              <a:t>Simple, modular design</a:t>
+            </a:r>
+          </a:p>
+          <a:p>
+            <a:pPr>
+              <a:spcAft>
+                <a:spcPts val="0"/>
+              </a:spcAft>
+            </a:pPr>
+            <a:r>
+              <a:rPr sz="1150" b="0">
+                <a:solidFill>
+                  <a:srgbClr val="1E2530"/>
+                </a:solidFill>
+                <a:latin typeface="Calibri"/>
+              </a:rPr>
+              <a:t>Collect → group → learn → output: each part can be improved on its own.</a:t>
             </a:r>
           </a:p>
         </p:txBody>
@@ -15404,7 +15430,7 @@
                 </a:solidFill>
                 <a:latin typeface="Calibri"/>
               </a:rPr>
-              <a:t>AI runs once per log format, not per line; 99.5% of lines skip AI</a:t>
+              <a:t>AI runs once per log format, not per line; most lines never need AI</a:t>
             </a:r>
           </a:p>
         </p:txBody>
@@ -17909,7 +17935,7 @@
                 </a:solidFill>
                 <a:latin typeface="Calibri"/>
               </a:rPr>
-              <a:t>Illustrative estimate for ~50 log sources (engineer ₹5,000/day, typical AI pricing); our AI-call rate is measured in our benchmark.</a:t>
+              <a:t>Illustrative estimate for ~50 log sources (engineer ₹5,000/day, typical AI pricing); actual results will vary by organisation.</a:t>
             </a:r>
           </a:p>
         </p:txBody>

</xml_diff>

<commit_message>
PPT slide 3: add brief 'why used' to each technology tile
Co-authored-by: arena-agent <297053741+arena-agent@users.noreply.github.com>
</commit_message>
<xml_diff>
--- a/presentation/SIH2026_Idea_Submission.pptx
+++ b/presentation/SIH2026_Idea_Submission.pptx
@@ -10276,7 +10276,7 @@
         </p:nvSpPr>
         <p:spPr>
           <a:xfrm>
-            <a:off x="365760" y="3794760"/>
+            <a:off x="365760" y="4087368"/>
             <a:ext cx="4937760" cy="292608"/>
           </a:xfrm>
           <a:prstGeom prst="rect">
@@ -10318,7 +10318,7 @@
         </p:nvSpPr>
         <p:spPr>
           <a:xfrm>
-            <a:off x="402336" y="4096512"/>
+            <a:off x="402336" y="4389120"/>
             <a:ext cx="822960" cy="32004"/>
           </a:xfrm>
           <a:prstGeom prst="rect">
@@ -11979,7 +11979,7 @@
         <p:spPr>
           <a:xfrm>
             <a:off x="365760" y="1444752"/>
-            <a:ext cx="1591056" cy="676656"/>
+            <a:ext cx="1591056" cy="786384"/>
           </a:xfrm>
           <a:prstGeom prst="roundRect">
             <a:avLst>
@@ -12034,7 +12034,7 @@
         </p:blipFill>
         <p:spPr>
           <a:xfrm>
-            <a:off x="457200" y="1572768"/>
+            <a:off x="457200" y="1627632"/>
             <a:ext cx="420624" cy="420624"/>
           </a:xfrm>
           <a:prstGeom prst="rect">
@@ -12050,8 +12050,8 @@
         </p:nvSpPr>
         <p:spPr>
           <a:xfrm>
-            <a:off x="932688" y="1517904"/>
-            <a:ext cx="1005840" cy="274320"/>
+            <a:off x="932688" y="1499616"/>
+            <a:ext cx="1005840" cy="256032"/>
           </a:xfrm>
           <a:prstGeom prst="rect">
             <a:avLst/>
@@ -12089,8 +12089,8 @@
         </p:nvSpPr>
         <p:spPr>
           <a:xfrm>
-            <a:off x="932688" y="1773936"/>
-            <a:ext cx="1005840" cy="329184"/>
+            <a:off x="932688" y="1737360"/>
+            <a:ext cx="1042416" cy="475488"/>
           </a:xfrm>
           <a:prstGeom prst="rect">
             <a:avLst/>
@@ -12109,13 +12109,22 @@
               </a:spcAft>
             </a:pPr>
             <a:r>
-              <a:rPr sz="950" b="0">
-                <a:solidFill>
-                  <a:srgbClr val="5B6778"/>
-                </a:solidFill>
-                <a:latin typeface="Calibri"/>
-              </a:rPr>
-              <a:t>Core language</a:t>
+              <a:rPr sz="850" b="1">
+                <a:solidFill>
+                  <a:srgbClr val="1F5FBF"/>
+                </a:solidFill>
+                <a:latin typeface="Calibri"/>
+              </a:rPr>
+              <a:t>Core language: </a:t>
+            </a:r>
+            <a:r>
+              <a:rPr sz="850" b="0">
+                <a:solidFill>
+                  <a:srgbClr val="5F6B7A"/>
+                </a:solidFill>
+                <a:latin typeface="Calibri"/>
+              </a:rPr>
+              <a:t>simple, huge library support</a:t>
             </a:r>
           </a:p>
         </p:txBody>
@@ -12129,7 +12138,7 @@
         <p:spPr>
           <a:xfrm>
             <a:off x="2039112" y="1444752"/>
-            <a:ext cx="1591056" cy="676656"/>
+            <a:ext cx="1591056" cy="786384"/>
           </a:xfrm>
           <a:prstGeom prst="roundRect">
             <a:avLst>
@@ -12184,7 +12193,7 @@
         </p:blipFill>
         <p:spPr>
           <a:xfrm>
-            <a:off x="2130552" y="1572768"/>
+            <a:off x="2130552" y="1627632"/>
             <a:ext cx="420624" cy="420624"/>
           </a:xfrm>
           <a:prstGeom prst="rect">
@@ -12200,8 +12209,8 @@
         </p:nvSpPr>
         <p:spPr>
           <a:xfrm>
-            <a:off x="2606040" y="1517904"/>
-            <a:ext cx="1005840" cy="274320"/>
+            <a:off x="2606040" y="1499616"/>
+            <a:ext cx="1005840" cy="256032"/>
           </a:xfrm>
           <a:prstGeom prst="rect">
             <a:avLst/>
@@ -12239,8 +12248,8 @@
         </p:nvSpPr>
         <p:spPr>
           <a:xfrm>
-            <a:off x="2606040" y="1773936"/>
-            <a:ext cx="1005840" cy="329184"/>
+            <a:off x="2606040" y="1737360"/>
+            <a:ext cx="1042416" cy="475488"/>
           </a:xfrm>
           <a:prstGeom prst="rect">
             <a:avLst/>
@@ -12259,13 +12268,22 @@
               </a:spcAft>
             </a:pPr>
             <a:r>
-              <a:rPr sz="950" b="0">
-                <a:solidFill>
-                  <a:srgbClr val="5B6778"/>
-                </a:solidFill>
-                <a:latin typeface="Calibri"/>
-              </a:rPr>
-              <a:t>REST API backend</a:t>
+              <a:rPr sz="850" b="1">
+                <a:solidFill>
+                  <a:srgbClr val="1F5FBF"/>
+                </a:solidFill>
+                <a:latin typeface="Calibri"/>
+              </a:rPr>
+              <a:t>Web API: </a:t>
+            </a:r>
+            <a:r>
+              <a:rPr sz="850" b="0">
+                <a:solidFill>
+                  <a:srgbClr val="5F6B7A"/>
+                </a:solidFill>
+                <a:latin typeface="Calibri"/>
+              </a:rPr>
+              <a:t>fast and easy for any tool to send logs to</a:t>
             </a:r>
           </a:p>
         </p:txBody>
@@ -12279,7 +12297,7 @@
         <p:spPr>
           <a:xfrm>
             <a:off x="3712464" y="1444752"/>
-            <a:ext cx="1591056" cy="676656"/>
+            <a:ext cx="1591056" cy="786384"/>
           </a:xfrm>
           <a:prstGeom prst="roundRect">
             <a:avLst>
@@ -12326,7 +12344,7 @@
         </p:nvSpPr>
         <p:spPr>
           <a:xfrm>
-            <a:off x="3803904" y="1572768"/>
+            <a:off x="3803904" y="1627632"/>
             <a:ext cx="420624" cy="420624"/>
           </a:xfrm>
           <a:prstGeom prst="ellipse">
@@ -12379,8 +12397,8 @@
         </p:nvSpPr>
         <p:spPr>
           <a:xfrm>
-            <a:off x="4279392" y="1517904"/>
-            <a:ext cx="1005840" cy="274320"/>
+            <a:off x="4279392" y="1499616"/>
+            <a:ext cx="1005840" cy="256032"/>
           </a:xfrm>
           <a:prstGeom prst="rect">
             <a:avLst/>
@@ -12418,8 +12436,8 @@
         </p:nvSpPr>
         <p:spPr>
           <a:xfrm>
-            <a:off x="4279392" y="1773936"/>
-            <a:ext cx="1005840" cy="329184"/>
+            <a:off x="4279392" y="1737360"/>
+            <a:ext cx="1042416" cy="475488"/>
           </a:xfrm>
           <a:prstGeom prst="rect">
             <a:avLst/>
@@ -12438,13 +12456,22 @@
               </a:spcAft>
             </a:pPr>
             <a:r>
-              <a:rPr sz="950" b="0">
-                <a:solidFill>
-                  <a:srgbClr val="5B6778"/>
-                </a:solidFill>
-                <a:latin typeface="Calibri"/>
-              </a:rPr>
-              <a:t>Groups similar log lines</a:t>
+              <a:rPr sz="850" b="1">
+                <a:solidFill>
+                  <a:srgbClr val="1F5FBF"/>
+                </a:solidFill>
+                <a:latin typeface="Calibri"/>
+              </a:rPr>
+              <a:t>Groups similar lines: </a:t>
+            </a:r>
+            <a:r>
+              <a:rPr sz="850" b="0">
+                <a:solidFill>
+                  <a:srgbClr val="5F6B7A"/>
+                </a:solidFill>
+                <a:latin typeface="Calibri"/>
+              </a:rPr>
+              <a:t>learns log patterns on the fly</a:t>
             </a:r>
           </a:p>
         </p:txBody>
@@ -12457,8 +12484,8 @@
         </p:nvSpPr>
         <p:spPr>
           <a:xfrm>
-            <a:off x="365760" y="2203704"/>
-            <a:ext cx="1591056" cy="676656"/>
+            <a:off x="365760" y="2295144"/>
+            <a:ext cx="1591056" cy="786384"/>
           </a:xfrm>
           <a:prstGeom prst="roundRect">
             <a:avLst>
@@ -12513,7 +12540,7 @@
         </p:blipFill>
         <p:spPr>
           <a:xfrm>
-            <a:off x="457200" y="2331720"/>
+            <a:off x="457200" y="2478024"/>
             <a:ext cx="420624" cy="420624"/>
           </a:xfrm>
           <a:prstGeom prst="rect">
@@ -12529,8 +12556,8 @@
         </p:nvSpPr>
         <p:spPr>
           <a:xfrm>
-            <a:off x="932688" y="2276856"/>
-            <a:ext cx="1005840" cy="274320"/>
+            <a:off x="932688" y="2350008"/>
+            <a:ext cx="1005840" cy="256032"/>
           </a:xfrm>
           <a:prstGeom prst="rect">
             <a:avLst/>
@@ -12568,8 +12595,8 @@
         </p:nvSpPr>
         <p:spPr>
           <a:xfrm>
-            <a:off x="932688" y="2532888"/>
-            <a:ext cx="1005840" cy="329184"/>
+            <a:off x="932688" y="2587752"/>
+            <a:ext cx="1042416" cy="475488"/>
           </a:xfrm>
           <a:prstGeom prst="rect">
             <a:avLst/>
@@ -12588,13 +12615,22 @@
               </a:spcAft>
             </a:pPr>
             <a:r>
-              <a:rPr sz="950" b="0">
-                <a:solidFill>
-                  <a:srgbClr val="5B6778"/>
-                </a:solidFill>
-                <a:latin typeface="Calibri"/>
-              </a:rPr>
-              <a:t>ML: spots new formats</a:t>
+              <a:rPr sz="850" b="1">
+                <a:solidFill>
+                  <a:srgbClr val="1F5FBF"/>
+                </a:solidFill>
+                <a:latin typeface="Calibri"/>
+              </a:rPr>
+              <a:t>ML model: </a:t>
+            </a:r>
+            <a:r>
+              <a:rPr sz="850" b="0">
+                <a:solidFill>
+                  <a:srgbClr val="5F6B7A"/>
+                </a:solidFill>
+                <a:latin typeface="Calibri"/>
+              </a:rPr>
+              <a:t>spots new, unknown log formats cheaply</a:t>
             </a:r>
           </a:p>
         </p:txBody>
@@ -12607,8 +12643,8 @@
         </p:nvSpPr>
         <p:spPr>
           <a:xfrm>
-            <a:off x="2039112" y="2203704"/>
-            <a:ext cx="1591056" cy="676656"/>
+            <a:off x="2039112" y="2295144"/>
+            <a:ext cx="1591056" cy="786384"/>
           </a:xfrm>
           <a:prstGeom prst="roundRect">
             <a:avLst>
@@ -12663,7 +12699,7 @@
         </p:blipFill>
         <p:spPr>
           <a:xfrm>
-            <a:off x="2093976" y="2295144"/>
+            <a:off x="2093976" y="2441448"/>
             <a:ext cx="292608" cy="292608"/>
           </a:xfrm>
           <a:prstGeom prst="rect">
@@ -12687,7 +12723,7 @@
         </p:blipFill>
         <p:spPr>
           <a:xfrm>
-            <a:off x="2276856" y="2514600"/>
+            <a:off x="2276856" y="2660904"/>
             <a:ext cx="292608" cy="292608"/>
           </a:xfrm>
           <a:prstGeom prst="rect">
@@ -12703,8 +12739,8 @@
         </p:nvSpPr>
         <p:spPr>
           <a:xfrm>
-            <a:off x="2606040" y="2276856"/>
-            <a:ext cx="1005840" cy="274320"/>
+            <a:off x="2606040" y="2350008"/>
+            <a:ext cx="1005840" cy="256032"/>
           </a:xfrm>
           <a:prstGeom prst="rect">
             <a:avLst/>
@@ -12742,8 +12778,8 @@
         </p:nvSpPr>
         <p:spPr>
           <a:xfrm>
-            <a:off x="2606040" y="2532888"/>
-            <a:ext cx="1005840" cy="329184"/>
+            <a:off x="2606040" y="2587752"/>
+            <a:ext cx="1042416" cy="475488"/>
           </a:xfrm>
           <a:prstGeom prst="rect">
             <a:avLst/>
@@ -12762,13 +12798,22 @@
               </a:spcAft>
             </a:pPr>
             <a:r>
-              <a:rPr sz="950" b="0">
-                <a:solidFill>
-                  <a:srgbClr val="5B6778"/>
-                </a:solidFill>
-                <a:latin typeface="Calibri"/>
-              </a:rPr>
-              <a:t>Gemini · Groq · Claude</a:t>
+              <a:rPr sz="850" b="1">
+                <a:solidFill>
+                  <a:srgbClr val="1F5FBF"/>
+                </a:solidFill>
+                <a:latin typeface="Calibri"/>
+              </a:rPr>
+              <a:t>Writes rules: </a:t>
+            </a:r>
+            <a:r>
+              <a:rPr sz="850" b="0">
+                <a:solidFill>
+                  <a:srgbClr val="5F6B7A"/>
+                </a:solidFill>
+                <a:latin typeface="Calibri"/>
+              </a:rPr>
+              <a:t>for new formats (Gemini, Groq, Claude)</a:t>
             </a:r>
           </a:p>
         </p:txBody>
@@ -12781,8 +12826,8 @@
         </p:nvSpPr>
         <p:spPr>
           <a:xfrm>
-            <a:off x="3712464" y="2203704"/>
-            <a:ext cx="1591056" cy="676656"/>
+            <a:off x="3712464" y="2295144"/>
+            <a:ext cx="1591056" cy="786384"/>
           </a:xfrm>
           <a:prstGeom prst="roundRect">
             <a:avLst>
@@ -12837,7 +12882,7 @@
         </p:blipFill>
         <p:spPr>
           <a:xfrm>
-            <a:off x="3803904" y="2331720"/>
+            <a:off x="3803904" y="2478024"/>
             <a:ext cx="420624" cy="420624"/>
           </a:xfrm>
           <a:prstGeom prst="rect">
@@ -12853,8 +12898,8 @@
         </p:nvSpPr>
         <p:spPr>
           <a:xfrm>
-            <a:off x="4279392" y="2276856"/>
-            <a:ext cx="1005840" cy="274320"/>
+            <a:off x="4279392" y="2350008"/>
+            <a:ext cx="1005840" cy="256032"/>
           </a:xfrm>
           <a:prstGeom prst="rect">
             <a:avLst/>
@@ -12892,8 +12937,8 @@
         </p:nvSpPr>
         <p:spPr>
           <a:xfrm>
-            <a:off x="4279392" y="2532888"/>
-            <a:ext cx="1005840" cy="329184"/>
+            <a:off x="4279392" y="2587752"/>
+            <a:ext cx="1042416" cy="475488"/>
           </a:xfrm>
           <a:prstGeom prst="rect">
             <a:avLst/>
@@ -12912,13 +12957,22 @@
               </a:spcAft>
             </a:pPr>
             <a:r>
-              <a:rPr sz="950" b="0">
-                <a:solidFill>
-                  <a:srgbClr val="5B6778"/>
-                </a:solidFill>
-                <a:latin typeface="Calibri"/>
-              </a:rPr>
-              <a:t>Data analysis</a:t>
+              <a:rPr sz="850" b="1">
+                <a:solidFill>
+                  <a:srgbClr val="1F5FBF"/>
+                </a:solidFill>
+                <a:latin typeface="Calibri"/>
+              </a:rPr>
+              <a:t>Data analysis: </a:t>
+            </a:r>
+            <a:r>
+              <a:rPr sz="850" b="0">
+                <a:solidFill>
+                  <a:srgbClr val="5F6B7A"/>
+                </a:solidFill>
+                <a:latin typeface="Calibri"/>
+              </a:rPr>
+              <a:t>summarises log statistics &amp; reports</a:t>
             </a:r>
           </a:p>
         </p:txBody>
@@ -12931,8 +12985,8 @@
         </p:nvSpPr>
         <p:spPr>
           <a:xfrm>
-            <a:off x="365760" y="2962656"/>
-            <a:ext cx="1591056" cy="676656"/>
+            <a:off x="365760" y="3145536"/>
+            <a:ext cx="1591056" cy="786384"/>
           </a:xfrm>
           <a:prstGeom prst="roundRect">
             <a:avLst>
@@ -12987,7 +13041,7 @@
         </p:blipFill>
         <p:spPr>
           <a:xfrm>
-            <a:off x="420624" y="3054096"/>
+            <a:off x="420624" y="3291840"/>
             <a:ext cx="292608" cy="292608"/>
           </a:xfrm>
           <a:prstGeom prst="rect">
@@ -13011,7 +13065,7 @@
         </p:blipFill>
         <p:spPr>
           <a:xfrm>
-            <a:off x="603504" y="3273552"/>
+            <a:off x="603504" y="3511296"/>
             <a:ext cx="292608" cy="292608"/>
           </a:xfrm>
           <a:prstGeom prst="rect">
@@ -13027,8 +13081,8 @@
         </p:nvSpPr>
         <p:spPr>
           <a:xfrm>
-            <a:off x="932688" y="3035808"/>
-            <a:ext cx="1005840" cy="274320"/>
+            <a:off x="932688" y="3200400"/>
+            <a:ext cx="1005840" cy="256032"/>
           </a:xfrm>
           <a:prstGeom prst="rect">
             <a:avLst/>
@@ -13066,8 +13120,8 @@
         </p:nvSpPr>
         <p:spPr>
           <a:xfrm>
-            <a:off x="932688" y="3291840"/>
-            <a:ext cx="1005840" cy="329184"/>
+            <a:off x="932688" y="3438144"/>
+            <a:ext cx="1042416" cy="475488"/>
           </a:xfrm>
           <a:prstGeom prst="rect">
             <a:avLst/>
@@ -13086,13 +13140,22 @@
               </a:spcAft>
             </a:pPr>
             <a:r>
-              <a:rPr sz="950" b="0">
-                <a:solidFill>
-                  <a:srgbClr val="5B6778"/>
-                </a:solidFill>
-                <a:latin typeface="Calibri"/>
-              </a:rPr>
-              <a:t>Collects system logs</a:t>
+              <a:rPr sz="850" b="1">
+                <a:solidFill>
+                  <a:srgbClr val="1F5FBF"/>
+                </a:solidFill>
+                <a:latin typeface="Calibri"/>
+              </a:rPr>
+              <a:t>Collects system logs: </a:t>
+            </a:r>
+            <a:r>
+              <a:rPr sz="850" b="0">
+                <a:solidFill>
+                  <a:srgbClr val="5F6B7A"/>
+                </a:solidFill>
+                <a:latin typeface="Calibri"/>
+              </a:rPr>
+              <a:t>runs on any Linux server</a:t>
             </a:r>
           </a:p>
         </p:txBody>
@@ -13105,8 +13168,8 @@
         </p:nvSpPr>
         <p:spPr>
           <a:xfrm>
-            <a:off x="2039112" y="2962656"/>
-            <a:ext cx="1591056" cy="676656"/>
+            <a:off x="2039112" y="3145536"/>
+            <a:ext cx="1591056" cy="786384"/>
           </a:xfrm>
           <a:prstGeom prst="roundRect">
             <a:avLst>
@@ -13161,7 +13224,7 @@
         </p:blipFill>
         <p:spPr>
           <a:xfrm>
-            <a:off x="2130552" y="3090672"/>
+            <a:off x="2130552" y="3328416"/>
             <a:ext cx="420624" cy="420624"/>
           </a:xfrm>
           <a:prstGeom prst="rect">
@@ -13177,8 +13240,8 @@
         </p:nvSpPr>
         <p:spPr>
           <a:xfrm>
-            <a:off x="2606040" y="3035808"/>
-            <a:ext cx="1005840" cy="274320"/>
+            <a:off x="2606040" y="3200400"/>
+            <a:ext cx="1005840" cy="256032"/>
           </a:xfrm>
           <a:prstGeom prst="rect">
             <a:avLst/>
@@ -13216,8 +13279,8 @@
         </p:nvSpPr>
         <p:spPr>
           <a:xfrm>
-            <a:off x="2606040" y="3291840"/>
-            <a:ext cx="1005840" cy="329184"/>
+            <a:off x="2606040" y="3438144"/>
+            <a:ext cx="1042416" cy="475488"/>
           </a:xfrm>
           <a:prstGeom prst="rect">
             <a:avLst/>
@@ -13236,13 +13299,22 @@
               </a:spcAft>
             </a:pPr>
             <a:r>
-              <a:rPr sz="950" b="0">
-                <a:solidFill>
-                  <a:srgbClr val="5B6778"/>
-                </a:solidFill>
-                <a:latin typeface="Calibri"/>
-              </a:rPr>
-              <a:t>Live deployment</a:t>
+              <a:rPr sz="850" b="1">
+                <a:solidFill>
+                  <a:srgbClr val="1F5FBF"/>
+                </a:solidFill>
+                <a:latin typeface="Calibri"/>
+              </a:rPr>
+              <a:t>Hosting: </a:t>
+            </a:r>
+            <a:r>
+              <a:rPr sz="850" b="0">
+                <a:solidFill>
+                  <a:srgbClr val="5F6B7A"/>
+                </a:solidFill>
+                <a:latin typeface="Calibri"/>
+              </a:rPr>
+              <a:t>quick, free online prototype</a:t>
             </a:r>
           </a:p>
         </p:txBody>
@@ -13255,8 +13327,8 @@
         </p:nvSpPr>
         <p:spPr>
           <a:xfrm>
-            <a:off x="3712464" y="2962656"/>
-            <a:ext cx="1591056" cy="676656"/>
+            <a:off x="3712464" y="3145536"/>
+            <a:ext cx="1591056" cy="786384"/>
           </a:xfrm>
           <a:prstGeom prst="roundRect">
             <a:avLst>
@@ -13311,7 +13383,7 @@
         </p:blipFill>
         <p:spPr>
           <a:xfrm>
-            <a:off x="3803904" y="3090672"/>
+            <a:off x="3803904" y="3328416"/>
             <a:ext cx="420624" cy="420624"/>
           </a:xfrm>
           <a:prstGeom prst="rect">
@@ -13327,8 +13399,8 @@
         </p:nvSpPr>
         <p:spPr>
           <a:xfrm>
-            <a:off x="4279392" y="3035808"/>
-            <a:ext cx="1005840" cy="274320"/>
+            <a:off x="4279392" y="3200400"/>
+            <a:ext cx="1005840" cy="256032"/>
           </a:xfrm>
           <a:prstGeom prst="rect">
             <a:avLst/>
@@ -13366,8 +13438,8 @@
         </p:nvSpPr>
         <p:spPr>
           <a:xfrm>
-            <a:off x="4279392" y="3291840"/>
-            <a:ext cx="1005840" cy="329184"/>
+            <a:off x="4279392" y="3438144"/>
+            <a:ext cx="1042416" cy="475488"/>
           </a:xfrm>
           <a:prstGeom prst="rect">
             <a:avLst/>
@@ -13386,13 +13458,22 @@
               </a:spcAft>
             </a:pPr>
             <a:r>
-              <a:rPr sz="950" b="0">
-                <a:solidFill>
-                  <a:srgbClr val="5B6778"/>
-                </a:solidFill>
-                <a:latin typeface="Calibri"/>
-              </a:rPr>
-              <a:t>Stores learned rules</a:t>
+              <a:rPr sz="850" b="1">
+                <a:solidFill>
+                  <a:srgbClr val="1F5FBF"/>
+                </a:solidFill>
+                <a:latin typeface="Calibri"/>
+              </a:rPr>
+              <a:t>Stores learned rules: </a:t>
+            </a:r>
+            <a:r>
+              <a:rPr sz="850" b="0">
+                <a:solidFill>
+                  <a:srgbClr val="5F6B7A"/>
+                </a:solidFill>
+                <a:latin typeface="Calibri"/>
+              </a:rPr>
+              <a:t>fast cloud cache</a:t>
             </a:r>
           </a:p>
         </p:txBody>
@@ -13405,8 +13486,8 @@
         </p:nvSpPr>
         <p:spPr>
           <a:xfrm>
-            <a:off x="365760" y="4178808"/>
-            <a:ext cx="4937760" cy="1600200"/>
+            <a:off x="365760" y="4462272"/>
+            <a:ext cx="4937760" cy="1325880"/>
           </a:xfrm>
           <a:prstGeom prst="rect">
             <a:avLst/>
@@ -13421,11 +13502,11 @@
           <a:p>
             <a:pPr algn="l">
               <a:spcAft>
-                <a:spcPts val="700"/>
+                <a:spcPts val="300"/>
               </a:spcAft>
             </a:pPr>
             <a:r>
-              <a:rPr sz="1300" b="0">
+              <a:rPr sz="1200" b="0">
                 <a:solidFill>
                   <a:srgbClr val="F58220"/>
                 </a:solidFill>
@@ -13434,7 +13515,7 @@
               <a:t>① </a:t>
             </a:r>
             <a:r>
-              <a:rPr sz="1300" b="1">
+              <a:rPr sz="1200" b="1">
                 <a:solidFill>
                   <a:srgbClr val="0B2A5B"/>
                 </a:solidFill>
@@ -13443,7 +13524,7 @@
               <a:t>Collect: </a:t>
             </a:r>
             <a:r>
-              <a:rPr sz="1300" b="0">
+              <a:rPr sz="1200" b="0">
                 <a:solidFill>
                   <a:srgbClr val="1E2530"/>
                 </a:solidFill>
@@ -13455,11 +13536,11 @@
           <a:p>
             <a:pPr algn="l">
               <a:spcAft>
-                <a:spcPts val="700"/>
+                <a:spcPts val="300"/>
               </a:spcAft>
             </a:pPr>
             <a:r>
-              <a:rPr sz="1300" b="0">
+              <a:rPr sz="1200" b="0">
                 <a:solidFill>
                   <a:srgbClr val="F58220"/>
                 </a:solidFill>
@@ -13468,7 +13549,7 @@
               <a:t>② </a:t>
             </a:r>
             <a:r>
-              <a:rPr sz="1300" b="1">
+              <a:rPr sz="1200" b="1">
                 <a:solidFill>
                   <a:srgbClr val="0B2A5B"/>
                 </a:solidFill>
@@ -13477,7 +13558,7 @@
               <a:t>Group: </a:t>
             </a:r>
             <a:r>
-              <a:rPr sz="1300" b="0">
+              <a:rPr sz="1200" b="0">
                 <a:solidFill>
                   <a:srgbClr val="1E2530"/>
                 </a:solidFill>
@@ -13489,11 +13570,11 @@
           <a:p>
             <a:pPr algn="l">
               <a:spcAft>
-                <a:spcPts val="700"/>
+                <a:spcPts val="300"/>
               </a:spcAft>
             </a:pPr>
             <a:r>
-              <a:rPr sz="1300" b="0">
+              <a:rPr sz="1200" b="0">
                 <a:solidFill>
                   <a:srgbClr val="F58220"/>
                 </a:solidFill>
@@ -13502,7 +13583,7 @@
               <a:t>③ </a:t>
             </a:r>
             <a:r>
-              <a:rPr sz="1300" b="1">
+              <a:rPr sz="1200" b="1">
                 <a:solidFill>
                   <a:srgbClr val="0B2A5B"/>
                 </a:solidFill>
@@ -13511,7 +13592,7 @@
               <a:t>Check: </a:t>
             </a:r>
             <a:r>
-              <a:rPr sz="1300" b="0">
+              <a:rPr sz="1200" b="0">
                 <a:solidFill>
                   <a:srgbClr val="1E2530"/>
                 </a:solidFill>
@@ -13523,11 +13604,11 @@
           <a:p>
             <a:pPr algn="l">
               <a:spcAft>
-                <a:spcPts val="700"/>
+                <a:spcPts val="300"/>
               </a:spcAft>
             </a:pPr>
             <a:r>
-              <a:rPr sz="1300" b="0">
+              <a:rPr sz="1200" b="0">
                 <a:solidFill>
                   <a:srgbClr val="F58220"/>
                 </a:solidFill>
@@ -13536,7 +13617,7 @@
               <a:t>④ </a:t>
             </a:r>
             <a:r>
-              <a:rPr sz="1300" b="1">
+              <a:rPr sz="1200" b="1">
                 <a:solidFill>
                   <a:srgbClr val="0B2A5B"/>
                 </a:solidFill>
@@ -13545,7 +13626,7 @@
               <a:t>Learn: </a:t>
             </a:r>
             <a:r>
-              <a:rPr sz="1300" b="0">
+              <a:rPr sz="1200" b="0">
                 <a:solidFill>
                   <a:srgbClr val="1E2530"/>
                 </a:solidFill>
@@ -13557,11 +13638,11 @@
           <a:p>
             <a:pPr algn="l">
               <a:spcAft>
-                <a:spcPts val="700"/>
+                <a:spcPts val="300"/>
               </a:spcAft>
             </a:pPr>
             <a:r>
-              <a:rPr sz="1300" b="0">
+              <a:rPr sz="1200" b="0">
                 <a:solidFill>
                   <a:srgbClr val="F58220"/>
                 </a:solidFill>
@@ -13570,7 +13651,7 @@
               <a:t>⑤ </a:t>
             </a:r>
             <a:r>
-              <a:rPr sz="1300" b="1">
+              <a:rPr sz="1200" b="1">
                 <a:solidFill>
                   <a:srgbClr val="0B2A5B"/>
                 </a:solidFill>
@@ -13579,7 +13660,7 @@
               <a:t>Output: </a:t>
             </a:r>
             <a:r>
-              <a:rPr sz="1300" b="0">
+              <a:rPr sz="1200" b="0">
                 <a:solidFill>
                   <a:srgbClr val="1E2530"/>
                 </a:solidFill>

</xml_diff>

<commit_message>
PPT slide 2: redesign - crisp one-line idea, then detailed 4-step solution, problem->fix pairs, USPs
Co-authored-by: arena-agent <297053741+arena-agent@users.noreply.github.com>
</commit_message>
<xml_diff>
--- a/presentation/SIH2026_Idea_Submission.pptx
+++ b/presentation/SIH2026_Idea_Submission.pptx
@@ -7751,14 +7751,91 @@
       </p:sp>
       <p:sp>
         <p:nvSpPr>
-          <p:cNvPr id="10" name="TextBox 9"/>
+          <p:cNvPr id="51" name="Oval 50"/>
+          <p:cNvSpPr/>
+          <p:nvPr/>
+        </p:nvSpPr>
+        <p:spPr>
+          <a:xfrm>
+            <a:off x="320040" y="182880"/>
+            <a:ext cx="1463040" cy="731520"/>
+          </a:xfrm>
+          <a:prstGeom prst="ellipse">
+            <a:avLst/>
+          </a:prstGeom>
+          <a:noFill/>
+          <a:ln w="25400">
+            <a:solidFill>
+              <a:srgbClr val="8064A2"/>
+            </a:solidFill>
+          </a:ln>
+          <a:effectLst/>
+        </p:spPr>
+        <p:style>
+          <a:lnRef idx="1">
+            <a:schemeClr val="accent1"/>
+          </a:lnRef>
+          <a:fillRef idx="3">
+            <a:schemeClr val="accent1"/>
+          </a:fillRef>
+          <a:effectRef idx="2">
+            <a:schemeClr val="accent1"/>
+          </a:effectRef>
+          <a:fontRef idx="minor">
+            <a:schemeClr val="lt1"/>
+          </a:fontRef>
+        </p:style>
+        <p:txBody>
+          <a:bodyPr rtlCol="0" anchor="ctr" wrap="square" lIns="45720" rIns="45720" tIns="18288" bIns="18288"/>
+          <a:lstStyle/>
+          <a:p>
+            <a:pPr algn="ctr"/>
+            <a:r>
+              <a:rPr sz="1200" b="1">
+                <a:solidFill>
+                  <a:srgbClr val="F58220"/>
+                </a:solidFill>
+                <a:latin typeface="Calibri"/>
+              </a:rPr>
+              <a:t>[Team Name]</a:t>
+            </a:r>
+          </a:p>
+        </p:txBody>
+      </p:sp>
+      <p:pic>
+        <p:nvPicPr>
+          <p:cNvPr id="52" name="Picture 51" descr="sih_icon_s.png"/>
+          <p:cNvPicPr>
+            <a:picLocks noChangeAspect="1"/>
+          </p:cNvPicPr>
+          <p:nvPr/>
+        </p:nvPicPr>
+        <p:blipFill>
+          <a:blip r:embed="rId4"/>
+          <a:stretch>
+            <a:fillRect/>
+          </a:stretch>
+        </p:blipFill>
+        <p:spPr>
+          <a:xfrm>
+            <a:off x="10076688" y="91440"/>
+            <a:ext cx="676894" cy="822960"/>
+          </a:xfrm>
+          <a:prstGeom prst="rect">
+            <a:avLst/>
+          </a:prstGeom>
+        </p:spPr>
+      </p:pic>
+      <p:sp>
+        <p:nvSpPr>
+          <p:cNvPr id="53" name="TextBox 52"/>
           <p:cNvSpPr txBox="1"/>
           <p:nvPr/>
         </p:nvSpPr>
         <p:spPr>
           <a:xfrm>
-            <a:off x="365760" y="1051560"/>
-            <a:ext cx="5394960" cy="292608"/>
+            <a:off x="10789920" y="109728"/>
+            <a:ext cx="1371600" cy="777240"/>
           </a:xfrm>
           <a:prstGeom prst="rect">
             <a:avLst/>
@@ -7766,44 +7843,109 @@
           <a:noFill/>
         </p:spPr>
         <p:txBody>
-          <a:bodyPr wrap="square" anchor="t" lIns="36576" rIns="36576" tIns="18288" bIns="18288">
+          <a:bodyPr wrap="square" lIns="36576" rIns="36576" tIns="18288" bIns="18288" anchor="t">
             <a:spAutoFit/>
           </a:bodyPr>
           <a:lstStyle/>
           <a:p>
-            <a:pPr algn="l">
-              <a:lnSpc>
-                <a:spcPct val="100000"/>
-              </a:lnSpc>
-              <a:spcAft>
-                <a:spcPts val="0"/>
-              </a:spcAft>
-            </a:pPr>
-            <a:r>
-              <a:rPr sz="1350" b="1" i="0">
-                <a:solidFill>
-                  <a:srgbClr val="C0392B"/>
-                </a:solidFill>
-                <a:latin typeface="Calibri"/>
-              </a:rPr>
-              <a:t>Understanding the Problem</a:t>
-            </a:r>
-          </a:p>
-        </p:txBody>
-      </p:sp>
-      <p:sp>
-        <p:nvSpPr>
-          <p:cNvPr id="11" name="Rectangle 10"/>
+            <a:pPr algn="ctr"/>
+            <a:r>
+              <a:rPr sz="1250" b="1">
+                <a:solidFill>
+                  <a:srgbClr val="455A64"/>
+                </a:solidFill>
+                <a:latin typeface="Calibri"/>
+              </a:rPr>
+              <a:t>SMART INDIA</a:t>
+            </a:r>
+          </a:p>
+          <a:p>
+            <a:pPr algn="ctr"/>
+            <a:r>
+              <a:rPr sz="1250" b="1">
+                <a:solidFill>
+                  <a:srgbClr val="455A64"/>
+                </a:solidFill>
+                <a:latin typeface="Calibri"/>
+              </a:rPr>
+              <a:t>HACKATHON</a:t>
+            </a:r>
+          </a:p>
+          <a:p>
+            <a:pPr algn="ctr"/>
+            <a:r>
+              <a:rPr sz="1250" b="1">
+                <a:solidFill>
+                  <a:srgbClr val="455A64"/>
+                </a:solidFill>
+                <a:latin typeface="Calibri"/>
+              </a:rPr>
+              <a:t>2026</a:t>
+            </a:r>
+          </a:p>
+        </p:txBody>
+      </p:sp>
+      <p:sp>
+        <p:nvSpPr>
+          <p:cNvPr id="55" name="Rounded Rectangle 54"/>
           <p:cNvSpPr/>
           <p:nvPr/>
         </p:nvSpPr>
         <p:spPr>
           <a:xfrm>
-            <a:off x="402336" y="1353312"/>
-            <a:ext cx="822960" cy="32004"/>
-          </a:xfrm>
-          <a:prstGeom prst="rect">
-            <a:avLst/>
+            <a:off x="365760" y="1024128"/>
+            <a:ext cx="11503152" cy="786384"/>
+          </a:xfrm>
+          <a:prstGeom prst="roundRect">
+            <a:avLst>
+              <a:gd name="adj" fmla="val 12000"/>
+            </a:avLst>
+          </a:prstGeom>
+          <a:solidFill>
+            <a:srgbClr val="0B2A5B"/>
+          </a:solidFill>
+          <a:ln>
+            <a:noFill/>
+          </a:ln>
+          <a:effectLst/>
+        </p:spPr>
+        <p:style>
+          <a:lnRef idx="1">
+            <a:schemeClr val="accent1"/>
+          </a:lnRef>
+          <a:fillRef idx="3">
+            <a:schemeClr val="accent1"/>
+          </a:fillRef>
+          <a:effectRef idx="2">
+            <a:schemeClr val="accent1"/>
+          </a:effectRef>
+          <a:fontRef idx="minor">
+            <a:schemeClr val="lt1"/>
+          </a:fontRef>
+        </p:style>
+        <p:txBody>
+          <a:bodyPr rtlCol="0" anchor="ctr"/>
+          <a:lstStyle/>
+          <a:p>
+            <a:pPr algn="ctr"/>
+          </a:p>
+        </p:txBody>
+      </p:sp>
+      <p:sp>
+        <p:nvSpPr>
+          <p:cNvPr id="56" name="Rounded Rectangle 55"/>
+          <p:cNvSpPr/>
+          <p:nvPr/>
+        </p:nvSpPr>
+        <p:spPr>
+          <a:xfrm>
+            <a:off x="502920" y="1161288"/>
+            <a:ext cx="1417320" cy="512064"/>
+          </a:xfrm>
+          <a:prstGeom prst="roundRect">
+            <a:avLst>
+              <a:gd name="adj" fmla="val 30000"/>
+            </a:avLst>
           </a:prstGeom>
           <a:solidFill>
             <a:srgbClr val="F58220"/>
@@ -7837,14 +7979,14 @@
       </p:sp>
       <p:sp>
         <p:nvSpPr>
-          <p:cNvPr id="13" name="TextBox 12"/>
+          <p:cNvPr id="57" name="TextBox 56"/>
           <p:cNvSpPr txBox="1"/>
           <p:nvPr/>
         </p:nvSpPr>
         <p:spPr>
           <a:xfrm>
-            <a:off x="6035040" y="1051560"/>
-            <a:ext cx="5852160" cy="292608"/>
+            <a:off x="502920" y="1161288"/>
+            <a:ext cx="1417320" cy="512064"/>
           </a:xfrm>
           <a:prstGeom prst="rect">
             <a:avLst/>
@@ -7852,41 +7994,149 @@
           <a:noFill/>
         </p:spPr>
         <p:txBody>
-          <a:bodyPr wrap="square" anchor="t" lIns="36576" rIns="36576" tIns="18288" bIns="18288">
+          <a:bodyPr wrap="square" lIns="36576" rIns="36576" tIns="18288" bIns="18288" anchor="ctr">
             <a:spAutoFit/>
           </a:bodyPr>
           <a:lstStyle/>
           <a:p>
-            <a:pPr algn="l">
-              <a:lnSpc>
-                <a:spcPct val="100000"/>
-              </a:lnSpc>
-              <a:spcAft>
-                <a:spcPts val="0"/>
-              </a:spcAft>
-            </a:pPr>
-            <a:r>
-              <a:rPr sz="1350" b="1" i="0">
-                <a:solidFill>
-                  <a:srgbClr val="138A36"/>
-                </a:solidFill>
-                <a:latin typeface="Calibri"/>
-              </a:rPr>
-              <a:t>Our Solution</a:t>
-            </a:r>
-          </a:p>
-        </p:txBody>
-      </p:sp>
-      <p:sp>
-        <p:nvSpPr>
-          <p:cNvPr id="14" name="Rectangle 13"/>
+            <a:pPr algn="ctr"/>
+            <a:r>
+              <a:rPr sz="1400" b="1">
+                <a:solidFill>
+                  <a:srgbClr val="FFFFFF"/>
+                </a:solidFill>
+                <a:latin typeface="Calibri"/>
+              </a:rPr>
+              <a:t>THE IDEA</a:t>
+            </a:r>
+          </a:p>
+        </p:txBody>
+      </p:sp>
+      <p:sp>
+        <p:nvSpPr>
+          <p:cNvPr id="58" name="TextBox 57"/>
+          <p:cNvSpPr txBox="1"/>
+          <p:nvPr/>
+        </p:nvSpPr>
+        <p:spPr>
+          <a:xfrm>
+            <a:off x="2057400" y="1042416"/>
+            <a:ext cx="9692640" cy="749808"/>
+          </a:xfrm>
+          <a:prstGeom prst="rect">
+            <a:avLst/>
+          </a:prstGeom>
+          <a:noFill/>
+        </p:spPr>
+        <p:txBody>
+          <a:bodyPr wrap="square" lIns="36576" rIns="36576" tIns="18288" bIns="18288" anchor="ctr">
+            <a:spAutoFit/>
+          </a:bodyPr>
+          <a:lstStyle/>
+          <a:p>
+            <a:pPr algn="l"/>
+            <a:r>
+              <a:rPr sz="1600" b="0">
+                <a:solidFill>
+                  <a:srgbClr val="FFFFFF"/>
+                </a:solidFill>
+                <a:latin typeface="Calibri"/>
+              </a:rPr>
+              <a:t>Turn messy logs in hundreds of formats into </a:t>
+            </a:r>
+            <a:r>
+              <a:rPr sz="1600" b="1">
+                <a:solidFill>
+                  <a:srgbClr val="FFC98A"/>
+                </a:solidFill>
+                <a:latin typeface="Calibri"/>
+              </a:rPr>
+              <a:t>one clean, common format</a:t>
+            </a:r>
+            <a:r>
+              <a:rPr sz="1600" b="0">
+                <a:solidFill>
+                  <a:srgbClr val="FFFFFF"/>
+                </a:solidFill>
+                <a:latin typeface="Calibri"/>
+              </a:rPr>
+              <a:t>. AI learns each new format </a:t>
+            </a:r>
+            <a:r>
+              <a:rPr sz="1600" b="1">
+                <a:solidFill>
+                  <a:srgbClr val="FFC98A"/>
+                </a:solidFill>
+                <a:latin typeface="Calibri"/>
+              </a:rPr>
+              <a:t>only once</a:t>
+            </a:r>
+            <a:r>
+              <a:rPr sz="1600" b="0">
+                <a:solidFill>
+                  <a:srgbClr val="FFFFFF"/>
+                </a:solidFill>
+                <a:latin typeface="Calibri"/>
+              </a:rPr>
+              <a:t>; after that, fast saved rules do the work.</a:t>
+            </a:r>
+          </a:p>
+        </p:txBody>
+      </p:sp>
+      <p:sp>
+        <p:nvSpPr>
+          <p:cNvPr id="59" name="TextBox 58"/>
+          <p:cNvSpPr txBox="1"/>
+          <p:nvPr/>
+        </p:nvSpPr>
+        <p:spPr>
+          <a:xfrm>
+            <a:off x="365760" y="1901952"/>
+            <a:ext cx="11430000" cy="292608"/>
+          </a:xfrm>
+          <a:prstGeom prst="rect">
+            <a:avLst/>
+          </a:prstGeom>
+          <a:noFill/>
+        </p:spPr>
+        <p:txBody>
+          <a:bodyPr wrap="square" lIns="36576" rIns="36576" tIns="18288" bIns="18288" anchor="t">
+            <a:spAutoFit/>
+          </a:bodyPr>
+          <a:lstStyle/>
+          <a:p>
+            <a:pPr algn="l"/>
+            <a:r>
+              <a:rPr sz="1450" b="1">
+                <a:solidFill>
+                  <a:srgbClr val="0B2A5B"/>
+                </a:solidFill>
+                <a:latin typeface="Calibri"/>
+              </a:rPr>
+              <a:t>Our Solution: how it works</a:t>
+            </a:r>
+            <a:r>
+              <a:rPr sz="1150" b="0">
+                <a:solidFill>
+                  <a:srgbClr val="5F6B7A"/>
+                </a:solidFill>
+                <a:latin typeface="Calibri"/>
+              </a:rPr>
+              <a:t>   every log goes through four simple steps</a:t>
+            </a:r>
+          </a:p>
+        </p:txBody>
+      </p:sp>
+      <p:sp>
+        <p:nvSpPr>
+          <p:cNvPr id="60" name="Rectangle 59"/>
           <p:cNvSpPr/>
           <p:nvPr/>
         </p:nvSpPr>
         <p:spPr>
           <a:xfrm>
-            <a:off x="6071616" y="1353312"/>
-            <a:ext cx="822960" cy="32004"/>
+            <a:off x="402336" y="2203704"/>
+            <a:ext cx="822960" cy="41148"/>
           </a:xfrm>
           <a:prstGeom prst="rect">
             <a:avLst/>
@@ -7923,104 +8173,18 @@
       </p:sp>
       <p:sp>
         <p:nvSpPr>
-          <p:cNvPr id="16" name="TextBox 15"/>
-          <p:cNvSpPr txBox="1"/>
-          <p:nvPr/>
-        </p:nvSpPr>
-        <p:spPr>
-          <a:xfrm>
-            <a:off x="365760" y="4069080"/>
-            <a:ext cx="8229600" cy="292608"/>
-          </a:xfrm>
-          <a:prstGeom prst="rect">
-            <a:avLst/>
-          </a:prstGeom>
-          <a:noFill/>
-        </p:spPr>
-        <p:txBody>
-          <a:bodyPr wrap="square" anchor="t" lIns="36576" rIns="36576" tIns="18288" bIns="18288">
-            <a:spAutoFit/>
-          </a:bodyPr>
-          <a:lstStyle/>
-          <a:p>
-            <a:pPr algn="l">
-              <a:lnSpc>
-                <a:spcPct val="100000"/>
-              </a:lnSpc>
-              <a:spcAft>
-                <a:spcPts val="0"/>
-              </a:spcAft>
-            </a:pPr>
-            <a:r>
-              <a:rPr sz="1350" b="1" i="0">
-                <a:solidFill>
-                  <a:srgbClr val="1F5FBF"/>
-                </a:solidFill>
-                <a:latin typeface="Calibri"/>
-              </a:rPr>
-              <a:t>Innovation &amp; Uniqueness (USPs)</a:t>
-            </a:r>
-          </a:p>
-        </p:txBody>
-      </p:sp>
-      <p:sp>
-        <p:nvSpPr>
-          <p:cNvPr id="17" name="Rectangle 16"/>
+          <p:cNvPr id="61" name="Rounded Rectangle 60"/>
           <p:cNvSpPr/>
           <p:nvPr/>
         </p:nvSpPr>
         <p:spPr>
           <a:xfrm>
-            <a:off x="402336" y="4370832"/>
-            <a:ext cx="822960" cy="32004"/>
-          </a:xfrm>
-          <a:prstGeom prst="rect">
-            <a:avLst/>
-          </a:prstGeom>
-          <a:solidFill>
-            <a:srgbClr val="F58220"/>
-          </a:solidFill>
-          <a:ln>
-            <a:noFill/>
-          </a:ln>
-          <a:effectLst/>
-        </p:spPr>
-        <p:style>
-          <a:lnRef idx="1">
-            <a:schemeClr val="accent1"/>
-          </a:lnRef>
-          <a:fillRef idx="3">
-            <a:schemeClr val="accent1"/>
-          </a:fillRef>
-          <a:effectRef idx="2">
-            <a:schemeClr val="accent1"/>
-          </a:effectRef>
-          <a:fontRef idx="minor">
-            <a:schemeClr val="lt1"/>
-          </a:fontRef>
-        </p:style>
-        <p:txBody>
-          <a:bodyPr rtlCol="0" anchor="ctr"/>
-          <a:lstStyle/>
-          <a:p>
-            <a:pPr algn="ctr"/>
-          </a:p>
-        </p:txBody>
-      </p:sp>
-      <p:sp>
-        <p:nvSpPr>
-          <p:cNvPr id="18" name="Rounded Rectangle 17"/>
-          <p:cNvSpPr/>
-          <p:nvPr/>
-        </p:nvSpPr>
-        <p:spPr>
-          <a:xfrm>
-            <a:off x="365760" y="4480560"/>
-            <a:ext cx="2011680" cy="1783080"/>
+            <a:off x="365760" y="2340864"/>
+            <a:ext cx="2615184" cy="1325880"/>
           </a:xfrm>
           <a:prstGeom prst="roundRect">
             <a:avLst>
-              <a:gd name="adj" fmla="val 8000"/>
+              <a:gd name="adj" fmla="val 7000"/>
             </a:avLst>
           </a:prstGeom>
           <a:solidFill>
@@ -8057,17 +8221,19 @@
       </p:sp>
       <p:sp>
         <p:nvSpPr>
-          <p:cNvPr id="19" name="Rectangle 18"/>
+          <p:cNvPr id="62" name="Rounded Rectangle 61"/>
           <p:cNvSpPr/>
           <p:nvPr/>
         </p:nvSpPr>
         <p:spPr>
           <a:xfrm>
-            <a:off x="365760" y="4480560"/>
-            <a:ext cx="2011680" cy="109728"/>
-          </a:xfrm>
-          <a:prstGeom prst="rect">
-            <a:avLst/>
+            <a:off x="365760" y="2340864"/>
+            <a:ext cx="2615184" cy="420624"/>
+          </a:xfrm>
+          <a:prstGeom prst="roundRect">
+            <a:avLst>
+              <a:gd name="adj" fmla="val 30000"/>
+            </a:avLst>
           </a:prstGeom>
           <a:solidFill>
             <a:srgbClr val="1F5FBF"/>
@@ -8101,14 +8267,58 @@
       </p:sp>
       <p:sp>
         <p:nvSpPr>
-          <p:cNvPr id="20" name="TextBox 19"/>
+          <p:cNvPr id="63" name="Oval 62"/>
+          <p:cNvSpPr/>
+          <p:nvPr/>
+        </p:nvSpPr>
+        <p:spPr>
+          <a:xfrm>
+            <a:off x="457200" y="2395728"/>
+            <a:ext cx="310896" cy="310896"/>
+          </a:xfrm>
+          <a:prstGeom prst="ellipse">
+            <a:avLst/>
+          </a:prstGeom>
+          <a:solidFill>
+            <a:srgbClr val="FFFFFF"/>
+          </a:solidFill>
+          <a:ln>
+            <a:noFill/>
+          </a:ln>
+          <a:effectLst/>
+        </p:spPr>
+        <p:style>
+          <a:lnRef idx="1">
+            <a:schemeClr val="accent1"/>
+          </a:lnRef>
+          <a:fillRef idx="3">
+            <a:schemeClr val="accent1"/>
+          </a:fillRef>
+          <a:effectRef idx="2">
+            <a:schemeClr val="accent1"/>
+          </a:effectRef>
+          <a:fontRef idx="minor">
+            <a:schemeClr val="lt1"/>
+          </a:fontRef>
+        </p:style>
+        <p:txBody>
+          <a:bodyPr rtlCol="0" anchor="ctr"/>
+          <a:lstStyle/>
+          <a:p>
+            <a:pPr algn="ctr"/>
+          </a:p>
+        </p:txBody>
+      </p:sp>
+      <p:sp>
+        <p:nvSpPr>
+          <p:cNvPr id="64" name="TextBox 63"/>
           <p:cNvSpPr txBox="1"/>
           <p:nvPr/>
         </p:nvSpPr>
         <p:spPr>
           <a:xfrm>
-            <a:off x="457200" y="4645152"/>
-            <a:ext cx="1828800" cy="685800"/>
+            <a:off x="457200" y="2395728"/>
+            <a:ext cx="310896" cy="310896"/>
           </a:xfrm>
           <a:prstGeom prst="rect">
             <a:avLst/>
@@ -8116,41 +8326,34 @@
           <a:noFill/>
         </p:spPr>
         <p:txBody>
-          <a:bodyPr wrap="square" anchor="t" lIns="36576" rIns="36576" tIns="18288" bIns="18288">
+          <a:bodyPr wrap="square" lIns="36576" rIns="36576" tIns="18288" bIns="18288" anchor="ctr">
             <a:spAutoFit/>
           </a:bodyPr>
           <a:lstStyle/>
           <a:p>
-            <a:pPr algn="ctr">
-              <a:lnSpc>
-                <a:spcPct val="90000"/>
-              </a:lnSpc>
-              <a:spcAft>
-                <a:spcPts val="0"/>
-              </a:spcAft>
-            </a:pPr>
-            <a:r>
-              <a:rPr sz="1400" b="1" i="0">
+            <a:pPr algn="ctr"/>
+            <a:r>
+              <a:rPr sz="1200" b="1">
                 <a:solidFill>
                   <a:srgbClr val="1F5FBF"/>
                 </a:solidFill>
                 <a:latin typeface="Calibri"/>
               </a:rPr>
-              <a:t>Fast and flexible</a:t>
-            </a:r>
-          </a:p>
-        </p:txBody>
-      </p:sp>
-      <p:sp>
-        <p:nvSpPr>
-          <p:cNvPr id="21" name="TextBox 20"/>
+              <a:t>1</a:t>
+            </a:r>
+          </a:p>
+        </p:txBody>
+      </p:sp>
+      <p:sp>
+        <p:nvSpPr>
+          <p:cNvPr id="65" name="TextBox 64"/>
           <p:cNvSpPr txBox="1"/>
           <p:nvPr/>
         </p:nvSpPr>
         <p:spPr>
           <a:xfrm>
-            <a:off x="475488" y="5349240"/>
-            <a:ext cx="1792224" cy="868680"/>
+            <a:off x="822960" y="2340864"/>
+            <a:ext cx="2066544" cy="420624"/>
           </a:xfrm>
           <a:prstGeom prst="rect">
             <a:avLst/>
@@ -8158,45 +8361,108 @@
           <a:noFill/>
         </p:spPr>
         <p:txBody>
-          <a:bodyPr wrap="square" anchor="t" lIns="36576" rIns="36576" tIns="18288" bIns="18288">
+          <a:bodyPr wrap="square" lIns="36576" rIns="36576" tIns="18288" bIns="18288" anchor="ctr">
             <a:spAutoFit/>
           </a:bodyPr>
           <a:lstStyle/>
           <a:p>
-            <a:pPr algn="ctr">
-              <a:lnSpc>
-                <a:spcPct val="100000"/>
-              </a:lnSpc>
-              <a:spcAft>
-                <a:spcPts val="0"/>
-              </a:spcAft>
-            </a:pPr>
-            <a:r>
-              <a:rPr sz="1100" b="0" i="0">
+            <a:pPr algn="l"/>
+            <a:r>
+              <a:rPr sz="1400" b="1">
+                <a:solidFill>
+                  <a:srgbClr val="FFFFFF"/>
+                </a:solidFill>
+                <a:latin typeface="Calibri"/>
+              </a:rPr>
+              <a:t>Collect</a:t>
+            </a:r>
+          </a:p>
+        </p:txBody>
+      </p:sp>
+      <p:sp>
+        <p:nvSpPr>
+          <p:cNvPr id="66" name="TextBox 65"/>
+          <p:cNvSpPr txBox="1"/>
+          <p:nvPr/>
+        </p:nvSpPr>
+        <p:spPr>
+          <a:xfrm>
+            <a:off x="475488" y="2816352"/>
+            <a:ext cx="2395728" cy="795528"/>
+          </a:xfrm>
+          <a:prstGeom prst="rect">
+            <a:avLst/>
+          </a:prstGeom>
+          <a:noFill/>
+        </p:spPr>
+        <p:txBody>
+          <a:bodyPr wrap="square" lIns="36576" rIns="36576" tIns="18288" bIns="18288" anchor="ctr">
+            <a:spAutoFit/>
+          </a:bodyPr>
+          <a:lstStyle/>
+          <a:p>
+            <a:pPr algn="l"/>
+            <a:r>
+              <a:rPr sz="1150" b="0">
                 <a:solidFill>
                   <a:srgbClr val="1E2530"/>
                 </a:solidFill>
                 <a:latin typeface="Calibri"/>
               </a:rPr>
-              <a:t>Most lines are handled by fast saved rules; AI is used only when truly needed</a:t>
-            </a:r>
-          </a:p>
-        </p:txBody>
-      </p:sp>
-      <p:sp>
-        <p:nvSpPr>
-          <p:cNvPr id="22" name="Rounded Rectangle 21"/>
+              <a:t>Logs arrive from any source (servers, apps, firewalls, cloud) through a web API or a small Bash script.</a:t>
+            </a:r>
+          </a:p>
+        </p:txBody>
+      </p:sp>
+      <p:sp>
+        <p:nvSpPr>
+          <p:cNvPr id="67" name="TextBox 66"/>
+          <p:cNvSpPr txBox="1"/>
+          <p:nvPr/>
+        </p:nvSpPr>
+        <p:spPr>
+          <a:xfrm>
+            <a:off x="2980944" y="2779776"/>
+            <a:ext cx="347472" cy="457200"/>
+          </a:xfrm>
+          <a:prstGeom prst="rect">
+            <a:avLst/>
+          </a:prstGeom>
+          <a:noFill/>
+        </p:spPr>
+        <p:txBody>
+          <a:bodyPr wrap="square" lIns="36576" rIns="36576" tIns="18288" bIns="18288" anchor="t">
+            <a:spAutoFit/>
+          </a:bodyPr>
+          <a:lstStyle/>
+          <a:p>
+            <a:pPr algn="ctr"/>
+            <a:r>
+              <a:rPr sz="1600" b="0">
+                <a:solidFill>
+                  <a:srgbClr val="5F6B7A"/>
+                </a:solidFill>
+                <a:latin typeface="Calibri"/>
+              </a:rPr>
+              <a:t>▶</a:t>
+            </a:r>
+          </a:p>
+        </p:txBody>
+      </p:sp>
+      <p:sp>
+        <p:nvSpPr>
+          <p:cNvPr id="68" name="Rounded Rectangle 67"/>
           <p:cNvSpPr/>
           <p:nvPr/>
         </p:nvSpPr>
         <p:spPr>
           <a:xfrm>
-            <a:off x="2496312" y="4480560"/>
-            <a:ext cx="2011680" cy="1783080"/>
+            <a:off x="3328416" y="2340864"/>
+            <a:ext cx="2615184" cy="1325880"/>
           </a:xfrm>
           <a:prstGeom prst="roundRect">
             <a:avLst>
-              <a:gd name="adj" fmla="val 8000"/>
+              <a:gd name="adj" fmla="val 7000"/>
             </a:avLst>
           </a:prstGeom>
           <a:solidFill>
@@ -8204,7 +8470,7 @@
           </a:solidFill>
           <a:ln w="19050">
             <a:solidFill>
-              <a:srgbClr val="F58220"/>
+              <a:srgbClr val="0E8C8C"/>
             </a:solidFill>
           </a:ln>
           <a:effectLst/>
@@ -8233,20 +8499,22 @@
       </p:sp>
       <p:sp>
         <p:nvSpPr>
-          <p:cNvPr id="23" name="Rectangle 22"/>
+          <p:cNvPr id="69" name="Rounded Rectangle 68"/>
           <p:cNvSpPr/>
           <p:nvPr/>
         </p:nvSpPr>
         <p:spPr>
           <a:xfrm>
-            <a:off x="2496312" y="4480560"/>
-            <a:ext cx="2011680" cy="109728"/>
-          </a:xfrm>
-          <a:prstGeom prst="rect">
-            <a:avLst/>
+            <a:off x="3328416" y="2340864"/>
+            <a:ext cx="2615184" cy="420624"/>
+          </a:xfrm>
+          <a:prstGeom prst="roundRect">
+            <a:avLst>
+              <a:gd name="adj" fmla="val 30000"/>
+            </a:avLst>
           </a:prstGeom>
           <a:solidFill>
-            <a:srgbClr val="F58220"/>
+            <a:srgbClr val="0E8C8C"/>
           </a:solidFill>
           <a:ln>
             <a:noFill/>
@@ -8277,14 +8545,58 @@
       </p:sp>
       <p:sp>
         <p:nvSpPr>
-          <p:cNvPr id="24" name="TextBox 23"/>
+          <p:cNvPr id="70" name="Oval 69"/>
+          <p:cNvSpPr/>
+          <p:nvPr/>
+        </p:nvSpPr>
+        <p:spPr>
+          <a:xfrm>
+            <a:off x="3419856" y="2395728"/>
+            <a:ext cx="310896" cy="310896"/>
+          </a:xfrm>
+          <a:prstGeom prst="ellipse">
+            <a:avLst/>
+          </a:prstGeom>
+          <a:solidFill>
+            <a:srgbClr val="FFFFFF"/>
+          </a:solidFill>
+          <a:ln>
+            <a:noFill/>
+          </a:ln>
+          <a:effectLst/>
+        </p:spPr>
+        <p:style>
+          <a:lnRef idx="1">
+            <a:schemeClr val="accent1"/>
+          </a:lnRef>
+          <a:fillRef idx="3">
+            <a:schemeClr val="accent1"/>
+          </a:fillRef>
+          <a:effectRef idx="2">
+            <a:schemeClr val="accent1"/>
+          </a:effectRef>
+          <a:fontRef idx="minor">
+            <a:schemeClr val="lt1"/>
+          </a:fontRef>
+        </p:style>
+        <p:txBody>
+          <a:bodyPr rtlCol="0" anchor="ctr"/>
+          <a:lstStyle/>
+          <a:p>
+            <a:pPr algn="ctr"/>
+          </a:p>
+        </p:txBody>
+      </p:sp>
+      <p:sp>
+        <p:nvSpPr>
+          <p:cNvPr id="71" name="TextBox 70"/>
           <p:cNvSpPr txBox="1"/>
           <p:nvPr/>
         </p:nvSpPr>
         <p:spPr>
           <a:xfrm>
-            <a:off x="2587752" y="4645152"/>
-            <a:ext cx="1828800" cy="685800"/>
+            <a:off x="3419856" y="2395728"/>
+            <a:ext cx="310896" cy="310896"/>
           </a:xfrm>
           <a:prstGeom prst="rect">
             <a:avLst/>
@@ -8292,60 +8604,34 @@
           <a:noFill/>
         </p:spPr>
         <p:txBody>
-          <a:bodyPr wrap="square" anchor="t" lIns="36576" rIns="36576" tIns="18288" bIns="18288">
+          <a:bodyPr wrap="square" lIns="36576" rIns="36576" tIns="18288" bIns="18288" anchor="ctr">
             <a:spAutoFit/>
           </a:bodyPr>
           <a:lstStyle/>
           <a:p>
-            <a:pPr algn="ctr">
-              <a:lnSpc>
-                <a:spcPct val="90000"/>
-              </a:lnSpc>
-              <a:spcAft>
-                <a:spcPts val="0"/>
-              </a:spcAft>
-            </a:pPr>
-            <a:r>
-              <a:rPr sz="1400" b="1" i="0">
-                <a:solidFill>
-                  <a:srgbClr val="F58220"/>
-                </a:solidFill>
-                <a:latin typeface="Calibri"/>
-              </a:rPr>
-              <a:t>Far fewer</a:t>
-            </a:r>
-          </a:p>
-          <a:p>
-            <a:pPr algn="ctr">
-              <a:lnSpc>
-                <a:spcPct val="90000"/>
-              </a:lnSpc>
-              <a:spcAft>
-                <a:spcPts val="0"/>
-              </a:spcAft>
-            </a:pPr>
-            <a:r>
-              <a:rPr sz="1400" b="1" i="0">
-                <a:solidFill>
-                  <a:srgbClr val="F58220"/>
-                </a:solidFill>
-                <a:latin typeface="Calibri"/>
-              </a:rPr>
-              <a:t>AI calls</a:t>
-            </a:r>
-          </a:p>
-        </p:txBody>
-      </p:sp>
-      <p:sp>
-        <p:nvSpPr>
-          <p:cNvPr id="25" name="TextBox 24"/>
+            <a:pPr algn="ctr"/>
+            <a:r>
+              <a:rPr sz="1200" b="1">
+                <a:solidFill>
+                  <a:srgbClr val="0E8C8C"/>
+                </a:solidFill>
+                <a:latin typeface="Calibri"/>
+              </a:rPr>
+              <a:t>2</a:t>
+            </a:r>
+          </a:p>
+        </p:txBody>
+      </p:sp>
+      <p:sp>
+        <p:nvSpPr>
+          <p:cNvPr id="72" name="TextBox 71"/>
           <p:cNvSpPr txBox="1"/>
           <p:nvPr/>
         </p:nvSpPr>
         <p:spPr>
           <a:xfrm>
-            <a:off x="2606040" y="5349240"/>
-            <a:ext cx="1792224" cy="868680"/>
+            <a:off x="3785616" y="2340864"/>
+            <a:ext cx="2066544" cy="420624"/>
           </a:xfrm>
           <a:prstGeom prst="rect">
             <a:avLst/>
@@ -8353,45 +8639,386 @@
           <a:noFill/>
         </p:spPr>
         <p:txBody>
-          <a:bodyPr wrap="square" anchor="t" lIns="36576" rIns="36576" tIns="18288" bIns="18288">
+          <a:bodyPr wrap="square" lIns="36576" rIns="36576" tIns="18288" bIns="18288" anchor="ctr">
             <a:spAutoFit/>
           </a:bodyPr>
           <a:lstStyle/>
           <a:p>
-            <a:pPr algn="ctr">
-              <a:lnSpc>
-                <a:spcPct val="100000"/>
-              </a:lnSpc>
-              <a:spcAft>
-                <a:spcPts val="0"/>
-              </a:spcAft>
-            </a:pPr>
-            <a:r>
-              <a:rPr sz="1100" b="0" i="0">
+            <a:pPr algn="l"/>
+            <a:r>
+              <a:rPr sz="1400" b="1">
+                <a:solidFill>
+                  <a:srgbClr val="FFFFFF"/>
+                </a:solidFill>
+                <a:latin typeface="Calibri"/>
+              </a:rPr>
+              <a:t>Group</a:t>
+            </a:r>
+          </a:p>
+        </p:txBody>
+      </p:sp>
+      <p:sp>
+        <p:nvSpPr>
+          <p:cNvPr id="73" name="TextBox 72"/>
+          <p:cNvSpPr txBox="1"/>
+          <p:nvPr/>
+        </p:nvSpPr>
+        <p:spPr>
+          <a:xfrm>
+            <a:off x="3438144" y="2816352"/>
+            <a:ext cx="2395728" cy="795528"/>
+          </a:xfrm>
+          <a:prstGeom prst="rect">
+            <a:avLst/>
+          </a:prstGeom>
+          <a:noFill/>
+        </p:spPr>
+        <p:txBody>
+          <a:bodyPr wrap="square" lIns="36576" rIns="36576" tIns="18288" bIns="18288" anchor="ctr">
+            <a:spAutoFit/>
+          </a:bodyPr>
+          <a:lstStyle/>
+          <a:p>
+            <a:pPr algn="l"/>
+            <a:r>
+              <a:rPr sz="1150" b="0">
                 <a:solidFill>
                   <a:srgbClr val="1E2530"/>
                 </a:solidFill>
                 <a:latin typeface="Calibri"/>
               </a:rPr>
-              <a:t>A new format is learned once, then reused for every similar line</a:t>
-            </a:r>
-          </a:p>
-        </p:txBody>
-      </p:sp>
-      <p:sp>
-        <p:nvSpPr>
-          <p:cNvPr id="26" name="Rounded Rectangle 25"/>
+              <a:t>Similar lines are grouped into patterns, so millions of lines become a few thousand templates.</a:t>
+            </a:r>
+          </a:p>
+        </p:txBody>
+      </p:sp>
+      <p:sp>
+        <p:nvSpPr>
+          <p:cNvPr id="74" name="TextBox 73"/>
+          <p:cNvSpPr txBox="1"/>
+          <p:nvPr/>
+        </p:nvSpPr>
+        <p:spPr>
+          <a:xfrm>
+            <a:off x="5943600" y="2779776"/>
+            <a:ext cx="347472" cy="457200"/>
+          </a:xfrm>
+          <a:prstGeom prst="rect">
+            <a:avLst/>
+          </a:prstGeom>
+          <a:noFill/>
+        </p:spPr>
+        <p:txBody>
+          <a:bodyPr wrap="square" lIns="36576" rIns="36576" tIns="18288" bIns="18288" anchor="t">
+            <a:spAutoFit/>
+          </a:bodyPr>
+          <a:lstStyle/>
+          <a:p>
+            <a:pPr algn="ctr"/>
+            <a:r>
+              <a:rPr sz="1600" b="0">
+                <a:solidFill>
+                  <a:srgbClr val="5F6B7A"/>
+                </a:solidFill>
+                <a:latin typeface="Calibri"/>
+              </a:rPr>
+              <a:t>▶</a:t>
+            </a:r>
+          </a:p>
+        </p:txBody>
+      </p:sp>
+      <p:sp>
+        <p:nvSpPr>
+          <p:cNvPr id="75" name="Rounded Rectangle 74"/>
           <p:cNvSpPr/>
           <p:nvPr/>
         </p:nvSpPr>
         <p:spPr>
           <a:xfrm>
-            <a:off x="4626864" y="4480560"/>
-            <a:ext cx="2011680" cy="1783080"/>
+            <a:off x="6291072" y="2340864"/>
+            <a:ext cx="2615184" cy="1325880"/>
           </a:xfrm>
           <a:prstGeom prst="roundRect">
             <a:avLst>
-              <a:gd name="adj" fmla="val 8000"/>
+              <a:gd name="adj" fmla="val 7000"/>
+            </a:avLst>
+          </a:prstGeom>
+          <a:solidFill>
+            <a:srgbClr val="FFFFFF"/>
+          </a:solidFill>
+          <a:ln w="19050">
+            <a:solidFill>
+              <a:srgbClr val="6A3FB5"/>
+            </a:solidFill>
+          </a:ln>
+          <a:effectLst/>
+        </p:spPr>
+        <p:style>
+          <a:lnRef idx="1">
+            <a:schemeClr val="accent1"/>
+          </a:lnRef>
+          <a:fillRef idx="3">
+            <a:schemeClr val="accent1"/>
+          </a:fillRef>
+          <a:effectRef idx="2">
+            <a:schemeClr val="accent1"/>
+          </a:effectRef>
+          <a:fontRef idx="minor">
+            <a:schemeClr val="lt1"/>
+          </a:fontRef>
+        </p:style>
+        <p:txBody>
+          <a:bodyPr rtlCol="0" anchor="ctr"/>
+          <a:lstStyle/>
+          <a:p>
+            <a:pPr algn="ctr"/>
+          </a:p>
+        </p:txBody>
+      </p:sp>
+      <p:sp>
+        <p:nvSpPr>
+          <p:cNvPr id="76" name="Rounded Rectangle 75"/>
+          <p:cNvSpPr/>
+          <p:nvPr/>
+        </p:nvSpPr>
+        <p:spPr>
+          <a:xfrm>
+            <a:off x="6291072" y="2340864"/>
+            <a:ext cx="2615184" cy="420624"/>
+          </a:xfrm>
+          <a:prstGeom prst="roundRect">
+            <a:avLst>
+              <a:gd name="adj" fmla="val 30000"/>
+            </a:avLst>
+          </a:prstGeom>
+          <a:solidFill>
+            <a:srgbClr val="6A3FB5"/>
+          </a:solidFill>
+          <a:ln>
+            <a:noFill/>
+          </a:ln>
+          <a:effectLst/>
+        </p:spPr>
+        <p:style>
+          <a:lnRef idx="1">
+            <a:schemeClr val="accent1"/>
+          </a:lnRef>
+          <a:fillRef idx="3">
+            <a:schemeClr val="accent1"/>
+          </a:fillRef>
+          <a:effectRef idx="2">
+            <a:schemeClr val="accent1"/>
+          </a:effectRef>
+          <a:fontRef idx="minor">
+            <a:schemeClr val="lt1"/>
+          </a:fontRef>
+        </p:style>
+        <p:txBody>
+          <a:bodyPr rtlCol="0" anchor="ctr"/>
+          <a:lstStyle/>
+          <a:p>
+            <a:pPr algn="ctr"/>
+          </a:p>
+        </p:txBody>
+      </p:sp>
+      <p:sp>
+        <p:nvSpPr>
+          <p:cNvPr id="77" name="Oval 76"/>
+          <p:cNvSpPr/>
+          <p:nvPr/>
+        </p:nvSpPr>
+        <p:spPr>
+          <a:xfrm>
+            <a:off x="6382512" y="2395728"/>
+            <a:ext cx="310896" cy="310896"/>
+          </a:xfrm>
+          <a:prstGeom prst="ellipse">
+            <a:avLst/>
+          </a:prstGeom>
+          <a:solidFill>
+            <a:srgbClr val="FFFFFF"/>
+          </a:solidFill>
+          <a:ln>
+            <a:noFill/>
+          </a:ln>
+          <a:effectLst/>
+        </p:spPr>
+        <p:style>
+          <a:lnRef idx="1">
+            <a:schemeClr val="accent1"/>
+          </a:lnRef>
+          <a:fillRef idx="3">
+            <a:schemeClr val="accent1"/>
+          </a:fillRef>
+          <a:effectRef idx="2">
+            <a:schemeClr val="accent1"/>
+          </a:effectRef>
+          <a:fontRef idx="minor">
+            <a:schemeClr val="lt1"/>
+          </a:fontRef>
+        </p:style>
+        <p:txBody>
+          <a:bodyPr rtlCol="0" anchor="ctr"/>
+          <a:lstStyle/>
+          <a:p>
+            <a:pPr algn="ctr"/>
+          </a:p>
+        </p:txBody>
+      </p:sp>
+      <p:sp>
+        <p:nvSpPr>
+          <p:cNvPr id="78" name="TextBox 77"/>
+          <p:cNvSpPr txBox="1"/>
+          <p:nvPr/>
+        </p:nvSpPr>
+        <p:spPr>
+          <a:xfrm>
+            <a:off x="6382512" y="2395728"/>
+            <a:ext cx="310896" cy="310896"/>
+          </a:xfrm>
+          <a:prstGeom prst="rect">
+            <a:avLst/>
+          </a:prstGeom>
+          <a:noFill/>
+        </p:spPr>
+        <p:txBody>
+          <a:bodyPr wrap="square" lIns="36576" rIns="36576" tIns="18288" bIns="18288" anchor="ctr">
+            <a:spAutoFit/>
+          </a:bodyPr>
+          <a:lstStyle/>
+          <a:p>
+            <a:pPr algn="ctr"/>
+            <a:r>
+              <a:rPr sz="1200" b="1">
+                <a:solidFill>
+                  <a:srgbClr val="6A3FB5"/>
+                </a:solidFill>
+                <a:latin typeface="Calibri"/>
+              </a:rPr>
+              <a:t>3</a:t>
+            </a:r>
+          </a:p>
+        </p:txBody>
+      </p:sp>
+      <p:sp>
+        <p:nvSpPr>
+          <p:cNvPr id="79" name="TextBox 78"/>
+          <p:cNvSpPr txBox="1"/>
+          <p:nvPr/>
+        </p:nvSpPr>
+        <p:spPr>
+          <a:xfrm>
+            <a:off x="6748272" y="2340864"/>
+            <a:ext cx="2066544" cy="420624"/>
+          </a:xfrm>
+          <a:prstGeom prst="rect">
+            <a:avLst/>
+          </a:prstGeom>
+          <a:noFill/>
+        </p:spPr>
+        <p:txBody>
+          <a:bodyPr wrap="square" lIns="36576" rIns="36576" tIns="18288" bIns="18288" anchor="ctr">
+            <a:spAutoFit/>
+          </a:bodyPr>
+          <a:lstStyle/>
+          <a:p>
+            <a:pPr algn="l"/>
+            <a:r>
+              <a:rPr sz="1400" b="1">
+                <a:solidFill>
+                  <a:srgbClr val="FFFFFF"/>
+                </a:solidFill>
+                <a:latin typeface="Calibri"/>
+              </a:rPr>
+              <a:t>Learn once</a:t>
+            </a:r>
+          </a:p>
+        </p:txBody>
+      </p:sp>
+      <p:sp>
+        <p:nvSpPr>
+          <p:cNvPr id="80" name="TextBox 79"/>
+          <p:cNvSpPr txBox="1"/>
+          <p:nvPr/>
+        </p:nvSpPr>
+        <p:spPr>
+          <a:xfrm>
+            <a:off x="6400800" y="2816352"/>
+            <a:ext cx="2395728" cy="795528"/>
+          </a:xfrm>
+          <a:prstGeom prst="rect">
+            <a:avLst/>
+          </a:prstGeom>
+          <a:noFill/>
+        </p:spPr>
+        <p:txBody>
+          <a:bodyPr wrap="square" lIns="36576" rIns="36576" tIns="18288" bIns="18288" anchor="ctr">
+            <a:spAutoFit/>
+          </a:bodyPr>
+          <a:lstStyle/>
+          <a:p>
+            <a:pPr algn="l"/>
+            <a:r>
+              <a:rPr sz="1150" b="0">
+                <a:solidFill>
+                  <a:srgbClr val="1E2530"/>
+                </a:solidFill>
+                <a:latin typeface="Calibri"/>
+              </a:rPr>
+              <a:t>For a brand-new pattern, AI writes a parsing rule one time. The rule is saved and reused.</a:t>
+            </a:r>
+          </a:p>
+        </p:txBody>
+      </p:sp>
+      <p:sp>
+        <p:nvSpPr>
+          <p:cNvPr id="81" name="TextBox 80"/>
+          <p:cNvSpPr txBox="1"/>
+          <p:nvPr/>
+        </p:nvSpPr>
+        <p:spPr>
+          <a:xfrm>
+            <a:off x="8906256" y="2779776"/>
+            <a:ext cx="347472" cy="457200"/>
+          </a:xfrm>
+          <a:prstGeom prst="rect">
+            <a:avLst/>
+          </a:prstGeom>
+          <a:noFill/>
+        </p:spPr>
+        <p:txBody>
+          <a:bodyPr wrap="square" lIns="36576" rIns="36576" tIns="18288" bIns="18288" anchor="t">
+            <a:spAutoFit/>
+          </a:bodyPr>
+          <a:lstStyle/>
+          <a:p>
+            <a:pPr algn="ctr"/>
+            <a:r>
+              <a:rPr sz="1600" b="0">
+                <a:solidFill>
+                  <a:srgbClr val="5F6B7A"/>
+                </a:solidFill>
+                <a:latin typeface="Calibri"/>
+              </a:rPr>
+              <a:t>▶</a:t>
+            </a:r>
+          </a:p>
+        </p:txBody>
+      </p:sp>
+      <p:sp>
+        <p:nvSpPr>
+          <p:cNvPr id="82" name="Rounded Rectangle 81"/>
+          <p:cNvSpPr/>
+          <p:nvPr/>
+        </p:nvSpPr>
+        <p:spPr>
+          <a:xfrm>
+            <a:off x="9253728" y="2340864"/>
+            <a:ext cx="2615184" cy="1325880"/>
+          </a:xfrm>
+          <a:prstGeom prst="roundRect">
+            <a:avLst>
+              <a:gd name="adj" fmla="val 7000"/>
             </a:avLst>
           </a:prstGeom>
           <a:solidFill>
@@ -8428,17 +9055,19 @@
       </p:sp>
       <p:sp>
         <p:nvSpPr>
-          <p:cNvPr id="27" name="Rectangle 26"/>
+          <p:cNvPr id="83" name="Rounded Rectangle 82"/>
           <p:cNvSpPr/>
           <p:nvPr/>
         </p:nvSpPr>
         <p:spPr>
           <a:xfrm>
-            <a:off x="4626864" y="4480560"/>
-            <a:ext cx="2011680" cy="109728"/>
-          </a:xfrm>
-          <a:prstGeom prst="rect">
-            <a:avLst/>
+            <a:off x="9253728" y="2340864"/>
+            <a:ext cx="2615184" cy="420624"/>
+          </a:xfrm>
+          <a:prstGeom prst="roundRect">
+            <a:avLst>
+              <a:gd name="adj" fmla="val 30000"/>
+            </a:avLst>
           </a:prstGeom>
           <a:solidFill>
             <a:srgbClr val="138A36"/>
@@ -8472,130 +9101,23 @@
       </p:sp>
       <p:sp>
         <p:nvSpPr>
-          <p:cNvPr id="28" name="TextBox 27"/>
-          <p:cNvSpPr txBox="1"/>
-          <p:nvPr/>
-        </p:nvSpPr>
-        <p:spPr>
-          <a:xfrm>
-            <a:off x="4718304" y="4645152"/>
-            <a:ext cx="1828800" cy="685800"/>
-          </a:xfrm>
-          <a:prstGeom prst="rect">
-            <a:avLst/>
-          </a:prstGeom>
-          <a:noFill/>
-        </p:spPr>
-        <p:txBody>
-          <a:bodyPr wrap="square" anchor="t" lIns="36576" rIns="36576" tIns="18288" bIns="18288">
-            <a:spAutoFit/>
-          </a:bodyPr>
-          <a:lstStyle/>
-          <a:p>
-            <a:pPr algn="ctr">
-              <a:lnSpc>
-                <a:spcPct val="90000"/>
-              </a:lnSpc>
-              <a:spcAft>
-                <a:spcPts val="0"/>
-              </a:spcAft>
-            </a:pPr>
-            <a:r>
-              <a:rPr sz="1400" b="1" i="0">
-                <a:solidFill>
-                  <a:srgbClr val="138A36"/>
-                </a:solidFill>
-                <a:latin typeface="Calibri"/>
-              </a:rPr>
-              <a:t>Flags never-</a:t>
-            </a:r>
-          </a:p>
-          <a:p>
-            <a:pPr algn="ctr">
-              <a:lnSpc>
-                <a:spcPct val="90000"/>
-              </a:lnSpc>
-              <a:spcAft>
-                <a:spcPts val="0"/>
-              </a:spcAft>
-            </a:pPr>
-            <a:r>
-              <a:rPr sz="1400" b="1" i="0">
-                <a:solidFill>
-                  <a:srgbClr val="138A36"/>
-                </a:solidFill>
-                <a:latin typeface="Calibri"/>
-              </a:rPr>
-              <a:t>seen formats</a:t>
-            </a:r>
-          </a:p>
-        </p:txBody>
-      </p:sp>
-      <p:sp>
-        <p:nvSpPr>
-          <p:cNvPr id="29" name="TextBox 28"/>
-          <p:cNvSpPr txBox="1"/>
-          <p:nvPr/>
-        </p:nvSpPr>
-        <p:spPr>
-          <a:xfrm>
-            <a:off x="4736592" y="5349240"/>
-            <a:ext cx="1792224" cy="868680"/>
-          </a:xfrm>
-          <a:prstGeom prst="rect">
-            <a:avLst/>
-          </a:prstGeom>
-          <a:noFill/>
-        </p:spPr>
-        <p:txBody>
-          <a:bodyPr wrap="square" anchor="t" lIns="36576" rIns="36576" tIns="18288" bIns="18288">
-            <a:spAutoFit/>
-          </a:bodyPr>
-          <a:lstStyle/>
-          <a:p>
-            <a:pPr algn="ctr">
-              <a:lnSpc>
-                <a:spcPct val="100000"/>
-              </a:lnSpc>
-              <a:spcAft>
-                <a:spcPts val="0"/>
-              </a:spcAft>
-            </a:pPr>
-            <a:r>
-              <a:rPr sz="1100" b="0" i="0">
-                <a:solidFill>
-                  <a:srgbClr val="1E2530"/>
-                </a:solidFill>
-                <a:latin typeface="Calibri"/>
-              </a:rPr>
-              <a:t>Designed to flag log formats it has never seen before, for human review</a:t>
-            </a:r>
-          </a:p>
-        </p:txBody>
-      </p:sp>
-      <p:sp>
-        <p:nvSpPr>
-          <p:cNvPr id="30" name="Rounded Rectangle 29"/>
+          <p:cNvPr id="84" name="Oval 83"/>
           <p:cNvSpPr/>
           <p:nvPr/>
         </p:nvSpPr>
         <p:spPr>
           <a:xfrm>
-            <a:off x="6757416" y="4480560"/>
-            <a:ext cx="2011680" cy="1783080"/>
-          </a:xfrm>
-          <a:prstGeom prst="roundRect">
-            <a:avLst>
-              <a:gd name="adj" fmla="val 8000"/>
-            </a:avLst>
+            <a:off x="9345168" y="2395728"/>
+            <a:ext cx="310896" cy="310896"/>
+          </a:xfrm>
+          <a:prstGeom prst="ellipse">
+            <a:avLst/>
           </a:prstGeom>
           <a:solidFill>
             <a:srgbClr val="FFFFFF"/>
           </a:solidFill>
-          <a:ln w="19050">
-            <a:solidFill>
-              <a:srgbClr val="6A3FB5"/>
-            </a:solidFill>
+          <a:ln>
+            <a:noFill/>
           </a:ln>
           <a:effectLst/>
         </p:spPr>
@@ -8623,14 +9145,1475 @@
       </p:sp>
       <p:sp>
         <p:nvSpPr>
-          <p:cNvPr id="31" name="Rectangle 30"/>
+          <p:cNvPr id="85" name="TextBox 84"/>
+          <p:cNvSpPr txBox="1"/>
+          <p:nvPr/>
+        </p:nvSpPr>
+        <p:spPr>
+          <a:xfrm>
+            <a:off x="9345168" y="2395728"/>
+            <a:ext cx="310896" cy="310896"/>
+          </a:xfrm>
+          <a:prstGeom prst="rect">
+            <a:avLst/>
+          </a:prstGeom>
+          <a:noFill/>
+        </p:spPr>
+        <p:txBody>
+          <a:bodyPr wrap="square" lIns="36576" rIns="36576" tIns="18288" bIns="18288" anchor="ctr">
+            <a:spAutoFit/>
+          </a:bodyPr>
+          <a:lstStyle/>
+          <a:p>
+            <a:pPr algn="ctr"/>
+            <a:r>
+              <a:rPr sz="1200" b="1">
+                <a:solidFill>
+                  <a:srgbClr val="138A36"/>
+                </a:solidFill>
+                <a:latin typeface="Calibri"/>
+              </a:rPr>
+              <a:t>4</a:t>
+            </a:r>
+          </a:p>
+        </p:txBody>
+      </p:sp>
+      <p:sp>
+        <p:nvSpPr>
+          <p:cNvPr id="86" name="TextBox 85"/>
+          <p:cNvSpPr txBox="1"/>
+          <p:nvPr/>
+        </p:nvSpPr>
+        <p:spPr>
+          <a:xfrm>
+            <a:off x="9710928" y="2340864"/>
+            <a:ext cx="2066544" cy="420624"/>
+          </a:xfrm>
+          <a:prstGeom prst="rect">
+            <a:avLst/>
+          </a:prstGeom>
+          <a:noFill/>
+        </p:spPr>
+        <p:txBody>
+          <a:bodyPr wrap="square" lIns="36576" rIns="36576" tIns="18288" bIns="18288" anchor="ctr">
+            <a:spAutoFit/>
+          </a:bodyPr>
+          <a:lstStyle/>
+          <a:p>
+            <a:pPr algn="l"/>
+            <a:r>
+              <a:rPr sz="1400" b="1">
+                <a:solidFill>
+                  <a:srgbClr val="FFFFFF"/>
+                </a:solidFill>
+                <a:latin typeface="Calibri"/>
+              </a:rPr>
+              <a:t>Clean output</a:t>
+            </a:r>
+          </a:p>
+        </p:txBody>
+      </p:sp>
+      <p:sp>
+        <p:nvSpPr>
+          <p:cNvPr id="87" name="TextBox 86"/>
+          <p:cNvSpPr txBox="1"/>
+          <p:nvPr/>
+        </p:nvSpPr>
+        <p:spPr>
+          <a:xfrm>
+            <a:off x="9363456" y="2816352"/>
+            <a:ext cx="2395728" cy="795528"/>
+          </a:xfrm>
+          <a:prstGeom prst="rect">
+            <a:avLst/>
+          </a:prstGeom>
+          <a:noFill/>
+        </p:spPr>
+        <p:txBody>
+          <a:bodyPr wrap="square" lIns="36576" rIns="36576" tIns="18288" bIns="18288" anchor="ctr">
+            <a:spAutoFit/>
+          </a:bodyPr>
+          <a:lstStyle/>
+          <a:p>
+            <a:pPr algn="l"/>
+            <a:r>
+              <a:rPr sz="1150" b="0">
+                <a:solidFill>
+                  <a:srgbClr val="1E2530"/>
+                </a:solidFill>
+                <a:latin typeface="Calibri"/>
+              </a:rPr>
+              <a:t>Every log leaves in one format: time (UTC), source, event, severity and message.</a:t>
+            </a:r>
+          </a:p>
+        </p:txBody>
+      </p:sp>
+      <p:sp>
+        <p:nvSpPr>
+          <p:cNvPr id="88" name="Rounded Rectangle 87"/>
           <p:cNvSpPr/>
           <p:nvPr/>
         </p:nvSpPr>
         <p:spPr>
           <a:xfrm>
-            <a:off x="6757416" y="4480560"/>
-            <a:ext cx="2011680" cy="109728"/>
+            <a:off x="365760" y="3739896"/>
+            <a:ext cx="11503152" cy="329184"/>
+          </a:xfrm>
+          <a:prstGeom prst="roundRect">
+            <a:avLst>
+              <a:gd name="adj" fmla="val 30000"/>
+            </a:avLst>
+          </a:prstGeom>
+          <a:solidFill>
+            <a:srgbClr val="F2F5FA"/>
+          </a:solidFill>
+          <a:ln>
+            <a:noFill/>
+          </a:ln>
+          <a:effectLst/>
+        </p:spPr>
+        <p:style>
+          <a:lnRef idx="1">
+            <a:schemeClr val="accent1"/>
+          </a:lnRef>
+          <a:fillRef idx="3">
+            <a:schemeClr val="accent1"/>
+          </a:fillRef>
+          <a:effectRef idx="2">
+            <a:schemeClr val="accent1"/>
+          </a:effectRef>
+          <a:fontRef idx="minor">
+            <a:schemeClr val="lt1"/>
+          </a:fontRef>
+        </p:style>
+        <p:txBody>
+          <a:bodyPr rtlCol="0" anchor="ctr"/>
+          <a:lstStyle/>
+          <a:p>
+            <a:pPr algn="ctr"/>
+          </a:p>
+        </p:txBody>
+      </p:sp>
+      <p:sp>
+        <p:nvSpPr>
+          <p:cNvPr id="89" name="TextBox 88"/>
+          <p:cNvSpPr txBox="1"/>
+          <p:nvPr/>
+        </p:nvSpPr>
+        <p:spPr>
+          <a:xfrm>
+            <a:off x="502920" y="3739896"/>
+            <a:ext cx="11247120" cy="329184"/>
+          </a:xfrm>
+          <a:prstGeom prst="rect">
+            <a:avLst/>
+          </a:prstGeom>
+          <a:noFill/>
+        </p:spPr>
+        <p:txBody>
+          <a:bodyPr wrap="square" lIns="36576" rIns="36576" tIns="18288" bIns="18288" anchor="ctr">
+            <a:spAutoFit/>
+          </a:bodyPr>
+          <a:lstStyle/>
+          <a:p>
+            <a:pPr algn="l"/>
+            <a:r>
+              <a:rPr sz="1100" b="1">
+                <a:solidFill>
+                  <a:srgbClr val="0B2A5B"/>
+                </a:solidFill>
+                <a:latin typeface="Calibri"/>
+              </a:rPr>
+              <a:t>Safety net:  </a:t>
+            </a:r>
+            <a:r>
+              <a:rPr sz="1100" b="0">
+                <a:solidFill>
+                  <a:srgbClr val="1E2530"/>
+                </a:solidFill>
+                <a:latin typeface="Calibri"/>
+              </a:rPr>
+              <a:t>unfamiliar formats are held for review, never lost  ·  if the AI service is down, a backup AI and built-in rules take over  ·  can run fully on-premise</a:t>
+            </a:r>
+          </a:p>
+        </p:txBody>
+      </p:sp>
+      <p:sp>
+        <p:nvSpPr>
+          <p:cNvPr id="90" name="TextBox 89"/>
+          <p:cNvSpPr txBox="1"/>
+          <p:nvPr/>
+        </p:nvSpPr>
+        <p:spPr>
+          <a:xfrm>
+            <a:off x="365760" y="4160520"/>
+            <a:ext cx="5669280" cy="292608"/>
+          </a:xfrm>
+          <a:prstGeom prst="rect">
+            <a:avLst/>
+          </a:prstGeom>
+          <a:noFill/>
+        </p:spPr>
+        <p:txBody>
+          <a:bodyPr wrap="square" lIns="36576" rIns="36576" tIns="18288" bIns="18288" anchor="t">
+            <a:spAutoFit/>
+          </a:bodyPr>
+          <a:lstStyle/>
+          <a:p>
+            <a:pPr algn="l"/>
+            <a:r>
+              <a:rPr sz="1450" b="1">
+                <a:solidFill>
+                  <a:srgbClr val="0B2A5B"/>
+                </a:solidFill>
+                <a:latin typeface="Calibri"/>
+              </a:rPr>
+              <a:t>How it addresses the problem</a:t>
+            </a:r>
+          </a:p>
+        </p:txBody>
+      </p:sp>
+      <p:sp>
+        <p:nvSpPr>
+          <p:cNvPr id="91" name="Rectangle 90"/>
+          <p:cNvSpPr/>
+          <p:nvPr/>
+        </p:nvSpPr>
+        <p:spPr>
+          <a:xfrm>
+            <a:off x="402336" y="4462272"/>
+            <a:ext cx="822960" cy="41148"/>
+          </a:xfrm>
+          <a:prstGeom prst="rect">
+            <a:avLst/>
+          </a:prstGeom>
+          <a:solidFill>
+            <a:srgbClr val="F58220"/>
+          </a:solidFill>
+          <a:ln>
+            <a:noFill/>
+          </a:ln>
+          <a:effectLst/>
+        </p:spPr>
+        <p:style>
+          <a:lnRef idx="1">
+            <a:schemeClr val="accent1"/>
+          </a:lnRef>
+          <a:fillRef idx="3">
+            <a:schemeClr val="accent1"/>
+          </a:fillRef>
+          <a:effectRef idx="2">
+            <a:schemeClr val="accent1"/>
+          </a:effectRef>
+          <a:fontRef idx="minor">
+            <a:schemeClr val="lt1"/>
+          </a:fontRef>
+        </p:style>
+        <p:txBody>
+          <a:bodyPr rtlCol="0" anchor="ctr"/>
+          <a:lstStyle/>
+          <a:p>
+            <a:pPr algn="ctr"/>
+          </a:p>
+        </p:txBody>
+      </p:sp>
+      <p:sp>
+        <p:nvSpPr>
+          <p:cNvPr id="92" name="Rounded Rectangle 91"/>
+          <p:cNvSpPr/>
+          <p:nvPr/>
+        </p:nvSpPr>
+        <p:spPr>
+          <a:xfrm>
+            <a:off x="365760" y="4562856"/>
+            <a:ext cx="2514600" cy="329184"/>
+          </a:xfrm>
+          <a:prstGeom prst="roundRect">
+            <a:avLst>
+              <a:gd name="adj" fmla="val 30000"/>
+            </a:avLst>
+          </a:prstGeom>
+          <a:solidFill>
+            <a:srgbClr val="FDECEA"/>
+          </a:solidFill>
+          <a:ln>
+            <a:noFill/>
+          </a:ln>
+          <a:effectLst/>
+        </p:spPr>
+        <p:style>
+          <a:lnRef idx="1">
+            <a:schemeClr val="accent1"/>
+          </a:lnRef>
+          <a:fillRef idx="3">
+            <a:schemeClr val="accent1"/>
+          </a:fillRef>
+          <a:effectRef idx="2">
+            <a:schemeClr val="accent1"/>
+          </a:effectRef>
+          <a:fontRef idx="minor">
+            <a:schemeClr val="lt1"/>
+          </a:fontRef>
+        </p:style>
+        <p:txBody>
+          <a:bodyPr rtlCol="0" anchor="ctr"/>
+          <a:lstStyle/>
+          <a:p>
+            <a:pPr algn="ctr"/>
+          </a:p>
+        </p:txBody>
+      </p:sp>
+      <p:sp>
+        <p:nvSpPr>
+          <p:cNvPr id="93" name="TextBox 92"/>
+          <p:cNvSpPr txBox="1"/>
+          <p:nvPr/>
+        </p:nvSpPr>
+        <p:spPr>
+          <a:xfrm>
+            <a:off x="411480" y="4562856"/>
+            <a:ext cx="2423160" cy="329184"/>
+          </a:xfrm>
+          <a:prstGeom prst="rect">
+            <a:avLst/>
+          </a:prstGeom>
+          <a:noFill/>
+        </p:spPr>
+        <p:txBody>
+          <a:bodyPr wrap="square" lIns="36576" rIns="36576" tIns="18288" bIns="18288" anchor="ctr">
+            <a:spAutoFit/>
+          </a:bodyPr>
+          <a:lstStyle/>
+          <a:p>
+            <a:pPr algn="l"/>
+            <a:r>
+              <a:rPr sz="1100" b="1">
+                <a:solidFill>
+                  <a:srgbClr val="C0392B"/>
+                </a:solidFill>
+                <a:latin typeface="Calibri"/>
+              </a:rPr>
+              <a:t>✖ Hundreds of log formats</a:t>
+            </a:r>
+          </a:p>
+        </p:txBody>
+      </p:sp>
+      <p:sp>
+        <p:nvSpPr>
+          <p:cNvPr id="94" name="TextBox 93"/>
+          <p:cNvSpPr txBox="1"/>
+          <p:nvPr/>
+        </p:nvSpPr>
+        <p:spPr>
+          <a:xfrm>
+            <a:off x="2880360" y="4562856"/>
+            <a:ext cx="320040" cy="329184"/>
+          </a:xfrm>
+          <a:prstGeom prst="rect">
+            <a:avLst/>
+          </a:prstGeom>
+          <a:noFill/>
+        </p:spPr>
+        <p:txBody>
+          <a:bodyPr wrap="square" lIns="36576" rIns="36576" tIns="18288" bIns="18288" anchor="ctr">
+            <a:spAutoFit/>
+          </a:bodyPr>
+          <a:lstStyle/>
+          <a:p>
+            <a:pPr algn="ctr"/>
+            <a:r>
+              <a:rPr sz="1400" b="1">
+                <a:solidFill>
+                  <a:srgbClr val="5F6B7A"/>
+                </a:solidFill>
+                <a:latin typeface="Calibri"/>
+              </a:rPr>
+              <a:t>→</a:t>
+            </a:r>
+          </a:p>
+        </p:txBody>
+      </p:sp>
+      <p:sp>
+        <p:nvSpPr>
+          <p:cNvPr id="95" name="Rounded Rectangle 94"/>
+          <p:cNvSpPr/>
+          <p:nvPr/>
+        </p:nvSpPr>
+        <p:spPr>
+          <a:xfrm>
+            <a:off x="3200400" y="4562856"/>
+            <a:ext cx="2834640" cy="329184"/>
+          </a:xfrm>
+          <a:prstGeom prst="roundRect">
+            <a:avLst>
+              <a:gd name="adj" fmla="val 30000"/>
+            </a:avLst>
+          </a:prstGeom>
+          <a:solidFill>
+            <a:srgbClr val="E8F5EC"/>
+          </a:solidFill>
+          <a:ln>
+            <a:noFill/>
+          </a:ln>
+          <a:effectLst/>
+        </p:spPr>
+        <p:style>
+          <a:lnRef idx="1">
+            <a:schemeClr val="accent1"/>
+          </a:lnRef>
+          <a:fillRef idx="3">
+            <a:schemeClr val="accent1"/>
+          </a:fillRef>
+          <a:effectRef idx="2">
+            <a:schemeClr val="accent1"/>
+          </a:effectRef>
+          <a:fontRef idx="minor">
+            <a:schemeClr val="lt1"/>
+          </a:fontRef>
+        </p:style>
+        <p:txBody>
+          <a:bodyPr rtlCol="0" anchor="ctr"/>
+          <a:lstStyle/>
+          <a:p>
+            <a:pPr algn="ctr"/>
+          </a:p>
+        </p:txBody>
+      </p:sp>
+      <p:sp>
+        <p:nvSpPr>
+          <p:cNvPr id="96" name="TextBox 95"/>
+          <p:cNvSpPr txBox="1"/>
+          <p:nvPr/>
+        </p:nvSpPr>
+        <p:spPr>
+          <a:xfrm>
+            <a:off x="3246120" y="4562856"/>
+            <a:ext cx="2743200" cy="329184"/>
+          </a:xfrm>
+          <a:prstGeom prst="rect">
+            <a:avLst/>
+          </a:prstGeom>
+          <a:noFill/>
+        </p:spPr>
+        <p:txBody>
+          <a:bodyPr wrap="square" lIns="36576" rIns="36576" tIns="18288" bIns="18288" anchor="ctr">
+            <a:spAutoFit/>
+          </a:bodyPr>
+          <a:lstStyle/>
+          <a:p>
+            <a:pPr algn="l"/>
+            <a:r>
+              <a:rPr sz="1100" b="1">
+                <a:solidFill>
+                  <a:srgbClr val="138A36"/>
+                </a:solidFill>
+                <a:latin typeface="Calibri"/>
+              </a:rPr>
+              <a:t>✔ Learned automatically, no coding</a:t>
+            </a:r>
+          </a:p>
+        </p:txBody>
+      </p:sp>
+      <p:sp>
+        <p:nvSpPr>
+          <p:cNvPr id="97" name="Rounded Rectangle 96"/>
+          <p:cNvSpPr/>
+          <p:nvPr/>
+        </p:nvSpPr>
+        <p:spPr>
+          <a:xfrm>
+            <a:off x="365760" y="4937760"/>
+            <a:ext cx="2514600" cy="329184"/>
+          </a:xfrm>
+          <a:prstGeom prst="roundRect">
+            <a:avLst>
+              <a:gd name="adj" fmla="val 30000"/>
+            </a:avLst>
+          </a:prstGeom>
+          <a:solidFill>
+            <a:srgbClr val="FDECEA"/>
+          </a:solidFill>
+          <a:ln>
+            <a:noFill/>
+          </a:ln>
+          <a:effectLst/>
+        </p:spPr>
+        <p:style>
+          <a:lnRef idx="1">
+            <a:schemeClr val="accent1"/>
+          </a:lnRef>
+          <a:fillRef idx="3">
+            <a:schemeClr val="accent1"/>
+          </a:fillRef>
+          <a:effectRef idx="2">
+            <a:schemeClr val="accent1"/>
+          </a:effectRef>
+          <a:fontRef idx="minor">
+            <a:schemeClr val="lt1"/>
+          </a:fontRef>
+        </p:style>
+        <p:txBody>
+          <a:bodyPr rtlCol="0" anchor="ctr"/>
+          <a:lstStyle/>
+          <a:p>
+            <a:pPr algn="ctr"/>
+          </a:p>
+        </p:txBody>
+      </p:sp>
+      <p:sp>
+        <p:nvSpPr>
+          <p:cNvPr id="98" name="TextBox 97"/>
+          <p:cNvSpPr txBox="1"/>
+          <p:nvPr/>
+        </p:nvSpPr>
+        <p:spPr>
+          <a:xfrm>
+            <a:off x="411480" y="4937760"/>
+            <a:ext cx="2423160" cy="329184"/>
+          </a:xfrm>
+          <a:prstGeom prst="rect">
+            <a:avLst/>
+          </a:prstGeom>
+          <a:noFill/>
+        </p:spPr>
+        <p:txBody>
+          <a:bodyPr wrap="square" lIns="36576" rIns="36576" tIns="18288" bIns="18288" anchor="ctr">
+            <a:spAutoFit/>
+          </a:bodyPr>
+          <a:lstStyle/>
+          <a:p>
+            <a:pPr algn="l"/>
+            <a:r>
+              <a:rPr sz="1100" b="1">
+                <a:solidFill>
+                  <a:srgbClr val="C0392B"/>
+                </a:solidFill>
+                <a:latin typeface="Calibri"/>
+              </a:rPr>
+              <a:t>✖ Hand-written parsers break</a:t>
+            </a:r>
+          </a:p>
+        </p:txBody>
+      </p:sp>
+      <p:sp>
+        <p:nvSpPr>
+          <p:cNvPr id="99" name="TextBox 98"/>
+          <p:cNvSpPr txBox="1"/>
+          <p:nvPr/>
+        </p:nvSpPr>
+        <p:spPr>
+          <a:xfrm>
+            <a:off x="2880360" y="4937760"/>
+            <a:ext cx="320040" cy="329184"/>
+          </a:xfrm>
+          <a:prstGeom prst="rect">
+            <a:avLst/>
+          </a:prstGeom>
+          <a:noFill/>
+        </p:spPr>
+        <p:txBody>
+          <a:bodyPr wrap="square" lIns="36576" rIns="36576" tIns="18288" bIns="18288" anchor="ctr">
+            <a:spAutoFit/>
+          </a:bodyPr>
+          <a:lstStyle/>
+          <a:p>
+            <a:pPr algn="ctr"/>
+            <a:r>
+              <a:rPr sz="1400" b="1">
+                <a:solidFill>
+                  <a:srgbClr val="5F6B7A"/>
+                </a:solidFill>
+                <a:latin typeface="Calibri"/>
+              </a:rPr>
+              <a:t>→</a:t>
+            </a:r>
+          </a:p>
+        </p:txBody>
+      </p:sp>
+      <p:sp>
+        <p:nvSpPr>
+          <p:cNvPr id="100" name="Rounded Rectangle 99"/>
+          <p:cNvSpPr/>
+          <p:nvPr/>
+        </p:nvSpPr>
+        <p:spPr>
+          <a:xfrm>
+            <a:off x="3200400" y="4937760"/>
+            <a:ext cx="2834640" cy="329184"/>
+          </a:xfrm>
+          <a:prstGeom prst="roundRect">
+            <a:avLst>
+              <a:gd name="adj" fmla="val 30000"/>
+            </a:avLst>
+          </a:prstGeom>
+          <a:solidFill>
+            <a:srgbClr val="E8F5EC"/>
+          </a:solidFill>
+          <a:ln>
+            <a:noFill/>
+          </a:ln>
+          <a:effectLst/>
+        </p:spPr>
+        <p:style>
+          <a:lnRef idx="1">
+            <a:schemeClr val="accent1"/>
+          </a:lnRef>
+          <a:fillRef idx="3">
+            <a:schemeClr val="accent1"/>
+          </a:fillRef>
+          <a:effectRef idx="2">
+            <a:schemeClr val="accent1"/>
+          </a:effectRef>
+          <a:fontRef idx="minor">
+            <a:schemeClr val="lt1"/>
+          </a:fontRef>
+        </p:style>
+        <p:txBody>
+          <a:bodyPr rtlCol="0" anchor="ctr"/>
+          <a:lstStyle/>
+          <a:p>
+            <a:pPr algn="ctr"/>
+          </a:p>
+        </p:txBody>
+      </p:sp>
+      <p:sp>
+        <p:nvSpPr>
+          <p:cNvPr id="101" name="TextBox 100"/>
+          <p:cNvSpPr txBox="1"/>
+          <p:nvPr/>
+        </p:nvSpPr>
+        <p:spPr>
+          <a:xfrm>
+            <a:off x="3246120" y="4937760"/>
+            <a:ext cx="2743200" cy="329184"/>
+          </a:xfrm>
+          <a:prstGeom prst="rect">
+            <a:avLst/>
+          </a:prstGeom>
+          <a:noFill/>
+        </p:spPr>
+        <p:txBody>
+          <a:bodyPr wrap="square" lIns="36576" rIns="36576" tIns="18288" bIns="18288" anchor="ctr">
+            <a:spAutoFit/>
+          </a:bodyPr>
+          <a:lstStyle/>
+          <a:p>
+            <a:pPr algn="l"/>
+            <a:r>
+              <a:rPr sz="1100" b="1">
+                <a:solidFill>
+                  <a:srgbClr val="138A36"/>
+                </a:solidFill>
+                <a:latin typeface="Calibri"/>
+              </a:rPr>
+              <a:t>✔ No parser code to write or fix</a:t>
+            </a:r>
+          </a:p>
+        </p:txBody>
+      </p:sp>
+      <p:sp>
+        <p:nvSpPr>
+          <p:cNvPr id="102" name="Rounded Rectangle 101"/>
+          <p:cNvSpPr/>
+          <p:nvPr/>
+        </p:nvSpPr>
+        <p:spPr>
+          <a:xfrm>
+            <a:off x="365760" y="5312664"/>
+            <a:ext cx="2514600" cy="329184"/>
+          </a:xfrm>
+          <a:prstGeom prst="roundRect">
+            <a:avLst>
+              <a:gd name="adj" fmla="val 30000"/>
+            </a:avLst>
+          </a:prstGeom>
+          <a:solidFill>
+            <a:srgbClr val="FDECEA"/>
+          </a:solidFill>
+          <a:ln>
+            <a:noFill/>
+          </a:ln>
+          <a:effectLst/>
+        </p:spPr>
+        <p:style>
+          <a:lnRef idx="1">
+            <a:schemeClr val="accent1"/>
+          </a:lnRef>
+          <a:fillRef idx="3">
+            <a:schemeClr val="accent1"/>
+          </a:fillRef>
+          <a:effectRef idx="2">
+            <a:schemeClr val="accent1"/>
+          </a:effectRef>
+          <a:fontRef idx="minor">
+            <a:schemeClr val="lt1"/>
+          </a:fontRef>
+        </p:style>
+        <p:txBody>
+          <a:bodyPr rtlCol="0" anchor="ctr"/>
+          <a:lstStyle/>
+          <a:p>
+            <a:pPr algn="ctr"/>
+          </a:p>
+        </p:txBody>
+      </p:sp>
+      <p:sp>
+        <p:nvSpPr>
+          <p:cNvPr id="103" name="TextBox 102"/>
+          <p:cNvSpPr txBox="1"/>
+          <p:nvPr/>
+        </p:nvSpPr>
+        <p:spPr>
+          <a:xfrm>
+            <a:off x="411480" y="5312664"/>
+            <a:ext cx="2423160" cy="329184"/>
+          </a:xfrm>
+          <a:prstGeom prst="rect">
+            <a:avLst/>
+          </a:prstGeom>
+          <a:noFill/>
+        </p:spPr>
+        <p:txBody>
+          <a:bodyPr wrap="square" lIns="36576" rIns="36576" tIns="18288" bIns="18288" anchor="ctr">
+            <a:spAutoFit/>
+          </a:bodyPr>
+          <a:lstStyle/>
+          <a:p>
+            <a:pPr algn="l"/>
+            <a:r>
+              <a:rPr sz="1100" b="1">
+                <a:solidFill>
+                  <a:srgbClr val="C0392B"/>
+                </a:solidFill>
+                <a:latin typeface="Calibri"/>
+              </a:rPr>
+              <a:t>✖ AI on every log is costly</a:t>
+            </a:r>
+          </a:p>
+        </p:txBody>
+      </p:sp>
+      <p:sp>
+        <p:nvSpPr>
+          <p:cNvPr id="104" name="TextBox 103"/>
+          <p:cNvSpPr txBox="1"/>
+          <p:nvPr/>
+        </p:nvSpPr>
+        <p:spPr>
+          <a:xfrm>
+            <a:off x="2880360" y="5312664"/>
+            <a:ext cx="320040" cy="329184"/>
+          </a:xfrm>
+          <a:prstGeom prst="rect">
+            <a:avLst/>
+          </a:prstGeom>
+          <a:noFill/>
+        </p:spPr>
+        <p:txBody>
+          <a:bodyPr wrap="square" lIns="36576" rIns="36576" tIns="18288" bIns="18288" anchor="ctr">
+            <a:spAutoFit/>
+          </a:bodyPr>
+          <a:lstStyle/>
+          <a:p>
+            <a:pPr algn="ctr"/>
+            <a:r>
+              <a:rPr sz="1400" b="1">
+                <a:solidFill>
+                  <a:srgbClr val="5F6B7A"/>
+                </a:solidFill>
+                <a:latin typeface="Calibri"/>
+              </a:rPr>
+              <a:t>→</a:t>
+            </a:r>
+          </a:p>
+        </p:txBody>
+      </p:sp>
+      <p:sp>
+        <p:nvSpPr>
+          <p:cNvPr id="105" name="Rounded Rectangle 104"/>
+          <p:cNvSpPr/>
+          <p:nvPr/>
+        </p:nvSpPr>
+        <p:spPr>
+          <a:xfrm>
+            <a:off x="3200400" y="5312664"/>
+            <a:ext cx="2834640" cy="329184"/>
+          </a:xfrm>
+          <a:prstGeom prst="roundRect">
+            <a:avLst>
+              <a:gd name="adj" fmla="val 30000"/>
+            </a:avLst>
+          </a:prstGeom>
+          <a:solidFill>
+            <a:srgbClr val="E8F5EC"/>
+          </a:solidFill>
+          <a:ln>
+            <a:noFill/>
+          </a:ln>
+          <a:effectLst/>
+        </p:spPr>
+        <p:style>
+          <a:lnRef idx="1">
+            <a:schemeClr val="accent1"/>
+          </a:lnRef>
+          <a:fillRef idx="3">
+            <a:schemeClr val="accent1"/>
+          </a:fillRef>
+          <a:effectRef idx="2">
+            <a:schemeClr val="accent1"/>
+          </a:effectRef>
+          <a:fontRef idx="minor">
+            <a:schemeClr val="lt1"/>
+          </a:fontRef>
+        </p:style>
+        <p:txBody>
+          <a:bodyPr rtlCol="0" anchor="ctr"/>
+          <a:lstStyle/>
+          <a:p>
+            <a:pPr algn="ctr"/>
+          </a:p>
+        </p:txBody>
+      </p:sp>
+      <p:sp>
+        <p:nvSpPr>
+          <p:cNvPr id="106" name="TextBox 105"/>
+          <p:cNvSpPr txBox="1"/>
+          <p:nvPr/>
+        </p:nvSpPr>
+        <p:spPr>
+          <a:xfrm>
+            <a:off x="3246120" y="5312664"/>
+            <a:ext cx="2743200" cy="329184"/>
+          </a:xfrm>
+          <a:prstGeom prst="rect">
+            <a:avLst/>
+          </a:prstGeom>
+          <a:noFill/>
+        </p:spPr>
+        <p:txBody>
+          <a:bodyPr wrap="square" lIns="36576" rIns="36576" tIns="18288" bIns="18288" anchor="ctr">
+            <a:spAutoFit/>
+          </a:bodyPr>
+          <a:lstStyle/>
+          <a:p>
+            <a:pPr algn="l"/>
+            <a:r>
+              <a:rPr sz="1100" b="1">
+                <a:solidFill>
+                  <a:srgbClr val="138A36"/>
+                </a:solidFill>
+                <a:latin typeface="Calibri"/>
+              </a:rPr>
+              <a:t>✔ AI once per format, not per log</a:t>
+            </a:r>
+          </a:p>
+        </p:txBody>
+      </p:sp>
+      <p:sp>
+        <p:nvSpPr>
+          <p:cNvPr id="107" name="Rounded Rectangle 106"/>
+          <p:cNvSpPr/>
+          <p:nvPr/>
+        </p:nvSpPr>
+        <p:spPr>
+          <a:xfrm>
+            <a:off x="365760" y="5687568"/>
+            <a:ext cx="2514600" cy="329184"/>
+          </a:xfrm>
+          <a:prstGeom prst="roundRect">
+            <a:avLst>
+              <a:gd name="adj" fmla="val 30000"/>
+            </a:avLst>
+          </a:prstGeom>
+          <a:solidFill>
+            <a:srgbClr val="FDECEA"/>
+          </a:solidFill>
+          <a:ln>
+            <a:noFill/>
+          </a:ln>
+          <a:effectLst/>
+        </p:spPr>
+        <p:style>
+          <a:lnRef idx="1">
+            <a:schemeClr val="accent1"/>
+          </a:lnRef>
+          <a:fillRef idx="3">
+            <a:schemeClr val="accent1"/>
+          </a:fillRef>
+          <a:effectRef idx="2">
+            <a:schemeClr val="accent1"/>
+          </a:effectRef>
+          <a:fontRef idx="minor">
+            <a:schemeClr val="lt1"/>
+          </a:fontRef>
+        </p:style>
+        <p:txBody>
+          <a:bodyPr rtlCol="0" anchor="ctr"/>
+          <a:lstStyle/>
+          <a:p>
+            <a:pPr algn="ctr"/>
+          </a:p>
+        </p:txBody>
+      </p:sp>
+      <p:sp>
+        <p:nvSpPr>
+          <p:cNvPr id="108" name="TextBox 107"/>
+          <p:cNvSpPr txBox="1"/>
+          <p:nvPr/>
+        </p:nvSpPr>
+        <p:spPr>
+          <a:xfrm>
+            <a:off x="411480" y="5687568"/>
+            <a:ext cx="2423160" cy="329184"/>
+          </a:xfrm>
+          <a:prstGeom prst="rect">
+            <a:avLst/>
+          </a:prstGeom>
+          <a:noFill/>
+        </p:spPr>
+        <p:txBody>
+          <a:bodyPr wrap="square" lIns="36576" rIns="36576" tIns="18288" bIns="18288" anchor="ctr">
+            <a:spAutoFit/>
+          </a:bodyPr>
+          <a:lstStyle/>
+          <a:p>
+            <a:pPr algn="l"/>
+            <a:r>
+              <a:rPr sz="1100" b="1">
+                <a:solidFill>
+                  <a:srgbClr val="C0392B"/>
+                </a:solidFill>
+                <a:latin typeface="Calibri"/>
+              </a:rPr>
+              <a:t>✖ Logs are hard to search</a:t>
+            </a:r>
+          </a:p>
+        </p:txBody>
+      </p:sp>
+      <p:sp>
+        <p:nvSpPr>
+          <p:cNvPr id="109" name="TextBox 108"/>
+          <p:cNvSpPr txBox="1"/>
+          <p:nvPr/>
+        </p:nvSpPr>
+        <p:spPr>
+          <a:xfrm>
+            <a:off x="2880360" y="5687568"/>
+            <a:ext cx="320040" cy="329184"/>
+          </a:xfrm>
+          <a:prstGeom prst="rect">
+            <a:avLst/>
+          </a:prstGeom>
+          <a:noFill/>
+        </p:spPr>
+        <p:txBody>
+          <a:bodyPr wrap="square" lIns="36576" rIns="36576" tIns="18288" bIns="18288" anchor="ctr">
+            <a:spAutoFit/>
+          </a:bodyPr>
+          <a:lstStyle/>
+          <a:p>
+            <a:pPr algn="ctr"/>
+            <a:r>
+              <a:rPr sz="1400" b="1">
+                <a:solidFill>
+                  <a:srgbClr val="5F6B7A"/>
+                </a:solidFill>
+                <a:latin typeface="Calibri"/>
+              </a:rPr>
+              <a:t>→</a:t>
+            </a:r>
+          </a:p>
+        </p:txBody>
+      </p:sp>
+      <p:sp>
+        <p:nvSpPr>
+          <p:cNvPr id="110" name="Rounded Rectangle 109"/>
+          <p:cNvSpPr/>
+          <p:nvPr/>
+        </p:nvSpPr>
+        <p:spPr>
+          <a:xfrm>
+            <a:off x="3200400" y="5687568"/>
+            <a:ext cx="2834640" cy="329184"/>
+          </a:xfrm>
+          <a:prstGeom prst="roundRect">
+            <a:avLst>
+              <a:gd name="adj" fmla="val 30000"/>
+            </a:avLst>
+          </a:prstGeom>
+          <a:solidFill>
+            <a:srgbClr val="E8F5EC"/>
+          </a:solidFill>
+          <a:ln>
+            <a:noFill/>
+          </a:ln>
+          <a:effectLst/>
+        </p:spPr>
+        <p:style>
+          <a:lnRef idx="1">
+            <a:schemeClr val="accent1"/>
+          </a:lnRef>
+          <a:fillRef idx="3">
+            <a:schemeClr val="accent1"/>
+          </a:fillRef>
+          <a:effectRef idx="2">
+            <a:schemeClr val="accent1"/>
+          </a:effectRef>
+          <a:fontRef idx="minor">
+            <a:schemeClr val="lt1"/>
+          </a:fontRef>
+        </p:style>
+        <p:txBody>
+          <a:bodyPr rtlCol="0" anchor="ctr"/>
+          <a:lstStyle/>
+          <a:p>
+            <a:pPr algn="ctr"/>
+          </a:p>
+        </p:txBody>
+      </p:sp>
+      <p:sp>
+        <p:nvSpPr>
+          <p:cNvPr id="111" name="TextBox 110"/>
+          <p:cNvSpPr txBox="1"/>
+          <p:nvPr/>
+        </p:nvSpPr>
+        <p:spPr>
+          <a:xfrm>
+            <a:off x="3246120" y="5687568"/>
+            <a:ext cx="2743200" cy="329184"/>
+          </a:xfrm>
+          <a:prstGeom prst="rect">
+            <a:avLst/>
+          </a:prstGeom>
+          <a:noFill/>
+        </p:spPr>
+        <p:txBody>
+          <a:bodyPr wrap="square" lIns="36576" rIns="36576" tIns="18288" bIns="18288" anchor="ctr">
+            <a:spAutoFit/>
+          </a:bodyPr>
+          <a:lstStyle/>
+          <a:p>
+            <a:pPr algn="l"/>
+            <a:r>
+              <a:rPr sz="1100" b="1">
+                <a:solidFill>
+                  <a:srgbClr val="138A36"/>
+                </a:solidFill>
+                <a:latin typeface="Calibri"/>
+              </a:rPr>
+              <a:t>✔ One clean, time-aligned format</a:t>
+            </a:r>
+          </a:p>
+        </p:txBody>
+      </p:sp>
+      <p:sp>
+        <p:nvSpPr>
+          <p:cNvPr id="112" name="TextBox 111"/>
+          <p:cNvSpPr txBox="1"/>
+          <p:nvPr/>
+        </p:nvSpPr>
+        <p:spPr>
+          <a:xfrm>
+            <a:off x="6263640" y="4160520"/>
+            <a:ext cx="5577840" cy="292608"/>
+          </a:xfrm>
+          <a:prstGeom prst="rect">
+            <a:avLst/>
+          </a:prstGeom>
+          <a:noFill/>
+        </p:spPr>
+        <p:txBody>
+          <a:bodyPr wrap="square" lIns="36576" rIns="36576" tIns="18288" bIns="18288" anchor="t">
+            <a:spAutoFit/>
+          </a:bodyPr>
+          <a:lstStyle/>
+          <a:p>
+            <a:pPr algn="l"/>
+            <a:r>
+              <a:rPr sz="1450" b="1">
+                <a:solidFill>
+                  <a:srgbClr val="0B2A5B"/>
+                </a:solidFill>
+                <a:latin typeface="Calibri"/>
+              </a:rPr>
+              <a:t>Innovation &amp; uniqueness</a:t>
+            </a:r>
+          </a:p>
+        </p:txBody>
+      </p:sp>
+      <p:sp>
+        <p:nvSpPr>
+          <p:cNvPr id="113" name="Rectangle 112"/>
+          <p:cNvSpPr/>
+          <p:nvPr/>
+        </p:nvSpPr>
+        <p:spPr>
+          <a:xfrm>
+            <a:off x="6300216" y="4462272"/>
+            <a:ext cx="822960" cy="41148"/>
+          </a:xfrm>
+          <a:prstGeom prst="rect">
+            <a:avLst/>
+          </a:prstGeom>
+          <a:solidFill>
+            <a:srgbClr val="F58220"/>
+          </a:solidFill>
+          <a:ln>
+            <a:noFill/>
+          </a:ln>
+          <a:effectLst/>
+        </p:spPr>
+        <p:style>
+          <a:lnRef idx="1">
+            <a:schemeClr val="accent1"/>
+          </a:lnRef>
+          <a:fillRef idx="3">
+            <a:schemeClr val="accent1"/>
+          </a:fillRef>
+          <a:effectRef idx="2">
+            <a:schemeClr val="accent1"/>
+          </a:effectRef>
+          <a:fontRef idx="minor">
+            <a:schemeClr val="lt1"/>
+          </a:fontRef>
+        </p:style>
+        <p:txBody>
+          <a:bodyPr rtlCol="0" anchor="ctr"/>
+          <a:lstStyle/>
+          <a:p>
+            <a:pPr algn="ctr"/>
+          </a:p>
+        </p:txBody>
+      </p:sp>
+      <p:sp>
+        <p:nvSpPr>
+          <p:cNvPr id="114" name="Rounded Rectangle 113"/>
+          <p:cNvSpPr/>
+          <p:nvPr/>
+        </p:nvSpPr>
+        <p:spPr>
+          <a:xfrm>
+            <a:off x="6263640" y="4562856"/>
+            <a:ext cx="2734056" cy="676656"/>
+          </a:xfrm>
+          <a:prstGeom prst="roundRect">
+            <a:avLst>
+              <a:gd name="adj" fmla="val 12000"/>
+            </a:avLst>
+          </a:prstGeom>
+          <a:solidFill>
+            <a:srgbClr val="E8F0FB"/>
+          </a:solidFill>
+          <a:ln>
+            <a:noFill/>
+          </a:ln>
+          <a:effectLst/>
+        </p:spPr>
+        <p:style>
+          <a:lnRef idx="1">
+            <a:schemeClr val="accent1"/>
+          </a:lnRef>
+          <a:fillRef idx="3">
+            <a:schemeClr val="accent1"/>
+          </a:fillRef>
+          <a:effectRef idx="2">
+            <a:schemeClr val="accent1"/>
+          </a:effectRef>
+          <a:fontRef idx="minor">
+            <a:schemeClr val="lt1"/>
+          </a:fontRef>
+        </p:style>
+        <p:txBody>
+          <a:bodyPr rtlCol="0" anchor="ctr"/>
+          <a:lstStyle/>
+          <a:p>
+            <a:pPr algn="ctr"/>
+          </a:p>
+        </p:txBody>
+      </p:sp>
+      <p:sp>
+        <p:nvSpPr>
+          <p:cNvPr id="115" name="Rectangle 114"/>
+          <p:cNvSpPr/>
+          <p:nvPr/>
+        </p:nvSpPr>
+        <p:spPr>
+          <a:xfrm>
+            <a:off x="6263640" y="4654296"/>
+            <a:ext cx="64008" cy="493776"/>
+          </a:xfrm>
+          <a:prstGeom prst="rect">
+            <a:avLst/>
+          </a:prstGeom>
+          <a:solidFill>
+            <a:srgbClr val="1F5FBF"/>
+          </a:solidFill>
+          <a:ln>
+            <a:noFill/>
+          </a:ln>
+          <a:effectLst/>
+        </p:spPr>
+        <p:style>
+          <a:lnRef idx="1">
+            <a:schemeClr val="accent1"/>
+          </a:lnRef>
+          <a:fillRef idx="3">
+            <a:schemeClr val="accent1"/>
+          </a:fillRef>
+          <a:effectRef idx="2">
+            <a:schemeClr val="accent1"/>
+          </a:effectRef>
+          <a:fontRef idx="minor">
+            <a:schemeClr val="lt1"/>
+          </a:fontRef>
+        </p:style>
+        <p:txBody>
+          <a:bodyPr rtlCol="0" anchor="ctr"/>
+          <a:lstStyle/>
+          <a:p>
+            <a:pPr algn="ctr"/>
+          </a:p>
+        </p:txBody>
+      </p:sp>
+      <p:sp>
+        <p:nvSpPr>
+          <p:cNvPr id="116" name="TextBox 115"/>
+          <p:cNvSpPr txBox="1"/>
+          <p:nvPr/>
+        </p:nvSpPr>
+        <p:spPr>
+          <a:xfrm>
+            <a:off x="6428232" y="4599432"/>
+            <a:ext cx="2505456" cy="603504"/>
+          </a:xfrm>
+          <a:prstGeom prst="rect">
+            <a:avLst/>
+          </a:prstGeom>
+          <a:noFill/>
+        </p:spPr>
+        <p:txBody>
+          <a:bodyPr wrap="square" lIns="36576" rIns="36576" tIns="18288" bIns="18288" anchor="ctr">
+            <a:spAutoFit/>
+          </a:bodyPr>
+          <a:lstStyle/>
+          <a:p>
+            <a:pPr algn="l"/>
+            <a:r>
+              <a:rPr sz="1300" b="1">
+                <a:solidFill>
+                  <a:srgbClr val="1F5FBF"/>
+                </a:solidFill>
+                <a:latin typeface="Calibri"/>
+              </a:rPr>
+              <a:t>Learns by itself</a:t>
+            </a:r>
+          </a:p>
+          <a:p>
+            <a:pPr algn="l"/>
+            <a:r>
+              <a:rPr sz="1100" b="0">
+                <a:solidFill>
+                  <a:srgbClr val="1E2530"/>
+                </a:solidFill>
+                <a:latin typeface="Calibri"/>
+              </a:rPr>
+              <a:t>no hand-written rules</a:t>
+            </a:r>
+          </a:p>
+        </p:txBody>
+      </p:sp>
+      <p:sp>
+        <p:nvSpPr>
+          <p:cNvPr id="117" name="Rounded Rectangle 116"/>
+          <p:cNvSpPr/>
+          <p:nvPr/>
+        </p:nvSpPr>
+        <p:spPr>
+          <a:xfrm>
+            <a:off x="9089136" y="4562856"/>
+            <a:ext cx="2734056" cy="676656"/>
+          </a:xfrm>
+          <a:prstGeom prst="roundRect">
+            <a:avLst>
+              <a:gd name="adj" fmla="val 12000"/>
+            </a:avLst>
+          </a:prstGeom>
+          <a:solidFill>
+            <a:srgbClr val="FFF4E0"/>
+          </a:solidFill>
+          <a:ln>
+            <a:noFill/>
+          </a:ln>
+          <a:effectLst/>
+        </p:spPr>
+        <p:style>
+          <a:lnRef idx="1">
+            <a:schemeClr val="accent1"/>
+          </a:lnRef>
+          <a:fillRef idx="3">
+            <a:schemeClr val="accent1"/>
+          </a:fillRef>
+          <a:effectRef idx="2">
+            <a:schemeClr val="accent1"/>
+          </a:effectRef>
+          <a:fontRef idx="minor">
+            <a:schemeClr val="lt1"/>
+          </a:fontRef>
+        </p:style>
+        <p:txBody>
+          <a:bodyPr rtlCol="0" anchor="ctr"/>
+          <a:lstStyle/>
+          <a:p>
+            <a:pPr algn="ctr"/>
+          </a:p>
+        </p:txBody>
+      </p:sp>
+      <p:sp>
+        <p:nvSpPr>
+          <p:cNvPr id="118" name="Rectangle 117"/>
+          <p:cNvSpPr/>
+          <p:nvPr/>
+        </p:nvSpPr>
+        <p:spPr>
+          <a:xfrm>
+            <a:off x="9089136" y="4654296"/>
+            <a:ext cx="64008" cy="493776"/>
+          </a:xfrm>
+          <a:prstGeom prst="rect">
+            <a:avLst/>
+          </a:prstGeom>
+          <a:solidFill>
+            <a:srgbClr val="F58220"/>
+          </a:solidFill>
+          <a:ln>
+            <a:noFill/>
+          </a:ln>
+          <a:effectLst/>
+        </p:spPr>
+        <p:style>
+          <a:lnRef idx="1">
+            <a:schemeClr val="accent1"/>
+          </a:lnRef>
+          <a:fillRef idx="3">
+            <a:schemeClr val="accent1"/>
+          </a:fillRef>
+          <a:effectRef idx="2">
+            <a:schemeClr val="accent1"/>
+          </a:effectRef>
+          <a:fontRef idx="minor">
+            <a:schemeClr val="lt1"/>
+          </a:fontRef>
+        </p:style>
+        <p:txBody>
+          <a:bodyPr rtlCol="0" anchor="ctr"/>
+          <a:lstStyle/>
+          <a:p>
+            <a:pPr algn="ctr"/>
+          </a:p>
+        </p:txBody>
+      </p:sp>
+      <p:sp>
+        <p:nvSpPr>
+          <p:cNvPr id="119" name="TextBox 118"/>
+          <p:cNvSpPr txBox="1"/>
+          <p:nvPr/>
+        </p:nvSpPr>
+        <p:spPr>
+          <a:xfrm>
+            <a:off x="9253728" y="4599432"/>
+            <a:ext cx="2505456" cy="603504"/>
+          </a:xfrm>
+          <a:prstGeom prst="rect">
+            <a:avLst/>
+          </a:prstGeom>
+          <a:noFill/>
+        </p:spPr>
+        <p:txBody>
+          <a:bodyPr wrap="square" lIns="36576" rIns="36576" tIns="18288" bIns="18288" anchor="ctr">
+            <a:spAutoFit/>
+          </a:bodyPr>
+          <a:lstStyle/>
+          <a:p>
+            <a:pPr algn="l"/>
+            <a:r>
+              <a:rPr sz="1300" b="1">
+                <a:solidFill>
+                  <a:srgbClr val="F58220"/>
+                </a:solidFill>
+                <a:latin typeface="Calibri"/>
+              </a:rPr>
+              <a:t>AI only when needed</a:t>
+            </a:r>
+          </a:p>
+          <a:p>
+            <a:pPr algn="l"/>
+            <a:r>
+              <a:rPr sz="1100" b="0">
+                <a:solidFill>
+                  <a:srgbClr val="1E2530"/>
+                </a:solidFill>
+                <a:latin typeface="Calibri"/>
+              </a:rPr>
+              <a:t>keeps cost low</a:t>
+            </a:r>
+          </a:p>
+        </p:txBody>
+      </p:sp>
+      <p:sp>
+        <p:nvSpPr>
+          <p:cNvPr id="120" name="Rounded Rectangle 119"/>
+          <p:cNvSpPr/>
+          <p:nvPr/>
+        </p:nvSpPr>
+        <p:spPr>
+          <a:xfrm>
+            <a:off x="6263640" y="5303520"/>
+            <a:ext cx="2734056" cy="676656"/>
+          </a:xfrm>
+          <a:prstGeom prst="roundRect">
+            <a:avLst>
+              <a:gd name="adj" fmla="val 12000"/>
+            </a:avLst>
+          </a:prstGeom>
+          <a:solidFill>
+            <a:srgbClr val="F1ECFA"/>
+          </a:solidFill>
+          <a:ln>
+            <a:noFill/>
+          </a:ln>
+          <a:effectLst/>
+        </p:spPr>
+        <p:style>
+          <a:lnRef idx="1">
+            <a:schemeClr val="accent1"/>
+          </a:lnRef>
+          <a:fillRef idx="3">
+            <a:schemeClr val="accent1"/>
+          </a:fillRef>
+          <a:effectRef idx="2">
+            <a:schemeClr val="accent1"/>
+          </a:effectRef>
+          <a:fontRef idx="minor">
+            <a:schemeClr val="lt1"/>
+          </a:fontRef>
+        </p:style>
+        <p:txBody>
+          <a:bodyPr rtlCol="0" anchor="ctr"/>
+          <a:lstStyle/>
+          <a:p>
+            <a:pPr algn="ctr"/>
+          </a:p>
+        </p:txBody>
+      </p:sp>
+      <p:sp>
+        <p:nvSpPr>
+          <p:cNvPr id="121" name="Rectangle 120"/>
+          <p:cNvSpPr/>
+          <p:nvPr/>
+        </p:nvSpPr>
+        <p:spPr>
+          <a:xfrm>
+            <a:off x="6263640" y="5394960"/>
+            <a:ext cx="64008" cy="493776"/>
           </a:xfrm>
           <a:prstGeom prst="rect">
             <a:avLst/>
@@ -8667,14 +10650,14 @@
       </p:sp>
       <p:sp>
         <p:nvSpPr>
-          <p:cNvPr id="32" name="TextBox 31"/>
+          <p:cNvPr id="122" name="TextBox 121"/>
           <p:cNvSpPr txBox="1"/>
           <p:nvPr/>
         </p:nvSpPr>
         <p:spPr>
           <a:xfrm>
-            <a:off x="6848856" y="4645152"/>
-            <a:ext cx="1828800" cy="685800"/>
+            <a:off x="6428232" y="5340096"/>
+            <a:ext cx="2505456" cy="603504"/>
           </a:xfrm>
           <a:prstGeom prst="rect">
             <a:avLst/>
@@ -8682,110 +10665,54 @@
           <a:noFill/>
         </p:spPr>
         <p:txBody>
-          <a:bodyPr wrap="square" anchor="t" lIns="36576" rIns="36576" tIns="18288" bIns="18288">
+          <a:bodyPr wrap="square" lIns="36576" rIns="36576" tIns="18288" bIns="18288" anchor="ctr">
             <a:spAutoFit/>
           </a:bodyPr>
           <a:lstStyle/>
           <a:p>
-            <a:pPr algn="ctr">
-              <a:lnSpc>
-                <a:spcPct val="90000"/>
-              </a:lnSpc>
-              <a:spcAft>
-                <a:spcPts val="0"/>
-              </a:spcAft>
-            </a:pPr>
-            <a:r>
-              <a:rPr sz="1400" b="1" i="0">
+            <a:pPr algn="l"/>
+            <a:r>
+              <a:rPr sz="1300" b="1">
                 <a:solidFill>
                   <a:srgbClr val="6A3FB5"/>
                 </a:solidFill>
                 <a:latin typeface="Calibri"/>
               </a:rPr>
-              <a:t>Low-risk</a:t>
-            </a:r>
-          </a:p>
-          <a:p>
-            <a:pPr algn="ctr">
-              <a:lnSpc>
-                <a:spcPct val="90000"/>
-              </a:lnSpc>
-              <a:spcAft>
-                <a:spcPts val="0"/>
-              </a:spcAft>
-            </a:pPr>
-            <a:r>
-              <a:rPr sz="1400" b="1" i="0">
-                <a:solidFill>
-                  <a:srgbClr val="6A3FB5"/>
-                </a:solidFill>
-                <a:latin typeface="Calibri"/>
-              </a:rPr>
-              <a:t>rollout</a:t>
-            </a:r>
-          </a:p>
-        </p:txBody>
-      </p:sp>
-      <p:sp>
-        <p:nvSpPr>
-          <p:cNvPr id="33" name="TextBox 32"/>
-          <p:cNvSpPr txBox="1"/>
-          <p:nvPr/>
-        </p:nvSpPr>
-        <p:spPr>
-          <a:xfrm>
-            <a:off x="6867144" y="5349240"/>
-            <a:ext cx="1792224" cy="868680"/>
-          </a:xfrm>
-          <a:prstGeom prst="rect">
-            <a:avLst/>
-          </a:prstGeom>
-          <a:noFill/>
-        </p:spPr>
-        <p:txBody>
-          <a:bodyPr wrap="square" anchor="t" lIns="36576" rIns="36576" tIns="18288" bIns="18288">
-            <a:spAutoFit/>
-          </a:bodyPr>
-          <a:lstStyle/>
-          <a:p>
-            <a:pPr algn="ctr">
-              <a:lnSpc>
-                <a:spcPct val="100000"/>
-              </a:lnSpc>
-              <a:spcAft>
-                <a:spcPts val="0"/>
-              </a:spcAft>
-            </a:pPr>
-            <a:r>
-              <a:rPr sz="1100" b="0" i="0">
+              <a:t>Flags unknown formats</a:t>
+            </a:r>
+          </a:p>
+          <a:p>
+            <a:pPr algn="l"/>
+            <a:r>
+              <a:rPr sz="1100" b="0">
                 <a:solidFill>
                   <a:srgbClr val="1E2530"/>
                 </a:solidFill>
                 <a:latin typeface="Calibri"/>
               </a:rPr>
-              <a:t>Shadow mode first; works with no API key (heuristic fallback)</a:t>
-            </a:r>
-          </a:p>
-        </p:txBody>
-      </p:sp>
-      <p:sp>
-        <p:nvSpPr>
-          <p:cNvPr id="34" name="Rounded Rectangle 33"/>
+              <a:t>for human review</a:t>
+            </a:r>
+          </a:p>
+        </p:txBody>
+      </p:sp>
+      <p:sp>
+        <p:nvSpPr>
+          <p:cNvPr id="123" name="Rounded Rectangle 122"/>
           <p:cNvSpPr/>
           <p:nvPr/>
         </p:nvSpPr>
         <p:spPr>
           <a:xfrm>
-            <a:off x="8961120" y="4114800"/>
-            <a:ext cx="2907792" cy="2148840"/>
+            <a:off x="9089136" y="5303520"/>
+            <a:ext cx="2734056" cy="676656"/>
           </a:xfrm>
           <a:prstGeom prst="roundRect">
             <a:avLst>
-              <a:gd name="adj" fmla="val 6000"/>
+              <a:gd name="adj" fmla="val 12000"/>
             </a:avLst>
           </a:prstGeom>
           <a:solidFill>
-            <a:srgbClr val="0B2A5B"/>
+            <a:srgbClr val="E8F5EC"/>
           </a:solidFill>
           <a:ln>
             <a:noFill/>
@@ -8814,602 +10741,22 @@
           </a:p>
         </p:txBody>
       </p:sp>
-      <p:pic>
-        <p:nvPicPr>
-          <p:cNvPr id="35" name="Picture 34" descr="qr_1729944884779286991.png"/>
-          <p:cNvPicPr>
-            <a:picLocks noChangeAspect="1"/>
-          </p:cNvPicPr>
-          <p:nvPr/>
-        </p:nvPicPr>
-        <p:blipFill>
-          <a:blip r:embed="rId2"/>
-          <a:stretch>
-            <a:fillRect/>
-          </a:stretch>
-        </p:blipFill>
-        <p:spPr>
-          <a:xfrm>
-            <a:off x="9144000" y="4315968"/>
-            <a:ext cx="1188720" cy="1188720"/>
+      <p:sp>
+        <p:nvSpPr>
+          <p:cNvPr id="124" name="Rectangle 123"/>
+          <p:cNvSpPr/>
+          <p:nvPr/>
+        </p:nvSpPr>
+        <p:spPr>
+          <a:xfrm>
+            <a:off x="9089136" y="5394960"/>
+            <a:ext cx="64008" cy="493776"/>
           </a:xfrm>
           <a:prstGeom prst="rect">
             <a:avLst/>
           </a:prstGeom>
-        </p:spPr>
-      </p:pic>
-      <p:sp>
-        <p:nvSpPr>
-          <p:cNvPr id="36" name="TextBox 35"/>
-          <p:cNvSpPr txBox="1"/>
-          <p:nvPr/>
-        </p:nvSpPr>
-        <p:spPr>
-          <a:xfrm>
-            <a:off x="10405872" y="4315968"/>
-            <a:ext cx="1417320" cy="1188720"/>
-          </a:xfrm>
-          <a:prstGeom prst="rect">
-            <a:avLst/>
-          </a:prstGeom>
-          <a:noFill/>
-        </p:spPr>
-        <p:txBody>
-          <a:bodyPr wrap="square" anchor="ctr" lIns="36576" rIns="36576" tIns="18288" bIns="18288">
-            <a:spAutoFit/>
-          </a:bodyPr>
-          <a:lstStyle/>
-          <a:p>
-            <a:pPr algn="l">
-              <a:lnSpc>
-                <a:spcPct val="100000"/>
-              </a:lnSpc>
-              <a:spcAft>
-                <a:spcPts val="0"/>
-              </a:spcAft>
-            </a:pPr>
-            <a:r>
-              <a:rPr sz="1200" b="1" i="0">
-                <a:solidFill>
-                  <a:srgbClr val="F58220"/>
-                </a:solidFill>
-                <a:latin typeface="Calibri"/>
-              </a:rPr>
-              <a:t>SCAN TO</a:t>
-            </a:r>
-          </a:p>
-          <a:p>
-            <a:pPr algn="l">
-              <a:lnSpc>
-                <a:spcPct val="100000"/>
-              </a:lnSpc>
-              <a:spcAft>
-                <a:spcPts val="0"/>
-              </a:spcAft>
-            </a:pPr>
-            <a:r>
-              <a:rPr sz="1200" b="1" i="0">
-                <a:solidFill>
-                  <a:srgbClr val="F58220"/>
-                </a:solidFill>
-                <a:latin typeface="Calibri"/>
-              </a:rPr>
-              <a:t>VIEW</a:t>
-            </a:r>
-          </a:p>
-          <a:p>
-            <a:pPr algn="l">
-              <a:lnSpc>
-                <a:spcPct val="100000"/>
-              </a:lnSpc>
-              <a:spcAft>
-                <a:spcPts val="0"/>
-              </a:spcAft>
-            </a:pPr>
-            <a:r>
-              <a:rPr sz="1200" b="1" i="0">
-                <a:solidFill>
-                  <a:srgbClr val="F58220"/>
-                </a:solidFill>
-                <a:latin typeface="Calibri"/>
-              </a:rPr>
-              <a:t>PROTOTYPE</a:t>
-            </a:r>
-          </a:p>
-        </p:txBody>
-      </p:sp>
-      <p:sp>
-        <p:nvSpPr>
-          <p:cNvPr id="37" name="TextBox 36"/>
-          <p:cNvSpPr txBox="1"/>
-          <p:nvPr/>
-        </p:nvSpPr>
-        <p:spPr>
-          <a:xfrm>
-            <a:off x="9098280" y="5577840"/>
-            <a:ext cx="2697480" cy="274320"/>
-          </a:xfrm>
-          <a:prstGeom prst="rect">
-            <a:avLst/>
-          </a:prstGeom>
-          <a:noFill/>
-        </p:spPr>
-        <p:txBody>
-          <a:bodyPr wrap="square" anchor="t" lIns="36576" rIns="36576" tIns="18288" bIns="18288">
-            <a:spAutoFit/>
-          </a:bodyPr>
-          <a:lstStyle/>
-          <a:p>
-            <a:pPr algn="l">
-              <a:lnSpc>
-                <a:spcPct val="100000"/>
-              </a:lnSpc>
-              <a:spcAft>
-                <a:spcPts val="0"/>
-              </a:spcAft>
-            </a:pPr>
-            <a:r>
-              <a:rPr sz="1150" b="1" i="0">
-                <a:solidFill>
-                  <a:srgbClr val="FFFFFF"/>
-                </a:solidFill>
-                <a:latin typeface="Calibri"/>
-                <a:hlinkClick r:id="rId3"/>
-              </a:rPr>
-              <a:t>sih2026-w6sr.vercel.app</a:t>
-            </a:r>
-          </a:p>
-        </p:txBody>
-      </p:sp>
-      <p:sp>
-        <p:nvSpPr>
-          <p:cNvPr id="38" name="TextBox 37"/>
-          <p:cNvSpPr txBox="1"/>
-          <p:nvPr/>
-        </p:nvSpPr>
-        <p:spPr>
-          <a:xfrm>
-            <a:off x="9098280" y="5852160"/>
-            <a:ext cx="2697480" cy="365760"/>
-          </a:xfrm>
-          <a:prstGeom prst="rect">
-            <a:avLst/>
-          </a:prstGeom>
-          <a:noFill/>
-        </p:spPr>
-        <p:txBody>
-          <a:bodyPr wrap="square" anchor="t" lIns="36576" rIns="36576" tIns="18288" bIns="18288">
-            <a:spAutoFit/>
-          </a:bodyPr>
-          <a:lstStyle/>
-          <a:p>
-            <a:pPr algn="l">
-              <a:lnSpc>
-                <a:spcPct val="100000"/>
-              </a:lnSpc>
-              <a:spcAft>
-                <a:spcPts val="0"/>
-              </a:spcAft>
-            </a:pPr>
-            <a:r>
-              <a:rPr sz="1050" b="0" i="0">
-                <a:solidFill>
-                  <a:srgbClr val="C9D6EA"/>
-                </a:solidFill>
-                <a:latin typeface="Calibri"/>
-              </a:rPr>
-              <a:t>Try it with your own log lines</a:t>
-            </a:r>
-          </a:p>
-        </p:txBody>
-      </p:sp>
-      <p:sp>
-        <p:nvSpPr>
-          <p:cNvPr id="39" name="TextBox 38"/>
-          <p:cNvSpPr txBox="1"/>
-          <p:nvPr/>
-        </p:nvSpPr>
-        <p:spPr>
-          <a:xfrm>
-            <a:off x="365760" y="1444752"/>
-            <a:ext cx="5394960" cy="1463040"/>
-          </a:xfrm>
-          <a:prstGeom prst="rect">
-            <a:avLst/>
-          </a:prstGeom>
-          <a:noFill/>
-        </p:spPr>
-        <p:txBody>
-          <a:bodyPr wrap="square" anchor="t" lIns="36576" rIns="36576" tIns="18288" bIns="18288">
-            <a:spAutoFit/>
-          </a:bodyPr>
-          <a:lstStyle/>
-          <a:p>
-            <a:pPr algn="l">
-              <a:spcAft>
-                <a:spcPts val="300"/>
-              </a:spcAft>
-            </a:pPr>
-            <a:r>
-              <a:rPr sz="1150" b="0">
-                <a:solidFill>
-                  <a:srgbClr val="C0392B"/>
-                </a:solidFill>
-                <a:latin typeface="Calibri"/>
-              </a:rPr>
-              <a:t>✖ </a:t>
-            </a:r>
-            <a:r>
-              <a:rPr sz="1250" b="1">
-                <a:solidFill>
-                  <a:srgbClr val="0B2A5B"/>
-                </a:solidFill>
-                <a:latin typeface="Calibri"/>
-              </a:rPr>
-              <a:t>Too many formats: </a:t>
-            </a:r>
-            <a:r>
-              <a:rPr sz="1250" b="0">
-                <a:solidFill>
-                  <a:srgbClr val="1E2530"/>
-                </a:solidFill>
-                <a:latin typeface="Calibri"/>
-              </a:rPr>
-              <a:t>Syslog, JSON, CEF, K8s, Java, free text, all in one stream.</a:t>
-            </a:r>
-          </a:p>
-          <a:p>
-            <a:pPr algn="l">
-              <a:spcAft>
-                <a:spcPts val="300"/>
-              </a:spcAft>
-            </a:pPr>
-            <a:r>
-              <a:rPr sz="1150" b="0">
-                <a:solidFill>
-                  <a:srgbClr val="C0392B"/>
-                </a:solidFill>
-                <a:latin typeface="Calibri"/>
-              </a:rPr>
-              <a:t>✖ </a:t>
-            </a:r>
-            <a:r>
-              <a:rPr sz="1250" b="1">
-                <a:solidFill>
-                  <a:srgbClr val="0B2A5B"/>
-                </a:solidFill>
-                <a:latin typeface="Calibri"/>
-              </a:rPr>
-              <a:t>Manual parsers break: </a:t>
-            </a:r>
-            <a:r>
-              <a:rPr sz="1250" b="0">
-                <a:solidFill>
-                  <a:srgbClr val="1E2530"/>
-                </a:solidFill>
-                <a:latin typeface="Calibri"/>
-              </a:rPr>
-              <a:t>every new source needs a hand-written regex.</a:t>
-            </a:r>
-          </a:p>
-          <a:p>
-            <a:pPr algn="l">
-              <a:spcAft>
-                <a:spcPts val="300"/>
-              </a:spcAft>
-            </a:pPr>
-            <a:r>
-              <a:rPr sz="1150" b="0">
-                <a:solidFill>
-                  <a:srgbClr val="C0392B"/>
-                </a:solidFill>
-                <a:latin typeface="Calibri"/>
-              </a:rPr>
-              <a:t>✖ </a:t>
-            </a:r>
-            <a:r>
-              <a:rPr sz="1250" b="1">
-                <a:solidFill>
-                  <a:srgbClr val="0B2A5B"/>
-                </a:solidFill>
-                <a:latin typeface="Calibri"/>
-              </a:rPr>
-              <a:t>AI on every line is too costly: </a:t>
-            </a:r>
-            <a:r>
-              <a:rPr sz="1250" b="0">
-                <a:solidFill>
-                  <a:srgbClr val="1E2530"/>
-                </a:solidFill>
-                <a:latin typeface="Calibri"/>
-              </a:rPr>
-              <a:t>slow and expensive at millions of lines/day.</a:t>
-            </a:r>
-          </a:p>
-          <a:p>
-            <a:pPr algn="l">
-              <a:spcAft>
-                <a:spcPts val="300"/>
-              </a:spcAft>
-            </a:pPr>
-            <a:r>
-              <a:rPr sz="1150" b="0">
-                <a:solidFill>
-                  <a:srgbClr val="C0392B"/>
-                </a:solidFill>
-                <a:latin typeface="Calibri"/>
-              </a:rPr>
-              <a:t>✖ </a:t>
-            </a:r>
-            <a:r>
-              <a:rPr sz="1250" b="1">
-                <a:solidFill>
-                  <a:srgbClr val="0B2A5B"/>
-                </a:solidFill>
-                <a:latin typeface="Calibri"/>
-              </a:rPr>
-              <a:t>Compliance: </a:t>
-            </a:r>
-            <a:r>
-              <a:rPr sz="1250" b="0">
-                <a:solidFill>
-                  <a:srgbClr val="1E2530"/>
-                </a:solidFill>
-                <a:latin typeface="Calibri"/>
-              </a:rPr>
-              <a:t>CERT-In requires 180-day, searchable logs of all ICT systems.</a:t>
-            </a:r>
-          </a:p>
-        </p:txBody>
-      </p:sp>
-      <p:sp>
-        <p:nvSpPr>
-          <p:cNvPr id="40" name="TextBox 39"/>
-          <p:cNvSpPr txBox="1"/>
-          <p:nvPr/>
-        </p:nvSpPr>
-        <p:spPr>
-          <a:xfrm>
-            <a:off x="6035040" y="1444752"/>
-            <a:ext cx="5852160" cy="1463040"/>
-          </a:xfrm>
-          <a:prstGeom prst="rect">
-            <a:avLst/>
-          </a:prstGeom>
-          <a:noFill/>
-        </p:spPr>
-        <p:txBody>
-          <a:bodyPr wrap="square" anchor="t" lIns="36576" rIns="36576" tIns="18288" bIns="18288">
-            <a:spAutoFit/>
-          </a:bodyPr>
-          <a:lstStyle/>
-          <a:p>
-            <a:pPr algn="l">
-              <a:spcAft>
-                <a:spcPts val="300"/>
-              </a:spcAft>
-            </a:pPr>
-            <a:r>
-              <a:rPr sz="1150" b="0">
-                <a:solidFill>
-                  <a:srgbClr val="138A36"/>
-                </a:solidFill>
-                <a:latin typeface="Calibri"/>
-              </a:rPr>
-              <a:t>✔ </a:t>
-            </a:r>
-            <a:r>
-              <a:rPr sz="1250" b="1">
-                <a:solidFill>
-                  <a:srgbClr val="0B2A5B"/>
-                </a:solidFill>
-                <a:latin typeface="Calibri"/>
-              </a:rPr>
-              <a:t>Tiered pipeline: </a:t>
-            </a:r>
-            <a:r>
-              <a:rPr sz="1250" b="0">
-                <a:solidFill>
-                  <a:srgbClr val="1E2530"/>
-                </a:solidFill>
-                <a:latin typeface="Calibri"/>
-              </a:rPr>
-              <a:t>the cheapest tier answers first; the LLM is the last resort.</a:t>
-            </a:r>
-          </a:p>
-          <a:p>
-            <a:pPr algn="l">
-              <a:spcAft>
-                <a:spcPts val="300"/>
-              </a:spcAft>
-            </a:pPr>
-            <a:r>
-              <a:rPr sz="1150" b="0">
-                <a:solidFill>
-                  <a:srgbClr val="138A36"/>
-                </a:solidFill>
-                <a:latin typeface="Calibri"/>
-              </a:rPr>
-              <a:t>✔ </a:t>
-            </a:r>
-            <a:r>
-              <a:rPr sz="1250" b="1">
-                <a:solidFill>
-                  <a:srgbClr val="0B2A5B"/>
-                </a:solidFill>
-                <a:latin typeface="Calibri"/>
-              </a:rPr>
-              <a:t>Learn once: </a:t>
-            </a:r>
-            <a:r>
-              <a:rPr sz="1250" b="0">
-                <a:solidFill>
-                  <a:srgbClr val="1E2530"/>
-                </a:solidFill>
-                <a:latin typeface="Calibri"/>
-              </a:rPr>
-              <a:t>the LLM writes one rule per template; reused with zero AI calls.</a:t>
-            </a:r>
-          </a:p>
-          <a:p>
-            <a:pPr algn="l">
-              <a:spcAft>
-                <a:spcPts val="300"/>
-              </a:spcAft>
-            </a:pPr>
-            <a:r>
-              <a:rPr sz="1150" b="0">
-                <a:solidFill>
-                  <a:srgbClr val="138A36"/>
-                </a:solidFill>
-                <a:latin typeface="Calibri"/>
-              </a:rPr>
-              <a:t>✔ </a:t>
-            </a:r>
-            <a:r>
-              <a:rPr sz="1250" b="1">
-                <a:solidFill>
-                  <a:srgbClr val="0B2A5B"/>
-                </a:solidFill>
-                <a:latin typeface="Calibri"/>
-              </a:rPr>
-              <a:t>ML novelty gate: </a:t>
-            </a:r>
-            <a:r>
-              <a:rPr sz="1250" b="0">
-                <a:solidFill>
-                  <a:srgbClr val="1E2530"/>
-                </a:solidFill>
-                <a:latin typeface="Calibri"/>
-              </a:rPr>
-              <a:t>spots never-seen formats and quarantines floods.</a:t>
-            </a:r>
-          </a:p>
-          <a:p>
-            <a:pPr algn="l">
-              <a:spcAft>
-                <a:spcPts val="300"/>
-              </a:spcAft>
-            </a:pPr>
-            <a:r>
-              <a:rPr sz="1150" b="0">
-                <a:solidFill>
-                  <a:srgbClr val="138A36"/>
-                </a:solidFill>
-                <a:latin typeface="Calibri"/>
-              </a:rPr>
-              <a:t>✔ </a:t>
-            </a:r>
-            <a:r>
-              <a:rPr sz="1250" b="1">
-                <a:solidFill>
-                  <a:srgbClr val="0B2A5B"/>
-                </a:solidFill>
-                <a:latin typeface="Calibri"/>
-              </a:rPr>
-              <a:t>One schema: </a:t>
-            </a:r>
-            <a:r>
-              <a:rPr sz="1250" b="0">
-                <a:solidFill>
-                  <a:srgbClr val="1E2530"/>
-                </a:solidFill>
-                <a:latin typeface="Calibri"/>
-              </a:rPr>
-              <a:t>timestamp · source · event_type · severity · message · extra.</a:t>
-            </a:r>
-          </a:p>
-          <a:p>
-            <a:pPr algn="l">
-              <a:spcAft>
-                <a:spcPts val="300"/>
-              </a:spcAft>
-            </a:pPr>
-            <a:r>
-              <a:rPr sz="1150" b="0">
-                <a:solidFill>
-                  <a:srgbClr val="138A36"/>
-                </a:solidFill>
-                <a:latin typeface="Calibri"/>
-              </a:rPr>
-              <a:t>✔ </a:t>
-            </a:r>
-            <a:r>
-              <a:rPr sz="1250" b="1">
-                <a:solidFill>
-                  <a:srgbClr val="0B2A5B"/>
-                </a:solidFill>
-                <a:latin typeface="Calibri"/>
-              </a:rPr>
-              <a:t>Ready to use: </a:t>
-            </a:r>
-            <a:r>
-              <a:rPr sz="1250" b="0">
-                <a:solidFill>
-                  <a:srgbClr val="1E2530"/>
-                </a:solidFill>
-                <a:latin typeface="Calibri"/>
-              </a:rPr>
-              <a:t>REST API, web console and a Bash log collector.</a:t>
-            </a:r>
-          </a:p>
-        </p:txBody>
-      </p:sp>
-      <p:sp>
-        <p:nvSpPr>
-          <p:cNvPr id="41" name="TextBox 40"/>
-          <p:cNvSpPr txBox="1"/>
-          <p:nvPr/>
-        </p:nvSpPr>
-        <p:spPr>
-          <a:xfrm>
-            <a:off x="365760" y="2971800"/>
-            <a:ext cx="11430000" cy="292608"/>
-          </a:xfrm>
-          <a:prstGeom prst="rect">
-            <a:avLst/>
-          </a:prstGeom>
-          <a:noFill/>
-        </p:spPr>
-        <p:txBody>
-          <a:bodyPr wrap="square" anchor="t" lIns="36576" rIns="36576" tIns="18288" bIns="18288">
-            <a:spAutoFit/>
-          </a:bodyPr>
-          <a:lstStyle/>
-          <a:p>
-            <a:pPr algn="l">
-              <a:spcAft>
-                <a:spcPts val="0"/>
-              </a:spcAft>
-            </a:pPr>
-            <a:r>
-              <a:rPr sz="1350" b="1">
-                <a:solidFill>
-                  <a:srgbClr val="0B2A5B"/>
-                </a:solidFill>
-                <a:latin typeface="Calibri"/>
-              </a:rPr>
-              <a:t>How It Addresses the Problem</a:t>
-            </a:r>
-          </a:p>
-        </p:txBody>
-      </p:sp>
-      <p:sp>
-        <p:nvSpPr>
-          <p:cNvPr id="42" name="Rectangle 41"/>
-          <p:cNvSpPr/>
-          <p:nvPr/>
-        </p:nvSpPr>
-        <p:spPr>
-          <a:xfrm>
-            <a:off x="402336" y="3273552"/>
-            <a:ext cx="822960" cy="32004"/>
-          </a:xfrm>
-          <a:prstGeom prst="rect">
-            <a:avLst/>
-          </a:prstGeom>
           <a:solidFill>
-            <a:srgbClr val="F58220"/>
+            <a:srgbClr val="138A36"/>
           </a:solidFill>
           <a:ln>
             <a:noFill/>
@@ -9440,62 +10787,14 @@
       </p:sp>
       <p:sp>
         <p:nvSpPr>
-          <p:cNvPr id="43" name="Rounded Rectangle 42"/>
-          <p:cNvSpPr/>
-          <p:nvPr/>
-        </p:nvSpPr>
-        <p:spPr>
-          <a:xfrm>
-            <a:off x="365760" y="3364992"/>
-            <a:ext cx="2788920" cy="548640"/>
-          </a:xfrm>
-          <a:prstGeom prst="roundRect">
-            <a:avLst>
-              <a:gd name="adj" fmla="val 15000"/>
-            </a:avLst>
-          </a:prstGeom>
-          <a:solidFill>
-            <a:srgbClr val="F2F5FA"/>
-          </a:solidFill>
-          <a:ln w="12700">
-            <a:solidFill>
-              <a:srgbClr val="1F5FBF"/>
-            </a:solidFill>
-          </a:ln>
-          <a:effectLst/>
-        </p:spPr>
-        <p:style>
-          <a:lnRef idx="1">
-            <a:schemeClr val="accent1"/>
-          </a:lnRef>
-          <a:fillRef idx="3">
-            <a:schemeClr val="accent1"/>
-          </a:fillRef>
-          <a:effectRef idx="2">
-            <a:schemeClr val="accent1"/>
-          </a:effectRef>
-          <a:fontRef idx="minor">
-            <a:schemeClr val="lt1"/>
-          </a:fontRef>
-        </p:style>
-        <p:txBody>
-          <a:bodyPr rtlCol="0" anchor="ctr"/>
-          <a:lstStyle/>
-          <a:p>
-            <a:pPr algn="ctr"/>
-          </a:p>
-        </p:txBody>
-      </p:sp>
-      <p:sp>
-        <p:nvSpPr>
-          <p:cNvPr id="44" name="TextBox 43"/>
+          <p:cNvPr id="125" name="TextBox 124"/>
           <p:cNvSpPr txBox="1"/>
           <p:nvPr/>
         </p:nvSpPr>
         <p:spPr>
           <a:xfrm>
-            <a:off x="438912" y="3364992"/>
-            <a:ext cx="2651760" cy="548640"/>
+            <a:off x="9253728" y="5340096"/>
+            <a:ext cx="2505456" cy="603504"/>
           </a:xfrm>
           <a:prstGeom prst="rect">
             <a:avLst/>
@@ -9503,493 +10802,32 @@
           <a:noFill/>
         </p:spPr>
         <p:txBody>
-          <a:bodyPr wrap="square" anchor="ctr" lIns="36576" rIns="36576" tIns="18288" bIns="18288">
+          <a:bodyPr wrap="square" lIns="36576" rIns="36576" tIns="18288" bIns="18288" anchor="ctr">
             <a:spAutoFit/>
           </a:bodyPr>
           <a:lstStyle/>
           <a:p>
-            <a:pPr algn="ctr">
-              <a:spcAft>
-                <a:spcPts val="0"/>
-              </a:spcAft>
-            </a:pPr>
-            <a:r>
-              <a:rPr sz="1100" b="1">
-                <a:solidFill>
-                  <a:srgbClr val="C0392B"/>
-                </a:solidFill>
-                <a:latin typeface="Calibri"/>
-              </a:rPr>
-              <a:t>Too many formats</a:t>
-            </a:r>
-            <a:r>
-              <a:rPr sz="1100" b="1">
-                <a:solidFill>
-                  <a:srgbClr val="5B6778"/>
-                </a:solidFill>
-                <a:latin typeface="Calibri"/>
-              </a:rPr>
-              <a:t>  →  </a:t>
-            </a:r>
-            <a:r>
-              <a:rPr sz="1100" b="1">
-                <a:solidFill>
-                  <a:srgbClr val="1F5FBF"/>
-                </a:solidFill>
-                <a:latin typeface="Calibri"/>
-              </a:rPr>
-              <a:t>Rules auto-learned per template</a:t>
-            </a:r>
-          </a:p>
-        </p:txBody>
-      </p:sp>
-      <p:sp>
-        <p:nvSpPr>
-          <p:cNvPr id="45" name="Rounded Rectangle 44"/>
-          <p:cNvSpPr/>
-          <p:nvPr/>
-        </p:nvSpPr>
-        <p:spPr>
-          <a:xfrm>
-            <a:off x="3264408" y="3364992"/>
-            <a:ext cx="2788920" cy="548640"/>
-          </a:xfrm>
-          <a:prstGeom prst="roundRect">
-            <a:avLst>
-              <a:gd name="adj" fmla="val 15000"/>
-            </a:avLst>
-          </a:prstGeom>
-          <a:solidFill>
-            <a:srgbClr val="F2F5FA"/>
-          </a:solidFill>
-          <a:ln w="12700">
-            <a:solidFill>
-              <a:srgbClr val="F58220"/>
-            </a:solidFill>
-          </a:ln>
-          <a:effectLst/>
-        </p:spPr>
-        <p:style>
-          <a:lnRef idx="1">
-            <a:schemeClr val="accent1"/>
-          </a:lnRef>
-          <a:fillRef idx="3">
-            <a:schemeClr val="accent1"/>
-          </a:fillRef>
-          <a:effectRef idx="2">
-            <a:schemeClr val="accent1"/>
-          </a:effectRef>
-          <a:fontRef idx="minor">
-            <a:schemeClr val="lt1"/>
-          </a:fontRef>
-        </p:style>
-        <p:txBody>
-          <a:bodyPr rtlCol="0" anchor="ctr"/>
-          <a:lstStyle/>
-          <a:p>
-            <a:pPr algn="ctr"/>
-          </a:p>
-        </p:txBody>
-      </p:sp>
-      <p:sp>
-        <p:nvSpPr>
-          <p:cNvPr id="46" name="TextBox 45"/>
-          <p:cNvSpPr txBox="1"/>
-          <p:nvPr/>
-        </p:nvSpPr>
-        <p:spPr>
-          <a:xfrm>
-            <a:off x="3337560" y="3364992"/>
-            <a:ext cx="2651760" cy="548640"/>
-          </a:xfrm>
-          <a:prstGeom prst="rect">
-            <a:avLst/>
-          </a:prstGeom>
-          <a:noFill/>
-        </p:spPr>
-        <p:txBody>
-          <a:bodyPr wrap="square" anchor="ctr" lIns="36576" rIns="36576" tIns="18288" bIns="18288">
-            <a:spAutoFit/>
-          </a:bodyPr>
-          <a:lstStyle/>
-          <a:p>
-            <a:pPr algn="ctr">
-              <a:spcAft>
-                <a:spcPts val="0"/>
-              </a:spcAft>
-            </a:pPr>
-            <a:r>
-              <a:rPr sz="1100" b="1">
-                <a:solidFill>
-                  <a:srgbClr val="C0392B"/>
-                </a:solidFill>
-                <a:latin typeface="Calibri"/>
-              </a:rPr>
-              <a:t>Manual parsers</a:t>
-            </a:r>
-            <a:r>
-              <a:rPr sz="1100" b="1">
-                <a:solidFill>
-                  <a:srgbClr val="5B6778"/>
-                </a:solidFill>
-                <a:latin typeface="Calibri"/>
-              </a:rPr>
-              <a:t>  →  </a:t>
-            </a:r>
-            <a:r>
-              <a:rPr sz="1100" b="1">
-                <a:solidFill>
-                  <a:srgbClr val="F58220"/>
-                </a:solidFill>
-                <a:latin typeface="Calibri"/>
-              </a:rPr>
-              <a:t>Zero hand-written regex</a:t>
-            </a:r>
-          </a:p>
-        </p:txBody>
-      </p:sp>
-      <p:sp>
-        <p:nvSpPr>
-          <p:cNvPr id="47" name="Rounded Rectangle 46"/>
-          <p:cNvSpPr/>
-          <p:nvPr/>
-        </p:nvSpPr>
-        <p:spPr>
-          <a:xfrm>
-            <a:off x="6163056" y="3364992"/>
-            <a:ext cx="2788920" cy="548640"/>
-          </a:xfrm>
-          <a:prstGeom prst="roundRect">
-            <a:avLst>
-              <a:gd name="adj" fmla="val 15000"/>
-            </a:avLst>
-          </a:prstGeom>
-          <a:solidFill>
-            <a:srgbClr val="F2F5FA"/>
-          </a:solidFill>
-          <a:ln w="12700">
-            <a:solidFill>
-              <a:srgbClr val="138A36"/>
-            </a:solidFill>
-          </a:ln>
-          <a:effectLst/>
-        </p:spPr>
-        <p:style>
-          <a:lnRef idx="1">
-            <a:schemeClr val="accent1"/>
-          </a:lnRef>
-          <a:fillRef idx="3">
-            <a:schemeClr val="accent1"/>
-          </a:fillRef>
-          <a:effectRef idx="2">
-            <a:schemeClr val="accent1"/>
-          </a:effectRef>
-          <a:fontRef idx="minor">
-            <a:schemeClr val="lt1"/>
-          </a:fontRef>
-        </p:style>
-        <p:txBody>
-          <a:bodyPr rtlCol="0" anchor="ctr"/>
-          <a:lstStyle/>
-          <a:p>
-            <a:pPr algn="ctr"/>
-          </a:p>
-        </p:txBody>
-      </p:sp>
-      <p:sp>
-        <p:nvSpPr>
-          <p:cNvPr id="48" name="TextBox 47"/>
-          <p:cNvSpPr txBox="1"/>
-          <p:nvPr/>
-        </p:nvSpPr>
-        <p:spPr>
-          <a:xfrm>
-            <a:off x="6236208" y="3364992"/>
-            <a:ext cx="2651760" cy="548640"/>
-          </a:xfrm>
-          <a:prstGeom prst="rect">
-            <a:avLst/>
-          </a:prstGeom>
-          <a:noFill/>
-        </p:spPr>
-        <p:txBody>
-          <a:bodyPr wrap="square" anchor="ctr" lIns="36576" rIns="36576" tIns="18288" bIns="18288">
-            <a:spAutoFit/>
-          </a:bodyPr>
-          <a:lstStyle/>
-          <a:p>
-            <a:pPr algn="ctr">
-              <a:spcAft>
-                <a:spcPts val="0"/>
-              </a:spcAft>
-            </a:pPr>
-            <a:r>
-              <a:rPr sz="1100" b="1">
-                <a:solidFill>
-                  <a:srgbClr val="C0392B"/>
-                </a:solidFill>
-                <a:latin typeface="Calibri"/>
-              </a:rPr>
-              <a:t>AI cost</a:t>
-            </a:r>
-            <a:r>
-              <a:rPr sz="1100" b="1">
-                <a:solidFill>
-                  <a:srgbClr val="5B6778"/>
-                </a:solidFill>
-                <a:latin typeface="Calibri"/>
-              </a:rPr>
-              <a:t>  →  </a:t>
-            </a:r>
-            <a:r>
-              <a:rPr sz="1100" b="1">
+            <a:pPr algn="l"/>
+            <a:r>
+              <a:rPr sz="1300" b="1">
                 <a:solidFill>
                   <a:srgbClr val="138A36"/>
                 </a:solidFill>
                 <a:latin typeface="Calibri"/>
               </a:rPr>
-              <a:t>most lines skip the AI</a:t>
-            </a:r>
-          </a:p>
-        </p:txBody>
-      </p:sp>
-      <p:sp>
-        <p:nvSpPr>
-          <p:cNvPr id="49" name="Rounded Rectangle 48"/>
-          <p:cNvSpPr/>
-          <p:nvPr/>
-        </p:nvSpPr>
-        <p:spPr>
-          <a:xfrm>
-            <a:off x="9061704" y="3364992"/>
-            <a:ext cx="2788920" cy="548640"/>
-          </a:xfrm>
-          <a:prstGeom prst="roundRect">
-            <a:avLst>
-              <a:gd name="adj" fmla="val 15000"/>
-            </a:avLst>
-          </a:prstGeom>
-          <a:solidFill>
-            <a:srgbClr val="F2F5FA"/>
-          </a:solidFill>
-          <a:ln w="12700">
-            <a:solidFill>
-              <a:srgbClr val="6A3FB5"/>
-            </a:solidFill>
-          </a:ln>
-          <a:effectLst/>
-        </p:spPr>
-        <p:style>
-          <a:lnRef idx="1">
-            <a:schemeClr val="accent1"/>
-          </a:lnRef>
-          <a:fillRef idx="3">
-            <a:schemeClr val="accent1"/>
-          </a:fillRef>
-          <a:effectRef idx="2">
-            <a:schemeClr val="accent1"/>
-          </a:effectRef>
-          <a:fontRef idx="minor">
-            <a:schemeClr val="lt1"/>
-          </a:fontRef>
-        </p:style>
-        <p:txBody>
-          <a:bodyPr rtlCol="0" anchor="ctr"/>
-          <a:lstStyle/>
-          <a:p>
-            <a:pPr algn="ctr"/>
-          </a:p>
-        </p:txBody>
-      </p:sp>
-      <p:sp>
-        <p:nvSpPr>
-          <p:cNvPr id="50" name="TextBox 49"/>
-          <p:cNvSpPr txBox="1"/>
-          <p:nvPr/>
-        </p:nvSpPr>
-        <p:spPr>
-          <a:xfrm>
-            <a:off x="9134856" y="3364992"/>
-            <a:ext cx="2651760" cy="548640"/>
-          </a:xfrm>
-          <a:prstGeom prst="rect">
-            <a:avLst/>
-          </a:prstGeom>
-          <a:noFill/>
-        </p:spPr>
-        <p:txBody>
-          <a:bodyPr wrap="square" anchor="ctr" lIns="36576" rIns="36576" tIns="18288" bIns="18288">
-            <a:spAutoFit/>
-          </a:bodyPr>
-          <a:lstStyle/>
-          <a:p>
-            <a:pPr algn="ctr">
-              <a:spcAft>
-                <a:spcPts val="0"/>
-              </a:spcAft>
-            </a:pPr>
-            <a:r>
-              <a:rPr sz="1100" b="1">
-                <a:solidFill>
-                  <a:srgbClr val="C0392B"/>
-                </a:solidFill>
-                <a:latin typeface="Calibri"/>
-              </a:rPr>
-              <a:t>Compliance</a:t>
-            </a:r>
-            <a:r>
-              <a:rPr sz="1100" b="1">
-                <a:solidFill>
-                  <a:srgbClr val="5B6778"/>
-                </a:solidFill>
-                <a:latin typeface="Calibri"/>
-              </a:rPr>
-              <a:t>  →  </a:t>
-            </a:r>
-            <a:r>
-              <a:rPr sz="1100" b="1">
-                <a:solidFill>
-                  <a:srgbClr val="6A3FB5"/>
-                </a:solidFill>
-                <a:latin typeface="Calibri"/>
-              </a:rPr>
-              <a:t>UTC-normalised, searchable schema</a:t>
-            </a:r>
-          </a:p>
-        </p:txBody>
-      </p:sp>
-      <p:sp>
-        <p:nvSpPr>
-          <p:cNvPr id="51" name="Oval 50"/>
-          <p:cNvSpPr/>
-          <p:nvPr/>
-        </p:nvSpPr>
-        <p:spPr>
-          <a:xfrm>
-            <a:off x="320040" y="182880"/>
-            <a:ext cx="1463040" cy="731520"/>
-          </a:xfrm>
-          <a:prstGeom prst="ellipse">
-            <a:avLst/>
-          </a:prstGeom>
-          <a:noFill/>
-          <a:ln w="25400">
-            <a:solidFill>
-              <a:srgbClr val="8064A2"/>
-            </a:solidFill>
-          </a:ln>
-          <a:effectLst/>
-        </p:spPr>
-        <p:style>
-          <a:lnRef idx="1">
-            <a:schemeClr val="accent1"/>
-          </a:lnRef>
-          <a:fillRef idx="3">
-            <a:schemeClr val="accent1"/>
-          </a:fillRef>
-          <a:effectRef idx="2">
-            <a:schemeClr val="accent1"/>
-          </a:effectRef>
-          <a:fontRef idx="minor">
-            <a:schemeClr val="lt1"/>
-          </a:fontRef>
-        </p:style>
-        <p:txBody>
-          <a:bodyPr rtlCol="0" anchor="ctr" wrap="square" lIns="45720" rIns="45720" tIns="18288" bIns="18288"/>
-          <a:lstStyle/>
-          <a:p>
-            <a:pPr algn="ctr"/>
-            <a:r>
-              <a:rPr sz="1200" b="1">
-                <a:solidFill>
-                  <a:srgbClr val="F58220"/>
-                </a:solidFill>
-                <a:latin typeface="Calibri"/>
-              </a:rPr>
-              <a:t>[Team Name]</a:t>
-            </a:r>
-          </a:p>
-        </p:txBody>
-      </p:sp>
-      <p:pic>
-        <p:nvPicPr>
-          <p:cNvPr id="52" name="Picture 51" descr="sih_icon_s.png"/>
-          <p:cNvPicPr>
-            <a:picLocks noChangeAspect="1"/>
-          </p:cNvPicPr>
-          <p:nvPr/>
-        </p:nvPicPr>
-        <p:blipFill>
-          <a:blip r:embed="rId4"/>
-          <a:stretch>
-            <a:fillRect/>
-          </a:stretch>
-        </p:blipFill>
-        <p:spPr>
-          <a:xfrm>
-            <a:off x="10076688" y="91440"/>
-            <a:ext cx="676894" cy="822960"/>
-          </a:xfrm>
-          <a:prstGeom prst="rect">
-            <a:avLst/>
-          </a:prstGeom>
-        </p:spPr>
-      </p:pic>
-      <p:sp>
-        <p:nvSpPr>
-          <p:cNvPr id="53" name="TextBox 52"/>
-          <p:cNvSpPr txBox="1"/>
-          <p:nvPr/>
-        </p:nvSpPr>
-        <p:spPr>
-          <a:xfrm>
-            <a:off x="10789920" y="109728"/>
-            <a:ext cx="1371600" cy="777240"/>
-          </a:xfrm>
-          <a:prstGeom prst="rect">
-            <a:avLst/>
-          </a:prstGeom>
-          <a:noFill/>
-        </p:spPr>
-        <p:txBody>
-          <a:bodyPr wrap="square" lIns="36576" rIns="36576" tIns="18288" bIns="18288" anchor="t">
-            <a:spAutoFit/>
-          </a:bodyPr>
-          <a:lstStyle/>
-          <a:p>
-            <a:pPr algn="ctr"/>
-            <a:r>
-              <a:rPr sz="1250" b="1">
-                <a:solidFill>
-                  <a:srgbClr val="455A64"/>
-                </a:solidFill>
-                <a:latin typeface="Calibri"/>
-              </a:rPr>
-              <a:t>SMART INDIA</a:t>
-            </a:r>
-          </a:p>
-          <a:p>
-            <a:pPr algn="ctr"/>
-            <a:r>
-              <a:rPr sz="1250" b="1">
-                <a:solidFill>
-                  <a:srgbClr val="455A64"/>
-                </a:solidFill>
-                <a:latin typeface="Calibri"/>
-              </a:rPr>
-              <a:t>HACKATHON</a:t>
-            </a:r>
-          </a:p>
-          <a:p>
-            <a:pPr algn="ctr"/>
-            <a:r>
-              <a:rPr sz="1250" b="1">
-                <a:solidFill>
-                  <a:srgbClr val="455A64"/>
-                </a:solidFill>
-                <a:latin typeface="Calibri"/>
-              </a:rPr>
-              <a:t>2026</a:t>
+              <a:t>Works offline</a:t>
+            </a:r>
+          </a:p>
+          <a:p>
+            <a:pPr algn="l"/>
+            <a:r>
+              <a:rPr sz="1100" b="0">
+                <a:solidFill>
+                  <a:srgbClr val="1E2530"/>
+                </a:solidFill>
+                <a:latin typeface="Calibri"/>
+              </a:rPr>
+              <a:t>data stays in India</a:t>
             </a:r>
           </a:p>
         </p:txBody>

</xml_diff>

<commit_message>
PPT slide 2: solution section as bullet points (how it works + how it addresses the problem)
Co-authored-by: arena-agent <297053741+arena-agent@users.noreply.github.com>
</commit_message>
<xml_diff>
--- a/presentation/SIH2026_Idea_Submission.pptx
+++ b/presentation/SIH2026_Idea_Submission.pptx
@@ -8085,14 +8085,152 @@
       </p:sp>
       <p:sp>
         <p:nvSpPr>
-          <p:cNvPr id="59" name="TextBox 58"/>
+          <p:cNvPr id="59" name="Rounded Rectangle 58"/>
+          <p:cNvSpPr/>
+          <p:nvPr/>
+        </p:nvSpPr>
+        <p:spPr>
+          <a:xfrm>
+            <a:off x="365760" y="1920240"/>
+            <a:ext cx="11503152" cy="3154680"/>
+          </a:xfrm>
+          <a:prstGeom prst="roundRect">
+            <a:avLst>
+              <a:gd name="adj" fmla="val 3000"/>
+            </a:avLst>
+          </a:prstGeom>
+          <a:solidFill>
+            <a:srgbClr val="FFFFFF"/>
+          </a:solidFill>
+          <a:ln w="12700">
+            <a:solidFill>
+              <a:srgbClr val="D3DBE8"/>
+            </a:solidFill>
+          </a:ln>
+          <a:effectLst/>
+        </p:spPr>
+        <p:style>
+          <a:lnRef idx="1">
+            <a:schemeClr val="accent1"/>
+          </a:lnRef>
+          <a:fillRef idx="3">
+            <a:schemeClr val="accent1"/>
+          </a:fillRef>
+          <a:effectRef idx="2">
+            <a:schemeClr val="accent1"/>
+          </a:effectRef>
+          <a:fontRef idx="minor">
+            <a:schemeClr val="lt1"/>
+          </a:fontRef>
+        </p:style>
+        <p:txBody>
+          <a:bodyPr rtlCol="0" anchor="ctr"/>
+          <a:lstStyle/>
+          <a:p>
+            <a:pPr algn="ctr"/>
+          </a:p>
+        </p:txBody>
+      </p:sp>
+      <p:sp>
+        <p:nvSpPr>
+          <p:cNvPr id="60" name="Rounded Rectangle 59"/>
+          <p:cNvSpPr/>
+          <p:nvPr/>
+        </p:nvSpPr>
+        <p:spPr>
+          <a:xfrm>
+            <a:off x="365760" y="1920240"/>
+            <a:ext cx="11503152" cy="384048"/>
+          </a:xfrm>
+          <a:prstGeom prst="roundRect">
+            <a:avLst>
+              <a:gd name="adj" fmla="val 30000"/>
+            </a:avLst>
+          </a:prstGeom>
+          <a:solidFill>
+            <a:srgbClr val="1F5FBF"/>
+          </a:solidFill>
+          <a:ln>
+            <a:noFill/>
+          </a:ln>
+          <a:effectLst/>
+        </p:spPr>
+        <p:style>
+          <a:lnRef idx="1">
+            <a:schemeClr val="accent1"/>
+          </a:lnRef>
+          <a:fillRef idx="3">
+            <a:schemeClr val="accent1"/>
+          </a:fillRef>
+          <a:effectRef idx="2">
+            <a:schemeClr val="accent1"/>
+          </a:effectRef>
+          <a:fontRef idx="minor">
+            <a:schemeClr val="lt1"/>
+          </a:fontRef>
+        </p:style>
+        <p:txBody>
+          <a:bodyPr rtlCol="0" anchor="ctr"/>
+          <a:lstStyle/>
+          <a:p>
+            <a:pPr algn="ctr"/>
+          </a:p>
+        </p:txBody>
+      </p:sp>
+      <p:sp>
+        <p:nvSpPr>
+          <p:cNvPr id="61" name="TextBox 60"/>
           <p:cNvSpPr txBox="1"/>
           <p:nvPr/>
         </p:nvSpPr>
         <p:spPr>
           <a:xfrm>
-            <a:off x="365760" y="1901952"/>
-            <a:ext cx="11430000" cy="292608"/>
+            <a:off x="548640" y="1920240"/>
+            <a:ext cx="11155680" cy="384048"/>
+          </a:xfrm>
+          <a:prstGeom prst="rect">
+            <a:avLst/>
+          </a:prstGeom>
+          <a:noFill/>
+        </p:spPr>
+        <p:txBody>
+          <a:bodyPr wrap="square" lIns="36576" rIns="36576" tIns="18288" bIns="18288" anchor="ctr">
+            <a:spAutoFit/>
+          </a:bodyPr>
+          <a:lstStyle/>
+          <a:p>
+            <a:pPr algn="l"/>
+            <a:r>
+              <a:rPr sz="1450" b="1">
+                <a:solidFill>
+                  <a:srgbClr val="FFFFFF"/>
+                </a:solidFill>
+                <a:latin typeface="Calibri"/>
+              </a:rPr>
+              <a:t>OUR SOLUTION</a:t>
+            </a:r>
+            <a:r>
+              <a:rPr sz="1200" b="0">
+                <a:solidFill>
+                  <a:srgbClr val="FFFFFF"/>
+                </a:solidFill>
+                <a:latin typeface="Calibri"/>
+              </a:rPr>
+              <a:t>   a smart, self-learning log pre-processing pipeline</a:t>
+            </a:r>
+          </a:p>
+        </p:txBody>
+      </p:sp>
+      <p:sp>
+        <p:nvSpPr>
+          <p:cNvPr id="62" name="TextBox 61"/>
+          <p:cNvSpPr txBox="1"/>
+          <p:nvPr/>
+        </p:nvSpPr>
+        <p:spPr>
+          <a:xfrm>
+            <a:off x="548640" y="2377440"/>
+            <a:ext cx="5486400" cy="274320"/>
           </a:xfrm>
           <a:prstGeom prst="rect">
             <a:avLst/>
@@ -8107,35 +8245,586 @@
           <a:p>
             <a:pPr algn="l"/>
             <a:r>
+              <a:rPr sz="1300" b="1">
+                <a:solidFill>
+                  <a:srgbClr val="1F5FBF"/>
+                </a:solidFill>
+                <a:latin typeface="Calibri"/>
+              </a:rPr>
+              <a:t>How it works</a:t>
+            </a:r>
+          </a:p>
+        </p:txBody>
+      </p:sp>
+      <p:sp>
+        <p:nvSpPr>
+          <p:cNvPr id="63" name="TextBox 62"/>
+          <p:cNvSpPr txBox="1"/>
+          <p:nvPr/>
+        </p:nvSpPr>
+        <p:spPr>
+          <a:xfrm>
+            <a:off x="6355080" y="2377440"/>
+            <a:ext cx="5486400" cy="274320"/>
+          </a:xfrm>
+          <a:prstGeom prst="rect">
+            <a:avLst/>
+          </a:prstGeom>
+          <a:noFill/>
+        </p:spPr>
+        <p:txBody>
+          <a:bodyPr wrap="square" lIns="36576" rIns="36576" tIns="18288" bIns="18288" anchor="t">
+            <a:spAutoFit/>
+          </a:bodyPr>
+          <a:lstStyle/>
+          <a:p>
+            <a:pPr algn="l"/>
+            <a:r>
+              <a:rPr sz="1300" b="1">
+                <a:solidFill>
+                  <a:srgbClr val="138A36"/>
+                </a:solidFill>
+                <a:latin typeface="Calibri"/>
+              </a:rPr>
+              <a:t>How it addresses the problem</a:t>
+            </a:r>
+          </a:p>
+        </p:txBody>
+      </p:sp>
+      <p:sp>
+        <p:nvSpPr>
+          <p:cNvPr id="64" name="Rectangle 63"/>
+          <p:cNvSpPr/>
+          <p:nvPr/>
+        </p:nvSpPr>
+        <p:spPr>
+          <a:xfrm>
+            <a:off x="6144768" y="2423160"/>
+            <a:ext cx="18288" cy="2560320"/>
+          </a:xfrm>
+          <a:prstGeom prst="rect">
+            <a:avLst/>
+          </a:prstGeom>
+          <a:solidFill>
+            <a:srgbClr val="D3DBE8"/>
+          </a:solidFill>
+          <a:ln>
+            <a:noFill/>
+          </a:ln>
+          <a:effectLst/>
+        </p:spPr>
+        <p:style>
+          <a:lnRef idx="1">
+            <a:schemeClr val="accent1"/>
+          </a:lnRef>
+          <a:fillRef idx="3">
+            <a:schemeClr val="accent1"/>
+          </a:fillRef>
+          <a:effectRef idx="2">
+            <a:schemeClr val="accent1"/>
+          </a:effectRef>
+          <a:fontRef idx="minor">
+            <a:schemeClr val="lt1"/>
+          </a:fontRef>
+        </p:style>
+        <p:txBody>
+          <a:bodyPr rtlCol="0" anchor="ctr"/>
+          <a:lstStyle/>
+          <a:p>
+            <a:pPr algn="ctr"/>
+          </a:p>
+        </p:txBody>
+      </p:sp>
+      <p:sp>
+        <p:nvSpPr>
+          <p:cNvPr id="65" name="TextBox 64"/>
+          <p:cNvSpPr txBox="1"/>
+          <p:nvPr/>
+        </p:nvSpPr>
+        <p:spPr>
+          <a:xfrm>
+            <a:off x="548640" y="2688336"/>
+            <a:ext cx="5486400" cy="2331720"/>
+          </a:xfrm>
+          <a:prstGeom prst="rect">
+            <a:avLst/>
+          </a:prstGeom>
+          <a:noFill/>
+        </p:spPr>
+        <p:txBody>
+          <a:bodyPr wrap="square" lIns="36576" rIns="36576" tIns="18288" bIns="18288" anchor="t">
+            <a:spAutoFit/>
+          </a:bodyPr>
+          <a:lstStyle/>
+          <a:p>
+            <a:pPr algn="l">
+              <a:spcAft>
+                <a:spcPts val="400"/>
+              </a:spcAft>
+            </a:pPr>
+            <a:r>
+              <a:rPr sz="1150" b="1">
+                <a:solidFill>
+                  <a:srgbClr val="1F5FBF"/>
+                </a:solidFill>
+                <a:latin typeface="Calibri"/>
+              </a:rPr>
+              <a:t>•  </a:t>
+            </a:r>
+            <a:r>
+              <a:rPr sz="1150" b="1">
+                <a:solidFill>
+                  <a:srgbClr val="0B2A5B"/>
+                </a:solidFill>
+                <a:latin typeface="Calibri"/>
+              </a:rPr>
+              <a:t>Collect: </a:t>
+            </a:r>
+            <a:r>
+              <a:rPr sz="1150" b="0">
+                <a:solidFill>
+                  <a:srgbClr val="1E2530"/>
+                </a:solidFill>
+                <a:latin typeface="Calibri"/>
+              </a:rPr>
+              <a:t>logs from any source (servers, apps, firewalls, cloud) arrive through a web API or a small Bash script.</a:t>
+            </a:r>
+          </a:p>
+          <a:p>
+            <a:pPr algn="l">
+              <a:spcAft>
+                <a:spcPts val="400"/>
+              </a:spcAft>
+            </a:pPr>
+            <a:r>
+              <a:rPr sz="1150" b="1">
+                <a:solidFill>
+                  <a:srgbClr val="1F5FBF"/>
+                </a:solidFill>
+                <a:latin typeface="Calibri"/>
+              </a:rPr>
+              <a:t>•  </a:t>
+            </a:r>
+            <a:r>
+              <a:rPr sz="1150" b="1">
+                <a:solidFill>
+                  <a:srgbClr val="0B2A5B"/>
+                </a:solidFill>
+                <a:latin typeface="Calibri"/>
+              </a:rPr>
+              <a:t>Group: </a:t>
+            </a:r>
+            <a:r>
+              <a:rPr sz="1150" b="0">
+                <a:solidFill>
+                  <a:srgbClr val="1E2530"/>
+                </a:solidFill>
+                <a:latin typeface="Calibri"/>
+              </a:rPr>
+              <a:t>similar lines are grouped into patterns, so millions of lines become a few thousand templates.</a:t>
+            </a:r>
+          </a:p>
+          <a:p>
+            <a:pPr algn="l">
+              <a:spcAft>
+                <a:spcPts val="400"/>
+              </a:spcAft>
+            </a:pPr>
+            <a:r>
+              <a:rPr sz="1150" b="1">
+                <a:solidFill>
+                  <a:srgbClr val="1F5FBF"/>
+                </a:solidFill>
+                <a:latin typeface="Calibri"/>
+              </a:rPr>
+              <a:t>•  </a:t>
+            </a:r>
+            <a:r>
+              <a:rPr sz="1150" b="1">
+                <a:solidFill>
+                  <a:srgbClr val="0B2A5B"/>
+                </a:solidFill>
+                <a:latin typeface="Calibri"/>
+              </a:rPr>
+              <a:t>Check: </a:t>
+            </a:r>
+            <a:r>
+              <a:rPr sz="1150" b="0">
+                <a:solidFill>
+                  <a:srgbClr val="1E2530"/>
+                </a:solidFill>
+                <a:latin typeface="Calibri"/>
+              </a:rPr>
+              <a:t>a light ML model decides whether a pattern is already known or brand new.</a:t>
+            </a:r>
+          </a:p>
+          <a:p>
+            <a:pPr algn="l">
+              <a:spcAft>
+                <a:spcPts val="400"/>
+              </a:spcAft>
+            </a:pPr>
+            <a:r>
+              <a:rPr sz="1150" b="1">
+                <a:solidFill>
+                  <a:srgbClr val="1F5FBF"/>
+                </a:solidFill>
+                <a:latin typeface="Calibri"/>
+              </a:rPr>
+              <a:t>•  </a:t>
+            </a:r>
+            <a:r>
+              <a:rPr sz="1150" b="1">
+                <a:solidFill>
+                  <a:srgbClr val="0B2A5B"/>
+                </a:solidFill>
+                <a:latin typeface="Calibri"/>
+              </a:rPr>
+              <a:t>Learn once: </a:t>
+            </a:r>
+            <a:r>
+              <a:rPr sz="1150" b="0">
+                <a:solidFill>
+                  <a:srgbClr val="1E2530"/>
+                </a:solidFill>
+                <a:latin typeface="Calibri"/>
+              </a:rPr>
+              <a:t>for a new pattern, AI writes a parsing rule one time; the rule is saved and reused.</a:t>
+            </a:r>
+          </a:p>
+          <a:p>
+            <a:pPr algn="l">
+              <a:spcAft>
+                <a:spcPts val="400"/>
+              </a:spcAft>
+            </a:pPr>
+            <a:r>
+              <a:rPr sz="1150" b="1">
+                <a:solidFill>
+                  <a:srgbClr val="1F5FBF"/>
+                </a:solidFill>
+                <a:latin typeface="Calibri"/>
+              </a:rPr>
+              <a:t>•  </a:t>
+            </a:r>
+            <a:r>
+              <a:rPr sz="1150" b="1">
+                <a:solidFill>
+                  <a:srgbClr val="0B2A5B"/>
+                </a:solidFill>
+                <a:latin typeface="Calibri"/>
+              </a:rPr>
+              <a:t>Clean output: </a:t>
+            </a:r>
+            <a:r>
+              <a:rPr sz="1150" b="0">
+                <a:solidFill>
+                  <a:srgbClr val="1E2530"/>
+                </a:solidFill>
+                <a:latin typeface="Calibri"/>
+              </a:rPr>
+              <a:t>every log leaves in one format: time (UTC), source, event, severity and message.</a:t>
+            </a:r>
+          </a:p>
+          <a:p>
+            <a:pPr algn="l"/>
+            <a:r>
+              <a:rPr sz="1150" b="1">
+                <a:solidFill>
+                  <a:srgbClr val="1F5FBF"/>
+                </a:solidFill>
+                <a:latin typeface="Calibri"/>
+              </a:rPr>
+              <a:t>•  </a:t>
+            </a:r>
+            <a:r>
+              <a:rPr sz="1150" b="1">
+                <a:solidFill>
+                  <a:srgbClr val="0B2A5B"/>
+                </a:solidFill>
+                <a:latin typeface="Calibri"/>
+              </a:rPr>
+              <a:t>Safety net: </a:t>
+            </a:r>
+            <a:r>
+              <a:rPr sz="1150" b="0">
+                <a:solidFill>
+                  <a:srgbClr val="1E2530"/>
+                </a:solidFill>
+                <a:latin typeface="Calibri"/>
+              </a:rPr>
+              <a:t>unfamiliar formats are held for review; a backup AI and built-in rules take over if AI is down.</a:t>
+            </a:r>
+          </a:p>
+        </p:txBody>
+      </p:sp>
+      <p:sp>
+        <p:nvSpPr>
+          <p:cNvPr id="66" name="TextBox 65"/>
+          <p:cNvSpPr txBox="1"/>
+          <p:nvPr/>
+        </p:nvSpPr>
+        <p:spPr>
+          <a:xfrm>
+            <a:off x="6355080" y="2688336"/>
+            <a:ext cx="5394960" cy="2331720"/>
+          </a:xfrm>
+          <a:prstGeom prst="rect">
+            <a:avLst/>
+          </a:prstGeom>
+          <a:noFill/>
+        </p:spPr>
+        <p:txBody>
+          <a:bodyPr wrap="square" lIns="36576" rIns="36576" tIns="18288" bIns="18288" anchor="t">
+            <a:spAutoFit/>
+          </a:bodyPr>
+          <a:lstStyle/>
+          <a:p>
+            <a:pPr algn="l">
+              <a:spcAft>
+                <a:spcPts val="400"/>
+              </a:spcAft>
+            </a:pPr>
+            <a:r>
+              <a:rPr sz="1150" b="1">
+                <a:solidFill>
+                  <a:srgbClr val="138A36"/>
+                </a:solidFill>
+                <a:latin typeface="Calibri"/>
+              </a:rPr>
+              <a:t>•  </a:t>
+            </a:r>
+            <a:r>
+              <a:rPr sz="1150" b="1">
+                <a:solidFill>
+                  <a:srgbClr val="C0392B"/>
+                </a:solidFill>
+                <a:latin typeface="Calibri"/>
+              </a:rPr>
+              <a:t>Too many formats → </a:t>
+            </a:r>
+            <a:r>
+              <a:rPr sz="1150" b="0">
+                <a:solidFill>
+                  <a:srgbClr val="1E2530"/>
+                </a:solidFill>
+                <a:latin typeface="Calibri"/>
+              </a:rPr>
+              <a:t>each new format is learned automatically, so any source can be connected.</a:t>
+            </a:r>
+          </a:p>
+          <a:p>
+            <a:pPr algn="l">
+              <a:spcAft>
+                <a:spcPts val="400"/>
+              </a:spcAft>
+            </a:pPr>
+            <a:r>
+              <a:rPr sz="1150" b="1">
+                <a:solidFill>
+                  <a:srgbClr val="138A36"/>
+                </a:solidFill>
+                <a:latin typeface="Calibri"/>
+              </a:rPr>
+              <a:t>•  </a:t>
+            </a:r>
+            <a:r>
+              <a:rPr sz="1150" b="1">
+                <a:solidFill>
+                  <a:srgbClr val="C0392B"/>
+                </a:solidFill>
+                <a:latin typeface="Calibri"/>
+              </a:rPr>
+              <a:t>Parsers keep breaking → </a:t>
+            </a:r>
+            <a:r>
+              <a:rPr sz="1150" b="0">
+                <a:solidFill>
+                  <a:srgbClr val="1E2530"/>
+                </a:solidFill>
+                <a:latin typeface="Calibri"/>
+              </a:rPr>
+              <a:t>no hand-written parser code to write, fix or maintain.</a:t>
+            </a:r>
+          </a:p>
+          <a:p>
+            <a:pPr algn="l">
+              <a:spcAft>
+                <a:spcPts val="400"/>
+              </a:spcAft>
+            </a:pPr>
+            <a:r>
+              <a:rPr sz="1150" b="1">
+                <a:solidFill>
+                  <a:srgbClr val="138A36"/>
+                </a:solidFill>
+                <a:latin typeface="Calibri"/>
+              </a:rPr>
+              <a:t>•  </a:t>
+            </a:r>
+            <a:r>
+              <a:rPr sz="1150" b="1">
+                <a:solidFill>
+                  <a:srgbClr val="C0392B"/>
+                </a:solidFill>
+                <a:latin typeface="Calibri"/>
+              </a:rPr>
+              <a:t>AI is slow &amp; costly → </a:t>
+            </a:r>
+            <a:r>
+              <a:rPr sz="1150" b="0">
+                <a:solidFill>
+                  <a:srgbClr val="1E2530"/>
+                </a:solidFill>
+                <a:latin typeface="Calibri"/>
+              </a:rPr>
+              <a:t>AI runs once per format, not per log; everyday logs use fast saved rules.</a:t>
+            </a:r>
+          </a:p>
+          <a:p>
+            <a:pPr algn="l">
+              <a:spcAft>
+                <a:spcPts val="400"/>
+              </a:spcAft>
+            </a:pPr>
+            <a:r>
+              <a:rPr sz="1150" b="1">
+                <a:solidFill>
+                  <a:srgbClr val="138A36"/>
+                </a:solidFill>
+                <a:latin typeface="Calibri"/>
+              </a:rPr>
+              <a:t>•  </a:t>
+            </a:r>
+            <a:r>
+              <a:rPr sz="1150" b="1">
+                <a:solidFill>
+                  <a:srgbClr val="C0392B"/>
+                </a:solidFill>
+                <a:latin typeface="Calibri"/>
+              </a:rPr>
+              <a:t>Hard to investigate → </a:t>
+            </a:r>
+            <a:r>
+              <a:rPr sz="1150" b="0">
+                <a:solidFill>
+                  <a:srgbClr val="1E2530"/>
+                </a:solidFill>
+                <a:latin typeface="Calibri"/>
+              </a:rPr>
+              <a:t>all logs share one clean, time-aligned format, so analysts search one place.</a:t>
+            </a:r>
+          </a:p>
+          <a:p>
+            <a:pPr algn="l">
+              <a:spcAft>
+                <a:spcPts val="400"/>
+              </a:spcAft>
+            </a:pPr>
+            <a:r>
+              <a:rPr sz="1150" b="1">
+                <a:solidFill>
+                  <a:srgbClr val="138A36"/>
+                </a:solidFill>
+                <a:latin typeface="Calibri"/>
+              </a:rPr>
+              <a:t>•  </a:t>
+            </a:r>
+            <a:r>
+              <a:rPr sz="1150" b="1">
+                <a:solidFill>
+                  <a:srgbClr val="C0392B"/>
+                </a:solidFill>
+                <a:latin typeface="Calibri"/>
+              </a:rPr>
+              <a:t>Compliance → </a:t>
+            </a:r>
+            <a:r>
+              <a:rPr sz="1150" b="0">
+                <a:solidFill>
+                  <a:srgbClr val="1E2530"/>
+                </a:solidFill>
+                <a:latin typeface="Calibri"/>
+              </a:rPr>
+              <a:t>clean, searchable logs make it easier to keep 180 days of records, as CERT-In requires.</a:t>
+            </a:r>
+          </a:p>
+          <a:p>
+            <a:pPr algn="l"/>
+            <a:r>
+              <a:rPr sz="1150" b="1">
+                <a:solidFill>
+                  <a:srgbClr val="138A36"/>
+                </a:solidFill>
+                <a:latin typeface="Calibri"/>
+              </a:rPr>
+              <a:t>•  </a:t>
+            </a:r>
+            <a:r>
+              <a:rPr sz="1150" b="1">
+                <a:solidFill>
+                  <a:srgbClr val="C0392B"/>
+                </a:solidFill>
+                <a:latin typeface="Calibri"/>
+              </a:rPr>
+              <a:t>Data privacy → </a:t>
+            </a:r>
+            <a:r>
+              <a:rPr sz="1150" b="0">
+                <a:solidFill>
+                  <a:srgbClr val="1E2530"/>
+                </a:solidFill>
+                <a:latin typeface="Calibri"/>
+              </a:rPr>
+              <a:t>can run fully on-premise, so sensitive logs stay inside the organisation.</a:t>
+            </a:r>
+          </a:p>
+        </p:txBody>
+      </p:sp>
+      <p:sp>
+        <p:nvSpPr>
+          <p:cNvPr id="67" name="TextBox 66"/>
+          <p:cNvSpPr txBox="1"/>
+          <p:nvPr/>
+        </p:nvSpPr>
+        <p:spPr>
+          <a:xfrm>
+            <a:off x="365760" y="5193792"/>
+            <a:ext cx="5486400" cy="274320"/>
+          </a:xfrm>
+          <a:prstGeom prst="rect">
+            <a:avLst/>
+          </a:prstGeom>
+          <a:noFill/>
+        </p:spPr>
+        <p:txBody>
+          <a:bodyPr wrap="square" lIns="36576" rIns="36576" tIns="18288" bIns="18288" anchor="t">
+            <a:spAutoFit/>
+          </a:bodyPr>
+          <a:lstStyle/>
+          <a:p>
+            <a:pPr algn="l"/>
+            <a:r>
               <a:rPr sz="1450" b="1">
                 <a:solidFill>
                   <a:srgbClr val="0B2A5B"/>
                 </a:solidFill>
                 <a:latin typeface="Calibri"/>
               </a:rPr>
-              <a:t>Our Solution: how it works</a:t>
-            </a:r>
-            <a:r>
-              <a:rPr sz="1150" b="0">
-                <a:solidFill>
-                  <a:srgbClr val="5F6B7A"/>
-                </a:solidFill>
-                <a:latin typeface="Calibri"/>
-              </a:rPr>
-              <a:t>   every log goes through four simple steps</a:t>
-            </a:r>
-          </a:p>
-        </p:txBody>
-      </p:sp>
-      <p:sp>
-        <p:nvSpPr>
-          <p:cNvPr id="60" name="Rectangle 59"/>
+              <a:t>Innovation &amp; uniqueness</a:t>
+            </a:r>
+          </a:p>
+        </p:txBody>
+      </p:sp>
+      <p:sp>
+        <p:nvSpPr>
+          <p:cNvPr id="68" name="Rectangle 67"/>
           <p:cNvSpPr/>
           <p:nvPr/>
         </p:nvSpPr>
         <p:spPr>
           <a:xfrm>
-            <a:off x="402336" y="2203704"/>
+            <a:off x="402336" y="5486400"/>
             <a:ext cx="822960" cy="41148"/>
           </a:xfrm>
           <a:prstGeom prst="rect">
@@ -8173,27 +8862,25 @@
       </p:sp>
       <p:sp>
         <p:nvSpPr>
-          <p:cNvPr id="61" name="Rounded Rectangle 60"/>
+          <p:cNvPr id="69" name="Rounded Rectangle 68"/>
           <p:cNvSpPr/>
           <p:nvPr/>
         </p:nvSpPr>
         <p:spPr>
           <a:xfrm>
-            <a:off x="365760" y="2340864"/>
-            <a:ext cx="2615184" cy="1325880"/>
+            <a:off x="365760" y="5605272"/>
+            <a:ext cx="2807208" cy="658368"/>
           </a:xfrm>
           <a:prstGeom prst="roundRect">
             <a:avLst>
-              <a:gd name="adj" fmla="val 7000"/>
+              <a:gd name="adj" fmla="val 12000"/>
             </a:avLst>
           </a:prstGeom>
           <a:solidFill>
-            <a:srgbClr val="FFFFFF"/>
+            <a:srgbClr val="E8F0FB"/>
           </a:solidFill>
-          <a:ln w="19050">
-            <a:solidFill>
-              <a:srgbClr val="1F5FBF"/>
-            </a:solidFill>
+          <a:ln>
+            <a:noFill/>
           </a:ln>
           <a:effectLst/>
         </p:spPr>
@@ -8221,19 +8908,17 @@
       </p:sp>
       <p:sp>
         <p:nvSpPr>
-          <p:cNvPr id="62" name="Rounded Rectangle 61"/>
+          <p:cNvPr id="70" name="Rectangle 69"/>
           <p:cNvSpPr/>
           <p:nvPr/>
         </p:nvSpPr>
         <p:spPr>
           <a:xfrm>
-            <a:off x="365760" y="2340864"/>
-            <a:ext cx="2615184" cy="420624"/>
-          </a:xfrm>
-          <a:prstGeom prst="roundRect">
-            <a:avLst>
-              <a:gd name="adj" fmla="val 30000"/>
-            </a:avLst>
+            <a:off x="365760" y="5696712"/>
+            <a:ext cx="64008" cy="475488"/>
+          </a:xfrm>
+          <a:prstGeom prst="rect">
+            <a:avLst/>
           </a:prstGeom>
           <a:solidFill>
             <a:srgbClr val="1F5FBF"/>
@@ -8267,20 +8952,69 @@
       </p:sp>
       <p:sp>
         <p:nvSpPr>
-          <p:cNvPr id="63" name="Oval 62"/>
+          <p:cNvPr id="71" name="TextBox 70"/>
+          <p:cNvSpPr txBox="1"/>
+          <p:nvPr/>
+        </p:nvSpPr>
+        <p:spPr>
+          <a:xfrm>
+            <a:off x="530352" y="5623560"/>
+            <a:ext cx="2578608" cy="621792"/>
+          </a:xfrm>
+          <a:prstGeom prst="rect">
+            <a:avLst/>
+          </a:prstGeom>
+          <a:noFill/>
+        </p:spPr>
+        <p:txBody>
+          <a:bodyPr wrap="square" lIns="36576" rIns="36576" tIns="18288" bIns="18288" anchor="ctr">
+            <a:spAutoFit/>
+          </a:bodyPr>
+          <a:lstStyle/>
+          <a:p>
+            <a:pPr algn="l"/>
+            <a:r>
+              <a:rPr sz="1250" b="1">
+                <a:solidFill>
+                  <a:srgbClr val="1F5FBF"/>
+                </a:solidFill>
+                <a:latin typeface="Calibri"/>
+              </a:rPr>
+              <a:t>Learns by itself</a:t>
+            </a:r>
+          </a:p>
+          <a:p>
+            <a:pPr algn="l"/>
+            <a:r>
+              <a:rPr sz="1100" b="0">
+                <a:solidFill>
+                  <a:srgbClr val="1E2530"/>
+                </a:solidFill>
+                <a:latin typeface="Calibri"/>
+              </a:rPr>
+              <a:t>no hand-written rules</a:t>
+            </a:r>
+          </a:p>
+        </p:txBody>
+      </p:sp>
+      <p:sp>
+        <p:nvSpPr>
+          <p:cNvPr id="72" name="Rounded Rectangle 71"/>
           <p:cNvSpPr/>
           <p:nvPr/>
         </p:nvSpPr>
         <p:spPr>
           <a:xfrm>
-            <a:off x="457200" y="2395728"/>
-            <a:ext cx="310896" cy="310896"/>
-          </a:xfrm>
-          <a:prstGeom prst="ellipse">
-            <a:avLst/>
+            <a:off x="3264408" y="5605272"/>
+            <a:ext cx="2807208" cy="658368"/>
+          </a:xfrm>
+          <a:prstGeom prst="roundRect">
+            <a:avLst>
+              <a:gd name="adj" fmla="val 12000"/>
+            </a:avLst>
           </a:prstGeom>
           <a:solidFill>
-            <a:srgbClr val="FFFFFF"/>
+            <a:srgbClr val="FFF4E0"/>
           </a:solidFill>
           <a:ln>
             <a:noFill/>
@@ -8311,167 +9045,23 @@
       </p:sp>
       <p:sp>
         <p:nvSpPr>
-          <p:cNvPr id="64" name="TextBox 63"/>
-          <p:cNvSpPr txBox="1"/>
-          <p:nvPr/>
-        </p:nvSpPr>
-        <p:spPr>
-          <a:xfrm>
-            <a:off x="457200" y="2395728"/>
-            <a:ext cx="310896" cy="310896"/>
+          <p:cNvPr id="73" name="Rectangle 72"/>
+          <p:cNvSpPr/>
+          <p:nvPr/>
+        </p:nvSpPr>
+        <p:spPr>
+          <a:xfrm>
+            <a:off x="3264408" y="5696712"/>
+            <a:ext cx="64008" cy="475488"/>
           </a:xfrm>
           <a:prstGeom prst="rect">
             <a:avLst/>
           </a:prstGeom>
-          <a:noFill/>
-        </p:spPr>
-        <p:txBody>
-          <a:bodyPr wrap="square" lIns="36576" rIns="36576" tIns="18288" bIns="18288" anchor="ctr">
-            <a:spAutoFit/>
-          </a:bodyPr>
-          <a:lstStyle/>
-          <a:p>
-            <a:pPr algn="ctr"/>
-            <a:r>
-              <a:rPr sz="1200" b="1">
-                <a:solidFill>
-                  <a:srgbClr val="1F5FBF"/>
-                </a:solidFill>
-                <a:latin typeface="Calibri"/>
-              </a:rPr>
-              <a:t>1</a:t>
-            </a:r>
-          </a:p>
-        </p:txBody>
-      </p:sp>
-      <p:sp>
-        <p:nvSpPr>
-          <p:cNvPr id="65" name="TextBox 64"/>
-          <p:cNvSpPr txBox="1"/>
-          <p:nvPr/>
-        </p:nvSpPr>
-        <p:spPr>
-          <a:xfrm>
-            <a:off x="822960" y="2340864"/>
-            <a:ext cx="2066544" cy="420624"/>
-          </a:xfrm>
-          <a:prstGeom prst="rect">
-            <a:avLst/>
-          </a:prstGeom>
-          <a:noFill/>
-        </p:spPr>
-        <p:txBody>
-          <a:bodyPr wrap="square" lIns="36576" rIns="36576" tIns="18288" bIns="18288" anchor="ctr">
-            <a:spAutoFit/>
-          </a:bodyPr>
-          <a:lstStyle/>
-          <a:p>
-            <a:pPr algn="l"/>
-            <a:r>
-              <a:rPr sz="1400" b="1">
-                <a:solidFill>
-                  <a:srgbClr val="FFFFFF"/>
-                </a:solidFill>
-                <a:latin typeface="Calibri"/>
-              </a:rPr>
-              <a:t>Collect</a:t>
-            </a:r>
-          </a:p>
-        </p:txBody>
-      </p:sp>
-      <p:sp>
-        <p:nvSpPr>
-          <p:cNvPr id="66" name="TextBox 65"/>
-          <p:cNvSpPr txBox="1"/>
-          <p:nvPr/>
-        </p:nvSpPr>
-        <p:spPr>
-          <a:xfrm>
-            <a:off x="475488" y="2816352"/>
-            <a:ext cx="2395728" cy="795528"/>
-          </a:xfrm>
-          <a:prstGeom prst="rect">
-            <a:avLst/>
-          </a:prstGeom>
-          <a:noFill/>
-        </p:spPr>
-        <p:txBody>
-          <a:bodyPr wrap="square" lIns="36576" rIns="36576" tIns="18288" bIns="18288" anchor="ctr">
-            <a:spAutoFit/>
-          </a:bodyPr>
-          <a:lstStyle/>
-          <a:p>
-            <a:pPr algn="l"/>
-            <a:r>
-              <a:rPr sz="1150" b="0">
-                <a:solidFill>
-                  <a:srgbClr val="1E2530"/>
-                </a:solidFill>
-                <a:latin typeface="Calibri"/>
-              </a:rPr>
-              <a:t>Logs arrive from any source (servers, apps, firewalls, cloud) through a web API or a small Bash script.</a:t>
-            </a:r>
-          </a:p>
-        </p:txBody>
-      </p:sp>
-      <p:sp>
-        <p:nvSpPr>
-          <p:cNvPr id="67" name="TextBox 66"/>
-          <p:cNvSpPr txBox="1"/>
-          <p:nvPr/>
-        </p:nvSpPr>
-        <p:spPr>
-          <a:xfrm>
-            <a:off x="2980944" y="2779776"/>
-            <a:ext cx="347472" cy="457200"/>
-          </a:xfrm>
-          <a:prstGeom prst="rect">
-            <a:avLst/>
-          </a:prstGeom>
-          <a:noFill/>
-        </p:spPr>
-        <p:txBody>
-          <a:bodyPr wrap="square" lIns="36576" rIns="36576" tIns="18288" bIns="18288" anchor="t">
-            <a:spAutoFit/>
-          </a:bodyPr>
-          <a:lstStyle/>
-          <a:p>
-            <a:pPr algn="ctr"/>
-            <a:r>
-              <a:rPr sz="1600" b="0">
-                <a:solidFill>
-                  <a:srgbClr val="5F6B7A"/>
-                </a:solidFill>
-                <a:latin typeface="Calibri"/>
-              </a:rPr>
-              <a:t>▶</a:t>
-            </a:r>
-          </a:p>
-        </p:txBody>
-      </p:sp>
-      <p:sp>
-        <p:nvSpPr>
-          <p:cNvPr id="68" name="Rounded Rectangle 67"/>
-          <p:cNvSpPr/>
-          <p:nvPr/>
-        </p:nvSpPr>
-        <p:spPr>
-          <a:xfrm>
-            <a:off x="3328416" y="2340864"/>
-            <a:ext cx="2615184" cy="1325880"/>
-          </a:xfrm>
-          <a:prstGeom prst="roundRect">
-            <a:avLst>
-              <a:gd name="adj" fmla="val 7000"/>
-            </a:avLst>
-          </a:prstGeom>
           <a:solidFill>
-            <a:srgbClr val="FFFFFF"/>
+            <a:srgbClr val="F58220"/>
           </a:solidFill>
-          <a:ln w="19050">
-            <a:solidFill>
-              <a:srgbClr val="0E8C8C"/>
-            </a:solidFill>
+          <a:ln>
+            <a:noFill/>
           </a:ln>
           <a:effectLst/>
         </p:spPr>
@@ -8499,22 +9089,69 @@
       </p:sp>
       <p:sp>
         <p:nvSpPr>
-          <p:cNvPr id="69" name="Rounded Rectangle 68"/>
+          <p:cNvPr id="74" name="TextBox 73"/>
+          <p:cNvSpPr txBox="1"/>
+          <p:nvPr/>
+        </p:nvSpPr>
+        <p:spPr>
+          <a:xfrm>
+            <a:off x="3429000" y="5623560"/>
+            <a:ext cx="2578608" cy="621792"/>
+          </a:xfrm>
+          <a:prstGeom prst="rect">
+            <a:avLst/>
+          </a:prstGeom>
+          <a:noFill/>
+        </p:spPr>
+        <p:txBody>
+          <a:bodyPr wrap="square" lIns="36576" rIns="36576" tIns="18288" bIns="18288" anchor="ctr">
+            <a:spAutoFit/>
+          </a:bodyPr>
+          <a:lstStyle/>
+          <a:p>
+            <a:pPr algn="l"/>
+            <a:r>
+              <a:rPr sz="1250" b="1">
+                <a:solidFill>
+                  <a:srgbClr val="F58220"/>
+                </a:solidFill>
+                <a:latin typeface="Calibri"/>
+              </a:rPr>
+              <a:t>AI only when needed</a:t>
+            </a:r>
+          </a:p>
+          <a:p>
+            <a:pPr algn="l"/>
+            <a:r>
+              <a:rPr sz="1100" b="0">
+                <a:solidFill>
+                  <a:srgbClr val="1E2530"/>
+                </a:solidFill>
+                <a:latin typeface="Calibri"/>
+              </a:rPr>
+              <a:t>keeps cost low</a:t>
+            </a:r>
+          </a:p>
+        </p:txBody>
+      </p:sp>
+      <p:sp>
+        <p:nvSpPr>
+          <p:cNvPr id="75" name="Rounded Rectangle 74"/>
           <p:cNvSpPr/>
           <p:nvPr/>
         </p:nvSpPr>
         <p:spPr>
           <a:xfrm>
-            <a:off x="3328416" y="2340864"/>
-            <a:ext cx="2615184" cy="420624"/>
+            <a:off x="6163056" y="5605272"/>
+            <a:ext cx="2807208" cy="658368"/>
           </a:xfrm>
           <a:prstGeom prst="roundRect">
             <a:avLst>
-              <a:gd name="adj" fmla="val 30000"/>
+              <a:gd name="adj" fmla="val 12000"/>
             </a:avLst>
           </a:prstGeom>
           <a:solidFill>
-            <a:srgbClr val="0E8C8C"/>
+            <a:srgbClr val="F1ECFA"/>
           </a:solidFill>
           <a:ln>
             <a:noFill/>
@@ -8545,251 +9182,17 @@
       </p:sp>
       <p:sp>
         <p:nvSpPr>
-          <p:cNvPr id="70" name="Oval 69"/>
+          <p:cNvPr id="76" name="Rectangle 75"/>
           <p:cNvSpPr/>
           <p:nvPr/>
         </p:nvSpPr>
         <p:spPr>
           <a:xfrm>
-            <a:off x="3419856" y="2395728"/>
-            <a:ext cx="310896" cy="310896"/>
-          </a:xfrm>
-          <a:prstGeom prst="ellipse">
-            <a:avLst/>
-          </a:prstGeom>
-          <a:solidFill>
-            <a:srgbClr val="FFFFFF"/>
-          </a:solidFill>
-          <a:ln>
-            <a:noFill/>
-          </a:ln>
-          <a:effectLst/>
-        </p:spPr>
-        <p:style>
-          <a:lnRef idx="1">
-            <a:schemeClr val="accent1"/>
-          </a:lnRef>
-          <a:fillRef idx="3">
-            <a:schemeClr val="accent1"/>
-          </a:fillRef>
-          <a:effectRef idx="2">
-            <a:schemeClr val="accent1"/>
-          </a:effectRef>
-          <a:fontRef idx="minor">
-            <a:schemeClr val="lt1"/>
-          </a:fontRef>
-        </p:style>
-        <p:txBody>
-          <a:bodyPr rtlCol="0" anchor="ctr"/>
-          <a:lstStyle/>
-          <a:p>
-            <a:pPr algn="ctr"/>
-          </a:p>
-        </p:txBody>
-      </p:sp>
-      <p:sp>
-        <p:nvSpPr>
-          <p:cNvPr id="71" name="TextBox 70"/>
-          <p:cNvSpPr txBox="1"/>
-          <p:nvPr/>
-        </p:nvSpPr>
-        <p:spPr>
-          <a:xfrm>
-            <a:off x="3419856" y="2395728"/>
-            <a:ext cx="310896" cy="310896"/>
+            <a:off x="6163056" y="5696712"/>
+            <a:ext cx="64008" cy="475488"/>
           </a:xfrm>
           <a:prstGeom prst="rect">
             <a:avLst/>
-          </a:prstGeom>
-          <a:noFill/>
-        </p:spPr>
-        <p:txBody>
-          <a:bodyPr wrap="square" lIns="36576" rIns="36576" tIns="18288" bIns="18288" anchor="ctr">
-            <a:spAutoFit/>
-          </a:bodyPr>
-          <a:lstStyle/>
-          <a:p>
-            <a:pPr algn="ctr"/>
-            <a:r>
-              <a:rPr sz="1200" b="1">
-                <a:solidFill>
-                  <a:srgbClr val="0E8C8C"/>
-                </a:solidFill>
-                <a:latin typeface="Calibri"/>
-              </a:rPr>
-              <a:t>2</a:t>
-            </a:r>
-          </a:p>
-        </p:txBody>
-      </p:sp>
-      <p:sp>
-        <p:nvSpPr>
-          <p:cNvPr id="72" name="TextBox 71"/>
-          <p:cNvSpPr txBox="1"/>
-          <p:nvPr/>
-        </p:nvSpPr>
-        <p:spPr>
-          <a:xfrm>
-            <a:off x="3785616" y="2340864"/>
-            <a:ext cx="2066544" cy="420624"/>
-          </a:xfrm>
-          <a:prstGeom prst="rect">
-            <a:avLst/>
-          </a:prstGeom>
-          <a:noFill/>
-        </p:spPr>
-        <p:txBody>
-          <a:bodyPr wrap="square" lIns="36576" rIns="36576" tIns="18288" bIns="18288" anchor="ctr">
-            <a:spAutoFit/>
-          </a:bodyPr>
-          <a:lstStyle/>
-          <a:p>
-            <a:pPr algn="l"/>
-            <a:r>
-              <a:rPr sz="1400" b="1">
-                <a:solidFill>
-                  <a:srgbClr val="FFFFFF"/>
-                </a:solidFill>
-                <a:latin typeface="Calibri"/>
-              </a:rPr>
-              <a:t>Group</a:t>
-            </a:r>
-          </a:p>
-        </p:txBody>
-      </p:sp>
-      <p:sp>
-        <p:nvSpPr>
-          <p:cNvPr id="73" name="TextBox 72"/>
-          <p:cNvSpPr txBox="1"/>
-          <p:nvPr/>
-        </p:nvSpPr>
-        <p:spPr>
-          <a:xfrm>
-            <a:off x="3438144" y="2816352"/>
-            <a:ext cx="2395728" cy="795528"/>
-          </a:xfrm>
-          <a:prstGeom prst="rect">
-            <a:avLst/>
-          </a:prstGeom>
-          <a:noFill/>
-        </p:spPr>
-        <p:txBody>
-          <a:bodyPr wrap="square" lIns="36576" rIns="36576" tIns="18288" bIns="18288" anchor="ctr">
-            <a:spAutoFit/>
-          </a:bodyPr>
-          <a:lstStyle/>
-          <a:p>
-            <a:pPr algn="l"/>
-            <a:r>
-              <a:rPr sz="1150" b="0">
-                <a:solidFill>
-                  <a:srgbClr val="1E2530"/>
-                </a:solidFill>
-                <a:latin typeface="Calibri"/>
-              </a:rPr>
-              <a:t>Similar lines are grouped into patterns, so millions of lines become a few thousand templates.</a:t>
-            </a:r>
-          </a:p>
-        </p:txBody>
-      </p:sp>
-      <p:sp>
-        <p:nvSpPr>
-          <p:cNvPr id="74" name="TextBox 73"/>
-          <p:cNvSpPr txBox="1"/>
-          <p:nvPr/>
-        </p:nvSpPr>
-        <p:spPr>
-          <a:xfrm>
-            <a:off x="5943600" y="2779776"/>
-            <a:ext cx="347472" cy="457200"/>
-          </a:xfrm>
-          <a:prstGeom prst="rect">
-            <a:avLst/>
-          </a:prstGeom>
-          <a:noFill/>
-        </p:spPr>
-        <p:txBody>
-          <a:bodyPr wrap="square" lIns="36576" rIns="36576" tIns="18288" bIns="18288" anchor="t">
-            <a:spAutoFit/>
-          </a:bodyPr>
-          <a:lstStyle/>
-          <a:p>
-            <a:pPr algn="ctr"/>
-            <a:r>
-              <a:rPr sz="1600" b="0">
-                <a:solidFill>
-                  <a:srgbClr val="5F6B7A"/>
-                </a:solidFill>
-                <a:latin typeface="Calibri"/>
-              </a:rPr>
-              <a:t>▶</a:t>
-            </a:r>
-          </a:p>
-        </p:txBody>
-      </p:sp>
-      <p:sp>
-        <p:nvSpPr>
-          <p:cNvPr id="75" name="Rounded Rectangle 74"/>
-          <p:cNvSpPr/>
-          <p:nvPr/>
-        </p:nvSpPr>
-        <p:spPr>
-          <a:xfrm>
-            <a:off x="6291072" y="2340864"/>
-            <a:ext cx="2615184" cy="1325880"/>
-          </a:xfrm>
-          <a:prstGeom prst="roundRect">
-            <a:avLst>
-              <a:gd name="adj" fmla="val 7000"/>
-            </a:avLst>
-          </a:prstGeom>
-          <a:solidFill>
-            <a:srgbClr val="FFFFFF"/>
-          </a:solidFill>
-          <a:ln w="19050">
-            <a:solidFill>
-              <a:srgbClr val="6A3FB5"/>
-            </a:solidFill>
-          </a:ln>
-          <a:effectLst/>
-        </p:spPr>
-        <p:style>
-          <a:lnRef idx="1">
-            <a:schemeClr val="accent1"/>
-          </a:lnRef>
-          <a:fillRef idx="3">
-            <a:schemeClr val="accent1"/>
-          </a:fillRef>
-          <a:effectRef idx="2">
-            <a:schemeClr val="accent1"/>
-          </a:effectRef>
-          <a:fontRef idx="minor">
-            <a:schemeClr val="lt1"/>
-          </a:fontRef>
-        </p:style>
-        <p:txBody>
-          <a:bodyPr rtlCol="0" anchor="ctr"/>
-          <a:lstStyle/>
-          <a:p>
-            <a:pPr algn="ctr"/>
-          </a:p>
-        </p:txBody>
-      </p:sp>
-      <p:sp>
-        <p:nvSpPr>
-          <p:cNvPr id="76" name="Rounded Rectangle 75"/>
-          <p:cNvSpPr/>
-          <p:nvPr/>
-        </p:nvSpPr>
-        <p:spPr>
-          <a:xfrm>
-            <a:off x="6291072" y="2340864"/>
-            <a:ext cx="2615184" cy="420624"/>
-          </a:xfrm>
-          <a:prstGeom prst="roundRect">
-            <a:avLst>
-              <a:gd name="adj" fmla="val 30000"/>
-            </a:avLst>
           </a:prstGeom>
           <a:solidFill>
             <a:srgbClr val="6A3FB5"/>
@@ -8823,20 +9226,69 @@
       </p:sp>
       <p:sp>
         <p:nvSpPr>
-          <p:cNvPr id="77" name="Oval 76"/>
+          <p:cNvPr id="77" name="TextBox 76"/>
+          <p:cNvSpPr txBox="1"/>
+          <p:nvPr/>
+        </p:nvSpPr>
+        <p:spPr>
+          <a:xfrm>
+            <a:off x="6327648" y="5623560"/>
+            <a:ext cx="2578608" cy="621792"/>
+          </a:xfrm>
+          <a:prstGeom prst="rect">
+            <a:avLst/>
+          </a:prstGeom>
+          <a:noFill/>
+        </p:spPr>
+        <p:txBody>
+          <a:bodyPr wrap="square" lIns="36576" rIns="36576" tIns="18288" bIns="18288" anchor="ctr">
+            <a:spAutoFit/>
+          </a:bodyPr>
+          <a:lstStyle/>
+          <a:p>
+            <a:pPr algn="l"/>
+            <a:r>
+              <a:rPr sz="1250" b="1">
+                <a:solidFill>
+                  <a:srgbClr val="6A3FB5"/>
+                </a:solidFill>
+                <a:latin typeface="Calibri"/>
+              </a:rPr>
+              <a:t>Flags unknown formats</a:t>
+            </a:r>
+          </a:p>
+          <a:p>
+            <a:pPr algn="l"/>
+            <a:r>
+              <a:rPr sz="1100" b="0">
+                <a:solidFill>
+                  <a:srgbClr val="1E2530"/>
+                </a:solidFill>
+                <a:latin typeface="Calibri"/>
+              </a:rPr>
+              <a:t>sent for human review</a:t>
+            </a:r>
+          </a:p>
+        </p:txBody>
+      </p:sp>
+      <p:sp>
+        <p:nvSpPr>
+          <p:cNvPr id="78" name="Rounded Rectangle 77"/>
           <p:cNvSpPr/>
           <p:nvPr/>
         </p:nvSpPr>
         <p:spPr>
           <a:xfrm>
-            <a:off x="6382512" y="2395728"/>
-            <a:ext cx="310896" cy="310896"/>
-          </a:xfrm>
-          <a:prstGeom prst="ellipse">
-            <a:avLst/>
+            <a:off x="9061704" y="5605272"/>
+            <a:ext cx="2807208" cy="658368"/>
+          </a:xfrm>
+          <a:prstGeom prst="roundRect">
+            <a:avLst>
+              <a:gd name="adj" fmla="val 12000"/>
+            </a:avLst>
           </a:prstGeom>
           <a:solidFill>
-            <a:srgbClr val="FFFFFF"/>
+            <a:srgbClr val="E8F5EC"/>
           </a:solidFill>
           <a:ln>
             <a:noFill/>
@@ -8867,207 +9319,17 @@
       </p:sp>
       <p:sp>
         <p:nvSpPr>
-          <p:cNvPr id="78" name="TextBox 77"/>
-          <p:cNvSpPr txBox="1"/>
-          <p:nvPr/>
-        </p:nvSpPr>
-        <p:spPr>
-          <a:xfrm>
-            <a:off x="6382512" y="2395728"/>
-            <a:ext cx="310896" cy="310896"/>
+          <p:cNvPr id="79" name="Rectangle 78"/>
+          <p:cNvSpPr/>
+          <p:nvPr/>
+        </p:nvSpPr>
+        <p:spPr>
+          <a:xfrm>
+            <a:off x="9061704" y="5696712"/>
+            <a:ext cx="64008" cy="475488"/>
           </a:xfrm>
           <a:prstGeom prst="rect">
             <a:avLst/>
-          </a:prstGeom>
-          <a:noFill/>
-        </p:spPr>
-        <p:txBody>
-          <a:bodyPr wrap="square" lIns="36576" rIns="36576" tIns="18288" bIns="18288" anchor="ctr">
-            <a:spAutoFit/>
-          </a:bodyPr>
-          <a:lstStyle/>
-          <a:p>
-            <a:pPr algn="ctr"/>
-            <a:r>
-              <a:rPr sz="1200" b="1">
-                <a:solidFill>
-                  <a:srgbClr val="6A3FB5"/>
-                </a:solidFill>
-                <a:latin typeface="Calibri"/>
-              </a:rPr>
-              <a:t>3</a:t>
-            </a:r>
-          </a:p>
-        </p:txBody>
-      </p:sp>
-      <p:sp>
-        <p:nvSpPr>
-          <p:cNvPr id="79" name="TextBox 78"/>
-          <p:cNvSpPr txBox="1"/>
-          <p:nvPr/>
-        </p:nvSpPr>
-        <p:spPr>
-          <a:xfrm>
-            <a:off x="6748272" y="2340864"/>
-            <a:ext cx="2066544" cy="420624"/>
-          </a:xfrm>
-          <a:prstGeom prst="rect">
-            <a:avLst/>
-          </a:prstGeom>
-          <a:noFill/>
-        </p:spPr>
-        <p:txBody>
-          <a:bodyPr wrap="square" lIns="36576" rIns="36576" tIns="18288" bIns="18288" anchor="ctr">
-            <a:spAutoFit/>
-          </a:bodyPr>
-          <a:lstStyle/>
-          <a:p>
-            <a:pPr algn="l"/>
-            <a:r>
-              <a:rPr sz="1400" b="1">
-                <a:solidFill>
-                  <a:srgbClr val="FFFFFF"/>
-                </a:solidFill>
-                <a:latin typeface="Calibri"/>
-              </a:rPr>
-              <a:t>Learn once</a:t>
-            </a:r>
-          </a:p>
-        </p:txBody>
-      </p:sp>
-      <p:sp>
-        <p:nvSpPr>
-          <p:cNvPr id="80" name="TextBox 79"/>
-          <p:cNvSpPr txBox="1"/>
-          <p:nvPr/>
-        </p:nvSpPr>
-        <p:spPr>
-          <a:xfrm>
-            <a:off x="6400800" y="2816352"/>
-            <a:ext cx="2395728" cy="795528"/>
-          </a:xfrm>
-          <a:prstGeom prst="rect">
-            <a:avLst/>
-          </a:prstGeom>
-          <a:noFill/>
-        </p:spPr>
-        <p:txBody>
-          <a:bodyPr wrap="square" lIns="36576" rIns="36576" tIns="18288" bIns="18288" anchor="ctr">
-            <a:spAutoFit/>
-          </a:bodyPr>
-          <a:lstStyle/>
-          <a:p>
-            <a:pPr algn="l"/>
-            <a:r>
-              <a:rPr sz="1150" b="0">
-                <a:solidFill>
-                  <a:srgbClr val="1E2530"/>
-                </a:solidFill>
-                <a:latin typeface="Calibri"/>
-              </a:rPr>
-              <a:t>For a brand-new pattern, AI writes a parsing rule one time. The rule is saved and reused.</a:t>
-            </a:r>
-          </a:p>
-        </p:txBody>
-      </p:sp>
-      <p:sp>
-        <p:nvSpPr>
-          <p:cNvPr id="81" name="TextBox 80"/>
-          <p:cNvSpPr txBox="1"/>
-          <p:nvPr/>
-        </p:nvSpPr>
-        <p:spPr>
-          <a:xfrm>
-            <a:off x="8906256" y="2779776"/>
-            <a:ext cx="347472" cy="457200"/>
-          </a:xfrm>
-          <a:prstGeom prst="rect">
-            <a:avLst/>
-          </a:prstGeom>
-          <a:noFill/>
-        </p:spPr>
-        <p:txBody>
-          <a:bodyPr wrap="square" lIns="36576" rIns="36576" tIns="18288" bIns="18288" anchor="t">
-            <a:spAutoFit/>
-          </a:bodyPr>
-          <a:lstStyle/>
-          <a:p>
-            <a:pPr algn="ctr"/>
-            <a:r>
-              <a:rPr sz="1600" b="0">
-                <a:solidFill>
-                  <a:srgbClr val="5F6B7A"/>
-                </a:solidFill>
-                <a:latin typeface="Calibri"/>
-              </a:rPr>
-              <a:t>▶</a:t>
-            </a:r>
-          </a:p>
-        </p:txBody>
-      </p:sp>
-      <p:sp>
-        <p:nvSpPr>
-          <p:cNvPr id="82" name="Rounded Rectangle 81"/>
-          <p:cNvSpPr/>
-          <p:nvPr/>
-        </p:nvSpPr>
-        <p:spPr>
-          <a:xfrm>
-            <a:off x="9253728" y="2340864"/>
-            <a:ext cx="2615184" cy="1325880"/>
-          </a:xfrm>
-          <a:prstGeom prst="roundRect">
-            <a:avLst>
-              <a:gd name="adj" fmla="val 7000"/>
-            </a:avLst>
-          </a:prstGeom>
-          <a:solidFill>
-            <a:srgbClr val="FFFFFF"/>
-          </a:solidFill>
-          <a:ln w="19050">
-            <a:solidFill>
-              <a:srgbClr val="138A36"/>
-            </a:solidFill>
-          </a:ln>
-          <a:effectLst/>
-        </p:spPr>
-        <p:style>
-          <a:lnRef idx="1">
-            <a:schemeClr val="accent1"/>
-          </a:lnRef>
-          <a:fillRef idx="3">
-            <a:schemeClr val="accent1"/>
-          </a:fillRef>
-          <a:effectRef idx="2">
-            <a:schemeClr val="accent1"/>
-          </a:effectRef>
-          <a:fontRef idx="minor">
-            <a:schemeClr val="lt1"/>
-          </a:fontRef>
-        </p:style>
-        <p:txBody>
-          <a:bodyPr rtlCol="0" anchor="ctr"/>
-          <a:lstStyle/>
-          <a:p>
-            <a:pPr algn="ctr"/>
-          </a:p>
-        </p:txBody>
-      </p:sp>
-      <p:sp>
-        <p:nvSpPr>
-          <p:cNvPr id="83" name="Rounded Rectangle 82"/>
-          <p:cNvSpPr/>
-          <p:nvPr/>
-        </p:nvSpPr>
-        <p:spPr>
-          <a:xfrm>
-            <a:off x="9253728" y="2340864"/>
-            <a:ext cx="2615184" cy="420624"/>
-          </a:xfrm>
-          <a:prstGeom prst="roundRect">
-            <a:avLst>
-              <a:gd name="adj" fmla="val 30000"/>
-            </a:avLst>
           </a:prstGeom>
           <a:solidFill>
             <a:srgbClr val="138A36"/>
@@ -9101,58 +9363,14 @@
       </p:sp>
       <p:sp>
         <p:nvSpPr>
-          <p:cNvPr id="84" name="Oval 83"/>
-          <p:cNvSpPr/>
-          <p:nvPr/>
-        </p:nvSpPr>
-        <p:spPr>
-          <a:xfrm>
-            <a:off x="9345168" y="2395728"/>
-            <a:ext cx="310896" cy="310896"/>
-          </a:xfrm>
-          <a:prstGeom prst="ellipse">
-            <a:avLst/>
-          </a:prstGeom>
-          <a:solidFill>
-            <a:srgbClr val="FFFFFF"/>
-          </a:solidFill>
-          <a:ln>
-            <a:noFill/>
-          </a:ln>
-          <a:effectLst/>
-        </p:spPr>
-        <p:style>
-          <a:lnRef idx="1">
-            <a:schemeClr val="accent1"/>
-          </a:lnRef>
-          <a:fillRef idx="3">
-            <a:schemeClr val="accent1"/>
-          </a:fillRef>
-          <a:effectRef idx="2">
-            <a:schemeClr val="accent1"/>
-          </a:effectRef>
-          <a:fontRef idx="minor">
-            <a:schemeClr val="lt1"/>
-          </a:fontRef>
-        </p:style>
-        <p:txBody>
-          <a:bodyPr rtlCol="0" anchor="ctr"/>
-          <a:lstStyle/>
-          <a:p>
-            <a:pPr algn="ctr"/>
-          </a:p>
-        </p:txBody>
-      </p:sp>
-      <p:sp>
-        <p:nvSpPr>
-          <p:cNvPr id="85" name="TextBox 84"/>
+          <p:cNvPr id="80" name="TextBox 79"/>
           <p:cNvSpPr txBox="1"/>
           <p:nvPr/>
         </p:nvSpPr>
         <p:spPr>
           <a:xfrm>
-            <a:off x="9345168" y="2395728"/>
-            <a:ext cx="310896" cy="310896"/>
+            <a:off x="9226296" y="5623560"/>
+            <a:ext cx="2578608" cy="621792"/>
           </a:xfrm>
           <a:prstGeom prst="rect">
             <a:avLst/>
@@ -9165,1651 +9383,9 @@
           </a:bodyPr>
           <a:lstStyle/>
           <a:p>
-            <a:pPr algn="ctr"/>
-            <a:r>
-              <a:rPr sz="1200" b="1">
-                <a:solidFill>
-                  <a:srgbClr val="138A36"/>
-                </a:solidFill>
-                <a:latin typeface="Calibri"/>
-              </a:rPr>
-              <a:t>4</a:t>
-            </a:r>
-          </a:p>
-        </p:txBody>
-      </p:sp>
-      <p:sp>
-        <p:nvSpPr>
-          <p:cNvPr id="86" name="TextBox 85"/>
-          <p:cNvSpPr txBox="1"/>
-          <p:nvPr/>
-        </p:nvSpPr>
-        <p:spPr>
-          <a:xfrm>
-            <a:off x="9710928" y="2340864"/>
-            <a:ext cx="2066544" cy="420624"/>
-          </a:xfrm>
-          <a:prstGeom prst="rect">
-            <a:avLst/>
-          </a:prstGeom>
-          <a:noFill/>
-        </p:spPr>
-        <p:txBody>
-          <a:bodyPr wrap="square" lIns="36576" rIns="36576" tIns="18288" bIns="18288" anchor="ctr">
-            <a:spAutoFit/>
-          </a:bodyPr>
-          <a:lstStyle/>
-          <a:p>
             <a:pPr algn="l"/>
             <a:r>
-              <a:rPr sz="1400" b="1">
-                <a:solidFill>
-                  <a:srgbClr val="FFFFFF"/>
-                </a:solidFill>
-                <a:latin typeface="Calibri"/>
-              </a:rPr>
-              <a:t>Clean output</a:t>
-            </a:r>
-          </a:p>
-        </p:txBody>
-      </p:sp>
-      <p:sp>
-        <p:nvSpPr>
-          <p:cNvPr id="87" name="TextBox 86"/>
-          <p:cNvSpPr txBox="1"/>
-          <p:nvPr/>
-        </p:nvSpPr>
-        <p:spPr>
-          <a:xfrm>
-            <a:off x="9363456" y="2816352"/>
-            <a:ext cx="2395728" cy="795528"/>
-          </a:xfrm>
-          <a:prstGeom prst="rect">
-            <a:avLst/>
-          </a:prstGeom>
-          <a:noFill/>
-        </p:spPr>
-        <p:txBody>
-          <a:bodyPr wrap="square" lIns="36576" rIns="36576" tIns="18288" bIns="18288" anchor="ctr">
-            <a:spAutoFit/>
-          </a:bodyPr>
-          <a:lstStyle/>
-          <a:p>
-            <a:pPr algn="l"/>
-            <a:r>
-              <a:rPr sz="1150" b="0">
-                <a:solidFill>
-                  <a:srgbClr val="1E2530"/>
-                </a:solidFill>
-                <a:latin typeface="Calibri"/>
-              </a:rPr>
-              <a:t>Every log leaves in one format: time (UTC), source, event, severity and message.</a:t>
-            </a:r>
-          </a:p>
-        </p:txBody>
-      </p:sp>
-      <p:sp>
-        <p:nvSpPr>
-          <p:cNvPr id="88" name="Rounded Rectangle 87"/>
-          <p:cNvSpPr/>
-          <p:nvPr/>
-        </p:nvSpPr>
-        <p:spPr>
-          <a:xfrm>
-            <a:off x="365760" y="3739896"/>
-            <a:ext cx="11503152" cy="329184"/>
-          </a:xfrm>
-          <a:prstGeom prst="roundRect">
-            <a:avLst>
-              <a:gd name="adj" fmla="val 30000"/>
-            </a:avLst>
-          </a:prstGeom>
-          <a:solidFill>
-            <a:srgbClr val="F2F5FA"/>
-          </a:solidFill>
-          <a:ln>
-            <a:noFill/>
-          </a:ln>
-          <a:effectLst/>
-        </p:spPr>
-        <p:style>
-          <a:lnRef idx="1">
-            <a:schemeClr val="accent1"/>
-          </a:lnRef>
-          <a:fillRef idx="3">
-            <a:schemeClr val="accent1"/>
-          </a:fillRef>
-          <a:effectRef idx="2">
-            <a:schemeClr val="accent1"/>
-          </a:effectRef>
-          <a:fontRef idx="minor">
-            <a:schemeClr val="lt1"/>
-          </a:fontRef>
-        </p:style>
-        <p:txBody>
-          <a:bodyPr rtlCol="0" anchor="ctr"/>
-          <a:lstStyle/>
-          <a:p>
-            <a:pPr algn="ctr"/>
-          </a:p>
-        </p:txBody>
-      </p:sp>
-      <p:sp>
-        <p:nvSpPr>
-          <p:cNvPr id="89" name="TextBox 88"/>
-          <p:cNvSpPr txBox="1"/>
-          <p:nvPr/>
-        </p:nvSpPr>
-        <p:spPr>
-          <a:xfrm>
-            <a:off x="502920" y="3739896"/>
-            <a:ext cx="11247120" cy="329184"/>
-          </a:xfrm>
-          <a:prstGeom prst="rect">
-            <a:avLst/>
-          </a:prstGeom>
-          <a:noFill/>
-        </p:spPr>
-        <p:txBody>
-          <a:bodyPr wrap="square" lIns="36576" rIns="36576" tIns="18288" bIns="18288" anchor="ctr">
-            <a:spAutoFit/>
-          </a:bodyPr>
-          <a:lstStyle/>
-          <a:p>
-            <a:pPr algn="l"/>
-            <a:r>
-              <a:rPr sz="1100" b="1">
-                <a:solidFill>
-                  <a:srgbClr val="0B2A5B"/>
-                </a:solidFill>
-                <a:latin typeface="Calibri"/>
-              </a:rPr>
-              <a:t>Safety net:  </a:t>
-            </a:r>
-            <a:r>
-              <a:rPr sz="1100" b="0">
-                <a:solidFill>
-                  <a:srgbClr val="1E2530"/>
-                </a:solidFill>
-                <a:latin typeface="Calibri"/>
-              </a:rPr>
-              <a:t>unfamiliar formats are held for review, never lost  ·  if the AI service is down, a backup AI and built-in rules take over  ·  can run fully on-premise</a:t>
-            </a:r>
-          </a:p>
-        </p:txBody>
-      </p:sp>
-      <p:sp>
-        <p:nvSpPr>
-          <p:cNvPr id="90" name="TextBox 89"/>
-          <p:cNvSpPr txBox="1"/>
-          <p:nvPr/>
-        </p:nvSpPr>
-        <p:spPr>
-          <a:xfrm>
-            <a:off x="365760" y="4160520"/>
-            <a:ext cx="5669280" cy="292608"/>
-          </a:xfrm>
-          <a:prstGeom prst="rect">
-            <a:avLst/>
-          </a:prstGeom>
-          <a:noFill/>
-        </p:spPr>
-        <p:txBody>
-          <a:bodyPr wrap="square" lIns="36576" rIns="36576" tIns="18288" bIns="18288" anchor="t">
-            <a:spAutoFit/>
-          </a:bodyPr>
-          <a:lstStyle/>
-          <a:p>
-            <a:pPr algn="l"/>
-            <a:r>
-              <a:rPr sz="1450" b="1">
-                <a:solidFill>
-                  <a:srgbClr val="0B2A5B"/>
-                </a:solidFill>
-                <a:latin typeface="Calibri"/>
-              </a:rPr>
-              <a:t>How it addresses the problem</a:t>
-            </a:r>
-          </a:p>
-        </p:txBody>
-      </p:sp>
-      <p:sp>
-        <p:nvSpPr>
-          <p:cNvPr id="91" name="Rectangle 90"/>
-          <p:cNvSpPr/>
-          <p:nvPr/>
-        </p:nvSpPr>
-        <p:spPr>
-          <a:xfrm>
-            <a:off x="402336" y="4462272"/>
-            <a:ext cx="822960" cy="41148"/>
-          </a:xfrm>
-          <a:prstGeom prst="rect">
-            <a:avLst/>
-          </a:prstGeom>
-          <a:solidFill>
-            <a:srgbClr val="F58220"/>
-          </a:solidFill>
-          <a:ln>
-            <a:noFill/>
-          </a:ln>
-          <a:effectLst/>
-        </p:spPr>
-        <p:style>
-          <a:lnRef idx="1">
-            <a:schemeClr val="accent1"/>
-          </a:lnRef>
-          <a:fillRef idx="3">
-            <a:schemeClr val="accent1"/>
-          </a:fillRef>
-          <a:effectRef idx="2">
-            <a:schemeClr val="accent1"/>
-          </a:effectRef>
-          <a:fontRef idx="minor">
-            <a:schemeClr val="lt1"/>
-          </a:fontRef>
-        </p:style>
-        <p:txBody>
-          <a:bodyPr rtlCol="0" anchor="ctr"/>
-          <a:lstStyle/>
-          <a:p>
-            <a:pPr algn="ctr"/>
-          </a:p>
-        </p:txBody>
-      </p:sp>
-      <p:sp>
-        <p:nvSpPr>
-          <p:cNvPr id="92" name="Rounded Rectangle 91"/>
-          <p:cNvSpPr/>
-          <p:nvPr/>
-        </p:nvSpPr>
-        <p:spPr>
-          <a:xfrm>
-            <a:off x="365760" y="4562856"/>
-            <a:ext cx="2514600" cy="329184"/>
-          </a:xfrm>
-          <a:prstGeom prst="roundRect">
-            <a:avLst>
-              <a:gd name="adj" fmla="val 30000"/>
-            </a:avLst>
-          </a:prstGeom>
-          <a:solidFill>
-            <a:srgbClr val="FDECEA"/>
-          </a:solidFill>
-          <a:ln>
-            <a:noFill/>
-          </a:ln>
-          <a:effectLst/>
-        </p:spPr>
-        <p:style>
-          <a:lnRef idx="1">
-            <a:schemeClr val="accent1"/>
-          </a:lnRef>
-          <a:fillRef idx="3">
-            <a:schemeClr val="accent1"/>
-          </a:fillRef>
-          <a:effectRef idx="2">
-            <a:schemeClr val="accent1"/>
-          </a:effectRef>
-          <a:fontRef idx="minor">
-            <a:schemeClr val="lt1"/>
-          </a:fontRef>
-        </p:style>
-        <p:txBody>
-          <a:bodyPr rtlCol="0" anchor="ctr"/>
-          <a:lstStyle/>
-          <a:p>
-            <a:pPr algn="ctr"/>
-          </a:p>
-        </p:txBody>
-      </p:sp>
-      <p:sp>
-        <p:nvSpPr>
-          <p:cNvPr id="93" name="TextBox 92"/>
-          <p:cNvSpPr txBox="1"/>
-          <p:nvPr/>
-        </p:nvSpPr>
-        <p:spPr>
-          <a:xfrm>
-            <a:off x="411480" y="4562856"/>
-            <a:ext cx="2423160" cy="329184"/>
-          </a:xfrm>
-          <a:prstGeom prst="rect">
-            <a:avLst/>
-          </a:prstGeom>
-          <a:noFill/>
-        </p:spPr>
-        <p:txBody>
-          <a:bodyPr wrap="square" lIns="36576" rIns="36576" tIns="18288" bIns="18288" anchor="ctr">
-            <a:spAutoFit/>
-          </a:bodyPr>
-          <a:lstStyle/>
-          <a:p>
-            <a:pPr algn="l"/>
-            <a:r>
-              <a:rPr sz="1100" b="1">
-                <a:solidFill>
-                  <a:srgbClr val="C0392B"/>
-                </a:solidFill>
-                <a:latin typeface="Calibri"/>
-              </a:rPr>
-              <a:t>✖ Hundreds of log formats</a:t>
-            </a:r>
-          </a:p>
-        </p:txBody>
-      </p:sp>
-      <p:sp>
-        <p:nvSpPr>
-          <p:cNvPr id="94" name="TextBox 93"/>
-          <p:cNvSpPr txBox="1"/>
-          <p:nvPr/>
-        </p:nvSpPr>
-        <p:spPr>
-          <a:xfrm>
-            <a:off x="2880360" y="4562856"/>
-            <a:ext cx="320040" cy="329184"/>
-          </a:xfrm>
-          <a:prstGeom prst="rect">
-            <a:avLst/>
-          </a:prstGeom>
-          <a:noFill/>
-        </p:spPr>
-        <p:txBody>
-          <a:bodyPr wrap="square" lIns="36576" rIns="36576" tIns="18288" bIns="18288" anchor="ctr">
-            <a:spAutoFit/>
-          </a:bodyPr>
-          <a:lstStyle/>
-          <a:p>
-            <a:pPr algn="ctr"/>
-            <a:r>
-              <a:rPr sz="1400" b="1">
-                <a:solidFill>
-                  <a:srgbClr val="5F6B7A"/>
-                </a:solidFill>
-                <a:latin typeface="Calibri"/>
-              </a:rPr>
-              <a:t>→</a:t>
-            </a:r>
-          </a:p>
-        </p:txBody>
-      </p:sp>
-      <p:sp>
-        <p:nvSpPr>
-          <p:cNvPr id="95" name="Rounded Rectangle 94"/>
-          <p:cNvSpPr/>
-          <p:nvPr/>
-        </p:nvSpPr>
-        <p:spPr>
-          <a:xfrm>
-            <a:off x="3200400" y="4562856"/>
-            <a:ext cx="2834640" cy="329184"/>
-          </a:xfrm>
-          <a:prstGeom prst="roundRect">
-            <a:avLst>
-              <a:gd name="adj" fmla="val 30000"/>
-            </a:avLst>
-          </a:prstGeom>
-          <a:solidFill>
-            <a:srgbClr val="E8F5EC"/>
-          </a:solidFill>
-          <a:ln>
-            <a:noFill/>
-          </a:ln>
-          <a:effectLst/>
-        </p:spPr>
-        <p:style>
-          <a:lnRef idx="1">
-            <a:schemeClr val="accent1"/>
-          </a:lnRef>
-          <a:fillRef idx="3">
-            <a:schemeClr val="accent1"/>
-          </a:fillRef>
-          <a:effectRef idx="2">
-            <a:schemeClr val="accent1"/>
-          </a:effectRef>
-          <a:fontRef idx="minor">
-            <a:schemeClr val="lt1"/>
-          </a:fontRef>
-        </p:style>
-        <p:txBody>
-          <a:bodyPr rtlCol="0" anchor="ctr"/>
-          <a:lstStyle/>
-          <a:p>
-            <a:pPr algn="ctr"/>
-          </a:p>
-        </p:txBody>
-      </p:sp>
-      <p:sp>
-        <p:nvSpPr>
-          <p:cNvPr id="96" name="TextBox 95"/>
-          <p:cNvSpPr txBox="1"/>
-          <p:nvPr/>
-        </p:nvSpPr>
-        <p:spPr>
-          <a:xfrm>
-            <a:off x="3246120" y="4562856"/>
-            <a:ext cx="2743200" cy="329184"/>
-          </a:xfrm>
-          <a:prstGeom prst="rect">
-            <a:avLst/>
-          </a:prstGeom>
-          <a:noFill/>
-        </p:spPr>
-        <p:txBody>
-          <a:bodyPr wrap="square" lIns="36576" rIns="36576" tIns="18288" bIns="18288" anchor="ctr">
-            <a:spAutoFit/>
-          </a:bodyPr>
-          <a:lstStyle/>
-          <a:p>
-            <a:pPr algn="l"/>
-            <a:r>
-              <a:rPr sz="1100" b="1">
-                <a:solidFill>
-                  <a:srgbClr val="138A36"/>
-                </a:solidFill>
-                <a:latin typeface="Calibri"/>
-              </a:rPr>
-              <a:t>✔ Learned automatically, no coding</a:t>
-            </a:r>
-          </a:p>
-        </p:txBody>
-      </p:sp>
-      <p:sp>
-        <p:nvSpPr>
-          <p:cNvPr id="97" name="Rounded Rectangle 96"/>
-          <p:cNvSpPr/>
-          <p:nvPr/>
-        </p:nvSpPr>
-        <p:spPr>
-          <a:xfrm>
-            <a:off x="365760" y="4937760"/>
-            <a:ext cx="2514600" cy="329184"/>
-          </a:xfrm>
-          <a:prstGeom prst="roundRect">
-            <a:avLst>
-              <a:gd name="adj" fmla="val 30000"/>
-            </a:avLst>
-          </a:prstGeom>
-          <a:solidFill>
-            <a:srgbClr val="FDECEA"/>
-          </a:solidFill>
-          <a:ln>
-            <a:noFill/>
-          </a:ln>
-          <a:effectLst/>
-        </p:spPr>
-        <p:style>
-          <a:lnRef idx="1">
-            <a:schemeClr val="accent1"/>
-          </a:lnRef>
-          <a:fillRef idx="3">
-            <a:schemeClr val="accent1"/>
-          </a:fillRef>
-          <a:effectRef idx="2">
-            <a:schemeClr val="accent1"/>
-          </a:effectRef>
-          <a:fontRef idx="minor">
-            <a:schemeClr val="lt1"/>
-          </a:fontRef>
-        </p:style>
-        <p:txBody>
-          <a:bodyPr rtlCol="0" anchor="ctr"/>
-          <a:lstStyle/>
-          <a:p>
-            <a:pPr algn="ctr"/>
-          </a:p>
-        </p:txBody>
-      </p:sp>
-      <p:sp>
-        <p:nvSpPr>
-          <p:cNvPr id="98" name="TextBox 97"/>
-          <p:cNvSpPr txBox="1"/>
-          <p:nvPr/>
-        </p:nvSpPr>
-        <p:spPr>
-          <a:xfrm>
-            <a:off x="411480" y="4937760"/>
-            <a:ext cx="2423160" cy="329184"/>
-          </a:xfrm>
-          <a:prstGeom prst="rect">
-            <a:avLst/>
-          </a:prstGeom>
-          <a:noFill/>
-        </p:spPr>
-        <p:txBody>
-          <a:bodyPr wrap="square" lIns="36576" rIns="36576" tIns="18288" bIns="18288" anchor="ctr">
-            <a:spAutoFit/>
-          </a:bodyPr>
-          <a:lstStyle/>
-          <a:p>
-            <a:pPr algn="l"/>
-            <a:r>
-              <a:rPr sz="1100" b="1">
-                <a:solidFill>
-                  <a:srgbClr val="C0392B"/>
-                </a:solidFill>
-                <a:latin typeface="Calibri"/>
-              </a:rPr>
-              <a:t>✖ Hand-written parsers break</a:t>
-            </a:r>
-          </a:p>
-        </p:txBody>
-      </p:sp>
-      <p:sp>
-        <p:nvSpPr>
-          <p:cNvPr id="99" name="TextBox 98"/>
-          <p:cNvSpPr txBox="1"/>
-          <p:nvPr/>
-        </p:nvSpPr>
-        <p:spPr>
-          <a:xfrm>
-            <a:off x="2880360" y="4937760"/>
-            <a:ext cx="320040" cy="329184"/>
-          </a:xfrm>
-          <a:prstGeom prst="rect">
-            <a:avLst/>
-          </a:prstGeom>
-          <a:noFill/>
-        </p:spPr>
-        <p:txBody>
-          <a:bodyPr wrap="square" lIns="36576" rIns="36576" tIns="18288" bIns="18288" anchor="ctr">
-            <a:spAutoFit/>
-          </a:bodyPr>
-          <a:lstStyle/>
-          <a:p>
-            <a:pPr algn="ctr"/>
-            <a:r>
-              <a:rPr sz="1400" b="1">
-                <a:solidFill>
-                  <a:srgbClr val="5F6B7A"/>
-                </a:solidFill>
-                <a:latin typeface="Calibri"/>
-              </a:rPr>
-              <a:t>→</a:t>
-            </a:r>
-          </a:p>
-        </p:txBody>
-      </p:sp>
-      <p:sp>
-        <p:nvSpPr>
-          <p:cNvPr id="100" name="Rounded Rectangle 99"/>
-          <p:cNvSpPr/>
-          <p:nvPr/>
-        </p:nvSpPr>
-        <p:spPr>
-          <a:xfrm>
-            <a:off x="3200400" y="4937760"/>
-            <a:ext cx="2834640" cy="329184"/>
-          </a:xfrm>
-          <a:prstGeom prst="roundRect">
-            <a:avLst>
-              <a:gd name="adj" fmla="val 30000"/>
-            </a:avLst>
-          </a:prstGeom>
-          <a:solidFill>
-            <a:srgbClr val="E8F5EC"/>
-          </a:solidFill>
-          <a:ln>
-            <a:noFill/>
-          </a:ln>
-          <a:effectLst/>
-        </p:spPr>
-        <p:style>
-          <a:lnRef idx="1">
-            <a:schemeClr val="accent1"/>
-          </a:lnRef>
-          <a:fillRef idx="3">
-            <a:schemeClr val="accent1"/>
-          </a:fillRef>
-          <a:effectRef idx="2">
-            <a:schemeClr val="accent1"/>
-          </a:effectRef>
-          <a:fontRef idx="minor">
-            <a:schemeClr val="lt1"/>
-          </a:fontRef>
-        </p:style>
-        <p:txBody>
-          <a:bodyPr rtlCol="0" anchor="ctr"/>
-          <a:lstStyle/>
-          <a:p>
-            <a:pPr algn="ctr"/>
-          </a:p>
-        </p:txBody>
-      </p:sp>
-      <p:sp>
-        <p:nvSpPr>
-          <p:cNvPr id="101" name="TextBox 100"/>
-          <p:cNvSpPr txBox="1"/>
-          <p:nvPr/>
-        </p:nvSpPr>
-        <p:spPr>
-          <a:xfrm>
-            <a:off x="3246120" y="4937760"/>
-            <a:ext cx="2743200" cy="329184"/>
-          </a:xfrm>
-          <a:prstGeom prst="rect">
-            <a:avLst/>
-          </a:prstGeom>
-          <a:noFill/>
-        </p:spPr>
-        <p:txBody>
-          <a:bodyPr wrap="square" lIns="36576" rIns="36576" tIns="18288" bIns="18288" anchor="ctr">
-            <a:spAutoFit/>
-          </a:bodyPr>
-          <a:lstStyle/>
-          <a:p>
-            <a:pPr algn="l"/>
-            <a:r>
-              <a:rPr sz="1100" b="1">
-                <a:solidFill>
-                  <a:srgbClr val="138A36"/>
-                </a:solidFill>
-                <a:latin typeface="Calibri"/>
-              </a:rPr>
-              <a:t>✔ No parser code to write or fix</a:t>
-            </a:r>
-          </a:p>
-        </p:txBody>
-      </p:sp>
-      <p:sp>
-        <p:nvSpPr>
-          <p:cNvPr id="102" name="Rounded Rectangle 101"/>
-          <p:cNvSpPr/>
-          <p:nvPr/>
-        </p:nvSpPr>
-        <p:spPr>
-          <a:xfrm>
-            <a:off x="365760" y="5312664"/>
-            <a:ext cx="2514600" cy="329184"/>
-          </a:xfrm>
-          <a:prstGeom prst="roundRect">
-            <a:avLst>
-              <a:gd name="adj" fmla="val 30000"/>
-            </a:avLst>
-          </a:prstGeom>
-          <a:solidFill>
-            <a:srgbClr val="FDECEA"/>
-          </a:solidFill>
-          <a:ln>
-            <a:noFill/>
-          </a:ln>
-          <a:effectLst/>
-        </p:spPr>
-        <p:style>
-          <a:lnRef idx="1">
-            <a:schemeClr val="accent1"/>
-          </a:lnRef>
-          <a:fillRef idx="3">
-            <a:schemeClr val="accent1"/>
-          </a:fillRef>
-          <a:effectRef idx="2">
-            <a:schemeClr val="accent1"/>
-          </a:effectRef>
-          <a:fontRef idx="minor">
-            <a:schemeClr val="lt1"/>
-          </a:fontRef>
-        </p:style>
-        <p:txBody>
-          <a:bodyPr rtlCol="0" anchor="ctr"/>
-          <a:lstStyle/>
-          <a:p>
-            <a:pPr algn="ctr"/>
-          </a:p>
-        </p:txBody>
-      </p:sp>
-      <p:sp>
-        <p:nvSpPr>
-          <p:cNvPr id="103" name="TextBox 102"/>
-          <p:cNvSpPr txBox="1"/>
-          <p:nvPr/>
-        </p:nvSpPr>
-        <p:spPr>
-          <a:xfrm>
-            <a:off x="411480" y="5312664"/>
-            <a:ext cx="2423160" cy="329184"/>
-          </a:xfrm>
-          <a:prstGeom prst="rect">
-            <a:avLst/>
-          </a:prstGeom>
-          <a:noFill/>
-        </p:spPr>
-        <p:txBody>
-          <a:bodyPr wrap="square" lIns="36576" rIns="36576" tIns="18288" bIns="18288" anchor="ctr">
-            <a:spAutoFit/>
-          </a:bodyPr>
-          <a:lstStyle/>
-          <a:p>
-            <a:pPr algn="l"/>
-            <a:r>
-              <a:rPr sz="1100" b="1">
-                <a:solidFill>
-                  <a:srgbClr val="C0392B"/>
-                </a:solidFill>
-                <a:latin typeface="Calibri"/>
-              </a:rPr>
-              <a:t>✖ AI on every log is costly</a:t>
-            </a:r>
-          </a:p>
-        </p:txBody>
-      </p:sp>
-      <p:sp>
-        <p:nvSpPr>
-          <p:cNvPr id="104" name="TextBox 103"/>
-          <p:cNvSpPr txBox="1"/>
-          <p:nvPr/>
-        </p:nvSpPr>
-        <p:spPr>
-          <a:xfrm>
-            <a:off x="2880360" y="5312664"/>
-            <a:ext cx="320040" cy="329184"/>
-          </a:xfrm>
-          <a:prstGeom prst="rect">
-            <a:avLst/>
-          </a:prstGeom>
-          <a:noFill/>
-        </p:spPr>
-        <p:txBody>
-          <a:bodyPr wrap="square" lIns="36576" rIns="36576" tIns="18288" bIns="18288" anchor="ctr">
-            <a:spAutoFit/>
-          </a:bodyPr>
-          <a:lstStyle/>
-          <a:p>
-            <a:pPr algn="ctr"/>
-            <a:r>
-              <a:rPr sz="1400" b="1">
-                <a:solidFill>
-                  <a:srgbClr val="5F6B7A"/>
-                </a:solidFill>
-                <a:latin typeface="Calibri"/>
-              </a:rPr>
-              <a:t>→</a:t>
-            </a:r>
-          </a:p>
-        </p:txBody>
-      </p:sp>
-      <p:sp>
-        <p:nvSpPr>
-          <p:cNvPr id="105" name="Rounded Rectangle 104"/>
-          <p:cNvSpPr/>
-          <p:nvPr/>
-        </p:nvSpPr>
-        <p:spPr>
-          <a:xfrm>
-            <a:off x="3200400" y="5312664"/>
-            <a:ext cx="2834640" cy="329184"/>
-          </a:xfrm>
-          <a:prstGeom prst="roundRect">
-            <a:avLst>
-              <a:gd name="adj" fmla="val 30000"/>
-            </a:avLst>
-          </a:prstGeom>
-          <a:solidFill>
-            <a:srgbClr val="E8F5EC"/>
-          </a:solidFill>
-          <a:ln>
-            <a:noFill/>
-          </a:ln>
-          <a:effectLst/>
-        </p:spPr>
-        <p:style>
-          <a:lnRef idx="1">
-            <a:schemeClr val="accent1"/>
-          </a:lnRef>
-          <a:fillRef idx="3">
-            <a:schemeClr val="accent1"/>
-          </a:fillRef>
-          <a:effectRef idx="2">
-            <a:schemeClr val="accent1"/>
-          </a:effectRef>
-          <a:fontRef idx="minor">
-            <a:schemeClr val="lt1"/>
-          </a:fontRef>
-        </p:style>
-        <p:txBody>
-          <a:bodyPr rtlCol="0" anchor="ctr"/>
-          <a:lstStyle/>
-          <a:p>
-            <a:pPr algn="ctr"/>
-          </a:p>
-        </p:txBody>
-      </p:sp>
-      <p:sp>
-        <p:nvSpPr>
-          <p:cNvPr id="106" name="TextBox 105"/>
-          <p:cNvSpPr txBox="1"/>
-          <p:nvPr/>
-        </p:nvSpPr>
-        <p:spPr>
-          <a:xfrm>
-            <a:off x="3246120" y="5312664"/>
-            <a:ext cx="2743200" cy="329184"/>
-          </a:xfrm>
-          <a:prstGeom prst="rect">
-            <a:avLst/>
-          </a:prstGeom>
-          <a:noFill/>
-        </p:spPr>
-        <p:txBody>
-          <a:bodyPr wrap="square" lIns="36576" rIns="36576" tIns="18288" bIns="18288" anchor="ctr">
-            <a:spAutoFit/>
-          </a:bodyPr>
-          <a:lstStyle/>
-          <a:p>
-            <a:pPr algn="l"/>
-            <a:r>
-              <a:rPr sz="1100" b="1">
-                <a:solidFill>
-                  <a:srgbClr val="138A36"/>
-                </a:solidFill>
-                <a:latin typeface="Calibri"/>
-              </a:rPr>
-              <a:t>✔ AI once per format, not per log</a:t>
-            </a:r>
-          </a:p>
-        </p:txBody>
-      </p:sp>
-      <p:sp>
-        <p:nvSpPr>
-          <p:cNvPr id="107" name="Rounded Rectangle 106"/>
-          <p:cNvSpPr/>
-          <p:nvPr/>
-        </p:nvSpPr>
-        <p:spPr>
-          <a:xfrm>
-            <a:off x="365760" y="5687568"/>
-            <a:ext cx="2514600" cy="329184"/>
-          </a:xfrm>
-          <a:prstGeom prst="roundRect">
-            <a:avLst>
-              <a:gd name="adj" fmla="val 30000"/>
-            </a:avLst>
-          </a:prstGeom>
-          <a:solidFill>
-            <a:srgbClr val="FDECEA"/>
-          </a:solidFill>
-          <a:ln>
-            <a:noFill/>
-          </a:ln>
-          <a:effectLst/>
-        </p:spPr>
-        <p:style>
-          <a:lnRef idx="1">
-            <a:schemeClr val="accent1"/>
-          </a:lnRef>
-          <a:fillRef idx="3">
-            <a:schemeClr val="accent1"/>
-          </a:fillRef>
-          <a:effectRef idx="2">
-            <a:schemeClr val="accent1"/>
-          </a:effectRef>
-          <a:fontRef idx="minor">
-            <a:schemeClr val="lt1"/>
-          </a:fontRef>
-        </p:style>
-        <p:txBody>
-          <a:bodyPr rtlCol="0" anchor="ctr"/>
-          <a:lstStyle/>
-          <a:p>
-            <a:pPr algn="ctr"/>
-          </a:p>
-        </p:txBody>
-      </p:sp>
-      <p:sp>
-        <p:nvSpPr>
-          <p:cNvPr id="108" name="TextBox 107"/>
-          <p:cNvSpPr txBox="1"/>
-          <p:nvPr/>
-        </p:nvSpPr>
-        <p:spPr>
-          <a:xfrm>
-            <a:off x="411480" y="5687568"/>
-            <a:ext cx="2423160" cy="329184"/>
-          </a:xfrm>
-          <a:prstGeom prst="rect">
-            <a:avLst/>
-          </a:prstGeom>
-          <a:noFill/>
-        </p:spPr>
-        <p:txBody>
-          <a:bodyPr wrap="square" lIns="36576" rIns="36576" tIns="18288" bIns="18288" anchor="ctr">
-            <a:spAutoFit/>
-          </a:bodyPr>
-          <a:lstStyle/>
-          <a:p>
-            <a:pPr algn="l"/>
-            <a:r>
-              <a:rPr sz="1100" b="1">
-                <a:solidFill>
-                  <a:srgbClr val="C0392B"/>
-                </a:solidFill>
-                <a:latin typeface="Calibri"/>
-              </a:rPr>
-              <a:t>✖ Logs are hard to search</a:t>
-            </a:r>
-          </a:p>
-        </p:txBody>
-      </p:sp>
-      <p:sp>
-        <p:nvSpPr>
-          <p:cNvPr id="109" name="TextBox 108"/>
-          <p:cNvSpPr txBox="1"/>
-          <p:nvPr/>
-        </p:nvSpPr>
-        <p:spPr>
-          <a:xfrm>
-            <a:off x="2880360" y="5687568"/>
-            <a:ext cx="320040" cy="329184"/>
-          </a:xfrm>
-          <a:prstGeom prst="rect">
-            <a:avLst/>
-          </a:prstGeom>
-          <a:noFill/>
-        </p:spPr>
-        <p:txBody>
-          <a:bodyPr wrap="square" lIns="36576" rIns="36576" tIns="18288" bIns="18288" anchor="ctr">
-            <a:spAutoFit/>
-          </a:bodyPr>
-          <a:lstStyle/>
-          <a:p>
-            <a:pPr algn="ctr"/>
-            <a:r>
-              <a:rPr sz="1400" b="1">
-                <a:solidFill>
-                  <a:srgbClr val="5F6B7A"/>
-                </a:solidFill>
-                <a:latin typeface="Calibri"/>
-              </a:rPr>
-              <a:t>→</a:t>
-            </a:r>
-          </a:p>
-        </p:txBody>
-      </p:sp>
-      <p:sp>
-        <p:nvSpPr>
-          <p:cNvPr id="110" name="Rounded Rectangle 109"/>
-          <p:cNvSpPr/>
-          <p:nvPr/>
-        </p:nvSpPr>
-        <p:spPr>
-          <a:xfrm>
-            <a:off x="3200400" y="5687568"/>
-            <a:ext cx="2834640" cy="329184"/>
-          </a:xfrm>
-          <a:prstGeom prst="roundRect">
-            <a:avLst>
-              <a:gd name="adj" fmla="val 30000"/>
-            </a:avLst>
-          </a:prstGeom>
-          <a:solidFill>
-            <a:srgbClr val="E8F5EC"/>
-          </a:solidFill>
-          <a:ln>
-            <a:noFill/>
-          </a:ln>
-          <a:effectLst/>
-        </p:spPr>
-        <p:style>
-          <a:lnRef idx="1">
-            <a:schemeClr val="accent1"/>
-          </a:lnRef>
-          <a:fillRef idx="3">
-            <a:schemeClr val="accent1"/>
-          </a:fillRef>
-          <a:effectRef idx="2">
-            <a:schemeClr val="accent1"/>
-          </a:effectRef>
-          <a:fontRef idx="minor">
-            <a:schemeClr val="lt1"/>
-          </a:fontRef>
-        </p:style>
-        <p:txBody>
-          <a:bodyPr rtlCol="0" anchor="ctr"/>
-          <a:lstStyle/>
-          <a:p>
-            <a:pPr algn="ctr"/>
-          </a:p>
-        </p:txBody>
-      </p:sp>
-      <p:sp>
-        <p:nvSpPr>
-          <p:cNvPr id="111" name="TextBox 110"/>
-          <p:cNvSpPr txBox="1"/>
-          <p:nvPr/>
-        </p:nvSpPr>
-        <p:spPr>
-          <a:xfrm>
-            <a:off x="3246120" y="5687568"/>
-            <a:ext cx="2743200" cy="329184"/>
-          </a:xfrm>
-          <a:prstGeom prst="rect">
-            <a:avLst/>
-          </a:prstGeom>
-          <a:noFill/>
-        </p:spPr>
-        <p:txBody>
-          <a:bodyPr wrap="square" lIns="36576" rIns="36576" tIns="18288" bIns="18288" anchor="ctr">
-            <a:spAutoFit/>
-          </a:bodyPr>
-          <a:lstStyle/>
-          <a:p>
-            <a:pPr algn="l"/>
-            <a:r>
-              <a:rPr sz="1100" b="1">
-                <a:solidFill>
-                  <a:srgbClr val="138A36"/>
-                </a:solidFill>
-                <a:latin typeface="Calibri"/>
-              </a:rPr>
-              <a:t>✔ One clean, time-aligned format</a:t>
-            </a:r>
-          </a:p>
-        </p:txBody>
-      </p:sp>
-      <p:sp>
-        <p:nvSpPr>
-          <p:cNvPr id="112" name="TextBox 111"/>
-          <p:cNvSpPr txBox="1"/>
-          <p:nvPr/>
-        </p:nvSpPr>
-        <p:spPr>
-          <a:xfrm>
-            <a:off x="6263640" y="4160520"/>
-            <a:ext cx="5577840" cy="292608"/>
-          </a:xfrm>
-          <a:prstGeom prst="rect">
-            <a:avLst/>
-          </a:prstGeom>
-          <a:noFill/>
-        </p:spPr>
-        <p:txBody>
-          <a:bodyPr wrap="square" lIns="36576" rIns="36576" tIns="18288" bIns="18288" anchor="t">
-            <a:spAutoFit/>
-          </a:bodyPr>
-          <a:lstStyle/>
-          <a:p>
-            <a:pPr algn="l"/>
-            <a:r>
-              <a:rPr sz="1450" b="1">
-                <a:solidFill>
-                  <a:srgbClr val="0B2A5B"/>
-                </a:solidFill>
-                <a:latin typeface="Calibri"/>
-              </a:rPr>
-              <a:t>Innovation &amp; uniqueness</a:t>
-            </a:r>
-          </a:p>
-        </p:txBody>
-      </p:sp>
-      <p:sp>
-        <p:nvSpPr>
-          <p:cNvPr id="113" name="Rectangle 112"/>
-          <p:cNvSpPr/>
-          <p:nvPr/>
-        </p:nvSpPr>
-        <p:spPr>
-          <a:xfrm>
-            <a:off x="6300216" y="4462272"/>
-            <a:ext cx="822960" cy="41148"/>
-          </a:xfrm>
-          <a:prstGeom prst="rect">
-            <a:avLst/>
-          </a:prstGeom>
-          <a:solidFill>
-            <a:srgbClr val="F58220"/>
-          </a:solidFill>
-          <a:ln>
-            <a:noFill/>
-          </a:ln>
-          <a:effectLst/>
-        </p:spPr>
-        <p:style>
-          <a:lnRef idx="1">
-            <a:schemeClr val="accent1"/>
-          </a:lnRef>
-          <a:fillRef idx="3">
-            <a:schemeClr val="accent1"/>
-          </a:fillRef>
-          <a:effectRef idx="2">
-            <a:schemeClr val="accent1"/>
-          </a:effectRef>
-          <a:fontRef idx="minor">
-            <a:schemeClr val="lt1"/>
-          </a:fontRef>
-        </p:style>
-        <p:txBody>
-          <a:bodyPr rtlCol="0" anchor="ctr"/>
-          <a:lstStyle/>
-          <a:p>
-            <a:pPr algn="ctr"/>
-          </a:p>
-        </p:txBody>
-      </p:sp>
-      <p:sp>
-        <p:nvSpPr>
-          <p:cNvPr id="114" name="Rounded Rectangle 113"/>
-          <p:cNvSpPr/>
-          <p:nvPr/>
-        </p:nvSpPr>
-        <p:spPr>
-          <a:xfrm>
-            <a:off x="6263640" y="4562856"/>
-            <a:ext cx="2734056" cy="676656"/>
-          </a:xfrm>
-          <a:prstGeom prst="roundRect">
-            <a:avLst>
-              <a:gd name="adj" fmla="val 12000"/>
-            </a:avLst>
-          </a:prstGeom>
-          <a:solidFill>
-            <a:srgbClr val="E8F0FB"/>
-          </a:solidFill>
-          <a:ln>
-            <a:noFill/>
-          </a:ln>
-          <a:effectLst/>
-        </p:spPr>
-        <p:style>
-          <a:lnRef idx="1">
-            <a:schemeClr val="accent1"/>
-          </a:lnRef>
-          <a:fillRef idx="3">
-            <a:schemeClr val="accent1"/>
-          </a:fillRef>
-          <a:effectRef idx="2">
-            <a:schemeClr val="accent1"/>
-          </a:effectRef>
-          <a:fontRef idx="minor">
-            <a:schemeClr val="lt1"/>
-          </a:fontRef>
-        </p:style>
-        <p:txBody>
-          <a:bodyPr rtlCol="0" anchor="ctr"/>
-          <a:lstStyle/>
-          <a:p>
-            <a:pPr algn="ctr"/>
-          </a:p>
-        </p:txBody>
-      </p:sp>
-      <p:sp>
-        <p:nvSpPr>
-          <p:cNvPr id="115" name="Rectangle 114"/>
-          <p:cNvSpPr/>
-          <p:nvPr/>
-        </p:nvSpPr>
-        <p:spPr>
-          <a:xfrm>
-            <a:off x="6263640" y="4654296"/>
-            <a:ext cx="64008" cy="493776"/>
-          </a:xfrm>
-          <a:prstGeom prst="rect">
-            <a:avLst/>
-          </a:prstGeom>
-          <a:solidFill>
-            <a:srgbClr val="1F5FBF"/>
-          </a:solidFill>
-          <a:ln>
-            <a:noFill/>
-          </a:ln>
-          <a:effectLst/>
-        </p:spPr>
-        <p:style>
-          <a:lnRef idx="1">
-            <a:schemeClr val="accent1"/>
-          </a:lnRef>
-          <a:fillRef idx="3">
-            <a:schemeClr val="accent1"/>
-          </a:fillRef>
-          <a:effectRef idx="2">
-            <a:schemeClr val="accent1"/>
-          </a:effectRef>
-          <a:fontRef idx="minor">
-            <a:schemeClr val="lt1"/>
-          </a:fontRef>
-        </p:style>
-        <p:txBody>
-          <a:bodyPr rtlCol="0" anchor="ctr"/>
-          <a:lstStyle/>
-          <a:p>
-            <a:pPr algn="ctr"/>
-          </a:p>
-        </p:txBody>
-      </p:sp>
-      <p:sp>
-        <p:nvSpPr>
-          <p:cNvPr id="116" name="TextBox 115"/>
-          <p:cNvSpPr txBox="1"/>
-          <p:nvPr/>
-        </p:nvSpPr>
-        <p:spPr>
-          <a:xfrm>
-            <a:off x="6428232" y="4599432"/>
-            <a:ext cx="2505456" cy="603504"/>
-          </a:xfrm>
-          <a:prstGeom prst="rect">
-            <a:avLst/>
-          </a:prstGeom>
-          <a:noFill/>
-        </p:spPr>
-        <p:txBody>
-          <a:bodyPr wrap="square" lIns="36576" rIns="36576" tIns="18288" bIns="18288" anchor="ctr">
-            <a:spAutoFit/>
-          </a:bodyPr>
-          <a:lstStyle/>
-          <a:p>
-            <a:pPr algn="l"/>
-            <a:r>
-              <a:rPr sz="1300" b="1">
-                <a:solidFill>
-                  <a:srgbClr val="1F5FBF"/>
-                </a:solidFill>
-                <a:latin typeface="Calibri"/>
-              </a:rPr>
-              <a:t>Learns by itself</a:t>
-            </a:r>
-          </a:p>
-          <a:p>
-            <a:pPr algn="l"/>
-            <a:r>
-              <a:rPr sz="1100" b="0">
-                <a:solidFill>
-                  <a:srgbClr val="1E2530"/>
-                </a:solidFill>
-                <a:latin typeface="Calibri"/>
-              </a:rPr>
-              <a:t>no hand-written rules</a:t>
-            </a:r>
-          </a:p>
-        </p:txBody>
-      </p:sp>
-      <p:sp>
-        <p:nvSpPr>
-          <p:cNvPr id="117" name="Rounded Rectangle 116"/>
-          <p:cNvSpPr/>
-          <p:nvPr/>
-        </p:nvSpPr>
-        <p:spPr>
-          <a:xfrm>
-            <a:off x="9089136" y="4562856"/>
-            <a:ext cx="2734056" cy="676656"/>
-          </a:xfrm>
-          <a:prstGeom prst="roundRect">
-            <a:avLst>
-              <a:gd name="adj" fmla="val 12000"/>
-            </a:avLst>
-          </a:prstGeom>
-          <a:solidFill>
-            <a:srgbClr val="FFF4E0"/>
-          </a:solidFill>
-          <a:ln>
-            <a:noFill/>
-          </a:ln>
-          <a:effectLst/>
-        </p:spPr>
-        <p:style>
-          <a:lnRef idx="1">
-            <a:schemeClr val="accent1"/>
-          </a:lnRef>
-          <a:fillRef idx="3">
-            <a:schemeClr val="accent1"/>
-          </a:fillRef>
-          <a:effectRef idx="2">
-            <a:schemeClr val="accent1"/>
-          </a:effectRef>
-          <a:fontRef idx="minor">
-            <a:schemeClr val="lt1"/>
-          </a:fontRef>
-        </p:style>
-        <p:txBody>
-          <a:bodyPr rtlCol="0" anchor="ctr"/>
-          <a:lstStyle/>
-          <a:p>
-            <a:pPr algn="ctr"/>
-          </a:p>
-        </p:txBody>
-      </p:sp>
-      <p:sp>
-        <p:nvSpPr>
-          <p:cNvPr id="118" name="Rectangle 117"/>
-          <p:cNvSpPr/>
-          <p:nvPr/>
-        </p:nvSpPr>
-        <p:spPr>
-          <a:xfrm>
-            <a:off x="9089136" y="4654296"/>
-            <a:ext cx="64008" cy="493776"/>
-          </a:xfrm>
-          <a:prstGeom prst="rect">
-            <a:avLst/>
-          </a:prstGeom>
-          <a:solidFill>
-            <a:srgbClr val="F58220"/>
-          </a:solidFill>
-          <a:ln>
-            <a:noFill/>
-          </a:ln>
-          <a:effectLst/>
-        </p:spPr>
-        <p:style>
-          <a:lnRef idx="1">
-            <a:schemeClr val="accent1"/>
-          </a:lnRef>
-          <a:fillRef idx="3">
-            <a:schemeClr val="accent1"/>
-          </a:fillRef>
-          <a:effectRef idx="2">
-            <a:schemeClr val="accent1"/>
-          </a:effectRef>
-          <a:fontRef idx="minor">
-            <a:schemeClr val="lt1"/>
-          </a:fontRef>
-        </p:style>
-        <p:txBody>
-          <a:bodyPr rtlCol="0" anchor="ctr"/>
-          <a:lstStyle/>
-          <a:p>
-            <a:pPr algn="ctr"/>
-          </a:p>
-        </p:txBody>
-      </p:sp>
-      <p:sp>
-        <p:nvSpPr>
-          <p:cNvPr id="119" name="TextBox 118"/>
-          <p:cNvSpPr txBox="1"/>
-          <p:nvPr/>
-        </p:nvSpPr>
-        <p:spPr>
-          <a:xfrm>
-            <a:off x="9253728" y="4599432"/>
-            <a:ext cx="2505456" cy="603504"/>
-          </a:xfrm>
-          <a:prstGeom prst="rect">
-            <a:avLst/>
-          </a:prstGeom>
-          <a:noFill/>
-        </p:spPr>
-        <p:txBody>
-          <a:bodyPr wrap="square" lIns="36576" rIns="36576" tIns="18288" bIns="18288" anchor="ctr">
-            <a:spAutoFit/>
-          </a:bodyPr>
-          <a:lstStyle/>
-          <a:p>
-            <a:pPr algn="l"/>
-            <a:r>
-              <a:rPr sz="1300" b="1">
-                <a:solidFill>
-                  <a:srgbClr val="F58220"/>
-                </a:solidFill>
-                <a:latin typeface="Calibri"/>
-              </a:rPr>
-              <a:t>AI only when needed</a:t>
-            </a:r>
-          </a:p>
-          <a:p>
-            <a:pPr algn="l"/>
-            <a:r>
-              <a:rPr sz="1100" b="0">
-                <a:solidFill>
-                  <a:srgbClr val="1E2530"/>
-                </a:solidFill>
-                <a:latin typeface="Calibri"/>
-              </a:rPr>
-              <a:t>keeps cost low</a:t>
-            </a:r>
-          </a:p>
-        </p:txBody>
-      </p:sp>
-      <p:sp>
-        <p:nvSpPr>
-          <p:cNvPr id="120" name="Rounded Rectangle 119"/>
-          <p:cNvSpPr/>
-          <p:nvPr/>
-        </p:nvSpPr>
-        <p:spPr>
-          <a:xfrm>
-            <a:off x="6263640" y="5303520"/>
-            <a:ext cx="2734056" cy="676656"/>
-          </a:xfrm>
-          <a:prstGeom prst="roundRect">
-            <a:avLst>
-              <a:gd name="adj" fmla="val 12000"/>
-            </a:avLst>
-          </a:prstGeom>
-          <a:solidFill>
-            <a:srgbClr val="F1ECFA"/>
-          </a:solidFill>
-          <a:ln>
-            <a:noFill/>
-          </a:ln>
-          <a:effectLst/>
-        </p:spPr>
-        <p:style>
-          <a:lnRef idx="1">
-            <a:schemeClr val="accent1"/>
-          </a:lnRef>
-          <a:fillRef idx="3">
-            <a:schemeClr val="accent1"/>
-          </a:fillRef>
-          <a:effectRef idx="2">
-            <a:schemeClr val="accent1"/>
-          </a:effectRef>
-          <a:fontRef idx="minor">
-            <a:schemeClr val="lt1"/>
-          </a:fontRef>
-        </p:style>
-        <p:txBody>
-          <a:bodyPr rtlCol="0" anchor="ctr"/>
-          <a:lstStyle/>
-          <a:p>
-            <a:pPr algn="ctr"/>
-          </a:p>
-        </p:txBody>
-      </p:sp>
-      <p:sp>
-        <p:nvSpPr>
-          <p:cNvPr id="121" name="Rectangle 120"/>
-          <p:cNvSpPr/>
-          <p:nvPr/>
-        </p:nvSpPr>
-        <p:spPr>
-          <a:xfrm>
-            <a:off x="6263640" y="5394960"/>
-            <a:ext cx="64008" cy="493776"/>
-          </a:xfrm>
-          <a:prstGeom prst="rect">
-            <a:avLst/>
-          </a:prstGeom>
-          <a:solidFill>
-            <a:srgbClr val="6A3FB5"/>
-          </a:solidFill>
-          <a:ln>
-            <a:noFill/>
-          </a:ln>
-          <a:effectLst/>
-        </p:spPr>
-        <p:style>
-          <a:lnRef idx="1">
-            <a:schemeClr val="accent1"/>
-          </a:lnRef>
-          <a:fillRef idx="3">
-            <a:schemeClr val="accent1"/>
-          </a:fillRef>
-          <a:effectRef idx="2">
-            <a:schemeClr val="accent1"/>
-          </a:effectRef>
-          <a:fontRef idx="minor">
-            <a:schemeClr val="lt1"/>
-          </a:fontRef>
-        </p:style>
-        <p:txBody>
-          <a:bodyPr rtlCol="0" anchor="ctr"/>
-          <a:lstStyle/>
-          <a:p>
-            <a:pPr algn="ctr"/>
-          </a:p>
-        </p:txBody>
-      </p:sp>
-      <p:sp>
-        <p:nvSpPr>
-          <p:cNvPr id="122" name="TextBox 121"/>
-          <p:cNvSpPr txBox="1"/>
-          <p:nvPr/>
-        </p:nvSpPr>
-        <p:spPr>
-          <a:xfrm>
-            <a:off x="6428232" y="5340096"/>
-            <a:ext cx="2505456" cy="603504"/>
-          </a:xfrm>
-          <a:prstGeom prst="rect">
-            <a:avLst/>
-          </a:prstGeom>
-          <a:noFill/>
-        </p:spPr>
-        <p:txBody>
-          <a:bodyPr wrap="square" lIns="36576" rIns="36576" tIns="18288" bIns="18288" anchor="ctr">
-            <a:spAutoFit/>
-          </a:bodyPr>
-          <a:lstStyle/>
-          <a:p>
-            <a:pPr algn="l"/>
-            <a:r>
-              <a:rPr sz="1300" b="1">
-                <a:solidFill>
-                  <a:srgbClr val="6A3FB5"/>
-                </a:solidFill>
-                <a:latin typeface="Calibri"/>
-              </a:rPr>
-              <a:t>Flags unknown formats</a:t>
-            </a:r>
-          </a:p>
-          <a:p>
-            <a:pPr algn="l"/>
-            <a:r>
-              <a:rPr sz="1100" b="0">
-                <a:solidFill>
-                  <a:srgbClr val="1E2530"/>
-                </a:solidFill>
-                <a:latin typeface="Calibri"/>
-              </a:rPr>
-              <a:t>for human review</a:t>
-            </a:r>
-          </a:p>
-        </p:txBody>
-      </p:sp>
-      <p:sp>
-        <p:nvSpPr>
-          <p:cNvPr id="123" name="Rounded Rectangle 122"/>
-          <p:cNvSpPr/>
-          <p:nvPr/>
-        </p:nvSpPr>
-        <p:spPr>
-          <a:xfrm>
-            <a:off x="9089136" y="5303520"/>
-            <a:ext cx="2734056" cy="676656"/>
-          </a:xfrm>
-          <a:prstGeom prst="roundRect">
-            <a:avLst>
-              <a:gd name="adj" fmla="val 12000"/>
-            </a:avLst>
-          </a:prstGeom>
-          <a:solidFill>
-            <a:srgbClr val="E8F5EC"/>
-          </a:solidFill>
-          <a:ln>
-            <a:noFill/>
-          </a:ln>
-          <a:effectLst/>
-        </p:spPr>
-        <p:style>
-          <a:lnRef idx="1">
-            <a:schemeClr val="accent1"/>
-          </a:lnRef>
-          <a:fillRef idx="3">
-            <a:schemeClr val="accent1"/>
-          </a:fillRef>
-          <a:effectRef idx="2">
-            <a:schemeClr val="accent1"/>
-          </a:effectRef>
-          <a:fontRef idx="minor">
-            <a:schemeClr val="lt1"/>
-          </a:fontRef>
-        </p:style>
-        <p:txBody>
-          <a:bodyPr rtlCol="0" anchor="ctr"/>
-          <a:lstStyle/>
-          <a:p>
-            <a:pPr algn="ctr"/>
-          </a:p>
-        </p:txBody>
-      </p:sp>
-      <p:sp>
-        <p:nvSpPr>
-          <p:cNvPr id="124" name="Rectangle 123"/>
-          <p:cNvSpPr/>
-          <p:nvPr/>
-        </p:nvSpPr>
-        <p:spPr>
-          <a:xfrm>
-            <a:off x="9089136" y="5394960"/>
-            <a:ext cx="64008" cy="493776"/>
-          </a:xfrm>
-          <a:prstGeom prst="rect">
-            <a:avLst/>
-          </a:prstGeom>
-          <a:solidFill>
-            <a:srgbClr val="138A36"/>
-          </a:solidFill>
-          <a:ln>
-            <a:noFill/>
-          </a:ln>
-          <a:effectLst/>
-        </p:spPr>
-        <p:style>
-          <a:lnRef idx="1">
-            <a:schemeClr val="accent1"/>
-          </a:lnRef>
-          <a:fillRef idx="3">
-            <a:schemeClr val="accent1"/>
-          </a:fillRef>
-          <a:effectRef idx="2">
-            <a:schemeClr val="accent1"/>
-          </a:effectRef>
-          <a:fontRef idx="minor">
-            <a:schemeClr val="lt1"/>
-          </a:fontRef>
-        </p:style>
-        <p:txBody>
-          <a:bodyPr rtlCol="0" anchor="ctr"/>
-          <a:lstStyle/>
-          <a:p>
-            <a:pPr algn="ctr"/>
-          </a:p>
-        </p:txBody>
-      </p:sp>
-      <p:sp>
-        <p:nvSpPr>
-          <p:cNvPr id="125" name="TextBox 124"/>
-          <p:cNvSpPr txBox="1"/>
-          <p:nvPr/>
-        </p:nvSpPr>
-        <p:spPr>
-          <a:xfrm>
-            <a:off x="9253728" y="5340096"/>
-            <a:ext cx="2505456" cy="603504"/>
-          </a:xfrm>
-          <a:prstGeom prst="rect">
-            <a:avLst/>
-          </a:prstGeom>
-          <a:noFill/>
-        </p:spPr>
-        <p:txBody>
-          <a:bodyPr wrap="square" lIns="36576" rIns="36576" tIns="18288" bIns="18288" anchor="ctr">
-            <a:spAutoFit/>
-          </a:bodyPr>
-          <a:lstStyle/>
-          <a:p>
-            <a:pPr algn="l"/>
-            <a:r>
-              <a:rPr sz="1300" b="1">
+              <a:rPr sz="1250" b="1">
                 <a:solidFill>
                   <a:srgbClr val="138A36"/>
                 </a:solidFill>

</xml_diff>

<commit_message>
PPT: plain-word flowchart, before/after log example, JSON output note, privacy fix, roadmap, humble slide 5 wording
Co-authored-by: arena-agent <297053741+arena-agent@users.noreply.github.com>
</commit_message>
<xml_diff>
--- a/presentation/SIH2026_Idea_Submission.pptx
+++ b/presentation/SIH2026_Idea_Submission.pptx
@@ -7345,7 +7345,7 @@
                 </a:solidFill>
                 <a:latin typeface="Calibri"/>
               </a:rPr>
-              <a:t>Any log format in, one clean common schema out: learned once by AI, then parsed at regex speed</a:t>
+              <a:t>Any log format in, one clean common format out: AI learns each new format once, then saved rules do the rest.</a:t>
             </a:r>
           </a:p>
         </p:txBody>
@@ -8523,7 +8523,7 @@
                 </a:solidFill>
                 <a:latin typeface="Calibri"/>
               </a:rPr>
-              <a:t>every log leaves in one format: time (UTC), source, event, severity and message.</a:t>
+              <a:t>every log leaves as plain JSON in one format (time, source, event, severity, message), ready for existing search &amp; monitoring tools.</a:t>
             </a:r>
           </a:p>
           <a:p>
@@ -9684,201 +9684,6 @@
       </p:sp>
       <p:sp>
         <p:nvSpPr>
-          <p:cNvPr id="13" name="TextBox 12"/>
-          <p:cNvSpPr txBox="1"/>
-          <p:nvPr/>
-        </p:nvSpPr>
-        <p:spPr>
-          <a:xfrm>
-            <a:off x="365760" y="4087368"/>
-            <a:ext cx="4937760" cy="292608"/>
-          </a:xfrm>
-          <a:prstGeom prst="rect">
-            <a:avLst/>
-          </a:prstGeom>
-          <a:noFill/>
-        </p:spPr>
-        <p:txBody>
-          <a:bodyPr wrap="square" anchor="t" lIns="36576" rIns="36576" tIns="18288" bIns="18288">
-            <a:spAutoFit/>
-          </a:bodyPr>
-          <a:lstStyle/>
-          <a:p>
-            <a:pPr algn="l">
-              <a:lnSpc>
-                <a:spcPct val="100000"/>
-              </a:lnSpc>
-              <a:spcAft>
-                <a:spcPts val="0"/>
-              </a:spcAft>
-            </a:pPr>
-            <a:r>
-              <a:rPr sz="1350" b="1" i="0">
-                <a:solidFill>
-                  <a:srgbClr val="1F5FBF"/>
-                </a:solidFill>
-                <a:latin typeface="Calibri"/>
-              </a:rPr>
-              <a:t>Methodology</a:t>
-            </a:r>
-          </a:p>
-        </p:txBody>
-      </p:sp>
-      <p:sp>
-        <p:nvSpPr>
-          <p:cNvPr id="14" name="Rectangle 13"/>
-          <p:cNvSpPr/>
-          <p:nvPr/>
-        </p:nvSpPr>
-        <p:spPr>
-          <a:xfrm>
-            <a:off x="402336" y="4389120"/>
-            <a:ext cx="822960" cy="32004"/>
-          </a:xfrm>
-          <a:prstGeom prst="rect">
-            <a:avLst/>
-          </a:prstGeom>
-          <a:solidFill>
-            <a:srgbClr val="F58220"/>
-          </a:solidFill>
-          <a:ln>
-            <a:noFill/>
-          </a:ln>
-          <a:effectLst/>
-        </p:spPr>
-        <p:style>
-          <a:lnRef idx="1">
-            <a:schemeClr val="accent1"/>
-          </a:lnRef>
-          <a:fillRef idx="3">
-            <a:schemeClr val="accent1"/>
-          </a:fillRef>
-          <a:effectRef idx="2">
-            <a:schemeClr val="accent1"/>
-          </a:effectRef>
-          <a:fontRef idx="minor">
-            <a:schemeClr val="lt1"/>
-          </a:fontRef>
-        </p:style>
-        <p:txBody>
-          <a:bodyPr rtlCol="0" anchor="ctr"/>
-          <a:lstStyle/>
-          <a:p>
-            <a:pPr algn="ctr"/>
-          </a:p>
-        </p:txBody>
-      </p:sp>
-      <p:sp>
-        <p:nvSpPr>
-          <p:cNvPr id="16" name="Rounded Rectangle 15"/>
-          <p:cNvSpPr/>
-          <p:nvPr/>
-        </p:nvSpPr>
-        <p:spPr>
-          <a:xfrm>
-            <a:off x="365760" y="5833872"/>
-            <a:ext cx="4937760" cy="502920"/>
-          </a:xfrm>
-          <a:prstGeom prst="roundRect">
-            <a:avLst>
-              <a:gd name="adj" fmla="val 15000"/>
-            </a:avLst>
-          </a:prstGeom>
-          <a:solidFill>
-            <a:srgbClr val="E8F5EC"/>
-          </a:solidFill>
-          <a:ln w="12700">
-            <a:solidFill>
-              <a:srgbClr val="138A36"/>
-            </a:solidFill>
-          </a:ln>
-          <a:effectLst/>
-        </p:spPr>
-        <p:style>
-          <a:lnRef idx="1">
-            <a:schemeClr val="accent1"/>
-          </a:lnRef>
-          <a:fillRef idx="3">
-            <a:schemeClr val="accent1"/>
-          </a:fillRef>
-          <a:effectRef idx="2">
-            <a:schemeClr val="accent1"/>
-          </a:effectRef>
-          <a:fontRef idx="minor">
-            <a:schemeClr val="lt1"/>
-          </a:fontRef>
-        </p:style>
-        <p:txBody>
-          <a:bodyPr rtlCol="0" anchor="ctr"/>
-          <a:lstStyle/>
-          <a:p>
-            <a:pPr algn="ctr"/>
-          </a:p>
-        </p:txBody>
-      </p:sp>
-      <p:sp>
-        <p:nvSpPr>
-          <p:cNvPr id="17" name="TextBox 16"/>
-          <p:cNvSpPr txBox="1"/>
-          <p:nvPr/>
-        </p:nvSpPr>
-        <p:spPr>
-          <a:xfrm>
-            <a:off x="457200" y="5833872"/>
-            <a:ext cx="4754880" cy="502920"/>
-          </a:xfrm>
-          <a:prstGeom prst="rect">
-            <a:avLst/>
-          </a:prstGeom>
-          <a:noFill/>
-        </p:spPr>
-        <p:txBody>
-          <a:bodyPr wrap="square" anchor="ctr" lIns="36576" rIns="36576" tIns="18288" bIns="18288">
-            <a:spAutoFit/>
-          </a:bodyPr>
-          <a:lstStyle/>
-          <a:p>
-            <a:pPr algn="l">
-              <a:lnSpc>
-                <a:spcPct val="100000"/>
-              </a:lnSpc>
-              <a:spcAft>
-                <a:spcPts val="0"/>
-              </a:spcAft>
-            </a:pPr>
-            <a:r>
-              <a:rPr sz="1050" b="1" i="0">
-                <a:solidFill>
-                  <a:srgbClr val="138A36"/>
-                </a:solidFill>
-                <a:latin typeface="Calibri"/>
-              </a:rPr>
-              <a:t>Prototype: </a:t>
-            </a:r>
-            <a:r>
-              <a:rPr sz="1050" b="0" i="0">
-                <a:solidFill>
-                  <a:srgbClr val="1E2530"/>
-                </a:solidFill>
-                <a:latin typeface="Calibri"/>
-              </a:rPr>
-              <a:t>view it at </a:t>
-            </a:r>
-            <a:r>
-              <a:rPr sz="1050" b="1" i="0">
-                <a:solidFill>
-                  <a:srgbClr val="1F5FBF"/>
-                </a:solidFill>
-                <a:latin typeface="Calibri"/>
-                <a:hlinkClick r:id="rId2"/>
-              </a:rPr>
-              <a:t>sih2026-w6sr.vercel.app</a:t>
-            </a:r>
-          </a:p>
-        </p:txBody>
-      </p:sp>
-      <p:sp>
-        <p:nvSpPr>
           <p:cNvPr id="18" name="Rounded Rectangle 17"/>
           <p:cNvSpPr/>
           <p:nvPr/>
@@ -9933,8 +9738,8 @@
         </p:nvSpPr>
         <p:spPr>
           <a:xfrm>
-            <a:off x="8732520" y="1143000"/>
-            <a:ext cx="3063240" cy="274320"/>
+            <a:off x="8458200" y="1143000"/>
+            <a:ext cx="3383280" cy="274320"/>
           </a:xfrm>
           <a:prstGeom prst="rect">
             <a:avLst/>
@@ -9962,7 +9767,7 @@
                 </a:solidFill>
                 <a:latin typeface="Calibri"/>
               </a:rPr>
-              <a:t>PIPELINE ARCHITECTURE</a:t>
+              <a:t>METHODOLOGY: HOW A LOG FLOWS</a:t>
             </a:r>
           </a:p>
         </p:txBody>
@@ -10004,7 +9809,7 @@
                 </a:solidFill>
                 <a:latin typeface="Calibri"/>
               </a:rPr>
-              <a:t>Solid path = every line</a:t>
+              <a:t>Most logs take the fast green path</a:t>
             </a:r>
           </a:p>
           <a:p>
@@ -10023,7 +9828,7 @@
                 </a:solidFill>
                 <a:latin typeface="Calibri"/>
               </a:rPr>
-              <a:t>LLM is reached only for new templates</a:t>
+              <a:t>AI is used only for new patterns</a:t>
             </a:r>
           </a:p>
         </p:txBody>
@@ -10082,7 +9887,7 @@
                 </a:solidFill>
                 <a:latin typeface="Calibri"/>
               </a:rPr>
-              <a:t>Log Ingestion / Buffering</a:t>
+              <a:t>Logs come in (web API / Bash script)</a:t>
             </a:r>
           </a:p>
         </p:txBody>
@@ -10141,7 +9946,7 @@
                 </a:solidFill>
                 <a:latin typeface="Calibri"/>
               </a:rPr>
-              <a:t>Tier 1: Fingerprint Cache</a:t>
+              <a:t>Seen this line shape before?</a:t>
             </a:r>
           </a:p>
           <a:p>
@@ -10157,7 +9962,7 @@
                 </a:solidFill>
                 <a:latin typeface="Calibri"/>
               </a:rPr>
-              <a:t>regex fast path</a:t>
+              <a:t>yes: use its saved rule instantly</a:t>
             </a:r>
           </a:p>
         </p:txBody>
@@ -10216,7 +10021,7 @@
                 </a:solidFill>
                 <a:latin typeface="Calibri"/>
               </a:rPr>
-              <a:t>Tier 2a: Drain3 Template Mining</a:t>
+              <a:t>Group similar lines (Drain3)</a:t>
             </a:r>
           </a:p>
           <a:p>
@@ -10232,7 +10037,7 @@
                 </a:solidFill>
                 <a:latin typeface="Calibri"/>
               </a:rPr>
-              <a:t>groups similar lines</a:t>
+              <a:t>turns lines into patterns</a:t>
             </a:r>
           </a:p>
         </p:txBody>
@@ -10291,7 +10096,7 @@
                 </a:solidFill>
                 <a:latin typeface="Calibri"/>
               </a:rPr>
-              <a:t>Template already has</a:t>
+              <a:t>Does this pattern already</a:t>
             </a:r>
           </a:p>
           <a:p>
@@ -10307,7 +10112,7 @@
                 </a:solidFill>
                 <a:latin typeface="Calibri"/>
               </a:rPr>
-              <a:t>a learned rule?</a:t>
+              <a:t>have a saved rule?</a:t>
             </a:r>
           </a:p>
         </p:txBody>
@@ -10366,7 +10171,7 @@
                 </a:solidFill>
                 <a:latin typeface="Calibri"/>
               </a:rPr>
-              <a:t>scikit-learn FormatGate</a:t>
+              <a:t>ML check (scikit-learn)</a:t>
             </a:r>
           </a:p>
           <a:p>
@@ -10382,7 +10187,7 @@
                 </a:solidFill>
                 <a:latin typeface="Calibri"/>
               </a:rPr>
-              <a:t>known vs novel</a:t>
+              <a:t>known or brand-new format?</a:t>
             </a:r>
           </a:p>
         </p:txBody>
@@ -10441,7 +10246,7 @@
                 </a:solidFill>
                 <a:latin typeface="Calibri"/>
               </a:rPr>
-              <a:t>Tier 3a: LLM</a:t>
+              <a:t>AI learns</a:t>
             </a:r>
           </a:p>
           <a:p>
@@ -10457,7 +10262,7 @@
                 </a:solidFill>
                 <a:latin typeface="Calibri"/>
               </a:rPr>
-              <a:t>Discovery</a:t>
+              <a:t>the format</a:t>
             </a:r>
           </a:p>
           <a:p>
@@ -10473,7 +10278,7 @@
                 </a:solidFill>
                 <a:latin typeface="Calibri"/>
               </a:rPr>
-              <a:t>once per template</a:t>
+              <a:t>once per pattern</a:t>
             </a:r>
           </a:p>
         </p:txBody>
@@ -10532,7 +10337,7 @@
                 </a:solidFill>
                 <a:latin typeface="Calibri"/>
               </a:rPr>
-              <a:t>Tier 3b:</a:t>
+              <a:t>Hold for</a:t>
             </a:r>
           </a:p>
           <a:p>
@@ -10548,7 +10353,7 @@
                 </a:solidFill>
                 <a:latin typeface="Calibri"/>
               </a:rPr>
-              <a:t>Quarantine</a:t>
+              <a:t>review</a:t>
             </a:r>
           </a:p>
           <a:p>
@@ -10564,7 +10369,7 @@
                 </a:solidFill>
                 <a:latin typeface="Calibri"/>
               </a:rPr>
-              <a:t>LLM only on graduation</a:t>
+              <a:t>unusual formats</a:t>
             </a:r>
           </a:p>
         </p:txBody>
@@ -10623,7 +10428,7 @@
                 </a:solidFill>
                 <a:latin typeface="Calibri"/>
               </a:rPr>
-              <a:t>Store Rule</a:t>
+              <a:t>Save the rule</a:t>
             </a:r>
           </a:p>
           <a:p>
@@ -10639,7 +10444,7 @@
                 </a:solidFill>
                 <a:latin typeface="Calibri"/>
               </a:rPr>
-              <a:t>fingerprint + template</a:t>
+              <a:t>reused for next time</a:t>
             </a:r>
           </a:p>
         </p:txBody>
@@ -10698,7 +10503,7 @@
                 </a:solidFill>
                 <a:latin typeface="Calibri"/>
               </a:rPr>
-              <a:t>Tier 2b: Execute Cached Rule</a:t>
+              <a:t>Apply saved rule</a:t>
             </a:r>
           </a:p>
           <a:p>
@@ -10714,7 +10519,7 @@
                 </a:solidFill>
                 <a:latin typeface="Calibri"/>
               </a:rPr>
-              <a:t>zero LLM calls</a:t>
+              <a:t>no AI needed</a:t>
             </a:r>
           </a:p>
         </p:txBody>
@@ -10773,7 +10578,7 @@
                 </a:solidFill>
                 <a:latin typeface="Calibri"/>
               </a:rPr>
-              <a:t>Tier 4: Normalize to Common Schema</a:t>
+              <a:t>Clean, common output (JSON)</a:t>
             </a:r>
           </a:p>
         </p:txBody>
@@ -10887,7 +10692,7 @@
                 </a:solidFill>
                 <a:latin typeface="Calibri"/>
               </a:rPr>
-              <a:t>miss</a:t>
+              <a:t>new</a:t>
             </a:r>
           </a:p>
         </p:txBody>
@@ -11193,7 +10998,7 @@
                 </a:solidFill>
                 <a:latin typeface="Calibri"/>
               </a:rPr>
-              <a:t>known / shadow mode</a:t>
+              <a:t>known</a:t>
             </a:r>
           </a:p>
         </p:txBody>
@@ -11235,7 +11040,7 @@
                 </a:solidFill>
                 <a:latin typeface="Calibri"/>
               </a:rPr>
-              <a:t>novel + enforce</a:t>
+              <a:t>brand-new</a:t>
             </a:r>
           </a:p>
         </p:txBody>
@@ -12894,199 +12699,6 @@
       </p:sp>
       <p:sp>
         <p:nvSpPr>
-          <p:cNvPr id="86" name="TextBox 85"/>
-          <p:cNvSpPr txBox="1"/>
-          <p:nvPr/>
-        </p:nvSpPr>
-        <p:spPr>
-          <a:xfrm>
-            <a:off x="365760" y="4462272"/>
-            <a:ext cx="4937760" cy="1325880"/>
-          </a:xfrm>
-          <a:prstGeom prst="rect">
-            <a:avLst/>
-          </a:prstGeom>
-          <a:noFill/>
-        </p:spPr>
-        <p:txBody>
-          <a:bodyPr wrap="square" anchor="t" lIns="36576" rIns="36576" tIns="18288" bIns="18288">
-            <a:spAutoFit/>
-          </a:bodyPr>
-          <a:lstStyle/>
-          <a:p>
-            <a:pPr algn="l">
-              <a:spcAft>
-                <a:spcPts val="300"/>
-              </a:spcAft>
-            </a:pPr>
-            <a:r>
-              <a:rPr sz="1200" b="0">
-                <a:solidFill>
-                  <a:srgbClr val="F58220"/>
-                </a:solidFill>
-                <a:latin typeface="Calibri"/>
-              </a:rPr>
-              <a:t>① </a:t>
-            </a:r>
-            <a:r>
-              <a:rPr sz="1200" b="1">
-                <a:solidFill>
-                  <a:srgbClr val="0B2A5B"/>
-                </a:solidFill>
-                <a:latin typeface="Calibri"/>
-              </a:rPr>
-              <a:t>Collect: </a:t>
-            </a:r>
-            <a:r>
-              <a:rPr sz="1200" b="0">
-                <a:solidFill>
-                  <a:srgbClr val="1E2530"/>
-                </a:solidFill>
-                <a:latin typeface="Calibri"/>
-              </a:rPr>
-              <a:t>logs come in through the API or a Bash script.</a:t>
-            </a:r>
-          </a:p>
-          <a:p>
-            <a:pPr algn="l">
-              <a:spcAft>
-                <a:spcPts val="300"/>
-              </a:spcAft>
-            </a:pPr>
-            <a:r>
-              <a:rPr sz="1200" b="0">
-                <a:solidFill>
-                  <a:srgbClr val="F58220"/>
-                </a:solidFill>
-                <a:latin typeface="Calibri"/>
-              </a:rPr>
-              <a:t>② </a:t>
-            </a:r>
-            <a:r>
-              <a:rPr sz="1200" b="1">
-                <a:solidFill>
-                  <a:srgbClr val="0B2A5B"/>
-                </a:solidFill>
-                <a:latin typeface="Calibri"/>
-              </a:rPr>
-              <a:t>Group: </a:t>
-            </a:r>
-            <a:r>
-              <a:rPr sz="1200" b="0">
-                <a:solidFill>
-                  <a:srgbClr val="1E2530"/>
-                </a:solidFill>
-                <a:latin typeface="Calibri"/>
-              </a:rPr>
-              <a:t>similar lines are grouped into templates.</a:t>
-            </a:r>
-          </a:p>
-          <a:p>
-            <a:pPr algn="l">
-              <a:spcAft>
-                <a:spcPts val="300"/>
-              </a:spcAft>
-            </a:pPr>
-            <a:r>
-              <a:rPr sz="1200" b="0">
-                <a:solidFill>
-                  <a:srgbClr val="F58220"/>
-                </a:solidFill>
-                <a:latin typeface="Calibri"/>
-              </a:rPr>
-              <a:t>③ </a:t>
-            </a:r>
-            <a:r>
-              <a:rPr sz="1200" b="1">
-                <a:solidFill>
-                  <a:srgbClr val="0B2A5B"/>
-                </a:solidFill>
-                <a:latin typeface="Calibri"/>
-              </a:rPr>
-              <a:t>Check: </a:t>
-            </a:r>
-            <a:r>
-              <a:rPr sz="1200" b="0">
-                <a:solidFill>
-                  <a:srgbClr val="1E2530"/>
-                </a:solidFill>
-                <a:latin typeface="Calibri"/>
-              </a:rPr>
-              <a:t>ML decides: known format or brand new?</a:t>
-            </a:r>
-          </a:p>
-          <a:p>
-            <a:pPr algn="l">
-              <a:spcAft>
-                <a:spcPts val="300"/>
-              </a:spcAft>
-            </a:pPr>
-            <a:r>
-              <a:rPr sz="1200" b="0">
-                <a:solidFill>
-                  <a:srgbClr val="F58220"/>
-                </a:solidFill>
-                <a:latin typeface="Calibri"/>
-              </a:rPr>
-              <a:t>④ </a:t>
-            </a:r>
-            <a:r>
-              <a:rPr sz="1200" b="1">
-                <a:solidFill>
-                  <a:srgbClr val="0B2A5B"/>
-                </a:solidFill>
-                <a:latin typeface="Calibri"/>
-              </a:rPr>
-              <a:t>Learn: </a:t>
-            </a:r>
-            <a:r>
-              <a:rPr sz="1200" b="0">
-                <a:solidFill>
-                  <a:srgbClr val="1E2530"/>
-                </a:solidFill>
-                <a:latin typeface="Calibri"/>
-              </a:rPr>
-              <a:t>AI writes a rule once; it is reused forever.</a:t>
-            </a:r>
-          </a:p>
-          <a:p>
-            <a:pPr algn="l">
-              <a:spcAft>
-                <a:spcPts val="300"/>
-              </a:spcAft>
-            </a:pPr>
-            <a:r>
-              <a:rPr sz="1200" b="0">
-                <a:solidFill>
-                  <a:srgbClr val="F58220"/>
-                </a:solidFill>
-                <a:latin typeface="Calibri"/>
-              </a:rPr>
-              <a:t>⑤ </a:t>
-            </a:r>
-            <a:r>
-              <a:rPr sz="1200" b="1">
-                <a:solidFill>
-                  <a:srgbClr val="0B2A5B"/>
-                </a:solidFill>
-                <a:latin typeface="Calibri"/>
-              </a:rPr>
-              <a:t>Output: </a:t>
-            </a:r>
-            <a:r>
-              <a:rPr sz="1200" b="0">
-                <a:solidFill>
-                  <a:srgbClr val="1E2530"/>
-                </a:solidFill>
-                <a:latin typeface="Calibri"/>
-              </a:rPr>
-              <a:t>every log leaves in one clean, common format.</a:t>
-            </a:r>
-          </a:p>
-        </p:txBody>
-      </p:sp>
-      <p:sp>
-        <p:nvSpPr>
           <p:cNvPr id="87" name="Oval 86"/>
           <p:cNvSpPr/>
           <p:nvPr/>
@@ -13217,6 +12829,1523 @@
                 <a:latin typeface="Calibri"/>
               </a:rPr>
               <a:t>2026</a:t>
+            </a:r>
+          </a:p>
+        </p:txBody>
+      </p:sp>
+      <p:sp>
+        <p:nvSpPr>
+          <p:cNvPr id="91" name="TextBox 90"/>
+          <p:cNvSpPr txBox="1"/>
+          <p:nvPr/>
+        </p:nvSpPr>
+        <p:spPr>
+          <a:xfrm>
+            <a:off x="365760" y="4087368"/>
+            <a:ext cx="4937760" cy="292608"/>
+          </a:xfrm>
+          <a:prstGeom prst="rect">
+            <a:avLst/>
+          </a:prstGeom>
+          <a:noFill/>
+        </p:spPr>
+        <p:txBody>
+          <a:bodyPr wrap="square" lIns="36576" rIns="36576" tIns="18288" bIns="18288" anchor="t">
+            <a:spAutoFit/>
+          </a:bodyPr>
+          <a:lstStyle/>
+          <a:p>
+            <a:pPr algn="l"/>
+            <a:r>
+              <a:rPr sz="1350" b="1">
+                <a:solidFill>
+                  <a:srgbClr val="0B2A5B"/>
+                </a:solidFill>
+                <a:latin typeface="Calibri"/>
+              </a:rPr>
+              <a:t>Example: messy logs in → clean logs out</a:t>
+            </a:r>
+          </a:p>
+        </p:txBody>
+      </p:sp>
+      <p:sp>
+        <p:nvSpPr>
+          <p:cNvPr id="92" name="Rectangle 91"/>
+          <p:cNvSpPr/>
+          <p:nvPr/>
+        </p:nvSpPr>
+        <p:spPr>
+          <a:xfrm>
+            <a:off x="402336" y="4389120"/>
+            <a:ext cx="822960" cy="41148"/>
+          </a:xfrm>
+          <a:prstGeom prst="rect">
+            <a:avLst/>
+          </a:prstGeom>
+          <a:solidFill>
+            <a:srgbClr val="F58220"/>
+          </a:solidFill>
+          <a:ln>
+            <a:noFill/>
+          </a:ln>
+          <a:effectLst/>
+        </p:spPr>
+        <p:style>
+          <a:lnRef idx="1">
+            <a:schemeClr val="accent1"/>
+          </a:lnRef>
+          <a:fillRef idx="3">
+            <a:schemeClr val="accent1"/>
+          </a:fillRef>
+          <a:effectRef idx="2">
+            <a:schemeClr val="accent1"/>
+          </a:effectRef>
+          <a:fontRef idx="minor">
+            <a:schemeClr val="lt1"/>
+          </a:fontRef>
+        </p:style>
+        <p:txBody>
+          <a:bodyPr rtlCol="0" anchor="ctr"/>
+          <a:lstStyle/>
+          <a:p>
+            <a:pPr algn="ctr"/>
+          </a:p>
+        </p:txBody>
+      </p:sp>
+      <p:sp>
+        <p:nvSpPr>
+          <p:cNvPr id="93" name="Rounded Rectangle 92"/>
+          <p:cNvSpPr/>
+          <p:nvPr/>
+        </p:nvSpPr>
+        <p:spPr>
+          <a:xfrm>
+            <a:off x="365760" y="4480560"/>
+            <a:ext cx="4937760" cy="868680"/>
+          </a:xfrm>
+          <a:prstGeom prst="roundRect">
+            <a:avLst>
+              <a:gd name="adj" fmla="val 6000"/>
+            </a:avLst>
+          </a:prstGeom>
+          <a:solidFill>
+            <a:srgbClr val="FBFBFC"/>
+          </a:solidFill>
+          <a:ln w="12700">
+            <a:solidFill>
+              <a:srgbClr val="D3DBE8"/>
+            </a:solidFill>
+          </a:ln>
+          <a:effectLst/>
+        </p:spPr>
+        <p:style>
+          <a:lnRef idx="1">
+            <a:schemeClr val="accent1"/>
+          </a:lnRef>
+          <a:fillRef idx="3">
+            <a:schemeClr val="accent1"/>
+          </a:fillRef>
+          <a:effectRef idx="2">
+            <a:schemeClr val="accent1"/>
+          </a:effectRef>
+          <a:fontRef idx="minor">
+            <a:schemeClr val="lt1"/>
+          </a:fontRef>
+        </p:style>
+        <p:txBody>
+          <a:bodyPr rtlCol="0" anchor="ctr"/>
+          <a:lstStyle/>
+          <a:p>
+            <a:pPr algn="ctr"/>
+          </a:p>
+        </p:txBody>
+      </p:sp>
+      <p:sp>
+        <p:nvSpPr>
+          <p:cNvPr id="94" name="TextBox 93"/>
+          <p:cNvSpPr txBox="1"/>
+          <p:nvPr/>
+        </p:nvSpPr>
+        <p:spPr>
+          <a:xfrm>
+            <a:off x="457200" y="4526280"/>
+            <a:ext cx="4754880" cy="777240"/>
+          </a:xfrm>
+          <a:prstGeom prst="rect">
+            <a:avLst/>
+          </a:prstGeom>
+          <a:noFill/>
+        </p:spPr>
+        <p:txBody>
+          <a:bodyPr wrap="square" lIns="36576" rIns="36576" tIns="18288" bIns="18288" anchor="ctr">
+            <a:spAutoFit/>
+          </a:bodyPr>
+          <a:lstStyle/>
+          <a:p>
+            <a:pPr algn="l">
+              <a:spcAft>
+                <a:spcPts val="300"/>
+              </a:spcAft>
+            </a:pPr>
+            <a:r>
+              <a:rPr sz="900" b="0">
+                <a:solidFill>
+                  <a:srgbClr val="8E44AD"/>
+                </a:solidFill>
+                <a:latin typeface="Consolas"/>
+              </a:rPr>
+              <a:t>&lt;34&gt;Oct 11 22:14:15 srv1 sshd: Failed password</a:t>
+            </a:r>
+          </a:p>
+          <a:p>
+            <a:pPr algn="l">
+              <a:spcAft>
+                <a:spcPts val="300"/>
+              </a:spcAft>
+            </a:pPr>
+            <a:r>
+              <a:rPr sz="900" b="0">
+                <a:solidFill>
+                  <a:srgbClr val="B35C00"/>
+                </a:solidFill>
+                <a:latin typeface="Consolas"/>
+              </a:rPr>
+              <a:t>{"t":"22:14:16Z","lvl":"ERROR","msg":"DB timeout"}</a:t>
+            </a:r>
+          </a:p>
+          <a:p>
+            <a:pPr algn="l"/>
+            <a:r>
+              <a:rPr sz="900" b="0">
+                <a:solidFill>
+                  <a:srgbClr val="1F5FBF"/>
+                </a:solidFill>
+                <a:latin typeface="Consolas"/>
+              </a:rPr>
+              <a:t>10.0.0.5 - [11/Oct/2026:22:14:17] "GET /login" 500</a:t>
+            </a:r>
+          </a:p>
+        </p:txBody>
+      </p:sp>
+      <p:sp>
+        <p:nvSpPr>
+          <p:cNvPr id="95" name="TextBox 94"/>
+          <p:cNvSpPr txBox="1"/>
+          <p:nvPr/>
+        </p:nvSpPr>
+        <p:spPr>
+          <a:xfrm>
+            <a:off x="365760" y="5340096"/>
+            <a:ext cx="4937760" cy="237744"/>
+          </a:xfrm>
+          <a:prstGeom prst="rect">
+            <a:avLst/>
+          </a:prstGeom>
+          <a:noFill/>
+        </p:spPr>
+        <p:txBody>
+          <a:bodyPr wrap="square" lIns="36576" rIns="36576" tIns="18288" bIns="18288" anchor="t">
+            <a:spAutoFit/>
+          </a:bodyPr>
+          <a:lstStyle/>
+          <a:p>
+            <a:pPr algn="ctr"/>
+            <a:r>
+              <a:rPr sz="1000" b="1">
+                <a:solidFill>
+                  <a:srgbClr val="138A36"/>
+                </a:solidFill>
+                <a:latin typeface="Calibri"/>
+              </a:rPr>
+              <a:t>▼  one common format</a:t>
+            </a:r>
+          </a:p>
+        </p:txBody>
+      </p:sp>
+      <p:sp>
+        <p:nvSpPr>
+          <p:cNvPr id="96" name="Rectangle 95"/>
+          <p:cNvSpPr/>
+          <p:nvPr/>
+        </p:nvSpPr>
+        <p:spPr>
+          <a:xfrm>
+            <a:off x="365760" y="5577840"/>
+            <a:ext cx="1051560" cy="201168"/>
+          </a:xfrm>
+          <a:prstGeom prst="rect">
+            <a:avLst/>
+          </a:prstGeom>
+          <a:solidFill>
+            <a:srgbClr val="138A36"/>
+          </a:solidFill>
+          <a:ln>
+            <a:noFill/>
+          </a:ln>
+          <a:effectLst/>
+        </p:spPr>
+        <p:style>
+          <a:lnRef idx="1">
+            <a:schemeClr val="accent1"/>
+          </a:lnRef>
+          <a:fillRef idx="3">
+            <a:schemeClr val="accent1"/>
+          </a:fillRef>
+          <a:effectRef idx="2">
+            <a:schemeClr val="accent1"/>
+          </a:effectRef>
+          <a:fontRef idx="minor">
+            <a:schemeClr val="lt1"/>
+          </a:fontRef>
+        </p:style>
+        <p:txBody>
+          <a:bodyPr rtlCol="0" anchor="ctr"/>
+          <a:lstStyle/>
+          <a:p>
+            <a:pPr algn="ctr"/>
+          </a:p>
+        </p:txBody>
+      </p:sp>
+      <p:sp>
+        <p:nvSpPr>
+          <p:cNvPr id="97" name="TextBox 96"/>
+          <p:cNvSpPr txBox="1"/>
+          <p:nvPr/>
+        </p:nvSpPr>
+        <p:spPr>
+          <a:xfrm>
+            <a:off x="365760" y="5577840"/>
+            <a:ext cx="1051560" cy="201168"/>
+          </a:xfrm>
+          <a:prstGeom prst="rect">
+            <a:avLst/>
+          </a:prstGeom>
+          <a:noFill/>
+        </p:spPr>
+        <p:txBody>
+          <a:bodyPr wrap="square" lIns="36576" rIns="36576" tIns="18288" bIns="18288" anchor="ctr">
+            <a:spAutoFit/>
+          </a:bodyPr>
+          <a:lstStyle/>
+          <a:p>
+            <a:pPr algn="l"/>
+            <a:r>
+              <a:rPr sz="900" b="1">
+                <a:solidFill>
+                  <a:srgbClr val="FFFFFF"/>
+                </a:solidFill>
+                <a:latin typeface="Calibri"/>
+              </a:rPr>
+              <a:t>Time (UTC)</a:t>
+            </a:r>
+          </a:p>
+        </p:txBody>
+      </p:sp>
+      <p:sp>
+        <p:nvSpPr>
+          <p:cNvPr id="98" name="Rectangle 97"/>
+          <p:cNvSpPr/>
+          <p:nvPr/>
+        </p:nvSpPr>
+        <p:spPr>
+          <a:xfrm>
+            <a:off x="1417320" y="5577840"/>
+            <a:ext cx="868680" cy="201168"/>
+          </a:xfrm>
+          <a:prstGeom prst="rect">
+            <a:avLst/>
+          </a:prstGeom>
+          <a:solidFill>
+            <a:srgbClr val="138A36"/>
+          </a:solidFill>
+          <a:ln>
+            <a:noFill/>
+          </a:ln>
+          <a:effectLst/>
+        </p:spPr>
+        <p:style>
+          <a:lnRef idx="1">
+            <a:schemeClr val="accent1"/>
+          </a:lnRef>
+          <a:fillRef idx="3">
+            <a:schemeClr val="accent1"/>
+          </a:fillRef>
+          <a:effectRef idx="2">
+            <a:schemeClr val="accent1"/>
+          </a:effectRef>
+          <a:fontRef idx="minor">
+            <a:schemeClr val="lt1"/>
+          </a:fontRef>
+        </p:style>
+        <p:txBody>
+          <a:bodyPr rtlCol="0" anchor="ctr"/>
+          <a:lstStyle/>
+          <a:p>
+            <a:pPr algn="ctr"/>
+          </a:p>
+        </p:txBody>
+      </p:sp>
+      <p:sp>
+        <p:nvSpPr>
+          <p:cNvPr id="99" name="TextBox 98"/>
+          <p:cNvSpPr txBox="1"/>
+          <p:nvPr/>
+        </p:nvSpPr>
+        <p:spPr>
+          <a:xfrm>
+            <a:off x="1417320" y="5577840"/>
+            <a:ext cx="868680" cy="201168"/>
+          </a:xfrm>
+          <a:prstGeom prst="rect">
+            <a:avLst/>
+          </a:prstGeom>
+          <a:noFill/>
+        </p:spPr>
+        <p:txBody>
+          <a:bodyPr wrap="square" lIns="36576" rIns="36576" tIns="18288" bIns="18288" anchor="ctr">
+            <a:spAutoFit/>
+          </a:bodyPr>
+          <a:lstStyle/>
+          <a:p>
+            <a:pPr algn="l"/>
+            <a:r>
+              <a:rPr sz="900" b="1">
+                <a:solidFill>
+                  <a:srgbClr val="FFFFFF"/>
+                </a:solidFill>
+                <a:latin typeface="Calibri"/>
+              </a:rPr>
+              <a:t>Source</a:t>
+            </a:r>
+          </a:p>
+        </p:txBody>
+      </p:sp>
+      <p:sp>
+        <p:nvSpPr>
+          <p:cNvPr id="100" name="Rectangle 99"/>
+          <p:cNvSpPr/>
+          <p:nvPr/>
+        </p:nvSpPr>
+        <p:spPr>
+          <a:xfrm>
+            <a:off x="2286000" y="5577840"/>
+            <a:ext cx="914400" cy="201168"/>
+          </a:xfrm>
+          <a:prstGeom prst="rect">
+            <a:avLst/>
+          </a:prstGeom>
+          <a:solidFill>
+            <a:srgbClr val="138A36"/>
+          </a:solidFill>
+          <a:ln>
+            <a:noFill/>
+          </a:ln>
+          <a:effectLst/>
+        </p:spPr>
+        <p:style>
+          <a:lnRef idx="1">
+            <a:schemeClr val="accent1"/>
+          </a:lnRef>
+          <a:fillRef idx="3">
+            <a:schemeClr val="accent1"/>
+          </a:fillRef>
+          <a:effectRef idx="2">
+            <a:schemeClr val="accent1"/>
+          </a:effectRef>
+          <a:fontRef idx="minor">
+            <a:schemeClr val="lt1"/>
+          </a:fontRef>
+        </p:style>
+        <p:txBody>
+          <a:bodyPr rtlCol="0" anchor="ctr"/>
+          <a:lstStyle/>
+          <a:p>
+            <a:pPr algn="ctr"/>
+          </a:p>
+        </p:txBody>
+      </p:sp>
+      <p:sp>
+        <p:nvSpPr>
+          <p:cNvPr id="101" name="TextBox 100"/>
+          <p:cNvSpPr txBox="1"/>
+          <p:nvPr/>
+        </p:nvSpPr>
+        <p:spPr>
+          <a:xfrm>
+            <a:off x="2286000" y="5577840"/>
+            <a:ext cx="914400" cy="201168"/>
+          </a:xfrm>
+          <a:prstGeom prst="rect">
+            <a:avLst/>
+          </a:prstGeom>
+          <a:noFill/>
+        </p:spPr>
+        <p:txBody>
+          <a:bodyPr wrap="square" lIns="36576" rIns="36576" tIns="18288" bIns="18288" anchor="ctr">
+            <a:spAutoFit/>
+          </a:bodyPr>
+          <a:lstStyle/>
+          <a:p>
+            <a:pPr algn="l"/>
+            <a:r>
+              <a:rPr sz="900" b="1">
+                <a:solidFill>
+                  <a:srgbClr val="FFFFFF"/>
+                </a:solidFill>
+                <a:latin typeface="Calibri"/>
+              </a:rPr>
+              <a:t>Severity</a:t>
+            </a:r>
+          </a:p>
+        </p:txBody>
+      </p:sp>
+      <p:sp>
+        <p:nvSpPr>
+          <p:cNvPr id="102" name="Rectangle 101"/>
+          <p:cNvSpPr/>
+          <p:nvPr/>
+        </p:nvSpPr>
+        <p:spPr>
+          <a:xfrm>
+            <a:off x="3200400" y="5577840"/>
+            <a:ext cx="2103120" cy="201168"/>
+          </a:xfrm>
+          <a:prstGeom prst="rect">
+            <a:avLst/>
+          </a:prstGeom>
+          <a:solidFill>
+            <a:srgbClr val="138A36"/>
+          </a:solidFill>
+          <a:ln>
+            <a:noFill/>
+          </a:ln>
+          <a:effectLst/>
+        </p:spPr>
+        <p:style>
+          <a:lnRef idx="1">
+            <a:schemeClr val="accent1"/>
+          </a:lnRef>
+          <a:fillRef idx="3">
+            <a:schemeClr val="accent1"/>
+          </a:fillRef>
+          <a:effectRef idx="2">
+            <a:schemeClr val="accent1"/>
+          </a:effectRef>
+          <a:fontRef idx="minor">
+            <a:schemeClr val="lt1"/>
+          </a:fontRef>
+        </p:style>
+        <p:txBody>
+          <a:bodyPr rtlCol="0" anchor="ctr"/>
+          <a:lstStyle/>
+          <a:p>
+            <a:pPr algn="ctr"/>
+          </a:p>
+        </p:txBody>
+      </p:sp>
+      <p:sp>
+        <p:nvSpPr>
+          <p:cNvPr id="103" name="TextBox 102"/>
+          <p:cNvSpPr txBox="1"/>
+          <p:nvPr/>
+        </p:nvSpPr>
+        <p:spPr>
+          <a:xfrm>
+            <a:off x="3200400" y="5577840"/>
+            <a:ext cx="2103120" cy="201168"/>
+          </a:xfrm>
+          <a:prstGeom prst="rect">
+            <a:avLst/>
+          </a:prstGeom>
+          <a:noFill/>
+        </p:spPr>
+        <p:txBody>
+          <a:bodyPr wrap="square" lIns="36576" rIns="36576" tIns="18288" bIns="18288" anchor="ctr">
+            <a:spAutoFit/>
+          </a:bodyPr>
+          <a:lstStyle/>
+          <a:p>
+            <a:pPr algn="l"/>
+            <a:r>
+              <a:rPr sz="900" b="1">
+                <a:solidFill>
+                  <a:srgbClr val="FFFFFF"/>
+                </a:solidFill>
+                <a:latin typeface="Calibri"/>
+              </a:rPr>
+              <a:t>Message</a:t>
+            </a:r>
+          </a:p>
+        </p:txBody>
+      </p:sp>
+      <p:sp>
+        <p:nvSpPr>
+          <p:cNvPr id="104" name="Rectangle 103"/>
+          <p:cNvSpPr/>
+          <p:nvPr/>
+        </p:nvSpPr>
+        <p:spPr>
+          <a:xfrm>
+            <a:off x="365760" y="5779008"/>
+            <a:ext cx="1051560" cy="182880"/>
+          </a:xfrm>
+          <a:prstGeom prst="rect">
+            <a:avLst/>
+          </a:prstGeom>
+          <a:solidFill>
+            <a:srgbClr val="FFFFFF"/>
+          </a:solidFill>
+          <a:ln w="6350">
+            <a:solidFill>
+              <a:srgbClr val="D3DBE8"/>
+            </a:solidFill>
+          </a:ln>
+          <a:effectLst/>
+        </p:spPr>
+        <p:style>
+          <a:lnRef idx="1">
+            <a:schemeClr val="accent1"/>
+          </a:lnRef>
+          <a:fillRef idx="3">
+            <a:schemeClr val="accent1"/>
+          </a:fillRef>
+          <a:effectRef idx="2">
+            <a:schemeClr val="accent1"/>
+          </a:effectRef>
+          <a:fontRef idx="minor">
+            <a:schemeClr val="lt1"/>
+          </a:fontRef>
+        </p:style>
+        <p:txBody>
+          <a:bodyPr rtlCol="0" anchor="ctr"/>
+          <a:lstStyle/>
+          <a:p>
+            <a:pPr algn="ctr"/>
+          </a:p>
+        </p:txBody>
+      </p:sp>
+      <p:sp>
+        <p:nvSpPr>
+          <p:cNvPr id="105" name="TextBox 104"/>
+          <p:cNvSpPr txBox="1"/>
+          <p:nvPr/>
+        </p:nvSpPr>
+        <p:spPr>
+          <a:xfrm>
+            <a:off x="365760" y="5779008"/>
+            <a:ext cx="1051560" cy="182880"/>
+          </a:xfrm>
+          <a:prstGeom prst="rect">
+            <a:avLst/>
+          </a:prstGeom>
+          <a:noFill/>
+        </p:spPr>
+        <p:txBody>
+          <a:bodyPr wrap="square" lIns="36576" rIns="36576" tIns="18288" bIns="18288" anchor="ctr">
+            <a:spAutoFit/>
+          </a:bodyPr>
+          <a:lstStyle/>
+          <a:p>
+            <a:pPr algn="l"/>
+            <a:r>
+              <a:rPr sz="850" b="0">
+                <a:solidFill>
+                  <a:srgbClr val="1E2530"/>
+                </a:solidFill>
+                <a:latin typeface="Calibri"/>
+              </a:rPr>
+              <a:t>22:14:15</a:t>
+            </a:r>
+          </a:p>
+        </p:txBody>
+      </p:sp>
+      <p:sp>
+        <p:nvSpPr>
+          <p:cNvPr id="106" name="Rectangle 105"/>
+          <p:cNvSpPr/>
+          <p:nvPr/>
+        </p:nvSpPr>
+        <p:spPr>
+          <a:xfrm>
+            <a:off x="1417320" y="5779008"/>
+            <a:ext cx="868680" cy="182880"/>
+          </a:xfrm>
+          <a:prstGeom prst="rect">
+            <a:avLst/>
+          </a:prstGeom>
+          <a:solidFill>
+            <a:srgbClr val="FFFFFF"/>
+          </a:solidFill>
+          <a:ln w="6350">
+            <a:solidFill>
+              <a:srgbClr val="D3DBE8"/>
+            </a:solidFill>
+          </a:ln>
+          <a:effectLst/>
+        </p:spPr>
+        <p:style>
+          <a:lnRef idx="1">
+            <a:schemeClr val="accent1"/>
+          </a:lnRef>
+          <a:fillRef idx="3">
+            <a:schemeClr val="accent1"/>
+          </a:fillRef>
+          <a:effectRef idx="2">
+            <a:schemeClr val="accent1"/>
+          </a:effectRef>
+          <a:fontRef idx="minor">
+            <a:schemeClr val="lt1"/>
+          </a:fontRef>
+        </p:style>
+        <p:txBody>
+          <a:bodyPr rtlCol="0" anchor="ctr"/>
+          <a:lstStyle/>
+          <a:p>
+            <a:pPr algn="ctr"/>
+          </a:p>
+        </p:txBody>
+      </p:sp>
+      <p:sp>
+        <p:nvSpPr>
+          <p:cNvPr id="107" name="TextBox 106"/>
+          <p:cNvSpPr txBox="1"/>
+          <p:nvPr/>
+        </p:nvSpPr>
+        <p:spPr>
+          <a:xfrm>
+            <a:off x="1417320" y="5779008"/>
+            <a:ext cx="868680" cy="182880"/>
+          </a:xfrm>
+          <a:prstGeom prst="rect">
+            <a:avLst/>
+          </a:prstGeom>
+          <a:noFill/>
+        </p:spPr>
+        <p:txBody>
+          <a:bodyPr wrap="square" lIns="36576" rIns="36576" tIns="18288" bIns="18288" anchor="ctr">
+            <a:spAutoFit/>
+          </a:bodyPr>
+          <a:lstStyle/>
+          <a:p>
+            <a:pPr algn="l"/>
+            <a:r>
+              <a:rPr sz="850" b="0">
+                <a:solidFill>
+                  <a:srgbClr val="1E2530"/>
+                </a:solidFill>
+                <a:latin typeface="Calibri"/>
+              </a:rPr>
+              <a:t>sshd</a:t>
+            </a:r>
+          </a:p>
+        </p:txBody>
+      </p:sp>
+      <p:sp>
+        <p:nvSpPr>
+          <p:cNvPr id="108" name="Rectangle 107"/>
+          <p:cNvSpPr/>
+          <p:nvPr/>
+        </p:nvSpPr>
+        <p:spPr>
+          <a:xfrm>
+            <a:off x="2286000" y="5779008"/>
+            <a:ext cx="914400" cy="182880"/>
+          </a:xfrm>
+          <a:prstGeom prst="rect">
+            <a:avLst/>
+          </a:prstGeom>
+          <a:solidFill>
+            <a:srgbClr val="FFFFFF"/>
+          </a:solidFill>
+          <a:ln w="6350">
+            <a:solidFill>
+              <a:srgbClr val="D3DBE8"/>
+            </a:solidFill>
+          </a:ln>
+          <a:effectLst/>
+        </p:spPr>
+        <p:style>
+          <a:lnRef idx="1">
+            <a:schemeClr val="accent1"/>
+          </a:lnRef>
+          <a:fillRef idx="3">
+            <a:schemeClr val="accent1"/>
+          </a:fillRef>
+          <a:effectRef idx="2">
+            <a:schemeClr val="accent1"/>
+          </a:effectRef>
+          <a:fontRef idx="minor">
+            <a:schemeClr val="lt1"/>
+          </a:fontRef>
+        </p:style>
+        <p:txBody>
+          <a:bodyPr rtlCol="0" anchor="ctr"/>
+          <a:lstStyle/>
+          <a:p>
+            <a:pPr algn="ctr"/>
+          </a:p>
+        </p:txBody>
+      </p:sp>
+      <p:sp>
+        <p:nvSpPr>
+          <p:cNvPr id="109" name="TextBox 108"/>
+          <p:cNvSpPr txBox="1"/>
+          <p:nvPr/>
+        </p:nvSpPr>
+        <p:spPr>
+          <a:xfrm>
+            <a:off x="2286000" y="5779008"/>
+            <a:ext cx="914400" cy="182880"/>
+          </a:xfrm>
+          <a:prstGeom prst="rect">
+            <a:avLst/>
+          </a:prstGeom>
+          <a:noFill/>
+        </p:spPr>
+        <p:txBody>
+          <a:bodyPr wrap="square" lIns="36576" rIns="36576" tIns="18288" bIns="18288" anchor="ctr">
+            <a:spAutoFit/>
+          </a:bodyPr>
+          <a:lstStyle/>
+          <a:p>
+            <a:pPr algn="l"/>
+            <a:r>
+              <a:rPr sz="850" b="1">
+                <a:solidFill>
+                  <a:srgbClr val="B35C00"/>
+                </a:solidFill>
+                <a:latin typeface="Calibri"/>
+              </a:rPr>
+              <a:t>WARNING</a:t>
+            </a:r>
+          </a:p>
+        </p:txBody>
+      </p:sp>
+      <p:sp>
+        <p:nvSpPr>
+          <p:cNvPr id="110" name="Rectangle 109"/>
+          <p:cNvSpPr/>
+          <p:nvPr/>
+        </p:nvSpPr>
+        <p:spPr>
+          <a:xfrm>
+            <a:off x="3200400" y="5779008"/>
+            <a:ext cx="2103120" cy="182880"/>
+          </a:xfrm>
+          <a:prstGeom prst="rect">
+            <a:avLst/>
+          </a:prstGeom>
+          <a:solidFill>
+            <a:srgbClr val="FFFFFF"/>
+          </a:solidFill>
+          <a:ln w="6350">
+            <a:solidFill>
+              <a:srgbClr val="D3DBE8"/>
+            </a:solidFill>
+          </a:ln>
+          <a:effectLst/>
+        </p:spPr>
+        <p:style>
+          <a:lnRef idx="1">
+            <a:schemeClr val="accent1"/>
+          </a:lnRef>
+          <a:fillRef idx="3">
+            <a:schemeClr val="accent1"/>
+          </a:fillRef>
+          <a:effectRef idx="2">
+            <a:schemeClr val="accent1"/>
+          </a:effectRef>
+          <a:fontRef idx="minor">
+            <a:schemeClr val="lt1"/>
+          </a:fontRef>
+        </p:style>
+        <p:txBody>
+          <a:bodyPr rtlCol="0" anchor="ctr"/>
+          <a:lstStyle/>
+          <a:p>
+            <a:pPr algn="ctr"/>
+          </a:p>
+        </p:txBody>
+      </p:sp>
+      <p:sp>
+        <p:nvSpPr>
+          <p:cNvPr id="111" name="TextBox 110"/>
+          <p:cNvSpPr txBox="1"/>
+          <p:nvPr/>
+        </p:nvSpPr>
+        <p:spPr>
+          <a:xfrm>
+            <a:off x="3200400" y="5779008"/>
+            <a:ext cx="2103120" cy="182880"/>
+          </a:xfrm>
+          <a:prstGeom prst="rect">
+            <a:avLst/>
+          </a:prstGeom>
+          <a:noFill/>
+        </p:spPr>
+        <p:txBody>
+          <a:bodyPr wrap="square" lIns="36576" rIns="36576" tIns="18288" bIns="18288" anchor="ctr">
+            <a:spAutoFit/>
+          </a:bodyPr>
+          <a:lstStyle/>
+          <a:p>
+            <a:pPr algn="l"/>
+            <a:r>
+              <a:rPr sz="850" b="0">
+                <a:solidFill>
+                  <a:srgbClr val="1E2530"/>
+                </a:solidFill>
+                <a:latin typeface="Calibri"/>
+              </a:rPr>
+              <a:t>Failed login (root)</a:t>
+            </a:r>
+          </a:p>
+        </p:txBody>
+      </p:sp>
+      <p:sp>
+        <p:nvSpPr>
+          <p:cNvPr id="112" name="Rectangle 111"/>
+          <p:cNvSpPr/>
+          <p:nvPr/>
+        </p:nvSpPr>
+        <p:spPr>
+          <a:xfrm>
+            <a:off x="365760" y="5961888"/>
+            <a:ext cx="1051560" cy="182880"/>
+          </a:xfrm>
+          <a:prstGeom prst="rect">
+            <a:avLst/>
+          </a:prstGeom>
+          <a:solidFill>
+            <a:srgbClr val="F2F5FA"/>
+          </a:solidFill>
+          <a:ln w="6350">
+            <a:solidFill>
+              <a:srgbClr val="D3DBE8"/>
+            </a:solidFill>
+          </a:ln>
+          <a:effectLst/>
+        </p:spPr>
+        <p:style>
+          <a:lnRef idx="1">
+            <a:schemeClr val="accent1"/>
+          </a:lnRef>
+          <a:fillRef idx="3">
+            <a:schemeClr val="accent1"/>
+          </a:fillRef>
+          <a:effectRef idx="2">
+            <a:schemeClr val="accent1"/>
+          </a:effectRef>
+          <a:fontRef idx="minor">
+            <a:schemeClr val="lt1"/>
+          </a:fontRef>
+        </p:style>
+        <p:txBody>
+          <a:bodyPr rtlCol="0" anchor="ctr"/>
+          <a:lstStyle/>
+          <a:p>
+            <a:pPr algn="ctr"/>
+          </a:p>
+        </p:txBody>
+      </p:sp>
+      <p:sp>
+        <p:nvSpPr>
+          <p:cNvPr id="113" name="TextBox 112"/>
+          <p:cNvSpPr txBox="1"/>
+          <p:nvPr/>
+        </p:nvSpPr>
+        <p:spPr>
+          <a:xfrm>
+            <a:off x="365760" y="5961888"/>
+            <a:ext cx="1051560" cy="182880"/>
+          </a:xfrm>
+          <a:prstGeom prst="rect">
+            <a:avLst/>
+          </a:prstGeom>
+          <a:noFill/>
+        </p:spPr>
+        <p:txBody>
+          <a:bodyPr wrap="square" lIns="36576" rIns="36576" tIns="18288" bIns="18288" anchor="ctr">
+            <a:spAutoFit/>
+          </a:bodyPr>
+          <a:lstStyle/>
+          <a:p>
+            <a:pPr algn="l"/>
+            <a:r>
+              <a:rPr sz="850" b="0">
+                <a:solidFill>
+                  <a:srgbClr val="1E2530"/>
+                </a:solidFill>
+                <a:latin typeface="Calibri"/>
+              </a:rPr>
+              <a:t>22:14:16</a:t>
+            </a:r>
+          </a:p>
+        </p:txBody>
+      </p:sp>
+      <p:sp>
+        <p:nvSpPr>
+          <p:cNvPr id="114" name="Rectangle 113"/>
+          <p:cNvSpPr/>
+          <p:nvPr/>
+        </p:nvSpPr>
+        <p:spPr>
+          <a:xfrm>
+            <a:off x="1417320" y="5961888"/>
+            <a:ext cx="868680" cy="182880"/>
+          </a:xfrm>
+          <a:prstGeom prst="rect">
+            <a:avLst/>
+          </a:prstGeom>
+          <a:solidFill>
+            <a:srgbClr val="F2F5FA"/>
+          </a:solidFill>
+          <a:ln w="6350">
+            <a:solidFill>
+              <a:srgbClr val="D3DBE8"/>
+            </a:solidFill>
+          </a:ln>
+          <a:effectLst/>
+        </p:spPr>
+        <p:style>
+          <a:lnRef idx="1">
+            <a:schemeClr val="accent1"/>
+          </a:lnRef>
+          <a:fillRef idx="3">
+            <a:schemeClr val="accent1"/>
+          </a:fillRef>
+          <a:effectRef idx="2">
+            <a:schemeClr val="accent1"/>
+          </a:effectRef>
+          <a:fontRef idx="minor">
+            <a:schemeClr val="lt1"/>
+          </a:fontRef>
+        </p:style>
+        <p:txBody>
+          <a:bodyPr rtlCol="0" anchor="ctr"/>
+          <a:lstStyle/>
+          <a:p>
+            <a:pPr algn="ctr"/>
+          </a:p>
+        </p:txBody>
+      </p:sp>
+      <p:sp>
+        <p:nvSpPr>
+          <p:cNvPr id="115" name="TextBox 114"/>
+          <p:cNvSpPr txBox="1"/>
+          <p:nvPr/>
+        </p:nvSpPr>
+        <p:spPr>
+          <a:xfrm>
+            <a:off x="1417320" y="5961888"/>
+            <a:ext cx="868680" cy="182880"/>
+          </a:xfrm>
+          <a:prstGeom prst="rect">
+            <a:avLst/>
+          </a:prstGeom>
+          <a:noFill/>
+        </p:spPr>
+        <p:txBody>
+          <a:bodyPr wrap="square" lIns="36576" rIns="36576" tIns="18288" bIns="18288" anchor="ctr">
+            <a:spAutoFit/>
+          </a:bodyPr>
+          <a:lstStyle/>
+          <a:p>
+            <a:pPr algn="l"/>
+            <a:r>
+              <a:rPr sz="850" b="0">
+                <a:solidFill>
+                  <a:srgbClr val="1E2530"/>
+                </a:solidFill>
+                <a:latin typeface="Calibri"/>
+              </a:rPr>
+              <a:t>app</a:t>
+            </a:r>
+          </a:p>
+        </p:txBody>
+      </p:sp>
+      <p:sp>
+        <p:nvSpPr>
+          <p:cNvPr id="116" name="Rectangle 115"/>
+          <p:cNvSpPr/>
+          <p:nvPr/>
+        </p:nvSpPr>
+        <p:spPr>
+          <a:xfrm>
+            <a:off x="2286000" y="5961888"/>
+            <a:ext cx="914400" cy="182880"/>
+          </a:xfrm>
+          <a:prstGeom prst="rect">
+            <a:avLst/>
+          </a:prstGeom>
+          <a:solidFill>
+            <a:srgbClr val="F2F5FA"/>
+          </a:solidFill>
+          <a:ln w="6350">
+            <a:solidFill>
+              <a:srgbClr val="D3DBE8"/>
+            </a:solidFill>
+          </a:ln>
+          <a:effectLst/>
+        </p:spPr>
+        <p:style>
+          <a:lnRef idx="1">
+            <a:schemeClr val="accent1"/>
+          </a:lnRef>
+          <a:fillRef idx="3">
+            <a:schemeClr val="accent1"/>
+          </a:fillRef>
+          <a:effectRef idx="2">
+            <a:schemeClr val="accent1"/>
+          </a:effectRef>
+          <a:fontRef idx="minor">
+            <a:schemeClr val="lt1"/>
+          </a:fontRef>
+        </p:style>
+        <p:txBody>
+          <a:bodyPr rtlCol="0" anchor="ctr"/>
+          <a:lstStyle/>
+          <a:p>
+            <a:pPr algn="ctr"/>
+          </a:p>
+        </p:txBody>
+      </p:sp>
+      <p:sp>
+        <p:nvSpPr>
+          <p:cNvPr id="117" name="TextBox 116"/>
+          <p:cNvSpPr txBox="1"/>
+          <p:nvPr/>
+        </p:nvSpPr>
+        <p:spPr>
+          <a:xfrm>
+            <a:off x="2286000" y="5961888"/>
+            <a:ext cx="914400" cy="182880"/>
+          </a:xfrm>
+          <a:prstGeom prst="rect">
+            <a:avLst/>
+          </a:prstGeom>
+          <a:noFill/>
+        </p:spPr>
+        <p:txBody>
+          <a:bodyPr wrap="square" lIns="36576" rIns="36576" tIns="18288" bIns="18288" anchor="ctr">
+            <a:spAutoFit/>
+          </a:bodyPr>
+          <a:lstStyle/>
+          <a:p>
+            <a:pPr algn="l"/>
+            <a:r>
+              <a:rPr sz="850" b="1">
+                <a:solidFill>
+                  <a:srgbClr val="C0392B"/>
+                </a:solidFill>
+                <a:latin typeface="Calibri"/>
+              </a:rPr>
+              <a:t>ERROR</a:t>
+            </a:r>
+          </a:p>
+        </p:txBody>
+      </p:sp>
+      <p:sp>
+        <p:nvSpPr>
+          <p:cNvPr id="118" name="Rectangle 117"/>
+          <p:cNvSpPr/>
+          <p:nvPr/>
+        </p:nvSpPr>
+        <p:spPr>
+          <a:xfrm>
+            <a:off x="3200400" y="5961888"/>
+            <a:ext cx="2103120" cy="182880"/>
+          </a:xfrm>
+          <a:prstGeom prst="rect">
+            <a:avLst/>
+          </a:prstGeom>
+          <a:solidFill>
+            <a:srgbClr val="F2F5FA"/>
+          </a:solidFill>
+          <a:ln w="6350">
+            <a:solidFill>
+              <a:srgbClr val="D3DBE8"/>
+            </a:solidFill>
+          </a:ln>
+          <a:effectLst/>
+        </p:spPr>
+        <p:style>
+          <a:lnRef idx="1">
+            <a:schemeClr val="accent1"/>
+          </a:lnRef>
+          <a:fillRef idx="3">
+            <a:schemeClr val="accent1"/>
+          </a:fillRef>
+          <a:effectRef idx="2">
+            <a:schemeClr val="accent1"/>
+          </a:effectRef>
+          <a:fontRef idx="minor">
+            <a:schemeClr val="lt1"/>
+          </a:fontRef>
+        </p:style>
+        <p:txBody>
+          <a:bodyPr rtlCol="0" anchor="ctr"/>
+          <a:lstStyle/>
+          <a:p>
+            <a:pPr algn="ctr"/>
+          </a:p>
+        </p:txBody>
+      </p:sp>
+      <p:sp>
+        <p:nvSpPr>
+          <p:cNvPr id="119" name="TextBox 118"/>
+          <p:cNvSpPr txBox="1"/>
+          <p:nvPr/>
+        </p:nvSpPr>
+        <p:spPr>
+          <a:xfrm>
+            <a:off x="3200400" y="5961888"/>
+            <a:ext cx="2103120" cy="182880"/>
+          </a:xfrm>
+          <a:prstGeom prst="rect">
+            <a:avLst/>
+          </a:prstGeom>
+          <a:noFill/>
+        </p:spPr>
+        <p:txBody>
+          <a:bodyPr wrap="square" lIns="36576" rIns="36576" tIns="18288" bIns="18288" anchor="ctr">
+            <a:spAutoFit/>
+          </a:bodyPr>
+          <a:lstStyle/>
+          <a:p>
+            <a:pPr algn="l"/>
+            <a:r>
+              <a:rPr sz="850" b="0">
+                <a:solidFill>
+                  <a:srgbClr val="1E2530"/>
+                </a:solidFill>
+                <a:latin typeface="Calibri"/>
+              </a:rPr>
+              <a:t>Database timeout</a:t>
+            </a:r>
+          </a:p>
+        </p:txBody>
+      </p:sp>
+      <p:sp>
+        <p:nvSpPr>
+          <p:cNvPr id="120" name="Rectangle 119"/>
+          <p:cNvSpPr/>
+          <p:nvPr/>
+        </p:nvSpPr>
+        <p:spPr>
+          <a:xfrm>
+            <a:off x="365760" y="6144768"/>
+            <a:ext cx="1051560" cy="182880"/>
+          </a:xfrm>
+          <a:prstGeom prst="rect">
+            <a:avLst/>
+          </a:prstGeom>
+          <a:solidFill>
+            <a:srgbClr val="FFFFFF"/>
+          </a:solidFill>
+          <a:ln w="6350">
+            <a:solidFill>
+              <a:srgbClr val="D3DBE8"/>
+            </a:solidFill>
+          </a:ln>
+          <a:effectLst/>
+        </p:spPr>
+        <p:style>
+          <a:lnRef idx="1">
+            <a:schemeClr val="accent1"/>
+          </a:lnRef>
+          <a:fillRef idx="3">
+            <a:schemeClr val="accent1"/>
+          </a:fillRef>
+          <a:effectRef idx="2">
+            <a:schemeClr val="accent1"/>
+          </a:effectRef>
+          <a:fontRef idx="minor">
+            <a:schemeClr val="lt1"/>
+          </a:fontRef>
+        </p:style>
+        <p:txBody>
+          <a:bodyPr rtlCol="0" anchor="ctr"/>
+          <a:lstStyle/>
+          <a:p>
+            <a:pPr algn="ctr"/>
+          </a:p>
+        </p:txBody>
+      </p:sp>
+      <p:sp>
+        <p:nvSpPr>
+          <p:cNvPr id="121" name="TextBox 120"/>
+          <p:cNvSpPr txBox="1"/>
+          <p:nvPr/>
+        </p:nvSpPr>
+        <p:spPr>
+          <a:xfrm>
+            <a:off x="365760" y="6144768"/>
+            <a:ext cx="1051560" cy="182880"/>
+          </a:xfrm>
+          <a:prstGeom prst="rect">
+            <a:avLst/>
+          </a:prstGeom>
+          <a:noFill/>
+        </p:spPr>
+        <p:txBody>
+          <a:bodyPr wrap="square" lIns="36576" rIns="36576" tIns="18288" bIns="18288" anchor="ctr">
+            <a:spAutoFit/>
+          </a:bodyPr>
+          <a:lstStyle/>
+          <a:p>
+            <a:pPr algn="l"/>
+            <a:r>
+              <a:rPr sz="850" b="0">
+                <a:solidFill>
+                  <a:srgbClr val="1E2530"/>
+                </a:solidFill>
+                <a:latin typeface="Calibri"/>
+              </a:rPr>
+              <a:t>22:14:17</a:t>
+            </a:r>
+          </a:p>
+        </p:txBody>
+      </p:sp>
+      <p:sp>
+        <p:nvSpPr>
+          <p:cNvPr id="122" name="Rectangle 121"/>
+          <p:cNvSpPr/>
+          <p:nvPr/>
+        </p:nvSpPr>
+        <p:spPr>
+          <a:xfrm>
+            <a:off x="1417320" y="6144768"/>
+            <a:ext cx="868680" cy="182880"/>
+          </a:xfrm>
+          <a:prstGeom prst="rect">
+            <a:avLst/>
+          </a:prstGeom>
+          <a:solidFill>
+            <a:srgbClr val="FFFFFF"/>
+          </a:solidFill>
+          <a:ln w="6350">
+            <a:solidFill>
+              <a:srgbClr val="D3DBE8"/>
+            </a:solidFill>
+          </a:ln>
+          <a:effectLst/>
+        </p:spPr>
+        <p:style>
+          <a:lnRef idx="1">
+            <a:schemeClr val="accent1"/>
+          </a:lnRef>
+          <a:fillRef idx="3">
+            <a:schemeClr val="accent1"/>
+          </a:fillRef>
+          <a:effectRef idx="2">
+            <a:schemeClr val="accent1"/>
+          </a:effectRef>
+          <a:fontRef idx="minor">
+            <a:schemeClr val="lt1"/>
+          </a:fontRef>
+        </p:style>
+        <p:txBody>
+          <a:bodyPr rtlCol="0" anchor="ctr"/>
+          <a:lstStyle/>
+          <a:p>
+            <a:pPr algn="ctr"/>
+          </a:p>
+        </p:txBody>
+      </p:sp>
+      <p:sp>
+        <p:nvSpPr>
+          <p:cNvPr id="123" name="TextBox 122"/>
+          <p:cNvSpPr txBox="1"/>
+          <p:nvPr/>
+        </p:nvSpPr>
+        <p:spPr>
+          <a:xfrm>
+            <a:off x="1417320" y="6144768"/>
+            <a:ext cx="868680" cy="182880"/>
+          </a:xfrm>
+          <a:prstGeom prst="rect">
+            <a:avLst/>
+          </a:prstGeom>
+          <a:noFill/>
+        </p:spPr>
+        <p:txBody>
+          <a:bodyPr wrap="square" lIns="36576" rIns="36576" tIns="18288" bIns="18288" anchor="ctr">
+            <a:spAutoFit/>
+          </a:bodyPr>
+          <a:lstStyle/>
+          <a:p>
+            <a:pPr algn="l"/>
+            <a:r>
+              <a:rPr sz="850" b="0">
+                <a:solidFill>
+                  <a:srgbClr val="1E2530"/>
+                </a:solidFill>
+                <a:latin typeface="Calibri"/>
+              </a:rPr>
+              <a:t>web</a:t>
+            </a:r>
+          </a:p>
+        </p:txBody>
+      </p:sp>
+      <p:sp>
+        <p:nvSpPr>
+          <p:cNvPr id="124" name="Rectangle 123"/>
+          <p:cNvSpPr/>
+          <p:nvPr/>
+        </p:nvSpPr>
+        <p:spPr>
+          <a:xfrm>
+            <a:off x="2286000" y="6144768"/>
+            <a:ext cx="914400" cy="182880"/>
+          </a:xfrm>
+          <a:prstGeom prst="rect">
+            <a:avLst/>
+          </a:prstGeom>
+          <a:solidFill>
+            <a:srgbClr val="FFFFFF"/>
+          </a:solidFill>
+          <a:ln w="6350">
+            <a:solidFill>
+              <a:srgbClr val="D3DBE8"/>
+            </a:solidFill>
+          </a:ln>
+          <a:effectLst/>
+        </p:spPr>
+        <p:style>
+          <a:lnRef idx="1">
+            <a:schemeClr val="accent1"/>
+          </a:lnRef>
+          <a:fillRef idx="3">
+            <a:schemeClr val="accent1"/>
+          </a:fillRef>
+          <a:effectRef idx="2">
+            <a:schemeClr val="accent1"/>
+          </a:effectRef>
+          <a:fontRef idx="minor">
+            <a:schemeClr val="lt1"/>
+          </a:fontRef>
+        </p:style>
+        <p:txBody>
+          <a:bodyPr rtlCol="0" anchor="ctr"/>
+          <a:lstStyle/>
+          <a:p>
+            <a:pPr algn="ctr"/>
+          </a:p>
+        </p:txBody>
+      </p:sp>
+      <p:sp>
+        <p:nvSpPr>
+          <p:cNvPr id="125" name="TextBox 124"/>
+          <p:cNvSpPr txBox="1"/>
+          <p:nvPr/>
+        </p:nvSpPr>
+        <p:spPr>
+          <a:xfrm>
+            <a:off x="2286000" y="6144768"/>
+            <a:ext cx="914400" cy="182880"/>
+          </a:xfrm>
+          <a:prstGeom prst="rect">
+            <a:avLst/>
+          </a:prstGeom>
+          <a:noFill/>
+        </p:spPr>
+        <p:txBody>
+          <a:bodyPr wrap="square" lIns="36576" rIns="36576" tIns="18288" bIns="18288" anchor="ctr">
+            <a:spAutoFit/>
+          </a:bodyPr>
+          <a:lstStyle/>
+          <a:p>
+            <a:pPr algn="l"/>
+            <a:r>
+              <a:rPr sz="850" b="1">
+                <a:solidFill>
+                  <a:srgbClr val="C0392B"/>
+                </a:solidFill>
+                <a:latin typeface="Calibri"/>
+              </a:rPr>
+              <a:t>ERROR</a:t>
+            </a:r>
+          </a:p>
+        </p:txBody>
+      </p:sp>
+      <p:sp>
+        <p:nvSpPr>
+          <p:cNvPr id="126" name="Rectangle 125"/>
+          <p:cNvSpPr/>
+          <p:nvPr/>
+        </p:nvSpPr>
+        <p:spPr>
+          <a:xfrm>
+            <a:off x="3200400" y="6144768"/>
+            <a:ext cx="2103120" cy="182880"/>
+          </a:xfrm>
+          <a:prstGeom prst="rect">
+            <a:avLst/>
+          </a:prstGeom>
+          <a:solidFill>
+            <a:srgbClr val="FFFFFF"/>
+          </a:solidFill>
+          <a:ln w="6350">
+            <a:solidFill>
+              <a:srgbClr val="D3DBE8"/>
+            </a:solidFill>
+          </a:ln>
+          <a:effectLst/>
+        </p:spPr>
+        <p:style>
+          <a:lnRef idx="1">
+            <a:schemeClr val="accent1"/>
+          </a:lnRef>
+          <a:fillRef idx="3">
+            <a:schemeClr val="accent1"/>
+          </a:fillRef>
+          <a:effectRef idx="2">
+            <a:schemeClr val="accent1"/>
+          </a:effectRef>
+          <a:fontRef idx="minor">
+            <a:schemeClr val="lt1"/>
+          </a:fontRef>
+        </p:style>
+        <p:txBody>
+          <a:bodyPr rtlCol="0" anchor="ctr"/>
+          <a:lstStyle/>
+          <a:p>
+            <a:pPr algn="ctr"/>
+          </a:p>
+        </p:txBody>
+      </p:sp>
+      <p:sp>
+        <p:nvSpPr>
+          <p:cNvPr id="127" name="TextBox 126"/>
+          <p:cNvSpPr txBox="1"/>
+          <p:nvPr/>
+        </p:nvSpPr>
+        <p:spPr>
+          <a:xfrm>
+            <a:off x="3200400" y="6144768"/>
+            <a:ext cx="2103120" cy="182880"/>
+          </a:xfrm>
+          <a:prstGeom prst="rect">
+            <a:avLst/>
+          </a:prstGeom>
+          <a:noFill/>
+        </p:spPr>
+        <p:txBody>
+          <a:bodyPr wrap="square" lIns="36576" rIns="36576" tIns="18288" bIns="18288" anchor="ctr">
+            <a:spAutoFit/>
+          </a:bodyPr>
+          <a:lstStyle/>
+          <a:p>
+            <a:pPr algn="l"/>
+            <a:r>
+              <a:rPr sz="850" b="0">
+                <a:solidFill>
+                  <a:srgbClr val="1E2530"/>
+                </a:solidFill>
+                <a:latin typeface="Calibri"/>
+              </a:rPr>
+              <a:t>GET /login returned 500</a:t>
             </a:r>
           </a:p>
         </p:txBody>
@@ -13554,7 +14683,7 @@
         <p:spPr>
           <a:xfrm>
             <a:off x="365760" y="1097280"/>
-            <a:ext cx="3657600" cy="5193792"/>
+            <a:ext cx="3657600" cy="4315968"/>
           </a:xfrm>
           <a:prstGeom prst="roundRect">
             <a:avLst>
@@ -13602,7 +14731,7 @@
         <p:spPr>
           <a:xfrm>
             <a:off x="365760" y="1097280"/>
-            <a:ext cx="3657600" cy="457200"/>
+            <a:ext cx="3657600" cy="438912"/>
           </a:xfrm>
           <a:prstGeom prst="roundRect">
             <a:avLst>
@@ -13648,7 +14777,7 @@
         <p:spPr>
           <a:xfrm>
             <a:off x="365760" y="1097280"/>
-            <a:ext cx="3657600" cy="457200"/>
+            <a:ext cx="3657600" cy="438912"/>
           </a:xfrm>
           <a:prstGeom prst="rect">
             <a:avLst/>
@@ -13682,8 +14811,8 @@
         </p:nvSpPr>
         <p:spPr>
           <a:xfrm>
-            <a:off x="502920" y="1719072"/>
-            <a:ext cx="3401568" cy="4462272"/>
+            <a:off x="502920" y="1645920"/>
+            <a:ext cx="3401568" cy="3712464"/>
           </a:xfrm>
           <a:prstGeom prst="rect">
             <a:avLst/>
@@ -13698,7 +14827,7 @@
           <a:p>
             <a:pPr algn="l">
               <a:spcAft>
-                <a:spcPts val="200"/>
+                <a:spcPts val="100"/>
               </a:spcAft>
             </a:pPr>
             <a:r>
@@ -13721,9 +14850,9 @@
             </a:r>
           </a:p>
           <a:p>
-            <a:pPr>
+            <a:pPr algn="l">
               <a:spcAft>
-                <a:spcPts val="1000"/>
+                <a:spcPts val="800"/>
               </a:spcAft>
             </a:pPr>
             <a:r>
@@ -13737,9 +14866,9 @@
             </a:r>
           </a:p>
           <a:p>
-            <a:pPr>
+            <a:pPr algn="l">
               <a:spcAft>
-                <a:spcPts val="200"/>
+                <a:spcPts val="100"/>
               </a:spcAft>
             </a:pPr>
             <a:r>
@@ -13762,9 +14891,9 @@
             </a:r>
           </a:p>
           <a:p>
-            <a:pPr>
+            <a:pPr algn="l">
               <a:spcAft>
-                <a:spcPts val="1000"/>
+                <a:spcPts val="800"/>
               </a:spcAft>
             </a:pPr>
             <a:r>
@@ -13778,9 +14907,9 @@
             </a:r>
           </a:p>
           <a:p>
-            <a:pPr>
+            <a:pPr algn="l">
               <a:spcAft>
-                <a:spcPts val="200"/>
+                <a:spcPts val="100"/>
               </a:spcAft>
             </a:pPr>
             <a:r>
@@ -13803,9 +14932,9 @@
             </a:r>
           </a:p>
           <a:p>
-            <a:pPr>
+            <a:pPr algn="l">
               <a:spcAft>
-                <a:spcPts val="1000"/>
+                <a:spcPts val="800"/>
               </a:spcAft>
             </a:pPr>
             <a:r>
@@ -13819,9 +14948,9 @@
             </a:r>
           </a:p>
           <a:p>
-            <a:pPr>
+            <a:pPr algn="l">
               <a:spcAft>
-                <a:spcPts val="200"/>
+                <a:spcPts val="100"/>
               </a:spcAft>
             </a:pPr>
             <a:r>
@@ -13844,9 +14973,9 @@
             </a:r>
           </a:p>
           <a:p>
-            <a:pPr>
+            <a:pPr algn="l">
               <a:spcAft>
-                <a:spcPts val="1000"/>
+                <a:spcPts val="800"/>
               </a:spcAft>
             </a:pPr>
             <a:r>
@@ -13860,9 +14989,9 @@
             </a:r>
           </a:p>
           <a:p>
-            <a:pPr>
+            <a:pPr algn="l">
               <a:spcAft>
-                <a:spcPts val="200"/>
+                <a:spcPts val="100"/>
               </a:spcAft>
             </a:pPr>
             <a:r>
@@ -13885,11 +15014,7 @@
             </a:r>
           </a:p>
           <a:p>
-            <a:pPr>
-              <a:spcAft>
-                <a:spcPts val="1000"/>
-              </a:spcAft>
-            </a:pPr>
+            <a:pPr algn="l"/>
             <a:r>
               <a:rPr sz="1150" b="0">
                 <a:solidFill>
@@ -13898,47 +15023,6 @@
                 <a:latin typeface="Calibri"/>
               </a:rPr>
               <a:t>Can run in watch-only 'shadow mode' next to current tools before teams rely on it.</a:t>
-            </a:r>
-          </a:p>
-          <a:p>
-            <a:pPr>
-              <a:spcAft>
-                <a:spcPts val="200"/>
-              </a:spcAft>
-            </a:pPr>
-            <a:r>
-              <a:rPr sz="1150" b="1">
-                <a:solidFill>
-                  <a:srgbClr val="138A36"/>
-                </a:solidFill>
-                <a:latin typeface="Calibri"/>
-              </a:rPr>
-              <a:t>✔ </a:t>
-            </a:r>
-            <a:r>
-              <a:rPr sz="1300" b="1">
-                <a:solidFill>
-                  <a:srgbClr val="0B2A5B"/>
-                </a:solidFill>
-                <a:latin typeface="Calibri"/>
-              </a:rPr>
-              <a:t>Simple, modular design</a:t>
-            </a:r>
-          </a:p>
-          <a:p>
-            <a:pPr>
-              <a:spcAft>
-                <a:spcPts val="0"/>
-              </a:spcAft>
-            </a:pPr>
-            <a:r>
-              <a:rPr sz="1150" b="0">
-                <a:solidFill>
-                  <a:srgbClr val="1E2530"/>
-                </a:solidFill>
-                <a:latin typeface="Calibri"/>
-              </a:rPr>
-              <a:t>Collect → group → learn → output: each part can be improved on its own.</a:t>
             </a:r>
           </a:p>
         </p:txBody>
@@ -13952,7 +15036,7 @@
         <p:spPr>
           <a:xfrm>
             <a:off x="8165592" y="1097280"/>
-            <a:ext cx="3703320" cy="5193792"/>
+            <a:ext cx="3703320" cy="4315968"/>
           </a:xfrm>
           <a:prstGeom prst="roundRect">
             <a:avLst>
@@ -14000,7 +15084,7 @@
         <p:spPr>
           <a:xfrm>
             <a:off x="8165592" y="1097280"/>
-            <a:ext cx="3703320" cy="457200"/>
+            <a:ext cx="3703320" cy="438912"/>
           </a:xfrm>
           <a:prstGeom prst="roundRect">
             <a:avLst>
@@ -14046,7 +15130,7 @@
         <p:spPr>
           <a:xfrm>
             <a:off x="8165592" y="1097280"/>
-            <a:ext cx="3703320" cy="457200"/>
+            <a:ext cx="3703320" cy="438912"/>
           </a:xfrm>
           <a:prstGeom prst="rect">
             <a:avLst/>
@@ -14080,8 +15164,8 @@
         </p:nvSpPr>
         <p:spPr>
           <a:xfrm>
-            <a:off x="8302752" y="1719072"/>
-            <a:ext cx="3447288" cy="4462272"/>
+            <a:off x="8302752" y="1645920"/>
+            <a:ext cx="3447288" cy="3712464"/>
           </a:xfrm>
           <a:prstGeom prst="rect">
             <a:avLst/>
@@ -14096,7 +15180,7 @@
           <a:p>
             <a:pPr algn="l">
               <a:spcAft>
-                <a:spcPts val="200"/>
+                <a:spcPts val="100"/>
               </a:spcAft>
             </a:pPr>
             <a:r>
@@ -14121,7 +15205,7 @@
           <a:p>
             <a:pPr algn="l">
               <a:spcAft>
-                <a:spcPts val="1100"/>
+                <a:spcPts val="800"/>
               </a:spcAft>
             </a:pPr>
             <a:r>
@@ -14137,7 +15221,7 @@
           <a:p>
             <a:pPr algn="l">
               <a:spcAft>
-                <a:spcPts val="200"/>
+                <a:spcPts val="100"/>
               </a:spcAft>
             </a:pPr>
             <a:r>
@@ -14162,7 +15246,7 @@
           <a:p>
             <a:pPr algn="l">
               <a:spcAft>
-                <a:spcPts val="1100"/>
+                <a:spcPts val="800"/>
               </a:spcAft>
             </a:pPr>
             <a:r>
@@ -14178,7 +15262,7 @@
           <a:p>
             <a:pPr algn="l">
               <a:spcAft>
-                <a:spcPts val="200"/>
+                <a:spcPts val="100"/>
               </a:spcAft>
             </a:pPr>
             <a:r>
@@ -14203,7 +15287,7 @@
           <a:p>
             <a:pPr algn="l">
               <a:spcAft>
-                <a:spcPts val="1100"/>
+                <a:spcPts val="800"/>
               </a:spcAft>
             </a:pPr>
             <a:r>
@@ -14219,7 +15303,7 @@
           <a:p>
             <a:pPr algn="l">
               <a:spcAft>
-                <a:spcPts val="200"/>
+                <a:spcPts val="100"/>
               </a:spcAft>
             </a:pPr>
             <a:r>
@@ -14244,7 +15328,7 @@
           <a:p>
             <a:pPr algn="l">
               <a:spcAft>
-                <a:spcPts val="1100"/>
+                <a:spcPts val="800"/>
               </a:spcAft>
             </a:pPr>
             <a:r>
@@ -14260,7 +15344,7 @@
           <a:p>
             <a:pPr algn="l">
               <a:spcAft>
-                <a:spcPts val="200"/>
+                <a:spcPts val="100"/>
               </a:spcAft>
             </a:pPr>
             <a:r>
@@ -14283,11 +15367,7 @@
             </a:r>
           </a:p>
           <a:p>
-            <a:pPr algn="l">
-              <a:spcAft>
-                <a:spcPts val="1100"/>
-              </a:spcAft>
-            </a:pPr>
+            <a:pPr algn="l"/>
             <a:r>
               <a:rPr sz="1150" b="0">
                 <a:solidFill>
@@ -14296,43 +15376,6 @@
                 <a:latin typeface="Calibri"/>
               </a:rPr>
               <a:t>Every bank, power utility, telecom operator and ministry produces huge, mixed logs.</a:t>
-            </a:r>
-          </a:p>
-          <a:p>
-            <a:pPr algn="l">
-              <a:spcAft>
-                <a:spcPts val="200"/>
-              </a:spcAft>
-            </a:pPr>
-            <a:r>
-              <a:rPr sz="1150" b="1">
-                <a:solidFill>
-                  <a:srgbClr val="1F5FBF"/>
-                </a:solidFill>
-                <a:latin typeface="Calibri"/>
-              </a:rPr>
-              <a:t>✔ </a:t>
-            </a:r>
-            <a:r>
-              <a:rPr sz="1300" b="1">
-                <a:solidFill>
-                  <a:srgbClr val="0B2A5B"/>
-                </a:solidFill>
-                <a:latin typeface="Calibri"/>
-              </a:rPr>
-              <a:t>Clear rollout path</a:t>
-            </a:r>
-          </a:p>
-          <a:p>
-            <a:pPr algn="l"/>
-            <a:r>
-              <a:rPr sz="1150" b="0">
-                <a:solidFill>
-                  <a:srgbClr val="1E2530"/>
-                </a:solidFill>
-                <a:latin typeface="Calibri"/>
-              </a:rPr>
-              <a:t>Pilot with one PSU, then sector security centres, then a nationwide NCIIPC rollout.</a:t>
             </a:r>
           </a:p>
         </p:txBody>
@@ -14346,7 +15389,7 @@
         <p:spPr>
           <a:xfrm>
             <a:off x="4206240" y="1097280"/>
-            <a:ext cx="3776472" cy="5193792"/>
+            <a:ext cx="3776472" cy="4315968"/>
           </a:xfrm>
           <a:prstGeom prst="roundRect">
             <a:avLst>
@@ -14394,7 +15437,7 @@
         <p:spPr>
           <a:xfrm>
             <a:off x="4206240" y="1097280"/>
-            <a:ext cx="3776472" cy="457200"/>
+            <a:ext cx="3776472" cy="438912"/>
           </a:xfrm>
           <a:prstGeom prst="roundRect">
             <a:avLst>
@@ -14440,7 +15483,7 @@
         <p:spPr>
           <a:xfrm>
             <a:off x="4206240" y="1097280"/>
-            <a:ext cx="3776472" cy="457200"/>
+            <a:ext cx="3776472" cy="438912"/>
           </a:xfrm>
           <a:prstGeom prst="rect">
             <a:avLst/>
@@ -14474,8 +15517,8 @@
         </p:nvSpPr>
         <p:spPr>
           <a:xfrm>
-            <a:off x="4297680" y="1609344"/>
-            <a:ext cx="1645920" cy="237744"/>
+            <a:off x="4297680" y="1572768"/>
+            <a:ext cx="1645920" cy="219456"/>
           </a:xfrm>
           <a:prstGeom prst="rect">
             <a:avLst/>
@@ -14509,8 +15552,8 @@
         </p:nvSpPr>
         <p:spPr>
           <a:xfrm>
-            <a:off x="6217920" y="1609344"/>
-            <a:ext cx="1691640" cy="237744"/>
+            <a:off x="6217920" y="1572768"/>
+            <a:ext cx="1691640" cy="219456"/>
           </a:xfrm>
           <a:prstGeom prst="rect">
             <a:avLst/>
@@ -14544,8 +15587,8 @@
         </p:nvSpPr>
         <p:spPr>
           <a:xfrm>
-            <a:off x="4315968" y="1883664"/>
-            <a:ext cx="1627632" cy="777240"/>
+            <a:off x="4315968" y="1828800"/>
+            <a:ext cx="1627632" cy="640080"/>
           </a:xfrm>
           <a:prstGeom prst="roundRect">
             <a:avLst>
@@ -14590,8 +15633,8 @@
         </p:nvSpPr>
         <p:spPr>
           <a:xfrm>
-            <a:off x="4343400" y="1883664"/>
-            <a:ext cx="1572768" cy="777240"/>
+            <a:off x="4343400" y="1828800"/>
+            <a:ext cx="1572768" cy="640080"/>
           </a:xfrm>
           <a:prstGeom prst="rect">
             <a:avLst/>
@@ -14606,7 +15649,7 @@
           <a:p>
             <a:pPr algn="ctr"/>
             <a:r>
-              <a:rPr sz="1150" b="1">
+              <a:rPr sz="1100" b="1">
                 <a:solidFill>
                   <a:srgbClr val="C0392B"/>
                 </a:solidFill>
@@ -14625,8 +15668,8 @@
         </p:nvSpPr>
         <p:spPr>
           <a:xfrm>
-            <a:off x="5925312" y="1883664"/>
-            <a:ext cx="292608" cy="777240"/>
+            <a:off x="5925312" y="1828800"/>
+            <a:ext cx="292608" cy="640080"/>
           </a:xfrm>
           <a:prstGeom prst="rect">
             <a:avLst/>
@@ -14660,8 +15703,8 @@
         </p:nvSpPr>
         <p:spPr>
           <a:xfrm>
-            <a:off x="6217920" y="1883664"/>
-            <a:ext cx="1664208" cy="777240"/>
+            <a:off x="6217920" y="1828800"/>
+            <a:ext cx="1664208" cy="640080"/>
           </a:xfrm>
           <a:prstGeom prst="roundRect">
             <a:avLst>
@@ -14706,8 +15749,8 @@
         </p:nvSpPr>
         <p:spPr>
           <a:xfrm>
-            <a:off x="6245352" y="1883664"/>
-            <a:ext cx="1609344" cy="777240"/>
+            <a:off x="6245352" y="1828800"/>
+            <a:ext cx="1609344" cy="640080"/>
           </a:xfrm>
           <a:prstGeom prst="rect">
             <a:avLst/>
@@ -14722,13 +15765,13 @@
           <a:p>
             <a:pPr algn="ctr"/>
             <a:r>
-              <a:rPr sz="1050" b="1">
+              <a:rPr sz="1000" b="1">
                 <a:solidFill>
                   <a:srgbClr val="138A36"/>
                 </a:solidFill>
                 <a:latin typeface="Calibri"/>
               </a:rPr>
-              <a:t>Switches to a backup AI, then to built-in rules; logs keep flowing</a:t>
+              <a:t>Switches to a backup AI, then built-in rules; logs keep flowing</a:t>
             </a:r>
           </a:p>
         </p:txBody>
@@ -14741,8 +15784,8 @@
         </p:nvSpPr>
         <p:spPr>
           <a:xfrm>
-            <a:off x="4315968" y="2752344"/>
-            <a:ext cx="1627632" cy="777240"/>
+            <a:off x="4315968" y="2542032"/>
+            <a:ext cx="1627632" cy="640080"/>
           </a:xfrm>
           <a:prstGeom prst="roundRect">
             <a:avLst>
@@ -14787,8 +15830,8 @@
         </p:nvSpPr>
         <p:spPr>
           <a:xfrm>
-            <a:off x="4343400" y="2752344"/>
-            <a:ext cx="1572768" cy="777240"/>
+            <a:off x="4343400" y="2542032"/>
+            <a:ext cx="1572768" cy="640080"/>
           </a:xfrm>
           <a:prstGeom prst="rect">
             <a:avLst/>
@@ -14803,7 +15846,7 @@
           <a:p>
             <a:pPr algn="ctr"/>
             <a:r>
-              <a:rPr sz="1150" b="1">
+              <a:rPr sz="1100" b="1">
                 <a:solidFill>
                   <a:srgbClr val="C0392B"/>
                 </a:solidFill>
@@ -14822,8 +15865,8 @@
         </p:nvSpPr>
         <p:spPr>
           <a:xfrm>
-            <a:off x="5925312" y="2752344"/>
-            <a:ext cx="292608" cy="777240"/>
+            <a:off x="5925312" y="2542032"/>
+            <a:ext cx="292608" cy="640080"/>
           </a:xfrm>
           <a:prstGeom prst="rect">
             <a:avLst/>
@@ -14857,8 +15900,8 @@
         </p:nvSpPr>
         <p:spPr>
           <a:xfrm>
-            <a:off x="6217920" y="2752344"/>
-            <a:ext cx="1664208" cy="777240"/>
+            <a:off x="6217920" y="2542032"/>
+            <a:ext cx="1664208" cy="640080"/>
           </a:xfrm>
           <a:prstGeom prst="roundRect">
             <a:avLst>
@@ -14903,8 +15946,8 @@
         </p:nvSpPr>
         <p:spPr>
           <a:xfrm>
-            <a:off x="6245352" y="2752344"/>
-            <a:ext cx="1609344" cy="777240"/>
+            <a:off x="6245352" y="2542032"/>
+            <a:ext cx="1609344" cy="640080"/>
           </a:xfrm>
           <a:prstGeom prst="rect">
             <a:avLst/>
@@ -14919,13 +15962,13 @@
           <a:p>
             <a:pPr algn="ctr"/>
             <a:r>
-              <a:rPr sz="1050" b="1">
+              <a:rPr sz="1000" b="1">
                 <a:solidFill>
                   <a:srgbClr val="138A36"/>
                 </a:solidFill>
                 <a:latin typeface="Calibri"/>
               </a:rPr>
-              <a:t>AI runs once per log format, not per line; most lines never need AI</a:t>
+              <a:t>AI runs once per format, not per line; most lines never need AI</a:t>
             </a:r>
           </a:p>
         </p:txBody>
@@ -14938,8 +15981,8 @@
         </p:nvSpPr>
         <p:spPr>
           <a:xfrm>
-            <a:off x="4315968" y="3621024"/>
-            <a:ext cx="1627632" cy="777240"/>
+            <a:off x="4315968" y="3255264"/>
+            <a:ext cx="1627632" cy="640080"/>
           </a:xfrm>
           <a:prstGeom prst="roundRect">
             <a:avLst>
@@ -14984,8 +16027,8 @@
         </p:nvSpPr>
         <p:spPr>
           <a:xfrm>
-            <a:off x="4343400" y="3621024"/>
-            <a:ext cx="1572768" cy="777240"/>
+            <a:off x="4343400" y="3255264"/>
+            <a:ext cx="1572768" cy="640080"/>
           </a:xfrm>
           <a:prstGeom prst="rect">
             <a:avLst/>
@@ -15000,7 +16043,7 @@
           <a:p>
             <a:pPr algn="ctr"/>
             <a:r>
-              <a:rPr sz="1150" b="1">
+              <a:rPr sz="1100" b="1">
                 <a:solidFill>
                   <a:srgbClr val="C0392B"/>
                 </a:solidFill>
@@ -15019,8 +16062,8 @@
         </p:nvSpPr>
         <p:spPr>
           <a:xfrm>
-            <a:off x="5925312" y="3621024"/>
-            <a:ext cx="292608" cy="777240"/>
+            <a:off x="5925312" y="3255264"/>
+            <a:ext cx="292608" cy="640080"/>
           </a:xfrm>
           <a:prstGeom prst="rect">
             <a:avLst/>
@@ -15054,8 +16097,8 @@
         </p:nvSpPr>
         <p:spPr>
           <a:xfrm>
-            <a:off x="6217920" y="3621024"/>
-            <a:ext cx="1664208" cy="777240"/>
+            <a:off x="6217920" y="3255264"/>
+            <a:ext cx="1664208" cy="640080"/>
           </a:xfrm>
           <a:prstGeom prst="roundRect">
             <a:avLst>
@@ -15100,8 +16143,8 @@
         </p:nvSpPr>
         <p:spPr>
           <a:xfrm>
-            <a:off x="6245352" y="3621024"/>
-            <a:ext cx="1609344" cy="777240"/>
+            <a:off x="6245352" y="3255264"/>
+            <a:ext cx="1609344" cy="640080"/>
           </a:xfrm>
           <a:prstGeom prst="rect">
             <a:avLst/>
@@ -15116,13 +16159,13 @@
           <a:p>
             <a:pPr algn="ctr"/>
             <a:r>
-              <a:rPr sz="1050" b="1">
+              <a:rPr sz="1000" b="1">
                 <a:solidFill>
                   <a:srgbClr val="138A36"/>
                 </a:solidFill>
                 <a:latin typeface="Calibri"/>
               </a:rPr>
-              <a:t>Held in a review queue, never dropped; accepted once confirmed</a:t>
+              <a:t>Held in a review queue, never dropped</a:t>
             </a:r>
           </a:p>
         </p:txBody>
@@ -15135,8 +16178,8 @@
         </p:nvSpPr>
         <p:spPr>
           <a:xfrm>
-            <a:off x="4315968" y="4489704"/>
-            <a:ext cx="1627632" cy="777240"/>
+            <a:off x="4315968" y="3968496"/>
+            <a:ext cx="1627632" cy="640080"/>
           </a:xfrm>
           <a:prstGeom prst="roundRect">
             <a:avLst>
@@ -15181,8 +16224,8 @@
         </p:nvSpPr>
         <p:spPr>
           <a:xfrm>
-            <a:off x="4343400" y="4489704"/>
-            <a:ext cx="1572768" cy="777240"/>
+            <a:off x="4343400" y="3968496"/>
+            <a:ext cx="1572768" cy="640080"/>
           </a:xfrm>
           <a:prstGeom prst="rect">
             <a:avLst/>
@@ -15197,7 +16240,7 @@
           <a:p>
             <a:pPr algn="ctr"/>
             <a:r>
-              <a:rPr sz="1150" b="1">
+              <a:rPr sz="1100" b="1">
                 <a:solidFill>
                   <a:srgbClr val="C0392B"/>
                 </a:solidFill>
@@ -15216,8 +16259,8 @@
         </p:nvSpPr>
         <p:spPr>
           <a:xfrm>
-            <a:off x="5925312" y="4489704"/>
-            <a:ext cx="292608" cy="777240"/>
+            <a:off x="5925312" y="3968496"/>
+            <a:ext cx="292608" cy="640080"/>
           </a:xfrm>
           <a:prstGeom prst="rect">
             <a:avLst/>
@@ -15251,8 +16294,8 @@
         </p:nvSpPr>
         <p:spPr>
           <a:xfrm>
-            <a:off x="6217920" y="4489704"/>
-            <a:ext cx="1664208" cy="777240"/>
+            <a:off x="6217920" y="3968496"/>
+            <a:ext cx="1664208" cy="640080"/>
           </a:xfrm>
           <a:prstGeom prst="roundRect">
             <a:avLst>
@@ -15297,8 +16340,8 @@
         </p:nvSpPr>
         <p:spPr>
           <a:xfrm>
-            <a:off x="6245352" y="4489704"/>
-            <a:ext cx="1609344" cy="777240"/>
+            <a:off x="6245352" y="3968496"/>
+            <a:ext cx="1609344" cy="640080"/>
           </a:xfrm>
           <a:prstGeom prst="rect">
             <a:avLst/>
@@ -15313,7 +16356,7 @@
           <a:p>
             <a:pPr algn="ctr"/>
             <a:r>
-              <a:rPr sz="1050" b="1">
+              <a:rPr sz="1000" b="1">
                 <a:solidFill>
                   <a:srgbClr val="138A36"/>
                 </a:solidFill>
@@ -15332,8 +16375,8 @@
         </p:nvSpPr>
         <p:spPr>
           <a:xfrm>
-            <a:off x="4315968" y="5358384"/>
-            <a:ext cx="1627632" cy="777240"/>
+            <a:off x="4315968" y="4681728"/>
+            <a:ext cx="1627632" cy="640080"/>
           </a:xfrm>
           <a:prstGeom prst="roundRect">
             <a:avLst>
@@ -15378,8 +16421,8 @@
         </p:nvSpPr>
         <p:spPr>
           <a:xfrm>
-            <a:off x="4343400" y="5358384"/>
-            <a:ext cx="1572768" cy="777240"/>
+            <a:off x="4343400" y="4681728"/>
+            <a:ext cx="1572768" cy="640080"/>
           </a:xfrm>
           <a:prstGeom prst="rect">
             <a:avLst/>
@@ -15394,13 +16437,13 @@
           <a:p>
             <a:pPr algn="ctr"/>
             <a:r>
-              <a:rPr sz="1150" b="1">
+              <a:rPr sz="1100" b="1">
                 <a:solidFill>
                   <a:srgbClr val="C0392B"/>
                 </a:solidFill>
                 <a:latin typeface="Calibri"/>
               </a:rPr>
-              <a:t>Sensitive data in logs</a:t>
+              <a:t>Personal data inside logs</a:t>
             </a:r>
           </a:p>
         </p:txBody>
@@ -15413,8 +16456,8 @@
         </p:nvSpPr>
         <p:spPr>
           <a:xfrm>
-            <a:off x="5925312" y="5358384"/>
-            <a:ext cx="292608" cy="777240"/>
+            <a:off x="5925312" y="4681728"/>
+            <a:ext cx="292608" cy="640080"/>
           </a:xfrm>
           <a:prstGeom prst="rect">
             <a:avLst/>
@@ -15448,8 +16491,8 @@
         </p:nvSpPr>
         <p:spPr>
           <a:xfrm>
-            <a:off x="6217920" y="5358384"/>
-            <a:ext cx="1664208" cy="777240"/>
+            <a:off x="6217920" y="4681728"/>
+            <a:ext cx="1664208" cy="640080"/>
           </a:xfrm>
           <a:prstGeom prst="roundRect">
             <a:avLst>
@@ -15494,8 +16537,8 @@
         </p:nvSpPr>
         <p:spPr>
           <a:xfrm>
-            <a:off x="6245352" y="5358384"/>
-            <a:ext cx="1609344" cy="777240"/>
+            <a:off x="6245352" y="4681728"/>
+            <a:ext cx="1609344" cy="640080"/>
           </a:xfrm>
           <a:prstGeom prst="rect">
             <a:avLst/>
@@ -15510,13 +16553,559 @@
           <a:p>
             <a:pPr algn="ctr"/>
             <a:r>
-              <a:rPr sz="1050" b="1">
+              <a:rPr sz="1000" b="1">
                 <a:solidFill>
                   <a:srgbClr val="138A36"/>
                 </a:solidFill>
                 <a:latin typeface="Calibri"/>
               </a:rPr>
-              <a:t>Runs on-premise; self-hosted AI planned so nothing leaves the network</a:t>
+              <a:t>Runs on-premise; data masking &amp; self-hosted AI planned</a:t>
+            </a:r>
+          </a:p>
+        </p:txBody>
+      </p:sp>
+      <p:sp>
+        <p:nvSpPr>
+          <p:cNvPr id="97" name="Rounded Rectangle 96"/>
+          <p:cNvSpPr/>
+          <p:nvPr/>
+        </p:nvSpPr>
+        <p:spPr>
+          <a:xfrm>
+            <a:off x="365760" y="5522976"/>
+            <a:ext cx="11503152" cy="768096"/>
+          </a:xfrm>
+          <a:prstGeom prst="roundRect">
+            <a:avLst>
+              <a:gd name="adj" fmla="val 10000"/>
+            </a:avLst>
+          </a:prstGeom>
+          <a:solidFill>
+            <a:srgbClr val="F2F5FA"/>
+          </a:solidFill>
+          <a:ln>
+            <a:noFill/>
+          </a:ln>
+          <a:effectLst/>
+        </p:spPr>
+        <p:style>
+          <a:lnRef idx="1">
+            <a:schemeClr val="accent1"/>
+          </a:lnRef>
+          <a:fillRef idx="3">
+            <a:schemeClr val="accent1"/>
+          </a:fillRef>
+          <a:effectRef idx="2">
+            <a:schemeClr val="accent1"/>
+          </a:effectRef>
+          <a:fontRef idx="minor">
+            <a:schemeClr val="lt1"/>
+          </a:fontRef>
+        </p:style>
+        <p:txBody>
+          <a:bodyPr rtlCol="0" anchor="ctr"/>
+          <a:lstStyle/>
+          <a:p>
+            <a:pPr algn="ctr"/>
+          </a:p>
+        </p:txBody>
+      </p:sp>
+      <p:sp>
+        <p:nvSpPr>
+          <p:cNvPr id="98" name="TextBox 97"/>
+          <p:cNvSpPr txBox="1"/>
+          <p:nvPr/>
+        </p:nvSpPr>
+        <p:spPr>
+          <a:xfrm>
+            <a:off x="457200" y="5522976"/>
+            <a:ext cx="1143000" cy="768096"/>
+          </a:xfrm>
+          <a:prstGeom prst="rect">
+            <a:avLst/>
+          </a:prstGeom>
+          <a:noFill/>
+        </p:spPr>
+        <p:txBody>
+          <a:bodyPr wrap="square" lIns="36576" rIns="36576" tIns="18288" bIns="18288" anchor="ctr">
+            <a:spAutoFit/>
+          </a:bodyPr>
+          <a:lstStyle/>
+          <a:p>
+            <a:pPr algn="l"/>
+            <a:r>
+              <a:rPr sz="1300" b="1">
+                <a:solidFill>
+                  <a:srgbClr val="0B2A5B"/>
+                </a:solidFill>
+                <a:latin typeface="Calibri"/>
+              </a:rPr>
+              <a:t>ROADMAP</a:t>
+            </a:r>
+          </a:p>
+        </p:txBody>
+      </p:sp>
+      <p:sp>
+        <p:nvSpPr>
+          <p:cNvPr id="99" name="Pentagon 98"/>
+          <p:cNvSpPr/>
+          <p:nvPr/>
+        </p:nvSpPr>
+        <p:spPr>
+          <a:xfrm>
+            <a:off x="1572768" y="5614416"/>
+            <a:ext cx="2011680" cy="585216"/>
+          </a:xfrm>
+          <a:prstGeom prst="homePlate">
+            <a:avLst>
+              <a:gd name="adj" fmla="val 25000"/>
+            </a:avLst>
+          </a:prstGeom>
+          <a:solidFill>
+            <a:srgbClr val="1F5FBF"/>
+          </a:solidFill>
+          <a:ln>
+            <a:noFill/>
+          </a:ln>
+          <a:effectLst/>
+        </p:spPr>
+        <p:style>
+          <a:lnRef idx="1">
+            <a:schemeClr val="accent1"/>
+          </a:lnRef>
+          <a:fillRef idx="3">
+            <a:schemeClr val="accent1"/>
+          </a:fillRef>
+          <a:effectRef idx="2">
+            <a:schemeClr val="accent1"/>
+          </a:effectRef>
+          <a:fontRef idx="minor">
+            <a:schemeClr val="lt1"/>
+          </a:fontRef>
+        </p:style>
+        <p:txBody>
+          <a:bodyPr rtlCol="0" anchor="ctr"/>
+          <a:lstStyle/>
+          <a:p>
+            <a:pPr algn="ctr"/>
+          </a:p>
+        </p:txBody>
+      </p:sp>
+      <p:sp>
+        <p:nvSpPr>
+          <p:cNvPr id="100" name="TextBox 99"/>
+          <p:cNvSpPr txBox="1"/>
+          <p:nvPr/>
+        </p:nvSpPr>
+        <p:spPr>
+          <a:xfrm>
+            <a:off x="1664208" y="5614416"/>
+            <a:ext cx="1600200" cy="585216"/>
+          </a:xfrm>
+          <a:prstGeom prst="rect">
+            <a:avLst/>
+          </a:prstGeom>
+          <a:noFill/>
+        </p:spPr>
+        <p:txBody>
+          <a:bodyPr wrap="square" lIns="36576" rIns="36576" tIns="18288" bIns="18288" anchor="ctr">
+            <a:spAutoFit/>
+          </a:bodyPr>
+          <a:lstStyle/>
+          <a:p>
+            <a:pPr algn="l"/>
+            <a:r>
+              <a:rPr sz="1100" b="1">
+                <a:solidFill>
+                  <a:srgbClr val="FFFFFF"/>
+                </a:solidFill>
+                <a:latin typeface="Calibri"/>
+              </a:rPr>
+              <a:t>1  Core pipeline</a:t>
+            </a:r>
+          </a:p>
+          <a:p>
+            <a:pPr algn="l"/>
+            <a:r>
+              <a:rPr sz="900" b="0">
+                <a:solidFill>
+                  <a:srgbClr val="FFFFFF"/>
+                </a:solidFill>
+                <a:latin typeface="Calibri"/>
+              </a:rPr>
+              <a:t>collect · group · learn</a:t>
+            </a:r>
+          </a:p>
+        </p:txBody>
+      </p:sp>
+      <p:sp>
+        <p:nvSpPr>
+          <p:cNvPr id="101" name="Chevron 100"/>
+          <p:cNvSpPr/>
+          <p:nvPr/>
+        </p:nvSpPr>
+        <p:spPr>
+          <a:xfrm>
+            <a:off x="3630168" y="5614416"/>
+            <a:ext cx="2011680" cy="585216"/>
+          </a:xfrm>
+          <a:prstGeom prst="chevron">
+            <a:avLst>
+              <a:gd name="adj" fmla="val 25000"/>
+            </a:avLst>
+          </a:prstGeom>
+          <a:solidFill>
+            <a:srgbClr val="6A3FB5"/>
+          </a:solidFill>
+          <a:ln>
+            <a:noFill/>
+          </a:ln>
+          <a:effectLst/>
+        </p:spPr>
+        <p:style>
+          <a:lnRef idx="1">
+            <a:schemeClr val="accent1"/>
+          </a:lnRef>
+          <a:fillRef idx="3">
+            <a:schemeClr val="accent1"/>
+          </a:fillRef>
+          <a:effectRef idx="2">
+            <a:schemeClr val="accent1"/>
+          </a:effectRef>
+          <a:fontRef idx="minor">
+            <a:schemeClr val="lt1"/>
+          </a:fontRef>
+        </p:style>
+        <p:txBody>
+          <a:bodyPr rtlCol="0" anchor="ctr"/>
+          <a:lstStyle/>
+          <a:p>
+            <a:pPr algn="ctr"/>
+          </a:p>
+        </p:txBody>
+      </p:sp>
+      <p:sp>
+        <p:nvSpPr>
+          <p:cNvPr id="102" name="TextBox 101"/>
+          <p:cNvSpPr txBox="1"/>
+          <p:nvPr/>
+        </p:nvSpPr>
+        <p:spPr>
+          <a:xfrm>
+            <a:off x="3904488" y="5614416"/>
+            <a:ext cx="1600200" cy="585216"/>
+          </a:xfrm>
+          <a:prstGeom prst="rect">
+            <a:avLst/>
+          </a:prstGeom>
+          <a:noFill/>
+        </p:spPr>
+        <p:txBody>
+          <a:bodyPr wrap="square" lIns="36576" rIns="36576" tIns="18288" bIns="18288" anchor="ctr">
+            <a:spAutoFit/>
+          </a:bodyPr>
+          <a:lstStyle/>
+          <a:p>
+            <a:pPr algn="l"/>
+            <a:r>
+              <a:rPr sz="1100" b="1">
+                <a:solidFill>
+                  <a:srgbClr val="FFFFFF"/>
+                </a:solidFill>
+                <a:latin typeface="Calibri"/>
+              </a:rPr>
+              <a:t>2  Privacy</a:t>
+            </a:r>
+          </a:p>
+          <a:p>
+            <a:pPr algn="l"/>
+            <a:r>
+              <a:rPr sz="900" b="0">
+                <a:solidFill>
+                  <a:srgbClr val="FFFFFF"/>
+                </a:solidFill>
+                <a:latin typeface="Calibri"/>
+              </a:rPr>
+              <a:t>masking + self-hosted AI</a:t>
+            </a:r>
+          </a:p>
+        </p:txBody>
+      </p:sp>
+      <p:sp>
+        <p:nvSpPr>
+          <p:cNvPr id="103" name="Chevron 102"/>
+          <p:cNvSpPr/>
+          <p:nvPr/>
+        </p:nvSpPr>
+        <p:spPr>
+          <a:xfrm>
+            <a:off x="5687568" y="5614416"/>
+            <a:ext cx="2011680" cy="585216"/>
+          </a:xfrm>
+          <a:prstGeom prst="chevron">
+            <a:avLst>
+              <a:gd name="adj" fmla="val 25000"/>
+            </a:avLst>
+          </a:prstGeom>
+          <a:solidFill>
+            <a:srgbClr val="0E8C8C"/>
+          </a:solidFill>
+          <a:ln>
+            <a:noFill/>
+          </a:ln>
+          <a:effectLst/>
+        </p:spPr>
+        <p:style>
+          <a:lnRef idx="1">
+            <a:schemeClr val="accent1"/>
+          </a:lnRef>
+          <a:fillRef idx="3">
+            <a:schemeClr val="accent1"/>
+          </a:fillRef>
+          <a:effectRef idx="2">
+            <a:schemeClr val="accent1"/>
+          </a:effectRef>
+          <a:fontRef idx="minor">
+            <a:schemeClr val="lt1"/>
+          </a:fontRef>
+        </p:style>
+        <p:txBody>
+          <a:bodyPr rtlCol="0" anchor="ctr"/>
+          <a:lstStyle/>
+          <a:p>
+            <a:pPr algn="ctr"/>
+          </a:p>
+        </p:txBody>
+      </p:sp>
+      <p:sp>
+        <p:nvSpPr>
+          <p:cNvPr id="104" name="TextBox 103"/>
+          <p:cNvSpPr txBox="1"/>
+          <p:nvPr/>
+        </p:nvSpPr>
+        <p:spPr>
+          <a:xfrm>
+            <a:off x="5961888" y="5614416"/>
+            <a:ext cx="1600200" cy="585216"/>
+          </a:xfrm>
+          <a:prstGeom prst="rect">
+            <a:avLst/>
+          </a:prstGeom>
+          <a:noFill/>
+        </p:spPr>
+        <p:txBody>
+          <a:bodyPr wrap="square" lIns="36576" rIns="36576" tIns="18288" bIns="18288" anchor="ctr">
+            <a:spAutoFit/>
+          </a:bodyPr>
+          <a:lstStyle/>
+          <a:p>
+            <a:pPr algn="l"/>
+            <a:r>
+              <a:rPr sz="1100" b="1">
+                <a:solidFill>
+                  <a:srgbClr val="FFFFFF"/>
+                </a:solidFill>
+                <a:latin typeface="Calibri"/>
+              </a:rPr>
+              <a:t>3  On-premise</a:t>
+            </a:r>
+          </a:p>
+          <a:p>
+            <a:pPr algn="l"/>
+            <a:r>
+              <a:rPr sz="900" b="0">
+                <a:solidFill>
+                  <a:srgbClr val="FFFFFF"/>
+                </a:solidFill>
+                <a:latin typeface="Calibri"/>
+              </a:rPr>
+              <a:t>one-command Docker</a:t>
+            </a:r>
+          </a:p>
+        </p:txBody>
+      </p:sp>
+      <p:sp>
+        <p:nvSpPr>
+          <p:cNvPr id="105" name="Chevron 104"/>
+          <p:cNvSpPr/>
+          <p:nvPr/>
+        </p:nvSpPr>
+        <p:spPr>
+          <a:xfrm>
+            <a:off x="7744968" y="5614416"/>
+            <a:ext cx="2011680" cy="585216"/>
+          </a:xfrm>
+          <a:prstGeom prst="chevron">
+            <a:avLst>
+              <a:gd name="adj" fmla="val 25000"/>
+            </a:avLst>
+          </a:prstGeom>
+          <a:solidFill>
+            <a:srgbClr val="F58220"/>
+          </a:solidFill>
+          <a:ln>
+            <a:noFill/>
+          </a:ln>
+          <a:effectLst/>
+        </p:spPr>
+        <p:style>
+          <a:lnRef idx="1">
+            <a:schemeClr val="accent1"/>
+          </a:lnRef>
+          <a:fillRef idx="3">
+            <a:schemeClr val="accent1"/>
+          </a:fillRef>
+          <a:effectRef idx="2">
+            <a:schemeClr val="accent1"/>
+          </a:effectRef>
+          <a:fontRef idx="minor">
+            <a:schemeClr val="lt1"/>
+          </a:fontRef>
+        </p:style>
+        <p:txBody>
+          <a:bodyPr rtlCol="0" anchor="ctr"/>
+          <a:lstStyle/>
+          <a:p>
+            <a:pPr algn="ctr"/>
+          </a:p>
+        </p:txBody>
+      </p:sp>
+      <p:sp>
+        <p:nvSpPr>
+          <p:cNvPr id="106" name="TextBox 105"/>
+          <p:cNvSpPr txBox="1"/>
+          <p:nvPr/>
+        </p:nvSpPr>
+        <p:spPr>
+          <a:xfrm>
+            <a:off x="8019288" y="5614416"/>
+            <a:ext cx="1600200" cy="585216"/>
+          </a:xfrm>
+          <a:prstGeom prst="rect">
+            <a:avLst/>
+          </a:prstGeom>
+          <a:noFill/>
+        </p:spPr>
+        <p:txBody>
+          <a:bodyPr wrap="square" lIns="36576" rIns="36576" tIns="18288" bIns="18288" anchor="ctr">
+            <a:spAutoFit/>
+          </a:bodyPr>
+          <a:lstStyle/>
+          <a:p>
+            <a:pPr algn="l"/>
+            <a:r>
+              <a:rPr sz="1100" b="1">
+                <a:solidFill>
+                  <a:srgbClr val="FFFFFF"/>
+                </a:solidFill>
+                <a:latin typeface="Calibri"/>
+              </a:rPr>
+              <a:t>4  PSU pilot</a:t>
+            </a:r>
+          </a:p>
+          <a:p>
+            <a:pPr algn="l"/>
+            <a:r>
+              <a:rPr sz="900" b="0">
+                <a:solidFill>
+                  <a:srgbClr val="FFFFFF"/>
+                </a:solidFill>
+                <a:latin typeface="Calibri"/>
+              </a:rPr>
+              <a:t>feedback &amp; tuning</a:t>
+            </a:r>
+          </a:p>
+        </p:txBody>
+      </p:sp>
+      <p:sp>
+        <p:nvSpPr>
+          <p:cNvPr id="107" name="Chevron 106"/>
+          <p:cNvSpPr/>
+          <p:nvPr/>
+        </p:nvSpPr>
+        <p:spPr>
+          <a:xfrm>
+            <a:off x="9802368" y="5614416"/>
+            <a:ext cx="2011680" cy="585216"/>
+          </a:xfrm>
+          <a:prstGeom prst="chevron">
+            <a:avLst>
+              <a:gd name="adj" fmla="val 25000"/>
+            </a:avLst>
+          </a:prstGeom>
+          <a:solidFill>
+            <a:srgbClr val="138A36"/>
+          </a:solidFill>
+          <a:ln>
+            <a:noFill/>
+          </a:ln>
+          <a:effectLst/>
+        </p:spPr>
+        <p:style>
+          <a:lnRef idx="1">
+            <a:schemeClr val="accent1"/>
+          </a:lnRef>
+          <a:fillRef idx="3">
+            <a:schemeClr val="accent1"/>
+          </a:fillRef>
+          <a:effectRef idx="2">
+            <a:schemeClr val="accent1"/>
+          </a:effectRef>
+          <a:fontRef idx="minor">
+            <a:schemeClr val="lt1"/>
+          </a:fontRef>
+        </p:style>
+        <p:txBody>
+          <a:bodyPr rtlCol="0" anchor="ctr"/>
+          <a:lstStyle/>
+          <a:p>
+            <a:pPr algn="ctr"/>
+          </a:p>
+        </p:txBody>
+      </p:sp>
+      <p:sp>
+        <p:nvSpPr>
+          <p:cNvPr id="108" name="TextBox 107"/>
+          <p:cNvSpPr txBox="1"/>
+          <p:nvPr/>
+        </p:nvSpPr>
+        <p:spPr>
+          <a:xfrm>
+            <a:off x="10076688" y="5614416"/>
+            <a:ext cx="1600200" cy="585216"/>
+          </a:xfrm>
+          <a:prstGeom prst="rect">
+            <a:avLst/>
+          </a:prstGeom>
+          <a:noFill/>
+        </p:spPr>
+        <p:txBody>
+          <a:bodyPr wrap="square" lIns="36576" rIns="36576" tIns="18288" bIns="18288" anchor="ctr">
+            <a:spAutoFit/>
+          </a:bodyPr>
+          <a:lstStyle/>
+          <a:p>
+            <a:pPr algn="l"/>
+            <a:r>
+              <a:rPr sz="1100" b="1">
+                <a:solidFill>
+                  <a:srgbClr val="FFFFFF"/>
+                </a:solidFill>
+                <a:latin typeface="Calibri"/>
+              </a:rPr>
+              <a:t>5  Scale up</a:t>
+            </a:r>
+          </a:p>
+          <a:p>
+            <a:pPr algn="l"/>
+            <a:r>
+              <a:rPr sz="900" b="0">
+                <a:solidFill>
+                  <a:srgbClr val="FFFFFF"/>
+                </a:solidFill>
+                <a:latin typeface="Calibri"/>
+              </a:rPr>
+              <a:t>sector SOCs → NCIIPC</a:t>
             </a:r>
           </a:p>
         </p:txBody>
@@ -16629,7 +18218,7 @@
                 </a:solidFill>
                 <a:latin typeface="Calibri"/>
               </a:rPr>
-              <a:t>99.5% fewer AI calls means far less computing power and energy used.</a:t>
+              <a:t>AI is used only for new formats, so far less computing power and energy is used.</a:t>
             </a:r>
           </a:p>
         </p:txBody>
@@ -17281,7 +18870,7 @@
                 </a:solidFill>
                 <a:latin typeface="Calibri"/>
               </a:rPr>
-              <a:t>0.5%</a:t>
+              <a:t>~0.5%</a:t>
             </a:r>
           </a:p>
         </p:txBody>
@@ -17365,13 +18954,13 @@
           <a:p>
             <a:pPr algn="ctr"/>
             <a:r>
-              <a:rPr sz="2400" b="1">
+              <a:rPr sz="2000" b="1">
                 <a:solidFill>
                   <a:srgbClr val="138A36"/>
                 </a:solidFill>
                 <a:latin typeface="Calibri"/>
               </a:rPr>
-              <a:t>99.5%</a:t>
+              <a:t>Almost all</a:t>
             </a:r>
           </a:p>
           <a:p>
@@ -17383,7 +18972,7 @@
                 </a:solidFill>
                 <a:latin typeface="Calibri"/>
               </a:rPr>
-              <a:t>fewer AI calls</a:t>
+              <a:t>logs need no AI</a:t>
             </a:r>
           </a:p>
           <a:p>

</xml_diff>

<commit_message>
PPT: show all built features (ready-made formats, security tags, raw line kept, multi-line, dashboard, collector, access key), honest privacy wording, 6-step roadmap with connectors
Co-authored-by: arena-agent <297053741+arena-agent@users.noreply.github.com>
</commit_message>
<xml_diff>
--- a/presentation/SIH2026_Idea_Submission.pptx
+++ b/presentation/SIH2026_Idea_Submission.pptx
@@ -8092,7 +8092,7 @@
         <p:spPr>
           <a:xfrm>
             <a:off x="365760" y="1920240"/>
-            <a:ext cx="11503152" cy="3154680"/>
+            <a:ext cx="11503152" cy="3493008"/>
           </a:xfrm>
           <a:prstGeom prst="roundRect">
             <a:avLst>
@@ -8300,7 +8300,7 @@
         <p:spPr>
           <a:xfrm>
             <a:off x="6144768" y="2423160"/>
-            <a:ext cx="18288" cy="2560320"/>
+            <a:ext cx="18288" cy="2880360"/>
           </a:xfrm>
           <a:prstGeom prst="rect">
             <a:avLst/>
@@ -8344,7 +8344,7 @@
         <p:spPr>
           <a:xfrm>
             <a:off x="548640" y="2688336"/>
-            <a:ext cx="5486400" cy="2331720"/>
+            <a:ext cx="5486400" cy="2743200"/>
           </a:xfrm>
           <a:prstGeom prst="rect">
             <a:avLst/>
@@ -8363,7 +8363,7 @@
               </a:spcAft>
             </a:pPr>
             <a:r>
-              <a:rPr sz="1150" b="1">
+              <a:rPr sz="1100" b="1">
                 <a:solidFill>
                   <a:srgbClr val="1F5FBF"/>
                 </a:solidFill>
@@ -8372,7 +8372,7 @@
               <a:t>•  </a:t>
             </a:r>
             <a:r>
-              <a:rPr sz="1150" b="1">
+              <a:rPr sz="1100" b="1">
                 <a:solidFill>
                   <a:srgbClr val="0B2A5B"/>
                 </a:solidFill>
@@ -8381,13 +8381,13 @@
               <a:t>Collect: </a:t>
             </a:r>
             <a:r>
-              <a:rPr sz="1150" b="0">
+              <a:rPr sz="1100" b="0">
                 <a:solidFill>
                   <a:srgbClr val="1E2530"/>
                 </a:solidFill>
                 <a:latin typeface="Calibri"/>
               </a:rPr>
-              <a:t>logs from any source (servers, apps, firewalls, cloud) arrive through a web API or a small Bash script.</a:t>
+              <a:t>servers, apps, firewalls and cloud send logs through a web API or a Bash collector (syslog, journalctl, Docker, Kubernetes).</a:t>
             </a:r>
           </a:p>
           <a:p>
@@ -8397,7 +8397,7 @@
               </a:spcAft>
             </a:pPr>
             <a:r>
-              <a:rPr sz="1150" b="1">
+              <a:rPr sz="1100" b="1">
                 <a:solidFill>
                   <a:srgbClr val="1F5FBF"/>
                 </a:solidFill>
@@ -8406,22 +8406,22 @@
               <a:t>•  </a:t>
             </a:r>
             <a:r>
-              <a:rPr sz="1150" b="1">
+              <a:rPr sz="1100" b="1">
                 <a:solidFill>
                   <a:srgbClr val="0B2A5B"/>
                 </a:solidFill>
                 <a:latin typeface="Calibri"/>
               </a:rPr>
-              <a:t>Group: </a:t>
-            </a:r>
-            <a:r>
-              <a:rPr sz="1150" b="0">
+              <a:t>Ready-made formats: </a:t>
+            </a:r>
+            <a:r>
+              <a:rPr sz="1100" b="0">
                 <a:solidFill>
                   <a:srgbClr val="1E2530"/>
                 </a:solidFill>
                 <a:latin typeface="Calibri"/>
               </a:rPr>
-              <a:t>similar lines are grouped into patterns, so millions of lines become a few thousand templates.</a:t>
+              <a:t>Syslog, JSON, Apache/Nginx, Java, Kubernetes, PostgreSQL and firewall formats (CEF/LEEF) work at once, without AI.</a:t>
             </a:r>
           </a:p>
           <a:p>
@@ -8431,7 +8431,7 @@
               </a:spcAft>
             </a:pPr>
             <a:r>
-              <a:rPr sz="1150" b="1">
+              <a:rPr sz="1100" b="1">
                 <a:solidFill>
                   <a:srgbClr val="1F5FBF"/>
                 </a:solidFill>
@@ -8440,22 +8440,22 @@
               <a:t>•  </a:t>
             </a:r>
             <a:r>
-              <a:rPr sz="1150" b="1">
+              <a:rPr sz="1100" b="1">
                 <a:solidFill>
                   <a:srgbClr val="0B2A5B"/>
                 </a:solidFill>
                 <a:latin typeface="Calibri"/>
               </a:rPr>
-              <a:t>Check: </a:t>
-            </a:r>
-            <a:r>
-              <a:rPr sz="1150" b="0">
+              <a:t>Group &amp; check: </a:t>
+            </a:r>
+            <a:r>
+              <a:rPr sz="1100" b="0">
                 <a:solidFill>
                   <a:srgbClr val="1E2530"/>
                 </a:solidFill>
                 <a:latin typeface="Calibri"/>
               </a:rPr>
-              <a:t>a light ML model decides whether a pattern is already known or brand new.</a:t>
+              <a:t>similar lines become patterns; a light ML model tells whether a pattern is known or brand new.</a:t>
             </a:r>
           </a:p>
           <a:p>
@@ -8465,7 +8465,7 @@
               </a:spcAft>
             </a:pPr>
             <a:r>
-              <a:rPr sz="1150" b="1">
+              <a:rPr sz="1100" b="1">
                 <a:solidFill>
                   <a:srgbClr val="1F5FBF"/>
                 </a:solidFill>
@@ -8474,7 +8474,7 @@
               <a:t>•  </a:t>
             </a:r>
             <a:r>
-              <a:rPr sz="1150" b="1">
+              <a:rPr sz="1100" b="1">
                 <a:solidFill>
                   <a:srgbClr val="0B2A5B"/>
                 </a:solidFill>
@@ -8483,7 +8483,7 @@
               <a:t>Learn once: </a:t>
             </a:r>
             <a:r>
-              <a:rPr sz="1150" b="0">
+              <a:rPr sz="1100" b="0">
                 <a:solidFill>
                   <a:srgbClr val="1E2530"/>
                 </a:solidFill>
@@ -8499,7 +8499,7 @@
               </a:spcAft>
             </a:pPr>
             <a:r>
-              <a:rPr sz="1150" b="1">
+              <a:rPr sz="1100" b="1">
                 <a:solidFill>
                   <a:srgbClr val="1F5FBF"/>
                 </a:solidFill>
@@ -8508,7 +8508,7 @@
               <a:t>•  </a:t>
             </a:r>
             <a:r>
-              <a:rPr sz="1150" b="1">
+              <a:rPr sz="1100" b="1">
                 <a:solidFill>
                   <a:srgbClr val="0B2A5B"/>
                 </a:solidFill>
@@ -8517,68 +8517,15 @@
               <a:t>Clean output: </a:t>
             </a:r>
             <a:r>
-              <a:rPr sz="1150" b="0">
+              <a:rPr sz="1100" b="0">
                 <a:solidFill>
                   <a:srgbClr val="1E2530"/>
                 </a:solidFill>
                 <a:latin typeface="Calibri"/>
               </a:rPr>
-              <a:t>every log leaves as plain JSON in one format (time, source, event, severity, message), ready for existing search &amp; monitoring tools.</a:t>
-            </a:r>
-          </a:p>
-          <a:p>
-            <a:pPr algn="l"/>
-            <a:r>
-              <a:rPr sz="1150" b="1">
-                <a:solidFill>
-                  <a:srgbClr val="1F5FBF"/>
-                </a:solidFill>
-                <a:latin typeface="Calibri"/>
-              </a:rPr>
-              <a:t>•  </a:t>
-            </a:r>
-            <a:r>
-              <a:rPr sz="1150" b="1">
-                <a:solidFill>
-                  <a:srgbClr val="0B2A5B"/>
-                </a:solidFill>
-                <a:latin typeface="Calibri"/>
-              </a:rPr>
-              <a:t>Safety net: </a:t>
-            </a:r>
-            <a:r>
-              <a:rPr sz="1150" b="0">
-                <a:solidFill>
-                  <a:srgbClr val="1E2530"/>
-                </a:solidFill>
-                <a:latin typeface="Calibri"/>
-              </a:rPr>
-              <a:t>unfamiliar formats are held for review; a backup AI and built-in rules take over if AI is down.</a:t>
-            </a:r>
-          </a:p>
-        </p:txBody>
-      </p:sp>
-      <p:sp>
-        <p:nvSpPr>
-          <p:cNvPr id="66" name="TextBox 65"/>
-          <p:cNvSpPr txBox="1"/>
-          <p:nvPr/>
-        </p:nvSpPr>
-        <p:spPr>
-          <a:xfrm>
-            <a:off x="6355080" y="2688336"/>
-            <a:ext cx="5394960" cy="2331720"/>
-          </a:xfrm>
-          <a:prstGeom prst="rect">
-            <a:avLst/>
-          </a:prstGeom>
-          <a:noFill/>
-        </p:spPr>
-        <p:txBody>
-          <a:bodyPr wrap="square" lIns="36576" rIns="36576" tIns="18288" bIns="18288" anchor="t">
-            <a:spAutoFit/>
-          </a:bodyPr>
-          <a:lstStyle/>
+              <a:t>plain JSON with time (UTC), source, event, severity and message; multi-line errors stay one event; the original line is always kept.</a:t>
+            </a:r>
+          </a:p>
           <a:p>
             <a:pPr algn="l">
               <a:spcAft>
@@ -8586,31 +8533,31 @@
               </a:spcAft>
             </a:pPr>
             <a:r>
-              <a:rPr sz="1150" b="1">
-                <a:solidFill>
-                  <a:srgbClr val="138A36"/>
+              <a:rPr sz="1100" b="1">
+                <a:solidFill>
+                  <a:srgbClr val="1F5FBF"/>
                 </a:solidFill>
                 <a:latin typeface="Calibri"/>
               </a:rPr>
               <a:t>•  </a:t>
             </a:r>
             <a:r>
-              <a:rPr sz="1150" b="1">
-                <a:solidFill>
-                  <a:srgbClr val="C0392B"/>
-                </a:solidFill>
-                <a:latin typeface="Calibri"/>
-              </a:rPr>
-              <a:t>Too many formats → </a:t>
-            </a:r>
-            <a:r>
-              <a:rPr sz="1150" b="0">
+              <a:rPr sz="1100" b="1">
+                <a:solidFill>
+                  <a:srgbClr val="0B2A5B"/>
+                </a:solidFill>
+                <a:latin typeface="Calibri"/>
+              </a:rPr>
+              <a:t>Security tags: </a:t>
+            </a:r>
+            <a:r>
+              <a:rPr sz="1100" b="0">
                 <a:solidFill>
                   <a:srgbClr val="1E2530"/>
                 </a:solidFill>
                 <a:latin typeface="Calibri"/>
               </a:rPr>
-              <a:t>each new format is learned automatically, so any source can be connected.</a:t>
+              <a:t>failed logins, connection errors and database queries are tagged; IPs, users and ports are pulled out.</a:t>
             </a:r>
           </a:p>
           <a:p>
@@ -8620,33 +8567,56 @@
               </a:spcAft>
             </a:pPr>
             <a:r>
-              <a:rPr sz="1150" b="1">
-                <a:solidFill>
-                  <a:srgbClr val="138A36"/>
+              <a:rPr sz="1100" b="1">
+                <a:solidFill>
+                  <a:srgbClr val="1F5FBF"/>
                 </a:solidFill>
                 <a:latin typeface="Calibri"/>
               </a:rPr>
               <a:t>•  </a:t>
             </a:r>
             <a:r>
-              <a:rPr sz="1150" b="1">
-                <a:solidFill>
-                  <a:srgbClr val="C0392B"/>
-                </a:solidFill>
-                <a:latin typeface="Calibri"/>
-              </a:rPr>
-              <a:t>Parsers keep breaking → </a:t>
-            </a:r>
-            <a:r>
-              <a:rPr sz="1150" b="0">
+              <a:rPr sz="1100" b="1">
+                <a:solidFill>
+                  <a:srgbClr val="0B2A5B"/>
+                </a:solidFill>
+                <a:latin typeface="Calibri"/>
+              </a:rPr>
+              <a:t>Safety net: </a:t>
+            </a:r>
+            <a:r>
+              <a:rPr sz="1100" b="0">
                 <a:solidFill>
                   <a:srgbClr val="1E2530"/>
                 </a:solidFill>
                 <a:latin typeface="Calibri"/>
               </a:rPr>
-              <a:t>no hand-written parser code to write, fix or maintain.</a:t>
-            </a:r>
-          </a:p>
+              <a:t>unusual formats wait in a review queue and are learned in one go once they repeat; a backup AI and built-in rules take over if AI is down.</a:t>
+            </a:r>
+          </a:p>
+        </p:txBody>
+      </p:sp>
+      <p:sp>
+        <p:nvSpPr>
+          <p:cNvPr id="66" name="TextBox 65"/>
+          <p:cNvSpPr txBox="1"/>
+          <p:nvPr/>
+        </p:nvSpPr>
+        <p:spPr>
+          <a:xfrm>
+            <a:off x="6355080" y="2688336"/>
+            <a:ext cx="5394960" cy="2743200"/>
+          </a:xfrm>
+          <a:prstGeom prst="rect">
+            <a:avLst/>
+          </a:prstGeom>
+          <a:noFill/>
+        </p:spPr>
+        <p:txBody>
+          <a:bodyPr wrap="square" lIns="36576" rIns="36576" tIns="18288" bIns="18288" anchor="t">
+            <a:spAutoFit/>
+          </a:bodyPr>
+          <a:lstStyle/>
           <a:p>
             <a:pPr algn="l">
               <a:spcAft>
@@ -8654,7 +8624,7 @@
               </a:spcAft>
             </a:pPr>
             <a:r>
-              <a:rPr sz="1150" b="1">
+              <a:rPr sz="1100" b="1">
                 <a:solidFill>
                   <a:srgbClr val="138A36"/>
                 </a:solidFill>
@@ -8663,22 +8633,22 @@
               <a:t>•  </a:t>
             </a:r>
             <a:r>
-              <a:rPr sz="1150" b="1">
+              <a:rPr sz="1100" b="1">
                 <a:solidFill>
                   <a:srgbClr val="C0392B"/>
                 </a:solidFill>
                 <a:latin typeface="Calibri"/>
               </a:rPr>
-              <a:t>AI is slow &amp; costly → </a:t>
-            </a:r>
-            <a:r>
-              <a:rPr sz="1150" b="0">
+              <a:t>Too many formats → </a:t>
+            </a:r>
+            <a:r>
+              <a:rPr sz="1100" b="0">
                 <a:solidFill>
                   <a:srgbClr val="1E2530"/>
                 </a:solidFill>
                 <a:latin typeface="Calibri"/>
               </a:rPr>
-              <a:t>AI runs once per format, not per log; everyday logs use fast saved rules.</a:t>
+              <a:t>common formats work at once and new ones are learned automatically, so any source can be connected.</a:t>
             </a:r>
           </a:p>
           <a:p>
@@ -8688,7 +8658,7 @@
               </a:spcAft>
             </a:pPr>
             <a:r>
-              <a:rPr sz="1150" b="1">
+              <a:rPr sz="1100" b="1">
                 <a:solidFill>
                   <a:srgbClr val="138A36"/>
                 </a:solidFill>
@@ -8697,22 +8667,22 @@
               <a:t>•  </a:t>
             </a:r>
             <a:r>
-              <a:rPr sz="1150" b="1">
+              <a:rPr sz="1100" b="1">
                 <a:solidFill>
                   <a:srgbClr val="C0392B"/>
                 </a:solidFill>
                 <a:latin typeface="Calibri"/>
               </a:rPr>
-              <a:t>Hard to investigate → </a:t>
-            </a:r>
-            <a:r>
-              <a:rPr sz="1150" b="0">
+              <a:t>Parsers keep breaking → </a:t>
+            </a:r>
+            <a:r>
+              <a:rPr sz="1100" b="0">
                 <a:solidFill>
                   <a:srgbClr val="1E2530"/>
                 </a:solidFill>
                 <a:latin typeface="Calibri"/>
               </a:rPr>
-              <a:t>all logs share one clean, time-aligned format, so analysts search one place.</a:t>
+              <a:t>no hand-written parser code to write, fix or maintain.</a:t>
             </a:r>
           </a:p>
           <a:p>
@@ -8722,7 +8692,7 @@
               </a:spcAft>
             </a:pPr>
             <a:r>
-              <a:rPr sz="1150" b="1">
+              <a:rPr sz="1100" b="1">
                 <a:solidFill>
                   <a:srgbClr val="138A36"/>
                 </a:solidFill>
@@ -8731,28 +8701,32 @@
               <a:t>•  </a:t>
             </a:r>
             <a:r>
-              <a:rPr sz="1150" b="1">
+              <a:rPr sz="1100" b="1">
                 <a:solidFill>
                   <a:srgbClr val="C0392B"/>
                 </a:solidFill>
                 <a:latin typeface="Calibri"/>
               </a:rPr>
-              <a:t>Compliance → </a:t>
-            </a:r>
-            <a:r>
-              <a:rPr sz="1150" b="0">
+              <a:t>AI is slow &amp; costly → </a:t>
+            </a:r>
+            <a:r>
+              <a:rPr sz="1100" b="0">
                 <a:solidFill>
                   <a:srgbClr val="1E2530"/>
                 </a:solidFill>
                 <a:latin typeface="Calibri"/>
               </a:rPr>
-              <a:t>clean, searchable logs make it easier to keep 180 days of records, as CERT-In requires.</a:t>
-            </a:r>
-          </a:p>
-          <a:p>
-            <a:pPr algn="l"/>
-            <a:r>
-              <a:rPr sz="1150" b="1">
+              <a:t>AI runs once per format, not per log; everyday logs use fast saved rules.</a:t>
+            </a:r>
+          </a:p>
+          <a:p>
+            <a:pPr algn="l">
+              <a:spcAft>
+                <a:spcPts val="400"/>
+              </a:spcAft>
+            </a:pPr>
+            <a:r>
+              <a:rPr sz="1100" b="1">
                 <a:solidFill>
                   <a:srgbClr val="138A36"/>
                 </a:solidFill>
@@ -8761,22 +8735,124 @@
               <a:t>•  </a:t>
             </a:r>
             <a:r>
-              <a:rPr sz="1150" b="1">
+              <a:rPr sz="1100" b="1">
                 <a:solidFill>
                   <a:srgbClr val="C0392B"/>
                 </a:solidFill>
                 <a:latin typeface="Calibri"/>
               </a:rPr>
+              <a:t>Hard to investigate → </a:t>
+            </a:r>
+            <a:r>
+              <a:rPr sz="1100" b="0">
+                <a:solidFill>
+                  <a:srgbClr val="1E2530"/>
+                </a:solidFill>
+                <a:latin typeface="Calibri"/>
+              </a:rPr>
+              <a:t>all logs share one clean, time-aligned, security-tagged format, so analysts search one place.</a:t>
+            </a:r>
+          </a:p>
+          <a:p>
+            <a:pPr algn="l">
+              <a:spcAft>
+                <a:spcPts val="400"/>
+              </a:spcAft>
+            </a:pPr>
+            <a:r>
+              <a:rPr sz="1100" b="1">
+                <a:solidFill>
+                  <a:srgbClr val="138A36"/>
+                </a:solidFill>
+                <a:latin typeface="Calibri"/>
+              </a:rPr>
+              <a:t>•  </a:t>
+            </a:r>
+            <a:r>
+              <a:rPr sz="1100" b="1">
+                <a:solidFill>
+                  <a:srgbClr val="C0392B"/>
+                </a:solidFill>
+                <a:latin typeface="Calibri"/>
+              </a:rPr>
+              <a:t>Compliance &amp; audits → </a:t>
+            </a:r>
+            <a:r>
+              <a:rPr sz="1100" b="0">
+                <a:solidFill>
+                  <a:srgbClr val="1E2530"/>
+                </a:solidFill>
+                <a:latin typeface="Calibri"/>
+              </a:rPr>
+              <a:t>the original line is kept with every clean record, helping CERT-In's 180-day log rule and forensics.</a:t>
+            </a:r>
+          </a:p>
+          <a:p>
+            <a:pPr algn="l">
+              <a:spcAft>
+                <a:spcPts val="400"/>
+              </a:spcAft>
+            </a:pPr>
+            <a:r>
+              <a:rPr sz="1100" b="1">
+                <a:solidFill>
+                  <a:srgbClr val="138A36"/>
+                </a:solidFill>
+                <a:latin typeface="Calibri"/>
+              </a:rPr>
+              <a:t>•  </a:t>
+            </a:r>
+            <a:r>
+              <a:rPr sz="1100" b="1">
+                <a:solidFill>
+                  <a:srgbClr val="C0392B"/>
+                </a:solidFill>
+                <a:latin typeface="Calibri"/>
+              </a:rPr>
+              <a:t>Tool lock-in → </a:t>
+            </a:r>
+            <a:r>
+              <a:rPr sz="1100" b="0">
+                <a:solidFill>
+                  <a:srgbClr val="1E2530"/>
+                </a:solidFill>
+                <a:latin typeface="Calibri"/>
+              </a:rPr>
+              <a:t>plain JSON output can feed existing search &amp; monitoring tools (ready connectors planned).</a:t>
+            </a:r>
+          </a:p>
+          <a:p>
+            <a:pPr algn="l">
+              <a:spcAft>
+                <a:spcPts val="400"/>
+              </a:spcAft>
+            </a:pPr>
+            <a:r>
+              <a:rPr sz="1100" b="1">
+                <a:solidFill>
+                  <a:srgbClr val="138A36"/>
+                </a:solidFill>
+                <a:latin typeface="Calibri"/>
+              </a:rPr>
+              <a:t>•  </a:t>
+            </a:r>
+            <a:r>
+              <a:rPr sz="1100" b="1">
+                <a:solidFill>
+                  <a:srgbClr val="C0392B"/>
+                </a:solidFill>
+                <a:latin typeface="Calibri"/>
+              </a:rPr>
               <a:t>Data privacy → </a:t>
             </a:r>
             <a:r>
-              <a:rPr sz="1150" b="0">
+              <a:rPr sz="1100" b="0">
                 <a:solidFill>
                   <a:srgbClr val="1E2530"/>
                 </a:solidFill>
                 <a:latin typeface="Calibri"/>
               </a:rPr>
-              <a:t>can run fully on-premise, so sensitive logs stay inside the organisation.</a:t>
+              <a:t>can run on-premise with built-in rules; self-hosted AI (planned) keeps sensitive logs inside the organisation.</a:t>
             </a:r>
           </a:p>
         </p:txBody>
@@ -8789,8 +8865,8 @@
         </p:nvSpPr>
         <p:spPr>
           <a:xfrm>
-            <a:off x="365760" y="5193792"/>
-            <a:ext cx="5486400" cy="274320"/>
+            <a:off x="365760" y="5486400"/>
+            <a:ext cx="5486400" cy="256032"/>
           </a:xfrm>
           <a:prstGeom prst="rect">
             <a:avLst/>
@@ -8824,7 +8900,7 @@
         </p:nvSpPr>
         <p:spPr>
           <a:xfrm>
-            <a:off x="402336" y="5486400"/>
+            <a:off x="402336" y="5751576"/>
             <a:ext cx="822960" cy="41148"/>
           </a:xfrm>
           <a:prstGeom prst="rect">
@@ -8868,8 +8944,8 @@
         </p:nvSpPr>
         <p:spPr>
           <a:xfrm>
-            <a:off x="365760" y="5605272"/>
-            <a:ext cx="2807208" cy="658368"/>
+            <a:off x="365760" y="5833872"/>
+            <a:ext cx="2807208" cy="530352"/>
           </a:xfrm>
           <a:prstGeom prst="roundRect">
             <a:avLst>
@@ -8914,8 +8990,8 @@
         </p:nvSpPr>
         <p:spPr>
           <a:xfrm>
-            <a:off x="365760" y="5696712"/>
-            <a:ext cx="64008" cy="475488"/>
+            <a:off x="365760" y="5897880"/>
+            <a:ext cx="64008" cy="402336"/>
           </a:xfrm>
           <a:prstGeom prst="rect">
             <a:avLst/>
@@ -8958,8 +9034,8 @@
         </p:nvSpPr>
         <p:spPr>
           <a:xfrm>
-            <a:off x="530352" y="5623560"/>
-            <a:ext cx="2578608" cy="621792"/>
+            <a:off x="530352" y="5833872"/>
+            <a:ext cx="2578608" cy="530352"/>
           </a:xfrm>
           <a:prstGeom prst="rect">
             <a:avLst/>
@@ -8974,7 +9050,7 @@
           <a:p>
             <a:pPr algn="l"/>
             <a:r>
-              <a:rPr sz="1250" b="1">
+              <a:rPr sz="1100" b="1">
                 <a:solidFill>
                   <a:srgbClr val="1F5FBF"/>
                 </a:solidFill>
@@ -9005,8 +9081,8 @@
         </p:nvSpPr>
         <p:spPr>
           <a:xfrm>
-            <a:off x="3264408" y="5605272"/>
-            <a:ext cx="2807208" cy="658368"/>
+            <a:off x="3264408" y="5833872"/>
+            <a:ext cx="2807208" cy="530352"/>
           </a:xfrm>
           <a:prstGeom prst="roundRect">
             <a:avLst>
@@ -9051,8 +9127,8 @@
         </p:nvSpPr>
         <p:spPr>
           <a:xfrm>
-            <a:off x="3264408" y="5696712"/>
-            <a:ext cx="64008" cy="475488"/>
+            <a:off x="3264408" y="5897880"/>
+            <a:ext cx="64008" cy="402336"/>
           </a:xfrm>
           <a:prstGeom prst="rect">
             <a:avLst/>
@@ -9095,8 +9171,8 @@
         </p:nvSpPr>
         <p:spPr>
           <a:xfrm>
-            <a:off x="3429000" y="5623560"/>
-            <a:ext cx="2578608" cy="621792"/>
+            <a:off x="3429000" y="5833872"/>
+            <a:ext cx="2578608" cy="530352"/>
           </a:xfrm>
           <a:prstGeom prst="rect">
             <a:avLst/>
@@ -9111,7 +9187,7 @@
           <a:p>
             <a:pPr algn="l"/>
             <a:r>
-              <a:rPr sz="1250" b="1">
+              <a:rPr sz="1100" b="1">
                 <a:solidFill>
                   <a:srgbClr val="F58220"/>
                 </a:solidFill>
@@ -9142,8 +9218,8 @@
         </p:nvSpPr>
         <p:spPr>
           <a:xfrm>
-            <a:off x="6163056" y="5605272"/>
-            <a:ext cx="2807208" cy="658368"/>
+            <a:off x="6163056" y="5833872"/>
+            <a:ext cx="2807208" cy="530352"/>
           </a:xfrm>
           <a:prstGeom prst="roundRect">
             <a:avLst>
@@ -9188,8 +9264,8 @@
         </p:nvSpPr>
         <p:spPr>
           <a:xfrm>
-            <a:off x="6163056" y="5696712"/>
-            <a:ext cx="64008" cy="475488"/>
+            <a:off x="6163056" y="5897880"/>
+            <a:ext cx="64008" cy="402336"/>
           </a:xfrm>
           <a:prstGeom prst="rect">
             <a:avLst/>
@@ -9232,8 +9308,8 @@
         </p:nvSpPr>
         <p:spPr>
           <a:xfrm>
-            <a:off x="6327648" y="5623560"/>
-            <a:ext cx="2578608" cy="621792"/>
+            <a:off x="6327648" y="5833872"/>
+            <a:ext cx="2578608" cy="530352"/>
           </a:xfrm>
           <a:prstGeom prst="rect">
             <a:avLst/>
@@ -9248,7 +9324,7 @@
           <a:p>
             <a:pPr algn="l"/>
             <a:r>
-              <a:rPr sz="1250" b="1">
+              <a:rPr sz="1100" b="1">
                 <a:solidFill>
                   <a:srgbClr val="6A3FB5"/>
                 </a:solidFill>
@@ -9279,8 +9355,8 @@
         </p:nvSpPr>
         <p:spPr>
           <a:xfrm>
-            <a:off x="9061704" y="5605272"/>
-            <a:ext cx="2807208" cy="658368"/>
+            <a:off x="9061704" y="5833872"/>
+            <a:ext cx="2807208" cy="530352"/>
           </a:xfrm>
           <a:prstGeom prst="roundRect">
             <a:avLst>
@@ -9325,8 +9401,8 @@
         </p:nvSpPr>
         <p:spPr>
           <a:xfrm>
-            <a:off x="9061704" y="5696712"/>
-            <a:ext cx="64008" cy="475488"/>
+            <a:off x="9061704" y="5897880"/>
+            <a:ext cx="64008" cy="402336"/>
           </a:xfrm>
           <a:prstGeom prst="rect">
             <a:avLst/>
@@ -9369,8 +9445,8 @@
         </p:nvSpPr>
         <p:spPr>
           <a:xfrm>
-            <a:off x="9226296" y="5623560"/>
-            <a:ext cx="2578608" cy="621792"/>
+            <a:off x="9226296" y="5833872"/>
+            <a:ext cx="2578608" cy="530352"/>
           </a:xfrm>
           <a:prstGeom prst="rect">
             <a:avLst/>
@@ -9385,13 +9461,13 @@
           <a:p>
             <a:pPr algn="l"/>
             <a:r>
-              <a:rPr sz="1250" b="1">
+              <a:rPr sz="1100" b="1">
                 <a:solidFill>
                   <a:srgbClr val="138A36"/>
                 </a:solidFill>
                 <a:latin typeface="Calibri"/>
               </a:rPr>
-              <a:t>Works offline</a:t>
+              <a:t>Security-aware</a:t>
             </a:r>
           </a:p>
           <a:p>
@@ -9403,7 +9479,7 @@
                 </a:solidFill>
                 <a:latin typeface="Calibri"/>
               </a:rPr>
-              <a:t>data stays in India</a:t>
+              <a:t>tags failed logins, IPs &amp; users</a:t>
             </a:r>
           </a:p>
         </p:txBody>
@@ -10369,7 +10445,7 @@
                 </a:solidFill>
                 <a:latin typeface="Calibri"/>
               </a:rPr>
-              <a:t>unusual formats</a:t>
+              <a:t>learned once it repeats</a:t>
             </a:r>
           </a:p>
         </p:txBody>
@@ -12182,7 +12258,7 @@
                 </a:solidFill>
                 <a:latin typeface="Calibri"/>
               </a:rPr>
-              <a:t>Data analysis: </a:t>
+              <a:t>Quality reports: </a:t>
             </a:r>
             <a:r>
               <a:rPr sz="850" b="0">
@@ -12191,7 +12267,7 @@
                 </a:solidFill>
                 <a:latin typeface="Calibri"/>
               </a:rPr>
-              <a:t>summarises log statistics &amp; reports</a:t>
+              <a:t>checks output quality offline</a:t>
             </a:r>
           </a:p>
         </p:txBody>
@@ -12365,7 +12441,7 @@
                 </a:solidFill>
                 <a:latin typeface="Calibri"/>
               </a:rPr>
-              <a:t>Collects system logs: </a:t>
+              <a:t>Collects logs: </a:t>
             </a:r>
             <a:r>
               <a:rPr sz="850" b="0">
@@ -12374,7 +12450,7 @@
                 </a:solidFill>
                 <a:latin typeface="Calibri"/>
               </a:rPr>
-              <a:t>runs on any Linux server</a:t>
+              <a:t>syslog, journalctl, Docker, Kubernetes</a:t>
             </a:r>
           </a:p>
         </p:txBody>
@@ -12921,7 +12997,7 @@
         <p:spPr>
           <a:xfrm>
             <a:off x="365760" y="4480560"/>
-            <a:ext cx="4937760" cy="868680"/>
+            <a:ext cx="4937760" cy="694944"/>
           </a:xfrm>
           <a:prstGeom prst="roundRect">
             <a:avLst>
@@ -12968,8 +13044,8 @@
         </p:nvSpPr>
         <p:spPr>
           <a:xfrm>
-            <a:off x="457200" y="4526280"/>
-            <a:ext cx="4754880" cy="777240"/>
+            <a:off x="457200" y="4498848"/>
+            <a:ext cx="4754880" cy="658368"/>
           </a:xfrm>
           <a:prstGeom prst="rect">
             <a:avLst/>
@@ -12994,7 +13070,7 @@
                 </a:solidFill>
                 <a:latin typeface="Consolas"/>
               </a:rPr>
-              <a:t>&lt;34&gt;Oct 11 22:14:15 srv1 sshd: Failed password</a:t>
+              <a:t>&lt;34&gt;Oct 11 22:14:15 srv1 sshd: Failed password for root</a:t>
             </a:r>
           </a:p>
           <a:p>
@@ -13010,7 +13086,7 @@
                 </a:solidFill>
                 <a:latin typeface="Consolas"/>
               </a:rPr>
-              <a:t>{"t":"22:14:16Z","lvl":"ERROR","msg":"DB timeout"}</a:t>
+              <a:t>{"t":"22:14:16Z","lvl":"ERROR","msg":"DB connection timeout"}</a:t>
             </a:r>
           </a:p>
           <a:p>
@@ -13035,8 +13111,8 @@
         </p:nvSpPr>
         <p:spPr>
           <a:xfrm>
-            <a:off x="365760" y="5340096"/>
-            <a:ext cx="4937760" cy="237744"/>
+            <a:off x="365760" y="5175504"/>
+            <a:ext cx="4937760" cy="219456"/>
           </a:xfrm>
           <a:prstGeom prst="rect">
             <a:avLst/>
@@ -13064,14 +13140,49 @@
       </p:sp>
       <p:sp>
         <p:nvSpPr>
+          <p:cNvPr id="136" name="TextBox 94"/>
+          <p:cNvSpPr txBox="1"/>
+          <p:nvPr/>
+        </p:nvSpPr>
+        <p:spPr>
+          <a:xfrm>
+            <a:off x="365760" y="6153912"/>
+            <a:ext cx="4937760" cy="201168"/>
+          </a:xfrm>
+          <a:prstGeom prst="rect">
+            <a:avLst/>
+          </a:prstGeom>
+          <a:noFill/>
+        </p:spPr>
+        <p:txBody>
+          <a:bodyPr wrap="square" lIns="36576" rIns="36576" tIns="18288" bIns="18288" anchor="t">
+            <a:spAutoFit/>
+          </a:bodyPr>
+          <a:lstStyle/>
+          <a:p>
+            <a:pPr algn="ctr"/>
+            <a:r>
+              <a:rPr sz="850" b="0" i="1">
+                <a:solidFill>
+                  <a:srgbClr val="555F6D"/>
+                </a:solidFill>
+                <a:latin typeface="Calibri"/>
+              </a:rPr>
+              <a:t>Every record also keeps the original line and extra fields (IPs, users, ports) for audits.</a:t>
+            </a:r>
+          </a:p>
+        </p:txBody>
+      </p:sp>
+      <p:sp>
+        <p:nvSpPr>
           <p:cNvPr id="96" name="Rectangle 95"/>
           <p:cNvSpPr/>
           <p:nvPr/>
         </p:nvSpPr>
         <p:spPr>
           <a:xfrm>
-            <a:off x="365760" y="5577840"/>
-            <a:ext cx="1051560" cy="201168"/>
+            <a:off x="365760" y="5394960"/>
+            <a:ext cx="713232" cy="201168"/>
           </a:xfrm>
           <a:prstGeom prst="rect">
             <a:avLst/>
@@ -13114,8 +13225,8 @@
         </p:nvSpPr>
         <p:spPr>
           <a:xfrm>
-            <a:off x="365760" y="5577840"/>
-            <a:ext cx="1051560" cy="201168"/>
+            <a:off x="365760" y="5394960"/>
+            <a:ext cx="713232" cy="201168"/>
           </a:xfrm>
           <a:prstGeom prst="rect">
             <a:avLst/>
@@ -13149,8 +13260,8 @@
         </p:nvSpPr>
         <p:spPr>
           <a:xfrm>
-            <a:off x="1417320" y="5577840"/>
-            <a:ext cx="868680" cy="201168"/>
+            <a:off x="1078992" y="5394960"/>
+            <a:ext cx="640080" cy="201168"/>
           </a:xfrm>
           <a:prstGeom prst="rect">
             <a:avLst/>
@@ -13193,8 +13304,8 @@
         </p:nvSpPr>
         <p:spPr>
           <a:xfrm>
-            <a:off x="1417320" y="5577840"/>
-            <a:ext cx="868680" cy="201168"/>
+            <a:off x="1078992" y="5394960"/>
+            <a:ext cx="640080" cy="201168"/>
           </a:xfrm>
           <a:prstGeom prst="rect">
             <a:avLst/>
@@ -13228,8 +13339,8 @@
         </p:nvSpPr>
         <p:spPr>
           <a:xfrm>
-            <a:off x="2286000" y="5577840"/>
-            <a:ext cx="914400" cy="201168"/>
+            <a:off x="1719072" y="5394960"/>
+            <a:ext cx="777240" cy="201168"/>
           </a:xfrm>
           <a:prstGeom prst="rect">
             <a:avLst/>
@@ -13266,49 +13377,14 @@
       </p:sp>
       <p:sp>
         <p:nvSpPr>
-          <p:cNvPr id="101" name="TextBox 100"/>
-          <p:cNvSpPr txBox="1"/>
-          <p:nvPr/>
-        </p:nvSpPr>
-        <p:spPr>
-          <a:xfrm>
-            <a:off x="2286000" y="5577840"/>
-            <a:ext cx="914400" cy="201168"/>
-          </a:xfrm>
-          <a:prstGeom prst="rect">
-            <a:avLst/>
-          </a:prstGeom>
-          <a:noFill/>
-        </p:spPr>
-        <p:txBody>
-          <a:bodyPr wrap="square" lIns="36576" rIns="36576" tIns="18288" bIns="18288" anchor="ctr">
-            <a:spAutoFit/>
-          </a:bodyPr>
-          <a:lstStyle/>
-          <a:p>
-            <a:pPr algn="l"/>
-            <a:r>
-              <a:rPr sz="900" b="1">
-                <a:solidFill>
-                  <a:srgbClr val="FFFFFF"/>
-                </a:solidFill>
-                <a:latin typeface="Calibri"/>
-              </a:rPr>
-              <a:t>Severity</a:t>
-            </a:r>
-          </a:p>
-        </p:txBody>
-      </p:sp>
-      <p:sp>
-        <p:nvSpPr>
-          <p:cNvPr id="102" name="Rectangle 101"/>
+          <p:cNvPr id="128" name="Rectangle 99"/>
           <p:cNvSpPr/>
           <p:nvPr/>
         </p:nvSpPr>
         <p:spPr>
           <a:xfrm>
-            <a:off x="3200400" y="5577840"/>
-            <a:ext cx="2103120" cy="201168"/>
+            <a:off x="2496312" y="5394960"/>
+            <a:ext cx="1097280" cy="201168"/>
           </a:xfrm>
           <a:prstGeom prst="rect">
             <a:avLst/>
@@ -13345,14 +13421,14 @@
       </p:sp>
       <p:sp>
         <p:nvSpPr>
-          <p:cNvPr id="103" name="TextBox 102"/>
+          <p:cNvPr id="101" name="TextBox 100"/>
           <p:cNvSpPr txBox="1"/>
           <p:nvPr/>
         </p:nvSpPr>
         <p:spPr>
           <a:xfrm>
-            <a:off x="3200400" y="5577840"/>
-            <a:ext cx="2103120" cy="201168"/>
+            <a:off x="1719072" y="5394960"/>
+            <a:ext cx="777240" cy="201168"/>
           </a:xfrm>
           <a:prstGeom prst="rect">
             <a:avLst/>
@@ -13373,6 +13449,120 @@
                 </a:solidFill>
                 <a:latin typeface="Calibri"/>
               </a:rPr>
+              <a:t>Severity</a:t>
+            </a:r>
+          </a:p>
+        </p:txBody>
+      </p:sp>
+      <p:sp>
+        <p:nvSpPr>
+          <p:cNvPr id="129" name="TextBox 100"/>
+          <p:cNvSpPr txBox="1"/>
+          <p:nvPr/>
+        </p:nvSpPr>
+        <p:spPr>
+          <a:xfrm>
+            <a:off x="2496312" y="5394960"/>
+            <a:ext cx="1097280" cy="201168"/>
+          </a:xfrm>
+          <a:prstGeom prst="rect">
+            <a:avLst/>
+          </a:prstGeom>
+          <a:noFill/>
+        </p:spPr>
+        <p:txBody>
+          <a:bodyPr wrap="square" lIns="36576" rIns="36576" tIns="18288" bIns="18288" anchor="ctr">
+            <a:spAutoFit/>
+          </a:bodyPr>
+          <a:lstStyle/>
+          <a:p>
+            <a:pPr algn="l"/>
+            <a:r>
+              <a:rPr sz="900" b="1">
+                <a:solidFill>
+                  <a:srgbClr val="FFFFFF"/>
+                </a:solidFill>
+                <a:latin typeface="Calibri"/>
+              </a:rPr>
+              <a:t>Event tag</a:t>
+            </a:r>
+          </a:p>
+        </p:txBody>
+      </p:sp>
+      <p:sp>
+        <p:nvSpPr>
+          <p:cNvPr id="102" name="Rectangle 101"/>
+          <p:cNvSpPr/>
+          <p:nvPr/>
+        </p:nvSpPr>
+        <p:spPr>
+          <a:xfrm>
+            <a:off x="3593592" y="5394960"/>
+            <a:ext cx="1709928" cy="201168"/>
+          </a:xfrm>
+          <a:prstGeom prst="rect">
+            <a:avLst/>
+          </a:prstGeom>
+          <a:solidFill>
+            <a:srgbClr val="138A36"/>
+          </a:solidFill>
+          <a:ln>
+            <a:noFill/>
+          </a:ln>
+          <a:effectLst/>
+        </p:spPr>
+        <p:style>
+          <a:lnRef idx="1">
+            <a:schemeClr val="accent1"/>
+          </a:lnRef>
+          <a:fillRef idx="3">
+            <a:schemeClr val="accent1"/>
+          </a:fillRef>
+          <a:effectRef idx="2">
+            <a:schemeClr val="accent1"/>
+          </a:effectRef>
+          <a:fontRef idx="minor">
+            <a:schemeClr val="lt1"/>
+          </a:fontRef>
+        </p:style>
+        <p:txBody>
+          <a:bodyPr rtlCol="0" anchor="ctr"/>
+          <a:lstStyle/>
+          <a:p>
+            <a:pPr algn="ctr"/>
+          </a:p>
+        </p:txBody>
+      </p:sp>
+      <p:sp>
+        <p:nvSpPr>
+          <p:cNvPr id="103" name="TextBox 102"/>
+          <p:cNvSpPr txBox="1"/>
+          <p:nvPr/>
+        </p:nvSpPr>
+        <p:spPr>
+          <a:xfrm>
+            <a:off x="3593592" y="5394960"/>
+            <a:ext cx="1709928" cy="201168"/>
+          </a:xfrm>
+          <a:prstGeom prst="rect">
+            <a:avLst/>
+          </a:prstGeom>
+          <a:noFill/>
+        </p:spPr>
+        <p:txBody>
+          <a:bodyPr wrap="square" lIns="36576" rIns="36576" tIns="18288" bIns="18288" anchor="ctr">
+            <a:spAutoFit/>
+          </a:bodyPr>
+          <a:lstStyle/>
+          <a:p>
+            <a:pPr algn="l"/>
+            <a:r>
+              <a:rPr sz="900" b="1">
+                <a:solidFill>
+                  <a:srgbClr val="FFFFFF"/>
+                </a:solidFill>
+                <a:latin typeface="Calibri"/>
+              </a:rPr>
               <a:t>Message</a:t>
             </a:r>
           </a:p>
@@ -13386,8 +13576,8 @@
         </p:nvSpPr>
         <p:spPr>
           <a:xfrm>
-            <a:off x="365760" y="5779008"/>
-            <a:ext cx="1051560" cy="182880"/>
+            <a:off x="365760" y="5596128"/>
+            <a:ext cx="713232" cy="182880"/>
           </a:xfrm>
           <a:prstGeom prst="rect">
             <a:avLst/>
@@ -13432,8 +13622,8 @@
         </p:nvSpPr>
         <p:spPr>
           <a:xfrm>
-            <a:off x="365760" y="5779008"/>
-            <a:ext cx="1051560" cy="182880"/>
+            <a:off x="365760" y="5596128"/>
+            <a:ext cx="713232" cy="182880"/>
           </a:xfrm>
           <a:prstGeom prst="rect">
             <a:avLst/>
@@ -13467,8 +13657,8 @@
         </p:nvSpPr>
         <p:spPr>
           <a:xfrm>
-            <a:off x="1417320" y="5779008"/>
-            <a:ext cx="868680" cy="182880"/>
+            <a:off x="1078992" y="5596128"/>
+            <a:ext cx="640080" cy="182880"/>
           </a:xfrm>
           <a:prstGeom prst="rect">
             <a:avLst/>
@@ -13513,8 +13703,8 @@
         </p:nvSpPr>
         <p:spPr>
           <a:xfrm>
-            <a:off x="1417320" y="5779008"/>
-            <a:ext cx="868680" cy="182880"/>
+            <a:off x="1078992" y="5596128"/>
+            <a:ext cx="640080" cy="182880"/>
           </a:xfrm>
           <a:prstGeom prst="rect">
             <a:avLst/>
@@ -13548,8 +13738,8 @@
         </p:nvSpPr>
         <p:spPr>
           <a:xfrm>
-            <a:off x="2286000" y="5779008"/>
-            <a:ext cx="914400" cy="182880"/>
+            <a:off x="1719072" y="5596128"/>
+            <a:ext cx="777240" cy="182880"/>
           </a:xfrm>
           <a:prstGeom prst="rect">
             <a:avLst/>
@@ -13588,49 +13778,14 @@
       </p:sp>
       <p:sp>
         <p:nvSpPr>
-          <p:cNvPr id="109" name="TextBox 108"/>
-          <p:cNvSpPr txBox="1"/>
-          <p:nvPr/>
-        </p:nvSpPr>
-        <p:spPr>
-          <a:xfrm>
-            <a:off x="2286000" y="5779008"/>
-            <a:ext cx="914400" cy="182880"/>
-          </a:xfrm>
-          <a:prstGeom prst="rect">
-            <a:avLst/>
-          </a:prstGeom>
-          <a:noFill/>
-        </p:spPr>
-        <p:txBody>
-          <a:bodyPr wrap="square" lIns="36576" rIns="36576" tIns="18288" bIns="18288" anchor="ctr">
-            <a:spAutoFit/>
-          </a:bodyPr>
-          <a:lstStyle/>
-          <a:p>
-            <a:pPr algn="l"/>
-            <a:r>
-              <a:rPr sz="850" b="1">
-                <a:solidFill>
-                  <a:srgbClr val="B35C00"/>
-                </a:solidFill>
-                <a:latin typeface="Calibri"/>
-              </a:rPr>
-              <a:t>WARNING</a:t>
-            </a:r>
-          </a:p>
-        </p:txBody>
-      </p:sp>
-      <p:sp>
-        <p:nvSpPr>
-          <p:cNvPr id="110" name="Rectangle 109"/>
+          <p:cNvPr id="130" name="Rectangle 107"/>
           <p:cNvSpPr/>
           <p:nvPr/>
         </p:nvSpPr>
         <p:spPr>
           <a:xfrm>
-            <a:off x="3200400" y="5779008"/>
-            <a:ext cx="2103120" cy="182880"/>
+            <a:off x="2496312" y="5596128"/>
+            <a:ext cx="1097280" cy="182880"/>
           </a:xfrm>
           <a:prstGeom prst="rect">
             <a:avLst/>
@@ -13669,14 +13824,14 @@
       </p:sp>
       <p:sp>
         <p:nvSpPr>
-          <p:cNvPr id="111" name="TextBox 110"/>
+          <p:cNvPr id="109" name="TextBox 108"/>
           <p:cNvSpPr txBox="1"/>
           <p:nvPr/>
         </p:nvSpPr>
         <p:spPr>
           <a:xfrm>
-            <a:off x="3200400" y="5779008"/>
-            <a:ext cx="2103120" cy="182880"/>
+            <a:off x="1719072" y="5596128"/>
+            <a:ext cx="777240" cy="182880"/>
           </a:xfrm>
           <a:prstGeom prst="rect">
             <a:avLst/>
@@ -13691,6 +13846,122 @@
           <a:p>
             <a:pPr algn="l"/>
             <a:r>
+              <a:rPr sz="850" b="1">
+                <a:solidFill>
+                  <a:srgbClr val="B35C00"/>
+                </a:solidFill>
+                <a:latin typeface="Calibri"/>
+              </a:rPr>
+              <a:t>WARNING</a:t>
+            </a:r>
+          </a:p>
+        </p:txBody>
+      </p:sp>
+      <p:sp>
+        <p:nvSpPr>
+          <p:cNvPr id="131" name="TextBox 108"/>
+          <p:cNvSpPr txBox="1"/>
+          <p:nvPr/>
+        </p:nvSpPr>
+        <p:spPr>
+          <a:xfrm>
+            <a:off x="2496312" y="5596128"/>
+            <a:ext cx="1097280" cy="182880"/>
+          </a:xfrm>
+          <a:prstGeom prst="rect">
+            <a:avLst/>
+          </a:prstGeom>
+          <a:noFill/>
+        </p:spPr>
+        <p:txBody>
+          <a:bodyPr wrap="square" lIns="36576" rIns="36576" tIns="18288" bIns="18288" anchor="ctr">
+            <a:spAutoFit/>
+          </a:bodyPr>
+          <a:lstStyle/>
+          <a:p>
+            <a:pPr algn="l"/>
+            <a:r>
+              <a:rPr sz="800" b="1">
+                <a:solidFill>
+                  <a:srgbClr val="6A3FB5"/>
+                </a:solidFill>
+                <a:latin typeface="Calibri"/>
+              </a:rPr>
+              <a:t>auth_failure</a:t>
+            </a:r>
+          </a:p>
+        </p:txBody>
+      </p:sp>
+      <p:sp>
+        <p:nvSpPr>
+          <p:cNvPr id="110" name="Rectangle 109"/>
+          <p:cNvSpPr/>
+          <p:nvPr/>
+        </p:nvSpPr>
+        <p:spPr>
+          <a:xfrm>
+            <a:off x="3593592" y="5596128"/>
+            <a:ext cx="1709928" cy="182880"/>
+          </a:xfrm>
+          <a:prstGeom prst="rect">
+            <a:avLst/>
+          </a:prstGeom>
+          <a:solidFill>
+            <a:srgbClr val="FFFFFF"/>
+          </a:solidFill>
+          <a:ln w="6350">
+            <a:solidFill>
+              <a:srgbClr val="D3DBE8"/>
+            </a:solidFill>
+          </a:ln>
+          <a:effectLst/>
+        </p:spPr>
+        <p:style>
+          <a:lnRef idx="1">
+            <a:schemeClr val="accent1"/>
+          </a:lnRef>
+          <a:fillRef idx="3">
+            <a:schemeClr val="accent1"/>
+          </a:fillRef>
+          <a:effectRef idx="2">
+            <a:schemeClr val="accent1"/>
+          </a:effectRef>
+          <a:fontRef idx="minor">
+            <a:schemeClr val="lt1"/>
+          </a:fontRef>
+        </p:style>
+        <p:txBody>
+          <a:bodyPr rtlCol="0" anchor="ctr"/>
+          <a:lstStyle/>
+          <a:p>
+            <a:pPr algn="ctr"/>
+          </a:p>
+        </p:txBody>
+      </p:sp>
+      <p:sp>
+        <p:nvSpPr>
+          <p:cNvPr id="111" name="TextBox 110"/>
+          <p:cNvSpPr txBox="1"/>
+          <p:nvPr/>
+        </p:nvSpPr>
+        <p:spPr>
+          <a:xfrm>
+            <a:off x="3593592" y="5596128"/>
+            <a:ext cx="1709928" cy="182880"/>
+          </a:xfrm>
+          <a:prstGeom prst="rect">
+            <a:avLst/>
+          </a:prstGeom>
+          <a:noFill/>
+        </p:spPr>
+        <p:txBody>
+          <a:bodyPr wrap="square" lIns="36576" rIns="36576" tIns="18288" bIns="18288" anchor="ctr">
+            <a:spAutoFit/>
+          </a:bodyPr>
+          <a:lstStyle/>
+          <a:p>
+            <a:pPr algn="l"/>
+            <a:r>
               <a:rPr sz="850" b="0">
                 <a:solidFill>
                   <a:srgbClr val="1E2530"/>
@@ -13710,8 +13981,8 @@
         </p:nvSpPr>
         <p:spPr>
           <a:xfrm>
-            <a:off x="365760" y="5961888"/>
-            <a:ext cx="1051560" cy="182880"/>
+            <a:off x="365760" y="5779008"/>
+            <a:ext cx="713232" cy="182880"/>
           </a:xfrm>
           <a:prstGeom prst="rect">
             <a:avLst/>
@@ -13756,8 +14027,8 @@
         </p:nvSpPr>
         <p:spPr>
           <a:xfrm>
-            <a:off x="365760" y="5961888"/>
-            <a:ext cx="1051560" cy="182880"/>
+            <a:off x="365760" y="5779008"/>
+            <a:ext cx="713232" cy="182880"/>
           </a:xfrm>
           <a:prstGeom prst="rect">
             <a:avLst/>
@@ -13791,8 +14062,8 @@
         </p:nvSpPr>
         <p:spPr>
           <a:xfrm>
-            <a:off x="1417320" y="5961888"/>
-            <a:ext cx="868680" cy="182880"/>
+            <a:off x="1078992" y="5779008"/>
+            <a:ext cx="640080" cy="182880"/>
           </a:xfrm>
           <a:prstGeom prst="rect">
             <a:avLst/>
@@ -13837,8 +14108,8 @@
         </p:nvSpPr>
         <p:spPr>
           <a:xfrm>
-            <a:off x="1417320" y="5961888"/>
-            <a:ext cx="868680" cy="182880"/>
+            <a:off x="1078992" y="5779008"/>
+            <a:ext cx="640080" cy="182880"/>
           </a:xfrm>
           <a:prstGeom prst="rect">
             <a:avLst/>
@@ -13872,8 +14143,8 @@
         </p:nvSpPr>
         <p:spPr>
           <a:xfrm>
-            <a:off x="2286000" y="5961888"/>
-            <a:ext cx="914400" cy="182880"/>
+            <a:off x="1719072" y="5779008"/>
+            <a:ext cx="777240" cy="182880"/>
           </a:xfrm>
           <a:prstGeom prst="rect">
             <a:avLst/>
@@ -13912,49 +14183,14 @@
       </p:sp>
       <p:sp>
         <p:nvSpPr>
-          <p:cNvPr id="117" name="TextBox 116"/>
-          <p:cNvSpPr txBox="1"/>
-          <p:nvPr/>
-        </p:nvSpPr>
-        <p:spPr>
-          <a:xfrm>
-            <a:off x="2286000" y="5961888"/>
-            <a:ext cx="914400" cy="182880"/>
-          </a:xfrm>
-          <a:prstGeom prst="rect">
-            <a:avLst/>
-          </a:prstGeom>
-          <a:noFill/>
-        </p:spPr>
-        <p:txBody>
-          <a:bodyPr wrap="square" lIns="36576" rIns="36576" tIns="18288" bIns="18288" anchor="ctr">
-            <a:spAutoFit/>
-          </a:bodyPr>
-          <a:lstStyle/>
-          <a:p>
-            <a:pPr algn="l"/>
-            <a:r>
-              <a:rPr sz="850" b="1">
-                <a:solidFill>
-                  <a:srgbClr val="C0392B"/>
-                </a:solidFill>
-                <a:latin typeface="Calibri"/>
-              </a:rPr>
-              <a:t>ERROR</a:t>
-            </a:r>
-          </a:p>
-        </p:txBody>
-      </p:sp>
-      <p:sp>
-        <p:nvSpPr>
-          <p:cNvPr id="118" name="Rectangle 117"/>
+          <p:cNvPr id="132" name="Rectangle 115"/>
           <p:cNvSpPr/>
           <p:nvPr/>
         </p:nvSpPr>
         <p:spPr>
           <a:xfrm>
-            <a:off x="3200400" y="5961888"/>
-            <a:ext cx="2103120" cy="182880"/>
+            <a:off x="2496312" y="5779008"/>
+            <a:ext cx="1097280" cy="182880"/>
           </a:xfrm>
           <a:prstGeom prst="rect">
             <a:avLst/>
@@ -13993,14 +14229,14 @@
       </p:sp>
       <p:sp>
         <p:nvSpPr>
-          <p:cNvPr id="119" name="TextBox 118"/>
+          <p:cNvPr id="117" name="TextBox 116"/>
           <p:cNvSpPr txBox="1"/>
           <p:nvPr/>
         </p:nvSpPr>
         <p:spPr>
           <a:xfrm>
-            <a:off x="3200400" y="5961888"/>
-            <a:ext cx="2103120" cy="182880"/>
+            <a:off x="1719072" y="5779008"/>
+            <a:ext cx="777240" cy="182880"/>
           </a:xfrm>
           <a:prstGeom prst="rect">
             <a:avLst/>
@@ -14015,13 +14251,129 @@
           <a:p>
             <a:pPr algn="l"/>
             <a:r>
+              <a:rPr sz="850" b="1">
+                <a:solidFill>
+                  <a:srgbClr val="C0392B"/>
+                </a:solidFill>
+                <a:latin typeface="Calibri"/>
+              </a:rPr>
+              <a:t>ERROR</a:t>
+            </a:r>
+          </a:p>
+        </p:txBody>
+      </p:sp>
+      <p:sp>
+        <p:nvSpPr>
+          <p:cNvPr id="133" name="TextBox 116"/>
+          <p:cNvSpPr txBox="1"/>
+          <p:nvPr/>
+        </p:nvSpPr>
+        <p:spPr>
+          <a:xfrm>
+            <a:off x="2496312" y="5779008"/>
+            <a:ext cx="1097280" cy="182880"/>
+          </a:xfrm>
+          <a:prstGeom prst="rect">
+            <a:avLst/>
+          </a:prstGeom>
+          <a:noFill/>
+        </p:spPr>
+        <p:txBody>
+          <a:bodyPr wrap="square" lIns="36576" rIns="36576" tIns="18288" bIns="18288" anchor="ctr">
+            <a:spAutoFit/>
+          </a:bodyPr>
+          <a:lstStyle/>
+          <a:p>
+            <a:pPr algn="l"/>
+            <a:r>
+              <a:rPr sz="800" b="1">
+                <a:solidFill>
+                  <a:srgbClr val="6A3FB5"/>
+                </a:solidFill>
+                <a:latin typeface="Calibri"/>
+              </a:rPr>
+              <a:t>connection_error</a:t>
+            </a:r>
+          </a:p>
+        </p:txBody>
+      </p:sp>
+      <p:sp>
+        <p:nvSpPr>
+          <p:cNvPr id="118" name="Rectangle 117"/>
+          <p:cNvSpPr/>
+          <p:nvPr/>
+        </p:nvSpPr>
+        <p:spPr>
+          <a:xfrm>
+            <a:off x="3593592" y="5779008"/>
+            <a:ext cx="1709928" cy="182880"/>
+          </a:xfrm>
+          <a:prstGeom prst="rect">
+            <a:avLst/>
+          </a:prstGeom>
+          <a:solidFill>
+            <a:srgbClr val="F2F5FA"/>
+          </a:solidFill>
+          <a:ln w="6350">
+            <a:solidFill>
+              <a:srgbClr val="D3DBE8"/>
+            </a:solidFill>
+          </a:ln>
+          <a:effectLst/>
+        </p:spPr>
+        <p:style>
+          <a:lnRef idx="1">
+            <a:schemeClr val="accent1"/>
+          </a:lnRef>
+          <a:fillRef idx="3">
+            <a:schemeClr val="accent1"/>
+          </a:fillRef>
+          <a:effectRef idx="2">
+            <a:schemeClr val="accent1"/>
+          </a:effectRef>
+          <a:fontRef idx="minor">
+            <a:schemeClr val="lt1"/>
+          </a:fontRef>
+        </p:style>
+        <p:txBody>
+          <a:bodyPr rtlCol="0" anchor="ctr"/>
+          <a:lstStyle/>
+          <a:p>
+            <a:pPr algn="ctr"/>
+          </a:p>
+        </p:txBody>
+      </p:sp>
+      <p:sp>
+        <p:nvSpPr>
+          <p:cNvPr id="119" name="TextBox 118"/>
+          <p:cNvSpPr txBox="1"/>
+          <p:nvPr/>
+        </p:nvSpPr>
+        <p:spPr>
+          <a:xfrm>
+            <a:off x="3593592" y="5779008"/>
+            <a:ext cx="1709928" cy="182880"/>
+          </a:xfrm>
+          <a:prstGeom prst="rect">
+            <a:avLst/>
+          </a:prstGeom>
+          <a:noFill/>
+        </p:spPr>
+        <p:txBody>
+          <a:bodyPr wrap="square" lIns="36576" rIns="36576" tIns="18288" bIns="18288" anchor="ctr">
+            <a:spAutoFit/>
+          </a:bodyPr>
+          <a:lstStyle/>
+          <a:p>
+            <a:pPr algn="l"/>
+            <a:r>
               <a:rPr sz="850" b="0">
                 <a:solidFill>
                   <a:srgbClr val="1E2530"/>
                 </a:solidFill>
                 <a:latin typeface="Calibri"/>
               </a:rPr>
-              <a:t>Database timeout</a:t>
+              <a:t>DB connection timeout</a:t>
             </a:r>
           </a:p>
         </p:txBody>
@@ -14034,8 +14386,8 @@
         </p:nvSpPr>
         <p:spPr>
           <a:xfrm>
-            <a:off x="365760" y="6144768"/>
-            <a:ext cx="1051560" cy="182880"/>
+            <a:off x="365760" y="5961888"/>
+            <a:ext cx="713232" cy="182880"/>
           </a:xfrm>
           <a:prstGeom prst="rect">
             <a:avLst/>
@@ -14080,8 +14432,8 @@
         </p:nvSpPr>
         <p:spPr>
           <a:xfrm>
-            <a:off x="365760" y="6144768"/>
-            <a:ext cx="1051560" cy="182880"/>
+            <a:off x="365760" y="5961888"/>
+            <a:ext cx="713232" cy="182880"/>
           </a:xfrm>
           <a:prstGeom prst="rect">
             <a:avLst/>
@@ -14115,8 +14467,8 @@
         </p:nvSpPr>
         <p:spPr>
           <a:xfrm>
-            <a:off x="1417320" y="6144768"/>
-            <a:ext cx="868680" cy="182880"/>
+            <a:off x="1078992" y="5961888"/>
+            <a:ext cx="640080" cy="182880"/>
           </a:xfrm>
           <a:prstGeom prst="rect">
             <a:avLst/>
@@ -14161,8 +14513,8 @@
         </p:nvSpPr>
         <p:spPr>
           <a:xfrm>
-            <a:off x="1417320" y="6144768"/>
-            <a:ext cx="868680" cy="182880"/>
+            <a:off x="1078992" y="5961888"/>
+            <a:ext cx="640080" cy="182880"/>
           </a:xfrm>
           <a:prstGeom prst="rect">
             <a:avLst/>
@@ -14196,8 +14548,8 @@
         </p:nvSpPr>
         <p:spPr>
           <a:xfrm>
-            <a:off x="2286000" y="6144768"/>
-            <a:ext cx="914400" cy="182880"/>
+            <a:off x="1719072" y="5961888"/>
+            <a:ext cx="777240" cy="182880"/>
           </a:xfrm>
           <a:prstGeom prst="rect">
             <a:avLst/>
@@ -14236,49 +14588,14 @@
       </p:sp>
       <p:sp>
         <p:nvSpPr>
-          <p:cNvPr id="125" name="TextBox 124"/>
-          <p:cNvSpPr txBox="1"/>
-          <p:nvPr/>
-        </p:nvSpPr>
-        <p:spPr>
-          <a:xfrm>
-            <a:off x="2286000" y="6144768"/>
-            <a:ext cx="914400" cy="182880"/>
-          </a:xfrm>
-          <a:prstGeom prst="rect">
-            <a:avLst/>
-          </a:prstGeom>
-          <a:noFill/>
-        </p:spPr>
-        <p:txBody>
-          <a:bodyPr wrap="square" lIns="36576" rIns="36576" tIns="18288" bIns="18288" anchor="ctr">
-            <a:spAutoFit/>
-          </a:bodyPr>
-          <a:lstStyle/>
-          <a:p>
-            <a:pPr algn="l"/>
-            <a:r>
-              <a:rPr sz="850" b="1">
-                <a:solidFill>
-                  <a:srgbClr val="C0392B"/>
-                </a:solidFill>
-                <a:latin typeface="Calibri"/>
-              </a:rPr>
-              <a:t>ERROR</a:t>
-            </a:r>
-          </a:p>
-        </p:txBody>
-      </p:sp>
-      <p:sp>
-        <p:nvSpPr>
-          <p:cNvPr id="126" name="Rectangle 125"/>
+          <p:cNvPr id="134" name="Rectangle 123"/>
           <p:cNvSpPr/>
           <p:nvPr/>
         </p:nvSpPr>
         <p:spPr>
           <a:xfrm>
-            <a:off x="3200400" y="6144768"/>
-            <a:ext cx="2103120" cy="182880"/>
+            <a:off x="2496312" y="5961888"/>
+            <a:ext cx="1097280" cy="182880"/>
           </a:xfrm>
           <a:prstGeom prst="rect">
             <a:avLst/>
@@ -14317,14 +14634,14 @@
       </p:sp>
       <p:sp>
         <p:nvSpPr>
-          <p:cNvPr id="127" name="TextBox 126"/>
+          <p:cNvPr id="125" name="TextBox 124"/>
           <p:cNvSpPr txBox="1"/>
           <p:nvPr/>
         </p:nvSpPr>
         <p:spPr>
           <a:xfrm>
-            <a:off x="3200400" y="6144768"/>
-            <a:ext cx="2103120" cy="182880"/>
+            <a:off x="1719072" y="5961888"/>
+            <a:ext cx="777240" cy="182880"/>
           </a:xfrm>
           <a:prstGeom prst="rect">
             <a:avLst/>
@@ -14339,13 +14656,129 @@
           <a:p>
             <a:pPr algn="l"/>
             <a:r>
+              <a:rPr sz="850" b="1">
+                <a:solidFill>
+                  <a:srgbClr val="C0392B"/>
+                </a:solidFill>
+                <a:latin typeface="Calibri"/>
+              </a:rPr>
+              <a:t>ERROR</a:t>
+            </a:r>
+          </a:p>
+        </p:txBody>
+      </p:sp>
+      <p:sp>
+        <p:nvSpPr>
+          <p:cNvPr id="135" name="TextBox 124"/>
+          <p:cNvSpPr txBox="1"/>
+          <p:nvPr/>
+        </p:nvSpPr>
+        <p:spPr>
+          <a:xfrm>
+            <a:off x="2496312" y="5961888"/>
+            <a:ext cx="1097280" cy="182880"/>
+          </a:xfrm>
+          <a:prstGeom prst="rect">
+            <a:avLst/>
+          </a:prstGeom>
+          <a:noFill/>
+        </p:spPr>
+        <p:txBody>
+          <a:bodyPr wrap="square" lIns="36576" rIns="36576" tIns="18288" bIns="18288" anchor="ctr">
+            <a:spAutoFit/>
+          </a:bodyPr>
+          <a:lstStyle/>
+          <a:p>
+            <a:pPr algn="l"/>
+            <a:r>
+              <a:rPr sz="800" b="1">
+                <a:solidFill>
+                  <a:srgbClr val="6A3FB5"/>
+                </a:solidFill>
+                <a:latin typeface="Calibri"/>
+              </a:rPr>
+              <a:t>http_request</a:t>
+            </a:r>
+          </a:p>
+        </p:txBody>
+      </p:sp>
+      <p:sp>
+        <p:nvSpPr>
+          <p:cNvPr id="126" name="Rectangle 125"/>
+          <p:cNvSpPr/>
+          <p:nvPr/>
+        </p:nvSpPr>
+        <p:spPr>
+          <a:xfrm>
+            <a:off x="3593592" y="5961888"/>
+            <a:ext cx="1709928" cy="182880"/>
+          </a:xfrm>
+          <a:prstGeom prst="rect">
+            <a:avLst/>
+          </a:prstGeom>
+          <a:solidFill>
+            <a:srgbClr val="FFFFFF"/>
+          </a:solidFill>
+          <a:ln w="6350">
+            <a:solidFill>
+              <a:srgbClr val="D3DBE8"/>
+            </a:solidFill>
+          </a:ln>
+          <a:effectLst/>
+        </p:spPr>
+        <p:style>
+          <a:lnRef idx="1">
+            <a:schemeClr val="accent1"/>
+          </a:lnRef>
+          <a:fillRef idx="3">
+            <a:schemeClr val="accent1"/>
+          </a:fillRef>
+          <a:effectRef idx="2">
+            <a:schemeClr val="accent1"/>
+          </a:effectRef>
+          <a:fontRef idx="minor">
+            <a:schemeClr val="lt1"/>
+          </a:fontRef>
+        </p:style>
+        <p:txBody>
+          <a:bodyPr rtlCol="0" anchor="ctr"/>
+          <a:lstStyle/>
+          <a:p>
+            <a:pPr algn="ctr"/>
+          </a:p>
+        </p:txBody>
+      </p:sp>
+      <p:sp>
+        <p:nvSpPr>
+          <p:cNvPr id="127" name="TextBox 126"/>
+          <p:cNvSpPr txBox="1"/>
+          <p:nvPr/>
+        </p:nvSpPr>
+        <p:spPr>
+          <a:xfrm>
+            <a:off x="3593592" y="5961888"/>
+            <a:ext cx="1709928" cy="182880"/>
+          </a:xfrm>
+          <a:prstGeom prst="rect">
+            <a:avLst/>
+          </a:prstGeom>
+          <a:noFill/>
+        </p:spPr>
+        <p:txBody>
+          <a:bodyPr wrap="square" lIns="36576" rIns="36576" tIns="18288" bIns="18288" anchor="ctr">
+            <a:spAutoFit/>
+          </a:bodyPr>
+          <a:lstStyle/>
+          <a:p>
+            <a:pPr algn="l"/>
+            <a:r>
               <a:rPr sz="850" b="0">
                 <a:solidFill>
                   <a:srgbClr val="1E2530"/>
                 </a:solidFill>
                 <a:latin typeface="Calibri"/>
               </a:rPr>
-              <a:t>GET /login returned 500</a:t>
+              <a:t>GET /login → 500</a:t>
             </a:r>
           </a:p>
         </p:txBody>
@@ -14944,7 +15377,7 @@
                 </a:solidFill>
                 <a:latin typeface="Calibri"/>
               </a:rPr>
-              <a:t>Works alongside current tools; logs arrive through a simple web API or a small script.</a:t>
+              <a:t>Works alongside current tools; logs arrive via a web API or Bash collector; a web dashboard shows learned rules and the review queue.</a:t>
             </a:r>
           </a:p>
           <a:p>
@@ -15240,7 +15673,7 @@
                 </a:solidFill>
                 <a:latin typeface="Calibri"/>
               </a:rPr>
-              <a:t>Data stays in India</a:t>
+              <a:t>Can stay in India</a:t>
             </a:r>
           </a:p>
           <a:p>
@@ -15256,7 +15689,7 @@
                 </a:solidFill>
                 <a:latin typeface="Calibri"/>
               </a:rPr>
-              <a:t>Runs on Indian cloud or fully on-premise servers, even in air-gapped networks.</a:t>
+              <a:t>A plain Python app that can run on Indian cloud or on-premise; offline with built-in rules (self-hosted AI planned).</a:t>
             </a:r>
           </a:p>
           <a:p>
@@ -15587,8 +16020,8 @@
         </p:nvSpPr>
         <p:spPr>
           <a:xfrm>
-            <a:off x="4315968" y="1828800"/>
-            <a:ext cx="1627632" cy="640080"/>
+            <a:off x="4315968" y="1810512"/>
+            <a:ext cx="1627632" cy="530352"/>
           </a:xfrm>
           <a:prstGeom prst="roundRect">
             <a:avLst>
@@ -15633,8 +16066,8 @@
         </p:nvSpPr>
         <p:spPr>
           <a:xfrm>
-            <a:off x="4343400" y="1828800"/>
-            <a:ext cx="1572768" cy="640080"/>
+            <a:off x="4343400" y="1810512"/>
+            <a:ext cx="1572768" cy="530352"/>
           </a:xfrm>
           <a:prstGeom prst="rect">
             <a:avLst/>
@@ -15649,7 +16082,7 @@
           <a:p>
             <a:pPr algn="ctr"/>
             <a:r>
-              <a:rPr sz="1100" b="1">
+              <a:rPr sz="1050" b="1">
                 <a:solidFill>
                   <a:srgbClr val="C0392B"/>
                 </a:solidFill>
@@ -15668,8 +16101,8 @@
         </p:nvSpPr>
         <p:spPr>
           <a:xfrm>
-            <a:off x="5925312" y="1828800"/>
-            <a:ext cx="292608" cy="640080"/>
+            <a:off x="5925312" y="1810512"/>
+            <a:ext cx="292608" cy="530352"/>
           </a:xfrm>
           <a:prstGeom prst="rect">
             <a:avLst/>
@@ -15703,8 +16136,8 @@
         </p:nvSpPr>
         <p:spPr>
           <a:xfrm>
-            <a:off x="6217920" y="1828800"/>
-            <a:ext cx="1664208" cy="640080"/>
+            <a:off x="6217920" y="1810512"/>
+            <a:ext cx="1664208" cy="530352"/>
           </a:xfrm>
           <a:prstGeom prst="roundRect">
             <a:avLst>
@@ -15749,8 +16182,8 @@
         </p:nvSpPr>
         <p:spPr>
           <a:xfrm>
-            <a:off x="6245352" y="1828800"/>
-            <a:ext cx="1609344" cy="640080"/>
+            <a:off x="6245352" y="1810512"/>
+            <a:ext cx="1609344" cy="530352"/>
           </a:xfrm>
           <a:prstGeom prst="rect">
             <a:avLst/>
@@ -15765,7 +16198,7 @@
           <a:p>
             <a:pPr algn="ctr"/>
             <a:r>
-              <a:rPr sz="1000" b="1">
+              <a:rPr sz="950" b="1">
                 <a:solidFill>
                   <a:srgbClr val="138A36"/>
                 </a:solidFill>
@@ -15784,8 +16217,8 @@
         </p:nvSpPr>
         <p:spPr>
           <a:xfrm>
-            <a:off x="4315968" y="2542032"/>
-            <a:ext cx="1627632" cy="640080"/>
+            <a:off x="4315968" y="2400300"/>
+            <a:ext cx="1627632" cy="530352"/>
           </a:xfrm>
           <a:prstGeom prst="roundRect">
             <a:avLst>
@@ -15830,8 +16263,8 @@
         </p:nvSpPr>
         <p:spPr>
           <a:xfrm>
-            <a:off x="4343400" y="2542032"/>
-            <a:ext cx="1572768" cy="640080"/>
+            <a:off x="4343400" y="2400300"/>
+            <a:ext cx="1572768" cy="530352"/>
           </a:xfrm>
           <a:prstGeom prst="rect">
             <a:avLst/>
@@ -15846,7 +16279,7 @@
           <a:p>
             <a:pPr algn="ctr"/>
             <a:r>
-              <a:rPr sz="1100" b="1">
+              <a:rPr sz="1050" b="1">
                 <a:solidFill>
                   <a:srgbClr val="C0392B"/>
                 </a:solidFill>
@@ -15865,8 +16298,8 @@
         </p:nvSpPr>
         <p:spPr>
           <a:xfrm>
-            <a:off x="5925312" y="2542032"/>
-            <a:ext cx="292608" cy="640080"/>
+            <a:off x="5925312" y="2400300"/>
+            <a:ext cx="292608" cy="530352"/>
           </a:xfrm>
           <a:prstGeom prst="rect">
             <a:avLst/>
@@ -15900,8 +16333,8 @@
         </p:nvSpPr>
         <p:spPr>
           <a:xfrm>
-            <a:off x="6217920" y="2542032"/>
-            <a:ext cx="1664208" cy="640080"/>
+            <a:off x="6217920" y="2400300"/>
+            <a:ext cx="1664208" cy="530352"/>
           </a:xfrm>
           <a:prstGeom prst="roundRect">
             <a:avLst>
@@ -15946,8 +16379,8 @@
         </p:nvSpPr>
         <p:spPr>
           <a:xfrm>
-            <a:off x="6245352" y="2542032"/>
-            <a:ext cx="1609344" cy="640080"/>
+            <a:off x="6245352" y="2400300"/>
+            <a:ext cx="1609344" cy="530352"/>
           </a:xfrm>
           <a:prstGeom prst="rect">
             <a:avLst/>
@@ -15962,7 +16395,7 @@
           <a:p>
             <a:pPr algn="ctr"/>
             <a:r>
-              <a:rPr sz="1000" b="1">
+              <a:rPr sz="950" b="1">
                 <a:solidFill>
                   <a:srgbClr val="138A36"/>
                 </a:solidFill>
@@ -15981,8 +16414,8 @@
         </p:nvSpPr>
         <p:spPr>
           <a:xfrm>
-            <a:off x="4315968" y="3255264"/>
-            <a:ext cx="1627632" cy="640080"/>
+            <a:off x="4315968" y="2990088"/>
+            <a:ext cx="1627632" cy="530352"/>
           </a:xfrm>
           <a:prstGeom prst="roundRect">
             <a:avLst>
@@ -16027,8 +16460,8 @@
         </p:nvSpPr>
         <p:spPr>
           <a:xfrm>
-            <a:off x="4343400" y="3255264"/>
-            <a:ext cx="1572768" cy="640080"/>
+            <a:off x="4343400" y="2990088"/>
+            <a:ext cx="1572768" cy="530352"/>
           </a:xfrm>
           <a:prstGeom prst="rect">
             <a:avLst/>
@@ -16043,7 +16476,7 @@
           <a:p>
             <a:pPr algn="ctr"/>
             <a:r>
-              <a:rPr sz="1100" b="1">
+              <a:rPr sz="1050" b="1">
                 <a:solidFill>
                   <a:srgbClr val="C0392B"/>
                 </a:solidFill>
@@ -16062,8 +16495,8 @@
         </p:nvSpPr>
         <p:spPr>
           <a:xfrm>
-            <a:off x="5925312" y="3255264"/>
-            <a:ext cx="292608" cy="640080"/>
+            <a:off x="5925312" y="2990088"/>
+            <a:ext cx="292608" cy="530352"/>
           </a:xfrm>
           <a:prstGeom prst="rect">
             <a:avLst/>
@@ -16097,8 +16530,8 @@
         </p:nvSpPr>
         <p:spPr>
           <a:xfrm>
-            <a:off x="6217920" y="3255264"/>
-            <a:ext cx="1664208" cy="640080"/>
+            <a:off x="6217920" y="2990088"/>
+            <a:ext cx="1664208" cy="530352"/>
           </a:xfrm>
           <a:prstGeom prst="roundRect">
             <a:avLst>
@@ -16143,8 +16576,8 @@
         </p:nvSpPr>
         <p:spPr>
           <a:xfrm>
-            <a:off x="6245352" y="3255264"/>
-            <a:ext cx="1609344" cy="640080"/>
+            <a:off x="6245352" y="2990088"/>
+            <a:ext cx="1609344" cy="530352"/>
           </a:xfrm>
           <a:prstGeom prst="rect">
             <a:avLst/>
@@ -16159,7 +16592,7 @@
           <a:p>
             <a:pPr algn="ctr"/>
             <a:r>
-              <a:rPr sz="1000" b="1">
+              <a:rPr sz="950" b="1">
                 <a:solidFill>
                   <a:srgbClr val="138A36"/>
                 </a:solidFill>
@@ -16178,8 +16611,8 @@
         </p:nvSpPr>
         <p:spPr>
           <a:xfrm>
-            <a:off x="4315968" y="3968496"/>
-            <a:ext cx="1627632" cy="640080"/>
+            <a:off x="4315968" y="3579876"/>
+            <a:ext cx="1627632" cy="530352"/>
           </a:xfrm>
           <a:prstGeom prst="roundRect">
             <a:avLst>
@@ -16224,8 +16657,8 @@
         </p:nvSpPr>
         <p:spPr>
           <a:xfrm>
-            <a:off x="4343400" y="3968496"/>
-            <a:ext cx="1572768" cy="640080"/>
+            <a:off x="4343400" y="3579876"/>
+            <a:ext cx="1572768" cy="530352"/>
           </a:xfrm>
           <a:prstGeom prst="rect">
             <a:avLst/>
@@ -16240,7 +16673,7 @@
           <a:p>
             <a:pPr algn="ctr"/>
             <a:r>
-              <a:rPr sz="1100" b="1">
+              <a:rPr sz="1050" b="1">
                 <a:solidFill>
                   <a:srgbClr val="C0392B"/>
                 </a:solidFill>
@@ -16259,8 +16692,8 @@
         </p:nvSpPr>
         <p:spPr>
           <a:xfrm>
-            <a:off x="5925312" y="3968496"/>
-            <a:ext cx="292608" cy="640080"/>
+            <a:off x="5925312" y="3579876"/>
+            <a:ext cx="292608" cy="530352"/>
           </a:xfrm>
           <a:prstGeom prst="rect">
             <a:avLst/>
@@ -16294,8 +16727,8 @@
         </p:nvSpPr>
         <p:spPr>
           <a:xfrm>
-            <a:off x="6217920" y="3968496"/>
-            <a:ext cx="1664208" cy="640080"/>
+            <a:off x="6217920" y="3579876"/>
+            <a:ext cx="1664208" cy="530352"/>
           </a:xfrm>
           <a:prstGeom prst="roundRect">
             <a:avLst>
@@ -16340,8 +16773,8 @@
         </p:nvSpPr>
         <p:spPr>
           <a:xfrm>
-            <a:off x="6245352" y="3968496"/>
-            <a:ext cx="1609344" cy="640080"/>
+            <a:off x="6245352" y="3579876"/>
+            <a:ext cx="1609344" cy="530352"/>
           </a:xfrm>
           <a:prstGeom prst="rect">
             <a:avLst/>
@@ -16356,7 +16789,7 @@
           <a:p>
             <a:pPr algn="ctr"/>
             <a:r>
-              <a:rPr sz="1000" b="1">
+              <a:rPr sz="950" b="1">
                 <a:solidFill>
                   <a:srgbClr val="138A36"/>
                 </a:solidFill>
@@ -16375,8 +16808,8 @@
         </p:nvSpPr>
         <p:spPr>
           <a:xfrm>
-            <a:off x="4315968" y="4681728"/>
-            <a:ext cx="1627632" cy="640080"/>
+            <a:off x="4315968" y="4169664"/>
+            <a:ext cx="1627632" cy="530352"/>
           </a:xfrm>
           <a:prstGeom prst="roundRect">
             <a:avLst>
@@ -16415,14 +16848,60 @@
       </p:sp>
       <p:sp>
         <p:nvSpPr>
+          <p:cNvPr id="109" name="Rounded Rectangle 91"/>
+          <p:cNvSpPr/>
+          <p:nvPr/>
+        </p:nvSpPr>
+        <p:spPr>
+          <a:xfrm>
+            <a:off x="4315968" y="4759452"/>
+            <a:ext cx="1627632" cy="530352"/>
+          </a:xfrm>
+          <a:prstGeom prst="roundRect">
+            <a:avLst>
+              <a:gd name="adj" fmla="val 12000"/>
+            </a:avLst>
+          </a:prstGeom>
+          <a:solidFill>
+            <a:srgbClr val="FDECEA"/>
+          </a:solidFill>
+          <a:ln>
+            <a:noFill/>
+          </a:ln>
+          <a:effectLst/>
+        </p:spPr>
+        <p:style>
+          <a:lnRef idx="1">
+            <a:schemeClr val="accent1"/>
+          </a:lnRef>
+          <a:fillRef idx="3">
+            <a:schemeClr val="accent1"/>
+          </a:fillRef>
+          <a:effectRef idx="2">
+            <a:schemeClr val="accent1"/>
+          </a:effectRef>
+          <a:fontRef idx="minor">
+            <a:schemeClr val="lt1"/>
+          </a:fontRef>
+        </p:style>
+        <p:txBody>
+          <a:bodyPr rtlCol="0" anchor="ctr"/>
+          <a:lstStyle/>
+          <a:p>
+            <a:pPr algn="ctr"/>
+          </a:p>
+        </p:txBody>
+      </p:sp>
+      <p:sp>
+        <p:nvSpPr>
           <p:cNvPr id="93" name="TextBox 92"/>
           <p:cNvSpPr txBox="1"/>
           <p:nvPr/>
         </p:nvSpPr>
         <p:spPr>
           <a:xfrm>
-            <a:off x="4343400" y="4681728"/>
-            <a:ext cx="1572768" cy="640080"/>
+            <a:off x="4343400" y="4169664"/>
+            <a:ext cx="1572768" cy="530352"/>
           </a:xfrm>
           <a:prstGeom prst="rect">
             <a:avLst/>
@@ -16437,7 +16916,7 @@
           <a:p>
             <a:pPr algn="ctr"/>
             <a:r>
-              <a:rPr sz="1100" b="1">
+              <a:rPr sz="1050" b="1">
                 <a:solidFill>
                   <a:srgbClr val="C0392B"/>
                 </a:solidFill>
@@ -16450,14 +16929,14 @@
       </p:sp>
       <p:sp>
         <p:nvSpPr>
-          <p:cNvPr id="94" name="TextBox 93"/>
+          <p:cNvPr id="110" name="TextBox 92"/>
           <p:cNvSpPr txBox="1"/>
           <p:nvPr/>
         </p:nvSpPr>
         <p:spPr>
           <a:xfrm>
-            <a:off x="5925312" y="4681728"/>
-            <a:ext cx="292608" cy="640080"/>
+            <a:off x="4343400" y="4759452"/>
+            <a:ext cx="1572768" cy="530352"/>
           </a:xfrm>
           <a:prstGeom prst="rect">
             <a:avLst/>
@@ -16472,6 +16951,76 @@
           <a:p>
             <a:pPr algn="ctr"/>
             <a:r>
+              <a:rPr sz="1050" b="1">
+                <a:solidFill>
+                  <a:srgbClr val="C0392B"/>
+                </a:solidFill>
+                <a:latin typeface="Calibri"/>
+              </a:rPr>
+              <a:t>Junk or flood of logs</a:t>
+            </a:r>
+          </a:p>
+        </p:txBody>
+      </p:sp>
+      <p:sp>
+        <p:nvSpPr>
+          <p:cNvPr id="94" name="TextBox 93"/>
+          <p:cNvSpPr txBox="1"/>
+          <p:nvPr/>
+        </p:nvSpPr>
+        <p:spPr>
+          <a:xfrm>
+            <a:off x="5925312" y="4169664"/>
+            <a:ext cx="292608" cy="530352"/>
+          </a:xfrm>
+          <a:prstGeom prst="rect">
+            <a:avLst/>
+          </a:prstGeom>
+          <a:noFill/>
+        </p:spPr>
+        <p:txBody>
+          <a:bodyPr wrap="square" lIns="36576" rIns="36576" tIns="18288" bIns="18288" anchor="ctr">
+            <a:spAutoFit/>
+          </a:bodyPr>
+          <a:lstStyle/>
+          <a:p>
+            <a:pPr algn="ctr"/>
+            <a:r>
+              <a:rPr sz="1600" b="1">
+                <a:solidFill>
+                  <a:srgbClr val="5F6B7A"/>
+                </a:solidFill>
+                <a:latin typeface="Calibri"/>
+              </a:rPr>
+              <a:t>→</a:t>
+            </a:r>
+          </a:p>
+        </p:txBody>
+      </p:sp>
+      <p:sp>
+        <p:nvSpPr>
+          <p:cNvPr id="111" name="TextBox 93"/>
+          <p:cNvSpPr txBox="1"/>
+          <p:nvPr/>
+        </p:nvSpPr>
+        <p:spPr>
+          <a:xfrm>
+            <a:off x="5925312" y="4759452"/>
+            <a:ext cx="292608" cy="530352"/>
+          </a:xfrm>
+          <a:prstGeom prst="rect">
+            <a:avLst/>
+          </a:prstGeom>
+          <a:noFill/>
+        </p:spPr>
+        <p:txBody>
+          <a:bodyPr wrap="square" lIns="36576" rIns="36576" tIns="18288" bIns="18288" anchor="ctr">
+            <a:spAutoFit/>
+          </a:bodyPr>
+          <a:lstStyle/>
+          <a:p>
+            <a:pPr algn="ctr"/>
+            <a:r>
               <a:rPr sz="1600" b="1">
                 <a:solidFill>
                   <a:srgbClr val="5F6B7A"/>
@@ -16491,8 +17040,8 @@
         </p:nvSpPr>
         <p:spPr>
           <a:xfrm>
-            <a:off x="6217920" y="4681728"/>
-            <a:ext cx="1664208" cy="640080"/>
+            <a:off x="6217920" y="4169664"/>
+            <a:ext cx="1664208" cy="530352"/>
           </a:xfrm>
           <a:prstGeom prst="roundRect">
             <a:avLst>
@@ -16531,14 +17080,60 @@
       </p:sp>
       <p:sp>
         <p:nvSpPr>
+          <p:cNvPr id="112" name="Rounded Rectangle 94"/>
+          <p:cNvSpPr/>
+          <p:nvPr/>
+        </p:nvSpPr>
+        <p:spPr>
+          <a:xfrm>
+            <a:off x="6217920" y="4759452"/>
+            <a:ext cx="1664208" cy="530352"/>
+          </a:xfrm>
+          <a:prstGeom prst="roundRect">
+            <a:avLst>
+              <a:gd name="adj" fmla="val 12000"/>
+            </a:avLst>
+          </a:prstGeom>
+          <a:solidFill>
+            <a:srgbClr val="E8F5EC"/>
+          </a:solidFill>
+          <a:ln>
+            <a:noFill/>
+          </a:ln>
+          <a:effectLst/>
+        </p:spPr>
+        <p:style>
+          <a:lnRef idx="1">
+            <a:schemeClr val="accent1"/>
+          </a:lnRef>
+          <a:fillRef idx="3">
+            <a:schemeClr val="accent1"/>
+          </a:fillRef>
+          <a:effectRef idx="2">
+            <a:schemeClr val="accent1"/>
+          </a:effectRef>
+          <a:fontRef idx="minor">
+            <a:schemeClr val="lt1"/>
+          </a:fontRef>
+        </p:style>
+        <p:txBody>
+          <a:bodyPr rtlCol="0" anchor="ctr"/>
+          <a:lstStyle/>
+          <a:p>
+            <a:pPr algn="ctr"/>
+          </a:p>
+        </p:txBody>
+      </p:sp>
+      <p:sp>
+        <p:nvSpPr>
           <p:cNvPr id="96" name="TextBox 95"/>
           <p:cNvSpPr txBox="1"/>
           <p:nvPr/>
         </p:nvSpPr>
         <p:spPr>
           <a:xfrm>
-            <a:off x="6245352" y="4681728"/>
-            <a:ext cx="1609344" cy="640080"/>
+            <a:off x="6245352" y="4169664"/>
+            <a:ext cx="1609344" cy="530352"/>
           </a:xfrm>
           <a:prstGeom prst="rect">
             <a:avLst/>
@@ -16553,13 +17148,48 @@
           <a:p>
             <a:pPr algn="ctr"/>
             <a:r>
-              <a:rPr sz="1000" b="1">
+              <a:rPr sz="950" b="1">
                 <a:solidFill>
                   <a:srgbClr val="138A36"/>
                 </a:solidFill>
                 <a:latin typeface="Calibri"/>
               </a:rPr>
-              <a:t>Runs on-premise; data masking &amp; self-hosted AI planned</a:t>
+              <a:t>On-premise with built-in rules; masking &amp; self-hosted AI planned</a:t>
+            </a:r>
+          </a:p>
+        </p:txBody>
+      </p:sp>
+      <p:sp>
+        <p:nvSpPr>
+          <p:cNvPr id="113" name="TextBox 95"/>
+          <p:cNvSpPr txBox="1"/>
+          <p:nvPr/>
+        </p:nvSpPr>
+        <p:spPr>
+          <a:xfrm>
+            <a:off x="6245352" y="4759452"/>
+            <a:ext cx="1609344" cy="530352"/>
+          </a:xfrm>
+          <a:prstGeom prst="rect">
+            <a:avLst/>
+          </a:prstGeom>
+          <a:noFill/>
+        </p:spPr>
+        <p:txBody>
+          <a:bodyPr wrap="square" lIns="36576" rIns="36576" tIns="18288" bIns="18288" anchor="ctr">
+            <a:spAutoFit/>
+          </a:bodyPr>
+          <a:lstStyle/>
+          <a:p>
+            <a:pPr algn="ctr"/>
+            <a:r>
+              <a:rPr sz="950" b="1">
+                <a:solidFill>
+                  <a:srgbClr val="138A36"/>
+                </a:solidFill>
+                <a:latin typeface="Calibri"/>
+              </a:rPr>
+              <a:t>Optional access key and size limits on every batch</a:t>
             </a:r>
           </a:p>
         </p:txBody>
@@ -16653,8 +17283,8 @@
         </p:nvSpPr>
         <p:spPr>
           <a:xfrm>
-            <a:off x="1572768" y="5614416"/>
-            <a:ext cx="2011680" cy="585216"/>
+            <a:off x="1481328" y="5614416"/>
+            <a:ext cx="1783080" cy="585216"/>
           </a:xfrm>
           <a:prstGeom prst="homePlate">
             <a:avLst>
@@ -16699,8 +17329,8 @@
         </p:nvSpPr>
         <p:spPr>
           <a:xfrm>
-            <a:off x="1664208" y="5614416"/>
-            <a:ext cx="1600200" cy="585216"/>
+            <a:off x="1591056" y="5614416"/>
+            <a:ext cx="1325880" cy="585216"/>
           </a:xfrm>
           <a:prstGeom prst="rect">
             <a:avLst/>
@@ -16715,7 +17345,7 @@
           <a:p>
             <a:pPr algn="l"/>
             <a:r>
-              <a:rPr sz="1100" b="1">
+              <a:rPr sz="1050" b="1">
                 <a:solidFill>
                   <a:srgbClr val="FFFFFF"/>
                 </a:solidFill>
@@ -16727,7 +17357,7 @@
           <a:p>
             <a:pPr algn="l"/>
             <a:r>
-              <a:rPr sz="900" b="0">
+              <a:rPr sz="800" b="0">
                 <a:solidFill>
                   <a:srgbClr val="FFFFFF"/>
                 </a:solidFill>
@@ -16746,8 +17376,8 @@
         </p:nvSpPr>
         <p:spPr>
           <a:xfrm>
-            <a:off x="3630168" y="5614416"/>
-            <a:ext cx="2011680" cy="585216"/>
+            <a:off x="3200400" y="5614416"/>
+            <a:ext cx="1783080" cy="585216"/>
           </a:xfrm>
           <a:prstGeom prst="chevron">
             <a:avLst>
@@ -16792,8 +17422,8 @@
         </p:nvSpPr>
         <p:spPr>
           <a:xfrm>
-            <a:off x="3904488" y="5614416"/>
-            <a:ext cx="1600200" cy="585216"/>
+            <a:off x="3456432" y="5614416"/>
+            <a:ext cx="1325880" cy="585216"/>
           </a:xfrm>
           <a:prstGeom prst="rect">
             <a:avLst/>
@@ -16808,7 +17438,7 @@
           <a:p>
             <a:pPr algn="l"/>
             <a:r>
-              <a:rPr sz="1100" b="1">
+              <a:rPr sz="1050" b="1">
                 <a:solidFill>
                   <a:srgbClr val="FFFFFF"/>
                 </a:solidFill>
@@ -16820,7 +17450,7 @@
           <a:p>
             <a:pPr algn="l"/>
             <a:r>
-              <a:rPr sz="900" b="0">
+              <a:rPr sz="800" b="0">
                 <a:solidFill>
                   <a:srgbClr val="FFFFFF"/>
                 </a:solidFill>
@@ -16839,8 +17469,8 @@
         </p:nvSpPr>
         <p:spPr>
           <a:xfrm>
-            <a:off x="5687568" y="5614416"/>
-            <a:ext cx="2011680" cy="585216"/>
+            <a:off x="4919472" y="5614416"/>
+            <a:ext cx="1783080" cy="585216"/>
           </a:xfrm>
           <a:prstGeom prst="chevron">
             <a:avLst>
@@ -16885,8 +17515,8 @@
         </p:nvSpPr>
         <p:spPr>
           <a:xfrm>
-            <a:off x="5961888" y="5614416"/>
-            <a:ext cx="1600200" cy="585216"/>
+            <a:off x="5175504" y="5614416"/>
+            <a:ext cx="1325880" cy="585216"/>
           </a:xfrm>
           <a:prstGeom prst="rect">
             <a:avLst/>
@@ -16901,7 +17531,7 @@
           <a:p>
             <a:pPr algn="l"/>
             <a:r>
-              <a:rPr sz="1100" b="1">
+              <a:rPr sz="1050" b="1">
                 <a:solidFill>
                   <a:srgbClr val="FFFFFF"/>
                 </a:solidFill>
@@ -16913,7 +17543,7 @@
           <a:p>
             <a:pPr algn="l"/>
             <a:r>
-              <a:rPr sz="900" b="0">
+              <a:rPr sz="800" b="0">
                 <a:solidFill>
                   <a:srgbClr val="FFFFFF"/>
                 </a:solidFill>
@@ -16932,8 +17562,8 @@
         </p:nvSpPr>
         <p:spPr>
           <a:xfrm>
-            <a:off x="7744968" y="5614416"/>
-            <a:ext cx="2011680" cy="585216"/>
+            <a:off x="6638544" y="5614416"/>
+            <a:ext cx="1783080" cy="585216"/>
           </a:xfrm>
           <a:prstGeom prst="chevron">
             <a:avLst>
@@ -16941,7 +17571,7 @@
             </a:avLst>
           </a:prstGeom>
           <a:solidFill>
-            <a:srgbClr val="F58220"/>
+            <a:srgbClr val="2C7BB6"/>
           </a:solidFill>
           <a:ln>
             <a:noFill/>
@@ -16978,8 +17608,8 @@
         </p:nvSpPr>
         <p:spPr>
           <a:xfrm>
-            <a:off x="8019288" y="5614416"/>
-            <a:ext cx="1600200" cy="585216"/>
+            <a:off x="6894576" y="5614416"/>
+            <a:ext cx="1325880" cy="585216"/>
           </a:xfrm>
           <a:prstGeom prst="rect">
             <a:avLst/>
@@ -16994,25 +17624,25 @@
           <a:p>
             <a:pPr algn="l"/>
             <a:r>
-              <a:rPr sz="1100" b="1">
+              <a:rPr sz="1050" b="1">
                 <a:solidFill>
                   <a:srgbClr val="FFFFFF"/>
                 </a:solidFill>
                 <a:latin typeface="Calibri"/>
               </a:rPr>
-              <a:t>4  PSU pilot</a:t>
+              <a:t>4  Connectors</a:t>
             </a:r>
           </a:p>
           <a:p>
             <a:pPr algn="l"/>
             <a:r>
-              <a:rPr sz="900" b="0">
+              <a:rPr sz="800" b="0">
                 <a:solidFill>
                   <a:srgbClr val="FFFFFF"/>
                 </a:solidFill>
                 <a:latin typeface="Calibri"/>
               </a:rPr>
-              <a:t>feedback &amp; tuning</a:t>
+              <a:t>Splunk · ELK · Wazuh</a:t>
             </a:r>
           </a:p>
         </p:txBody>
@@ -17025,8 +17655,54 @@
         </p:nvSpPr>
         <p:spPr>
           <a:xfrm>
-            <a:off x="9802368" y="5614416"/>
-            <a:ext cx="2011680" cy="585216"/>
+            <a:off x="8357616" y="5614416"/>
+            <a:ext cx="1783080" cy="585216"/>
+          </a:xfrm>
+          <a:prstGeom prst="chevron">
+            <a:avLst>
+              <a:gd name="adj" fmla="val 25000"/>
+            </a:avLst>
+          </a:prstGeom>
+          <a:solidFill>
+            <a:srgbClr val="F28322"/>
+          </a:solidFill>
+          <a:ln>
+            <a:noFill/>
+          </a:ln>
+          <a:effectLst/>
+        </p:spPr>
+        <p:style>
+          <a:lnRef idx="1">
+            <a:schemeClr val="accent1"/>
+          </a:lnRef>
+          <a:fillRef idx="3">
+            <a:schemeClr val="accent1"/>
+          </a:fillRef>
+          <a:effectRef idx="2">
+            <a:schemeClr val="accent1"/>
+          </a:effectRef>
+          <a:fontRef idx="minor">
+            <a:schemeClr val="lt1"/>
+          </a:fontRef>
+        </p:style>
+        <p:txBody>
+          <a:bodyPr rtlCol="0" anchor="ctr"/>
+          <a:lstStyle/>
+          <a:p>
+            <a:pPr algn="ctr"/>
+          </a:p>
+        </p:txBody>
+      </p:sp>
+      <p:sp>
+        <p:nvSpPr>
+          <p:cNvPr id="114" name="Chevron 106"/>
+          <p:cNvSpPr/>
+          <p:nvPr/>
+        </p:nvSpPr>
+        <p:spPr>
+          <a:xfrm>
+            <a:off x="10076688" y="5614416"/>
+            <a:ext cx="1783080" cy="585216"/>
           </a:xfrm>
           <a:prstGeom prst="chevron">
             <a:avLst>
@@ -17071,8 +17747,8 @@
         </p:nvSpPr>
         <p:spPr>
           <a:xfrm>
-            <a:off x="10076688" y="5614416"/>
-            <a:ext cx="1600200" cy="585216"/>
+            <a:off x="8613648" y="5614416"/>
+            <a:ext cx="1325880" cy="585216"/>
           </a:xfrm>
           <a:prstGeom prst="rect">
             <a:avLst/>
@@ -17087,19 +17763,66 @@
           <a:p>
             <a:pPr algn="l"/>
             <a:r>
-              <a:rPr sz="1100" b="1">
+              <a:rPr sz="1050" b="1">
                 <a:solidFill>
                   <a:srgbClr val="FFFFFF"/>
                 </a:solidFill>
                 <a:latin typeface="Calibri"/>
               </a:rPr>
-              <a:t>5  Scale up</a:t>
+              <a:t>5  PSU pilot</a:t>
             </a:r>
           </a:p>
           <a:p>
             <a:pPr algn="l"/>
             <a:r>
-              <a:rPr sz="900" b="0">
+              <a:rPr sz="800" b="0">
+                <a:solidFill>
+                  <a:srgbClr val="FFFFFF"/>
+                </a:solidFill>
+                <a:latin typeface="Calibri"/>
+              </a:rPr>
+              <a:t>feedback &amp; tuning</a:t>
+            </a:r>
+          </a:p>
+        </p:txBody>
+      </p:sp>
+      <p:sp>
+        <p:nvSpPr>
+          <p:cNvPr id="115" name="TextBox 107"/>
+          <p:cNvSpPr txBox="1"/>
+          <p:nvPr/>
+        </p:nvSpPr>
+        <p:spPr>
+          <a:xfrm>
+            <a:off x="10332720" y="5614416"/>
+            <a:ext cx="1325880" cy="585216"/>
+          </a:xfrm>
+          <a:prstGeom prst="rect">
+            <a:avLst/>
+          </a:prstGeom>
+          <a:noFill/>
+        </p:spPr>
+        <p:txBody>
+          <a:bodyPr wrap="square" lIns="36576" rIns="36576" tIns="18288" bIns="18288" anchor="ctr">
+            <a:spAutoFit/>
+          </a:bodyPr>
+          <a:lstStyle/>
+          <a:p>
+            <a:pPr algn="l"/>
+            <a:r>
+              <a:rPr sz="1050" b="1">
+                <a:solidFill>
+                  <a:srgbClr val="FFFFFF"/>
+                </a:solidFill>
+                <a:latin typeface="Calibri"/>
+              </a:rPr>
+              <a:t>6  Scale up</a:t>
+            </a:r>
+          </a:p>
+          <a:p>
+            <a:pPr algn="l"/>
+            <a:r>
+              <a:rPr sz="800" b="0">
                 <a:solidFill>
                   <a:srgbClr val="FFFFFF"/>
                 </a:solidFill>
@@ -17693,7 +18416,7 @@
                 </a:solidFill>
                 <a:latin typeface="Calibri"/>
               </a:rPr>
-              <a:t>analysts search one clean format instead of hundreds; events from different systems line up by time.</a:t>
+              <a:t>analysts search one clean format; failed logins, IPs and users are tagged automatically, and events line up by time.</a:t>
             </a:r>
           </a:p>
         </p:txBody>
@@ -17869,7 +18592,7 @@
                 </a:solidFill>
                 <a:latin typeface="Calibri"/>
               </a:rPr>
-              <a:t>runs on-premise with no internet, so sensitive logs never leave India (self-hosted AI planned).</a:t>
+              <a:t>can run on-premise with built-in rules, so sensitive logs stay in India (self-hosted AI planned).</a:t>
             </a:r>
           </a:p>
         </p:txBody>
@@ -19918,7 +20641,7 @@
                 </a:solidFill>
                 <a:latin typeface="Calibri"/>
               </a:rPr>
-              <a:t>Syslog (RFC 5424) · ISO 8601 time format</a:t>
+              <a:t>Syslog (RFC 5424) · CEF / LEEF · ISO 8601</a:t>
             </a:r>
           </a:p>
           <a:p>

</xml_diff>

<commit_message>
PPT: sharper one-line idea on slide 2
Co-authored-by: arena-agent <297053741+arena-agent@users.noreply.github.com>
</commit_message>
<xml_diff>
--- a/presentation/SIH2026_Idea_Submission.pptx
+++ b/presentation/SIH2026_Idea_Submission.pptx
@@ -8042,7 +8042,7 @@
                 </a:solidFill>
                 <a:latin typeface="Calibri"/>
               </a:rPr>
-              <a:t>Turn messy logs in hundreds of formats into </a:t>
+              <a:t>Hundreds of log formats in, </a:t>
             </a:r>
             <a:r>
               <a:rPr sz="1600" b="1">
@@ -8051,7 +8051,7 @@
                 </a:solidFill>
                 <a:latin typeface="Calibri"/>
               </a:rPr>
-              <a:t>one clean, common format</a:t>
+              <a:t>one clean format out</a:t>
             </a:r>
             <a:r>
               <a:rPr sz="1600" b="0">
@@ -8060,7 +8060,7 @@
                 </a:solidFill>
                 <a:latin typeface="Calibri"/>
               </a:rPr>
-              <a:t>. AI learns each new format </a:t>
+              <a:t>: AI learns each new format </a:t>
             </a:r>
             <a:r>
               <a:rPr sz="1600" b="1">
@@ -8069,7 +8069,7 @@
                 </a:solidFill>
                 <a:latin typeface="Calibri"/>
               </a:rPr>
-              <a:t>only once</a:t>
+              <a:t>once</a:t>
             </a:r>
             <a:r>
               <a:rPr sz="1600" b="0">
@@ -8078,7 +8078,7 @@
                 </a:solidFill>
                 <a:latin typeface="Calibri"/>
               </a:rPr>
-              <a:t>; after that, fast saved rules do the work.</a:t>
+              <a:t>, and saved rules handle it from then on.</a:t>
             </a:r>
           </a:p>
         </p:txBody>

</xml_diff>

<commit_message>
PPT: slide 5 impact & benefits rewritten from team points (5 + 5)
Co-authored-by: arena-agent <297053741+arena-agent@users.noreply.github.com>
</commit_message>
<xml_diff>
--- a/presentation/SIH2026_Idea_Submission.pptx
+++ b/presentation/SIH2026_Idea_Submission.pptx
@@ -18187,7 +18187,7 @@
                 </a:solidFill>
                 <a:latin typeface="Calibri"/>
               </a:rPr>
-              <a:t>Impact on NTRO &amp; NCIIPC</a:t>
+              <a:t>Impact</a:t>
             </a:r>
             <a:r>
               <a:rPr sz="1200" b="0">
@@ -18196,7 +18196,7 @@
                 </a:solidFill>
                 <a:latin typeface="Calibri"/>
               </a:rPr>
-              <a:t>   our target users</a:t>
+              <a:t>   for NTRO, NCIIPC &amp; sector security teams</a:t>
             </a:r>
           </a:p>
         </p:txBody>
@@ -18253,8 +18253,8 @@
         </p:nvSpPr>
         <p:spPr>
           <a:xfrm>
-            <a:off x="365760" y="1572768"/>
-            <a:ext cx="64008" cy="457200"/>
+            <a:off x="365760" y="1545336"/>
+            <a:ext cx="64008" cy="365760"/>
           </a:xfrm>
           <a:prstGeom prst="rect">
             <a:avLst/>
@@ -18297,8 +18297,8 @@
         </p:nvSpPr>
         <p:spPr>
           <a:xfrm>
-            <a:off x="502920" y="1554480"/>
-            <a:ext cx="5577840" cy="512064"/>
+            <a:off x="502920" y="1517904"/>
+            <a:ext cx="5577840" cy="420624"/>
           </a:xfrm>
           <a:prstGeom prst="rect">
             <a:avLst/>
@@ -18313,22 +18313,22 @@
           <a:p>
             <a:pPr algn="l"/>
             <a:r>
-              <a:rPr sz="1150" b="1">
+              <a:rPr sz="1050" b="1">
                 <a:solidFill>
                   <a:srgbClr val="1F5FBF"/>
                 </a:solidFill>
                 <a:latin typeface="Calibri"/>
               </a:rPr>
-              <a:t>One view of all sectors: </a:t>
-            </a:r>
-            <a:r>
-              <a:rPr sz="1150" b="0">
+              <a:t>Sharper security analysis: </a:t>
+            </a:r>
+            <a:r>
+              <a:rPr sz="1050" b="0">
                 <a:solidFill>
                   <a:srgbClr val="1E2530"/>
                 </a:solidFill>
                 <a:latin typeface="Calibri"/>
               </a:rPr>
-              <a:t>logs from power, banking, telecom &amp; govt security centres arrive in one common format, so NCIIPC sees the full picture.</a:t>
+              <a:t>logs from every system share one structure, so failed logins, errors and unusual events stand out.</a:t>
             </a:r>
           </a:p>
         </p:txBody>
@@ -18341,8 +18341,8 @@
         </p:nvSpPr>
         <p:spPr>
           <a:xfrm>
-            <a:off x="365760" y="2139696"/>
-            <a:ext cx="64008" cy="457200"/>
+            <a:off x="365760" y="2002536"/>
+            <a:ext cx="64008" cy="365760"/>
           </a:xfrm>
           <a:prstGeom prst="rect">
             <a:avLst/>
@@ -18385,8 +18385,8 @@
         </p:nvSpPr>
         <p:spPr>
           <a:xfrm>
-            <a:off x="502920" y="2121408"/>
-            <a:ext cx="5577840" cy="512064"/>
+            <a:off x="502920" y="1975104"/>
+            <a:ext cx="5577840" cy="420624"/>
           </a:xfrm>
           <a:prstGeom prst="rect">
             <a:avLst/>
@@ -18401,22 +18401,22 @@
           <a:p>
             <a:pPr algn="l"/>
             <a:r>
-              <a:rPr sz="1150" b="1">
+              <a:rPr sz="1050" b="1">
                 <a:solidFill>
                   <a:srgbClr val="138A36"/>
                 </a:solidFill>
                 <a:latin typeface="Calibri"/>
               </a:rPr>
-              <a:t>Faster threat detection: </a:t>
-            </a:r>
-            <a:r>
-              <a:rPr sz="1150" b="0">
+              <a:t>Faster processing: </a:t>
+            </a:r>
+            <a:r>
+              <a:rPr sz="1050" b="0">
                 <a:solidFill>
                   <a:srgbClr val="1E2530"/>
                 </a:solidFill>
                 <a:latin typeface="Calibri"/>
               </a:rPr>
-              <a:t>analysts search one clean format; failed logins, IPs and users are tagged automatically, and events line up by time.</a:t>
+              <a:t>parsing and cleanup are automatic; saved rules handle everyday logs instantly.</a:t>
             </a:r>
           </a:p>
         </p:txBody>
@@ -18429,8 +18429,8 @@
         </p:nvSpPr>
         <p:spPr>
           <a:xfrm>
-            <a:off x="365760" y="2706624"/>
-            <a:ext cx="64008" cy="457200"/>
+            <a:off x="365760" y="2459736"/>
+            <a:ext cx="64008" cy="365760"/>
           </a:xfrm>
           <a:prstGeom prst="rect">
             <a:avLst/>
@@ -18473,8 +18473,8 @@
         </p:nvSpPr>
         <p:spPr>
           <a:xfrm>
-            <a:off x="502920" y="2688336"/>
-            <a:ext cx="5577840" cy="512064"/>
+            <a:off x="502920" y="2432304"/>
+            <a:ext cx="5577840" cy="420624"/>
           </a:xfrm>
           <a:prstGeom prst="rect">
             <a:avLst/>
@@ -18489,22 +18489,22 @@
           <a:p>
             <a:pPr algn="l"/>
             <a:r>
-              <a:rPr sz="1150" b="1">
+              <a:rPr sz="1050" b="1">
                 <a:solidFill>
                   <a:srgbClr val="F58220"/>
                 </a:solidFill>
                 <a:latin typeface="Calibri"/>
               </a:rPr>
-              <a:t>Unusual logs flagged: </a:t>
-            </a:r>
-            <a:r>
-              <a:rPr sz="1150" b="0">
+              <a:t>Cleaner, reliable data: </a:t>
+            </a:r>
+            <a:r>
+              <a:rPr sz="1050" b="0">
                 <a:solidFill>
                   <a:srgbClr val="1E2530"/>
                 </a:solidFill>
                 <a:latin typeface="Calibri"/>
               </a:rPr>
-              <a:t>a never-seen log format is flagged automatically; it may be a new device, a misconfiguration or tampering.</a:t>
+              <a:t>missing fields get safe defaults, all times become UTC, and the original line is always kept.</a:t>
             </a:r>
           </a:p>
         </p:txBody>
@@ -18517,8 +18517,8 @@
         </p:nvSpPr>
         <p:spPr>
           <a:xfrm>
-            <a:off x="365760" y="3273552"/>
-            <a:ext cx="64008" cy="457200"/>
+            <a:off x="365760" y="2916936"/>
+            <a:ext cx="64008" cy="365760"/>
           </a:xfrm>
           <a:prstGeom prst="rect">
             <a:avLst/>
@@ -18555,14 +18555,58 @@
       </p:sp>
       <p:sp>
         <p:nvSpPr>
+          <p:cNvPr id="102" name="Rectangle 71"/>
+          <p:cNvSpPr/>
+          <p:nvPr/>
+        </p:nvSpPr>
+        <p:spPr>
+          <a:xfrm>
+            <a:off x="365760" y="3374136"/>
+            <a:ext cx="64008" cy="365760"/>
+          </a:xfrm>
+          <a:prstGeom prst="rect">
+            <a:avLst/>
+          </a:prstGeom>
+          <a:solidFill>
+            <a:srgbClr val="0E8C8C"/>
+          </a:solidFill>
+          <a:ln>
+            <a:noFill/>
+          </a:ln>
+          <a:effectLst/>
+        </p:spPr>
+        <p:style>
+          <a:lnRef idx="1">
+            <a:schemeClr val="accent1"/>
+          </a:lnRef>
+          <a:fillRef idx="3">
+            <a:schemeClr val="accent1"/>
+          </a:fillRef>
+          <a:effectRef idx="2">
+            <a:schemeClr val="accent1"/>
+          </a:effectRef>
+          <a:fontRef idx="minor">
+            <a:schemeClr val="lt1"/>
+          </a:fontRef>
+        </p:style>
+        <p:txBody>
+          <a:bodyPr rtlCol="0" anchor="ctr"/>
+          <a:lstStyle/>
+          <a:p>
+            <a:pPr algn="ctr"/>
+          </a:p>
+        </p:txBody>
+      </p:sp>
+      <p:sp>
+        <p:nvSpPr>
           <p:cNvPr id="73" name="TextBox 72"/>
           <p:cNvSpPr txBox="1"/>
           <p:nvPr/>
         </p:nvSpPr>
         <p:spPr>
           <a:xfrm>
-            <a:off x="502920" y="3255264"/>
-            <a:ext cx="5577840" cy="512064"/>
+            <a:off x="502920" y="2889504"/>
+            <a:ext cx="5577840" cy="420624"/>
           </a:xfrm>
           <a:prstGeom prst="rect">
             <a:avLst/>
@@ -18577,22 +18621,66 @@
           <a:p>
             <a:pPr algn="l"/>
             <a:r>
-              <a:rPr sz="1150" b="1">
+              <a:rPr sz="1050" b="1">
                 <a:solidFill>
                   <a:srgbClr val="6A3FB5"/>
                 </a:solidFill>
                 <a:latin typeface="Calibri"/>
               </a:rPr>
-              <a:t>Sovereign &amp; offline: </a:t>
-            </a:r>
-            <a:r>
-              <a:rPr sz="1150" b="0">
+              <a:t>Less operational effort: </a:t>
+            </a:r>
+            <a:r>
+              <a:rPr sz="1050" b="0">
                 <a:solidFill>
                   <a:srgbClr val="1E2530"/>
                 </a:solidFill>
                 <a:latin typeface="Calibri"/>
               </a:rPr>
-              <a:t>can run on-premise with built-in rules, so sensitive logs stay in India (self-hosted AI planned).</a:t>
+              <a:t>one pipeline replaces a separate hand-written parser for every log source.</a:t>
+            </a:r>
+          </a:p>
+        </p:txBody>
+      </p:sp>
+      <p:sp>
+        <p:nvSpPr>
+          <p:cNvPr id="103" name="TextBox 72"/>
+          <p:cNvSpPr txBox="1"/>
+          <p:nvPr/>
+        </p:nvSpPr>
+        <p:spPr>
+          <a:xfrm>
+            <a:off x="502920" y="3346704"/>
+            <a:ext cx="5577840" cy="420624"/>
+          </a:xfrm>
+          <a:prstGeom prst="rect">
+            <a:avLst/>
+          </a:prstGeom>
+          <a:noFill/>
+        </p:spPr>
+        <p:txBody>
+          <a:bodyPr wrap="square" lIns="36576" rIns="36576" tIns="18288" bIns="18288" anchor="ctr">
+            <a:spAutoFit/>
+          </a:bodyPr>
+          <a:lstStyle/>
+          <a:p>
+            <a:pPr algn="l"/>
+            <a:r>
+              <a:rPr sz="1050" b="1">
+                <a:solidFill>
+                  <a:srgbClr val="0E8C8C"/>
+                </a:solidFill>
+                <a:latin typeface="Calibri"/>
+              </a:rPr>
+              <a:t>Scales with growth: </a:t>
+            </a:r>
+            <a:r>
+              <a:rPr sz="1050" b="0">
+                <a:solidFill>
+                  <a:srgbClr val="1E2530"/>
+                </a:solidFill>
+                <a:latin typeface="Calibri"/>
+              </a:rPr>
+              <a:t>more logs do not mean more work; each format is learned once and reused.</a:t>
             </a:r>
           </a:p>
         </p:txBody>
@@ -18684,8 +18772,8 @@
         </p:nvSpPr>
         <p:spPr>
           <a:xfrm>
-            <a:off x="6263640" y="1609344"/>
-            <a:ext cx="1371600" cy="402336"/>
+            <a:off x="6263640" y="1554480"/>
+            <a:ext cx="1371600" cy="347472"/>
           </a:xfrm>
           <a:prstGeom prst="roundRect">
             <a:avLst>
@@ -18720,13 +18808,13 @@
           <a:p>
             <a:pPr algn="ctr"/>
             <a:r>
-              <a:rPr sz="1150" b="1">
+              <a:rPr sz="1100" b="1">
                 <a:solidFill>
                   <a:srgbClr val="1F5FBF"/>
                 </a:solidFill>
                 <a:latin typeface="Calibri"/>
               </a:rPr>
-              <a:t>Social</a:t>
+              <a:t>Any format</a:t>
             </a:r>
           </a:p>
         </p:txBody>
@@ -18739,8 +18827,8 @@
         </p:nvSpPr>
         <p:spPr>
           <a:xfrm>
-            <a:off x="7726680" y="1554480"/>
-            <a:ext cx="4160520" cy="512064"/>
+            <a:off x="7726680" y="1517904"/>
+            <a:ext cx="4160520" cy="420624"/>
           </a:xfrm>
           <a:prstGeom prst="rect">
             <a:avLst/>
@@ -18755,13 +18843,13 @@
           <a:p>
             <a:pPr algn="l"/>
             <a:r>
-              <a:rPr sz="1150" b="0">
+              <a:rPr sz="1050" b="0">
                 <a:solidFill>
                   <a:srgbClr val="1E2530"/>
                 </a:solidFill>
                 <a:latin typeface="Calibri"/>
               </a:rPr>
-              <a:t>Safer power, banking and telecom services for citizens, thanks to faster attack detection.</a:t>
+              <a:t>Standard formats work at once; new and custom formats are learned automatically.</a:t>
             </a:r>
           </a:p>
         </p:txBody>
@@ -18774,8 +18862,8 @@
         </p:nvSpPr>
         <p:spPr>
           <a:xfrm>
-            <a:off x="6263640" y="2176272"/>
-            <a:ext cx="1371600" cy="402336"/>
+            <a:off x="6263640" y="2011680"/>
+            <a:ext cx="1371600" cy="347472"/>
           </a:xfrm>
           <a:prstGeom prst="roundRect">
             <a:avLst>
@@ -18810,13 +18898,13 @@
           <a:p>
             <a:pPr algn="ctr"/>
             <a:r>
-              <a:rPr sz="1150" b="1">
+              <a:rPr sz="1100" b="1">
                 <a:solidFill>
                   <a:srgbClr val="B35C00"/>
                 </a:solidFill>
                 <a:latin typeface="Calibri"/>
               </a:rPr>
-              <a:t>Economic</a:t>
+              <a:t>No parser code</a:t>
             </a:r>
           </a:p>
         </p:txBody>
@@ -18829,8 +18917,8 @@
         </p:nvSpPr>
         <p:spPr>
           <a:xfrm>
-            <a:off x="7726680" y="2121408"/>
-            <a:ext cx="4160520" cy="512064"/>
+            <a:off x="7726680" y="1975104"/>
+            <a:ext cx="4160520" cy="420624"/>
           </a:xfrm>
           <a:prstGeom prst="rect">
             <a:avLst/>
@@ -18845,13 +18933,13 @@
           <a:p>
             <a:pPr algn="l"/>
             <a:r>
-              <a:rPr sz="1150" b="0">
+              <a:rPr sz="1050" b="0">
                 <a:solidFill>
                   <a:srgbClr val="1E2530"/>
                 </a:solidFill>
                 <a:latin typeface="Calibri"/>
               </a:rPr>
-              <a:t>No costly paid tools or hand-written parsers; the AI bill stays tiny even as logs grow.</a:t>
+              <a:t>Time, source, severity, IPs and users are found and mapped automatically.</a:t>
             </a:r>
           </a:p>
         </p:txBody>
@@ -18864,8 +18952,8 @@
         </p:nvSpPr>
         <p:spPr>
           <a:xfrm>
-            <a:off x="6263640" y="2743200"/>
-            <a:ext cx="1371600" cy="402336"/>
+            <a:off x="6263640" y="2468880"/>
+            <a:ext cx="1371600" cy="347472"/>
           </a:xfrm>
           <a:prstGeom prst="roundRect">
             <a:avLst>
@@ -18900,13 +18988,13 @@
           <a:p>
             <a:pPr algn="ctr"/>
             <a:r>
-              <a:rPr sz="1150" b="1">
+              <a:rPr sz="1100" b="1">
                 <a:solidFill>
                   <a:srgbClr val="138A36"/>
                 </a:solidFill>
                 <a:latin typeface="Calibri"/>
               </a:rPr>
-              <a:t>Environmental</a:t>
+              <a:t>One schema</a:t>
             </a:r>
           </a:p>
         </p:txBody>
@@ -18919,8 +19007,8 @@
         </p:nvSpPr>
         <p:spPr>
           <a:xfrm>
-            <a:off x="7726680" y="2688336"/>
-            <a:ext cx="4160520" cy="512064"/>
+            <a:off x="7726680" y="2432304"/>
+            <a:ext cx="4160520" cy="420624"/>
           </a:xfrm>
           <a:prstGeom prst="rect">
             <a:avLst/>
@@ -18935,13 +19023,13 @@
           <a:p>
             <a:pPr algn="l"/>
             <a:r>
-              <a:rPr sz="1150" b="0">
+              <a:rPr sz="1050" b="0">
                 <a:solidFill>
                   <a:srgbClr val="1E2530"/>
                 </a:solidFill>
                 <a:latin typeface="Calibri"/>
               </a:rPr>
-              <a:t>AI is used only for new formats, so far less computing power and energy is used.</a:t>
+              <a:t>Every log leaves in the same clean, common JSON format.</a:t>
             </a:r>
           </a:p>
         </p:txBody>
@@ -18954,8 +19042,8 @@
         </p:nvSpPr>
         <p:spPr>
           <a:xfrm>
-            <a:off x="6263640" y="3310128"/>
-            <a:ext cx="1371600" cy="402336"/>
+            <a:off x="6263640" y="2926080"/>
+            <a:ext cx="1371600" cy="347472"/>
           </a:xfrm>
           <a:prstGeom prst="roundRect">
             <a:avLst>
@@ -18990,13 +19078,68 @@
           <a:p>
             <a:pPr algn="ctr"/>
             <a:r>
-              <a:rPr sz="1150" b="1">
+              <a:rPr sz="1100" b="1">
                 <a:solidFill>
                   <a:srgbClr val="6A3FB5"/>
                 </a:solidFill>
                 <a:latin typeface="Calibri"/>
               </a:rPr>
-              <a:t>Strategic</a:t>
+              <a:t>Easy to plug in</a:t>
+            </a:r>
+          </a:p>
+        </p:txBody>
+      </p:sp>
+      <p:sp>
+        <p:nvSpPr>
+          <p:cNvPr id="104" name="Rounded Rectangle 81"/>
+          <p:cNvSpPr/>
+          <p:nvPr/>
+        </p:nvSpPr>
+        <p:spPr>
+          <a:xfrm>
+            <a:off x="6263640" y="3383280"/>
+            <a:ext cx="1371600" cy="347472"/>
+          </a:xfrm>
+          <a:prstGeom prst="roundRect">
+            <a:avLst>
+              <a:gd name="adj" fmla="val 30000"/>
+            </a:avLst>
+          </a:prstGeom>
+          <a:solidFill>
+            <a:srgbClr val="E3F4F4"/>
+          </a:solidFill>
+          <a:ln>
+            <a:noFill/>
+          </a:ln>
+          <a:effectLst/>
+        </p:spPr>
+        <p:style>
+          <a:lnRef idx="1">
+            <a:schemeClr val="accent1"/>
+          </a:lnRef>
+          <a:fillRef idx="3">
+            <a:schemeClr val="accent1"/>
+          </a:fillRef>
+          <a:effectRef idx="2">
+            <a:schemeClr val="accent1"/>
+          </a:effectRef>
+          <a:fontRef idx="minor">
+            <a:schemeClr val="lt1"/>
+          </a:fontRef>
+        </p:style>
+        <p:txBody>
+          <a:bodyPr rtlCol="0" anchor="ctr" wrap="square" lIns="54864" rIns="54864"/>
+          <a:lstStyle/>
+          <a:p>
+            <a:pPr algn="ctr"/>
+            <a:r>
+              <a:rPr sz="1100" b="1">
+                <a:solidFill>
+                  <a:srgbClr val="0E8C8C"/>
+                </a:solidFill>
+                <a:latin typeface="Calibri"/>
+              </a:rPr>
+              <a:t>Future-ready</a:t>
             </a:r>
           </a:p>
         </p:txBody>
@@ -19009,8 +19152,8 @@
         </p:nvSpPr>
         <p:spPr>
           <a:xfrm>
-            <a:off x="7726680" y="3255264"/>
-            <a:ext cx="4160520" cy="512064"/>
+            <a:off x="7726680" y="2889504"/>
+            <a:ext cx="4160520" cy="420624"/>
           </a:xfrm>
           <a:prstGeom prst="rect">
             <a:avLst/>
@@ -19025,13 +19168,48 @@
           <a:p>
             <a:pPr algn="l"/>
             <a:r>
-              <a:rPr sz="1150" b="0">
+              <a:rPr sz="1050" b="0">
                 <a:solidFill>
                   <a:srgbClr val="1E2530"/>
                 </a:solidFill>
                 <a:latin typeface="Calibri"/>
               </a:rPr>
-              <a:t>Self-reliant and open-source; helps every organisation meet CERT-In's 180-day log rule.</a:t>
+              <a:t>Output is ready for SIEM, monitoring &amp; analytics tools (connectors planned).</a:t>
+            </a:r>
+          </a:p>
+        </p:txBody>
+      </p:sp>
+      <p:sp>
+        <p:nvSpPr>
+          <p:cNvPr id="105" name="TextBox 82"/>
+          <p:cNvSpPr txBox="1"/>
+          <p:nvPr/>
+        </p:nvSpPr>
+        <p:spPr>
+          <a:xfrm>
+            <a:off x="7726680" y="3346704"/>
+            <a:ext cx="4160520" cy="420624"/>
+          </a:xfrm>
+          <a:prstGeom prst="rect">
+            <a:avLst/>
+          </a:prstGeom>
+          <a:noFill/>
+        </p:spPr>
+        <p:txBody>
+          <a:bodyPr wrap="square" lIns="36576" rIns="36576" tIns="18288" bIns="18288" anchor="ctr">
+            <a:spAutoFit/>
+          </a:bodyPr>
+          <a:lstStyle/>
+          <a:p>
+            <a:pPr algn="l"/>
+            <a:r>
+              <a:rPr sz="1050" b="0">
+                <a:solidFill>
+                  <a:srgbClr val="1E2530"/>
+                </a:solidFill>
+                <a:latin typeface="Calibri"/>
+              </a:rPr>
+              <a:t>New formats, rules and smarter methods can be added without redesign.</a:t>
             </a:r>
           </a:p>
         </p:txBody>

</xml_diff>

<commit_message>
PPT: slide 2 redesigned as 3-stage solution (collect, understand, deliver) from team content
Co-authored-by: arena-agent <297053741+arena-agent@users.noreply.github.com>
</commit_message>
<xml_diff>
--- a/presentation/SIH2026_Idea_Submission.pptx
+++ b/presentation/SIH2026_Idea_Submission.pptx
@@ -8085,27 +8085,58 @@
       </p:sp>
       <p:sp>
         <p:nvSpPr>
-          <p:cNvPr id="59" name="Rounded Rectangle 58"/>
+          <p:cNvPr id="67" name="TextBox 66"/>
+          <p:cNvSpPr txBox="1"/>
+          <p:nvPr/>
+        </p:nvSpPr>
+        <p:spPr>
+          <a:xfrm>
+            <a:off x="365760" y="5303520"/>
+            <a:ext cx="5486400" cy="256032"/>
+          </a:xfrm>
+          <a:prstGeom prst="rect">
+            <a:avLst/>
+          </a:prstGeom>
+          <a:noFill/>
+        </p:spPr>
+        <p:txBody>
+          <a:bodyPr wrap="square" lIns="36576" rIns="36576" tIns="18288" bIns="18288" anchor="t">
+            <a:spAutoFit/>
+          </a:bodyPr>
+          <a:lstStyle/>
+          <a:p>
+            <a:pPr algn="l"/>
+            <a:r>
+              <a:rPr sz="1450" b="1">
+                <a:solidFill>
+                  <a:srgbClr val="0B2A5B"/>
+                </a:solidFill>
+                <a:latin typeface="Calibri"/>
+              </a:rPr>
+              <a:t>Innovation &amp; uniqueness</a:t>
+            </a:r>
+          </a:p>
+        </p:txBody>
+      </p:sp>
+      <p:sp>
+        <p:nvSpPr>
+          <p:cNvPr id="68" name="Rectangle 67"/>
           <p:cNvSpPr/>
           <p:nvPr/>
         </p:nvSpPr>
         <p:spPr>
           <a:xfrm>
-            <a:off x="365760" y="1920240"/>
-            <a:ext cx="11503152" cy="3493008"/>
-          </a:xfrm>
-          <a:prstGeom prst="roundRect">
-            <a:avLst>
-              <a:gd name="adj" fmla="val 3000"/>
-            </a:avLst>
+            <a:off x="402336" y="5568696"/>
+            <a:ext cx="822960" cy="41148"/>
+          </a:xfrm>
+          <a:prstGeom prst="rect">
+            <a:avLst/>
           </a:prstGeom>
           <a:solidFill>
-            <a:srgbClr val="FFFFFF"/>
+            <a:srgbClr val="F58220"/>
           </a:solidFill>
-          <a:ln w="12700">
-            <a:solidFill>
-              <a:srgbClr val="D3DBE8"/>
-            </a:solidFill>
+          <a:ln>
+            <a:noFill/>
           </a:ln>
           <a:effectLst/>
         </p:spPr>
@@ -8133,19 +8164,63 @@
       </p:sp>
       <p:sp>
         <p:nvSpPr>
-          <p:cNvPr id="60" name="Rounded Rectangle 59"/>
+          <p:cNvPr id="69" name="Rounded Rectangle 68"/>
           <p:cNvSpPr/>
           <p:nvPr/>
         </p:nvSpPr>
         <p:spPr>
           <a:xfrm>
-            <a:off x="365760" y="1920240"/>
-            <a:ext cx="11503152" cy="384048"/>
+            <a:off x="365760" y="5650992"/>
+            <a:ext cx="2807208" cy="658368"/>
           </a:xfrm>
           <a:prstGeom prst="roundRect">
             <a:avLst>
-              <a:gd name="adj" fmla="val 30000"/>
+              <a:gd name="adj" fmla="val 12000"/>
             </a:avLst>
+          </a:prstGeom>
+          <a:solidFill>
+            <a:srgbClr val="E8F0FB"/>
+          </a:solidFill>
+          <a:ln>
+            <a:noFill/>
+          </a:ln>
+          <a:effectLst/>
+        </p:spPr>
+        <p:style>
+          <a:lnRef idx="1">
+            <a:schemeClr val="accent1"/>
+          </a:lnRef>
+          <a:fillRef idx="3">
+            <a:schemeClr val="accent1"/>
+          </a:fillRef>
+          <a:effectRef idx="2">
+            <a:schemeClr val="accent1"/>
+          </a:effectRef>
+          <a:fontRef idx="minor">
+            <a:schemeClr val="lt1"/>
+          </a:fontRef>
+        </p:style>
+        <p:txBody>
+          <a:bodyPr rtlCol="0" anchor="ctr"/>
+          <a:lstStyle/>
+          <a:p>
+            <a:pPr algn="ctr"/>
+          </a:p>
+        </p:txBody>
+      </p:sp>
+      <p:sp>
+        <p:nvSpPr>
+          <p:cNvPr id="70" name="Rectangle 69"/>
+          <p:cNvSpPr/>
+          <p:nvPr/>
+        </p:nvSpPr>
+        <p:spPr>
+          <a:xfrm>
+            <a:off x="365760" y="5733288"/>
+            <a:ext cx="64008" cy="493776"/>
+          </a:xfrm>
+          <a:prstGeom prst="rect">
+            <a:avLst/>
           </a:prstGeom>
           <a:solidFill>
             <a:srgbClr val="1F5FBF"/>
@@ -8179,14 +8254,14 @@
       </p:sp>
       <p:sp>
         <p:nvSpPr>
-          <p:cNvPr id="61" name="TextBox 60"/>
+          <p:cNvPr id="71" name="TextBox 70"/>
           <p:cNvSpPr txBox="1"/>
           <p:nvPr/>
         </p:nvSpPr>
         <p:spPr>
           <a:xfrm>
-            <a:off x="548640" y="1920240"/>
-            <a:ext cx="11155680" cy="384048"/>
+            <a:off x="530352" y="5650992"/>
+            <a:ext cx="2578608" cy="658368"/>
           </a:xfrm>
           <a:prstGeom prst="rect">
             <a:avLst/>
@@ -8201,112 +8276,47 @@
           <a:p>
             <a:pPr algn="l"/>
             <a:r>
-              <a:rPr sz="1450" b="1">
-                <a:solidFill>
-                  <a:srgbClr val="FFFFFF"/>
-                </a:solidFill>
-                <a:latin typeface="Calibri"/>
-              </a:rPr>
-              <a:t>OUR SOLUTION</a:t>
-            </a:r>
-            <a:r>
-              <a:rPr sz="1200" b="0">
-                <a:solidFill>
-                  <a:srgbClr val="FFFFFF"/>
-                </a:solidFill>
-                <a:latin typeface="Calibri"/>
-              </a:rPr>
-              <a:t>   a smart, self-learning log pre-processing pipeline</a:t>
-            </a:r>
-          </a:p>
-        </p:txBody>
-      </p:sp>
-      <p:sp>
-        <p:nvSpPr>
-          <p:cNvPr id="62" name="TextBox 61"/>
-          <p:cNvSpPr txBox="1"/>
-          <p:nvPr/>
-        </p:nvSpPr>
-        <p:spPr>
-          <a:xfrm>
-            <a:off x="548640" y="2377440"/>
-            <a:ext cx="5486400" cy="274320"/>
-          </a:xfrm>
-          <a:prstGeom prst="rect">
-            <a:avLst/>
-          </a:prstGeom>
-          <a:noFill/>
-        </p:spPr>
-        <p:txBody>
-          <a:bodyPr wrap="square" lIns="36576" rIns="36576" tIns="18288" bIns="18288" anchor="t">
-            <a:spAutoFit/>
-          </a:bodyPr>
-          <a:lstStyle/>
+              <a:rPr sz="1100" b="1">
+                <a:solidFill>
+                  <a:srgbClr val="1F5FBF"/>
+                </a:solidFill>
+                <a:latin typeface="Calibri"/>
+              </a:rPr>
+              <a:t>Learns by itself</a:t>
+            </a:r>
+          </a:p>
           <a:p>
             <a:pPr algn="l"/>
             <a:r>
-              <a:rPr sz="1300" b="1">
-                <a:solidFill>
-                  <a:srgbClr val="1F5FBF"/>
-                </a:solidFill>
-                <a:latin typeface="Calibri"/>
-              </a:rPr>
-              <a:t>How it works</a:t>
-            </a:r>
-          </a:p>
-        </p:txBody>
-      </p:sp>
-      <p:sp>
-        <p:nvSpPr>
-          <p:cNvPr id="63" name="TextBox 62"/>
-          <p:cNvSpPr txBox="1"/>
-          <p:nvPr/>
-        </p:nvSpPr>
-        <p:spPr>
-          <a:xfrm>
-            <a:off x="6355080" y="2377440"/>
-            <a:ext cx="5486400" cy="274320"/>
-          </a:xfrm>
-          <a:prstGeom prst="rect">
-            <a:avLst/>
-          </a:prstGeom>
-          <a:noFill/>
-        </p:spPr>
-        <p:txBody>
-          <a:bodyPr wrap="square" lIns="36576" rIns="36576" tIns="18288" bIns="18288" anchor="t">
-            <a:spAutoFit/>
-          </a:bodyPr>
-          <a:lstStyle/>
-          <a:p>
-            <a:pPr algn="l"/>
-            <a:r>
-              <a:rPr sz="1300" b="1">
-                <a:solidFill>
-                  <a:srgbClr val="138A36"/>
-                </a:solidFill>
-                <a:latin typeface="Calibri"/>
-              </a:rPr>
-              <a:t>How it addresses the problem</a:t>
-            </a:r>
-          </a:p>
-        </p:txBody>
-      </p:sp>
-      <p:sp>
-        <p:nvSpPr>
-          <p:cNvPr id="64" name="Rectangle 63"/>
+              <a:rPr sz="1100" b="0">
+                <a:solidFill>
+                  <a:srgbClr val="1E2530"/>
+                </a:solidFill>
+                <a:latin typeface="Calibri"/>
+              </a:rPr>
+              <a:t>no hand-written rules</a:t>
+            </a:r>
+          </a:p>
+        </p:txBody>
+      </p:sp>
+      <p:sp>
+        <p:nvSpPr>
+          <p:cNvPr id="72" name="Rounded Rectangle 71"/>
           <p:cNvSpPr/>
           <p:nvPr/>
         </p:nvSpPr>
         <p:spPr>
           <a:xfrm>
-            <a:off x="6144768" y="2423160"/>
-            <a:ext cx="18288" cy="2880360"/>
-          </a:xfrm>
-          <a:prstGeom prst="rect">
-            <a:avLst/>
+            <a:off x="3264408" y="5650992"/>
+            <a:ext cx="2807208" cy="658368"/>
+          </a:xfrm>
+          <a:prstGeom prst="roundRect">
+            <a:avLst>
+              <a:gd name="adj" fmla="val 12000"/>
+            </a:avLst>
           </a:prstGeom>
           <a:solidFill>
-            <a:srgbClr val="D3DBE8"/>
+            <a:srgbClr val="FFF4E0"/>
           </a:solidFill>
           <a:ln>
             <a:noFill/>
@@ -8337,571 +8347,14 @@
       </p:sp>
       <p:sp>
         <p:nvSpPr>
-          <p:cNvPr id="65" name="TextBox 64"/>
-          <p:cNvSpPr txBox="1"/>
-          <p:nvPr/>
-        </p:nvSpPr>
-        <p:spPr>
-          <a:xfrm>
-            <a:off x="548640" y="2688336"/>
-            <a:ext cx="5486400" cy="2743200"/>
-          </a:xfrm>
-          <a:prstGeom prst="rect">
-            <a:avLst/>
-          </a:prstGeom>
-          <a:noFill/>
-        </p:spPr>
-        <p:txBody>
-          <a:bodyPr wrap="square" lIns="36576" rIns="36576" tIns="18288" bIns="18288" anchor="t">
-            <a:spAutoFit/>
-          </a:bodyPr>
-          <a:lstStyle/>
-          <a:p>
-            <a:pPr algn="l">
-              <a:spcAft>
-                <a:spcPts val="400"/>
-              </a:spcAft>
-            </a:pPr>
-            <a:r>
-              <a:rPr sz="1100" b="1">
-                <a:solidFill>
-                  <a:srgbClr val="1F5FBF"/>
-                </a:solidFill>
-                <a:latin typeface="Calibri"/>
-              </a:rPr>
-              <a:t>•  </a:t>
-            </a:r>
-            <a:r>
-              <a:rPr sz="1100" b="1">
-                <a:solidFill>
-                  <a:srgbClr val="0B2A5B"/>
-                </a:solidFill>
-                <a:latin typeface="Calibri"/>
-              </a:rPr>
-              <a:t>Collect: </a:t>
-            </a:r>
-            <a:r>
-              <a:rPr sz="1100" b="0">
-                <a:solidFill>
-                  <a:srgbClr val="1E2530"/>
-                </a:solidFill>
-                <a:latin typeface="Calibri"/>
-              </a:rPr>
-              <a:t>servers, apps, firewalls and cloud send logs through a web API or a Bash collector (syslog, journalctl, Docker, Kubernetes).</a:t>
-            </a:r>
-          </a:p>
-          <a:p>
-            <a:pPr algn="l">
-              <a:spcAft>
-                <a:spcPts val="400"/>
-              </a:spcAft>
-            </a:pPr>
-            <a:r>
-              <a:rPr sz="1100" b="1">
-                <a:solidFill>
-                  <a:srgbClr val="1F5FBF"/>
-                </a:solidFill>
-                <a:latin typeface="Calibri"/>
-              </a:rPr>
-              <a:t>•  </a:t>
-            </a:r>
-            <a:r>
-              <a:rPr sz="1100" b="1">
-                <a:solidFill>
-                  <a:srgbClr val="0B2A5B"/>
-                </a:solidFill>
-                <a:latin typeface="Calibri"/>
-              </a:rPr>
-              <a:t>Ready-made formats: </a:t>
-            </a:r>
-            <a:r>
-              <a:rPr sz="1100" b="0">
-                <a:solidFill>
-                  <a:srgbClr val="1E2530"/>
-                </a:solidFill>
-                <a:latin typeface="Calibri"/>
-              </a:rPr>
-              <a:t>Syslog, JSON, Apache/Nginx, Java, Kubernetes, PostgreSQL and firewall formats (CEF/LEEF) work at once, without AI.</a:t>
-            </a:r>
-          </a:p>
-          <a:p>
-            <a:pPr algn="l">
-              <a:spcAft>
-                <a:spcPts val="400"/>
-              </a:spcAft>
-            </a:pPr>
-            <a:r>
-              <a:rPr sz="1100" b="1">
-                <a:solidFill>
-                  <a:srgbClr val="1F5FBF"/>
-                </a:solidFill>
-                <a:latin typeface="Calibri"/>
-              </a:rPr>
-              <a:t>•  </a:t>
-            </a:r>
-            <a:r>
-              <a:rPr sz="1100" b="1">
-                <a:solidFill>
-                  <a:srgbClr val="0B2A5B"/>
-                </a:solidFill>
-                <a:latin typeface="Calibri"/>
-              </a:rPr>
-              <a:t>Group &amp; check: </a:t>
-            </a:r>
-            <a:r>
-              <a:rPr sz="1100" b="0">
-                <a:solidFill>
-                  <a:srgbClr val="1E2530"/>
-                </a:solidFill>
-                <a:latin typeface="Calibri"/>
-              </a:rPr>
-              <a:t>similar lines become patterns; a light ML model tells whether a pattern is known or brand new.</a:t>
-            </a:r>
-          </a:p>
-          <a:p>
-            <a:pPr algn="l">
-              <a:spcAft>
-                <a:spcPts val="400"/>
-              </a:spcAft>
-            </a:pPr>
-            <a:r>
-              <a:rPr sz="1100" b="1">
-                <a:solidFill>
-                  <a:srgbClr val="1F5FBF"/>
-                </a:solidFill>
-                <a:latin typeface="Calibri"/>
-              </a:rPr>
-              <a:t>•  </a:t>
-            </a:r>
-            <a:r>
-              <a:rPr sz="1100" b="1">
-                <a:solidFill>
-                  <a:srgbClr val="0B2A5B"/>
-                </a:solidFill>
-                <a:latin typeface="Calibri"/>
-              </a:rPr>
-              <a:t>Learn once: </a:t>
-            </a:r>
-            <a:r>
-              <a:rPr sz="1100" b="0">
-                <a:solidFill>
-                  <a:srgbClr val="1E2530"/>
-                </a:solidFill>
-                <a:latin typeface="Calibri"/>
-              </a:rPr>
-              <a:t>for a new pattern, AI writes a parsing rule one time; the rule is saved and reused.</a:t>
-            </a:r>
-          </a:p>
-          <a:p>
-            <a:pPr algn="l">
-              <a:spcAft>
-                <a:spcPts val="400"/>
-              </a:spcAft>
-            </a:pPr>
-            <a:r>
-              <a:rPr sz="1100" b="1">
-                <a:solidFill>
-                  <a:srgbClr val="1F5FBF"/>
-                </a:solidFill>
-                <a:latin typeface="Calibri"/>
-              </a:rPr>
-              <a:t>•  </a:t>
-            </a:r>
-            <a:r>
-              <a:rPr sz="1100" b="1">
-                <a:solidFill>
-                  <a:srgbClr val="0B2A5B"/>
-                </a:solidFill>
-                <a:latin typeface="Calibri"/>
-              </a:rPr>
-              <a:t>Clean output: </a:t>
-            </a:r>
-            <a:r>
-              <a:rPr sz="1100" b="0">
-                <a:solidFill>
-                  <a:srgbClr val="1E2530"/>
-                </a:solidFill>
-                <a:latin typeface="Calibri"/>
-              </a:rPr>
-              <a:t>plain JSON with time (UTC), source, event, severity and message; multi-line errors stay one event; the original line is always kept.</a:t>
-            </a:r>
-          </a:p>
-          <a:p>
-            <a:pPr algn="l">
-              <a:spcAft>
-                <a:spcPts val="400"/>
-              </a:spcAft>
-            </a:pPr>
-            <a:r>
-              <a:rPr sz="1100" b="1">
-                <a:solidFill>
-                  <a:srgbClr val="1F5FBF"/>
-                </a:solidFill>
-                <a:latin typeface="Calibri"/>
-              </a:rPr>
-              <a:t>•  </a:t>
-            </a:r>
-            <a:r>
-              <a:rPr sz="1100" b="1">
-                <a:solidFill>
-                  <a:srgbClr val="0B2A5B"/>
-                </a:solidFill>
-                <a:latin typeface="Calibri"/>
-              </a:rPr>
-              <a:t>Security tags: </a:t>
-            </a:r>
-            <a:r>
-              <a:rPr sz="1100" b="0">
-                <a:solidFill>
-                  <a:srgbClr val="1E2530"/>
-                </a:solidFill>
-                <a:latin typeface="Calibri"/>
-              </a:rPr>
-              <a:t>failed logins, connection errors and database queries are tagged; IPs, users and ports are pulled out.</a:t>
-            </a:r>
-          </a:p>
-          <a:p>
-            <a:pPr algn="l">
-              <a:spcAft>
-                <a:spcPts val="400"/>
-              </a:spcAft>
-            </a:pPr>
-            <a:r>
-              <a:rPr sz="1100" b="1">
-                <a:solidFill>
-                  <a:srgbClr val="1F5FBF"/>
-                </a:solidFill>
-                <a:latin typeface="Calibri"/>
-              </a:rPr>
-              <a:t>•  </a:t>
-            </a:r>
-            <a:r>
-              <a:rPr sz="1100" b="1">
-                <a:solidFill>
-                  <a:srgbClr val="0B2A5B"/>
-                </a:solidFill>
-                <a:latin typeface="Calibri"/>
-              </a:rPr>
-              <a:t>Safety net: </a:t>
-            </a:r>
-            <a:r>
-              <a:rPr sz="1100" b="0">
-                <a:solidFill>
-                  <a:srgbClr val="1E2530"/>
-                </a:solidFill>
-                <a:latin typeface="Calibri"/>
-              </a:rPr>
-              <a:t>unusual formats wait in a review queue and are learned in one go once they repeat; a backup AI and built-in rules take over if AI is down.</a:t>
-            </a:r>
-          </a:p>
-        </p:txBody>
-      </p:sp>
-      <p:sp>
-        <p:nvSpPr>
-          <p:cNvPr id="66" name="TextBox 65"/>
-          <p:cNvSpPr txBox="1"/>
-          <p:nvPr/>
-        </p:nvSpPr>
-        <p:spPr>
-          <a:xfrm>
-            <a:off x="6355080" y="2688336"/>
-            <a:ext cx="5394960" cy="2743200"/>
-          </a:xfrm>
-          <a:prstGeom prst="rect">
-            <a:avLst/>
-          </a:prstGeom>
-          <a:noFill/>
-        </p:spPr>
-        <p:txBody>
-          <a:bodyPr wrap="square" lIns="36576" rIns="36576" tIns="18288" bIns="18288" anchor="t">
-            <a:spAutoFit/>
-          </a:bodyPr>
-          <a:lstStyle/>
-          <a:p>
-            <a:pPr algn="l">
-              <a:spcAft>
-                <a:spcPts val="400"/>
-              </a:spcAft>
-            </a:pPr>
-            <a:r>
-              <a:rPr sz="1100" b="1">
-                <a:solidFill>
-                  <a:srgbClr val="138A36"/>
-                </a:solidFill>
-                <a:latin typeface="Calibri"/>
-              </a:rPr>
-              <a:t>•  </a:t>
-            </a:r>
-            <a:r>
-              <a:rPr sz="1100" b="1">
-                <a:solidFill>
-                  <a:srgbClr val="C0392B"/>
-                </a:solidFill>
-                <a:latin typeface="Calibri"/>
-              </a:rPr>
-              <a:t>Too many formats → </a:t>
-            </a:r>
-            <a:r>
-              <a:rPr sz="1100" b="0">
-                <a:solidFill>
-                  <a:srgbClr val="1E2530"/>
-                </a:solidFill>
-                <a:latin typeface="Calibri"/>
-              </a:rPr>
-              <a:t>common formats work at once and new ones are learned automatically, so any source can be connected.</a:t>
-            </a:r>
-          </a:p>
-          <a:p>
-            <a:pPr algn="l">
-              <a:spcAft>
-                <a:spcPts val="400"/>
-              </a:spcAft>
-            </a:pPr>
-            <a:r>
-              <a:rPr sz="1100" b="1">
-                <a:solidFill>
-                  <a:srgbClr val="138A36"/>
-                </a:solidFill>
-                <a:latin typeface="Calibri"/>
-              </a:rPr>
-              <a:t>•  </a:t>
-            </a:r>
-            <a:r>
-              <a:rPr sz="1100" b="1">
-                <a:solidFill>
-                  <a:srgbClr val="C0392B"/>
-                </a:solidFill>
-                <a:latin typeface="Calibri"/>
-              </a:rPr>
-              <a:t>Parsers keep breaking → </a:t>
-            </a:r>
-            <a:r>
-              <a:rPr sz="1100" b="0">
-                <a:solidFill>
-                  <a:srgbClr val="1E2530"/>
-                </a:solidFill>
-                <a:latin typeface="Calibri"/>
-              </a:rPr>
-              <a:t>no hand-written parser code to write, fix or maintain.</a:t>
-            </a:r>
-          </a:p>
-          <a:p>
-            <a:pPr algn="l">
-              <a:spcAft>
-                <a:spcPts val="400"/>
-              </a:spcAft>
-            </a:pPr>
-            <a:r>
-              <a:rPr sz="1100" b="1">
-                <a:solidFill>
-                  <a:srgbClr val="138A36"/>
-                </a:solidFill>
-                <a:latin typeface="Calibri"/>
-              </a:rPr>
-              <a:t>•  </a:t>
-            </a:r>
-            <a:r>
-              <a:rPr sz="1100" b="1">
-                <a:solidFill>
-                  <a:srgbClr val="C0392B"/>
-                </a:solidFill>
-                <a:latin typeface="Calibri"/>
-              </a:rPr>
-              <a:t>AI is slow &amp; costly → </a:t>
-            </a:r>
-            <a:r>
-              <a:rPr sz="1100" b="0">
-                <a:solidFill>
-                  <a:srgbClr val="1E2530"/>
-                </a:solidFill>
-                <a:latin typeface="Calibri"/>
-              </a:rPr>
-              <a:t>AI runs once per format, not per log; everyday logs use fast saved rules.</a:t>
-            </a:r>
-          </a:p>
-          <a:p>
-            <a:pPr algn="l">
-              <a:spcAft>
-                <a:spcPts val="400"/>
-              </a:spcAft>
-            </a:pPr>
-            <a:r>
-              <a:rPr sz="1100" b="1">
-                <a:solidFill>
-                  <a:srgbClr val="138A36"/>
-                </a:solidFill>
-                <a:latin typeface="Calibri"/>
-              </a:rPr>
-              <a:t>•  </a:t>
-            </a:r>
-            <a:r>
-              <a:rPr sz="1100" b="1">
-                <a:solidFill>
-                  <a:srgbClr val="C0392B"/>
-                </a:solidFill>
-                <a:latin typeface="Calibri"/>
-              </a:rPr>
-              <a:t>Hard to investigate → </a:t>
-            </a:r>
-            <a:r>
-              <a:rPr sz="1100" b="0">
-                <a:solidFill>
-                  <a:srgbClr val="1E2530"/>
-                </a:solidFill>
-                <a:latin typeface="Calibri"/>
-              </a:rPr>
-              <a:t>all logs share one clean, time-aligned, security-tagged format, so analysts search one place.</a:t>
-            </a:r>
-          </a:p>
-          <a:p>
-            <a:pPr algn="l">
-              <a:spcAft>
-                <a:spcPts val="400"/>
-              </a:spcAft>
-            </a:pPr>
-            <a:r>
-              <a:rPr sz="1100" b="1">
-                <a:solidFill>
-                  <a:srgbClr val="138A36"/>
-                </a:solidFill>
-                <a:latin typeface="Calibri"/>
-              </a:rPr>
-              <a:t>•  </a:t>
-            </a:r>
-            <a:r>
-              <a:rPr sz="1100" b="1">
-                <a:solidFill>
-                  <a:srgbClr val="C0392B"/>
-                </a:solidFill>
-                <a:latin typeface="Calibri"/>
-              </a:rPr>
-              <a:t>Compliance &amp; audits → </a:t>
-            </a:r>
-            <a:r>
-              <a:rPr sz="1100" b="0">
-                <a:solidFill>
-                  <a:srgbClr val="1E2530"/>
-                </a:solidFill>
-                <a:latin typeface="Calibri"/>
-              </a:rPr>
-              <a:t>the original line is kept with every clean record, helping CERT-In's 180-day log rule and forensics.</a:t>
-            </a:r>
-          </a:p>
-          <a:p>
-            <a:pPr algn="l">
-              <a:spcAft>
-                <a:spcPts val="400"/>
-              </a:spcAft>
-            </a:pPr>
-            <a:r>
-              <a:rPr sz="1100" b="1">
-                <a:solidFill>
-                  <a:srgbClr val="138A36"/>
-                </a:solidFill>
-                <a:latin typeface="Calibri"/>
-              </a:rPr>
-              <a:t>•  </a:t>
-            </a:r>
-            <a:r>
-              <a:rPr sz="1100" b="1">
-                <a:solidFill>
-                  <a:srgbClr val="C0392B"/>
-                </a:solidFill>
-                <a:latin typeface="Calibri"/>
-              </a:rPr>
-              <a:t>Tool lock-in → </a:t>
-            </a:r>
-            <a:r>
-              <a:rPr sz="1100" b="0">
-                <a:solidFill>
-                  <a:srgbClr val="1E2530"/>
-                </a:solidFill>
-                <a:latin typeface="Calibri"/>
-              </a:rPr>
-              <a:t>plain JSON output can feed existing search &amp; monitoring tools (ready connectors planned).</a:t>
-            </a:r>
-          </a:p>
-          <a:p>
-            <a:pPr algn="l">
-              <a:spcAft>
-                <a:spcPts val="400"/>
-              </a:spcAft>
-            </a:pPr>
-            <a:r>
-              <a:rPr sz="1100" b="1">
-                <a:solidFill>
-                  <a:srgbClr val="138A36"/>
-                </a:solidFill>
-                <a:latin typeface="Calibri"/>
-              </a:rPr>
-              <a:t>•  </a:t>
-            </a:r>
-            <a:r>
-              <a:rPr sz="1100" b="1">
-                <a:solidFill>
-                  <a:srgbClr val="C0392B"/>
-                </a:solidFill>
-                <a:latin typeface="Calibri"/>
-              </a:rPr>
-              <a:t>Data privacy → </a:t>
-            </a:r>
-            <a:r>
-              <a:rPr sz="1100" b="0">
-                <a:solidFill>
-                  <a:srgbClr val="1E2530"/>
-                </a:solidFill>
-                <a:latin typeface="Calibri"/>
-              </a:rPr>
-              <a:t>can run on-premise with built-in rules; self-hosted AI (planned) keeps sensitive logs inside the organisation.</a:t>
-            </a:r>
-          </a:p>
-        </p:txBody>
-      </p:sp>
-      <p:sp>
-        <p:nvSpPr>
-          <p:cNvPr id="67" name="TextBox 66"/>
-          <p:cNvSpPr txBox="1"/>
-          <p:nvPr/>
-        </p:nvSpPr>
-        <p:spPr>
-          <a:xfrm>
-            <a:off x="365760" y="5486400"/>
-            <a:ext cx="5486400" cy="256032"/>
-          </a:xfrm>
-          <a:prstGeom prst="rect">
-            <a:avLst/>
-          </a:prstGeom>
-          <a:noFill/>
-        </p:spPr>
-        <p:txBody>
-          <a:bodyPr wrap="square" lIns="36576" rIns="36576" tIns="18288" bIns="18288" anchor="t">
-            <a:spAutoFit/>
-          </a:bodyPr>
-          <a:lstStyle/>
-          <a:p>
-            <a:pPr algn="l"/>
-            <a:r>
-              <a:rPr sz="1450" b="1">
-                <a:solidFill>
-                  <a:srgbClr val="0B2A5B"/>
-                </a:solidFill>
-                <a:latin typeface="Calibri"/>
-              </a:rPr>
-              <a:t>Innovation &amp; uniqueness</a:t>
-            </a:r>
-          </a:p>
-        </p:txBody>
-      </p:sp>
-      <p:sp>
-        <p:nvSpPr>
-          <p:cNvPr id="68" name="Rectangle 67"/>
+          <p:cNvPr id="73" name="Rectangle 72"/>
           <p:cNvSpPr/>
           <p:nvPr/>
         </p:nvSpPr>
         <p:spPr>
           <a:xfrm>
-            <a:off x="402336" y="5751576"/>
-            <a:ext cx="822960" cy="41148"/>
+            <a:off x="3264408" y="5733288"/>
+            <a:ext cx="64008" cy="493776"/>
           </a:xfrm>
           <a:prstGeom prst="rect">
             <a:avLst/>
@@ -8938,14 +8391,61 @@
       </p:sp>
       <p:sp>
         <p:nvSpPr>
-          <p:cNvPr id="69" name="Rounded Rectangle 68"/>
+          <p:cNvPr id="74" name="TextBox 73"/>
+          <p:cNvSpPr txBox="1"/>
+          <p:nvPr/>
+        </p:nvSpPr>
+        <p:spPr>
+          <a:xfrm>
+            <a:off x="3429000" y="5650992"/>
+            <a:ext cx="2578608" cy="658368"/>
+          </a:xfrm>
+          <a:prstGeom prst="rect">
+            <a:avLst/>
+          </a:prstGeom>
+          <a:noFill/>
+        </p:spPr>
+        <p:txBody>
+          <a:bodyPr wrap="square" lIns="36576" rIns="36576" tIns="18288" bIns="18288" anchor="ctr">
+            <a:spAutoFit/>
+          </a:bodyPr>
+          <a:lstStyle/>
+          <a:p>
+            <a:pPr algn="l"/>
+            <a:r>
+              <a:rPr sz="1100" b="1">
+                <a:solidFill>
+                  <a:srgbClr val="F58220"/>
+                </a:solidFill>
+                <a:latin typeface="Calibri"/>
+              </a:rPr>
+              <a:t>AI only when needed</a:t>
+            </a:r>
+          </a:p>
+          <a:p>
+            <a:pPr algn="l"/>
+            <a:r>
+              <a:rPr sz="1100" b="0">
+                <a:solidFill>
+                  <a:srgbClr val="1E2530"/>
+                </a:solidFill>
+                <a:latin typeface="Calibri"/>
+              </a:rPr>
+              <a:t>keeps cost low</a:t>
+            </a:r>
+          </a:p>
+        </p:txBody>
+      </p:sp>
+      <p:sp>
+        <p:nvSpPr>
+          <p:cNvPr id="75" name="Rounded Rectangle 74"/>
           <p:cNvSpPr/>
           <p:nvPr/>
         </p:nvSpPr>
         <p:spPr>
           <a:xfrm>
-            <a:off x="365760" y="5833872"/>
-            <a:ext cx="2807208" cy="530352"/>
+            <a:off x="6163056" y="5650992"/>
+            <a:ext cx="2807208" cy="658368"/>
           </a:xfrm>
           <a:prstGeom prst="roundRect">
             <a:avLst>
@@ -8953,7 +8453,7 @@
             </a:avLst>
           </a:prstGeom>
           <a:solidFill>
-            <a:srgbClr val="E8F0FB"/>
+            <a:srgbClr val="F1ECFA"/>
           </a:solidFill>
           <a:ln>
             <a:noFill/>
@@ -8984,17 +8484,295 @@
       </p:sp>
       <p:sp>
         <p:nvSpPr>
-          <p:cNvPr id="70" name="Rectangle 69"/>
+          <p:cNvPr id="76" name="Rectangle 75"/>
           <p:cNvSpPr/>
           <p:nvPr/>
         </p:nvSpPr>
         <p:spPr>
           <a:xfrm>
-            <a:off x="365760" y="5897880"/>
-            <a:ext cx="64008" cy="402336"/>
-          </a:xfrm>
-          <a:prstGeom prst="rect">
-            <a:avLst/>
+            <a:off x="6163056" y="5733288"/>
+            <a:ext cx="64008" cy="493776"/>
+          </a:xfrm>
+          <a:prstGeom prst="rect">
+            <a:avLst/>
+          </a:prstGeom>
+          <a:solidFill>
+            <a:srgbClr val="6A3FB5"/>
+          </a:solidFill>
+          <a:ln>
+            <a:noFill/>
+          </a:ln>
+          <a:effectLst/>
+        </p:spPr>
+        <p:style>
+          <a:lnRef idx="1">
+            <a:schemeClr val="accent1"/>
+          </a:lnRef>
+          <a:fillRef idx="3">
+            <a:schemeClr val="accent1"/>
+          </a:fillRef>
+          <a:effectRef idx="2">
+            <a:schemeClr val="accent1"/>
+          </a:effectRef>
+          <a:fontRef idx="minor">
+            <a:schemeClr val="lt1"/>
+          </a:fontRef>
+        </p:style>
+        <p:txBody>
+          <a:bodyPr rtlCol="0" anchor="ctr"/>
+          <a:lstStyle/>
+          <a:p>
+            <a:pPr algn="ctr"/>
+          </a:p>
+        </p:txBody>
+      </p:sp>
+      <p:sp>
+        <p:nvSpPr>
+          <p:cNvPr id="77" name="TextBox 76"/>
+          <p:cNvSpPr txBox="1"/>
+          <p:nvPr/>
+        </p:nvSpPr>
+        <p:spPr>
+          <a:xfrm>
+            <a:off x="6327648" y="5650992"/>
+            <a:ext cx="2578608" cy="658368"/>
+          </a:xfrm>
+          <a:prstGeom prst="rect">
+            <a:avLst/>
+          </a:prstGeom>
+          <a:noFill/>
+        </p:spPr>
+        <p:txBody>
+          <a:bodyPr wrap="square" lIns="36576" rIns="36576" tIns="18288" bIns="18288" anchor="ctr">
+            <a:spAutoFit/>
+          </a:bodyPr>
+          <a:lstStyle/>
+          <a:p>
+            <a:pPr algn="l"/>
+            <a:r>
+              <a:rPr sz="1100" b="1">
+                <a:solidFill>
+                  <a:srgbClr val="6A3FB5"/>
+                </a:solidFill>
+                <a:latin typeface="Calibri"/>
+              </a:rPr>
+              <a:t>Flags unknown formats</a:t>
+            </a:r>
+          </a:p>
+          <a:p>
+            <a:pPr algn="l"/>
+            <a:r>
+              <a:rPr sz="1100" b="0">
+                <a:solidFill>
+                  <a:srgbClr val="1E2530"/>
+                </a:solidFill>
+                <a:latin typeface="Calibri"/>
+              </a:rPr>
+              <a:t>sent for human review</a:t>
+            </a:r>
+          </a:p>
+        </p:txBody>
+      </p:sp>
+      <p:sp>
+        <p:nvSpPr>
+          <p:cNvPr id="78" name="Rounded Rectangle 77"/>
+          <p:cNvSpPr/>
+          <p:nvPr/>
+        </p:nvSpPr>
+        <p:spPr>
+          <a:xfrm>
+            <a:off x="9061704" y="5650992"/>
+            <a:ext cx="2807208" cy="658368"/>
+          </a:xfrm>
+          <a:prstGeom prst="roundRect">
+            <a:avLst>
+              <a:gd name="adj" fmla="val 12000"/>
+            </a:avLst>
+          </a:prstGeom>
+          <a:solidFill>
+            <a:srgbClr val="E8F5EC"/>
+          </a:solidFill>
+          <a:ln>
+            <a:noFill/>
+          </a:ln>
+          <a:effectLst/>
+        </p:spPr>
+        <p:style>
+          <a:lnRef idx="1">
+            <a:schemeClr val="accent1"/>
+          </a:lnRef>
+          <a:fillRef idx="3">
+            <a:schemeClr val="accent1"/>
+          </a:fillRef>
+          <a:effectRef idx="2">
+            <a:schemeClr val="accent1"/>
+          </a:effectRef>
+          <a:fontRef idx="minor">
+            <a:schemeClr val="lt1"/>
+          </a:fontRef>
+        </p:style>
+        <p:txBody>
+          <a:bodyPr rtlCol="0" anchor="ctr"/>
+          <a:lstStyle/>
+          <a:p>
+            <a:pPr algn="ctr"/>
+          </a:p>
+        </p:txBody>
+      </p:sp>
+      <p:sp>
+        <p:nvSpPr>
+          <p:cNvPr id="79" name="Rectangle 78"/>
+          <p:cNvSpPr/>
+          <p:nvPr/>
+        </p:nvSpPr>
+        <p:spPr>
+          <a:xfrm>
+            <a:off x="9061704" y="5733288"/>
+            <a:ext cx="64008" cy="493776"/>
+          </a:xfrm>
+          <a:prstGeom prst="rect">
+            <a:avLst/>
+          </a:prstGeom>
+          <a:solidFill>
+            <a:srgbClr val="138A36"/>
+          </a:solidFill>
+          <a:ln>
+            <a:noFill/>
+          </a:ln>
+          <a:effectLst/>
+        </p:spPr>
+        <p:style>
+          <a:lnRef idx="1">
+            <a:schemeClr val="accent1"/>
+          </a:lnRef>
+          <a:fillRef idx="3">
+            <a:schemeClr val="accent1"/>
+          </a:fillRef>
+          <a:effectRef idx="2">
+            <a:schemeClr val="accent1"/>
+          </a:effectRef>
+          <a:fontRef idx="minor">
+            <a:schemeClr val="lt1"/>
+          </a:fontRef>
+        </p:style>
+        <p:txBody>
+          <a:bodyPr rtlCol="0" anchor="ctr"/>
+          <a:lstStyle/>
+          <a:p>
+            <a:pPr algn="ctr"/>
+          </a:p>
+        </p:txBody>
+      </p:sp>
+      <p:sp>
+        <p:nvSpPr>
+          <p:cNvPr id="80" name="TextBox 79"/>
+          <p:cNvSpPr txBox="1"/>
+          <p:nvPr/>
+        </p:nvSpPr>
+        <p:spPr>
+          <a:xfrm>
+            <a:off x="9226296" y="5650992"/>
+            <a:ext cx="2578608" cy="658368"/>
+          </a:xfrm>
+          <a:prstGeom prst="rect">
+            <a:avLst/>
+          </a:prstGeom>
+          <a:noFill/>
+        </p:spPr>
+        <p:txBody>
+          <a:bodyPr wrap="square" lIns="36576" rIns="36576" tIns="18288" bIns="18288" anchor="ctr">
+            <a:spAutoFit/>
+          </a:bodyPr>
+          <a:lstStyle/>
+          <a:p>
+            <a:pPr algn="l"/>
+            <a:r>
+              <a:rPr sz="1100" b="1">
+                <a:solidFill>
+                  <a:srgbClr val="138A36"/>
+                </a:solidFill>
+                <a:latin typeface="Calibri"/>
+              </a:rPr>
+              <a:t>Security-aware</a:t>
+            </a:r>
+          </a:p>
+          <a:p>
+            <a:pPr algn="l"/>
+            <a:r>
+              <a:rPr sz="1100" b="0">
+                <a:solidFill>
+                  <a:srgbClr val="1E2530"/>
+                </a:solidFill>
+                <a:latin typeface="Calibri"/>
+              </a:rPr>
+              <a:t>tags failed logins, IPs &amp; users</a:t>
+            </a:r>
+          </a:p>
+        </p:txBody>
+      </p:sp>
+      <p:sp>
+        <p:nvSpPr>
+          <p:cNvPr id="81" name="Rounded Rectangle 80"/>
+          <p:cNvSpPr/>
+          <p:nvPr/>
+        </p:nvSpPr>
+        <p:spPr>
+          <a:xfrm>
+            <a:off x="365760" y="1920240"/>
+            <a:ext cx="3651504" cy="3310128"/>
+          </a:xfrm>
+          <a:prstGeom prst="roundRect">
+            <a:avLst>
+              <a:gd name="adj" fmla="val 4000"/>
+            </a:avLst>
+          </a:prstGeom>
+          <a:solidFill>
+            <a:srgbClr val="FFFFFF"/>
+          </a:solidFill>
+          <a:ln w="12700">
+            <a:solidFill>
+              <a:srgbClr val="D5DCE6"/>
+            </a:solidFill>
+          </a:ln>
+          <a:effectLst/>
+        </p:spPr>
+        <p:style>
+          <a:lnRef idx="1">
+            <a:schemeClr val="accent1"/>
+          </a:lnRef>
+          <a:fillRef idx="3">
+            <a:schemeClr val="accent1"/>
+          </a:fillRef>
+          <a:effectRef idx="2">
+            <a:schemeClr val="accent1"/>
+          </a:effectRef>
+          <a:fontRef idx="minor">
+            <a:schemeClr val="lt1"/>
+          </a:fontRef>
+        </p:style>
+        <p:txBody>
+          <a:bodyPr rtlCol="0" anchor="ctr"/>
+          <a:lstStyle/>
+          <a:p>
+            <a:pPr algn="ctr"/>
+          </a:p>
+        </p:txBody>
+      </p:sp>
+      <p:sp>
+        <p:nvSpPr>
+          <p:cNvPr id="82" name="Rounded Rectangle 81"/>
+          <p:cNvSpPr/>
+          <p:nvPr/>
+        </p:nvSpPr>
+        <p:spPr>
+          <a:xfrm>
+            <a:off x="365760" y="1920240"/>
+            <a:ext cx="3651504" cy="384048"/>
+          </a:xfrm>
+          <a:prstGeom prst="roundRect">
+            <a:avLst>
+              <a:gd name="adj" fmla="val 20000"/>
+            </a:avLst>
           </a:prstGeom>
           <a:solidFill>
             <a:srgbClr val="1F5FBF"/>
@@ -9028,14 +8806,14 @@
       </p:sp>
       <p:sp>
         <p:nvSpPr>
-          <p:cNvPr id="71" name="TextBox 70"/>
+          <p:cNvPr id="83" name="TextBox 82"/>
           <p:cNvSpPr txBox="1"/>
           <p:nvPr/>
         </p:nvSpPr>
         <p:spPr>
           <a:xfrm>
-            <a:off x="530352" y="5833872"/>
-            <a:ext cx="2578608" cy="530352"/>
+            <a:off x="365760" y="1920240"/>
+            <a:ext cx="3651504" cy="384048"/>
           </a:xfrm>
           <a:prstGeom prst="rect">
             <a:avLst/>
@@ -9043,54 +8821,268 @@
           <a:noFill/>
         </p:spPr>
         <p:txBody>
-          <a:bodyPr wrap="square" lIns="36576" rIns="36576" tIns="18288" bIns="18288" anchor="ctr">
+          <a:bodyPr wrap="square" lIns="54864" rIns="54864" tIns="18288" bIns="18288" anchor="ctr">
             <a:spAutoFit/>
           </a:bodyPr>
           <a:lstStyle/>
           <a:p>
-            <a:pPr algn="l"/>
-            <a:r>
-              <a:rPr sz="1100" b="1">
+            <a:pPr algn="ctr"/>
+            <a:r>
+              <a:rPr sz="1350" b="1">
+                <a:solidFill>
+                  <a:srgbClr val="FFFFFF"/>
+                </a:solidFill>
+                <a:latin typeface="Calibri"/>
+              </a:rPr>
+              <a:t>1   COLLECT &amp; IDENTIFY</a:t>
+            </a:r>
+          </a:p>
+        </p:txBody>
+      </p:sp>
+      <p:sp>
+        <p:nvSpPr>
+          <p:cNvPr id="84" name="TextBox 83"/>
+          <p:cNvSpPr txBox="1"/>
+          <p:nvPr/>
+        </p:nvSpPr>
+        <p:spPr>
+          <a:xfrm>
+            <a:off x="475488" y="2377440"/>
+            <a:ext cx="3450336" cy="2807208"/>
+          </a:xfrm>
+          <a:prstGeom prst="rect">
+            <a:avLst/>
+          </a:prstGeom>
+          <a:noFill/>
+        </p:spPr>
+        <p:txBody>
+          <a:bodyPr wrap="square" lIns="54864" rIns="54864" tIns="18288" bIns="18288" anchor="t">
+            <a:spAutoFit/>
+          </a:bodyPr>
+          <a:lstStyle/>
+          <a:p>
+            <a:pPr>
+              <a:spcAft>
+                <a:spcPts val="0"/>
+              </a:spcAft>
+            </a:pPr>
+            <a:r>
+              <a:rPr sz="900" b="1">
                 <a:solidFill>
                   <a:srgbClr val="1F5FBF"/>
                 </a:solidFill>
                 <a:latin typeface="Calibri"/>
               </a:rPr>
-              <a:t>Learns by itself</a:t>
-            </a:r>
-          </a:p>
-          <a:p>
-            <a:pPr algn="l"/>
-            <a:r>
-              <a:rPr sz="1100" b="0">
+              <a:t>■ </a:t>
+            </a:r>
+            <a:r>
+              <a:rPr sz="1150" b="1">
+                <a:solidFill>
+                  <a:srgbClr val="1F5FBF"/>
+                </a:solidFill>
+                <a:latin typeface="Calibri"/>
+              </a:rPr>
+              <a:t>Multi-source collection</a:t>
+            </a:r>
+          </a:p>
+          <a:p>
+            <a:pPr>
+              <a:spcAft>
+                <a:spcPts val="550"/>
+              </a:spcAft>
+            </a:pPr>
+            <a:r>
+              <a:rPr sz="1000" b="0">
                 <a:solidFill>
                   <a:srgbClr val="1E2530"/>
                 </a:solidFill>
                 <a:latin typeface="Calibri"/>
               </a:rPr>
-              <a:t>no hand-written rules</a:t>
-            </a:r>
-          </a:p>
-        </p:txBody>
-      </p:sp>
-      <p:sp>
-        <p:nvSpPr>
-          <p:cNvPr id="72" name="Rounded Rectangle 71"/>
+              <a:t>Network devices, servers, apps, databases, cloud and IoT send logs via a web API or Bash collector.</a:t>
+            </a:r>
+          </a:p>
+          <a:p>
+            <a:pPr>
+              <a:spcAft>
+                <a:spcPts val="0"/>
+              </a:spcAft>
+            </a:pPr>
+            <a:r>
+              <a:rPr sz="900" b="1">
+                <a:solidFill>
+                  <a:srgbClr val="1F5FBF"/>
+                </a:solidFill>
+                <a:latin typeface="Calibri"/>
+              </a:rPr>
+              <a:t>■ </a:t>
+            </a:r>
+            <a:r>
+              <a:rPr sz="1150" b="1">
+                <a:solidFill>
+                  <a:srgbClr val="1F5FBF"/>
+                </a:solidFill>
+                <a:latin typeface="Calibri"/>
+              </a:rPr>
+              <a:t>Automatic format identification</a:t>
+            </a:r>
+          </a:p>
+          <a:p>
+            <a:pPr>
+              <a:spcAft>
+                <a:spcPts val="550"/>
+              </a:spcAft>
+            </a:pPr>
+            <a:r>
+              <a:rPr sz="1000" b="0">
+                <a:solidFill>
+                  <a:srgbClr val="1E2530"/>
+                </a:solidFill>
+                <a:latin typeface="Calibri"/>
+              </a:rPr>
+              <a:t>Recognises Syslog, JSON, CSV, CEF, LEEF, web-server and Java logs on its own.</a:t>
+            </a:r>
+          </a:p>
+          <a:p>
+            <a:pPr>
+              <a:spcAft>
+                <a:spcPts val="0"/>
+              </a:spcAft>
+            </a:pPr>
+            <a:r>
+              <a:rPr sz="900" b="1">
+                <a:solidFill>
+                  <a:srgbClr val="1F5FBF"/>
+                </a:solidFill>
+                <a:latin typeface="Calibri"/>
+              </a:rPr>
+              <a:t>■ </a:t>
+            </a:r>
+            <a:r>
+              <a:rPr sz="1150" b="1">
+                <a:solidFill>
+                  <a:srgbClr val="1F5FBF"/>
+                </a:solidFill>
+                <a:latin typeface="Calibri"/>
+              </a:rPr>
+              <a:t>Unknown format support</a:t>
+            </a:r>
+          </a:p>
+          <a:p>
+            <a:pPr>
+              <a:spcAft>
+                <a:spcPts val="550"/>
+              </a:spcAft>
+            </a:pPr>
+            <a:r>
+              <a:rPr sz="1000" b="0">
+                <a:solidFill>
+                  <a:srgbClr val="1E2530"/>
+                </a:solidFill>
+                <a:latin typeface="Calibri"/>
+              </a:rPr>
+              <a:t>New and proprietary formats (e.g. XML) are learned once, with no parser to write.</a:t>
+            </a:r>
+          </a:p>
+          <a:p>
+            <a:pPr>
+              <a:spcAft>
+                <a:spcPts val="0"/>
+              </a:spcAft>
+            </a:pPr>
+            <a:r>
+              <a:rPr sz="900" b="1">
+                <a:solidFill>
+                  <a:srgbClr val="1F5FBF"/>
+                </a:solidFill>
+                <a:latin typeface="Calibri"/>
+              </a:rPr>
+              <a:t>■ </a:t>
+            </a:r>
+            <a:r>
+              <a:rPr sz="1150" b="1">
+                <a:solidFill>
+                  <a:srgbClr val="1F5FBF"/>
+                </a:solidFill>
+                <a:latin typeface="Calibri"/>
+              </a:rPr>
+              <a:t>Real-time processing</a:t>
+            </a:r>
+          </a:p>
+          <a:p>
+            <a:pPr>
+              <a:spcAft>
+                <a:spcPts val="550"/>
+              </a:spcAft>
+            </a:pPr>
+            <a:r>
+              <a:rPr sz="1000" b="0">
+                <a:solidFill>
+                  <a:srgbClr val="1E2530"/>
+                </a:solidFill>
+                <a:latin typeface="Calibri"/>
+              </a:rPr>
+              <a:t>Live streams (syslog, Docker, Kubernetes) are cleaned as they arrive.</a:t>
+            </a:r>
+          </a:p>
+          <a:p>
+            <a:pPr>
+              <a:spcAft>
+                <a:spcPts val="0"/>
+              </a:spcAft>
+            </a:pPr>
+            <a:r>
+              <a:rPr sz="900" b="1">
+                <a:solidFill>
+                  <a:srgbClr val="1F5FBF"/>
+                </a:solidFill>
+                <a:latin typeface="Calibri"/>
+              </a:rPr>
+              <a:t>■ </a:t>
+            </a:r>
+            <a:r>
+              <a:rPr sz="1150" b="1">
+                <a:solidFill>
+                  <a:srgbClr val="1F5FBF"/>
+                </a:solidFill>
+                <a:latin typeface="Calibri"/>
+              </a:rPr>
+              <a:t>Batch processing</a:t>
+            </a:r>
+          </a:p>
+          <a:p>
+            <a:pPr>
+              <a:spcAft>
+                <a:spcPts val="550"/>
+              </a:spcAft>
+            </a:pPr>
+            <a:r>
+              <a:rPr sz="1000" b="0">
+                <a:solidFill>
+                  <a:srgbClr val="1E2530"/>
+                </a:solidFill>
+                <a:latin typeface="Calibri"/>
+              </a:rPr>
+              <a:t>Large existing log files can be sent in bulk batches for one-time cleanup.</a:t>
+            </a:r>
+          </a:p>
+        </p:txBody>
+      </p:sp>
+      <p:sp>
+        <p:nvSpPr>
+          <p:cNvPr id="85" name="Right Arrow 84"/>
           <p:cNvSpPr/>
           <p:nvPr/>
         </p:nvSpPr>
         <p:spPr>
           <a:xfrm>
-            <a:off x="3264408" y="5833872"/>
-            <a:ext cx="2807208" cy="530352"/>
-          </a:xfrm>
-          <a:prstGeom prst="roundRect">
-            <a:avLst>
-              <a:gd name="adj" fmla="val 12000"/>
-            </a:avLst>
+            <a:off x="4053840" y="3392424"/>
+            <a:ext cx="201168" cy="365760"/>
+          </a:xfrm>
+          <a:prstGeom prst="rightArrow">
+            <a:avLst/>
           </a:prstGeom>
           <a:solidFill>
-            <a:srgbClr val="FFF4E0"/>
+            <a:srgbClr val="F28322"/>
           </a:solidFill>
           <a:ln>
             <a:noFill/>
@@ -9121,23 +9113,27 @@
       </p:sp>
       <p:sp>
         <p:nvSpPr>
-          <p:cNvPr id="73" name="Rectangle 72"/>
+          <p:cNvPr id="86" name="Rounded Rectangle 85"/>
           <p:cNvSpPr/>
           <p:nvPr/>
         </p:nvSpPr>
         <p:spPr>
           <a:xfrm>
-            <a:off x="3264408" y="5897880"/>
-            <a:ext cx="64008" cy="402336"/>
-          </a:xfrm>
-          <a:prstGeom prst="rect">
-            <a:avLst/>
+            <a:off x="4291584" y="1920240"/>
+            <a:ext cx="3651504" cy="3310128"/>
+          </a:xfrm>
+          <a:prstGeom prst="roundRect">
+            <a:avLst>
+              <a:gd name="adj" fmla="val 4000"/>
+            </a:avLst>
           </a:prstGeom>
           <a:solidFill>
-            <a:srgbClr val="F58220"/>
+            <a:srgbClr val="FFFFFF"/>
           </a:solidFill>
-          <a:ln>
-            <a:noFill/>
+          <a:ln w="12700">
+            <a:solidFill>
+              <a:srgbClr val="D5DCE6"/>
+            </a:solidFill>
           </a:ln>
           <a:effectLst/>
         </p:spPr>
@@ -9165,110 +9161,19 @@
       </p:sp>
       <p:sp>
         <p:nvSpPr>
-          <p:cNvPr id="74" name="TextBox 73"/>
-          <p:cNvSpPr txBox="1"/>
-          <p:nvPr/>
-        </p:nvSpPr>
-        <p:spPr>
-          <a:xfrm>
-            <a:off x="3429000" y="5833872"/>
-            <a:ext cx="2578608" cy="530352"/>
-          </a:xfrm>
-          <a:prstGeom prst="rect">
-            <a:avLst/>
-          </a:prstGeom>
-          <a:noFill/>
-        </p:spPr>
-        <p:txBody>
-          <a:bodyPr wrap="square" lIns="36576" rIns="36576" tIns="18288" bIns="18288" anchor="ctr">
-            <a:spAutoFit/>
-          </a:bodyPr>
-          <a:lstStyle/>
-          <a:p>
-            <a:pPr algn="l"/>
-            <a:r>
-              <a:rPr sz="1100" b="1">
-                <a:solidFill>
-                  <a:srgbClr val="F58220"/>
-                </a:solidFill>
-                <a:latin typeface="Calibri"/>
-              </a:rPr>
-              <a:t>AI only when needed</a:t>
-            </a:r>
-          </a:p>
-          <a:p>
-            <a:pPr algn="l"/>
-            <a:r>
-              <a:rPr sz="1100" b="0">
-                <a:solidFill>
-                  <a:srgbClr val="1E2530"/>
-                </a:solidFill>
-                <a:latin typeface="Calibri"/>
-              </a:rPr>
-              <a:t>keeps cost low</a:t>
-            </a:r>
-          </a:p>
-        </p:txBody>
-      </p:sp>
-      <p:sp>
-        <p:nvSpPr>
-          <p:cNvPr id="75" name="Rounded Rectangle 74"/>
+          <p:cNvPr id="87" name="Rounded Rectangle 86"/>
           <p:cNvSpPr/>
           <p:nvPr/>
         </p:nvSpPr>
         <p:spPr>
           <a:xfrm>
-            <a:off x="6163056" y="5833872"/>
-            <a:ext cx="2807208" cy="530352"/>
+            <a:off x="4291584" y="1920240"/>
+            <a:ext cx="3651504" cy="384048"/>
           </a:xfrm>
           <a:prstGeom prst="roundRect">
             <a:avLst>
-              <a:gd name="adj" fmla="val 12000"/>
+              <a:gd name="adj" fmla="val 20000"/>
             </a:avLst>
-          </a:prstGeom>
-          <a:solidFill>
-            <a:srgbClr val="F1ECFA"/>
-          </a:solidFill>
-          <a:ln>
-            <a:noFill/>
-          </a:ln>
-          <a:effectLst/>
-        </p:spPr>
-        <p:style>
-          <a:lnRef idx="1">
-            <a:schemeClr val="accent1"/>
-          </a:lnRef>
-          <a:fillRef idx="3">
-            <a:schemeClr val="accent1"/>
-          </a:fillRef>
-          <a:effectRef idx="2">
-            <a:schemeClr val="accent1"/>
-          </a:effectRef>
-          <a:fontRef idx="minor">
-            <a:schemeClr val="lt1"/>
-          </a:fontRef>
-        </p:style>
-        <p:txBody>
-          <a:bodyPr rtlCol="0" anchor="ctr"/>
-          <a:lstStyle/>
-          <a:p>
-            <a:pPr algn="ctr"/>
-          </a:p>
-        </p:txBody>
-      </p:sp>
-      <p:sp>
-        <p:nvSpPr>
-          <p:cNvPr id="76" name="Rectangle 75"/>
-          <p:cNvSpPr/>
-          <p:nvPr/>
-        </p:nvSpPr>
-        <p:spPr>
-          <a:xfrm>
-            <a:off x="6163056" y="5897880"/>
-            <a:ext cx="64008" cy="402336"/>
-          </a:xfrm>
-          <a:prstGeom prst="rect">
-            <a:avLst/>
           </a:prstGeom>
           <a:solidFill>
             <a:srgbClr val="6A3FB5"/>
@@ -9302,14 +9207,14 @@
       </p:sp>
       <p:sp>
         <p:nvSpPr>
-          <p:cNvPr id="77" name="TextBox 76"/>
+          <p:cNvPr id="88" name="TextBox 87"/>
           <p:cNvSpPr txBox="1"/>
           <p:nvPr/>
         </p:nvSpPr>
         <p:spPr>
           <a:xfrm>
-            <a:off x="6327648" y="5833872"/>
-            <a:ext cx="2578608" cy="530352"/>
+            <a:off x="4291584" y="1920240"/>
+            <a:ext cx="3651504" cy="384048"/>
           </a:xfrm>
           <a:prstGeom prst="rect">
             <a:avLst/>
@@ -9317,54 +9222,227 @@
           <a:noFill/>
         </p:spPr>
         <p:txBody>
-          <a:bodyPr wrap="square" lIns="36576" rIns="36576" tIns="18288" bIns="18288" anchor="ctr">
+          <a:bodyPr wrap="square" lIns="54864" rIns="54864" tIns="18288" bIns="18288" anchor="ctr">
             <a:spAutoFit/>
           </a:bodyPr>
           <a:lstStyle/>
           <a:p>
-            <a:pPr algn="l"/>
-            <a:r>
-              <a:rPr sz="1100" b="1">
+            <a:pPr algn="ctr"/>
+            <a:r>
+              <a:rPr sz="1350" b="1">
+                <a:solidFill>
+                  <a:srgbClr val="FFFFFF"/>
+                </a:solidFill>
+                <a:latin typeface="Calibri"/>
+              </a:rPr>
+              <a:t>2   UNDERSTAND &amp; MAP</a:t>
+            </a:r>
+          </a:p>
+        </p:txBody>
+      </p:sp>
+      <p:sp>
+        <p:nvSpPr>
+          <p:cNvPr id="89" name="TextBox 88"/>
+          <p:cNvSpPr txBox="1"/>
+          <p:nvPr/>
+        </p:nvSpPr>
+        <p:spPr>
+          <a:xfrm>
+            <a:off x="4401312" y="2377440"/>
+            <a:ext cx="3450336" cy="2807208"/>
+          </a:xfrm>
+          <a:prstGeom prst="rect">
+            <a:avLst/>
+          </a:prstGeom>
+          <a:noFill/>
+        </p:spPr>
+        <p:txBody>
+          <a:bodyPr wrap="square" lIns="54864" rIns="54864" tIns="18288" bIns="18288" anchor="t">
+            <a:spAutoFit/>
+          </a:bodyPr>
+          <a:lstStyle/>
+          <a:p>
+            <a:pPr>
+              <a:spcAft>
+                <a:spcPts val="0"/>
+              </a:spcAft>
+            </a:pPr>
+            <a:r>
+              <a:rPr sz="900" b="1">
                 <a:solidFill>
                   <a:srgbClr val="6A3FB5"/>
                 </a:solidFill>
                 <a:latin typeface="Calibri"/>
               </a:rPr>
-              <a:t>Flags unknown formats</a:t>
-            </a:r>
-          </a:p>
-          <a:p>
-            <a:pPr algn="l"/>
-            <a:r>
-              <a:rPr sz="1100" b="0">
+              <a:t>■ </a:t>
+            </a:r>
+            <a:r>
+              <a:rPr sz="1150" b="1">
+                <a:solidFill>
+                  <a:srgbClr val="6A3FB5"/>
+                </a:solidFill>
+                <a:latin typeface="Calibri"/>
+              </a:rPr>
+              <a:t>Universal parsing</a:t>
+            </a:r>
+          </a:p>
+          <a:p>
+            <a:pPr>
+              <a:spcAft>
+                <a:spcPts val="1100"/>
+              </a:spcAft>
+            </a:pPr>
+            <a:r>
+              <a:rPr sz="1000" b="0">
                 <a:solidFill>
                   <a:srgbClr val="1E2530"/>
                 </a:solidFill>
                 <a:latin typeface="Calibri"/>
               </a:rPr>
-              <a:t>sent for human review</a:t>
-            </a:r>
-          </a:p>
-        </p:txBody>
-      </p:sp>
-      <p:sp>
-        <p:nvSpPr>
-          <p:cNvPr id="78" name="Rounded Rectangle 77"/>
+              <a:t>Pulls key details out of structured, semi-structured and free-text logs.</a:t>
+            </a:r>
+          </a:p>
+          <a:p>
+            <a:pPr>
+              <a:spcAft>
+                <a:spcPts val="0"/>
+              </a:spcAft>
+            </a:pPr>
+            <a:r>
+              <a:rPr sz="900" b="1">
+                <a:solidFill>
+                  <a:srgbClr val="6A3FB5"/>
+                </a:solidFill>
+                <a:latin typeface="Calibri"/>
+              </a:rPr>
+              <a:t>■ </a:t>
+            </a:r>
+            <a:r>
+              <a:rPr sz="1150" b="1">
+                <a:solidFill>
+                  <a:srgbClr val="6A3FB5"/>
+                </a:solidFill>
+                <a:latin typeface="Calibri"/>
+              </a:rPr>
+              <a:t>Pattern extraction</a:t>
+            </a:r>
+          </a:p>
+          <a:p>
+            <a:pPr>
+              <a:spcAft>
+                <a:spcPts val="1100"/>
+              </a:spcAft>
+            </a:pPr>
+            <a:r>
+              <a:rPr sz="1000" b="0">
+                <a:solidFill>
+                  <a:srgbClr val="1E2530"/>
+                </a:solidFill>
+                <a:latin typeface="Calibri"/>
+              </a:rPr>
+              <a:t>Groups repeating lines into patterns, so millions of lines become a few thousand.</a:t>
+            </a:r>
+          </a:p>
+          <a:p>
+            <a:pPr>
+              <a:spcAft>
+                <a:spcPts val="0"/>
+              </a:spcAft>
+            </a:pPr>
+            <a:r>
+              <a:rPr sz="900" b="1">
+                <a:solidFill>
+                  <a:srgbClr val="6A3FB5"/>
+                </a:solidFill>
+                <a:latin typeface="Calibri"/>
+              </a:rPr>
+              <a:t>■ </a:t>
+            </a:r>
+            <a:r>
+              <a:rPr sz="1150" b="1">
+                <a:solidFill>
+                  <a:srgbClr val="6A3FB5"/>
+                </a:solidFill>
+                <a:latin typeface="Calibri"/>
+              </a:rPr>
+              <a:t>Intelligent field mapping</a:t>
+            </a:r>
+          </a:p>
+          <a:p>
+            <a:pPr>
+              <a:spcAft>
+                <a:spcPts val="1100"/>
+              </a:spcAft>
+            </a:pPr>
+            <a:r>
+              <a:rPr sz="1000" b="0">
+                <a:solidFill>
+                  <a:srgbClr val="1E2530"/>
+                </a:solidFill>
+                <a:latin typeface="Calibri"/>
+              </a:rPr>
+              <a:t>'lvl', 'level', 'severity': differently named fields land in one common field.</a:t>
+            </a:r>
+          </a:p>
+          <a:p>
+            <a:pPr>
+              <a:spcAft>
+                <a:spcPts val="0"/>
+              </a:spcAft>
+            </a:pPr>
+            <a:r>
+              <a:rPr sz="900" b="1">
+                <a:solidFill>
+                  <a:srgbClr val="6A3FB5"/>
+                </a:solidFill>
+                <a:latin typeface="Calibri"/>
+              </a:rPr>
+              <a:t>■ </a:t>
+            </a:r>
+            <a:r>
+              <a:rPr sz="1150" b="1">
+                <a:solidFill>
+                  <a:srgbClr val="6A3FB5"/>
+                </a:solidFill>
+                <a:latin typeface="Calibri"/>
+              </a:rPr>
+              <a:t>Field normalisation</a:t>
+            </a:r>
+          </a:p>
+          <a:p>
+            <a:pPr>
+              <a:spcAft>
+                <a:spcPts val="1100"/>
+              </a:spcAft>
+            </a:pPr>
+            <a:r>
+              <a:rPr sz="1000" b="0">
+                <a:solidFill>
+                  <a:srgbClr val="1E2530"/>
+                </a:solidFill>
+                <a:latin typeface="Calibri"/>
+              </a:rPr>
+              <a:t>Times become UTC and severity one scale; event type, host, IPs and users are extracted.</a:t>
+            </a:r>
+          </a:p>
+        </p:txBody>
+      </p:sp>
+      <p:sp>
+        <p:nvSpPr>
+          <p:cNvPr id="90" name="Right Arrow 89"/>
           <p:cNvSpPr/>
           <p:nvPr/>
         </p:nvSpPr>
         <p:spPr>
           <a:xfrm>
-            <a:off x="9061704" y="5833872"/>
-            <a:ext cx="2807208" cy="530352"/>
-          </a:xfrm>
-          <a:prstGeom prst="roundRect">
-            <a:avLst>
-              <a:gd name="adj" fmla="val 12000"/>
-            </a:avLst>
+            <a:off x="7979664" y="3392424"/>
+            <a:ext cx="201168" cy="365760"/>
+          </a:xfrm>
+          <a:prstGeom prst="rightArrow">
+            <a:avLst/>
           </a:prstGeom>
           <a:solidFill>
-            <a:srgbClr val="E8F5EC"/>
+            <a:srgbClr val="F28322"/>
           </a:solidFill>
           <a:ln>
             <a:noFill/>
@@ -9395,17 +9473,67 @@
       </p:sp>
       <p:sp>
         <p:nvSpPr>
-          <p:cNvPr id="79" name="Rectangle 78"/>
+          <p:cNvPr id="91" name="Rounded Rectangle 90"/>
           <p:cNvSpPr/>
           <p:nvPr/>
         </p:nvSpPr>
         <p:spPr>
           <a:xfrm>
-            <a:off x="9061704" y="5897880"/>
-            <a:ext cx="64008" cy="402336"/>
-          </a:xfrm>
-          <a:prstGeom prst="rect">
-            <a:avLst/>
+            <a:off x="8217408" y="1920240"/>
+            <a:ext cx="3651504" cy="3310128"/>
+          </a:xfrm>
+          <a:prstGeom prst="roundRect">
+            <a:avLst>
+              <a:gd name="adj" fmla="val 4000"/>
+            </a:avLst>
+          </a:prstGeom>
+          <a:solidFill>
+            <a:srgbClr val="FFFFFF"/>
+          </a:solidFill>
+          <a:ln w="12700">
+            <a:solidFill>
+              <a:srgbClr val="D5DCE6"/>
+            </a:solidFill>
+          </a:ln>
+          <a:effectLst/>
+        </p:spPr>
+        <p:style>
+          <a:lnRef idx="1">
+            <a:schemeClr val="accent1"/>
+          </a:lnRef>
+          <a:fillRef idx="3">
+            <a:schemeClr val="accent1"/>
+          </a:fillRef>
+          <a:effectRef idx="2">
+            <a:schemeClr val="accent1"/>
+          </a:effectRef>
+          <a:fontRef idx="minor">
+            <a:schemeClr val="lt1"/>
+          </a:fontRef>
+        </p:style>
+        <p:txBody>
+          <a:bodyPr rtlCol="0" anchor="ctr"/>
+          <a:lstStyle/>
+          <a:p>
+            <a:pPr algn="ctr"/>
+          </a:p>
+        </p:txBody>
+      </p:sp>
+      <p:sp>
+        <p:nvSpPr>
+          <p:cNvPr id="92" name="Rounded Rectangle 91"/>
+          <p:cNvSpPr/>
+          <p:nvPr/>
+        </p:nvSpPr>
+        <p:spPr>
+          <a:xfrm>
+            <a:off x="8217408" y="1920240"/>
+            <a:ext cx="3651504" cy="384048"/>
+          </a:xfrm>
+          <a:prstGeom prst="roundRect">
+            <a:avLst>
+              <a:gd name="adj" fmla="val 20000"/>
+            </a:avLst>
           </a:prstGeom>
           <a:solidFill>
             <a:srgbClr val="138A36"/>
@@ -9439,14 +9567,14 @@
       </p:sp>
       <p:sp>
         <p:nvSpPr>
-          <p:cNvPr id="80" name="TextBox 79"/>
+          <p:cNvPr id="93" name="TextBox 92"/>
           <p:cNvSpPr txBox="1"/>
           <p:nvPr/>
         </p:nvSpPr>
         <p:spPr>
           <a:xfrm>
-            <a:off x="9226296" y="5833872"/>
-            <a:ext cx="2578608" cy="530352"/>
+            <a:off x="8217408" y="1920240"/>
+            <a:ext cx="3651504" cy="384048"/>
           </a:xfrm>
           <a:prstGeom prst="rect">
             <a:avLst/>
@@ -9454,32 +9582,248 @@
           <a:noFill/>
         </p:spPr>
         <p:txBody>
-          <a:bodyPr wrap="square" lIns="36576" rIns="36576" tIns="18288" bIns="18288" anchor="ctr">
+          <a:bodyPr wrap="square" lIns="54864" rIns="54864" tIns="18288" bIns="18288" anchor="ctr">
             <a:spAutoFit/>
           </a:bodyPr>
           <a:lstStyle/>
           <a:p>
-            <a:pPr algn="l"/>
-            <a:r>
-              <a:rPr sz="1100" b="1">
+            <a:pPr algn="ctr"/>
+            <a:r>
+              <a:rPr sz="1350" b="1">
+                <a:solidFill>
+                  <a:srgbClr val="FFFFFF"/>
+                </a:solidFill>
+                <a:latin typeface="Calibri"/>
+              </a:rPr>
+              <a:t>3   CLEAN &amp; DELIVER</a:t>
+            </a:r>
+          </a:p>
+        </p:txBody>
+      </p:sp>
+      <p:sp>
+        <p:nvSpPr>
+          <p:cNvPr id="94" name="TextBox 93"/>
+          <p:cNvSpPr txBox="1"/>
+          <p:nvPr/>
+        </p:nvSpPr>
+        <p:spPr>
+          <a:xfrm>
+            <a:off x="8327136" y="2377440"/>
+            <a:ext cx="3450336" cy="2807208"/>
+          </a:xfrm>
+          <a:prstGeom prst="rect">
+            <a:avLst/>
+          </a:prstGeom>
+          <a:noFill/>
+        </p:spPr>
+        <p:txBody>
+          <a:bodyPr wrap="square" lIns="54864" rIns="54864" tIns="18288" bIns="18288" anchor="t">
+            <a:spAutoFit/>
+          </a:bodyPr>
+          <a:lstStyle/>
+          <a:p>
+            <a:pPr>
+              <a:spcAft>
+                <a:spcPts val="0"/>
+              </a:spcAft>
+            </a:pPr>
+            <a:r>
+              <a:rPr sz="900" b="1">
                 <a:solidFill>
                   <a:srgbClr val="138A36"/>
                 </a:solidFill>
                 <a:latin typeface="Calibri"/>
               </a:rPr>
-              <a:t>Security-aware</a:t>
-            </a:r>
-          </a:p>
-          <a:p>
-            <a:pPr algn="l"/>
-            <a:r>
-              <a:rPr sz="1100" b="0">
+              <a:t>■ </a:t>
+            </a:r>
+            <a:r>
+              <a:rPr sz="1150" b="1">
+                <a:solidFill>
+                  <a:srgbClr val="138A36"/>
+                </a:solidFill>
+                <a:latin typeface="Calibri"/>
+              </a:rPr>
+              <a:t>Error &amp; anomaly handling</a:t>
+            </a:r>
+          </a:p>
+          <a:p>
+            <a:pPr>
+              <a:spcAft>
+                <a:spcPts val="550"/>
+              </a:spcAft>
+            </a:pPr>
+            <a:r>
+              <a:rPr sz="1000" b="0">
                 <a:solidFill>
                   <a:srgbClr val="1E2530"/>
                 </a:solidFill>
                 <a:latin typeface="Calibri"/>
               </a:rPr>
-              <a:t>tags failed logins, IPs &amp; users</a:t>
+              <a:t>Missing fields get safe defaults; unusual lines are flagged for review.</a:t>
+            </a:r>
+          </a:p>
+          <a:p>
+            <a:pPr>
+              <a:spcAft>
+                <a:spcPts val="0"/>
+              </a:spcAft>
+            </a:pPr>
+            <a:r>
+              <a:rPr sz="900" b="1">
+                <a:solidFill>
+                  <a:srgbClr val="138A36"/>
+                </a:solidFill>
+                <a:latin typeface="Calibri"/>
+              </a:rPr>
+              <a:t>■ </a:t>
+            </a:r>
+            <a:r>
+              <a:rPr sz="1150" b="1">
+                <a:solidFill>
+                  <a:srgbClr val="138A36"/>
+                </a:solidFill>
+                <a:latin typeface="Calibri"/>
+              </a:rPr>
+              <a:t>Duplicate removal (planned)</a:t>
+            </a:r>
+          </a:p>
+          <a:p>
+            <a:pPr>
+              <a:spcAft>
+                <a:spcPts val="550"/>
+              </a:spcAft>
+            </a:pPr>
+            <a:r>
+              <a:rPr sz="1000" b="0">
+                <a:solidFill>
+                  <a:srgbClr val="1E2530"/>
+                </a:solidFill>
+                <a:latin typeface="Calibri"/>
+              </a:rPr>
+              <a:t>Repeated entries dropped to cut noise and storage.</a:t>
+            </a:r>
+          </a:p>
+          <a:p>
+            <a:pPr>
+              <a:spcAft>
+                <a:spcPts val="0"/>
+              </a:spcAft>
+            </a:pPr>
+            <a:r>
+              <a:rPr sz="900" b="1">
+                <a:solidFill>
+                  <a:srgbClr val="138A36"/>
+                </a:solidFill>
+                <a:latin typeface="Calibri"/>
+              </a:rPr>
+              <a:t>■ </a:t>
+            </a:r>
+            <a:r>
+              <a:rPr sz="1150" b="1">
+                <a:solidFill>
+                  <a:srgbClr val="138A36"/>
+                </a:solidFill>
+                <a:latin typeface="Calibri"/>
+              </a:rPr>
+              <a:t>Common schema</a:t>
+            </a:r>
+          </a:p>
+          <a:p>
+            <a:pPr>
+              <a:spcAft>
+                <a:spcPts val="550"/>
+              </a:spcAft>
+            </a:pPr>
+            <a:r>
+              <a:rPr sz="1000" b="0">
+                <a:solidFill>
+                  <a:srgbClr val="1E2530"/>
+                </a:solidFill>
+                <a:latin typeface="Calibri"/>
+              </a:rPr>
+              <a:t>Every log gets the same fields: time, source, event, severity, message.</a:t>
+            </a:r>
+          </a:p>
+          <a:p>
+            <a:pPr>
+              <a:spcAft>
+                <a:spcPts val="0"/>
+              </a:spcAft>
+            </a:pPr>
+            <a:r>
+              <a:rPr sz="900" b="1">
+                <a:solidFill>
+                  <a:srgbClr val="138A36"/>
+                </a:solidFill>
+                <a:latin typeface="Calibri"/>
+              </a:rPr>
+              <a:t>■ </a:t>
+            </a:r>
+            <a:r>
+              <a:rPr sz="1150" b="1">
+                <a:solidFill>
+                  <a:srgbClr val="138A36"/>
+                </a:solidFill>
+                <a:latin typeface="Calibri"/>
+              </a:rPr>
+              <a:t>Standardised output</a:t>
+            </a:r>
+          </a:p>
+          <a:p>
+            <a:pPr>
+              <a:spcAft>
+                <a:spcPts val="550"/>
+              </a:spcAft>
+            </a:pPr>
+            <a:r>
+              <a:rPr sz="1000" b="0">
+                <a:solidFill>
+                  <a:srgbClr val="1E2530"/>
+                </a:solidFill>
+                <a:latin typeface="Calibri"/>
+              </a:rPr>
+              <a:t>Clean, machine-readable JSON for SIEM, monitoring &amp; analytics (connectors planned).</a:t>
+            </a:r>
+          </a:p>
+          <a:p>
+            <a:pPr>
+              <a:spcAft>
+                <a:spcPts val="0"/>
+              </a:spcAft>
+            </a:pPr>
+            <a:r>
+              <a:rPr sz="900" b="1">
+                <a:solidFill>
+                  <a:srgbClr val="138A36"/>
+                </a:solidFill>
+                <a:latin typeface="Calibri"/>
+              </a:rPr>
+              <a:t>■ </a:t>
+            </a:r>
+            <a:r>
+              <a:rPr sz="1150" b="1">
+                <a:solidFill>
+                  <a:srgbClr val="138A36"/>
+                </a:solidFill>
+                <a:latin typeface="Calibri"/>
+              </a:rPr>
+              <a:t>Easy integration</a:t>
+            </a:r>
+          </a:p>
+          <a:p>
+            <a:pPr>
+              <a:spcAft>
+                <a:spcPts val="550"/>
+              </a:spcAft>
+            </a:pPr>
+            <a:r>
+              <a:rPr sz="1000" b="0">
+                <a:solidFill>
+                  <a:srgbClr val="1E2530"/>
+                </a:solidFill>
+                <a:latin typeface="Calibri"/>
+              </a:rPr>
+              <a:t>One simple interface for every downstream tool, whatever the original source.</a:t>
             </a:r>
           </a:p>
         </p:txBody>

</xml_diff>

<commit_message>
PPT: slide 2 split into How it works (3 stages) and How it addresses the problem
Co-authored-by: arena-agent <297053741+arena-agent@users.noreply.github.com>
</commit_message>
<xml_diff>
--- a/presentation/SIH2026_Idea_Submission.pptx
+++ b/presentation/SIH2026_Idea_Submission.pptx
@@ -8085,14 +8085,104 @@
       </p:sp>
       <p:sp>
         <p:nvSpPr>
-          <p:cNvPr id="67" name="TextBox 66"/>
+          <p:cNvPr id="69" name="Rounded Rectangle 68"/>
+          <p:cNvSpPr/>
+          <p:nvPr/>
+        </p:nvSpPr>
+        <p:spPr>
+          <a:xfrm>
+            <a:off x="2148840" y="5632704"/>
+            <a:ext cx="2375154" cy="676656"/>
+          </a:xfrm>
+          <a:prstGeom prst="roundRect">
+            <a:avLst>
+              <a:gd name="adj" fmla="val 12000"/>
+            </a:avLst>
+          </a:prstGeom>
+          <a:solidFill>
+            <a:srgbClr val="E8F0FB"/>
+          </a:solidFill>
+          <a:ln>
+            <a:noFill/>
+          </a:ln>
+          <a:effectLst/>
+        </p:spPr>
+        <p:style>
+          <a:lnRef idx="1">
+            <a:schemeClr val="accent1"/>
+          </a:lnRef>
+          <a:fillRef idx="3">
+            <a:schemeClr val="accent1"/>
+          </a:fillRef>
+          <a:effectRef idx="2">
+            <a:schemeClr val="accent1"/>
+          </a:effectRef>
+          <a:fontRef idx="minor">
+            <a:schemeClr val="lt1"/>
+          </a:fontRef>
+        </p:style>
+        <p:txBody>
+          <a:bodyPr rtlCol="0" anchor="ctr"/>
+          <a:lstStyle/>
+          <a:p>
+            <a:pPr algn="ctr"/>
+          </a:p>
+        </p:txBody>
+      </p:sp>
+      <p:sp>
+        <p:nvSpPr>
+          <p:cNvPr id="70" name="Rectangle 69"/>
+          <p:cNvSpPr/>
+          <p:nvPr/>
+        </p:nvSpPr>
+        <p:spPr>
+          <a:xfrm>
+            <a:off x="2148840" y="5724144"/>
+            <a:ext cx="64008" cy="493776"/>
+          </a:xfrm>
+          <a:prstGeom prst="rect">
+            <a:avLst/>
+          </a:prstGeom>
+          <a:solidFill>
+            <a:srgbClr val="1F5FBF"/>
+          </a:solidFill>
+          <a:ln>
+            <a:noFill/>
+          </a:ln>
+          <a:effectLst/>
+        </p:spPr>
+        <p:style>
+          <a:lnRef idx="1">
+            <a:schemeClr val="accent1"/>
+          </a:lnRef>
+          <a:fillRef idx="3">
+            <a:schemeClr val="accent1"/>
+          </a:fillRef>
+          <a:effectRef idx="2">
+            <a:schemeClr val="accent1"/>
+          </a:effectRef>
+          <a:fontRef idx="minor">
+            <a:schemeClr val="lt1"/>
+          </a:fontRef>
+        </p:style>
+        <p:txBody>
+          <a:bodyPr rtlCol="0" anchor="ctr"/>
+          <a:lstStyle/>
+          <a:p>
+            <a:pPr algn="ctr"/>
+          </a:p>
+        </p:txBody>
+      </p:sp>
+      <p:sp>
+        <p:nvSpPr>
+          <p:cNvPr id="71" name="TextBox 70"/>
           <p:cNvSpPr txBox="1"/>
           <p:nvPr/>
         </p:nvSpPr>
         <p:spPr>
           <a:xfrm>
-            <a:off x="365760" y="5303520"/>
-            <a:ext cx="5486400" cy="256032"/>
+            <a:off x="2286000" y="5632704"/>
+            <a:ext cx="2192274" cy="676656"/>
           </a:xfrm>
           <a:prstGeom prst="rect">
             <a:avLst/>
@@ -8100,34 +8190,92 @@
           <a:noFill/>
         </p:spPr>
         <p:txBody>
-          <a:bodyPr wrap="square" lIns="36576" rIns="36576" tIns="18288" bIns="18288" anchor="t">
+          <a:bodyPr wrap="square" lIns="36576" rIns="36576" tIns="18288" bIns="18288" anchor="ctr">
             <a:spAutoFit/>
           </a:bodyPr>
           <a:lstStyle/>
           <a:p>
             <a:pPr algn="l"/>
             <a:r>
-              <a:rPr sz="1450" b="1">
-                <a:solidFill>
-                  <a:srgbClr val="0B2A5B"/>
-                </a:solidFill>
-                <a:latin typeface="Calibri"/>
-              </a:rPr>
-              <a:t>Innovation &amp; uniqueness</a:t>
-            </a:r>
-          </a:p>
-        </p:txBody>
-      </p:sp>
-      <p:sp>
-        <p:nvSpPr>
-          <p:cNvPr id="68" name="Rectangle 67"/>
+              <a:rPr sz="1100" b="1">
+                <a:solidFill>
+                  <a:srgbClr val="1F5FBF"/>
+                </a:solidFill>
+                <a:latin typeface="Calibri"/>
+              </a:rPr>
+              <a:t>Learns by itself</a:t>
+            </a:r>
+          </a:p>
+          <a:p>
+            <a:pPr algn="l"/>
+            <a:r>
+              <a:rPr sz="1100" b="0">
+                <a:solidFill>
+                  <a:srgbClr val="1E2530"/>
+                </a:solidFill>
+                <a:latin typeface="Calibri"/>
+              </a:rPr>
+              <a:t>no hand-written rules</a:t>
+            </a:r>
+          </a:p>
+        </p:txBody>
+      </p:sp>
+      <p:sp>
+        <p:nvSpPr>
+          <p:cNvPr id="72" name="Rounded Rectangle 71"/>
           <p:cNvSpPr/>
           <p:nvPr/>
         </p:nvSpPr>
         <p:spPr>
           <a:xfrm>
-            <a:off x="402336" y="5568696"/>
-            <a:ext cx="822960" cy="41148"/>
+            <a:off x="4597146" y="5632704"/>
+            <a:ext cx="2375154" cy="676656"/>
+          </a:xfrm>
+          <a:prstGeom prst="roundRect">
+            <a:avLst>
+              <a:gd name="adj" fmla="val 12000"/>
+            </a:avLst>
+          </a:prstGeom>
+          <a:solidFill>
+            <a:srgbClr val="FFF4E0"/>
+          </a:solidFill>
+          <a:ln>
+            <a:noFill/>
+          </a:ln>
+          <a:effectLst/>
+        </p:spPr>
+        <p:style>
+          <a:lnRef idx="1">
+            <a:schemeClr val="accent1"/>
+          </a:lnRef>
+          <a:fillRef idx="3">
+            <a:schemeClr val="accent1"/>
+          </a:fillRef>
+          <a:effectRef idx="2">
+            <a:schemeClr val="accent1"/>
+          </a:effectRef>
+          <a:fontRef idx="minor">
+            <a:schemeClr val="lt1"/>
+          </a:fontRef>
+        </p:style>
+        <p:txBody>
+          <a:bodyPr rtlCol="0" anchor="ctr"/>
+          <a:lstStyle/>
+          <a:p>
+            <a:pPr algn="ctr"/>
+          </a:p>
+        </p:txBody>
+      </p:sp>
+      <p:sp>
+        <p:nvSpPr>
+          <p:cNvPr id="73" name="Rectangle 72"/>
+          <p:cNvSpPr/>
+          <p:nvPr/>
+        </p:nvSpPr>
+        <p:spPr>
+          <a:xfrm>
+            <a:off x="4597146" y="5724144"/>
+            <a:ext cx="64008" cy="493776"/>
           </a:xfrm>
           <a:prstGeom prst="rect">
             <a:avLst/>
@@ -8164,104 +8312,14 @@
       </p:sp>
       <p:sp>
         <p:nvSpPr>
-          <p:cNvPr id="69" name="Rounded Rectangle 68"/>
-          <p:cNvSpPr/>
-          <p:nvPr/>
-        </p:nvSpPr>
-        <p:spPr>
-          <a:xfrm>
-            <a:off x="365760" y="5650992"/>
-            <a:ext cx="2807208" cy="658368"/>
-          </a:xfrm>
-          <a:prstGeom prst="roundRect">
-            <a:avLst>
-              <a:gd name="adj" fmla="val 12000"/>
-            </a:avLst>
-          </a:prstGeom>
-          <a:solidFill>
-            <a:srgbClr val="E8F0FB"/>
-          </a:solidFill>
-          <a:ln>
-            <a:noFill/>
-          </a:ln>
-          <a:effectLst/>
-        </p:spPr>
-        <p:style>
-          <a:lnRef idx="1">
-            <a:schemeClr val="accent1"/>
-          </a:lnRef>
-          <a:fillRef idx="3">
-            <a:schemeClr val="accent1"/>
-          </a:fillRef>
-          <a:effectRef idx="2">
-            <a:schemeClr val="accent1"/>
-          </a:effectRef>
-          <a:fontRef idx="minor">
-            <a:schemeClr val="lt1"/>
-          </a:fontRef>
-        </p:style>
-        <p:txBody>
-          <a:bodyPr rtlCol="0" anchor="ctr"/>
-          <a:lstStyle/>
-          <a:p>
-            <a:pPr algn="ctr"/>
-          </a:p>
-        </p:txBody>
-      </p:sp>
-      <p:sp>
-        <p:nvSpPr>
-          <p:cNvPr id="70" name="Rectangle 69"/>
-          <p:cNvSpPr/>
-          <p:nvPr/>
-        </p:nvSpPr>
-        <p:spPr>
-          <a:xfrm>
-            <a:off x="365760" y="5733288"/>
-            <a:ext cx="64008" cy="493776"/>
-          </a:xfrm>
-          <a:prstGeom prst="rect">
-            <a:avLst/>
-          </a:prstGeom>
-          <a:solidFill>
-            <a:srgbClr val="1F5FBF"/>
-          </a:solidFill>
-          <a:ln>
-            <a:noFill/>
-          </a:ln>
-          <a:effectLst/>
-        </p:spPr>
-        <p:style>
-          <a:lnRef idx="1">
-            <a:schemeClr val="accent1"/>
-          </a:lnRef>
-          <a:fillRef idx="3">
-            <a:schemeClr val="accent1"/>
-          </a:fillRef>
-          <a:effectRef idx="2">
-            <a:schemeClr val="accent1"/>
-          </a:effectRef>
-          <a:fontRef idx="minor">
-            <a:schemeClr val="lt1"/>
-          </a:fontRef>
-        </p:style>
-        <p:txBody>
-          <a:bodyPr rtlCol="0" anchor="ctr"/>
-          <a:lstStyle/>
-          <a:p>
-            <a:pPr algn="ctr"/>
-          </a:p>
-        </p:txBody>
-      </p:sp>
-      <p:sp>
-        <p:nvSpPr>
-          <p:cNvPr id="71" name="TextBox 70"/>
+          <p:cNvPr id="74" name="TextBox 73"/>
           <p:cNvSpPr txBox="1"/>
           <p:nvPr/>
         </p:nvSpPr>
         <p:spPr>
           <a:xfrm>
-            <a:off x="530352" y="5650992"/>
-            <a:ext cx="2578608" cy="658368"/>
+            <a:off x="4734306" y="5632704"/>
+            <a:ext cx="2192274" cy="676656"/>
           </a:xfrm>
           <a:prstGeom prst="rect">
             <a:avLst/>
@@ -8278,143 +8336,6 @@
             <a:r>
               <a:rPr sz="1100" b="1">
                 <a:solidFill>
-                  <a:srgbClr val="1F5FBF"/>
-                </a:solidFill>
-                <a:latin typeface="Calibri"/>
-              </a:rPr>
-              <a:t>Learns by itself</a:t>
-            </a:r>
-          </a:p>
-          <a:p>
-            <a:pPr algn="l"/>
-            <a:r>
-              <a:rPr sz="1100" b="0">
-                <a:solidFill>
-                  <a:srgbClr val="1E2530"/>
-                </a:solidFill>
-                <a:latin typeface="Calibri"/>
-              </a:rPr>
-              <a:t>no hand-written rules</a:t>
-            </a:r>
-          </a:p>
-        </p:txBody>
-      </p:sp>
-      <p:sp>
-        <p:nvSpPr>
-          <p:cNvPr id="72" name="Rounded Rectangle 71"/>
-          <p:cNvSpPr/>
-          <p:nvPr/>
-        </p:nvSpPr>
-        <p:spPr>
-          <a:xfrm>
-            <a:off x="3264408" y="5650992"/>
-            <a:ext cx="2807208" cy="658368"/>
-          </a:xfrm>
-          <a:prstGeom prst="roundRect">
-            <a:avLst>
-              <a:gd name="adj" fmla="val 12000"/>
-            </a:avLst>
-          </a:prstGeom>
-          <a:solidFill>
-            <a:srgbClr val="FFF4E0"/>
-          </a:solidFill>
-          <a:ln>
-            <a:noFill/>
-          </a:ln>
-          <a:effectLst/>
-        </p:spPr>
-        <p:style>
-          <a:lnRef idx="1">
-            <a:schemeClr val="accent1"/>
-          </a:lnRef>
-          <a:fillRef idx="3">
-            <a:schemeClr val="accent1"/>
-          </a:fillRef>
-          <a:effectRef idx="2">
-            <a:schemeClr val="accent1"/>
-          </a:effectRef>
-          <a:fontRef idx="minor">
-            <a:schemeClr val="lt1"/>
-          </a:fontRef>
-        </p:style>
-        <p:txBody>
-          <a:bodyPr rtlCol="0" anchor="ctr"/>
-          <a:lstStyle/>
-          <a:p>
-            <a:pPr algn="ctr"/>
-          </a:p>
-        </p:txBody>
-      </p:sp>
-      <p:sp>
-        <p:nvSpPr>
-          <p:cNvPr id="73" name="Rectangle 72"/>
-          <p:cNvSpPr/>
-          <p:nvPr/>
-        </p:nvSpPr>
-        <p:spPr>
-          <a:xfrm>
-            <a:off x="3264408" y="5733288"/>
-            <a:ext cx="64008" cy="493776"/>
-          </a:xfrm>
-          <a:prstGeom prst="rect">
-            <a:avLst/>
-          </a:prstGeom>
-          <a:solidFill>
-            <a:srgbClr val="F58220"/>
-          </a:solidFill>
-          <a:ln>
-            <a:noFill/>
-          </a:ln>
-          <a:effectLst/>
-        </p:spPr>
-        <p:style>
-          <a:lnRef idx="1">
-            <a:schemeClr val="accent1"/>
-          </a:lnRef>
-          <a:fillRef idx="3">
-            <a:schemeClr val="accent1"/>
-          </a:fillRef>
-          <a:effectRef idx="2">
-            <a:schemeClr val="accent1"/>
-          </a:effectRef>
-          <a:fontRef idx="minor">
-            <a:schemeClr val="lt1"/>
-          </a:fontRef>
-        </p:style>
-        <p:txBody>
-          <a:bodyPr rtlCol="0" anchor="ctr"/>
-          <a:lstStyle/>
-          <a:p>
-            <a:pPr algn="ctr"/>
-          </a:p>
-        </p:txBody>
-      </p:sp>
-      <p:sp>
-        <p:nvSpPr>
-          <p:cNvPr id="74" name="TextBox 73"/>
-          <p:cNvSpPr txBox="1"/>
-          <p:nvPr/>
-        </p:nvSpPr>
-        <p:spPr>
-          <a:xfrm>
-            <a:off x="3429000" y="5650992"/>
-            <a:ext cx="2578608" cy="658368"/>
-          </a:xfrm>
-          <a:prstGeom prst="rect">
-            <a:avLst/>
-          </a:prstGeom>
-          <a:noFill/>
-        </p:spPr>
-        <p:txBody>
-          <a:bodyPr wrap="square" lIns="36576" rIns="36576" tIns="18288" bIns="18288" anchor="ctr">
-            <a:spAutoFit/>
-          </a:bodyPr>
-          <a:lstStyle/>
-          <a:p>
-            <a:pPr algn="l"/>
-            <a:r>
-              <a:rPr sz="1100" b="1">
-                <a:solidFill>
                   <a:srgbClr val="F58220"/>
                 </a:solidFill>
                 <a:latin typeface="Calibri"/>
@@ -8444,8 +8365,8 @@
         </p:nvSpPr>
         <p:spPr>
           <a:xfrm>
-            <a:off x="6163056" y="5650992"/>
-            <a:ext cx="2807208" cy="658368"/>
+            <a:off x="7045452" y="5632704"/>
+            <a:ext cx="2375154" cy="676656"/>
           </a:xfrm>
           <a:prstGeom prst="roundRect">
             <a:avLst>
@@ -8490,7 +8411,7 @@
         </p:nvSpPr>
         <p:spPr>
           <a:xfrm>
-            <a:off x="6163056" y="5733288"/>
+            <a:off x="7045452" y="5724144"/>
             <a:ext cx="64008" cy="493776"/>
           </a:xfrm>
           <a:prstGeom prst="rect">
@@ -8534,8 +8455,8 @@
         </p:nvSpPr>
         <p:spPr>
           <a:xfrm>
-            <a:off x="6327648" y="5650992"/>
-            <a:ext cx="2578608" cy="658368"/>
+            <a:off x="7182612" y="5632704"/>
+            <a:ext cx="2192274" cy="676656"/>
           </a:xfrm>
           <a:prstGeom prst="rect">
             <a:avLst/>
@@ -8581,8 +8502,8 @@
         </p:nvSpPr>
         <p:spPr>
           <a:xfrm>
-            <a:off x="9061704" y="5650992"/>
-            <a:ext cx="2807208" cy="658368"/>
+            <a:off x="9493758" y="5632704"/>
+            <a:ext cx="2375154" cy="676656"/>
           </a:xfrm>
           <a:prstGeom prst="roundRect">
             <a:avLst>
@@ -8627,7 +8548,7 @@
         </p:nvSpPr>
         <p:spPr>
           <a:xfrm>
-            <a:off x="9061704" y="5733288"/>
+            <a:off x="9493758" y="5724144"/>
             <a:ext cx="64008" cy="493776"/>
           </a:xfrm>
           <a:prstGeom prst="rect">
@@ -8671,8 +8592,8 @@
         </p:nvSpPr>
         <p:spPr>
           <a:xfrm>
-            <a:off x="9226296" y="5650992"/>
-            <a:ext cx="2578608" cy="658368"/>
+            <a:off x="9630918" y="5632704"/>
+            <a:ext cx="2192274" cy="676656"/>
           </a:xfrm>
           <a:prstGeom prst="rect">
             <a:avLst/>
@@ -8718,12 +8639,12 @@
         </p:nvSpPr>
         <p:spPr>
           <a:xfrm>
-            <a:off x="365760" y="1920240"/>
-            <a:ext cx="3651504" cy="3310128"/>
+            <a:off x="365760" y="1901952"/>
+            <a:ext cx="7269480" cy="3639312"/>
           </a:xfrm>
           <a:prstGeom prst="roundRect">
             <a:avLst>
-              <a:gd name="adj" fmla="val 4000"/>
+              <a:gd name="adj" fmla="val 3000"/>
             </a:avLst>
           </a:prstGeom>
           <a:solidFill>
@@ -8766,12 +8687,12 @@
         </p:nvSpPr>
         <p:spPr>
           <a:xfrm>
-            <a:off x="365760" y="1920240"/>
-            <a:ext cx="3651504" cy="384048"/>
+            <a:off x="365760" y="1901952"/>
+            <a:ext cx="7269480" cy="365760"/>
           </a:xfrm>
           <a:prstGeom prst="roundRect">
             <a:avLst>
-              <a:gd name="adj" fmla="val 20000"/>
+              <a:gd name="adj" fmla="val 18000"/>
             </a:avLst>
           </a:prstGeom>
           <a:solidFill>
@@ -8812,8 +8733,8 @@
         </p:nvSpPr>
         <p:spPr>
           <a:xfrm>
-            <a:off x="365760" y="1920240"/>
-            <a:ext cx="3651504" cy="384048"/>
+            <a:off x="502920" y="1901952"/>
+            <a:ext cx="6995160" cy="365760"/>
           </a:xfrm>
           <a:prstGeom prst="rect">
             <a:avLst/>
@@ -8821,268 +8742,50 @@
           <a:noFill/>
         </p:spPr>
         <p:txBody>
-          <a:bodyPr wrap="square" lIns="54864" rIns="54864" tIns="18288" bIns="18288" anchor="ctr">
+          <a:bodyPr wrap="square" lIns="45720" rIns="45720" tIns="18288" bIns="18288" anchor="ctr">
             <a:spAutoFit/>
           </a:bodyPr>
           <a:lstStyle/>
           <a:p>
-            <a:pPr algn="ctr"/>
-            <a:r>
-              <a:rPr sz="1350" b="1">
+            <a:r>
+              <a:rPr sz="1400" b="1">
                 <a:solidFill>
                   <a:srgbClr val="FFFFFF"/>
                 </a:solidFill>
                 <a:latin typeface="Calibri"/>
               </a:rPr>
-              <a:t>1   COLLECT &amp; IDENTIFY</a:t>
-            </a:r>
-          </a:p>
-        </p:txBody>
-      </p:sp>
-      <p:sp>
-        <p:nvSpPr>
-          <p:cNvPr id="84" name="TextBox 83"/>
-          <p:cNvSpPr txBox="1"/>
-          <p:nvPr/>
-        </p:nvSpPr>
-        <p:spPr>
-          <a:xfrm>
-            <a:off x="475488" y="2377440"/>
-            <a:ext cx="3450336" cy="2807208"/>
-          </a:xfrm>
-          <a:prstGeom prst="rect">
-            <a:avLst/>
-          </a:prstGeom>
-          <a:noFill/>
-        </p:spPr>
-        <p:txBody>
-          <a:bodyPr wrap="square" lIns="54864" rIns="54864" tIns="18288" bIns="18288" anchor="t">
-            <a:spAutoFit/>
-          </a:bodyPr>
-          <a:lstStyle/>
-          <a:p>
-            <a:pPr>
-              <a:spcAft>
-                <a:spcPts val="0"/>
-              </a:spcAft>
-            </a:pPr>
-            <a:r>
-              <a:rPr sz="900" b="1">
-                <a:solidFill>
-                  <a:srgbClr val="1F5FBF"/>
-                </a:solidFill>
-                <a:latin typeface="Calibri"/>
-              </a:rPr>
-              <a:t>■ </a:t>
-            </a:r>
-            <a:r>
-              <a:rPr sz="1150" b="1">
-                <a:solidFill>
-                  <a:srgbClr val="1F5FBF"/>
-                </a:solidFill>
-                <a:latin typeface="Calibri"/>
-              </a:rPr>
-              <a:t>Multi-source collection</a:t>
-            </a:r>
-          </a:p>
-          <a:p>
-            <a:pPr>
-              <a:spcAft>
-                <a:spcPts val="550"/>
-              </a:spcAft>
-            </a:pPr>
-            <a:r>
-              <a:rPr sz="1000" b="0">
-                <a:solidFill>
-                  <a:srgbClr val="1E2530"/>
-                </a:solidFill>
-                <a:latin typeface="Calibri"/>
-              </a:rPr>
-              <a:t>Network devices, servers, apps, databases, cloud and IoT send logs via a web API or Bash collector.</a:t>
-            </a:r>
-          </a:p>
-          <a:p>
-            <a:pPr>
-              <a:spcAft>
-                <a:spcPts val="0"/>
-              </a:spcAft>
-            </a:pPr>
-            <a:r>
-              <a:rPr sz="900" b="1">
-                <a:solidFill>
-                  <a:srgbClr val="1F5FBF"/>
-                </a:solidFill>
-                <a:latin typeface="Calibri"/>
-              </a:rPr>
-              <a:t>■ </a:t>
-            </a:r>
-            <a:r>
-              <a:rPr sz="1150" b="1">
-                <a:solidFill>
-                  <a:srgbClr val="1F5FBF"/>
-                </a:solidFill>
-                <a:latin typeface="Calibri"/>
-              </a:rPr>
-              <a:t>Automatic format identification</a:t>
-            </a:r>
-          </a:p>
-          <a:p>
-            <a:pPr>
-              <a:spcAft>
-                <a:spcPts val="550"/>
-              </a:spcAft>
-            </a:pPr>
-            <a:r>
-              <a:rPr sz="1000" b="0">
-                <a:solidFill>
-                  <a:srgbClr val="1E2530"/>
-                </a:solidFill>
-                <a:latin typeface="Calibri"/>
-              </a:rPr>
-              <a:t>Recognises Syslog, JSON, CSV, CEF, LEEF, web-server and Java logs on its own.</a:t>
-            </a:r>
-          </a:p>
-          <a:p>
-            <a:pPr>
-              <a:spcAft>
-                <a:spcPts val="0"/>
-              </a:spcAft>
-            </a:pPr>
-            <a:r>
-              <a:rPr sz="900" b="1">
-                <a:solidFill>
-                  <a:srgbClr val="1F5FBF"/>
-                </a:solidFill>
-                <a:latin typeface="Calibri"/>
-              </a:rPr>
-              <a:t>■ </a:t>
-            </a:r>
-            <a:r>
-              <a:rPr sz="1150" b="1">
-                <a:solidFill>
-                  <a:srgbClr val="1F5FBF"/>
-                </a:solidFill>
-                <a:latin typeface="Calibri"/>
-              </a:rPr>
-              <a:t>Unknown format support</a:t>
-            </a:r>
-          </a:p>
-          <a:p>
-            <a:pPr>
-              <a:spcAft>
-                <a:spcPts val="550"/>
-              </a:spcAft>
-            </a:pPr>
-            <a:r>
-              <a:rPr sz="1000" b="0">
-                <a:solidFill>
-                  <a:srgbClr val="1E2530"/>
-                </a:solidFill>
-                <a:latin typeface="Calibri"/>
-              </a:rPr>
-              <a:t>New and proprietary formats (e.g. XML) are learned once, with no parser to write.</a:t>
-            </a:r>
-          </a:p>
-          <a:p>
-            <a:pPr>
-              <a:spcAft>
-                <a:spcPts val="0"/>
-              </a:spcAft>
-            </a:pPr>
-            <a:r>
-              <a:rPr sz="900" b="1">
-                <a:solidFill>
-                  <a:srgbClr val="1F5FBF"/>
-                </a:solidFill>
-                <a:latin typeface="Calibri"/>
-              </a:rPr>
-              <a:t>■ </a:t>
-            </a:r>
-            <a:r>
-              <a:rPr sz="1150" b="1">
-                <a:solidFill>
-                  <a:srgbClr val="1F5FBF"/>
-                </a:solidFill>
-                <a:latin typeface="Calibri"/>
-              </a:rPr>
-              <a:t>Real-time processing</a:t>
-            </a:r>
-          </a:p>
-          <a:p>
-            <a:pPr>
-              <a:spcAft>
-                <a:spcPts val="550"/>
-              </a:spcAft>
-            </a:pPr>
-            <a:r>
-              <a:rPr sz="1000" b="0">
-                <a:solidFill>
-                  <a:srgbClr val="1E2530"/>
-                </a:solidFill>
-                <a:latin typeface="Calibri"/>
-              </a:rPr>
-              <a:t>Live streams (syslog, Docker, Kubernetes) are cleaned as they arrive.</a:t>
-            </a:r>
-          </a:p>
-          <a:p>
-            <a:pPr>
-              <a:spcAft>
-                <a:spcPts val="0"/>
-              </a:spcAft>
-            </a:pPr>
-            <a:r>
-              <a:rPr sz="900" b="1">
-                <a:solidFill>
-                  <a:srgbClr val="1F5FBF"/>
-                </a:solidFill>
-                <a:latin typeface="Calibri"/>
-              </a:rPr>
-              <a:t>■ </a:t>
-            </a:r>
-            <a:r>
-              <a:rPr sz="1150" b="1">
-                <a:solidFill>
-                  <a:srgbClr val="1F5FBF"/>
-                </a:solidFill>
-                <a:latin typeface="Calibri"/>
-              </a:rPr>
-              <a:t>Batch processing</a:t>
-            </a:r>
-          </a:p>
-          <a:p>
-            <a:pPr>
-              <a:spcAft>
-                <a:spcPts val="550"/>
-              </a:spcAft>
-            </a:pPr>
-            <a:r>
-              <a:rPr sz="1000" b="0">
-                <a:solidFill>
-                  <a:srgbClr val="1E2530"/>
-                </a:solidFill>
-                <a:latin typeface="Calibri"/>
-              </a:rPr>
-              <a:t>Large existing log files can be sent in bulk batches for one-time cleanup.</a:t>
-            </a:r>
-          </a:p>
-        </p:txBody>
-      </p:sp>
-      <p:sp>
-        <p:nvSpPr>
-          <p:cNvPr id="85" name="Right Arrow 84"/>
+              <a:t>HOW IT WORKS</a:t>
+            </a:r>
+            <a:r>
+              <a:rPr sz="1100" b="0">
+                <a:solidFill>
+                  <a:srgbClr val="DCE8FA"/>
+                </a:solidFill>
+                <a:latin typeface="Calibri"/>
+              </a:rPr>
+              <a:t>     three simple stages, from raw log to clean record</a:t>
+            </a:r>
+          </a:p>
+        </p:txBody>
+      </p:sp>
+      <p:sp>
+        <p:nvSpPr>
+          <p:cNvPr id="84" name="Rounded Rectangle 83"/>
           <p:cNvSpPr/>
           <p:nvPr/>
         </p:nvSpPr>
         <p:spPr>
           <a:xfrm>
-            <a:off x="4053840" y="3392424"/>
-            <a:ext cx="201168" cy="365760"/>
-          </a:xfrm>
-          <a:prstGeom prst="rightArrow">
-            <a:avLst/>
+            <a:off x="475488" y="2340864"/>
+            <a:ext cx="7050024" cy="1097280"/>
+          </a:xfrm>
+          <a:prstGeom prst="roundRect">
+            <a:avLst>
+              <a:gd name="adj" fmla="val 8000"/>
+            </a:avLst>
           </a:prstGeom>
           <a:solidFill>
-            <a:srgbClr val="F28322"/>
+            <a:srgbClr val="EAF1FB"/>
           </a:solidFill>
           <a:ln>
             <a:noFill/>
@@ -9113,18 +8816,913 @@
       </p:sp>
       <p:sp>
         <p:nvSpPr>
-          <p:cNvPr id="86" name="Rounded Rectangle 85"/>
+          <p:cNvPr id="85" name="Rounded Rectangle 84"/>
           <p:cNvSpPr/>
           <p:nvPr/>
         </p:nvSpPr>
         <p:spPr>
           <a:xfrm>
-            <a:off x="4291584" y="1920240"/>
-            <a:ext cx="3651504" cy="3310128"/>
+            <a:off x="475488" y="2340864"/>
+            <a:ext cx="1024128" cy="1097280"/>
           </a:xfrm>
           <a:prstGeom prst="roundRect">
             <a:avLst>
-              <a:gd name="adj" fmla="val 4000"/>
+              <a:gd name="adj" fmla="val 12000"/>
+            </a:avLst>
+          </a:prstGeom>
+          <a:solidFill>
+            <a:srgbClr val="1F5FBF"/>
+          </a:solidFill>
+          <a:ln>
+            <a:noFill/>
+          </a:ln>
+          <a:effectLst/>
+        </p:spPr>
+        <p:style>
+          <a:lnRef idx="1">
+            <a:schemeClr val="accent1"/>
+          </a:lnRef>
+          <a:fillRef idx="3">
+            <a:schemeClr val="accent1"/>
+          </a:fillRef>
+          <a:effectRef idx="2">
+            <a:schemeClr val="accent1"/>
+          </a:effectRef>
+          <a:fontRef idx="minor">
+            <a:schemeClr val="lt1"/>
+          </a:fontRef>
+        </p:style>
+        <p:txBody>
+          <a:bodyPr rtlCol="0" anchor="ctr"/>
+          <a:lstStyle/>
+          <a:p>
+            <a:pPr algn="ctr"/>
+          </a:p>
+        </p:txBody>
+      </p:sp>
+      <p:sp>
+        <p:nvSpPr>
+          <p:cNvPr id="86" name="TextBox 85"/>
+          <p:cNvSpPr txBox="1"/>
+          <p:nvPr/>
+        </p:nvSpPr>
+        <p:spPr>
+          <a:xfrm>
+            <a:off x="475488" y="2340864"/>
+            <a:ext cx="1024128" cy="1097280"/>
+          </a:xfrm>
+          <a:prstGeom prst="rect">
+            <a:avLst/>
+          </a:prstGeom>
+          <a:noFill/>
+        </p:spPr>
+        <p:txBody>
+          <a:bodyPr wrap="square" lIns="27432" rIns="27432" tIns="18288" bIns="18288" anchor="ctr">
+            <a:spAutoFit/>
+          </a:bodyPr>
+          <a:lstStyle/>
+          <a:p>
+            <a:pPr algn="ctr"/>
+            <a:r>
+              <a:rPr sz="1800" b="1">
+                <a:solidFill>
+                  <a:srgbClr val="FFFFFF"/>
+                </a:solidFill>
+                <a:latin typeface="Calibri"/>
+              </a:rPr>
+              <a:t>1</a:t>
+            </a:r>
+          </a:p>
+          <a:p>
+            <a:pPr algn="ctr"/>
+            <a:r>
+              <a:rPr sz="950" b="1">
+                <a:solidFill>
+                  <a:srgbClr val="FFFFFF"/>
+                </a:solidFill>
+                <a:latin typeface="Calibri"/>
+              </a:rPr>
+              <a:t>COLLECT &amp;</a:t>
+            </a:r>
+          </a:p>
+          <a:p>
+            <a:pPr algn="ctr"/>
+            <a:r>
+              <a:rPr sz="950" b="1">
+                <a:solidFill>
+                  <a:srgbClr val="FFFFFF"/>
+                </a:solidFill>
+                <a:latin typeface="Calibri"/>
+              </a:rPr>
+              <a:t>IDENTIFY</a:t>
+            </a:r>
+          </a:p>
+        </p:txBody>
+      </p:sp>
+      <p:sp>
+        <p:nvSpPr>
+          <p:cNvPr id="87" name="TextBox 86"/>
+          <p:cNvSpPr txBox="1"/>
+          <p:nvPr/>
+        </p:nvSpPr>
+        <p:spPr>
+          <a:xfrm>
+            <a:off x="1591056" y="2386584"/>
+            <a:ext cx="2921508" cy="1024128"/>
+          </a:xfrm>
+          <a:prstGeom prst="rect">
+            <a:avLst/>
+          </a:prstGeom>
+          <a:noFill/>
+        </p:spPr>
+        <p:txBody>
+          <a:bodyPr wrap="square" lIns="36576" rIns="36576" tIns="18288" bIns="18288" anchor="t">
+            <a:spAutoFit/>
+          </a:bodyPr>
+          <a:lstStyle/>
+          <a:p>
+            <a:pPr>
+              <a:spcAft>
+                <a:spcPts val="200"/>
+              </a:spcAft>
+            </a:pPr>
+            <a:r>
+              <a:rPr sz="950" b="1">
+                <a:solidFill>
+                  <a:srgbClr val="1F5FBF"/>
+                </a:solidFill>
+                <a:latin typeface="Calibri"/>
+              </a:rPr>
+              <a:t>Multi-source collection: </a:t>
+            </a:r>
+            <a:r>
+              <a:rPr sz="950" b="0">
+                <a:solidFill>
+                  <a:srgbClr val="1E2530"/>
+                </a:solidFill>
+                <a:latin typeface="Calibri"/>
+              </a:rPr>
+              <a:t>network devices, servers, apps, databases, cloud and IoT via a web API or Bash collector.</a:t>
+            </a:r>
+          </a:p>
+          <a:p>
+            <a:pPr>
+              <a:spcAft>
+                <a:spcPts val="200"/>
+              </a:spcAft>
+            </a:pPr>
+            <a:r>
+              <a:rPr sz="950" b="1">
+                <a:solidFill>
+                  <a:srgbClr val="1F5FBF"/>
+                </a:solidFill>
+                <a:latin typeface="Calibri"/>
+              </a:rPr>
+              <a:t>Automatic format identification: </a:t>
+            </a:r>
+            <a:r>
+              <a:rPr sz="950" b="0">
+                <a:solidFill>
+                  <a:srgbClr val="1E2530"/>
+                </a:solidFill>
+                <a:latin typeface="Calibri"/>
+              </a:rPr>
+              <a:t>Syslog, JSON, CSV, CEF, LEEF, web and Java logs are recognised on their own.</a:t>
+            </a:r>
+          </a:p>
+        </p:txBody>
+      </p:sp>
+      <p:sp>
+        <p:nvSpPr>
+          <p:cNvPr id="88" name="TextBox 87"/>
+          <p:cNvSpPr txBox="1"/>
+          <p:nvPr/>
+        </p:nvSpPr>
+        <p:spPr>
+          <a:xfrm>
+            <a:off x="4567428" y="2386584"/>
+            <a:ext cx="2921508" cy="1024128"/>
+          </a:xfrm>
+          <a:prstGeom prst="rect">
+            <a:avLst/>
+          </a:prstGeom>
+          <a:noFill/>
+        </p:spPr>
+        <p:txBody>
+          <a:bodyPr wrap="square" lIns="36576" rIns="36576" tIns="18288" bIns="18288" anchor="t">
+            <a:spAutoFit/>
+          </a:bodyPr>
+          <a:lstStyle/>
+          <a:p>
+            <a:pPr>
+              <a:spcAft>
+                <a:spcPts val="200"/>
+              </a:spcAft>
+            </a:pPr>
+            <a:r>
+              <a:rPr sz="950" b="1">
+                <a:solidFill>
+                  <a:srgbClr val="1F5FBF"/>
+                </a:solidFill>
+                <a:latin typeface="Calibri"/>
+              </a:rPr>
+              <a:t>Unknown format support: </a:t>
+            </a:r>
+            <a:r>
+              <a:rPr sz="950" b="0">
+                <a:solidFill>
+                  <a:srgbClr val="1E2530"/>
+                </a:solidFill>
+                <a:latin typeface="Calibri"/>
+              </a:rPr>
+              <a:t>new or proprietary formats (e.g. XML) are learned once; no parser has to be written.</a:t>
+            </a:r>
+          </a:p>
+          <a:p>
+            <a:pPr>
+              <a:spcAft>
+                <a:spcPts val="200"/>
+              </a:spcAft>
+            </a:pPr>
+            <a:r>
+              <a:rPr sz="950" b="1">
+                <a:solidFill>
+                  <a:srgbClr val="1F5FBF"/>
+                </a:solidFill>
+                <a:latin typeface="Calibri"/>
+              </a:rPr>
+              <a:t>Real-time processing: </a:t>
+            </a:r>
+            <a:r>
+              <a:rPr sz="950" b="0">
+                <a:solidFill>
+                  <a:srgbClr val="1E2530"/>
+                </a:solidFill>
+                <a:latin typeface="Calibri"/>
+              </a:rPr>
+              <a:t>live syslog, Docker and Kubernetes streams are cleaned as they arrive.</a:t>
+            </a:r>
+          </a:p>
+          <a:p>
+            <a:pPr>
+              <a:spcAft>
+                <a:spcPts val="200"/>
+              </a:spcAft>
+            </a:pPr>
+            <a:r>
+              <a:rPr sz="950" b="1">
+                <a:solidFill>
+                  <a:srgbClr val="1F5FBF"/>
+                </a:solidFill>
+                <a:latin typeface="Calibri"/>
+              </a:rPr>
+              <a:t>Batch processing: </a:t>
+            </a:r>
+            <a:r>
+              <a:rPr sz="950" b="0">
+                <a:solidFill>
+                  <a:srgbClr val="1E2530"/>
+                </a:solidFill>
+                <a:latin typeface="Calibri"/>
+              </a:rPr>
+              <a:t>large existing log files can be sent in bulk for one-time cleanup.</a:t>
+            </a:r>
+          </a:p>
+        </p:txBody>
+      </p:sp>
+      <p:sp>
+        <p:nvSpPr>
+          <p:cNvPr id="89" name="Rounded Rectangle 88"/>
+          <p:cNvSpPr/>
+          <p:nvPr/>
+        </p:nvSpPr>
+        <p:spPr>
+          <a:xfrm>
+            <a:off x="475488" y="3511296"/>
+            <a:ext cx="7050024" cy="841248"/>
+          </a:xfrm>
+          <a:prstGeom prst="roundRect">
+            <a:avLst>
+              <a:gd name="adj" fmla="val 8000"/>
+            </a:avLst>
+          </a:prstGeom>
+          <a:solidFill>
+            <a:srgbClr val="F1ECFA"/>
+          </a:solidFill>
+          <a:ln>
+            <a:noFill/>
+          </a:ln>
+          <a:effectLst/>
+        </p:spPr>
+        <p:style>
+          <a:lnRef idx="1">
+            <a:schemeClr val="accent1"/>
+          </a:lnRef>
+          <a:fillRef idx="3">
+            <a:schemeClr val="accent1"/>
+          </a:fillRef>
+          <a:effectRef idx="2">
+            <a:schemeClr val="accent1"/>
+          </a:effectRef>
+          <a:fontRef idx="minor">
+            <a:schemeClr val="lt1"/>
+          </a:fontRef>
+        </p:style>
+        <p:txBody>
+          <a:bodyPr rtlCol="0" anchor="ctr"/>
+          <a:lstStyle/>
+          <a:p>
+            <a:pPr algn="ctr"/>
+          </a:p>
+        </p:txBody>
+      </p:sp>
+      <p:sp>
+        <p:nvSpPr>
+          <p:cNvPr id="90" name="Rounded Rectangle 89"/>
+          <p:cNvSpPr/>
+          <p:nvPr/>
+        </p:nvSpPr>
+        <p:spPr>
+          <a:xfrm>
+            <a:off x="475488" y="3511296"/>
+            <a:ext cx="1024128" cy="841248"/>
+          </a:xfrm>
+          <a:prstGeom prst="roundRect">
+            <a:avLst>
+              <a:gd name="adj" fmla="val 12000"/>
+            </a:avLst>
+          </a:prstGeom>
+          <a:solidFill>
+            <a:srgbClr val="6A3FB5"/>
+          </a:solidFill>
+          <a:ln>
+            <a:noFill/>
+          </a:ln>
+          <a:effectLst/>
+        </p:spPr>
+        <p:style>
+          <a:lnRef idx="1">
+            <a:schemeClr val="accent1"/>
+          </a:lnRef>
+          <a:fillRef idx="3">
+            <a:schemeClr val="accent1"/>
+          </a:fillRef>
+          <a:effectRef idx="2">
+            <a:schemeClr val="accent1"/>
+          </a:effectRef>
+          <a:fontRef idx="minor">
+            <a:schemeClr val="lt1"/>
+          </a:fontRef>
+        </p:style>
+        <p:txBody>
+          <a:bodyPr rtlCol="0" anchor="ctr"/>
+          <a:lstStyle/>
+          <a:p>
+            <a:pPr algn="ctr"/>
+          </a:p>
+        </p:txBody>
+      </p:sp>
+      <p:sp>
+        <p:nvSpPr>
+          <p:cNvPr id="91" name="TextBox 90"/>
+          <p:cNvSpPr txBox="1"/>
+          <p:nvPr/>
+        </p:nvSpPr>
+        <p:spPr>
+          <a:xfrm>
+            <a:off x="475488" y="3511296"/>
+            <a:ext cx="1024128" cy="841248"/>
+          </a:xfrm>
+          <a:prstGeom prst="rect">
+            <a:avLst/>
+          </a:prstGeom>
+          <a:noFill/>
+        </p:spPr>
+        <p:txBody>
+          <a:bodyPr wrap="square" lIns="27432" rIns="27432" tIns="18288" bIns="18288" anchor="ctr">
+            <a:spAutoFit/>
+          </a:bodyPr>
+          <a:lstStyle/>
+          <a:p>
+            <a:pPr algn="ctr"/>
+            <a:r>
+              <a:rPr sz="1800" b="1">
+                <a:solidFill>
+                  <a:srgbClr val="FFFFFF"/>
+                </a:solidFill>
+                <a:latin typeface="Calibri"/>
+              </a:rPr>
+              <a:t>2</a:t>
+            </a:r>
+          </a:p>
+          <a:p>
+            <a:pPr algn="ctr"/>
+            <a:r>
+              <a:rPr sz="950" b="1">
+                <a:solidFill>
+                  <a:srgbClr val="FFFFFF"/>
+                </a:solidFill>
+                <a:latin typeface="Calibri"/>
+              </a:rPr>
+              <a:t>UNDERSTAND</a:t>
+            </a:r>
+          </a:p>
+          <a:p>
+            <a:pPr algn="ctr"/>
+            <a:r>
+              <a:rPr sz="950" b="1">
+                <a:solidFill>
+                  <a:srgbClr val="FFFFFF"/>
+                </a:solidFill>
+                <a:latin typeface="Calibri"/>
+              </a:rPr>
+              <a:t>&amp; MAP</a:t>
+            </a:r>
+          </a:p>
+        </p:txBody>
+      </p:sp>
+      <p:sp>
+        <p:nvSpPr>
+          <p:cNvPr id="92" name="TextBox 91"/>
+          <p:cNvSpPr txBox="1"/>
+          <p:nvPr/>
+        </p:nvSpPr>
+        <p:spPr>
+          <a:xfrm>
+            <a:off x="1591056" y="3557016"/>
+            <a:ext cx="2921508" cy="768096"/>
+          </a:xfrm>
+          <a:prstGeom prst="rect">
+            <a:avLst/>
+          </a:prstGeom>
+          <a:noFill/>
+        </p:spPr>
+        <p:txBody>
+          <a:bodyPr wrap="square" lIns="36576" rIns="36576" tIns="18288" bIns="18288" anchor="t">
+            <a:spAutoFit/>
+          </a:bodyPr>
+          <a:lstStyle/>
+          <a:p>
+            <a:pPr>
+              <a:spcAft>
+                <a:spcPts val="200"/>
+              </a:spcAft>
+            </a:pPr>
+            <a:r>
+              <a:rPr sz="950" b="1">
+                <a:solidFill>
+                  <a:srgbClr val="6A3FB5"/>
+                </a:solidFill>
+                <a:latin typeface="Calibri"/>
+              </a:rPr>
+              <a:t>Universal parsing: </a:t>
+            </a:r>
+            <a:r>
+              <a:rPr sz="950" b="0">
+                <a:solidFill>
+                  <a:srgbClr val="1E2530"/>
+                </a:solidFill>
+                <a:latin typeface="Calibri"/>
+              </a:rPr>
+              <a:t>key details are pulled from structured, semi-structured and free-text logs.</a:t>
+            </a:r>
+          </a:p>
+          <a:p>
+            <a:pPr>
+              <a:spcAft>
+                <a:spcPts val="200"/>
+              </a:spcAft>
+            </a:pPr>
+            <a:r>
+              <a:rPr sz="950" b="1">
+                <a:solidFill>
+                  <a:srgbClr val="6A3FB5"/>
+                </a:solidFill>
+                <a:latin typeface="Calibri"/>
+              </a:rPr>
+              <a:t>Pattern extraction: </a:t>
+            </a:r>
+            <a:r>
+              <a:rPr sz="950" b="0">
+                <a:solidFill>
+                  <a:srgbClr val="1E2530"/>
+                </a:solidFill>
+                <a:latin typeface="Calibri"/>
+              </a:rPr>
+              <a:t>repeating lines are grouped into patterns; millions of lines become a few thousand.</a:t>
+            </a:r>
+          </a:p>
+        </p:txBody>
+      </p:sp>
+      <p:sp>
+        <p:nvSpPr>
+          <p:cNvPr id="93" name="TextBox 92"/>
+          <p:cNvSpPr txBox="1"/>
+          <p:nvPr/>
+        </p:nvSpPr>
+        <p:spPr>
+          <a:xfrm>
+            <a:off x="4567428" y="3557016"/>
+            <a:ext cx="2921508" cy="768096"/>
+          </a:xfrm>
+          <a:prstGeom prst="rect">
+            <a:avLst/>
+          </a:prstGeom>
+          <a:noFill/>
+        </p:spPr>
+        <p:txBody>
+          <a:bodyPr wrap="square" lIns="36576" rIns="36576" tIns="18288" bIns="18288" anchor="t">
+            <a:spAutoFit/>
+          </a:bodyPr>
+          <a:lstStyle/>
+          <a:p>
+            <a:pPr>
+              <a:spcAft>
+                <a:spcPts val="200"/>
+              </a:spcAft>
+            </a:pPr>
+            <a:r>
+              <a:rPr sz="950" b="1">
+                <a:solidFill>
+                  <a:srgbClr val="6A3FB5"/>
+                </a:solidFill>
+                <a:latin typeface="Calibri"/>
+              </a:rPr>
+              <a:t>Intelligent field mapping: </a:t>
+            </a:r>
+            <a:r>
+              <a:rPr sz="950" b="0">
+                <a:solidFill>
+                  <a:srgbClr val="1E2530"/>
+                </a:solidFill>
+                <a:latin typeface="Calibri"/>
+              </a:rPr>
+              <a:t>'lvl', 'level', 'severity' and other differently named fields land in one field.</a:t>
+            </a:r>
+          </a:p>
+          <a:p>
+            <a:pPr>
+              <a:spcAft>
+                <a:spcPts val="200"/>
+              </a:spcAft>
+            </a:pPr>
+            <a:r>
+              <a:rPr sz="950" b="1">
+                <a:solidFill>
+                  <a:srgbClr val="6A3FB5"/>
+                </a:solidFill>
+                <a:latin typeface="Calibri"/>
+              </a:rPr>
+              <a:t>Field normalisation: </a:t>
+            </a:r>
+            <a:r>
+              <a:rPr sz="950" b="0">
+                <a:solidFill>
+                  <a:srgbClr val="1E2530"/>
+                </a:solidFill>
+                <a:latin typeface="Calibri"/>
+              </a:rPr>
+              <a:t>times become UTC, severity one scale; event type, host, IPs and users are extracted.</a:t>
+            </a:r>
+          </a:p>
+        </p:txBody>
+      </p:sp>
+      <p:sp>
+        <p:nvSpPr>
+          <p:cNvPr id="94" name="Rounded Rectangle 93"/>
+          <p:cNvSpPr/>
+          <p:nvPr/>
+        </p:nvSpPr>
+        <p:spPr>
+          <a:xfrm>
+            <a:off x="475488" y="4425696"/>
+            <a:ext cx="7050024" cy="1024128"/>
+          </a:xfrm>
+          <a:prstGeom prst="roundRect">
+            <a:avLst>
+              <a:gd name="adj" fmla="val 8000"/>
+            </a:avLst>
+          </a:prstGeom>
+          <a:solidFill>
+            <a:srgbClr val="E8F5EC"/>
+          </a:solidFill>
+          <a:ln>
+            <a:noFill/>
+          </a:ln>
+          <a:effectLst/>
+        </p:spPr>
+        <p:style>
+          <a:lnRef idx="1">
+            <a:schemeClr val="accent1"/>
+          </a:lnRef>
+          <a:fillRef idx="3">
+            <a:schemeClr val="accent1"/>
+          </a:fillRef>
+          <a:effectRef idx="2">
+            <a:schemeClr val="accent1"/>
+          </a:effectRef>
+          <a:fontRef idx="minor">
+            <a:schemeClr val="lt1"/>
+          </a:fontRef>
+        </p:style>
+        <p:txBody>
+          <a:bodyPr rtlCol="0" anchor="ctr"/>
+          <a:lstStyle/>
+          <a:p>
+            <a:pPr algn="ctr"/>
+          </a:p>
+        </p:txBody>
+      </p:sp>
+      <p:sp>
+        <p:nvSpPr>
+          <p:cNvPr id="95" name="Rounded Rectangle 94"/>
+          <p:cNvSpPr/>
+          <p:nvPr/>
+        </p:nvSpPr>
+        <p:spPr>
+          <a:xfrm>
+            <a:off x="475488" y="4425696"/>
+            <a:ext cx="1024128" cy="1024128"/>
+          </a:xfrm>
+          <a:prstGeom prst="roundRect">
+            <a:avLst>
+              <a:gd name="adj" fmla="val 12000"/>
+            </a:avLst>
+          </a:prstGeom>
+          <a:solidFill>
+            <a:srgbClr val="138A36"/>
+          </a:solidFill>
+          <a:ln>
+            <a:noFill/>
+          </a:ln>
+          <a:effectLst/>
+        </p:spPr>
+        <p:style>
+          <a:lnRef idx="1">
+            <a:schemeClr val="accent1"/>
+          </a:lnRef>
+          <a:fillRef idx="3">
+            <a:schemeClr val="accent1"/>
+          </a:fillRef>
+          <a:effectRef idx="2">
+            <a:schemeClr val="accent1"/>
+          </a:effectRef>
+          <a:fontRef idx="minor">
+            <a:schemeClr val="lt1"/>
+          </a:fontRef>
+        </p:style>
+        <p:txBody>
+          <a:bodyPr rtlCol="0" anchor="ctr"/>
+          <a:lstStyle/>
+          <a:p>
+            <a:pPr algn="ctr"/>
+          </a:p>
+        </p:txBody>
+      </p:sp>
+      <p:sp>
+        <p:nvSpPr>
+          <p:cNvPr id="96" name="TextBox 95"/>
+          <p:cNvSpPr txBox="1"/>
+          <p:nvPr/>
+        </p:nvSpPr>
+        <p:spPr>
+          <a:xfrm>
+            <a:off x="475488" y="4425696"/>
+            <a:ext cx="1024128" cy="1024128"/>
+          </a:xfrm>
+          <a:prstGeom prst="rect">
+            <a:avLst/>
+          </a:prstGeom>
+          <a:noFill/>
+        </p:spPr>
+        <p:txBody>
+          <a:bodyPr wrap="square" lIns="27432" rIns="27432" tIns="18288" bIns="18288" anchor="ctr">
+            <a:spAutoFit/>
+          </a:bodyPr>
+          <a:lstStyle/>
+          <a:p>
+            <a:pPr algn="ctr"/>
+            <a:r>
+              <a:rPr sz="1800" b="1">
+                <a:solidFill>
+                  <a:srgbClr val="FFFFFF"/>
+                </a:solidFill>
+                <a:latin typeface="Calibri"/>
+              </a:rPr>
+              <a:t>3</a:t>
+            </a:r>
+          </a:p>
+          <a:p>
+            <a:pPr algn="ctr"/>
+            <a:r>
+              <a:rPr sz="950" b="1">
+                <a:solidFill>
+                  <a:srgbClr val="FFFFFF"/>
+                </a:solidFill>
+                <a:latin typeface="Calibri"/>
+              </a:rPr>
+              <a:t>CLEAN &amp;</a:t>
+            </a:r>
+          </a:p>
+          <a:p>
+            <a:pPr algn="ctr"/>
+            <a:r>
+              <a:rPr sz="950" b="1">
+                <a:solidFill>
+                  <a:srgbClr val="FFFFFF"/>
+                </a:solidFill>
+                <a:latin typeface="Calibri"/>
+              </a:rPr>
+              <a:t>DELIVER</a:t>
+            </a:r>
+          </a:p>
+        </p:txBody>
+      </p:sp>
+      <p:sp>
+        <p:nvSpPr>
+          <p:cNvPr id="97" name="TextBox 96"/>
+          <p:cNvSpPr txBox="1"/>
+          <p:nvPr/>
+        </p:nvSpPr>
+        <p:spPr>
+          <a:xfrm>
+            <a:off x="1591056" y="4471416"/>
+            <a:ext cx="2921508" cy="950976"/>
+          </a:xfrm>
+          <a:prstGeom prst="rect">
+            <a:avLst/>
+          </a:prstGeom>
+          <a:noFill/>
+        </p:spPr>
+        <p:txBody>
+          <a:bodyPr wrap="square" lIns="36576" rIns="36576" tIns="18288" bIns="18288" anchor="t">
+            <a:spAutoFit/>
+          </a:bodyPr>
+          <a:lstStyle/>
+          <a:p>
+            <a:pPr>
+              <a:spcAft>
+                <a:spcPts val="200"/>
+              </a:spcAft>
+            </a:pPr>
+            <a:r>
+              <a:rPr sz="950" b="1">
+                <a:solidFill>
+                  <a:srgbClr val="138A36"/>
+                </a:solidFill>
+                <a:latin typeface="Calibri"/>
+              </a:rPr>
+              <a:t>Error &amp; anomaly handling: </a:t>
+            </a:r>
+            <a:r>
+              <a:rPr sz="950" b="0">
+                <a:solidFill>
+                  <a:srgbClr val="1E2530"/>
+                </a:solidFill>
+                <a:latin typeface="Calibri"/>
+              </a:rPr>
+              <a:t>missing fields get safe defaults; unusual lines are flagged for review.</a:t>
+            </a:r>
+          </a:p>
+          <a:p>
+            <a:pPr>
+              <a:spcAft>
+                <a:spcPts val="200"/>
+              </a:spcAft>
+            </a:pPr>
+            <a:r>
+              <a:rPr sz="950" b="1">
+                <a:solidFill>
+                  <a:srgbClr val="138A36"/>
+                </a:solidFill>
+                <a:latin typeface="Calibri"/>
+              </a:rPr>
+              <a:t>Duplicate removal (planned): </a:t>
+            </a:r>
+            <a:r>
+              <a:rPr sz="950" b="0">
+                <a:solidFill>
+                  <a:srgbClr val="1E2530"/>
+                </a:solidFill>
+                <a:latin typeface="Calibri"/>
+              </a:rPr>
+              <a:t>repeated entries are dropped to cut noise and storage.</a:t>
+            </a:r>
+          </a:p>
+          <a:p>
+            <a:pPr>
+              <a:spcAft>
+                <a:spcPts val="200"/>
+              </a:spcAft>
+            </a:pPr>
+            <a:r>
+              <a:rPr sz="950" b="1">
+                <a:solidFill>
+                  <a:srgbClr val="138A36"/>
+                </a:solidFill>
+                <a:latin typeface="Calibri"/>
+              </a:rPr>
+              <a:t>Common schema: </a:t>
+            </a:r>
+            <a:r>
+              <a:rPr sz="950" b="0">
+                <a:solidFill>
+                  <a:srgbClr val="1E2530"/>
+                </a:solidFill>
+                <a:latin typeface="Calibri"/>
+              </a:rPr>
+              <a:t>every log gets the same fields: time, source, event, severity and message.</a:t>
+            </a:r>
+          </a:p>
+        </p:txBody>
+      </p:sp>
+      <p:sp>
+        <p:nvSpPr>
+          <p:cNvPr id="98" name="TextBox 97"/>
+          <p:cNvSpPr txBox="1"/>
+          <p:nvPr/>
+        </p:nvSpPr>
+        <p:spPr>
+          <a:xfrm>
+            <a:off x="4567428" y="4471416"/>
+            <a:ext cx="2921508" cy="950976"/>
+          </a:xfrm>
+          <a:prstGeom prst="rect">
+            <a:avLst/>
+          </a:prstGeom>
+          <a:noFill/>
+        </p:spPr>
+        <p:txBody>
+          <a:bodyPr wrap="square" lIns="36576" rIns="36576" tIns="18288" bIns="18288" anchor="t">
+            <a:spAutoFit/>
+          </a:bodyPr>
+          <a:lstStyle/>
+          <a:p>
+            <a:pPr>
+              <a:spcAft>
+                <a:spcPts val="200"/>
+              </a:spcAft>
+            </a:pPr>
+            <a:r>
+              <a:rPr sz="950" b="1">
+                <a:solidFill>
+                  <a:srgbClr val="138A36"/>
+                </a:solidFill>
+                <a:latin typeface="Calibri"/>
+              </a:rPr>
+              <a:t>Standardised output: </a:t>
+            </a:r>
+            <a:r>
+              <a:rPr sz="950" b="0">
+                <a:solidFill>
+                  <a:srgbClr val="1E2530"/>
+                </a:solidFill>
+                <a:latin typeface="Calibri"/>
+              </a:rPr>
+              <a:t>clean, machine-readable JSON for SIEM, monitoring &amp; analytics (connectors planned).</a:t>
+            </a:r>
+          </a:p>
+          <a:p>
+            <a:pPr>
+              <a:spcAft>
+                <a:spcPts val="200"/>
+              </a:spcAft>
+            </a:pPr>
+            <a:r>
+              <a:rPr sz="950" b="1">
+                <a:solidFill>
+                  <a:srgbClr val="138A36"/>
+                </a:solidFill>
+                <a:latin typeface="Calibri"/>
+              </a:rPr>
+              <a:t>Easy integration: </a:t>
+            </a:r>
+            <a:r>
+              <a:rPr sz="950" b="0">
+                <a:solidFill>
+                  <a:srgbClr val="1E2530"/>
+                </a:solidFill>
+                <a:latin typeface="Calibri"/>
+              </a:rPr>
+              <a:t>one simple interface for every downstream tool, whatever the original source.</a:t>
+            </a:r>
+          </a:p>
+        </p:txBody>
+      </p:sp>
+      <p:sp>
+        <p:nvSpPr>
+          <p:cNvPr id="99" name="Rounded Rectangle 98"/>
+          <p:cNvSpPr/>
+          <p:nvPr/>
+        </p:nvSpPr>
+        <p:spPr>
+          <a:xfrm>
+            <a:off x="7818120" y="1901952"/>
+            <a:ext cx="4050792" cy="3639312"/>
+          </a:xfrm>
+          <a:prstGeom prst="roundRect">
+            <a:avLst>
+              <a:gd name="adj" fmla="val 3000"/>
             </a:avLst>
           </a:prstGeom>
           <a:solidFill>
@@ -9161,378 +9759,18 @@
       </p:sp>
       <p:sp>
         <p:nvSpPr>
-          <p:cNvPr id="87" name="Rounded Rectangle 86"/>
+          <p:cNvPr id="100" name="Rounded Rectangle 99"/>
           <p:cNvSpPr/>
           <p:nvPr/>
         </p:nvSpPr>
         <p:spPr>
           <a:xfrm>
-            <a:off x="4291584" y="1920240"/>
-            <a:ext cx="3651504" cy="384048"/>
+            <a:off x="7818120" y="1901952"/>
+            <a:ext cx="4050792" cy="365760"/>
           </a:xfrm>
           <a:prstGeom prst="roundRect">
             <a:avLst>
-              <a:gd name="adj" fmla="val 20000"/>
-            </a:avLst>
-          </a:prstGeom>
-          <a:solidFill>
-            <a:srgbClr val="6A3FB5"/>
-          </a:solidFill>
-          <a:ln>
-            <a:noFill/>
-          </a:ln>
-          <a:effectLst/>
-        </p:spPr>
-        <p:style>
-          <a:lnRef idx="1">
-            <a:schemeClr val="accent1"/>
-          </a:lnRef>
-          <a:fillRef idx="3">
-            <a:schemeClr val="accent1"/>
-          </a:fillRef>
-          <a:effectRef idx="2">
-            <a:schemeClr val="accent1"/>
-          </a:effectRef>
-          <a:fontRef idx="minor">
-            <a:schemeClr val="lt1"/>
-          </a:fontRef>
-        </p:style>
-        <p:txBody>
-          <a:bodyPr rtlCol="0" anchor="ctr"/>
-          <a:lstStyle/>
-          <a:p>
-            <a:pPr algn="ctr"/>
-          </a:p>
-        </p:txBody>
-      </p:sp>
-      <p:sp>
-        <p:nvSpPr>
-          <p:cNvPr id="88" name="TextBox 87"/>
-          <p:cNvSpPr txBox="1"/>
-          <p:nvPr/>
-        </p:nvSpPr>
-        <p:spPr>
-          <a:xfrm>
-            <a:off x="4291584" y="1920240"/>
-            <a:ext cx="3651504" cy="384048"/>
-          </a:xfrm>
-          <a:prstGeom prst="rect">
-            <a:avLst/>
-          </a:prstGeom>
-          <a:noFill/>
-        </p:spPr>
-        <p:txBody>
-          <a:bodyPr wrap="square" lIns="54864" rIns="54864" tIns="18288" bIns="18288" anchor="ctr">
-            <a:spAutoFit/>
-          </a:bodyPr>
-          <a:lstStyle/>
-          <a:p>
-            <a:pPr algn="ctr"/>
-            <a:r>
-              <a:rPr sz="1350" b="1">
-                <a:solidFill>
-                  <a:srgbClr val="FFFFFF"/>
-                </a:solidFill>
-                <a:latin typeface="Calibri"/>
-              </a:rPr>
-              <a:t>2   UNDERSTAND &amp; MAP</a:t>
-            </a:r>
-          </a:p>
-        </p:txBody>
-      </p:sp>
-      <p:sp>
-        <p:nvSpPr>
-          <p:cNvPr id="89" name="TextBox 88"/>
-          <p:cNvSpPr txBox="1"/>
-          <p:nvPr/>
-        </p:nvSpPr>
-        <p:spPr>
-          <a:xfrm>
-            <a:off x="4401312" y="2377440"/>
-            <a:ext cx="3450336" cy="2807208"/>
-          </a:xfrm>
-          <a:prstGeom prst="rect">
-            <a:avLst/>
-          </a:prstGeom>
-          <a:noFill/>
-        </p:spPr>
-        <p:txBody>
-          <a:bodyPr wrap="square" lIns="54864" rIns="54864" tIns="18288" bIns="18288" anchor="t">
-            <a:spAutoFit/>
-          </a:bodyPr>
-          <a:lstStyle/>
-          <a:p>
-            <a:pPr>
-              <a:spcAft>
-                <a:spcPts val="0"/>
-              </a:spcAft>
-            </a:pPr>
-            <a:r>
-              <a:rPr sz="900" b="1">
-                <a:solidFill>
-                  <a:srgbClr val="6A3FB5"/>
-                </a:solidFill>
-                <a:latin typeface="Calibri"/>
-              </a:rPr>
-              <a:t>■ </a:t>
-            </a:r>
-            <a:r>
-              <a:rPr sz="1150" b="1">
-                <a:solidFill>
-                  <a:srgbClr val="6A3FB5"/>
-                </a:solidFill>
-                <a:latin typeface="Calibri"/>
-              </a:rPr>
-              <a:t>Universal parsing</a:t>
-            </a:r>
-          </a:p>
-          <a:p>
-            <a:pPr>
-              <a:spcAft>
-                <a:spcPts val="1100"/>
-              </a:spcAft>
-            </a:pPr>
-            <a:r>
-              <a:rPr sz="1000" b="0">
-                <a:solidFill>
-                  <a:srgbClr val="1E2530"/>
-                </a:solidFill>
-                <a:latin typeface="Calibri"/>
-              </a:rPr>
-              <a:t>Pulls key details out of structured, semi-structured and free-text logs.</a:t>
-            </a:r>
-          </a:p>
-          <a:p>
-            <a:pPr>
-              <a:spcAft>
-                <a:spcPts val="0"/>
-              </a:spcAft>
-            </a:pPr>
-            <a:r>
-              <a:rPr sz="900" b="1">
-                <a:solidFill>
-                  <a:srgbClr val="6A3FB5"/>
-                </a:solidFill>
-                <a:latin typeface="Calibri"/>
-              </a:rPr>
-              <a:t>■ </a:t>
-            </a:r>
-            <a:r>
-              <a:rPr sz="1150" b="1">
-                <a:solidFill>
-                  <a:srgbClr val="6A3FB5"/>
-                </a:solidFill>
-                <a:latin typeface="Calibri"/>
-              </a:rPr>
-              <a:t>Pattern extraction</a:t>
-            </a:r>
-          </a:p>
-          <a:p>
-            <a:pPr>
-              <a:spcAft>
-                <a:spcPts val="1100"/>
-              </a:spcAft>
-            </a:pPr>
-            <a:r>
-              <a:rPr sz="1000" b="0">
-                <a:solidFill>
-                  <a:srgbClr val="1E2530"/>
-                </a:solidFill>
-                <a:latin typeface="Calibri"/>
-              </a:rPr>
-              <a:t>Groups repeating lines into patterns, so millions of lines become a few thousand.</a:t>
-            </a:r>
-          </a:p>
-          <a:p>
-            <a:pPr>
-              <a:spcAft>
-                <a:spcPts val="0"/>
-              </a:spcAft>
-            </a:pPr>
-            <a:r>
-              <a:rPr sz="900" b="1">
-                <a:solidFill>
-                  <a:srgbClr val="6A3FB5"/>
-                </a:solidFill>
-                <a:latin typeface="Calibri"/>
-              </a:rPr>
-              <a:t>■ </a:t>
-            </a:r>
-            <a:r>
-              <a:rPr sz="1150" b="1">
-                <a:solidFill>
-                  <a:srgbClr val="6A3FB5"/>
-                </a:solidFill>
-                <a:latin typeface="Calibri"/>
-              </a:rPr>
-              <a:t>Intelligent field mapping</a:t>
-            </a:r>
-          </a:p>
-          <a:p>
-            <a:pPr>
-              <a:spcAft>
-                <a:spcPts val="1100"/>
-              </a:spcAft>
-            </a:pPr>
-            <a:r>
-              <a:rPr sz="1000" b="0">
-                <a:solidFill>
-                  <a:srgbClr val="1E2530"/>
-                </a:solidFill>
-                <a:latin typeface="Calibri"/>
-              </a:rPr>
-              <a:t>'lvl', 'level', 'severity': differently named fields land in one common field.</a:t>
-            </a:r>
-          </a:p>
-          <a:p>
-            <a:pPr>
-              <a:spcAft>
-                <a:spcPts val="0"/>
-              </a:spcAft>
-            </a:pPr>
-            <a:r>
-              <a:rPr sz="900" b="1">
-                <a:solidFill>
-                  <a:srgbClr val="6A3FB5"/>
-                </a:solidFill>
-                <a:latin typeface="Calibri"/>
-              </a:rPr>
-              <a:t>■ </a:t>
-            </a:r>
-            <a:r>
-              <a:rPr sz="1150" b="1">
-                <a:solidFill>
-                  <a:srgbClr val="6A3FB5"/>
-                </a:solidFill>
-                <a:latin typeface="Calibri"/>
-              </a:rPr>
-              <a:t>Field normalisation</a:t>
-            </a:r>
-          </a:p>
-          <a:p>
-            <a:pPr>
-              <a:spcAft>
-                <a:spcPts val="1100"/>
-              </a:spcAft>
-            </a:pPr>
-            <a:r>
-              <a:rPr sz="1000" b="0">
-                <a:solidFill>
-                  <a:srgbClr val="1E2530"/>
-                </a:solidFill>
-                <a:latin typeface="Calibri"/>
-              </a:rPr>
-              <a:t>Times become UTC and severity one scale; event type, host, IPs and users are extracted.</a:t>
-            </a:r>
-          </a:p>
-        </p:txBody>
-      </p:sp>
-      <p:sp>
-        <p:nvSpPr>
-          <p:cNvPr id="90" name="Right Arrow 89"/>
-          <p:cNvSpPr/>
-          <p:nvPr/>
-        </p:nvSpPr>
-        <p:spPr>
-          <a:xfrm>
-            <a:off x="7979664" y="3392424"/>
-            <a:ext cx="201168" cy="365760"/>
-          </a:xfrm>
-          <a:prstGeom prst="rightArrow">
-            <a:avLst/>
-          </a:prstGeom>
-          <a:solidFill>
-            <a:srgbClr val="F28322"/>
-          </a:solidFill>
-          <a:ln>
-            <a:noFill/>
-          </a:ln>
-          <a:effectLst/>
-        </p:spPr>
-        <p:style>
-          <a:lnRef idx="1">
-            <a:schemeClr val="accent1"/>
-          </a:lnRef>
-          <a:fillRef idx="3">
-            <a:schemeClr val="accent1"/>
-          </a:fillRef>
-          <a:effectRef idx="2">
-            <a:schemeClr val="accent1"/>
-          </a:effectRef>
-          <a:fontRef idx="minor">
-            <a:schemeClr val="lt1"/>
-          </a:fontRef>
-        </p:style>
-        <p:txBody>
-          <a:bodyPr rtlCol="0" anchor="ctr"/>
-          <a:lstStyle/>
-          <a:p>
-            <a:pPr algn="ctr"/>
-          </a:p>
-        </p:txBody>
-      </p:sp>
-      <p:sp>
-        <p:nvSpPr>
-          <p:cNvPr id="91" name="Rounded Rectangle 90"/>
-          <p:cNvSpPr/>
-          <p:nvPr/>
-        </p:nvSpPr>
-        <p:spPr>
-          <a:xfrm>
-            <a:off x="8217408" y="1920240"/>
-            <a:ext cx="3651504" cy="3310128"/>
-          </a:xfrm>
-          <a:prstGeom prst="roundRect">
-            <a:avLst>
-              <a:gd name="adj" fmla="val 4000"/>
-            </a:avLst>
-          </a:prstGeom>
-          <a:solidFill>
-            <a:srgbClr val="FFFFFF"/>
-          </a:solidFill>
-          <a:ln w="12700">
-            <a:solidFill>
-              <a:srgbClr val="D5DCE6"/>
-            </a:solidFill>
-          </a:ln>
-          <a:effectLst/>
-        </p:spPr>
-        <p:style>
-          <a:lnRef idx="1">
-            <a:schemeClr val="accent1"/>
-          </a:lnRef>
-          <a:fillRef idx="3">
-            <a:schemeClr val="accent1"/>
-          </a:fillRef>
-          <a:effectRef idx="2">
-            <a:schemeClr val="accent1"/>
-          </a:effectRef>
-          <a:fontRef idx="minor">
-            <a:schemeClr val="lt1"/>
-          </a:fontRef>
-        </p:style>
-        <p:txBody>
-          <a:bodyPr rtlCol="0" anchor="ctr"/>
-          <a:lstStyle/>
-          <a:p>
-            <a:pPr algn="ctr"/>
-          </a:p>
-        </p:txBody>
-      </p:sp>
-      <p:sp>
-        <p:nvSpPr>
-          <p:cNvPr id="92" name="Rounded Rectangle 91"/>
-          <p:cNvSpPr/>
-          <p:nvPr/>
-        </p:nvSpPr>
-        <p:spPr>
-          <a:xfrm>
-            <a:off x="8217408" y="1920240"/>
-            <a:ext cx="3651504" cy="384048"/>
-          </a:xfrm>
-          <a:prstGeom prst="roundRect">
-            <a:avLst>
-              <a:gd name="adj" fmla="val 20000"/>
+              <a:gd name="adj" fmla="val 18000"/>
             </a:avLst>
           </a:prstGeom>
           <a:solidFill>
@@ -9567,14 +9805,14 @@
       </p:sp>
       <p:sp>
         <p:nvSpPr>
-          <p:cNvPr id="93" name="TextBox 92"/>
+          <p:cNvPr id="101" name="TextBox 100"/>
           <p:cNvSpPr txBox="1"/>
           <p:nvPr/>
         </p:nvSpPr>
         <p:spPr>
           <a:xfrm>
-            <a:off x="8217408" y="1920240"/>
-            <a:ext cx="3651504" cy="384048"/>
+            <a:off x="7927848" y="1901952"/>
+            <a:ext cx="3867912" cy="365760"/>
           </a:xfrm>
           <a:prstGeom prst="rect">
             <a:avLst/>
@@ -9582,34 +9820,33 @@
           <a:noFill/>
         </p:spPr>
         <p:txBody>
-          <a:bodyPr wrap="square" lIns="54864" rIns="54864" tIns="18288" bIns="18288" anchor="ctr">
+          <a:bodyPr wrap="square" lIns="45720" rIns="45720" tIns="18288" bIns="18288" anchor="ctr">
             <a:spAutoFit/>
           </a:bodyPr>
           <a:lstStyle/>
           <a:p>
-            <a:pPr algn="ctr"/>
-            <a:r>
-              <a:rPr sz="1350" b="1">
+            <a:r>
+              <a:rPr sz="1400" b="1">
                 <a:solidFill>
                   <a:srgbClr val="FFFFFF"/>
                 </a:solidFill>
                 <a:latin typeface="Calibri"/>
               </a:rPr>
-              <a:t>3   CLEAN &amp; DELIVER</a:t>
-            </a:r>
-          </a:p>
-        </p:txBody>
-      </p:sp>
-      <p:sp>
-        <p:nvSpPr>
-          <p:cNvPr id="94" name="TextBox 93"/>
+              <a:t>HOW IT ADDRESSES THE PROBLEM</a:t>
+            </a:r>
+          </a:p>
+        </p:txBody>
+      </p:sp>
+      <p:sp>
+        <p:nvSpPr>
+          <p:cNvPr id="102" name="TextBox 101"/>
           <p:cNvSpPr txBox="1"/>
           <p:nvPr/>
         </p:nvSpPr>
         <p:spPr>
           <a:xfrm>
-            <a:off x="8327136" y="2377440"/>
-            <a:ext cx="3450336" cy="2807208"/>
+            <a:off x="7946136" y="2359152"/>
+            <a:ext cx="3813048" cy="3136392"/>
           </a:xfrm>
           <a:prstGeom prst="rect">
             <a:avLst/>
@@ -9617,213 +9854,401 @@
           <a:noFill/>
         </p:spPr>
         <p:txBody>
-          <a:bodyPr wrap="square" lIns="54864" rIns="54864" tIns="18288" bIns="18288" anchor="t">
+          <a:bodyPr wrap="square" lIns="36576" rIns="36576" tIns="18288" bIns="18288" anchor="t">
             <a:spAutoFit/>
           </a:bodyPr>
           <a:lstStyle/>
           <a:p>
             <a:pPr>
               <a:spcAft>
-                <a:spcPts val="0"/>
+                <a:spcPts val="100"/>
               </a:spcAft>
             </a:pPr>
             <a:r>
-              <a:rPr sz="900" b="1">
-                <a:solidFill>
-                  <a:srgbClr val="138A36"/>
-                </a:solidFill>
-                <a:latin typeface="Calibri"/>
-              </a:rPr>
-              <a:t>■ </a:t>
-            </a:r>
-            <a:r>
-              <a:rPr sz="1150" b="1">
-                <a:solidFill>
-                  <a:srgbClr val="138A36"/>
-                </a:solidFill>
-                <a:latin typeface="Calibri"/>
-              </a:rPr>
-              <a:t>Error &amp; anomaly handling</a:t>
+              <a:rPr sz="950" b="1">
+                <a:solidFill>
+                  <a:srgbClr val="C0392B"/>
+                </a:solidFill>
+                <a:latin typeface="Calibri"/>
+              </a:rPr>
+              <a:t>✖ </a:t>
+            </a:r>
+            <a:r>
+              <a:rPr sz="1050" b="1">
+                <a:solidFill>
+                  <a:srgbClr val="C0392B"/>
+                </a:solidFill>
+                <a:latin typeface="Calibri"/>
+              </a:rPr>
+              <a:t>Too many log formats</a:t>
             </a:r>
           </a:p>
           <a:p>
             <a:pPr>
               <a:spcAft>
-                <a:spcPts val="550"/>
+                <a:spcPts val="500"/>
               </a:spcAft>
             </a:pPr>
             <a:r>
-              <a:rPr sz="1000" b="0">
+              <a:rPr sz="950" b="1">
+                <a:solidFill>
+                  <a:srgbClr val="138A36"/>
+                </a:solidFill>
+                <a:latin typeface="Calibri"/>
+              </a:rPr>
+              <a:t>✔ </a:t>
+            </a:r>
+            <a:r>
+              <a:rPr sz="950" b="0">
                 <a:solidFill>
                   <a:srgbClr val="1E2530"/>
                 </a:solidFill>
                 <a:latin typeface="Calibri"/>
               </a:rPr>
-              <a:t>Missing fields get safe defaults; unusual lines are flagged for review.</a:t>
+              <a:t>common formats are recognised instantly and new ones are learned automatically, so any source can be connected.</a:t>
             </a:r>
           </a:p>
           <a:p>
             <a:pPr>
               <a:spcAft>
-                <a:spcPts val="0"/>
+                <a:spcPts val="100"/>
               </a:spcAft>
             </a:pPr>
             <a:r>
-              <a:rPr sz="900" b="1">
-                <a:solidFill>
-                  <a:srgbClr val="138A36"/>
-                </a:solidFill>
-                <a:latin typeface="Calibri"/>
-              </a:rPr>
-              <a:t>■ </a:t>
-            </a:r>
-            <a:r>
-              <a:rPr sz="1150" b="1">
-                <a:solidFill>
-                  <a:srgbClr val="138A36"/>
-                </a:solidFill>
-                <a:latin typeface="Calibri"/>
-              </a:rPr>
-              <a:t>Duplicate removal (planned)</a:t>
+              <a:rPr sz="950" b="1">
+                <a:solidFill>
+                  <a:srgbClr val="C0392B"/>
+                </a:solidFill>
+                <a:latin typeface="Calibri"/>
+              </a:rPr>
+              <a:t>✖ </a:t>
+            </a:r>
+            <a:r>
+              <a:rPr sz="1050" b="1">
+                <a:solidFill>
+                  <a:srgbClr val="C0392B"/>
+                </a:solidFill>
+                <a:latin typeface="Calibri"/>
+              </a:rPr>
+              <a:t>Parsers keep breaking</a:t>
             </a:r>
           </a:p>
           <a:p>
             <a:pPr>
               <a:spcAft>
-                <a:spcPts val="550"/>
+                <a:spcPts val="500"/>
               </a:spcAft>
             </a:pPr>
             <a:r>
-              <a:rPr sz="1000" b="0">
+              <a:rPr sz="950" b="1">
+                <a:solidFill>
+                  <a:srgbClr val="138A36"/>
+                </a:solidFill>
+                <a:latin typeface="Calibri"/>
+              </a:rPr>
+              <a:t>✔ </a:t>
+            </a:r>
+            <a:r>
+              <a:rPr sz="950" b="0">
                 <a:solidFill>
                   <a:srgbClr val="1E2530"/>
                 </a:solidFill>
                 <a:latin typeface="Calibri"/>
               </a:rPr>
-              <a:t>Repeated entries dropped to cut noise and storage.</a:t>
+              <a:t>no hand-written parser code to write, fix or maintain; rules are created and saved by the system.</a:t>
             </a:r>
           </a:p>
           <a:p>
             <a:pPr>
               <a:spcAft>
-                <a:spcPts val="0"/>
+                <a:spcPts val="100"/>
               </a:spcAft>
             </a:pPr>
             <a:r>
-              <a:rPr sz="900" b="1">
-                <a:solidFill>
-                  <a:srgbClr val="138A36"/>
-                </a:solidFill>
-                <a:latin typeface="Calibri"/>
-              </a:rPr>
-              <a:t>■ </a:t>
-            </a:r>
-            <a:r>
-              <a:rPr sz="1150" b="1">
-                <a:solidFill>
-                  <a:srgbClr val="138A36"/>
-                </a:solidFill>
-                <a:latin typeface="Calibri"/>
-              </a:rPr>
-              <a:t>Common schema</a:t>
+              <a:rPr sz="950" b="1">
+                <a:solidFill>
+                  <a:srgbClr val="C0392B"/>
+                </a:solidFill>
+                <a:latin typeface="Calibri"/>
+              </a:rPr>
+              <a:t>✖ </a:t>
+            </a:r>
+            <a:r>
+              <a:rPr sz="1050" b="1">
+                <a:solidFill>
+                  <a:srgbClr val="C0392B"/>
+                </a:solidFill>
+                <a:latin typeface="Calibri"/>
+              </a:rPr>
+              <a:t>Slow, manual investigation</a:t>
             </a:r>
           </a:p>
           <a:p>
             <a:pPr>
               <a:spcAft>
-                <a:spcPts val="550"/>
+                <a:spcPts val="500"/>
               </a:spcAft>
             </a:pPr>
             <a:r>
-              <a:rPr sz="1000" b="0">
+              <a:rPr sz="950" b="1">
+                <a:solidFill>
+                  <a:srgbClr val="138A36"/>
+                </a:solidFill>
+                <a:latin typeface="Calibri"/>
+              </a:rPr>
+              <a:t>✔ </a:t>
+            </a:r>
+            <a:r>
+              <a:rPr sz="950" b="0">
                 <a:solidFill>
                   <a:srgbClr val="1E2530"/>
                 </a:solidFill>
                 <a:latin typeface="Calibri"/>
               </a:rPr>
-              <a:t>Every log gets the same fields: time, source, event, severity, message.</a:t>
+              <a:t>all logs share one clean, time-aligned and security-tagged format, so analysts search one place.</a:t>
             </a:r>
           </a:p>
           <a:p>
             <a:pPr>
               <a:spcAft>
-                <a:spcPts val="0"/>
+                <a:spcPts val="100"/>
               </a:spcAft>
             </a:pPr>
             <a:r>
-              <a:rPr sz="900" b="1">
-                <a:solidFill>
-                  <a:srgbClr val="138A36"/>
-                </a:solidFill>
-                <a:latin typeface="Calibri"/>
-              </a:rPr>
-              <a:t>■ </a:t>
-            </a:r>
-            <a:r>
-              <a:rPr sz="1150" b="1">
-                <a:solidFill>
-                  <a:srgbClr val="138A36"/>
-                </a:solidFill>
-                <a:latin typeface="Calibri"/>
-              </a:rPr>
-              <a:t>Standardised output</a:t>
+              <a:rPr sz="950" b="1">
+                <a:solidFill>
+                  <a:srgbClr val="C0392B"/>
+                </a:solidFill>
+                <a:latin typeface="Calibri"/>
+              </a:rPr>
+              <a:t>✖ </a:t>
+            </a:r>
+            <a:r>
+              <a:rPr sz="1050" b="1">
+                <a:solidFill>
+                  <a:srgbClr val="C0392B"/>
+                </a:solidFill>
+                <a:latin typeface="Calibri"/>
+              </a:rPr>
+              <a:t>AI is slow &amp; costly</a:t>
             </a:r>
           </a:p>
           <a:p>
             <a:pPr>
               <a:spcAft>
-                <a:spcPts val="550"/>
+                <a:spcPts val="500"/>
               </a:spcAft>
             </a:pPr>
             <a:r>
-              <a:rPr sz="1000" b="0">
+              <a:rPr sz="950" b="1">
+                <a:solidFill>
+                  <a:srgbClr val="138A36"/>
+                </a:solidFill>
+                <a:latin typeface="Calibri"/>
+              </a:rPr>
+              <a:t>✔ </a:t>
+            </a:r>
+            <a:r>
+              <a:rPr sz="950" b="0">
                 <a:solidFill>
                   <a:srgbClr val="1E2530"/>
                 </a:solidFill>
                 <a:latin typeface="Calibri"/>
               </a:rPr>
-              <a:t>Clean, machine-readable JSON for SIEM, monitoring &amp; analytics (connectors planned).</a:t>
+              <a:t>AI is used only once per new format, never per log line; everyday logs run on fast saved rules.</a:t>
             </a:r>
           </a:p>
           <a:p>
             <a:pPr>
               <a:spcAft>
-                <a:spcPts val="0"/>
+                <a:spcPts val="100"/>
               </a:spcAft>
             </a:pPr>
             <a:r>
-              <a:rPr sz="900" b="1">
-                <a:solidFill>
-                  <a:srgbClr val="138A36"/>
-                </a:solidFill>
-                <a:latin typeface="Calibri"/>
-              </a:rPr>
-              <a:t>■ </a:t>
-            </a:r>
-            <a:r>
-              <a:rPr sz="1150" b="1">
-                <a:solidFill>
-                  <a:srgbClr val="138A36"/>
-                </a:solidFill>
-                <a:latin typeface="Calibri"/>
-              </a:rPr>
-              <a:t>Easy integration</a:t>
+              <a:rPr sz="950" b="1">
+                <a:solidFill>
+                  <a:srgbClr val="C0392B"/>
+                </a:solidFill>
+                <a:latin typeface="Calibri"/>
+              </a:rPr>
+              <a:t>✖ </a:t>
+            </a:r>
+            <a:r>
+              <a:rPr sz="1050" b="1">
+                <a:solidFill>
+                  <a:srgbClr val="C0392B"/>
+                </a:solidFill>
+                <a:latin typeface="Calibri"/>
+              </a:rPr>
+              <a:t>Messy, unreliable data</a:t>
             </a:r>
           </a:p>
           <a:p>
             <a:pPr>
               <a:spcAft>
-                <a:spcPts val="550"/>
+                <a:spcPts val="500"/>
               </a:spcAft>
             </a:pPr>
             <a:r>
-              <a:rPr sz="1000" b="0">
+              <a:rPr sz="950" b="1">
+                <a:solidFill>
+                  <a:srgbClr val="138A36"/>
+                </a:solidFill>
+                <a:latin typeface="Calibri"/>
+              </a:rPr>
+              <a:t>✔ </a:t>
+            </a:r>
+            <a:r>
+              <a:rPr sz="950" b="0">
                 <a:solidFill>
                   <a:srgbClr val="1E2530"/>
                 </a:solidFill>
                 <a:latin typeface="Calibri"/>
               </a:rPr>
-              <a:t>One simple interface for every downstream tool, whatever the original source.</a:t>
+              <a:t>fields are standardised, gaps get safe defaults and the original line is always kept for audits.</a:t>
+            </a:r>
+          </a:p>
+          <a:p>
+            <a:pPr>
+              <a:spcAft>
+                <a:spcPts val="100"/>
+              </a:spcAft>
+            </a:pPr>
+            <a:r>
+              <a:rPr sz="950" b="1">
+                <a:solidFill>
+                  <a:srgbClr val="C0392B"/>
+                </a:solidFill>
+                <a:latin typeface="Calibri"/>
+              </a:rPr>
+              <a:t>✖ </a:t>
+            </a:r>
+            <a:r>
+              <a:rPr sz="1050" b="1">
+                <a:solidFill>
+                  <a:srgbClr val="C0392B"/>
+                </a:solidFill>
+                <a:latin typeface="Calibri"/>
+              </a:rPr>
+              <a:t>Compliance &amp; privacy</a:t>
+            </a:r>
+          </a:p>
+          <a:p>
+            <a:pPr>
+              <a:spcAft>
+                <a:spcPts val="500"/>
+              </a:spcAft>
+            </a:pPr>
+            <a:r>
+              <a:rPr sz="950" b="1">
+                <a:solidFill>
+                  <a:srgbClr val="138A36"/>
+                </a:solidFill>
+                <a:latin typeface="Calibri"/>
+              </a:rPr>
+              <a:t>✔ </a:t>
+            </a:r>
+            <a:r>
+              <a:rPr sz="950" b="0">
+                <a:solidFill>
+                  <a:srgbClr val="1E2530"/>
+                </a:solidFill>
+                <a:latin typeface="Calibri"/>
+              </a:rPr>
+              <a:t>clean records help meet CERT-In's 180-day log rule; can run on-premise with built-in rules (self-hosted AI planned).</a:t>
+            </a:r>
+          </a:p>
+        </p:txBody>
+      </p:sp>
+      <p:sp>
+        <p:nvSpPr>
+          <p:cNvPr id="103" name="Rounded Rectangle 102"/>
+          <p:cNvSpPr/>
+          <p:nvPr/>
+        </p:nvSpPr>
+        <p:spPr>
+          <a:xfrm>
+            <a:off x="365760" y="5632704"/>
+            <a:ext cx="1691640" cy="676656"/>
+          </a:xfrm>
+          <a:prstGeom prst="roundRect">
+            <a:avLst>
+              <a:gd name="adj" fmla="val 15000"/>
+            </a:avLst>
+          </a:prstGeom>
+          <a:solidFill>
+            <a:srgbClr val="0B2A5B"/>
+          </a:solidFill>
+          <a:ln>
+            <a:noFill/>
+          </a:ln>
+          <a:effectLst/>
+        </p:spPr>
+        <p:style>
+          <a:lnRef idx="1">
+            <a:schemeClr val="accent1"/>
+          </a:lnRef>
+          <a:fillRef idx="3">
+            <a:schemeClr val="accent1"/>
+          </a:fillRef>
+          <a:effectRef idx="2">
+            <a:schemeClr val="accent1"/>
+          </a:effectRef>
+          <a:fontRef idx="minor">
+            <a:schemeClr val="lt1"/>
+          </a:fontRef>
+        </p:style>
+        <p:txBody>
+          <a:bodyPr rtlCol="0" anchor="ctr"/>
+          <a:lstStyle/>
+          <a:p>
+            <a:pPr algn="ctr"/>
+          </a:p>
+        </p:txBody>
+      </p:sp>
+      <p:sp>
+        <p:nvSpPr>
+          <p:cNvPr id="104" name="TextBox 103"/>
+          <p:cNvSpPr txBox="1"/>
+          <p:nvPr/>
+        </p:nvSpPr>
+        <p:spPr>
+          <a:xfrm>
+            <a:off x="365760" y="5632704"/>
+            <a:ext cx="1691640" cy="676656"/>
+          </a:xfrm>
+          <a:prstGeom prst="rect">
+            <a:avLst/>
+          </a:prstGeom>
+          <a:noFill/>
+        </p:spPr>
+        <p:txBody>
+          <a:bodyPr wrap="square" lIns="45720" rIns="45720" tIns="18288" bIns="18288" anchor="ctr">
+            <a:spAutoFit/>
+          </a:bodyPr>
+          <a:lstStyle/>
+          <a:p>
+            <a:pPr algn="ctr"/>
+            <a:r>
+              <a:rPr sz="1100" b="1">
+                <a:solidFill>
+                  <a:srgbClr val="FFFFFF"/>
+                </a:solidFill>
+                <a:latin typeface="Calibri"/>
+              </a:rPr>
+              <a:t>INNOVATION &amp;</a:t>
+            </a:r>
+          </a:p>
+          <a:p>
+            <a:pPr algn="ctr"/>
+            <a:r>
+              <a:rPr sz="1100" b="1">
+                <a:solidFill>
+                  <a:srgbClr val="FFFFFF"/>
+                </a:solidFill>
+                <a:latin typeface="Calibri"/>
+              </a:rPr>
+              <a:t>UNIQUENESS</a:t>
             </a:r>
           </a:p>
         </p:txBody>

</xml_diff>

<commit_message>
PPT: slide 3 detailed 8-step methodology flow with fast path and AI path
Co-authored-by: arena-agent <297053741+arena-agent@users.noreply.github.com>
</commit_message>
<xml_diff>
--- a/presentation/SIH2026_Idea_Submission.pptx
+++ b/presentation/SIH2026_Idea_Submission.pptx
@@ -10529,1513 +10529,6 @@
       </p:sp>
       <p:sp>
         <p:nvSpPr>
-          <p:cNvPr id="18" name="Rounded Rectangle 17"/>
-          <p:cNvSpPr/>
-          <p:nvPr/>
-        </p:nvSpPr>
-        <p:spPr>
-          <a:xfrm>
-            <a:off x="5532120" y="1051560"/>
-            <a:ext cx="6336792" cy="5303520"/>
-          </a:xfrm>
-          <a:prstGeom prst="roundRect">
-            <a:avLst>
-              <a:gd name="adj" fmla="val 3000"/>
-            </a:avLst>
-          </a:prstGeom>
-          <a:solidFill>
-            <a:srgbClr val="FAFBFD"/>
-          </a:solidFill>
-          <a:ln w="12700">
-            <a:solidFill>
-              <a:srgbClr val="D3DBE8"/>
-            </a:solidFill>
-          </a:ln>
-          <a:effectLst/>
-        </p:spPr>
-        <p:style>
-          <a:lnRef idx="1">
-            <a:schemeClr val="accent1"/>
-          </a:lnRef>
-          <a:fillRef idx="3">
-            <a:schemeClr val="accent1"/>
-          </a:fillRef>
-          <a:effectRef idx="2">
-            <a:schemeClr val="accent1"/>
-          </a:effectRef>
-          <a:fontRef idx="minor">
-            <a:schemeClr val="lt1"/>
-          </a:fontRef>
-        </p:style>
-        <p:txBody>
-          <a:bodyPr rtlCol="0" anchor="ctr"/>
-          <a:lstStyle/>
-          <a:p>
-            <a:pPr algn="ctr"/>
-          </a:p>
-        </p:txBody>
-      </p:sp>
-      <p:sp>
-        <p:nvSpPr>
-          <p:cNvPr id="19" name="TextBox 18"/>
-          <p:cNvSpPr txBox="1"/>
-          <p:nvPr/>
-        </p:nvSpPr>
-        <p:spPr>
-          <a:xfrm>
-            <a:off x="8458200" y="1143000"/>
-            <a:ext cx="3383280" cy="274320"/>
-          </a:xfrm>
-          <a:prstGeom prst="rect">
-            <a:avLst/>
-          </a:prstGeom>
-          <a:noFill/>
-        </p:spPr>
-        <p:txBody>
-          <a:bodyPr wrap="square" anchor="t" lIns="36576" rIns="36576" tIns="18288" bIns="18288">
-            <a:spAutoFit/>
-          </a:bodyPr>
-          <a:lstStyle/>
-          <a:p>
-            <a:pPr algn="r">
-              <a:lnSpc>
-                <a:spcPct val="100000"/>
-              </a:lnSpc>
-              <a:spcAft>
-                <a:spcPts val="0"/>
-              </a:spcAft>
-            </a:pPr>
-            <a:r>
-              <a:rPr sz="1250" b="1" i="0">
-                <a:solidFill>
-                  <a:srgbClr val="1F5FBF"/>
-                </a:solidFill>
-                <a:latin typeface="Calibri"/>
-              </a:rPr>
-              <a:t>METHODOLOGY: HOW A LOG FLOWS</a:t>
-            </a:r>
-          </a:p>
-        </p:txBody>
-      </p:sp>
-      <p:sp>
-        <p:nvSpPr>
-          <p:cNvPr id="20" name="TextBox 19"/>
-          <p:cNvSpPr txBox="1"/>
-          <p:nvPr/>
-        </p:nvSpPr>
-        <p:spPr>
-          <a:xfrm>
-            <a:off x="8732520" y="1389888"/>
-            <a:ext cx="3063240" cy="457200"/>
-          </a:xfrm>
-          <a:prstGeom prst="rect">
-            <a:avLst/>
-          </a:prstGeom>
-          <a:noFill/>
-        </p:spPr>
-        <p:txBody>
-          <a:bodyPr wrap="square" anchor="t" lIns="36576" rIns="36576" tIns="18288" bIns="18288">
-            <a:spAutoFit/>
-          </a:bodyPr>
-          <a:lstStyle/>
-          <a:p>
-            <a:pPr algn="r">
-              <a:lnSpc>
-                <a:spcPct val="100000"/>
-              </a:lnSpc>
-              <a:spcAft>
-                <a:spcPts val="0"/>
-              </a:spcAft>
-            </a:pPr>
-            <a:r>
-              <a:rPr sz="950" b="0" i="0">
-                <a:solidFill>
-                  <a:srgbClr val="5B6778"/>
-                </a:solidFill>
-                <a:latin typeface="Calibri"/>
-              </a:rPr>
-              <a:t>Most logs take the fast green path</a:t>
-            </a:r>
-          </a:p>
-          <a:p>
-            <a:pPr algn="r">
-              <a:lnSpc>
-                <a:spcPct val="100000"/>
-              </a:lnSpc>
-              <a:spcAft>
-                <a:spcPts val="0"/>
-              </a:spcAft>
-            </a:pPr>
-            <a:r>
-              <a:rPr sz="950" b="0" i="0">
-                <a:solidFill>
-                  <a:srgbClr val="5B6778"/>
-                </a:solidFill>
-                <a:latin typeface="Calibri"/>
-              </a:rPr>
-              <a:t>AI is used only for new patterns</a:t>
-            </a:r>
-          </a:p>
-        </p:txBody>
-      </p:sp>
-      <p:sp>
-        <p:nvSpPr>
-          <p:cNvPr id="21" name="Rounded Rectangle 20"/>
-          <p:cNvSpPr/>
-          <p:nvPr/>
-        </p:nvSpPr>
-        <p:spPr>
-          <a:xfrm>
-            <a:off x="5760720" y="1234440"/>
-            <a:ext cx="2697480" cy="457200"/>
-          </a:xfrm>
-          <a:prstGeom prst="roundRect">
-            <a:avLst>
-              <a:gd name="adj" fmla="val 18000"/>
-            </a:avLst>
-          </a:prstGeom>
-          <a:solidFill>
-            <a:srgbClr val="5B6778"/>
-          </a:solidFill>
-          <a:ln>
-            <a:noFill/>
-          </a:ln>
-          <a:effectLst/>
-        </p:spPr>
-        <p:style>
-          <a:lnRef idx="1">
-            <a:schemeClr val="accent1"/>
-          </a:lnRef>
-          <a:fillRef idx="3">
-            <a:schemeClr val="accent1"/>
-          </a:fillRef>
-          <a:effectRef idx="2">
-            <a:schemeClr val="accent1"/>
-          </a:effectRef>
-          <a:fontRef idx="minor">
-            <a:schemeClr val="lt1"/>
-          </a:fontRef>
-        </p:style>
-        <p:txBody>
-          <a:bodyPr rtlCol="0" anchor="ctr" wrap="square" lIns="45720" rIns="45720" tIns="9144" bIns="9144"/>
-          <a:lstStyle/>
-          <a:p>
-            <a:pPr algn="ctr">
-              <a:lnSpc>
-                <a:spcPct val="90000"/>
-              </a:lnSpc>
-            </a:pPr>
-            <a:r>
-              <a:rPr sz="1050" b="1" i="0">
-                <a:solidFill>
-                  <a:srgbClr val="FFFFFF"/>
-                </a:solidFill>
-                <a:latin typeface="Calibri"/>
-              </a:rPr>
-              <a:t>Logs come in (web API / Bash script)</a:t>
-            </a:r>
-          </a:p>
-        </p:txBody>
-      </p:sp>
-      <p:sp>
-        <p:nvSpPr>
-          <p:cNvPr id="22" name="Rounded Rectangle 21"/>
-          <p:cNvSpPr/>
-          <p:nvPr/>
-        </p:nvSpPr>
-        <p:spPr>
-          <a:xfrm>
-            <a:off x="5760720" y="1874519"/>
-            <a:ext cx="2697480" cy="457200"/>
-          </a:xfrm>
-          <a:prstGeom prst="roundRect">
-            <a:avLst>
-              <a:gd name="adj" fmla="val 18000"/>
-            </a:avLst>
-          </a:prstGeom>
-          <a:solidFill>
-            <a:srgbClr val="1F5FBF"/>
-          </a:solidFill>
-          <a:ln>
-            <a:noFill/>
-          </a:ln>
-          <a:effectLst/>
-        </p:spPr>
-        <p:style>
-          <a:lnRef idx="1">
-            <a:schemeClr val="accent1"/>
-          </a:lnRef>
-          <a:fillRef idx="3">
-            <a:schemeClr val="accent1"/>
-          </a:fillRef>
-          <a:effectRef idx="2">
-            <a:schemeClr val="accent1"/>
-          </a:effectRef>
-          <a:fontRef idx="minor">
-            <a:schemeClr val="lt1"/>
-          </a:fontRef>
-        </p:style>
-        <p:txBody>
-          <a:bodyPr rtlCol="0" anchor="ctr" wrap="square" lIns="45720" rIns="45720" tIns="9144" bIns="9144"/>
-          <a:lstStyle/>
-          <a:p>
-            <a:pPr algn="ctr">
-              <a:lnSpc>
-                <a:spcPct val="90000"/>
-              </a:lnSpc>
-            </a:pPr>
-            <a:r>
-              <a:rPr sz="1050" b="1" i="0">
-                <a:solidFill>
-                  <a:srgbClr val="FFFFFF"/>
-                </a:solidFill>
-                <a:latin typeface="Calibri"/>
-              </a:rPr>
-              <a:t>Seen this line shape before?</a:t>
-            </a:r>
-          </a:p>
-          <a:p>
-            <a:pPr algn="ctr">
-              <a:lnSpc>
-                <a:spcPct val="90000"/>
-              </a:lnSpc>
-            </a:pPr>
-            <a:r>
-              <a:rPr sz="950" b="0" i="0">
-                <a:solidFill>
-                  <a:srgbClr val="FFFFFF"/>
-                </a:solidFill>
-                <a:latin typeface="Calibri"/>
-              </a:rPr>
-              <a:t>yes: use its saved rule instantly</a:t>
-            </a:r>
-          </a:p>
-        </p:txBody>
-      </p:sp>
-      <p:sp>
-        <p:nvSpPr>
-          <p:cNvPr id="23" name="Rounded Rectangle 22"/>
-          <p:cNvSpPr/>
-          <p:nvPr/>
-        </p:nvSpPr>
-        <p:spPr>
-          <a:xfrm>
-            <a:off x="5760720" y="2514600"/>
-            <a:ext cx="2697480" cy="457200"/>
-          </a:xfrm>
-          <a:prstGeom prst="roundRect">
-            <a:avLst>
-              <a:gd name="adj" fmla="val 18000"/>
-            </a:avLst>
-          </a:prstGeom>
-          <a:solidFill>
-            <a:srgbClr val="1F5FBF"/>
-          </a:solidFill>
-          <a:ln>
-            <a:noFill/>
-          </a:ln>
-          <a:effectLst/>
-        </p:spPr>
-        <p:style>
-          <a:lnRef idx="1">
-            <a:schemeClr val="accent1"/>
-          </a:lnRef>
-          <a:fillRef idx="3">
-            <a:schemeClr val="accent1"/>
-          </a:fillRef>
-          <a:effectRef idx="2">
-            <a:schemeClr val="accent1"/>
-          </a:effectRef>
-          <a:fontRef idx="minor">
-            <a:schemeClr val="lt1"/>
-          </a:fontRef>
-        </p:style>
-        <p:txBody>
-          <a:bodyPr rtlCol="0" anchor="ctr" wrap="square" lIns="45720" rIns="45720" tIns="9144" bIns="9144"/>
-          <a:lstStyle/>
-          <a:p>
-            <a:pPr algn="ctr">
-              <a:lnSpc>
-                <a:spcPct val="90000"/>
-              </a:lnSpc>
-            </a:pPr>
-            <a:r>
-              <a:rPr sz="1050" b="1" i="0">
-                <a:solidFill>
-                  <a:srgbClr val="FFFFFF"/>
-                </a:solidFill>
-                <a:latin typeface="Calibri"/>
-              </a:rPr>
-              <a:t>Group similar lines (Drain3)</a:t>
-            </a:r>
-          </a:p>
-          <a:p>
-            <a:pPr algn="ctr">
-              <a:lnSpc>
-                <a:spcPct val="90000"/>
-              </a:lnSpc>
-            </a:pPr>
-            <a:r>
-              <a:rPr sz="950" b="0" i="0">
-                <a:solidFill>
-                  <a:srgbClr val="FFFFFF"/>
-                </a:solidFill>
-                <a:latin typeface="Calibri"/>
-              </a:rPr>
-              <a:t>turns lines into patterns</a:t>
-            </a:r>
-          </a:p>
-        </p:txBody>
-      </p:sp>
-      <p:sp>
-        <p:nvSpPr>
-          <p:cNvPr id="24" name="Diamond 23"/>
-          <p:cNvSpPr/>
-          <p:nvPr/>
-        </p:nvSpPr>
-        <p:spPr>
-          <a:xfrm>
-            <a:off x="5852159" y="3127248"/>
-            <a:ext cx="2514600" cy="822960"/>
-          </a:xfrm>
-          <a:prstGeom prst="diamond">
-            <a:avLst/>
-          </a:prstGeom>
-          <a:solidFill>
-            <a:srgbClr val="FFF4E0"/>
-          </a:solidFill>
-          <a:ln w="19050">
-            <a:solidFill>
-              <a:srgbClr val="F58220"/>
-            </a:solidFill>
-          </a:ln>
-          <a:effectLst/>
-        </p:spPr>
-        <p:style>
-          <a:lnRef idx="1">
-            <a:schemeClr val="accent1"/>
-          </a:lnRef>
-          <a:fillRef idx="3">
-            <a:schemeClr val="accent1"/>
-          </a:fillRef>
-          <a:effectRef idx="2">
-            <a:schemeClr val="accent1"/>
-          </a:effectRef>
-          <a:fontRef idx="minor">
-            <a:schemeClr val="lt1"/>
-          </a:fontRef>
-        </p:style>
-        <p:txBody>
-          <a:bodyPr rtlCol="0" anchor="ctr" wrap="square" lIns="45720" rIns="45720" tIns="9144" bIns="9144"/>
-          <a:lstStyle/>
-          <a:p>
-            <a:pPr algn="ctr">
-              <a:lnSpc>
-                <a:spcPct val="90000"/>
-              </a:lnSpc>
-            </a:pPr>
-            <a:r>
-              <a:rPr sz="1000" b="1" i="0">
-                <a:solidFill>
-                  <a:srgbClr val="1E2530"/>
-                </a:solidFill>
-                <a:latin typeface="Calibri"/>
-              </a:rPr>
-              <a:t>Does this pattern already</a:t>
-            </a:r>
-          </a:p>
-          <a:p>
-            <a:pPr algn="ctr">
-              <a:lnSpc>
-                <a:spcPct val="90000"/>
-              </a:lnSpc>
-            </a:pPr>
-            <a:r>
-              <a:rPr sz="1000" b="0" i="0">
-                <a:solidFill>
-                  <a:srgbClr val="1E2530"/>
-                </a:solidFill>
-                <a:latin typeface="Calibri"/>
-              </a:rPr>
-              <a:t>have a saved rule?</a:t>
-            </a:r>
-          </a:p>
-        </p:txBody>
-      </p:sp>
-      <p:sp>
-        <p:nvSpPr>
-          <p:cNvPr id="25" name="Rounded Rectangle 24"/>
-          <p:cNvSpPr/>
-          <p:nvPr/>
-        </p:nvSpPr>
-        <p:spPr>
-          <a:xfrm>
-            <a:off x="9006840" y="3310128"/>
-            <a:ext cx="2423160" cy="457200"/>
-          </a:xfrm>
-          <a:prstGeom prst="roundRect">
-            <a:avLst>
-              <a:gd name="adj" fmla="val 18000"/>
-            </a:avLst>
-          </a:prstGeom>
-          <a:solidFill>
-            <a:srgbClr val="6A3FB5"/>
-          </a:solidFill>
-          <a:ln>
-            <a:noFill/>
-          </a:ln>
-          <a:effectLst/>
-        </p:spPr>
-        <p:style>
-          <a:lnRef idx="1">
-            <a:schemeClr val="accent1"/>
-          </a:lnRef>
-          <a:fillRef idx="3">
-            <a:schemeClr val="accent1"/>
-          </a:fillRef>
-          <a:effectRef idx="2">
-            <a:schemeClr val="accent1"/>
-          </a:effectRef>
-          <a:fontRef idx="minor">
-            <a:schemeClr val="lt1"/>
-          </a:fontRef>
-        </p:style>
-        <p:txBody>
-          <a:bodyPr rtlCol="0" anchor="ctr" wrap="square" lIns="45720" rIns="45720" tIns="9144" bIns="9144"/>
-          <a:lstStyle/>
-          <a:p>
-            <a:pPr algn="ctr">
-              <a:lnSpc>
-                <a:spcPct val="90000"/>
-              </a:lnSpc>
-            </a:pPr>
-            <a:r>
-              <a:rPr sz="1050" b="1" i="0">
-                <a:solidFill>
-                  <a:srgbClr val="FFFFFF"/>
-                </a:solidFill>
-                <a:latin typeface="Calibri"/>
-              </a:rPr>
-              <a:t>ML check (scikit-learn)</a:t>
-            </a:r>
-          </a:p>
-          <a:p>
-            <a:pPr algn="ctr">
-              <a:lnSpc>
-                <a:spcPct val="90000"/>
-              </a:lnSpc>
-            </a:pPr>
-            <a:r>
-              <a:rPr sz="950" b="0" i="0">
-                <a:solidFill>
-                  <a:srgbClr val="FFFFFF"/>
-                </a:solidFill>
-                <a:latin typeface="Calibri"/>
-              </a:rPr>
-              <a:t>known or brand-new format?</a:t>
-            </a:r>
-          </a:p>
-        </p:txBody>
-      </p:sp>
-      <p:sp>
-        <p:nvSpPr>
-          <p:cNvPr id="26" name="Rounded Rectangle 25"/>
-          <p:cNvSpPr/>
-          <p:nvPr/>
-        </p:nvSpPr>
-        <p:spPr>
-          <a:xfrm>
-            <a:off x="8732520" y="4160520"/>
-            <a:ext cx="1417320" cy="566928"/>
-          </a:xfrm>
-          <a:prstGeom prst="roundRect">
-            <a:avLst>
-              <a:gd name="adj" fmla="val 18000"/>
-            </a:avLst>
-          </a:prstGeom>
-          <a:solidFill>
-            <a:srgbClr val="F58220"/>
-          </a:solidFill>
-          <a:ln>
-            <a:noFill/>
-          </a:ln>
-          <a:effectLst/>
-        </p:spPr>
-        <p:style>
-          <a:lnRef idx="1">
-            <a:schemeClr val="accent1"/>
-          </a:lnRef>
-          <a:fillRef idx="3">
-            <a:schemeClr val="accent1"/>
-          </a:fillRef>
-          <a:effectRef idx="2">
-            <a:schemeClr val="accent1"/>
-          </a:effectRef>
-          <a:fontRef idx="minor">
-            <a:schemeClr val="lt1"/>
-          </a:fontRef>
-        </p:style>
-        <p:txBody>
-          <a:bodyPr rtlCol="0" anchor="ctr" wrap="square" lIns="45720" rIns="45720" tIns="9144" bIns="9144"/>
-          <a:lstStyle/>
-          <a:p>
-            <a:pPr algn="ctr">
-              <a:lnSpc>
-                <a:spcPct val="90000"/>
-              </a:lnSpc>
-            </a:pPr>
-            <a:r>
-              <a:rPr sz="1000" b="1" i="0">
-                <a:solidFill>
-                  <a:srgbClr val="FFFFFF"/>
-                </a:solidFill>
-                <a:latin typeface="Calibri"/>
-              </a:rPr>
-              <a:t>AI learns</a:t>
-            </a:r>
-          </a:p>
-          <a:p>
-            <a:pPr algn="ctr">
-              <a:lnSpc>
-                <a:spcPct val="90000"/>
-              </a:lnSpc>
-            </a:pPr>
-            <a:r>
-              <a:rPr sz="1000" b="0" i="0">
-                <a:solidFill>
-                  <a:srgbClr val="FFFFFF"/>
-                </a:solidFill>
-                <a:latin typeface="Calibri"/>
-              </a:rPr>
-              <a:t>the format</a:t>
-            </a:r>
-          </a:p>
-          <a:p>
-            <a:pPr algn="ctr">
-              <a:lnSpc>
-                <a:spcPct val="90000"/>
-              </a:lnSpc>
-            </a:pPr>
-            <a:r>
-              <a:rPr sz="850" b="0" i="0">
-                <a:solidFill>
-                  <a:srgbClr val="FFFFFF"/>
-                </a:solidFill>
-                <a:latin typeface="Calibri"/>
-              </a:rPr>
-              <a:t>once per pattern</a:t>
-            </a:r>
-          </a:p>
-        </p:txBody>
-      </p:sp>
-      <p:sp>
-        <p:nvSpPr>
-          <p:cNvPr id="27" name="Rounded Rectangle 26"/>
-          <p:cNvSpPr/>
-          <p:nvPr/>
-        </p:nvSpPr>
-        <p:spPr>
-          <a:xfrm>
-            <a:off x="10287000" y="4160520"/>
-            <a:ext cx="1417320" cy="566928"/>
-          </a:xfrm>
-          <a:prstGeom prst="roundRect">
-            <a:avLst>
-              <a:gd name="adj" fmla="val 18000"/>
-            </a:avLst>
-          </a:prstGeom>
-          <a:solidFill>
-            <a:srgbClr val="C0392B"/>
-          </a:solidFill>
-          <a:ln>
-            <a:noFill/>
-          </a:ln>
-          <a:effectLst/>
-        </p:spPr>
-        <p:style>
-          <a:lnRef idx="1">
-            <a:schemeClr val="accent1"/>
-          </a:lnRef>
-          <a:fillRef idx="3">
-            <a:schemeClr val="accent1"/>
-          </a:fillRef>
-          <a:effectRef idx="2">
-            <a:schemeClr val="accent1"/>
-          </a:effectRef>
-          <a:fontRef idx="minor">
-            <a:schemeClr val="lt1"/>
-          </a:fontRef>
-        </p:style>
-        <p:txBody>
-          <a:bodyPr rtlCol="0" anchor="ctr" wrap="square" lIns="45720" rIns="45720" tIns="9144" bIns="9144"/>
-          <a:lstStyle/>
-          <a:p>
-            <a:pPr algn="ctr">
-              <a:lnSpc>
-                <a:spcPct val="90000"/>
-              </a:lnSpc>
-            </a:pPr>
-            <a:r>
-              <a:rPr sz="1000" b="1" i="0">
-                <a:solidFill>
-                  <a:srgbClr val="FFFFFF"/>
-                </a:solidFill>
-                <a:latin typeface="Calibri"/>
-              </a:rPr>
-              <a:t>Hold for</a:t>
-            </a:r>
-          </a:p>
-          <a:p>
-            <a:pPr algn="ctr">
-              <a:lnSpc>
-                <a:spcPct val="90000"/>
-              </a:lnSpc>
-            </a:pPr>
-            <a:r>
-              <a:rPr sz="1000" b="0" i="0">
-                <a:solidFill>
-                  <a:srgbClr val="FFFFFF"/>
-                </a:solidFill>
-                <a:latin typeface="Calibri"/>
-              </a:rPr>
-              <a:t>review</a:t>
-            </a:r>
-          </a:p>
-          <a:p>
-            <a:pPr algn="ctr">
-              <a:lnSpc>
-                <a:spcPct val="90000"/>
-              </a:lnSpc>
-            </a:pPr>
-            <a:r>
-              <a:rPr sz="850" b="0" i="0">
-                <a:solidFill>
-                  <a:srgbClr val="FFFFFF"/>
-                </a:solidFill>
-                <a:latin typeface="Calibri"/>
-              </a:rPr>
-              <a:t>learned once it repeats</a:t>
-            </a:r>
-          </a:p>
-        </p:txBody>
-      </p:sp>
-      <p:sp>
-        <p:nvSpPr>
-          <p:cNvPr id="28" name="Rounded Rectangle 27"/>
-          <p:cNvSpPr/>
-          <p:nvPr/>
-        </p:nvSpPr>
-        <p:spPr>
-          <a:xfrm>
-            <a:off x="9006840" y="5120640"/>
-            <a:ext cx="2423160" cy="457200"/>
-          </a:xfrm>
-          <a:prstGeom prst="roundRect">
-            <a:avLst>
-              <a:gd name="adj" fmla="val 18000"/>
-            </a:avLst>
-          </a:prstGeom>
-          <a:solidFill>
-            <a:srgbClr val="0E8C8C"/>
-          </a:solidFill>
-          <a:ln>
-            <a:noFill/>
-          </a:ln>
-          <a:effectLst/>
-        </p:spPr>
-        <p:style>
-          <a:lnRef idx="1">
-            <a:schemeClr val="accent1"/>
-          </a:lnRef>
-          <a:fillRef idx="3">
-            <a:schemeClr val="accent1"/>
-          </a:fillRef>
-          <a:effectRef idx="2">
-            <a:schemeClr val="accent1"/>
-          </a:effectRef>
-          <a:fontRef idx="minor">
-            <a:schemeClr val="lt1"/>
-          </a:fontRef>
-        </p:style>
-        <p:txBody>
-          <a:bodyPr rtlCol="0" anchor="ctr" wrap="square" lIns="45720" rIns="45720" tIns="9144" bIns="9144"/>
-          <a:lstStyle/>
-          <a:p>
-            <a:pPr algn="ctr">
-              <a:lnSpc>
-                <a:spcPct val="90000"/>
-              </a:lnSpc>
-            </a:pPr>
-            <a:r>
-              <a:rPr sz="1050" b="1" i="0">
-                <a:solidFill>
-                  <a:srgbClr val="FFFFFF"/>
-                </a:solidFill>
-                <a:latin typeface="Calibri"/>
-              </a:rPr>
-              <a:t>Save the rule</a:t>
-            </a:r>
-          </a:p>
-          <a:p>
-            <a:pPr algn="ctr">
-              <a:lnSpc>
-                <a:spcPct val="90000"/>
-              </a:lnSpc>
-            </a:pPr>
-            <a:r>
-              <a:rPr sz="950" b="0" i="0">
-                <a:solidFill>
-                  <a:srgbClr val="FFFFFF"/>
-                </a:solidFill>
-                <a:latin typeface="Calibri"/>
-              </a:rPr>
-              <a:t>reused for next time</a:t>
-            </a:r>
-          </a:p>
-        </p:txBody>
-      </p:sp>
-      <p:sp>
-        <p:nvSpPr>
-          <p:cNvPr id="29" name="Rounded Rectangle 28"/>
-          <p:cNvSpPr/>
-          <p:nvPr/>
-        </p:nvSpPr>
-        <p:spPr>
-          <a:xfrm>
-            <a:off x="5760720" y="5120640"/>
-            <a:ext cx="2697480" cy="457200"/>
-          </a:xfrm>
-          <a:prstGeom prst="roundRect">
-            <a:avLst>
-              <a:gd name="adj" fmla="val 18000"/>
-            </a:avLst>
-          </a:prstGeom>
-          <a:solidFill>
-            <a:srgbClr val="138A36"/>
-          </a:solidFill>
-          <a:ln>
-            <a:noFill/>
-          </a:ln>
-          <a:effectLst/>
-        </p:spPr>
-        <p:style>
-          <a:lnRef idx="1">
-            <a:schemeClr val="accent1"/>
-          </a:lnRef>
-          <a:fillRef idx="3">
-            <a:schemeClr val="accent1"/>
-          </a:fillRef>
-          <a:effectRef idx="2">
-            <a:schemeClr val="accent1"/>
-          </a:effectRef>
-          <a:fontRef idx="minor">
-            <a:schemeClr val="lt1"/>
-          </a:fontRef>
-        </p:style>
-        <p:txBody>
-          <a:bodyPr rtlCol="0" anchor="ctr" wrap="square" lIns="45720" rIns="45720" tIns="9144" bIns="9144"/>
-          <a:lstStyle/>
-          <a:p>
-            <a:pPr algn="ctr">
-              <a:lnSpc>
-                <a:spcPct val="90000"/>
-              </a:lnSpc>
-            </a:pPr>
-            <a:r>
-              <a:rPr sz="1050" b="1" i="0">
-                <a:solidFill>
-                  <a:srgbClr val="FFFFFF"/>
-                </a:solidFill>
-                <a:latin typeface="Calibri"/>
-              </a:rPr>
-              <a:t>Apply saved rule</a:t>
-            </a:r>
-          </a:p>
-          <a:p>
-            <a:pPr algn="ctr">
-              <a:lnSpc>
-                <a:spcPct val="90000"/>
-              </a:lnSpc>
-            </a:pPr>
-            <a:r>
-              <a:rPr sz="950" b="0" i="0">
-                <a:solidFill>
-                  <a:srgbClr val="FFFFFF"/>
-                </a:solidFill>
-                <a:latin typeface="Calibri"/>
-              </a:rPr>
-              <a:t>no AI needed</a:t>
-            </a:r>
-          </a:p>
-        </p:txBody>
-      </p:sp>
-      <p:sp>
-        <p:nvSpPr>
-          <p:cNvPr id="30" name="Rounded Rectangle 29"/>
-          <p:cNvSpPr/>
-          <p:nvPr/>
-        </p:nvSpPr>
-        <p:spPr>
-          <a:xfrm>
-            <a:off x="5760720" y="5779008"/>
-            <a:ext cx="2697480" cy="457200"/>
-          </a:xfrm>
-          <a:prstGeom prst="roundRect">
-            <a:avLst>
-              <a:gd name="adj" fmla="val 18000"/>
-            </a:avLst>
-          </a:prstGeom>
-          <a:solidFill>
-            <a:srgbClr val="0B2A5B"/>
-          </a:solidFill>
-          <a:ln>
-            <a:noFill/>
-          </a:ln>
-          <a:effectLst/>
-        </p:spPr>
-        <p:style>
-          <a:lnRef idx="1">
-            <a:schemeClr val="accent1"/>
-          </a:lnRef>
-          <a:fillRef idx="3">
-            <a:schemeClr val="accent1"/>
-          </a:fillRef>
-          <a:effectRef idx="2">
-            <a:schemeClr val="accent1"/>
-          </a:effectRef>
-          <a:fontRef idx="minor">
-            <a:schemeClr val="lt1"/>
-          </a:fontRef>
-        </p:style>
-        <p:txBody>
-          <a:bodyPr rtlCol="0" anchor="ctr" wrap="square" lIns="45720" rIns="45720" tIns="9144" bIns="9144"/>
-          <a:lstStyle/>
-          <a:p>
-            <a:pPr algn="ctr">
-              <a:lnSpc>
-                <a:spcPct val="90000"/>
-              </a:lnSpc>
-            </a:pPr>
-            <a:r>
-              <a:rPr sz="1050" b="1" i="0">
-                <a:solidFill>
-                  <a:srgbClr val="FFFFFF"/>
-                </a:solidFill>
-                <a:latin typeface="Calibri"/>
-              </a:rPr>
-              <a:t>Clean, common output (JSON)</a:t>
-            </a:r>
-          </a:p>
-        </p:txBody>
-      </p:sp>
-      <p:cxnSp>
-        <p:nvCxnSpPr>
-          <p:cNvPr id="31" name="Connector 30"/>
-          <p:cNvCxnSpPr/>
-          <p:nvPr/>
-        </p:nvCxnSpPr>
-        <p:spPr>
-          <a:xfrm>
-            <a:off x="7109460" y="1691640"/>
-            <a:ext cx="0" cy="182879"/>
-          </a:xfrm>
-          <a:prstGeom prst="line">
-            <a:avLst/>
-          </a:prstGeom>
-          <a:ln w="19050">
-            <a:solidFill>
-              <a:srgbClr val="5B6778"/>
-            </a:solidFill>
-            <a:tailEnd type="triangle" w="med" len="med"/>
-          </a:ln>
-        </p:spPr>
-        <p:style>
-          <a:lnRef idx="2">
-            <a:schemeClr val="accent1"/>
-          </a:lnRef>
-          <a:fillRef idx="0">
-            <a:schemeClr val="accent1"/>
-          </a:fillRef>
-          <a:effectRef idx="1">
-            <a:schemeClr val="accent1"/>
-          </a:effectRef>
-          <a:fontRef idx="minor">
-            <a:schemeClr val="tx1"/>
-          </a:fontRef>
-        </p:style>
-      </p:cxnSp>
-      <p:cxnSp>
-        <p:nvCxnSpPr>
-          <p:cNvPr id="32" name="Connector 31"/>
-          <p:cNvCxnSpPr/>
-          <p:nvPr/>
-        </p:nvCxnSpPr>
-        <p:spPr>
-          <a:xfrm>
-            <a:off x="7109460" y="2331720"/>
-            <a:ext cx="0" cy="182880"/>
-          </a:xfrm>
-          <a:prstGeom prst="line">
-            <a:avLst/>
-          </a:prstGeom>
-          <a:ln w="19050">
-            <a:solidFill>
-              <a:srgbClr val="5B6778"/>
-            </a:solidFill>
-            <a:tailEnd type="triangle" w="med" len="med"/>
-          </a:ln>
-        </p:spPr>
-        <p:style>
-          <a:lnRef idx="2">
-            <a:schemeClr val="accent1"/>
-          </a:lnRef>
-          <a:fillRef idx="0">
-            <a:schemeClr val="accent1"/>
-          </a:fillRef>
-          <a:effectRef idx="1">
-            <a:schemeClr val="accent1"/>
-          </a:effectRef>
-          <a:fontRef idx="minor">
-            <a:schemeClr val="tx1"/>
-          </a:fontRef>
-        </p:style>
-      </p:cxnSp>
-      <p:sp>
-        <p:nvSpPr>
-          <p:cNvPr id="33" name="TextBox 32"/>
-          <p:cNvSpPr txBox="1"/>
-          <p:nvPr/>
-        </p:nvSpPr>
-        <p:spPr>
-          <a:xfrm>
-            <a:off x="7155180" y="2286000"/>
-            <a:ext cx="548640" cy="228600"/>
-          </a:xfrm>
-          <a:prstGeom prst="rect">
-            <a:avLst/>
-          </a:prstGeom>
-          <a:noFill/>
-        </p:spPr>
-        <p:txBody>
-          <a:bodyPr wrap="square" anchor="t" lIns="36576" rIns="36576" tIns="18288" bIns="18288">
-            <a:spAutoFit/>
-          </a:bodyPr>
-          <a:lstStyle/>
-          <a:p>
-            <a:pPr algn="l">
-              <a:lnSpc>
-                <a:spcPct val="100000"/>
-              </a:lnSpc>
-              <a:spcAft>
-                <a:spcPts val="0"/>
-              </a:spcAft>
-            </a:pPr>
-            <a:r>
-              <a:rPr sz="900" b="1" i="0">
-                <a:solidFill>
-                  <a:srgbClr val="5B6778"/>
-                </a:solidFill>
-                <a:latin typeface="Calibri"/>
-              </a:rPr>
-              <a:t>new</a:t>
-            </a:r>
-          </a:p>
-        </p:txBody>
-      </p:sp>
-      <p:cxnSp>
-        <p:nvCxnSpPr>
-          <p:cNvPr id="34" name="Connector 33"/>
-          <p:cNvCxnSpPr/>
-          <p:nvPr/>
-        </p:nvCxnSpPr>
-        <p:spPr>
-          <a:xfrm>
-            <a:off x="7109460" y="2971800"/>
-            <a:ext cx="0" cy="155448"/>
-          </a:xfrm>
-          <a:prstGeom prst="line">
-            <a:avLst/>
-          </a:prstGeom>
-          <a:ln w="19050">
-            <a:solidFill>
-              <a:srgbClr val="5B6778"/>
-            </a:solidFill>
-            <a:tailEnd type="triangle" w="med" len="med"/>
-          </a:ln>
-        </p:spPr>
-        <p:style>
-          <a:lnRef idx="2">
-            <a:schemeClr val="accent1"/>
-          </a:lnRef>
-          <a:fillRef idx="0">
-            <a:schemeClr val="accent1"/>
-          </a:fillRef>
-          <a:effectRef idx="1">
-            <a:schemeClr val="accent1"/>
-          </a:effectRef>
-          <a:fontRef idx="minor">
-            <a:schemeClr val="tx1"/>
-          </a:fontRef>
-        </p:style>
-      </p:cxnSp>
-      <p:cxnSp>
-        <p:nvCxnSpPr>
-          <p:cNvPr id="35" name="Connector 34"/>
-          <p:cNvCxnSpPr/>
-          <p:nvPr/>
-        </p:nvCxnSpPr>
-        <p:spPr>
-          <a:xfrm>
-            <a:off x="7109460" y="3950208"/>
-            <a:ext cx="0" cy="1170432"/>
-          </a:xfrm>
-          <a:prstGeom prst="line">
-            <a:avLst/>
-          </a:prstGeom>
-          <a:ln w="25400">
-            <a:solidFill>
-              <a:srgbClr val="138A36"/>
-            </a:solidFill>
-            <a:tailEnd type="triangle" w="med" len="med"/>
-          </a:ln>
-        </p:spPr>
-        <p:style>
-          <a:lnRef idx="2">
-            <a:schemeClr val="accent1"/>
-          </a:lnRef>
-          <a:fillRef idx="0">
-            <a:schemeClr val="accent1"/>
-          </a:fillRef>
-          <a:effectRef idx="1">
-            <a:schemeClr val="accent1"/>
-          </a:effectRef>
-          <a:fontRef idx="minor">
-            <a:schemeClr val="tx1"/>
-          </a:fontRef>
-        </p:style>
-      </p:cxnSp>
-      <p:sp>
-        <p:nvSpPr>
-          <p:cNvPr id="36" name="TextBox 35"/>
-          <p:cNvSpPr txBox="1"/>
-          <p:nvPr/>
-        </p:nvSpPr>
-        <p:spPr>
-          <a:xfrm>
-            <a:off x="7182612" y="4389120"/>
-            <a:ext cx="457200" cy="228600"/>
-          </a:xfrm>
-          <a:prstGeom prst="rect">
-            <a:avLst/>
-          </a:prstGeom>
-          <a:noFill/>
-        </p:spPr>
-        <p:txBody>
-          <a:bodyPr wrap="square" anchor="t" lIns="36576" rIns="36576" tIns="18288" bIns="18288">
-            <a:spAutoFit/>
-          </a:bodyPr>
-          <a:lstStyle/>
-          <a:p>
-            <a:pPr algn="l">
-              <a:lnSpc>
-                <a:spcPct val="100000"/>
-              </a:lnSpc>
-              <a:spcAft>
-                <a:spcPts val="0"/>
-              </a:spcAft>
-            </a:pPr>
-            <a:r>
-              <a:rPr sz="1000" b="1" i="0">
-                <a:solidFill>
-                  <a:srgbClr val="138A36"/>
-                </a:solidFill>
-                <a:latin typeface="Calibri"/>
-              </a:rPr>
-              <a:t>Yes</a:t>
-            </a:r>
-          </a:p>
-        </p:txBody>
-      </p:sp>
-      <p:cxnSp>
-        <p:nvCxnSpPr>
-          <p:cNvPr id="37" name="Connector 36"/>
-          <p:cNvCxnSpPr/>
-          <p:nvPr/>
-        </p:nvCxnSpPr>
-        <p:spPr>
-          <a:xfrm>
-            <a:off x="8366760" y="3538728"/>
-            <a:ext cx="640080" cy="0"/>
-          </a:xfrm>
-          <a:prstGeom prst="line">
-            <a:avLst/>
-          </a:prstGeom>
-          <a:ln w="25400">
-            <a:solidFill>
-              <a:srgbClr val="F58220"/>
-            </a:solidFill>
-            <a:tailEnd type="triangle" w="med" len="med"/>
-          </a:ln>
-        </p:spPr>
-        <p:style>
-          <a:lnRef idx="2">
-            <a:schemeClr val="accent1"/>
-          </a:lnRef>
-          <a:fillRef idx="0">
-            <a:schemeClr val="accent1"/>
-          </a:fillRef>
-          <a:effectRef idx="1">
-            <a:schemeClr val="accent1"/>
-          </a:effectRef>
-          <a:fontRef idx="minor">
-            <a:schemeClr val="tx1"/>
-          </a:fontRef>
-        </p:style>
-      </p:cxnSp>
-      <p:sp>
-        <p:nvSpPr>
-          <p:cNvPr id="38" name="TextBox 37"/>
-          <p:cNvSpPr txBox="1"/>
-          <p:nvPr/>
-        </p:nvSpPr>
-        <p:spPr>
-          <a:xfrm>
-            <a:off x="8412480" y="3291840"/>
-            <a:ext cx="457200" cy="228600"/>
-          </a:xfrm>
-          <a:prstGeom prst="rect">
-            <a:avLst/>
-          </a:prstGeom>
-          <a:noFill/>
-        </p:spPr>
-        <p:txBody>
-          <a:bodyPr wrap="square" anchor="t" lIns="36576" rIns="36576" tIns="18288" bIns="18288">
-            <a:spAutoFit/>
-          </a:bodyPr>
-          <a:lstStyle/>
-          <a:p>
-            <a:pPr algn="l">
-              <a:lnSpc>
-                <a:spcPct val="100000"/>
-              </a:lnSpc>
-              <a:spcAft>
-                <a:spcPts val="0"/>
-              </a:spcAft>
-            </a:pPr>
-            <a:r>
-              <a:rPr sz="1000" b="1" i="0">
-                <a:solidFill>
-                  <a:srgbClr val="F58220"/>
-                </a:solidFill>
-                <a:latin typeface="Calibri"/>
-              </a:rPr>
-              <a:t>No</a:t>
-            </a:r>
-          </a:p>
-        </p:txBody>
-      </p:sp>
-      <p:cxnSp>
-        <p:nvCxnSpPr>
-          <p:cNvPr id="39" name="Connector 38"/>
-          <p:cNvCxnSpPr/>
-          <p:nvPr/>
-        </p:nvCxnSpPr>
-        <p:spPr>
-          <a:xfrm flipH="1">
-            <a:off x="9445752" y="3767328"/>
-            <a:ext cx="406908" cy="393192"/>
-          </a:xfrm>
-          <a:prstGeom prst="line">
-            <a:avLst/>
-          </a:prstGeom>
-          <a:ln w="19050">
-            <a:solidFill>
-              <a:srgbClr val="5B6778"/>
-            </a:solidFill>
-            <a:tailEnd type="triangle" w="med" len="med"/>
-          </a:ln>
-        </p:spPr>
-        <p:style>
-          <a:lnRef idx="2">
-            <a:schemeClr val="accent1"/>
-          </a:lnRef>
-          <a:fillRef idx="0">
-            <a:schemeClr val="accent1"/>
-          </a:fillRef>
-          <a:effectRef idx="1">
-            <a:schemeClr val="accent1"/>
-          </a:effectRef>
-          <a:fontRef idx="minor">
-            <a:schemeClr val="tx1"/>
-          </a:fontRef>
-        </p:style>
-      </p:cxnSp>
-      <p:cxnSp>
-        <p:nvCxnSpPr>
-          <p:cNvPr id="40" name="Connector 39"/>
-          <p:cNvCxnSpPr/>
-          <p:nvPr/>
-        </p:nvCxnSpPr>
-        <p:spPr>
-          <a:xfrm>
-            <a:off x="10584180" y="3767328"/>
-            <a:ext cx="416052" cy="393192"/>
-          </a:xfrm>
-          <a:prstGeom prst="line">
-            <a:avLst/>
-          </a:prstGeom>
-          <a:ln w="19050">
-            <a:solidFill>
-              <a:srgbClr val="5B6778"/>
-            </a:solidFill>
-            <a:tailEnd type="triangle" w="med" len="med"/>
-          </a:ln>
-        </p:spPr>
-        <p:style>
-          <a:lnRef idx="2">
-            <a:schemeClr val="accent1"/>
-          </a:lnRef>
-          <a:fillRef idx="0">
-            <a:schemeClr val="accent1"/>
-          </a:fillRef>
-          <a:effectRef idx="1">
-            <a:schemeClr val="accent1"/>
-          </a:effectRef>
-          <a:fontRef idx="minor">
-            <a:schemeClr val="tx1"/>
-          </a:fontRef>
-        </p:style>
-      </p:cxnSp>
-      <p:sp>
-        <p:nvSpPr>
-          <p:cNvPr id="41" name="TextBox 40"/>
-          <p:cNvSpPr txBox="1"/>
-          <p:nvPr/>
-        </p:nvSpPr>
-        <p:spPr>
-          <a:xfrm>
-            <a:off x="8412480" y="3840480"/>
-            <a:ext cx="1463040" cy="228600"/>
-          </a:xfrm>
-          <a:prstGeom prst="rect">
-            <a:avLst/>
-          </a:prstGeom>
-          <a:noFill/>
-        </p:spPr>
-        <p:txBody>
-          <a:bodyPr wrap="square" anchor="t" lIns="36576" rIns="36576" tIns="18288" bIns="18288">
-            <a:spAutoFit/>
-          </a:bodyPr>
-          <a:lstStyle/>
-          <a:p>
-            <a:pPr algn="l">
-              <a:lnSpc>
-                <a:spcPct val="100000"/>
-              </a:lnSpc>
-              <a:spcAft>
-                <a:spcPts val="0"/>
-              </a:spcAft>
-            </a:pPr>
-            <a:r>
-              <a:rPr sz="850" b="0" i="0">
-                <a:solidFill>
-                  <a:srgbClr val="5B6778"/>
-                </a:solidFill>
-                <a:latin typeface="Calibri"/>
-              </a:rPr>
-              <a:t>known</a:t>
-            </a:r>
-          </a:p>
-        </p:txBody>
-      </p:sp>
-      <p:sp>
-        <p:nvSpPr>
-          <p:cNvPr id="42" name="TextBox 41"/>
-          <p:cNvSpPr txBox="1"/>
-          <p:nvPr/>
-        </p:nvSpPr>
-        <p:spPr>
-          <a:xfrm>
-            <a:off x="10607040" y="3840480"/>
-            <a:ext cx="1234440" cy="228600"/>
-          </a:xfrm>
-          <a:prstGeom prst="rect">
-            <a:avLst/>
-          </a:prstGeom>
-          <a:noFill/>
-        </p:spPr>
-        <p:txBody>
-          <a:bodyPr wrap="square" anchor="t" lIns="36576" rIns="36576" tIns="18288" bIns="18288">
-            <a:spAutoFit/>
-          </a:bodyPr>
-          <a:lstStyle/>
-          <a:p>
-            <a:pPr algn="r">
-              <a:lnSpc>
-                <a:spcPct val="100000"/>
-              </a:lnSpc>
-              <a:spcAft>
-                <a:spcPts val="0"/>
-              </a:spcAft>
-            </a:pPr>
-            <a:r>
-              <a:rPr sz="850" b="0" i="0">
-                <a:solidFill>
-                  <a:srgbClr val="5B6778"/>
-                </a:solidFill>
-                <a:latin typeface="Calibri"/>
-              </a:rPr>
-              <a:t>brand-new</a:t>
-            </a:r>
-          </a:p>
-        </p:txBody>
-      </p:sp>
-      <p:cxnSp>
-        <p:nvCxnSpPr>
-          <p:cNvPr id="43" name="Connector 42"/>
-          <p:cNvCxnSpPr/>
-          <p:nvPr/>
-        </p:nvCxnSpPr>
-        <p:spPr>
-          <a:xfrm>
-            <a:off x="9445752" y="4727448"/>
-            <a:ext cx="406908" cy="393192"/>
-          </a:xfrm>
-          <a:prstGeom prst="line">
-            <a:avLst/>
-          </a:prstGeom>
-          <a:ln w="19050">
-            <a:solidFill>
-              <a:srgbClr val="5B6778"/>
-            </a:solidFill>
-            <a:tailEnd type="triangle" w="med" len="med"/>
-          </a:ln>
-        </p:spPr>
-        <p:style>
-          <a:lnRef idx="2">
-            <a:schemeClr val="accent1"/>
-          </a:lnRef>
-          <a:fillRef idx="0">
-            <a:schemeClr val="accent1"/>
-          </a:fillRef>
-          <a:effectRef idx="1">
-            <a:schemeClr val="accent1"/>
-          </a:effectRef>
-          <a:fontRef idx="minor">
-            <a:schemeClr val="tx1"/>
-          </a:fontRef>
-        </p:style>
-      </p:cxnSp>
-      <p:cxnSp>
-        <p:nvCxnSpPr>
-          <p:cNvPr id="44" name="Connector 43"/>
-          <p:cNvCxnSpPr/>
-          <p:nvPr/>
-        </p:nvCxnSpPr>
-        <p:spPr>
-          <a:xfrm flipH="1">
-            <a:off x="10584180" y="4727448"/>
-            <a:ext cx="416052" cy="393192"/>
-          </a:xfrm>
-          <a:prstGeom prst="line">
-            <a:avLst/>
-          </a:prstGeom>
-          <a:ln w="19050">
-            <a:solidFill>
-              <a:srgbClr val="5B6778"/>
-            </a:solidFill>
-            <a:tailEnd type="triangle" w="med" len="med"/>
-          </a:ln>
-        </p:spPr>
-        <p:style>
-          <a:lnRef idx="2">
-            <a:schemeClr val="accent1"/>
-          </a:lnRef>
-          <a:fillRef idx="0">
-            <a:schemeClr val="accent1"/>
-          </a:fillRef>
-          <a:effectRef idx="1">
-            <a:schemeClr val="accent1"/>
-          </a:effectRef>
-          <a:fontRef idx="minor">
-            <a:schemeClr val="tx1"/>
-          </a:fontRef>
-        </p:style>
-      </p:cxnSp>
-      <p:cxnSp>
-        <p:nvCxnSpPr>
-          <p:cNvPr id="45" name="Connector 44"/>
-          <p:cNvCxnSpPr/>
-          <p:nvPr/>
-        </p:nvCxnSpPr>
-        <p:spPr>
-          <a:xfrm flipH="1">
-            <a:off x="8458200" y="5349240"/>
-            <a:ext cx="548640" cy="0"/>
-          </a:xfrm>
-          <a:prstGeom prst="line">
-            <a:avLst/>
-          </a:prstGeom>
-          <a:ln w="25400">
-            <a:solidFill>
-              <a:srgbClr val="0E8C8C"/>
-            </a:solidFill>
-            <a:tailEnd type="triangle" w="med" len="med"/>
-          </a:ln>
-        </p:spPr>
-        <p:style>
-          <a:lnRef idx="2">
-            <a:schemeClr val="accent1"/>
-          </a:lnRef>
-          <a:fillRef idx="0">
-            <a:schemeClr val="accent1"/>
-          </a:fillRef>
-          <a:effectRef idx="1">
-            <a:schemeClr val="accent1"/>
-          </a:effectRef>
-          <a:fontRef idx="minor">
-            <a:schemeClr val="tx1"/>
-          </a:fontRef>
-        </p:style>
-      </p:cxnSp>
-      <p:cxnSp>
-        <p:nvCxnSpPr>
-          <p:cNvPr id="46" name="Connector 45"/>
-          <p:cNvCxnSpPr/>
-          <p:nvPr/>
-        </p:nvCxnSpPr>
-        <p:spPr>
-          <a:xfrm>
-            <a:off x="7109460" y="5577840"/>
-            <a:ext cx="0" cy="201168"/>
-          </a:xfrm>
-          <a:prstGeom prst="line">
-            <a:avLst/>
-          </a:prstGeom>
-          <a:ln w="19050">
-            <a:solidFill>
-              <a:srgbClr val="5B6778"/>
-            </a:solidFill>
-            <a:tailEnd type="triangle" w="med" len="med"/>
-          </a:ln>
-        </p:spPr>
-        <p:style>
-          <a:lnRef idx="2">
-            <a:schemeClr val="accent1"/>
-          </a:lnRef>
-          <a:fillRef idx="0">
-            <a:schemeClr val="accent1"/>
-          </a:fillRef>
-          <a:effectRef idx="1">
-            <a:schemeClr val="accent1"/>
-          </a:effectRef>
-          <a:fontRef idx="minor">
-            <a:schemeClr val="tx1"/>
-          </a:fontRef>
-        </p:style>
-      </p:cxnSp>
-      <p:sp>
-        <p:nvSpPr>
           <p:cNvPr id="47" name="Rounded Rectangle 46"/>
           <p:cNvSpPr/>
           <p:nvPr/>
@@ -15552,6 +14045,2144 @@
           </a:p>
         </p:txBody>
       </p:sp>
+      <p:sp>
+        <p:nvSpPr>
+          <p:cNvPr id="137" name="Rounded Rectangle 136"/>
+          <p:cNvSpPr/>
+          <p:nvPr/>
+        </p:nvSpPr>
+        <p:spPr>
+          <a:xfrm>
+            <a:off x="5532120" y="1051560"/>
+            <a:ext cx="6336792" cy="5303520"/>
+          </a:xfrm>
+          <a:prstGeom prst="roundRect">
+            <a:avLst>
+              <a:gd name="adj" fmla="val 3000"/>
+            </a:avLst>
+          </a:prstGeom>
+          <a:solidFill>
+            <a:srgbClr val="F7F9FC"/>
+          </a:solidFill>
+          <a:ln w="12700">
+            <a:solidFill>
+              <a:srgbClr val="D5DCE6"/>
+            </a:solidFill>
+          </a:ln>
+          <a:effectLst/>
+        </p:spPr>
+        <p:style>
+          <a:lnRef idx="1">
+            <a:schemeClr val="accent1"/>
+          </a:lnRef>
+          <a:fillRef idx="3">
+            <a:schemeClr val="accent1"/>
+          </a:fillRef>
+          <a:effectRef idx="2">
+            <a:schemeClr val="accent1"/>
+          </a:effectRef>
+          <a:fontRef idx="minor">
+            <a:schemeClr val="lt1"/>
+          </a:fontRef>
+        </p:style>
+        <p:txBody>
+          <a:bodyPr rtlCol="0" anchor="ctr"/>
+          <a:lstStyle/>
+          <a:p>
+            <a:pPr algn="ctr"/>
+          </a:p>
+        </p:txBody>
+      </p:sp>
+      <p:sp>
+        <p:nvSpPr>
+          <p:cNvPr id="138" name="TextBox 137"/>
+          <p:cNvSpPr txBox="1"/>
+          <p:nvPr/>
+        </p:nvSpPr>
+        <p:spPr>
+          <a:xfrm>
+            <a:off x="5669280" y="1106424"/>
+            <a:ext cx="3840480" cy="292608"/>
+          </a:xfrm>
+          <a:prstGeom prst="rect">
+            <a:avLst/>
+          </a:prstGeom>
+          <a:noFill/>
+        </p:spPr>
+        <p:txBody>
+          <a:bodyPr wrap="square" lIns="45720" rIns="45720" tIns="9144" bIns="9144" anchor="ctr">
+            <a:spAutoFit/>
+          </a:bodyPr>
+          <a:lstStyle/>
+          <a:p>
+            <a:r>
+              <a:rPr sz="1300" b="1">
+                <a:solidFill>
+                  <a:srgbClr val="1F5FBF"/>
+                </a:solidFill>
+                <a:latin typeface="Calibri"/>
+              </a:rPr>
+              <a:t>METHODOLOGY: HOW EVERY LOG FLOWS</a:t>
+            </a:r>
+          </a:p>
+        </p:txBody>
+      </p:sp>
+      <p:sp>
+        <p:nvSpPr>
+          <p:cNvPr id="139" name="Rounded Rectangle 138"/>
+          <p:cNvSpPr/>
+          <p:nvPr/>
+        </p:nvSpPr>
+        <p:spPr>
+          <a:xfrm>
+            <a:off x="9601200" y="1179576"/>
+            <a:ext cx="201168" cy="128016"/>
+          </a:xfrm>
+          <a:prstGeom prst="roundRect">
+            <a:avLst>
+              <a:gd name="adj" fmla="val 30000"/>
+            </a:avLst>
+          </a:prstGeom>
+          <a:solidFill>
+            <a:srgbClr val="138A36"/>
+          </a:solidFill>
+          <a:ln>
+            <a:noFill/>
+          </a:ln>
+          <a:effectLst/>
+        </p:spPr>
+        <p:style>
+          <a:lnRef idx="1">
+            <a:schemeClr val="accent1"/>
+          </a:lnRef>
+          <a:fillRef idx="3">
+            <a:schemeClr val="accent1"/>
+          </a:fillRef>
+          <a:effectRef idx="2">
+            <a:schemeClr val="accent1"/>
+          </a:effectRef>
+          <a:fontRef idx="minor">
+            <a:schemeClr val="lt1"/>
+          </a:fontRef>
+        </p:style>
+        <p:txBody>
+          <a:bodyPr rtlCol="0" anchor="ctr"/>
+          <a:lstStyle/>
+          <a:p>
+            <a:pPr algn="ctr"/>
+          </a:p>
+        </p:txBody>
+      </p:sp>
+      <p:sp>
+        <p:nvSpPr>
+          <p:cNvPr id="140" name="TextBox 139"/>
+          <p:cNvSpPr txBox="1"/>
+          <p:nvPr/>
+        </p:nvSpPr>
+        <p:spPr>
+          <a:xfrm>
+            <a:off x="9829800" y="1152144"/>
+            <a:ext cx="868680" cy="182880"/>
+          </a:xfrm>
+          <a:prstGeom prst="rect">
+            <a:avLst/>
+          </a:prstGeom>
+          <a:noFill/>
+        </p:spPr>
+        <p:txBody>
+          <a:bodyPr wrap="square" lIns="18288" rIns="18288" tIns="9144" bIns="9144" anchor="ctr">
+            <a:spAutoFit/>
+          </a:bodyPr>
+          <a:lstStyle/>
+          <a:p>
+            <a:pPr algn="l"/>
+            <a:r>
+              <a:rPr sz="800" b="1">
+                <a:solidFill>
+                  <a:srgbClr val="138A36"/>
+                </a:solidFill>
+                <a:latin typeface="Calibri"/>
+              </a:rPr>
+              <a:t>fast path</a:t>
+            </a:r>
+          </a:p>
+        </p:txBody>
+      </p:sp>
+      <p:sp>
+        <p:nvSpPr>
+          <p:cNvPr id="141" name="Rounded Rectangle 140"/>
+          <p:cNvSpPr/>
+          <p:nvPr/>
+        </p:nvSpPr>
+        <p:spPr>
+          <a:xfrm>
+            <a:off x="10698480" y="1179576"/>
+            <a:ext cx="201168" cy="128016"/>
+          </a:xfrm>
+          <a:prstGeom prst="roundRect">
+            <a:avLst>
+              <a:gd name="adj" fmla="val 30000"/>
+            </a:avLst>
+          </a:prstGeom>
+          <a:solidFill>
+            <a:srgbClr val="F28322"/>
+          </a:solidFill>
+          <a:ln>
+            <a:noFill/>
+          </a:ln>
+          <a:effectLst/>
+        </p:spPr>
+        <p:style>
+          <a:lnRef idx="1">
+            <a:schemeClr val="accent1"/>
+          </a:lnRef>
+          <a:fillRef idx="3">
+            <a:schemeClr val="accent1"/>
+          </a:fillRef>
+          <a:effectRef idx="2">
+            <a:schemeClr val="accent1"/>
+          </a:effectRef>
+          <a:fontRef idx="minor">
+            <a:schemeClr val="lt1"/>
+          </a:fontRef>
+        </p:style>
+        <p:txBody>
+          <a:bodyPr rtlCol="0" anchor="ctr"/>
+          <a:lstStyle/>
+          <a:p>
+            <a:pPr algn="ctr"/>
+          </a:p>
+        </p:txBody>
+      </p:sp>
+      <p:sp>
+        <p:nvSpPr>
+          <p:cNvPr id="142" name="TextBox 141"/>
+          <p:cNvSpPr txBox="1"/>
+          <p:nvPr/>
+        </p:nvSpPr>
+        <p:spPr>
+          <a:xfrm>
+            <a:off x="10927080" y="1152144"/>
+            <a:ext cx="868680" cy="182880"/>
+          </a:xfrm>
+          <a:prstGeom prst="rect">
+            <a:avLst/>
+          </a:prstGeom>
+          <a:noFill/>
+        </p:spPr>
+        <p:txBody>
+          <a:bodyPr wrap="square" lIns="18288" rIns="18288" tIns="9144" bIns="9144" anchor="ctr">
+            <a:spAutoFit/>
+          </a:bodyPr>
+          <a:lstStyle/>
+          <a:p>
+            <a:pPr algn="l"/>
+            <a:r>
+              <a:rPr sz="800" b="1">
+                <a:solidFill>
+                  <a:srgbClr val="C06010"/>
+                </a:solidFill>
+                <a:latin typeface="Calibri"/>
+              </a:rPr>
+              <a:t>AI path</a:t>
+            </a:r>
+          </a:p>
+        </p:txBody>
+      </p:sp>
+      <p:sp>
+        <p:nvSpPr>
+          <p:cNvPr id="143" name="Rounded Rectangle 142"/>
+          <p:cNvSpPr/>
+          <p:nvPr/>
+        </p:nvSpPr>
+        <p:spPr>
+          <a:xfrm>
+            <a:off x="5715000" y="1463040"/>
+            <a:ext cx="3200400" cy="420624"/>
+          </a:xfrm>
+          <a:prstGeom prst="roundRect">
+            <a:avLst>
+              <a:gd name="adj" fmla="val 15000"/>
+            </a:avLst>
+          </a:prstGeom>
+          <a:solidFill>
+            <a:srgbClr val="4A5568"/>
+          </a:solidFill>
+          <a:ln>
+            <a:noFill/>
+          </a:ln>
+          <a:effectLst/>
+        </p:spPr>
+        <p:style>
+          <a:lnRef idx="1">
+            <a:schemeClr val="accent1"/>
+          </a:lnRef>
+          <a:fillRef idx="3">
+            <a:schemeClr val="accent1"/>
+          </a:fillRef>
+          <a:effectRef idx="2">
+            <a:schemeClr val="accent1"/>
+          </a:effectRef>
+          <a:fontRef idx="minor">
+            <a:schemeClr val="lt1"/>
+          </a:fontRef>
+        </p:style>
+        <p:txBody>
+          <a:bodyPr rtlCol="0" anchor="ctr"/>
+          <a:lstStyle/>
+          <a:p>
+            <a:pPr algn="ctr"/>
+          </a:p>
+        </p:txBody>
+      </p:sp>
+      <p:sp>
+        <p:nvSpPr>
+          <p:cNvPr id="144" name="TextBox 143"/>
+          <p:cNvSpPr txBox="1"/>
+          <p:nvPr/>
+        </p:nvSpPr>
+        <p:spPr>
+          <a:xfrm>
+            <a:off x="5715000" y="1463040"/>
+            <a:ext cx="3200400" cy="420624"/>
+          </a:xfrm>
+          <a:prstGeom prst="rect">
+            <a:avLst/>
+          </a:prstGeom>
+          <a:noFill/>
+        </p:spPr>
+        <p:txBody>
+          <a:bodyPr wrap="square" lIns="45720" rIns="45720" tIns="9144" bIns="9144" anchor="ctr">
+            <a:spAutoFit/>
+          </a:bodyPr>
+          <a:lstStyle/>
+          <a:p>
+            <a:pPr algn="ctr"/>
+            <a:r>
+              <a:rPr sz="1050" b="1">
+                <a:solidFill>
+                  <a:srgbClr val="FFFFFF"/>
+                </a:solidFill>
+                <a:latin typeface="Calibri"/>
+              </a:rPr>
+              <a:t>1  Logs come in</a:t>
+            </a:r>
+          </a:p>
+          <a:p>
+            <a:pPr algn="ctr"/>
+            <a:r>
+              <a:rPr sz="850" b="0">
+                <a:solidFill>
+                  <a:srgbClr val="EEF3FA"/>
+                </a:solidFill>
+                <a:latin typeface="Calibri"/>
+              </a:rPr>
+              <a:t>web API or Bash collector · multi-line errors joined</a:t>
+            </a:r>
+          </a:p>
+        </p:txBody>
+      </p:sp>
+      <p:sp>
+        <p:nvSpPr>
+          <p:cNvPr id="145" name="Rounded Rectangle 144"/>
+          <p:cNvSpPr/>
+          <p:nvPr/>
+        </p:nvSpPr>
+        <p:spPr>
+          <a:xfrm>
+            <a:off x="5715000" y="1993392"/>
+            <a:ext cx="3200400" cy="420624"/>
+          </a:xfrm>
+          <a:prstGeom prst="roundRect">
+            <a:avLst>
+              <a:gd name="adj" fmla="val 15000"/>
+            </a:avLst>
+          </a:prstGeom>
+          <a:solidFill>
+            <a:srgbClr val="1F5FBF"/>
+          </a:solidFill>
+          <a:ln>
+            <a:noFill/>
+          </a:ln>
+          <a:effectLst/>
+        </p:spPr>
+        <p:style>
+          <a:lnRef idx="1">
+            <a:schemeClr val="accent1"/>
+          </a:lnRef>
+          <a:fillRef idx="3">
+            <a:schemeClr val="accent1"/>
+          </a:fillRef>
+          <a:effectRef idx="2">
+            <a:schemeClr val="accent1"/>
+          </a:effectRef>
+          <a:fontRef idx="minor">
+            <a:schemeClr val="lt1"/>
+          </a:fontRef>
+        </p:style>
+        <p:txBody>
+          <a:bodyPr rtlCol="0" anchor="ctr"/>
+          <a:lstStyle/>
+          <a:p>
+            <a:pPr algn="ctr"/>
+          </a:p>
+        </p:txBody>
+      </p:sp>
+      <p:sp>
+        <p:nvSpPr>
+          <p:cNvPr id="146" name="TextBox 145"/>
+          <p:cNvSpPr txBox="1"/>
+          <p:nvPr/>
+        </p:nvSpPr>
+        <p:spPr>
+          <a:xfrm>
+            <a:off x="5715000" y="1993392"/>
+            <a:ext cx="3200400" cy="420624"/>
+          </a:xfrm>
+          <a:prstGeom prst="rect">
+            <a:avLst/>
+          </a:prstGeom>
+          <a:noFill/>
+        </p:spPr>
+        <p:txBody>
+          <a:bodyPr wrap="square" lIns="45720" rIns="45720" tIns="9144" bIns="9144" anchor="ctr">
+            <a:spAutoFit/>
+          </a:bodyPr>
+          <a:lstStyle/>
+          <a:p>
+            <a:pPr algn="ctr"/>
+            <a:r>
+              <a:rPr sz="1050" b="1">
+                <a:solidFill>
+                  <a:srgbClr val="FFFFFF"/>
+                </a:solidFill>
+                <a:latin typeface="Calibri"/>
+              </a:rPr>
+              <a:t>2  Seen this exact line shape before?</a:t>
+            </a:r>
+          </a:p>
+          <a:p>
+            <a:pPr algn="ctr"/>
+            <a:r>
+              <a:rPr sz="850" b="0">
+                <a:solidFill>
+                  <a:srgbClr val="EEF3FA"/>
+                </a:solidFill>
+                <a:latin typeface="Calibri"/>
+              </a:rPr>
+              <a:t>quick fingerprint check</a:t>
+            </a:r>
+          </a:p>
+        </p:txBody>
+      </p:sp>
+      <p:sp>
+        <p:nvSpPr>
+          <p:cNvPr id="147" name="Rounded Rectangle 146"/>
+          <p:cNvSpPr/>
+          <p:nvPr/>
+        </p:nvSpPr>
+        <p:spPr>
+          <a:xfrm>
+            <a:off x="5715000" y="2523744"/>
+            <a:ext cx="3200400" cy="420624"/>
+          </a:xfrm>
+          <a:prstGeom prst="roundRect">
+            <a:avLst>
+              <a:gd name="adj" fmla="val 15000"/>
+            </a:avLst>
+          </a:prstGeom>
+          <a:solidFill>
+            <a:srgbClr val="1F5FBF"/>
+          </a:solidFill>
+          <a:ln>
+            <a:noFill/>
+          </a:ln>
+          <a:effectLst/>
+        </p:spPr>
+        <p:style>
+          <a:lnRef idx="1">
+            <a:schemeClr val="accent1"/>
+          </a:lnRef>
+          <a:fillRef idx="3">
+            <a:schemeClr val="accent1"/>
+          </a:fillRef>
+          <a:effectRef idx="2">
+            <a:schemeClr val="accent1"/>
+          </a:effectRef>
+          <a:fontRef idx="minor">
+            <a:schemeClr val="lt1"/>
+          </a:fontRef>
+        </p:style>
+        <p:txBody>
+          <a:bodyPr rtlCol="0" anchor="ctr"/>
+          <a:lstStyle/>
+          <a:p>
+            <a:pPr algn="ctr"/>
+          </a:p>
+        </p:txBody>
+      </p:sp>
+      <p:sp>
+        <p:nvSpPr>
+          <p:cNvPr id="148" name="TextBox 147"/>
+          <p:cNvSpPr txBox="1"/>
+          <p:nvPr/>
+        </p:nvSpPr>
+        <p:spPr>
+          <a:xfrm>
+            <a:off x="5715000" y="2523744"/>
+            <a:ext cx="3200400" cy="420624"/>
+          </a:xfrm>
+          <a:prstGeom prst="rect">
+            <a:avLst/>
+          </a:prstGeom>
+          <a:noFill/>
+        </p:spPr>
+        <p:txBody>
+          <a:bodyPr wrap="square" lIns="45720" rIns="45720" tIns="9144" bIns="9144" anchor="ctr">
+            <a:spAutoFit/>
+          </a:bodyPr>
+          <a:lstStyle/>
+          <a:p>
+            <a:pPr algn="ctr"/>
+            <a:r>
+              <a:rPr sz="1050" b="1">
+                <a:solidFill>
+                  <a:srgbClr val="FFFFFF"/>
+                </a:solidFill>
+                <a:latin typeface="Calibri"/>
+              </a:rPr>
+              <a:t>3  Group similar lines (Drain3)</a:t>
+            </a:r>
+          </a:p>
+          <a:p>
+            <a:pPr algn="ctr"/>
+            <a:r>
+              <a:rPr sz="850" b="0">
+                <a:solidFill>
+                  <a:srgbClr val="EEF3FA"/>
+                </a:solidFill>
+                <a:latin typeface="Calibri"/>
+              </a:rPr>
+              <a:t>millions of lines → a few thousand patterns</a:t>
+            </a:r>
+          </a:p>
+        </p:txBody>
+      </p:sp>
+      <p:sp>
+        <p:nvSpPr>
+          <p:cNvPr id="149" name="Rounded Rectangle 148"/>
+          <p:cNvSpPr/>
+          <p:nvPr/>
+        </p:nvSpPr>
+        <p:spPr>
+          <a:xfrm>
+            <a:off x="5715000" y="3054096"/>
+            <a:ext cx="3200400" cy="420624"/>
+          </a:xfrm>
+          <a:prstGeom prst="roundRect">
+            <a:avLst>
+              <a:gd name="adj" fmla="val 15000"/>
+            </a:avLst>
+          </a:prstGeom>
+          <a:solidFill>
+            <a:srgbClr val="1F5FBF"/>
+          </a:solidFill>
+          <a:ln>
+            <a:noFill/>
+          </a:ln>
+          <a:effectLst/>
+        </p:spPr>
+        <p:style>
+          <a:lnRef idx="1">
+            <a:schemeClr val="accent1"/>
+          </a:lnRef>
+          <a:fillRef idx="3">
+            <a:schemeClr val="accent1"/>
+          </a:fillRef>
+          <a:effectRef idx="2">
+            <a:schemeClr val="accent1"/>
+          </a:effectRef>
+          <a:fontRef idx="minor">
+            <a:schemeClr val="lt1"/>
+          </a:fontRef>
+        </p:style>
+        <p:txBody>
+          <a:bodyPr rtlCol="0" anchor="ctr"/>
+          <a:lstStyle/>
+          <a:p>
+            <a:pPr algn="ctr"/>
+          </a:p>
+        </p:txBody>
+      </p:sp>
+      <p:sp>
+        <p:nvSpPr>
+          <p:cNvPr id="150" name="TextBox 149"/>
+          <p:cNvSpPr txBox="1"/>
+          <p:nvPr/>
+        </p:nvSpPr>
+        <p:spPr>
+          <a:xfrm>
+            <a:off x="5715000" y="3054096"/>
+            <a:ext cx="3200400" cy="420624"/>
+          </a:xfrm>
+          <a:prstGeom prst="rect">
+            <a:avLst/>
+          </a:prstGeom>
+          <a:noFill/>
+        </p:spPr>
+        <p:txBody>
+          <a:bodyPr wrap="square" lIns="45720" rIns="45720" tIns="9144" bIns="9144" anchor="ctr">
+            <a:spAutoFit/>
+          </a:bodyPr>
+          <a:lstStyle/>
+          <a:p>
+            <a:pPr algn="ctr"/>
+            <a:r>
+              <a:rPr sz="1050" b="1">
+                <a:solidFill>
+                  <a:srgbClr val="FFFFFF"/>
+                </a:solidFill>
+                <a:latin typeface="Calibri"/>
+              </a:rPr>
+              <a:t>4  Does this pattern have a saved rule?</a:t>
+            </a:r>
+          </a:p>
+          <a:p>
+            <a:pPr algn="ctr"/>
+            <a:r>
+              <a:rPr sz="850" b="0">
+                <a:solidFill>
+                  <a:srgbClr val="EEF3FA"/>
+                </a:solidFill>
+                <a:latin typeface="Calibri"/>
+              </a:rPr>
+              <a:t>checked once per pattern, not per line</a:t>
+            </a:r>
+          </a:p>
+        </p:txBody>
+      </p:sp>
+      <p:sp>
+        <p:nvSpPr>
+          <p:cNvPr id="151" name="Rounded Rectangle 150"/>
+          <p:cNvSpPr/>
+          <p:nvPr/>
+        </p:nvSpPr>
+        <p:spPr>
+          <a:xfrm>
+            <a:off x="5715000" y="3584448"/>
+            <a:ext cx="3200400" cy="420624"/>
+          </a:xfrm>
+          <a:prstGeom prst="roundRect">
+            <a:avLst>
+              <a:gd name="adj" fmla="val 15000"/>
+            </a:avLst>
+          </a:prstGeom>
+          <a:solidFill>
+            <a:srgbClr val="6A3FB5"/>
+          </a:solidFill>
+          <a:ln>
+            <a:noFill/>
+          </a:ln>
+          <a:effectLst/>
+        </p:spPr>
+        <p:style>
+          <a:lnRef idx="1">
+            <a:schemeClr val="accent1"/>
+          </a:lnRef>
+          <a:fillRef idx="3">
+            <a:schemeClr val="accent1"/>
+          </a:fillRef>
+          <a:effectRef idx="2">
+            <a:schemeClr val="accent1"/>
+          </a:effectRef>
+          <a:fontRef idx="minor">
+            <a:schemeClr val="lt1"/>
+          </a:fontRef>
+        </p:style>
+        <p:txBody>
+          <a:bodyPr rtlCol="0" anchor="ctr"/>
+          <a:lstStyle/>
+          <a:p>
+            <a:pPr algn="ctr"/>
+          </a:p>
+        </p:txBody>
+      </p:sp>
+      <p:sp>
+        <p:nvSpPr>
+          <p:cNvPr id="152" name="TextBox 151"/>
+          <p:cNvSpPr txBox="1"/>
+          <p:nvPr/>
+        </p:nvSpPr>
+        <p:spPr>
+          <a:xfrm>
+            <a:off x="5715000" y="3584448"/>
+            <a:ext cx="3200400" cy="420624"/>
+          </a:xfrm>
+          <a:prstGeom prst="rect">
+            <a:avLst/>
+          </a:prstGeom>
+          <a:noFill/>
+        </p:spPr>
+        <p:txBody>
+          <a:bodyPr wrap="square" lIns="45720" rIns="45720" tIns="9144" bIns="9144" anchor="ctr">
+            <a:spAutoFit/>
+          </a:bodyPr>
+          <a:lstStyle/>
+          <a:p>
+            <a:pPr algn="ctr"/>
+            <a:r>
+              <a:rPr sz="1050" b="1">
+                <a:solidFill>
+                  <a:srgbClr val="FFFFFF"/>
+                </a:solidFill>
+                <a:latin typeface="Calibri"/>
+              </a:rPr>
+              <a:t>5  ML format check (scikit-learn)</a:t>
+            </a:r>
+          </a:p>
+          <a:p>
+            <a:pPr algn="ctr"/>
+            <a:r>
+              <a:rPr sz="850" b="0">
+                <a:solidFill>
+                  <a:srgbClr val="EEF3FA"/>
+                </a:solidFill>
+                <a:latin typeface="Calibri"/>
+              </a:rPr>
+              <a:t>known log family, or a brand-new format?</a:t>
+            </a:r>
+          </a:p>
+        </p:txBody>
+      </p:sp>
+      <p:sp>
+        <p:nvSpPr>
+          <p:cNvPr id="153" name="Rounded Rectangle 152"/>
+          <p:cNvSpPr/>
+          <p:nvPr/>
+        </p:nvSpPr>
+        <p:spPr>
+          <a:xfrm>
+            <a:off x="5715000" y="4114800"/>
+            <a:ext cx="1554480" cy="420624"/>
+          </a:xfrm>
+          <a:prstGeom prst="roundRect">
+            <a:avLst>
+              <a:gd name="adj" fmla="val 15000"/>
+            </a:avLst>
+          </a:prstGeom>
+          <a:solidFill>
+            <a:srgbClr val="F28322"/>
+          </a:solidFill>
+          <a:ln>
+            <a:noFill/>
+          </a:ln>
+          <a:effectLst/>
+        </p:spPr>
+        <p:style>
+          <a:lnRef idx="1">
+            <a:schemeClr val="accent1"/>
+          </a:lnRef>
+          <a:fillRef idx="3">
+            <a:schemeClr val="accent1"/>
+          </a:fillRef>
+          <a:effectRef idx="2">
+            <a:schemeClr val="accent1"/>
+          </a:effectRef>
+          <a:fontRef idx="minor">
+            <a:schemeClr val="lt1"/>
+          </a:fontRef>
+        </p:style>
+        <p:txBody>
+          <a:bodyPr rtlCol="0" anchor="ctr"/>
+          <a:lstStyle/>
+          <a:p>
+            <a:pPr algn="ctr"/>
+          </a:p>
+        </p:txBody>
+      </p:sp>
+      <p:sp>
+        <p:nvSpPr>
+          <p:cNvPr id="154" name="TextBox 153"/>
+          <p:cNvSpPr txBox="1"/>
+          <p:nvPr/>
+        </p:nvSpPr>
+        <p:spPr>
+          <a:xfrm>
+            <a:off x="5715000" y="4114800"/>
+            <a:ext cx="1554480" cy="420624"/>
+          </a:xfrm>
+          <a:prstGeom prst="rect">
+            <a:avLst/>
+          </a:prstGeom>
+          <a:noFill/>
+        </p:spPr>
+        <p:txBody>
+          <a:bodyPr wrap="square" lIns="45720" rIns="45720" tIns="9144" bIns="9144" anchor="ctr">
+            <a:spAutoFit/>
+          </a:bodyPr>
+          <a:lstStyle/>
+          <a:p>
+            <a:pPr algn="ctr"/>
+            <a:r>
+              <a:rPr sz="1000" b="1">
+                <a:solidFill>
+                  <a:srgbClr val="FFFFFF"/>
+                </a:solidFill>
+                <a:latin typeface="Calibri"/>
+              </a:rPr>
+              <a:t>AI writes a rule</a:t>
+            </a:r>
+          </a:p>
+          <a:p>
+            <a:pPr algn="ctr"/>
+            <a:r>
+              <a:rPr sz="750" b="0">
+                <a:solidFill>
+                  <a:srgbClr val="FFF4E8"/>
+                </a:solidFill>
+                <a:latin typeface="Calibri"/>
+              </a:rPr>
+              <a:t>once per pattern</a:t>
+            </a:r>
+          </a:p>
+        </p:txBody>
+      </p:sp>
+      <p:sp>
+        <p:nvSpPr>
+          <p:cNvPr id="155" name="Rounded Rectangle 154"/>
+          <p:cNvSpPr/>
+          <p:nvPr/>
+        </p:nvSpPr>
+        <p:spPr>
+          <a:xfrm>
+            <a:off x="7360920" y="4114800"/>
+            <a:ext cx="1554480" cy="420624"/>
+          </a:xfrm>
+          <a:prstGeom prst="roundRect">
+            <a:avLst>
+              <a:gd name="adj" fmla="val 15000"/>
+            </a:avLst>
+          </a:prstGeom>
+          <a:solidFill>
+            <a:srgbClr val="C0392B"/>
+          </a:solidFill>
+          <a:ln>
+            <a:noFill/>
+          </a:ln>
+          <a:effectLst/>
+        </p:spPr>
+        <p:style>
+          <a:lnRef idx="1">
+            <a:schemeClr val="accent1"/>
+          </a:lnRef>
+          <a:fillRef idx="3">
+            <a:schemeClr val="accent1"/>
+          </a:fillRef>
+          <a:effectRef idx="2">
+            <a:schemeClr val="accent1"/>
+          </a:effectRef>
+          <a:fontRef idx="minor">
+            <a:schemeClr val="lt1"/>
+          </a:fontRef>
+        </p:style>
+        <p:txBody>
+          <a:bodyPr rtlCol="0" anchor="ctr"/>
+          <a:lstStyle/>
+          <a:p>
+            <a:pPr algn="ctr"/>
+          </a:p>
+        </p:txBody>
+      </p:sp>
+      <p:sp>
+        <p:nvSpPr>
+          <p:cNvPr id="156" name="TextBox 155"/>
+          <p:cNvSpPr txBox="1"/>
+          <p:nvPr/>
+        </p:nvSpPr>
+        <p:spPr>
+          <a:xfrm>
+            <a:off x="7360920" y="4114800"/>
+            <a:ext cx="1554480" cy="420624"/>
+          </a:xfrm>
+          <a:prstGeom prst="rect">
+            <a:avLst/>
+          </a:prstGeom>
+          <a:noFill/>
+        </p:spPr>
+        <p:txBody>
+          <a:bodyPr wrap="square" lIns="45720" rIns="45720" tIns="9144" bIns="9144" anchor="ctr">
+            <a:spAutoFit/>
+          </a:bodyPr>
+          <a:lstStyle/>
+          <a:p>
+            <a:pPr algn="ctr"/>
+            <a:r>
+              <a:rPr sz="1000" b="1">
+                <a:solidFill>
+                  <a:srgbClr val="FFFFFF"/>
+                </a:solidFill>
+                <a:latin typeface="Calibri"/>
+              </a:rPr>
+              <a:t>Hold for review</a:t>
+            </a:r>
+          </a:p>
+          <a:p>
+            <a:pPr algn="ctr"/>
+            <a:r>
+              <a:rPr sz="750" b="0">
+                <a:solidFill>
+                  <a:srgbClr val="FDECEA"/>
+                </a:solidFill>
+                <a:latin typeface="Calibri"/>
+              </a:rPr>
+              <a:t>learned once it repeats</a:t>
+            </a:r>
+          </a:p>
+        </p:txBody>
+      </p:sp>
+      <p:sp>
+        <p:nvSpPr>
+          <p:cNvPr id="157" name="Rounded Rectangle 156"/>
+          <p:cNvSpPr/>
+          <p:nvPr/>
+        </p:nvSpPr>
+        <p:spPr>
+          <a:xfrm>
+            <a:off x="5715000" y="4645152"/>
+            <a:ext cx="3200400" cy="420624"/>
+          </a:xfrm>
+          <a:prstGeom prst="roundRect">
+            <a:avLst>
+              <a:gd name="adj" fmla="val 15000"/>
+            </a:avLst>
+          </a:prstGeom>
+          <a:solidFill>
+            <a:srgbClr val="0E8C8C"/>
+          </a:solidFill>
+          <a:ln>
+            <a:noFill/>
+          </a:ln>
+          <a:effectLst/>
+        </p:spPr>
+        <p:style>
+          <a:lnRef idx="1">
+            <a:schemeClr val="accent1"/>
+          </a:lnRef>
+          <a:fillRef idx="3">
+            <a:schemeClr val="accent1"/>
+          </a:fillRef>
+          <a:effectRef idx="2">
+            <a:schemeClr val="accent1"/>
+          </a:effectRef>
+          <a:fontRef idx="minor">
+            <a:schemeClr val="lt1"/>
+          </a:fontRef>
+        </p:style>
+        <p:txBody>
+          <a:bodyPr rtlCol="0" anchor="ctr"/>
+          <a:lstStyle/>
+          <a:p>
+            <a:pPr algn="ctr"/>
+          </a:p>
+        </p:txBody>
+      </p:sp>
+      <p:sp>
+        <p:nvSpPr>
+          <p:cNvPr id="158" name="TextBox 157"/>
+          <p:cNvSpPr txBox="1"/>
+          <p:nvPr/>
+        </p:nvSpPr>
+        <p:spPr>
+          <a:xfrm>
+            <a:off x="5715000" y="4645152"/>
+            <a:ext cx="3200400" cy="420624"/>
+          </a:xfrm>
+          <a:prstGeom prst="rect">
+            <a:avLst/>
+          </a:prstGeom>
+          <a:noFill/>
+        </p:spPr>
+        <p:txBody>
+          <a:bodyPr wrap="square" lIns="45720" rIns="45720" tIns="9144" bIns="9144" anchor="ctr">
+            <a:spAutoFit/>
+          </a:bodyPr>
+          <a:lstStyle/>
+          <a:p>
+            <a:pPr algn="ctr"/>
+            <a:r>
+              <a:rPr sz="1050" b="1">
+                <a:solidFill>
+                  <a:srgbClr val="FFFFFF"/>
+                </a:solidFill>
+                <a:latin typeface="Calibri"/>
+              </a:rPr>
+              <a:t>6  Save the rule</a:t>
+            </a:r>
+          </a:p>
+          <a:p>
+            <a:pPr algn="ctr"/>
+            <a:r>
+              <a:rPr sz="850" b="0">
+                <a:solidFill>
+                  <a:srgbClr val="EEF3FA"/>
+                </a:solidFill>
+                <a:latin typeface="Calibri"/>
+              </a:rPr>
+              <a:t>every future matching line reuses it</a:t>
+            </a:r>
+          </a:p>
+        </p:txBody>
+      </p:sp>
+      <p:sp>
+        <p:nvSpPr>
+          <p:cNvPr id="159" name="Rounded Rectangle 158"/>
+          <p:cNvSpPr/>
+          <p:nvPr/>
+        </p:nvSpPr>
+        <p:spPr>
+          <a:xfrm>
+            <a:off x="5715000" y="5175504"/>
+            <a:ext cx="5989320" cy="420624"/>
+          </a:xfrm>
+          <a:prstGeom prst="roundRect">
+            <a:avLst>
+              <a:gd name="adj" fmla="val 15000"/>
+            </a:avLst>
+          </a:prstGeom>
+          <a:solidFill>
+            <a:srgbClr val="138A36"/>
+          </a:solidFill>
+          <a:ln>
+            <a:noFill/>
+          </a:ln>
+          <a:effectLst/>
+        </p:spPr>
+        <p:style>
+          <a:lnRef idx="1">
+            <a:schemeClr val="accent1"/>
+          </a:lnRef>
+          <a:fillRef idx="3">
+            <a:schemeClr val="accent1"/>
+          </a:fillRef>
+          <a:effectRef idx="2">
+            <a:schemeClr val="accent1"/>
+          </a:effectRef>
+          <a:fontRef idx="minor">
+            <a:schemeClr val="lt1"/>
+          </a:fontRef>
+        </p:style>
+        <p:txBody>
+          <a:bodyPr rtlCol="0" anchor="ctr"/>
+          <a:lstStyle/>
+          <a:p>
+            <a:pPr algn="ctr"/>
+          </a:p>
+        </p:txBody>
+      </p:sp>
+      <p:sp>
+        <p:nvSpPr>
+          <p:cNvPr id="160" name="TextBox 159"/>
+          <p:cNvSpPr txBox="1"/>
+          <p:nvPr/>
+        </p:nvSpPr>
+        <p:spPr>
+          <a:xfrm>
+            <a:off x="5715000" y="5175504"/>
+            <a:ext cx="5989320" cy="420624"/>
+          </a:xfrm>
+          <a:prstGeom prst="rect">
+            <a:avLst/>
+          </a:prstGeom>
+          <a:noFill/>
+        </p:spPr>
+        <p:txBody>
+          <a:bodyPr wrap="square" lIns="45720" rIns="45720" tIns="9144" bIns="9144" anchor="ctr">
+            <a:spAutoFit/>
+          </a:bodyPr>
+          <a:lstStyle/>
+          <a:p>
+            <a:pPr algn="ctr"/>
+            <a:r>
+              <a:rPr sz="1050" b="1">
+                <a:solidFill>
+                  <a:srgbClr val="FFFFFF"/>
+                </a:solidFill>
+                <a:latin typeface="Calibri"/>
+              </a:rPr>
+              <a:t>7  Apply rule &amp; clean up</a:t>
+            </a:r>
+          </a:p>
+          <a:p>
+            <a:pPr algn="ctr"/>
+            <a:r>
+              <a:rPr sz="850" b="0">
+                <a:solidFill>
+                  <a:srgbClr val="EEF3FA"/>
+                </a:solidFill>
+                <a:latin typeface="Calibri"/>
+              </a:rPr>
+              <a:t>time → UTC · one severity scale · event tags · IPs &amp; users pulled out · original line kept</a:t>
+            </a:r>
+          </a:p>
+        </p:txBody>
+      </p:sp>
+      <p:sp>
+        <p:nvSpPr>
+          <p:cNvPr id="161" name="Rounded Rectangle 160"/>
+          <p:cNvSpPr/>
+          <p:nvPr/>
+        </p:nvSpPr>
+        <p:spPr>
+          <a:xfrm>
+            <a:off x="5715000" y="5705856"/>
+            <a:ext cx="5989320" cy="420624"/>
+          </a:xfrm>
+          <a:prstGeom prst="roundRect">
+            <a:avLst>
+              <a:gd name="adj" fmla="val 15000"/>
+            </a:avLst>
+          </a:prstGeom>
+          <a:solidFill>
+            <a:srgbClr val="0B2A5B"/>
+          </a:solidFill>
+          <a:ln>
+            <a:noFill/>
+          </a:ln>
+          <a:effectLst/>
+        </p:spPr>
+        <p:style>
+          <a:lnRef idx="1">
+            <a:schemeClr val="accent1"/>
+          </a:lnRef>
+          <a:fillRef idx="3">
+            <a:schemeClr val="accent1"/>
+          </a:fillRef>
+          <a:effectRef idx="2">
+            <a:schemeClr val="accent1"/>
+          </a:effectRef>
+          <a:fontRef idx="minor">
+            <a:schemeClr val="lt1"/>
+          </a:fontRef>
+        </p:style>
+        <p:txBody>
+          <a:bodyPr rtlCol="0" anchor="ctr"/>
+          <a:lstStyle/>
+          <a:p>
+            <a:pPr algn="ctr"/>
+          </a:p>
+        </p:txBody>
+      </p:sp>
+      <p:sp>
+        <p:nvSpPr>
+          <p:cNvPr id="162" name="TextBox 161"/>
+          <p:cNvSpPr txBox="1"/>
+          <p:nvPr/>
+        </p:nvSpPr>
+        <p:spPr>
+          <a:xfrm>
+            <a:off x="5715000" y="5705856"/>
+            <a:ext cx="5989320" cy="420624"/>
+          </a:xfrm>
+          <a:prstGeom prst="rect">
+            <a:avLst/>
+          </a:prstGeom>
+          <a:noFill/>
+        </p:spPr>
+        <p:txBody>
+          <a:bodyPr wrap="square" lIns="45720" rIns="45720" tIns="9144" bIns="9144" anchor="ctr">
+            <a:spAutoFit/>
+          </a:bodyPr>
+          <a:lstStyle/>
+          <a:p>
+            <a:pPr algn="ctr"/>
+            <a:r>
+              <a:rPr sz="1050" b="1">
+                <a:solidFill>
+                  <a:srgbClr val="FFFFFF"/>
+                </a:solidFill>
+                <a:latin typeface="Calibri"/>
+              </a:rPr>
+              <a:t>8  One clean, common JSON format out</a:t>
+            </a:r>
+          </a:p>
+          <a:p>
+            <a:pPr algn="ctr"/>
+            <a:r>
+              <a:rPr sz="850" b="0">
+                <a:solidFill>
+                  <a:srgbClr val="EEF3FA"/>
+                </a:solidFill>
+                <a:latin typeface="Calibri"/>
+              </a:rPr>
+              <a:t>ready for SIEM, dashboards and search</a:t>
+            </a:r>
+          </a:p>
+        </p:txBody>
+      </p:sp>
+      <p:sp>
+        <p:nvSpPr>
+          <p:cNvPr id="163" name="Rounded Rectangle 162"/>
+          <p:cNvSpPr/>
+          <p:nvPr/>
+        </p:nvSpPr>
+        <p:spPr>
+          <a:xfrm>
+            <a:off x="9326880" y="1993392"/>
+            <a:ext cx="2377440" cy="1481328"/>
+          </a:xfrm>
+          <a:prstGeom prst="roundRect">
+            <a:avLst>
+              <a:gd name="adj" fmla="val 6000"/>
+            </a:avLst>
+          </a:prstGeom>
+          <a:solidFill>
+            <a:srgbClr val="E8F5EC"/>
+          </a:solidFill>
+          <a:ln w="15875">
+            <a:solidFill>
+              <a:srgbClr val="138A36"/>
+            </a:solidFill>
+          </a:ln>
+          <a:effectLst/>
+        </p:spPr>
+        <p:style>
+          <a:lnRef idx="1">
+            <a:schemeClr val="accent1"/>
+          </a:lnRef>
+          <a:fillRef idx="3">
+            <a:schemeClr val="accent1"/>
+          </a:fillRef>
+          <a:effectRef idx="2">
+            <a:schemeClr val="accent1"/>
+          </a:effectRef>
+          <a:fontRef idx="minor">
+            <a:schemeClr val="lt1"/>
+          </a:fontRef>
+        </p:style>
+        <p:txBody>
+          <a:bodyPr rtlCol="0" anchor="ctr"/>
+          <a:lstStyle/>
+          <a:p>
+            <a:pPr algn="ctr"/>
+          </a:p>
+        </p:txBody>
+      </p:sp>
+      <p:sp>
+        <p:nvSpPr>
+          <p:cNvPr id="164" name="TextBox 163"/>
+          <p:cNvSpPr txBox="1"/>
+          <p:nvPr/>
+        </p:nvSpPr>
+        <p:spPr>
+          <a:xfrm>
+            <a:off x="9400032" y="1993392"/>
+            <a:ext cx="2231136" cy="1481328"/>
+          </a:xfrm>
+          <a:prstGeom prst="rect">
+            <a:avLst/>
+          </a:prstGeom>
+          <a:noFill/>
+        </p:spPr>
+        <p:txBody>
+          <a:bodyPr wrap="square" lIns="45720" rIns="45720" tIns="9144" bIns="9144" anchor="ctr">
+            <a:spAutoFit/>
+          </a:bodyPr>
+          <a:lstStyle/>
+          <a:p>
+            <a:pPr algn="ctr"/>
+            <a:r>
+              <a:rPr sz="1300" b="1">
+                <a:solidFill>
+                  <a:srgbClr val="138A36"/>
+                </a:solidFill>
+                <a:latin typeface="Calibri"/>
+              </a:rPr>
+              <a:t>FAST PATH</a:t>
+            </a:r>
+          </a:p>
+          <a:p>
+            <a:pPr algn="ctr"/>
+            <a:r>
+              <a:rPr sz="950" b="0">
+                <a:solidFill>
+                  <a:srgbClr val="1E2530"/>
+                </a:solidFill>
+                <a:latin typeface="Calibri"/>
+              </a:rPr>
+              <a:t>most logs take this route</a:t>
+            </a:r>
+          </a:p>
+          <a:p>
+            <a:pPr algn="ctr"/>
+            <a:r>
+              <a:rPr sz="400" b="0">
+                <a:solidFill>
+                  <a:srgbClr val="1E2530"/>
+                </a:solidFill>
+                <a:latin typeface="Calibri"/>
+              </a:rPr>
+              <a:t> </a:t>
+            </a:r>
+          </a:p>
+          <a:p>
+            <a:pPr algn="ctr"/>
+            <a:r>
+              <a:rPr sz="950" b="0">
+                <a:solidFill>
+                  <a:srgbClr val="1E2530"/>
+                </a:solidFill>
+                <a:latin typeface="Calibri"/>
+              </a:rPr>
+              <a:t>saved rule applied instantly</a:t>
+            </a:r>
+          </a:p>
+          <a:p>
+            <a:pPr algn="ctr"/>
+            <a:r>
+              <a:rPr sz="950" b="0">
+                <a:solidFill>
+                  <a:srgbClr val="1E2530"/>
+                </a:solidFill>
+                <a:latin typeface="Calibri"/>
+              </a:rPr>
+              <a:t>no AI call · no waiting · no cost</a:t>
+            </a:r>
+          </a:p>
+        </p:txBody>
+      </p:sp>
+      <p:sp>
+        <p:nvSpPr>
+          <p:cNvPr id="165" name="Rounded Rectangle 164"/>
+          <p:cNvSpPr/>
+          <p:nvPr/>
+        </p:nvSpPr>
+        <p:spPr>
+          <a:xfrm>
+            <a:off x="9326880" y="3584448"/>
+            <a:ext cx="1920240" cy="1481328"/>
+          </a:xfrm>
+          <a:prstGeom prst="roundRect">
+            <a:avLst>
+              <a:gd name="adj" fmla="val 8000"/>
+            </a:avLst>
+          </a:prstGeom>
+          <a:solidFill>
+            <a:srgbClr val="FFF4E8"/>
+          </a:solidFill>
+          <a:ln w="12700">
+            <a:solidFill>
+              <a:srgbClr val="F28322"/>
+            </a:solidFill>
+          </a:ln>
+          <a:effectLst/>
+        </p:spPr>
+        <p:style>
+          <a:lnRef idx="1">
+            <a:schemeClr val="accent1"/>
+          </a:lnRef>
+          <a:fillRef idx="3">
+            <a:schemeClr val="accent1"/>
+          </a:fillRef>
+          <a:effectRef idx="2">
+            <a:schemeClr val="accent1"/>
+          </a:effectRef>
+          <a:fontRef idx="minor">
+            <a:schemeClr val="lt1"/>
+          </a:fontRef>
+        </p:style>
+        <p:txBody>
+          <a:bodyPr rtlCol="0" anchor="ctr"/>
+          <a:lstStyle/>
+          <a:p>
+            <a:pPr algn="ctr"/>
+          </a:p>
+        </p:txBody>
+      </p:sp>
+      <p:sp>
+        <p:nvSpPr>
+          <p:cNvPr id="166" name="TextBox 165"/>
+          <p:cNvSpPr txBox="1"/>
+          <p:nvPr/>
+        </p:nvSpPr>
+        <p:spPr>
+          <a:xfrm>
+            <a:off x="9363456" y="3584448"/>
+            <a:ext cx="1847088" cy="1481328"/>
+          </a:xfrm>
+          <a:prstGeom prst="rect">
+            <a:avLst/>
+          </a:prstGeom>
+          <a:noFill/>
+        </p:spPr>
+        <p:txBody>
+          <a:bodyPr wrap="square" lIns="45720" rIns="45720" tIns="9144" bIns="9144" anchor="ctr">
+            <a:spAutoFit/>
+          </a:bodyPr>
+          <a:lstStyle/>
+          <a:p>
+            <a:pPr algn="ctr"/>
+            <a:r>
+              <a:rPr sz="1100" b="1">
+                <a:solidFill>
+                  <a:srgbClr val="C06010"/>
+                </a:solidFill>
+                <a:latin typeface="Calibri"/>
+              </a:rPr>
+              <a:t>AI PATH</a:t>
+            </a:r>
+          </a:p>
+          <a:p>
+            <a:pPr algn="ctr"/>
+            <a:r>
+              <a:rPr sz="900" b="0">
+                <a:solidFill>
+                  <a:srgbClr val="1E2530"/>
+                </a:solidFill>
+                <a:latin typeface="Calibri"/>
+              </a:rPr>
+              <a:t>used only when a format is new</a:t>
+            </a:r>
+          </a:p>
+          <a:p>
+            <a:pPr algn="ctr"/>
+            <a:r>
+              <a:rPr sz="900" b="0">
+                <a:solidFill>
+                  <a:srgbClr val="1E2530"/>
+                </a:solidFill>
+                <a:latin typeface="Calibri"/>
+              </a:rPr>
+              <a:t>rule learned once, then it</a:t>
+            </a:r>
+          </a:p>
+          <a:p>
+            <a:pPr algn="ctr"/>
+            <a:r>
+              <a:rPr sz="900" b="0">
+                <a:solidFill>
+                  <a:srgbClr val="1E2530"/>
+                </a:solidFill>
+                <a:latin typeface="Calibri"/>
+              </a:rPr>
+              <a:t>joins the fast path</a:t>
+            </a:r>
+          </a:p>
+          <a:p>
+            <a:pPr algn="ctr"/>
+            <a:r>
+              <a:rPr sz="400" b="0">
+                <a:solidFill>
+                  <a:srgbClr val="1E2530"/>
+                </a:solidFill>
+                <a:latin typeface="Calibri"/>
+              </a:rPr>
+              <a:t> </a:t>
+            </a:r>
+          </a:p>
+          <a:p>
+            <a:pPr algn="ctr"/>
+            <a:r>
+              <a:rPr sz="900" b="0">
+                <a:solidFill>
+                  <a:srgbClr val="1E2530"/>
+                </a:solidFill>
+                <a:latin typeface="Calibri"/>
+              </a:rPr>
+              <a:t>AI down? backup AI, then</a:t>
+            </a:r>
+          </a:p>
+          <a:p>
+            <a:pPr algn="ctr"/>
+            <a:r>
+              <a:rPr sz="900" b="0">
+                <a:solidFill>
+                  <a:srgbClr val="1E2530"/>
+                </a:solidFill>
+                <a:latin typeface="Calibri"/>
+              </a:rPr>
+              <a:t>built-in rules take over</a:t>
+            </a:r>
+          </a:p>
+        </p:txBody>
+      </p:sp>
+      <p:cxnSp>
+        <p:nvCxnSpPr>
+          <p:cNvPr id="167" name="Connector 166"/>
+          <p:cNvCxnSpPr/>
+          <p:nvPr/>
+        </p:nvCxnSpPr>
+        <p:spPr>
+          <a:xfrm>
+            <a:off x="7315200" y="1883664"/>
+            <a:ext cx="0" cy="109728"/>
+          </a:xfrm>
+          <a:prstGeom prst="line">
+            <a:avLst/>
+          </a:prstGeom>
+          <a:ln w="19050">
+            <a:solidFill>
+              <a:srgbClr val="5B6573"/>
+            </a:solidFill>
+            <a:tailEnd type="triangle" w="med" len="med"/>
+          </a:ln>
+        </p:spPr>
+        <p:style>
+          <a:lnRef idx="2">
+            <a:schemeClr val="accent1"/>
+          </a:lnRef>
+          <a:fillRef idx="0">
+            <a:schemeClr val="accent1"/>
+          </a:fillRef>
+          <a:effectRef idx="1">
+            <a:schemeClr val="accent1"/>
+          </a:effectRef>
+          <a:fontRef idx="minor">
+            <a:schemeClr val="tx1"/>
+          </a:fontRef>
+        </p:style>
+      </p:cxnSp>
+      <p:cxnSp>
+        <p:nvCxnSpPr>
+          <p:cNvPr id="168" name="Connector 167"/>
+          <p:cNvCxnSpPr/>
+          <p:nvPr/>
+        </p:nvCxnSpPr>
+        <p:spPr>
+          <a:xfrm>
+            <a:off x="7315200" y="2414016"/>
+            <a:ext cx="0" cy="109728"/>
+          </a:xfrm>
+          <a:prstGeom prst="line">
+            <a:avLst/>
+          </a:prstGeom>
+          <a:ln w="19050">
+            <a:solidFill>
+              <a:srgbClr val="5B6573"/>
+            </a:solidFill>
+            <a:tailEnd type="triangle" w="med" len="med"/>
+          </a:ln>
+        </p:spPr>
+        <p:style>
+          <a:lnRef idx="2">
+            <a:schemeClr val="accent1"/>
+          </a:lnRef>
+          <a:fillRef idx="0">
+            <a:schemeClr val="accent1"/>
+          </a:fillRef>
+          <a:effectRef idx="1">
+            <a:schemeClr val="accent1"/>
+          </a:effectRef>
+          <a:fontRef idx="minor">
+            <a:schemeClr val="tx1"/>
+          </a:fontRef>
+        </p:style>
+      </p:cxnSp>
+      <p:cxnSp>
+        <p:nvCxnSpPr>
+          <p:cNvPr id="169" name="Connector 168"/>
+          <p:cNvCxnSpPr/>
+          <p:nvPr/>
+        </p:nvCxnSpPr>
+        <p:spPr>
+          <a:xfrm>
+            <a:off x="7315200" y="2944368"/>
+            <a:ext cx="0" cy="109728"/>
+          </a:xfrm>
+          <a:prstGeom prst="line">
+            <a:avLst/>
+          </a:prstGeom>
+          <a:ln w="19050">
+            <a:solidFill>
+              <a:srgbClr val="5B6573"/>
+            </a:solidFill>
+            <a:tailEnd type="triangle" w="med" len="med"/>
+          </a:ln>
+        </p:spPr>
+        <p:style>
+          <a:lnRef idx="2">
+            <a:schemeClr val="accent1"/>
+          </a:lnRef>
+          <a:fillRef idx="0">
+            <a:schemeClr val="accent1"/>
+          </a:fillRef>
+          <a:effectRef idx="1">
+            <a:schemeClr val="accent1"/>
+          </a:effectRef>
+          <a:fontRef idx="minor">
+            <a:schemeClr val="tx1"/>
+          </a:fontRef>
+        </p:style>
+      </p:cxnSp>
+      <p:cxnSp>
+        <p:nvCxnSpPr>
+          <p:cNvPr id="170" name="Connector 169"/>
+          <p:cNvCxnSpPr/>
+          <p:nvPr/>
+        </p:nvCxnSpPr>
+        <p:spPr>
+          <a:xfrm>
+            <a:off x="7315200" y="3474720"/>
+            <a:ext cx="0" cy="109728"/>
+          </a:xfrm>
+          <a:prstGeom prst="line">
+            <a:avLst/>
+          </a:prstGeom>
+          <a:ln w="19050">
+            <a:solidFill>
+              <a:srgbClr val="5B6573"/>
+            </a:solidFill>
+            <a:tailEnd type="triangle" w="med" len="med"/>
+          </a:ln>
+        </p:spPr>
+        <p:style>
+          <a:lnRef idx="2">
+            <a:schemeClr val="accent1"/>
+          </a:lnRef>
+          <a:fillRef idx="0">
+            <a:schemeClr val="accent1"/>
+          </a:fillRef>
+          <a:effectRef idx="1">
+            <a:schemeClr val="accent1"/>
+          </a:effectRef>
+          <a:fontRef idx="minor">
+            <a:schemeClr val="tx1"/>
+          </a:fontRef>
+        </p:style>
+      </p:cxnSp>
+      <p:sp>
+        <p:nvSpPr>
+          <p:cNvPr id="171" name="TextBox 170"/>
+          <p:cNvSpPr txBox="1"/>
+          <p:nvPr/>
+        </p:nvSpPr>
+        <p:spPr>
+          <a:xfrm>
+            <a:off x="7370064" y="2404872"/>
+            <a:ext cx="822960" cy="182880"/>
+          </a:xfrm>
+          <a:prstGeom prst="rect">
+            <a:avLst/>
+          </a:prstGeom>
+          <a:noFill/>
+        </p:spPr>
+        <p:txBody>
+          <a:bodyPr wrap="square" lIns="18288" rIns="18288" tIns="9144" bIns="9144" anchor="ctr">
+            <a:spAutoFit/>
+          </a:bodyPr>
+          <a:lstStyle/>
+          <a:p>
+            <a:pPr algn="l"/>
+            <a:r>
+              <a:rPr sz="800" b="1">
+                <a:solidFill>
+                  <a:srgbClr val="C0392B"/>
+                </a:solidFill>
+                <a:latin typeface="Calibri"/>
+              </a:rPr>
+              <a:t>No</a:t>
+            </a:r>
+          </a:p>
+        </p:txBody>
+      </p:sp>
+      <p:sp>
+        <p:nvSpPr>
+          <p:cNvPr id="172" name="TextBox 171"/>
+          <p:cNvSpPr txBox="1"/>
+          <p:nvPr/>
+        </p:nvSpPr>
+        <p:spPr>
+          <a:xfrm>
+            <a:off x="7370064" y="3465576"/>
+            <a:ext cx="822960" cy="182880"/>
+          </a:xfrm>
+          <a:prstGeom prst="rect">
+            <a:avLst/>
+          </a:prstGeom>
+          <a:noFill/>
+        </p:spPr>
+        <p:txBody>
+          <a:bodyPr wrap="square" lIns="18288" rIns="18288" tIns="9144" bIns="9144" anchor="ctr">
+            <a:spAutoFit/>
+          </a:bodyPr>
+          <a:lstStyle/>
+          <a:p>
+            <a:pPr algn="l"/>
+            <a:r>
+              <a:rPr sz="800" b="1">
+                <a:solidFill>
+                  <a:srgbClr val="C0392B"/>
+                </a:solidFill>
+                <a:latin typeface="Calibri"/>
+              </a:rPr>
+              <a:t>No</a:t>
+            </a:r>
+          </a:p>
+        </p:txBody>
+      </p:sp>
+      <p:cxnSp>
+        <p:nvCxnSpPr>
+          <p:cNvPr id="173" name="Connector 172"/>
+          <p:cNvCxnSpPr/>
+          <p:nvPr/>
+        </p:nvCxnSpPr>
+        <p:spPr>
+          <a:xfrm>
+            <a:off x="6492240" y="4005072"/>
+            <a:ext cx="0" cy="109728"/>
+          </a:xfrm>
+          <a:prstGeom prst="line">
+            <a:avLst/>
+          </a:prstGeom>
+          <a:ln w="19050">
+            <a:solidFill>
+              <a:srgbClr val="5B6573"/>
+            </a:solidFill>
+            <a:tailEnd type="triangle" w="med" len="med"/>
+          </a:ln>
+        </p:spPr>
+        <p:style>
+          <a:lnRef idx="2">
+            <a:schemeClr val="accent1"/>
+          </a:lnRef>
+          <a:fillRef idx="0">
+            <a:schemeClr val="accent1"/>
+          </a:fillRef>
+          <a:effectRef idx="1">
+            <a:schemeClr val="accent1"/>
+          </a:effectRef>
+          <a:fontRef idx="minor">
+            <a:schemeClr val="tx1"/>
+          </a:fontRef>
+        </p:style>
+      </p:cxnSp>
+      <p:cxnSp>
+        <p:nvCxnSpPr>
+          <p:cNvPr id="174" name="Connector 173"/>
+          <p:cNvCxnSpPr/>
+          <p:nvPr/>
+        </p:nvCxnSpPr>
+        <p:spPr>
+          <a:xfrm>
+            <a:off x="8138160" y="4005072"/>
+            <a:ext cx="0" cy="109728"/>
+          </a:xfrm>
+          <a:prstGeom prst="line">
+            <a:avLst/>
+          </a:prstGeom>
+          <a:ln w="19050">
+            <a:solidFill>
+              <a:srgbClr val="5B6573"/>
+            </a:solidFill>
+            <a:tailEnd type="triangle" w="med" len="med"/>
+          </a:ln>
+        </p:spPr>
+        <p:style>
+          <a:lnRef idx="2">
+            <a:schemeClr val="accent1"/>
+          </a:lnRef>
+          <a:fillRef idx="0">
+            <a:schemeClr val="accent1"/>
+          </a:fillRef>
+          <a:effectRef idx="1">
+            <a:schemeClr val="accent1"/>
+          </a:effectRef>
+          <a:fontRef idx="minor">
+            <a:schemeClr val="tx1"/>
+          </a:fontRef>
+        </p:style>
+      </p:cxnSp>
+      <p:sp>
+        <p:nvSpPr>
+          <p:cNvPr id="175" name="TextBox 174"/>
+          <p:cNvSpPr txBox="1"/>
+          <p:nvPr/>
+        </p:nvSpPr>
+        <p:spPr>
+          <a:xfrm>
+            <a:off x="6537960" y="3995928"/>
+            <a:ext cx="822960" cy="182880"/>
+          </a:xfrm>
+          <a:prstGeom prst="rect">
+            <a:avLst/>
+          </a:prstGeom>
+          <a:noFill/>
+        </p:spPr>
+        <p:txBody>
+          <a:bodyPr wrap="square" lIns="18288" rIns="18288" tIns="9144" bIns="9144" anchor="ctr">
+            <a:spAutoFit/>
+          </a:bodyPr>
+          <a:lstStyle/>
+          <a:p>
+            <a:pPr algn="l"/>
+            <a:r>
+              <a:rPr sz="750" b="1">
+                <a:solidFill>
+                  <a:srgbClr val="6A3FB5"/>
+                </a:solidFill>
+                <a:latin typeface="Calibri"/>
+              </a:rPr>
+              <a:t>known</a:t>
+            </a:r>
+          </a:p>
+        </p:txBody>
+      </p:sp>
+      <p:sp>
+        <p:nvSpPr>
+          <p:cNvPr id="176" name="TextBox 175"/>
+          <p:cNvSpPr txBox="1"/>
+          <p:nvPr/>
+        </p:nvSpPr>
+        <p:spPr>
+          <a:xfrm>
+            <a:off x="8183880" y="3995928"/>
+            <a:ext cx="822960" cy="182880"/>
+          </a:xfrm>
+          <a:prstGeom prst="rect">
+            <a:avLst/>
+          </a:prstGeom>
+          <a:noFill/>
+        </p:spPr>
+        <p:txBody>
+          <a:bodyPr wrap="square" lIns="18288" rIns="18288" tIns="9144" bIns="9144" anchor="ctr">
+            <a:spAutoFit/>
+          </a:bodyPr>
+          <a:lstStyle/>
+          <a:p>
+            <a:pPr algn="l"/>
+            <a:r>
+              <a:rPr sz="750" b="1">
+                <a:solidFill>
+                  <a:srgbClr val="6A3FB5"/>
+                </a:solidFill>
+                <a:latin typeface="Calibri"/>
+              </a:rPr>
+              <a:t>brand-new</a:t>
+            </a:r>
+          </a:p>
+        </p:txBody>
+      </p:sp>
+      <p:cxnSp>
+        <p:nvCxnSpPr>
+          <p:cNvPr id="177" name="Connector 176"/>
+          <p:cNvCxnSpPr/>
+          <p:nvPr/>
+        </p:nvCxnSpPr>
+        <p:spPr>
+          <a:xfrm>
+            <a:off x="6492240" y="4535424"/>
+            <a:ext cx="0" cy="109728"/>
+          </a:xfrm>
+          <a:prstGeom prst="line">
+            <a:avLst/>
+          </a:prstGeom>
+          <a:ln w="19050">
+            <a:solidFill>
+              <a:srgbClr val="5B6573"/>
+            </a:solidFill>
+            <a:tailEnd type="triangle" w="med" len="med"/>
+          </a:ln>
+        </p:spPr>
+        <p:style>
+          <a:lnRef idx="2">
+            <a:schemeClr val="accent1"/>
+          </a:lnRef>
+          <a:fillRef idx="0">
+            <a:schemeClr val="accent1"/>
+          </a:fillRef>
+          <a:effectRef idx="1">
+            <a:schemeClr val="accent1"/>
+          </a:effectRef>
+          <a:fontRef idx="minor">
+            <a:schemeClr val="tx1"/>
+          </a:fontRef>
+        </p:style>
+      </p:cxnSp>
+      <p:cxnSp>
+        <p:nvCxnSpPr>
+          <p:cNvPr id="178" name="Connector 177"/>
+          <p:cNvCxnSpPr/>
+          <p:nvPr/>
+        </p:nvCxnSpPr>
+        <p:spPr>
+          <a:xfrm>
+            <a:off x="8138160" y="4535424"/>
+            <a:ext cx="0" cy="109728"/>
+          </a:xfrm>
+          <a:prstGeom prst="line">
+            <a:avLst/>
+          </a:prstGeom>
+          <a:ln w="19050">
+            <a:solidFill>
+              <a:srgbClr val="5B6573"/>
+            </a:solidFill>
+            <a:tailEnd type="triangle" w="med" len="med"/>
+          </a:ln>
+        </p:spPr>
+        <p:style>
+          <a:lnRef idx="2">
+            <a:schemeClr val="accent1"/>
+          </a:lnRef>
+          <a:fillRef idx="0">
+            <a:schemeClr val="accent1"/>
+          </a:fillRef>
+          <a:effectRef idx="1">
+            <a:schemeClr val="accent1"/>
+          </a:effectRef>
+          <a:fontRef idx="minor">
+            <a:schemeClr val="tx1"/>
+          </a:fontRef>
+        </p:style>
+      </p:cxnSp>
+      <p:cxnSp>
+        <p:nvCxnSpPr>
+          <p:cNvPr id="179" name="Connector 178"/>
+          <p:cNvCxnSpPr/>
+          <p:nvPr/>
+        </p:nvCxnSpPr>
+        <p:spPr>
+          <a:xfrm>
+            <a:off x="7315200" y="5065776"/>
+            <a:ext cx="0" cy="109728"/>
+          </a:xfrm>
+          <a:prstGeom prst="line">
+            <a:avLst/>
+          </a:prstGeom>
+          <a:ln w="19050">
+            <a:solidFill>
+              <a:srgbClr val="5B6573"/>
+            </a:solidFill>
+            <a:tailEnd type="triangle" w="med" len="med"/>
+          </a:ln>
+        </p:spPr>
+        <p:style>
+          <a:lnRef idx="2">
+            <a:schemeClr val="accent1"/>
+          </a:lnRef>
+          <a:fillRef idx="0">
+            <a:schemeClr val="accent1"/>
+          </a:fillRef>
+          <a:effectRef idx="1">
+            <a:schemeClr val="accent1"/>
+          </a:effectRef>
+          <a:fontRef idx="minor">
+            <a:schemeClr val="tx1"/>
+          </a:fontRef>
+        </p:style>
+      </p:cxnSp>
+      <p:cxnSp>
+        <p:nvCxnSpPr>
+          <p:cNvPr id="180" name="Connector 179"/>
+          <p:cNvCxnSpPr/>
+          <p:nvPr/>
+        </p:nvCxnSpPr>
+        <p:spPr>
+          <a:xfrm>
+            <a:off x="7315200" y="5596128"/>
+            <a:ext cx="0" cy="109728"/>
+          </a:xfrm>
+          <a:prstGeom prst="line">
+            <a:avLst/>
+          </a:prstGeom>
+          <a:ln w="19050">
+            <a:solidFill>
+              <a:srgbClr val="5B6573"/>
+            </a:solidFill>
+            <a:tailEnd type="triangle" w="med" len="med"/>
+          </a:ln>
+        </p:spPr>
+        <p:style>
+          <a:lnRef idx="2">
+            <a:schemeClr val="accent1"/>
+          </a:lnRef>
+          <a:fillRef idx="0">
+            <a:schemeClr val="accent1"/>
+          </a:fillRef>
+          <a:effectRef idx="1">
+            <a:schemeClr val="accent1"/>
+          </a:effectRef>
+          <a:fontRef idx="minor">
+            <a:schemeClr val="tx1"/>
+          </a:fontRef>
+        </p:style>
+      </p:cxnSp>
+      <p:cxnSp>
+        <p:nvCxnSpPr>
+          <p:cNvPr id="181" name="Connector 180"/>
+          <p:cNvCxnSpPr/>
+          <p:nvPr/>
+        </p:nvCxnSpPr>
+        <p:spPr>
+          <a:xfrm>
+            <a:off x="8915400" y="2203704"/>
+            <a:ext cx="411480" cy="0"/>
+          </a:xfrm>
+          <a:prstGeom prst="line">
+            <a:avLst/>
+          </a:prstGeom>
+          <a:ln w="22225">
+            <a:solidFill>
+              <a:srgbClr val="138A36"/>
+            </a:solidFill>
+            <a:tailEnd type="triangle" w="med" len="med"/>
+          </a:ln>
+        </p:spPr>
+        <p:style>
+          <a:lnRef idx="2">
+            <a:schemeClr val="accent1"/>
+          </a:lnRef>
+          <a:fillRef idx="0">
+            <a:schemeClr val="accent1"/>
+          </a:fillRef>
+          <a:effectRef idx="1">
+            <a:schemeClr val="accent1"/>
+          </a:effectRef>
+          <a:fontRef idx="minor">
+            <a:schemeClr val="tx1"/>
+          </a:fontRef>
+        </p:style>
+      </p:cxnSp>
+      <p:sp>
+        <p:nvSpPr>
+          <p:cNvPr id="182" name="TextBox 181"/>
+          <p:cNvSpPr txBox="1"/>
+          <p:nvPr/>
+        </p:nvSpPr>
+        <p:spPr>
+          <a:xfrm>
+            <a:off x="8988552" y="2020824"/>
+            <a:ext cx="365760" cy="182880"/>
+          </a:xfrm>
+          <a:prstGeom prst="rect">
+            <a:avLst/>
+          </a:prstGeom>
+          <a:noFill/>
+        </p:spPr>
+        <p:txBody>
+          <a:bodyPr wrap="square" lIns="18288" rIns="18288" tIns="9144" bIns="9144" anchor="ctr">
+            <a:spAutoFit/>
+          </a:bodyPr>
+          <a:lstStyle/>
+          <a:p>
+            <a:pPr algn="l"/>
+            <a:r>
+              <a:rPr sz="850" b="1">
+                <a:solidFill>
+                  <a:srgbClr val="138A36"/>
+                </a:solidFill>
+                <a:latin typeface="Calibri"/>
+              </a:rPr>
+              <a:t>Yes</a:t>
+            </a:r>
+          </a:p>
+        </p:txBody>
+      </p:sp>
+      <p:cxnSp>
+        <p:nvCxnSpPr>
+          <p:cNvPr id="183" name="Connector 182"/>
+          <p:cNvCxnSpPr/>
+          <p:nvPr/>
+        </p:nvCxnSpPr>
+        <p:spPr>
+          <a:xfrm>
+            <a:off x="8915400" y="3264408"/>
+            <a:ext cx="411480" cy="0"/>
+          </a:xfrm>
+          <a:prstGeom prst="line">
+            <a:avLst/>
+          </a:prstGeom>
+          <a:ln w="22225">
+            <a:solidFill>
+              <a:srgbClr val="138A36"/>
+            </a:solidFill>
+            <a:tailEnd type="triangle" w="med" len="med"/>
+          </a:ln>
+        </p:spPr>
+        <p:style>
+          <a:lnRef idx="2">
+            <a:schemeClr val="accent1"/>
+          </a:lnRef>
+          <a:fillRef idx="0">
+            <a:schemeClr val="accent1"/>
+          </a:fillRef>
+          <a:effectRef idx="1">
+            <a:schemeClr val="accent1"/>
+          </a:effectRef>
+          <a:fontRef idx="minor">
+            <a:schemeClr val="tx1"/>
+          </a:fontRef>
+        </p:style>
+      </p:cxnSp>
+      <p:sp>
+        <p:nvSpPr>
+          <p:cNvPr id="184" name="TextBox 183"/>
+          <p:cNvSpPr txBox="1"/>
+          <p:nvPr/>
+        </p:nvSpPr>
+        <p:spPr>
+          <a:xfrm>
+            <a:off x="8988552" y="3081528"/>
+            <a:ext cx="365760" cy="182880"/>
+          </a:xfrm>
+          <a:prstGeom prst="rect">
+            <a:avLst/>
+          </a:prstGeom>
+          <a:noFill/>
+        </p:spPr>
+        <p:txBody>
+          <a:bodyPr wrap="square" lIns="18288" rIns="18288" tIns="9144" bIns="9144" anchor="ctr">
+            <a:spAutoFit/>
+          </a:bodyPr>
+          <a:lstStyle/>
+          <a:p>
+            <a:pPr algn="l"/>
+            <a:r>
+              <a:rPr sz="850" b="1">
+                <a:solidFill>
+                  <a:srgbClr val="138A36"/>
+                </a:solidFill>
+                <a:latin typeface="Calibri"/>
+              </a:rPr>
+              <a:t>Yes</a:t>
+            </a:r>
+          </a:p>
+        </p:txBody>
+      </p:sp>
+      <p:cxnSp>
+        <p:nvCxnSpPr>
+          <p:cNvPr id="185" name="Connector 184"/>
+          <p:cNvCxnSpPr/>
+          <p:nvPr/>
+        </p:nvCxnSpPr>
+        <p:spPr>
+          <a:xfrm>
+            <a:off x="11503152" y="3474720"/>
+            <a:ext cx="0" cy="1700784"/>
+          </a:xfrm>
+          <a:prstGeom prst="line">
+            <a:avLst/>
+          </a:prstGeom>
+          <a:ln w="22225">
+            <a:solidFill>
+              <a:srgbClr val="138A36"/>
+            </a:solidFill>
+            <a:tailEnd type="triangle" w="med" len="med"/>
+          </a:ln>
+        </p:spPr>
+        <p:style>
+          <a:lnRef idx="2">
+            <a:schemeClr val="accent1"/>
+          </a:lnRef>
+          <a:fillRef idx="0">
+            <a:schemeClr val="accent1"/>
+          </a:fillRef>
+          <a:effectRef idx="1">
+            <a:schemeClr val="accent1"/>
+          </a:effectRef>
+          <a:fontRef idx="minor">
+            <a:schemeClr val="tx1"/>
+          </a:fontRef>
+        </p:style>
+      </p:cxnSp>
     </p:spTree>
   </p:cSld>
   <p:clrMapOvr>

</xml_diff>

<commit_message>
PPT: slide 3 flowchart redesigned with step cards, tech logos per step, fast lane and AI path
Co-authored-by: arena-agent <297053741+arena-agent@users.noreply.github.com>
</commit_message>
<xml_diff>
--- a/presentation/SIH2026_Idea_Submission.pptx
+++ b/presentation/SIH2026_Idea_Submission.pptx
@@ -14062,7 +14062,7 @@
             </a:avLst>
           </a:prstGeom>
           <a:solidFill>
-            <a:srgbClr val="F7F9FC"/>
+            <a:srgbClr val="F4F7FB"/>
           </a:solidFill>
           <a:ln w="12700">
             <a:solidFill>
@@ -14101,8 +14101,8 @@
         </p:nvSpPr>
         <p:spPr>
           <a:xfrm>
-            <a:off x="5669280" y="1106424"/>
-            <a:ext cx="3840480" cy="292608"/>
+            <a:off x="5669280" y="1115568"/>
+            <a:ext cx="3931920" cy="274320"/>
           </a:xfrm>
           <a:prstGeom prst="rect">
             <a:avLst/>
@@ -14110,13 +14110,13 @@
           <a:noFill/>
         </p:spPr>
         <p:txBody>
-          <a:bodyPr wrap="square" lIns="45720" rIns="45720" tIns="9144" bIns="9144" anchor="ctr">
+          <a:bodyPr wrap="square" lIns="36576" rIns="36576" tIns="0" bIns="0" anchor="ctr">
             <a:spAutoFit/>
           </a:bodyPr>
           <a:lstStyle/>
           <a:p>
             <a:r>
-              <a:rPr sz="1300" b="1">
+              <a:rPr sz="1300" b="1" i="0">
                 <a:solidFill>
                   <a:srgbClr val="1F5FBF"/>
                 </a:solidFill>
@@ -14129,19 +14129,1912 @@
       </p:sp>
       <p:sp>
         <p:nvSpPr>
-          <p:cNvPr id="139" name="Rounded Rectangle 138"/>
+          <p:cNvPr id="139" name="TextBox 138"/>
+          <p:cNvSpPr txBox="1"/>
+          <p:nvPr/>
+        </p:nvSpPr>
+        <p:spPr>
+          <a:xfrm>
+            <a:off x="5669280" y="1362456"/>
+            <a:ext cx="4206240" cy="182880"/>
+          </a:xfrm>
+          <a:prstGeom prst="rect">
+            <a:avLst/>
+          </a:prstGeom>
+          <a:noFill/>
+        </p:spPr>
+        <p:txBody>
+          <a:bodyPr wrap="square" lIns="36576" rIns="36576" tIns="0" bIns="0" anchor="ctr">
+            <a:spAutoFit/>
+          </a:bodyPr>
+          <a:lstStyle/>
+          <a:p>
+            <a:r>
+              <a:rPr sz="850" b="0" i="1">
+                <a:solidFill>
+                  <a:srgbClr val="5B6573"/>
+                </a:solidFill>
+                <a:latin typeface="Calibri"/>
+              </a:rPr>
+              <a:t>Follow the numbers. Logos show the technology used in each step.</a:t>
+            </a:r>
+          </a:p>
+        </p:txBody>
+      </p:sp>
+      <p:sp>
+        <p:nvSpPr>
+          <p:cNvPr id="140" name="Rounded Rectangle 139"/>
           <p:cNvSpPr/>
           <p:nvPr/>
         </p:nvSpPr>
         <p:spPr>
           <a:xfrm>
-            <a:off x="9601200" y="1179576"/>
-            <a:ext cx="201168" cy="128016"/>
+            <a:off x="5669280" y="1572768"/>
+            <a:ext cx="4096512" cy="420624"/>
           </a:xfrm>
           <a:prstGeom prst="roundRect">
             <a:avLst>
-              <a:gd name="adj" fmla="val 30000"/>
+              <a:gd name="adj" fmla="val 14000"/>
             </a:avLst>
+          </a:prstGeom>
+          <a:solidFill>
+            <a:srgbClr val="FFFFFF"/>
+          </a:solidFill>
+          <a:ln w="9525">
+            <a:solidFill>
+              <a:srgbClr val="D5DCE6"/>
+            </a:solidFill>
+          </a:ln>
+          <a:effectLst/>
+        </p:spPr>
+        <p:style>
+          <a:lnRef idx="1">
+            <a:schemeClr val="accent1"/>
+          </a:lnRef>
+          <a:fillRef idx="3">
+            <a:schemeClr val="accent1"/>
+          </a:fillRef>
+          <a:effectRef idx="2">
+            <a:schemeClr val="accent1"/>
+          </a:effectRef>
+          <a:fontRef idx="minor">
+            <a:schemeClr val="lt1"/>
+          </a:fontRef>
+        </p:style>
+        <p:txBody>
+          <a:bodyPr rtlCol="0" anchor="ctr"/>
+          <a:lstStyle/>
+          <a:p>
+            <a:pPr algn="ctr"/>
+          </a:p>
+        </p:txBody>
+      </p:sp>
+      <p:sp>
+        <p:nvSpPr>
+          <p:cNvPr id="141" name="Rectangle 140"/>
+          <p:cNvSpPr/>
+          <p:nvPr/>
+        </p:nvSpPr>
+        <p:spPr>
+          <a:xfrm>
+            <a:off x="5669280" y="1609344"/>
+            <a:ext cx="54864" cy="347472"/>
+          </a:xfrm>
+          <a:prstGeom prst="rect">
+            <a:avLst/>
+          </a:prstGeom>
+          <a:solidFill>
+            <a:srgbClr val="4A5568"/>
+          </a:solidFill>
+          <a:ln>
+            <a:noFill/>
+          </a:ln>
+          <a:effectLst/>
+        </p:spPr>
+        <p:style>
+          <a:lnRef idx="1">
+            <a:schemeClr val="accent1"/>
+          </a:lnRef>
+          <a:fillRef idx="3">
+            <a:schemeClr val="accent1"/>
+          </a:fillRef>
+          <a:effectRef idx="2">
+            <a:schemeClr val="accent1"/>
+          </a:effectRef>
+          <a:fontRef idx="minor">
+            <a:schemeClr val="lt1"/>
+          </a:fontRef>
+        </p:style>
+        <p:txBody>
+          <a:bodyPr rtlCol="0" anchor="ctr"/>
+          <a:lstStyle/>
+          <a:p>
+            <a:pPr algn="ctr"/>
+          </a:p>
+        </p:txBody>
+      </p:sp>
+      <p:sp>
+        <p:nvSpPr>
+          <p:cNvPr id="142" name="Oval 141"/>
+          <p:cNvSpPr/>
+          <p:nvPr/>
+        </p:nvSpPr>
+        <p:spPr>
+          <a:xfrm>
+            <a:off x="5788152" y="1636776"/>
+            <a:ext cx="292608" cy="292608"/>
+          </a:xfrm>
+          <a:prstGeom prst="ellipse">
+            <a:avLst/>
+          </a:prstGeom>
+          <a:solidFill>
+            <a:srgbClr val="4A5568"/>
+          </a:solidFill>
+          <a:ln>
+            <a:noFill/>
+          </a:ln>
+          <a:effectLst/>
+        </p:spPr>
+        <p:style>
+          <a:lnRef idx="1">
+            <a:schemeClr val="accent1"/>
+          </a:lnRef>
+          <a:fillRef idx="3">
+            <a:schemeClr val="accent1"/>
+          </a:fillRef>
+          <a:effectRef idx="2">
+            <a:schemeClr val="accent1"/>
+          </a:effectRef>
+          <a:fontRef idx="minor">
+            <a:schemeClr val="lt1"/>
+          </a:fontRef>
+        </p:style>
+        <p:txBody>
+          <a:bodyPr rtlCol="0" anchor="ctr" lIns="0" rIns="0" tIns="0" bIns="0"/>
+          <a:lstStyle/>
+          <a:p>
+            <a:pPr algn="ctr"/>
+            <a:r>
+              <a:rPr sz="1050" b="1" i="0">
+                <a:solidFill>
+                  <a:srgbClr val="FFFFFF"/>
+                </a:solidFill>
+                <a:latin typeface="Calibri"/>
+              </a:rPr>
+              <a:t>1</a:t>
+            </a:r>
+          </a:p>
+        </p:txBody>
+      </p:sp>
+      <p:sp>
+        <p:nvSpPr>
+          <p:cNvPr id="143" name="TextBox 142"/>
+          <p:cNvSpPr txBox="1"/>
+          <p:nvPr/>
+        </p:nvSpPr>
+        <p:spPr>
+          <a:xfrm>
+            <a:off x="6144768" y="1591056"/>
+            <a:ext cx="2560320" cy="384048"/>
+          </a:xfrm>
+          <a:prstGeom prst="rect">
+            <a:avLst/>
+          </a:prstGeom>
+          <a:noFill/>
+        </p:spPr>
+        <p:txBody>
+          <a:bodyPr wrap="square" lIns="36576" rIns="36576" tIns="0" bIns="0" anchor="ctr">
+            <a:spAutoFit/>
+          </a:bodyPr>
+          <a:lstStyle/>
+          <a:p>
+            <a:r>
+              <a:rPr sz="1050" b="1" i="0">
+                <a:solidFill>
+                  <a:srgbClr val="4A5568"/>
+                </a:solidFill>
+                <a:latin typeface="Calibri"/>
+              </a:rPr>
+              <a:t>Logs arrive</a:t>
+            </a:r>
+          </a:p>
+          <a:p>
+            <a:r>
+              <a:rPr sz="850" b="0" i="0">
+                <a:solidFill>
+                  <a:srgbClr val="3A4250"/>
+                </a:solidFill>
+                <a:latin typeface="Calibri"/>
+              </a:rPr>
+              <a:t>Servers, apps &amp; firewalls send raw logs; multi-line errors joined</a:t>
+            </a:r>
+          </a:p>
+        </p:txBody>
+      </p:sp>
+      <p:pic>
+        <p:nvPicPr>
+          <p:cNvPr id="144" name="Picture 143" descr="image.png"/>
+          <p:cNvPicPr>
+            <a:picLocks noChangeAspect="1"/>
+          </p:cNvPicPr>
+          <p:nvPr/>
+        </p:nvPicPr>
+        <p:blipFill>
+          <a:blip r:embed="rId9"/>
+          <a:stretch>
+            <a:fillRect/>
+          </a:stretch>
+        </p:blipFill>
+        <p:spPr>
+          <a:xfrm>
+            <a:off x="8741664" y="1645920"/>
+            <a:ext cx="274320" cy="274320"/>
+          </a:xfrm>
+          <a:prstGeom prst="rect">
+            <a:avLst/>
+          </a:prstGeom>
+        </p:spPr>
+      </p:pic>
+      <p:pic>
+        <p:nvPicPr>
+          <p:cNvPr id="145" name="Picture 144" descr="image.png"/>
+          <p:cNvPicPr>
+            <a:picLocks noChangeAspect="1"/>
+          </p:cNvPicPr>
+          <p:nvPr/>
+        </p:nvPicPr>
+        <p:blipFill>
+          <a:blip r:embed="rId10"/>
+          <a:stretch>
+            <a:fillRect/>
+          </a:stretch>
+        </p:blipFill>
+        <p:spPr>
+          <a:xfrm>
+            <a:off x="9070848" y="1645920"/>
+            <a:ext cx="274320" cy="274320"/>
+          </a:xfrm>
+          <a:prstGeom prst="rect">
+            <a:avLst/>
+          </a:prstGeom>
+        </p:spPr>
+      </p:pic>
+      <p:pic>
+        <p:nvPicPr>
+          <p:cNvPr id="146" name="Picture 145" descr="image.png"/>
+          <p:cNvPicPr>
+            <a:picLocks noChangeAspect="1"/>
+          </p:cNvPicPr>
+          <p:nvPr/>
+        </p:nvPicPr>
+        <p:blipFill>
+          <a:blip r:embed="rId4"/>
+          <a:stretch>
+            <a:fillRect/>
+          </a:stretch>
+        </p:blipFill>
+        <p:spPr>
+          <a:xfrm>
+            <a:off x="9400032" y="1645920"/>
+            <a:ext cx="274320" cy="274320"/>
+          </a:xfrm>
+          <a:prstGeom prst="rect">
+            <a:avLst/>
+          </a:prstGeom>
+        </p:spPr>
+      </p:pic>
+      <p:sp>
+        <p:nvSpPr>
+          <p:cNvPr id="147" name="Rounded Rectangle 146"/>
+          <p:cNvSpPr/>
+          <p:nvPr/>
+        </p:nvSpPr>
+        <p:spPr>
+          <a:xfrm>
+            <a:off x="5669280" y="2084832"/>
+            <a:ext cx="4096512" cy="420624"/>
+          </a:xfrm>
+          <a:prstGeom prst="roundRect">
+            <a:avLst>
+              <a:gd name="adj" fmla="val 14000"/>
+            </a:avLst>
+          </a:prstGeom>
+          <a:solidFill>
+            <a:srgbClr val="FFFFFF"/>
+          </a:solidFill>
+          <a:ln w="9525">
+            <a:solidFill>
+              <a:srgbClr val="D5DCE6"/>
+            </a:solidFill>
+          </a:ln>
+          <a:effectLst/>
+        </p:spPr>
+        <p:style>
+          <a:lnRef idx="1">
+            <a:schemeClr val="accent1"/>
+          </a:lnRef>
+          <a:fillRef idx="3">
+            <a:schemeClr val="accent1"/>
+          </a:fillRef>
+          <a:effectRef idx="2">
+            <a:schemeClr val="accent1"/>
+          </a:effectRef>
+          <a:fontRef idx="minor">
+            <a:schemeClr val="lt1"/>
+          </a:fontRef>
+        </p:style>
+        <p:txBody>
+          <a:bodyPr rtlCol="0" anchor="ctr"/>
+          <a:lstStyle/>
+          <a:p>
+            <a:pPr algn="ctr"/>
+          </a:p>
+        </p:txBody>
+      </p:sp>
+      <p:sp>
+        <p:nvSpPr>
+          <p:cNvPr id="148" name="Rectangle 147"/>
+          <p:cNvSpPr/>
+          <p:nvPr/>
+        </p:nvSpPr>
+        <p:spPr>
+          <a:xfrm>
+            <a:off x="5669280" y="2121408"/>
+            <a:ext cx="54864" cy="347472"/>
+          </a:xfrm>
+          <a:prstGeom prst="rect">
+            <a:avLst/>
+          </a:prstGeom>
+          <a:solidFill>
+            <a:srgbClr val="1F5FBF"/>
+          </a:solidFill>
+          <a:ln>
+            <a:noFill/>
+          </a:ln>
+          <a:effectLst/>
+        </p:spPr>
+        <p:style>
+          <a:lnRef idx="1">
+            <a:schemeClr val="accent1"/>
+          </a:lnRef>
+          <a:fillRef idx="3">
+            <a:schemeClr val="accent1"/>
+          </a:fillRef>
+          <a:effectRef idx="2">
+            <a:schemeClr val="accent1"/>
+          </a:effectRef>
+          <a:fontRef idx="minor">
+            <a:schemeClr val="lt1"/>
+          </a:fontRef>
+        </p:style>
+        <p:txBody>
+          <a:bodyPr rtlCol="0" anchor="ctr"/>
+          <a:lstStyle/>
+          <a:p>
+            <a:pPr algn="ctr"/>
+          </a:p>
+        </p:txBody>
+      </p:sp>
+      <p:sp>
+        <p:nvSpPr>
+          <p:cNvPr id="149" name="Oval 148"/>
+          <p:cNvSpPr/>
+          <p:nvPr/>
+        </p:nvSpPr>
+        <p:spPr>
+          <a:xfrm>
+            <a:off x="5788152" y="2148840"/>
+            <a:ext cx="292608" cy="292608"/>
+          </a:xfrm>
+          <a:prstGeom prst="ellipse">
+            <a:avLst/>
+          </a:prstGeom>
+          <a:solidFill>
+            <a:srgbClr val="1F5FBF"/>
+          </a:solidFill>
+          <a:ln>
+            <a:noFill/>
+          </a:ln>
+          <a:effectLst/>
+        </p:spPr>
+        <p:style>
+          <a:lnRef idx="1">
+            <a:schemeClr val="accent1"/>
+          </a:lnRef>
+          <a:fillRef idx="3">
+            <a:schemeClr val="accent1"/>
+          </a:fillRef>
+          <a:effectRef idx="2">
+            <a:schemeClr val="accent1"/>
+          </a:effectRef>
+          <a:fontRef idx="minor">
+            <a:schemeClr val="lt1"/>
+          </a:fontRef>
+        </p:style>
+        <p:txBody>
+          <a:bodyPr rtlCol="0" anchor="ctr" lIns="0" rIns="0" tIns="0" bIns="0"/>
+          <a:lstStyle/>
+          <a:p>
+            <a:pPr algn="ctr"/>
+            <a:r>
+              <a:rPr sz="1050" b="1" i="0">
+                <a:solidFill>
+                  <a:srgbClr val="FFFFFF"/>
+                </a:solidFill>
+                <a:latin typeface="Calibri"/>
+              </a:rPr>
+              <a:t>2</a:t>
+            </a:r>
+          </a:p>
+        </p:txBody>
+      </p:sp>
+      <p:sp>
+        <p:nvSpPr>
+          <p:cNvPr id="150" name="TextBox 149"/>
+          <p:cNvSpPr txBox="1"/>
+          <p:nvPr/>
+        </p:nvSpPr>
+        <p:spPr>
+          <a:xfrm>
+            <a:off x="6144768" y="2103120"/>
+            <a:ext cx="3218688" cy="384048"/>
+          </a:xfrm>
+          <a:prstGeom prst="rect">
+            <a:avLst/>
+          </a:prstGeom>
+          <a:noFill/>
+        </p:spPr>
+        <p:txBody>
+          <a:bodyPr wrap="square" lIns="36576" rIns="36576" tIns="0" bIns="0" anchor="ctr">
+            <a:spAutoFit/>
+          </a:bodyPr>
+          <a:lstStyle/>
+          <a:p>
+            <a:r>
+              <a:rPr sz="1050" b="1" i="0">
+                <a:solidFill>
+                  <a:srgbClr val="1F5FBF"/>
+                </a:solidFill>
+                <a:latin typeface="Calibri"/>
+              </a:rPr>
+              <a:t>Seen this exact line before?</a:t>
+            </a:r>
+          </a:p>
+          <a:p>
+            <a:r>
+              <a:rPr sz="850" b="0" i="0">
+                <a:solidFill>
+                  <a:srgbClr val="3A4250"/>
+                </a:solidFill>
+                <a:latin typeface="Calibri"/>
+              </a:rPr>
+              <a:t>Instant match against saved line shapes</a:t>
+            </a:r>
+          </a:p>
+        </p:txBody>
+      </p:sp>
+      <p:pic>
+        <p:nvPicPr>
+          <p:cNvPr id="151" name="Picture 150" descr="image.png"/>
+          <p:cNvPicPr>
+            <a:picLocks noChangeAspect="1"/>
+          </p:cNvPicPr>
+          <p:nvPr/>
+        </p:nvPicPr>
+        <p:blipFill>
+          <a:blip r:embed="rId3"/>
+          <a:stretch>
+            <a:fillRect/>
+          </a:stretch>
+        </p:blipFill>
+        <p:spPr>
+          <a:xfrm>
+            <a:off x="9400032" y="2157984"/>
+            <a:ext cx="274320" cy="274320"/>
+          </a:xfrm>
+          <a:prstGeom prst="rect">
+            <a:avLst/>
+          </a:prstGeom>
+        </p:spPr>
+      </p:pic>
+      <p:sp>
+        <p:nvSpPr>
+          <p:cNvPr id="152" name="Rounded Rectangle 151"/>
+          <p:cNvSpPr/>
+          <p:nvPr/>
+        </p:nvSpPr>
+        <p:spPr>
+          <a:xfrm>
+            <a:off x="5669280" y="2596896"/>
+            <a:ext cx="4096512" cy="420624"/>
+          </a:xfrm>
+          <a:prstGeom prst="roundRect">
+            <a:avLst>
+              <a:gd name="adj" fmla="val 14000"/>
+            </a:avLst>
+          </a:prstGeom>
+          <a:solidFill>
+            <a:srgbClr val="FFFFFF"/>
+          </a:solidFill>
+          <a:ln w="9525">
+            <a:solidFill>
+              <a:srgbClr val="D5DCE6"/>
+            </a:solidFill>
+          </a:ln>
+          <a:effectLst/>
+        </p:spPr>
+        <p:style>
+          <a:lnRef idx="1">
+            <a:schemeClr val="accent1"/>
+          </a:lnRef>
+          <a:fillRef idx="3">
+            <a:schemeClr val="accent1"/>
+          </a:fillRef>
+          <a:effectRef idx="2">
+            <a:schemeClr val="accent1"/>
+          </a:effectRef>
+          <a:fontRef idx="minor">
+            <a:schemeClr val="lt1"/>
+          </a:fontRef>
+        </p:style>
+        <p:txBody>
+          <a:bodyPr rtlCol="0" anchor="ctr"/>
+          <a:lstStyle/>
+          <a:p>
+            <a:pPr algn="ctr"/>
+          </a:p>
+        </p:txBody>
+      </p:sp>
+      <p:sp>
+        <p:nvSpPr>
+          <p:cNvPr id="153" name="Rectangle 152"/>
+          <p:cNvSpPr/>
+          <p:nvPr/>
+        </p:nvSpPr>
+        <p:spPr>
+          <a:xfrm>
+            <a:off x="5669280" y="2633472"/>
+            <a:ext cx="54864" cy="347472"/>
+          </a:xfrm>
+          <a:prstGeom prst="rect">
+            <a:avLst/>
+          </a:prstGeom>
+          <a:solidFill>
+            <a:srgbClr val="2C7BB6"/>
+          </a:solidFill>
+          <a:ln>
+            <a:noFill/>
+          </a:ln>
+          <a:effectLst/>
+        </p:spPr>
+        <p:style>
+          <a:lnRef idx="1">
+            <a:schemeClr val="accent1"/>
+          </a:lnRef>
+          <a:fillRef idx="3">
+            <a:schemeClr val="accent1"/>
+          </a:fillRef>
+          <a:effectRef idx="2">
+            <a:schemeClr val="accent1"/>
+          </a:effectRef>
+          <a:fontRef idx="minor">
+            <a:schemeClr val="lt1"/>
+          </a:fontRef>
+        </p:style>
+        <p:txBody>
+          <a:bodyPr rtlCol="0" anchor="ctr"/>
+          <a:lstStyle/>
+          <a:p>
+            <a:pPr algn="ctr"/>
+          </a:p>
+        </p:txBody>
+      </p:sp>
+      <p:sp>
+        <p:nvSpPr>
+          <p:cNvPr id="154" name="Oval 153"/>
+          <p:cNvSpPr/>
+          <p:nvPr/>
+        </p:nvSpPr>
+        <p:spPr>
+          <a:xfrm>
+            <a:off x="5788152" y="2660904"/>
+            <a:ext cx="292608" cy="292608"/>
+          </a:xfrm>
+          <a:prstGeom prst="ellipse">
+            <a:avLst/>
+          </a:prstGeom>
+          <a:solidFill>
+            <a:srgbClr val="2C7BB6"/>
+          </a:solidFill>
+          <a:ln>
+            <a:noFill/>
+          </a:ln>
+          <a:effectLst/>
+        </p:spPr>
+        <p:style>
+          <a:lnRef idx="1">
+            <a:schemeClr val="accent1"/>
+          </a:lnRef>
+          <a:fillRef idx="3">
+            <a:schemeClr val="accent1"/>
+          </a:fillRef>
+          <a:effectRef idx="2">
+            <a:schemeClr val="accent1"/>
+          </a:effectRef>
+          <a:fontRef idx="minor">
+            <a:schemeClr val="lt1"/>
+          </a:fontRef>
+        </p:style>
+        <p:txBody>
+          <a:bodyPr rtlCol="0" anchor="ctr" lIns="0" rIns="0" tIns="0" bIns="0"/>
+          <a:lstStyle/>
+          <a:p>
+            <a:pPr algn="ctr"/>
+            <a:r>
+              <a:rPr sz="1050" b="1" i="0">
+                <a:solidFill>
+                  <a:srgbClr val="FFFFFF"/>
+                </a:solidFill>
+                <a:latin typeface="Calibri"/>
+              </a:rPr>
+              <a:t>3</a:t>
+            </a:r>
+          </a:p>
+        </p:txBody>
+      </p:sp>
+      <p:sp>
+        <p:nvSpPr>
+          <p:cNvPr id="155" name="TextBox 154"/>
+          <p:cNvSpPr txBox="1"/>
+          <p:nvPr/>
+        </p:nvSpPr>
+        <p:spPr>
+          <a:xfrm>
+            <a:off x="6144768" y="2615184"/>
+            <a:ext cx="3218688" cy="384048"/>
+          </a:xfrm>
+          <a:prstGeom prst="rect">
+            <a:avLst/>
+          </a:prstGeom>
+          <a:noFill/>
+        </p:spPr>
+        <p:txBody>
+          <a:bodyPr wrap="square" lIns="36576" rIns="36576" tIns="0" bIns="0" anchor="ctr">
+            <a:spAutoFit/>
+          </a:bodyPr>
+          <a:lstStyle/>
+          <a:p>
+            <a:r>
+              <a:rPr sz="1050" b="1" i="0">
+                <a:solidFill>
+                  <a:srgbClr val="2C7BB6"/>
+                </a:solidFill>
+                <a:latin typeface="Calibri"/>
+              </a:rPr>
+              <a:t>Group similar lines</a:t>
+            </a:r>
+          </a:p>
+          <a:p>
+            <a:r>
+              <a:rPr sz="850" b="0" i="0">
+                <a:solidFill>
+                  <a:srgbClr val="3A4250"/>
+                </a:solidFill>
+                <a:latin typeface="Calibri"/>
+              </a:rPr>
+              <a:t>Lines differing only in values (IP, time, ID) become one pattern</a:t>
+            </a:r>
+          </a:p>
+        </p:txBody>
+      </p:sp>
+      <p:sp>
+        <p:nvSpPr>
+          <p:cNvPr id="156" name="Oval 155"/>
+          <p:cNvSpPr/>
+          <p:nvPr/>
+        </p:nvSpPr>
+        <p:spPr>
+          <a:xfrm>
+            <a:off x="9400032" y="2670048"/>
+            <a:ext cx="274320" cy="274320"/>
+          </a:xfrm>
+          <a:prstGeom prst="ellipse">
+            <a:avLst/>
+          </a:prstGeom>
+          <a:solidFill>
+            <a:srgbClr val="0B2A5B"/>
+          </a:solidFill>
+          <a:ln>
+            <a:noFill/>
+          </a:ln>
+          <a:effectLst/>
+        </p:spPr>
+        <p:style>
+          <a:lnRef idx="1">
+            <a:schemeClr val="accent1"/>
+          </a:lnRef>
+          <a:fillRef idx="3">
+            <a:schemeClr val="accent1"/>
+          </a:fillRef>
+          <a:effectRef idx="2">
+            <a:schemeClr val="accent1"/>
+          </a:effectRef>
+          <a:fontRef idx="minor">
+            <a:schemeClr val="lt1"/>
+          </a:fontRef>
+        </p:style>
+        <p:txBody>
+          <a:bodyPr rtlCol="0" anchor="ctr" lIns="0" rIns="0" tIns="0" bIns="0"/>
+          <a:lstStyle/>
+          <a:p>
+            <a:pPr algn="ctr"/>
+            <a:r>
+              <a:rPr sz="800" b="1" i="0">
+                <a:solidFill>
+                  <a:srgbClr val="FFFFFF"/>
+                </a:solidFill>
+                <a:latin typeface="Calibri"/>
+              </a:rPr>
+              <a:t>D3</a:t>
+            </a:r>
+          </a:p>
+        </p:txBody>
+      </p:sp>
+      <p:sp>
+        <p:nvSpPr>
+          <p:cNvPr id="157" name="Rounded Rectangle 156"/>
+          <p:cNvSpPr/>
+          <p:nvPr/>
+        </p:nvSpPr>
+        <p:spPr>
+          <a:xfrm>
+            <a:off x="5669280" y="3108960"/>
+            <a:ext cx="4096512" cy="420624"/>
+          </a:xfrm>
+          <a:prstGeom prst="roundRect">
+            <a:avLst>
+              <a:gd name="adj" fmla="val 14000"/>
+            </a:avLst>
+          </a:prstGeom>
+          <a:solidFill>
+            <a:srgbClr val="FFFFFF"/>
+          </a:solidFill>
+          <a:ln w="9525">
+            <a:solidFill>
+              <a:srgbClr val="D5DCE6"/>
+            </a:solidFill>
+          </a:ln>
+          <a:effectLst/>
+        </p:spPr>
+        <p:style>
+          <a:lnRef idx="1">
+            <a:schemeClr val="accent1"/>
+          </a:lnRef>
+          <a:fillRef idx="3">
+            <a:schemeClr val="accent1"/>
+          </a:fillRef>
+          <a:effectRef idx="2">
+            <a:schemeClr val="accent1"/>
+          </a:effectRef>
+          <a:fontRef idx="minor">
+            <a:schemeClr val="lt1"/>
+          </a:fontRef>
+        </p:style>
+        <p:txBody>
+          <a:bodyPr rtlCol="0" anchor="ctr"/>
+          <a:lstStyle/>
+          <a:p>
+            <a:pPr algn="ctr"/>
+          </a:p>
+        </p:txBody>
+      </p:sp>
+      <p:sp>
+        <p:nvSpPr>
+          <p:cNvPr id="158" name="Rectangle 157"/>
+          <p:cNvSpPr/>
+          <p:nvPr/>
+        </p:nvSpPr>
+        <p:spPr>
+          <a:xfrm>
+            <a:off x="5669280" y="3145536"/>
+            <a:ext cx="54864" cy="347472"/>
+          </a:xfrm>
+          <a:prstGeom prst="rect">
+            <a:avLst/>
+          </a:prstGeom>
+          <a:solidFill>
+            <a:srgbClr val="1F5FBF"/>
+          </a:solidFill>
+          <a:ln>
+            <a:noFill/>
+          </a:ln>
+          <a:effectLst/>
+        </p:spPr>
+        <p:style>
+          <a:lnRef idx="1">
+            <a:schemeClr val="accent1"/>
+          </a:lnRef>
+          <a:fillRef idx="3">
+            <a:schemeClr val="accent1"/>
+          </a:fillRef>
+          <a:effectRef idx="2">
+            <a:schemeClr val="accent1"/>
+          </a:effectRef>
+          <a:fontRef idx="minor">
+            <a:schemeClr val="lt1"/>
+          </a:fontRef>
+        </p:style>
+        <p:txBody>
+          <a:bodyPr rtlCol="0" anchor="ctr"/>
+          <a:lstStyle/>
+          <a:p>
+            <a:pPr algn="ctr"/>
+          </a:p>
+        </p:txBody>
+      </p:sp>
+      <p:sp>
+        <p:nvSpPr>
+          <p:cNvPr id="159" name="Oval 158"/>
+          <p:cNvSpPr/>
+          <p:nvPr/>
+        </p:nvSpPr>
+        <p:spPr>
+          <a:xfrm>
+            <a:off x="5788152" y="3172968"/>
+            <a:ext cx="292608" cy="292608"/>
+          </a:xfrm>
+          <a:prstGeom prst="ellipse">
+            <a:avLst/>
+          </a:prstGeom>
+          <a:solidFill>
+            <a:srgbClr val="1F5FBF"/>
+          </a:solidFill>
+          <a:ln>
+            <a:noFill/>
+          </a:ln>
+          <a:effectLst/>
+        </p:spPr>
+        <p:style>
+          <a:lnRef idx="1">
+            <a:schemeClr val="accent1"/>
+          </a:lnRef>
+          <a:fillRef idx="3">
+            <a:schemeClr val="accent1"/>
+          </a:fillRef>
+          <a:effectRef idx="2">
+            <a:schemeClr val="accent1"/>
+          </a:effectRef>
+          <a:fontRef idx="minor">
+            <a:schemeClr val="lt1"/>
+          </a:fontRef>
+        </p:style>
+        <p:txBody>
+          <a:bodyPr rtlCol="0" anchor="ctr" lIns="0" rIns="0" tIns="0" bIns="0"/>
+          <a:lstStyle/>
+          <a:p>
+            <a:pPr algn="ctr"/>
+            <a:r>
+              <a:rPr sz="1050" b="1" i="0">
+                <a:solidFill>
+                  <a:srgbClr val="FFFFFF"/>
+                </a:solidFill>
+                <a:latin typeface="Calibri"/>
+              </a:rPr>
+              <a:t>4</a:t>
+            </a:r>
+          </a:p>
+        </p:txBody>
+      </p:sp>
+      <p:sp>
+        <p:nvSpPr>
+          <p:cNvPr id="160" name="TextBox 159"/>
+          <p:cNvSpPr txBox="1"/>
+          <p:nvPr/>
+        </p:nvSpPr>
+        <p:spPr>
+          <a:xfrm>
+            <a:off x="6144768" y="3127248"/>
+            <a:ext cx="3218688" cy="384048"/>
+          </a:xfrm>
+          <a:prstGeom prst="rect">
+            <a:avLst/>
+          </a:prstGeom>
+          <a:noFill/>
+        </p:spPr>
+        <p:txBody>
+          <a:bodyPr wrap="square" lIns="36576" rIns="36576" tIns="0" bIns="0" anchor="ctr">
+            <a:spAutoFit/>
+          </a:bodyPr>
+          <a:lstStyle/>
+          <a:p>
+            <a:r>
+              <a:rPr sz="1050" b="1" i="0">
+                <a:solidFill>
+                  <a:srgbClr val="1F5FBF"/>
+                </a:solidFill>
+                <a:latin typeface="Calibri"/>
+              </a:rPr>
+              <a:t>Is there a saved rule?</a:t>
+            </a:r>
+          </a:p>
+          <a:p>
+            <a:r>
+              <a:rPr sz="850" b="0" i="0">
+                <a:solidFill>
+                  <a:srgbClr val="3A4250"/>
+                </a:solidFill>
+                <a:latin typeface="Calibri"/>
+              </a:rPr>
+              <a:t>Looks up the rule store for this pattern</a:t>
+            </a:r>
+          </a:p>
+        </p:txBody>
+      </p:sp>
+      <p:pic>
+        <p:nvPicPr>
+          <p:cNvPr id="161" name="Picture 160" descr="image.png"/>
+          <p:cNvPicPr>
+            <a:picLocks noChangeAspect="1"/>
+          </p:cNvPicPr>
+          <p:nvPr/>
+        </p:nvPicPr>
+        <p:blipFill>
+          <a:blip r:embed="rId12"/>
+          <a:stretch>
+            <a:fillRect/>
+          </a:stretch>
+        </p:blipFill>
+        <p:spPr>
+          <a:xfrm>
+            <a:off x="9400032" y="3182112"/>
+            <a:ext cx="274320" cy="274320"/>
+          </a:xfrm>
+          <a:prstGeom prst="rect">
+            <a:avLst/>
+          </a:prstGeom>
+        </p:spPr>
+      </p:pic>
+      <p:sp>
+        <p:nvSpPr>
+          <p:cNvPr id="162" name="Rounded Rectangle 161"/>
+          <p:cNvSpPr/>
+          <p:nvPr/>
+        </p:nvSpPr>
+        <p:spPr>
+          <a:xfrm>
+            <a:off x="5669280" y="3621024"/>
+            <a:ext cx="4096512" cy="420624"/>
+          </a:xfrm>
+          <a:prstGeom prst="roundRect">
+            <a:avLst>
+              <a:gd name="adj" fmla="val 14000"/>
+            </a:avLst>
+          </a:prstGeom>
+          <a:solidFill>
+            <a:srgbClr val="FFFFFF"/>
+          </a:solidFill>
+          <a:ln w="9525">
+            <a:solidFill>
+              <a:srgbClr val="D5DCE6"/>
+            </a:solidFill>
+          </a:ln>
+          <a:effectLst/>
+        </p:spPr>
+        <p:style>
+          <a:lnRef idx="1">
+            <a:schemeClr val="accent1"/>
+          </a:lnRef>
+          <a:fillRef idx="3">
+            <a:schemeClr val="accent1"/>
+          </a:fillRef>
+          <a:effectRef idx="2">
+            <a:schemeClr val="accent1"/>
+          </a:effectRef>
+          <a:fontRef idx="minor">
+            <a:schemeClr val="lt1"/>
+          </a:fontRef>
+        </p:style>
+        <p:txBody>
+          <a:bodyPr rtlCol="0" anchor="ctr"/>
+          <a:lstStyle/>
+          <a:p>
+            <a:pPr algn="ctr"/>
+          </a:p>
+        </p:txBody>
+      </p:sp>
+      <p:sp>
+        <p:nvSpPr>
+          <p:cNvPr id="163" name="Rectangle 162"/>
+          <p:cNvSpPr/>
+          <p:nvPr/>
+        </p:nvSpPr>
+        <p:spPr>
+          <a:xfrm>
+            <a:off x="5669280" y="3657600"/>
+            <a:ext cx="54864" cy="347472"/>
+          </a:xfrm>
+          <a:prstGeom prst="rect">
+            <a:avLst/>
+          </a:prstGeom>
+          <a:solidFill>
+            <a:srgbClr val="6A3FB5"/>
+          </a:solidFill>
+          <a:ln>
+            <a:noFill/>
+          </a:ln>
+          <a:effectLst/>
+        </p:spPr>
+        <p:style>
+          <a:lnRef idx="1">
+            <a:schemeClr val="accent1"/>
+          </a:lnRef>
+          <a:fillRef idx="3">
+            <a:schemeClr val="accent1"/>
+          </a:fillRef>
+          <a:effectRef idx="2">
+            <a:schemeClr val="accent1"/>
+          </a:effectRef>
+          <a:fontRef idx="minor">
+            <a:schemeClr val="lt1"/>
+          </a:fontRef>
+        </p:style>
+        <p:txBody>
+          <a:bodyPr rtlCol="0" anchor="ctr"/>
+          <a:lstStyle/>
+          <a:p>
+            <a:pPr algn="ctr"/>
+          </a:p>
+        </p:txBody>
+      </p:sp>
+      <p:sp>
+        <p:nvSpPr>
+          <p:cNvPr id="164" name="Oval 163"/>
+          <p:cNvSpPr/>
+          <p:nvPr/>
+        </p:nvSpPr>
+        <p:spPr>
+          <a:xfrm>
+            <a:off x="5788152" y="3685032"/>
+            <a:ext cx="292608" cy="292608"/>
+          </a:xfrm>
+          <a:prstGeom prst="ellipse">
+            <a:avLst/>
+          </a:prstGeom>
+          <a:solidFill>
+            <a:srgbClr val="6A3FB5"/>
+          </a:solidFill>
+          <a:ln>
+            <a:noFill/>
+          </a:ln>
+          <a:effectLst/>
+        </p:spPr>
+        <p:style>
+          <a:lnRef idx="1">
+            <a:schemeClr val="accent1"/>
+          </a:lnRef>
+          <a:fillRef idx="3">
+            <a:schemeClr val="accent1"/>
+          </a:fillRef>
+          <a:effectRef idx="2">
+            <a:schemeClr val="accent1"/>
+          </a:effectRef>
+          <a:fontRef idx="minor">
+            <a:schemeClr val="lt1"/>
+          </a:fontRef>
+        </p:style>
+        <p:txBody>
+          <a:bodyPr rtlCol="0" anchor="ctr" lIns="0" rIns="0" tIns="0" bIns="0"/>
+          <a:lstStyle/>
+          <a:p>
+            <a:pPr algn="ctr"/>
+            <a:r>
+              <a:rPr sz="1050" b="1" i="0">
+                <a:solidFill>
+                  <a:srgbClr val="FFFFFF"/>
+                </a:solidFill>
+                <a:latin typeface="Calibri"/>
+              </a:rPr>
+              <a:t>5</a:t>
+            </a:r>
+          </a:p>
+        </p:txBody>
+      </p:sp>
+      <p:sp>
+        <p:nvSpPr>
+          <p:cNvPr id="165" name="TextBox 164"/>
+          <p:cNvSpPr txBox="1"/>
+          <p:nvPr/>
+        </p:nvSpPr>
+        <p:spPr>
+          <a:xfrm>
+            <a:off x="6144768" y="3639312"/>
+            <a:ext cx="3218688" cy="384048"/>
+          </a:xfrm>
+          <a:prstGeom prst="rect">
+            <a:avLst/>
+          </a:prstGeom>
+          <a:noFill/>
+        </p:spPr>
+        <p:txBody>
+          <a:bodyPr wrap="square" lIns="36576" rIns="36576" tIns="0" bIns="0" anchor="ctr">
+            <a:spAutoFit/>
+          </a:bodyPr>
+          <a:lstStyle/>
+          <a:p>
+            <a:r>
+              <a:rPr sz="1050" b="1" i="0">
+                <a:solidFill>
+                  <a:srgbClr val="6A3FB5"/>
+                </a:solidFill>
+                <a:latin typeface="Calibri"/>
+              </a:rPr>
+              <a:t>Is the format familiar?</a:t>
+            </a:r>
+          </a:p>
+          <a:p>
+            <a:r>
+              <a:rPr sz="850" b="0" i="0">
+                <a:solidFill>
+                  <a:srgbClr val="3A4250"/>
+                </a:solidFill>
+                <a:latin typeface="Calibri"/>
+              </a:rPr>
+              <a:t>ML model compares it with known log families</a:t>
+            </a:r>
+          </a:p>
+        </p:txBody>
+      </p:sp>
+      <p:pic>
+        <p:nvPicPr>
+          <p:cNvPr id="166" name="Picture 165" descr="image.png"/>
+          <p:cNvPicPr>
+            <a:picLocks noChangeAspect="1"/>
+          </p:cNvPicPr>
+          <p:nvPr/>
+        </p:nvPicPr>
+        <p:blipFill>
+          <a:blip r:embed="rId5"/>
+          <a:stretch>
+            <a:fillRect/>
+          </a:stretch>
+        </p:blipFill>
+        <p:spPr>
+          <a:xfrm>
+            <a:off x="9400032" y="3694176"/>
+            <a:ext cx="274320" cy="274320"/>
+          </a:xfrm>
+          <a:prstGeom prst="rect">
+            <a:avLst/>
+          </a:prstGeom>
+        </p:spPr>
+      </p:pic>
+      <p:sp>
+        <p:nvSpPr>
+          <p:cNvPr id="167" name="Rounded Rectangle 166"/>
+          <p:cNvSpPr/>
+          <p:nvPr/>
+        </p:nvSpPr>
+        <p:spPr>
+          <a:xfrm>
+            <a:off x="5669280" y="4133088"/>
+            <a:ext cx="2002536" cy="420624"/>
+          </a:xfrm>
+          <a:prstGeom prst="roundRect">
+            <a:avLst>
+              <a:gd name="adj" fmla="val 14000"/>
+            </a:avLst>
+          </a:prstGeom>
+          <a:solidFill>
+            <a:srgbClr val="FFF6EC"/>
+          </a:solidFill>
+          <a:ln w="9525">
+            <a:solidFill>
+              <a:srgbClr val="D5DCE6"/>
+            </a:solidFill>
+          </a:ln>
+          <a:effectLst/>
+        </p:spPr>
+        <p:style>
+          <a:lnRef idx="1">
+            <a:schemeClr val="accent1"/>
+          </a:lnRef>
+          <a:fillRef idx="3">
+            <a:schemeClr val="accent1"/>
+          </a:fillRef>
+          <a:effectRef idx="2">
+            <a:schemeClr val="accent1"/>
+          </a:effectRef>
+          <a:fontRef idx="minor">
+            <a:schemeClr val="lt1"/>
+          </a:fontRef>
+        </p:style>
+        <p:txBody>
+          <a:bodyPr rtlCol="0" anchor="ctr"/>
+          <a:lstStyle/>
+          <a:p>
+            <a:pPr algn="ctr"/>
+          </a:p>
+        </p:txBody>
+      </p:sp>
+      <p:sp>
+        <p:nvSpPr>
+          <p:cNvPr id="168" name="Rectangle 167"/>
+          <p:cNvSpPr/>
+          <p:nvPr/>
+        </p:nvSpPr>
+        <p:spPr>
+          <a:xfrm>
+            <a:off x="5669280" y="4169664"/>
+            <a:ext cx="54864" cy="347472"/>
+          </a:xfrm>
+          <a:prstGeom prst="rect">
+            <a:avLst/>
+          </a:prstGeom>
+          <a:solidFill>
+            <a:srgbClr val="E07A10"/>
+          </a:solidFill>
+          <a:ln>
+            <a:noFill/>
+          </a:ln>
+          <a:effectLst/>
+        </p:spPr>
+        <p:style>
+          <a:lnRef idx="1">
+            <a:schemeClr val="accent1"/>
+          </a:lnRef>
+          <a:fillRef idx="3">
+            <a:schemeClr val="accent1"/>
+          </a:fillRef>
+          <a:effectRef idx="2">
+            <a:schemeClr val="accent1"/>
+          </a:effectRef>
+          <a:fontRef idx="minor">
+            <a:schemeClr val="lt1"/>
+          </a:fontRef>
+        </p:style>
+        <p:txBody>
+          <a:bodyPr rtlCol="0" anchor="ctr"/>
+          <a:lstStyle/>
+          <a:p>
+            <a:pPr algn="ctr"/>
+          </a:p>
+        </p:txBody>
+      </p:sp>
+      <p:sp>
+        <p:nvSpPr>
+          <p:cNvPr id="169" name="Oval 168"/>
+          <p:cNvSpPr/>
+          <p:nvPr/>
+        </p:nvSpPr>
+        <p:spPr>
+          <a:xfrm>
+            <a:off x="5788152" y="4197096"/>
+            <a:ext cx="292608" cy="292608"/>
+          </a:xfrm>
+          <a:prstGeom prst="ellipse">
+            <a:avLst/>
+          </a:prstGeom>
+          <a:solidFill>
+            <a:srgbClr val="E07A10"/>
+          </a:solidFill>
+          <a:ln>
+            <a:noFill/>
+          </a:ln>
+          <a:effectLst/>
+        </p:spPr>
+        <p:style>
+          <a:lnRef idx="1">
+            <a:schemeClr val="accent1"/>
+          </a:lnRef>
+          <a:fillRef idx="3">
+            <a:schemeClr val="accent1"/>
+          </a:fillRef>
+          <a:effectRef idx="2">
+            <a:schemeClr val="accent1"/>
+          </a:effectRef>
+          <a:fontRef idx="minor">
+            <a:schemeClr val="lt1"/>
+          </a:fontRef>
+        </p:style>
+        <p:txBody>
+          <a:bodyPr rtlCol="0" anchor="ctr" lIns="0" rIns="0" tIns="0" bIns="0"/>
+          <a:lstStyle/>
+          <a:p>
+            <a:pPr algn="ctr"/>
+            <a:r>
+              <a:rPr sz="850" b="1" i="0">
+                <a:solidFill>
+                  <a:srgbClr val="FFFFFF"/>
+                </a:solidFill>
+                <a:latin typeface="Calibri"/>
+              </a:rPr>
+              <a:t>5a</a:t>
+            </a:r>
+          </a:p>
+        </p:txBody>
+      </p:sp>
+      <p:sp>
+        <p:nvSpPr>
+          <p:cNvPr id="170" name="TextBox 169"/>
+          <p:cNvSpPr txBox="1"/>
+          <p:nvPr/>
+        </p:nvSpPr>
+        <p:spPr>
+          <a:xfrm>
+            <a:off x="6144768" y="4151376"/>
+            <a:ext cx="996696" cy="384048"/>
+          </a:xfrm>
+          <a:prstGeom prst="rect">
+            <a:avLst/>
+          </a:prstGeom>
+          <a:noFill/>
+        </p:spPr>
+        <p:txBody>
+          <a:bodyPr wrap="square" lIns="36576" rIns="36576" tIns="0" bIns="0" anchor="ctr">
+            <a:spAutoFit/>
+          </a:bodyPr>
+          <a:lstStyle/>
+          <a:p>
+            <a:r>
+              <a:rPr sz="1000" b="1" i="0">
+                <a:solidFill>
+                  <a:srgbClr val="E07A10"/>
+                </a:solidFill>
+                <a:latin typeface="Calibri"/>
+              </a:rPr>
+              <a:t>AI writes a rule</a:t>
+            </a:r>
+          </a:p>
+          <a:p>
+            <a:r>
+              <a:rPr sz="800" b="0" i="0">
+                <a:solidFill>
+                  <a:srgbClr val="3A4250"/>
+                </a:solidFill>
+                <a:latin typeface="Calibri"/>
+              </a:rPr>
+              <a:t>once per pattern</a:t>
+            </a:r>
+          </a:p>
+        </p:txBody>
+      </p:sp>
+      <p:pic>
+        <p:nvPicPr>
+          <p:cNvPr id="171" name="Picture 170" descr="image.png"/>
+          <p:cNvPicPr>
+            <a:picLocks noChangeAspect="1"/>
+          </p:cNvPicPr>
+          <p:nvPr/>
+        </p:nvPicPr>
+        <p:blipFill>
+          <a:blip r:embed="rId6"/>
+          <a:stretch>
+            <a:fillRect/>
+          </a:stretch>
+        </p:blipFill>
+        <p:spPr>
+          <a:xfrm>
+            <a:off x="7123176" y="4242816"/>
+            <a:ext cx="201168" cy="201168"/>
+          </a:xfrm>
+          <a:prstGeom prst="rect">
+            <a:avLst/>
+          </a:prstGeom>
+        </p:spPr>
+      </p:pic>
+      <p:pic>
+        <p:nvPicPr>
+          <p:cNvPr id="172" name="Picture 171" descr="image.png"/>
+          <p:cNvPicPr>
+            <a:picLocks noChangeAspect="1"/>
+          </p:cNvPicPr>
+          <p:nvPr/>
+        </p:nvPicPr>
+        <p:blipFill>
+          <a:blip r:embed="rId7"/>
+          <a:stretch>
+            <a:fillRect/>
+          </a:stretch>
+        </p:blipFill>
+        <p:spPr>
+          <a:xfrm>
+            <a:off x="7379208" y="4242816"/>
+            <a:ext cx="201168" cy="201168"/>
+          </a:xfrm>
+          <a:prstGeom prst="rect">
+            <a:avLst/>
+          </a:prstGeom>
+        </p:spPr>
+      </p:pic>
+      <p:sp>
+        <p:nvSpPr>
+          <p:cNvPr id="173" name="Rounded Rectangle 172"/>
+          <p:cNvSpPr/>
+          <p:nvPr/>
+        </p:nvSpPr>
+        <p:spPr>
+          <a:xfrm>
+            <a:off x="7763256" y="4133088"/>
+            <a:ext cx="2002536" cy="420624"/>
+          </a:xfrm>
+          <a:prstGeom prst="roundRect">
+            <a:avLst>
+              <a:gd name="adj" fmla="val 14000"/>
+            </a:avLst>
+          </a:prstGeom>
+          <a:solidFill>
+            <a:srgbClr val="FDEEEC"/>
+          </a:solidFill>
+          <a:ln w="9525">
+            <a:solidFill>
+              <a:srgbClr val="D5DCE6"/>
+            </a:solidFill>
+          </a:ln>
+          <a:effectLst/>
+        </p:spPr>
+        <p:style>
+          <a:lnRef idx="1">
+            <a:schemeClr val="accent1"/>
+          </a:lnRef>
+          <a:fillRef idx="3">
+            <a:schemeClr val="accent1"/>
+          </a:fillRef>
+          <a:effectRef idx="2">
+            <a:schemeClr val="accent1"/>
+          </a:effectRef>
+          <a:fontRef idx="minor">
+            <a:schemeClr val="lt1"/>
+          </a:fontRef>
+        </p:style>
+        <p:txBody>
+          <a:bodyPr rtlCol="0" anchor="ctr"/>
+          <a:lstStyle/>
+          <a:p>
+            <a:pPr algn="ctr"/>
+          </a:p>
+        </p:txBody>
+      </p:sp>
+      <p:sp>
+        <p:nvSpPr>
+          <p:cNvPr id="174" name="Rectangle 173"/>
+          <p:cNvSpPr/>
+          <p:nvPr/>
+        </p:nvSpPr>
+        <p:spPr>
+          <a:xfrm>
+            <a:off x="7763256" y="4169664"/>
+            <a:ext cx="54864" cy="347472"/>
+          </a:xfrm>
+          <a:prstGeom prst="rect">
+            <a:avLst/>
+          </a:prstGeom>
+          <a:solidFill>
+            <a:srgbClr val="C0392B"/>
+          </a:solidFill>
+          <a:ln>
+            <a:noFill/>
+          </a:ln>
+          <a:effectLst/>
+        </p:spPr>
+        <p:style>
+          <a:lnRef idx="1">
+            <a:schemeClr val="accent1"/>
+          </a:lnRef>
+          <a:fillRef idx="3">
+            <a:schemeClr val="accent1"/>
+          </a:fillRef>
+          <a:effectRef idx="2">
+            <a:schemeClr val="accent1"/>
+          </a:effectRef>
+          <a:fontRef idx="minor">
+            <a:schemeClr val="lt1"/>
+          </a:fontRef>
+        </p:style>
+        <p:txBody>
+          <a:bodyPr rtlCol="0" anchor="ctr"/>
+          <a:lstStyle/>
+          <a:p>
+            <a:pPr algn="ctr"/>
+          </a:p>
+        </p:txBody>
+      </p:sp>
+      <p:sp>
+        <p:nvSpPr>
+          <p:cNvPr id="175" name="Oval 174"/>
+          <p:cNvSpPr/>
+          <p:nvPr/>
+        </p:nvSpPr>
+        <p:spPr>
+          <a:xfrm>
+            <a:off x="7882128" y="4197096"/>
+            <a:ext cx="292608" cy="292608"/>
+          </a:xfrm>
+          <a:prstGeom prst="ellipse">
+            <a:avLst/>
+          </a:prstGeom>
+          <a:solidFill>
+            <a:srgbClr val="C0392B"/>
+          </a:solidFill>
+          <a:ln>
+            <a:noFill/>
+          </a:ln>
+          <a:effectLst/>
+        </p:spPr>
+        <p:style>
+          <a:lnRef idx="1">
+            <a:schemeClr val="accent1"/>
+          </a:lnRef>
+          <a:fillRef idx="3">
+            <a:schemeClr val="accent1"/>
+          </a:fillRef>
+          <a:effectRef idx="2">
+            <a:schemeClr val="accent1"/>
+          </a:effectRef>
+          <a:fontRef idx="minor">
+            <a:schemeClr val="lt1"/>
+          </a:fontRef>
+        </p:style>
+        <p:txBody>
+          <a:bodyPr rtlCol="0" anchor="ctr" lIns="0" rIns="0" tIns="0" bIns="0"/>
+          <a:lstStyle/>
+          <a:p>
+            <a:pPr algn="ctr"/>
+            <a:r>
+              <a:rPr sz="850" b="1" i="0">
+                <a:solidFill>
+                  <a:srgbClr val="FFFFFF"/>
+                </a:solidFill>
+                <a:latin typeface="Calibri"/>
+              </a:rPr>
+              <a:t>5b</a:t>
+            </a:r>
+          </a:p>
+        </p:txBody>
+      </p:sp>
+      <p:sp>
+        <p:nvSpPr>
+          <p:cNvPr id="176" name="TextBox 175"/>
+          <p:cNvSpPr txBox="1"/>
+          <p:nvPr/>
+        </p:nvSpPr>
+        <p:spPr>
+          <a:xfrm>
+            <a:off x="8238744" y="4151376"/>
+            <a:ext cx="1124712" cy="384048"/>
+          </a:xfrm>
+          <a:prstGeom prst="rect">
+            <a:avLst/>
+          </a:prstGeom>
+          <a:noFill/>
+        </p:spPr>
+        <p:txBody>
+          <a:bodyPr wrap="square" lIns="36576" rIns="36576" tIns="0" bIns="0" anchor="ctr">
+            <a:spAutoFit/>
+          </a:bodyPr>
+          <a:lstStyle/>
+          <a:p>
+            <a:r>
+              <a:rPr sz="1000" b="1" i="0">
+                <a:solidFill>
+                  <a:srgbClr val="C0392B"/>
+                </a:solidFill>
+                <a:latin typeface="Calibri"/>
+              </a:rPr>
+              <a:t>Hold for review</a:t>
+            </a:r>
+          </a:p>
+          <a:p>
+            <a:r>
+              <a:rPr sz="800" b="0" i="0">
+                <a:solidFill>
+                  <a:srgbClr val="3A4250"/>
+                </a:solidFill>
+                <a:latin typeface="Calibri"/>
+              </a:rPr>
+              <a:t>learned once it repeats</a:t>
+            </a:r>
+          </a:p>
+        </p:txBody>
+      </p:sp>
+      <p:pic>
+        <p:nvPicPr>
+          <p:cNvPr id="177" name="Picture 176" descr="image.png"/>
+          <p:cNvPicPr>
+            <a:picLocks noChangeAspect="1"/>
+          </p:cNvPicPr>
+          <p:nvPr/>
+        </p:nvPicPr>
+        <p:blipFill>
+          <a:blip r:embed="rId4"/>
+          <a:stretch>
+            <a:fillRect/>
+          </a:stretch>
+        </p:blipFill>
+        <p:spPr>
+          <a:xfrm>
+            <a:off x="9400032" y="4206240"/>
+            <a:ext cx="274320" cy="274320"/>
+          </a:xfrm>
+          <a:prstGeom prst="rect">
+            <a:avLst/>
+          </a:prstGeom>
+        </p:spPr>
+      </p:pic>
+      <p:sp>
+        <p:nvSpPr>
+          <p:cNvPr id="178" name="Rounded Rectangle 177"/>
+          <p:cNvSpPr/>
+          <p:nvPr/>
+        </p:nvSpPr>
+        <p:spPr>
+          <a:xfrm>
+            <a:off x="5669280" y="4645152"/>
+            <a:ext cx="4096512" cy="420624"/>
+          </a:xfrm>
+          <a:prstGeom prst="roundRect">
+            <a:avLst>
+              <a:gd name="adj" fmla="val 14000"/>
+            </a:avLst>
+          </a:prstGeom>
+          <a:solidFill>
+            <a:srgbClr val="FFFFFF"/>
+          </a:solidFill>
+          <a:ln w="9525">
+            <a:solidFill>
+              <a:srgbClr val="D5DCE6"/>
+            </a:solidFill>
+          </a:ln>
+          <a:effectLst/>
+        </p:spPr>
+        <p:style>
+          <a:lnRef idx="1">
+            <a:schemeClr val="accent1"/>
+          </a:lnRef>
+          <a:fillRef idx="3">
+            <a:schemeClr val="accent1"/>
+          </a:fillRef>
+          <a:effectRef idx="2">
+            <a:schemeClr val="accent1"/>
+          </a:effectRef>
+          <a:fontRef idx="minor">
+            <a:schemeClr val="lt1"/>
+          </a:fontRef>
+        </p:style>
+        <p:txBody>
+          <a:bodyPr rtlCol="0" anchor="ctr"/>
+          <a:lstStyle/>
+          <a:p>
+            <a:pPr algn="ctr"/>
+          </a:p>
+        </p:txBody>
+      </p:sp>
+      <p:sp>
+        <p:nvSpPr>
+          <p:cNvPr id="179" name="Rectangle 178"/>
+          <p:cNvSpPr/>
+          <p:nvPr/>
+        </p:nvSpPr>
+        <p:spPr>
+          <a:xfrm>
+            <a:off x="5669280" y="4681728"/>
+            <a:ext cx="54864" cy="347472"/>
+          </a:xfrm>
+          <a:prstGeom prst="rect">
+            <a:avLst/>
+          </a:prstGeom>
+          <a:solidFill>
+            <a:srgbClr val="0E8C8C"/>
+          </a:solidFill>
+          <a:ln>
+            <a:noFill/>
+          </a:ln>
+          <a:effectLst/>
+        </p:spPr>
+        <p:style>
+          <a:lnRef idx="1">
+            <a:schemeClr val="accent1"/>
+          </a:lnRef>
+          <a:fillRef idx="3">
+            <a:schemeClr val="accent1"/>
+          </a:fillRef>
+          <a:effectRef idx="2">
+            <a:schemeClr val="accent1"/>
+          </a:effectRef>
+          <a:fontRef idx="minor">
+            <a:schemeClr val="lt1"/>
+          </a:fontRef>
+        </p:style>
+        <p:txBody>
+          <a:bodyPr rtlCol="0" anchor="ctr"/>
+          <a:lstStyle/>
+          <a:p>
+            <a:pPr algn="ctr"/>
+          </a:p>
+        </p:txBody>
+      </p:sp>
+      <p:sp>
+        <p:nvSpPr>
+          <p:cNvPr id="180" name="Oval 179"/>
+          <p:cNvSpPr/>
+          <p:nvPr/>
+        </p:nvSpPr>
+        <p:spPr>
+          <a:xfrm>
+            <a:off x="5788152" y="4709160"/>
+            <a:ext cx="292608" cy="292608"/>
+          </a:xfrm>
+          <a:prstGeom prst="ellipse">
+            <a:avLst/>
+          </a:prstGeom>
+          <a:solidFill>
+            <a:srgbClr val="0E8C8C"/>
+          </a:solidFill>
+          <a:ln>
+            <a:noFill/>
+          </a:ln>
+          <a:effectLst/>
+        </p:spPr>
+        <p:style>
+          <a:lnRef idx="1">
+            <a:schemeClr val="accent1"/>
+          </a:lnRef>
+          <a:fillRef idx="3">
+            <a:schemeClr val="accent1"/>
+          </a:fillRef>
+          <a:effectRef idx="2">
+            <a:schemeClr val="accent1"/>
+          </a:effectRef>
+          <a:fontRef idx="minor">
+            <a:schemeClr val="lt1"/>
+          </a:fontRef>
+        </p:style>
+        <p:txBody>
+          <a:bodyPr rtlCol="0" anchor="ctr" lIns="0" rIns="0" tIns="0" bIns="0"/>
+          <a:lstStyle/>
+          <a:p>
+            <a:pPr algn="ctr"/>
+            <a:r>
+              <a:rPr sz="1050" b="1" i="0">
+                <a:solidFill>
+                  <a:srgbClr val="FFFFFF"/>
+                </a:solidFill>
+                <a:latin typeface="Calibri"/>
+              </a:rPr>
+              <a:t>6</a:t>
+            </a:r>
+          </a:p>
+        </p:txBody>
+      </p:sp>
+      <p:sp>
+        <p:nvSpPr>
+          <p:cNvPr id="181" name="TextBox 180"/>
+          <p:cNvSpPr txBox="1"/>
+          <p:nvPr/>
+        </p:nvSpPr>
+        <p:spPr>
+          <a:xfrm>
+            <a:off x="6144768" y="4663440"/>
+            <a:ext cx="3218688" cy="384048"/>
+          </a:xfrm>
+          <a:prstGeom prst="rect">
+            <a:avLst/>
+          </a:prstGeom>
+          <a:noFill/>
+        </p:spPr>
+        <p:txBody>
+          <a:bodyPr wrap="square" lIns="36576" rIns="36576" tIns="0" bIns="0" anchor="ctr">
+            <a:spAutoFit/>
+          </a:bodyPr>
+          <a:lstStyle/>
+          <a:p>
+            <a:r>
+              <a:rPr sz="1050" b="1" i="0">
+                <a:solidFill>
+                  <a:srgbClr val="0E8C8C"/>
+                </a:solidFill>
+                <a:latin typeface="Calibri"/>
+              </a:rPr>
+              <a:t>Save the rule</a:t>
+            </a:r>
+          </a:p>
+          <a:p>
+            <a:r>
+              <a:rPr sz="850" b="0" i="0">
+                <a:solidFill>
+                  <a:srgbClr val="3A4250"/>
+                </a:solidFill>
+                <a:latin typeface="Calibri"/>
+              </a:rPr>
+              <a:t>Stored, so every future matching line skips AI</a:t>
+            </a:r>
+          </a:p>
+        </p:txBody>
+      </p:sp>
+      <p:pic>
+        <p:nvPicPr>
+          <p:cNvPr id="182" name="Picture 181" descr="image.png"/>
+          <p:cNvPicPr>
+            <a:picLocks noChangeAspect="1"/>
+          </p:cNvPicPr>
+          <p:nvPr/>
+        </p:nvPicPr>
+        <p:blipFill>
+          <a:blip r:embed="rId12"/>
+          <a:stretch>
+            <a:fillRect/>
+          </a:stretch>
+        </p:blipFill>
+        <p:spPr>
+          <a:xfrm>
+            <a:off x="9400032" y="4718304"/>
+            <a:ext cx="274320" cy="274320"/>
+          </a:xfrm>
+          <a:prstGeom prst="rect">
+            <a:avLst/>
+          </a:prstGeom>
+        </p:spPr>
+      </p:pic>
+      <p:sp>
+        <p:nvSpPr>
+          <p:cNvPr id="183" name="Rounded Rectangle 182"/>
+          <p:cNvSpPr/>
+          <p:nvPr/>
+        </p:nvSpPr>
+        <p:spPr>
+          <a:xfrm>
+            <a:off x="5669280" y="5157216"/>
+            <a:ext cx="6108192" cy="420624"/>
+          </a:xfrm>
+          <a:prstGeom prst="roundRect">
+            <a:avLst>
+              <a:gd name="adj" fmla="val 14000"/>
+            </a:avLst>
+          </a:prstGeom>
+          <a:solidFill>
+            <a:srgbClr val="FFFFFF"/>
+          </a:solidFill>
+          <a:ln w="9525">
+            <a:solidFill>
+              <a:srgbClr val="D5DCE6"/>
+            </a:solidFill>
+          </a:ln>
+          <a:effectLst/>
+        </p:spPr>
+        <p:style>
+          <a:lnRef idx="1">
+            <a:schemeClr val="accent1"/>
+          </a:lnRef>
+          <a:fillRef idx="3">
+            <a:schemeClr val="accent1"/>
+          </a:fillRef>
+          <a:effectRef idx="2">
+            <a:schemeClr val="accent1"/>
+          </a:effectRef>
+          <a:fontRef idx="minor">
+            <a:schemeClr val="lt1"/>
+          </a:fontRef>
+        </p:style>
+        <p:txBody>
+          <a:bodyPr rtlCol="0" anchor="ctr"/>
+          <a:lstStyle/>
+          <a:p>
+            <a:pPr algn="ctr"/>
+          </a:p>
+        </p:txBody>
+      </p:sp>
+      <p:sp>
+        <p:nvSpPr>
+          <p:cNvPr id="184" name="Rectangle 183"/>
+          <p:cNvSpPr/>
+          <p:nvPr/>
+        </p:nvSpPr>
+        <p:spPr>
+          <a:xfrm>
+            <a:off x="5669280" y="5193792"/>
+            <a:ext cx="54864" cy="347472"/>
+          </a:xfrm>
+          <a:prstGeom prst="rect">
+            <a:avLst/>
           </a:prstGeom>
           <a:solidFill>
             <a:srgbClr val="138A36"/>
@@ -14175,879 +16068,17 @@
       </p:sp>
       <p:sp>
         <p:nvSpPr>
-          <p:cNvPr id="140" name="TextBox 139"/>
-          <p:cNvSpPr txBox="1"/>
-          <p:nvPr/>
-        </p:nvSpPr>
-        <p:spPr>
-          <a:xfrm>
-            <a:off x="9829800" y="1152144"/>
-            <a:ext cx="868680" cy="182880"/>
-          </a:xfrm>
-          <a:prstGeom prst="rect">
-            <a:avLst/>
-          </a:prstGeom>
-          <a:noFill/>
-        </p:spPr>
-        <p:txBody>
-          <a:bodyPr wrap="square" lIns="18288" rIns="18288" tIns="9144" bIns="9144" anchor="ctr">
-            <a:spAutoFit/>
-          </a:bodyPr>
-          <a:lstStyle/>
-          <a:p>
-            <a:pPr algn="l"/>
-            <a:r>
-              <a:rPr sz="800" b="1">
-                <a:solidFill>
-                  <a:srgbClr val="138A36"/>
-                </a:solidFill>
-                <a:latin typeface="Calibri"/>
-              </a:rPr>
-              <a:t>fast path</a:t>
-            </a:r>
-          </a:p>
-        </p:txBody>
-      </p:sp>
-      <p:sp>
-        <p:nvSpPr>
-          <p:cNvPr id="141" name="Rounded Rectangle 140"/>
+          <p:cNvPr id="185" name="Oval 184"/>
           <p:cNvSpPr/>
           <p:nvPr/>
         </p:nvSpPr>
         <p:spPr>
           <a:xfrm>
-            <a:off x="10698480" y="1179576"/>
-            <a:ext cx="201168" cy="128016"/>
-          </a:xfrm>
-          <a:prstGeom prst="roundRect">
-            <a:avLst>
-              <a:gd name="adj" fmla="val 30000"/>
-            </a:avLst>
-          </a:prstGeom>
-          <a:solidFill>
-            <a:srgbClr val="F28322"/>
-          </a:solidFill>
-          <a:ln>
-            <a:noFill/>
-          </a:ln>
-          <a:effectLst/>
-        </p:spPr>
-        <p:style>
-          <a:lnRef idx="1">
-            <a:schemeClr val="accent1"/>
-          </a:lnRef>
-          <a:fillRef idx="3">
-            <a:schemeClr val="accent1"/>
-          </a:fillRef>
-          <a:effectRef idx="2">
-            <a:schemeClr val="accent1"/>
-          </a:effectRef>
-          <a:fontRef idx="minor">
-            <a:schemeClr val="lt1"/>
-          </a:fontRef>
-        </p:style>
-        <p:txBody>
-          <a:bodyPr rtlCol="0" anchor="ctr"/>
-          <a:lstStyle/>
-          <a:p>
-            <a:pPr algn="ctr"/>
-          </a:p>
-        </p:txBody>
-      </p:sp>
-      <p:sp>
-        <p:nvSpPr>
-          <p:cNvPr id="142" name="TextBox 141"/>
-          <p:cNvSpPr txBox="1"/>
-          <p:nvPr/>
-        </p:nvSpPr>
-        <p:spPr>
-          <a:xfrm>
-            <a:off x="10927080" y="1152144"/>
-            <a:ext cx="868680" cy="182880"/>
-          </a:xfrm>
-          <a:prstGeom prst="rect">
-            <a:avLst/>
-          </a:prstGeom>
-          <a:noFill/>
-        </p:spPr>
-        <p:txBody>
-          <a:bodyPr wrap="square" lIns="18288" rIns="18288" tIns="9144" bIns="9144" anchor="ctr">
-            <a:spAutoFit/>
-          </a:bodyPr>
-          <a:lstStyle/>
-          <a:p>
-            <a:pPr algn="l"/>
-            <a:r>
-              <a:rPr sz="800" b="1">
-                <a:solidFill>
-                  <a:srgbClr val="C06010"/>
-                </a:solidFill>
-                <a:latin typeface="Calibri"/>
-              </a:rPr>
-              <a:t>AI path</a:t>
-            </a:r>
-          </a:p>
-        </p:txBody>
-      </p:sp>
-      <p:sp>
-        <p:nvSpPr>
-          <p:cNvPr id="143" name="Rounded Rectangle 142"/>
-          <p:cNvSpPr/>
-          <p:nvPr/>
-        </p:nvSpPr>
-        <p:spPr>
-          <a:xfrm>
-            <a:off x="5715000" y="1463040"/>
-            <a:ext cx="3200400" cy="420624"/>
-          </a:xfrm>
-          <a:prstGeom prst="roundRect">
-            <a:avLst>
-              <a:gd name="adj" fmla="val 15000"/>
-            </a:avLst>
-          </a:prstGeom>
-          <a:solidFill>
-            <a:srgbClr val="4A5568"/>
-          </a:solidFill>
-          <a:ln>
-            <a:noFill/>
-          </a:ln>
-          <a:effectLst/>
-        </p:spPr>
-        <p:style>
-          <a:lnRef idx="1">
-            <a:schemeClr val="accent1"/>
-          </a:lnRef>
-          <a:fillRef idx="3">
-            <a:schemeClr val="accent1"/>
-          </a:fillRef>
-          <a:effectRef idx="2">
-            <a:schemeClr val="accent1"/>
-          </a:effectRef>
-          <a:fontRef idx="minor">
-            <a:schemeClr val="lt1"/>
-          </a:fontRef>
-        </p:style>
-        <p:txBody>
-          <a:bodyPr rtlCol="0" anchor="ctr"/>
-          <a:lstStyle/>
-          <a:p>
-            <a:pPr algn="ctr"/>
-          </a:p>
-        </p:txBody>
-      </p:sp>
-      <p:sp>
-        <p:nvSpPr>
-          <p:cNvPr id="144" name="TextBox 143"/>
-          <p:cNvSpPr txBox="1"/>
-          <p:nvPr/>
-        </p:nvSpPr>
-        <p:spPr>
-          <a:xfrm>
-            <a:off x="5715000" y="1463040"/>
-            <a:ext cx="3200400" cy="420624"/>
-          </a:xfrm>
-          <a:prstGeom prst="rect">
-            <a:avLst/>
-          </a:prstGeom>
-          <a:noFill/>
-        </p:spPr>
-        <p:txBody>
-          <a:bodyPr wrap="square" lIns="45720" rIns="45720" tIns="9144" bIns="9144" anchor="ctr">
-            <a:spAutoFit/>
-          </a:bodyPr>
-          <a:lstStyle/>
-          <a:p>
-            <a:pPr algn="ctr"/>
-            <a:r>
-              <a:rPr sz="1050" b="1">
-                <a:solidFill>
-                  <a:srgbClr val="FFFFFF"/>
-                </a:solidFill>
-                <a:latin typeface="Calibri"/>
-              </a:rPr>
-              <a:t>1  Logs come in</a:t>
-            </a:r>
-          </a:p>
-          <a:p>
-            <a:pPr algn="ctr"/>
-            <a:r>
-              <a:rPr sz="850" b="0">
-                <a:solidFill>
-                  <a:srgbClr val="EEF3FA"/>
-                </a:solidFill>
-                <a:latin typeface="Calibri"/>
-              </a:rPr>
-              <a:t>web API or Bash collector · multi-line errors joined</a:t>
-            </a:r>
-          </a:p>
-        </p:txBody>
-      </p:sp>
-      <p:sp>
-        <p:nvSpPr>
-          <p:cNvPr id="145" name="Rounded Rectangle 144"/>
-          <p:cNvSpPr/>
-          <p:nvPr/>
-        </p:nvSpPr>
-        <p:spPr>
-          <a:xfrm>
-            <a:off x="5715000" y="1993392"/>
-            <a:ext cx="3200400" cy="420624"/>
-          </a:xfrm>
-          <a:prstGeom prst="roundRect">
-            <a:avLst>
-              <a:gd name="adj" fmla="val 15000"/>
-            </a:avLst>
-          </a:prstGeom>
-          <a:solidFill>
-            <a:srgbClr val="1F5FBF"/>
-          </a:solidFill>
-          <a:ln>
-            <a:noFill/>
-          </a:ln>
-          <a:effectLst/>
-        </p:spPr>
-        <p:style>
-          <a:lnRef idx="1">
-            <a:schemeClr val="accent1"/>
-          </a:lnRef>
-          <a:fillRef idx="3">
-            <a:schemeClr val="accent1"/>
-          </a:fillRef>
-          <a:effectRef idx="2">
-            <a:schemeClr val="accent1"/>
-          </a:effectRef>
-          <a:fontRef idx="minor">
-            <a:schemeClr val="lt1"/>
-          </a:fontRef>
-        </p:style>
-        <p:txBody>
-          <a:bodyPr rtlCol="0" anchor="ctr"/>
-          <a:lstStyle/>
-          <a:p>
-            <a:pPr algn="ctr"/>
-          </a:p>
-        </p:txBody>
-      </p:sp>
-      <p:sp>
-        <p:nvSpPr>
-          <p:cNvPr id="146" name="TextBox 145"/>
-          <p:cNvSpPr txBox="1"/>
-          <p:nvPr/>
-        </p:nvSpPr>
-        <p:spPr>
-          <a:xfrm>
-            <a:off x="5715000" y="1993392"/>
-            <a:ext cx="3200400" cy="420624"/>
-          </a:xfrm>
-          <a:prstGeom prst="rect">
-            <a:avLst/>
-          </a:prstGeom>
-          <a:noFill/>
-        </p:spPr>
-        <p:txBody>
-          <a:bodyPr wrap="square" lIns="45720" rIns="45720" tIns="9144" bIns="9144" anchor="ctr">
-            <a:spAutoFit/>
-          </a:bodyPr>
-          <a:lstStyle/>
-          <a:p>
-            <a:pPr algn="ctr"/>
-            <a:r>
-              <a:rPr sz="1050" b="1">
-                <a:solidFill>
-                  <a:srgbClr val="FFFFFF"/>
-                </a:solidFill>
-                <a:latin typeface="Calibri"/>
-              </a:rPr>
-              <a:t>2  Seen this exact line shape before?</a:t>
-            </a:r>
-          </a:p>
-          <a:p>
-            <a:pPr algn="ctr"/>
-            <a:r>
-              <a:rPr sz="850" b="0">
-                <a:solidFill>
-                  <a:srgbClr val="EEF3FA"/>
-                </a:solidFill>
-                <a:latin typeface="Calibri"/>
-              </a:rPr>
-              <a:t>quick fingerprint check</a:t>
-            </a:r>
-          </a:p>
-        </p:txBody>
-      </p:sp>
-      <p:sp>
-        <p:nvSpPr>
-          <p:cNvPr id="147" name="Rounded Rectangle 146"/>
-          <p:cNvSpPr/>
-          <p:nvPr/>
-        </p:nvSpPr>
-        <p:spPr>
-          <a:xfrm>
-            <a:off x="5715000" y="2523744"/>
-            <a:ext cx="3200400" cy="420624"/>
-          </a:xfrm>
-          <a:prstGeom prst="roundRect">
-            <a:avLst>
-              <a:gd name="adj" fmla="val 15000"/>
-            </a:avLst>
-          </a:prstGeom>
-          <a:solidFill>
-            <a:srgbClr val="1F5FBF"/>
-          </a:solidFill>
-          <a:ln>
-            <a:noFill/>
-          </a:ln>
-          <a:effectLst/>
-        </p:spPr>
-        <p:style>
-          <a:lnRef idx="1">
-            <a:schemeClr val="accent1"/>
-          </a:lnRef>
-          <a:fillRef idx="3">
-            <a:schemeClr val="accent1"/>
-          </a:fillRef>
-          <a:effectRef idx="2">
-            <a:schemeClr val="accent1"/>
-          </a:effectRef>
-          <a:fontRef idx="minor">
-            <a:schemeClr val="lt1"/>
-          </a:fontRef>
-        </p:style>
-        <p:txBody>
-          <a:bodyPr rtlCol="0" anchor="ctr"/>
-          <a:lstStyle/>
-          <a:p>
-            <a:pPr algn="ctr"/>
-          </a:p>
-        </p:txBody>
-      </p:sp>
-      <p:sp>
-        <p:nvSpPr>
-          <p:cNvPr id="148" name="TextBox 147"/>
-          <p:cNvSpPr txBox="1"/>
-          <p:nvPr/>
-        </p:nvSpPr>
-        <p:spPr>
-          <a:xfrm>
-            <a:off x="5715000" y="2523744"/>
-            <a:ext cx="3200400" cy="420624"/>
-          </a:xfrm>
-          <a:prstGeom prst="rect">
-            <a:avLst/>
-          </a:prstGeom>
-          <a:noFill/>
-        </p:spPr>
-        <p:txBody>
-          <a:bodyPr wrap="square" lIns="45720" rIns="45720" tIns="9144" bIns="9144" anchor="ctr">
-            <a:spAutoFit/>
-          </a:bodyPr>
-          <a:lstStyle/>
-          <a:p>
-            <a:pPr algn="ctr"/>
-            <a:r>
-              <a:rPr sz="1050" b="1">
-                <a:solidFill>
-                  <a:srgbClr val="FFFFFF"/>
-                </a:solidFill>
-                <a:latin typeface="Calibri"/>
-              </a:rPr>
-              <a:t>3  Group similar lines (Drain3)</a:t>
-            </a:r>
-          </a:p>
-          <a:p>
-            <a:pPr algn="ctr"/>
-            <a:r>
-              <a:rPr sz="850" b="0">
-                <a:solidFill>
-                  <a:srgbClr val="EEF3FA"/>
-                </a:solidFill>
-                <a:latin typeface="Calibri"/>
-              </a:rPr>
-              <a:t>millions of lines → a few thousand patterns</a:t>
-            </a:r>
-          </a:p>
-        </p:txBody>
-      </p:sp>
-      <p:sp>
-        <p:nvSpPr>
-          <p:cNvPr id="149" name="Rounded Rectangle 148"/>
-          <p:cNvSpPr/>
-          <p:nvPr/>
-        </p:nvSpPr>
-        <p:spPr>
-          <a:xfrm>
-            <a:off x="5715000" y="3054096"/>
-            <a:ext cx="3200400" cy="420624"/>
-          </a:xfrm>
-          <a:prstGeom prst="roundRect">
-            <a:avLst>
-              <a:gd name="adj" fmla="val 15000"/>
-            </a:avLst>
-          </a:prstGeom>
-          <a:solidFill>
-            <a:srgbClr val="1F5FBF"/>
-          </a:solidFill>
-          <a:ln>
-            <a:noFill/>
-          </a:ln>
-          <a:effectLst/>
-        </p:spPr>
-        <p:style>
-          <a:lnRef idx="1">
-            <a:schemeClr val="accent1"/>
-          </a:lnRef>
-          <a:fillRef idx="3">
-            <a:schemeClr val="accent1"/>
-          </a:fillRef>
-          <a:effectRef idx="2">
-            <a:schemeClr val="accent1"/>
-          </a:effectRef>
-          <a:fontRef idx="minor">
-            <a:schemeClr val="lt1"/>
-          </a:fontRef>
-        </p:style>
-        <p:txBody>
-          <a:bodyPr rtlCol="0" anchor="ctr"/>
-          <a:lstStyle/>
-          <a:p>
-            <a:pPr algn="ctr"/>
-          </a:p>
-        </p:txBody>
-      </p:sp>
-      <p:sp>
-        <p:nvSpPr>
-          <p:cNvPr id="150" name="TextBox 149"/>
-          <p:cNvSpPr txBox="1"/>
-          <p:nvPr/>
-        </p:nvSpPr>
-        <p:spPr>
-          <a:xfrm>
-            <a:off x="5715000" y="3054096"/>
-            <a:ext cx="3200400" cy="420624"/>
-          </a:xfrm>
-          <a:prstGeom prst="rect">
-            <a:avLst/>
-          </a:prstGeom>
-          <a:noFill/>
-        </p:spPr>
-        <p:txBody>
-          <a:bodyPr wrap="square" lIns="45720" rIns="45720" tIns="9144" bIns="9144" anchor="ctr">
-            <a:spAutoFit/>
-          </a:bodyPr>
-          <a:lstStyle/>
-          <a:p>
-            <a:pPr algn="ctr"/>
-            <a:r>
-              <a:rPr sz="1050" b="1">
-                <a:solidFill>
-                  <a:srgbClr val="FFFFFF"/>
-                </a:solidFill>
-                <a:latin typeface="Calibri"/>
-              </a:rPr>
-              <a:t>4  Does this pattern have a saved rule?</a:t>
-            </a:r>
-          </a:p>
-          <a:p>
-            <a:pPr algn="ctr"/>
-            <a:r>
-              <a:rPr sz="850" b="0">
-                <a:solidFill>
-                  <a:srgbClr val="EEF3FA"/>
-                </a:solidFill>
-                <a:latin typeface="Calibri"/>
-              </a:rPr>
-              <a:t>checked once per pattern, not per line</a:t>
-            </a:r>
-          </a:p>
-        </p:txBody>
-      </p:sp>
-      <p:sp>
-        <p:nvSpPr>
-          <p:cNvPr id="151" name="Rounded Rectangle 150"/>
-          <p:cNvSpPr/>
-          <p:nvPr/>
-        </p:nvSpPr>
-        <p:spPr>
-          <a:xfrm>
-            <a:off x="5715000" y="3584448"/>
-            <a:ext cx="3200400" cy="420624"/>
-          </a:xfrm>
-          <a:prstGeom prst="roundRect">
-            <a:avLst>
-              <a:gd name="adj" fmla="val 15000"/>
-            </a:avLst>
-          </a:prstGeom>
-          <a:solidFill>
-            <a:srgbClr val="6A3FB5"/>
-          </a:solidFill>
-          <a:ln>
-            <a:noFill/>
-          </a:ln>
-          <a:effectLst/>
-        </p:spPr>
-        <p:style>
-          <a:lnRef idx="1">
-            <a:schemeClr val="accent1"/>
-          </a:lnRef>
-          <a:fillRef idx="3">
-            <a:schemeClr val="accent1"/>
-          </a:fillRef>
-          <a:effectRef idx="2">
-            <a:schemeClr val="accent1"/>
-          </a:effectRef>
-          <a:fontRef idx="minor">
-            <a:schemeClr val="lt1"/>
-          </a:fontRef>
-        </p:style>
-        <p:txBody>
-          <a:bodyPr rtlCol="0" anchor="ctr"/>
-          <a:lstStyle/>
-          <a:p>
-            <a:pPr algn="ctr"/>
-          </a:p>
-        </p:txBody>
-      </p:sp>
-      <p:sp>
-        <p:nvSpPr>
-          <p:cNvPr id="152" name="TextBox 151"/>
-          <p:cNvSpPr txBox="1"/>
-          <p:nvPr/>
-        </p:nvSpPr>
-        <p:spPr>
-          <a:xfrm>
-            <a:off x="5715000" y="3584448"/>
-            <a:ext cx="3200400" cy="420624"/>
-          </a:xfrm>
-          <a:prstGeom prst="rect">
-            <a:avLst/>
-          </a:prstGeom>
-          <a:noFill/>
-        </p:spPr>
-        <p:txBody>
-          <a:bodyPr wrap="square" lIns="45720" rIns="45720" tIns="9144" bIns="9144" anchor="ctr">
-            <a:spAutoFit/>
-          </a:bodyPr>
-          <a:lstStyle/>
-          <a:p>
-            <a:pPr algn="ctr"/>
-            <a:r>
-              <a:rPr sz="1050" b="1">
-                <a:solidFill>
-                  <a:srgbClr val="FFFFFF"/>
-                </a:solidFill>
-                <a:latin typeface="Calibri"/>
-              </a:rPr>
-              <a:t>5  ML format check (scikit-learn)</a:t>
-            </a:r>
-          </a:p>
-          <a:p>
-            <a:pPr algn="ctr"/>
-            <a:r>
-              <a:rPr sz="850" b="0">
-                <a:solidFill>
-                  <a:srgbClr val="EEF3FA"/>
-                </a:solidFill>
-                <a:latin typeface="Calibri"/>
-              </a:rPr>
-              <a:t>known log family, or a brand-new format?</a:t>
-            </a:r>
-          </a:p>
-        </p:txBody>
-      </p:sp>
-      <p:sp>
-        <p:nvSpPr>
-          <p:cNvPr id="153" name="Rounded Rectangle 152"/>
-          <p:cNvSpPr/>
-          <p:nvPr/>
-        </p:nvSpPr>
-        <p:spPr>
-          <a:xfrm>
-            <a:off x="5715000" y="4114800"/>
-            <a:ext cx="1554480" cy="420624"/>
-          </a:xfrm>
-          <a:prstGeom prst="roundRect">
-            <a:avLst>
-              <a:gd name="adj" fmla="val 15000"/>
-            </a:avLst>
-          </a:prstGeom>
-          <a:solidFill>
-            <a:srgbClr val="F28322"/>
-          </a:solidFill>
-          <a:ln>
-            <a:noFill/>
-          </a:ln>
-          <a:effectLst/>
-        </p:spPr>
-        <p:style>
-          <a:lnRef idx="1">
-            <a:schemeClr val="accent1"/>
-          </a:lnRef>
-          <a:fillRef idx="3">
-            <a:schemeClr val="accent1"/>
-          </a:fillRef>
-          <a:effectRef idx="2">
-            <a:schemeClr val="accent1"/>
-          </a:effectRef>
-          <a:fontRef idx="minor">
-            <a:schemeClr val="lt1"/>
-          </a:fontRef>
-        </p:style>
-        <p:txBody>
-          <a:bodyPr rtlCol="0" anchor="ctr"/>
-          <a:lstStyle/>
-          <a:p>
-            <a:pPr algn="ctr"/>
-          </a:p>
-        </p:txBody>
-      </p:sp>
-      <p:sp>
-        <p:nvSpPr>
-          <p:cNvPr id="154" name="TextBox 153"/>
-          <p:cNvSpPr txBox="1"/>
-          <p:nvPr/>
-        </p:nvSpPr>
-        <p:spPr>
-          <a:xfrm>
-            <a:off x="5715000" y="4114800"/>
-            <a:ext cx="1554480" cy="420624"/>
-          </a:xfrm>
-          <a:prstGeom prst="rect">
-            <a:avLst/>
-          </a:prstGeom>
-          <a:noFill/>
-        </p:spPr>
-        <p:txBody>
-          <a:bodyPr wrap="square" lIns="45720" rIns="45720" tIns="9144" bIns="9144" anchor="ctr">
-            <a:spAutoFit/>
-          </a:bodyPr>
-          <a:lstStyle/>
-          <a:p>
-            <a:pPr algn="ctr"/>
-            <a:r>
-              <a:rPr sz="1000" b="1">
-                <a:solidFill>
-                  <a:srgbClr val="FFFFFF"/>
-                </a:solidFill>
-                <a:latin typeface="Calibri"/>
-              </a:rPr>
-              <a:t>AI writes a rule</a:t>
-            </a:r>
-          </a:p>
-          <a:p>
-            <a:pPr algn="ctr"/>
-            <a:r>
-              <a:rPr sz="750" b="0">
-                <a:solidFill>
-                  <a:srgbClr val="FFF4E8"/>
-                </a:solidFill>
-                <a:latin typeface="Calibri"/>
-              </a:rPr>
-              <a:t>once per pattern</a:t>
-            </a:r>
-          </a:p>
-        </p:txBody>
-      </p:sp>
-      <p:sp>
-        <p:nvSpPr>
-          <p:cNvPr id="155" name="Rounded Rectangle 154"/>
-          <p:cNvSpPr/>
-          <p:nvPr/>
-        </p:nvSpPr>
-        <p:spPr>
-          <a:xfrm>
-            <a:off x="7360920" y="4114800"/>
-            <a:ext cx="1554480" cy="420624"/>
-          </a:xfrm>
-          <a:prstGeom prst="roundRect">
-            <a:avLst>
-              <a:gd name="adj" fmla="val 15000"/>
-            </a:avLst>
-          </a:prstGeom>
-          <a:solidFill>
-            <a:srgbClr val="C0392B"/>
-          </a:solidFill>
-          <a:ln>
-            <a:noFill/>
-          </a:ln>
-          <a:effectLst/>
-        </p:spPr>
-        <p:style>
-          <a:lnRef idx="1">
-            <a:schemeClr val="accent1"/>
-          </a:lnRef>
-          <a:fillRef idx="3">
-            <a:schemeClr val="accent1"/>
-          </a:fillRef>
-          <a:effectRef idx="2">
-            <a:schemeClr val="accent1"/>
-          </a:effectRef>
-          <a:fontRef idx="minor">
-            <a:schemeClr val="lt1"/>
-          </a:fontRef>
-        </p:style>
-        <p:txBody>
-          <a:bodyPr rtlCol="0" anchor="ctr"/>
-          <a:lstStyle/>
-          <a:p>
-            <a:pPr algn="ctr"/>
-          </a:p>
-        </p:txBody>
-      </p:sp>
-      <p:sp>
-        <p:nvSpPr>
-          <p:cNvPr id="156" name="TextBox 155"/>
-          <p:cNvSpPr txBox="1"/>
-          <p:nvPr/>
-        </p:nvSpPr>
-        <p:spPr>
-          <a:xfrm>
-            <a:off x="7360920" y="4114800"/>
-            <a:ext cx="1554480" cy="420624"/>
-          </a:xfrm>
-          <a:prstGeom prst="rect">
-            <a:avLst/>
-          </a:prstGeom>
-          <a:noFill/>
-        </p:spPr>
-        <p:txBody>
-          <a:bodyPr wrap="square" lIns="45720" rIns="45720" tIns="9144" bIns="9144" anchor="ctr">
-            <a:spAutoFit/>
-          </a:bodyPr>
-          <a:lstStyle/>
-          <a:p>
-            <a:pPr algn="ctr"/>
-            <a:r>
-              <a:rPr sz="1000" b="1">
-                <a:solidFill>
-                  <a:srgbClr val="FFFFFF"/>
-                </a:solidFill>
-                <a:latin typeface="Calibri"/>
-              </a:rPr>
-              <a:t>Hold for review</a:t>
-            </a:r>
-          </a:p>
-          <a:p>
-            <a:pPr algn="ctr"/>
-            <a:r>
-              <a:rPr sz="750" b="0">
-                <a:solidFill>
-                  <a:srgbClr val="FDECEA"/>
-                </a:solidFill>
-                <a:latin typeface="Calibri"/>
-              </a:rPr>
-              <a:t>learned once it repeats</a:t>
-            </a:r>
-          </a:p>
-        </p:txBody>
-      </p:sp>
-      <p:sp>
-        <p:nvSpPr>
-          <p:cNvPr id="157" name="Rounded Rectangle 156"/>
-          <p:cNvSpPr/>
-          <p:nvPr/>
-        </p:nvSpPr>
-        <p:spPr>
-          <a:xfrm>
-            <a:off x="5715000" y="4645152"/>
-            <a:ext cx="3200400" cy="420624"/>
-          </a:xfrm>
-          <a:prstGeom prst="roundRect">
-            <a:avLst>
-              <a:gd name="adj" fmla="val 15000"/>
-            </a:avLst>
-          </a:prstGeom>
-          <a:solidFill>
-            <a:srgbClr val="0E8C8C"/>
-          </a:solidFill>
-          <a:ln>
-            <a:noFill/>
-          </a:ln>
-          <a:effectLst/>
-        </p:spPr>
-        <p:style>
-          <a:lnRef idx="1">
-            <a:schemeClr val="accent1"/>
-          </a:lnRef>
-          <a:fillRef idx="3">
-            <a:schemeClr val="accent1"/>
-          </a:fillRef>
-          <a:effectRef idx="2">
-            <a:schemeClr val="accent1"/>
-          </a:effectRef>
-          <a:fontRef idx="minor">
-            <a:schemeClr val="lt1"/>
-          </a:fontRef>
-        </p:style>
-        <p:txBody>
-          <a:bodyPr rtlCol="0" anchor="ctr"/>
-          <a:lstStyle/>
-          <a:p>
-            <a:pPr algn="ctr"/>
-          </a:p>
-        </p:txBody>
-      </p:sp>
-      <p:sp>
-        <p:nvSpPr>
-          <p:cNvPr id="158" name="TextBox 157"/>
-          <p:cNvSpPr txBox="1"/>
-          <p:nvPr/>
-        </p:nvSpPr>
-        <p:spPr>
-          <a:xfrm>
-            <a:off x="5715000" y="4645152"/>
-            <a:ext cx="3200400" cy="420624"/>
-          </a:xfrm>
-          <a:prstGeom prst="rect">
-            <a:avLst/>
-          </a:prstGeom>
-          <a:noFill/>
-        </p:spPr>
-        <p:txBody>
-          <a:bodyPr wrap="square" lIns="45720" rIns="45720" tIns="9144" bIns="9144" anchor="ctr">
-            <a:spAutoFit/>
-          </a:bodyPr>
-          <a:lstStyle/>
-          <a:p>
-            <a:pPr algn="ctr"/>
-            <a:r>
-              <a:rPr sz="1050" b="1">
-                <a:solidFill>
-                  <a:srgbClr val="FFFFFF"/>
-                </a:solidFill>
-                <a:latin typeface="Calibri"/>
-              </a:rPr>
-              <a:t>6  Save the rule</a:t>
-            </a:r>
-          </a:p>
-          <a:p>
-            <a:pPr algn="ctr"/>
-            <a:r>
-              <a:rPr sz="850" b="0">
-                <a:solidFill>
-                  <a:srgbClr val="EEF3FA"/>
-                </a:solidFill>
-                <a:latin typeface="Calibri"/>
-              </a:rPr>
-              <a:t>every future matching line reuses it</a:t>
-            </a:r>
-          </a:p>
-        </p:txBody>
-      </p:sp>
-      <p:sp>
-        <p:nvSpPr>
-          <p:cNvPr id="159" name="Rounded Rectangle 158"/>
-          <p:cNvSpPr/>
-          <p:nvPr/>
-        </p:nvSpPr>
-        <p:spPr>
-          <a:xfrm>
-            <a:off x="5715000" y="5175504"/>
-            <a:ext cx="5989320" cy="420624"/>
-          </a:xfrm>
-          <a:prstGeom prst="roundRect">
-            <a:avLst>
-              <a:gd name="adj" fmla="val 15000"/>
-            </a:avLst>
+            <a:off x="5788152" y="5221224"/>
+            <a:ext cx="292608" cy="292608"/>
+          </a:xfrm>
+          <a:prstGeom prst="ellipse">
+            <a:avLst/>
           </a:prstGeom>
           <a:solidFill>
             <a:srgbClr val="138A36"/>
@@ -15072,23 +16103,32 @@
           </a:fontRef>
         </p:style>
         <p:txBody>
-          <a:bodyPr rtlCol="0" anchor="ctr"/>
+          <a:bodyPr rtlCol="0" anchor="ctr" lIns="0" rIns="0" tIns="0" bIns="0"/>
           <a:lstStyle/>
           <a:p>
             <a:pPr algn="ctr"/>
-          </a:p>
-        </p:txBody>
-      </p:sp>
-      <p:sp>
-        <p:nvSpPr>
-          <p:cNvPr id="160" name="TextBox 159"/>
+            <a:r>
+              <a:rPr sz="1050" b="1" i="0">
+                <a:solidFill>
+                  <a:srgbClr val="FFFFFF"/>
+                </a:solidFill>
+                <a:latin typeface="Calibri"/>
+              </a:rPr>
+              <a:t>7</a:t>
+            </a:r>
+          </a:p>
+        </p:txBody>
+      </p:sp>
+      <p:sp>
+        <p:nvSpPr>
+          <p:cNvPr id="186" name="TextBox 185"/>
           <p:cNvSpPr txBox="1"/>
           <p:nvPr/>
         </p:nvSpPr>
         <p:spPr>
           <a:xfrm>
-            <a:off x="5715000" y="5175504"/>
-            <a:ext cx="5989320" cy="420624"/>
+            <a:off x="6144768" y="5175504"/>
+            <a:ext cx="5230368" cy="384048"/>
           </a:xfrm>
           <a:prstGeom prst="rect">
             <a:avLst/>
@@ -15096,51 +16136,119 @@
           <a:noFill/>
         </p:spPr>
         <p:txBody>
-          <a:bodyPr wrap="square" lIns="45720" rIns="45720" tIns="9144" bIns="9144" anchor="ctr">
+          <a:bodyPr wrap="square" lIns="36576" rIns="36576" tIns="0" bIns="0" anchor="ctr">
             <a:spAutoFit/>
           </a:bodyPr>
           <a:lstStyle/>
           <a:p>
-            <a:pPr algn="ctr"/>
-            <a:r>
-              <a:rPr sz="1050" b="1">
-                <a:solidFill>
-                  <a:srgbClr val="FFFFFF"/>
-                </a:solidFill>
-                <a:latin typeface="Calibri"/>
-              </a:rPr>
-              <a:t>7  Apply rule &amp; clean up</a:t>
-            </a:r>
-          </a:p>
-          <a:p>
-            <a:pPr algn="ctr"/>
-            <a:r>
-              <a:rPr sz="850" b="0">
-                <a:solidFill>
-                  <a:srgbClr val="EEF3FA"/>
-                </a:solidFill>
-                <a:latin typeface="Calibri"/>
-              </a:rPr>
-              <a:t>time → UTC · one severity scale · event tags · IPs &amp; users pulled out · original line kept</a:t>
-            </a:r>
-          </a:p>
-        </p:txBody>
-      </p:sp>
-      <p:sp>
-        <p:nvSpPr>
-          <p:cNvPr id="161" name="Rounded Rectangle 160"/>
+            <a:r>
+              <a:rPr sz="1050" b="1" i="0">
+                <a:solidFill>
+                  <a:srgbClr val="138A36"/>
+                </a:solidFill>
+                <a:latin typeface="Calibri"/>
+              </a:rPr>
+              <a:t>Clean up every line</a:t>
+            </a:r>
+          </a:p>
+          <a:p>
+            <a:r>
+              <a:rPr sz="850" b="0" i="0">
+                <a:solidFill>
+                  <a:srgbClr val="3A4250"/>
+                </a:solidFill>
+                <a:latin typeface="Calibri"/>
+              </a:rPr>
+              <a:t>Fields mapped · time → UTC · one severity scale · IPs &amp; users tagged · original line kept</a:t>
+            </a:r>
+          </a:p>
+        </p:txBody>
+      </p:sp>
+      <p:pic>
+        <p:nvPicPr>
+          <p:cNvPr id="187" name="Picture 186" descr="image.png"/>
+          <p:cNvPicPr>
+            <a:picLocks noChangeAspect="1"/>
+          </p:cNvPicPr>
+          <p:nvPr/>
+        </p:nvPicPr>
+        <p:blipFill>
+          <a:blip r:embed="rId3"/>
+          <a:stretch>
+            <a:fillRect/>
+          </a:stretch>
+        </p:blipFill>
+        <p:spPr>
+          <a:xfrm>
+            <a:off x="11411712" y="5230368"/>
+            <a:ext cx="274320" cy="274320"/>
+          </a:xfrm>
+          <a:prstGeom prst="rect">
+            <a:avLst/>
+          </a:prstGeom>
+        </p:spPr>
+      </p:pic>
+      <p:sp>
+        <p:nvSpPr>
+          <p:cNvPr id="188" name="Rounded Rectangle 187"/>
           <p:cNvSpPr/>
           <p:nvPr/>
         </p:nvSpPr>
         <p:spPr>
           <a:xfrm>
-            <a:off x="5715000" y="5705856"/>
-            <a:ext cx="5989320" cy="420624"/>
+            <a:off x="5669280" y="5669280"/>
+            <a:ext cx="6108192" cy="420624"/>
           </a:xfrm>
           <a:prstGeom prst="roundRect">
             <a:avLst>
-              <a:gd name="adj" fmla="val 15000"/>
+              <a:gd name="adj" fmla="val 14000"/>
             </a:avLst>
+          </a:prstGeom>
+          <a:solidFill>
+            <a:srgbClr val="FFFFFF"/>
+          </a:solidFill>
+          <a:ln w="9525">
+            <a:solidFill>
+              <a:srgbClr val="D5DCE6"/>
+            </a:solidFill>
+          </a:ln>
+          <a:effectLst/>
+        </p:spPr>
+        <p:style>
+          <a:lnRef idx="1">
+            <a:schemeClr val="accent1"/>
+          </a:lnRef>
+          <a:fillRef idx="3">
+            <a:schemeClr val="accent1"/>
+          </a:fillRef>
+          <a:effectRef idx="2">
+            <a:schemeClr val="accent1"/>
+          </a:effectRef>
+          <a:fontRef idx="minor">
+            <a:schemeClr val="lt1"/>
+          </a:fontRef>
+        </p:style>
+        <p:txBody>
+          <a:bodyPr rtlCol="0" anchor="ctr"/>
+          <a:lstStyle/>
+          <a:p>
+            <a:pPr algn="ctr"/>
+          </a:p>
+        </p:txBody>
+      </p:sp>
+      <p:sp>
+        <p:nvSpPr>
+          <p:cNvPr id="189" name="Rectangle 188"/>
+          <p:cNvSpPr/>
+          <p:nvPr/>
+        </p:nvSpPr>
+        <p:spPr>
+          <a:xfrm>
+            <a:off x="5669280" y="5705856"/>
+            <a:ext cx="54864" cy="347472"/>
+          </a:xfrm>
+          <a:prstGeom prst="rect">
+            <a:avLst/>
           </a:prstGeom>
           <a:solidFill>
             <a:srgbClr val="0B2A5B"/>
@@ -15174,74 +16282,23 @@
       </p:sp>
       <p:sp>
         <p:nvSpPr>
-          <p:cNvPr id="162" name="TextBox 161"/>
-          <p:cNvSpPr txBox="1"/>
-          <p:nvPr/>
-        </p:nvSpPr>
-        <p:spPr>
-          <a:xfrm>
-            <a:off x="5715000" y="5705856"/>
-            <a:ext cx="5989320" cy="420624"/>
-          </a:xfrm>
-          <a:prstGeom prst="rect">
-            <a:avLst/>
-          </a:prstGeom>
-          <a:noFill/>
-        </p:spPr>
-        <p:txBody>
-          <a:bodyPr wrap="square" lIns="45720" rIns="45720" tIns="9144" bIns="9144" anchor="ctr">
-            <a:spAutoFit/>
-          </a:bodyPr>
-          <a:lstStyle/>
-          <a:p>
-            <a:pPr algn="ctr"/>
-            <a:r>
-              <a:rPr sz="1050" b="1">
-                <a:solidFill>
-                  <a:srgbClr val="FFFFFF"/>
-                </a:solidFill>
-                <a:latin typeface="Calibri"/>
-              </a:rPr>
-              <a:t>8  One clean, common JSON format out</a:t>
-            </a:r>
-          </a:p>
-          <a:p>
-            <a:pPr algn="ctr"/>
-            <a:r>
-              <a:rPr sz="850" b="0">
-                <a:solidFill>
-                  <a:srgbClr val="EEF3FA"/>
-                </a:solidFill>
-                <a:latin typeface="Calibri"/>
-              </a:rPr>
-              <a:t>ready for SIEM, dashboards and search</a:t>
-            </a:r>
-          </a:p>
-        </p:txBody>
-      </p:sp>
-      <p:sp>
-        <p:nvSpPr>
-          <p:cNvPr id="163" name="Rounded Rectangle 162"/>
+          <p:cNvPr id="190" name="Oval 189"/>
           <p:cNvSpPr/>
           <p:nvPr/>
         </p:nvSpPr>
         <p:spPr>
           <a:xfrm>
-            <a:off x="9326880" y="1993392"/>
-            <a:ext cx="2377440" cy="1481328"/>
-          </a:xfrm>
-          <a:prstGeom prst="roundRect">
-            <a:avLst>
-              <a:gd name="adj" fmla="val 6000"/>
-            </a:avLst>
+            <a:off x="5788152" y="5733288"/>
+            <a:ext cx="292608" cy="292608"/>
+          </a:xfrm>
+          <a:prstGeom prst="ellipse">
+            <a:avLst/>
           </a:prstGeom>
           <a:solidFill>
-            <a:srgbClr val="E8F5EC"/>
+            <a:srgbClr val="0B2A5B"/>
           </a:solidFill>
-          <a:ln w="15875">
-            <a:solidFill>
-              <a:srgbClr val="138A36"/>
-            </a:solidFill>
+          <a:ln>
+            <a:noFill/>
           </a:ln>
           <a:effectLst/>
         </p:spPr>
@@ -15260,23 +16317,32 @@
           </a:fontRef>
         </p:style>
         <p:txBody>
-          <a:bodyPr rtlCol="0" anchor="ctr"/>
+          <a:bodyPr rtlCol="0" anchor="ctr" lIns="0" rIns="0" tIns="0" bIns="0"/>
           <a:lstStyle/>
           <a:p>
             <a:pPr algn="ctr"/>
-          </a:p>
-        </p:txBody>
-      </p:sp>
-      <p:sp>
-        <p:nvSpPr>
-          <p:cNvPr id="164" name="TextBox 163"/>
+            <a:r>
+              <a:rPr sz="1050" b="1" i="0">
+                <a:solidFill>
+                  <a:srgbClr val="FFFFFF"/>
+                </a:solidFill>
+                <a:latin typeface="Calibri"/>
+              </a:rPr>
+              <a:t>8</a:t>
+            </a:r>
+          </a:p>
+        </p:txBody>
+      </p:sp>
+      <p:sp>
+        <p:nvSpPr>
+          <p:cNvPr id="191" name="TextBox 190"/>
           <p:cNvSpPr txBox="1"/>
           <p:nvPr/>
         </p:nvSpPr>
         <p:spPr>
           <a:xfrm>
-            <a:off x="9400032" y="1993392"/>
-            <a:ext cx="2231136" cy="1481328"/>
+            <a:off x="6144768" y="5687568"/>
+            <a:ext cx="4901184" cy="384048"/>
           </a:xfrm>
           <a:prstGeom prst="rect">
             <a:avLst/>
@@ -15284,95 +16350,104 @@
           <a:noFill/>
         </p:spPr>
         <p:txBody>
-          <a:bodyPr wrap="square" lIns="45720" rIns="45720" tIns="9144" bIns="9144" anchor="ctr">
+          <a:bodyPr wrap="square" lIns="36576" rIns="36576" tIns="0" bIns="0" anchor="ctr">
             <a:spAutoFit/>
           </a:bodyPr>
           <a:lstStyle/>
           <a:p>
-            <a:pPr algn="ctr"/>
-            <a:r>
-              <a:rPr sz="1300" b="1">
-                <a:solidFill>
-                  <a:srgbClr val="138A36"/>
-                </a:solidFill>
-                <a:latin typeface="Calibri"/>
-              </a:rPr>
-              <a:t>FAST PATH</a:t>
-            </a:r>
-          </a:p>
-          <a:p>
-            <a:pPr algn="ctr"/>
-            <a:r>
-              <a:rPr sz="950" b="0">
-                <a:solidFill>
-                  <a:srgbClr val="1E2530"/>
-                </a:solidFill>
-                <a:latin typeface="Calibri"/>
-              </a:rPr>
-              <a:t>most logs take this route</a:t>
-            </a:r>
-          </a:p>
-          <a:p>
-            <a:pPr algn="ctr"/>
-            <a:r>
-              <a:rPr sz="400" b="0">
-                <a:solidFill>
-                  <a:srgbClr val="1E2530"/>
-                </a:solidFill>
-                <a:latin typeface="Calibri"/>
-              </a:rPr>
-              <a:t> </a:t>
-            </a:r>
-          </a:p>
-          <a:p>
-            <a:pPr algn="ctr"/>
-            <a:r>
-              <a:rPr sz="950" b="0">
-                <a:solidFill>
-                  <a:srgbClr val="1E2530"/>
-                </a:solidFill>
-                <a:latin typeface="Calibri"/>
-              </a:rPr>
-              <a:t>saved rule applied instantly</a:t>
-            </a:r>
-          </a:p>
-          <a:p>
-            <a:pPr algn="ctr"/>
-            <a:r>
-              <a:rPr sz="950" b="0">
-                <a:solidFill>
-                  <a:srgbClr val="1E2530"/>
-                </a:solidFill>
-                <a:latin typeface="Calibri"/>
-              </a:rPr>
-              <a:t>no AI call · no waiting · no cost</a:t>
-            </a:r>
-          </a:p>
-        </p:txBody>
-      </p:sp>
-      <p:sp>
-        <p:nvSpPr>
-          <p:cNvPr id="165" name="Rounded Rectangle 164"/>
+            <a:r>
+              <a:rPr sz="1050" b="1" i="0">
+                <a:solidFill>
+                  <a:srgbClr val="0B2A5B"/>
+                </a:solidFill>
+                <a:latin typeface="Calibri"/>
+              </a:rPr>
+              <a:t>One clean JSON format out</a:t>
+            </a:r>
+          </a:p>
+          <a:p>
+            <a:r>
+              <a:rPr sz="850" b="0" i="0">
+                <a:solidFill>
+                  <a:srgbClr val="3A4250"/>
+                </a:solidFill>
+                <a:latin typeface="Calibri"/>
+              </a:rPr>
+              <a:t>Ready for SIEM tools, dashboards and search</a:t>
+            </a:r>
+          </a:p>
+        </p:txBody>
+      </p:sp>
+      <p:pic>
+        <p:nvPicPr>
+          <p:cNvPr id="192" name="Picture 191" descr="image.png"/>
+          <p:cNvPicPr>
+            <a:picLocks noChangeAspect="1"/>
+          </p:cNvPicPr>
+          <p:nvPr/>
+        </p:nvPicPr>
+        <p:blipFill>
+          <a:blip r:embed="rId4"/>
+          <a:stretch>
+            <a:fillRect/>
+          </a:stretch>
+        </p:blipFill>
+        <p:spPr>
+          <a:xfrm>
+            <a:off x="11082528" y="5742432"/>
+            <a:ext cx="274320" cy="274320"/>
+          </a:xfrm>
+          <a:prstGeom prst="rect">
+            <a:avLst/>
+          </a:prstGeom>
+        </p:spPr>
+      </p:pic>
+      <p:pic>
+        <p:nvPicPr>
+          <p:cNvPr id="193" name="Picture 192" descr="image.png"/>
+          <p:cNvPicPr>
+            <a:picLocks noChangeAspect="1"/>
+          </p:cNvPicPr>
+          <p:nvPr/>
+        </p:nvPicPr>
+        <p:blipFill>
+          <a:blip r:embed="rId11"/>
+          <a:stretch>
+            <a:fillRect/>
+          </a:stretch>
+        </p:blipFill>
+        <p:spPr>
+          <a:xfrm>
+            <a:off x="11411712" y="5742432"/>
+            <a:ext cx="274320" cy="274320"/>
+          </a:xfrm>
+          <a:prstGeom prst="rect">
+            <a:avLst/>
+          </a:prstGeom>
+        </p:spPr>
+      </p:pic>
+      <p:sp>
+        <p:nvSpPr>
+          <p:cNvPr id="194" name="Rounded Rectangle 193"/>
           <p:cNvSpPr/>
           <p:nvPr/>
         </p:nvSpPr>
         <p:spPr>
           <a:xfrm>
-            <a:off x="9326880" y="3584448"/>
-            <a:ext cx="1920240" cy="1481328"/>
+            <a:off x="5614416" y="4087368"/>
+            <a:ext cx="4206240" cy="1024128"/>
           </a:xfrm>
           <a:prstGeom prst="roundRect">
             <a:avLst>
               <a:gd name="adj" fmla="val 8000"/>
             </a:avLst>
           </a:prstGeom>
-          <a:solidFill>
-            <a:srgbClr val="FFF4E8"/>
-          </a:solidFill>
-          <a:ln w="12700">
+          <a:noFill/>
+          <a:ln w="15875">
             <a:solidFill>
               <a:srgbClr val="F28322"/>
             </a:solidFill>
+            <a:prstDash val="dash"/>
           </a:ln>
           <a:effectLst/>
         </p:spPr>
@@ -15398,132 +16473,25 @@
           </a:p>
         </p:txBody>
       </p:sp>
-      <p:sp>
-        <p:nvSpPr>
-          <p:cNvPr id="166" name="TextBox 165"/>
-          <p:cNvSpPr txBox="1"/>
-          <p:nvPr/>
-        </p:nvSpPr>
-        <p:spPr>
-          <a:xfrm>
-            <a:off x="9363456" y="3584448"/>
-            <a:ext cx="1847088" cy="1481328"/>
-          </a:xfrm>
-          <a:prstGeom prst="rect">
-            <a:avLst/>
-          </a:prstGeom>
-          <a:noFill/>
-        </p:spPr>
-        <p:txBody>
-          <a:bodyPr wrap="square" lIns="45720" rIns="45720" tIns="9144" bIns="9144" anchor="ctr">
-            <a:spAutoFit/>
-          </a:bodyPr>
-          <a:lstStyle/>
-          <a:p>
-            <a:pPr algn="ctr"/>
-            <a:r>
-              <a:rPr sz="1100" b="1">
-                <a:solidFill>
-                  <a:srgbClr val="C06010"/>
-                </a:solidFill>
-                <a:latin typeface="Calibri"/>
-              </a:rPr>
-              <a:t>AI PATH</a:t>
-            </a:r>
-          </a:p>
-          <a:p>
-            <a:pPr algn="ctr"/>
-            <a:r>
-              <a:rPr sz="900" b="0">
-                <a:solidFill>
-                  <a:srgbClr val="1E2530"/>
-                </a:solidFill>
-                <a:latin typeface="Calibri"/>
-              </a:rPr>
-              <a:t>used only when a format is new</a:t>
-            </a:r>
-          </a:p>
-          <a:p>
-            <a:pPr algn="ctr"/>
-            <a:r>
-              <a:rPr sz="900" b="0">
-                <a:solidFill>
-                  <a:srgbClr val="1E2530"/>
-                </a:solidFill>
-                <a:latin typeface="Calibri"/>
-              </a:rPr>
-              <a:t>rule learned once, then it</a:t>
-            </a:r>
-          </a:p>
-          <a:p>
-            <a:pPr algn="ctr"/>
-            <a:r>
-              <a:rPr sz="900" b="0">
-                <a:solidFill>
-                  <a:srgbClr val="1E2530"/>
-                </a:solidFill>
-                <a:latin typeface="Calibri"/>
-              </a:rPr>
-              <a:t>joins the fast path</a:t>
-            </a:r>
-          </a:p>
-          <a:p>
-            <a:pPr algn="ctr"/>
-            <a:r>
-              <a:rPr sz="400" b="0">
-                <a:solidFill>
-                  <a:srgbClr val="1E2530"/>
-                </a:solidFill>
-                <a:latin typeface="Calibri"/>
-              </a:rPr>
-              <a:t> </a:t>
-            </a:r>
-          </a:p>
-          <a:p>
-            <a:pPr algn="ctr"/>
-            <a:r>
-              <a:rPr sz="900" b="0">
-                <a:solidFill>
-                  <a:srgbClr val="1E2530"/>
-                </a:solidFill>
-                <a:latin typeface="Calibri"/>
-              </a:rPr>
-              <a:t>AI down? backup AI, then</a:t>
-            </a:r>
-          </a:p>
-          <a:p>
-            <a:pPr algn="ctr"/>
-            <a:r>
-              <a:rPr sz="900" b="0">
-                <a:solidFill>
-                  <a:srgbClr val="1E2530"/>
-                </a:solidFill>
-                <a:latin typeface="Calibri"/>
-              </a:rPr>
-              <a:t>built-in rules take over</a:t>
-            </a:r>
-          </a:p>
-        </p:txBody>
-      </p:sp>
       <p:cxnSp>
         <p:nvCxnSpPr>
-          <p:cNvPr id="167" name="Connector 166"/>
+          <p:cNvPr id="195" name="Connector 194"/>
           <p:cNvCxnSpPr/>
           <p:nvPr/>
         </p:nvCxnSpPr>
         <p:spPr>
           <a:xfrm>
-            <a:off x="7315200" y="1883664"/>
-            <a:ext cx="0" cy="109728"/>
+            <a:off x="5934456" y="1993392"/>
+            <a:ext cx="0" cy="91440"/>
           </a:xfrm>
           <a:prstGeom prst="line">
             <a:avLst/>
           </a:prstGeom>
           <a:ln w="19050">
             <a:solidFill>
-              <a:srgbClr val="5B6573"/>
+              <a:srgbClr val="8A94A6"/>
             </a:solidFill>
-            <a:tailEnd type="triangle" w="med" len="med"/>
+            <a:tailEnd type="triangle" w="med" len="sm"/>
           </a:ln>
         </p:spPr>
         <p:style>
@@ -15543,23 +16511,23 @@
       </p:cxnSp>
       <p:cxnSp>
         <p:nvCxnSpPr>
-          <p:cNvPr id="168" name="Connector 167"/>
+          <p:cNvPr id="196" name="Connector 195"/>
           <p:cNvCxnSpPr/>
           <p:nvPr/>
         </p:nvCxnSpPr>
         <p:spPr>
           <a:xfrm>
-            <a:off x="7315200" y="2414016"/>
-            <a:ext cx="0" cy="109728"/>
+            <a:off x="5934456" y="2505456"/>
+            <a:ext cx="0" cy="91440"/>
           </a:xfrm>
           <a:prstGeom prst="line">
             <a:avLst/>
           </a:prstGeom>
           <a:ln w="19050">
             <a:solidFill>
-              <a:srgbClr val="5B6573"/>
+              <a:srgbClr val="8A94A6"/>
             </a:solidFill>
-            <a:tailEnd type="triangle" w="med" len="med"/>
+            <a:tailEnd type="triangle" w="med" len="sm"/>
           </a:ln>
         </p:spPr>
         <p:style>
@@ -15579,23 +16547,23 @@
       </p:cxnSp>
       <p:cxnSp>
         <p:nvCxnSpPr>
-          <p:cNvPr id="169" name="Connector 168"/>
+          <p:cNvPr id="197" name="Connector 196"/>
           <p:cNvCxnSpPr/>
           <p:nvPr/>
         </p:nvCxnSpPr>
         <p:spPr>
           <a:xfrm>
-            <a:off x="7315200" y="2944368"/>
-            <a:ext cx="0" cy="109728"/>
+            <a:off x="5934456" y="3017520"/>
+            <a:ext cx="0" cy="91440"/>
           </a:xfrm>
           <a:prstGeom prst="line">
             <a:avLst/>
           </a:prstGeom>
           <a:ln w="19050">
             <a:solidFill>
-              <a:srgbClr val="5B6573"/>
+              <a:srgbClr val="8A94A6"/>
             </a:solidFill>
-            <a:tailEnd type="triangle" w="med" len="med"/>
+            <a:tailEnd type="triangle" w="med" len="sm"/>
           </a:ln>
         </p:spPr>
         <p:style>
@@ -15615,23 +16583,23 @@
       </p:cxnSp>
       <p:cxnSp>
         <p:nvCxnSpPr>
-          <p:cNvPr id="170" name="Connector 169"/>
+          <p:cNvPr id="198" name="Connector 197"/>
           <p:cNvCxnSpPr/>
           <p:nvPr/>
         </p:nvCxnSpPr>
         <p:spPr>
           <a:xfrm>
-            <a:off x="7315200" y="3474720"/>
-            <a:ext cx="0" cy="109728"/>
+            <a:off x="5934456" y="3529584"/>
+            <a:ext cx="0" cy="91440"/>
           </a:xfrm>
           <a:prstGeom prst="line">
             <a:avLst/>
           </a:prstGeom>
           <a:ln w="19050">
             <a:solidFill>
-              <a:srgbClr val="5B6573"/>
+              <a:srgbClr val="8A94A6"/>
             </a:solidFill>
-            <a:tailEnd type="triangle" w="med" len="med"/>
+            <a:tailEnd type="triangle" w="med" len="sm"/>
           </a:ln>
         </p:spPr>
         <p:style>
@@ -15651,14 +16619,14 @@
       </p:cxnSp>
       <p:sp>
         <p:nvSpPr>
-          <p:cNvPr id="171" name="TextBox 170"/>
+          <p:cNvPr id="199" name="TextBox 198"/>
           <p:cNvSpPr txBox="1"/>
           <p:nvPr/>
         </p:nvSpPr>
         <p:spPr>
           <a:xfrm>
-            <a:off x="7370064" y="2404872"/>
-            <a:ext cx="822960" cy="182880"/>
+            <a:off x="5998464" y="2487168"/>
+            <a:ext cx="365760" cy="164592"/>
           </a:xfrm>
           <a:prstGeom prst="rect">
             <a:avLst/>
@@ -15666,14 +16634,14 @@
           <a:noFill/>
         </p:spPr>
         <p:txBody>
-          <a:bodyPr wrap="square" lIns="18288" rIns="18288" tIns="9144" bIns="9144" anchor="ctr">
+          <a:bodyPr wrap="square" lIns="9144" rIns="9144" tIns="0" bIns="0" anchor="ctr">
             <a:spAutoFit/>
           </a:bodyPr>
           <a:lstStyle/>
           <a:p>
             <a:pPr algn="l"/>
             <a:r>
-              <a:rPr sz="800" b="1">
+              <a:rPr sz="750" b="1" i="0">
                 <a:solidFill>
                   <a:srgbClr val="C0392B"/>
                 </a:solidFill>
@@ -15686,14 +16654,14 @@
       </p:sp>
       <p:sp>
         <p:nvSpPr>
-          <p:cNvPr id="172" name="TextBox 171"/>
+          <p:cNvPr id="200" name="TextBox 199"/>
           <p:cNvSpPr txBox="1"/>
           <p:nvPr/>
         </p:nvSpPr>
         <p:spPr>
           <a:xfrm>
-            <a:off x="7370064" y="3465576"/>
-            <a:ext cx="822960" cy="182880"/>
+            <a:off x="5998464" y="3511296"/>
+            <a:ext cx="365760" cy="164592"/>
           </a:xfrm>
           <a:prstGeom prst="rect">
             <a:avLst/>
@@ -15701,14 +16669,14 @@
           <a:noFill/>
         </p:spPr>
         <p:txBody>
-          <a:bodyPr wrap="square" lIns="18288" rIns="18288" tIns="9144" bIns="9144" anchor="ctr">
+          <a:bodyPr wrap="square" lIns="9144" rIns="9144" tIns="0" bIns="0" anchor="ctr">
             <a:spAutoFit/>
           </a:bodyPr>
           <a:lstStyle/>
           <a:p>
             <a:pPr algn="l"/>
             <a:r>
-              <a:rPr sz="800" b="1">
+              <a:rPr sz="750" b="1" i="0">
                 <a:solidFill>
                   <a:srgbClr val="C0392B"/>
                 </a:solidFill>
@@ -15721,23 +16689,23 @@
       </p:sp>
       <p:cxnSp>
         <p:nvCxnSpPr>
-          <p:cNvPr id="173" name="Connector 172"/>
+          <p:cNvPr id="201" name="Connector 200"/>
           <p:cNvCxnSpPr/>
           <p:nvPr/>
         </p:nvCxnSpPr>
         <p:spPr>
           <a:xfrm>
-            <a:off x="6492240" y="4005072"/>
-            <a:ext cx="0" cy="109728"/>
+            <a:off x="5934456" y="4041648"/>
+            <a:ext cx="0" cy="91440"/>
           </a:xfrm>
           <a:prstGeom prst="line">
             <a:avLst/>
           </a:prstGeom>
           <a:ln w="19050">
             <a:solidFill>
-              <a:srgbClr val="5B6573"/>
+              <a:srgbClr val="8A94A6"/>
             </a:solidFill>
-            <a:tailEnd type="triangle" w="med" len="med"/>
+            <a:tailEnd type="triangle" w="med" len="sm"/>
           </a:ln>
         </p:spPr>
         <p:style>
@@ -15757,23 +16725,23 @@
       </p:cxnSp>
       <p:cxnSp>
         <p:nvCxnSpPr>
-          <p:cNvPr id="174" name="Connector 173"/>
+          <p:cNvPr id="202" name="Connector 201"/>
           <p:cNvCxnSpPr/>
           <p:nvPr/>
         </p:nvCxnSpPr>
         <p:spPr>
           <a:xfrm>
-            <a:off x="8138160" y="4005072"/>
-            <a:ext cx="0" cy="109728"/>
+            <a:off x="8028432" y="4041648"/>
+            <a:ext cx="0" cy="91440"/>
           </a:xfrm>
           <a:prstGeom prst="line">
             <a:avLst/>
           </a:prstGeom>
           <a:ln w="19050">
             <a:solidFill>
-              <a:srgbClr val="5B6573"/>
+              <a:srgbClr val="8A94A6"/>
             </a:solidFill>
-            <a:tailEnd type="triangle" w="med" len="med"/>
+            <a:tailEnd type="triangle" w="med" len="sm"/>
           </a:ln>
         </p:spPr>
         <p:style>
@@ -15793,14 +16761,14 @@
       </p:cxnSp>
       <p:sp>
         <p:nvSpPr>
-          <p:cNvPr id="175" name="TextBox 174"/>
+          <p:cNvPr id="203" name="TextBox 202"/>
           <p:cNvSpPr txBox="1"/>
           <p:nvPr/>
         </p:nvSpPr>
         <p:spPr>
           <a:xfrm>
-            <a:off x="6537960" y="3995928"/>
-            <a:ext cx="822960" cy="182880"/>
+            <a:off x="5998464" y="4023360"/>
+            <a:ext cx="731520" cy="164592"/>
           </a:xfrm>
           <a:prstGeom prst="rect">
             <a:avLst/>
@@ -15808,34 +16776,34 @@
           <a:noFill/>
         </p:spPr>
         <p:txBody>
-          <a:bodyPr wrap="square" lIns="18288" rIns="18288" tIns="9144" bIns="9144" anchor="ctr">
+          <a:bodyPr wrap="square" lIns="9144" rIns="9144" tIns="0" bIns="0" anchor="ctr">
             <a:spAutoFit/>
           </a:bodyPr>
           <a:lstStyle/>
           <a:p>
             <a:pPr algn="l"/>
             <a:r>
-              <a:rPr sz="750" b="1">
+              <a:rPr sz="750" b="1" i="0">
                 <a:solidFill>
                   <a:srgbClr val="6A3FB5"/>
                 </a:solidFill>
                 <a:latin typeface="Calibri"/>
               </a:rPr>
-              <a:t>known</a:t>
-            </a:r>
-          </a:p>
-        </p:txBody>
-      </p:sp>
-      <p:sp>
-        <p:nvSpPr>
-          <p:cNvPr id="176" name="TextBox 175"/>
+              <a:t>familiar</a:t>
+            </a:r>
+          </a:p>
+        </p:txBody>
+      </p:sp>
+      <p:sp>
+        <p:nvSpPr>
+          <p:cNvPr id="204" name="TextBox 203"/>
           <p:cNvSpPr txBox="1"/>
           <p:nvPr/>
         </p:nvSpPr>
         <p:spPr>
           <a:xfrm>
-            <a:off x="8183880" y="3995928"/>
-            <a:ext cx="822960" cy="182880"/>
+            <a:off x="8092440" y="4023360"/>
+            <a:ext cx="731520" cy="164592"/>
           </a:xfrm>
           <a:prstGeom prst="rect">
             <a:avLst/>
@@ -15843,14 +16811,14 @@
           <a:noFill/>
         </p:spPr>
         <p:txBody>
-          <a:bodyPr wrap="square" lIns="18288" rIns="18288" tIns="9144" bIns="9144" anchor="ctr">
+          <a:bodyPr wrap="square" lIns="9144" rIns="9144" tIns="0" bIns="0" anchor="ctr">
             <a:spAutoFit/>
           </a:bodyPr>
           <a:lstStyle/>
           <a:p>
             <a:pPr algn="l"/>
             <a:r>
-              <a:rPr sz="750" b="1">
+              <a:rPr sz="750" b="1" i="0">
                 <a:solidFill>
                   <a:srgbClr val="6A3FB5"/>
                 </a:solidFill>
@@ -15863,23 +16831,23 @@
       </p:sp>
       <p:cxnSp>
         <p:nvCxnSpPr>
-          <p:cNvPr id="177" name="Connector 176"/>
+          <p:cNvPr id="205" name="Connector 204"/>
           <p:cNvCxnSpPr/>
           <p:nvPr/>
         </p:nvCxnSpPr>
         <p:spPr>
           <a:xfrm>
-            <a:off x="6492240" y="4535424"/>
-            <a:ext cx="0" cy="109728"/>
+            <a:off x="5934456" y="4553712"/>
+            <a:ext cx="0" cy="91440"/>
           </a:xfrm>
           <a:prstGeom prst="line">
             <a:avLst/>
           </a:prstGeom>
           <a:ln w="19050">
             <a:solidFill>
-              <a:srgbClr val="5B6573"/>
+              <a:srgbClr val="8A94A6"/>
             </a:solidFill>
-            <a:tailEnd type="triangle" w="med" len="med"/>
+            <a:tailEnd type="triangle" w="med" len="sm"/>
           </a:ln>
         </p:spPr>
         <p:style>
@@ -15899,23 +16867,23 @@
       </p:cxnSp>
       <p:cxnSp>
         <p:nvCxnSpPr>
-          <p:cNvPr id="178" name="Connector 177"/>
+          <p:cNvPr id="206" name="Connector 205"/>
           <p:cNvCxnSpPr/>
           <p:nvPr/>
         </p:nvCxnSpPr>
         <p:spPr>
           <a:xfrm>
-            <a:off x="8138160" y="4535424"/>
-            <a:ext cx="0" cy="109728"/>
+            <a:off x="8028432" y="4553712"/>
+            <a:ext cx="0" cy="91440"/>
           </a:xfrm>
           <a:prstGeom prst="line">
             <a:avLst/>
           </a:prstGeom>
           <a:ln w="19050">
             <a:solidFill>
-              <a:srgbClr val="5B6573"/>
+              <a:srgbClr val="8A94A6"/>
             </a:solidFill>
-            <a:tailEnd type="triangle" w="med" len="med"/>
+            <a:tailEnd type="triangle" w="med" len="sm"/>
           </a:ln>
         </p:spPr>
         <p:style>
@@ -15935,23 +16903,23 @@
       </p:cxnSp>
       <p:cxnSp>
         <p:nvCxnSpPr>
-          <p:cNvPr id="179" name="Connector 178"/>
+          <p:cNvPr id="207" name="Connector 206"/>
           <p:cNvCxnSpPr/>
           <p:nvPr/>
         </p:nvCxnSpPr>
         <p:spPr>
           <a:xfrm>
-            <a:off x="7315200" y="5065776"/>
-            <a:ext cx="0" cy="109728"/>
+            <a:off x="5934456" y="5065776"/>
+            <a:ext cx="0" cy="91440"/>
           </a:xfrm>
           <a:prstGeom prst="line">
             <a:avLst/>
           </a:prstGeom>
           <a:ln w="19050">
             <a:solidFill>
-              <a:srgbClr val="5B6573"/>
+              <a:srgbClr val="8A94A6"/>
             </a:solidFill>
-            <a:tailEnd type="triangle" w="med" len="med"/>
+            <a:tailEnd type="triangle" w="med" len="sm"/>
           </a:ln>
         </p:spPr>
         <p:style>
@@ -15971,23 +16939,140 @@
       </p:cxnSp>
       <p:cxnSp>
         <p:nvCxnSpPr>
-          <p:cNvPr id="180" name="Connector 179"/>
+          <p:cNvPr id="208" name="Connector 207"/>
           <p:cNvCxnSpPr/>
           <p:nvPr/>
         </p:nvCxnSpPr>
         <p:spPr>
           <a:xfrm>
-            <a:off x="7315200" y="5596128"/>
-            <a:ext cx="0" cy="109728"/>
+            <a:off x="5934456" y="5577840"/>
+            <a:ext cx="0" cy="91440"/>
           </a:xfrm>
           <a:prstGeom prst="line">
             <a:avLst/>
           </a:prstGeom>
           <a:ln w="19050">
             <a:solidFill>
-              <a:srgbClr val="5B6573"/>
+              <a:srgbClr val="8A94A6"/>
             </a:solidFill>
-            <a:tailEnd type="triangle" w="med" len="med"/>
+            <a:tailEnd type="triangle" w="med" len="sm"/>
+          </a:ln>
+        </p:spPr>
+        <p:style>
+          <a:lnRef idx="2">
+            <a:schemeClr val="accent1"/>
+          </a:lnRef>
+          <a:fillRef idx="0">
+            <a:schemeClr val="accent1"/>
+          </a:fillRef>
+          <a:effectRef idx="1">
+            <a:schemeClr val="accent1"/>
+          </a:effectRef>
+          <a:fontRef idx="minor">
+            <a:schemeClr val="tx1"/>
+          </a:fontRef>
+        </p:style>
+      </p:cxnSp>
+      <p:sp>
+        <p:nvSpPr>
+          <p:cNvPr id="209" name="Rounded Rectangle 208"/>
+          <p:cNvSpPr/>
+          <p:nvPr/>
+        </p:nvSpPr>
+        <p:spPr>
+          <a:xfrm>
+            <a:off x="10040112" y="2130552"/>
+            <a:ext cx="384048" cy="2916936"/>
+          </a:xfrm>
+          <a:prstGeom prst="roundRect">
+            <a:avLst>
+              <a:gd name="adj" fmla="val 50000"/>
+            </a:avLst>
+          </a:prstGeom>
+          <a:solidFill>
+            <a:srgbClr val="138A36"/>
+          </a:solidFill>
+          <a:ln>
+            <a:noFill/>
+          </a:ln>
+          <a:effectLst/>
+        </p:spPr>
+        <p:style>
+          <a:lnRef idx="1">
+            <a:schemeClr val="accent1"/>
+          </a:lnRef>
+          <a:fillRef idx="3">
+            <a:schemeClr val="accent1"/>
+          </a:fillRef>
+          <a:effectRef idx="2">
+            <a:schemeClr val="accent1"/>
+          </a:effectRef>
+          <a:fontRef idx="minor">
+            <a:schemeClr val="lt1"/>
+          </a:fontRef>
+        </p:style>
+        <p:txBody>
+          <a:bodyPr rtlCol="0" anchor="ctr"/>
+          <a:lstStyle/>
+          <a:p>
+            <a:pPr algn="ctr"/>
+          </a:p>
+        </p:txBody>
+      </p:sp>
+      <p:sp>
+        <p:nvSpPr>
+          <p:cNvPr id="210" name="TextBox 209"/>
+          <p:cNvSpPr txBox="1"/>
+          <p:nvPr/>
+        </p:nvSpPr>
+        <p:spPr>
+          <a:xfrm rot="16200000">
+            <a:off x="8773668" y="3396996"/>
+            <a:ext cx="2916936" cy="384048"/>
+          </a:xfrm>
+          <a:prstGeom prst="rect">
+            <a:avLst/>
+          </a:prstGeom>
+          <a:noFill/>
+        </p:spPr>
+        <p:txBody>
+          <a:bodyPr wrap="none" anchor="ctr" lIns="0" rIns="0" tIns="0" bIns="0">
+            <a:spAutoFit/>
+          </a:bodyPr>
+          <a:lstStyle/>
+          <a:p>
+            <a:pPr algn="ctr"/>
+            <a:r>
+              <a:rPr sz="1050" b="1" i="0">
+                <a:solidFill>
+                  <a:srgbClr val="FFFFFF"/>
+                </a:solidFill>
+                <a:latin typeface="Calibri"/>
+              </a:rPr>
+              <a:t>FAST PATH  ·  most logs  ·  no AI</a:t>
+            </a:r>
+          </a:p>
+        </p:txBody>
+      </p:sp>
+      <p:cxnSp>
+        <p:nvCxnSpPr>
+          <p:cNvPr id="211" name="Connector 210"/>
+          <p:cNvCxnSpPr/>
+          <p:nvPr/>
+        </p:nvCxnSpPr>
+        <p:spPr>
+          <a:xfrm>
+            <a:off x="10232136" y="5047488"/>
+            <a:ext cx="0" cy="109728"/>
+          </a:xfrm>
+          <a:prstGeom prst="line">
+            <a:avLst/>
+          </a:prstGeom>
+          <a:ln w="25400">
+            <a:solidFill>
+              <a:srgbClr val="138A36"/>
+            </a:solidFill>
+            <a:tailEnd type="triangle" w="med" len="sm"/>
           </a:ln>
         </p:spPr>
         <p:style>
@@ -16007,14 +17092,14 @@
       </p:cxnSp>
       <p:cxnSp>
         <p:nvCxnSpPr>
-          <p:cNvPr id="181" name="Connector 180"/>
+          <p:cNvPr id="212" name="Connector 211"/>
           <p:cNvCxnSpPr/>
           <p:nvPr/>
         </p:nvCxnSpPr>
         <p:spPr>
           <a:xfrm>
-            <a:off x="8915400" y="2203704"/>
-            <a:ext cx="411480" cy="0"/>
+            <a:off x="9765792" y="2295144"/>
+            <a:ext cx="274320" cy="0"/>
           </a:xfrm>
           <a:prstGeom prst="line">
             <a:avLst/>
@@ -16023,7 +17108,7 @@
             <a:solidFill>
               <a:srgbClr val="138A36"/>
             </a:solidFill>
-            <a:tailEnd type="triangle" w="med" len="med"/>
+            <a:tailEnd type="triangle" w="med" len="sm"/>
           </a:ln>
         </p:spPr>
         <p:style>
@@ -16043,14 +17128,14 @@
       </p:cxnSp>
       <p:sp>
         <p:nvSpPr>
-          <p:cNvPr id="182" name="TextBox 181"/>
+          <p:cNvPr id="213" name="TextBox 212"/>
           <p:cNvSpPr txBox="1"/>
           <p:nvPr/>
         </p:nvSpPr>
         <p:spPr>
           <a:xfrm>
-            <a:off x="8988552" y="2020824"/>
-            <a:ext cx="365760" cy="182880"/>
+            <a:off x="9774936" y="2112264"/>
+            <a:ext cx="274320" cy="164592"/>
           </a:xfrm>
           <a:prstGeom prst="rect">
             <a:avLst/>
@@ -16058,14 +17143,14 @@
           <a:noFill/>
         </p:spPr>
         <p:txBody>
-          <a:bodyPr wrap="square" lIns="18288" rIns="18288" tIns="9144" bIns="9144" anchor="ctr">
+          <a:bodyPr wrap="square" lIns="9144" rIns="9144" tIns="0" bIns="0" anchor="ctr">
             <a:spAutoFit/>
           </a:bodyPr>
           <a:lstStyle/>
           <a:p>
             <a:pPr algn="l"/>
             <a:r>
-              <a:rPr sz="850" b="1">
+              <a:rPr sz="750" b="1" i="0">
                 <a:solidFill>
                   <a:srgbClr val="138A36"/>
                 </a:solidFill>
@@ -16078,14 +17163,14 @@
       </p:sp>
       <p:cxnSp>
         <p:nvCxnSpPr>
-          <p:cNvPr id="183" name="Connector 182"/>
+          <p:cNvPr id="214" name="Connector 213"/>
           <p:cNvCxnSpPr/>
           <p:nvPr/>
         </p:nvCxnSpPr>
         <p:spPr>
           <a:xfrm>
-            <a:off x="8915400" y="3264408"/>
-            <a:ext cx="411480" cy="0"/>
+            <a:off x="9765792" y="3319272"/>
+            <a:ext cx="274320" cy="0"/>
           </a:xfrm>
           <a:prstGeom prst="line">
             <a:avLst/>
@@ -16094,7 +17179,7 @@
             <a:solidFill>
               <a:srgbClr val="138A36"/>
             </a:solidFill>
-            <a:tailEnd type="triangle" w="med" len="med"/>
+            <a:tailEnd type="triangle" w="med" len="sm"/>
           </a:ln>
         </p:spPr>
         <p:style>
@@ -16114,14 +17199,14 @@
       </p:cxnSp>
       <p:sp>
         <p:nvSpPr>
-          <p:cNvPr id="184" name="TextBox 183"/>
+          <p:cNvPr id="215" name="TextBox 214"/>
           <p:cNvSpPr txBox="1"/>
           <p:nvPr/>
         </p:nvSpPr>
         <p:spPr>
           <a:xfrm>
-            <a:off x="8988552" y="3081528"/>
-            <a:ext cx="365760" cy="182880"/>
+            <a:off x="9774936" y="3136392"/>
+            <a:ext cx="274320" cy="164592"/>
           </a:xfrm>
           <a:prstGeom prst="rect">
             <a:avLst/>
@@ -16129,14 +17214,14 @@
           <a:noFill/>
         </p:spPr>
         <p:txBody>
-          <a:bodyPr wrap="square" lIns="18288" rIns="18288" tIns="9144" bIns="9144" anchor="ctr">
+          <a:bodyPr wrap="square" lIns="9144" rIns="9144" tIns="0" bIns="0" anchor="ctr">
             <a:spAutoFit/>
           </a:bodyPr>
           <a:lstStyle/>
           <a:p>
             <a:pPr algn="l"/>
             <a:r>
-              <a:rPr sz="850" b="1">
+              <a:rPr sz="750" b="1" i="0">
                 <a:solidFill>
                   <a:srgbClr val="138A36"/>
                 </a:solidFill>
@@ -16147,42 +17232,268 @@
           </a:p>
         </p:txBody>
       </p:sp>
-      <p:cxnSp>
-        <p:nvCxnSpPr>
-          <p:cNvPr id="185" name="Connector 184"/>
-          <p:cNvCxnSpPr/>
-          <p:nvPr/>
-        </p:nvCxnSpPr>
-        <p:spPr>
-          <a:xfrm>
-            <a:off x="11503152" y="3474720"/>
-            <a:ext cx="0" cy="1700784"/>
-          </a:xfrm>
-          <a:prstGeom prst="line">
-            <a:avLst/>
-          </a:prstGeom>
-          <a:ln w="22225">
+      <p:sp>
+        <p:nvSpPr>
+          <p:cNvPr id="216" name="Rounded Rectangle 215"/>
+          <p:cNvSpPr/>
+          <p:nvPr/>
+        </p:nvSpPr>
+        <p:spPr>
+          <a:xfrm>
+            <a:off x="10515600" y="2084832"/>
+            <a:ext cx="1261872" cy="1444752"/>
+          </a:xfrm>
+          <a:prstGeom prst="roundRect">
+            <a:avLst>
+              <a:gd name="adj" fmla="val 10000"/>
+            </a:avLst>
+          </a:prstGeom>
+          <a:solidFill>
+            <a:srgbClr val="E8F5EC"/>
+          </a:solidFill>
+          <a:ln w="12700">
             <a:solidFill>
               <a:srgbClr val="138A36"/>
             </a:solidFill>
-            <a:tailEnd type="triangle" w="med" len="med"/>
           </a:ln>
+          <a:effectLst/>
         </p:spPr>
         <p:style>
-          <a:lnRef idx="2">
+          <a:lnRef idx="1">
             <a:schemeClr val="accent1"/>
           </a:lnRef>
-          <a:fillRef idx="0">
+          <a:fillRef idx="3">
             <a:schemeClr val="accent1"/>
           </a:fillRef>
-          <a:effectRef idx="1">
+          <a:effectRef idx="2">
             <a:schemeClr val="accent1"/>
           </a:effectRef>
           <a:fontRef idx="minor">
-            <a:schemeClr val="tx1"/>
+            <a:schemeClr val="lt1"/>
           </a:fontRef>
         </p:style>
-      </p:cxnSp>
+        <p:txBody>
+          <a:bodyPr rtlCol="0" anchor="ctr"/>
+          <a:lstStyle/>
+          <a:p>
+            <a:pPr algn="ctr"/>
+          </a:p>
+        </p:txBody>
+      </p:sp>
+      <p:sp>
+        <p:nvSpPr>
+          <p:cNvPr id="217" name="TextBox 216"/>
+          <p:cNvSpPr txBox="1"/>
+          <p:nvPr/>
+        </p:nvSpPr>
+        <p:spPr>
+          <a:xfrm>
+            <a:off x="10552176" y="2084832"/>
+            <a:ext cx="1188720" cy="1444752"/>
+          </a:xfrm>
+          <a:prstGeom prst="rect">
+            <a:avLst/>
+          </a:prstGeom>
+          <a:noFill/>
+        </p:spPr>
+        <p:txBody>
+          <a:bodyPr wrap="square" lIns="27432" rIns="27432" tIns="0" bIns="0" anchor="ctr">
+            <a:spAutoFit/>
+          </a:bodyPr>
+          <a:lstStyle/>
+          <a:p>
+            <a:pPr algn="ctr"/>
+            <a:r>
+              <a:rPr sz="1000" b="1" i="0">
+                <a:solidFill>
+                  <a:srgbClr val="138A36"/>
+                </a:solidFill>
+                <a:latin typeface="Calibri"/>
+              </a:rPr>
+              <a:t>Known log?</a:t>
+            </a:r>
+          </a:p>
+          <a:p>
+            <a:pPr algn="ctr"/>
+            <a:r>
+              <a:rPr sz="800" b="0" i="0">
+                <a:solidFill>
+                  <a:srgbClr val="2B3340"/>
+                </a:solidFill>
+                <a:latin typeface="Calibri"/>
+              </a:rPr>
+              <a:t>Goes 1 → 2 (or 4)</a:t>
+            </a:r>
+          </a:p>
+          <a:p>
+            <a:pPr algn="ctr"/>
+            <a:r>
+              <a:rPr sz="800" b="0" i="0">
+                <a:solidFill>
+                  <a:srgbClr val="2B3340"/>
+                </a:solidFill>
+                <a:latin typeface="Calibri"/>
+              </a:rPr>
+              <a:t>→ 7 → 8</a:t>
+            </a:r>
+          </a:p>
+          <a:p>
+            <a:pPr algn="ctr"/>
+            <a:r>
+              <a:rPr sz="800" b="0" i="0">
+                <a:solidFill>
+                  <a:srgbClr val="2B3340"/>
+                </a:solidFill>
+                <a:latin typeface="Calibri"/>
+              </a:rPr>
+              <a:t>instant, no AI cost</a:t>
+            </a:r>
+          </a:p>
+        </p:txBody>
+      </p:sp>
+      <p:sp>
+        <p:nvSpPr>
+          <p:cNvPr id="218" name="Rounded Rectangle 217"/>
+          <p:cNvSpPr/>
+          <p:nvPr/>
+        </p:nvSpPr>
+        <p:spPr>
+          <a:xfrm>
+            <a:off x="10515600" y="3712464"/>
+            <a:ext cx="1261872" cy="1335024"/>
+          </a:xfrm>
+          <a:prstGeom prst="roundRect">
+            <a:avLst>
+              <a:gd name="adj" fmla="val 10000"/>
+            </a:avLst>
+          </a:prstGeom>
+          <a:solidFill>
+            <a:srgbClr val="FFF6EC"/>
+          </a:solidFill>
+          <a:ln w="12700">
+            <a:solidFill>
+              <a:srgbClr val="F28322"/>
+            </a:solidFill>
+          </a:ln>
+          <a:effectLst/>
+        </p:spPr>
+        <p:style>
+          <a:lnRef idx="1">
+            <a:schemeClr val="accent1"/>
+          </a:lnRef>
+          <a:fillRef idx="3">
+            <a:schemeClr val="accent1"/>
+          </a:fillRef>
+          <a:effectRef idx="2">
+            <a:schemeClr val="accent1"/>
+          </a:effectRef>
+          <a:fontRef idx="minor">
+            <a:schemeClr val="lt1"/>
+          </a:fontRef>
+        </p:style>
+        <p:txBody>
+          <a:bodyPr rtlCol="0" anchor="ctr"/>
+          <a:lstStyle/>
+          <a:p>
+            <a:pPr algn="ctr"/>
+          </a:p>
+        </p:txBody>
+      </p:sp>
+      <p:sp>
+        <p:nvSpPr>
+          <p:cNvPr id="219" name="TextBox 218"/>
+          <p:cNvSpPr txBox="1"/>
+          <p:nvPr/>
+        </p:nvSpPr>
+        <p:spPr>
+          <a:xfrm>
+            <a:off x="10552176" y="3712464"/>
+            <a:ext cx="1188720" cy="1335024"/>
+          </a:xfrm>
+          <a:prstGeom prst="rect">
+            <a:avLst/>
+          </a:prstGeom>
+          <a:noFill/>
+        </p:spPr>
+        <p:txBody>
+          <a:bodyPr wrap="square" lIns="27432" rIns="27432" tIns="0" bIns="0" anchor="ctr">
+            <a:spAutoFit/>
+          </a:bodyPr>
+          <a:lstStyle/>
+          <a:p>
+            <a:pPr algn="ctr"/>
+            <a:r>
+              <a:rPr sz="1000" b="1" i="0">
+                <a:solidFill>
+                  <a:srgbClr val="C06010"/>
+                </a:solidFill>
+                <a:latin typeface="Calibri"/>
+              </a:rPr>
+              <a:t>New format?</a:t>
+            </a:r>
+          </a:p>
+          <a:p>
+            <a:pPr algn="ctr"/>
+            <a:r>
+              <a:rPr sz="800" b="0" i="0">
+                <a:solidFill>
+                  <a:srgbClr val="2B3340"/>
+                </a:solidFill>
+                <a:latin typeface="Calibri"/>
+              </a:rPr>
+              <a:t>Goes through 5 → 6</a:t>
+            </a:r>
+          </a:p>
+          <a:p>
+            <a:pPr algn="ctr"/>
+            <a:r>
+              <a:rPr sz="800" b="0" i="0">
+                <a:solidFill>
+                  <a:srgbClr val="2B3340"/>
+                </a:solidFill>
+                <a:latin typeface="Calibri"/>
+              </a:rPr>
+              <a:t>AI used once, then</a:t>
+            </a:r>
+          </a:p>
+          <a:p>
+            <a:pPr algn="ctr"/>
+            <a:r>
+              <a:rPr sz="800" b="0" i="0">
+                <a:solidFill>
+                  <a:srgbClr val="2B3340"/>
+                </a:solidFill>
+                <a:latin typeface="Calibri"/>
+              </a:rPr>
+              <a:t>it joins the fast path</a:t>
+            </a:r>
+          </a:p>
+          <a:p>
+            <a:pPr algn="ctr"/>
+            <a:r>
+              <a:rPr sz="800" b="0" i="0">
+                <a:solidFill>
+                  <a:srgbClr val="2B3340"/>
+                </a:solidFill>
+                <a:latin typeface="Calibri"/>
+              </a:rPr>
+              <a:t>AI down? backup AI,</a:t>
+            </a:r>
+          </a:p>
+          <a:p>
+            <a:pPr algn="ctr"/>
+            <a:r>
+              <a:rPr sz="800" b="0" i="0">
+                <a:solidFill>
+                  <a:srgbClr val="2B3340"/>
+                </a:solidFill>
+                <a:latin typeface="Calibri"/>
+              </a:rPr>
+              <a:t>then built-in rules</a:t>
+            </a:r>
+          </a:p>
+        </p:txBody>
+      </p:sp>
     </p:spTree>
   </p:cSld>
   <p:clrMapOvr>

</xml_diff>

<commit_message>
PPT: slide 3 flowchart redesigned as colourful snake flow with logos, big fast-path arrow and AI-path zone
Co-authored-by: arena-agent <297053741+arena-agent@users.noreply.github.com>
</commit_message>
<xml_diff>
--- a/presentation/SIH2026_Idea_Submission.pptx
+++ b/presentation/SIH2026_Idea_Submission.pptx
@@ -14101,8 +14101,8 @@
         </p:nvSpPr>
         <p:spPr>
           <a:xfrm>
-            <a:off x="5669280" y="1115568"/>
-            <a:ext cx="3931920" cy="274320"/>
+            <a:off x="5669280" y="1106424"/>
+            <a:ext cx="6035040" cy="274320"/>
           </a:xfrm>
           <a:prstGeom prst="rect">
             <a:avLst/>
@@ -14124,104 +14124,33 @@
               </a:rPr>
               <a:t>METHODOLOGY: HOW EVERY LOG FLOWS</a:t>
             </a:r>
-          </a:p>
-        </p:txBody>
-      </p:sp>
-      <p:sp>
-        <p:nvSpPr>
-          <p:cNvPr id="139" name="TextBox 138"/>
-          <p:cNvSpPr txBox="1"/>
-          <p:nvPr/>
-        </p:nvSpPr>
-        <p:spPr>
-          <a:xfrm>
-            <a:off x="5669280" y="1362456"/>
-            <a:ext cx="4206240" cy="182880"/>
-          </a:xfrm>
-          <a:prstGeom prst="rect">
-            <a:avLst/>
-          </a:prstGeom>
-          <a:noFill/>
-        </p:spPr>
-        <p:txBody>
-          <a:bodyPr wrap="square" lIns="36576" rIns="36576" tIns="0" bIns="0" anchor="ctr">
-            <a:spAutoFit/>
-          </a:bodyPr>
-          <a:lstStyle/>
-          <a:p>
-            <a:r>
-              <a:rPr sz="850" b="0" i="1">
+            <a:r>
+              <a:rPr sz="950" b="0" i="1">
                 <a:solidFill>
                   <a:srgbClr val="5B6573"/>
                 </a:solidFill>
                 <a:latin typeface="Calibri"/>
               </a:rPr>
-              <a:t>Follow the numbers. Logos show the technology used in each step.</a:t>
-            </a:r>
-          </a:p>
-        </p:txBody>
-      </p:sp>
-      <p:sp>
-        <p:nvSpPr>
-          <p:cNvPr id="140" name="Rounded Rectangle 139"/>
+              <a:t>    learn a format once, reuse it every time</a:t>
+            </a:r>
+          </a:p>
+        </p:txBody>
+      </p:sp>
+      <p:sp>
+        <p:nvSpPr>
+          <p:cNvPr id="139" name="Rounded Rectangle 138"/>
           <p:cNvSpPr/>
           <p:nvPr/>
         </p:nvSpPr>
         <p:spPr>
           <a:xfrm>
-            <a:off x="5669280" y="1572768"/>
-            <a:ext cx="4096512" cy="420624"/>
+            <a:off x="5669280" y="1463040"/>
+            <a:ext cx="1691640" cy="1051560"/>
           </a:xfrm>
           <a:prstGeom prst="roundRect">
             <a:avLst>
-              <a:gd name="adj" fmla="val 14000"/>
+              <a:gd name="adj" fmla="val 10000"/>
             </a:avLst>
-          </a:prstGeom>
-          <a:solidFill>
-            <a:srgbClr val="FFFFFF"/>
-          </a:solidFill>
-          <a:ln w="9525">
-            <a:solidFill>
-              <a:srgbClr val="D5DCE6"/>
-            </a:solidFill>
-          </a:ln>
-          <a:effectLst/>
-        </p:spPr>
-        <p:style>
-          <a:lnRef idx="1">
-            <a:schemeClr val="accent1"/>
-          </a:lnRef>
-          <a:fillRef idx="3">
-            <a:schemeClr val="accent1"/>
-          </a:fillRef>
-          <a:effectRef idx="2">
-            <a:schemeClr val="accent1"/>
-          </a:effectRef>
-          <a:fontRef idx="minor">
-            <a:schemeClr val="lt1"/>
-          </a:fontRef>
-        </p:style>
-        <p:txBody>
-          <a:bodyPr rtlCol="0" anchor="ctr"/>
-          <a:lstStyle/>
-          <a:p>
-            <a:pPr algn="ctr"/>
-          </a:p>
-        </p:txBody>
-      </p:sp>
-      <p:sp>
-        <p:nvSpPr>
-          <p:cNvPr id="141" name="Rectangle 140"/>
-          <p:cNvSpPr/>
-          <p:nvPr/>
-        </p:nvSpPr>
-        <p:spPr>
-          <a:xfrm>
-            <a:off x="5669280" y="1609344"/>
-            <a:ext cx="54864" cy="347472"/>
-          </a:xfrm>
-          <a:prstGeom prst="rect">
-            <a:avLst/>
           </a:prstGeom>
           <a:solidFill>
             <a:srgbClr val="4A5568"/>
@@ -14255,20 +14184,20 @@
       </p:sp>
       <p:sp>
         <p:nvSpPr>
-          <p:cNvPr id="142" name="Oval 141"/>
+          <p:cNvPr id="140" name="Oval 139"/>
           <p:cNvSpPr/>
           <p:nvPr/>
         </p:nvSpPr>
         <p:spPr>
           <a:xfrm>
-            <a:off x="5788152" y="1636776"/>
-            <a:ext cx="292608" cy="292608"/>
+            <a:off x="5760720" y="1554480"/>
+            <a:ext cx="274320" cy="274320"/>
           </a:xfrm>
           <a:prstGeom prst="ellipse">
             <a:avLst/>
           </a:prstGeom>
           <a:solidFill>
-            <a:srgbClr val="4A5568"/>
+            <a:srgbClr val="FFFFFF"/>
           </a:solidFill>
           <a:ln>
             <a:noFill/>
@@ -14297,7 +14226,7 @@
             <a:r>
               <a:rPr sz="1050" b="1" i="0">
                 <a:solidFill>
-                  <a:srgbClr val="FFFFFF"/>
+                  <a:srgbClr val="4A5568"/>
                 </a:solidFill>
                 <a:latin typeface="Calibri"/>
               </a:rPr>
@@ -14308,52 +14237,53 @@
       </p:sp>
       <p:sp>
         <p:nvSpPr>
-          <p:cNvPr id="143" name="TextBox 142"/>
-          <p:cNvSpPr txBox="1"/>
-          <p:nvPr/>
-        </p:nvSpPr>
-        <p:spPr>
-          <a:xfrm>
-            <a:off x="6144768" y="1591056"/>
-            <a:ext cx="2560320" cy="384048"/>
-          </a:xfrm>
-          <a:prstGeom prst="rect">
-            <a:avLst/>
-          </a:prstGeom>
-          <a:noFill/>
-        </p:spPr>
-        <p:txBody>
-          <a:bodyPr wrap="square" lIns="36576" rIns="36576" tIns="0" bIns="0" anchor="ctr">
-            <a:spAutoFit/>
-          </a:bodyPr>
-          <a:lstStyle/>
-          <a:p>
-            <a:r>
-              <a:rPr sz="1050" b="1" i="0">
-                <a:solidFill>
-                  <a:srgbClr val="4A5568"/>
-                </a:solidFill>
-                <a:latin typeface="Calibri"/>
-              </a:rPr>
-              <a:t>Logs arrive</a:t>
-            </a:r>
-          </a:p>
-          <a:p>
-            <a:r>
-              <a:rPr sz="850" b="0" i="0">
-                <a:solidFill>
-                  <a:srgbClr val="3A4250"/>
-                </a:solidFill>
-                <a:latin typeface="Calibri"/>
-              </a:rPr>
-              <a:t>Servers, apps &amp; firewalls send raw logs; multi-line errors joined</a:t>
-            </a:r>
+          <p:cNvPr id="141" name="Rounded Rectangle 140"/>
+          <p:cNvSpPr/>
+          <p:nvPr/>
+        </p:nvSpPr>
+        <p:spPr>
+          <a:xfrm>
+            <a:off x="6409944" y="1536192"/>
+            <a:ext cx="877824" cy="329184"/>
+          </a:xfrm>
+          <a:prstGeom prst="roundRect">
+            <a:avLst>
+              <a:gd name="adj" fmla="val 50000"/>
+            </a:avLst>
+          </a:prstGeom>
+          <a:solidFill>
+            <a:srgbClr val="FFFFFF"/>
+          </a:solidFill>
+          <a:ln>
+            <a:noFill/>
+          </a:ln>
+          <a:effectLst/>
+        </p:spPr>
+        <p:style>
+          <a:lnRef idx="1">
+            <a:schemeClr val="accent1"/>
+          </a:lnRef>
+          <a:fillRef idx="3">
+            <a:schemeClr val="accent1"/>
+          </a:fillRef>
+          <a:effectRef idx="2">
+            <a:schemeClr val="accent1"/>
+          </a:effectRef>
+          <a:fontRef idx="minor">
+            <a:schemeClr val="lt1"/>
+          </a:fontRef>
+        </p:style>
+        <p:txBody>
+          <a:bodyPr rtlCol="0" anchor="ctr"/>
+          <a:lstStyle/>
+          <a:p>
+            <a:pPr algn="ctr"/>
           </a:p>
         </p:txBody>
       </p:sp>
       <p:pic>
         <p:nvPicPr>
-          <p:cNvPr id="144" name="Picture 143" descr="image.png"/>
+          <p:cNvPr id="142" name="Picture 141" descr="image.png"/>
           <p:cNvPicPr>
             <a:picLocks noChangeAspect="1"/>
           </p:cNvPicPr>
@@ -14367,8 +14297,8 @@
         </p:blipFill>
         <p:spPr>
           <a:xfrm>
-            <a:off x="8741664" y="1645920"/>
-            <a:ext cx="274320" cy="274320"/>
+            <a:off x="6455664" y="1581912"/>
+            <a:ext cx="237744" cy="237744"/>
           </a:xfrm>
           <a:prstGeom prst="rect">
             <a:avLst/>
@@ -14377,7 +14307,7 @@
       </p:pic>
       <p:pic>
         <p:nvPicPr>
-          <p:cNvPr id="145" name="Picture 144" descr="image.png"/>
+          <p:cNvPr id="143" name="Picture 142" descr="image.png"/>
           <p:cNvPicPr>
             <a:picLocks noChangeAspect="1"/>
           </p:cNvPicPr>
@@ -14391,8 +14321,8 @@
         </p:blipFill>
         <p:spPr>
           <a:xfrm>
-            <a:off x="9070848" y="1645920"/>
-            <a:ext cx="274320" cy="274320"/>
+            <a:off x="6729984" y="1581912"/>
+            <a:ext cx="237744" cy="237744"/>
           </a:xfrm>
           <a:prstGeom prst="rect">
             <a:avLst/>
@@ -14401,7 +14331,7 @@
       </p:pic>
       <p:pic>
         <p:nvPicPr>
-          <p:cNvPr id="146" name="Picture 145" descr="image.png"/>
+          <p:cNvPr id="144" name="Picture 143" descr="image.png"/>
           <p:cNvPicPr>
             <a:picLocks noChangeAspect="1"/>
           </p:cNvPicPr>
@@ -14415,8 +14345,8 @@
         </p:blipFill>
         <p:spPr>
           <a:xfrm>
-            <a:off x="9400032" y="1645920"/>
-            <a:ext cx="274320" cy="274320"/>
+            <a:off x="7004304" y="1581912"/>
+            <a:ext cx="237744" cy="237744"/>
           </a:xfrm>
           <a:prstGeom prst="rect">
             <a:avLst/>
@@ -14425,65 +14355,64 @@
       </p:pic>
       <p:sp>
         <p:nvSpPr>
-          <p:cNvPr id="147" name="Rounded Rectangle 146"/>
+          <p:cNvPr id="145" name="TextBox 144"/>
+          <p:cNvSpPr txBox="1"/>
+          <p:nvPr/>
+        </p:nvSpPr>
+        <p:spPr>
+          <a:xfrm>
+            <a:off x="5742432" y="1892808"/>
+            <a:ext cx="1545336" cy="576072"/>
+          </a:xfrm>
+          <a:prstGeom prst="rect">
+            <a:avLst/>
+          </a:prstGeom>
+          <a:noFill/>
+        </p:spPr>
+        <p:txBody>
+          <a:bodyPr wrap="square" lIns="36576" rIns="36576" tIns="0" bIns="0" anchor="t">
+            <a:spAutoFit/>
+          </a:bodyPr>
+          <a:lstStyle/>
+          <a:p>
+            <a:r>
+              <a:rPr sz="1200" b="1" i="0">
+                <a:solidFill>
+                  <a:srgbClr val="FFFFFF"/>
+                </a:solidFill>
+                <a:latin typeface="Calibri"/>
+              </a:rPr>
+              <a:t>Logs arrive</a:t>
+            </a:r>
+          </a:p>
+          <a:p>
+            <a:r>
+              <a:rPr sz="900" b="0" i="0">
+                <a:solidFill>
+                  <a:srgbClr val="F2F5FA"/>
+                </a:solidFill>
+                <a:latin typeface="Calibri"/>
+              </a:rPr>
+              <a:t>from servers, apps &amp; firewalls</a:t>
+            </a:r>
+          </a:p>
+        </p:txBody>
+      </p:sp>
+      <p:sp>
+        <p:nvSpPr>
+          <p:cNvPr id="146" name="Rounded Rectangle 145"/>
           <p:cNvSpPr/>
           <p:nvPr/>
         </p:nvSpPr>
         <p:spPr>
           <a:xfrm>
-            <a:off x="5669280" y="2084832"/>
-            <a:ext cx="4096512" cy="420624"/>
+            <a:off x="7854696" y="1463040"/>
+            <a:ext cx="1691640" cy="1051560"/>
           </a:xfrm>
           <a:prstGeom prst="roundRect">
             <a:avLst>
-              <a:gd name="adj" fmla="val 14000"/>
+              <a:gd name="adj" fmla="val 10000"/>
             </a:avLst>
-          </a:prstGeom>
-          <a:solidFill>
-            <a:srgbClr val="FFFFFF"/>
-          </a:solidFill>
-          <a:ln w="9525">
-            <a:solidFill>
-              <a:srgbClr val="D5DCE6"/>
-            </a:solidFill>
-          </a:ln>
-          <a:effectLst/>
-        </p:spPr>
-        <p:style>
-          <a:lnRef idx="1">
-            <a:schemeClr val="accent1"/>
-          </a:lnRef>
-          <a:fillRef idx="3">
-            <a:schemeClr val="accent1"/>
-          </a:fillRef>
-          <a:effectRef idx="2">
-            <a:schemeClr val="accent1"/>
-          </a:effectRef>
-          <a:fontRef idx="minor">
-            <a:schemeClr val="lt1"/>
-          </a:fontRef>
-        </p:style>
-        <p:txBody>
-          <a:bodyPr rtlCol="0" anchor="ctr"/>
-          <a:lstStyle/>
-          <a:p>
-            <a:pPr algn="ctr"/>
-          </a:p>
-        </p:txBody>
-      </p:sp>
-      <p:sp>
-        <p:nvSpPr>
-          <p:cNvPr id="148" name="Rectangle 147"/>
-          <p:cNvSpPr/>
-          <p:nvPr/>
-        </p:nvSpPr>
-        <p:spPr>
-          <a:xfrm>
-            <a:off x="5669280" y="2121408"/>
-            <a:ext cx="54864" cy="347472"/>
-          </a:xfrm>
-          <a:prstGeom prst="rect">
-            <a:avLst/>
           </a:prstGeom>
           <a:solidFill>
             <a:srgbClr val="1F5FBF"/>
@@ -14517,20 +14446,20 @@
       </p:sp>
       <p:sp>
         <p:nvSpPr>
-          <p:cNvPr id="149" name="Oval 148"/>
+          <p:cNvPr id="147" name="Oval 146"/>
           <p:cNvSpPr/>
           <p:nvPr/>
         </p:nvSpPr>
         <p:spPr>
           <a:xfrm>
-            <a:off x="5788152" y="2148840"/>
-            <a:ext cx="292608" cy="292608"/>
+            <a:off x="7946136" y="1554480"/>
+            <a:ext cx="274320" cy="274320"/>
           </a:xfrm>
           <a:prstGeom prst="ellipse">
             <a:avLst/>
           </a:prstGeom>
           <a:solidFill>
-            <a:srgbClr val="1F5FBF"/>
+            <a:srgbClr val="FFFFFF"/>
           </a:solidFill>
           <a:ln>
             <a:noFill/>
@@ -14559,7 +14488,7 @@
             <a:r>
               <a:rPr sz="1050" b="1" i="0">
                 <a:solidFill>
-                  <a:srgbClr val="FFFFFF"/>
+                  <a:srgbClr val="1F5FBF"/>
                 </a:solidFill>
                 <a:latin typeface="Calibri"/>
               </a:rPr>
@@ -14570,52 +14499,53 @@
       </p:sp>
       <p:sp>
         <p:nvSpPr>
-          <p:cNvPr id="150" name="TextBox 149"/>
-          <p:cNvSpPr txBox="1"/>
-          <p:nvPr/>
-        </p:nvSpPr>
-        <p:spPr>
-          <a:xfrm>
-            <a:off x="6144768" y="2103120"/>
-            <a:ext cx="3218688" cy="384048"/>
-          </a:xfrm>
-          <a:prstGeom prst="rect">
-            <a:avLst/>
-          </a:prstGeom>
-          <a:noFill/>
-        </p:spPr>
-        <p:txBody>
-          <a:bodyPr wrap="square" lIns="36576" rIns="36576" tIns="0" bIns="0" anchor="ctr">
-            <a:spAutoFit/>
-          </a:bodyPr>
-          <a:lstStyle/>
-          <a:p>
-            <a:r>
-              <a:rPr sz="1050" b="1" i="0">
-                <a:solidFill>
-                  <a:srgbClr val="1F5FBF"/>
-                </a:solidFill>
-                <a:latin typeface="Calibri"/>
-              </a:rPr>
-              <a:t>Seen this exact line before?</a:t>
-            </a:r>
-          </a:p>
-          <a:p>
-            <a:r>
-              <a:rPr sz="850" b="0" i="0">
-                <a:solidFill>
-                  <a:srgbClr val="3A4250"/>
-                </a:solidFill>
-                <a:latin typeface="Calibri"/>
-              </a:rPr>
-              <a:t>Instant match against saved line shapes</a:t>
-            </a:r>
+          <p:cNvPr id="148" name="Rounded Rectangle 147"/>
+          <p:cNvSpPr/>
+          <p:nvPr/>
+        </p:nvSpPr>
+        <p:spPr>
+          <a:xfrm>
+            <a:off x="8595360" y="1536192"/>
+            <a:ext cx="877824" cy="329184"/>
+          </a:xfrm>
+          <a:prstGeom prst="roundRect">
+            <a:avLst>
+              <a:gd name="adj" fmla="val 50000"/>
+            </a:avLst>
+          </a:prstGeom>
+          <a:solidFill>
+            <a:srgbClr val="FFFFFF"/>
+          </a:solidFill>
+          <a:ln>
+            <a:noFill/>
+          </a:ln>
+          <a:effectLst/>
+        </p:spPr>
+        <p:style>
+          <a:lnRef idx="1">
+            <a:schemeClr val="accent1"/>
+          </a:lnRef>
+          <a:fillRef idx="3">
+            <a:schemeClr val="accent1"/>
+          </a:fillRef>
+          <a:effectRef idx="2">
+            <a:schemeClr val="accent1"/>
+          </a:effectRef>
+          <a:fontRef idx="minor">
+            <a:schemeClr val="lt1"/>
+          </a:fontRef>
+        </p:style>
+        <p:txBody>
+          <a:bodyPr rtlCol="0" anchor="ctr"/>
+          <a:lstStyle/>
+          <a:p>
+            <a:pPr algn="ctr"/>
           </a:p>
         </p:txBody>
       </p:sp>
       <p:pic>
         <p:nvPicPr>
-          <p:cNvPr id="151" name="Picture 150" descr="image.png"/>
+          <p:cNvPr id="149" name="Picture 148" descr="image.png"/>
           <p:cNvPicPr>
             <a:picLocks noChangeAspect="1"/>
           </p:cNvPicPr>
@@ -14629,8 +14559,8 @@
         </p:blipFill>
         <p:spPr>
           <a:xfrm>
-            <a:off x="9400032" y="2157984"/>
-            <a:ext cx="274320" cy="274320"/>
+            <a:off x="8641080" y="1581912"/>
+            <a:ext cx="237744" cy="237744"/>
           </a:xfrm>
           <a:prstGeom prst="rect">
             <a:avLst/>
@@ -14639,204 +14569,14 @@
       </p:pic>
       <p:sp>
         <p:nvSpPr>
-          <p:cNvPr id="152" name="Rounded Rectangle 151"/>
+          <p:cNvPr id="150" name="Oval 149"/>
           <p:cNvSpPr/>
           <p:nvPr/>
         </p:nvSpPr>
         <p:spPr>
           <a:xfrm>
-            <a:off x="5669280" y="2596896"/>
-            <a:ext cx="4096512" cy="420624"/>
-          </a:xfrm>
-          <a:prstGeom prst="roundRect">
-            <a:avLst>
-              <a:gd name="adj" fmla="val 14000"/>
-            </a:avLst>
-          </a:prstGeom>
-          <a:solidFill>
-            <a:srgbClr val="FFFFFF"/>
-          </a:solidFill>
-          <a:ln w="9525">
-            <a:solidFill>
-              <a:srgbClr val="D5DCE6"/>
-            </a:solidFill>
-          </a:ln>
-          <a:effectLst/>
-        </p:spPr>
-        <p:style>
-          <a:lnRef idx="1">
-            <a:schemeClr val="accent1"/>
-          </a:lnRef>
-          <a:fillRef idx="3">
-            <a:schemeClr val="accent1"/>
-          </a:fillRef>
-          <a:effectRef idx="2">
-            <a:schemeClr val="accent1"/>
-          </a:effectRef>
-          <a:fontRef idx="minor">
-            <a:schemeClr val="lt1"/>
-          </a:fontRef>
-        </p:style>
-        <p:txBody>
-          <a:bodyPr rtlCol="0" anchor="ctr"/>
-          <a:lstStyle/>
-          <a:p>
-            <a:pPr algn="ctr"/>
-          </a:p>
-        </p:txBody>
-      </p:sp>
-      <p:sp>
-        <p:nvSpPr>
-          <p:cNvPr id="153" name="Rectangle 152"/>
-          <p:cNvSpPr/>
-          <p:nvPr/>
-        </p:nvSpPr>
-        <p:spPr>
-          <a:xfrm>
-            <a:off x="5669280" y="2633472"/>
-            <a:ext cx="54864" cy="347472"/>
-          </a:xfrm>
-          <a:prstGeom prst="rect">
-            <a:avLst/>
-          </a:prstGeom>
-          <a:solidFill>
-            <a:srgbClr val="2C7BB6"/>
-          </a:solidFill>
-          <a:ln>
-            <a:noFill/>
-          </a:ln>
-          <a:effectLst/>
-        </p:spPr>
-        <p:style>
-          <a:lnRef idx="1">
-            <a:schemeClr val="accent1"/>
-          </a:lnRef>
-          <a:fillRef idx="3">
-            <a:schemeClr val="accent1"/>
-          </a:fillRef>
-          <a:effectRef idx="2">
-            <a:schemeClr val="accent1"/>
-          </a:effectRef>
-          <a:fontRef idx="minor">
-            <a:schemeClr val="lt1"/>
-          </a:fontRef>
-        </p:style>
-        <p:txBody>
-          <a:bodyPr rtlCol="0" anchor="ctr"/>
-          <a:lstStyle/>
-          <a:p>
-            <a:pPr algn="ctr"/>
-          </a:p>
-        </p:txBody>
-      </p:sp>
-      <p:sp>
-        <p:nvSpPr>
-          <p:cNvPr id="154" name="Oval 153"/>
-          <p:cNvSpPr/>
-          <p:nvPr/>
-        </p:nvSpPr>
-        <p:spPr>
-          <a:xfrm>
-            <a:off x="5788152" y="2660904"/>
-            <a:ext cx="292608" cy="292608"/>
-          </a:xfrm>
-          <a:prstGeom prst="ellipse">
-            <a:avLst/>
-          </a:prstGeom>
-          <a:solidFill>
-            <a:srgbClr val="2C7BB6"/>
-          </a:solidFill>
-          <a:ln>
-            <a:noFill/>
-          </a:ln>
-          <a:effectLst/>
-        </p:spPr>
-        <p:style>
-          <a:lnRef idx="1">
-            <a:schemeClr val="accent1"/>
-          </a:lnRef>
-          <a:fillRef idx="3">
-            <a:schemeClr val="accent1"/>
-          </a:fillRef>
-          <a:effectRef idx="2">
-            <a:schemeClr val="accent1"/>
-          </a:effectRef>
-          <a:fontRef idx="minor">
-            <a:schemeClr val="lt1"/>
-          </a:fontRef>
-        </p:style>
-        <p:txBody>
-          <a:bodyPr rtlCol="0" anchor="ctr" lIns="0" rIns="0" tIns="0" bIns="0"/>
-          <a:lstStyle/>
-          <a:p>
-            <a:pPr algn="ctr"/>
-            <a:r>
-              <a:rPr sz="1050" b="1" i="0">
-                <a:solidFill>
-                  <a:srgbClr val="FFFFFF"/>
-                </a:solidFill>
-                <a:latin typeface="Calibri"/>
-              </a:rPr>
-              <a:t>3</a:t>
-            </a:r>
-          </a:p>
-        </p:txBody>
-      </p:sp>
-      <p:sp>
-        <p:nvSpPr>
-          <p:cNvPr id="155" name="TextBox 154"/>
-          <p:cNvSpPr txBox="1"/>
-          <p:nvPr/>
-        </p:nvSpPr>
-        <p:spPr>
-          <a:xfrm>
-            <a:off x="6144768" y="2615184"/>
-            <a:ext cx="3218688" cy="384048"/>
-          </a:xfrm>
-          <a:prstGeom prst="rect">
-            <a:avLst/>
-          </a:prstGeom>
-          <a:noFill/>
-        </p:spPr>
-        <p:txBody>
-          <a:bodyPr wrap="square" lIns="36576" rIns="36576" tIns="0" bIns="0" anchor="ctr">
-            <a:spAutoFit/>
-          </a:bodyPr>
-          <a:lstStyle/>
-          <a:p>
-            <a:r>
-              <a:rPr sz="1050" b="1" i="0">
-                <a:solidFill>
-                  <a:srgbClr val="2C7BB6"/>
-                </a:solidFill>
-                <a:latin typeface="Calibri"/>
-              </a:rPr>
-              <a:t>Group similar lines</a:t>
-            </a:r>
-          </a:p>
-          <a:p>
-            <a:r>
-              <a:rPr sz="850" b="0" i="0">
-                <a:solidFill>
-                  <a:srgbClr val="3A4250"/>
-                </a:solidFill>
-                <a:latin typeface="Calibri"/>
-              </a:rPr>
-              <a:t>Lines differing only in values (IP, time, ID) become one pattern</a:t>
-            </a:r>
-          </a:p>
-        </p:txBody>
-      </p:sp>
-      <p:sp>
-        <p:nvSpPr>
-          <p:cNvPr id="156" name="Oval 155"/>
-          <p:cNvSpPr/>
-          <p:nvPr/>
-        </p:nvSpPr>
-        <p:spPr>
-          <a:xfrm>
-            <a:off x="9400032" y="2670048"/>
-            <a:ext cx="274320" cy="274320"/>
+            <a:off x="8915400" y="1581912"/>
+            <a:ext cx="237744" cy="237744"/>
           </a:xfrm>
           <a:prstGeom prst="ellipse">
             <a:avLst/>
@@ -14869,210 +14609,20 @@
           <a:p>
             <a:pPr algn="ctr"/>
             <a:r>
-              <a:rPr sz="800" b="1" i="0">
+              <a:rPr sz="700" b="1" i="0">
                 <a:solidFill>
                   <a:srgbClr val="FFFFFF"/>
                 </a:solidFill>
                 <a:latin typeface="Calibri"/>
               </a:rPr>
               <a:t>D3</a:t>
-            </a:r>
-          </a:p>
-        </p:txBody>
-      </p:sp>
-      <p:sp>
-        <p:nvSpPr>
-          <p:cNvPr id="157" name="Rounded Rectangle 156"/>
-          <p:cNvSpPr/>
-          <p:nvPr/>
-        </p:nvSpPr>
-        <p:spPr>
-          <a:xfrm>
-            <a:off x="5669280" y="3108960"/>
-            <a:ext cx="4096512" cy="420624"/>
-          </a:xfrm>
-          <a:prstGeom prst="roundRect">
-            <a:avLst>
-              <a:gd name="adj" fmla="val 14000"/>
-            </a:avLst>
-          </a:prstGeom>
-          <a:solidFill>
-            <a:srgbClr val="FFFFFF"/>
-          </a:solidFill>
-          <a:ln w="9525">
-            <a:solidFill>
-              <a:srgbClr val="D5DCE6"/>
-            </a:solidFill>
-          </a:ln>
-          <a:effectLst/>
-        </p:spPr>
-        <p:style>
-          <a:lnRef idx="1">
-            <a:schemeClr val="accent1"/>
-          </a:lnRef>
-          <a:fillRef idx="3">
-            <a:schemeClr val="accent1"/>
-          </a:fillRef>
-          <a:effectRef idx="2">
-            <a:schemeClr val="accent1"/>
-          </a:effectRef>
-          <a:fontRef idx="minor">
-            <a:schemeClr val="lt1"/>
-          </a:fontRef>
-        </p:style>
-        <p:txBody>
-          <a:bodyPr rtlCol="0" anchor="ctr"/>
-          <a:lstStyle/>
-          <a:p>
-            <a:pPr algn="ctr"/>
-          </a:p>
-        </p:txBody>
-      </p:sp>
-      <p:sp>
-        <p:nvSpPr>
-          <p:cNvPr id="158" name="Rectangle 157"/>
-          <p:cNvSpPr/>
-          <p:nvPr/>
-        </p:nvSpPr>
-        <p:spPr>
-          <a:xfrm>
-            <a:off x="5669280" y="3145536"/>
-            <a:ext cx="54864" cy="347472"/>
-          </a:xfrm>
-          <a:prstGeom prst="rect">
-            <a:avLst/>
-          </a:prstGeom>
-          <a:solidFill>
-            <a:srgbClr val="1F5FBF"/>
-          </a:solidFill>
-          <a:ln>
-            <a:noFill/>
-          </a:ln>
-          <a:effectLst/>
-        </p:spPr>
-        <p:style>
-          <a:lnRef idx="1">
-            <a:schemeClr val="accent1"/>
-          </a:lnRef>
-          <a:fillRef idx="3">
-            <a:schemeClr val="accent1"/>
-          </a:fillRef>
-          <a:effectRef idx="2">
-            <a:schemeClr val="accent1"/>
-          </a:effectRef>
-          <a:fontRef idx="minor">
-            <a:schemeClr val="lt1"/>
-          </a:fontRef>
-        </p:style>
-        <p:txBody>
-          <a:bodyPr rtlCol="0" anchor="ctr"/>
-          <a:lstStyle/>
-          <a:p>
-            <a:pPr algn="ctr"/>
-          </a:p>
-        </p:txBody>
-      </p:sp>
-      <p:sp>
-        <p:nvSpPr>
-          <p:cNvPr id="159" name="Oval 158"/>
-          <p:cNvSpPr/>
-          <p:nvPr/>
-        </p:nvSpPr>
-        <p:spPr>
-          <a:xfrm>
-            <a:off x="5788152" y="3172968"/>
-            <a:ext cx="292608" cy="292608"/>
-          </a:xfrm>
-          <a:prstGeom prst="ellipse">
-            <a:avLst/>
-          </a:prstGeom>
-          <a:solidFill>
-            <a:srgbClr val="1F5FBF"/>
-          </a:solidFill>
-          <a:ln>
-            <a:noFill/>
-          </a:ln>
-          <a:effectLst/>
-        </p:spPr>
-        <p:style>
-          <a:lnRef idx="1">
-            <a:schemeClr val="accent1"/>
-          </a:lnRef>
-          <a:fillRef idx="3">
-            <a:schemeClr val="accent1"/>
-          </a:fillRef>
-          <a:effectRef idx="2">
-            <a:schemeClr val="accent1"/>
-          </a:effectRef>
-          <a:fontRef idx="minor">
-            <a:schemeClr val="lt1"/>
-          </a:fontRef>
-        </p:style>
-        <p:txBody>
-          <a:bodyPr rtlCol="0" anchor="ctr" lIns="0" rIns="0" tIns="0" bIns="0"/>
-          <a:lstStyle/>
-          <a:p>
-            <a:pPr algn="ctr"/>
-            <a:r>
-              <a:rPr sz="1050" b="1" i="0">
-                <a:solidFill>
-                  <a:srgbClr val="FFFFFF"/>
-                </a:solidFill>
-                <a:latin typeface="Calibri"/>
-              </a:rPr>
-              <a:t>4</a:t>
-            </a:r>
-          </a:p>
-        </p:txBody>
-      </p:sp>
-      <p:sp>
-        <p:nvSpPr>
-          <p:cNvPr id="160" name="TextBox 159"/>
-          <p:cNvSpPr txBox="1"/>
-          <p:nvPr/>
-        </p:nvSpPr>
-        <p:spPr>
-          <a:xfrm>
-            <a:off x="6144768" y="3127248"/>
-            <a:ext cx="3218688" cy="384048"/>
-          </a:xfrm>
-          <a:prstGeom prst="rect">
-            <a:avLst/>
-          </a:prstGeom>
-          <a:noFill/>
-        </p:spPr>
-        <p:txBody>
-          <a:bodyPr wrap="square" lIns="36576" rIns="36576" tIns="0" bIns="0" anchor="ctr">
-            <a:spAutoFit/>
-          </a:bodyPr>
-          <a:lstStyle/>
-          <a:p>
-            <a:r>
-              <a:rPr sz="1050" b="1" i="0">
-                <a:solidFill>
-                  <a:srgbClr val="1F5FBF"/>
-                </a:solidFill>
-                <a:latin typeface="Calibri"/>
-              </a:rPr>
-              <a:t>Is there a saved rule?</a:t>
-            </a:r>
-          </a:p>
-          <a:p>
-            <a:r>
-              <a:rPr sz="850" b="0" i="0">
-                <a:solidFill>
-                  <a:srgbClr val="3A4250"/>
-                </a:solidFill>
-                <a:latin typeface="Calibri"/>
-              </a:rPr>
-              <a:t>Looks up the rule store for this pattern</a:t>
             </a:r>
           </a:p>
         </p:txBody>
       </p:sp>
       <p:pic>
         <p:nvPicPr>
-          <p:cNvPr id="161" name="Picture 160" descr="image.png"/>
+          <p:cNvPr id="151" name="Picture 150" descr="image.png"/>
           <p:cNvPicPr>
             <a:picLocks noChangeAspect="1"/>
           </p:cNvPicPr>
@@ -15086,8 +14636,8 @@
         </p:blipFill>
         <p:spPr>
           <a:xfrm>
-            <a:off x="9400032" y="3182112"/>
-            <a:ext cx="274320" cy="274320"/>
+            <a:off x="9189720" y="1581912"/>
+            <a:ext cx="237744" cy="237744"/>
           </a:xfrm>
           <a:prstGeom prst="rect">
             <a:avLst/>
@@ -15096,27 +14646,71 @@
       </p:pic>
       <p:sp>
         <p:nvSpPr>
-          <p:cNvPr id="162" name="Rounded Rectangle 161"/>
+          <p:cNvPr id="152" name="TextBox 151"/>
+          <p:cNvSpPr txBox="1"/>
+          <p:nvPr/>
+        </p:nvSpPr>
+        <p:spPr>
+          <a:xfrm>
+            <a:off x="7927848" y="1892808"/>
+            <a:ext cx="1545336" cy="576072"/>
+          </a:xfrm>
+          <a:prstGeom prst="rect">
+            <a:avLst/>
+          </a:prstGeom>
+          <a:noFill/>
+        </p:spPr>
+        <p:txBody>
+          <a:bodyPr wrap="square" lIns="36576" rIns="36576" tIns="0" bIns="0" anchor="t">
+            <a:spAutoFit/>
+          </a:bodyPr>
+          <a:lstStyle/>
+          <a:p>
+            <a:r>
+              <a:rPr sz="1200" b="1" i="0">
+                <a:solidFill>
+                  <a:srgbClr val="FFFFFF"/>
+                </a:solidFill>
+                <a:latin typeface="Calibri"/>
+              </a:rPr>
+              <a:t>Already known?</a:t>
+            </a:r>
+          </a:p>
+          <a:p>
+            <a:r>
+              <a:rPr sz="900" b="0" i="0">
+                <a:solidFill>
+                  <a:srgbClr val="F2F5FA"/>
+                </a:solidFill>
+                <a:latin typeface="Calibri"/>
+              </a:rPr>
+              <a:t>is there a saved rule for this line or its pattern?</a:t>
+            </a:r>
+          </a:p>
+        </p:txBody>
+      </p:sp>
+      <p:sp>
+        <p:nvSpPr>
+          <p:cNvPr id="153" name="Down Arrow 152"/>
           <p:cNvSpPr/>
           <p:nvPr/>
         </p:nvSpPr>
         <p:spPr>
           <a:xfrm>
-            <a:off x="5669280" y="3621024"/>
-            <a:ext cx="4096512" cy="420624"/>
-          </a:xfrm>
-          <a:prstGeom prst="roundRect">
+            <a:off x="10085832" y="1463040"/>
+            <a:ext cx="1600200" cy="2633472"/>
+          </a:xfrm>
+          <a:prstGeom prst="downArrow">
             <a:avLst>
-              <a:gd name="adj" fmla="val 14000"/>
+              <a:gd name="adj1" fmla="val 72000"/>
+              <a:gd name="adj2" fmla="val 28000"/>
             </a:avLst>
           </a:prstGeom>
           <a:solidFill>
-            <a:srgbClr val="FFFFFF"/>
+            <a:srgbClr val="138A36"/>
           </a:solidFill>
-          <a:ln w="9525">
-            <a:solidFill>
-              <a:srgbClr val="D5DCE6"/>
-            </a:solidFill>
+          <a:ln>
+            <a:noFill/>
           </a:ln>
           <a:effectLst/>
         </p:spPr>
@@ -15144,17 +14738,194 @@
       </p:sp>
       <p:sp>
         <p:nvSpPr>
-          <p:cNvPr id="163" name="Rectangle 162"/>
+          <p:cNvPr id="154" name="TextBox 153"/>
+          <p:cNvSpPr txBox="1"/>
+          <p:nvPr/>
+        </p:nvSpPr>
+        <p:spPr>
+          <a:xfrm>
+            <a:off x="10314432" y="1600200"/>
+            <a:ext cx="1143000" cy="1737360"/>
+          </a:xfrm>
+          <a:prstGeom prst="rect">
+            <a:avLst/>
+          </a:prstGeom>
+          <a:noFill/>
+        </p:spPr>
+        <p:txBody>
+          <a:bodyPr wrap="square" lIns="36576" rIns="36576" tIns="0" bIns="0" anchor="ctr">
+            <a:spAutoFit/>
+          </a:bodyPr>
+          <a:lstStyle/>
+          <a:p>
+            <a:pPr algn="ctr"/>
+            <a:r>
+              <a:rPr sz="1100" b="1" i="0">
+                <a:solidFill>
+                  <a:srgbClr val="C9F2D4"/>
+                </a:solidFill>
+                <a:latin typeface="Calibri"/>
+              </a:rPr>
+              <a:t>YES</a:t>
+            </a:r>
+          </a:p>
+          <a:p>
+            <a:pPr algn="ctr"/>
+            <a:r>
+              <a:rPr sz="1400" b="1" i="0">
+                <a:solidFill>
+                  <a:srgbClr val="FFFFFF"/>
+                </a:solidFill>
+                <a:latin typeface="Calibri"/>
+              </a:rPr>
+              <a:t>FAST PATH</a:t>
+            </a:r>
+          </a:p>
+          <a:p>
+            <a:pPr algn="ctr"/>
+            <a:r>
+              <a:rPr sz="900" b="0" i="0">
+                <a:solidFill>
+                  <a:srgbClr val="FFFFFF"/>
+                </a:solidFill>
+                <a:latin typeface="Calibri"/>
+              </a:rPr>
+              <a:t>most logs go here</a:t>
+            </a:r>
+          </a:p>
+          <a:p>
+            <a:pPr algn="ctr"/>
+            <a:r>
+              <a:rPr sz="900" b="0" i="0">
+                <a:solidFill>
+                  <a:srgbClr val="FFFFFF"/>
+                </a:solidFill>
+                <a:latin typeface="Calibri"/>
+              </a:rPr>
+              <a:t>instant · no AI · no cost</a:t>
+            </a:r>
+          </a:p>
+        </p:txBody>
+      </p:sp>
+      <p:sp>
+        <p:nvSpPr>
+          <p:cNvPr id="155" name="Rounded Rectangle 154"/>
           <p:cNvSpPr/>
           <p:nvPr/>
         </p:nvSpPr>
         <p:spPr>
           <a:xfrm>
-            <a:off x="5669280" y="3657600"/>
-            <a:ext cx="54864" cy="347472"/>
-          </a:xfrm>
-          <a:prstGeom prst="rect">
-            <a:avLst/>
+            <a:off x="5596128" y="2688336"/>
+            <a:ext cx="4023360" cy="2587752"/>
+          </a:xfrm>
+          <a:prstGeom prst="roundRect">
+            <a:avLst>
+              <a:gd name="adj" fmla="val 5000"/>
+            </a:avLst>
+          </a:prstGeom>
+          <a:solidFill>
+            <a:srgbClr val="FFF8F0"/>
+          </a:solidFill>
+          <a:ln w="19050">
+            <a:solidFill>
+              <a:srgbClr val="F28322"/>
+            </a:solidFill>
+            <a:prstDash val="dash"/>
+          </a:ln>
+          <a:effectLst/>
+        </p:spPr>
+        <p:style>
+          <a:lnRef idx="1">
+            <a:schemeClr val="accent1"/>
+          </a:lnRef>
+          <a:fillRef idx="3">
+            <a:schemeClr val="accent1"/>
+          </a:fillRef>
+          <a:effectRef idx="2">
+            <a:schemeClr val="accent1"/>
+          </a:effectRef>
+          <a:fontRef idx="minor">
+            <a:schemeClr val="lt1"/>
+          </a:fontRef>
+        </p:style>
+        <p:txBody>
+          <a:bodyPr rtlCol="0" anchor="ctr"/>
+          <a:lstStyle/>
+          <a:p>
+            <a:pPr algn="ctr"/>
+          </a:p>
+        </p:txBody>
+      </p:sp>
+      <p:sp>
+        <p:nvSpPr>
+          <p:cNvPr id="156" name="Rounded Rectangle 155"/>
+          <p:cNvSpPr/>
+          <p:nvPr/>
+        </p:nvSpPr>
+        <p:spPr>
+          <a:xfrm>
+            <a:off x="5705856" y="5175504"/>
+            <a:ext cx="2423160" cy="201168"/>
+          </a:xfrm>
+          <a:prstGeom prst="roundRect">
+            <a:avLst>
+              <a:gd name="adj" fmla="val 50000"/>
+            </a:avLst>
+          </a:prstGeom>
+          <a:solidFill>
+            <a:srgbClr val="F28322"/>
+          </a:solidFill>
+          <a:ln>
+            <a:noFill/>
+          </a:ln>
+          <a:effectLst/>
+        </p:spPr>
+        <p:style>
+          <a:lnRef idx="1">
+            <a:schemeClr val="accent1"/>
+          </a:lnRef>
+          <a:fillRef idx="3">
+            <a:schemeClr val="accent1"/>
+          </a:fillRef>
+          <a:effectRef idx="2">
+            <a:schemeClr val="accent1"/>
+          </a:effectRef>
+          <a:fontRef idx="minor">
+            <a:schemeClr val="lt1"/>
+          </a:fontRef>
+        </p:style>
+        <p:txBody>
+          <a:bodyPr rtlCol="0" anchor="ctr" tIns="0" bIns="0"/>
+          <a:lstStyle/>
+          <a:p>
+            <a:pPr algn="ctr"/>
+            <a:r>
+              <a:rPr sz="850" b="1" i="0">
+                <a:solidFill>
+                  <a:srgbClr val="FFFFFF"/>
+                </a:solidFill>
+                <a:latin typeface="Calibri"/>
+              </a:rPr>
+              <a:t>AI PATH · only for new formats, only once</a:t>
+            </a:r>
+          </a:p>
+        </p:txBody>
+      </p:sp>
+      <p:sp>
+        <p:nvSpPr>
+          <p:cNvPr id="157" name="Rounded Rectangle 156"/>
+          <p:cNvSpPr/>
+          <p:nvPr/>
+        </p:nvSpPr>
+        <p:spPr>
+          <a:xfrm>
+            <a:off x="7854696" y="2798064"/>
+            <a:ext cx="1691640" cy="1051560"/>
+          </a:xfrm>
+          <a:prstGeom prst="roundRect">
+            <a:avLst>
+              <a:gd name="adj" fmla="val 10000"/>
+            </a:avLst>
           </a:prstGeom>
           <a:solidFill>
             <a:srgbClr val="6A3FB5"/>
@@ -15188,20 +14959,20 @@
       </p:sp>
       <p:sp>
         <p:nvSpPr>
-          <p:cNvPr id="164" name="Oval 163"/>
+          <p:cNvPr id="158" name="Oval 157"/>
           <p:cNvSpPr/>
           <p:nvPr/>
         </p:nvSpPr>
         <p:spPr>
           <a:xfrm>
-            <a:off x="5788152" y="3685032"/>
-            <a:ext cx="292608" cy="292608"/>
+            <a:off x="7946136" y="2889504"/>
+            <a:ext cx="274320" cy="274320"/>
           </a:xfrm>
           <a:prstGeom prst="ellipse">
             <a:avLst/>
           </a:prstGeom>
           <a:solidFill>
-            <a:srgbClr val="6A3FB5"/>
+            <a:srgbClr val="FFFFFF"/>
           </a:solidFill>
           <a:ln>
             <a:noFill/>
@@ -15230,63 +15001,64 @@
             <a:r>
               <a:rPr sz="1050" b="1" i="0">
                 <a:solidFill>
-                  <a:srgbClr val="FFFFFF"/>
-                </a:solidFill>
-                <a:latin typeface="Calibri"/>
-              </a:rPr>
-              <a:t>5</a:t>
-            </a:r>
-          </a:p>
-        </p:txBody>
-      </p:sp>
-      <p:sp>
-        <p:nvSpPr>
-          <p:cNvPr id="165" name="TextBox 164"/>
-          <p:cNvSpPr txBox="1"/>
-          <p:nvPr/>
-        </p:nvSpPr>
-        <p:spPr>
-          <a:xfrm>
-            <a:off x="6144768" y="3639312"/>
-            <a:ext cx="3218688" cy="384048"/>
-          </a:xfrm>
-          <a:prstGeom prst="rect">
-            <a:avLst/>
-          </a:prstGeom>
-          <a:noFill/>
-        </p:spPr>
-        <p:txBody>
-          <a:bodyPr wrap="square" lIns="36576" rIns="36576" tIns="0" bIns="0" anchor="ctr">
-            <a:spAutoFit/>
-          </a:bodyPr>
-          <a:lstStyle/>
-          <a:p>
-            <a:r>
-              <a:rPr sz="1050" b="1" i="0">
-                <a:solidFill>
                   <a:srgbClr val="6A3FB5"/>
                 </a:solidFill>
                 <a:latin typeface="Calibri"/>
               </a:rPr>
-              <a:t>Is the format familiar?</a:t>
-            </a:r>
-          </a:p>
-          <a:p>
-            <a:r>
-              <a:rPr sz="850" b="0" i="0">
-                <a:solidFill>
-                  <a:srgbClr val="3A4250"/>
-                </a:solidFill>
-                <a:latin typeface="Calibri"/>
-              </a:rPr>
-              <a:t>ML model compares it with known log families</a:t>
-            </a:r>
+              <a:t>3</a:t>
+            </a:r>
+          </a:p>
+        </p:txBody>
+      </p:sp>
+      <p:sp>
+        <p:nvSpPr>
+          <p:cNvPr id="159" name="Rounded Rectangle 158"/>
+          <p:cNvSpPr/>
+          <p:nvPr/>
+        </p:nvSpPr>
+        <p:spPr>
+          <a:xfrm>
+            <a:off x="9144000" y="2871216"/>
+            <a:ext cx="329184" cy="329184"/>
+          </a:xfrm>
+          <a:prstGeom prst="roundRect">
+            <a:avLst>
+              <a:gd name="adj" fmla="val 50000"/>
+            </a:avLst>
+          </a:prstGeom>
+          <a:solidFill>
+            <a:srgbClr val="FFFFFF"/>
+          </a:solidFill>
+          <a:ln>
+            <a:noFill/>
+          </a:ln>
+          <a:effectLst/>
+        </p:spPr>
+        <p:style>
+          <a:lnRef idx="1">
+            <a:schemeClr val="accent1"/>
+          </a:lnRef>
+          <a:fillRef idx="3">
+            <a:schemeClr val="accent1"/>
+          </a:fillRef>
+          <a:effectRef idx="2">
+            <a:schemeClr val="accent1"/>
+          </a:effectRef>
+          <a:fontRef idx="minor">
+            <a:schemeClr val="lt1"/>
+          </a:fontRef>
+        </p:style>
+        <p:txBody>
+          <a:bodyPr rtlCol="0" anchor="ctr"/>
+          <a:lstStyle/>
+          <a:p>
+            <a:pPr algn="ctr"/>
           </a:p>
         </p:txBody>
       </p:sp>
       <p:pic>
         <p:nvPicPr>
-          <p:cNvPr id="166" name="Picture 165" descr="image.png"/>
+          <p:cNvPr id="160" name="Picture 159" descr="image.png"/>
           <p:cNvPicPr>
             <a:picLocks noChangeAspect="1"/>
           </p:cNvPicPr>
@@ -15300,8 +15072,8 @@
         </p:blipFill>
         <p:spPr>
           <a:xfrm>
-            <a:off x="9400032" y="3694176"/>
-            <a:ext cx="274320" cy="274320"/>
+            <a:off x="9189720" y="2916936"/>
+            <a:ext cx="237744" cy="237744"/>
           </a:xfrm>
           <a:prstGeom prst="rect">
             <a:avLst/>
@@ -15310,65 +15082,64 @@
       </p:pic>
       <p:sp>
         <p:nvSpPr>
-          <p:cNvPr id="167" name="Rounded Rectangle 166"/>
+          <p:cNvPr id="161" name="TextBox 160"/>
+          <p:cNvSpPr txBox="1"/>
+          <p:nvPr/>
+        </p:nvSpPr>
+        <p:spPr>
+          <a:xfrm>
+            <a:off x="7927848" y="3227832"/>
+            <a:ext cx="1545336" cy="576072"/>
+          </a:xfrm>
+          <a:prstGeom prst="rect">
+            <a:avLst/>
+          </a:prstGeom>
+          <a:noFill/>
+        </p:spPr>
+        <p:txBody>
+          <a:bodyPr wrap="square" lIns="36576" rIns="36576" tIns="0" bIns="0" anchor="t">
+            <a:spAutoFit/>
+          </a:bodyPr>
+          <a:lstStyle/>
+          <a:p>
+            <a:r>
+              <a:rPr sz="1200" b="1" i="0">
+                <a:solidFill>
+                  <a:srgbClr val="FFFFFF"/>
+                </a:solidFill>
+                <a:latin typeface="Calibri"/>
+              </a:rPr>
+              <a:t>Familiar format?</a:t>
+            </a:r>
+          </a:p>
+          <a:p>
+            <a:r>
+              <a:rPr sz="900" b="0" i="0">
+                <a:solidFill>
+                  <a:srgbClr val="F2F5FA"/>
+                </a:solidFill>
+                <a:latin typeface="Calibri"/>
+              </a:rPr>
+              <a:t>ML model compares it with known log types</a:t>
+            </a:r>
+          </a:p>
+        </p:txBody>
+      </p:sp>
+      <p:sp>
+        <p:nvSpPr>
+          <p:cNvPr id="162" name="Rounded Rectangle 161"/>
           <p:cNvSpPr/>
           <p:nvPr/>
         </p:nvSpPr>
         <p:spPr>
           <a:xfrm>
-            <a:off x="5669280" y="4133088"/>
-            <a:ext cx="2002536" cy="420624"/>
+            <a:off x="5669280" y="2798064"/>
+            <a:ext cx="1691640" cy="493776"/>
           </a:xfrm>
           <a:prstGeom prst="roundRect">
             <a:avLst>
               <a:gd name="adj" fmla="val 14000"/>
             </a:avLst>
-          </a:prstGeom>
-          <a:solidFill>
-            <a:srgbClr val="FFF6EC"/>
-          </a:solidFill>
-          <a:ln w="9525">
-            <a:solidFill>
-              <a:srgbClr val="D5DCE6"/>
-            </a:solidFill>
-          </a:ln>
-          <a:effectLst/>
-        </p:spPr>
-        <p:style>
-          <a:lnRef idx="1">
-            <a:schemeClr val="accent1"/>
-          </a:lnRef>
-          <a:fillRef idx="3">
-            <a:schemeClr val="accent1"/>
-          </a:fillRef>
-          <a:effectRef idx="2">
-            <a:schemeClr val="accent1"/>
-          </a:effectRef>
-          <a:fontRef idx="minor">
-            <a:schemeClr val="lt1"/>
-          </a:fontRef>
-        </p:style>
-        <p:txBody>
-          <a:bodyPr rtlCol="0" anchor="ctr"/>
-          <a:lstStyle/>
-          <a:p>
-            <a:pPr algn="ctr"/>
-          </a:p>
-        </p:txBody>
-      </p:sp>
-      <p:sp>
-        <p:nvSpPr>
-          <p:cNvPr id="168" name="Rectangle 167"/>
-          <p:cNvSpPr/>
-          <p:nvPr/>
-        </p:nvSpPr>
-        <p:spPr>
-          <a:xfrm>
-            <a:off x="5669280" y="4169664"/>
-            <a:ext cx="54864" cy="347472"/>
-          </a:xfrm>
-          <a:prstGeom prst="rect">
-            <a:avLst/>
           </a:prstGeom>
           <a:solidFill>
             <a:srgbClr val="E07A10"/>
@@ -15402,20 +15173,20 @@
       </p:sp>
       <p:sp>
         <p:nvSpPr>
-          <p:cNvPr id="169" name="Oval 168"/>
+          <p:cNvPr id="163" name="Oval 162"/>
           <p:cNvSpPr/>
           <p:nvPr/>
         </p:nvSpPr>
         <p:spPr>
           <a:xfrm>
-            <a:off x="5788152" y="4197096"/>
-            <a:ext cx="292608" cy="292608"/>
+            <a:off x="5742432" y="2907792"/>
+            <a:ext cx="274320" cy="274320"/>
           </a:xfrm>
           <a:prstGeom prst="ellipse">
             <a:avLst/>
           </a:prstGeom>
           <a:solidFill>
-            <a:srgbClr val="E07A10"/>
+            <a:srgbClr val="FFFFFF"/>
           </a:solidFill>
           <a:ln>
             <a:noFill/>
@@ -15444,63 +15215,64 @@
             <a:r>
               <a:rPr sz="850" b="1" i="0">
                 <a:solidFill>
-                  <a:srgbClr val="FFFFFF"/>
-                </a:solidFill>
-                <a:latin typeface="Calibri"/>
-              </a:rPr>
-              <a:t>5a</a:t>
-            </a:r>
-          </a:p>
-        </p:txBody>
-      </p:sp>
-      <p:sp>
-        <p:nvSpPr>
-          <p:cNvPr id="170" name="TextBox 169"/>
-          <p:cNvSpPr txBox="1"/>
-          <p:nvPr/>
-        </p:nvSpPr>
-        <p:spPr>
-          <a:xfrm>
-            <a:off x="6144768" y="4151376"/>
-            <a:ext cx="996696" cy="384048"/>
-          </a:xfrm>
-          <a:prstGeom prst="rect">
-            <a:avLst/>
-          </a:prstGeom>
-          <a:noFill/>
-        </p:spPr>
-        <p:txBody>
-          <a:bodyPr wrap="square" lIns="36576" rIns="36576" tIns="0" bIns="0" anchor="ctr">
-            <a:spAutoFit/>
-          </a:bodyPr>
-          <a:lstStyle/>
-          <a:p>
-            <a:r>
-              <a:rPr sz="1000" b="1" i="0">
-                <a:solidFill>
                   <a:srgbClr val="E07A10"/>
                 </a:solidFill>
                 <a:latin typeface="Calibri"/>
               </a:rPr>
-              <a:t>AI writes a rule</a:t>
-            </a:r>
-          </a:p>
-          <a:p>
-            <a:r>
-              <a:rPr sz="800" b="0" i="0">
-                <a:solidFill>
-                  <a:srgbClr val="3A4250"/>
-                </a:solidFill>
-                <a:latin typeface="Calibri"/>
-              </a:rPr>
-              <a:t>once per pattern</a:t>
-            </a:r>
+              <a:t>4a</a:t>
+            </a:r>
+          </a:p>
+        </p:txBody>
+      </p:sp>
+      <p:sp>
+        <p:nvSpPr>
+          <p:cNvPr id="164" name="Rounded Rectangle 163"/>
+          <p:cNvSpPr/>
+          <p:nvPr/>
+        </p:nvSpPr>
+        <p:spPr>
+          <a:xfrm>
+            <a:off x="6812280" y="2907792"/>
+            <a:ext cx="493776" cy="274320"/>
+          </a:xfrm>
+          <a:prstGeom prst="roundRect">
+            <a:avLst>
+              <a:gd name="adj" fmla="val 50000"/>
+            </a:avLst>
+          </a:prstGeom>
+          <a:solidFill>
+            <a:srgbClr val="FFFFFF"/>
+          </a:solidFill>
+          <a:ln>
+            <a:noFill/>
+          </a:ln>
+          <a:effectLst/>
+        </p:spPr>
+        <p:style>
+          <a:lnRef idx="1">
+            <a:schemeClr val="accent1"/>
+          </a:lnRef>
+          <a:fillRef idx="3">
+            <a:schemeClr val="accent1"/>
+          </a:fillRef>
+          <a:effectRef idx="2">
+            <a:schemeClr val="accent1"/>
+          </a:effectRef>
+          <a:fontRef idx="minor">
+            <a:schemeClr val="lt1"/>
+          </a:fontRef>
+        </p:style>
+        <p:txBody>
+          <a:bodyPr rtlCol="0" anchor="ctr"/>
+          <a:lstStyle/>
+          <a:p>
+            <a:pPr algn="ctr"/>
           </a:p>
         </p:txBody>
       </p:sp>
       <p:pic>
         <p:nvPicPr>
-          <p:cNvPr id="171" name="Picture 170" descr="image.png"/>
+          <p:cNvPr id="165" name="Picture 164" descr="image.png"/>
           <p:cNvPicPr>
             <a:picLocks noChangeAspect="1"/>
           </p:cNvPicPr>
@@ -15514,8 +15286,8 @@
         </p:blipFill>
         <p:spPr>
           <a:xfrm>
-            <a:off x="7123176" y="4242816"/>
-            <a:ext cx="201168" cy="201168"/>
+            <a:off x="6858000" y="2953512"/>
+            <a:ext cx="182880" cy="182880"/>
           </a:xfrm>
           <a:prstGeom prst="rect">
             <a:avLst/>
@@ -15524,7 +15296,7 @@
       </p:pic>
       <p:pic>
         <p:nvPicPr>
-          <p:cNvPr id="172" name="Picture 171" descr="image.png"/>
+          <p:cNvPr id="166" name="Picture 165" descr="image.png"/>
           <p:cNvPicPr>
             <a:picLocks noChangeAspect="1"/>
           </p:cNvPicPr>
@@ -15538,8 +15310,8 @@
         </p:blipFill>
         <p:spPr>
           <a:xfrm>
-            <a:off x="7379208" y="4242816"/>
-            <a:ext cx="201168" cy="201168"/>
+            <a:off x="7077456" y="2953512"/>
+            <a:ext cx="182880" cy="182880"/>
           </a:xfrm>
           <a:prstGeom prst="rect">
             <a:avLst/>
@@ -15548,65 +15320,64 @@
       </p:pic>
       <p:sp>
         <p:nvSpPr>
-          <p:cNvPr id="173" name="Rounded Rectangle 172"/>
+          <p:cNvPr id="167" name="TextBox 166"/>
+          <p:cNvSpPr txBox="1"/>
+          <p:nvPr/>
+        </p:nvSpPr>
+        <p:spPr>
+          <a:xfrm>
+            <a:off x="6044184" y="2798064"/>
+            <a:ext cx="731520" cy="493776"/>
+          </a:xfrm>
+          <a:prstGeom prst="rect">
+            <a:avLst/>
+          </a:prstGeom>
+          <a:noFill/>
+        </p:spPr>
+        <p:txBody>
+          <a:bodyPr wrap="square" lIns="36576" rIns="36576" tIns="0" bIns="0" anchor="ctr">
+            <a:spAutoFit/>
+          </a:bodyPr>
+          <a:lstStyle/>
+          <a:p>
+            <a:r>
+              <a:rPr sz="950" b="1" i="0">
+                <a:solidFill>
+                  <a:srgbClr val="FFFFFF"/>
+                </a:solidFill>
+                <a:latin typeface="Calibri"/>
+              </a:rPr>
+              <a:t>AI writes rule</a:t>
+            </a:r>
+          </a:p>
+          <a:p>
+            <a:r>
+              <a:rPr sz="800" b="0" i="0">
+                <a:solidFill>
+                  <a:srgbClr val="F2F5FA"/>
+                </a:solidFill>
+                <a:latin typeface="Calibri"/>
+              </a:rPr>
+              <a:t>only once</a:t>
+            </a:r>
+          </a:p>
+        </p:txBody>
+      </p:sp>
+      <p:sp>
+        <p:nvSpPr>
+          <p:cNvPr id="168" name="Rounded Rectangle 167"/>
           <p:cNvSpPr/>
           <p:nvPr/>
         </p:nvSpPr>
         <p:spPr>
           <a:xfrm>
-            <a:off x="7763256" y="4133088"/>
-            <a:ext cx="2002536" cy="420624"/>
+            <a:off x="5669280" y="3355848"/>
+            <a:ext cx="1691640" cy="493776"/>
           </a:xfrm>
           <a:prstGeom prst="roundRect">
             <a:avLst>
               <a:gd name="adj" fmla="val 14000"/>
             </a:avLst>
-          </a:prstGeom>
-          <a:solidFill>
-            <a:srgbClr val="FDEEEC"/>
-          </a:solidFill>
-          <a:ln w="9525">
-            <a:solidFill>
-              <a:srgbClr val="D5DCE6"/>
-            </a:solidFill>
-          </a:ln>
-          <a:effectLst/>
-        </p:spPr>
-        <p:style>
-          <a:lnRef idx="1">
-            <a:schemeClr val="accent1"/>
-          </a:lnRef>
-          <a:fillRef idx="3">
-            <a:schemeClr val="accent1"/>
-          </a:fillRef>
-          <a:effectRef idx="2">
-            <a:schemeClr val="accent1"/>
-          </a:effectRef>
-          <a:fontRef idx="minor">
-            <a:schemeClr val="lt1"/>
-          </a:fontRef>
-        </p:style>
-        <p:txBody>
-          <a:bodyPr rtlCol="0" anchor="ctr"/>
-          <a:lstStyle/>
-          <a:p>
-            <a:pPr algn="ctr"/>
-          </a:p>
-        </p:txBody>
-      </p:sp>
-      <p:sp>
-        <p:nvSpPr>
-          <p:cNvPr id="174" name="Rectangle 173"/>
-          <p:cNvSpPr/>
-          <p:nvPr/>
-        </p:nvSpPr>
-        <p:spPr>
-          <a:xfrm>
-            <a:off x="7763256" y="4169664"/>
-            <a:ext cx="54864" cy="347472"/>
-          </a:xfrm>
-          <a:prstGeom prst="rect">
-            <a:avLst/>
           </a:prstGeom>
           <a:solidFill>
             <a:srgbClr val="C0392B"/>
@@ -15640,20 +15411,20 @@
       </p:sp>
       <p:sp>
         <p:nvSpPr>
-          <p:cNvPr id="175" name="Oval 174"/>
+          <p:cNvPr id="169" name="Oval 168"/>
           <p:cNvSpPr/>
           <p:nvPr/>
         </p:nvSpPr>
         <p:spPr>
           <a:xfrm>
-            <a:off x="7882128" y="4197096"/>
-            <a:ext cx="292608" cy="292608"/>
+            <a:off x="5742432" y="3465576"/>
+            <a:ext cx="274320" cy="274320"/>
           </a:xfrm>
           <a:prstGeom prst="ellipse">
             <a:avLst/>
           </a:prstGeom>
           <a:solidFill>
-            <a:srgbClr val="C0392B"/>
+            <a:srgbClr val="FFFFFF"/>
           </a:solidFill>
           <a:ln>
             <a:noFill/>
@@ -15682,63 +15453,64 @@
             <a:r>
               <a:rPr sz="850" b="1" i="0">
                 <a:solidFill>
-                  <a:srgbClr val="FFFFFF"/>
-                </a:solidFill>
-                <a:latin typeface="Calibri"/>
-              </a:rPr>
-              <a:t>5b</a:t>
-            </a:r>
-          </a:p>
-        </p:txBody>
-      </p:sp>
-      <p:sp>
-        <p:nvSpPr>
-          <p:cNvPr id="176" name="TextBox 175"/>
-          <p:cNvSpPr txBox="1"/>
-          <p:nvPr/>
-        </p:nvSpPr>
-        <p:spPr>
-          <a:xfrm>
-            <a:off x="8238744" y="4151376"/>
-            <a:ext cx="1124712" cy="384048"/>
-          </a:xfrm>
-          <a:prstGeom prst="rect">
-            <a:avLst/>
-          </a:prstGeom>
-          <a:noFill/>
-        </p:spPr>
-        <p:txBody>
-          <a:bodyPr wrap="square" lIns="36576" rIns="36576" tIns="0" bIns="0" anchor="ctr">
-            <a:spAutoFit/>
-          </a:bodyPr>
-          <a:lstStyle/>
-          <a:p>
-            <a:r>
-              <a:rPr sz="1000" b="1" i="0">
-                <a:solidFill>
                   <a:srgbClr val="C0392B"/>
                 </a:solidFill>
                 <a:latin typeface="Calibri"/>
               </a:rPr>
-              <a:t>Hold for review</a:t>
-            </a:r>
-          </a:p>
-          <a:p>
-            <a:r>
-              <a:rPr sz="800" b="0" i="0">
-                <a:solidFill>
-                  <a:srgbClr val="3A4250"/>
-                </a:solidFill>
-                <a:latin typeface="Calibri"/>
-              </a:rPr>
-              <a:t>learned once it repeats</a:t>
-            </a:r>
+              <a:t>4b</a:t>
+            </a:r>
+          </a:p>
+        </p:txBody>
+      </p:sp>
+      <p:sp>
+        <p:nvSpPr>
+          <p:cNvPr id="170" name="Rounded Rectangle 169"/>
+          <p:cNvSpPr/>
+          <p:nvPr/>
+        </p:nvSpPr>
+        <p:spPr>
+          <a:xfrm>
+            <a:off x="7031736" y="3465576"/>
+            <a:ext cx="274320" cy="274320"/>
+          </a:xfrm>
+          <a:prstGeom prst="roundRect">
+            <a:avLst>
+              <a:gd name="adj" fmla="val 50000"/>
+            </a:avLst>
+          </a:prstGeom>
+          <a:solidFill>
+            <a:srgbClr val="FFFFFF"/>
+          </a:solidFill>
+          <a:ln>
+            <a:noFill/>
+          </a:ln>
+          <a:effectLst/>
+        </p:spPr>
+        <p:style>
+          <a:lnRef idx="1">
+            <a:schemeClr val="accent1"/>
+          </a:lnRef>
+          <a:fillRef idx="3">
+            <a:schemeClr val="accent1"/>
+          </a:fillRef>
+          <a:effectRef idx="2">
+            <a:schemeClr val="accent1"/>
+          </a:effectRef>
+          <a:fontRef idx="minor">
+            <a:schemeClr val="lt1"/>
+          </a:fontRef>
+        </p:style>
+        <p:txBody>
+          <a:bodyPr rtlCol="0" anchor="ctr"/>
+          <a:lstStyle/>
+          <a:p>
+            <a:pPr algn="ctr"/>
           </a:p>
         </p:txBody>
       </p:sp>
       <p:pic>
         <p:nvPicPr>
-          <p:cNvPr id="177" name="Picture 176" descr="image.png"/>
+          <p:cNvPr id="171" name="Picture 170" descr="image.png"/>
           <p:cNvPicPr>
             <a:picLocks noChangeAspect="1"/>
           </p:cNvPicPr>
@@ -15752,8 +15524,8 @@
         </p:blipFill>
         <p:spPr>
           <a:xfrm>
-            <a:off x="9400032" y="4206240"/>
-            <a:ext cx="274320" cy="274320"/>
+            <a:off x="7077456" y="3511296"/>
+            <a:ext cx="182880" cy="182880"/>
           </a:xfrm>
           <a:prstGeom prst="rect">
             <a:avLst/>
@@ -15762,65 +15534,64 @@
       </p:pic>
       <p:sp>
         <p:nvSpPr>
-          <p:cNvPr id="178" name="Rounded Rectangle 177"/>
+          <p:cNvPr id="172" name="TextBox 171"/>
+          <p:cNvSpPr txBox="1"/>
+          <p:nvPr/>
+        </p:nvSpPr>
+        <p:spPr>
+          <a:xfrm>
+            <a:off x="6044184" y="3355848"/>
+            <a:ext cx="950976" cy="493776"/>
+          </a:xfrm>
+          <a:prstGeom prst="rect">
+            <a:avLst/>
+          </a:prstGeom>
+          <a:noFill/>
+        </p:spPr>
+        <p:txBody>
+          <a:bodyPr wrap="square" lIns="36576" rIns="36576" tIns="0" bIns="0" anchor="ctr">
+            <a:spAutoFit/>
+          </a:bodyPr>
+          <a:lstStyle/>
+          <a:p>
+            <a:r>
+              <a:rPr sz="950" b="1" i="0">
+                <a:solidFill>
+                  <a:srgbClr val="FFFFFF"/>
+                </a:solidFill>
+                <a:latin typeface="Calibri"/>
+              </a:rPr>
+              <a:t>Review queue</a:t>
+            </a:r>
+          </a:p>
+          <a:p>
+            <a:r>
+              <a:rPr sz="800" b="0" i="0">
+                <a:solidFill>
+                  <a:srgbClr val="F2F5FA"/>
+                </a:solidFill>
+                <a:latin typeface="Calibri"/>
+              </a:rPr>
+              <a:t>if it repeats</a:t>
+            </a:r>
+          </a:p>
+        </p:txBody>
+      </p:sp>
+      <p:sp>
+        <p:nvSpPr>
+          <p:cNvPr id="173" name="Rounded Rectangle 172"/>
           <p:cNvSpPr/>
           <p:nvPr/>
         </p:nvSpPr>
         <p:spPr>
           <a:xfrm>
-            <a:off x="5669280" y="4645152"/>
-            <a:ext cx="4096512" cy="420624"/>
+            <a:off x="5669280" y="4133088"/>
+            <a:ext cx="3877056" cy="1051560"/>
           </a:xfrm>
           <a:prstGeom prst="roundRect">
             <a:avLst>
               <a:gd name="adj" fmla="val 14000"/>
             </a:avLst>
-          </a:prstGeom>
-          <a:solidFill>
-            <a:srgbClr val="FFFFFF"/>
-          </a:solidFill>
-          <a:ln w="9525">
-            <a:solidFill>
-              <a:srgbClr val="D5DCE6"/>
-            </a:solidFill>
-          </a:ln>
-          <a:effectLst/>
-        </p:spPr>
-        <p:style>
-          <a:lnRef idx="1">
-            <a:schemeClr val="accent1"/>
-          </a:lnRef>
-          <a:fillRef idx="3">
-            <a:schemeClr val="accent1"/>
-          </a:fillRef>
-          <a:effectRef idx="2">
-            <a:schemeClr val="accent1"/>
-          </a:effectRef>
-          <a:fontRef idx="minor">
-            <a:schemeClr val="lt1"/>
-          </a:fontRef>
-        </p:style>
-        <p:txBody>
-          <a:bodyPr rtlCol="0" anchor="ctr"/>
-          <a:lstStyle/>
-          <a:p>
-            <a:pPr algn="ctr"/>
-          </a:p>
-        </p:txBody>
-      </p:sp>
-      <p:sp>
-        <p:nvSpPr>
-          <p:cNvPr id="179" name="Rectangle 178"/>
-          <p:cNvSpPr/>
-          <p:nvPr/>
-        </p:nvSpPr>
-        <p:spPr>
-          <a:xfrm>
-            <a:off x="5669280" y="4681728"/>
-            <a:ext cx="54864" cy="347472"/>
-          </a:xfrm>
-          <a:prstGeom prst="rect">
-            <a:avLst/>
           </a:prstGeom>
           <a:solidFill>
             <a:srgbClr val="0E8C8C"/>
@@ -15854,20 +15625,20 @@
       </p:sp>
       <p:sp>
         <p:nvSpPr>
-          <p:cNvPr id="180" name="Oval 179"/>
+          <p:cNvPr id="174" name="Oval 173"/>
           <p:cNvSpPr/>
           <p:nvPr/>
         </p:nvSpPr>
         <p:spPr>
           <a:xfrm>
-            <a:off x="5788152" y="4709160"/>
-            <a:ext cx="292608" cy="292608"/>
+            <a:off x="5742432" y="4521708"/>
+            <a:ext cx="274320" cy="274320"/>
           </a:xfrm>
           <a:prstGeom prst="ellipse">
             <a:avLst/>
           </a:prstGeom>
           <a:solidFill>
-            <a:srgbClr val="0E8C8C"/>
+            <a:srgbClr val="FFFFFF"/>
           </a:solidFill>
           <a:ln>
             <a:noFill/>
@@ -15896,63 +15667,64 @@
             <a:r>
               <a:rPr sz="1050" b="1" i="0">
                 <a:solidFill>
-                  <a:srgbClr val="FFFFFF"/>
-                </a:solidFill>
-                <a:latin typeface="Calibri"/>
-              </a:rPr>
-              <a:t>6</a:t>
-            </a:r>
-          </a:p>
-        </p:txBody>
-      </p:sp>
-      <p:sp>
-        <p:nvSpPr>
-          <p:cNvPr id="181" name="TextBox 180"/>
-          <p:cNvSpPr txBox="1"/>
-          <p:nvPr/>
-        </p:nvSpPr>
-        <p:spPr>
-          <a:xfrm>
-            <a:off x="6144768" y="4663440"/>
-            <a:ext cx="3218688" cy="384048"/>
-          </a:xfrm>
-          <a:prstGeom prst="rect">
-            <a:avLst/>
-          </a:prstGeom>
-          <a:noFill/>
-        </p:spPr>
-        <p:txBody>
-          <a:bodyPr wrap="square" lIns="36576" rIns="36576" tIns="0" bIns="0" anchor="ctr">
-            <a:spAutoFit/>
-          </a:bodyPr>
-          <a:lstStyle/>
-          <a:p>
-            <a:r>
-              <a:rPr sz="1050" b="1" i="0">
-                <a:solidFill>
                   <a:srgbClr val="0E8C8C"/>
                 </a:solidFill>
                 <a:latin typeface="Calibri"/>
               </a:rPr>
-              <a:t>Save the rule</a:t>
-            </a:r>
-          </a:p>
-          <a:p>
-            <a:r>
-              <a:rPr sz="850" b="0" i="0">
-                <a:solidFill>
-                  <a:srgbClr val="3A4250"/>
-                </a:solidFill>
-                <a:latin typeface="Calibri"/>
-              </a:rPr>
-              <a:t>Stored, so every future matching line skips AI</a:t>
-            </a:r>
+              <a:t>5</a:t>
+            </a:r>
+          </a:p>
+        </p:txBody>
+      </p:sp>
+      <p:sp>
+        <p:nvSpPr>
+          <p:cNvPr id="175" name="Rounded Rectangle 174"/>
+          <p:cNvSpPr/>
+          <p:nvPr/>
+        </p:nvSpPr>
+        <p:spPr>
+          <a:xfrm>
+            <a:off x="9162288" y="4494276"/>
+            <a:ext cx="329184" cy="329184"/>
+          </a:xfrm>
+          <a:prstGeom prst="roundRect">
+            <a:avLst>
+              <a:gd name="adj" fmla="val 50000"/>
+            </a:avLst>
+          </a:prstGeom>
+          <a:solidFill>
+            <a:srgbClr val="FFFFFF"/>
+          </a:solidFill>
+          <a:ln>
+            <a:noFill/>
+          </a:ln>
+          <a:effectLst/>
+        </p:spPr>
+        <p:style>
+          <a:lnRef idx="1">
+            <a:schemeClr val="accent1"/>
+          </a:lnRef>
+          <a:fillRef idx="3">
+            <a:schemeClr val="accent1"/>
+          </a:fillRef>
+          <a:effectRef idx="2">
+            <a:schemeClr val="accent1"/>
+          </a:effectRef>
+          <a:fontRef idx="minor">
+            <a:schemeClr val="lt1"/>
+          </a:fontRef>
+        </p:style>
+        <p:txBody>
+          <a:bodyPr rtlCol="0" anchor="ctr"/>
+          <a:lstStyle/>
+          <a:p>
+            <a:pPr algn="ctr"/>
           </a:p>
         </p:txBody>
       </p:sp>
       <p:pic>
         <p:nvPicPr>
-          <p:cNvPr id="182" name="Picture 181" descr="image.png"/>
+          <p:cNvPr id="176" name="Picture 175" descr="image.png"/>
           <p:cNvPicPr>
             <a:picLocks noChangeAspect="1"/>
           </p:cNvPicPr>
@@ -15966,8 +15738,8 @@
         </p:blipFill>
         <p:spPr>
           <a:xfrm>
-            <a:off x="9400032" y="4718304"/>
-            <a:ext cx="274320" cy="274320"/>
+            <a:off x="9208008" y="4539996"/>
+            <a:ext cx="237744" cy="237744"/>
           </a:xfrm>
           <a:prstGeom prst="rect">
             <a:avLst/>
@@ -15976,65 +15748,64 @@
       </p:pic>
       <p:sp>
         <p:nvSpPr>
-          <p:cNvPr id="183" name="Rounded Rectangle 182"/>
+          <p:cNvPr id="177" name="TextBox 176"/>
+          <p:cNvSpPr txBox="1"/>
+          <p:nvPr/>
+        </p:nvSpPr>
+        <p:spPr>
+          <a:xfrm>
+            <a:off x="6044184" y="4133088"/>
+            <a:ext cx="3081528" cy="1051560"/>
+          </a:xfrm>
+          <a:prstGeom prst="rect">
+            <a:avLst/>
+          </a:prstGeom>
+          <a:noFill/>
+        </p:spPr>
+        <p:txBody>
+          <a:bodyPr wrap="square" lIns="36576" rIns="36576" tIns="0" bIns="0" anchor="ctr">
+            <a:spAutoFit/>
+          </a:bodyPr>
+          <a:lstStyle/>
+          <a:p>
+            <a:r>
+              <a:rPr sz="1300" b="1" i="0">
+                <a:solidFill>
+                  <a:srgbClr val="FFFFFF"/>
+                </a:solidFill>
+                <a:latin typeface="Calibri"/>
+              </a:rPr>
+              <a:t>Save the rule</a:t>
+            </a:r>
+          </a:p>
+          <a:p>
+            <a:r>
+              <a:rPr sz="950" b="0" i="0">
+                <a:solidFill>
+                  <a:srgbClr val="F2F5FA"/>
+                </a:solidFill>
+                <a:latin typeface="Calibri"/>
+              </a:rPr>
+              <a:t>stored in the rule store, so next time this format is instant and skips AI</a:t>
+            </a:r>
+          </a:p>
+        </p:txBody>
+      </p:sp>
+      <p:sp>
+        <p:nvSpPr>
+          <p:cNvPr id="178" name="Rounded Rectangle 177"/>
           <p:cNvSpPr/>
           <p:nvPr/>
         </p:nvSpPr>
         <p:spPr>
           <a:xfrm>
-            <a:off x="5669280" y="5157216"/>
-            <a:ext cx="6108192" cy="420624"/>
+            <a:off x="10040112" y="4133088"/>
+            <a:ext cx="1691640" cy="1051560"/>
           </a:xfrm>
           <a:prstGeom prst="roundRect">
             <a:avLst>
-              <a:gd name="adj" fmla="val 14000"/>
+              <a:gd name="adj" fmla="val 10000"/>
             </a:avLst>
-          </a:prstGeom>
-          <a:solidFill>
-            <a:srgbClr val="FFFFFF"/>
-          </a:solidFill>
-          <a:ln w="9525">
-            <a:solidFill>
-              <a:srgbClr val="D5DCE6"/>
-            </a:solidFill>
-          </a:ln>
-          <a:effectLst/>
-        </p:spPr>
-        <p:style>
-          <a:lnRef idx="1">
-            <a:schemeClr val="accent1"/>
-          </a:lnRef>
-          <a:fillRef idx="3">
-            <a:schemeClr val="accent1"/>
-          </a:fillRef>
-          <a:effectRef idx="2">
-            <a:schemeClr val="accent1"/>
-          </a:effectRef>
-          <a:fontRef idx="minor">
-            <a:schemeClr val="lt1"/>
-          </a:fontRef>
-        </p:style>
-        <p:txBody>
-          <a:bodyPr rtlCol="0" anchor="ctr"/>
-          <a:lstStyle/>
-          <a:p>
-            <a:pPr algn="ctr"/>
-          </a:p>
-        </p:txBody>
-      </p:sp>
-      <p:sp>
-        <p:nvSpPr>
-          <p:cNvPr id="184" name="Rectangle 183"/>
-          <p:cNvSpPr/>
-          <p:nvPr/>
-        </p:nvSpPr>
-        <p:spPr>
-          <a:xfrm>
-            <a:off x="5669280" y="5193792"/>
-            <a:ext cx="54864" cy="347472"/>
-          </a:xfrm>
-          <a:prstGeom prst="rect">
-            <a:avLst/>
           </a:prstGeom>
           <a:solidFill>
             <a:srgbClr val="138A36"/>
@@ -16068,20 +15839,20 @@
       </p:sp>
       <p:sp>
         <p:nvSpPr>
-          <p:cNvPr id="185" name="Oval 184"/>
+          <p:cNvPr id="179" name="Oval 178"/>
           <p:cNvSpPr/>
           <p:nvPr/>
         </p:nvSpPr>
         <p:spPr>
           <a:xfrm>
-            <a:off x="5788152" y="5221224"/>
-            <a:ext cx="292608" cy="292608"/>
+            <a:off x="10131552" y="4224528"/>
+            <a:ext cx="274320" cy="274320"/>
           </a:xfrm>
           <a:prstGeom prst="ellipse">
             <a:avLst/>
           </a:prstGeom>
           <a:solidFill>
-            <a:srgbClr val="138A36"/>
+            <a:srgbClr val="FFFFFF"/>
           </a:solidFill>
           <a:ln>
             <a:noFill/>
@@ -16110,63 +15881,64 @@
             <a:r>
               <a:rPr sz="1050" b="1" i="0">
                 <a:solidFill>
-                  <a:srgbClr val="FFFFFF"/>
-                </a:solidFill>
-                <a:latin typeface="Calibri"/>
-              </a:rPr>
-              <a:t>7</a:t>
-            </a:r>
-          </a:p>
-        </p:txBody>
-      </p:sp>
-      <p:sp>
-        <p:nvSpPr>
-          <p:cNvPr id="186" name="TextBox 185"/>
-          <p:cNvSpPr txBox="1"/>
-          <p:nvPr/>
-        </p:nvSpPr>
-        <p:spPr>
-          <a:xfrm>
-            <a:off x="6144768" y="5175504"/>
-            <a:ext cx="5230368" cy="384048"/>
-          </a:xfrm>
-          <a:prstGeom prst="rect">
-            <a:avLst/>
-          </a:prstGeom>
-          <a:noFill/>
-        </p:spPr>
-        <p:txBody>
-          <a:bodyPr wrap="square" lIns="36576" rIns="36576" tIns="0" bIns="0" anchor="ctr">
-            <a:spAutoFit/>
-          </a:bodyPr>
-          <a:lstStyle/>
-          <a:p>
-            <a:r>
-              <a:rPr sz="1050" b="1" i="0">
-                <a:solidFill>
                   <a:srgbClr val="138A36"/>
                 </a:solidFill>
                 <a:latin typeface="Calibri"/>
               </a:rPr>
-              <a:t>Clean up every line</a:t>
-            </a:r>
-          </a:p>
-          <a:p>
-            <a:r>
-              <a:rPr sz="850" b="0" i="0">
-                <a:solidFill>
-                  <a:srgbClr val="3A4250"/>
-                </a:solidFill>
-                <a:latin typeface="Calibri"/>
-              </a:rPr>
-              <a:t>Fields mapped · time → UTC · one severity scale · IPs &amp; users tagged · original line kept</a:t>
-            </a:r>
+              <a:t>6</a:t>
+            </a:r>
+          </a:p>
+        </p:txBody>
+      </p:sp>
+      <p:sp>
+        <p:nvSpPr>
+          <p:cNvPr id="180" name="Rounded Rectangle 179"/>
+          <p:cNvSpPr/>
+          <p:nvPr/>
+        </p:nvSpPr>
+        <p:spPr>
+          <a:xfrm>
+            <a:off x="11329416" y="4206240"/>
+            <a:ext cx="329184" cy="329184"/>
+          </a:xfrm>
+          <a:prstGeom prst="roundRect">
+            <a:avLst>
+              <a:gd name="adj" fmla="val 50000"/>
+            </a:avLst>
+          </a:prstGeom>
+          <a:solidFill>
+            <a:srgbClr val="FFFFFF"/>
+          </a:solidFill>
+          <a:ln>
+            <a:noFill/>
+          </a:ln>
+          <a:effectLst/>
+        </p:spPr>
+        <p:style>
+          <a:lnRef idx="1">
+            <a:schemeClr val="accent1"/>
+          </a:lnRef>
+          <a:fillRef idx="3">
+            <a:schemeClr val="accent1"/>
+          </a:fillRef>
+          <a:effectRef idx="2">
+            <a:schemeClr val="accent1"/>
+          </a:effectRef>
+          <a:fontRef idx="minor">
+            <a:schemeClr val="lt1"/>
+          </a:fontRef>
+        </p:style>
+        <p:txBody>
+          <a:bodyPr rtlCol="0" anchor="ctr"/>
+          <a:lstStyle/>
+          <a:p>
+            <a:pPr algn="ctr"/>
           </a:p>
         </p:txBody>
       </p:sp>
       <p:pic>
         <p:nvPicPr>
-          <p:cNvPr id="187" name="Picture 186" descr="image.png"/>
+          <p:cNvPr id="181" name="Picture 180" descr="image.png"/>
           <p:cNvPicPr>
             <a:picLocks noChangeAspect="1"/>
           </p:cNvPicPr>
@@ -16180,8 +15952,8 @@
         </p:blipFill>
         <p:spPr>
           <a:xfrm>
-            <a:off x="11411712" y="5230368"/>
-            <a:ext cx="274320" cy="274320"/>
+            <a:off x="11375136" y="4251960"/>
+            <a:ext cx="237744" cy="237744"/>
           </a:xfrm>
           <a:prstGeom prst="rect">
             <a:avLst/>
@@ -16190,65 +15962,64 @@
       </p:pic>
       <p:sp>
         <p:nvSpPr>
-          <p:cNvPr id="188" name="Rounded Rectangle 187"/>
+          <p:cNvPr id="182" name="TextBox 181"/>
+          <p:cNvSpPr txBox="1"/>
+          <p:nvPr/>
+        </p:nvSpPr>
+        <p:spPr>
+          <a:xfrm>
+            <a:off x="10113264" y="4562856"/>
+            <a:ext cx="1545336" cy="576072"/>
+          </a:xfrm>
+          <a:prstGeom prst="rect">
+            <a:avLst/>
+          </a:prstGeom>
+          <a:noFill/>
+        </p:spPr>
+        <p:txBody>
+          <a:bodyPr wrap="square" lIns="36576" rIns="36576" tIns="0" bIns="0" anchor="t">
+            <a:spAutoFit/>
+          </a:bodyPr>
+          <a:lstStyle/>
+          <a:p>
+            <a:r>
+              <a:rPr sz="1200" b="1" i="0">
+                <a:solidFill>
+                  <a:srgbClr val="FFFFFF"/>
+                </a:solidFill>
+                <a:latin typeface="Calibri"/>
+              </a:rPr>
+              <a:t>Clean up</a:t>
+            </a:r>
+          </a:p>
+          <a:p>
+            <a:r>
+              <a:rPr sz="850" b="0" i="0">
+                <a:solidFill>
+                  <a:srgbClr val="F2F5FA"/>
+                </a:solidFill>
+                <a:latin typeface="Calibri"/>
+              </a:rPr>
+              <a:t>time → UTC, severity unified, IPs &amp; users tagged, original kept</a:t>
+            </a:r>
+          </a:p>
+        </p:txBody>
+      </p:sp>
+      <p:sp>
+        <p:nvSpPr>
+          <p:cNvPr id="183" name="Rounded Rectangle 182"/>
           <p:cNvSpPr/>
           <p:nvPr/>
         </p:nvSpPr>
         <p:spPr>
           <a:xfrm>
-            <a:off x="5669280" y="5669280"/>
-            <a:ext cx="6108192" cy="420624"/>
+            <a:off x="5669280" y="5458968"/>
+            <a:ext cx="6062472" cy="813816"/>
           </a:xfrm>
           <a:prstGeom prst="roundRect">
             <a:avLst>
               <a:gd name="adj" fmla="val 14000"/>
             </a:avLst>
-          </a:prstGeom>
-          <a:solidFill>
-            <a:srgbClr val="FFFFFF"/>
-          </a:solidFill>
-          <a:ln w="9525">
-            <a:solidFill>
-              <a:srgbClr val="D5DCE6"/>
-            </a:solidFill>
-          </a:ln>
-          <a:effectLst/>
-        </p:spPr>
-        <p:style>
-          <a:lnRef idx="1">
-            <a:schemeClr val="accent1"/>
-          </a:lnRef>
-          <a:fillRef idx="3">
-            <a:schemeClr val="accent1"/>
-          </a:fillRef>
-          <a:effectRef idx="2">
-            <a:schemeClr val="accent1"/>
-          </a:effectRef>
-          <a:fontRef idx="minor">
-            <a:schemeClr val="lt1"/>
-          </a:fontRef>
-        </p:style>
-        <p:txBody>
-          <a:bodyPr rtlCol="0" anchor="ctr"/>
-          <a:lstStyle/>
-          <a:p>
-            <a:pPr algn="ctr"/>
-          </a:p>
-        </p:txBody>
-      </p:sp>
-      <p:sp>
-        <p:nvSpPr>
-          <p:cNvPr id="189" name="Rectangle 188"/>
-          <p:cNvSpPr/>
-          <p:nvPr/>
-        </p:nvSpPr>
-        <p:spPr>
-          <a:xfrm>
-            <a:off x="5669280" y="5705856"/>
-            <a:ext cx="54864" cy="347472"/>
-          </a:xfrm>
-          <a:prstGeom prst="rect">
-            <a:avLst/>
           </a:prstGeom>
           <a:solidFill>
             <a:srgbClr val="0B2A5B"/>
@@ -16282,20 +16053,20 @@
       </p:sp>
       <p:sp>
         <p:nvSpPr>
-          <p:cNvPr id="190" name="Oval 189"/>
+          <p:cNvPr id="184" name="Oval 183"/>
           <p:cNvSpPr/>
           <p:nvPr/>
         </p:nvSpPr>
         <p:spPr>
           <a:xfrm>
-            <a:off x="5788152" y="5733288"/>
-            <a:ext cx="292608" cy="292608"/>
+            <a:off x="5742432" y="5728716"/>
+            <a:ext cx="274320" cy="274320"/>
           </a:xfrm>
           <a:prstGeom prst="ellipse">
             <a:avLst/>
           </a:prstGeom>
           <a:solidFill>
-            <a:srgbClr val="0B2A5B"/>
+            <a:srgbClr val="FFFFFF"/>
           </a:solidFill>
           <a:ln>
             <a:noFill/>
@@ -16324,63 +16095,64 @@
             <a:r>
               <a:rPr sz="1050" b="1" i="0">
                 <a:solidFill>
-                  <a:srgbClr val="FFFFFF"/>
-                </a:solidFill>
-                <a:latin typeface="Calibri"/>
-              </a:rPr>
-              <a:t>8</a:t>
-            </a:r>
-          </a:p>
-        </p:txBody>
-      </p:sp>
-      <p:sp>
-        <p:nvSpPr>
-          <p:cNvPr id="191" name="TextBox 190"/>
-          <p:cNvSpPr txBox="1"/>
-          <p:nvPr/>
-        </p:nvSpPr>
-        <p:spPr>
-          <a:xfrm>
-            <a:off x="6144768" y="5687568"/>
-            <a:ext cx="4901184" cy="384048"/>
-          </a:xfrm>
-          <a:prstGeom prst="rect">
-            <a:avLst/>
-          </a:prstGeom>
-          <a:noFill/>
-        </p:spPr>
-        <p:txBody>
-          <a:bodyPr wrap="square" lIns="36576" rIns="36576" tIns="0" bIns="0" anchor="ctr">
-            <a:spAutoFit/>
-          </a:bodyPr>
-          <a:lstStyle/>
-          <a:p>
-            <a:r>
-              <a:rPr sz="1050" b="1" i="0">
-                <a:solidFill>
                   <a:srgbClr val="0B2A5B"/>
                 </a:solidFill>
                 <a:latin typeface="Calibri"/>
               </a:rPr>
-              <a:t>One clean JSON format out</a:t>
-            </a:r>
-          </a:p>
-          <a:p>
-            <a:r>
-              <a:rPr sz="850" b="0" i="0">
-                <a:solidFill>
-                  <a:srgbClr val="3A4250"/>
-                </a:solidFill>
-                <a:latin typeface="Calibri"/>
-              </a:rPr>
-              <a:t>Ready for SIEM tools, dashboards and search</a:t>
-            </a:r>
+              <a:t>7</a:t>
+            </a:r>
+          </a:p>
+        </p:txBody>
+      </p:sp>
+      <p:sp>
+        <p:nvSpPr>
+          <p:cNvPr id="185" name="Rounded Rectangle 184"/>
+          <p:cNvSpPr/>
+          <p:nvPr/>
+        </p:nvSpPr>
+        <p:spPr>
+          <a:xfrm>
+            <a:off x="11073384" y="5701284"/>
+            <a:ext cx="603504" cy="329184"/>
+          </a:xfrm>
+          <a:prstGeom prst="roundRect">
+            <a:avLst>
+              <a:gd name="adj" fmla="val 50000"/>
+            </a:avLst>
+          </a:prstGeom>
+          <a:solidFill>
+            <a:srgbClr val="FFFFFF"/>
+          </a:solidFill>
+          <a:ln>
+            <a:noFill/>
+          </a:ln>
+          <a:effectLst/>
+        </p:spPr>
+        <p:style>
+          <a:lnRef idx="1">
+            <a:schemeClr val="accent1"/>
+          </a:lnRef>
+          <a:fillRef idx="3">
+            <a:schemeClr val="accent1"/>
+          </a:fillRef>
+          <a:effectRef idx="2">
+            <a:schemeClr val="accent1"/>
+          </a:effectRef>
+          <a:fontRef idx="minor">
+            <a:schemeClr val="lt1"/>
+          </a:fontRef>
+        </p:style>
+        <p:txBody>
+          <a:bodyPr rtlCol="0" anchor="ctr"/>
+          <a:lstStyle/>
+          <a:p>
+            <a:pPr algn="ctr"/>
           </a:p>
         </p:txBody>
       </p:sp>
       <p:pic>
         <p:nvPicPr>
-          <p:cNvPr id="192" name="Picture 191" descr="image.png"/>
+          <p:cNvPr id="186" name="Picture 185" descr="image.png"/>
           <p:cNvPicPr>
             <a:picLocks noChangeAspect="1"/>
           </p:cNvPicPr>
@@ -16394,8 +16166,8 @@
         </p:blipFill>
         <p:spPr>
           <a:xfrm>
-            <a:off x="11082528" y="5742432"/>
-            <a:ext cx="274320" cy="274320"/>
+            <a:off x="11119104" y="5747004"/>
+            <a:ext cx="237744" cy="237744"/>
           </a:xfrm>
           <a:prstGeom prst="rect">
             <a:avLst/>
@@ -16404,7 +16176,7 @@
       </p:pic>
       <p:pic>
         <p:nvPicPr>
-          <p:cNvPr id="193" name="Picture 192" descr="image.png"/>
+          <p:cNvPr id="187" name="Picture 186" descr="image.png"/>
           <p:cNvPicPr>
             <a:picLocks noChangeAspect="1"/>
           </p:cNvPicPr>
@@ -16418,8 +16190,8 @@
         </p:blipFill>
         <p:spPr>
           <a:xfrm>
-            <a:off x="11411712" y="5742432"/>
-            <a:ext cx="274320" cy="274320"/>
+            <a:off x="11393424" y="5747004"/>
+            <a:ext cx="237744" cy="237744"/>
           </a:xfrm>
           <a:prstGeom prst="rect">
             <a:avLst/>
@@ -16428,70 +16200,68 @@
       </p:pic>
       <p:sp>
         <p:nvSpPr>
-          <p:cNvPr id="194" name="Rounded Rectangle 193"/>
-          <p:cNvSpPr/>
-          <p:nvPr/>
-        </p:nvSpPr>
-        <p:spPr>
-          <a:xfrm>
-            <a:off x="5614416" y="4087368"/>
-            <a:ext cx="4206240" cy="1024128"/>
-          </a:xfrm>
-          <a:prstGeom prst="roundRect">
-            <a:avLst>
-              <a:gd name="adj" fmla="val 8000"/>
-            </a:avLst>
+          <p:cNvPr id="188" name="TextBox 187"/>
+          <p:cNvSpPr txBox="1"/>
+          <p:nvPr/>
+        </p:nvSpPr>
+        <p:spPr>
+          <a:xfrm>
+            <a:off x="6044184" y="5458968"/>
+            <a:ext cx="4992624" cy="813816"/>
+          </a:xfrm>
+          <a:prstGeom prst="rect">
+            <a:avLst/>
           </a:prstGeom>
           <a:noFill/>
-          <a:ln w="15875">
-            <a:solidFill>
-              <a:srgbClr val="F28322"/>
-            </a:solidFill>
-            <a:prstDash val="dash"/>
-          </a:ln>
-          <a:effectLst/>
-        </p:spPr>
-        <p:style>
-          <a:lnRef idx="1">
-            <a:schemeClr val="accent1"/>
-          </a:lnRef>
-          <a:fillRef idx="3">
-            <a:schemeClr val="accent1"/>
-          </a:fillRef>
-          <a:effectRef idx="2">
-            <a:schemeClr val="accent1"/>
-          </a:effectRef>
-          <a:fontRef idx="minor">
-            <a:schemeClr val="lt1"/>
-          </a:fontRef>
-        </p:style>
-        <p:txBody>
-          <a:bodyPr rtlCol="0" anchor="ctr"/>
-          <a:lstStyle/>
-          <a:p>
-            <a:pPr algn="ctr"/>
+        </p:spPr>
+        <p:txBody>
+          <a:bodyPr wrap="square" lIns="36576" rIns="36576" tIns="0" bIns="0" anchor="ctr">
+            <a:spAutoFit/>
+          </a:bodyPr>
+          <a:lstStyle/>
+          <a:p>
+            <a:r>
+              <a:rPr sz="1250" b="1" i="0">
+                <a:solidFill>
+                  <a:srgbClr val="FFFFFF"/>
+                </a:solidFill>
+                <a:latin typeface="Calibri"/>
+              </a:rPr>
+              <a:t>One clean, common format out (JSON)</a:t>
+            </a:r>
+          </a:p>
+          <a:p>
+            <a:r>
+              <a:rPr sz="900" b="0" i="0">
+                <a:solidFill>
+                  <a:srgbClr val="F2F5FA"/>
+                </a:solidFill>
+                <a:latin typeface="Calibri"/>
+              </a:rPr>
+              <a:t>every log looks the same, ready for security tools, dashboards &amp; search</a:t>
+            </a:r>
           </a:p>
         </p:txBody>
       </p:sp>
       <p:cxnSp>
         <p:nvCxnSpPr>
-          <p:cNvPr id="195" name="Connector 194"/>
+          <p:cNvPr id="189" name="Connector 188"/>
           <p:cNvCxnSpPr/>
           <p:nvPr/>
         </p:nvCxnSpPr>
         <p:spPr>
           <a:xfrm>
-            <a:off x="5934456" y="1993392"/>
-            <a:ext cx="0" cy="91440"/>
+            <a:off x="7388352" y="1988820"/>
+            <a:ext cx="438912" cy="0"/>
           </a:xfrm>
           <a:prstGeom prst="line">
             <a:avLst/>
           </a:prstGeom>
-          <a:ln w="19050">
+          <a:ln w="22225">
             <a:solidFill>
-              <a:srgbClr val="8A94A6"/>
+              <a:srgbClr val="5B6573"/>
             </a:solidFill>
-            <a:tailEnd type="triangle" w="med" len="sm"/>
+            <a:tailEnd type="triangle" w="med" len="med"/>
           </a:ln>
         </p:spPr>
         <p:style>
@@ -16511,23 +16281,307 @@
       </p:cxnSp>
       <p:cxnSp>
         <p:nvCxnSpPr>
+          <p:cNvPr id="190" name="Connector 189"/>
+          <p:cNvCxnSpPr/>
+          <p:nvPr/>
+        </p:nvCxnSpPr>
+        <p:spPr>
+          <a:xfrm>
+            <a:off x="9573768" y="1988820"/>
+            <a:ext cx="740664" cy="0"/>
+          </a:xfrm>
+          <a:prstGeom prst="line">
+            <a:avLst/>
+          </a:prstGeom>
+          <a:ln w="28575">
+            <a:solidFill>
+              <a:srgbClr val="138A36"/>
+            </a:solidFill>
+            <a:tailEnd type="triangle" w="med" len="med"/>
+          </a:ln>
+        </p:spPr>
+        <p:style>
+          <a:lnRef idx="2">
+            <a:schemeClr val="accent1"/>
+          </a:lnRef>
+          <a:fillRef idx="0">
+            <a:schemeClr val="accent1"/>
+          </a:fillRef>
+          <a:effectRef idx="1">
+            <a:schemeClr val="accent1"/>
+          </a:effectRef>
+          <a:fontRef idx="minor">
+            <a:schemeClr val="tx1"/>
+          </a:fontRef>
+        </p:style>
+      </p:cxnSp>
+      <p:sp>
+        <p:nvSpPr>
+          <p:cNvPr id="191" name="TextBox 190"/>
+          <p:cNvSpPr txBox="1"/>
+          <p:nvPr/>
+        </p:nvSpPr>
+        <p:spPr>
+          <a:xfrm>
+            <a:off x="9564624" y="1769364"/>
+            <a:ext cx="457200" cy="182880"/>
+          </a:xfrm>
+          <a:prstGeom prst="rect">
+            <a:avLst/>
+          </a:prstGeom>
+          <a:noFill/>
+        </p:spPr>
+        <p:txBody>
+          <a:bodyPr wrap="square" lIns="9144" rIns="9144" tIns="0" bIns="0" anchor="ctr">
+            <a:spAutoFit/>
+          </a:bodyPr>
+          <a:lstStyle/>
+          <a:p>
+            <a:pPr algn="l"/>
+            <a:r>
+              <a:rPr sz="900" b="1" i="0">
+                <a:solidFill>
+                  <a:srgbClr val="138A36"/>
+                </a:solidFill>
+                <a:latin typeface="Calibri"/>
+              </a:rPr>
+              <a:t>Yes</a:t>
+            </a:r>
+          </a:p>
+        </p:txBody>
+      </p:sp>
+      <p:cxnSp>
+        <p:nvCxnSpPr>
+          <p:cNvPr id="192" name="Connector 191"/>
+          <p:cNvCxnSpPr/>
+          <p:nvPr/>
+        </p:nvCxnSpPr>
+        <p:spPr>
+          <a:xfrm>
+            <a:off x="8700516" y="2532888"/>
+            <a:ext cx="0" cy="246888"/>
+          </a:xfrm>
+          <a:prstGeom prst="line">
+            <a:avLst/>
+          </a:prstGeom>
+          <a:ln w="25400">
+            <a:solidFill>
+              <a:srgbClr val="C06010"/>
+            </a:solidFill>
+            <a:tailEnd type="triangle" w="med" len="med"/>
+          </a:ln>
+        </p:spPr>
+        <p:style>
+          <a:lnRef idx="2">
+            <a:schemeClr val="accent1"/>
+          </a:lnRef>
+          <a:fillRef idx="0">
+            <a:schemeClr val="accent1"/>
+          </a:fillRef>
+          <a:effectRef idx="1">
+            <a:schemeClr val="accent1"/>
+          </a:effectRef>
+          <a:fontRef idx="minor">
+            <a:schemeClr val="tx1"/>
+          </a:fontRef>
+        </p:style>
+      </p:cxnSp>
+      <p:sp>
+        <p:nvSpPr>
+          <p:cNvPr id="193" name="TextBox 192"/>
+          <p:cNvSpPr txBox="1"/>
+          <p:nvPr/>
+        </p:nvSpPr>
+        <p:spPr>
+          <a:xfrm>
+            <a:off x="8755380" y="2542032"/>
+            <a:ext cx="1280160" cy="182880"/>
+          </a:xfrm>
+          <a:prstGeom prst="rect">
+            <a:avLst/>
+          </a:prstGeom>
+          <a:noFill/>
+        </p:spPr>
+        <p:txBody>
+          <a:bodyPr wrap="square" lIns="9144" rIns="9144" tIns="0" bIns="0" anchor="ctr">
+            <a:spAutoFit/>
+          </a:bodyPr>
+          <a:lstStyle/>
+          <a:p>
+            <a:pPr algn="l"/>
+            <a:r>
+              <a:rPr sz="850" b="1" i="0">
+                <a:solidFill>
+                  <a:srgbClr val="C06010"/>
+                </a:solidFill>
+                <a:latin typeface="Calibri"/>
+              </a:rPr>
+              <a:t>No, it is new</a:t>
+            </a:r>
+          </a:p>
+        </p:txBody>
+      </p:sp>
+      <p:cxnSp>
+        <p:nvCxnSpPr>
+          <p:cNvPr id="194" name="Connector 193"/>
+          <p:cNvCxnSpPr/>
+          <p:nvPr/>
+        </p:nvCxnSpPr>
+        <p:spPr>
+          <a:xfrm flipH="1">
+            <a:off x="7388352" y="3044952"/>
+            <a:ext cx="438912" cy="0"/>
+          </a:xfrm>
+          <a:prstGeom prst="line">
+            <a:avLst/>
+          </a:prstGeom>
+          <a:ln w="22225">
+            <a:solidFill>
+              <a:srgbClr val="C06010"/>
+            </a:solidFill>
+            <a:tailEnd type="triangle" w="med" len="med"/>
+          </a:ln>
+        </p:spPr>
+        <p:style>
+          <a:lnRef idx="2">
+            <a:schemeClr val="accent1"/>
+          </a:lnRef>
+          <a:fillRef idx="0">
+            <a:schemeClr val="accent1"/>
+          </a:fillRef>
+          <a:effectRef idx="1">
+            <a:schemeClr val="accent1"/>
+          </a:effectRef>
+          <a:fontRef idx="minor">
+            <a:schemeClr val="tx1"/>
+          </a:fontRef>
+        </p:style>
+      </p:cxnSp>
+      <p:sp>
+        <p:nvSpPr>
+          <p:cNvPr id="195" name="TextBox 194"/>
+          <p:cNvSpPr txBox="1"/>
+          <p:nvPr/>
+        </p:nvSpPr>
+        <p:spPr>
+          <a:xfrm>
+            <a:off x="7397496" y="2843784"/>
+            <a:ext cx="457200" cy="182880"/>
+          </a:xfrm>
+          <a:prstGeom prst="rect">
+            <a:avLst/>
+          </a:prstGeom>
+          <a:noFill/>
+        </p:spPr>
+        <p:txBody>
+          <a:bodyPr wrap="square" lIns="9144" rIns="9144" tIns="0" bIns="0" anchor="ctr">
+            <a:spAutoFit/>
+          </a:bodyPr>
+          <a:lstStyle/>
+          <a:p>
+            <a:pPr algn="l"/>
+            <a:r>
+              <a:rPr sz="800" b="1" i="0">
+                <a:solidFill>
+                  <a:srgbClr val="C06010"/>
+                </a:solidFill>
+                <a:latin typeface="Calibri"/>
+              </a:rPr>
+              <a:t>yes</a:t>
+            </a:r>
+          </a:p>
+        </p:txBody>
+      </p:sp>
+      <p:cxnSp>
+        <p:nvCxnSpPr>
           <p:cNvPr id="196" name="Connector 195"/>
           <p:cNvCxnSpPr/>
           <p:nvPr/>
         </p:nvCxnSpPr>
         <p:spPr>
-          <a:xfrm>
-            <a:off x="5934456" y="2505456"/>
-            <a:ext cx="0" cy="91440"/>
+          <a:xfrm flipH="1">
+            <a:off x="7388352" y="3602736"/>
+            <a:ext cx="438912" cy="0"/>
           </a:xfrm>
           <a:prstGeom prst="line">
             <a:avLst/>
           </a:prstGeom>
-          <a:ln w="19050">
+          <a:ln w="22225">
             <a:solidFill>
-              <a:srgbClr val="8A94A6"/>
+              <a:srgbClr val="C0392B"/>
             </a:solidFill>
-            <a:tailEnd type="triangle" w="med" len="sm"/>
+            <a:tailEnd type="triangle" w="med" len="med"/>
+          </a:ln>
+        </p:spPr>
+        <p:style>
+          <a:lnRef idx="2">
+            <a:schemeClr val="accent1"/>
+          </a:lnRef>
+          <a:fillRef idx="0">
+            <a:schemeClr val="accent1"/>
+          </a:fillRef>
+          <a:effectRef idx="1">
+            <a:schemeClr val="accent1"/>
+          </a:effectRef>
+          <a:fontRef idx="minor">
+            <a:schemeClr val="tx1"/>
+          </a:fontRef>
+        </p:style>
+      </p:cxnSp>
+      <p:sp>
+        <p:nvSpPr>
+          <p:cNvPr id="197" name="TextBox 196"/>
+          <p:cNvSpPr txBox="1"/>
+          <p:nvPr/>
+        </p:nvSpPr>
+        <p:spPr>
+          <a:xfrm>
+            <a:off x="7397496" y="3401568"/>
+            <a:ext cx="457200" cy="182880"/>
+          </a:xfrm>
+          <a:prstGeom prst="rect">
+            <a:avLst/>
+          </a:prstGeom>
+          <a:noFill/>
+        </p:spPr>
+        <p:txBody>
+          <a:bodyPr wrap="square" lIns="9144" rIns="9144" tIns="0" bIns="0" anchor="ctr">
+            <a:spAutoFit/>
+          </a:bodyPr>
+          <a:lstStyle/>
+          <a:p>
+            <a:pPr algn="l"/>
+            <a:r>
+              <a:rPr sz="800" b="1" i="0">
+                <a:solidFill>
+                  <a:srgbClr val="C0392B"/>
+                </a:solidFill>
+                <a:latin typeface="Calibri"/>
+              </a:rPr>
+              <a:t>no</a:t>
+            </a:r>
+          </a:p>
+        </p:txBody>
+      </p:sp>
+      <p:cxnSp>
+        <p:nvCxnSpPr>
+          <p:cNvPr id="198" name="Connector 197"/>
+          <p:cNvCxnSpPr/>
+          <p:nvPr/>
+        </p:nvCxnSpPr>
+        <p:spPr>
+          <a:xfrm>
+            <a:off x="6515100" y="3867912"/>
+            <a:ext cx="0" cy="246888"/>
+          </a:xfrm>
+          <a:prstGeom prst="line">
+            <a:avLst/>
+          </a:prstGeom>
+          <a:ln w="25400">
+            <a:solidFill>
+              <a:srgbClr val="0E8C8C"/>
+            </a:solidFill>
+            <a:tailEnd type="triangle" w="med" len="med"/>
           </a:ln>
         </p:spPr>
         <p:style>
@@ -16547,23 +16601,23 @@
       </p:cxnSp>
       <p:cxnSp>
         <p:nvCxnSpPr>
-          <p:cNvPr id="197" name="Connector 196"/>
+          <p:cNvPr id="199" name="Connector 198"/>
           <p:cNvCxnSpPr/>
           <p:nvPr/>
         </p:nvCxnSpPr>
         <p:spPr>
           <a:xfrm>
-            <a:off x="5934456" y="3017520"/>
-            <a:ext cx="0" cy="91440"/>
+            <a:off x="9573768" y="4658868"/>
+            <a:ext cx="438912" cy="0"/>
           </a:xfrm>
           <a:prstGeom prst="line">
             <a:avLst/>
           </a:prstGeom>
-          <a:ln w="19050">
+          <a:ln w="25400">
             <a:solidFill>
-              <a:srgbClr val="8A94A6"/>
+              <a:srgbClr val="0E8C8C"/>
             </a:solidFill>
-            <a:tailEnd type="triangle" w="med" len="sm"/>
+            <a:tailEnd type="triangle" w="med" len="med"/>
           </a:ln>
         </p:spPr>
         <p:style>
@@ -16583,23 +16637,23 @@
       </p:cxnSp>
       <p:cxnSp>
         <p:nvCxnSpPr>
-          <p:cNvPr id="198" name="Connector 197"/>
+          <p:cNvPr id="200" name="Connector 199"/>
           <p:cNvCxnSpPr/>
           <p:nvPr/>
         </p:nvCxnSpPr>
         <p:spPr>
           <a:xfrm>
-            <a:off x="5934456" y="3529584"/>
-            <a:ext cx="0" cy="91440"/>
+            <a:off x="10885932" y="5202936"/>
+            <a:ext cx="0" cy="237744"/>
           </a:xfrm>
           <a:prstGeom prst="line">
             <a:avLst/>
           </a:prstGeom>
-          <a:ln w="19050">
+          <a:ln w="25400">
             <a:solidFill>
-              <a:srgbClr val="8A94A6"/>
+              <a:srgbClr val="138A36"/>
             </a:solidFill>
-            <a:tailEnd type="triangle" w="med" len="sm"/>
+            <a:tailEnd type="triangle" w="med" len="med"/>
           </a:ln>
         </p:spPr>
         <p:style>
@@ -16617,883 +16671,6 @@
           </a:fontRef>
         </p:style>
       </p:cxnSp>
-      <p:sp>
-        <p:nvSpPr>
-          <p:cNvPr id="199" name="TextBox 198"/>
-          <p:cNvSpPr txBox="1"/>
-          <p:nvPr/>
-        </p:nvSpPr>
-        <p:spPr>
-          <a:xfrm>
-            <a:off x="5998464" y="2487168"/>
-            <a:ext cx="365760" cy="164592"/>
-          </a:xfrm>
-          <a:prstGeom prst="rect">
-            <a:avLst/>
-          </a:prstGeom>
-          <a:noFill/>
-        </p:spPr>
-        <p:txBody>
-          <a:bodyPr wrap="square" lIns="9144" rIns="9144" tIns="0" bIns="0" anchor="ctr">
-            <a:spAutoFit/>
-          </a:bodyPr>
-          <a:lstStyle/>
-          <a:p>
-            <a:pPr algn="l"/>
-            <a:r>
-              <a:rPr sz="750" b="1" i="0">
-                <a:solidFill>
-                  <a:srgbClr val="C0392B"/>
-                </a:solidFill>
-                <a:latin typeface="Calibri"/>
-              </a:rPr>
-              <a:t>No</a:t>
-            </a:r>
-          </a:p>
-        </p:txBody>
-      </p:sp>
-      <p:sp>
-        <p:nvSpPr>
-          <p:cNvPr id="200" name="TextBox 199"/>
-          <p:cNvSpPr txBox="1"/>
-          <p:nvPr/>
-        </p:nvSpPr>
-        <p:spPr>
-          <a:xfrm>
-            <a:off x="5998464" y="3511296"/>
-            <a:ext cx="365760" cy="164592"/>
-          </a:xfrm>
-          <a:prstGeom prst="rect">
-            <a:avLst/>
-          </a:prstGeom>
-          <a:noFill/>
-        </p:spPr>
-        <p:txBody>
-          <a:bodyPr wrap="square" lIns="9144" rIns="9144" tIns="0" bIns="0" anchor="ctr">
-            <a:spAutoFit/>
-          </a:bodyPr>
-          <a:lstStyle/>
-          <a:p>
-            <a:pPr algn="l"/>
-            <a:r>
-              <a:rPr sz="750" b="1" i="0">
-                <a:solidFill>
-                  <a:srgbClr val="C0392B"/>
-                </a:solidFill>
-                <a:latin typeface="Calibri"/>
-              </a:rPr>
-              <a:t>No</a:t>
-            </a:r>
-          </a:p>
-        </p:txBody>
-      </p:sp>
-      <p:cxnSp>
-        <p:nvCxnSpPr>
-          <p:cNvPr id="201" name="Connector 200"/>
-          <p:cNvCxnSpPr/>
-          <p:nvPr/>
-        </p:nvCxnSpPr>
-        <p:spPr>
-          <a:xfrm>
-            <a:off x="5934456" y="4041648"/>
-            <a:ext cx="0" cy="91440"/>
-          </a:xfrm>
-          <a:prstGeom prst="line">
-            <a:avLst/>
-          </a:prstGeom>
-          <a:ln w="19050">
-            <a:solidFill>
-              <a:srgbClr val="8A94A6"/>
-            </a:solidFill>
-            <a:tailEnd type="triangle" w="med" len="sm"/>
-          </a:ln>
-        </p:spPr>
-        <p:style>
-          <a:lnRef idx="2">
-            <a:schemeClr val="accent1"/>
-          </a:lnRef>
-          <a:fillRef idx="0">
-            <a:schemeClr val="accent1"/>
-          </a:fillRef>
-          <a:effectRef idx="1">
-            <a:schemeClr val="accent1"/>
-          </a:effectRef>
-          <a:fontRef idx="minor">
-            <a:schemeClr val="tx1"/>
-          </a:fontRef>
-        </p:style>
-      </p:cxnSp>
-      <p:cxnSp>
-        <p:nvCxnSpPr>
-          <p:cNvPr id="202" name="Connector 201"/>
-          <p:cNvCxnSpPr/>
-          <p:nvPr/>
-        </p:nvCxnSpPr>
-        <p:spPr>
-          <a:xfrm>
-            <a:off x="8028432" y="4041648"/>
-            <a:ext cx="0" cy="91440"/>
-          </a:xfrm>
-          <a:prstGeom prst="line">
-            <a:avLst/>
-          </a:prstGeom>
-          <a:ln w="19050">
-            <a:solidFill>
-              <a:srgbClr val="8A94A6"/>
-            </a:solidFill>
-            <a:tailEnd type="triangle" w="med" len="sm"/>
-          </a:ln>
-        </p:spPr>
-        <p:style>
-          <a:lnRef idx="2">
-            <a:schemeClr val="accent1"/>
-          </a:lnRef>
-          <a:fillRef idx="0">
-            <a:schemeClr val="accent1"/>
-          </a:fillRef>
-          <a:effectRef idx="1">
-            <a:schemeClr val="accent1"/>
-          </a:effectRef>
-          <a:fontRef idx="minor">
-            <a:schemeClr val="tx1"/>
-          </a:fontRef>
-        </p:style>
-      </p:cxnSp>
-      <p:sp>
-        <p:nvSpPr>
-          <p:cNvPr id="203" name="TextBox 202"/>
-          <p:cNvSpPr txBox="1"/>
-          <p:nvPr/>
-        </p:nvSpPr>
-        <p:spPr>
-          <a:xfrm>
-            <a:off x="5998464" y="4023360"/>
-            <a:ext cx="731520" cy="164592"/>
-          </a:xfrm>
-          <a:prstGeom prst="rect">
-            <a:avLst/>
-          </a:prstGeom>
-          <a:noFill/>
-        </p:spPr>
-        <p:txBody>
-          <a:bodyPr wrap="square" lIns="9144" rIns="9144" tIns="0" bIns="0" anchor="ctr">
-            <a:spAutoFit/>
-          </a:bodyPr>
-          <a:lstStyle/>
-          <a:p>
-            <a:pPr algn="l"/>
-            <a:r>
-              <a:rPr sz="750" b="1" i="0">
-                <a:solidFill>
-                  <a:srgbClr val="6A3FB5"/>
-                </a:solidFill>
-                <a:latin typeface="Calibri"/>
-              </a:rPr>
-              <a:t>familiar</a:t>
-            </a:r>
-          </a:p>
-        </p:txBody>
-      </p:sp>
-      <p:sp>
-        <p:nvSpPr>
-          <p:cNvPr id="204" name="TextBox 203"/>
-          <p:cNvSpPr txBox="1"/>
-          <p:nvPr/>
-        </p:nvSpPr>
-        <p:spPr>
-          <a:xfrm>
-            <a:off x="8092440" y="4023360"/>
-            <a:ext cx="731520" cy="164592"/>
-          </a:xfrm>
-          <a:prstGeom prst="rect">
-            <a:avLst/>
-          </a:prstGeom>
-          <a:noFill/>
-        </p:spPr>
-        <p:txBody>
-          <a:bodyPr wrap="square" lIns="9144" rIns="9144" tIns="0" bIns="0" anchor="ctr">
-            <a:spAutoFit/>
-          </a:bodyPr>
-          <a:lstStyle/>
-          <a:p>
-            <a:pPr algn="l"/>
-            <a:r>
-              <a:rPr sz="750" b="1" i="0">
-                <a:solidFill>
-                  <a:srgbClr val="6A3FB5"/>
-                </a:solidFill>
-                <a:latin typeface="Calibri"/>
-              </a:rPr>
-              <a:t>brand-new</a:t>
-            </a:r>
-          </a:p>
-        </p:txBody>
-      </p:sp>
-      <p:cxnSp>
-        <p:nvCxnSpPr>
-          <p:cNvPr id="205" name="Connector 204"/>
-          <p:cNvCxnSpPr/>
-          <p:nvPr/>
-        </p:nvCxnSpPr>
-        <p:spPr>
-          <a:xfrm>
-            <a:off x="5934456" y="4553712"/>
-            <a:ext cx="0" cy="91440"/>
-          </a:xfrm>
-          <a:prstGeom prst="line">
-            <a:avLst/>
-          </a:prstGeom>
-          <a:ln w="19050">
-            <a:solidFill>
-              <a:srgbClr val="8A94A6"/>
-            </a:solidFill>
-            <a:tailEnd type="triangle" w="med" len="sm"/>
-          </a:ln>
-        </p:spPr>
-        <p:style>
-          <a:lnRef idx="2">
-            <a:schemeClr val="accent1"/>
-          </a:lnRef>
-          <a:fillRef idx="0">
-            <a:schemeClr val="accent1"/>
-          </a:fillRef>
-          <a:effectRef idx="1">
-            <a:schemeClr val="accent1"/>
-          </a:effectRef>
-          <a:fontRef idx="minor">
-            <a:schemeClr val="tx1"/>
-          </a:fontRef>
-        </p:style>
-      </p:cxnSp>
-      <p:cxnSp>
-        <p:nvCxnSpPr>
-          <p:cNvPr id="206" name="Connector 205"/>
-          <p:cNvCxnSpPr/>
-          <p:nvPr/>
-        </p:nvCxnSpPr>
-        <p:spPr>
-          <a:xfrm>
-            <a:off x="8028432" y="4553712"/>
-            <a:ext cx="0" cy="91440"/>
-          </a:xfrm>
-          <a:prstGeom prst="line">
-            <a:avLst/>
-          </a:prstGeom>
-          <a:ln w="19050">
-            <a:solidFill>
-              <a:srgbClr val="8A94A6"/>
-            </a:solidFill>
-            <a:tailEnd type="triangle" w="med" len="sm"/>
-          </a:ln>
-        </p:spPr>
-        <p:style>
-          <a:lnRef idx="2">
-            <a:schemeClr val="accent1"/>
-          </a:lnRef>
-          <a:fillRef idx="0">
-            <a:schemeClr val="accent1"/>
-          </a:fillRef>
-          <a:effectRef idx="1">
-            <a:schemeClr val="accent1"/>
-          </a:effectRef>
-          <a:fontRef idx="minor">
-            <a:schemeClr val="tx1"/>
-          </a:fontRef>
-        </p:style>
-      </p:cxnSp>
-      <p:cxnSp>
-        <p:nvCxnSpPr>
-          <p:cNvPr id="207" name="Connector 206"/>
-          <p:cNvCxnSpPr/>
-          <p:nvPr/>
-        </p:nvCxnSpPr>
-        <p:spPr>
-          <a:xfrm>
-            <a:off x="5934456" y="5065776"/>
-            <a:ext cx="0" cy="91440"/>
-          </a:xfrm>
-          <a:prstGeom prst="line">
-            <a:avLst/>
-          </a:prstGeom>
-          <a:ln w="19050">
-            <a:solidFill>
-              <a:srgbClr val="8A94A6"/>
-            </a:solidFill>
-            <a:tailEnd type="triangle" w="med" len="sm"/>
-          </a:ln>
-        </p:spPr>
-        <p:style>
-          <a:lnRef idx="2">
-            <a:schemeClr val="accent1"/>
-          </a:lnRef>
-          <a:fillRef idx="0">
-            <a:schemeClr val="accent1"/>
-          </a:fillRef>
-          <a:effectRef idx="1">
-            <a:schemeClr val="accent1"/>
-          </a:effectRef>
-          <a:fontRef idx="minor">
-            <a:schemeClr val="tx1"/>
-          </a:fontRef>
-        </p:style>
-      </p:cxnSp>
-      <p:cxnSp>
-        <p:nvCxnSpPr>
-          <p:cNvPr id="208" name="Connector 207"/>
-          <p:cNvCxnSpPr/>
-          <p:nvPr/>
-        </p:nvCxnSpPr>
-        <p:spPr>
-          <a:xfrm>
-            <a:off x="5934456" y="5577840"/>
-            <a:ext cx="0" cy="91440"/>
-          </a:xfrm>
-          <a:prstGeom prst="line">
-            <a:avLst/>
-          </a:prstGeom>
-          <a:ln w="19050">
-            <a:solidFill>
-              <a:srgbClr val="8A94A6"/>
-            </a:solidFill>
-            <a:tailEnd type="triangle" w="med" len="sm"/>
-          </a:ln>
-        </p:spPr>
-        <p:style>
-          <a:lnRef idx="2">
-            <a:schemeClr val="accent1"/>
-          </a:lnRef>
-          <a:fillRef idx="0">
-            <a:schemeClr val="accent1"/>
-          </a:fillRef>
-          <a:effectRef idx="1">
-            <a:schemeClr val="accent1"/>
-          </a:effectRef>
-          <a:fontRef idx="minor">
-            <a:schemeClr val="tx1"/>
-          </a:fontRef>
-        </p:style>
-      </p:cxnSp>
-      <p:sp>
-        <p:nvSpPr>
-          <p:cNvPr id="209" name="Rounded Rectangle 208"/>
-          <p:cNvSpPr/>
-          <p:nvPr/>
-        </p:nvSpPr>
-        <p:spPr>
-          <a:xfrm>
-            <a:off x="10040112" y="2130552"/>
-            <a:ext cx="384048" cy="2916936"/>
-          </a:xfrm>
-          <a:prstGeom prst="roundRect">
-            <a:avLst>
-              <a:gd name="adj" fmla="val 50000"/>
-            </a:avLst>
-          </a:prstGeom>
-          <a:solidFill>
-            <a:srgbClr val="138A36"/>
-          </a:solidFill>
-          <a:ln>
-            <a:noFill/>
-          </a:ln>
-          <a:effectLst/>
-        </p:spPr>
-        <p:style>
-          <a:lnRef idx="1">
-            <a:schemeClr val="accent1"/>
-          </a:lnRef>
-          <a:fillRef idx="3">
-            <a:schemeClr val="accent1"/>
-          </a:fillRef>
-          <a:effectRef idx="2">
-            <a:schemeClr val="accent1"/>
-          </a:effectRef>
-          <a:fontRef idx="minor">
-            <a:schemeClr val="lt1"/>
-          </a:fontRef>
-        </p:style>
-        <p:txBody>
-          <a:bodyPr rtlCol="0" anchor="ctr"/>
-          <a:lstStyle/>
-          <a:p>
-            <a:pPr algn="ctr"/>
-          </a:p>
-        </p:txBody>
-      </p:sp>
-      <p:sp>
-        <p:nvSpPr>
-          <p:cNvPr id="210" name="TextBox 209"/>
-          <p:cNvSpPr txBox="1"/>
-          <p:nvPr/>
-        </p:nvSpPr>
-        <p:spPr>
-          <a:xfrm rot="16200000">
-            <a:off x="8773668" y="3396996"/>
-            <a:ext cx="2916936" cy="384048"/>
-          </a:xfrm>
-          <a:prstGeom prst="rect">
-            <a:avLst/>
-          </a:prstGeom>
-          <a:noFill/>
-        </p:spPr>
-        <p:txBody>
-          <a:bodyPr wrap="none" anchor="ctr" lIns="0" rIns="0" tIns="0" bIns="0">
-            <a:spAutoFit/>
-          </a:bodyPr>
-          <a:lstStyle/>
-          <a:p>
-            <a:pPr algn="ctr"/>
-            <a:r>
-              <a:rPr sz="1050" b="1" i="0">
-                <a:solidFill>
-                  <a:srgbClr val="FFFFFF"/>
-                </a:solidFill>
-                <a:latin typeface="Calibri"/>
-              </a:rPr>
-              <a:t>FAST PATH  ·  most logs  ·  no AI</a:t>
-            </a:r>
-          </a:p>
-        </p:txBody>
-      </p:sp>
-      <p:cxnSp>
-        <p:nvCxnSpPr>
-          <p:cNvPr id="211" name="Connector 210"/>
-          <p:cNvCxnSpPr/>
-          <p:nvPr/>
-        </p:nvCxnSpPr>
-        <p:spPr>
-          <a:xfrm>
-            <a:off x="10232136" y="5047488"/>
-            <a:ext cx="0" cy="109728"/>
-          </a:xfrm>
-          <a:prstGeom prst="line">
-            <a:avLst/>
-          </a:prstGeom>
-          <a:ln w="25400">
-            <a:solidFill>
-              <a:srgbClr val="138A36"/>
-            </a:solidFill>
-            <a:tailEnd type="triangle" w="med" len="sm"/>
-          </a:ln>
-        </p:spPr>
-        <p:style>
-          <a:lnRef idx="2">
-            <a:schemeClr val="accent1"/>
-          </a:lnRef>
-          <a:fillRef idx="0">
-            <a:schemeClr val="accent1"/>
-          </a:fillRef>
-          <a:effectRef idx="1">
-            <a:schemeClr val="accent1"/>
-          </a:effectRef>
-          <a:fontRef idx="minor">
-            <a:schemeClr val="tx1"/>
-          </a:fontRef>
-        </p:style>
-      </p:cxnSp>
-      <p:cxnSp>
-        <p:nvCxnSpPr>
-          <p:cNvPr id="212" name="Connector 211"/>
-          <p:cNvCxnSpPr/>
-          <p:nvPr/>
-        </p:nvCxnSpPr>
-        <p:spPr>
-          <a:xfrm>
-            <a:off x="9765792" y="2295144"/>
-            <a:ext cx="274320" cy="0"/>
-          </a:xfrm>
-          <a:prstGeom prst="line">
-            <a:avLst/>
-          </a:prstGeom>
-          <a:ln w="22225">
-            <a:solidFill>
-              <a:srgbClr val="138A36"/>
-            </a:solidFill>
-            <a:tailEnd type="triangle" w="med" len="sm"/>
-          </a:ln>
-        </p:spPr>
-        <p:style>
-          <a:lnRef idx="2">
-            <a:schemeClr val="accent1"/>
-          </a:lnRef>
-          <a:fillRef idx="0">
-            <a:schemeClr val="accent1"/>
-          </a:fillRef>
-          <a:effectRef idx="1">
-            <a:schemeClr val="accent1"/>
-          </a:effectRef>
-          <a:fontRef idx="minor">
-            <a:schemeClr val="tx1"/>
-          </a:fontRef>
-        </p:style>
-      </p:cxnSp>
-      <p:sp>
-        <p:nvSpPr>
-          <p:cNvPr id="213" name="TextBox 212"/>
-          <p:cNvSpPr txBox="1"/>
-          <p:nvPr/>
-        </p:nvSpPr>
-        <p:spPr>
-          <a:xfrm>
-            <a:off x="9774936" y="2112264"/>
-            <a:ext cx="274320" cy="164592"/>
-          </a:xfrm>
-          <a:prstGeom prst="rect">
-            <a:avLst/>
-          </a:prstGeom>
-          <a:noFill/>
-        </p:spPr>
-        <p:txBody>
-          <a:bodyPr wrap="square" lIns="9144" rIns="9144" tIns="0" bIns="0" anchor="ctr">
-            <a:spAutoFit/>
-          </a:bodyPr>
-          <a:lstStyle/>
-          <a:p>
-            <a:pPr algn="l"/>
-            <a:r>
-              <a:rPr sz="750" b="1" i="0">
-                <a:solidFill>
-                  <a:srgbClr val="138A36"/>
-                </a:solidFill>
-                <a:latin typeface="Calibri"/>
-              </a:rPr>
-              <a:t>Yes</a:t>
-            </a:r>
-          </a:p>
-        </p:txBody>
-      </p:sp>
-      <p:cxnSp>
-        <p:nvCxnSpPr>
-          <p:cNvPr id="214" name="Connector 213"/>
-          <p:cNvCxnSpPr/>
-          <p:nvPr/>
-        </p:nvCxnSpPr>
-        <p:spPr>
-          <a:xfrm>
-            <a:off x="9765792" y="3319272"/>
-            <a:ext cx="274320" cy="0"/>
-          </a:xfrm>
-          <a:prstGeom prst="line">
-            <a:avLst/>
-          </a:prstGeom>
-          <a:ln w="22225">
-            <a:solidFill>
-              <a:srgbClr val="138A36"/>
-            </a:solidFill>
-            <a:tailEnd type="triangle" w="med" len="sm"/>
-          </a:ln>
-        </p:spPr>
-        <p:style>
-          <a:lnRef idx="2">
-            <a:schemeClr val="accent1"/>
-          </a:lnRef>
-          <a:fillRef idx="0">
-            <a:schemeClr val="accent1"/>
-          </a:fillRef>
-          <a:effectRef idx="1">
-            <a:schemeClr val="accent1"/>
-          </a:effectRef>
-          <a:fontRef idx="minor">
-            <a:schemeClr val="tx1"/>
-          </a:fontRef>
-        </p:style>
-      </p:cxnSp>
-      <p:sp>
-        <p:nvSpPr>
-          <p:cNvPr id="215" name="TextBox 214"/>
-          <p:cNvSpPr txBox="1"/>
-          <p:nvPr/>
-        </p:nvSpPr>
-        <p:spPr>
-          <a:xfrm>
-            <a:off x="9774936" y="3136392"/>
-            <a:ext cx="274320" cy="164592"/>
-          </a:xfrm>
-          <a:prstGeom prst="rect">
-            <a:avLst/>
-          </a:prstGeom>
-          <a:noFill/>
-        </p:spPr>
-        <p:txBody>
-          <a:bodyPr wrap="square" lIns="9144" rIns="9144" tIns="0" bIns="0" anchor="ctr">
-            <a:spAutoFit/>
-          </a:bodyPr>
-          <a:lstStyle/>
-          <a:p>
-            <a:pPr algn="l"/>
-            <a:r>
-              <a:rPr sz="750" b="1" i="0">
-                <a:solidFill>
-                  <a:srgbClr val="138A36"/>
-                </a:solidFill>
-                <a:latin typeface="Calibri"/>
-              </a:rPr>
-              <a:t>Yes</a:t>
-            </a:r>
-          </a:p>
-        </p:txBody>
-      </p:sp>
-      <p:sp>
-        <p:nvSpPr>
-          <p:cNvPr id="216" name="Rounded Rectangle 215"/>
-          <p:cNvSpPr/>
-          <p:nvPr/>
-        </p:nvSpPr>
-        <p:spPr>
-          <a:xfrm>
-            <a:off x="10515600" y="2084832"/>
-            <a:ext cx="1261872" cy="1444752"/>
-          </a:xfrm>
-          <a:prstGeom prst="roundRect">
-            <a:avLst>
-              <a:gd name="adj" fmla="val 10000"/>
-            </a:avLst>
-          </a:prstGeom>
-          <a:solidFill>
-            <a:srgbClr val="E8F5EC"/>
-          </a:solidFill>
-          <a:ln w="12700">
-            <a:solidFill>
-              <a:srgbClr val="138A36"/>
-            </a:solidFill>
-          </a:ln>
-          <a:effectLst/>
-        </p:spPr>
-        <p:style>
-          <a:lnRef idx="1">
-            <a:schemeClr val="accent1"/>
-          </a:lnRef>
-          <a:fillRef idx="3">
-            <a:schemeClr val="accent1"/>
-          </a:fillRef>
-          <a:effectRef idx="2">
-            <a:schemeClr val="accent1"/>
-          </a:effectRef>
-          <a:fontRef idx="minor">
-            <a:schemeClr val="lt1"/>
-          </a:fontRef>
-        </p:style>
-        <p:txBody>
-          <a:bodyPr rtlCol="0" anchor="ctr"/>
-          <a:lstStyle/>
-          <a:p>
-            <a:pPr algn="ctr"/>
-          </a:p>
-        </p:txBody>
-      </p:sp>
-      <p:sp>
-        <p:nvSpPr>
-          <p:cNvPr id="217" name="TextBox 216"/>
-          <p:cNvSpPr txBox="1"/>
-          <p:nvPr/>
-        </p:nvSpPr>
-        <p:spPr>
-          <a:xfrm>
-            <a:off x="10552176" y="2084832"/>
-            <a:ext cx="1188720" cy="1444752"/>
-          </a:xfrm>
-          <a:prstGeom prst="rect">
-            <a:avLst/>
-          </a:prstGeom>
-          <a:noFill/>
-        </p:spPr>
-        <p:txBody>
-          <a:bodyPr wrap="square" lIns="27432" rIns="27432" tIns="0" bIns="0" anchor="ctr">
-            <a:spAutoFit/>
-          </a:bodyPr>
-          <a:lstStyle/>
-          <a:p>
-            <a:pPr algn="ctr"/>
-            <a:r>
-              <a:rPr sz="1000" b="1" i="0">
-                <a:solidFill>
-                  <a:srgbClr val="138A36"/>
-                </a:solidFill>
-                <a:latin typeface="Calibri"/>
-              </a:rPr>
-              <a:t>Known log?</a:t>
-            </a:r>
-          </a:p>
-          <a:p>
-            <a:pPr algn="ctr"/>
-            <a:r>
-              <a:rPr sz="800" b="0" i="0">
-                <a:solidFill>
-                  <a:srgbClr val="2B3340"/>
-                </a:solidFill>
-                <a:latin typeface="Calibri"/>
-              </a:rPr>
-              <a:t>Goes 1 → 2 (or 4)</a:t>
-            </a:r>
-          </a:p>
-          <a:p>
-            <a:pPr algn="ctr"/>
-            <a:r>
-              <a:rPr sz="800" b="0" i="0">
-                <a:solidFill>
-                  <a:srgbClr val="2B3340"/>
-                </a:solidFill>
-                <a:latin typeface="Calibri"/>
-              </a:rPr>
-              <a:t>→ 7 → 8</a:t>
-            </a:r>
-          </a:p>
-          <a:p>
-            <a:pPr algn="ctr"/>
-            <a:r>
-              <a:rPr sz="800" b="0" i="0">
-                <a:solidFill>
-                  <a:srgbClr val="2B3340"/>
-                </a:solidFill>
-                <a:latin typeface="Calibri"/>
-              </a:rPr>
-              <a:t>instant, no AI cost</a:t>
-            </a:r>
-          </a:p>
-        </p:txBody>
-      </p:sp>
-      <p:sp>
-        <p:nvSpPr>
-          <p:cNvPr id="218" name="Rounded Rectangle 217"/>
-          <p:cNvSpPr/>
-          <p:nvPr/>
-        </p:nvSpPr>
-        <p:spPr>
-          <a:xfrm>
-            <a:off x="10515600" y="3712464"/>
-            <a:ext cx="1261872" cy="1335024"/>
-          </a:xfrm>
-          <a:prstGeom prst="roundRect">
-            <a:avLst>
-              <a:gd name="adj" fmla="val 10000"/>
-            </a:avLst>
-          </a:prstGeom>
-          <a:solidFill>
-            <a:srgbClr val="FFF6EC"/>
-          </a:solidFill>
-          <a:ln w="12700">
-            <a:solidFill>
-              <a:srgbClr val="F28322"/>
-            </a:solidFill>
-          </a:ln>
-          <a:effectLst/>
-        </p:spPr>
-        <p:style>
-          <a:lnRef idx="1">
-            <a:schemeClr val="accent1"/>
-          </a:lnRef>
-          <a:fillRef idx="3">
-            <a:schemeClr val="accent1"/>
-          </a:fillRef>
-          <a:effectRef idx="2">
-            <a:schemeClr val="accent1"/>
-          </a:effectRef>
-          <a:fontRef idx="minor">
-            <a:schemeClr val="lt1"/>
-          </a:fontRef>
-        </p:style>
-        <p:txBody>
-          <a:bodyPr rtlCol="0" anchor="ctr"/>
-          <a:lstStyle/>
-          <a:p>
-            <a:pPr algn="ctr"/>
-          </a:p>
-        </p:txBody>
-      </p:sp>
-      <p:sp>
-        <p:nvSpPr>
-          <p:cNvPr id="219" name="TextBox 218"/>
-          <p:cNvSpPr txBox="1"/>
-          <p:nvPr/>
-        </p:nvSpPr>
-        <p:spPr>
-          <a:xfrm>
-            <a:off x="10552176" y="3712464"/>
-            <a:ext cx="1188720" cy="1335024"/>
-          </a:xfrm>
-          <a:prstGeom prst="rect">
-            <a:avLst/>
-          </a:prstGeom>
-          <a:noFill/>
-        </p:spPr>
-        <p:txBody>
-          <a:bodyPr wrap="square" lIns="27432" rIns="27432" tIns="0" bIns="0" anchor="ctr">
-            <a:spAutoFit/>
-          </a:bodyPr>
-          <a:lstStyle/>
-          <a:p>
-            <a:pPr algn="ctr"/>
-            <a:r>
-              <a:rPr sz="1000" b="1" i="0">
-                <a:solidFill>
-                  <a:srgbClr val="C06010"/>
-                </a:solidFill>
-                <a:latin typeface="Calibri"/>
-              </a:rPr>
-              <a:t>New format?</a:t>
-            </a:r>
-          </a:p>
-          <a:p>
-            <a:pPr algn="ctr"/>
-            <a:r>
-              <a:rPr sz="800" b="0" i="0">
-                <a:solidFill>
-                  <a:srgbClr val="2B3340"/>
-                </a:solidFill>
-                <a:latin typeface="Calibri"/>
-              </a:rPr>
-              <a:t>Goes through 5 → 6</a:t>
-            </a:r>
-          </a:p>
-          <a:p>
-            <a:pPr algn="ctr"/>
-            <a:r>
-              <a:rPr sz="800" b="0" i="0">
-                <a:solidFill>
-                  <a:srgbClr val="2B3340"/>
-                </a:solidFill>
-                <a:latin typeface="Calibri"/>
-              </a:rPr>
-              <a:t>AI used once, then</a:t>
-            </a:r>
-          </a:p>
-          <a:p>
-            <a:pPr algn="ctr"/>
-            <a:r>
-              <a:rPr sz="800" b="0" i="0">
-                <a:solidFill>
-                  <a:srgbClr val="2B3340"/>
-                </a:solidFill>
-                <a:latin typeface="Calibri"/>
-              </a:rPr>
-              <a:t>it joins the fast path</a:t>
-            </a:r>
-          </a:p>
-          <a:p>
-            <a:pPr algn="ctr"/>
-            <a:r>
-              <a:rPr sz="800" b="0" i="0">
-                <a:solidFill>
-                  <a:srgbClr val="2B3340"/>
-                </a:solidFill>
-                <a:latin typeface="Calibri"/>
-              </a:rPr>
-              <a:t>AI down? backup AI,</a:t>
-            </a:r>
-          </a:p>
-          <a:p>
-            <a:pPr algn="ctr"/>
-            <a:r>
-              <a:rPr sz="800" b="0" i="0">
-                <a:solidFill>
-                  <a:srgbClr val="2B3340"/>
-                </a:solidFill>
-                <a:latin typeface="Calibri"/>
-              </a:rPr>
-              <a:t>then built-in rules</a:t>
-            </a:r>
-          </a:p>
-        </p:txBody>
-      </p:sp>
     </p:spTree>
   </p:cSld>
   <p:clrMapOvr>

</xml_diff>

<commit_message>
PPT: slide 6 references redesigned with clickable government, research and tool links
Co-authored-by: arena-agent <297053741+arena-agent@users.noreply.github.com>
</commit_message>
<xml_diff>
--- a/presentation/SIH2026_Idea_Submission.pptx
+++ b/presentation/SIH2026_Idea_Submission.pptx
@@ -22003,18 +22003,679 @@
       </p:sp>
       <p:sp>
         <p:nvSpPr>
-          <p:cNvPr id="10" name="Rounded Rectangle 9"/>
+          <p:cNvPr id="22" name="Rounded Rectangle 21"/>
           <p:cNvSpPr/>
           <p:nvPr/>
         </p:nvSpPr>
         <p:spPr>
           <a:xfrm>
-            <a:off x="365760" y="1097280"/>
-            <a:ext cx="7315200" cy="1783080"/>
+            <a:off x="7909560" y="1097280"/>
+            <a:ext cx="3959352" cy="5248656"/>
           </a:xfrm>
           <a:prstGeom prst="roundRect">
             <a:avLst>
               <a:gd name="adj" fmla="val 5000"/>
+            </a:avLst>
+          </a:prstGeom>
+          <a:solidFill>
+            <a:srgbClr val="0B2A5B"/>
+          </a:solidFill>
+          <a:ln>
+            <a:noFill/>
+          </a:ln>
+          <a:effectLst/>
+        </p:spPr>
+        <p:style>
+          <a:lnRef idx="1">
+            <a:schemeClr val="accent1"/>
+          </a:lnRef>
+          <a:fillRef idx="3">
+            <a:schemeClr val="accent1"/>
+          </a:fillRef>
+          <a:effectRef idx="2">
+            <a:schemeClr val="accent1"/>
+          </a:effectRef>
+          <a:fontRef idx="minor">
+            <a:schemeClr val="lt1"/>
+          </a:fontRef>
+        </p:style>
+        <p:txBody>
+          <a:bodyPr rtlCol="0" anchor="ctr"/>
+          <a:lstStyle/>
+          <a:p>
+            <a:pPr algn="ctr"/>
+          </a:p>
+        </p:txBody>
+      </p:sp>
+      <p:sp>
+        <p:nvSpPr>
+          <p:cNvPr id="23" name="TextBox 22"/>
+          <p:cNvSpPr txBox="1"/>
+          <p:nvPr/>
+        </p:nvSpPr>
+        <p:spPr>
+          <a:xfrm>
+            <a:off x="7909560" y="1234440"/>
+            <a:ext cx="3959352" cy="365760"/>
+          </a:xfrm>
+          <a:prstGeom prst="rect">
+            <a:avLst/>
+          </a:prstGeom>
+          <a:noFill/>
+        </p:spPr>
+        <p:txBody>
+          <a:bodyPr wrap="square" anchor="t" lIns="36576" rIns="36576" tIns="18288" bIns="18288">
+            <a:spAutoFit/>
+          </a:bodyPr>
+          <a:lstStyle/>
+          <a:p>
+            <a:pPr algn="ctr">
+              <a:spcAft>
+                <a:spcPts val="0"/>
+              </a:spcAft>
+            </a:pPr>
+            <a:r>
+              <a:rPr sz="1400" b="1">
+                <a:solidFill>
+                  <a:srgbClr val="F58220"/>
+                </a:solidFill>
+                <a:latin typeface="Calibri"/>
+              </a:rPr>
+              <a:t>SCAN TO EXPLORE</a:t>
+            </a:r>
+          </a:p>
+        </p:txBody>
+      </p:sp>
+      <p:sp>
+        <p:nvSpPr>
+          <p:cNvPr id="24" name="Rounded Rectangle 23"/>
+          <p:cNvSpPr/>
+          <p:nvPr/>
+        </p:nvSpPr>
+        <p:spPr>
+          <a:xfrm>
+            <a:off x="8092440" y="1737360"/>
+            <a:ext cx="1691640" cy="1691640"/>
+          </a:xfrm>
+          <a:prstGeom prst="roundRect">
+            <a:avLst>
+              <a:gd name="adj" fmla="val 6000"/>
+            </a:avLst>
+          </a:prstGeom>
+          <a:solidFill>
+            <a:srgbClr val="FFFFFF"/>
+          </a:solidFill>
+          <a:ln>
+            <a:noFill/>
+          </a:ln>
+          <a:effectLst/>
+        </p:spPr>
+        <p:style>
+          <a:lnRef idx="1">
+            <a:schemeClr val="accent1"/>
+          </a:lnRef>
+          <a:fillRef idx="3">
+            <a:schemeClr val="accent1"/>
+          </a:fillRef>
+          <a:effectRef idx="2">
+            <a:schemeClr val="accent1"/>
+          </a:effectRef>
+          <a:fontRef idx="minor">
+            <a:schemeClr val="lt1"/>
+          </a:fontRef>
+        </p:style>
+        <p:txBody>
+          <a:bodyPr rtlCol="0" anchor="ctr"/>
+          <a:lstStyle/>
+          <a:p>
+            <a:pPr algn="ctr"/>
+          </a:p>
+        </p:txBody>
+      </p:sp>
+      <p:pic>
+        <p:nvPicPr>
+          <p:cNvPr id="25" name="Picture 24" descr="image.png"/>
+          <p:cNvPicPr>
+            <a:picLocks noChangeAspect="1"/>
+          </p:cNvPicPr>
+          <p:nvPr/>
+        </p:nvPicPr>
+        <p:blipFill>
+          <a:blip r:embed="rId5"/>
+          <a:stretch>
+            <a:fillRect/>
+          </a:stretch>
+        </p:blipFill>
+        <p:spPr>
+          <a:xfrm>
+            <a:off x="8183879" y="1828800"/>
+            <a:ext cx="1508760" cy="1508760"/>
+          </a:xfrm>
+          <a:prstGeom prst="rect">
+            <a:avLst/>
+          </a:prstGeom>
+        </p:spPr>
+      </p:pic>
+      <p:sp>
+        <p:nvSpPr>
+          <p:cNvPr id="26" name="TextBox 25"/>
+          <p:cNvSpPr txBox="1"/>
+          <p:nvPr/>
+        </p:nvSpPr>
+        <p:spPr>
+          <a:xfrm>
+            <a:off x="8046719" y="3520440"/>
+            <a:ext cx="1783080" cy="274320"/>
+          </a:xfrm>
+          <a:prstGeom prst="rect">
+            <a:avLst/>
+          </a:prstGeom>
+          <a:noFill/>
+        </p:spPr>
+        <p:txBody>
+          <a:bodyPr wrap="square" anchor="t" lIns="36576" rIns="36576" tIns="18288" bIns="18288">
+            <a:spAutoFit/>
+          </a:bodyPr>
+          <a:lstStyle/>
+          <a:p>
+            <a:pPr algn="ctr">
+              <a:spcAft>
+                <a:spcPts val="0"/>
+              </a:spcAft>
+            </a:pPr>
+            <a:r>
+              <a:rPr sz="1200" b="1">
+                <a:solidFill>
+                  <a:srgbClr val="F58220"/>
+                </a:solidFill>
+                <a:latin typeface="Calibri"/>
+              </a:rPr>
+              <a:t>PROTOTYPE</a:t>
+            </a:r>
+          </a:p>
+        </p:txBody>
+      </p:sp>
+      <p:sp>
+        <p:nvSpPr>
+          <p:cNvPr id="27" name="TextBox 26"/>
+          <p:cNvSpPr txBox="1"/>
+          <p:nvPr/>
+        </p:nvSpPr>
+        <p:spPr>
+          <a:xfrm>
+            <a:off x="8001000" y="3794760"/>
+            <a:ext cx="1874519" cy="457200"/>
+          </a:xfrm>
+          <a:prstGeom prst="rect">
+            <a:avLst/>
+          </a:prstGeom>
+          <a:noFill/>
+        </p:spPr>
+        <p:txBody>
+          <a:bodyPr wrap="square" anchor="t" lIns="36576" rIns="36576" tIns="18288" bIns="18288">
+            <a:spAutoFit/>
+          </a:bodyPr>
+          <a:lstStyle/>
+          <a:p>
+            <a:pPr algn="ctr">
+              <a:spcAft>
+                <a:spcPts val="0"/>
+              </a:spcAft>
+            </a:pPr>
+            <a:r>
+              <a:rPr sz="950" b="0">
+                <a:solidFill>
+                  <a:srgbClr val="1E2530"/>
+                </a:solidFill>
+                <a:latin typeface="Calibri"/>
+                <a:hlinkClick r:id="rId7"/>
+              </a:rPr>
+              <a:t/>
+            </a:r>
+            <a:r>
+              <a:rPr sz="900" b="1">
+                <a:solidFill>
+                  <a:srgbClr val="FFFFFF"/>
+                </a:solidFill>
+                <a:latin typeface="Calibri"/>
+                <a:hlinkClick r:id="rId7"/>
+              </a:rPr>
+              <a:t>sih2026-w6sr.vercel.app</a:t>
+            </a:r>
+          </a:p>
+        </p:txBody>
+      </p:sp>
+      <p:sp>
+        <p:nvSpPr>
+          <p:cNvPr id="28" name="Rounded Rectangle 27"/>
+          <p:cNvSpPr/>
+          <p:nvPr/>
+        </p:nvSpPr>
+        <p:spPr>
+          <a:xfrm>
+            <a:off x="9994392" y="1737360"/>
+            <a:ext cx="1691640" cy="1691640"/>
+          </a:xfrm>
+          <a:prstGeom prst="roundRect">
+            <a:avLst>
+              <a:gd name="adj" fmla="val 6000"/>
+            </a:avLst>
+          </a:prstGeom>
+          <a:solidFill>
+            <a:srgbClr val="FFFFFF"/>
+          </a:solidFill>
+          <a:ln>
+            <a:noFill/>
+          </a:ln>
+          <a:effectLst/>
+        </p:spPr>
+        <p:style>
+          <a:lnRef idx="1">
+            <a:schemeClr val="accent1"/>
+          </a:lnRef>
+          <a:fillRef idx="3">
+            <a:schemeClr val="accent1"/>
+          </a:fillRef>
+          <a:effectRef idx="2">
+            <a:schemeClr val="accent1"/>
+          </a:effectRef>
+          <a:fontRef idx="minor">
+            <a:schemeClr val="lt1"/>
+          </a:fontRef>
+        </p:style>
+        <p:txBody>
+          <a:bodyPr rtlCol="0" anchor="ctr"/>
+          <a:lstStyle/>
+          <a:p>
+            <a:pPr algn="ctr"/>
+          </a:p>
+        </p:txBody>
+      </p:sp>
+      <p:pic>
+        <p:nvPicPr>
+          <p:cNvPr id="29" name="Picture 28" descr="image.png"/>
+          <p:cNvPicPr>
+            <a:picLocks noChangeAspect="1"/>
+          </p:cNvPicPr>
+          <p:nvPr/>
+        </p:nvPicPr>
+        <p:blipFill>
+          <a:blip r:embed="rId6"/>
+          <a:stretch>
+            <a:fillRect/>
+          </a:stretch>
+        </p:blipFill>
+        <p:spPr>
+          <a:xfrm>
+            <a:off x="10085832" y="1828800"/>
+            <a:ext cx="1508760" cy="1508760"/>
+          </a:xfrm>
+          <a:prstGeom prst="rect">
+            <a:avLst/>
+          </a:prstGeom>
+        </p:spPr>
+      </p:pic>
+      <p:sp>
+        <p:nvSpPr>
+          <p:cNvPr id="30" name="TextBox 29"/>
+          <p:cNvSpPr txBox="1"/>
+          <p:nvPr/>
+        </p:nvSpPr>
+        <p:spPr>
+          <a:xfrm>
+            <a:off x="9948672" y="3520440"/>
+            <a:ext cx="1783080" cy="274320"/>
+          </a:xfrm>
+          <a:prstGeom prst="rect">
+            <a:avLst/>
+          </a:prstGeom>
+          <a:noFill/>
+        </p:spPr>
+        <p:txBody>
+          <a:bodyPr wrap="square" anchor="t" lIns="36576" rIns="36576" tIns="18288" bIns="18288">
+            <a:spAutoFit/>
+          </a:bodyPr>
+          <a:lstStyle/>
+          <a:p>
+            <a:pPr algn="ctr">
+              <a:spcAft>
+                <a:spcPts val="0"/>
+              </a:spcAft>
+            </a:pPr>
+            <a:r>
+              <a:rPr sz="1200" b="1">
+                <a:solidFill>
+                  <a:srgbClr val="F58220"/>
+                </a:solidFill>
+                <a:latin typeface="Calibri"/>
+              </a:rPr>
+              <a:t>SOURCE CODE</a:t>
+            </a:r>
+          </a:p>
+        </p:txBody>
+      </p:sp>
+      <p:sp>
+        <p:nvSpPr>
+          <p:cNvPr id="31" name="TextBox 30"/>
+          <p:cNvSpPr txBox="1"/>
+          <p:nvPr/>
+        </p:nvSpPr>
+        <p:spPr>
+          <a:xfrm>
+            <a:off x="9811512" y="3794760"/>
+            <a:ext cx="2057400" cy="457200"/>
+          </a:xfrm>
+          <a:prstGeom prst="rect">
+            <a:avLst/>
+          </a:prstGeom>
+          <a:noFill/>
+        </p:spPr>
+        <p:txBody>
+          <a:bodyPr wrap="square" anchor="t" lIns="36576" rIns="36576" tIns="18288" bIns="18288">
+            <a:spAutoFit/>
+          </a:bodyPr>
+          <a:lstStyle/>
+          <a:p>
+            <a:pPr algn="ctr">
+              <a:spcAft>
+                <a:spcPts val="0"/>
+              </a:spcAft>
+            </a:pPr>
+            <a:r>
+              <a:rPr sz="950" b="0">
+                <a:solidFill>
+                  <a:srgbClr val="1E2530"/>
+                </a:solidFill>
+                <a:latin typeface="Calibri"/>
+                <a:hlinkClick r:id="rId8"/>
+              </a:rPr>
+              <a:t/>
+            </a:r>
+            <a:r>
+              <a:rPr sz="900" b="1">
+                <a:solidFill>
+                  <a:srgbClr val="FFFFFF"/>
+                </a:solidFill>
+                <a:latin typeface="Calibri"/>
+                <a:hlinkClick r:id="rId8"/>
+              </a:rPr>
+              <a:t>github.com/agrwl-utkarsh/sih2026</a:t>
+            </a:r>
+          </a:p>
+        </p:txBody>
+      </p:sp>
+      <p:sp>
+        <p:nvSpPr>
+          <p:cNvPr id="32" name="Rectangle 31"/>
+          <p:cNvSpPr/>
+          <p:nvPr/>
+        </p:nvSpPr>
+        <p:spPr>
+          <a:xfrm>
+            <a:off x="8275320" y="4526280"/>
+            <a:ext cx="3227832" cy="27432"/>
+          </a:xfrm>
+          <a:prstGeom prst="rect">
+            <a:avLst/>
+          </a:prstGeom>
+          <a:solidFill>
+            <a:srgbClr val="3A5585"/>
+          </a:solidFill>
+          <a:ln>
+            <a:noFill/>
+          </a:ln>
+          <a:effectLst/>
+        </p:spPr>
+        <p:style>
+          <a:lnRef idx="1">
+            <a:schemeClr val="accent1"/>
+          </a:lnRef>
+          <a:fillRef idx="3">
+            <a:schemeClr val="accent1"/>
+          </a:fillRef>
+          <a:effectRef idx="2">
+            <a:schemeClr val="accent1"/>
+          </a:effectRef>
+          <a:fontRef idx="minor">
+            <a:schemeClr val="lt1"/>
+          </a:fontRef>
+        </p:style>
+        <p:txBody>
+          <a:bodyPr rtlCol="0" anchor="ctr"/>
+          <a:lstStyle/>
+          <a:p>
+            <a:pPr algn="ctr"/>
+          </a:p>
+        </p:txBody>
+      </p:sp>
+      <p:sp>
+        <p:nvSpPr>
+          <p:cNvPr id="33" name="TextBox 32"/>
+          <p:cNvSpPr txBox="1"/>
+          <p:nvPr/>
+        </p:nvSpPr>
+        <p:spPr>
+          <a:xfrm>
+            <a:off x="7909560" y="4754880"/>
+            <a:ext cx="3959352" cy="731520"/>
+          </a:xfrm>
+          <a:prstGeom prst="rect">
+            <a:avLst/>
+          </a:prstGeom>
+          <a:noFill/>
+        </p:spPr>
+        <p:txBody>
+          <a:bodyPr wrap="square" anchor="t" lIns="36576" rIns="36576" tIns="18288" bIns="18288">
+            <a:spAutoFit/>
+          </a:bodyPr>
+          <a:lstStyle/>
+          <a:p>
+            <a:pPr algn="ctr">
+              <a:spcAft>
+                <a:spcPts val="0"/>
+              </a:spcAft>
+            </a:pPr>
+            <a:r>
+              <a:rPr sz="3000" b="1">
+                <a:solidFill>
+                  <a:srgbClr val="FFFFFF"/>
+                </a:solidFill>
+                <a:latin typeface="Calibri"/>
+              </a:rPr>
+              <a:t>Thank you!</a:t>
+            </a:r>
+          </a:p>
+        </p:txBody>
+      </p:sp>
+      <p:sp>
+        <p:nvSpPr>
+          <p:cNvPr id="34" name="TextBox 33"/>
+          <p:cNvSpPr txBox="1"/>
+          <p:nvPr/>
+        </p:nvSpPr>
+        <p:spPr>
+          <a:xfrm>
+            <a:off x="7909560" y="5486400"/>
+            <a:ext cx="3959352" cy="640080"/>
+          </a:xfrm>
+          <a:prstGeom prst="rect">
+            <a:avLst/>
+          </a:prstGeom>
+          <a:noFill/>
+        </p:spPr>
+        <p:txBody>
+          <a:bodyPr wrap="square" anchor="t" lIns="36576" rIns="36576" tIns="18288" bIns="18288">
+            <a:spAutoFit/>
+          </a:bodyPr>
+          <a:lstStyle/>
+          <a:p>
+            <a:pPr algn="ctr">
+              <a:spcAft>
+                <a:spcPts val="0"/>
+              </a:spcAft>
+            </a:pPr>
+            <a:r>
+              <a:rPr sz="1300" b="0">
+                <a:solidFill>
+                  <a:srgbClr val="C9D6EA"/>
+                </a:solidFill>
+                <a:latin typeface="Calibri"/>
+              </a:rPr>
+              <a:t>Questions are welcome.</a:t>
+            </a:r>
+          </a:p>
+        </p:txBody>
+      </p:sp>
+      <p:sp>
+        <p:nvSpPr>
+          <p:cNvPr id="35" name="Oval 34"/>
+          <p:cNvSpPr/>
+          <p:nvPr/>
+        </p:nvSpPr>
+        <p:spPr>
+          <a:xfrm>
+            <a:off x="320040" y="182880"/>
+            <a:ext cx="1463040" cy="731520"/>
+          </a:xfrm>
+          <a:prstGeom prst="ellipse">
+            <a:avLst/>
+          </a:prstGeom>
+          <a:noFill/>
+          <a:ln w="25400">
+            <a:solidFill>
+              <a:srgbClr val="8064A2"/>
+            </a:solidFill>
+          </a:ln>
+          <a:effectLst/>
+        </p:spPr>
+        <p:style>
+          <a:lnRef idx="1">
+            <a:schemeClr val="accent1"/>
+          </a:lnRef>
+          <a:fillRef idx="3">
+            <a:schemeClr val="accent1"/>
+          </a:fillRef>
+          <a:effectRef idx="2">
+            <a:schemeClr val="accent1"/>
+          </a:effectRef>
+          <a:fontRef idx="minor">
+            <a:schemeClr val="lt1"/>
+          </a:fontRef>
+        </p:style>
+        <p:txBody>
+          <a:bodyPr rtlCol="0" anchor="ctr" wrap="square" lIns="45720" rIns="45720" tIns="18288" bIns="18288"/>
+          <a:lstStyle/>
+          <a:p>
+            <a:pPr algn="ctr"/>
+            <a:r>
+              <a:rPr sz="1200" b="1">
+                <a:solidFill>
+                  <a:srgbClr val="F58220"/>
+                </a:solidFill>
+                <a:latin typeface="Calibri"/>
+              </a:rPr>
+              <a:t>[Team Name]</a:t>
+            </a:r>
+          </a:p>
+        </p:txBody>
+      </p:sp>
+      <p:pic>
+        <p:nvPicPr>
+          <p:cNvPr id="36" name="Picture 35" descr="sih_icon_s.png"/>
+          <p:cNvPicPr>
+            <a:picLocks noChangeAspect="1"/>
+          </p:cNvPicPr>
+          <p:nvPr/>
+        </p:nvPicPr>
+        <p:blipFill>
+          <a:blip r:embed="rId10"/>
+          <a:stretch>
+            <a:fillRect/>
+          </a:stretch>
+        </p:blipFill>
+        <p:spPr>
+          <a:xfrm>
+            <a:off x="10076688" y="91440"/>
+            <a:ext cx="676894" cy="822960"/>
+          </a:xfrm>
+          <a:prstGeom prst="rect">
+            <a:avLst/>
+          </a:prstGeom>
+        </p:spPr>
+      </p:pic>
+      <p:sp>
+        <p:nvSpPr>
+          <p:cNvPr id="37" name="TextBox 36"/>
+          <p:cNvSpPr txBox="1"/>
+          <p:nvPr/>
+        </p:nvSpPr>
+        <p:spPr>
+          <a:xfrm>
+            <a:off x="10789920" y="109728"/>
+            <a:ext cx="1371600" cy="777240"/>
+          </a:xfrm>
+          <a:prstGeom prst="rect">
+            <a:avLst/>
+          </a:prstGeom>
+          <a:noFill/>
+        </p:spPr>
+        <p:txBody>
+          <a:bodyPr wrap="square" lIns="36576" rIns="36576" tIns="18288" bIns="18288" anchor="t">
+            <a:spAutoFit/>
+          </a:bodyPr>
+          <a:lstStyle/>
+          <a:p>
+            <a:pPr algn="ctr"/>
+            <a:r>
+              <a:rPr sz="1250" b="1">
+                <a:solidFill>
+                  <a:srgbClr val="455A64"/>
+                </a:solidFill>
+                <a:latin typeface="Calibri"/>
+              </a:rPr>
+              <a:t>SMART INDIA</a:t>
+            </a:r>
+          </a:p>
+          <a:p>
+            <a:pPr algn="ctr"/>
+            <a:r>
+              <a:rPr sz="1250" b="1">
+                <a:solidFill>
+                  <a:srgbClr val="455A64"/>
+                </a:solidFill>
+                <a:latin typeface="Calibri"/>
+              </a:rPr>
+              <a:t>HACKATHON</a:t>
+            </a:r>
+          </a:p>
+          <a:p>
+            <a:pPr algn="ctr"/>
+            <a:r>
+              <a:rPr sz="1250" b="1">
+                <a:solidFill>
+                  <a:srgbClr val="455A64"/>
+                </a:solidFill>
+                <a:latin typeface="Calibri"/>
+              </a:rPr>
+              <a:t>2026</a:t>
+            </a:r>
+          </a:p>
+        </p:txBody>
+      </p:sp>
+      <p:sp>
+        <p:nvSpPr>
+          <p:cNvPr id="39" name="Rounded Rectangle 38"/>
+          <p:cNvSpPr/>
+          <p:nvPr/>
+        </p:nvSpPr>
+        <p:spPr>
+          <a:xfrm>
+            <a:off x="365760" y="1097280"/>
+            <a:ext cx="7315200" cy="2148840"/>
+          </a:xfrm>
+          <a:prstGeom prst="roundRect">
+            <a:avLst>
+              <a:gd name="adj" fmla="val 4000"/>
             </a:avLst>
           </a:prstGeom>
           <a:solidFill>
@@ -22022,7 +22683,7 @@
           </a:solidFill>
           <a:ln w="12700">
             <a:solidFill>
-              <a:srgbClr val="D3DBE8"/>
+              <a:srgbClr val="D5DCE6"/>
             </a:solidFill>
           </a:ln>
           <a:effectLst/>
@@ -22051,17 +22712,633 @@
       </p:sp>
       <p:sp>
         <p:nvSpPr>
-          <p:cNvPr id="11" name="Rectangle 10"/>
+          <p:cNvPr id="40" name="Rounded Rectangle 39"/>
           <p:cNvSpPr/>
           <p:nvPr/>
         </p:nvSpPr>
         <p:spPr>
           <a:xfrm>
-            <a:off x="365760" y="1207007"/>
-            <a:ext cx="73152" cy="1563624"/>
-          </a:xfrm>
-          <a:prstGeom prst="rect">
-            <a:avLst/>
+            <a:off x="365760" y="1097280"/>
+            <a:ext cx="7315200" cy="384048"/>
+          </a:xfrm>
+          <a:prstGeom prst="roundRect">
+            <a:avLst>
+              <a:gd name="adj" fmla="val 18000"/>
+            </a:avLst>
+          </a:prstGeom>
+          <a:solidFill>
+            <a:srgbClr val="0B2A5B"/>
+          </a:solidFill>
+          <a:ln>
+            <a:noFill/>
+          </a:ln>
+          <a:effectLst/>
+        </p:spPr>
+        <p:style>
+          <a:lnRef idx="1">
+            <a:schemeClr val="accent1"/>
+          </a:lnRef>
+          <a:fillRef idx="3">
+            <a:schemeClr val="accent1"/>
+          </a:fillRef>
+          <a:effectRef idx="2">
+            <a:schemeClr val="accent1"/>
+          </a:effectRef>
+          <a:fontRef idx="minor">
+            <a:schemeClr val="lt1"/>
+          </a:fontRef>
+        </p:style>
+        <p:txBody>
+          <a:bodyPr rtlCol="0" anchor="ctr"/>
+          <a:lstStyle/>
+          <a:p>
+            <a:pPr algn="ctr"/>
+          </a:p>
+        </p:txBody>
+      </p:sp>
+      <p:sp>
+        <p:nvSpPr>
+          <p:cNvPr id="41" name="TextBox 40"/>
+          <p:cNvSpPr txBox="1"/>
+          <p:nvPr/>
+        </p:nvSpPr>
+        <p:spPr>
+          <a:xfrm>
+            <a:off x="530352" y="1097280"/>
+            <a:ext cx="7040880" cy="384048"/>
+          </a:xfrm>
+          <a:prstGeom prst="rect">
+            <a:avLst/>
+          </a:prstGeom>
+          <a:noFill/>
+        </p:spPr>
+        <p:txBody>
+          <a:bodyPr wrap="square" lIns="36576" rIns="36576" tIns="9144" bIns="9144" anchor="ctr">
+            <a:spAutoFit/>
+          </a:bodyPr>
+          <a:lstStyle/>
+          <a:p>
+            <a:r>
+              <a:rPr sz="1350" b="1">
+                <a:solidFill>
+                  <a:srgbClr val="FFFFFF"/>
+                </a:solidFill>
+                <a:latin typeface="Calibri"/>
+              </a:rPr>
+              <a:t>GOVERNMENT OF INDIA</a:t>
+            </a:r>
+          </a:p>
+        </p:txBody>
+      </p:sp>
+      <p:sp>
+        <p:nvSpPr>
+          <p:cNvPr id="42" name="TextBox 41"/>
+          <p:cNvSpPr txBox="1"/>
+          <p:nvPr/>
+        </p:nvSpPr>
+        <p:spPr>
+          <a:xfrm>
+            <a:off x="530352" y="1645920"/>
+            <a:ext cx="3447288" cy="1554480"/>
+          </a:xfrm>
+          <a:prstGeom prst="rect">
+            <a:avLst/>
+          </a:prstGeom>
+          <a:noFill/>
+        </p:spPr>
+        <p:txBody>
+          <a:bodyPr wrap="square" lIns="36576" rIns="36576" tIns="9144" bIns="9144" anchor="t">
+            <a:spAutoFit/>
+          </a:bodyPr>
+          <a:lstStyle/>
+          <a:p>
+            <a:pPr>
+              <a:spcAft>
+                <a:spcPts val="0"/>
+              </a:spcAft>
+            </a:pPr>
+            <a:r>
+              <a:rPr sz="1050" b="1">
+                <a:solidFill>
+                  <a:srgbClr val="0B2A5B"/>
+                </a:solidFill>
+                <a:latin typeface="Calibri"/>
+              </a:rPr>
+              <a:t>▸ </a:t>
+            </a:r>
+            <a:r>
+              <a:rPr sz="1150" b="1">
+                <a:solidFill>
+                  <a:srgbClr val="0B2A5B"/>
+                </a:solidFill>
+                <a:latin typeface="Calibri"/>
+              </a:rPr>
+              <a:t>CERT-In Cyber Security Directions, 2022</a:t>
+            </a:r>
+          </a:p>
+          <a:p>
+            <a:pPr>
+              <a:spcAft>
+                <a:spcPts val="1100"/>
+              </a:spcAft>
+            </a:pPr>
+            <a:r>
+              <a:rPr sz="950" b="0">
+                <a:solidFill>
+                  <a:srgbClr val="1F5FBF"/>
+                </a:solidFill>
+                <a:latin typeface="Calibri"/>
+              </a:rPr>
+              <a:t>    </a:t>
+            </a:r>
+            <a:r>
+              <a:rPr sz="1050" b="0" u="sng">
+                <a:solidFill>
+                  <a:srgbClr val="1F5FBF"/>
+                </a:solidFill>
+                <a:latin typeface="Calibri"/>
+                <a:hlinkClick r:id="rId3"/>
+              </a:rPr>
+              <a:t>cert-in.org.in</a:t>
+            </a:r>
+          </a:p>
+          <a:p>
+            <a:pPr>
+              <a:spcAft>
+                <a:spcPts val="0"/>
+              </a:spcAft>
+            </a:pPr>
+            <a:r>
+              <a:rPr sz="1050" b="1">
+                <a:solidFill>
+                  <a:srgbClr val="0B2A5B"/>
+                </a:solidFill>
+                <a:latin typeface="Calibri"/>
+              </a:rPr>
+              <a:t>▸ </a:t>
+            </a:r>
+            <a:r>
+              <a:rPr sz="1150" b="1">
+                <a:solidFill>
+                  <a:srgbClr val="0B2A5B"/>
+                </a:solidFill>
+                <a:latin typeface="Calibri"/>
+              </a:rPr>
+              <a:t>CERT-In cyber incidents 2020–2024 (OGD)</a:t>
+            </a:r>
+          </a:p>
+          <a:p>
+            <a:pPr>
+              <a:spcAft>
+                <a:spcPts val="1100"/>
+              </a:spcAft>
+            </a:pPr>
+            <a:r>
+              <a:rPr sz="950" b="0">
+                <a:solidFill>
+                  <a:srgbClr val="1F5FBF"/>
+                </a:solidFill>
+                <a:latin typeface="Calibri"/>
+              </a:rPr>
+              <a:t>    </a:t>
+            </a:r>
+            <a:r>
+              <a:rPr sz="1050" b="0" u="sng">
+                <a:solidFill>
+                  <a:srgbClr val="1F5FBF"/>
+                </a:solidFill>
+                <a:latin typeface="Calibri"/>
+                <a:hlinkClick r:id="rId11"/>
+              </a:rPr>
+              <a:t>data.gov.in</a:t>
+            </a:r>
+          </a:p>
+          <a:p>
+            <a:pPr>
+              <a:spcAft>
+                <a:spcPts val="0"/>
+              </a:spcAft>
+            </a:pPr>
+            <a:r>
+              <a:rPr sz="1050" b="1">
+                <a:solidFill>
+                  <a:srgbClr val="0B2A5B"/>
+                </a:solidFill>
+                <a:latin typeface="Calibri"/>
+              </a:rPr>
+              <a:t>▸ </a:t>
+            </a:r>
+            <a:r>
+              <a:rPr sz="1150" b="1">
+                <a:solidFill>
+                  <a:srgbClr val="0B2A5B"/>
+                </a:solidFill>
+                <a:latin typeface="Calibri"/>
+              </a:rPr>
+              <a:t>PIB: CERT-In, India's frontline defender</a:t>
+            </a:r>
+          </a:p>
+          <a:p>
+            <a:pPr>
+              <a:spcAft>
+                <a:spcPts val="1100"/>
+              </a:spcAft>
+            </a:pPr>
+            <a:r>
+              <a:rPr sz="950" b="0">
+                <a:solidFill>
+                  <a:srgbClr val="1F5FBF"/>
+                </a:solidFill>
+                <a:latin typeface="Calibri"/>
+              </a:rPr>
+              <a:t>    </a:t>
+            </a:r>
+            <a:r>
+              <a:rPr sz="1050" b="0" u="sng">
+                <a:solidFill>
+                  <a:srgbClr val="1F5FBF"/>
+                </a:solidFill>
+                <a:latin typeface="Calibri"/>
+                <a:hlinkClick r:id="rId12"/>
+              </a:rPr>
+              <a:t>pib.gov.in</a:t>
+            </a:r>
+          </a:p>
+        </p:txBody>
+      </p:sp>
+      <p:sp>
+        <p:nvSpPr>
+          <p:cNvPr id="43" name="TextBox 42"/>
+          <p:cNvSpPr txBox="1"/>
+          <p:nvPr/>
+        </p:nvSpPr>
+        <p:spPr>
+          <a:xfrm>
+            <a:off x="4050792" y="1645920"/>
+            <a:ext cx="3447288" cy="1554480"/>
+          </a:xfrm>
+          <a:prstGeom prst="rect">
+            <a:avLst/>
+          </a:prstGeom>
+          <a:noFill/>
+        </p:spPr>
+        <p:txBody>
+          <a:bodyPr wrap="square" lIns="36576" rIns="36576" tIns="9144" bIns="9144" anchor="t">
+            <a:spAutoFit/>
+          </a:bodyPr>
+          <a:lstStyle/>
+          <a:p>
+            <a:pPr>
+              <a:spcAft>
+                <a:spcPts val="0"/>
+              </a:spcAft>
+            </a:pPr>
+            <a:r>
+              <a:rPr sz="1050" b="1">
+                <a:solidFill>
+                  <a:srgbClr val="0B2A5B"/>
+                </a:solidFill>
+                <a:latin typeface="Calibri"/>
+              </a:rPr>
+              <a:t>▸ </a:t>
+            </a:r>
+            <a:r>
+              <a:rPr sz="1150" b="1">
+                <a:solidFill>
+                  <a:srgbClr val="0B2A5B"/>
+                </a:solidFill>
+                <a:latin typeface="Calibri"/>
+              </a:rPr>
+              <a:t>NCIIPC, NTRO</a:t>
+            </a:r>
+          </a:p>
+          <a:p>
+            <a:pPr>
+              <a:spcAft>
+                <a:spcPts val="1100"/>
+              </a:spcAft>
+            </a:pPr>
+            <a:r>
+              <a:rPr sz="950" b="0">
+                <a:solidFill>
+                  <a:srgbClr val="1F5FBF"/>
+                </a:solidFill>
+                <a:latin typeface="Calibri"/>
+              </a:rPr>
+              <a:t>    </a:t>
+            </a:r>
+            <a:r>
+              <a:rPr sz="1050" b="0" u="sng">
+                <a:solidFill>
+                  <a:srgbClr val="1F5FBF"/>
+                </a:solidFill>
+                <a:latin typeface="Calibri"/>
+                <a:hlinkClick r:id="rId9"/>
+              </a:rPr>
+              <a:t>nciipc.gov.in</a:t>
+            </a:r>
+          </a:p>
+          <a:p>
+            <a:pPr>
+              <a:spcAft>
+                <a:spcPts val="0"/>
+              </a:spcAft>
+            </a:pPr>
+            <a:r>
+              <a:rPr sz="1050" b="1">
+                <a:solidFill>
+                  <a:srgbClr val="0B2A5B"/>
+                </a:solidFill>
+                <a:latin typeface="Calibri"/>
+              </a:rPr>
+              <a:t>▸ </a:t>
+            </a:r>
+            <a:r>
+              <a:rPr sz="1150" b="1">
+                <a:solidFill>
+                  <a:srgbClr val="0B2A5B"/>
+                </a:solidFill>
+                <a:latin typeface="Calibri"/>
+              </a:rPr>
+              <a:t>Information Technology Act, 2000</a:t>
+            </a:r>
+          </a:p>
+          <a:p>
+            <a:pPr>
+              <a:spcAft>
+                <a:spcPts val="1100"/>
+              </a:spcAft>
+            </a:pPr>
+            <a:r>
+              <a:rPr sz="950" b="0">
+                <a:solidFill>
+                  <a:srgbClr val="1F5FBF"/>
+                </a:solidFill>
+                <a:latin typeface="Calibri"/>
+              </a:rPr>
+              <a:t>    </a:t>
+            </a:r>
+            <a:r>
+              <a:rPr sz="1050" b="0" u="sng">
+                <a:solidFill>
+                  <a:srgbClr val="1F5FBF"/>
+                </a:solidFill>
+                <a:latin typeface="Calibri"/>
+                <a:hlinkClick r:id="rId13"/>
+              </a:rPr>
+              <a:t>indiacode.nic.in</a:t>
+            </a:r>
+          </a:p>
+          <a:p>
+            <a:pPr>
+              <a:spcAft>
+                <a:spcPts val="0"/>
+              </a:spcAft>
+            </a:pPr>
+            <a:r>
+              <a:rPr sz="1050" b="1">
+                <a:solidFill>
+                  <a:srgbClr val="0B2A5B"/>
+                </a:solidFill>
+                <a:latin typeface="Calibri"/>
+              </a:rPr>
+              <a:t>▸ </a:t>
+            </a:r>
+            <a:r>
+              <a:rPr sz="1150" b="1">
+                <a:solidFill>
+                  <a:srgbClr val="0B2A5B"/>
+                </a:solidFill>
+                <a:latin typeface="Calibri"/>
+              </a:rPr>
+              <a:t>Digital Personal Data Protection Act, 2023</a:t>
+            </a:r>
+          </a:p>
+          <a:p>
+            <a:pPr>
+              <a:spcAft>
+                <a:spcPts val="1100"/>
+              </a:spcAft>
+            </a:pPr>
+            <a:r>
+              <a:rPr sz="950" b="0">
+                <a:solidFill>
+                  <a:srgbClr val="1F5FBF"/>
+                </a:solidFill>
+                <a:latin typeface="Calibri"/>
+              </a:rPr>
+              <a:t>    </a:t>
+            </a:r>
+            <a:r>
+              <a:rPr sz="1050" b="0" u="sng">
+                <a:solidFill>
+                  <a:srgbClr val="1F5FBF"/>
+                </a:solidFill>
+                <a:latin typeface="Calibri"/>
+                <a:hlinkClick r:id="rId14"/>
+              </a:rPr>
+              <a:t>meity.gov.in</a:t>
+            </a:r>
+          </a:p>
+        </p:txBody>
+      </p:sp>
+      <p:sp>
+        <p:nvSpPr>
+          <p:cNvPr id="44" name="Rectangle 43"/>
+          <p:cNvSpPr/>
+          <p:nvPr/>
+        </p:nvSpPr>
+        <p:spPr>
+          <a:xfrm>
+            <a:off x="6903720" y="1216152"/>
+            <a:ext cx="228600" cy="146304"/>
+          </a:xfrm>
+          <a:prstGeom prst="rect">
+            <a:avLst/>
+          </a:prstGeom>
+          <a:solidFill>
+            <a:srgbClr val="FF9933"/>
+          </a:solidFill>
+          <a:ln>
+            <a:noFill/>
+          </a:ln>
+          <a:effectLst/>
+        </p:spPr>
+        <p:style>
+          <a:lnRef idx="1">
+            <a:schemeClr val="accent1"/>
+          </a:lnRef>
+          <a:fillRef idx="3">
+            <a:schemeClr val="accent1"/>
+          </a:fillRef>
+          <a:effectRef idx="2">
+            <a:schemeClr val="accent1"/>
+          </a:effectRef>
+          <a:fontRef idx="minor">
+            <a:schemeClr val="lt1"/>
+          </a:fontRef>
+        </p:style>
+        <p:txBody>
+          <a:bodyPr rtlCol="0" anchor="ctr"/>
+          <a:lstStyle/>
+          <a:p>
+            <a:pPr algn="ctr"/>
+          </a:p>
+        </p:txBody>
+      </p:sp>
+      <p:sp>
+        <p:nvSpPr>
+          <p:cNvPr id="45" name="Rectangle 44"/>
+          <p:cNvSpPr/>
+          <p:nvPr/>
+        </p:nvSpPr>
+        <p:spPr>
+          <a:xfrm>
+            <a:off x="7132320" y="1216152"/>
+            <a:ext cx="228600" cy="146304"/>
+          </a:xfrm>
+          <a:prstGeom prst="rect">
+            <a:avLst/>
+          </a:prstGeom>
+          <a:solidFill>
+            <a:srgbClr val="FFFFFF"/>
+          </a:solidFill>
+          <a:ln w="12700">
+            <a:solidFill>
+              <a:srgbClr val="D5DCE6"/>
+            </a:solidFill>
+          </a:ln>
+          <a:effectLst/>
+        </p:spPr>
+        <p:style>
+          <a:lnRef idx="1">
+            <a:schemeClr val="accent1"/>
+          </a:lnRef>
+          <a:fillRef idx="3">
+            <a:schemeClr val="accent1"/>
+          </a:fillRef>
+          <a:effectRef idx="2">
+            <a:schemeClr val="accent1"/>
+          </a:effectRef>
+          <a:fontRef idx="minor">
+            <a:schemeClr val="lt1"/>
+          </a:fontRef>
+        </p:style>
+        <p:txBody>
+          <a:bodyPr rtlCol="0" anchor="ctr"/>
+          <a:lstStyle/>
+          <a:p>
+            <a:pPr algn="ctr"/>
+          </a:p>
+        </p:txBody>
+      </p:sp>
+      <p:sp>
+        <p:nvSpPr>
+          <p:cNvPr id="46" name="Rectangle 45"/>
+          <p:cNvSpPr/>
+          <p:nvPr/>
+        </p:nvSpPr>
+        <p:spPr>
+          <a:xfrm>
+            <a:off x="7360920" y="1216152"/>
+            <a:ext cx="228600" cy="146304"/>
+          </a:xfrm>
+          <a:prstGeom prst="rect">
+            <a:avLst/>
+          </a:prstGeom>
+          <a:solidFill>
+            <a:srgbClr val="138808"/>
+          </a:solidFill>
+          <a:ln>
+            <a:noFill/>
+          </a:ln>
+          <a:effectLst/>
+        </p:spPr>
+        <p:style>
+          <a:lnRef idx="1">
+            <a:schemeClr val="accent1"/>
+          </a:lnRef>
+          <a:fillRef idx="3">
+            <a:schemeClr val="accent1"/>
+          </a:fillRef>
+          <a:effectRef idx="2">
+            <a:schemeClr val="accent1"/>
+          </a:effectRef>
+          <a:fontRef idx="minor">
+            <a:schemeClr val="lt1"/>
+          </a:fontRef>
+        </p:style>
+        <p:txBody>
+          <a:bodyPr rtlCol="0" anchor="ctr"/>
+          <a:lstStyle/>
+          <a:p>
+            <a:pPr algn="ctr"/>
+          </a:p>
+        </p:txBody>
+      </p:sp>
+      <p:sp>
+        <p:nvSpPr>
+          <p:cNvPr id="47" name="Rounded Rectangle 46"/>
+          <p:cNvSpPr/>
+          <p:nvPr/>
+        </p:nvSpPr>
+        <p:spPr>
+          <a:xfrm>
+            <a:off x="365760" y="3383280"/>
+            <a:ext cx="3593592" cy="2962656"/>
+          </a:xfrm>
+          <a:prstGeom prst="roundRect">
+            <a:avLst>
+              <a:gd name="adj" fmla="val 4000"/>
+            </a:avLst>
+          </a:prstGeom>
+          <a:solidFill>
+            <a:srgbClr val="FFFFFF"/>
+          </a:solidFill>
+          <a:ln w="12700">
+            <a:solidFill>
+              <a:srgbClr val="D5DCE6"/>
+            </a:solidFill>
+          </a:ln>
+          <a:effectLst/>
+        </p:spPr>
+        <p:style>
+          <a:lnRef idx="1">
+            <a:schemeClr val="accent1"/>
+          </a:lnRef>
+          <a:fillRef idx="3">
+            <a:schemeClr val="accent1"/>
+          </a:fillRef>
+          <a:effectRef idx="2">
+            <a:schemeClr val="accent1"/>
+          </a:effectRef>
+          <a:fontRef idx="minor">
+            <a:schemeClr val="lt1"/>
+          </a:fontRef>
+        </p:style>
+        <p:txBody>
+          <a:bodyPr rtlCol="0" anchor="ctr"/>
+          <a:lstStyle/>
+          <a:p>
+            <a:pPr algn="ctr"/>
+          </a:p>
+        </p:txBody>
+      </p:sp>
+      <p:sp>
+        <p:nvSpPr>
+          <p:cNvPr id="48" name="Rounded Rectangle 47"/>
+          <p:cNvSpPr/>
+          <p:nvPr/>
+        </p:nvSpPr>
+        <p:spPr>
+          <a:xfrm>
+            <a:off x="365760" y="3383280"/>
+            <a:ext cx="3593592" cy="384048"/>
+          </a:xfrm>
+          <a:prstGeom prst="roundRect">
+            <a:avLst>
+              <a:gd name="adj" fmla="val 18000"/>
+            </a:avLst>
           </a:prstGeom>
           <a:solidFill>
             <a:srgbClr val="1F5FBF"/>
@@ -22095,14 +23372,14 @@
       </p:sp>
       <p:sp>
         <p:nvSpPr>
-          <p:cNvPr id="12" name="TextBox 11"/>
+          <p:cNvPr id="49" name="TextBox 48"/>
           <p:cNvSpPr txBox="1"/>
           <p:nvPr/>
         </p:nvSpPr>
         <p:spPr>
           <a:xfrm>
-            <a:off x="566928" y="1161288"/>
-            <a:ext cx="6949440" cy="320040"/>
+            <a:off x="530352" y="3383280"/>
+            <a:ext cx="3319272" cy="384048"/>
           </a:xfrm>
           <a:prstGeom prst="rect">
             <a:avLst/>
@@ -22110,38 +23387,33 @@
           <a:noFill/>
         </p:spPr>
         <p:txBody>
-          <a:bodyPr wrap="square" anchor="t" lIns="36576" rIns="36576" tIns="18288" bIns="18288">
+          <a:bodyPr wrap="square" lIns="36576" rIns="36576" tIns="9144" bIns="9144" anchor="ctr">
             <a:spAutoFit/>
           </a:bodyPr>
           <a:lstStyle/>
           <a:p>
-            <a:pPr algn="l">
-              <a:spcAft>
-                <a:spcPts val="0"/>
-              </a:spcAft>
-            </a:pPr>
-            <a:r>
-              <a:rPr sz="1400" b="1">
-                <a:solidFill>
-                  <a:srgbClr val="1F5FBF"/>
-                </a:solidFill>
-                <a:latin typeface="Calibri"/>
-              </a:rPr>
-              <a:t>Research Papers</a:t>
-            </a:r>
-          </a:p>
-        </p:txBody>
-      </p:sp>
-      <p:sp>
-        <p:nvSpPr>
-          <p:cNvPr id="13" name="TextBox 12"/>
+            <a:r>
+              <a:rPr sz="1350" b="1">
+                <a:solidFill>
+                  <a:srgbClr val="FFFFFF"/>
+                </a:solidFill>
+                <a:latin typeface="Calibri"/>
+              </a:rPr>
+              <a:t>RESEARCH &amp; DATASETS</a:t>
+            </a:r>
+          </a:p>
+        </p:txBody>
+      </p:sp>
+      <p:sp>
+        <p:nvSpPr>
+          <p:cNvPr id="50" name="TextBox 49"/>
           <p:cNvSpPr txBox="1"/>
           <p:nvPr/>
         </p:nvSpPr>
         <p:spPr>
           <a:xfrm>
-            <a:off x="566928" y="1627632"/>
-            <a:ext cx="6995160" cy="1325880"/>
+            <a:off x="530352" y="3931920"/>
+            <a:ext cx="3246120" cy="2368296"/>
           </a:xfrm>
           <a:prstGeom prst="rect">
             <a:avLst/>
@@ -22149,78 +23421,10 @@
           <a:noFill/>
         </p:spPr>
         <p:txBody>
-          <a:bodyPr wrap="square" anchor="t" lIns="36576" rIns="36576" tIns="18288" bIns="18288">
+          <a:bodyPr wrap="square" lIns="36576" rIns="36576" tIns="9144" bIns="9144" anchor="t">
             <a:spAutoFit/>
           </a:bodyPr>
           <a:lstStyle/>
-          <a:p>
-            <a:pPr algn="l">
-              <a:spcAft>
-                <a:spcPts val="1300"/>
-              </a:spcAft>
-            </a:pPr>
-            <a:r>
-              <a:rPr sz="1300" b="0">
-                <a:solidFill>
-                  <a:srgbClr val="1F5FBF"/>
-                </a:solidFill>
-                <a:latin typeface="Calibri"/>
-              </a:rPr>
-              <a:t>▪  </a:t>
-            </a:r>
-            <a:r>
-              <a:rPr sz="1300" b="1">
-                <a:solidFill>
-                  <a:srgbClr val="0B2A5B"/>
-                </a:solidFill>
-                <a:latin typeface="Calibri"/>
-              </a:rPr>
-              <a:t>Drain log parsing</a:t>
-            </a:r>
-            <a:r>
-              <a:rPr sz="1300" b="0">
-                <a:solidFill>
-                  <a:srgbClr val="5F6B7A"/>
-                </a:solidFill>
-                <a:latin typeface="Calibri"/>
-              </a:rPr>
-              <a:t>  —  He et al., IEEE ICWS 2017</a:t>
-            </a:r>
-          </a:p>
-          <a:p>
-            <a:pPr>
-              <a:spcAft>
-                <a:spcPts val="1300"/>
-              </a:spcAft>
-            </a:pPr>
-            <a:r>
-              <a:rPr sz="1300" b="0">
-                <a:solidFill>
-                  <a:srgbClr val="1F5FBF"/>
-                </a:solidFill>
-                <a:latin typeface="Calibri"/>
-              </a:rPr>
-              <a:t>▪  </a:t>
-            </a:r>
-            <a:r>
-              <a:rPr sz="1300" b="1">
-                <a:solidFill>
-                  <a:srgbClr val="0B2A5B"/>
-                </a:solidFill>
-                <a:latin typeface="Calibri"/>
-              </a:rPr>
-              <a:t>Loghub real-world log datasets</a:t>
-            </a:r>
-            <a:r>
-              <a:rPr sz="1300" b="0">
-                <a:solidFill>
-                  <a:srgbClr val="5F6B7A"/>
-                </a:solidFill>
-                <a:latin typeface="Calibri"/>
-              </a:rPr>
-              <a:t>  —  Zhu et al., IEEE ISSRE 2023</a:t>
-            </a:r>
-          </a:p>
           <a:p>
             <a:pPr>
               <a:spcAft>
@@ -22228,49 +23432,219 @@
               </a:spcAft>
             </a:pPr>
             <a:r>
-              <a:rPr sz="1300" b="0">
+              <a:rPr sz="1050" b="1">
                 <a:solidFill>
                   <a:srgbClr val="1F5FBF"/>
                 </a:solidFill>
                 <a:latin typeface="Calibri"/>
               </a:rPr>
-              <a:t>▪  </a:t>
-            </a:r>
-            <a:r>
-              <a:rPr sz="1300" b="1">
+              <a:t>▸ </a:t>
+            </a:r>
+            <a:r>
+              <a:rPr sz="1200" b="1">
                 <a:solidFill>
                   <a:srgbClr val="0B2A5B"/>
                 </a:solidFill>
                 <a:latin typeface="Calibri"/>
               </a:rPr>
-              <a:t>Log-parser benchmark</a:t>
-            </a:r>
-            <a:r>
-              <a:rPr sz="1300" b="0">
-                <a:solidFill>
-                  <a:srgbClr val="5F6B7A"/>
-                </a:solidFill>
-                <a:latin typeface="Calibri"/>
-              </a:rPr>
-              <a:t>  —  Zhu et al., ICSE-SEIP 2019</a:t>
-            </a:r>
-          </a:p>
-        </p:txBody>
-      </p:sp>
-      <p:sp>
-        <p:nvSpPr>
-          <p:cNvPr id="14" name="Rounded Rectangle 13"/>
+              <a:t>Drain log parser, ICWS 2017</a:t>
+            </a:r>
+          </a:p>
+          <a:p>
+            <a:pPr>
+              <a:spcAft>
+                <a:spcPts val="1600"/>
+              </a:spcAft>
+            </a:pPr>
+            <a:r>
+              <a:rPr sz="950" b="0">
+                <a:solidFill>
+                  <a:srgbClr val="1F5FBF"/>
+                </a:solidFill>
+                <a:latin typeface="Calibri"/>
+              </a:rPr>
+              <a:t>    </a:t>
+            </a:r>
+            <a:r>
+              <a:rPr sz="1050" b="0" u="sng">
+                <a:solidFill>
+                  <a:srgbClr val="1F5FBF"/>
+                </a:solidFill>
+                <a:latin typeface="Calibri"/>
+                <a:hlinkClick r:id="rId15"/>
+              </a:rPr>
+              <a:t>doi.org/10.1109/ICWS.2017.13</a:t>
+            </a:r>
+          </a:p>
+          <a:p>
+            <a:pPr>
+              <a:spcAft>
+                <a:spcPts val="0"/>
+              </a:spcAft>
+            </a:pPr>
+            <a:r>
+              <a:rPr sz="1050" b="1">
+                <a:solidFill>
+                  <a:srgbClr val="1F5FBF"/>
+                </a:solidFill>
+                <a:latin typeface="Calibri"/>
+              </a:rPr>
+              <a:t>▸ </a:t>
+            </a:r>
+            <a:r>
+              <a:rPr sz="1200" b="1">
+                <a:solidFill>
+                  <a:srgbClr val="0B2A5B"/>
+                </a:solidFill>
+                <a:latin typeface="Calibri"/>
+              </a:rPr>
+              <a:t>Loghub datasets, ISSRE 2023</a:t>
+            </a:r>
+          </a:p>
+          <a:p>
+            <a:pPr>
+              <a:spcAft>
+                <a:spcPts val="1600"/>
+              </a:spcAft>
+            </a:pPr>
+            <a:r>
+              <a:rPr sz="950" b="0">
+                <a:solidFill>
+                  <a:srgbClr val="1F5FBF"/>
+                </a:solidFill>
+                <a:latin typeface="Calibri"/>
+              </a:rPr>
+              <a:t>    </a:t>
+            </a:r>
+            <a:r>
+              <a:rPr sz="1050" b="0" u="sng">
+                <a:solidFill>
+                  <a:srgbClr val="1F5FBF"/>
+                </a:solidFill>
+                <a:latin typeface="Calibri"/>
+                <a:hlinkClick r:id="rId16"/>
+              </a:rPr>
+              <a:t>arxiv.org/abs/2008.06448</a:t>
+            </a:r>
+          </a:p>
+          <a:p>
+            <a:pPr>
+              <a:spcAft>
+                <a:spcPts val="0"/>
+              </a:spcAft>
+            </a:pPr>
+            <a:r>
+              <a:rPr sz="1050" b="1">
+                <a:solidFill>
+                  <a:srgbClr val="1F5FBF"/>
+                </a:solidFill>
+                <a:latin typeface="Calibri"/>
+              </a:rPr>
+              <a:t>▸ </a:t>
+            </a:r>
+            <a:r>
+              <a:rPr sz="1200" b="1">
+                <a:solidFill>
+                  <a:srgbClr val="0B2A5B"/>
+                </a:solidFill>
+                <a:latin typeface="Calibri"/>
+              </a:rPr>
+              <a:t>Log-parser benchmark, ICSE-SEIP 2019</a:t>
+            </a:r>
+          </a:p>
+          <a:p>
+            <a:pPr>
+              <a:spcAft>
+                <a:spcPts val="1600"/>
+              </a:spcAft>
+            </a:pPr>
+            <a:r>
+              <a:rPr sz="950" b="0">
+                <a:solidFill>
+                  <a:srgbClr val="1F5FBF"/>
+                </a:solidFill>
+                <a:latin typeface="Calibri"/>
+              </a:rPr>
+              <a:t>    </a:t>
+            </a:r>
+            <a:r>
+              <a:rPr sz="1050" b="0" u="sng">
+                <a:solidFill>
+                  <a:srgbClr val="1F5FBF"/>
+                </a:solidFill>
+                <a:latin typeface="Calibri"/>
+                <a:hlinkClick r:id="rId17"/>
+              </a:rPr>
+              <a:t>arxiv.org/abs/1811.03509</a:t>
+            </a:r>
+          </a:p>
+          <a:p>
+            <a:pPr>
+              <a:spcAft>
+                <a:spcPts val="0"/>
+              </a:spcAft>
+            </a:pPr>
+            <a:r>
+              <a:rPr sz="1050" b="1">
+                <a:solidFill>
+                  <a:srgbClr val="1F5FBF"/>
+                </a:solidFill>
+                <a:latin typeface="Calibri"/>
+              </a:rPr>
+              <a:t>▸ </a:t>
+            </a:r>
+            <a:r>
+              <a:rPr sz="1200" b="1">
+                <a:solidFill>
+                  <a:srgbClr val="0B2A5B"/>
+                </a:solidFill>
+                <a:latin typeface="Calibri"/>
+              </a:rPr>
+              <a:t>Loghub log samples</a:t>
+            </a:r>
+          </a:p>
+          <a:p>
+            <a:pPr>
+              <a:spcAft>
+                <a:spcPts val="1600"/>
+              </a:spcAft>
+            </a:pPr>
+            <a:r>
+              <a:rPr sz="950" b="0">
+                <a:solidFill>
+                  <a:srgbClr val="1F5FBF"/>
+                </a:solidFill>
+                <a:latin typeface="Calibri"/>
+              </a:rPr>
+              <a:t>    </a:t>
+            </a:r>
+            <a:r>
+              <a:rPr sz="1050" b="0" u="sng">
+                <a:solidFill>
+                  <a:srgbClr val="1F5FBF"/>
+                </a:solidFill>
+                <a:latin typeface="Calibri"/>
+                <a:hlinkClick r:id="rId2"/>
+              </a:rPr>
+              <a:t>github.com/logpai/loghub</a:t>
+            </a:r>
+          </a:p>
+        </p:txBody>
+      </p:sp>
+      <p:sp>
+        <p:nvSpPr>
+          <p:cNvPr id="51" name="Rounded Rectangle 50"/>
           <p:cNvSpPr/>
           <p:nvPr/>
         </p:nvSpPr>
         <p:spPr>
           <a:xfrm>
-            <a:off x="365760" y="2999232"/>
-            <a:ext cx="7315200" cy="1783080"/>
+            <a:off x="4087368" y="3383280"/>
+            <a:ext cx="3593592" cy="2962656"/>
           </a:xfrm>
           <a:prstGeom prst="roundRect">
             <a:avLst>
-              <a:gd name="adj" fmla="val 5000"/>
+              <a:gd name="adj" fmla="val 4000"/>
             </a:avLst>
           </a:prstGeom>
           <a:solidFill>
@@ -22278,7 +23652,7 @@
           </a:solidFill>
           <a:ln w="12700">
             <a:solidFill>
-              <a:srgbClr val="D3DBE8"/>
+              <a:srgbClr val="D5DCE6"/>
             </a:solidFill>
           </a:ln>
           <a:effectLst/>
@@ -22307,293 +23681,19 @@
       </p:sp>
       <p:sp>
         <p:nvSpPr>
-          <p:cNvPr id="15" name="Rectangle 14"/>
+          <p:cNvPr id="52" name="Rounded Rectangle 51"/>
           <p:cNvSpPr/>
           <p:nvPr/>
         </p:nvSpPr>
         <p:spPr>
           <a:xfrm>
-            <a:off x="365760" y="3108960"/>
-            <a:ext cx="73152" cy="1563624"/>
-          </a:xfrm>
-          <a:prstGeom prst="rect">
-            <a:avLst/>
-          </a:prstGeom>
-          <a:solidFill>
-            <a:srgbClr val="F58220"/>
-          </a:solidFill>
-          <a:ln>
-            <a:noFill/>
-          </a:ln>
-          <a:effectLst/>
-        </p:spPr>
-        <p:style>
-          <a:lnRef idx="1">
-            <a:schemeClr val="accent1"/>
-          </a:lnRef>
-          <a:fillRef idx="3">
-            <a:schemeClr val="accent1"/>
-          </a:fillRef>
-          <a:effectRef idx="2">
-            <a:schemeClr val="accent1"/>
-          </a:effectRef>
-          <a:fontRef idx="minor">
-            <a:schemeClr val="lt1"/>
-          </a:fontRef>
-        </p:style>
-        <p:txBody>
-          <a:bodyPr rtlCol="0" anchor="ctr"/>
-          <a:lstStyle/>
-          <a:p>
-            <a:pPr algn="ctr"/>
-          </a:p>
-        </p:txBody>
-      </p:sp>
-      <p:sp>
-        <p:nvSpPr>
-          <p:cNvPr id="16" name="TextBox 15"/>
-          <p:cNvSpPr txBox="1"/>
-          <p:nvPr/>
-        </p:nvSpPr>
-        <p:spPr>
-          <a:xfrm>
-            <a:off x="566928" y="3063239"/>
-            <a:ext cx="6949440" cy="320040"/>
-          </a:xfrm>
-          <a:prstGeom prst="rect">
-            <a:avLst/>
-          </a:prstGeom>
-          <a:noFill/>
-        </p:spPr>
-        <p:txBody>
-          <a:bodyPr wrap="square" anchor="t" lIns="36576" rIns="36576" tIns="18288" bIns="18288">
-            <a:spAutoFit/>
-          </a:bodyPr>
-          <a:lstStyle/>
-          <a:p>
-            <a:pPr algn="l">
-              <a:spcAft>
-                <a:spcPts val="0"/>
-              </a:spcAft>
-            </a:pPr>
-            <a:r>
-              <a:rPr sz="1400" b="1">
-                <a:solidFill>
-                  <a:srgbClr val="F58220"/>
-                </a:solidFill>
-                <a:latin typeface="Calibri"/>
-              </a:rPr>
-              <a:t>Government &amp; Policy</a:t>
-            </a:r>
-          </a:p>
-        </p:txBody>
-      </p:sp>
-      <p:sp>
-        <p:nvSpPr>
-          <p:cNvPr id="17" name="TextBox 16"/>
-          <p:cNvSpPr txBox="1"/>
-          <p:nvPr/>
-        </p:nvSpPr>
-        <p:spPr>
-          <a:xfrm>
-            <a:off x="566928" y="3529584"/>
-            <a:ext cx="6995160" cy="1325880"/>
-          </a:xfrm>
-          <a:prstGeom prst="rect">
-            <a:avLst/>
-          </a:prstGeom>
-          <a:noFill/>
-        </p:spPr>
-        <p:txBody>
-          <a:bodyPr wrap="square" anchor="t" lIns="36576" rIns="36576" tIns="18288" bIns="18288">
-            <a:spAutoFit/>
-          </a:bodyPr>
-          <a:lstStyle/>
-          <a:p>
-            <a:pPr algn="l">
-              <a:spcAft>
-                <a:spcPts val="1300"/>
-              </a:spcAft>
-            </a:pPr>
-            <a:r>
-              <a:rPr sz="1300" b="0">
-                <a:solidFill>
-                  <a:srgbClr val="F58220"/>
-                </a:solidFill>
-                <a:latin typeface="Calibri"/>
-              </a:rPr>
-              <a:t>▪  </a:t>
-            </a:r>
-            <a:r>
-              <a:rPr sz="1300" b="1">
-                <a:solidFill>
-                  <a:srgbClr val="0B2A5B"/>
-                </a:solidFill>
-                <a:latin typeface="Calibri"/>
-              </a:rPr>
-              <a:t>NCIIPC, NTRO</a:t>
-            </a:r>
-            <a:r>
-              <a:rPr sz="1300" b="0">
-                <a:solidFill>
-                  <a:srgbClr val="5F6B7A"/>
-                </a:solidFill>
-                <a:latin typeface="Calibri"/>
-              </a:rPr>
-              <a:t>  —  IT Act Sec. 70A</a:t>
-            </a:r>
-            <a:r>
-              <a:rPr sz="1300" b="0">
-                <a:solidFill>
-                  <a:srgbClr val="1F5FBF"/>
-                </a:solidFill>
-                <a:latin typeface="Calibri"/>
-                <a:hlinkClick r:id="rId9"/>
-              </a:rPr>
-              <a:t>  ·  nciipc.gov.in</a:t>
-            </a:r>
-          </a:p>
-          <a:p>
-            <a:pPr>
-              <a:spcAft>
-                <a:spcPts val="1300"/>
-              </a:spcAft>
-            </a:pPr>
-            <a:r>
-              <a:rPr sz="1300" b="0">
-                <a:solidFill>
-                  <a:srgbClr val="F58220"/>
-                </a:solidFill>
-                <a:latin typeface="Calibri"/>
-              </a:rPr>
-              <a:t>▪  </a:t>
-            </a:r>
-            <a:r>
-              <a:rPr sz="1300" b="1">
-                <a:solidFill>
-                  <a:srgbClr val="0B2A5B"/>
-                </a:solidFill>
-                <a:latin typeface="Calibri"/>
-              </a:rPr>
-              <a:t>CERT-In Directions 2022</a:t>
-            </a:r>
-            <a:r>
-              <a:rPr sz="1300" b="0">
-                <a:solidFill>
-                  <a:srgbClr val="5F6B7A"/>
-                </a:solidFill>
-                <a:latin typeface="Calibri"/>
-              </a:rPr>
-              <a:t>  —  keep logs 180 days</a:t>
-            </a:r>
-            <a:r>
-              <a:rPr sz="1300" b="0">
-                <a:solidFill>
-                  <a:srgbClr val="1F5FBF"/>
-                </a:solidFill>
-                <a:latin typeface="Calibri"/>
-                <a:hlinkClick r:id="rId3"/>
-              </a:rPr>
-              <a:t>  ·  cert-in.org.in</a:t>
-            </a:r>
-          </a:p>
-          <a:p>
-            <a:pPr>
-              <a:spcAft>
-                <a:spcPts val="0"/>
-              </a:spcAft>
-            </a:pPr>
-            <a:r>
-              <a:rPr sz="1300" b="0">
-                <a:solidFill>
-                  <a:srgbClr val="F58220"/>
-                </a:solidFill>
-                <a:latin typeface="Calibri"/>
-              </a:rPr>
-              <a:t>▪  </a:t>
-            </a:r>
-            <a:r>
-              <a:rPr sz="1300" b="1">
-                <a:solidFill>
-                  <a:srgbClr val="0B2A5B"/>
-                </a:solidFill>
-                <a:latin typeface="Calibri"/>
-              </a:rPr>
-              <a:t>DPDP Act 2023</a:t>
-            </a:r>
-            <a:r>
-              <a:rPr sz="1300" b="0">
-                <a:solidFill>
-                  <a:srgbClr val="5F6B7A"/>
-                </a:solidFill>
-                <a:latin typeface="Calibri"/>
-              </a:rPr>
-              <a:t>  —  Govt. of India</a:t>
-            </a:r>
-          </a:p>
-        </p:txBody>
-      </p:sp>
-      <p:sp>
-        <p:nvSpPr>
-          <p:cNvPr id="18" name="Rounded Rectangle 17"/>
-          <p:cNvSpPr/>
-          <p:nvPr/>
-        </p:nvSpPr>
-        <p:spPr>
-          <a:xfrm>
-            <a:off x="365760" y="4901184"/>
-            <a:ext cx="7315200" cy="1444752"/>
+            <a:off x="4087368" y="3383280"/>
+            <a:ext cx="3593592" cy="384048"/>
           </a:xfrm>
           <a:prstGeom prst="roundRect">
             <a:avLst>
-              <a:gd name="adj" fmla="val 5000"/>
+              <a:gd name="adj" fmla="val 18000"/>
             </a:avLst>
-          </a:prstGeom>
-          <a:solidFill>
-            <a:srgbClr val="FFFFFF"/>
-          </a:solidFill>
-          <a:ln w="12700">
-            <a:solidFill>
-              <a:srgbClr val="D3DBE8"/>
-            </a:solidFill>
-          </a:ln>
-          <a:effectLst/>
-        </p:spPr>
-        <p:style>
-          <a:lnRef idx="1">
-            <a:schemeClr val="accent1"/>
-          </a:lnRef>
-          <a:fillRef idx="3">
-            <a:schemeClr val="accent1"/>
-          </a:fillRef>
-          <a:effectRef idx="2">
-            <a:schemeClr val="accent1"/>
-          </a:effectRef>
-          <a:fontRef idx="minor">
-            <a:schemeClr val="lt1"/>
-          </a:fontRef>
-        </p:style>
-        <p:txBody>
-          <a:bodyPr rtlCol="0" anchor="ctr"/>
-          <a:lstStyle/>
-          <a:p>
-            <a:pPr algn="ctr"/>
-          </a:p>
-        </p:txBody>
-      </p:sp>
-      <p:sp>
-        <p:nvSpPr>
-          <p:cNvPr id="19" name="Rectangle 18"/>
-          <p:cNvSpPr/>
-          <p:nvPr/>
-        </p:nvSpPr>
-        <p:spPr>
-          <a:xfrm>
-            <a:off x="365760" y="5010912"/>
-            <a:ext cx="73152" cy="1225296"/>
-          </a:xfrm>
-          <a:prstGeom prst="rect">
-            <a:avLst/>
           </a:prstGeom>
           <a:solidFill>
             <a:srgbClr val="138A36"/>
@@ -22627,14 +23727,14 @@
       </p:sp>
       <p:sp>
         <p:nvSpPr>
-          <p:cNvPr id="20" name="TextBox 19"/>
+          <p:cNvPr id="53" name="TextBox 52"/>
           <p:cNvSpPr txBox="1"/>
           <p:nvPr/>
         </p:nvSpPr>
         <p:spPr>
           <a:xfrm>
-            <a:off x="566928" y="4965192"/>
-            <a:ext cx="6949440" cy="320040"/>
+            <a:off x="4251960" y="3383280"/>
+            <a:ext cx="3319272" cy="384048"/>
           </a:xfrm>
           <a:prstGeom prst="rect">
             <a:avLst/>
@@ -22642,38 +23742,33 @@
           <a:noFill/>
         </p:spPr>
         <p:txBody>
-          <a:bodyPr wrap="square" anchor="t" lIns="36576" rIns="36576" tIns="18288" bIns="18288">
+          <a:bodyPr wrap="square" lIns="36576" rIns="36576" tIns="9144" bIns="9144" anchor="ctr">
             <a:spAutoFit/>
           </a:bodyPr>
           <a:lstStyle/>
           <a:p>
-            <a:pPr algn="l">
-              <a:spcAft>
-                <a:spcPts val="0"/>
-              </a:spcAft>
-            </a:pPr>
-            <a:r>
-              <a:rPr sz="1400" b="1">
-                <a:solidFill>
-                  <a:srgbClr val="138A36"/>
-                </a:solidFill>
-                <a:latin typeface="Calibri"/>
-              </a:rPr>
-              <a:t>Standards &amp; Tools</a:t>
-            </a:r>
-          </a:p>
-        </p:txBody>
-      </p:sp>
-      <p:sp>
-        <p:nvSpPr>
-          <p:cNvPr id="21" name="TextBox 20"/>
+            <a:r>
+              <a:rPr sz="1350" b="1">
+                <a:solidFill>
+                  <a:srgbClr val="FFFFFF"/>
+                </a:solidFill>
+                <a:latin typeface="Calibri"/>
+              </a:rPr>
+              <a:t>STANDARDS &amp; TOOLS</a:t>
+            </a:r>
+          </a:p>
+        </p:txBody>
+      </p:sp>
+      <p:sp>
+        <p:nvSpPr>
+          <p:cNvPr id="54" name="TextBox 53"/>
           <p:cNvSpPr txBox="1"/>
           <p:nvPr/>
         </p:nvSpPr>
         <p:spPr>
           <a:xfrm>
-            <a:off x="566928" y="5376672"/>
-            <a:ext cx="6995160" cy="987552"/>
+            <a:off x="4251960" y="3931920"/>
+            <a:ext cx="3246120" cy="2368296"/>
           </a:xfrm>
           <a:prstGeom prst="rect">
             <a:avLst/>
@@ -22681,70 +23776,10 @@
           <a:noFill/>
         </p:spPr>
         <p:txBody>
-          <a:bodyPr wrap="square" anchor="t" lIns="36576" rIns="36576" tIns="18288" bIns="18288">
+          <a:bodyPr wrap="square" lIns="36576" rIns="36576" tIns="9144" bIns="9144" anchor="t">
             <a:spAutoFit/>
           </a:bodyPr>
           <a:lstStyle/>
-          <a:p>
-            <a:pPr algn="l">
-              <a:spcAft>
-                <a:spcPts val="800"/>
-              </a:spcAft>
-            </a:pPr>
-            <a:r>
-              <a:rPr sz="1300" b="0">
-                <a:solidFill>
-                  <a:srgbClr val="138A36"/>
-                </a:solidFill>
-                <a:latin typeface="Calibri"/>
-              </a:rPr>
-              <a:t>▪  </a:t>
-            </a:r>
-            <a:r>
-              <a:rPr sz="1300" b="1">
-                <a:solidFill>
-                  <a:srgbClr val="0B2A5B"/>
-                </a:solidFill>
-                <a:latin typeface="Calibri"/>
-              </a:rPr>
-              <a:t>Syslog (RFC 5424) · CEF / LEEF · ISO 8601</a:t>
-            </a:r>
-          </a:p>
-          <a:p>
-            <a:pPr>
-              <a:spcAft>
-                <a:spcPts val="800"/>
-              </a:spcAft>
-            </a:pPr>
-            <a:r>
-              <a:rPr sz="1300" b="0">
-                <a:solidFill>
-                  <a:srgbClr val="138A36"/>
-                </a:solidFill>
-                <a:latin typeface="Calibri"/>
-              </a:rPr>
-              <a:t>▪  </a:t>
-            </a:r>
-            <a:r>
-              <a:rPr sz="1300" b="1">
-                <a:solidFill>
-                  <a:srgbClr val="0B2A5B"/>
-                </a:solidFill>
-                <a:latin typeface="Calibri"/>
-              </a:rPr>
-              <a:t>Drain3 library</a:t>
-            </a:r>
-            <a:r>
-              <a:rPr sz="1300" b="0">
-                <a:solidFill>
-                  <a:srgbClr val="1F5FBF"/>
-                </a:solidFill>
-                <a:latin typeface="Calibri"/>
-                <a:hlinkClick r:id="rId4"/>
-              </a:rPr>
-              <a:t>  ·  github.com/logpai/Drain3</a:t>
-            </a:r>
-          </a:p>
           <a:p>
             <a:pPr>
               <a:spcAft>
@@ -22752,690 +23787,201 @@
               </a:spcAft>
             </a:pPr>
             <a:r>
-              <a:rPr sz="1300" b="0">
+              <a:rPr sz="1050" b="1">
                 <a:solidFill>
                   <a:srgbClr val="138A36"/>
                 </a:solidFill>
                 <a:latin typeface="Calibri"/>
               </a:rPr>
-              <a:t>▪  </a:t>
-            </a:r>
-            <a:r>
-              <a:rPr sz="1300" b="1">
+              <a:t>▸ </a:t>
+            </a:r>
+            <a:r>
+              <a:rPr sz="1200" b="1">
                 <a:solidFill>
                   <a:srgbClr val="0B2A5B"/>
                 </a:solidFill>
                 <a:latin typeface="Calibri"/>
               </a:rPr>
-              <a:t>Scikit-learn</a:t>
-            </a:r>
-            <a:r>
-              <a:rPr sz="1300" b="0">
-                <a:solidFill>
-                  <a:srgbClr val="5F6B7A"/>
-                </a:solidFill>
-                <a:latin typeface="Calibri"/>
-              </a:rPr>
-              <a:t>  —  Pedregosa et al., JMLR 2011</a:t>
-            </a:r>
-          </a:p>
-        </p:txBody>
-      </p:sp>
-      <p:sp>
-        <p:nvSpPr>
-          <p:cNvPr id="22" name="Rounded Rectangle 21"/>
-          <p:cNvSpPr/>
-          <p:nvPr/>
-        </p:nvSpPr>
-        <p:spPr>
-          <a:xfrm>
-            <a:off x="7909560" y="1097280"/>
-            <a:ext cx="3959352" cy="5248656"/>
-          </a:xfrm>
-          <a:prstGeom prst="roundRect">
-            <a:avLst>
-              <a:gd name="adj" fmla="val 5000"/>
-            </a:avLst>
-          </a:prstGeom>
-          <a:solidFill>
-            <a:srgbClr val="0B2A5B"/>
-          </a:solidFill>
-          <a:ln>
-            <a:noFill/>
-          </a:ln>
-          <a:effectLst/>
-        </p:spPr>
-        <p:style>
-          <a:lnRef idx="1">
-            <a:schemeClr val="accent1"/>
-          </a:lnRef>
-          <a:fillRef idx="3">
-            <a:schemeClr val="accent1"/>
-          </a:fillRef>
-          <a:effectRef idx="2">
-            <a:schemeClr val="accent1"/>
-          </a:effectRef>
-          <a:fontRef idx="minor">
-            <a:schemeClr val="lt1"/>
-          </a:fontRef>
-        </p:style>
-        <p:txBody>
-          <a:bodyPr rtlCol="0" anchor="ctr"/>
-          <a:lstStyle/>
-          <a:p>
-            <a:pPr algn="ctr"/>
-          </a:p>
-        </p:txBody>
-      </p:sp>
-      <p:sp>
-        <p:nvSpPr>
-          <p:cNvPr id="23" name="TextBox 22"/>
-          <p:cNvSpPr txBox="1"/>
-          <p:nvPr/>
-        </p:nvSpPr>
-        <p:spPr>
-          <a:xfrm>
-            <a:off x="7909560" y="1234440"/>
-            <a:ext cx="3959352" cy="365760"/>
-          </a:xfrm>
-          <a:prstGeom prst="rect">
-            <a:avLst/>
-          </a:prstGeom>
-          <a:noFill/>
-        </p:spPr>
-        <p:txBody>
-          <a:bodyPr wrap="square" anchor="t" lIns="36576" rIns="36576" tIns="18288" bIns="18288">
-            <a:spAutoFit/>
-          </a:bodyPr>
-          <a:lstStyle/>
-          <a:p>
-            <a:pPr algn="ctr">
+              <a:t>Syslog protocol, RFC 5424</a:t>
+            </a:r>
+          </a:p>
+          <a:p>
+            <a:pPr>
+              <a:spcAft>
+                <a:spcPts val="1600"/>
+              </a:spcAft>
+            </a:pPr>
+            <a:r>
+              <a:rPr sz="950" b="0">
+                <a:solidFill>
+                  <a:srgbClr val="1F5FBF"/>
+                </a:solidFill>
+                <a:latin typeface="Calibri"/>
+              </a:rPr>
+              <a:t>    </a:t>
+            </a:r>
+            <a:r>
+              <a:rPr sz="1050" b="0" u="sng">
+                <a:solidFill>
+                  <a:srgbClr val="1F5FBF"/>
+                </a:solidFill>
+                <a:latin typeface="Calibri"/>
+                <a:hlinkClick r:id="rId18"/>
+              </a:rPr>
+              <a:t>datatracker.ietf.org/doc/rfc5424</a:t>
+            </a:r>
+          </a:p>
+          <a:p>
+            <a:pPr>
               <a:spcAft>
                 <a:spcPts val="0"/>
               </a:spcAft>
             </a:pPr>
             <a:r>
-              <a:rPr sz="1400" b="1">
-                <a:solidFill>
-                  <a:srgbClr val="F58220"/>
-                </a:solidFill>
-                <a:latin typeface="Calibri"/>
-              </a:rPr>
-              <a:t>SCAN TO EXPLORE</a:t>
-            </a:r>
-          </a:p>
-        </p:txBody>
-      </p:sp>
-      <p:sp>
-        <p:nvSpPr>
-          <p:cNvPr id="24" name="Rounded Rectangle 23"/>
-          <p:cNvSpPr/>
-          <p:nvPr/>
-        </p:nvSpPr>
-        <p:spPr>
-          <a:xfrm>
-            <a:off x="8092440" y="1737360"/>
-            <a:ext cx="1691640" cy="1691640"/>
-          </a:xfrm>
-          <a:prstGeom prst="roundRect">
-            <a:avLst>
-              <a:gd name="adj" fmla="val 6000"/>
-            </a:avLst>
-          </a:prstGeom>
-          <a:solidFill>
-            <a:srgbClr val="FFFFFF"/>
-          </a:solidFill>
-          <a:ln>
-            <a:noFill/>
-          </a:ln>
-          <a:effectLst/>
-        </p:spPr>
-        <p:style>
-          <a:lnRef idx="1">
-            <a:schemeClr val="accent1"/>
-          </a:lnRef>
-          <a:fillRef idx="3">
-            <a:schemeClr val="accent1"/>
-          </a:fillRef>
-          <a:effectRef idx="2">
-            <a:schemeClr val="accent1"/>
-          </a:effectRef>
-          <a:fontRef idx="minor">
-            <a:schemeClr val="lt1"/>
-          </a:fontRef>
-        </p:style>
-        <p:txBody>
-          <a:bodyPr rtlCol="0" anchor="ctr"/>
-          <a:lstStyle/>
-          <a:p>
-            <a:pPr algn="ctr"/>
-          </a:p>
-        </p:txBody>
-      </p:sp>
-      <p:pic>
-        <p:nvPicPr>
-          <p:cNvPr id="25" name="Picture 24" descr="image.png"/>
-          <p:cNvPicPr>
-            <a:picLocks noChangeAspect="1"/>
-          </p:cNvPicPr>
-          <p:nvPr/>
-        </p:nvPicPr>
-        <p:blipFill>
-          <a:blip r:embed="rId5"/>
-          <a:stretch>
-            <a:fillRect/>
-          </a:stretch>
-        </p:blipFill>
-        <p:spPr>
-          <a:xfrm>
-            <a:off x="8183879" y="1828800"/>
-            <a:ext cx="1508760" cy="1508760"/>
-          </a:xfrm>
-          <a:prstGeom prst="rect">
-            <a:avLst/>
-          </a:prstGeom>
-        </p:spPr>
-      </p:pic>
-      <p:sp>
-        <p:nvSpPr>
-          <p:cNvPr id="26" name="TextBox 25"/>
-          <p:cNvSpPr txBox="1"/>
-          <p:nvPr/>
-        </p:nvSpPr>
-        <p:spPr>
-          <a:xfrm>
-            <a:off x="8046719" y="3520440"/>
-            <a:ext cx="1783080" cy="274320"/>
-          </a:xfrm>
-          <a:prstGeom prst="rect">
-            <a:avLst/>
-          </a:prstGeom>
-          <a:noFill/>
-        </p:spPr>
-        <p:txBody>
-          <a:bodyPr wrap="square" anchor="t" lIns="36576" rIns="36576" tIns="18288" bIns="18288">
-            <a:spAutoFit/>
-          </a:bodyPr>
-          <a:lstStyle/>
-          <a:p>
-            <a:pPr algn="ctr">
+              <a:rPr sz="1050" b="1">
+                <a:solidFill>
+                  <a:srgbClr val="138A36"/>
+                </a:solidFill>
+                <a:latin typeface="Calibri"/>
+              </a:rPr>
+              <a:t>▸ </a:t>
+            </a:r>
+            <a:r>
+              <a:rPr sz="1200" b="1">
+                <a:solidFill>
+                  <a:srgbClr val="0B2A5B"/>
+                </a:solidFill>
+                <a:latin typeface="Calibri"/>
+              </a:rPr>
+              <a:t>Drain3 library</a:t>
+            </a:r>
+          </a:p>
+          <a:p>
+            <a:pPr>
+              <a:spcAft>
+                <a:spcPts val="1600"/>
+              </a:spcAft>
+            </a:pPr>
+            <a:r>
+              <a:rPr sz="950" b="0">
+                <a:solidFill>
+                  <a:srgbClr val="1F5FBF"/>
+                </a:solidFill>
+                <a:latin typeface="Calibri"/>
+              </a:rPr>
+              <a:t>    </a:t>
+            </a:r>
+            <a:r>
+              <a:rPr sz="1050" b="0" u="sng">
+                <a:solidFill>
+                  <a:srgbClr val="1F5FBF"/>
+                </a:solidFill>
+                <a:latin typeface="Calibri"/>
+                <a:hlinkClick r:id="rId4"/>
+              </a:rPr>
+              <a:t>github.com/logpai/Drain3</a:t>
+            </a:r>
+          </a:p>
+          <a:p>
+            <a:pPr>
               <a:spcAft>
                 <a:spcPts val="0"/>
               </a:spcAft>
             </a:pPr>
             <a:r>
+              <a:rPr sz="1050" b="1">
+                <a:solidFill>
+                  <a:srgbClr val="138A36"/>
+                </a:solidFill>
+                <a:latin typeface="Calibri"/>
+              </a:rPr>
+              <a:t>▸ </a:t>
+            </a:r>
+            <a:r>
               <a:rPr sz="1200" b="1">
                 <a:solidFill>
-                  <a:srgbClr val="F58220"/>
-                </a:solidFill>
-                <a:latin typeface="Calibri"/>
-              </a:rPr>
-              <a:t>PROTOTYPE</a:t>
-            </a:r>
-          </a:p>
-        </p:txBody>
-      </p:sp>
-      <p:sp>
-        <p:nvSpPr>
-          <p:cNvPr id="27" name="TextBox 26"/>
-          <p:cNvSpPr txBox="1"/>
-          <p:nvPr/>
-        </p:nvSpPr>
-        <p:spPr>
-          <a:xfrm>
-            <a:off x="8001000" y="3794760"/>
-            <a:ext cx="1874519" cy="457200"/>
-          </a:xfrm>
-          <a:prstGeom prst="rect">
-            <a:avLst/>
-          </a:prstGeom>
-          <a:noFill/>
-        </p:spPr>
-        <p:txBody>
-          <a:bodyPr wrap="square" anchor="t" lIns="36576" rIns="36576" tIns="18288" bIns="18288">
-            <a:spAutoFit/>
-          </a:bodyPr>
-          <a:lstStyle/>
-          <a:p>
-            <a:pPr algn="ctr">
+                  <a:srgbClr val="0B2A5B"/>
+                </a:solidFill>
+                <a:latin typeface="Calibri"/>
+              </a:rPr>
+              <a:t>scikit-learn</a:t>
+            </a:r>
+          </a:p>
+          <a:p>
+            <a:pPr>
+              <a:spcAft>
+                <a:spcPts val="1600"/>
+              </a:spcAft>
+            </a:pPr>
+            <a:r>
+              <a:rPr sz="950" b="0">
+                <a:solidFill>
+                  <a:srgbClr val="1F5FBF"/>
+                </a:solidFill>
+                <a:latin typeface="Calibri"/>
+              </a:rPr>
+              <a:t>    </a:t>
+            </a:r>
+            <a:r>
+              <a:rPr sz="1050" b="0" u="sng">
+                <a:solidFill>
+                  <a:srgbClr val="1F5FBF"/>
+                </a:solidFill>
+                <a:latin typeface="Calibri"/>
+                <a:hlinkClick r:id="rId19"/>
+              </a:rPr>
+              <a:t>scikit-learn.org</a:t>
+            </a:r>
+          </a:p>
+          <a:p>
+            <a:pPr>
               <a:spcAft>
                 <a:spcPts val="0"/>
               </a:spcAft>
             </a:pPr>
             <a:r>
-              <a:rPr sz="950" b="0">
-                <a:solidFill>
-                  <a:srgbClr val="1E2530"/>
-                </a:solidFill>
-                <a:latin typeface="Calibri"/>
-              </a:rPr>
-              <a:t/>
-            </a:r>
-            <a:r>
-              <a:rPr sz="900" b="1">
-                <a:solidFill>
-                  <a:srgbClr val="FFFFFF"/>
-                </a:solidFill>
-                <a:latin typeface="Calibri"/>
-                <a:hlinkClick r:id="rId7"/>
-              </a:rPr>
-              <a:t>sih2026-w6sr.vercel.app</a:t>
-            </a:r>
-          </a:p>
-        </p:txBody>
-      </p:sp>
-      <p:sp>
-        <p:nvSpPr>
-          <p:cNvPr id="28" name="Rounded Rectangle 27"/>
-          <p:cNvSpPr/>
-          <p:nvPr/>
-        </p:nvSpPr>
-        <p:spPr>
-          <a:xfrm>
-            <a:off x="9994392" y="1737360"/>
-            <a:ext cx="1691640" cy="1691640"/>
-          </a:xfrm>
-          <a:prstGeom prst="roundRect">
-            <a:avLst>
-              <a:gd name="adj" fmla="val 6000"/>
-            </a:avLst>
-          </a:prstGeom>
-          <a:solidFill>
-            <a:srgbClr val="FFFFFF"/>
-          </a:solidFill>
-          <a:ln>
-            <a:noFill/>
-          </a:ln>
-          <a:effectLst/>
-        </p:spPr>
-        <p:style>
-          <a:lnRef idx="1">
-            <a:schemeClr val="accent1"/>
-          </a:lnRef>
-          <a:fillRef idx="3">
-            <a:schemeClr val="accent1"/>
-          </a:fillRef>
-          <a:effectRef idx="2">
-            <a:schemeClr val="accent1"/>
-          </a:effectRef>
-          <a:fontRef idx="minor">
-            <a:schemeClr val="lt1"/>
-          </a:fontRef>
-        </p:style>
-        <p:txBody>
-          <a:bodyPr rtlCol="0" anchor="ctr"/>
-          <a:lstStyle/>
-          <a:p>
-            <a:pPr algn="ctr"/>
-          </a:p>
-        </p:txBody>
-      </p:sp>
-      <p:pic>
-        <p:nvPicPr>
-          <p:cNvPr id="29" name="Picture 28" descr="image.png"/>
-          <p:cNvPicPr>
-            <a:picLocks noChangeAspect="1"/>
-          </p:cNvPicPr>
-          <p:nvPr/>
-        </p:nvPicPr>
-        <p:blipFill>
-          <a:blip r:embed="rId6"/>
-          <a:stretch>
-            <a:fillRect/>
-          </a:stretch>
-        </p:blipFill>
-        <p:spPr>
-          <a:xfrm>
-            <a:off x="10085832" y="1828800"/>
-            <a:ext cx="1508760" cy="1508760"/>
-          </a:xfrm>
-          <a:prstGeom prst="rect">
-            <a:avLst/>
-          </a:prstGeom>
-        </p:spPr>
-      </p:pic>
-      <p:sp>
-        <p:nvSpPr>
-          <p:cNvPr id="30" name="TextBox 29"/>
-          <p:cNvSpPr txBox="1"/>
-          <p:nvPr/>
-        </p:nvSpPr>
-        <p:spPr>
-          <a:xfrm>
-            <a:off x="9948672" y="3520440"/>
-            <a:ext cx="1783080" cy="274320"/>
-          </a:xfrm>
-          <a:prstGeom prst="rect">
-            <a:avLst/>
-          </a:prstGeom>
-          <a:noFill/>
-        </p:spPr>
-        <p:txBody>
-          <a:bodyPr wrap="square" anchor="t" lIns="36576" rIns="36576" tIns="18288" bIns="18288">
-            <a:spAutoFit/>
-          </a:bodyPr>
-          <a:lstStyle/>
-          <a:p>
-            <a:pPr algn="ctr">
+              <a:rPr sz="1050" b="1">
+                <a:solidFill>
+                  <a:srgbClr val="138A36"/>
+                </a:solidFill>
+                <a:latin typeface="Calibri"/>
+              </a:rPr>
+              <a:t>▸ </a:t>
+            </a:r>
+            <a:r>
+              <a:rPr sz="1200" b="1">
+                <a:solidFill>
+                  <a:srgbClr val="0B2A5B"/>
+                </a:solidFill>
+                <a:latin typeface="Calibri"/>
+              </a:rPr>
+              <a:t>FastAPI</a:t>
+            </a:r>
+          </a:p>
+          <a:p>
+            <a:pPr>
               <a:spcAft>
-                <a:spcPts val="0"/>
+                <a:spcPts val="1600"/>
               </a:spcAft>
             </a:pPr>
             <a:r>
-              <a:rPr sz="1200" b="1">
-                <a:solidFill>
-                  <a:srgbClr val="F58220"/>
-                </a:solidFill>
-                <a:latin typeface="Calibri"/>
-              </a:rPr>
-              <a:t>SOURCE CODE</a:t>
-            </a:r>
-          </a:p>
-        </p:txBody>
-      </p:sp>
-      <p:sp>
-        <p:nvSpPr>
-          <p:cNvPr id="31" name="TextBox 30"/>
-          <p:cNvSpPr txBox="1"/>
-          <p:nvPr/>
-        </p:nvSpPr>
-        <p:spPr>
-          <a:xfrm>
-            <a:off x="9811512" y="3794760"/>
-            <a:ext cx="2057400" cy="457200"/>
-          </a:xfrm>
-          <a:prstGeom prst="rect">
-            <a:avLst/>
-          </a:prstGeom>
-          <a:noFill/>
-        </p:spPr>
-        <p:txBody>
-          <a:bodyPr wrap="square" anchor="t" lIns="36576" rIns="36576" tIns="18288" bIns="18288">
-            <a:spAutoFit/>
-          </a:bodyPr>
-          <a:lstStyle/>
-          <a:p>
-            <a:pPr algn="ctr">
-              <a:spcAft>
-                <a:spcPts val="0"/>
-              </a:spcAft>
-            </a:pPr>
-            <a:r>
               <a:rPr sz="950" b="0">
                 <a:solidFill>
-                  <a:srgbClr val="1E2530"/>
-                </a:solidFill>
-                <a:latin typeface="Calibri"/>
-              </a:rPr>
-              <a:t/>
-            </a:r>
-            <a:r>
-              <a:rPr sz="900" b="1">
-                <a:solidFill>
-                  <a:srgbClr val="FFFFFF"/>
-                </a:solidFill>
-                <a:latin typeface="Calibri"/>
-                <a:hlinkClick r:id="rId8"/>
-              </a:rPr>
-              <a:t>github.com/agrwl-utkarsh/sih2026</a:t>
-            </a:r>
-          </a:p>
-        </p:txBody>
-      </p:sp>
-      <p:sp>
-        <p:nvSpPr>
-          <p:cNvPr id="32" name="Rectangle 31"/>
-          <p:cNvSpPr/>
-          <p:nvPr/>
-        </p:nvSpPr>
-        <p:spPr>
-          <a:xfrm>
-            <a:off x="8275320" y="4526280"/>
-            <a:ext cx="3227832" cy="27432"/>
-          </a:xfrm>
-          <a:prstGeom prst="rect">
-            <a:avLst/>
-          </a:prstGeom>
-          <a:solidFill>
-            <a:srgbClr val="3A5585"/>
-          </a:solidFill>
-          <a:ln>
-            <a:noFill/>
-          </a:ln>
-          <a:effectLst/>
-        </p:spPr>
-        <p:style>
-          <a:lnRef idx="1">
-            <a:schemeClr val="accent1"/>
-          </a:lnRef>
-          <a:fillRef idx="3">
-            <a:schemeClr val="accent1"/>
-          </a:fillRef>
-          <a:effectRef idx="2">
-            <a:schemeClr val="accent1"/>
-          </a:effectRef>
-          <a:fontRef idx="minor">
-            <a:schemeClr val="lt1"/>
-          </a:fontRef>
-        </p:style>
-        <p:txBody>
-          <a:bodyPr rtlCol="0" anchor="ctr"/>
-          <a:lstStyle/>
-          <a:p>
-            <a:pPr algn="ctr"/>
-          </a:p>
-        </p:txBody>
-      </p:sp>
-      <p:sp>
-        <p:nvSpPr>
-          <p:cNvPr id="33" name="TextBox 32"/>
-          <p:cNvSpPr txBox="1"/>
-          <p:nvPr/>
-        </p:nvSpPr>
-        <p:spPr>
-          <a:xfrm>
-            <a:off x="7909560" y="4754880"/>
-            <a:ext cx="3959352" cy="731520"/>
-          </a:xfrm>
-          <a:prstGeom prst="rect">
-            <a:avLst/>
-          </a:prstGeom>
-          <a:noFill/>
-        </p:spPr>
-        <p:txBody>
-          <a:bodyPr wrap="square" anchor="t" lIns="36576" rIns="36576" tIns="18288" bIns="18288">
-            <a:spAutoFit/>
-          </a:bodyPr>
-          <a:lstStyle/>
-          <a:p>
-            <a:pPr algn="ctr">
-              <a:spcAft>
-                <a:spcPts val="0"/>
-              </a:spcAft>
-            </a:pPr>
-            <a:r>
-              <a:rPr sz="3000" b="1">
-                <a:solidFill>
-                  <a:srgbClr val="FFFFFF"/>
-                </a:solidFill>
-                <a:latin typeface="Calibri"/>
-              </a:rPr>
-              <a:t>Thank you!</a:t>
-            </a:r>
-          </a:p>
-        </p:txBody>
-      </p:sp>
-      <p:sp>
-        <p:nvSpPr>
-          <p:cNvPr id="34" name="TextBox 33"/>
-          <p:cNvSpPr txBox="1"/>
-          <p:nvPr/>
-        </p:nvSpPr>
-        <p:spPr>
-          <a:xfrm>
-            <a:off x="7909560" y="5486400"/>
-            <a:ext cx="3959352" cy="640080"/>
-          </a:xfrm>
-          <a:prstGeom prst="rect">
-            <a:avLst/>
-          </a:prstGeom>
-          <a:noFill/>
-        </p:spPr>
-        <p:txBody>
-          <a:bodyPr wrap="square" anchor="t" lIns="36576" rIns="36576" tIns="18288" bIns="18288">
-            <a:spAutoFit/>
-          </a:bodyPr>
-          <a:lstStyle/>
-          <a:p>
-            <a:pPr algn="ctr">
-              <a:spcAft>
-                <a:spcPts val="0"/>
-              </a:spcAft>
-            </a:pPr>
-            <a:r>
-              <a:rPr sz="1300" b="0">
-                <a:solidFill>
-                  <a:srgbClr val="C9D6EA"/>
-                </a:solidFill>
-                <a:latin typeface="Calibri"/>
-              </a:rPr>
-              <a:t>Questions are welcome.</a:t>
-            </a:r>
-          </a:p>
-        </p:txBody>
-      </p:sp>
-      <p:sp>
-        <p:nvSpPr>
-          <p:cNvPr id="35" name="Oval 34"/>
-          <p:cNvSpPr/>
-          <p:nvPr/>
-        </p:nvSpPr>
-        <p:spPr>
-          <a:xfrm>
-            <a:off x="320040" y="182880"/>
-            <a:ext cx="1463040" cy="731520"/>
-          </a:xfrm>
-          <a:prstGeom prst="ellipse">
-            <a:avLst/>
-          </a:prstGeom>
-          <a:noFill/>
-          <a:ln w="25400">
-            <a:solidFill>
-              <a:srgbClr val="8064A2"/>
-            </a:solidFill>
-          </a:ln>
-          <a:effectLst/>
-        </p:spPr>
-        <p:style>
-          <a:lnRef idx="1">
-            <a:schemeClr val="accent1"/>
-          </a:lnRef>
-          <a:fillRef idx="3">
-            <a:schemeClr val="accent1"/>
-          </a:fillRef>
-          <a:effectRef idx="2">
-            <a:schemeClr val="accent1"/>
-          </a:effectRef>
-          <a:fontRef idx="minor">
-            <a:schemeClr val="lt1"/>
-          </a:fontRef>
-        </p:style>
-        <p:txBody>
-          <a:bodyPr rtlCol="0" anchor="ctr" wrap="square" lIns="45720" rIns="45720" tIns="18288" bIns="18288"/>
-          <a:lstStyle/>
-          <a:p>
-            <a:pPr algn="ctr"/>
-            <a:r>
-              <a:rPr sz="1200" b="1">
-                <a:solidFill>
-                  <a:srgbClr val="F58220"/>
-                </a:solidFill>
-                <a:latin typeface="Calibri"/>
-              </a:rPr>
-              <a:t>[Team Name]</a:t>
-            </a:r>
-          </a:p>
-        </p:txBody>
-      </p:sp>
-      <p:pic>
-        <p:nvPicPr>
-          <p:cNvPr id="36" name="Picture 35" descr="sih_icon_s.png"/>
-          <p:cNvPicPr>
-            <a:picLocks noChangeAspect="1"/>
-          </p:cNvPicPr>
-          <p:nvPr/>
-        </p:nvPicPr>
-        <p:blipFill>
-          <a:blip r:embed="rId10"/>
-          <a:stretch>
-            <a:fillRect/>
-          </a:stretch>
-        </p:blipFill>
-        <p:spPr>
-          <a:xfrm>
-            <a:off x="10076688" y="91440"/>
-            <a:ext cx="676894" cy="822960"/>
-          </a:xfrm>
-          <a:prstGeom prst="rect">
-            <a:avLst/>
-          </a:prstGeom>
-        </p:spPr>
-      </p:pic>
-      <p:sp>
-        <p:nvSpPr>
-          <p:cNvPr id="37" name="TextBox 36"/>
-          <p:cNvSpPr txBox="1"/>
-          <p:nvPr/>
-        </p:nvSpPr>
-        <p:spPr>
-          <a:xfrm>
-            <a:off x="10789920" y="109728"/>
-            <a:ext cx="1371600" cy="777240"/>
-          </a:xfrm>
-          <a:prstGeom prst="rect">
-            <a:avLst/>
-          </a:prstGeom>
-          <a:noFill/>
-        </p:spPr>
-        <p:txBody>
-          <a:bodyPr wrap="square" lIns="36576" rIns="36576" tIns="18288" bIns="18288" anchor="t">
-            <a:spAutoFit/>
-          </a:bodyPr>
-          <a:lstStyle/>
-          <a:p>
-            <a:pPr algn="ctr"/>
-            <a:r>
-              <a:rPr sz="1250" b="1">
-                <a:solidFill>
-                  <a:srgbClr val="455A64"/>
-                </a:solidFill>
-                <a:latin typeface="Calibri"/>
-              </a:rPr>
-              <a:t>SMART INDIA</a:t>
-            </a:r>
-          </a:p>
-          <a:p>
-            <a:pPr algn="ctr"/>
-            <a:r>
-              <a:rPr sz="1250" b="1">
-                <a:solidFill>
-                  <a:srgbClr val="455A64"/>
-                </a:solidFill>
-                <a:latin typeface="Calibri"/>
-              </a:rPr>
-              <a:t>HACKATHON</a:t>
-            </a:r>
-          </a:p>
-          <a:p>
-            <a:pPr algn="ctr"/>
-            <a:r>
-              <a:rPr sz="1250" b="1">
-                <a:solidFill>
-                  <a:srgbClr val="455A64"/>
-                </a:solidFill>
-                <a:latin typeface="Calibri"/>
-              </a:rPr>
-              <a:t>2026</a:t>
+                  <a:srgbClr val="1F5FBF"/>
+                </a:solidFill>
+                <a:latin typeface="Calibri"/>
+              </a:rPr>
+              <a:t>    </a:t>
+            </a:r>
+            <a:r>
+              <a:rPr sz="1050" b="0" u="sng">
+                <a:solidFill>
+                  <a:srgbClr val="1F5FBF"/>
+                </a:solidFill>
+                <a:latin typeface="Calibri"/>
+                <a:hlinkClick r:id="rId20"/>
+              </a:rPr>
+              <a:t>fastapi.tiangolo.com</a:t>
             </a:r>
           </a:p>
         </p:txBody>

</xml_diff>

<commit_message>
PPT: slide 6 as numbered academic-style references with full links
Co-authored-by: arena-agent <297053741+arena-agent@users.noreply.github.com>
</commit_message>
<xml_diff>
--- a/presentation/SIH2026_Idea_Submission.pptx
+++ b/presentation/SIH2026_Idea_Submission.pptx
@@ -22018,10 +22018,12 @@
             </a:avLst>
           </a:prstGeom>
           <a:solidFill>
-            <a:srgbClr val="0B2A5B"/>
+            <a:srgbClr val="FFFFFF"/>
           </a:solidFill>
-          <a:ln>
-            <a:noFill/>
+          <a:ln w="12700">
+            <a:solidFill>
+              <a:srgbClr val="BFBFBF"/>
+            </a:solidFill>
           </a:ln>
           <a:effectLst/>
         </p:spPr>
@@ -22077,7 +22079,7 @@
             <a:r>
               <a:rPr sz="1400" b="1">
                 <a:solidFill>
-                  <a:srgbClr val="F58220"/>
+                  <a:srgbClr val="1F4E79"/>
                 </a:solidFill>
                 <a:latin typeface="Calibri"/>
               </a:rPr>
@@ -22106,7 +22108,9 @@
             <a:srgbClr val="FFFFFF"/>
           </a:solidFill>
           <a:ln>
-            <a:noFill/>
+            <a:solidFill>
+              <a:srgbClr val="D9D9D9"/>
+            </a:solidFill>
           </a:ln>
           <a:effectLst/>
         </p:spPr>
@@ -22186,7 +22190,7 @@
             <a:r>
               <a:rPr sz="1200" b="1">
                 <a:solidFill>
-                  <a:srgbClr val="F58220"/>
+                  <a:srgbClr val="000000"/>
                 </a:solidFill>
                 <a:latin typeface="Calibri"/>
               </a:rPr>
@@ -22223,9 +22227,9 @@
               </a:spcAft>
             </a:pPr>
             <a:r>
-              <a:rPr sz="950" b="0">
-                <a:solidFill>
-                  <a:srgbClr val="1E2530"/>
+              <a:rPr sz="950" b="0" u="sng">
+                <a:solidFill>
+                  <a:srgbClr val="0563C1"/>
                 </a:solidFill>
                 <a:latin typeface="Calibri"/>
                 <a:hlinkClick r:id="rId7"/>
@@ -22233,9 +22237,9 @@
               <a:t/>
             </a:r>
             <a:r>
-              <a:rPr sz="900" b="1">
-                <a:solidFill>
-                  <a:srgbClr val="FFFFFF"/>
+              <a:rPr sz="900" b="1" u="sng">
+                <a:solidFill>
+                  <a:srgbClr val="0563C1"/>
                 </a:solidFill>
                 <a:latin typeface="Calibri"/>
                 <a:hlinkClick r:id="rId7"/>
@@ -22265,7 +22269,9 @@
             <a:srgbClr val="FFFFFF"/>
           </a:solidFill>
           <a:ln>
-            <a:noFill/>
+            <a:solidFill>
+              <a:srgbClr val="D9D9D9"/>
+            </a:solidFill>
           </a:ln>
           <a:effectLst/>
         </p:spPr>
@@ -22345,7 +22351,7 @@
             <a:r>
               <a:rPr sz="1200" b="1">
                 <a:solidFill>
-                  <a:srgbClr val="F58220"/>
+                  <a:srgbClr val="000000"/>
                 </a:solidFill>
                 <a:latin typeface="Calibri"/>
               </a:rPr>
@@ -22382,9 +22388,9 @@
               </a:spcAft>
             </a:pPr>
             <a:r>
-              <a:rPr sz="950" b="0">
-                <a:solidFill>
-                  <a:srgbClr val="1E2530"/>
+              <a:rPr sz="950" b="0" u="sng">
+                <a:solidFill>
+                  <a:srgbClr val="0563C1"/>
                 </a:solidFill>
                 <a:latin typeface="Calibri"/>
                 <a:hlinkClick r:id="rId8"/>
@@ -22392,9 +22398,9 @@
               <a:t/>
             </a:r>
             <a:r>
-              <a:rPr sz="900" b="1">
-                <a:solidFill>
-                  <a:srgbClr val="FFFFFF"/>
+              <a:rPr sz="900" b="1" u="sng">
+                <a:solidFill>
+                  <a:srgbClr val="0563C1"/>
                 </a:solidFill>
                 <a:latin typeface="Calibri"/>
                 <a:hlinkClick r:id="rId8"/>
@@ -22419,7 +22425,7 @@
             <a:avLst/>
           </a:prstGeom>
           <a:solidFill>
-            <a:srgbClr val="3A5585"/>
+            <a:srgbClr val="D9D9D9"/>
           </a:solidFill>
           <a:ln>
             <a:noFill/>
@@ -22478,7 +22484,7 @@
             <a:r>
               <a:rPr sz="3000" b="1">
                 <a:solidFill>
-                  <a:srgbClr val="FFFFFF"/>
+                  <a:srgbClr val="1F4E79"/>
                 </a:solidFill>
                 <a:latin typeface="Calibri"/>
               </a:rPr>
@@ -22517,7 +22523,7 @@
             <a:r>
               <a:rPr sz="1300" b="0">
                 <a:solidFill>
-                  <a:srgbClr val="C9D6EA"/>
+                  <a:srgbClr val="404040"/>
                 </a:solidFill>
                 <a:latin typeface="Calibri"/>
               </a:rPr>
@@ -22664,142 +22670,14 @@
       </p:sp>
       <p:sp>
         <p:nvSpPr>
-          <p:cNvPr id="39" name="Rounded Rectangle 38"/>
-          <p:cNvSpPr/>
-          <p:nvPr/>
-        </p:nvSpPr>
-        <p:spPr>
-          <a:xfrm>
-            <a:off x="365760" y="1097280"/>
-            <a:ext cx="7315200" cy="2148840"/>
-          </a:xfrm>
-          <a:prstGeom prst="roundRect">
-            <a:avLst>
-              <a:gd name="adj" fmla="val 4000"/>
-            </a:avLst>
-          </a:prstGeom>
-          <a:solidFill>
-            <a:srgbClr val="FFFFFF"/>
-          </a:solidFill>
-          <a:ln w="12700">
-            <a:solidFill>
-              <a:srgbClr val="D5DCE6"/>
-            </a:solidFill>
-          </a:ln>
-          <a:effectLst/>
-        </p:spPr>
-        <p:style>
-          <a:lnRef idx="1">
-            <a:schemeClr val="accent1"/>
-          </a:lnRef>
-          <a:fillRef idx="3">
-            <a:schemeClr val="accent1"/>
-          </a:fillRef>
-          <a:effectRef idx="2">
-            <a:schemeClr val="accent1"/>
-          </a:effectRef>
-          <a:fontRef idx="minor">
-            <a:schemeClr val="lt1"/>
-          </a:fontRef>
-        </p:style>
-        <p:txBody>
-          <a:bodyPr rtlCol="0" anchor="ctr"/>
-          <a:lstStyle/>
-          <a:p>
-            <a:pPr algn="ctr"/>
-          </a:p>
-        </p:txBody>
-      </p:sp>
-      <p:sp>
-        <p:nvSpPr>
-          <p:cNvPr id="40" name="Rounded Rectangle 39"/>
-          <p:cNvSpPr/>
-          <p:nvPr/>
-        </p:nvSpPr>
-        <p:spPr>
-          <a:xfrm>
-            <a:off x="365760" y="1097280"/>
-            <a:ext cx="7315200" cy="384048"/>
-          </a:xfrm>
-          <a:prstGeom prst="roundRect">
-            <a:avLst>
-              <a:gd name="adj" fmla="val 18000"/>
-            </a:avLst>
-          </a:prstGeom>
-          <a:solidFill>
-            <a:srgbClr val="0B2A5B"/>
-          </a:solidFill>
-          <a:ln>
-            <a:noFill/>
-          </a:ln>
-          <a:effectLst/>
-        </p:spPr>
-        <p:style>
-          <a:lnRef idx="1">
-            <a:schemeClr val="accent1"/>
-          </a:lnRef>
-          <a:fillRef idx="3">
-            <a:schemeClr val="accent1"/>
-          </a:fillRef>
-          <a:effectRef idx="2">
-            <a:schemeClr val="accent1"/>
-          </a:effectRef>
-          <a:fontRef idx="minor">
-            <a:schemeClr val="lt1"/>
-          </a:fontRef>
-        </p:style>
-        <p:txBody>
-          <a:bodyPr rtlCol="0" anchor="ctr"/>
-          <a:lstStyle/>
-          <a:p>
-            <a:pPr algn="ctr"/>
-          </a:p>
-        </p:txBody>
-      </p:sp>
-      <p:sp>
-        <p:nvSpPr>
-          <p:cNvPr id="41" name="TextBox 40"/>
+          <p:cNvPr id="39" name="TextBox 38"/>
           <p:cNvSpPr txBox="1"/>
           <p:nvPr/>
         </p:nvSpPr>
         <p:spPr>
           <a:xfrm>
-            <a:off x="530352" y="1097280"/>
-            <a:ext cx="7040880" cy="384048"/>
-          </a:xfrm>
-          <a:prstGeom prst="rect">
-            <a:avLst/>
-          </a:prstGeom>
-          <a:noFill/>
-        </p:spPr>
-        <p:txBody>
-          <a:bodyPr wrap="square" lIns="36576" rIns="36576" tIns="9144" bIns="9144" anchor="ctr">
-            <a:spAutoFit/>
-          </a:bodyPr>
-          <a:lstStyle/>
-          <a:p>
-            <a:r>
-              <a:rPr sz="1350" b="1">
-                <a:solidFill>
-                  <a:srgbClr val="FFFFFF"/>
-                </a:solidFill>
-                <a:latin typeface="Calibri"/>
-              </a:rPr>
-              <a:t>GOVERNMENT OF INDIA</a:t>
-            </a:r>
-          </a:p>
-        </p:txBody>
-      </p:sp>
-      <p:sp>
-        <p:nvSpPr>
-          <p:cNvPr id="42" name="TextBox 41"/>
-          <p:cNvSpPr txBox="1"/>
-          <p:nvPr/>
-        </p:nvSpPr>
-        <p:spPr>
-          <a:xfrm>
-            <a:off x="530352" y="1645920"/>
-            <a:ext cx="3447288" cy="1554480"/>
+            <a:off x="365760" y="1051560"/>
+            <a:ext cx="7406640" cy="5303520"/>
           </a:xfrm>
           <a:prstGeom prst="rect">
             <a:avLst/>
@@ -22813,1175 +22691,541 @@
           <a:lstStyle/>
           <a:p>
             <a:pPr>
+              <a:spcBef>
+                <a:spcPts val="0"/>
+              </a:spcBef>
               <a:spcAft>
-                <a:spcPts val="0"/>
+                <a:spcPts val="200"/>
               </a:spcAft>
             </a:pPr>
             <a:r>
-              <a:rPr sz="1050" b="1">
-                <a:solidFill>
-                  <a:srgbClr val="0B2A5B"/>
-                </a:solidFill>
-                <a:latin typeface="Calibri"/>
-              </a:rPr>
-              <a:t>▸ </a:t>
-            </a:r>
-            <a:r>
-              <a:rPr sz="1150" b="1">
-                <a:solidFill>
-                  <a:srgbClr val="0B2A5B"/>
-                </a:solidFill>
-                <a:latin typeface="Calibri"/>
-              </a:rPr>
-              <a:t>CERT-In Cyber Security Directions, 2022</a:t>
+              <a:rPr sz="1400" b="1" i="0">
+                <a:solidFill>
+                  <a:srgbClr val="1F4E79"/>
+                </a:solidFill>
+                <a:latin typeface="Arial"/>
+              </a:rPr>
+              <a:t>❖  </a:t>
+            </a:r>
+            <a:r>
+              <a:rPr sz="1400" b="1" i="0" u="sng">
+                <a:solidFill>
+                  <a:srgbClr val="1F4E79"/>
+                </a:solidFill>
+                <a:latin typeface="Arial"/>
+              </a:rPr>
+              <a:t>Research Papers</a:t>
             </a:r>
           </a:p>
           <a:p>
             <a:pPr>
               <a:spcAft>
-                <a:spcPts val="1100"/>
+                <a:spcPts val="450"/>
               </a:spcAft>
             </a:pPr>
             <a:r>
-              <a:rPr sz="950" b="0">
-                <a:solidFill>
-                  <a:srgbClr val="1F5FBF"/>
-                </a:solidFill>
-                <a:latin typeface="Calibri"/>
-              </a:rPr>
-              <a:t>    </a:t>
-            </a:r>
-            <a:r>
-              <a:rPr sz="1050" b="0" u="sng">
-                <a:solidFill>
-                  <a:srgbClr val="1F5FBF"/>
-                </a:solidFill>
-                <a:latin typeface="Calibri"/>
-                <a:hlinkClick r:id="rId3"/>
-              </a:rPr>
-              <a:t>cert-in.org.in</a:t>
+              <a:rPr sz="1050" b="1" i="0">
+                <a:solidFill>
+                  <a:srgbClr val="000000"/>
+                </a:solidFill>
+                <a:latin typeface="Arial"/>
+              </a:rPr>
+              <a:t>[1]  </a:t>
+            </a:r>
+            <a:r>
+              <a:rPr sz="1050" b="0" i="0">
+                <a:solidFill>
+                  <a:srgbClr val="1A1A1A"/>
+                </a:solidFill>
+                <a:latin typeface="Arial"/>
+              </a:rPr>
+              <a:t>P. He, J. Zhu, Z. Zheng, M. R. Lyu, "Drain: An Online Log Parsing Approach with Fixed Depth Tree," IEEE ICWS, 2017. </a:t>
+            </a:r>
+            <a:r>
+              <a:rPr sz="1000" b="0" i="0" u="sng">
+                <a:solidFill>
+                  <a:srgbClr val="0563C1"/>
+                </a:solidFill>
+                <a:latin typeface="Arial"/>
+                <a:hlinkClick r:id="rId15"/>
+              </a:rPr>
+              <a:t>https://doi.org/10.1109/ICWS.2017.13</a:t>
             </a:r>
           </a:p>
           <a:p>
             <a:pPr>
               <a:spcAft>
-                <a:spcPts val="0"/>
+                <a:spcPts val="450"/>
               </a:spcAft>
             </a:pPr>
             <a:r>
-              <a:rPr sz="1050" b="1">
-                <a:solidFill>
-                  <a:srgbClr val="0B2A5B"/>
-                </a:solidFill>
-                <a:latin typeface="Calibri"/>
-              </a:rPr>
-              <a:t>▸ </a:t>
-            </a:r>
-            <a:r>
-              <a:rPr sz="1150" b="1">
-                <a:solidFill>
-                  <a:srgbClr val="0B2A5B"/>
-                </a:solidFill>
-                <a:latin typeface="Calibri"/>
-              </a:rPr>
-              <a:t>CERT-In cyber incidents 2020–2024 (OGD)</a:t>
+              <a:rPr sz="1050" b="1" i="0">
+                <a:solidFill>
+                  <a:srgbClr val="000000"/>
+                </a:solidFill>
+                <a:latin typeface="Arial"/>
+              </a:rPr>
+              <a:t>[2]  </a:t>
+            </a:r>
+            <a:r>
+              <a:rPr sz="1050" b="0" i="0">
+                <a:solidFill>
+                  <a:srgbClr val="1A1A1A"/>
+                </a:solidFill>
+                <a:latin typeface="Arial"/>
+              </a:rPr>
+              <a:t>J. Zhu et al., "Tools and Benchmarks for Automated Log Parsing," IEEE/ACM ICSE-SEIP, 2019. </a:t>
+            </a:r>
+            <a:r>
+              <a:rPr sz="1000" b="0" i="0" u="sng">
+                <a:solidFill>
+                  <a:srgbClr val="0563C1"/>
+                </a:solidFill>
+                <a:latin typeface="Arial"/>
+                <a:hlinkClick r:id="rId17"/>
+              </a:rPr>
+              <a:t>https://arxiv.org/abs/1811.03509</a:t>
             </a:r>
           </a:p>
           <a:p>
             <a:pPr>
               <a:spcAft>
-                <a:spcPts val="1100"/>
+                <a:spcPts val="450"/>
               </a:spcAft>
             </a:pPr>
             <a:r>
-              <a:rPr sz="950" b="0">
-                <a:solidFill>
-                  <a:srgbClr val="1F5FBF"/>
-                </a:solidFill>
-                <a:latin typeface="Calibri"/>
-              </a:rPr>
-              <a:t>    </a:t>
-            </a:r>
-            <a:r>
-              <a:rPr sz="1050" b="0" u="sng">
-                <a:solidFill>
-                  <a:srgbClr val="1F5FBF"/>
-                </a:solidFill>
-                <a:latin typeface="Calibri"/>
-                <a:hlinkClick r:id="rId11"/>
-              </a:rPr>
-              <a:t>data.gov.in</a:t>
+              <a:rPr sz="1050" b="1" i="0">
+                <a:solidFill>
+                  <a:srgbClr val="000000"/>
+                </a:solidFill>
+                <a:latin typeface="Arial"/>
+              </a:rPr>
+              <a:t>[3]  </a:t>
+            </a:r>
+            <a:r>
+              <a:rPr sz="1050" b="0" i="0">
+                <a:solidFill>
+                  <a:srgbClr val="1A1A1A"/>
+                </a:solidFill>
+                <a:latin typeface="Arial"/>
+              </a:rPr>
+              <a:t>J. Zhu, S. He, P. He, J. Liu, M. R. Lyu, "Loghub: A Large Collection of System Log Datasets for AI-driven Log Analytics," IEEE ISSRE, 2023. </a:t>
+            </a:r>
+            <a:r>
+              <a:rPr sz="1000" b="0" i="0" u="sng">
+                <a:solidFill>
+                  <a:srgbClr val="0563C1"/>
+                </a:solidFill>
+                <a:latin typeface="Arial"/>
+                <a:hlinkClick r:id="rId16"/>
+              </a:rPr>
+              <a:t>https://arxiv.org/abs/2008.06448</a:t>
+            </a:r>
+          </a:p>
+          <a:p>
+            <a:pPr>
+              <a:spcBef>
+                <a:spcPts val="800"/>
+              </a:spcBef>
+              <a:spcAft>
+                <a:spcPts val="200"/>
+              </a:spcAft>
+            </a:pPr>
+            <a:r>
+              <a:rPr sz="1400" b="1" i="0">
+                <a:solidFill>
+                  <a:srgbClr val="1F4E79"/>
+                </a:solidFill>
+                <a:latin typeface="Arial"/>
+              </a:rPr>
+              <a:t>❖  </a:t>
+            </a:r>
+            <a:r>
+              <a:rPr sz="1400" b="1" i="0" u="sng">
+                <a:solidFill>
+                  <a:srgbClr val="1F4E79"/>
+                </a:solidFill>
+                <a:latin typeface="Arial"/>
+              </a:rPr>
+              <a:t>Government of India</a:t>
             </a:r>
           </a:p>
           <a:p>
             <a:pPr>
               <a:spcAft>
-                <a:spcPts val="0"/>
+                <a:spcPts val="450"/>
               </a:spcAft>
             </a:pPr>
             <a:r>
-              <a:rPr sz="1050" b="1">
-                <a:solidFill>
-                  <a:srgbClr val="0B2A5B"/>
-                </a:solidFill>
-                <a:latin typeface="Calibri"/>
-              </a:rPr>
-              <a:t>▸ </a:t>
-            </a:r>
-            <a:r>
-              <a:rPr sz="1150" b="1">
-                <a:solidFill>
-                  <a:srgbClr val="0B2A5B"/>
-                </a:solidFill>
-                <a:latin typeface="Calibri"/>
-              </a:rPr>
-              <a:t>PIB: CERT-In, India's frontline defender</a:t>
+              <a:rPr sz="1050" b="1" i="0">
+                <a:solidFill>
+                  <a:srgbClr val="000000"/>
+                </a:solidFill>
+                <a:latin typeface="Arial"/>
+              </a:rPr>
+              <a:t>[4]  </a:t>
+            </a:r>
+            <a:r>
+              <a:rPr sz="1050" b="0" i="0">
+                <a:solidFill>
+                  <a:srgbClr val="1A1A1A"/>
+                </a:solidFill>
+                <a:latin typeface="Arial"/>
+              </a:rPr>
+              <a:t>CERT-In, Directions under Section 70B(6) of the IT Act, 2000 (log retention &amp; incident reporting), 28 April 2022. </a:t>
+            </a:r>
+            <a:r>
+              <a:rPr sz="1000" b="0" i="0" u="sng">
+                <a:solidFill>
+                  <a:srgbClr val="0563C1"/>
+                </a:solidFill>
+                <a:latin typeface="Arial"/>
+                <a:hlinkClick r:id="rId3"/>
+              </a:rPr>
+              <a:t>https://www.cert-in.org.in/PDF/CERT-In_Directions_70B_28.04.2022.pdf</a:t>
             </a:r>
           </a:p>
           <a:p>
             <a:pPr>
               <a:spcAft>
-                <a:spcPts val="1100"/>
+                <a:spcPts val="450"/>
               </a:spcAft>
             </a:pPr>
             <a:r>
-              <a:rPr sz="950" b="0">
-                <a:solidFill>
-                  <a:srgbClr val="1F5FBF"/>
-                </a:solidFill>
-                <a:latin typeface="Calibri"/>
-              </a:rPr>
-              <a:t>    </a:t>
-            </a:r>
-            <a:r>
-              <a:rPr sz="1050" b="0" u="sng">
-                <a:solidFill>
-                  <a:srgbClr val="1F5FBF"/>
-                </a:solidFill>
-                <a:latin typeface="Calibri"/>
-                <a:hlinkClick r:id="rId12"/>
-              </a:rPr>
-              <a:t>pib.gov.in</a:t>
-            </a:r>
-          </a:p>
-        </p:txBody>
-      </p:sp>
-      <p:sp>
-        <p:nvSpPr>
-          <p:cNvPr id="43" name="TextBox 42"/>
-          <p:cNvSpPr txBox="1"/>
-          <p:nvPr/>
-        </p:nvSpPr>
-        <p:spPr>
-          <a:xfrm>
-            <a:off x="4050792" y="1645920"/>
-            <a:ext cx="3447288" cy="1554480"/>
-          </a:xfrm>
-          <a:prstGeom prst="rect">
-            <a:avLst/>
-          </a:prstGeom>
-          <a:noFill/>
-        </p:spPr>
-        <p:txBody>
-          <a:bodyPr wrap="square" lIns="36576" rIns="36576" tIns="9144" bIns="9144" anchor="t">
-            <a:spAutoFit/>
-          </a:bodyPr>
-          <a:lstStyle/>
+              <a:rPr sz="1050" b="1" i="0">
+                <a:solidFill>
+                  <a:srgbClr val="000000"/>
+                </a:solidFill>
+                <a:latin typeface="Arial"/>
+              </a:rPr>
+              <a:t>[5]  </a:t>
+            </a:r>
+            <a:r>
+              <a:rPr sz="1050" b="0" i="0">
+                <a:solidFill>
+                  <a:srgbClr val="1A1A1A"/>
+                </a:solidFill>
+                <a:latin typeface="Arial"/>
+              </a:rPr>
+              <a:t>Open Government Data Platform India, "Year-wise Number of Cyber Security Incidents as per CERT-In, 2020–2024." </a:t>
+            </a:r>
+            <a:r>
+              <a:rPr sz="1000" b="0" i="0" u="sng">
+                <a:solidFill>
+                  <a:srgbClr val="0563C1"/>
+                </a:solidFill>
+                <a:latin typeface="Arial"/>
+                <a:hlinkClick r:id="rId11"/>
+              </a:rPr>
+              <a:t>https://www.data.gov.in/resource/year-wise-number-cyber-security-incidents-indian-computer-emergency-response-team-cert</a:t>
+            </a:r>
+          </a:p>
           <a:p>
             <a:pPr>
               <a:spcAft>
-                <a:spcPts val="0"/>
+                <a:spcPts val="450"/>
               </a:spcAft>
             </a:pPr>
             <a:r>
-              <a:rPr sz="1050" b="1">
-                <a:solidFill>
-                  <a:srgbClr val="0B2A5B"/>
-                </a:solidFill>
-                <a:latin typeface="Calibri"/>
-              </a:rPr>
-              <a:t>▸ </a:t>
-            </a:r>
-            <a:r>
-              <a:rPr sz="1150" b="1">
-                <a:solidFill>
-                  <a:srgbClr val="0B2A5B"/>
-                </a:solidFill>
-                <a:latin typeface="Calibri"/>
-              </a:rPr>
-              <a:t>NCIIPC, NTRO</a:t>
+              <a:rPr sz="1050" b="1" i="0">
+                <a:solidFill>
+                  <a:srgbClr val="000000"/>
+                </a:solidFill>
+                <a:latin typeface="Arial"/>
+              </a:rPr>
+              <a:t>[6]  </a:t>
+            </a:r>
+            <a:r>
+              <a:rPr sz="1050" b="0" i="0">
+                <a:solidFill>
+                  <a:srgbClr val="1A1A1A"/>
+                </a:solidFill>
+                <a:latin typeface="Arial"/>
+              </a:rPr>
+              <a:t>PIB, "CERT-In: India's Frontline Defender against Cyber Threats," 23 January 2026. </a:t>
+            </a:r>
+            <a:r>
+              <a:rPr sz="1000" b="0" i="0" u="sng">
+                <a:solidFill>
+                  <a:srgbClr val="0563C1"/>
+                </a:solidFill>
+                <a:latin typeface="Arial"/>
+                <a:hlinkClick r:id="rId12"/>
+              </a:rPr>
+              <a:t>https://www.pib.gov.in/PressReleasePage.aspx?PRID=2217537</a:t>
             </a:r>
           </a:p>
           <a:p>
             <a:pPr>
               <a:spcAft>
-                <a:spcPts val="1100"/>
+                <a:spcPts val="450"/>
               </a:spcAft>
             </a:pPr>
             <a:r>
-              <a:rPr sz="950" b="0">
-                <a:solidFill>
-                  <a:srgbClr val="1F5FBF"/>
-                </a:solidFill>
-                <a:latin typeface="Calibri"/>
-              </a:rPr>
-              <a:t>    </a:t>
-            </a:r>
-            <a:r>
-              <a:rPr sz="1050" b="0" u="sng">
-                <a:solidFill>
-                  <a:srgbClr val="1F5FBF"/>
-                </a:solidFill>
-                <a:latin typeface="Calibri"/>
+              <a:rPr sz="1050" b="1" i="0">
+                <a:solidFill>
+                  <a:srgbClr val="000000"/>
+                </a:solidFill>
+                <a:latin typeface="Arial"/>
+              </a:rPr>
+              <a:t>[7]  </a:t>
+            </a:r>
+            <a:r>
+              <a:rPr sz="1050" b="0" i="0">
+                <a:solidFill>
+                  <a:srgbClr val="1A1A1A"/>
+                </a:solidFill>
+                <a:latin typeface="Arial"/>
+              </a:rPr>
+              <a:t>National Critical Information Infrastructure Protection Centre (NCIIPC), NTRO. </a:t>
+            </a:r>
+            <a:r>
+              <a:rPr sz="1000" b="0" i="0" u="sng">
+                <a:solidFill>
+                  <a:srgbClr val="0563C1"/>
+                </a:solidFill>
+                <a:latin typeface="Arial"/>
                 <a:hlinkClick r:id="rId9"/>
               </a:rPr>
-              <a:t>nciipc.gov.in</a:t>
+              <a:t>https://nciipc.gov.in</a:t>
             </a:r>
           </a:p>
           <a:p>
             <a:pPr>
               <a:spcAft>
-                <a:spcPts val="0"/>
+                <a:spcPts val="450"/>
               </a:spcAft>
             </a:pPr>
             <a:r>
-              <a:rPr sz="1050" b="1">
-                <a:solidFill>
-                  <a:srgbClr val="0B2A5B"/>
-                </a:solidFill>
-                <a:latin typeface="Calibri"/>
-              </a:rPr>
-              <a:t>▸ </a:t>
-            </a:r>
-            <a:r>
-              <a:rPr sz="1150" b="1">
-                <a:solidFill>
-                  <a:srgbClr val="0B2A5B"/>
-                </a:solidFill>
-                <a:latin typeface="Calibri"/>
-              </a:rPr>
-              <a:t>Information Technology Act, 2000</a:t>
+              <a:rPr sz="1050" b="1" i="0">
+                <a:solidFill>
+                  <a:srgbClr val="000000"/>
+                </a:solidFill>
+                <a:latin typeface="Arial"/>
+              </a:rPr>
+              <a:t>[8]  </a:t>
+            </a:r>
+            <a:r>
+              <a:rPr sz="1050" b="0" i="0">
+                <a:solidFill>
+                  <a:srgbClr val="1A1A1A"/>
+                </a:solidFill>
+                <a:latin typeface="Arial"/>
+              </a:rPr>
+              <a:t>The Information Technology Act, 2000, India Code. </a:t>
+            </a:r>
+            <a:r>
+              <a:rPr sz="1000" b="0" i="0" u="sng">
+                <a:solidFill>
+                  <a:srgbClr val="0563C1"/>
+                </a:solidFill>
+                <a:latin typeface="Arial"/>
+                <a:hlinkClick r:id="rId13"/>
+              </a:rPr>
+              <a:t>https://www.indiacode.nic.in/handle/123456789/1999</a:t>
             </a:r>
           </a:p>
           <a:p>
             <a:pPr>
               <a:spcAft>
-                <a:spcPts val="1100"/>
+                <a:spcPts val="450"/>
               </a:spcAft>
             </a:pPr>
             <a:r>
-              <a:rPr sz="950" b="0">
-                <a:solidFill>
-                  <a:srgbClr val="1F5FBF"/>
-                </a:solidFill>
-                <a:latin typeface="Calibri"/>
-              </a:rPr>
-              <a:t>    </a:t>
-            </a:r>
-            <a:r>
-              <a:rPr sz="1050" b="0" u="sng">
-                <a:solidFill>
-                  <a:srgbClr val="1F5FBF"/>
-                </a:solidFill>
-                <a:latin typeface="Calibri"/>
-                <a:hlinkClick r:id="rId13"/>
-              </a:rPr>
-              <a:t>indiacode.nic.in</a:t>
+              <a:rPr sz="1050" b="1" i="0">
+                <a:solidFill>
+                  <a:srgbClr val="000000"/>
+                </a:solidFill>
+                <a:latin typeface="Arial"/>
+              </a:rPr>
+              <a:t>[9]  </a:t>
+            </a:r>
+            <a:r>
+              <a:rPr sz="1050" b="0" i="0">
+                <a:solidFill>
+                  <a:srgbClr val="1A1A1A"/>
+                </a:solidFill>
+                <a:latin typeface="Arial"/>
+              </a:rPr>
+              <a:t>The Digital Personal Data Protection Act, 2023, MeitY. </a:t>
+            </a:r>
+            <a:r>
+              <a:rPr sz="1000" b="0" i="0" u="sng">
+                <a:solidFill>
+                  <a:srgbClr val="0563C1"/>
+                </a:solidFill>
+                <a:latin typeface="Arial"/>
+                <a:hlinkClick r:id="rId14"/>
+              </a:rPr>
+              <a:t>https://www.meity.gov.in/static/uploads/2024/06/2bf1f0e9f04e6fb4f8fef35e82c42aa5.pdf</a:t>
+            </a:r>
+          </a:p>
+          <a:p>
+            <a:pPr>
+              <a:spcBef>
+                <a:spcPts val="800"/>
+              </a:spcBef>
+              <a:spcAft>
+                <a:spcPts val="200"/>
+              </a:spcAft>
+            </a:pPr>
+            <a:r>
+              <a:rPr sz="1400" b="1" i="0">
+                <a:solidFill>
+                  <a:srgbClr val="1F4E79"/>
+                </a:solidFill>
+                <a:latin typeface="Arial"/>
+              </a:rPr>
+              <a:t>❖  </a:t>
+            </a:r>
+            <a:r>
+              <a:rPr sz="1400" b="1" i="0" u="sng">
+                <a:solidFill>
+                  <a:srgbClr val="1F4E79"/>
+                </a:solidFill>
+                <a:latin typeface="Arial"/>
+              </a:rPr>
+              <a:t>Datasets, Standards &amp; Tools</a:t>
             </a:r>
           </a:p>
           <a:p>
             <a:pPr>
               <a:spcAft>
-                <a:spcPts val="0"/>
+                <a:spcPts val="450"/>
               </a:spcAft>
             </a:pPr>
             <a:r>
-              <a:rPr sz="1050" b="1">
-                <a:solidFill>
-                  <a:srgbClr val="0B2A5B"/>
-                </a:solidFill>
-                <a:latin typeface="Calibri"/>
-              </a:rPr>
-              <a:t>▸ </a:t>
-            </a:r>
-            <a:r>
-              <a:rPr sz="1150" b="1">
-                <a:solidFill>
-                  <a:srgbClr val="0B2A5B"/>
-                </a:solidFill>
-                <a:latin typeface="Calibri"/>
-              </a:rPr>
-              <a:t>Digital Personal Data Protection Act, 2023</a:t>
+              <a:rPr sz="1050" b="1" i="0">
+                <a:solidFill>
+                  <a:srgbClr val="000000"/>
+                </a:solidFill>
+                <a:latin typeface="Arial"/>
+              </a:rPr>
+              <a:t>[10]  </a:t>
+            </a:r>
+            <a:r>
+              <a:rPr sz="1050" b="0" i="0">
+                <a:solidFill>
+                  <a:srgbClr val="1A1A1A"/>
+                </a:solidFill>
+                <a:latin typeface="Arial"/>
+              </a:rPr>
+              <a:t>Loghub, real-world system log datasets (LogPAI). </a:t>
+            </a:r>
+            <a:r>
+              <a:rPr sz="1000" b="0" i="0" u="sng">
+                <a:solidFill>
+                  <a:srgbClr val="0563C1"/>
+                </a:solidFill>
+                <a:latin typeface="Arial"/>
+                <a:hlinkClick r:id="rId2"/>
+              </a:rPr>
+              <a:t>https://github.com/logpai/loghub</a:t>
             </a:r>
           </a:p>
           <a:p>
             <a:pPr>
               <a:spcAft>
-                <a:spcPts val="1100"/>
+                <a:spcPts val="450"/>
               </a:spcAft>
             </a:pPr>
             <a:r>
-              <a:rPr sz="950" b="0">
-                <a:solidFill>
-                  <a:srgbClr val="1F5FBF"/>
-                </a:solidFill>
-                <a:latin typeface="Calibri"/>
-              </a:rPr>
-              <a:t>    </a:t>
-            </a:r>
-            <a:r>
-              <a:rPr sz="1050" b="0" u="sng">
-                <a:solidFill>
-                  <a:srgbClr val="1F5FBF"/>
-                </a:solidFill>
-                <a:latin typeface="Calibri"/>
-                <a:hlinkClick r:id="rId14"/>
-              </a:rPr>
-              <a:t>meity.gov.in</a:t>
-            </a:r>
-          </a:p>
-        </p:txBody>
-      </p:sp>
-      <p:sp>
-        <p:nvSpPr>
-          <p:cNvPr id="44" name="Rectangle 43"/>
-          <p:cNvSpPr/>
-          <p:nvPr/>
-        </p:nvSpPr>
-        <p:spPr>
-          <a:xfrm>
-            <a:off x="6903720" y="1216152"/>
-            <a:ext cx="228600" cy="146304"/>
-          </a:xfrm>
-          <a:prstGeom prst="rect">
-            <a:avLst/>
-          </a:prstGeom>
-          <a:solidFill>
-            <a:srgbClr val="FF9933"/>
-          </a:solidFill>
-          <a:ln>
-            <a:noFill/>
-          </a:ln>
-          <a:effectLst/>
-        </p:spPr>
-        <p:style>
-          <a:lnRef idx="1">
-            <a:schemeClr val="accent1"/>
-          </a:lnRef>
-          <a:fillRef idx="3">
-            <a:schemeClr val="accent1"/>
-          </a:fillRef>
-          <a:effectRef idx="2">
-            <a:schemeClr val="accent1"/>
-          </a:effectRef>
-          <a:fontRef idx="minor">
-            <a:schemeClr val="lt1"/>
-          </a:fontRef>
-        </p:style>
-        <p:txBody>
-          <a:bodyPr rtlCol="0" anchor="ctr"/>
-          <a:lstStyle/>
-          <a:p>
-            <a:pPr algn="ctr"/>
-          </a:p>
-        </p:txBody>
-      </p:sp>
-      <p:sp>
-        <p:nvSpPr>
-          <p:cNvPr id="45" name="Rectangle 44"/>
-          <p:cNvSpPr/>
-          <p:nvPr/>
-        </p:nvSpPr>
-        <p:spPr>
-          <a:xfrm>
-            <a:off x="7132320" y="1216152"/>
-            <a:ext cx="228600" cy="146304"/>
-          </a:xfrm>
-          <a:prstGeom prst="rect">
-            <a:avLst/>
-          </a:prstGeom>
-          <a:solidFill>
-            <a:srgbClr val="FFFFFF"/>
-          </a:solidFill>
-          <a:ln w="12700">
-            <a:solidFill>
-              <a:srgbClr val="D5DCE6"/>
-            </a:solidFill>
-          </a:ln>
-          <a:effectLst/>
-        </p:spPr>
-        <p:style>
-          <a:lnRef idx="1">
-            <a:schemeClr val="accent1"/>
-          </a:lnRef>
-          <a:fillRef idx="3">
-            <a:schemeClr val="accent1"/>
-          </a:fillRef>
-          <a:effectRef idx="2">
-            <a:schemeClr val="accent1"/>
-          </a:effectRef>
-          <a:fontRef idx="minor">
-            <a:schemeClr val="lt1"/>
-          </a:fontRef>
-        </p:style>
-        <p:txBody>
-          <a:bodyPr rtlCol="0" anchor="ctr"/>
-          <a:lstStyle/>
-          <a:p>
-            <a:pPr algn="ctr"/>
-          </a:p>
-        </p:txBody>
-      </p:sp>
-      <p:sp>
-        <p:nvSpPr>
-          <p:cNvPr id="46" name="Rectangle 45"/>
-          <p:cNvSpPr/>
-          <p:nvPr/>
-        </p:nvSpPr>
-        <p:spPr>
-          <a:xfrm>
-            <a:off x="7360920" y="1216152"/>
-            <a:ext cx="228600" cy="146304"/>
-          </a:xfrm>
-          <a:prstGeom prst="rect">
-            <a:avLst/>
-          </a:prstGeom>
-          <a:solidFill>
-            <a:srgbClr val="138808"/>
-          </a:solidFill>
-          <a:ln>
-            <a:noFill/>
-          </a:ln>
-          <a:effectLst/>
-        </p:spPr>
-        <p:style>
-          <a:lnRef idx="1">
-            <a:schemeClr val="accent1"/>
-          </a:lnRef>
-          <a:fillRef idx="3">
-            <a:schemeClr val="accent1"/>
-          </a:fillRef>
-          <a:effectRef idx="2">
-            <a:schemeClr val="accent1"/>
-          </a:effectRef>
-          <a:fontRef idx="minor">
-            <a:schemeClr val="lt1"/>
-          </a:fontRef>
-        </p:style>
-        <p:txBody>
-          <a:bodyPr rtlCol="0" anchor="ctr"/>
-          <a:lstStyle/>
-          <a:p>
-            <a:pPr algn="ctr"/>
-          </a:p>
-        </p:txBody>
-      </p:sp>
-      <p:sp>
-        <p:nvSpPr>
-          <p:cNvPr id="47" name="Rounded Rectangle 46"/>
-          <p:cNvSpPr/>
-          <p:nvPr/>
-        </p:nvSpPr>
-        <p:spPr>
-          <a:xfrm>
-            <a:off x="365760" y="3383280"/>
-            <a:ext cx="3593592" cy="2962656"/>
-          </a:xfrm>
-          <a:prstGeom prst="roundRect">
-            <a:avLst>
-              <a:gd name="adj" fmla="val 4000"/>
-            </a:avLst>
-          </a:prstGeom>
-          <a:solidFill>
-            <a:srgbClr val="FFFFFF"/>
-          </a:solidFill>
-          <a:ln w="12700">
-            <a:solidFill>
-              <a:srgbClr val="D5DCE6"/>
-            </a:solidFill>
-          </a:ln>
-          <a:effectLst/>
-        </p:spPr>
-        <p:style>
-          <a:lnRef idx="1">
-            <a:schemeClr val="accent1"/>
-          </a:lnRef>
-          <a:fillRef idx="3">
-            <a:schemeClr val="accent1"/>
-          </a:fillRef>
-          <a:effectRef idx="2">
-            <a:schemeClr val="accent1"/>
-          </a:effectRef>
-          <a:fontRef idx="minor">
-            <a:schemeClr val="lt1"/>
-          </a:fontRef>
-        </p:style>
-        <p:txBody>
-          <a:bodyPr rtlCol="0" anchor="ctr"/>
-          <a:lstStyle/>
-          <a:p>
-            <a:pPr algn="ctr"/>
-          </a:p>
-        </p:txBody>
-      </p:sp>
-      <p:sp>
-        <p:nvSpPr>
-          <p:cNvPr id="48" name="Rounded Rectangle 47"/>
-          <p:cNvSpPr/>
-          <p:nvPr/>
-        </p:nvSpPr>
-        <p:spPr>
-          <a:xfrm>
-            <a:off x="365760" y="3383280"/>
-            <a:ext cx="3593592" cy="384048"/>
-          </a:xfrm>
-          <a:prstGeom prst="roundRect">
-            <a:avLst>
-              <a:gd name="adj" fmla="val 18000"/>
-            </a:avLst>
-          </a:prstGeom>
-          <a:solidFill>
-            <a:srgbClr val="1F5FBF"/>
-          </a:solidFill>
-          <a:ln>
-            <a:noFill/>
-          </a:ln>
-          <a:effectLst/>
-        </p:spPr>
-        <p:style>
-          <a:lnRef idx="1">
-            <a:schemeClr val="accent1"/>
-          </a:lnRef>
-          <a:fillRef idx="3">
-            <a:schemeClr val="accent1"/>
-          </a:fillRef>
-          <a:effectRef idx="2">
-            <a:schemeClr val="accent1"/>
-          </a:effectRef>
-          <a:fontRef idx="minor">
-            <a:schemeClr val="lt1"/>
-          </a:fontRef>
-        </p:style>
-        <p:txBody>
-          <a:bodyPr rtlCol="0" anchor="ctr"/>
-          <a:lstStyle/>
-          <a:p>
-            <a:pPr algn="ctr"/>
-          </a:p>
-        </p:txBody>
-      </p:sp>
-      <p:sp>
-        <p:nvSpPr>
-          <p:cNvPr id="49" name="TextBox 48"/>
-          <p:cNvSpPr txBox="1"/>
-          <p:nvPr/>
-        </p:nvSpPr>
-        <p:spPr>
-          <a:xfrm>
-            <a:off x="530352" y="3383280"/>
-            <a:ext cx="3319272" cy="384048"/>
-          </a:xfrm>
-          <a:prstGeom prst="rect">
-            <a:avLst/>
-          </a:prstGeom>
-          <a:noFill/>
-        </p:spPr>
-        <p:txBody>
-          <a:bodyPr wrap="square" lIns="36576" rIns="36576" tIns="9144" bIns="9144" anchor="ctr">
-            <a:spAutoFit/>
-          </a:bodyPr>
-          <a:lstStyle/>
-          <a:p>
-            <a:r>
-              <a:rPr sz="1350" b="1">
-                <a:solidFill>
-                  <a:srgbClr val="FFFFFF"/>
-                </a:solidFill>
-                <a:latin typeface="Calibri"/>
-              </a:rPr>
-              <a:t>RESEARCH &amp; DATASETS</a:t>
-            </a:r>
-          </a:p>
-        </p:txBody>
-      </p:sp>
-      <p:sp>
-        <p:nvSpPr>
-          <p:cNvPr id="50" name="TextBox 49"/>
-          <p:cNvSpPr txBox="1"/>
-          <p:nvPr/>
-        </p:nvSpPr>
-        <p:spPr>
-          <a:xfrm>
-            <a:off x="530352" y="3931920"/>
-            <a:ext cx="3246120" cy="2368296"/>
-          </a:xfrm>
-          <a:prstGeom prst="rect">
-            <a:avLst/>
-          </a:prstGeom>
-          <a:noFill/>
-        </p:spPr>
-        <p:txBody>
-          <a:bodyPr wrap="square" lIns="36576" rIns="36576" tIns="9144" bIns="9144" anchor="t">
-            <a:spAutoFit/>
-          </a:bodyPr>
-          <a:lstStyle/>
+              <a:rPr sz="1050" b="1" i="0">
+                <a:solidFill>
+                  <a:srgbClr val="000000"/>
+                </a:solidFill>
+                <a:latin typeface="Arial"/>
+              </a:rPr>
+              <a:t>[11]  </a:t>
+            </a:r>
+            <a:r>
+              <a:rPr sz="1050" b="0" i="0">
+                <a:solidFill>
+                  <a:srgbClr val="1A1A1A"/>
+                </a:solidFill>
+                <a:latin typeface="Arial"/>
+              </a:rPr>
+              <a:t>Drain3, streaming log template miner (LogPAI). </a:t>
+            </a:r>
+            <a:r>
+              <a:rPr sz="1000" b="0" i="0" u="sng">
+                <a:solidFill>
+                  <a:srgbClr val="0563C1"/>
+                </a:solidFill>
+                <a:latin typeface="Arial"/>
+                <a:hlinkClick r:id="rId4"/>
+              </a:rPr>
+              <a:t>https://github.com/logpai/Drain3</a:t>
+            </a:r>
+          </a:p>
           <a:p>
             <a:pPr>
               <a:spcAft>
-                <a:spcPts val="0"/>
+                <a:spcPts val="450"/>
               </a:spcAft>
             </a:pPr>
             <a:r>
-              <a:rPr sz="1050" b="1">
-                <a:solidFill>
-                  <a:srgbClr val="1F5FBF"/>
-                </a:solidFill>
-                <a:latin typeface="Calibri"/>
-              </a:rPr>
-              <a:t>▸ </a:t>
-            </a:r>
-            <a:r>
-              <a:rPr sz="1200" b="1">
-                <a:solidFill>
-                  <a:srgbClr val="0B2A5B"/>
-                </a:solidFill>
-                <a:latin typeface="Calibri"/>
-              </a:rPr>
-              <a:t>Drain log parser, ICWS 2017</a:t>
+              <a:rPr sz="1050" b="1" i="0">
+                <a:solidFill>
+                  <a:srgbClr val="000000"/>
+                </a:solidFill>
+                <a:latin typeface="Arial"/>
+              </a:rPr>
+              <a:t>[12]  </a:t>
+            </a:r>
+            <a:r>
+              <a:rPr sz="1050" b="0" i="0">
+                <a:solidFill>
+                  <a:srgbClr val="1A1A1A"/>
+                </a:solidFill>
+                <a:latin typeface="Arial"/>
+              </a:rPr>
+              <a:t>R. Gerhards, "The Syslog Protocol," IETF RFC 5424, 2009. </a:t>
+            </a:r>
+            <a:r>
+              <a:rPr sz="1000" b="0" i="0" u="sng">
+                <a:solidFill>
+                  <a:srgbClr val="0563C1"/>
+                </a:solidFill>
+                <a:latin typeface="Arial"/>
+                <a:hlinkClick r:id="rId18"/>
+              </a:rPr>
+              <a:t>https://datatracker.ietf.org/doc/html/rfc5424</a:t>
             </a:r>
           </a:p>
           <a:p>
             <a:pPr>
               <a:spcAft>
-                <a:spcPts val="1600"/>
+                <a:spcPts val="450"/>
               </a:spcAft>
             </a:pPr>
             <a:r>
-              <a:rPr sz="950" b="0">
-                <a:solidFill>
-                  <a:srgbClr val="1F5FBF"/>
-                </a:solidFill>
-                <a:latin typeface="Calibri"/>
-              </a:rPr>
-              <a:t>    </a:t>
-            </a:r>
-            <a:r>
-              <a:rPr sz="1050" b="0" u="sng">
-                <a:solidFill>
-                  <a:srgbClr val="1F5FBF"/>
-                </a:solidFill>
-                <a:latin typeface="Calibri"/>
-                <a:hlinkClick r:id="rId15"/>
-              </a:rPr>
-              <a:t>doi.org/10.1109/ICWS.2017.13</a:t>
-            </a:r>
-          </a:p>
-          <a:p>
-            <a:pPr>
-              <a:spcAft>
-                <a:spcPts val="0"/>
-              </a:spcAft>
-            </a:pPr>
-            <a:r>
-              <a:rPr sz="1050" b="1">
-                <a:solidFill>
-                  <a:srgbClr val="1F5FBF"/>
-                </a:solidFill>
-                <a:latin typeface="Calibri"/>
-              </a:rPr>
-              <a:t>▸ </a:t>
-            </a:r>
-            <a:r>
-              <a:rPr sz="1200" b="1">
-                <a:solidFill>
-                  <a:srgbClr val="0B2A5B"/>
-                </a:solidFill>
-                <a:latin typeface="Calibri"/>
-              </a:rPr>
-              <a:t>Loghub datasets, ISSRE 2023</a:t>
-            </a:r>
-          </a:p>
-          <a:p>
-            <a:pPr>
-              <a:spcAft>
-                <a:spcPts val="1600"/>
-              </a:spcAft>
-            </a:pPr>
-            <a:r>
-              <a:rPr sz="950" b="0">
-                <a:solidFill>
-                  <a:srgbClr val="1F5FBF"/>
-                </a:solidFill>
-                <a:latin typeface="Calibri"/>
-              </a:rPr>
-              <a:t>    </a:t>
-            </a:r>
-            <a:r>
-              <a:rPr sz="1050" b="0" u="sng">
-                <a:solidFill>
-                  <a:srgbClr val="1F5FBF"/>
-                </a:solidFill>
-                <a:latin typeface="Calibri"/>
-                <a:hlinkClick r:id="rId16"/>
-              </a:rPr>
-              <a:t>arxiv.org/abs/2008.06448</a:t>
-            </a:r>
-          </a:p>
-          <a:p>
-            <a:pPr>
-              <a:spcAft>
-                <a:spcPts val="0"/>
-              </a:spcAft>
-            </a:pPr>
-            <a:r>
-              <a:rPr sz="1050" b="1">
-                <a:solidFill>
-                  <a:srgbClr val="1F5FBF"/>
-                </a:solidFill>
-                <a:latin typeface="Calibri"/>
-              </a:rPr>
-              <a:t>▸ </a:t>
-            </a:r>
-            <a:r>
-              <a:rPr sz="1200" b="1">
-                <a:solidFill>
-                  <a:srgbClr val="0B2A5B"/>
-                </a:solidFill>
-                <a:latin typeface="Calibri"/>
-              </a:rPr>
-              <a:t>Log-parser benchmark, ICSE-SEIP 2019</a:t>
-            </a:r>
-          </a:p>
-          <a:p>
-            <a:pPr>
-              <a:spcAft>
-                <a:spcPts val="1600"/>
-              </a:spcAft>
-            </a:pPr>
-            <a:r>
-              <a:rPr sz="950" b="0">
-                <a:solidFill>
-                  <a:srgbClr val="1F5FBF"/>
-                </a:solidFill>
-                <a:latin typeface="Calibri"/>
-              </a:rPr>
-              <a:t>    </a:t>
-            </a:r>
-            <a:r>
-              <a:rPr sz="1050" b="0" u="sng">
-                <a:solidFill>
-                  <a:srgbClr val="1F5FBF"/>
-                </a:solidFill>
-                <a:latin typeface="Calibri"/>
-                <a:hlinkClick r:id="rId17"/>
-              </a:rPr>
-              <a:t>arxiv.org/abs/1811.03509</a:t>
-            </a:r>
-          </a:p>
-          <a:p>
-            <a:pPr>
-              <a:spcAft>
-                <a:spcPts val="0"/>
-              </a:spcAft>
-            </a:pPr>
-            <a:r>
-              <a:rPr sz="1050" b="1">
-                <a:solidFill>
-                  <a:srgbClr val="1F5FBF"/>
-                </a:solidFill>
-                <a:latin typeface="Calibri"/>
-              </a:rPr>
-              <a:t>▸ </a:t>
-            </a:r>
-            <a:r>
-              <a:rPr sz="1200" b="1">
-                <a:solidFill>
-                  <a:srgbClr val="0B2A5B"/>
-                </a:solidFill>
-                <a:latin typeface="Calibri"/>
-              </a:rPr>
-              <a:t>Loghub log samples</a:t>
-            </a:r>
-          </a:p>
-          <a:p>
-            <a:pPr>
-              <a:spcAft>
-                <a:spcPts val="1600"/>
-              </a:spcAft>
-            </a:pPr>
-            <a:r>
-              <a:rPr sz="950" b="0">
-                <a:solidFill>
-                  <a:srgbClr val="1F5FBF"/>
-                </a:solidFill>
-                <a:latin typeface="Calibri"/>
-              </a:rPr>
-              <a:t>    </a:t>
-            </a:r>
-            <a:r>
-              <a:rPr sz="1050" b="0" u="sng">
-                <a:solidFill>
-                  <a:srgbClr val="1F5FBF"/>
-                </a:solidFill>
-                <a:latin typeface="Calibri"/>
-                <a:hlinkClick r:id="rId2"/>
-              </a:rPr>
-              <a:t>github.com/logpai/loghub</a:t>
-            </a:r>
-          </a:p>
-        </p:txBody>
-      </p:sp>
-      <p:sp>
-        <p:nvSpPr>
-          <p:cNvPr id="51" name="Rounded Rectangle 50"/>
-          <p:cNvSpPr/>
-          <p:nvPr/>
-        </p:nvSpPr>
-        <p:spPr>
-          <a:xfrm>
-            <a:off x="4087368" y="3383280"/>
-            <a:ext cx="3593592" cy="2962656"/>
-          </a:xfrm>
-          <a:prstGeom prst="roundRect">
-            <a:avLst>
-              <a:gd name="adj" fmla="val 4000"/>
-            </a:avLst>
-          </a:prstGeom>
-          <a:solidFill>
-            <a:srgbClr val="FFFFFF"/>
-          </a:solidFill>
-          <a:ln w="12700">
-            <a:solidFill>
-              <a:srgbClr val="D5DCE6"/>
-            </a:solidFill>
-          </a:ln>
-          <a:effectLst/>
-        </p:spPr>
-        <p:style>
-          <a:lnRef idx="1">
-            <a:schemeClr val="accent1"/>
-          </a:lnRef>
-          <a:fillRef idx="3">
-            <a:schemeClr val="accent1"/>
-          </a:fillRef>
-          <a:effectRef idx="2">
-            <a:schemeClr val="accent1"/>
-          </a:effectRef>
-          <a:fontRef idx="minor">
-            <a:schemeClr val="lt1"/>
-          </a:fontRef>
-        </p:style>
-        <p:txBody>
-          <a:bodyPr rtlCol="0" anchor="ctr"/>
-          <a:lstStyle/>
-          <a:p>
-            <a:pPr algn="ctr"/>
-          </a:p>
-        </p:txBody>
-      </p:sp>
-      <p:sp>
-        <p:nvSpPr>
-          <p:cNvPr id="52" name="Rounded Rectangle 51"/>
-          <p:cNvSpPr/>
-          <p:nvPr/>
-        </p:nvSpPr>
-        <p:spPr>
-          <a:xfrm>
-            <a:off x="4087368" y="3383280"/>
-            <a:ext cx="3593592" cy="384048"/>
-          </a:xfrm>
-          <a:prstGeom prst="roundRect">
-            <a:avLst>
-              <a:gd name="adj" fmla="val 18000"/>
-            </a:avLst>
-          </a:prstGeom>
-          <a:solidFill>
-            <a:srgbClr val="138A36"/>
-          </a:solidFill>
-          <a:ln>
-            <a:noFill/>
-          </a:ln>
-          <a:effectLst/>
-        </p:spPr>
-        <p:style>
-          <a:lnRef idx="1">
-            <a:schemeClr val="accent1"/>
-          </a:lnRef>
-          <a:fillRef idx="3">
-            <a:schemeClr val="accent1"/>
-          </a:fillRef>
-          <a:effectRef idx="2">
-            <a:schemeClr val="accent1"/>
-          </a:effectRef>
-          <a:fontRef idx="minor">
-            <a:schemeClr val="lt1"/>
-          </a:fontRef>
-        </p:style>
-        <p:txBody>
-          <a:bodyPr rtlCol="0" anchor="ctr"/>
-          <a:lstStyle/>
-          <a:p>
-            <a:pPr algn="ctr"/>
-          </a:p>
-        </p:txBody>
-      </p:sp>
-      <p:sp>
-        <p:nvSpPr>
-          <p:cNvPr id="53" name="TextBox 52"/>
-          <p:cNvSpPr txBox="1"/>
-          <p:nvPr/>
-        </p:nvSpPr>
-        <p:spPr>
-          <a:xfrm>
-            <a:off x="4251960" y="3383280"/>
-            <a:ext cx="3319272" cy="384048"/>
-          </a:xfrm>
-          <a:prstGeom prst="rect">
-            <a:avLst/>
-          </a:prstGeom>
-          <a:noFill/>
-        </p:spPr>
-        <p:txBody>
-          <a:bodyPr wrap="square" lIns="36576" rIns="36576" tIns="9144" bIns="9144" anchor="ctr">
-            <a:spAutoFit/>
-          </a:bodyPr>
-          <a:lstStyle/>
-          <a:p>
-            <a:r>
-              <a:rPr sz="1350" b="1">
-                <a:solidFill>
-                  <a:srgbClr val="FFFFFF"/>
-                </a:solidFill>
-                <a:latin typeface="Calibri"/>
-              </a:rPr>
-              <a:t>STANDARDS &amp; TOOLS</a:t>
-            </a:r>
-          </a:p>
-        </p:txBody>
-      </p:sp>
-      <p:sp>
-        <p:nvSpPr>
-          <p:cNvPr id="54" name="TextBox 53"/>
-          <p:cNvSpPr txBox="1"/>
-          <p:nvPr/>
-        </p:nvSpPr>
-        <p:spPr>
-          <a:xfrm>
-            <a:off x="4251960" y="3931920"/>
-            <a:ext cx="3246120" cy="2368296"/>
-          </a:xfrm>
-          <a:prstGeom prst="rect">
-            <a:avLst/>
-          </a:prstGeom>
-          <a:noFill/>
-        </p:spPr>
-        <p:txBody>
-          <a:bodyPr wrap="square" lIns="36576" rIns="36576" tIns="9144" bIns="9144" anchor="t">
-            <a:spAutoFit/>
-          </a:bodyPr>
-          <a:lstStyle/>
-          <a:p>
-            <a:pPr>
-              <a:spcAft>
-                <a:spcPts val="0"/>
-              </a:spcAft>
-            </a:pPr>
-            <a:r>
-              <a:rPr sz="1050" b="1">
-                <a:solidFill>
-                  <a:srgbClr val="138A36"/>
-                </a:solidFill>
-                <a:latin typeface="Calibri"/>
-              </a:rPr>
-              <a:t>▸ </a:t>
-            </a:r>
-            <a:r>
-              <a:rPr sz="1200" b="1">
-                <a:solidFill>
-                  <a:srgbClr val="0B2A5B"/>
-                </a:solidFill>
-                <a:latin typeface="Calibri"/>
-              </a:rPr>
-              <a:t>Syslog protocol, RFC 5424</a:t>
-            </a:r>
-          </a:p>
-          <a:p>
-            <a:pPr>
-              <a:spcAft>
-                <a:spcPts val="1600"/>
-              </a:spcAft>
-            </a:pPr>
-            <a:r>
-              <a:rPr sz="950" b="0">
-                <a:solidFill>
-                  <a:srgbClr val="1F5FBF"/>
-                </a:solidFill>
-                <a:latin typeface="Calibri"/>
-              </a:rPr>
-              <a:t>    </a:t>
-            </a:r>
-            <a:r>
-              <a:rPr sz="1050" b="0" u="sng">
-                <a:solidFill>
-                  <a:srgbClr val="1F5FBF"/>
-                </a:solidFill>
-                <a:latin typeface="Calibri"/>
-                <a:hlinkClick r:id="rId18"/>
-              </a:rPr>
-              <a:t>datatracker.ietf.org/doc/rfc5424</a:t>
-            </a:r>
-          </a:p>
-          <a:p>
-            <a:pPr>
-              <a:spcAft>
-                <a:spcPts val="0"/>
-              </a:spcAft>
-            </a:pPr>
-            <a:r>
-              <a:rPr sz="1050" b="1">
-                <a:solidFill>
-                  <a:srgbClr val="138A36"/>
-                </a:solidFill>
-                <a:latin typeface="Calibri"/>
-              </a:rPr>
-              <a:t>▸ </a:t>
-            </a:r>
-            <a:r>
-              <a:rPr sz="1200" b="1">
-                <a:solidFill>
-                  <a:srgbClr val="0B2A5B"/>
-                </a:solidFill>
-                <a:latin typeface="Calibri"/>
-              </a:rPr>
-              <a:t>Drain3 library</a:t>
-            </a:r>
-          </a:p>
-          <a:p>
-            <a:pPr>
-              <a:spcAft>
-                <a:spcPts val="1600"/>
-              </a:spcAft>
-            </a:pPr>
-            <a:r>
-              <a:rPr sz="950" b="0">
-                <a:solidFill>
-                  <a:srgbClr val="1F5FBF"/>
-                </a:solidFill>
-                <a:latin typeface="Calibri"/>
-              </a:rPr>
-              <a:t>    </a:t>
-            </a:r>
-            <a:r>
-              <a:rPr sz="1050" b="0" u="sng">
-                <a:solidFill>
-                  <a:srgbClr val="1F5FBF"/>
-                </a:solidFill>
-                <a:latin typeface="Calibri"/>
-                <a:hlinkClick r:id="rId4"/>
-              </a:rPr>
-              <a:t>github.com/logpai/Drain3</a:t>
-            </a:r>
-          </a:p>
-          <a:p>
-            <a:pPr>
-              <a:spcAft>
-                <a:spcPts val="0"/>
-              </a:spcAft>
-            </a:pPr>
-            <a:r>
-              <a:rPr sz="1050" b="1">
-                <a:solidFill>
-                  <a:srgbClr val="138A36"/>
-                </a:solidFill>
-                <a:latin typeface="Calibri"/>
-              </a:rPr>
-              <a:t>▸ </a:t>
-            </a:r>
-            <a:r>
-              <a:rPr sz="1200" b="1">
-                <a:solidFill>
-                  <a:srgbClr val="0B2A5B"/>
-                </a:solidFill>
-                <a:latin typeface="Calibri"/>
-              </a:rPr>
-              <a:t>scikit-learn</a:t>
-            </a:r>
-          </a:p>
-          <a:p>
-            <a:pPr>
-              <a:spcAft>
-                <a:spcPts val="1600"/>
-              </a:spcAft>
-            </a:pPr>
-            <a:r>
-              <a:rPr sz="950" b="0">
-                <a:solidFill>
-                  <a:srgbClr val="1F5FBF"/>
-                </a:solidFill>
-                <a:latin typeface="Calibri"/>
-              </a:rPr>
-              <a:t>    </a:t>
-            </a:r>
-            <a:r>
-              <a:rPr sz="1050" b="0" u="sng">
-                <a:solidFill>
-                  <a:srgbClr val="1F5FBF"/>
-                </a:solidFill>
-                <a:latin typeface="Calibri"/>
+              <a:rPr sz="1050" b="1" i="0">
+                <a:solidFill>
+                  <a:srgbClr val="000000"/>
+                </a:solidFill>
+                <a:latin typeface="Arial"/>
+              </a:rPr>
+              <a:t>[13]  </a:t>
+            </a:r>
+            <a:r>
+              <a:rPr sz="1050" b="0" i="0">
+                <a:solidFill>
+                  <a:srgbClr val="1A1A1A"/>
+                </a:solidFill>
+                <a:latin typeface="Arial"/>
+              </a:rPr>
+              <a:t>F. Pedregosa et al., "Scikit-learn: Machine Learning in Python," JMLR 12, 2011. </a:t>
+            </a:r>
+            <a:r>
+              <a:rPr sz="1000" b="0" i="0" u="sng">
+                <a:solidFill>
+                  <a:srgbClr val="0563C1"/>
+                </a:solidFill>
+                <a:latin typeface="Arial"/>
                 <a:hlinkClick r:id="rId19"/>
               </a:rPr>
-              <a:t>scikit-learn.org</a:t>
-            </a:r>
-          </a:p>
-          <a:p>
-            <a:pPr>
-              <a:spcAft>
-                <a:spcPts val="0"/>
-              </a:spcAft>
-            </a:pPr>
-            <a:r>
-              <a:rPr sz="1050" b="1">
-                <a:solidFill>
-                  <a:srgbClr val="138A36"/>
-                </a:solidFill>
-                <a:latin typeface="Calibri"/>
-              </a:rPr>
-              <a:t>▸ </a:t>
-            </a:r>
-            <a:r>
-              <a:rPr sz="1200" b="1">
-                <a:solidFill>
-                  <a:srgbClr val="0B2A5B"/>
-                </a:solidFill>
-                <a:latin typeface="Calibri"/>
-              </a:rPr>
-              <a:t>FastAPI</a:t>
-            </a:r>
-          </a:p>
-          <a:p>
-            <a:pPr>
-              <a:spcAft>
-                <a:spcPts val="1600"/>
-              </a:spcAft>
-            </a:pPr>
-            <a:r>
-              <a:rPr sz="950" b="0">
-                <a:solidFill>
-                  <a:srgbClr val="1F5FBF"/>
-                </a:solidFill>
-                <a:latin typeface="Calibri"/>
-              </a:rPr>
-              <a:t>    </a:t>
-            </a:r>
-            <a:r>
-              <a:rPr sz="1050" b="0" u="sng">
-                <a:solidFill>
-                  <a:srgbClr val="1F5FBF"/>
-                </a:solidFill>
-                <a:latin typeface="Calibri"/>
-                <a:hlinkClick r:id="rId20"/>
-              </a:rPr>
-              <a:t>fastapi.tiangolo.com</a:t>
+              <a:t>https://scikit-learn.org</a:t>
             </a:r>
           </a:p>
         </p:txBody>

</xml_diff>